<commit_message>
update: refine portfolio strategies categorization in PPT sync with notebook analysis
</commit_message>
<xml_diff>
--- a/Presentasi_Proposal_Update.pptx
+++ b/Presentasi_Proposal_Update.pptx
@@ -4637,7 +4637,7 @@
                   <a:srgbClr val="003366"/>
                 </a:solidFill>
               </a:rPr>
-              <a:t>5. Network Markowitz (NW) Adaptif</a:t>
+              <a:t>Network Markowitz (NW) Adaptif</a:t>
             </a:r>
             <a:endParaRPr lang="en-US" sz="2800" dirty="0"/>
           </a:p>
@@ -4652,7 +4652,7 @@
         <p:spPr>
           <a:xfrm>
             <a:off x="457200" y="1005840"/>
-            <a:ext cx="8229600" cy="4572000"/>
+            <a:ext cx="8229600" cy="5029200"/>
           </a:xfrm>
           <a:prstGeom prst="rect">
             <a:avLst/>
@@ -4668,70 +4668,68 @@
               <a:buNone/>
             </a:pPr>
             <a:r>
-              <a:rPr lang="en-US" sz="1800" b="1" dirty="0">
+              <a:rPr lang="en-US" sz="1300" b="1" dirty="0">
                 <a:solidFill>
                   <a:srgbClr val="333333"/>
                 </a:solidFill>
               </a:rPr>
               <a:t>Mekanisme Optimasi Dinamis:</a:t>
             </a:r>
-            <a:endParaRPr lang="en-US" sz="1800" dirty="0"/>
-          </a:p>
-          <a:p>
-            <a:pPr marL="342900" indent="-342900">
-              <a:buSzPct val="100000"/>
-              <a:buChar char="•"/>
-            </a:pPr>
-            <a:r>
-              <a:rPr lang="en-US" sz="1800" dirty="0">
-                <a:solidFill>
-                  <a:srgbClr val="333333"/>
-                </a:solidFill>
-              </a:rPr>
-              <a:t>Rolling Window: Menggunakan jendela estimasi data historis selama </a:t>
-            </a:r>
-            <a:pPr indent="0" marL="0">
-              <a:buNone/>
-            </a:pPr>
-            <a:r>
-              <a:rPr lang="en-US" sz="1800" b="1" dirty="0">
-                <a:solidFill>
-                  <a:srgbClr val="333333"/>
-                </a:solidFill>
-              </a:rPr>
-              <a:t>120 hari</a:t>
-            </a:r>
-            <a:pPr indent="0" marL="0">
-              <a:buNone/>
-            </a:pPr>
-            <a:r>
-              <a:rPr lang="en-US" sz="1800" dirty="0">
+            <a:endParaRPr lang="en-US" sz="1300" dirty="0"/>
+          </a:p>
+          <a:p>
+            <a:pPr indent="0" marL="0">
+              <a:buNone/>
+            </a:pPr>
+            <a:r>
+              <a:rPr lang="en-US" sz="1300" dirty="0">
+                <a:solidFill>
+                  <a:srgbClr val="333333"/>
+                </a:solidFill>
+              </a:rPr>
+              <a:t>❑ Rolling Window: Menggunakan 4 variasi jendela estimasi: </a:t>
+            </a:r>
+            <a:pPr indent="0" marL="0">
+              <a:buNone/>
+            </a:pPr>
+            <a:r>
+              <a:rPr lang="en-US" sz="1300" b="1" dirty="0">
+                <a:solidFill>
+                  <a:srgbClr val="333333"/>
+                </a:solidFill>
+              </a:rPr>
+              <a:t>30, 60, 90, dan 120 hari</a:t>
+            </a:r>
+            <a:pPr indent="0" marL="0">
+              <a:buNone/>
+            </a:pPr>
+            <a:r>
+              <a:rPr lang="en-US" sz="1300" dirty="0">
                 <a:solidFill>
                   <a:srgbClr val="333333"/>
                 </a:solidFill>
               </a:rPr>
               <a:t>.</a:t>
             </a:r>
-            <a:endParaRPr lang="en-US" sz="1800" dirty="0"/>
-          </a:p>
-          <a:p>
-            <a:pPr marL="342900" indent="-342900">
-              <a:buSzPct val="100000"/>
-              <a:buChar char="•"/>
-            </a:pPr>
-            <a:r>
-              <a:rPr lang="en-US" sz="1800" dirty="0">
-                <a:solidFill>
-                  <a:srgbClr val="333333"/>
-                </a:solidFill>
-              </a:rPr>
-              <a:t>Rebalancing Frequency: Dilakukan setiap </a:t>
-            </a:r>
-            <a:pPr indent="0" marL="0">
-              <a:buNone/>
-            </a:pPr>
-            <a:r>
-              <a:rPr lang="en-US" sz="1800" b="1" dirty="0">
+            <a:endParaRPr lang="en-US" sz="1300" dirty="0"/>
+          </a:p>
+          <a:p>
+            <a:pPr indent="0" marL="0">
+              <a:buNone/>
+            </a:pPr>
+            <a:r>
+              <a:rPr lang="en-US" sz="1300" dirty="0">
+                <a:solidFill>
+                  <a:srgbClr val="333333"/>
+                </a:solidFill>
+              </a:rPr>
+              <a:t>❑ Rebalancing Frequency: Dilakukan setiap </a:t>
+            </a:r>
+            <a:pPr indent="0" marL="0">
+              <a:buNone/>
+            </a:pPr>
+            <a:r>
+              <a:rPr lang="en-US" sz="1300" b="1" dirty="0">
                 <a:solidFill>
                   <a:srgbClr val="333333"/>
                 </a:solidFill>
@@ -4742,33 +4740,32 @@
               <a:buNone/>
             </a:pPr>
             <a:r>
-              <a:rPr lang="en-US" sz="1800" dirty="0">
+              <a:rPr lang="en-US" sz="1300" dirty="0">
                 <a:solidFill>
                   <a:srgbClr val="333333"/>
                 </a:solidFill>
               </a:rPr>
               <a:t> sekali.</a:t>
             </a:r>
-            <a:endParaRPr lang="en-US" sz="1800" dirty="0"/>
-          </a:p>
-          <a:p>
-            <a:pPr marL="342900" indent="-342900">
-              <a:buSzPct val="100000"/>
-              <a:buChar char="•"/>
-            </a:pPr>
-            <a:r>
-              <a:rPr lang="en-US" sz="1800" dirty="0">
-                <a:solidFill>
-                  <a:srgbClr val="333333"/>
-                </a:solidFill>
-              </a:rPr>
-              <a:t>Transaction Cost: Biaya transaksi sebesar </a:t>
-            </a:r>
-            <a:pPr indent="0" marL="0">
-              <a:buNone/>
-            </a:pPr>
-            <a:r>
-              <a:rPr lang="en-US" sz="1800" b="1" dirty="0">
+            <a:endParaRPr lang="en-US" sz="1300" dirty="0"/>
+          </a:p>
+          <a:p>
+            <a:pPr indent="0" marL="0">
+              <a:buNone/>
+            </a:pPr>
+            <a:r>
+              <a:rPr lang="en-US" sz="1300" dirty="0">
+                <a:solidFill>
+                  <a:srgbClr val="333333"/>
+                </a:solidFill>
+              </a:rPr>
+              <a:t>❑ Transaction Cost: Biaya transaksi sebesar </a:t>
+            </a:r>
+            <a:pPr indent="0" marL="0">
+              <a:buNone/>
+            </a:pPr>
+            <a:r>
+              <a:rPr lang="en-US" sz="1300" b="1" dirty="0">
                 <a:solidFill>
                   <a:srgbClr val="333333"/>
                 </a:solidFill>
@@ -4779,33 +4776,32 @@
               <a:buNone/>
             </a:pPr>
             <a:r>
-              <a:rPr lang="en-US" sz="1800" dirty="0">
+              <a:rPr lang="en-US" sz="1300" dirty="0">
                 <a:solidFill>
                   <a:srgbClr val="333333"/>
                 </a:solidFill>
               </a:rPr>
               <a:t> diperhitungkan dalam simulasi.</a:t>
             </a:r>
-            <a:endParaRPr lang="en-US" sz="1800" dirty="0"/>
-          </a:p>
-          <a:p>
-            <a:pPr marL="342900" indent="-342900">
-              <a:buSzPct val="100000"/>
-              <a:buChar char="•"/>
-            </a:pPr>
-            <a:r>
-              <a:rPr lang="en-US" sz="1800" dirty="0">
-                <a:solidFill>
-                  <a:srgbClr val="333333"/>
-                </a:solidFill>
-              </a:rPr>
-              <a:t>Grid Search: Parameter gamma diuji dalam rentang </a:t>
-            </a:r>
-            <a:pPr indent="0" marL="0">
-              <a:buNone/>
-            </a:pPr>
-            <a:r>
-              <a:rPr lang="en-US" sz="1800" b="1" dirty="0">
+            <a:endParaRPr lang="en-US" sz="1300" dirty="0"/>
+          </a:p>
+          <a:p>
+            <a:pPr indent="0" marL="0">
+              <a:buNone/>
+            </a:pPr>
+            <a:r>
+              <a:rPr lang="en-US" sz="1300" dirty="0">
+                <a:solidFill>
+                  <a:srgbClr val="333333"/>
+                </a:solidFill>
+              </a:rPr>
+              <a:t>❑ Grid Search: Parameter gamma diuji dalam rentang </a:t>
+            </a:r>
+            <a:pPr indent="0" marL="0">
+              <a:buNone/>
+            </a:pPr>
+            <a:r>
+              <a:rPr lang="en-US" sz="1300" b="1" dirty="0">
                 <a:solidFill>
                   <a:srgbClr val="333333"/>
                 </a:solidFill>
@@ -4816,48 +4812,46 @@
               <a:buNone/>
             </a:pPr>
             <a:r>
-              <a:rPr lang="en-US" sz="1800" dirty="0">
+              <a:rPr lang="en-US" sz="1300" dirty="0">
                 <a:solidFill>
                   <a:srgbClr val="333333"/>
                 </a:solidFill>
               </a:rPr>
               <a:t> dengan iterasi 0.1.</a:t>
             </a:r>
-            <a:endParaRPr lang="en-US" sz="1800" dirty="0"/>
-          </a:p>
-          <a:p>
-            <a:pPr marL="342900" indent="-342900">
-              <a:buSzPct val="100000"/>
-              <a:buChar char="•"/>
-            </a:pPr>
-            <a:r>
-              <a:rPr lang="en-US" sz="1800" b="1" dirty="0">
+            <a:endParaRPr lang="en-US" sz="1300" dirty="0"/>
+          </a:p>
+          <a:p>
+            <a:pPr indent="0" marL="0">
+              <a:buNone/>
+            </a:pPr>
+            <a:r>
+              <a:rPr lang="en-US" sz="1300" b="1" dirty="0">
                 <a:solidFill>
                   <a:srgbClr val="333333"/>
                 </a:solidFill>
               </a:rPr>
               <a:t>Split Validasi Internal (80/20):</a:t>
             </a:r>
-            <a:endParaRPr lang="en-US" sz="1800" dirty="0"/>
-          </a:p>
-          <a:p>
-            <a:pPr marL="254000" indent="-254000">
-              <a:buSzPct val="100000"/>
-              <a:buChar char="•"/>
-            </a:pPr>
-            <a:r>
-              <a:rPr lang="en-US" sz="1800" dirty="0">
-                <a:solidFill>
-                  <a:srgbClr val="333333"/>
-                </a:solidFill>
-              </a:rPr>
-              <a:t>Training (80% ≈ 96 hari): Untuk estimasi </a:t>
-            </a:r>
-            <a:pPr indent="0" marL="0">
-              <a:buNone/>
-            </a:pPr>
-            <a:r>
-              <a:rPr lang="en-US" sz="1800" b="1" dirty="0">
+            <a:endParaRPr lang="en-US" sz="1300" dirty="0"/>
+          </a:p>
+          <a:p>
+            <a:pPr indent="0" marL="0">
+              <a:buNone/>
+            </a:pPr>
+            <a:r>
+              <a:rPr lang="en-US" sz="1300" dirty="0">
+                <a:solidFill>
+                  <a:srgbClr val="333333"/>
+                </a:solidFill>
+              </a:rPr>
+              <a:t>❑ Training (80%): Untuk estimasi </a:t>
+            </a:r>
+            <a:pPr indent="0" marL="0">
+              <a:buNone/>
+            </a:pPr>
+            <a:r>
+              <a:rPr lang="en-US" sz="1300" b="1" dirty="0">
                 <a:solidFill>
                   <a:srgbClr val="333333"/>
                 </a:solidFill>
@@ -4868,33 +4862,32 @@
               <a:buNone/>
             </a:pPr>
             <a:r>
-              <a:rPr lang="en-US" sz="1800" dirty="0">
+              <a:rPr lang="en-US" sz="1300" dirty="0">
                 <a:solidFill>
                   <a:srgbClr val="333333"/>
                 </a:solidFill>
               </a:rPr>
               <a:t> gamma.</a:t>
             </a:r>
-            <a:endParaRPr lang="en-US" sz="1800" dirty="0"/>
-          </a:p>
-          <a:p>
-            <a:pPr marL="254000" indent="-254000">
-              <a:buSzPct val="100000"/>
-              <a:buChar char="•"/>
-            </a:pPr>
-            <a:r>
-              <a:rPr lang="en-US" sz="1800" dirty="0">
-                <a:solidFill>
-                  <a:srgbClr val="333333"/>
-                </a:solidFill>
-              </a:rPr>
-              <a:t>Validation (20% ≈ 24 hari): Untuk seleksi </a:t>
-            </a:r>
-            <a:pPr indent="0" marL="0">
-              <a:buNone/>
-            </a:pPr>
-            <a:r>
-              <a:rPr lang="en-US" sz="1800" b="1" dirty="0">
+            <a:endParaRPr lang="en-US" sz="1300" dirty="0"/>
+          </a:p>
+          <a:p>
+            <a:pPr indent="0" marL="0">
+              <a:buNone/>
+            </a:pPr>
+            <a:r>
+              <a:rPr lang="en-US" sz="1300" dirty="0">
+                <a:solidFill>
+                  <a:srgbClr val="333333"/>
+                </a:solidFill>
+              </a:rPr>
+              <a:t>❑ Validation (20%): Untuk seleksi </a:t>
+            </a:r>
+            <a:pPr indent="0" marL="0">
+              <a:buNone/>
+            </a:pPr>
+            <a:r>
+              <a:rPr lang="en-US" sz="1300" b="1" dirty="0">
                 <a:solidFill>
                   <a:srgbClr val="333333"/>
                 </a:solidFill>
@@ -4905,33 +4898,32 @@
               <a:buNone/>
             </a:pPr>
             <a:r>
-              <a:rPr lang="en-US" sz="1800" dirty="0">
+              <a:rPr lang="en-US" sz="1300" dirty="0">
                 <a:solidFill>
                   <a:srgbClr val="333333"/>
                 </a:solidFill>
               </a:rPr>
               <a:t> dengan performa optimal.</a:t>
             </a:r>
-            <a:endParaRPr lang="en-US" sz="1800" dirty="0"/>
-          </a:p>
-          <a:p>
-            <a:pPr marL="342900" indent="-342900">
-              <a:buSzPct val="100000"/>
-              <a:buChar char="•"/>
-            </a:pPr>
-            <a:r>
-              <a:rPr lang="en-US" sz="1800" dirty="0">
-                <a:solidFill>
-                  <a:srgbClr val="333333"/>
-                </a:solidFill>
-              </a:rPr>
-              <a:t>Penanganan Data/Gagal: Menggunakan strategi </a:t>
-            </a:r>
-            <a:pPr indent="0" marL="0">
-              <a:buNone/>
-            </a:pPr>
-            <a:r>
-              <a:rPr lang="en-US" sz="1800" b="1" dirty="0">
+            <a:endParaRPr lang="en-US" sz="1300" dirty="0"/>
+          </a:p>
+          <a:p>
+            <a:pPr indent="0" marL="0">
+              <a:buNone/>
+            </a:pPr>
+            <a:r>
+              <a:rPr lang="en-US" sz="1300" dirty="0">
+                <a:solidFill>
+                  <a:srgbClr val="333333"/>
+                </a:solidFill>
+              </a:rPr>
+              <a:t>❑ Penanganan Data/Gagal: Menggunakan strategi </a:t>
+            </a:r>
+            <a:pPr indent="0" marL="0">
+              <a:buNone/>
+            </a:pPr>
+            <a:r>
+              <a:rPr lang="en-US" sz="1300" b="1" dirty="0">
                 <a:solidFill>
                   <a:srgbClr val="333333"/>
                 </a:solidFill>
@@ -4942,33 +4934,32 @@
               <a:buNone/>
             </a:pPr>
             <a:r>
-              <a:rPr lang="en-US" sz="1800" dirty="0">
-                <a:solidFill>
-                  <a:srgbClr val="333333"/>
-                </a:solidFill>
-              </a:rPr>
-              <a:t> jika jendela data &lt; 120 hari.</a:t>
-            </a:r>
-            <a:endParaRPr lang="en-US" sz="1800" dirty="0"/>
-          </a:p>
-          <a:p>
-            <a:pPr marL="342900" indent="-342900">
-              <a:buSzPct val="100000"/>
-              <a:buChar char="•"/>
-            </a:pPr>
-            <a:r>
-              <a:rPr lang="en-US" sz="1800" dirty="0">
-                <a:solidFill>
-                  <a:srgbClr val="333333"/>
-                </a:solidFill>
-              </a:rPr>
-              <a:t>Tujuan: Adaptasi terhadap perubahan </a:t>
-            </a:r>
-            <a:pPr indent="0" marL="0">
-              <a:buNone/>
-            </a:pPr>
-            <a:r>
-              <a:rPr lang="en-US" sz="1800" b="1" dirty="0">
+              <a:rPr lang="en-US" sz="1300" dirty="0">
+                <a:solidFill>
+                  <a:srgbClr val="333333"/>
+                </a:solidFill>
+              </a:rPr>
+              <a:t> jika jendela data tidak mencukupi sesuai variasi.</a:t>
+            </a:r>
+            <a:endParaRPr lang="en-US" sz="1300" dirty="0"/>
+          </a:p>
+          <a:p>
+            <a:pPr indent="0" marL="0">
+              <a:buNone/>
+            </a:pPr>
+            <a:r>
+              <a:rPr lang="en-US" sz="1300" dirty="0">
+                <a:solidFill>
+                  <a:srgbClr val="333333"/>
+                </a:solidFill>
+              </a:rPr>
+              <a:t>❑ Tujuan: Adaptasi terhadap perubahan </a:t>
+            </a:r>
+            <a:pPr indent="0" marL="0">
+              <a:buNone/>
+            </a:pPr>
+            <a:r>
+              <a:rPr lang="en-US" sz="1300" b="1" dirty="0">
                 <a:solidFill>
                   <a:srgbClr val="333333"/>
                 </a:solidFill>
@@ -4979,14 +4970,14 @@
               <a:buNone/>
             </a:pPr>
             <a:r>
-              <a:rPr lang="en-US" sz="1800" dirty="0">
+              <a:rPr lang="en-US" sz="1300" dirty="0">
                 <a:solidFill>
                   <a:srgbClr val="333333"/>
                 </a:solidFill>
               </a:rPr>
               <a:t> secara real-time.</a:t>
             </a:r>
-            <a:endParaRPr lang="en-US" sz="1800" dirty="0"/>
+            <a:endParaRPr lang="en-US" sz="1300" dirty="0"/>
           </a:p>
         </p:txBody>
       </p:sp>
@@ -9358,7 +9349,7 @@
         <p:spPr>
           <a:xfrm>
             <a:off x="457200" y="1005840"/>
-            <a:ext cx="8229600" cy="3657600"/>
+            <a:ext cx="8229600" cy="4572000"/>
           </a:xfrm>
           <a:prstGeom prst="rect">
             <a:avLst/>
@@ -9384,9 +9375,19 @@
             <a:endParaRPr lang="en-US" sz="1800" dirty="0"/>
           </a:p>
           <a:p>
-            <a:pPr marL="342900" indent="-342900">
-              <a:buSzPct val="100000"/>
-              <a:buChar char="•"/>
+            <a:pPr indent="0" marL="0">
+              <a:buNone/>
+            </a:pPr>
+            <a:r>
+              <a:rPr lang="en-US" sz="1800" b="1" dirty="0">
+                <a:solidFill>
+                  <a:srgbClr val="333333"/>
+                </a:solidFill>
+              </a:rPr>
+              <a:t>Fluktuasi harga acak</a:t>
+            </a:r>
+            <a:pPr indent="0" marL="0">
+              <a:buNone/>
             </a:pPr>
             <a:r>
               <a:rPr lang="en-US" sz="1800" dirty="0">
@@ -9394,8 +9395,17 @@
                   <a:srgbClr val="333333"/>
                 </a:solidFill>
               </a:rPr>
-              <a:t>   </a:t>
-            </a:r>
+              <a:t> akibat sentimen sesaat, rumor, FOMO, atau spekulasi yang tidak mencerminkan nilai fundamental aset.</a:t>
+            </a:r>
+            <a:endParaRPr lang="en-US" sz="1800" dirty="0"/>
+          </a:p>
+          <a:p>
+            <a:pPr indent="0" marL="0">
+              <a:buNone/>
+            </a:pPr>
+            <a:endParaRPr lang="en-US" sz="1800" dirty="0"/>
+          </a:p>
+          <a:p>
             <a:pPr indent="0" marL="0">
               <a:buNone/>
             </a:pPr>
@@ -9405,8 +9415,11 @@
                   <a:srgbClr val="333333"/>
                 </a:solidFill>
               </a:rPr>
-              <a:t>Fluktuasi harga acak</a:t>
-            </a:r>
+              <a:t>Estimation Error (Korelasi Palsu):</a:t>
+            </a:r>
+            <a:endParaRPr lang="en-US" sz="1800" dirty="0"/>
+          </a:p>
+          <a:p>
             <a:pPr indent="0" marL="0">
               <a:buNone/>
             </a:pPr>
@@ -9416,7 +9429,51 @@
                   <a:srgbClr val="333333"/>
                 </a:solidFill>
               </a:rPr>
-              <a:t> akibat sentimen sesaat, rumor, FOMO, atau spekulasi yang tidak mencerminkan nilai fundamental aset.</a:t>
+              <a:t>Model tradisional seringkali menangkap pergerakan acak ini sebagai korelasi tinggi antar aset, menghasilkan </a:t>
+            </a:r>
+            <a:pPr indent="0" marL="0">
+              <a:buNone/>
+            </a:pPr>
+            <a:r>
+              <a:rPr lang="en-US" sz="1800" b="1" dirty="0">
+                <a:solidFill>
+                  <a:srgbClr val="333333"/>
+                </a:solidFill>
+              </a:rPr>
+              <a:t>matriks kovarians</a:t>
+            </a:r>
+            <a:pPr indent="0" marL="0">
+              <a:buNone/>
+            </a:pPr>
+            <a:r>
+              <a:rPr lang="en-US" sz="1800" dirty="0">
+                <a:solidFill>
+                  <a:srgbClr val="333333"/>
+                </a:solidFill>
+              </a:rPr>
+              <a:t> yang </a:t>
+            </a:r>
+            <a:pPr indent="0" marL="0">
+              <a:buNone/>
+            </a:pPr>
+            <a:r>
+              <a:rPr lang="en-US" sz="1800" i="1" dirty="0">
+                <a:solidFill>
+                  <a:srgbClr val="333333"/>
+                </a:solidFill>
+              </a:rPr>
+              <a:t>berisik</a:t>
+            </a:r>
+            <a:pPr indent="0" marL="0">
+              <a:buNone/>
+            </a:pPr>
+            <a:r>
+              <a:rPr lang="en-US" sz="1800" dirty="0">
+                <a:solidFill>
+                  <a:srgbClr val="333333"/>
+                </a:solidFill>
+              </a:rPr>
+              <a:t> dan tidak stabil.</a:t>
             </a:r>
             <a:endParaRPr lang="en-US" sz="1800" dirty="0"/>
           </a:p>
@@ -9424,94 +9481,6 @@
             <a:pPr indent="0" marL="0">
               <a:buNone/>
             </a:pPr>
-            <a:r>
-              <a:rPr lang="en-US" sz="1800" b="1" dirty="0">
-                <a:solidFill>
-                  <a:srgbClr val="333333"/>
-                </a:solidFill>
-              </a:rPr>
-              <a:t>Estimation Error (</a:t>
-            </a:r>
-            <a:pPr indent="0" marL="0">
-              <a:buNone/>
-            </a:pPr>
-            <a:r>
-              <a:rPr lang="en-US" sz="1800" b="1" dirty="0">
-                <a:solidFill>
-                  <a:srgbClr val="333333"/>
-                </a:solidFill>
-              </a:rPr>
-              <a:t>Korelasi Palsu</a:t>
-            </a:r>
-            <a:pPr indent="0" marL="0">
-              <a:buNone/>
-            </a:pPr>
-            <a:r>
-              <a:rPr lang="en-US" sz="1800" b="1" dirty="0">
-                <a:solidFill>
-                  <a:srgbClr val="333333"/>
-                </a:solidFill>
-              </a:rPr>
-              <a:t>):</a:t>
-            </a:r>
-            <a:endParaRPr lang="en-US" sz="1800" dirty="0"/>
-          </a:p>
-          <a:p>
-            <a:pPr indent="0" marL="0">
-              <a:buNone/>
-            </a:pPr>
-            <a:r>
-              <a:rPr lang="en-US" sz="1800" dirty="0">
-                <a:solidFill>
-                  <a:srgbClr val="333333"/>
-                </a:solidFill>
-              </a:rPr>
-              <a:t>   Model tradisional seringkali menangkap pergerakan acak ini sebagai korelasi tinggi antar aset, menghasilkan </a:t>
-            </a:r>
-            <a:pPr indent="0" marL="0">
-              <a:buNone/>
-            </a:pPr>
-            <a:r>
-              <a:rPr lang="en-US" sz="1800" b="1" dirty="0">
-                <a:solidFill>
-                  <a:srgbClr val="333333"/>
-                </a:solidFill>
-              </a:rPr>
-              <a:t>matriks kovarians</a:t>
-            </a:r>
-            <a:pPr indent="0" marL="0">
-              <a:buNone/>
-            </a:pPr>
-            <a:r>
-              <a:rPr lang="en-US" sz="1800" dirty="0">
-                <a:solidFill>
-                  <a:srgbClr val="333333"/>
-                </a:solidFill>
-              </a:rPr>
-              <a:t> yang </a:t>
-            </a:r>
-            <a:pPr indent="0" marL="0">
-              <a:buNone/>
-            </a:pPr>
-            <a:r>
-              <a:rPr lang="en-US" sz="1800" b="1" i="1" dirty="0">
-                <a:solidFill>
-                  <a:srgbClr val="333333"/>
-                </a:solidFill>
-              </a:rPr>
-              <a:t>berisik</a:t>
-            </a:r>
-            <a:pPr indent="0" marL="0">
-              <a:buNone/>
-            </a:pPr>
-            <a:r>
-              <a:rPr lang="en-US" sz="1800" dirty="0">
-                <a:solidFill>
-                  <a:srgbClr val="333333"/>
-                </a:solidFill>
-              </a:rPr>
-              <a:t> dan tidak stabil.</a:t>
-            </a:r>
             <a:endParaRPr lang="en-US" sz="1800" dirty="0"/>
           </a:p>
           <a:p>
@@ -9558,9 +9527,8 @@
             <a:endParaRPr lang="en-US" sz="1800" dirty="0"/>
           </a:p>
           <a:p>
-            <a:pPr marL="342900" indent="-342900">
-              <a:buSzPct val="100000"/>
-              <a:buChar char="•"/>
+            <a:pPr indent="0" marL="0">
+              <a:buNone/>
             </a:pPr>
             <a:r>
               <a:rPr lang="en-US" sz="1800" dirty="0">
@@ -9568,7 +9536,7 @@
                   <a:srgbClr val="333333"/>
                 </a:solidFill>
               </a:rPr>
-              <a:t>   Berfungsi sebagai </a:t>
+              <a:t>Berfungsi sebagai </a:t>
             </a:r>
             <a:pPr indent="0" marL="0">
               <a:buNone/>
@@ -10621,33 +10589,54 @@
               <a:buNone/>
             </a:pPr>
             <a:r>
-              <a:rPr lang="en-US" sz="1300" b="1" dirty="0">
+              <a:rPr lang="en-US" sz="1350" b="1" dirty="0">
                 <a:solidFill>
                   <a:srgbClr val="333333"/>
                 </a:solidFill>
               </a:rPr>
               <a:t>Tinjauan Portofolio &amp; Risiko:</a:t>
             </a:r>
-            <a:endParaRPr lang="en-US" sz="1300" dirty="0"/>
-          </a:p>
-          <a:p>
-            <a:pPr marL="342900" indent="-342900">
-              <a:buSzPct val="100000"/>
-              <a:buChar char="•"/>
-            </a:pPr>
-            <a:r>
-              <a:rPr lang="en-US" sz="1300" dirty="0">
-                <a:solidFill>
-                  <a:srgbClr val="333333"/>
-                </a:solidFill>
-              </a:rPr>
-              <a:t>   Portofolio: Kumpulan aset finansial yang dikelola bersama untuk mengoptimalkan </a:t>
-            </a:r>
-            <a:pPr indent="0" marL="0">
-              <a:buNone/>
-            </a:pPr>
-            <a:r>
-              <a:rPr lang="en-US" sz="1300" b="1" dirty="0">
+            <a:endParaRPr lang="en-US" sz="1350" dirty="0"/>
+          </a:p>
+          <a:p>
+            <a:pPr indent="0" marL="0">
+              <a:buNone/>
+            </a:pPr>
+            <a:r>
+              <a:rPr lang="en-US" sz="1350" dirty="0">
+                <a:solidFill>
+                  <a:srgbClr val="333333"/>
+                </a:solidFill>
+              </a:rPr>
+              <a:t>➤ </a:t>
+            </a:r>
+            <a:pPr indent="0" marL="0">
+              <a:buNone/>
+            </a:pPr>
+            <a:r>
+              <a:rPr lang="en-US" sz="1350" u="sng" dirty="0">
+                <a:solidFill>
+                  <a:srgbClr val="333333"/>
+                </a:solidFill>
+              </a:rPr>
+              <a:t>Portofolio</a:t>
+            </a:r>
+            <a:pPr indent="0" marL="0">
+              <a:buNone/>
+            </a:pPr>
+            <a:r>
+              <a:rPr lang="en-US" sz="1350" dirty="0">
+                <a:solidFill>
+                  <a:srgbClr val="333333"/>
+                </a:solidFill>
+              </a:rPr>
+              <a:t>: Kumpulan aset finansial yang dikelola bersama untuk mengoptimalkan </a:t>
+            </a:r>
+            <a:pPr indent="0" marL="0">
+              <a:buNone/>
+            </a:pPr>
+            <a:r>
+              <a:rPr lang="en-US" sz="1350" b="1" dirty="0">
                 <a:solidFill>
                   <a:srgbClr val="333333"/>
                 </a:solidFill>
@@ -10658,33 +10647,54 @@
               <a:buNone/>
             </a:pPr>
             <a:r>
-              <a:rPr lang="en-US" sz="1300" dirty="0">
+              <a:rPr lang="en-US" sz="1350" dirty="0">
                 <a:solidFill>
                   <a:srgbClr val="333333"/>
                 </a:solidFill>
               </a:rPr>
               <a:t> melalui diversifikasi.</a:t>
             </a:r>
-            <a:endParaRPr lang="en-US" sz="1300" dirty="0"/>
-          </a:p>
-          <a:p>
-            <a:pPr marL="342900" indent="-342900">
-              <a:buSzPct val="100000"/>
-              <a:buChar char="•"/>
-            </a:pPr>
-            <a:r>
-              <a:rPr lang="en-US" sz="1300" dirty="0">
-                <a:solidFill>
-                  <a:srgbClr val="333333"/>
-                </a:solidFill>
-              </a:rPr>
-              <a:t>   Volatilitas: Alat statistik pemetaan </a:t>
-            </a:r>
-            <a:pPr indent="0" marL="0">
-              <a:buNone/>
-            </a:pPr>
-            <a:r>
-              <a:rPr lang="en-US" sz="1300" b="1" dirty="0">
+            <a:endParaRPr lang="en-US" sz="1350" dirty="0"/>
+          </a:p>
+          <a:p>
+            <a:pPr indent="0" marL="0">
+              <a:buNone/>
+            </a:pPr>
+            <a:r>
+              <a:rPr lang="en-US" sz="1350" dirty="0">
+                <a:solidFill>
+                  <a:srgbClr val="333333"/>
+                </a:solidFill>
+              </a:rPr>
+              <a:t>➤ </a:t>
+            </a:r>
+            <a:pPr indent="0" marL="0">
+              <a:buNone/>
+            </a:pPr>
+            <a:r>
+              <a:rPr lang="en-US" sz="1350" u="sng" dirty="0">
+                <a:solidFill>
+                  <a:srgbClr val="333333"/>
+                </a:solidFill>
+              </a:rPr>
+              <a:t>Volatilitas</a:t>
+            </a:r>
+            <a:pPr indent="0" marL="0">
+              <a:buNone/>
+            </a:pPr>
+            <a:r>
+              <a:rPr lang="en-US" sz="1350" dirty="0">
+                <a:solidFill>
+                  <a:srgbClr val="333333"/>
+                </a:solidFill>
+              </a:rPr>
+              <a:t>: Alat statistik pemetaan </a:t>
+            </a:r>
+            <a:pPr indent="0" marL="0">
+              <a:buNone/>
+            </a:pPr>
+            <a:r>
+              <a:rPr lang="en-US" sz="1350" b="1" dirty="0">
                 <a:solidFill>
                   <a:srgbClr val="333333"/>
                 </a:solidFill>
@@ -10695,7 +10705,7 @@
               <a:buNone/>
             </a:pPr>
             <a:r>
-              <a:rPr lang="en-US" sz="1300" dirty="0">
+              <a:rPr lang="en-US" sz="1350" dirty="0">
                 <a:solidFill>
                   <a:srgbClr val="333333"/>
                 </a:solidFill>
@@ -10706,7 +10716,7 @@
               <a:buNone/>
             </a:pPr>
             <a:r>
-              <a:rPr lang="en-US" sz="1300" b="1" dirty="0">
+              <a:rPr lang="en-US" sz="1350" b="1" dirty="0">
                 <a:solidFill>
                   <a:srgbClr val="333333"/>
                 </a:solidFill>
@@ -10717,33 +10727,54 @@
               <a:buNone/>
             </a:pPr>
             <a:r>
-              <a:rPr lang="en-US" sz="1300" dirty="0">
+              <a:rPr lang="en-US" sz="1350" dirty="0">
                 <a:solidFill>
                   <a:srgbClr val="333333"/>
                 </a:solidFill>
               </a:rPr>
               <a:t> pasar.</a:t>
             </a:r>
-            <a:endParaRPr lang="en-US" sz="1300" dirty="0"/>
-          </a:p>
-          <a:p>
-            <a:pPr marL="342900" indent="-342900">
-              <a:buSzPct val="100000"/>
-              <a:buChar char="•"/>
-            </a:pPr>
-            <a:r>
-              <a:rPr lang="en-US" sz="1300" dirty="0">
-                <a:solidFill>
-                  <a:srgbClr val="333333"/>
-                </a:solidFill>
-              </a:rPr>
-              <a:t>   Matriks Kovarians: Alat matematis yang mengukur arah </a:t>
-            </a:r>
-            <a:pPr indent="0" marL="0">
-              <a:buNone/>
-            </a:pPr>
-            <a:r>
-              <a:rPr lang="en-US" sz="1300" b="1" dirty="0">
+            <a:endParaRPr lang="en-US" sz="1350" dirty="0"/>
+          </a:p>
+          <a:p>
+            <a:pPr indent="0" marL="0">
+              <a:buNone/>
+            </a:pPr>
+            <a:r>
+              <a:rPr lang="en-US" sz="1350" dirty="0">
+                <a:solidFill>
+                  <a:srgbClr val="333333"/>
+                </a:solidFill>
+              </a:rPr>
+              <a:t>➤ </a:t>
+            </a:r>
+            <a:pPr indent="0" marL="0">
+              <a:buNone/>
+            </a:pPr>
+            <a:r>
+              <a:rPr lang="en-US" sz="1350" u="sng" dirty="0">
+                <a:solidFill>
+                  <a:srgbClr val="333333"/>
+                </a:solidFill>
+              </a:rPr>
+              <a:t>Matriks</a:t>
+            </a:r>
+            <a:pPr indent="0" marL="0">
+              <a:buNone/>
+            </a:pPr>
+            <a:r>
+              <a:rPr lang="en-US" sz="1350" dirty="0">
+                <a:solidFill>
+                  <a:srgbClr val="333333"/>
+                </a:solidFill>
+              </a:rPr>
+              <a:t> Kovarians: Alat matematis yang mengukur arah </a:t>
+            </a:r>
+            <a:pPr indent="0" marL="0">
+              <a:buNone/>
+            </a:pPr>
+            <a:r>
+              <a:rPr lang="en-US" sz="1350" b="1" dirty="0">
                 <a:solidFill>
                   <a:srgbClr val="333333"/>
                 </a:solidFill>
@@ -10754,7 +10785,7 @@
               <a:buNone/>
             </a:pPr>
             <a:r>
-              <a:rPr lang="en-US" sz="1300" dirty="0">
+              <a:rPr lang="en-US" sz="1350" dirty="0">
                 <a:solidFill>
                   <a:srgbClr val="333333"/>
                 </a:solidFill>
@@ -10765,7 +10796,7 @@
               <a:buNone/>
             </a:pPr>
             <a:r>
-              <a:rPr lang="en-US" sz="1300" b="1" dirty="0">
+              <a:rPr lang="en-US" sz="1350" b="1" dirty="0">
                 <a:solidFill>
                   <a:srgbClr val="333333"/>
                 </a:solidFill>
@@ -10776,47 +10807,74 @@
               <a:buNone/>
             </a:pPr>
             <a:r>
-              <a:rPr lang="en-US" sz="1300" dirty="0">
+              <a:rPr lang="en-US" sz="1350" dirty="0">
                 <a:solidFill>
                   <a:srgbClr val="333333"/>
                 </a:solidFill>
               </a:rPr>
               <a:t> seluruh aset dalam portofolio.</a:t>
             </a:r>
-            <a:endParaRPr lang="en-US" sz="1300" dirty="0"/>
-          </a:p>
-          <a:p>
-            <a:pPr indent="0" marL="0">
-              <a:buNone/>
-            </a:pPr>
-            <a:r>
-              <a:rPr lang="en-US" sz="1300" b="1" dirty="0">
+            <a:endParaRPr lang="en-US" sz="1350" dirty="0"/>
+          </a:p>
+          <a:p>
+            <a:pPr indent="0" marL="0">
+              <a:buNone/>
+            </a:pPr>
+            <a:endParaRPr lang="en-US" sz="1350" dirty="0"/>
+          </a:p>
+          <a:p>
+            <a:pPr indent="0" marL="0">
+              <a:buNone/>
+            </a:pPr>
+            <a:r>
+              <a:rPr lang="en-US" sz="1350" b="1" dirty="0">
                 <a:solidFill>
                   <a:srgbClr val="333333"/>
                 </a:solidFill>
               </a:rPr>
               <a:t>Pendekatan Struktur Jaringan:</a:t>
             </a:r>
-            <a:endParaRPr lang="en-US" sz="1300" dirty="0"/>
-          </a:p>
-          <a:p>
-            <a:pPr marL="342900" indent="-342900">
-              <a:buSzPct val="100000"/>
-              <a:buChar char="•"/>
-            </a:pPr>
-            <a:r>
-              <a:rPr lang="en-US" sz="1300" dirty="0">
-                <a:solidFill>
-                  <a:srgbClr val="333333"/>
-                </a:solidFill>
-              </a:rPr>
-              <a:t>   Random Matrix Theory (</a:t>
-            </a:r>
-            <a:pPr indent="0" marL="0">
-              <a:buNone/>
-            </a:pPr>
-            <a:r>
-              <a:rPr lang="en-US" sz="1300" u="sng" dirty="0">
+            <a:endParaRPr lang="en-US" sz="1350" dirty="0"/>
+          </a:p>
+          <a:p>
+            <a:pPr indent="0" marL="0">
+              <a:buNone/>
+            </a:pPr>
+            <a:r>
+              <a:rPr lang="en-US" sz="1350" dirty="0">
+                <a:solidFill>
+                  <a:srgbClr val="333333"/>
+                </a:solidFill>
+              </a:rPr>
+              <a:t>➤ </a:t>
+            </a:r>
+            <a:pPr indent="0" marL="0">
+              <a:buNone/>
+            </a:pPr>
+            <a:r>
+              <a:rPr lang="en-US" sz="1350" u="sng" dirty="0">
+                <a:solidFill>
+                  <a:srgbClr val="333333"/>
+                </a:solidFill>
+              </a:rPr>
+              <a:t>Random Matrix Theory</a:t>
+            </a:r>
+            <a:pPr indent="0" marL="0">
+              <a:buNone/>
+            </a:pPr>
+            <a:r>
+              <a:rPr lang="en-US" sz="1350" dirty="0">
+                <a:solidFill>
+                  <a:srgbClr val="333333"/>
+                </a:solidFill>
+              </a:rPr>
+              <a:t> (</a:t>
+            </a:r>
+            <a:pPr indent="0" marL="0">
+              <a:buNone/>
+            </a:pPr>
+            <a:r>
+              <a:rPr lang="en-US" sz="1350" b="1" u="sng" dirty="0">
                 <a:solidFill>
                   <a:srgbClr val="0563C1"/>
                 </a:solidFill>
@@ -10834,7 +10892,7 @@
               <a:buNone/>
             </a:pPr>
             <a:r>
-              <a:rPr lang="en-US" sz="1300" dirty="0">
+              <a:rPr lang="en-US" sz="1350" dirty="0">
                 <a:solidFill>
                   <a:srgbClr val="333333"/>
                 </a:solidFill>
@@ -10845,7 +10903,7 @@
               <a:buNone/>
             </a:pPr>
             <a:r>
-              <a:rPr lang="en-US" sz="1300" b="1" dirty="0">
+              <a:rPr lang="en-US" sz="1350" b="1" dirty="0">
                 <a:solidFill>
                   <a:srgbClr val="333333"/>
                 </a:solidFill>
@@ -10856,7 +10914,7 @@
               <a:buNone/>
             </a:pPr>
             <a:r>
-              <a:rPr lang="en-US" sz="1300" dirty="0">
+              <a:rPr lang="en-US" sz="1350" dirty="0">
                 <a:solidFill>
                   <a:srgbClr val="333333"/>
                 </a:solidFill>
@@ -10867,7 +10925,7 @@
               <a:buNone/>
             </a:pPr>
             <a:r>
-              <a:rPr lang="en-US" sz="1300" b="1" dirty="0">
+              <a:rPr lang="en-US" sz="1350" b="1" dirty="0">
                 <a:solidFill>
                   <a:srgbClr val="333333"/>
                 </a:solidFill>
@@ -10878,33 +10936,54 @@
               <a:buNone/>
             </a:pPr>
             <a:r>
-              <a:rPr lang="en-US" sz="1300" dirty="0">
+              <a:rPr lang="en-US" sz="1350" dirty="0">
                 <a:solidFill>
                   <a:srgbClr val="333333"/>
                 </a:solidFill>
               </a:rPr>
               <a:t>.</a:t>
             </a:r>
-            <a:endParaRPr lang="en-US" sz="1300" dirty="0"/>
-          </a:p>
-          <a:p>
-            <a:pPr marL="342900" indent="-342900">
-              <a:buSzPct val="100000"/>
-              <a:buChar char="•"/>
-            </a:pPr>
-            <a:r>
-              <a:rPr lang="en-US" sz="1300" dirty="0">
-                <a:solidFill>
-                  <a:srgbClr val="333333"/>
-                </a:solidFill>
-              </a:rPr>
-              <a:t>   Minimum Spanning Tree (MST): Konstruksi jaringan antar aset berdasarkan </a:t>
-            </a:r>
-            <a:pPr indent="0" marL="0">
-              <a:buNone/>
-            </a:pPr>
-            <a:r>
-              <a:rPr lang="en-US" sz="1300" b="1" dirty="0">
+            <a:endParaRPr lang="en-US" sz="1350" dirty="0"/>
+          </a:p>
+          <a:p>
+            <a:pPr indent="0" marL="0">
+              <a:buNone/>
+            </a:pPr>
+            <a:r>
+              <a:rPr lang="en-US" sz="1350" dirty="0">
+                <a:solidFill>
+                  <a:srgbClr val="333333"/>
+                </a:solidFill>
+              </a:rPr>
+              <a:t>➤ </a:t>
+            </a:r>
+            <a:pPr indent="0" marL="0">
+              <a:buNone/>
+            </a:pPr>
+            <a:r>
+              <a:rPr lang="en-US" sz="1350" u="sng" dirty="0">
+                <a:solidFill>
+                  <a:srgbClr val="333333"/>
+                </a:solidFill>
+              </a:rPr>
+              <a:t>Minimum Spanning Tree</a:t>
+            </a:r>
+            <a:pPr indent="0" marL="0">
+              <a:buNone/>
+            </a:pPr>
+            <a:r>
+              <a:rPr lang="en-US" sz="1350" dirty="0">
+                <a:solidFill>
+                  <a:srgbClr val="333333"/>
+                </a:solidFill>
+              </a:rPr>
+              <a:t> (MST): Konstruksi jaringan antar aset berdasarkan </a:t>
+            </a:r>
+            <a:pPr indent="0" marL="0">
+              <a:buNone/>
+            </a:pPr>
+            <a:r>
+              <a:rPr lang="en-US" sz="1350" b="1" dirty="0">
                 <a:solidFill>
                   <a:srgbClr val="333333"/>
                 </a:solidFill>
@@ -10915,7 +10994,7 @@
               <a:buNone/>
             </a:pPr>
             <a:r>
-              <a:rPr lang="en-US" sz="1300" dirty="0">
+              <a:rPr lang="en-US" sz="1350" dirty="0">
                 <a:solidFill>
                   <a:srgbClr val="333333"/>
                 </a:solidFill>
@@ -10926,7 +11005,7 @@
               <a:buNone/>
             </a:pPr>
             <a:r>
-              <a:rPr lang="en-US" sz="1300" b="1" dirty="0">
+              <a:rPr lang="en-US" sz="1350" b="1" dirty="0">
                 <a:solidFill>
                   <a:srgbClr val="333333"/>
                 </a:solidFill>
@@ -10937,33 +11016,54 @@
               <a:buNone/>
             </a:pPr>
             <a:r>
-              <a:rPr lang="en-US" sz="1300" dirty="0">
+              <a:rPr lang="en-US" sz="1350" dirty="0">
                 <a:solidFill>
                   <a:srgbClr val="333333"/>
                 </a:solidFill>
               </a:rPr>
               <a:t> (loop).</a:t>
             </a:r>
-            <a:endParaRPr lang="en-US" sz="1300" dirty="0"/>
-          </a:p>
-          <a:p>
-            <a:pPr marL="342900" indent="-342900">
-              <a:buSzPct val="100000"/>
-              <a:buChar char="•"/>
-            </a:pPr>
-            <a:r>
-              <a:rPr lang="en-US" sz="1300" dirty="0">
-                <a:solidFill>
-                  <a:srgbClr val="333333"/>
-                </a:solidFill>
-              </a:rPr>
-              <a:t>   Network Centrality: Metrik penghukuman pada aset pasar yang letaknya terpusat untuk menekan probabilitas </a:t>
-            </a:r>
-            <a:pPr indent="0" marL="0">
-              <a:buNone/>
-            </a:pPr>
-            <a:r>
-              <a:rPr lang="en-US" sz="1300" b="1" dirty="0">
+            <a:endParaRPr lang="en-US" sz="1350" dirty="0"/>
+          </a:p>
+          <a:p>
+            <a:pPr indent="0" marL="0">
+              <a:buNone/>
+            </a:pPr>
+            <a:r>
+              <a:rPr lang="en-US" sz="1350" dirty="0">
+                <a:solidFill>
+                  <a:srgbClr val="333333"/>
+                </a:solidFill>
+              </a:rPr>
+              <a:t>➤ </a:t>
+            </a:r>
+            <a:pPr indent="0" marL="0">
+              <a:buNone/>
+            </a:pPr>
+            <a:r>
+              <a:rPr lang="en-US" sz="1350" u="sng" dirty="0">
+                <a:solidFill>
+                  <a:srgbClr val="333333"/>
+                </a:solidFill>
+              </a:rPr>
+              <a:t>Network Centrality</a:t>
+            </a:r>
+            <a:pPr indent="0" marL="0">
+              <a:buNone/>
+            </a:pPr>
+            <a:r>
+              <a:rPr lang="en-US" sz="1350" dirty="0">
+                <a:solidFill>
+                  <a:srgbClr val="333333"/>
+                </a:solidFill>
+              </a:rPr>
+              <a:t>: Metrik penghukuman pada aset pasar yang letaknya terpusat untuk menekan probabilitas </a:t>
+            </a:r>
+            <a:pPr indent="0" marL="0">
+              <a:buNone/>
+            </a:pPr>
+            <a:r>
+              <a:rPr lang="en-US" sz="1350" b="1" dirty="0">
                 <a:solidFill>
                   <a:srgbClr val="333333"/>
                 </a:solidFill>
@@ -10974,14 +11074,14 @@
               <a:buNone/>
             </a:pPr>
             <a:r>
-              <a:rPr lang="en-US" sz="1300" dirty="0">
+              <a:rPr lang="en-US" sz="1350" dirty="0">
                 <a:solidFill>
                   <a:srgbClr val="333333"/>
                 </a:solidFill>
               </a:rPr>
               <a:t> letupan harga yang sistemik.</a:t>
             </a:r>
-            <a:endParaRPr lang="en-US" sz="1300" dirty="0"/>
+            <a:endParaRPr lang="en-US" sz="1350" dirty="0"/>
           </a:p>
         </p:txBody>
       </p:sp>
@@ -13510,7 +13610,7 @@
         <p:spPr>
           <a:xfrm>
             <a:off x="457200" y="1005840"/>
-            <a:ext cx="8229600" cy="3200400"/>
+            <a:ext cx="8229600" cy="4572000"/>
           </a:xfrm>
           <a:prstGeom prst="rect">
             <a:avLst/>
@@ -13522,299 +13622,203 @@
           <a:bodyPr wrap="square" rtlCol="0" anchor="t"/>
           <a:lstStyle/>
           <a:p>
-            <a:pPr marL="342900" indent="-342900">
-              <a:buSzPct val="100000"/>
-              <a:buChar char="•"/>
-            </a:pPr>
-            <a:r>
-              <a:rPr lang="en-US" sz="2000" dirty="0">
-                <a:solidFill>
-                  <a:srgbClr val="333333"/>
-                </a:solidFill>
-              </a:rPr>
-              <a:t>1. EW (</a:t>
-            </a:r>
-            <a:pPr indent="0" marL="0">
-              <a:buNone/>
-            </a:pPr>
-            <a:r>
-              <a:rPr lang="en-US" sz="2000" b="1" i="1" dirty="0">
-                <a:solidFill>
-                  <a:srgbClr val="333333"/>
-                </a:solidFill>
-              </a:rPr>
-              <a:t>Equally Weighted</a:t>
-            </a:r>
-            <a:pPr indent="0" marL="0">
-              <a:buNone/>
-            </a:pPr>
-            <a:r>
-              <a:rPr lang="en-US" sz="2000" dirty="0">
-                <a:solidFill>
-                  <a:srgbClr val="333333"/>
-                </a:solidFill>
-              </a:rPr>
-              <a:t>): </a:t>
-            </a:r>
-            <a:pPr indent="0" marL="0">
-              <a:buNone/>
-            </a:pPr>
-            <a:r>
-              <a:rPr lang="en-US" sz="2000" b="1" i="1" dirty="0">
-                <a:solidFill>
-                  <a:srgbClr val="333333"/>
-                </a:solidFill>
-              </a:rPr>
-              <a:t>Baseline naif</a:t>
-            </a:r>
-            <a:pPr indent="0" marL="0">
-              <a:buNone/>
-            </a:pPr>
-            <a:r>
-              <a:rPr lang="en-US" sz="2000" dirty="0">
-                <a:solidFill>
-                  <a:srgbClr val="333333"/>
-                </a:solidFill>
-              </a:rPr>
-              <a:t> 1/N.</a:t>
-            </a:r>
-            <a:endParaRPr lang="en-US" sz="2000" dirty="0"/>
-          </a:p>
-          <a:p>
-            <a:pPr marL="342900" indent="-342900">
-              <a:buSzPct val="100000"/>
-              <a:buChar char="•"/>
-            </a:pPr>
-            <a:r>
-              <a:rPr lang="en-US" sz="2000" dirty="0">
-                <a:solidFill>
-                  <a:srgbClr val="333333"/>
-                </a:solidFill>
-              </a:rPr>
-              <a:t>2. CM (</a:t>
-            </a:r>
-            <a:pPr indent="0" marL="0">
-              <a:buNone/>
-            </a:pPr>
-            <a:r>
-              <a:rPr lang="en-US" sz="2000" b="1" i="1" dirty="0">
-                <a:solidFill>
-                  <a:srgbClr val="333333"/>
-                </a:solidFill>
-              </a:rPr>
-              <a:t>Classical Markowitz</a:t>
-            </a:r>
-            <a:pPr indent="0" marL="0">
-              <a:buNone/>
-            </a:pPr>
-            <a:r>
-              <a:rPr lang="en-US" sz="2000" dirty="0">
-                <a:solidFill>
-                  <a:srgbClr val="333333"/>
-                </a:solidFill>
-              </a:rPr>
-              <a:t>): </a:t>
-            </a:r>
-            <a:pPr indent="0" marL="0">
-              <a:buNone/>
-            </a:pPr>
-            <a:r>
-              <a:rPr lang="en-US" sz="2000" b="1" i="1" dirty="0">
-                <a:solidFill>
-                  <a:srgbClr val="333333"/>
-                </a:solidFill>
-              </a:rPr>
-              <a:t>Mean-Variance Optimization</a:t>
-            </a:r>
-            <a:pPr indent="0" marL="0">
-              <a:buNone/>
-            </a:pPr>
-            <a:r>
-              <a:rPr lang="en-US" sz="2000" dirty="0">
-                <a:solidFill>
-                  <a:srgbClr val="333333"/>
-                </a:solidFill>
-              </a:rPr>
-              <a:t> murni.</a:t>
-            </a:r>
-            <a:endParaRPr lang="en-US" sz="2000" dirty="0"/>
-          </a:p>
-          <a:p>
-            <a:pPr marL="342900" indent="-342900">
-              <a:buSzPct val="100000"/>
-              <a:buChar char="•"/>
-            </a:pPr>
-            <a:r>
-              <a:rPr lang="en-US" sz="2000" dirty="0">
-                <a:solidFill>
-                  <a:srgbClr val="333333"/>
-                </a:solidFill>
-              </a:rPr>
-              <a:t>3. GM (</a:t>
-            </a:r>
-            <a:pPr indent="0" marL="0">
-              <a:buNone/>
-            </a:pPr>
-            <a:r>
-              <a:rPr lang="en-US" sz="2000" b="1" i="1" dirty="0">
-                <a:solidFill>
-                  <a:srgbClr val="333333"/>
-                </a:solidFill>
-              </a:rPr>
-              <a:t>Glasso Markowitz</a:t>
-            </a:r>
-            <a:pPr indent="0" marL="0">
-              <a:buNone/>
-            </a:pPr>
-            <a:r>
-              <a:rPr lang="en-US" sz="2000" dirty="0">
-                <a:solidFill>
-                  <a:srgbClr val="333333"/>
-                </a:solidFill>
-              </a:rPr>
-              <a:t>): Regularisasi L1 (</a:t>
-            </a:r>
-            <a:pPr indent="0" marL="0">
-              <a:buNone/>
-            </a:pPr>
-            <a:r>
-              <a:rPr lang="en-US" sz="2000" b="1" i="1" dirty="0">
-                <a:solidFill>
-                  <a:srgbClr val="333333"/>
-                </a:solidFill>
-              </a:rPr>
-              <a:t>Graphical Lasso</a:t>
-            </a:r>
-            <a:pPr indent="0" marL="0">
-              <a:buNone/>
-            </a:pPr>
-            <a:r>
-              <a:rPr lang="en-US" sz="2000" dirty="0">
-                <a:solidFill>
-                  <a:srgbClr val="333333"/>
-                </a:solidFill>
-              </a:rPr>
-              <a:t>) pada matriks kovarians.</a:t>
-            </a:r>
-            <a:endParaRPr lang="en-US" sz="2000" dirty="0"/>
-          </a:p>
-          <a:p>
-            <a:pPr marL="342900" indent="-342900">
-              <a:buSzPct val="100000"/>
-              <a:buChar char="•"/>
-            </a:pPr>
-            <a:r>
-              <a:rPr lang="en-US" sz="2000" dirty="0">
-                <a:solidFill>
-                  <a:srgbClr val="333333"/>
-                </a:solidFill>
-              </a:rPr>
-              <a:t>4. NW (</a:t>
-            </a:r>
-            <a:pPr indent="0" marL="0">
-              <a:buNone/>
-            </a:pPr>
-            <a:r>
-              <a:rPr lang="en-US" sz="2000" b="1" i="1" dirty="0">
-                <a:solidFill>
-                  <a:srgbClr val="333333"/>
-                </a:solidFill>
-              </a:rPr>
-              <a:t>Network Markowitz</a:t>
-            </a:r>
-            <a:pPr indent="0" marL="0">
-              <a:buNone/>
-            </a:pPr>
-            <a:r>
-              <a:rPr lang="en-US" sz="2000" dirty="0">
-                <a:solidFill>
-                  <a:srgbClr val="333333"/>
-                </a:solidFill>
-              </a:rPr>
-              <a:t>) Statis: Dengan parameter </a:t>
-            </a:r>
-            <a:pPr indent="0" marL="0">
-              <a:buNone/>
-            </a:pPr>
-            <a:r>
-              <a:rPr lang="en-US" sz="2000" b="1" dirty="0">
-                <a:solidFill>
-                  <a:srgbClr val="333333"/>
-                </a:solidFill>
-              </a:rPr>
-              <a:t>gamma statis</a:t>
-            </a:r>
-            <a:pPr indent="0" marL="0">
-              <a:buNone/>
-            </a:pPr>
-            <a:r>
-              <a:rPr lang="en-US" sz="2000" dirty="0">
-                <a:solidFill>
-                  <a:srgbClr val="333333"/>
-                </a:solidFill>
-              </a:rPr>
-              <a:t> (0, 1.0, 2.0).</a:t>
-            </a:r>
-            <a:endParaRPr lang="en-US" sz="2000" dirty="0"/>
-          </a:p>
-          <a:p>
-            <a:pPr marL="342900" indent="-342900">
-              <a:buSzPct val="100000"/>
-              <a:buChar char="•"/>
-            </a:pPr>
-            <a:r>
-              <a:rPr lang="en-US" sz="2000" dirty="0">
-                <a:solidFill>
-                  <a:srgbClr val="333333"/>
-                </a:solidFill>
-              </a:rPr>
-              <a:t>5. NW (</a:t>
-            </a:r>
-            <a:pPr indent="0" marL="0">
-              <a:buNone/>
-            </a:pPr>
-            <a:r>
-              <a:rPr lang="en-US" sz="2000" b="1" i="1" dirty="0">
-                <a:solidFill>
-                  <a:srgbClr val="333333"/>
-                </a:solidFill>
-              </a:rPr>
-              <a:t>Grid Search</a:t>
-            </a:r>
-            <a:pPr indent="0" marL="0">
-              <a:buNone/>
-            </a:pPr>
-            <a:r>
-              <a:rPr lang="en-US" sz="2000" dirty="0">
-                <a:solidFill>
-                  <a:srgbClr val="333333"/>
-                </a:solidFill>
-              </a:rPr>
-              <a:t>) Adaptif: Menggunakan </a:t>
-            </a:r>
-            <a:pPr indent="0" marL="0">
-              <a:buNone/>
-            </a:pPr>
-            <a:r>
-              <a:rPr lang="en-US" sz="2000" b="1" i="1" dirty="0">
-                <a:solidFill>
-                  <a:srgbClr val="333333"/>
-                </a:solidFill>
-              </a:rPr>
-              <a:t>rolling window</a:t>
-            </a:r>
-            <a:pPr indent="0" marL="0">
-              <a:buNone/>
-            </a:pPr>
-            <a:r>
-              <a:rPr lang="en-US" sz="2000" dirty="0">
-                <a:solidFill>
-                  <a:srgbClr val="333333"/>
-                </a:solidFill>
-              </a:rPr>
-              <a:t> untuk optimasi parameter dinamis.</a:t>
-            </a:r>
-            <a:endParaRPr lang="en-US" sz="2000" dirty="0"/>
+            <a:pPr indent="0" marL="0">
+              <a:buNone/>
+            </a:pPr>
+            <a:r>
+              <a:rPr lang="en-US" sz="1600" b="1" dirty="0">
+                <a:solidFill>
+                  <a:srgbClr val="2C3E50"/>
+                </a:solidFill>
+              </a:rPr>
+              <a:t>1. Kelompok Baseline:</a:t>
+            </a:r>
+            <a:endParaRPr lang="en-US" sz="1600" dirty="0"/>
+          </a:p>
+          <a:p>
+            <a:pPr indent="0" marL="0">
+              <a:buNone/>
+            </a:pPr>
+            <a:r>
+              <a:rPr lang="en-US" sz="1600" b="1" dirty="0">
+                <a:solidFill>
+                  <a:srgbClr val="333333"/>
+                </a:solidFill>
+              </a:rPr>
+              <a:t>   • EW (Equally Weighted): </a:t>
+            </a:r>
+            <a:pPr indent="0" marL="0">
+              <a:buNone/>
+            </a:pPr>
+            <a:r>
+              <a:rPr lang="en-US" sz="1600" dirty="0">
+                <a:solidFill>
+                  <a:srgbClr val="333333"/>
+                </a:solidFill>
+              </a:rPr>
+              <a:t>Portofolio naif 1/N sebagai pembanding dasar.</a:t>
+            </a:r>
+            <a:endParaRPr lang="en-US" sz="1600" dirty="0"/>
+          </a:p>
+          <a:p>
+            <a:pPr indent="0" marL="0">
+              <a:buNone/>
+            </a:pPr>
+            <a:r>
+              <a:rPr lang="en-US" sz="1600" b="1" dirty="0">
+                <a:solidFill>
+                  <a:srgbClr val="333333"/>
+                </a:solidFill>
+              </a:rPr>
+              <a:t>   • CM (Classical Markowitz): </a:t>
+            </a:r>
+            <a:pPr indent="0" marL="0">
+              <a:buNone/>
+            </a:pPr>
+            <a:r>
+              <a:rPr lang="en-US" sz="1600" dirty="0">
+                <a:solidFill>
+                  <a:srgbClr val="333333"/>
+                </a:solidFill>
+              </a:rPr>
+              <a:t>Optimasi Mean-Variance tradisional tanpa filter noise.</a:t>
+            </a:r>
+            <a:endParaRPr lang="en-US" sz="1600" dirty="0"/>
+          </a:p>
+          <a:p>
+            <a:pPr indent="0" marL="0">
+              <a:buNone/>
+            </a:pPr>
+            <a:endParaRPr lang="en-US" sz="1600" dirty="0"/>
+          </a:p>
+          <a:p>
+            <a:pPr indent="0" marL="0">
+              <a:buNone/>
+            </a:pPr>
+            <a:r>
+              <a:rPr lang="en-US" sz="1600" b="1" dirty="0">
+                <a:solidFill>
+                  <a:srgbClr val="2C3E50"/>
+                </a:solidFill>
+              </a:rPr>
+              <a:t>2. Kelompok Regularisasi:</a:t>
+            </a:r>
+            <a:endParaRPr lang="en-US" sz="1600" dirty="0"/>
+          </a:p>
+          <a:p>
+            <a:pPr indent="0" marL="0">
+              <a:buNone/>
+            </a:pPr>
+            <a:r>
+              <a:rPr lang="en-US" sz="1600" b="1" dirty="0">
+                <a:solidFill>
+                  <a:srgbClr val="333333"/>
+                </a:solidFill>
+              </a:rPr>
+              <a:t>   • GM (Glasso Markowitz): </a:t>
+            </a:r>
+            <a:pPr indent="0" marL="0">
+              <a:buNone/>
+            </a:pPr>
+            <a:r>
+              <a:rPr lang="en-US" sz="1600" dirty="0">
+                <a:solidFill>
+                  <a:srgbClr val="333333"/>
+                </a:solidFill>
+              </a:rPr>
+              <a:t>Menggunakan Graphical Lasso (L1) pada matriks kovarians.</a:t>
+            </a:r>
+            <a:endParaRPr lang="en-US" sz="1600" dirty="0"/>
+          </a:p>
+          <a:p>
+            <a:pPr indent="0" marL="0">
+              <a:buNone/>
+            </a:pPr>
+            <a:endParaRPr lang="en-US" sz="1600" dirty="0"/>
+          </a:p>
+          <a:p>
+            <a:pPr indent="0" marL="0">
+              <a:buNone/>
+            </a:pPr>
+            <a:r>
+              <a:rPr lang="en-US" sz="1600" b="1" dirty="0">
+                <a:solidFill>
+                  <a:srgbClr val="2C3E50"/>
+                </a:solidFill>
+              </a:rPr>
+              <a:t>3. Kelompok Network (Statis):</a:t>
+            </a:r>
+            <a:endParaRPr lang="en-US" sz="1600" dirty="0"/>
+          </a:p>
+          <a:p>
+            <a:pPr indent="0" marL="0">
+              <a:buNone/>
+            </a:pPr>
+            <a:r>
+              <a:rPr lang="en-US" sz="1600" b="1" dirty="0">
+                <a:solidFill>
+                  <a:srgbClr val="333333"/>
+                </a:solidFill>
+              </a:rPr>
+              <a:t>   • NW Statis: </a:t>
+            </a:r>
+            <a:pPr indent="0" marL="0">
+              <a:buNone/>
+            </a:pPr>
+            <a:r>
+              <a:rPr lang="en-US" sz="1600" dirty="0">
+                <a:solidFill>
+                  <a:srgbClr val="333333"/>
+                </a:solidFill>
+              </a:rPr>
+              <a:t>Parameter penalti gamma (γ) tetap: 0, 1.0, dan 2.0.</a:t>
+            </a:r>
+            <a:endParaRPr lang="en-US" sz="1600" dirty="0"/>
+          </a:p>
+          <a:p>
+            <a:pPr indent="0" marL="0">
+              <a:buNone/>
+            </a:pPr>
+            <a:endParaRPr lang="en-US" sz="1600" dirty="0"/>
+          </a:p>
+          <a:p>
+            <a:pPr indent="0" marL="0">
+              <a:buNone/>
+            </a:pPr>
+            <a:r>
+              <a:rPr lang="en-US" sz="1600" b="1" dirty="0">
+                <a:solidFill>
+                  <a:srgbClr val="2C3E50"/>
+                </a:solidFill>
+              </a:rPr>
+              <a:t>4. Kelompok Network (Adaptif):</a:t>
+            </a:r>
+            <a:endParaRPr lang="en-US" sz="1600" dirty="0"/>
+          </a:p>
+          <a:p>
+            <a:pPr indent="0" marL="0">
+              <a:buNone/>
+            </a:pPr>
+            <a:r>
+              <a:rPr lang="en-US" sz="1600" b="1" dirty="0">
+                <a:solidFill>
+                  <a:srgbClr val="333333"/>
+                </a:solidFill>
+              </a:rPr>
+              <a:t>   • NW Adaptif (Grid Search): </a:t>
+            </a:r>
+            <a:pPr indent="0" marL="0">
+              <a:buNone/>
+            </a:pPr>
+            <a:r>
+              <a:rPr lang="en-US" sz="1600" dirty="0">
+                <a:solidFill>
+                  <a:srgbClr val="333333"/>
+                </a:solidFill>
+              </a:rPr>
+              <a:t>Optimasi penalti dinamis dengan Jendela Rolling (30, 60, 90, 120 hari).</a:t>
+            </a:r>
+            <a:endParaRPr lang="en-US" sz="1600" dirty="0"/>
           </a:p>
         </p:txBody>
       </p:sp>

</xml_diff>

<commit_message>
feat: add numerical example of pearson correlation and classical markowitz to presentation
</commit_message>
<xml_diff>
--- a/Presentasi_Proposal_Update.pptx
+++ b/Presentasi_Proposal_Update.pptx
@@ -38,9 +38,11 @@
     <p:sldId id="286" r:id="rId32"/>
     <p:sldId id="287" r:id="rId33"/>
     <p:sldId id="288" r:id="rId34"/>
+    <p:sldId id="289" r:id="rId35"/>
+    <p:sldId id="290" r:id="rId36"/>
   </p:sldIdLst>
   <p:notesMasterIdLst>
-    <p:notesMasterId r:id="rId35"/>
+    <p:notesMasterId r:id="rId37"/>
   </p:notesMasterIdLst>
   <p:sldSz cx="9144000" cy="5143500"/>
   <p:notesSz cx="5143500" cy="9144000"/>
@@ -2846,6 +2848,182 @@
             <a:fld id="{F7021451-1387-4CA6-816F-3879F97B5CBC}" type="slidenum">
               <a:rPr lang="en-US"/>
               <a:t>33</a:t>
+            </a:fld>
+            <a:endParaRPr lang="en-US"/>
+          </a:p>
+        </p:txBody>
+      </p:sp>
+    </p:spTree>
+    <p:extLst>
+      <p:ext uri="{BB962C8B-B14F-4D97-AF65-F5344CB8AC3E}">
+        <p14:creationId xmlns:p14="http://schemas.microsoft.com/office/powerpoint/2010/main" val="1024086991"/>
+      </p:ext>
+    </p:extLst>
+  </p:cSld>
+  <p:clrMapOvr>
+    <a:masterClrMapping/>
+  </p:clrMapOvr>
+</p:notes>
+</file>
+
+<file path=ppt/notesSlides/notesSlide34.xml><?xml version="1.0" encoding="utf-8"?>
+<p:notes xmlns:a="http://schemas.openxmlformats.org/drawingml/2006/main" xmlns:r="http://schemas.openxmlformats.org/officeDocument/2006/relationships" xmlns:p="http://schemas.openxmlformats.org/presentationml/2006/main">
+  <p:cSld>
+    <p:spTree>
+      <p:nvGrpSpPr>
+        <p:cNvPr id="1" name=""/>
+        <p:cNvGrpSpPr/>
+        <p:nvPr/>
+      </p:nvGrpSpPr>
+      <p:grpSpPr>
+        <a:xfrm>
+          <a:off x="0" y="0"/>
+          <a:ext cx="0" cy="0"/>
+          <a:chOff x="0" y="0"/>
+          <a:chExt cx="0" cy="0"/>
+        </a:xfrm>
+      </p:grpSpPr>
+      <p:sp>
+        <p:nvSpPr>
+          <p:cNvPr id="2" name="Slide Image Placeholder 1"/>
+          <p:cNvSpPr>
+            <a:spLocks noGrp="1" noRot="1" noChangeAspect="1"/>
+          </p:cNvSpPr>
+          <p:nvPr>
+            <p:ph type="sldImg"/>
+          </p:nvPr>
+        </p:nvSpPr>
+        <p:spPr/>
+      </p:sp>
+      <p:sp>
+        <p:nvSpPr>
+          <p:cNvPr id="3" name="Notes Placeholder 2"/>
+          <p:cNvSpPr>
+            <a:spLocks noGrp="1"/>
+          </p:cNvSpPr>
+          <p:nvPr>
+            <p:ph type="body" idx="1"/>
+          </p:nvPr>
+        </p:nvSpPr>
+        <p:spPr/>
+        <p:txBody>
+          <a:bodyPr/>
+          <a:lstStyle/>
+          <a:p>
+            <a:r>
+              <a:rPr lang="en-US" dirty="0"/>
+              <a:t/>
+            </a:r>
+            <a:endParaRPr lang="en-US" dirty="0"/>
+          </a:p>
+        </p:txBody>
+      </p:sp>
+      <p:sp>
+        <p:nvSpPr>
+          <p:cNvPr id="4" name="Slide Number Placeholder 3"/>
+          <p:cNvSpPr>
+            <a:spLocks noGrp="1"/>
+          </p:cNvSpPr>
+          <p:nvPr>
+            <p:ph type="sldNum" sz="quarter" idx="10"/>
+          </p:nvPr>
+        </p:nvSpPr>
+        <p:spPr/>
+        <p:txBody>
+          <a:bodyPr/>
+          <a:lstStyle/>
+          <a:p>
+            <a:fld id="{F7021451-1387-4CA6-816F-3879F97B5CBC}" type="slidenum">
+              <a:rPr lang="en-US"/>
+              <a:t>34</a:t>
+            </a:fld>
+            <a:endParaRPr lang="en-US"/>
+          </a:p>
+        </p:txBody>
+      </p:sp>
+    </p:spTree>
+    <p:extLst>
+      <p:ext uri="{BB962C8B-B14F-4D97-AF65-F5344CB8AC3E}">
+        <p14:creationId xmlns:p14="http://schemas.microsoft.com/office/powerpoint/2010/main" val="1024086991"/>
+      </p:ext>
+    </p:extLst>
+  </p:cSld>
+  <p:clrMapOvr>
+    <a:masterClrMapping/>
+  </p:clrMapOvr>
+</p:notes>
+</file>
+
+<file path=ppt/notesSlides/notesSlide35.xml><?xml version="1.0" encoding="utf-8"?>
+<p:notes xmlns:a="http://schemas.openxmlformats.org/drawingml/2006/main" xmlns:r="http://schemas.openxmlformats.org/officeDocument/2006/relationships" xmlns:p="http://schemas.openxmlformats.org/presentationml/2006/main">
+  <p:cSld>
+    <p:spTree>
+      <p:nvGrpSpPr>
+        <p:cNvPr id="1" name=""/>
+        <p:cNvGrpSpPr/>
+        <p:nvPr/>
+      </p:nvGrpSpPr>
+      <p:grpSpPr>
+        <a:xfrm>
+          <a:off x="0" y="0"/>
+          <a:ext cx="0" cy="0"/>
+          <a:chOff x="0" y="0"/>
+          <a:chExt cx="0" cy="0"/>
+        </a:xfrm>
+      </p:grpSpPr>
+      <p:sp>
+        <p:nvSpPr>
+          <p:cNvPr id="2" name="Slide Image Placeholder 1"/>
+          <p:cNvSpPr>
+            <a:spLocks noGrp="1" noRot="1" noChangeAspect="1"/>
+          </p:cNvSpPr>
+          <p:nvPr>
+            <p:ph type="sldImg"/>
+          </p:nvPr>
+        </p:nvSpPr>
+        <p:spPr/>
+      </p:sp>
+      <p:sp>
+        <p:nvSpPr>
+          <p:cNvPr id="3" name="Notes Placeholder 2"/>
+          <p:cNvSpPr>
+            <a:spLocks noGrp="1"/>
+          </p:cNvSpPr>
+          <p:nvPr>
+            <p:ph type="body" idx="1"/>
+          </p:nvPr>
+        </p:nvSpPr>
+        <p:spPr/>
+        <p:txBody>
+          <a:bodyPr/>
+          <a:lstStyle/>
+          <a:p>
+            <a:r>
+              <a:rPr lang="en-US" dirty="0"/>
+              <a:t/>
+            </a:r>
+            <a:endParaRPr lang="en-US" dirty="0"/>
+          </a:p>
+        </p:txBody>
+      </p:sp>
+      <p:sp>
+        <p:nvSpPr>
+          <p:cNvPr id="4" name="Slide Number Placeholder 3"/>
+          <p:cNvSpPr>
+            <a:spLocks noGrp="1"/>
+          </p:cNvSpPr>
+          <p:nvPr>
+            <p:ph type="sldNum" sz="quarter" idx="10"/>
+          </p:nvPr>
+        </p:nvSpPr>
+        <p:spPr/>
+        <p:txBody>
+          <a:bodyPr/>
+          <a:lstStyle/>
+          <a:p>
+            <a:fld id="{F7021451-1387-4CA6-816F-3879F97B5CBC}" type="slidenum">
+              <a:rPr lang="en-US"/>
+              <a:t>35</a:t>
             </a:fld>
             <a:endParaRPr lang="en-US"/>
           </a:p>
@@ -3927,7 +4105,7 @@
                   <a:srgbClr val="003366"/>
                 </a:solidFill>
               </a:rPr>
-              <a:t>2. Classical Markowitz (CM)</a:t>
+              <a:t>1.2. Classical Markowitz (CM)</a:t>
             </a:r>
             <a:endParaRPr lang="en-US" sz="2800" dirty="0"/>
           </a:p>
@@ -4171,7 +4349,7 @@
                   <a:srgbClr val="003366"/>
                 </a:solidFill>
               </a:rPr>
-              <a:t>3. Graphical Lasso Markowitz (GM)</a:t>
+              <a:t>2. Graphical Lasso Markowitz (GM)</a:t>
             </a:r>
             <a:endParaRPr lang="en-US" sz="2800" dirty="0"/>
           </a:p>
@@ -4393,7 +4571,7 @@
                   <a:srgbClr val="003366"/>
                 </a:solidFill>
               </a:rPr>
-              <a:t>4. Network Markowitz (NW) Statis</a:t>
+              <a:t>3. Network Markowitz (NW) Statis</a:t>
             </a:r>
             <a:endParaRPr lang="en-US" sz="2800" dirty="0"/>
           </a:p>
@@ -4455,7 +4633,7 @@
                   <a:srgbClr val="333333"/>
                 </a:solidFill>
               </a:rPr>
-              <a:t>filter RMT</a:t>
+              <a:t>filter RMT (Random Matrix Theory)</a:t>
             </a:r>
             <a:pPr indent="0" marL="0">
               <a:buNone/>
@@ -4637,7 +4815,7 @@
                   <a:srgbClr val="003366"/>
                 </a:solidFill>
               </a:rPr>
-              <a:t>Network Markowitz (NW) Adaptif</a:t>
+              <a:t>4. Network Markowitz (NW) Adaptif</a:t>
             </a:r>
             <a:endParaRPr lang="en-US" sz="2800" dirty="0"/>
           </a:p>
@@ -4651,8 +4829,8 @@
         </p:nvSpPr>
         <p:spPr>
           <a:xfrm>
-            <a:off x="457200" y="1005840"/>
-            <a:ext cx="8229600" cy="5029200"/>
+            <a:off x="457200" y="1097280"/>
+            <a:ext cx="4114800" cy="3657600"/>
           </a:xfrm>
           <a:prstGeom prst="rect">
             <a:avLst/>
@@ -4668,316 +4846,162 @@
               <a:buNone/>
             </a:pPr>
             <a:r>
-              <a:rPr lang="en-US" sz="1300" b="1" dirty="0">
-                <a:solidFill>
-                  <a:srgbClr val="333333"/>
+              <a:rPr lang="en-US" sz="2000" b="1" dirty="0">
+                <a:solidFill>
+                  <a:srgbClr val="003366"/>
                 </a:solidFill>
               </a:rPr>
               <a:t>Mekanisme Optimasi Dinamis:</a:t>
             </a:r>
-            <a:endParaRPr lang="en-US" sz="1300" dirty="0"/>
-          </a:p>
-          <a:p>
-            <a:pPr indent="0" marL="0">
-              <a:buNone/>
-            </a:pPr>
-            <a:r>
-              <a:rPr lang="en-US" sz="1300" dirty="0">
-                <a:solidFill>
-                  <a:srgbClr val="333333"/>
-                </a:solidFill>
-              </a:rPr>
-              <a:t>❑ Rolling Window: Menggunakan 4 variasi jendela estimasi: </a:t>
-            </a:r>
-            <a:pPr indent="0" marL="0">
-              <a:buNone/>
-            </a:pPr>
-            <a:r>
-              <a:rPr lang="en-US" sz="1300" b="1" dirty="0">
-                <a:solidFill>
-                  <a:srgbClr val="333333"/>
-                </a:solidFill>
-              </a:rPr>
-              <a:t>30, 60, 90, dan 120 hari</a:t>
-            </a:r>
-            <a:pPr indent="0" marL="0">
-              <a:buNone/>
-            </a:pPr>
-            <a:r>
-              <a:rPr lang="en-US" sz="1300" dirty="0">
-                <a:solidFill>
-                  <a:srgbClr val="333333"/>
-                </a:solidFill>
-              </a:rPr>
-              <a:t>.</a:t>
-            </a:r>
-            <a:endParaRPr lang="en-US" sz="1300" dirty="0"/>
-          </a:p>
-          <a:p>
-            <a:pPr indent="0" marL="0">
-              <a:buNone/>
-            </a:pPr>
-            <a:r>
-              <a:rPr lang="en-US" sz="1300" dirty="0">
-                <a:solidFill>
-                  <a:srgbClr val="333333"/>
-                </a:solidFill>
-              </a:rPr>
-              <a:t>❑ Rebalancing Frequency: Dilakukan setiap </a:t>
-            </a:r>
-            <a:pPr indent="0" marL="0">
-              <a:buNone/>
-            </a:pPr>
-            <a:r>
-              <a:rPr lang="en-US" sz="1300" b="1" dirty="0">
-                <a:solidFill>
-                  <a:srgbClr val="333333"/>
-                </a:solidFill>
-              </a:rPr>
-              <a:t>7 hari</a:t>
-            </a:r>
-            <a:pPr indent="0" marL="0">
-              <a:buNone/>
-            </a:pPr>
-            <a:r>
-              <a:rPr lang="en-US" sz="1300" dirty="0">
-                <a:solidFill>
-                  <a:srgbClr val="333333"/>
-                </a:solidFill>
-              </a:rPr>
-              <a:t> sekali.</a:t>
-            </a:r>
-            <a:endParaRPr lang="en-US" sz="1300" dirty="0"/>
-          </a:p>
-          <a:p>
-            <a:pPr indent="0" marL="0">
-              <a:buNone/>
-            </a:pPr>
-            <a:r>
-              <a:rPr lang="en-US" sz="1300" dirty="0">
-                <a:solidFill>
-                  <a:srgbClr val="333333"/>
-                </a:solidFill>
-              </a:rPr>
-              <a:t>❑ Transaction Cost: Biaya transaksi sebesar </a:t>
-            </a:r>
-            <a:pPr indent="0" marL="0">
-              <a:buNone/>
-            </a:pPr>
-            <a:r>
-              <a:rPr lang="en-US" sz="1300" b="1" dirty="0">
-                <a:solidFill>
-                  <a:srgbClr val="333333"/>
-                </a:solidFill>
-              </a:rPr>
-              <a:t>0.1% (10 bps)</a:t>
-            </a:r>
-            <a:pPr indent="0" marL="0">
-              <a:buNone/>
-            </a:pPr>
-            <a:r>
-              <a:rPr lang="en-US" sz="1300" dirty="0">
-                <a:solidFill>
-                  <a:srgbClr val="333333"/>
-                </a:solidFill>
-              </a:rPr>
-              <a:t> diperhitungkan dalam simulasi.</a:t>
-            </a:r>
-            <a:endParaRPr lang="en-US" sz="1300" dirty="0"/>
-          </a:p>
-          <a:p>
-            <a:pPr indent="0" marL="0">
-              <a:buNone/>
-            </a:pPr>
-            <a:r>
-              <a:rPr lang="en-US" sz="1300" dirty="0">
-                <a:solidFill>
-                  <a:srgbClr val="333333"/>
-                </a:solidFill>
-              </a:rPr>
-              <a:t>❑ Grid Search: Parameter gamma diuji dalam rentang </a:t>
-            </a:r>
-            <a:pPr indent="0" marL="0">
-              <a:buNone/>
-            </a:pPr>
-            <a:r>
-              <a:rPr lang="en-US" sz="1300" b="1" dirty="0">
-                <a:solidFill>
-                  <a:srgbClr val="333333"/>
-                </a:solidFill>
-              </a:rPr>
-              <a:t>[0.0 - 2.0]</a:t>
-            </a:r>
-            <a:pPr indent="0" marL="0">
-              <a:buNone/>
-            </a:pPr>
-            <a:r>
-              <a:rPr lang="en-US" sz="1300" dirty="0">
-                <a:solidFill>
-                  <a:srgbClr val="333333"/>
-                </a:solidFill>
-              </a:rPr>
-              <a:t> dengan iterasi 0.1.</a:t>
-            </a:r>
-            <a:endParaRPr lang="en-US" sz="1300" dirty="0"/>
-          </a:p>
-          <a:p>
-            <a:pPr indent="0" marL="0">
-              <a:buNone/>
-            </a:pPr>
-            <a:r>
-              <a:rPr lang="en-US" sz="1300" b="1" dirty="0">
-                <a:solidFill>
-                  <a:srgbClr val="333333"/>
+            <a:endParaRPr lang="en-US" sz="2000" dirty="0"/>
+          </a:p>
+          <a:p>
+            <a:pPr indent="0" marL="0">
+              <a:buNone/>
+            </a:pPr>
+            <a:r>
+              <a:rPr lang="en-US" sz="2000" dirty="0">
+                <a:solidFill>
+                  <a:srgbClr val="333333"/>
+                </a:solidFill>
+              </a:rPr>
+              <a:t>❑ Rolling Window: 30, 60, 90, 120 hari.</a:t>
+            </a:r>
+            <a:endParaRPr lang="en-US" sz="2000" dirty="0"/>
+          </a:p>
+          <a:p>
+            <a:pPr indent="0" marL="0">
+              <a:buNone/>
+            </a:pPr>
+            <a:r>
+              <a:rPr lang="en-US" sz="2000" dirty="0">
+                <a:solidFill>
+                  <a:srgbClr val="333333"/>
+                </a:solidFill>
+              </a:rPr>
+              <a:t>❑ Rebalancing: Setiap 7 hari.</a:t>
+            </a:r>
+            <a:endParaRPr lang="en-US" sz="2000" dirty="0"/>
+          </a:p>
+          <a:p>
+            <a:pPr indent="0" marL="0">
+              <a:buNone/>
+            </a:pPr>
+            <a:r>
+              <a:rPr lang="en-US" sz="2000" dirty="0">
+                <a:solidFill>
+                  <a:srgbClr val="333333"/>
+                </a:solidFill>
+              </a:rPr>
+              <a:t>❑ Transaction Cost: 0.1% (10 basis points).</a:t>
+            </a:r>
+            <a:endParaRPr lang="en-US" sz="2000" dirty="0"/>
+          </a:p>
+          <a:p>
+            <a:pPr indent="0" marL="0">
+              <a:buNone/>
+            </a:pPr>
+            <a:r>
+              <a:rPr lang="en-US" sz="2000" dirty="0">
+                <a:solidFill>
+                  <a:srgbClr val="333333"/>
+                </a:solidFill>
+              </a:rPr>
+              <a:t>❑ Grid Search γ: Rentang [0.0 - 2.0].</a:t>
+            </a:r>
+            <a:endParaRPr lang="en-US" sz="2000" dirty="0"/>
+          </a:p>
+        </p:txBody>
+      </p:sp>
+      <p:sp>
+        <p:nvSpPr>
+          <p:cNvPr id="4" name="Text 2"/>
+          <p:cNvSpPr/>
+          <p:nvPr/>
+        </p:nvSpPr>
+        <p:spPr>
+          <a:xfrm>
+            <a:off x="4754880" y="1097280"/>
+            <a:ext cx="4114800" cy="3657600"/>
+          </a:xfrm>
+          <a:prstGeom prst="rect">
+            <a:avLst/>
+          </a:prstGeom>
+          <a:noFill/>
+          <a:ln/>
+        </p:spPr>
+        <p:txBody>
+          <a:bodyPr wrap="square" rtlCol="0" anchor="t"/>
+          <a:lstStyle/>
+          <a:p>
+            <a:pPr indent="0" marL="0">
+              <a:buNone/>
+            </a:pPr>
+            <a:r>
+              <a:rPr lang="en-US" sz="2000" b="1" dirty="0">
+                <a:solidFill>
+                  <a:srgbClr val="003366"/>
                 </a:solidFill>
               </a:rPr>
               <a:t>Split Validasi Internal (80/20):</a:t>
             </a:r>
-            <a:endParaRPr lang="en-US" sz="1300" dirty="0"/>
-          </a:p>
-          <a:p>
-            <a:pPr indent="0" marL="0">
-              <a:buNone/>
-            </a:pPr>
-            <a:r>
-              <a:rPr lang="en-US" sz="1300" dirty="0">
-                <a:solidFill>
-                  <a:srgbClr val="333333"/>
-                </a:solidFill>
-              </a:rPr>
-              <a:t>❑ Training (80%): Untuk estimasi </a:t>
-            </a:r>
-            <a:pPr indent="0" marL="0">
-              <a:buNone/>
-            </a:pPr>
-            <a:r>
-              <a:rPr lang="en-US" sz="1300" b="1" dirty="0">
-                <a:solidFill>
-                  <a:srgbClr val="333333"/>
-                </a:solidFill>
-              </a:rPr>
-              <a:t>bobot kandidat</a:t>
-            </a:r>
-            <a:pPr indent="0" marL="0">
-              <a:buNone/>
-            </a:pPr>
-            <a:r>
-              <a:rPr lang="en-US" sz="1300" dirty="0">
-                <a:solidFill>
-                  <a:srgbClr val="333333"/>
-                </a:solidFill>
-              </a:rPr>
-              <a:t> gamma.</a:t>
-            </a:r>
-            <a:endParaRPr lang="en-US" sz="1300" dirty="0"/>
-          </a:p>
-          <a:p>
-            <a:pPr indent="0" marL="0">
-              <a:buNone/>
-            </a:pPr>
-            <a:r>
-              <a:rPr lang="en-US" sz="1300" dirty="0">
-                <a:solidFill>
-                  <a:srgbClr val="333333"/>
-                </a:solidFill>
-              </a:rPr>
-              <a:t>❑ Validation (20%): Untuk seleksi </a:t>
-            </a:r>
-            <a:pPr indent="0" marL="0">
-              <a:buNone/>
-            </a:pPr>
-            <a:r>
-              <a:rPr lang="en-US" sz="1300" b="1" dirty="0">
-                <a:solidFill>
-                  <a:srgbClr val="333333"/>
-                </a:solidFill>
-              </a:rPr>
-              <a:t>gamma terbaik</a:t>
-            </a:r>
-            <a:pPr indent="0" marL="0">
-              <a:buNone/>
-            </a:pPr>
-            <a:r>
-              <a:rPr lang="en-US" sz="1300" dirty="0">
-                <a:solidFill>
-                  <a:srgbClr val="333333"/>
-                </a:solidFill>
-              </a:rPr>
-              <a:t> dengan performa optimal.</a:t>
-            </a:r>
-            <a:endParaRPr lang="en-US" sz="1300" dirty="0"/>
-          </a:p>
-          <a:p>
-            <a:pPr indent="0" marL="0">
-              <a:buNone/>
-            </a:pPr>
-            <a:r>
-              <a:rPr lang="en-US" sz="1300" dirty="0">
-                <a:solidFill>
-                  <a:srgbClr val="333333"/>
-                </a:solidFill>
-              </a:rPr>
-              <a:t>❑ Penanganan Data/Gagal: Menggunakan strategi </a:t>
-            </a:r>
-            <a:pPr indent="0" marL="0">
-              <a:buNone/>
-            </a:pPr>
-            <a:r>
-              <a:rPr lang="en-US" sz="1300" b="1" dirty="0">
-                <a:solidFill>
-                  <a:srgbClr val="333333"/>
-                </a:solidFill>
-              </a:rPr>
-              <a:t>fallback 'EW'</a:t>
-            </a:r>
-            <a:pPr indent="0" marL="0">
-              <a:buNone/>
-            </a:pPr>
-            <a:r>
-              <a:rPr lang="en-US" sz="1300" dirty="0">
-                <a:solidFill>
-                  <a:srgbClr val="333333"/>
-                </a:solidFill>
-              </a:rPr>
-              <a:t> jika jendela data tidak mencukupi sesuai variasi.</a:t>
-            </a:r>
-            <a:endParaRPr lang="en-US" sz="1300" dirty="0"/>
-          </a:p>
-          <a:p>
-            <a:pPr indent="0" marL="0">
-              <a:buNone/>
-            </a:pPr>
-            <a:r>
-              <a:rPr lang="en-US" sz="1300" dirty="0">
-                <a:solidFill>
-                  <a:srgbClr val="333333"/>
-                </a:solidFill>
-              </a:rPr>
-              <a:t>❑ Tujuan: Adaptasi terhadap perubahan </a:t>
-            </a:r>
-            <a:pPr indent="0" marL="0">
-              <a:buNone/>
-            </a:pPr>
-            <a:r>
-              <a:rPr lang="en-US" sz="1300" b="1" dirty="0">
-                <a:solidFill>
-                  <a:srgbClr val="333333"/>
-                </a:solidFill>
-              </a:rPr>
-              <a:t>rezim pasar</a:t>
-            </a:r>
-            <a:pPr indent="0" marL="0">
-              <a:buNone/>
-            </a:pPr>
-            <a:r>
-              <a:rPr lang="en-US" sz="1300" dirty="0">
-                <a:solidFill>
-                  <a:srgbClr val="333333"/>
-                </a:solidFill>
-              </a:rPr>
-              <a:t> secara real-time.</a:t>
-            </a:r>
-            <a:endParaRPr lang="en-US" sz="1300" dirty="0"/>
+            <a:endParaRPr lang="en-US" sz="2000" dirty="0"/>
+          </a:p>
+          <a:p>
+            <a:pPr indent="0" marL="0">
+              <a:buNone/>
+            </a:pPr>
+            <a:r>
+              <a:rPr lang="en-US" sz="2000" dirty="0">
+                <a:solidFill>
+                  <a:srgbClr val="333333"/>
+                </a:solidFill>
+              </a:rPr>
+              <a:t>❑ Training: Estimasi bobot gamma.</a:t>
+            </a:r>
+            <a:endParaRPr lang="en-US" sz="2000" dirty="0"/>
+          </a:p>
+          <a:p>
+            <a:pPr indent="0" marL="0">
+              <a:buNone/>
+            </a:pPr>
+            <a:r>
+              <a:rPr lang="en-US" sz="2000" dirty="0">
+                <a:solidFill>
+                  <a:srgbClr val="333333"/>
+                </a:solidFill>
+              </a:rPr>
+              <a:t>❑ Validation: Seleksi performa optimal.</a:t>
+            </a:r>
+            <a:endParaRPr lang="en-US" sz="2000" dirty="0"/>
+          </a:p>
+          <a:p>
+            <a:pPr indent="0" marL="0">
+              <a:buNone/>
+            </a:pPr>
+            <a:r>
+              <a:rPr lang="en-US" sz="2000" dirty="0">
+                <a:solidFill>
+                  <a:srgbClr val="333333"/>
+                </a:solidFill>
+              </a:rPr>
+              <a:t>❑ Fallback: Menggunakan strategi EW (Equally Weighted).</a:t>
+            </a:r>
+            <a:endParaRPr lang="en-US" sz="2000" dirty="0"/>
+          </a:p>
+          <a:p>
+            <a:pPr indent="0" marL="0">
+              <a:buNone/>
+            </a:pPr>
+            <a:r>
+              <a:rPr lang="en-US" sz="2000" dirty="0">
+                <a:solidFill>
+                  <a:srgbClr val="333333"/>
+                </a:solidFill>
+              </a:rPr>
+              <a:t>❑ Tujuan: Adaptasi rezim pasar.</a:t>
+            </a:r>
+            <a:endParaRPr lang="en-US" sz="2000" dirty="0"/>
           </a:p>
         </p:txBody>
       </p:sp>
@@ -5348,7 +5372,7 @@
                   </a:extLst>
                 </a:hlinkClick>
               </a:rPr>
-              <a:t>RMT</a:t>
+              <a:t>RMT (Random Matrix Theory)</a:t>
             </a:r>
             <a:pPr indent="0" marL="0">
               <a:buNone/>
@@ -5534,7 +5558,7 @@
                   <a:srgbClr val="333333"/>
                 </a:solidFill>
               </a:rPr>
-              <a:t> menggunakan MP-Distribution.</a:t>
+              <a:t> menggunakan Distribusi MP (Marchenko-Pastur).</a:t>
             </a:r>
             <a:endParaRPr lang="en-US" sz="2200" dirty="0"/>
           </a:p>
@@ -5771,7 +5795,7 @@
                   <a:srgbClr val="333333"/>
                 </a:solidFill>
               </a:rPr>
-              <a:t>RMT menghitung </a:t>
+              <a:t>RMT (Random Matrix Theory) menghitung </a:t>
             </a:r>
             <a:pPr indent="0" marL="0">
               <a:buNone/>
@@ -6316,7 +6340,7 @@
                   <a:srgbClr val="333333"/>
                 </a:solidFill>
               </a:rPr>
-              <a:t>Konteks Dummy: 2 Koin (BTC &amp; ETH) dengan korelasi = 0.5</a:t>
+              <a:t>Konteks Dummy: 2 Koin, BTC (Bitcoin) &amp; ETH (Ethereum), korelasi = 0.5</a:t>
             </a:r>
             <a:endParaRPr lang="en-US" sz="1600" dirty="0"/>
           </a:p>
@@ -6537,7 +6561,7 @@
                   <a:srgbClr val="333333"/>
                 </a:solidFill>
               </a:rPr>
-              <a:t>   Jika RMT mematok batas λ_max = 1.0, maka λ₂ dianggap </a:t>
+              <a:t>   Jika RMT (Random Matrix Theory) mematok batas λ_max = 1.0, maka λ₂ dianggap </a:t>
             </a:r>
             <a:pPr indent="0" marL="0">
               <a:buNone/>
@@ -8661,7 +8685,7 @@
                   <a:srgbClr val="333333"/>
                 </a:solidFill>
               </a:rPr>
-              <a:t>Model CM memakan mentah-mentah </a:t>
+              <a:t>Model CM (Classical Markowitz) memakan mentah-mentah </a:t>
             </a:r>
             <a:pPr indent="0" marL="0">
               <a:buNone/>
@@ -8712,7 +8736,7 @@
                   <a:srgbClr val="333333"/>
                 </a:solidFill>
               </a:rPr>
-              <a:t>Mengembangkan CM dengan membersihkan noise (RMT) dan menghukum koin yang rawan menderita </a:t>
+              <a:t>Mengembangkan CM (Classical Markowitz) dengan membersihkan noise menggunakan RMT (Random Matrix Theory) dan menghukum koin yang rawan menderita </a:t>
             </a:r>
             <a:pPr indent="0" marL="0">
               <a:buNone/>
@@ -8734,7 +8758,7 @@
                   <a:srgbClr val="333333"/>
                 </a:solidFill>
               </a:rPr>
-              <a:t> (MST).</a:t>
+              <a:t> menggunakan MST (Minimum Spanning Tree).</a:t>
             </a:r>
             <a:endParaRPr lang="en-US" sz="1800" dirty="0"/>
           </a:p>
@@ -8790,14 +8814,14 @@
               <a:buNone/>
             </a:pPr>
             <a:r>
-              <a:rPr lang="en-US" sz="2600" b="1" dirty="0">
+              <a:rPr lang="en-US" sz="2400" b="1" dirty="0">
                 <a:solidFill>
                   <a:srgbClr val="003366"/>
                 </a:solidFill>
               </a:rPr>
-              <a:t>Lampiran: Dua Tipe Pendekatan Grid Search</a:t>
-            </a:r>
-            <a:endParaRPr lang="en-US" sz="2600" dirty="0"/>
+              <a:t>Lampiran: Detail Perhitungan Korelasi (Pearson)</a:t>
+            </a:r>
+            <a:endParaRPr lang="en-US" sz="2400" dirty="0"/>
           </a:p>
         </p:txBody>
       </p:sp>
@@ -8826,190 +8850,232 @@
               <a:buNone/>
             </a:pPr>
             <a:r>
-              <a:rPr lang="en-US" sz="1800" b="1" dirty="0">
-                <a:solidFill>
-                  <a:srgbClr val="333333"/>
-                </a:solidFill>
-              </a:rPr>
-              <a:t>Dua Objektif Optimasi (Return vs Risk):</a:t>
-            </a:r>
-            <a:endParaRPr lang="en-US" sz="1800" dirty="0"/>
-          </a:p>
-          <a:p>
-            <a:pPr indent="0" marL="0">
-              <a:buNone/>
-            </a:pPr>
-            <a:r>
-              <a:rPr lang="en-US" sz="1800" b="1" dirty="0">
+              <a:rPr lang="en-US" sz="1600" b="1" dirty="0">
+                <a:solidFill>
+                  <a:srgbClr val="333333"/>
+                </a:solidFill>
+              </a:rPr>
+              <a:t>Bagaimana angka 0.50 didapatkan? (Dummy 3 Hari)</a:t>
+            </a:r>
+            <a:endParaRPr lang="en-US" sz="1600" dirty="0"/>
+          </a:p>
+          <a:p>
+            <a:pPr indent="0" marL="0">
+              <a:buNone/>
+            </a:pPr>
+            <a:r>
+              <a:rPr lang="en-US" sz="1600" b="1" dirty="0">
+                <a:solidFill>
+                  <a:srgbClr val="003366"/>
+                </a:solidFill>
+              </a:rPr>
+              <a:t>1. Data Return (X=BTC, Y=ETH):</a:t>
+            </a:r>
+            <a:endParaRPr lang="en-US" sz="1600" dirty="0"/>
+          </a:p>
+          <a:p>
+            <a:pPr indent="0" marL="0">
+              <a:buNone/>
+            </a:pPr>
+            <a:r>
+              <a:rPr lang="en-US" sz="1600" dirty="0">
+                <a:solidFill>
+                  <a:srgbClr val="333333"/>
+                </a:solidFill>
+              </a:rPr>
+              <a:t>   • Hari 1: X=2%, Y=2% | Hari 2: X=-2%, Y=0% | Hari 3: X=0%, Y=-2%</a:t>
+            </a:r>
+            <a:endParaRPr lang="en-US" sz="1600" dirty="0"/>
+          </a:p>
+          <a:p>
+            <a:pPr indent="0" marL="0">
+              <a:buNone/>
+            </a:pPr>
+            <a:r>
+              <a:rPr lang="en-US" sz="1600" dirty="0">
+                <a:solidFill>
+                  <a:srgbClr val="333333"/>
+                </a:solidFill>
+              </a:rPr>
+              <a:t>   • Rata-rata (Mean): X̄ = 0, Ȳ = 0</a:t>
+            </a:r>
+            <a:endParaRPr lang="en-US" sz="1600" dirty="0"/>
+          </a:p>
+          <a:p>
+            <a:pPr indent="0" marL="0">
+              <a:buNone/>
+            </a:pPr>
+            <a:r>
+              <a:rPr lang="en-US" sz="1600" b="1" dirty="0">
+                <a:solidFill>
+                  <a:srgbClr val="003366"/>
+                </a:solidFill>
+              </a:rPr>
+              <a:t>2. Tabel Deviasi &amp; Perkalian:</a:t>
+            </a:r>
+            <a:endParaRPr lang="en-US" sz="1600" dirty="0"/>
+          </a:p>
+          <a:p>
+            <a:pPr indent="0" marL="0">
+              <a:buNone/>
+            </a:pPr>
+            <a:r>
+              <a:rPr lang="en-US" sz="1600" dirty="0">
+                <a:solidFill>
+                  <a:srgbClr val="333333"/>
+                </a:solidFill>
+              </a:rPr>
+              <a:t>   • Σ(x-x̄)(y-ȳ) = (2)(2) + (-2)(0) + (0)(-2) = </a:t>
+            </a:r>
+            <a:pPr indent="0" marL="0">
+              <a:buNone/>
+            </a:pPr>
+            <a:r>
+              <a:rPr lang="en-US" sz="1600" b="1" dirty="0">
+                <a:solidFill>
+                  <a:srgbClr val="333333"/>
+                </a:solidFill>
+              </a:rPr>
+              <a:t>4</a:t>
+            </a:r>
+            <a:endParaRPr lang="en-US" sz="1600" dirty="0"/>
+          </a:p>
+          <a:p>
+            <a:pPr indent="0" marL="0">
+              <a:buNone/>
+            </a:pPr>
+            <a:r>
+              <a:rPr lang="en-US" sz="1600" dirty="0">
+                <a:solidFill>
+                  <a:srgbClr val="333333"/>
+                </a:solidFill>
+              </a:rPr>
+              <a:t>   • Σ(x-x̄)² = (2)² + (-2)² + (0)² = </a:t>
+            </a:r>
+            <a:pPr indent="0" marL="0">
+              <a:buNone/>
+            </a:pPr>
+            <a:r>
+              <a:rPr lang="en-US" sz="1600" b="1" dirty="0">
+                <a:solidFill>
+                  <a:srgbClr val="333333"/>
+                </a:solidFill>
+              </a:rPr>
+              <a:t>8</a:t>
+            </a:r>
+            <a:endParaRPr lang="en-US" sz="1600" dirty="0"/>
+          </a:p>
+          <a:p>
+            <a:pPr indent="0" marL="0">
+              <a:buNone/>
+            </a:pPr>
+            <a:r>
+              <a:rPr lang="en-US" sz="1600" dirty="0">
+                <a:solidFill>
+                  <a:srgbClr val="333333"/>
+                </a:solidFill>
+              </a:rPr>
+              <a:t>   • Σ(y-ȳ)² = (2)² + (0)² + (-2)² = </a:t>
+            </a:r>
+            <a:pPr indent="0" marL="0">
+              <a:buNone/>
+            </a:pPr>
+            <a:r>
+              <a:rPr lang="en-US" sz="1600" b="1" dirty="0">
+                <a:solidFill>
+                  <a:srgbClr val="333333"/>
+                </a:solidFill>
+              </a:rPr>
+              <a:t>8</a:t>
+            </a:r>
+            <a:endParaRPr lang="en-US" sz="1600" dirty="0"/>
+          </a:p>
+          <a:p>
+            <a:pPr indent="0" marL="0">
+              <a:buNone/>
+            </a:pPr>
+            <a:r>
+              <a:rPr lang="en-US" sz="1600" b="1" dirty="0">
+                <a:solidFill>
+                  <a:srgbClr val="003366"/>
+                </a:solidFill>
+              </a:rPr>
+              <a:t>3. Rumus Korelasi (ρ):</a:t>
+            </a:r>
+            <a:endParaRPr lang="en-US" sz="1600" dirty="0"/>
+          </a:p>
+          <a:p>
+            <a:pPr indent="0" marL="0">
+              <a:buNone/>
+            </a:pPr>
+            <a:r>
+              <a:rPr lang="en-US" sz="1600" dirty="0">
+                <a:solidFill>
+                  <a:srgbClr val="C0392B"/>
+                </a:solidFill>
+                <a:latin typeface="Courier New" pitchFamily="34" charset="0"/>
+                <a:ea typeface="Courier New" pitchFamily="34" charset="-122"/>
+                <a:cs typeface="Courier New" pitchFamily="34" charset="-120"/>
+              </a:rPr>
+              <a:t>   ρ = Σ(dev_x * dev_y) / √(Σdev_x² * Σdev_y²)</a:t>
+            </a:r>
+            <a:endParaRPr lang="en-US" sz="1600" dirty="0"/>
+          </a:p>
+          <a:p>
+            <a:pPr indent="0" marL="0">
+              <a:buNone/>
+            </a:pPr>
+            <a:r>
+              <a:rPr lang="en-US" sz="1600" dirty="0">
+                <a:solidFill>
+                  <a:srgbClr val="333333"/>
+                </a:solidFill>
+                <a:latin typeface="Courier New" pitchFamily="34" charset="0"/>
+                <a:ea typeface="Courier New" pitchFamily="34" charset="-122"/>
+                <a:cs typeface="Courier New" pitchFamily="34" charset="-120"/>
+              </a:rPr>
+              <a:t>   ρ = 4 / √(8 * 8) = 4 / 8 = </a:t>
+            </a:r>
+            <a:pPr indent="0" marL="0">
+              <a:buNone/>
+            </a:pPr>
+            <a:r>
+              <a:rPr lang="en-US" sz="1600" b="1" dirty="0">
                 <a:solidFill>
                   <a:srgbClr val="27AE60"/>
                 </a:solidFill>
-              </a:rPr>
-              <a:t>1. Network Markowitz dengan Target Return (NW - Return GS):</a:t>
-            </a:r>
-            <a:endParaRPr lang="en-US" sz="1800" dirty="0"/>
-          </a:p>
-          <a:p>
-            <a:pPr marL="342900" indent="-342900">
-              <a:buSzPct val="100000"/>
-              <a:buChar char="•"/>
-            </a:pPr>
-            <a:r>
-              <a:rPr lang="en-US" sz="1800" dirty="0">
-                <a:solidFill>
-                  <a:srgbClr val="333333"/>
-                </a:solidFill>
-              </a:rPr>
-              <a:t>Memaksimalkan capaian </a:t>
-            </a:r>
-            <a:pPr indent="0" marL="0">
-              <a:buNone/>
-            </a:pPr>
-            <a:r>
-              <a:rPr lang="en-US" sz="1800" b="1" dirty="0">
-                <a:solidFill>
-                  <a:srgbClr val="333333"/>
-                </a:solidFill>
-              </a:rPr>
-              <a:t>imbal hasil</a:t>
-            </a:r>
-            <a:pPr indent="0" marL="0">
-              <a:buNone/>
-            </a:pPr>
-            <a:r>
-              <a:rPr lang="en-US" sz="1800" dirty="0">
-                <a:solidFill>
-                  <a:srgbClr val="333333"/>
-                </a:solidFill>
-              </a:rPr>
-              <a:t> portofolio.</a:t>
-            </a:r>
-            <a:endParaRPr lang="en-US" sz="1800" dirty="0"/>
-          </a:p>
-          <a:p>
-            <a:pPr marL="342900" indent="-342900">
-              <a:buSzPct val="100000"/>
-              <a:buChar char="•"/>
-            </a:pPr>
-            <a:r>
-              <a:rPr lang="en-US" sz="1800" dirty="0">
-                <a:solidFill>
-                  <a:srgbClr val="333333"/>
-                </a:solidFill>
-              </a:rPr>
-              <a:t>Lebih Agresif untuk mengeksploitasi reli pada pasar </a:t>
-            </a:r>
-            <a:pPr indent="0" marL="0">
-              <a:buNone/>
-            </a:pPr>
-            <a:r>
-              <a:rPr lang="en-US" sz="1800" b="1" dirty="0">
-                <a:solidFill>
-                  <a:srgbClr val="333333"/>
-                </a:solidFill>
-              </a:rPr>
-              <a:t>Bullish</a:t>
-            </a:r>
-            <a:pPr indent="0" marL="0">
-              <a:buNone/>
-            </a:pPr>
-            <a:r>
-              <a:rPr lang="en-US" sz="1800" dirty="0">
-                <a:solidFill>
-                  <a:srgbClr val="333333"/>
-                </a:solidFill>
-              </a:rPr>
-              <a:t>.</a:t>
-            </a:r>
-            <a:endParaRPr lang="en-US" sz="1800" dirty="0"/>
-          </a:p>
-          <a:p>
-            <a:pPr indent="0" marL="0">
-              <a:buNone/>
-            </a:pPr>
-            <a:r>
-              <a:rPr lang="en-US" sz="1800" b="1" dirty="0">
+                <a:latin typeface="Courier New" pitchFamily="34" charset="0"/>
+                <a:ea typeface="Courier New" pitchFamily="34" charset="-122"/>
+                <a:cs typeface="Courier New" pitchFamily="34" charset="-120"/>
+              </a:rPr>
+              <a:t>0.50</a:t>
+            </a:r>
+            <a:pPr indent="0" marL="0">
+              <a:buNone/>
+            </a:pPr>
+            <a:r>
+              <a:rPr lang="en-US" sz="1600" b="1" dirty="0">
                 <a:solidFill>
                   <a:srgbClr val="C0392B"/>
                 </a:solidFill>
               </a:rPr>
-              <a:t>2. Network Markowitz dengan Target Risiko (NW - Risk GS):</a:t>
-            </a:r>
-            <a:endParaRPr lang="en-US" sz="1800" dirty="0"/>
-          </a:p>
-          <a:p>
-            <a:pPr marL="342900" indent="-342900">
-              <a:buSzPct val="100000"/>
-              <a:buChar char="•"/>
-            </a:pPr>
-            <a:r>
-              <a:rPr lang="en-US" sz="1800" dirty="0">
-                <a:solidFill>
-                  <a:srgbClr val="333333"/>
-                </a:solidFill>
-              </a:rPr>
-              <a:t>Menekan parameter </a:t>
-            </a:r>
-            <a:pPr indent="0" marL="0">
-              <a:buNone/>
-            </a:pPr>
-            <a:r>
-              <a:rPr lang="en-US" sz="1800" b="1" dirty="0">
-                <a:solidFill>
-                  <a:srgbClr val="333333"/>
-                </a:solidFill>
-              </a:rPr>
-              <a:t>risiko total</a:t>
-            </a:r>
-            <a:pPr indent="0" marL="0">
-              <a:buNone/>
-            </a:pPr>
-            <a:r>
-              <a:rPr lang="en-US" sz="1800" dirty="0">
-                <a:solidFill>
-                  <a:srgbClr val="333333"/>
-                </a:solidFill>
-              </a:rPr>
-              <a:t> hingga minimal.</a:t>
-            </a:r>
-            <a:endParaRPr lang="en-US" sz="1800" dirty="0"/>
-          </a:p>
-          <a:p>
-            <a:pPr marL="342900" indent="-342900">
-              <a:buSzPct val="100000"/>
-              <a:buChar char="•"/>
-            </a:pPr>
-            <a:r>
-              <a:rPr lang="en-US" sz="1800" dirty="0">
-                <a:solidFill>
-                  <a:srgbClr val="333333"/>
-                </a:solidFill>
-              </a:rPr>
-              <a:t>Lebih Defensif untuk meredam fluktuasi saat </a:t>
-            </a:r>
-            <a:pPr indent="0" marL="0">
-              <a:buNone/>
-            </a:pPr>
-            <a:r>
-              <a:rPr lang="en-US" sz="1800" b="1" dirty="0">
-                <a:solidFill>
-                  <a:srgbClr val="333333"/>
-                </a:solidFill>
-              </a:rPr>
-              <a:t>Crypto Winter</a:t>
-            </a:r>
-            <a:pPr indent="0" marL="0">
-              <a:buNone/>
-            </a:pPr>
-            <a:r>
-              <a:rPr lang="en-US" sz="1800" dirty="0">
-                <a:solidFill>
-                  <a:srgbClr val="333333"/>
-                </a:solidFill>
-              </a:rPr>
-              <a:t>.</a:t>
-            </a:r>
-            <a:endParaRPr lang="en-US" sz="1800" dirty="0"/>
+              <a:t>Kesimpulan:</a:t>
+            </a:r>
+            <a:endParaRPr lang="en-US" sz="1600" dirty="0"/>
+          </a:p>
+          <a:p>
+            <a:pPr indent="0" marL="0">
+              <a:buNone/>
+            </a:pPr>
+            <a:r>
+              <a:rPr lang="en-US" sz="1600" i="1" dirty="0">
+                <a:solidFill>
+                  <a:srgbClr val="333333"/>
+                </a:solidFill>
+              </a:rPr>
+              <a:t>Angka ini menunjukkan arah pergerakan yang searah (positif) namun tidak identik, yang kemudian digunakan sebagai input matriks kovarians.</a:t>
+            </a:r>
+            <a:endParaRPr lang="en-US" sz="1600" dirty="0"/>
           </a:p>
         </p:txBody>
       </p:sp>
@@ -9063,14 +9129,14 @@
               <a:buNone/>
             </a:pPr>
             <a:r>
-              <a:rPr lang="en-US" sz="2600" b="1" dirty="0">
+              <a:rPr lang="en-US" sz="2400" b="1" dirty="0">
                 <a:solidFill>
                   <a:srgbClr val="003366"/>
                 </a:solidFill>
               </a:rPr>
-              <a:t>Lampiran: Penanganan Data Kosong (Missing Values)</a:t>
-            </a:r>
-            <a:endParaRPr lang="en-US" sz="2600" dirty="0"/>
+              <a:t>Lampiran: Simulasi Sederhana Classical Markowitz (2 Aset)</a:t>
+            </a:r>
+            <a:endParaRPr lang="en-US" sz="2400" dirty="0"/>
           </a:p>
         </p:txBody>
       </p:sp>
@@ -9099,183 +9165,262 @@
               <a:buNone/>
             </a:pPr>
             <a:r>
-              <a:rPr lang="en-US" sz="1800" b="1" dirty="0">
+              <a:rPr lang="en-US" sz="1600" b="1" dirty="0">
+                <a:solidFill>
+                  <a:srgbClr val="333333"/>
+                </a:solidFill>
+              </a:rPr>
+              <a:t>Tujuan: Mencari bobot (w) untuk risiko terendah (Minimum Variance).</a:t>
+            </a:r>
+            <a:endParaRPr lang="en-US" sz="1600" dirty="0"/>
+          </a:p>
+          <a:p>
+            <a:pPr indent="0" marL="0">
+              <a:buNone/>
+            </a:pPr>
+            <a:r>
+              <a:rPr lang="en-US" sz="1600" b="1" dirty="0">
+                <a:solidFill>
+                  <a:srgbClr val="003366"/>
+                </a:solidFill>
+              </a:rPr>
+              <a:t>1. Data Input (Dummy):</a:t>
+            </a:r>
+            <a:endParaRPr lang="en-US" sz="1600" dirty="0"/>
+          </a:p>
+          <a:p>
+            <a:pPr indent="0" marL="0">
+              <a:buNone/>
+            </a:pPr>
+            <a:r>
+              <a:rPr lang="en-US" sz="1600" dirty="0">
+                <a:solidFill>
+                  <a:srgbClr val="333333"/>
+                </a:solidFill>
+              </a:rPr>
+              <a:t>   • Aset A (BTC): Volatilitas (σ₁) = 20% (0.20)</a:t>
+            </a:r>
+            <a:endParaRPr lang="en-US" sz="1600" dirty="0"/>
+          </a:p>
+          <a:p>
+            <a:pPr indent="0" marL="0">
+              <a:buNone/>
+            </a:pPr>
+            <a:r>
+              <a:rPr lang="en-US" sz="1600" dirty="0">
+                <a:solidFill>
+                  <a:srgbClr val="333333"/>
+                </a:solidFill>
+              </a:rPr>
+              <a:t>   • Aset B (ETH): Volatilitas (σ₂) = 30% (0.30)</a:t>
+            </a:r>
+            <a:endParaRPr lang="en-US" sz="1600" dirty="0"/>
+          </a:p>
+          <a:p>
+            <a:pPr indent="0" marL="0">
+              <a:buNone/>
+            </a:pPr>
+            <a:r>
+              <a:rPr lang="en-US" sz="1600" dirty="0">
+                <a:solidFill>
+                  <a:srgbClr val="333333"/>
+                </a:solidFill>
+              </a:rPr>
+              <a:t>   • Korelasi (ρ₁₂): 0.50 (Didapat dari return harian historis)</a:t>
+            </a:r>
+            <a:endParaRPr lang="en-US" sz="1600" dirty="0"/>
+          </a:p>
+          <a:p>
+            <a:pPr indent="0" marL="0">
+              <a:buNone/>
+            </a:pPr>
+            <a:r>
+              <a:rPr lang="en-US" sz="1600" b="1" dirty="0">
+                <a:solidFill>
+                  <a:srgbClr val="333333"/>
+                </a:solidFill>
+              </a:rPr>
+              <a:t>   • Kovarians (σ₁₂): </a:t>
+            </a:r>
+            <a:pPr indent="0" marL="0">
+              <a:buNone/>
+            </a:pPr>
+            <a:r>
+              <a:rPr lang="en-US" sz="1600" i="1" dirty="0">
+                <a:solidFill>
+                  <a:srgbClr val="333333"/>
+                </a:solidFill>
+              </a:rPr>
+              <a:t>ρ₁₂ × σ₁ × σ₂</a:t>
+            </a:r>
+            <a:pPr indent="0" marL="0">
+              <a:buNone/>
+            </a:pPr>
+            <a:r>
+              <a:rPr lang="en-US" sz="1600" dirty="0">
+                <a:solidFill>
+                  <a:srgbClr val="333333"/>
+                </a:solidFill>
+              </a:rPr>
+              <a:t> = 0.50 × 0.20 × 0.30 = </a:t>
+            </a:r>
+            <a:pPr indent="0" marL="0">
+              <a:buNone/>
+            </a:pPr>
+            <a:r>
+              <a:rPr lang="en-US" sz="1600" b="1" dirty="0">
+                <a:solidFill>
+                  <a:srgbClr val="333333"/>
+                </a:solidFill>
+              </a:rPr>
+              <a:t>0.03</a:t>
+            </a:r>
+            <a:endParaRPr lang="en-US" sz="1600" dirty="0"/>
+          </a:p>
+          <a:p>
+            <a:pPr indent="0" marL="0">
+              <a:buNone/>
+            </a:pPr>
+            <a:r>
+              <a:rPr lang="en-US" sz="1600" b="1" dirty="0">
+                <a:solidFill>
+                  <a:srgbClr val="003366"/>
+                </a:solidFill>
+              </a:rPr>
+              <a:t>2. Rumus Bobot Aset A (w₁):</a:t>
+            </a:r>
+            <a:endParaRPr lang="en-US" sz="1600" dirty="0"/>
+          </a:p>
+          <a:p>
+            <a:pPr indent="0" marL="0">
+              <a:buNone/>
+            </a:pPr>
+            <a:r>
+              <a:rPr lang="en-US" sz="1600" b="1" dirty="0">
                 <a:solidFill>
                   <a:srgbClr val="C0392B"/>
                 </a:solidFill>
-              </a:rPr>
-              <a:t>Pertanyaan: </a:t>
-            </a:r>
-            <a:pPr indent="0" marL="0">
-              <a:buNone/>
-            </a:pPr>
-            <a:r>
-              <a:rPr lang="en-US" sz="1800" i="1" dirty="0">
-                <a:solidFill>
-                  <a:srgbClr val="333333"/>
-                </a:solidFill>
-              </a:rPr>
-              <a:t>"Beberapa koin seperti Binance/EOS belum rilis di awal 2017 sehingga datanya kosong. Bukankah backward-fill memalsukan harga dan merusak matriks?"</a:t>
-            </a:r>
-            <a:endParaRPr lang="en-US" sz="1800" dirty="0"/>
-          </a:p>
-          <a:p>
-            <a:pPr indent="0" marL="0">
-              <a:buNone/>
-            </a:pPr>
-            <a:r>
-              <a:rPr lang="en-US" sz="1800" b="1" dirty="0">
+                <a:latin typeface="Courier New" pitchFamily="34" charset="0"/>
+                <a:ea typeface="Courier New" pitchFamily="34" charset="-122"/>
+                <a:cs typeface="Courier New" pitchFamily="34" charset="-120"/>
+              </a:rPr>
+              <a:t>   w₁ = (σ₂² - Cov) / (σ₁² + σ₂² - 2·Cov)</a:t>
+            </a:r>
+            <a:endParaRPr lang="en-US" sz="1600" dirty="0"/>
+          </a:p>
+          <a:p>
+            <a:pPr indent="0" marL="0">
+              <a:buNone/>
+            </a:pPr>
+            <a:r>
+              <a:rPr lang="en-US" sz="1600" dirty="0">
+                <a:solidFill>
+                  <a:srgbClr val="333333"/>
+                </a:solidFill>
+                <a:latin typeface="Courier New" pitchFamily="34" charset="0"/>
+                <a:ea typeface="Courier New" pitchFamily="34" charset="-122"/>
+                <a:cs typeface="Courier New" pitchFamily="34" charset="-120"/>
+              </a:rPr>
+              <a:t>   w₁ = (0.09 - 0.03) / (0.04 + 0.09 - 0.06)</a:t>
+            </a:r>
+            <a:endParaRPr lang="en-US" sz="1600" dirty="0"/>
+          </a:p>
+          <a:p>
+            <a:pPr indent="0" marL="0">
+              <a:buNone/>
+            </a:pPr>
+            <a:r>
+              <a:rPr lang="en-US" sz="1600" dirty="0">
+                <a:solidFill>
+                  <a:srgbClr val="333333"/>
+                </a:solidFill>
+                <a:latin typeface="Courier New" pitchFamily="34" charset="0"/>
+                <a:ea typeface="Courier New" pitchFamily="34" charset="-122"/>
+                <a:cs typeface="Courier New" pitchFamily="34" charset="-120"/>
+              </a:rPr>
+              <a:t>   w₁ = 0.06 / 0.07 ≈ </a:t>
+            </a:r>
+            <a:pPr indent="0" marL="0">
+              <a:buNone/>
+            </a:pPr>
+            <a:r>
+              <a:rPr lang="en-US" sz="1600" b="1" dirty="0">
                 <a:solidFill>
                   <a:srgbClr val="27AE60"/>
                 </a:solidFill>
               </a:rPr>
-              <a:t>Jawaban (Kenapa RMT sangat Krusial):</a:t>
-            </a:r>
-            <a:endParaRPr lang="en-US" sz="1800" dirty="0"/>
-          </a:p>
-          <a:p>
-            <a:pPr indent="0" marL="0">
-              <a:buNone/>
-            </a:pPr>
-            <a:r>
-              <a:rPr lang="en-US" sz="1800" dirty="0">
-                <a:solidFill>
-                  <a:srgbClr val="333333"/>
-                </a:solidFill>
-              </a:rPr>
-              <a:t>   1. Praktik pengisian data diam (</a:t>
-            </a:r>
-            <a:pPr indent="0" marL="0">
-              <a:buNone/>
-            </a:pPr>
-            <a:r>
-              <a:rPr lang="en-US" sz="1800" b="1" i="1" dirty="0">
-                <a:solidFill>
-                  <a:srgbClr val="333333"/>
-                </a:solidFill>
-              </a:rPr>
-              <a:t>backward fill</a:t>
-            </a:r>
-            <a:pPr indent="0" marL="0">
-              <a:buNone/>
-            </a:pPr>
-            <a:r>
-              <a:rPr lang="en-US" sz="1800" dirty="0">
-                <a:solidFill>
-                  <a:srgbClr val="333333"/>
-                </a:solidFill>
-              </a:rPr>
-              <a:t>) memang menciptakan rentetan nilai harga yang statis.</a:t>
-            </a:r>
-            <a:endParaRPr lang="en-US" sz="1800" dirty="0"/>
-          </a:p>
-          <a:p>
-            <a:pPr indent="0" marL="0">
-              <a:buNone/>
-            </a:pPr>
-            <a:r>
-              <a:rPr lang="en-US" sz="1800" dirty="0">
-                <a:solidFill>
-                  <a:srgbClr val="333333"/>
-                </a:solidFill>
-              </a:rPr>
-              <a:t>   2. Namun, kehebatan </a:t>
-            </a:r>
-            <a:pPr indent="0" marL="0">
-              <a:buNone/>
-            </a:pPr>
-            <a:r>
-              <a:rPr lang="en-US" sz="1800" b="1" dirty="0">
-                <a:solidFill>
-                  <a:srgbClr val="333333"/>
-                </a:solidFill>
-              </a:rPr>
-              <a:t>Random Matrix Theory</a:t>
-            </a:r>
-            <a:pPr indent="0" marL="0">
-              <a:buNone/>
-            </a:pPr>
-            <a:r>
-              <a:rPr lang="en-US" sz="1800" dirty="0">
-                <a:solidFill>
-                  <a:srgbClr val="333333"/>
-                </a:solidFill>
-              </a:rPr>
-              <a:t> diuji di sini! Karena data yang datar sama sekali tidak punya korelasi nyata.</a:t>
-            </a:r>
-            <a:endParaRPr lang="en-US" sz="1800" dirty="0"/>
-          </a:p>
-          <a:p>
-            <a:pPr indent="0" marL="0">
-              <a:buNone/>
-            </a:pPr>
-            <a:r>
-              <a:rPr lang="en-US" sz="1800" dirty="0">
-                <a:solidFill>
-                  <a:srgbClr val="333333"/>
-                </a:solidFill>
-              </a:rPr>
-              <a:t>   3. RMT otomatis akan mendeteksi korelasi buatan tersebut sebagai probabilitas </a:t>
-            </a:r>
-            <a:pPr indent="0" marL="0">
-              <a:buNone/>
-            </a:pPr>
-            <a:r>
-              <a:rPr lang="en-US" sz="1800" b="1" i="1" dirty="0">
-                <a:solidFill>
-                  <a:srgbClr val="333333"/>
-                </a:solidFill>
-              </a:rPr>
-              <a:t>Noise Acak</a:t>
-            </a:r>
-            <a:pPr indent="0" marL="0">
-              <a:buNone/>
-            </a:pPr>
-            <a:r>
-              <a:rPr lang="en-US" sz="1800" dirty="0">
-                <a:solidFill>
-                  <a:srgbClr val="333333"/>
-                </a:solidFill>
-              </a:rPr>
-              <a:t>, lalu membuangnya menjadi 0.</a:t>
-            </a:r>
-            <a:endParaRPr lang="en-US" sz="1800" dirty="0"/>
-          </a:p>
-          <a:p>
-            <a:pPr indent="0" marL="0">
-              <a:buNone/>
-            </a:pPr>
-            <a:r>
-              <a:rPr lang="en-US" sz="1800" dirty="0">
-                <a:solidFill>
-                  <a:srgbClr val="333333"/>
-                </a:solidFill>
-              </a:rPr>
-              <a:t>   4. Hasilnya, matriks korelasi </a:t>
-            </a:r>
-            <a:pPr indent="0" marL="0">
-              <a:buNone/>
-            </a:pPr>
-            <a:r>
-              <a:rPr lang="en-US" sz="1800" b="1" dirty="0">
-                <a:solidFill>
-                  <a:srgbClr val="333333"/>
-                </a:solidFill>
-              </a:rPr>
-              <a:t>terselamatkan</a:t>
-            </a:r>
-            <a:pPr indent="0" marL="0">
-              <a:buNone/>
-            </a:pPr>
-            <a:r>
-              <a:rPr lang="en-US" sz="1800" dirty="0">
-                <a:solidFill>
-                  <a:srgbClr val="333333"/>
-                </a:solidFill>
-              </a:rPr>
-              <a:t> dan tidak tercemar oleh cacat kelengkapan data.</a:t>
-            </a:r>
-            <a:endParaRPr lang="en-US" sz="1800" dirty="0"/>
+              <a:t>0.85 (85%)</a:t>
+            </a:r>
+            <a:endParaRPr lang="en-US" sz="1600" dirty="0"/>
+          </a:p>
+          <a:p>
+            <a:pPr indent="0" marL="0">
+              <a:buNone/>
+            </a:pPr>
+            <a:r>
+              <a:rPr lang="en-US" sz="1600" b="1" dirty="0">
+                <a:solidFill>
+                  <a:srgbClr val="003366"/>
+                </a:solidFill>
+              </a:rPr>
+              <a:t>3. Hasil Alokasi:</a:t>
+            </a:r>
+            <a:endParaRPr lang="en-US" sz="1600" dirty="0"/>
+          </a:p>
+          <a:p>
+            <a:pPr marL="342900" indent="-342900">
+              <a:buSzPct val="100000"/>
+              <a:buChar char="•"/>
+            </a:pPr>
+            <a:r>
+              <a:rPr lang="en-US" sz="1600" dirty="0">
+                <a:solidFill>
+                  <a:srgbClr val="333333"/>
+                </a:solidFill>
+              </a:rPr>
+              <a:t>   • Bobot BTC: 85%</a:t>
+            </a:r>
+            <a:endParaRPr lang="en-US" sz="1600" dirty="0"/>
+          </a:p>
+          <a:p>
+            <a:pPr marL="342900" indent="-342900">
+              <a:buSzPct val="100000"/>
+              <a:buChar char="•"/>
+            </a:pPr>
+            <a:r>
+              <a:rPr lang="en-US" sz="1600" dirty="0">
+                <a:solidFill>
+                  <a:srgbClr val="333333"/>
+                </a:solidFill>
+              </a:rPr>
+              <a:t>   • Bobot ETH: 15%</a:t>
+            </a:r>
+            <a:pPr indent="0" marL="0">
+              <a:buNone/>
+            </a:pPr>
+            <a:r>
+              <a:rPr lang="en-US" sz="1600" b="1" dirty="0">
+                <a:solidFill>
+                  <a:srgbClr val="C0392B"/>
+                </a:solidFill>
+              </a:rPr>
+              <a:t>Kesimpulan Klasik:</a:t>
+            </a:r>
+            <a:endParaRPr lang="en-US" sz="1600" dirty="0"/>
+          </a:p>
+          <a:p>
+            <a:pPr indent="0" marL="0">
+              <a:buNone/>
+            </a:pPr>
+            <a:r>
+              <a:rPr lang="en-US" sz="1600" i="1" dirty="0">
+                <a:solidFill>
+                  <a:srgbClr val="333333"/>
+                </a:solidFill>
+              </a:rPr>
+              <a:t>Markowitz akan memilih aset dengan volatilitas lebih rendah (BTC) secara dominan. Namun, jika angka σ₁ dan σ₂ ini mengandung "noise", maka alokasi ini menjadi tidak optimal (Over-concentration).</a:t>
+            </a:r>
+            <a:endParaRPr lang="en-US" sz="1600" dirty="0"/>
           </a:p>
         </p:txBody>
       </p:sp>
@@ -9395,7 +9540,7 @@
                   <a:srgbClr val="333333"/>
                 </a:solidFill>
               </a:rPr>
-              <a:t> akibat sentimen sesaat, rumor, FOMO, atau spekulasi yang tidak mencerminkan nilai fundamental aset.</a:t>
+              <a:t> akibat sentimen sesaat, rumor, FOMO (Fear Of Missing Out), atau spekulasi yang tidak mencerminkan nilai fundamental aset.</a:t>
             </a:r>
             <a:endParaRPr lang="en-US" sz="1800" dirty="0"/>
           </a:p>
@@ -9685,7 +9830,7 @@
                   <a:srgbClr val="003366"/>
                 </a:solidFill>
               </a:rPr>
-              <a:t>Lampiran: Mengapa Menyertakan Tether (USDT)? (1/2)</a:t>
+              <a:t>Lampiran: Dua Tipe Pendekatan Grid Search</a:t>
             </a:r>
             <a:endParaRPr lang="en-US" sz="2600" dirty="0"/>
           </a:p>
@@ -9718,21 +9863,10 @@
             <a:r>
               <a:rPr lang="en-US" sz="1800" b="1" dirty="0">
                 <a:solidFill>
-                  <a:srgbClr val="C0392B"/>
-                </a:solidFill>
-              </a:rPr>
-              <a:t>Pertanyaan: </a:t>
-            </a:r>
-            <a:pPr indent="0" marL="0">
-              <a:buNone/>
-            </a:pPr>
-            <a:r>
-              <a:rPr lang="en-US" sz="1800" i="1" dirty="0">
-                <a:solidFill>
-                  <a:srgbClr val="333333"/>
-                </a:solidFill>
-              </a:rPr>
-              <a:t>"Tether (USDT) itu stablecoin yang nilainya selalu fix ke 1 USD. Apakah tidak berbuat curang?"</a:t>
+                  <a:srgbClr val="333333"/>
+                </a:solidFill>
+              </a:rPr>
+              <a:t>Dua Objektif Optimasi (Return vs Risk):</a:t>
             </a:r>
             <a:endParaRPr lang="en-US" sz="1800" dirty="0"/>
           </a:p>
@@ -9746,7 +9880,7 @@
                   <a:srgbClr val="27AE60"/>
                 </a:solidFill>
               </a:rPr>
-              <a:t>Jawaban (Dinamika Portofolio Cerdas):</a:t>
+              <a:t>1. Network Markowitz dengan Target Return (NW - Return Grid Search):</a:t>
             </a:r>
             <a:endParaRPr lang="en-US" sz="1800" dirty="0"/>
           </a:p>
@@ -9761,18 +9895,18 @@
                   <a:srgbClr val="333333"/>
                 </a:solidFill>
               </a:rPr>
-              <a:t>Model ini mensimulasikan perilaku </a:t>
-            </a:r>
-            <a:pPr indent="0" marL="0">
-              <a:buNone/>
-            </a:pPr>
-            <a:r>
-              <a:rPr lang="en-US" sz="1800" b="1" i="1" dirty="0">
-                <a:solidFill>
-                  <a:srgbClr val="333333"/>
-                </a:solidFill>
-              </a:rPr>
-              <a:t>Robo-Advisory</a:t>
+              <a:t>Memaksimalkan capaian </a:t>
+            </a:r>
+            <a:pPr indent="0" marL="0">
+              <a:buNone/>
+            </a:pPr>
+            <a:r>
+              <a:rPr lang="en-US" sz="1800" b="1" dirty="0">
+                <a:solidFill>
+                  <a:srgbClr val="333333"/>
+                </a:solidFill>
+              </a:rPr>
+              <a:t>imbal hasil</a:t>
             </a:r>
             <a:pPr indent="0" marL="0">
               <a:buNone/>
@@ -9783,7 +9917,7 @@
                   <a:srgbClr val="333333"/>
                 </a:solidFill>
               </a:rPr>
-              <a:t> institusional.</a:t>
+              <a:t> portofolio.</a:t>
             </a:r>
             <a:endParaRPr lang="en-US" sz="1800" dirty="0"/>
           </a:p>
@@ -9798,7 +9932,7 @@
                   <a:srgbClr val="333333"/>
                 </a:solidFill>
               </a:rPr>
-              <a:t>Ketika pasar anjlok ekstrem, investor akan melarikan senjatanya ke posisi </a:t>
+              <a:t>Lebih Agresif untuk mengeksploitasi reli pada pasar </a:t>
             </a:r>
             <a:pPr indent="0" marL="0">
               <a:buNone/>
@@ -9809,7 +9943,7 @@
                   <a:srgbClr val="333333"/>
                 </a:solidFill>
               </a:rPr>
-              <a:t>tunai (USDT)</a:t>
+              <a:t>Bullish</a:t>
             </a:r>
             <a:pPr indent="0" marL="0">
               <a:buNone/>
@@ -9820,7 +9954,95 @@
                   <a:srgbClr val="333333"/>
                 </a:solidFill>
               </a:rPr>
-              <a:t> sebagai evakuasi risiko.</a:t>
+              <a:t>.</a:t>
+            </a:r>
+            <a:endParaRPr lang="en-US" sz="1800" dirty="0"/>
+          </a:p>
+          <a:p>
+            <a:pPr indent="0" marL="0">
+              <a:buNone/>
+            </a:pPr>
+            <a:r>
+              <a:rPr lang="en-US" sz="1800" b="1" dirty="0">
+                <a:solidFill>
+                  <a:srgbClr val="C0392B"/>
+                </a:solidFill>
+              </a:rPr>
+              <a:t>2. Network Markowitz dengan Target Risiko (NW - Risk Grid Search):</a:t>
+            </a:r>
+            <a:endParaRPr lang="en-US" sz="1800" dirty="0"/>
+          </a:p>
+          <a:p>
+            <a:pPr marL="342900" indent="-342900">
+              <a:buSzPct val="100000"/>
+              <a:buChar char="•"/>
+            </a:pPr>
+            <a:r>
+              <a:rPr lang="en-US" sz="1800" dirty="0">
+                <a:solidFill>
+                  <a:srgbClr val="333333"/>
+                </a:solidFill>
+              </a:rPr>
+              <a:t>Menekan parameter </a:t>
+            </a:r>
+            <a:pPr indent="0" marL="0">
+              <a:buNone/>
+            </a:pPr>
+            <a:r>
+              <a:rPr lang="en-US" sz="1800" b="1" dirty="0">
+                <a:solidFill>
+                  <a:srgbClr val="333333"/>
+                </a:solidFill>
+              </a:rPr>
+              <a:t>risiko total</a:t>
+            </a:r>
+            <a:pPr indent="0" marL="0">
+              <a:buNone/>
+            </a:pPr>
+            <a:r>
+              <a:rPr lang="en-US" sz="1800" dirty="0">
+                <a:solidFill>
+                  <a:srgbClr val="333333"/>
+                </a:solidFill>
+              </a:rPr>
+              <a:t> hingga minimal.</a:t>
+            </a:r>
+            <a:endParaRPr lang="en-US" sz="1800" dirty="0"/>
+          </a:p>
+          <a:p>
+            <a:pPr marL="342900" indent="-342900">
+              <a:buSzPct val="100000"/>
+              <a:buChar char="•"/>
+            </a:pPr>
+            <a:r>
+              <a:rPr lang="en-US" sz="1800" dirty="0">
+                <a:solidFill>
+                  <a:srgbClr val="333333"/>
+                </a:solidFill>
+              </a:rPr>
+              <a:t>Lebih Defensif untuk meredam fluktuasi saat </a:t>
+            </a:r>
+            <a:pPr indent="0" marL="0">
+              <a:buNone/>
+            </a:pPr>
+            <a:r>
+              <a:rPr lang="en-US" sz="1800" b="1" dirty="0">
+                <a:solidFill>
+                  <a:srgbClr val="333333"/>
+                </a:solidFill>
+              </a:rPr>
+              <a:t>Crypto Winter</a:t>
+            </a:r>
+            <a:pPr indent="0" marL="0">
+              <a:buNone/>
+            </a:pPr>
+            <a:r>
+              <a:rPr lang="en-US" sz="1800" dirty="0">
+                <a:solidFill>
+                  <a:srgbClr val="333333"/>
+                </a:solidFill>
+              </a:rPr>
+              <a:t>.</a:t>
             </a:r>
             <a:endParaRPr lang="en-US" sz="1800" dirty="0"/>
           </a:p>
@@ -9881,7 +10103,7 @@
                   <a:srgbClr val="003366"/>
                 </a:solidFill>
               </a:rPr>
-              <a:t>Lampiran: Mengapa Menyertakan Tether (USDT)? (2/2)</a:t>
+              <a:t>Lampiran: Penanganan Data Kosong (Missing Values)</a:t>
             </a:r>
             <a:endParaRPr lang="en-US" sz="2600" dirty="0"/>
           </a:p>
@@ -9912,12 +10134,87 @@
               <a:buNone/>
             </a:pPr>
             <a:r>
+              <a:rPr lang="en-US" sz="1800" b="1" dirty="0">
+                <a:solidFill>
+                  <a:srgbClr val="C0392B"/>
+                </a:solidFill>
+              </a:rPr>
+              <a:t>Pertanyaan: </a:t>
+            </a:r>
+            <a:pPr indent="0" marL="0">
+              <a:buNone/>
+            </a:pPr>
+            <a:r>
+              <a:rPr lang="en-US" sz="1800" i="1" dirty="0">
+                <a:solidFill>
+                  <a:srgbClr val="333333"/>
+                </a:solidFill>
+              </a:rPr>
+              <a:t>"Beberapa koin seperti Binance/EOS belum rilis di awal 2017 sehingga datanya kosong. Bukankah backward-fill memalsukan harga dan merusak matriks?"</a:t>
+            </a:r>
+            <a:endParaRPr lang="en-US" sz="1800" dirty="0"/>
+          </a:p>
+          <a:p>
+            <a:pPr indent="0" marL="0">
+              <a:buNone/>
+            </a:pPr>
+            <a:r>
+              <a:rPr lang="en-US" sz="1800" b="1" dirty="0">
+                <a:solidFill>
+                  <a:srgbClr val="27AE60"/>
+                </a:solidFill>
+              </a:rPr>
+              <a:t>Jawaban (Kenapa RMT sangat Krusial):</a:t>
+            </a:r>
+            <a:endParaRPr lang="en-US" sz="1800" dirty="0"/>
+          </a:p>
+          <a:p>
+            <a:pPr indent="0" marL="0">
+              <a:buNone/>
+            </a:pPr>
+            <a:r>
               <a:rPr lang="en-US" sz="1800" dirty="0">
                 <a:solidFill>
                   <a:srgbClr val="333333"/>
                 </a:solidFill>
               </a:rPr>
-              <a:t>3. Algoritma jaringan </a:t>
+              <a:t>   1. Praktik pengisian data diam (</a:t>
+            </a:r>
+            <a:pPr indent="0" marL="0">
+              <a:buNone/>
+            </a:pPr>
+            <a:r>
+              <a:rPr lang="en-US" sz="1800" b="1" i="1" dirty="0">
+                <a:solidFill>
+                  <a:srgbClr val="333333"/>
+                </a:solidFill>
+              </a:rPr>
+              <a:t>backward fill</a:t>
+            </a:r>
+            <a:pPr indent="0" marL="0">
+              <a:buNone/>
+            </a:pPr>
+            <a:r>
+              <a:rPr lang="en-US" sz="1800" dirty="0">
+                <a:solidFill>
+                  <a:srgbClr val="333333"/>
+                </a:solidFill>
+              </a:rPr>
+              <a:t>) memang menciptakan rentetan nilai harga yang statis.</a:t>
+            </a:r>
+            <a:endParaRPr lang="en-US" sz="1800" dirty="0"/>
+          </a:p>
+          <a:p>
+            <a:pPr indent="0" marL="0">
+              <a:buNone/>
+            </a:pPr>
+            <a:r>
+              <a:rPr lang="en-US" sz="1800" dirty="0">
+                <a:solidFill>
+                  <a:srgbClr val="333333"/>
+                </a:solidFill>
+              </a:rPr>
+              <a:t>   2. Namun, kehebatan </a:t>
             </a:r>
             <a:pPr indent="0" marL="0">
               <a:buNone/>
@@ -9928,7 +10225,7 @@
                   <a:srgbClr val="333333"/>
                 </a:solidFill>
               </a:rPr>
-              <a:t>Network Markowitz (GS)</a:t>
+              <a:t>Random Matrix Theory (RMT)</a:t>
             </a:r>
             <a:pPr indent="0" marL="0">
               <a:buNone/>
@@ -9939,7 +10236,57 @@
                   <a:srgbClr val="333333"/>
                 </a:solidFill>
               </a:rPr>
-              <a:t> dilatih secara matematis; jika mendeteksi korelasi ancaman kolaps merambat ke semua altcoin, ia akan melempar alokasi modalnya menuju node </a:t>
+              <a:t> diuji di sini! Karena data yang datar sama sekali tidak punya korelasi nyata.</a:t>
+            </a:r>
+            <a:endParaRPr lang="en-US" sz="1800" dirty="0"/>
+          </a:p>
+          <a:p>
+            <a:pPr indent="0" marL="0">
+              <a:buNone/>
+            </a:pPr>
+            <a:r>
+              <a:rPr lang="en-US" sz="1800" dirty="0">
+                <a:solidFill>
+                  <a:srgbClr val="333333"/>
+                </a:solidFill>
+              </a:rPr>
+              <a:t>   3. RMT otomatis akan mendeteksi korelasi buatan tersebut sebagai probabilitas </a:t>
+            </a:r>
+            <a:pPr indent="0" marL="0">
+              <a:buNone/>
+            </a:pPr>
+            <a:r>
+              <a:rPr lang="en-US" sz="1800" b="1" i="1" dirty="0">
+                <a:solidFill>
+                  <a:srgbClr val="333333"/>
+                </a:solidFill>
+              </a:rPr>
+              <a:t>Noise Acak</a:t>
+            </a:r>
+            <a:pPr indent="0" marL="0">
+              <a:buNone/>
+            </a:pPr>
+            <a:r>
+              <a:rPr lang="en-US" sz="1800" dirty="0">
+                <a:solidFill>
+                  <a:srgbClr val="333333"/>
+                </a:solidFill>
+              </a:rPr>
+              <a:t>, lalu membuangnya menjadi 0.</a:t>
+            </a:r>
+            <a:endParaRPr lang="en-US" sz="1800" dirty="0"/>
+          </a:p>
+          <a:p>
+            <a:pPr indent="0" marL="0">
+              <a:buNone/>
+            </a:pPr>
+            <a:r>
+              <a:rPr lang="en-US" sz="1800" dirty="0">
+                <a:solidFill>
+                  <a:srgbClr val="333333"/>
+                </a:solidFill>
+              </a:rPr>
+              <a:t>   4. Hasilnya, matriks korelasi </a:t>
             </a:r>
             <a:pPr indent="0" marL="0">
               <a:buNone/>
@@ -9950,7 +10297,7 @@
                   <a:srgbClr val="333333"/>
                 </a:solidFill>
               </a:rPr>
-              <a:t>USDT</a:t>
+              <a:t>terselamatkan</a:t>
             </a:r>
             <a:pPr indent="0" marL="0">
               <a:buNone/>
@@ -9961,65 +10308,7 @@
                   <a:srgbClr val="333333"/>
                 </a:solidFill>
               </a:rPr>
-              <a:t> sebagai langkah </a:t>
-            </a:r>
-            <a:pPr indent="0" marL="0">
-              <a:buNone/>
-            </a:pPr>
-            <a:r>
-              <a:rPr lang="en-US" sz="1800" b="1" dirty="0">
-                <a:solidFill>
-                  <a:srgbClr val="333333"/>
-                </a:solidFill>
-              </a:rPr>
-              <a:t>evakuasi otomatis</a:t>
-            </a:r>
-            <a:pPr indent="0" marL="0">
-              <a:buNone/>
-            </a:pPr>
-            <a:r>
-              <a:rPr lang="en-US" sz="1800" dirty="0">
-                <a:solidFill>
-                  <a:srgbClr val="333333"/>
-                </a:solidFill>
-              </a:rPr>
-              <a:t> (Shock-Absorber).</a:t>
-            </a:r>
-            <a:endParaRPr lang="en-US" sz="1800" dirty="0"/>
-          </a:p>
-          <a:p>
-            <a:pPr indent="0" marL="0">
-              <a:buNone/>
-            </a:pPr>
-            <a:r>
-              <a:rPr lang="en-US" sz="1800" dirty="0">
-                <a:solidFill>
-                  <a:srgbClr val="333333"/>
-                </a:solidFill>
-              </a:rPr>
-              <a:t>   4. Hal ini yang membuat performa Risk-GS sangat </a:t>
-            </a:r>
-            <a:pPr indent="0" marL="0">
-              <a:buNone/>
-            </a:pPr>
-            <a:r>
-              <a:rPr lang="en-US" sz="1800" b="1" dirty="0">
-                <a:solidFill>
-                  <a:srgbClr val="333333"/>
-                </a:solidFill>
-              </a:rPr>
-              <a:t>tangguh</a:t>
-            </a:r>
-            <a:pPr indent="0" marL="0">
-              <a:buNone/>
-            </a:pPr>
-            <a:r>
-              <a:rPr lang="en-US" sz="1800" dirty="0">
-                <a:solidFill>
-                  <a:srgbClr val="333333"/>
-                </a:solidFill>
-              </a:rPr>
-              <a:t> dari serangan Crypto Winter, suatu kapabilitas pertahanan yang tidak dipahami oleh model ortodoks murni Markowitz.</a:t>
+              <a:t> dan tidak tercemar oleh cacat kelengkapan data.</a:t>
             </a:r>
             <a:endParaRPr lang="en-US" sz="1800" dirty="0"/>
           </a:p>
@@ -10080,7 +10369,7 @@
                   <a:srgbClr val="003366"/>
                 </a:solidFill>
               </a:rPr>
-              <a:t>Lampiran: Bukti Empiris Non-Stationarity Pasar</a:t>
+              <a:t>Lampiran: Mengapa Menyertakan Tether (USDT)? (1/2)</a:t>
             </a:r>
             <a:endParaRPr lang="en-US" sz="2600" dirty="0"/>
           </a:p>
@@ -10116,7 +10405,7 @@
                   <a:srgbClr val="C0392B"/>
                 </a:solidFill>
               </a:rPr>
-              <a:t>Masalah: </a:t>
+              <a:t>Pertanyaan: </a:t>
             </a:r>
             <a:pPr indent="0" marL="0">
               <a:buNone/>
@@ -10127,7 +10416,7 @@
                   <a:srgbClr val="333333"/>
                 </a:solidFill>
               </a:rPr>
-              <a:t>Kenapa harus menggunakan model Adaptif (Dynamic Gamma)?</a:t>
+              <a:t>"Tether (USDT) itu stablecoin yang nilainya selalu fix ke 1 USD. Apakah tidak berbuat curang?"</a:t>
             </a:r>
             <a:endParaRPr lang="en-US" sz="1800" dirty="0"/>
           </a:p>
@@ -10141,7 +10430,7 @@
                   <a:srgbClr val="27AE60"/>
                 </a:solidFill>
               </a:rPr>
-              <a:t>Bukti dari Grid Search:</a:t>
+              <a:t>Jawaban (Dinamika Portofolio Cerdas):</a:t>
             </a:r>
             <a:endParaRPr lang="en-US" sz="1800" dirty="0"/>
           </a:p>
@@ -10156,18 +10445,18 @@
                   <a:srgbClr val="333333"/>
                 </a:solidFill>
               </a:rPr>
-              <a:t>Data menunjukkan nilai Gamma (γ) optimal </a:t>
-            </a:r>
-            <a:pPr indent="0" marL="0">
-              <a:buNone/>
-            </a:pPr>
-            <a:r>
-              <a:rPr lang="en-US" sz="1800" b="1" dirty="0">
-                <a:solidFill>
-                  <a:srgbClr val="333333"/>
-                </a:solidFill>
-              </a:rPr>
-              <a:t>terus bergeser</a:t>
+              <a:t>Model ini mensimulasikan perilaku </a:t>
+            </a:r>
+            <a:pPr indent="0" marL="0">
+              <a:buNone/>
+            </a:pPr>
+            <a:r>
+              <a:rPr lang="en-US" sz="1800" b="1" i="1" dirty="0">
+                <a:solidFill>
+                  <a:srgbClr val="333333"/>
+                </a:solidFill>
+              </a:rPr>
+              <a:t>Robo-Advisory</a:t>
             </a:r>
             <a:pPr indent="0" marL="0">
               <a:buNone/>
@@ -10178,7 +10467,7 @@
                   <a:srgbClr val="333333"/>
                 </a:solidFill>
               </a:rPr>
-              <a:t> setiap periode rebalancing.</a:t>
+              <a:t> institusional.</a:t>
             </a:r>
             <a:endParaRPr lang="en-US" sz="1800" dirty="0"/>
           </a:p>
@@ -10193,7 +10482,7 @@
                   <a:srgbClr val="333333"/>
                 </a:solidFill>
               </a:rPr>
-              <a:t>Penggunaan γ statis tidak cukup untuk menangkap perubahan </a:t>
+              <a:t>Ketika pasar anjlok ekstrem, investor akan melarikan senjatanya ke posisi </a:t>
             </a:r>
             <a:pPr indent="0" marL="0">
               <a:buNone/>
@@ -10204,7 +10493,7 @@
                   <a:srgbClr val="333333"/>
                 </a:solidFill>
               </a:rPr>
-              <a:t>struktur korelasi</a:t>
+              <a:t>tunai (USDT)</a:t>
             </a:r>
             <a:pPr indent="0" marL="0">
               <a:buNone/>
@@ -10215,44 +10504,7 @@
                   <a:srgbClr val="333333"/>
                 </a:solidFill>
               </a:rPr>
-              <a:t> yang sangat cepat di pasar kripto.</a:t>
-            </a:r>
-            <a:endParaRPr lang="en-US" sz="1800" dirty="0"/>
-          </a:p>
-          <a:p>
-            <a:pPr marL="342900" indent="-342900">
-              <a:buSzPct val="100000"/>
-              <a:buChar char="•"/>
-            </a:pPr>
-            <a:r>
-              <a:rPr lang="en-US" sz="1800" dirty="0">
-                <a:solidFill>
-                  <a:srgbClr val="333333"/>
-                </a:solidFill>
-              </a:rPr>
-              <a:t>Ini membenarkan bahwa pasar kripto membutuhkan </a:t>
-            </a:r>
-            <a:pPr indent="0" marL="0">
-              <a:buNone/>
-            </a:pPr>
-            <a:r>
-              <a:rPr lang="en-US" sz="1800" b="1" dirty="0">
-                <a:solidFill>
-                  <a:srgbClr val="333333"/>
-                </a:solidFill>
-              </a:rPr>
-              <a:t>kalibrasi otomatis</a:t>
-            </a:r>
-            <a:pPr indent="0" marL="0">
-              <a:buNone/>
-            </a:pPr>
-            <a:r>
-              <a:rPr lang="en-US" sz="1800" dirty="0">
-                <a:solidFill>
-                  <a:srgbClr val="333333"/>
-                </a:solidFill>
-              </a:rPr>
-              <a:t> secara temporal.</a:t>
+              <a:t> sebagai evakuasi risiko.</a:t>
             </a:r>
             <a:endParaRPr lang="en-US" sz="1800" dirty="0"/>
           </a:p>
@@ -10313,7 +10565,7 @@
                   <a:srgbClr val="003366"/>
                 </a:solidFill>
               </a:rPr>
-              <a:t>Lampiran: Jaringan sebagai 'Shock-Absorber'</a:t>
+              <a:t>Lampiran: Mengapa Menyertakan Tether (USDT)? (2/2)</a:t>
             </a:r>
             <a:endParaRPr lang="en-US" sz="2600" dirty="0"/>
           </a:p>
@@ -10344,12 +10596,236 @@
               <a:buNone/>
             </a:pPr>
             <a:r>
+              <a:rPr lang="en-US" sz="1800" dirty="0">
+                <a:solidFill>
+                  <a:srgbClr val="333333"/>
+                </a:solidFill>
+              </a:rPr>
+              <a:t>3. Algoritma jaringan </a:t>
+            </a:r>
+            <a:pPr indent="0" marL="0">
+              <a:buNone/>
+            </a:pPr>
+            <a:r>
               <a:rPr lang="en-US" sz="1800" b="1" dirty="0">
                 <a:solidFill>
+                  <a:srgbClr val="333333"/>
+                </a:solidFill>
+              </a:rPr>
+              <a:t>Network Markowitz GS (Grid Search)</a:t>
+            </a:r>
+            <a:pPr indent="0" marL="0">
+              <a:buNone/>
+            </a:pPr>
+            <a:r>
+              <a:rPr lang="en-US" sz="1800" dirty="0">
+                <a:solidFill>
+                  <a:srgbClr val="333333"/>
+                </a:solidFill>
+              </a:rPr>
+              <a:t> dilatih secara matematis; jika mendeteksi korelasi ancaman kolaps merambat ke semua altcoin, ia akan melempar alokasi modalnya menuju node </a:t>
+            </a:r>
+            <a:pPr indent="0" marL="0">
+              <a:buNone/>
+            </a:pPr>
+            <a:r>
+              <a:rPr lang="en-US" sz="1800" b="1" dirty="0">
+                <a:solidFill>
+                  <a:srgbClr val="333333"/>
+                </a:solidFill>
+              </a:rPr>
+              <a:t>USDT (Tether)</a:t>
+            </a:r>
+            <a:pPr indent="0" marL="0">
+              <a:buNone/>
+            </a:pPr>
+            <a:r>
+              <a:rPr lang="en-US" sz="1800" dirty="0">
+                <a:solidFill>
+                  <a:srgbClr val="333333"/>
+                </a:solidFill>
+              </a:rPr>
+              <a:t> sebagai langkah </a:t>
+            </a:r>
+            <a:pPr indent="0" marL="0">
+              <a:buNone/>
+            </a:pPr>
+            <a:r>
+              <a:rPr lang="en-US" sz="1800" b="1" dirty="0">
+                <a:solidFill>
+                  <a:srgbClr val="333333"/>
+                </a:solidFill>
+              </a:rPr>
+              <a:t>evakuasi otomatis</a:t>
+            </a:r>
+            <a:pPr indent="0" marL="0">
+              <a:buNone/>
+            </a:pPr>
+            <a:r>
+              <a:rPr lang="en-US" sz="1800" dirty="0">
+                <a:solidFill>
+                  <a:srgbClr val="333333"/>
+                </a:solidFill>
+              </a:rPr>
+              <a:t> (Shock-Absorber).</a:t>
+            </a:r>
+            <a:endParaRPr lang="en-US" sz="1800" dirty="0"/>
+          </a:p>
+          <a:p>
+            <a:pPr indent="0" marL="0">
+              <a:buNone/>
+            </a:pPr>
+            <a:r>
+              <a:rPr lang="en-US" sz="1800" dirty="0">
+                <a:solidFill>
+                  <a:srgbClr val="333333"/>
+                </a:solidFill>
+              </a:rPr>
+              <a:t>   4. Hal ini yang membuat performa Risk-GS (Grid Search) sangat </a:t>
+            </a:r>
+            <a:pPr indent="0" marL="0">
+              <a:buNone/>
+            </a:pPr>
+            <a:r>
+              <a:rPr lang="en-US" sz="1800" b="1" dirty="0">
+                <a:solidFill>
+                  <a:srgbClr val="333333"/>
+                </a:solidFill>
+              </a:rPr>
+              <a:t>tangguh</a:t>
+            </a:r>
+            <a:pPr indent="0" marL="0">
+              <a:buNone/>
+            </a:pPr>
+            <a:r>
+              <a:rPr lang="en-US" sz="1800" dirty="0">
+                <a:solidFill>
+                  <a:srgbClr val="333333"/>
+                </a:solidFill>
+              </a:rPr>
+              <a:t> dari serangan Crypto Winter, suatu kapabilitas pertahanan yang tidak dipahami oleh model ortodoks murni Markowitz.</a:t>
+            </a:r>
+            <a:endParaRPr lang="en-US" sz="1800" dirty="0"/>
+          </a:p>
+        </p:txBody>
+      </p:sp>
+    </p:spTree>
+  </p:cSld>
+  <p:clrMapOvr>
+    <a:masterClrMapping/>
+  </p:clrMapOvr>
+</p:sld>
+</file>
+
+<file path=ppt/slides/slide34.xml><?xml version="1.0" encoding="utf-8"?>
+<p:sld xmlns:a="http://schemas.openxmlformats.org/drawingml/2006/main" xmlns:r="http://schemas.openxmlformats.org/officeDocument/2006/relationships" xmlns:p="http://schemas.openxmlformats.org/presentationml/2006/main">
+  <p:cSld name="Slide 34">
+    <p:spTree>
+      <p:nvGrpSpPr>
+        <p:cNvPr id="1" name=""/>
+        <p:cNvGrpSpPr/>
+        <p:nvPr/>
+      </p:nvGrpSpPr>
+      <p:grpSpPr>
+        <a:xfrm>
+          <a:off x="0" y="0"/>
+          <a:ext cx="0" cy="0"/>
+          <a:chOff x="0" y="0"/>
+          <a:chExt cx="0" cy="0"/>
+        </a:xfrm>
+      </p:grpSpPr>
+      <p:sp>
+        <p:nvSpPr>
+          <p:cNvPr id="2" name="Text 0"/>
+          <p:cNvSpPr/>
+          <p:nvPr/>
+        </p:nvSpPr>
+        <p:spPr>
+          <a:xfrm>
+            <a:off x="457200" y="457200"/>
+            <a:ext cx="8229600" cy="0"/>
+          </a:xfrm>
+          <a:prstGeom prst="rect">
+            <a:avLst/>
+          </a:prstGeom>
+          <a:noFill/>
+          <a:ln/>
+        </p:spPr>
+        <p:txBody>
+          <a:bodyPr wrap="square" rtlCol="0" anchor="ctr"/>
+          <a:lstStyle/>
+          <a:p>
+            <a:pPr indent="0" marL="0">
+              <a:buNone/>
+            </a:pPr>
+            <a:r>
+              <a:rPr lang="en-US" sz="2600" b="1" dirty="0">
+                <a:solidFill>
+                  <a:srgbClr val="003366"/>
+                </a:solidFill>
+              </a:rPr>
+              <a:t>Lampiran: Bukti Empiris Non-Stationarity Pasar</a:t>
+            </a:r>
+            <a:endParaRPr lang="en-US" sz="2600" dirty="0"/>
+          </a:p>
+        </p:txBody>
+      </p:sp>
+      <p:sp>
+        <p:nvSpPr>
+          <p:cNvPr id="3" name="Text 1"/>
+          <p:cNvSpPr/>
+          <p:nvPr/>
+        </p:nvSpPr>
+        <p:spPr>
+          <a:xfrm>
+            <a:off x="457200" y="1005840"/>
+            <a:ext cx="8229600" cy="5029200"/>
+          </a:xfrm>
+          <a:prstGeom prst="rect">
+            <a:avLst/>
+          </a:prstGeom>
+          <a:noFill/>
+          <a:ln/>
+        </p:spPr>
+        <p:txBody>
+          <a:bodyPr wrap="square" rtlCol="0" anchor="t"/>
+          <a:lstStyle/>
+          <a:p>
+            <a:pPr indent="0" marL="0">
+              <a:buNone/>
+            </a:pPr>
+            <a:r>
+              <a:rPr lang="en-US" sz="1800" b="1" dirty="0">
+                <a:solidFill>
+                  <a:srgbClr val="C0392B"/>
+                </a:solidFill>
+              </a:rPr>
+              <a:t>Masalah: </a:t>
+            </a:r>
+            <a:pPr indent="0" marL="0">
+              <a:buNone/>
+            </a:pPr>
+            <a:r>
+              <a:rPr lang="en-US" sz="1800" i="1" dirty="0">
+                <a:solidFill>
+                  <a:srgbClr val="333333"/>
+                </a:solidFill>
+              </a:rPr>
+              <a:t>Kenapa harus menggunakan model Adaptif (Dynamic Gamma)?</a:t>
+            </a:r>
+            <a:endParaRPr lang="en-US" sz="1800" dirty="0"/>
+          </a:p>
+          <a:p>
+            <a:pPr indent="0" marL="0">
+              <a:buNone/>
+            </a:pPr>
+            <a:r>
+              <a:rPr lang="en-US" sz="1800" b="1" dirty="0">
+                <a:solidFill>
                   <a:srgbClr val="27AE60"/>
                 </a:solidFill>
               </a:rPr>
-              <a:t>Konsep Teoritis:</a:t>
+              <a:t>Bukti dari Grid Search:</a:t>
             </a:r>
             <a:endParaRPr lang="en-US" sz="1800" dirty="0"/>
           </a:p>
@@ -10364,7 +10840,7 @@
                   <a:srgbClr val="333333"/>
                 </a:solidFill>
               </a:rPr>
-              <a:t>Eigenvector Centrality mengidentifikasi koin yang menjadi </a:t>
+              <a:t>Data menunjukkan nilai Gamma (γ) optimal </a:t>
             </a:r>
             <a:pPr indent="0" marL="0">
               <a:buNone/>
@@ -10375,7 +10851,7 @@
                   <a:srgbClr val="333333"/>
                 </a:solidFill>
               </a:rPr>
-              <a:t>hub risiko</a:t>
+              <a:t>terus bergeser</a:t>
             </a:r>
             <a:pPr indent="0" marL="0">
               <a:buNone/>
@@ -10386,7 +10862,7 @@
                   <a:srgbClr val="333333"/>
                 </a:solidFill>
               </a:rPr>
-              <a:t>.</a:t>
+              <a:t> setiap periode rebalancing.</a:t>
             </a:r>
             <a:endParaRPr lang="en-US" sz="1800" dirty="0"/>
           </a:p>
@@ -10401,7 +10877,7 @@
                   <a:srgbClr val="333333"/>
                 </a:solidFill>
               </a:rPr>
-              <a:t>Penalti Gamma memaksa portofolio </a:t>
+              <a:t>Penggunaan γ statis tidak cukup untuk menangkap perubahan </a:t>
             </a:r>
             <a:pPr indent="0" marL="0">
               <a:buNone/>
@@ -10412,7 +10888,7 @@
                   <a:srgbClr val="333333"/>
                 </a:solidFill>
               </a:rPr>
-              <a:t>menjauhi aset</a:t>
+              <a:t>struktur korelasi</a:t>
             </a:r>
             <a:pPr indent="0" marL="0">
               <a:buNone/>
@@ -10423,7 +10899,7 @@
                   <a:srgbClr val="333333"/>
                 </a:solidFill>
               </a:rPr>
-              <a:t> yang terlalu dominan secara sistemik saat volatilitas tinggi.</a:t>
+              <a:t> yang sangat cepat di pasar kripto.</a:t>
             </a:r>
             <a:endParaRPr lang="en-US" sz="1800" dirty="0"/>
           </a:p>
@@ -10438,6 +10914,214 @@
                   <a:srgbClr val="333333"/>
                 </a:solidFill>
               </a:rPr>
+              <a:t>Ini membenarkan bahwa pasar kripto membutuhkan </a:t>
+            </a:r>
+            <a:pPr indent="0" marL="0">
+              <a:buNone/>
+            </a:pPr>
+            <a:r>
+              <a:rPr lang="en-US" sz="1800" b="1" dirty="0">
+                <a:solidFill>
+                  <a:srgbClr val="333333"/>
+                </a:solidFill>
+              </a:rPr>
+              <a:t>kalibrasi otomatis</a:t>
+            </a:r>
+            <a:pPr indent="0" marL="0">
+              <a:buNone/>
+            </a:pPr>
+            <a:r>
+              <a:rPr lang="en-US" sz="1800" dirty="0">
+                <a:solidFill>
+                  <a:srgbClr val="333333"/>
+                </a:solidFill>
+              </a:rPr>
+              <a:t> secara temporal.</a:t>
+            </a:r>
+            <a:endParaRPr lang="en-US" sz="1800" dirty="0"/>
+          </a:p>
+        </p:txBody>
+      </p:sp>
+    </p:spTree>
+  </p:cSld>
+  <p:clrMapOvr>
+    <a:masterClrMapping/>
+  </p:clrMapOvr>
+</p:sld>
+</file>
+
+<file path=ppt/slides/slide35.xml><?xml version="1.0" encoding="utf-8"?>
+<p:sld xmlns:a="http://schemas.openxmlformats.org/drawingml/2006/main" xmlns:r="http://schemas.openxmlformats.org/officeDocument/2006/relationships" xmlns:p="http://schemas.openxmlformats.org/presentationml/2006/main">
+  <p:cSld name="Slide 35">
+    <p:spTree>
+      <p:nvGrpSpPr>
+        <p:cNvPr id="1" name=""/>
+        <p:cNvGrpSpPr/>
+        <p:nvPr/>
+      </p:nvGrpSpPr>
+      <p:grpSpPr>
+        <a:xfrm>
+          <a:off x="0" y="0"/>
+          <a:ext cx="0" cy="0"/>
+          <a:chOff x="0" y="0"/>
+          <a:chExt cx="0" cy="0"/>
+        </a:xfrm>
+      </p:grpSpPr>
+      <p:sp>
+        <p:nvSpPr>
+          <p:cNvPr id="2" name="Text 0"/>
+          <p:cNvSpPr/>
+          <p:nvPr/>
+        </p:nvSpPr>
+        <p:spPr>
+          <a:xfrm>
+            <a:off x="457200" y="457200"/>
+            <a:ext cx="8229600" cy="0"/>
+          </a:xfrm>
+          <a:prstGeom prst="rect">
+            <a:avLst/>
+          </a:prstGeom>
+          <a:noFill/>
+          <a:ln/>
+        </p:spPr>
+        <p:txBody>
+          <a:bodyPr wrap="square" rtlCol="0" anchor="ctr"/>
+          <a:lstStyle/>
+          <a:p>
+            <a:pPr indent="0" marL="0">
+              <a:buNone/>
+            </a:pPr>
+            <a:r>
+              <a:rPr lang="en-US" sz="2600" b="1" dirty="0">
+                <a:solidFill>
+                  <a:srgbClr val="003366"/>
+                </a:solidFill>
+              </a:rPr>
+              <a:t>Lampiran: Jaringan sebagai 'Shock-Absorber'</a:t>
+            </a:r>
+            <a:endParaRPr lang="en-US" sz="2600" dirty="0"/>
+          </a:p>
+        </p:txBody>
+      </p:sp>
+      <p:sp>
+        <p:nvSpPr>
+          <p:cNvPr id="3" name="Text 1"/>
+          <p:cNvSpPr/>
+          <p:nvPr/>
+        </p:nvSpPr>
+        <p:spPr>
+          <a:xfrm>
+            <a:off x="457200" y="1005840"/>
+            <a:ext cx="8229600" cy="5029200"/>
+          </a:xfrm>
+          <a:prstGeom prst="rect">
+            <a:avLst/>
+          </a:prstGeom>
+          <a:noFill/>
+          <a:ln/>
+        </p:spPr>
+        <p:txBody>
+          <a:bodyPr wrap="square" rtlCol="0" anchor="t"/>
+          <a:lstStyle/>
+          <a:p>
+            <a:pPr indent="0" marL="0">
+              <a:buNone/>
+            </a:pPr>
+            <a:r>
+              <a:rPr lang="en-US" sz="1800" b="1" dirty="0">
+                <a:solidFill>
+                  <a:srgbClr val="27AE60"/>
+                </a:solidFill>
+              </a:rPr>
+              <a:t>Konsep Teoritis:</a:t>
+            </a:r>
+            <a:endParaRPr lang="en-US" sz="1800" dirty="0"/>
+          </a:p>
+          <a:p>
+            <a:pPr marL="342900" indent="-342900">
+              <a:buSzPct val="100000"/>
+              <a:buChar char="•"/>
+            </a:pPr>
+            <a:r>
+              <a:rPr lang="en-US" sz="1800" dirty="0">
+                <a:solidFill>
+                  <a:srgbClr val="333333"/>
+                </a:solidFill>
+              </a:rPr>
+              <a:t>Eigenvector Centrality mengidentifikasi koin yang menjadi </a:t>
+            </a:r>
+            <a:pPr indent="0" marL="0">
+              <a:buNone/>
+            </a:pPr>
+            <a:r>
+              <a:rPr lang="en-US" sz="1800" b="1" dirty="0">
+                <a:solidFill>
+                  <a:srgbClr val="333333"/>
+                </a:solidFill>
+              </a:rPr>
+              <a:t>hub risiko</a:t>
+            </a:r>
+            <a:pPr indent="0" marL="0">
+              <a:buNone/>
+            </a:pPr>
+            <a:r>
+              <a:rPr lang="en-US" sz="1800" dirty="0">
+                <a:solidFill>
+                  <a:srgbClr val="333333"/>
+                </a:solidFill>
+              </a:rPr>
+              <a:t>.</a:t>
+            </a:r>
+            <a:endParaRPr lang="en-US" sz="1800" dirty="0"/>
+          </a:p>
+          <a:p>
+            <a:pPr marL="342900" indent="-342900">
+              <a:buSzPct val="100000"/>
+              <a:buChar char="•"/>
+            </a:pPr>
+            <a:r>
+              <a:rPr lang="en-US" sz="1800" dirty="0">
+                <a:solidFill>
+                  <a:srgbClr val="333333"/>
+                </a:solidFill>
+              </a:rPr>
+              <a:t>Penalti Gamma memaksa portofolio </a:t>
+            </a:r>
+            <a:pPr indent="0" marL="0">
+              <a:buNone/>
+            </a:pPr>
+            <a:r>
+              <a:rPr lang="en-US" sz="1800" b="1" dirty="0">
+                <a:solidFill>
+                  <a:srgbClr val="333333"/>
+                </a:solidFill>
+              </a:rPr>
+              <a:t>menjauhi aset</a:t>
+            </a:r>
+            <a:pPr indent="0" marL="0">
+              <a:buNone/>
+            </a:pPr>
+            <a:r>
+              <a:rPr lang="en-US" sz="1800" dirty="0">
+                <a:solidFill>
+                  <a:srgbClr val="333333"/>
+                </a:solidFill>
+              </a:rPr>
+              <a:t> yang terlalu dominan secara sistemik saat volatilitas tinggi.</a:t>
+            </a:r>
+            <a:endParaRPr lang="en-US" sz="1800" dirty="0"/>
+          </a:p>
+          <a:p>
+            <a:pPr marL="342900" indent="-342900">
+              <a:buSzPct val="100000"/>
+              <a:buChar char="•"/>
+            </a:pPr>
+            <a:r>
+              <a:rPr lang="en-US" sz="1800" dirty="0">
+                <a:solidFill>
+                  <a:srgbClr val="333333"/>
+                </a:solidFill>
+              </a:rPr>
               <a:t>Hasil pada </a:t>
             </a:r>
             <a:pPr indent="0" marL="0">
@@ -10460,7 +11144,7 @@
                   <a:srgbClr val="333333"/>
                 </a:solidFill>
               </a:rPr>
-              <a:t> membuktikan bahwa saat crash, distribusi kerugian ekor model NW jauh lebih terjaga.</a:t>
+              <a:t> membuktikan bahwa saat crash, distribusi kerugian ekor model NW (Network Markowitz) jauh lebih terjaga.</a:t>
             </a:r>
             <a:endParaRPr lang="en-US" sz="1800" dirty="0"/>
           </a:p>
@@ -10572,8 +11256,8 @@
         </p:nvSpPr>
         <p:spPr>
           <a:xfrm>
-            <a:off x="457200" y="1005840"/>
-            <a:ext cx="8229600" cy="4572000"/>
+            <a:off x="457200" y="1097280"/>
+            <a:ext cx="4114800" cy="3657600"/>
           </a:xfrm>
           <a:prstGeom prst="rect">
             <a:avLst/>
@@ -10589,21 +11273,21 @@
               <a:buNone/>
             </a:pPr>
             <a:r>
-              <a:rPr lang="en-US" sz="1350" b="1" dirty="0">
-                <a:solidFill>
-                  <a:srgbClr val="333333"/>
+              <a:rPr lang="en-US" sz="2000" b="1" dirty="0">
+                <a:solidFill>
+                  <a:srgbClr val="003366"/>
                 </a:solidFill>
               </a:rPr>
               <a:t>Tinjauan Portofolio &amp; Risiko:</a:t>
             </a:r>
-            <a:endParaRPr lang="en-US" sz="1350" dirty="0"/>
-          </a:p>
-          <a:p>
-            <a:pPr indent="0" marL="0">
-              <a:buNone/>
-            </a:pPr>
-            <a:r>
-              <a:rPr lang="en-US" sz="1350" dirty="0">
+            <a:endParaRPr lang="en-US" sz="2000" dirty="0"/>
+          </a:p>
+          <a:p>
+            <a:pPr indent="0" marL="0">
+              <a:buNone/>
+            </a:pPr>
+            <a:r>
+              <a:rPr lang="en-US" sz="2000" dirty="0">
                 <a:solidFill>
                   <a:srgbClr val="333333"/>
                 </a:solidFill>
@@ -10614,7 +11298,7 @@
               <a:buNone/>
             </a:pPr>
             <a:r>
-              <a:rPr lang="en-US" sz="1350" u="sng" dirty="0">
+              <a:rPr lang="en-US" sz="2000" b="1" u="sng" dirty="0">
                 <a:solidFill>
                   <a:srgbClr val="333333"/>
                 </a:solidFill>
@@ -10625,43 +11309,21 @@
               <a:buNone/>
             </a:pPr>
             <a:r>
-              <a:rPr lang="en-US" sz="1350" dirty="0">
-                <a:solidFill>
-                  <a:srgbClr val="333333"/>
-                </a:solidFill>
-              </a:rPr>
-              <a:t>: Kumpulan aset finansial yang dikelola bersama untuk mengoptimalkan </a:t>
-            </a:r>
-            <a:pPr indent="0" marL="0">
-              <a:buNone/>
-            </a:pPr>
-            <a:r>
-              <a:rPr lang="en-US" sz="1350" b="1" dirty="0">
-                <a:solidFill>
-                  <a:srgbClr val="333333"/>
-                </a:solidFill>
-              </a:rPr>
-              <a:t>profil risiko-imbal hasil</a:t>
-            </a:r>
-            <a:pPr indent="0" marL="0">
-              <a:buNone/>
-            </a:pPr>
-            <a:r>
-              <a:rPr lang="en-US" sz="1350" dirty="0">
-                <a:solidFill>
-                  <a:srgbClr val="333333"/>
-                </a:solidFill>
-              </a:rPr>
-              <a:t> melalui diversifikasi.</a:t>
-            </a:r>
-            <a:endParaRPr lang="en-US" sz="1350" dirty="0"/>
-          </a:p>
-          <a:p>
-            <a:pPr indent="0" marL="0">
-              <a:buNone/>
-            </a:pPr>
-            <a:r>
-              <a:rPr lang="en-US" sz="1350" dirty="0">
+              <a:rPr lang="en-US" sz="2000" dirty="0">
+                <a:solidFill>
+                  <a:srgbClr val="333333"/>
+                </a:solidFill>
+              </a:rPr>
+              <a:t>: Diversifikasi aset untuk optimasi return-risiko.</a:t>
+            </a:r>
+            <a:endParaRPr lang="en-US" sz="2000" dirty="0"/>
+          </a:p>
+          <a:p>
+            <a:pPr indent="0" marL="0">
+              <a:buNone/>
+            </a:pPr>
+            <a:r>
+              <a:rPr lang="en-US" sz="2000" dirty="0">
                 <a:solidFill>
                   <a:srgbClr val="333333"/>
                 </a:solidFill>
@@ -10672,7 +11334,7 @@
               <a:buNone/>
             </a:pPr>
             <a:r>
-              <a:rPr lang="en-US" sz="1350" u="sng" dirty="0">
+              <a:rPr lang="en-US" sz="2000" b="1" u="sng" dirty="0">
                 <a:solidFill>
                   <a:srgbClr val="333333"/>
                 </a:solidFill>
@@ -10683,65 +11345,21 @@
               <a:buNone/>
             </a:pPr>
             <a:r>
-              <a:rPr lang="en-US" sz="1350" dirty="0">
-                <a:solidFill>
-                  <a:srgbClr val="333333"/>
-                </a:solidFill>
-              </a:rPr>
-              <a:t>: Alat statistik pemetaan </a:t>
-            </a:r>
-            <a:pPr indent="0" marL="0">
-              <a:buNone/>
-            </a:pPr>
-            <a:r>
-              <a:rPr lang="en-US" sz="1350" b="1" dirty="0">
-                <a:solidFill>
-                  <a:srgbClr val="333333"/>
-                </a:solidFill>
-              </a:rPr>
-              <a:t>fluktuasi harga</a:t>
-            </a:r>
-            <a:pPr indent="0" marL="0">
-              <a:buNone/>
-            </a:pPr>
-            <a:r>
-              <a:rPr lang="en-US" sz="1350" dirty="0">
-                <a:solidFill>
-                  <a:srgbClr val="333333"/>
-                </a:solidFill>
-              </a:rPr>
-              <a:t> yang menjadi basis penentuan </a:t>
-            </a:r>
-            <a:pPr indent="0" marL="0">
-              <a:buNone/>
-            </a:pPr>
-            <a:r>
-              <a:rPr lang="en-US" sz="1350" b="1" dirty="0">
-                <a:solidFill>
-                  <a:srgbClr val="333333"/>
-                </a:solidFill>
-              </a:rPr>
-              <a:t>tingkat risiko</a:t>
-            </a:r>
-            <a:pPr indent="0" marL="0">
-              <a:buNone/>
-            </a:pPr>
-            <a:r>
-              <a:rPr lang="en-US" sz="1350" dirty="0">
-                <a:solidFill>
-                  <a:srgbClr val="333333"/>
-                </a:solidFill>
-              </a:rPr>
-              <a:t> pasar.</a:t>
-            </a:r>
-            <a:endParaRPr lang="en-US" sz="1350" dirty="0"/>
-          </a:p>
-          <a:p>
-            <a:pPr indent="0" marL="0">
-              <a:buNone/>
-            </a:pPr>
-            <a:r>
-              <a:rPr lang="en-US" sz="1350" dirty="0">
+              <a:rPr lang="en-US" sz="2000" dirty="0">
+                <a:solidFill>
+                  <a:srgbClr val="333333"/>
+                </a:solidFill>
+              </a:rPr>
+              <a:t>: Ukuran fluktuasi harga pasar.</a:t>
+            </a:r>
+            <a:endParaRPr lang="en-US" sz="2000" dirty="0"/>
+          </a:p>
+          <a:p>
+            <a:pPr indent="0" marL="0">
+              <a:buNone/>
+            </a:pPr>
+            <a:r>
+              <a:rPr lang="en-US" sz="2000" dirty="0">
                 <a:solidFill>
                   <a:srgbClr val="333333"/>
                 </a:solidFill>
@@ -10752,96 +11370,68 @@
               <a:buNone/>
             </a:pPr>
             <a:r>
-              <a:rPr lang="en-US" sz="1350" u="sng" dirty="0">
-                <a:solidFill>
-                  <a:srgbClr val="333333"/>
-                </a:solidFill>
-              </a:rPr>
-              <a:t>Matriks</a:t>
-            </a:r>
-            <a:pPr indent="0" marL="0">
-              <a:buNone/>
-            </a:pPr>
-            <a:r>
-              <a:rPr lang="en-US" sz="1350" dirty="0">
-                <a:solidFill>
-                  <a:srgbClr val="333333"/>
-                </a:solidFill>
-              </a:rPr>
-              <a:t> Kovarians: Alat matematis yang mengukur arah </a:t>
-            </a:r>
-            <a:pPr indent="0" marL="0">
-              <a:buNone/>
-            </a:pPr>
-            <a:r>
-              <a:rPr lang="en-US" sz="1350" b="1" dirty="0">
-                <a:solidFill>
-                  <a:srgbClr val="333333"/>
-                </a:solidFill>
-              </a:rPr>
-              <a:t>pergerakan bersama</a:t>
-            </a:r>
-            <a:pPr indent="0" marL="0">
-              <a:buNone/>
-            </a:pPr>
-            <a:r>
-              <a:rPr lang="en-US" sz="1350" dirty="0">
-                <a:solidFill>
-                  <a:srgbClr val="333333"/>
-                </a:solidFill>
-              </a:rPr>
-              <a:t> (korelasi) serta </a:t>
-            </a:r>
-            <a:pPr indent="0" marL="0">
-              <a:buNone/>
-            </a:pPr>
-            <a:r>
-              <a:rPr lang="en-US" sz="1350" b="1" dirty="0">
-                <a:solidFill>
-                  <a:srgbClr val="333333"/>
-                </a:solidFill>
-              </a:rPr>
-              <a:t>tingkat fluktuasi</a:t>
-            </a:r>
-            <a:pPr indent="0" marL="0">
-              <a:buNone/>
-            </a:pPr>
-            <a:r>
-              <a:rPr lang="en-US" sz="1350" dirty="0">
-                <a:solidFill>
-                  <a:srgbClr val="333333"/>
-                </a:solidFill>
-              </a:rPr>
-              <a:t> seluruh aset dalam portofolio.</a:t>
-            </a:r>
-            <a:endParaRPr lang="en-US" sz="1350" dirty="0"/>
-          </a:p>
-          <a:p>
-            <a:pPr indent="0" marL="0">
-              <a:buNone/>
-            </a:pPr>
-            <a:endParaRPr lang="en-US" sz="1350" dirty="0"/>
-          </a:p>
-          <a:p>
-            <a:pPr indent="0" marL="0">
-              <a:buNone/>
-            </a:pPr>
-            <a:r>
-              <a:rPr lang="en-US" sz="1350" b="1" dirty="0">
-                <a:solidFill>
-                  <a:srgbClr val="333333"/>
+              <a:rPr lang="en-US" sz="2000" b="1" u="sng" dirty="0">
+                <a:solidFill>
+                  <a:srgbClr val="333333"/>
+                </a:solidFill>
+              </a:rPr>
+              <a:t>Kovarians</a:t>
+            </a:r>
+            <a:pPr indent="0" marL="0">
+              <a:buNone/>
+            </a:pPr>
+            <a:r>
+              <a:rPr lang="en-US" sz="2000" dirty="0">
+                <a:solidFill>
+                  <a:srgbClr val="333333"/>
+                </a:solidFill>
+              </a:rPr>
+              <a:t>: Ukuran pergerakan bersama aset.</a:t>
+            </a:r>
+            <a:endParaRPr lang="en-US" sz="2000" dirty="0"/>
+          </a:p>
+        </p:txBody>
+      </p:sp>
+      <p:sp>
+        <p:nvSpPr>
+          <p:cNvPr id="4" name="Text 2"/>
+          <p:cNvSpPr/>
+          <p:nvPr/>
+        </p:nvSpPr>
+        <p:spPr>
+          <a:xfrm>
+            <a:off x="4754880" y="1097280"/>
+            <a:ext cx="4114800" cy="3657600"/>
+          </a:xfrm>
+          <a:prstGeom prst="rect">
+            <a:avLst/>
+          </a:prstGeom>
+          <a:noFill/>
+          <a:ln/>
+        </p:spPr>
+        <p:txBody>
+          <a:bodyPr wrap="square" rtlCol="0" anchor="t"/>
+          <a:lstStyle/>
+          <a:p>
+            <a:pPr indent="0" marL="0">
+              <a:buNone/>
+            </a:pPr>
+            <a:r>
+              <a:rPr lang="en-US" sz="2000" b="1" dirty="0">
+                <a:solidFill>
+                  <a:srgbClr val="003366"/>
                 </a:solidFill>
               </a:rPr>
               <a:t>Pendekatan Struktur Jaringan:</a:t>
             </a:r>
-            <a:endParaRPr lang="en-US" sz="1350" dirty="0"/>
-          </a:p>
-          <a:p>
-            <a:pPr indent="0" marL="0">
-              <a:buNone/>
-            </a:pPr>
-            <a:r>
-              <a:rPr lang="en-US" sz="1350" dirty="0">
+            <a:endParaRPr lang="en-US" sz="2000" dirty="0"/>
+          </a:p>
+          <a:p>
+            <a:pPr indent="0" marL="0">
+              <a:buNone/>
+            </a:pPr>
+            <a:r>
+              <a:rPr lang="en-US" sz="2000" dirty="0">
                 <a:solidFill>
                   <a:srgbClr val="333333"/>
                 </a:solidFill>
@@ -10852,105 +11442,32 @@
               <a:buNone/>
             </a:pPr>
             <a:r>
-              <a:rPr lang="en-US" sz="1350" u="sng" dirty="0">
-                <a:solidFill>
-                  <a:srgbClr val="333333"/>
-                </a:solidFill>
-              </a:rPr>
-              <a:t>Random Matrix Theory</a:t>
-            </a:r>
-            <a:pPr indent="0" marL="0">
-              <a:buNone/>
-            </a:pPr>
-            <a:r>
-              <a:rPr lang="en-US" sz="1350" dirty="0">
-                <a:solidFill>
-                  <a:srgbClr val="333333"/>
-                </a:solidFill>
-              </a:rPr>
-              <a:t> (</a:t>
-            </a:r>
-            <a:pPr indent="0" marL="0">
-              <a:buNone/>
-            </a:pPr>
-            <a:r>
-              <a:rPr lang="en-US" sz="1350" b="1" u="sng" dirty="0">
-                <a:solidFill>
-                  <a:srgbClr val="0563C1"/>
-                </a:solidFill>
-                <a:hlinkClick r:id="rId1" action="ppaction://hlinksldjump" tooltip="">
-                  <a:extLst>
-                    <a:ext uri="{A12FA001-AC4F-418D-AE19-62706E023703}">
-                      <ahyp:hlinkClr xmlns:ahyp="http://schemas.microsoft.com/office/drawing/2018/hyperlinkcolor" val="tx"/>
-                    </a:ext>
-                  </a:extLst>
-                </a:hlinkClick>
-              </a:rPr>
-              <a:t>RMT</a:t>
-            </a:r>
-            <a:pPr indent="0" marL="0">
-              <a:buNone/>
-            </a:pPr>
-            <a:r>
-              <a:rPr lang="en-US" sz="1350" dirty="0">
-                <a:solidFill>
-                  <a:srgbClr val="333333"/>
-                </a:solidFill>
-              </a:rPr>
-              <a:t>): Metode fisika statistik </a:t>
-            </a:r>
-            <a:pPr indent="0" marL="0">
-              <a:buNone/>
-            </a:pPr>
-            <a:r>
-              <a:rPr lang="en-US" sz="1350" b="1" dirty="0">
-                <a:solidFill>
-                  <a:srgbClr val="333333"/>
-                </a:solidFill>
-              </a:rPr>
-              <a:t>pemfilter noise</a:t>
-            </a:r>
-            <a:pPr indent="0" marL="0">
-              <a:buNone/>
-            </a:pPr>
-            <a:r>
-              <a:rPr lang="en-US" sz="1350" dirty="0">
-                <a:solidFill>
-                  <a:srgbClr val="333333"/>
-                </a:solidFill>
-              </a:rPr>
-              <a:t> untuk merekonstruksi kestabilan </a:t>
-            </a:r>
-            <a:pPr indent="0" marL="0">
-              <a:buNone/>
-            </a:pPr>
-            <a:r>
-              <a:rPr lang="en-US" sz="1350" b="1" dirty="0">
-                <a:solidFill>
-                  <a:srgbClr val="333333"/>
-                </a:solidFill>
-              </a:rPr>
-              <a:t>matriks korelasi</a:t>
-            </a:r>
-            <a:pPr indent="0" marL="0">
-              <a:buNone/>
-            </a:pPr>
-            <a:r>
-              <a:rPr lang="en-US" sz="1350" dirty="0">
-                <a:solidFill>
-                  <a:srgbClr val="333333"/>
-                </a:solidFill>
-              </a:rPr>
-              <a:t>.</a:t>
-            </a:r>
-            <a:endParaRPr lang="en-US" sz="1350" dirty="0"/>
-          </a:p>
-          <a:p>
-            <a:pPr indent="0" marL="0">
-              <a:buNone/>
-            </a:pPr>
-            <a:r>
-              <a:rPr lang="en-US" sz="1350" dirty="0">
+              <a:rPr lang="en-US" sz="2000" b="1" u="sng" dirty="0">
+                <a:solidFill>
+                  <a:srgbClr val="333333"/>
+                </a:solidFill>
+              </a:rPr>
+              <a:t>RMT (Random Matrix Theory)</a:t>
+            </a:r>
+            <a:pPr indent="0" marL="0">
+              <a:buNone/>
+            </a:pPr>
+            <a:r>
+              <a:rPr lang="en-US" sz="2000" dirty="0">
+                <a:solidFill>
+                  <a:srgbClr val="333333"/>
+                </a:solidFill>
+              </a:rPr>
+              <a:t>: Filter noise untuk kestabilan matriks.</a:t>
+            </a:r>
+            <a:endParaRPr lang="en-US" sz="2000" dirty="0"/>
+          </a:p>
+          <a:p>
+            <a:pPr indent="0" marL="0">
+              <a:buNone/>
+            </a:pPr>
+            <a:r>
+              <a:rPr lang="en-US" sz="2000" dirty="0">
                 <a:solidFill>
                   <a:srgbClr val="333333"/>
                 </a:solidFill>
@@ -10961,76 +11478,32 @@
               <a:buNone/>
             </a:pPr>
             <a:r>
-              <a:rPr lang="en-US" sz="1350" u="sng" dirty="0">
-                <a:solidFill>
-                  <a:srgbClr val="333333"/>
-                </a:solidFill>
-              </a:rPr>
-              <a:t>Minimum Spanning Tree</a:t>
-            </a:r>
-            <a:pPr indent="0" marL="0">
-              <a:buNone/>
-            </a:pPr>
-            <a:r>
-              <a:rPr lang="en-US" sz="1350" dirty="0">
-                <a:solidFill>
-                  <a:srgbClr val="333333"/>
-                </a:solidFill>
-              </a:rPr>
-              <a:t> (MST): Konstruksi jaringan antar aset berdasarkan </a:t>
-            </a:r>
-            <a:pPr indent="0" marL="0">
-              <a:buNone/>
-            </a:pPr>
-            <a:r>
-              <a:rPr lang="en-US" sz="1350" b="1" dirty="0">
-                <a:solidFill>
-                  <a:srgbClr val="333333"/>
-                </a:solidFill>
-              </a:rPr>
-              <a:t>jarak korelasi terpendek</a:t>
-            </a:r>
-            <a:pPr indent="0" marL="0">
-              <a:buNone/>
-            </a:pPr>
-            <a:r>
-              <a:rPr lang="en-US" sz="1350" dirty="0">
-                <a:solidFill>
-                  <a:srgbClr val="333333"/>
-                </a:solidFill>
-              </a:rPr>
-              <a:t> (paling kuat); menyaring informasi redundan </a:t>
-            </a:r>
-            <a:pPr indent="0" marL="0">
-              <a:buNone/>
-            </a:pPr>
-            <a:r>
-              <a:rPr lang="en-US" sz="1350" b="1" dirty="0">
-                <a:solidFill>
-                  <a:srgbClr val="333333"/>
-                </a:solidFill>
-              </a:rPr>
-              <a:t>tanpa siklus</a:t>
-            </a:r>
-            <a:pPr indent="0" marL="0">
-              <a:buNone/>
-            </a:pPr>
-            <a:r>
-              <a:rPr lang="en-US" sz="1350" dirty="0">
-                <a:solidFill>
-                  <a:srgbClr val="333333"/>
-                </a:solidFill>
-              </a:rPr>
-              <a:t> (loop).</a:t>
-            </a:r>
-            <a:endParaRPr lang="en-US" sz="1350" dirty="0"/>
-          </a:p>
-          <a:p>
-            <a:pPr indent="0" marL="0">
-              <a:buNone/>
-            </a:pPr>
-            <a:r>
-              <a:rPr lang="en-US" sz="1350" dirty="0">
+              <a:rPr lang="en-US" sz="2000" b="1" u="sng" dirty="0">
+                <a:solidFill>
+                  <a:srgbClr val="333333"/>
+                </a:solidFill>
+              </a:rPr>
+              <a:t>MST (Minimum Spanning Tree)</a:t>
+            </a:r>
+            <a:pPr indent="0" marL="0">
+              <a:buNone/>
+            </a:pPr>
+            <a:r>
+              <a:rPr lang="en-US" sz="2000" dirty="0">
+                <a:solidFill>
+                  <a:srgbClr val="333333"/>
+                </a:solidFill>
+              </a:rPr>
+              <a:t>: Jaringan korelasi terkuat tanpa loop.</a:t>
+            </a:r>
+            <a:endParaRPr lang="en-US" sz="2000" dirty="0"/>
+          </a:p>
+          <a:p>
+            <a:pPr indent="0" marL="0">
+              <a:buNone/>
+            </a:pPr>
+            <a:r>
+              <a:rPr lang="en-US" sz="2000" dirty="0">
                 <a:solidFill>
                   <a:srgbClr val="333333"/>
                 </a:solidFill>
@@ -11041,47 +11514,25 @@
               <a:buNone/>
             </a:pPr>
             <a:r>
-              <a:rPr lang="en-US" sz="1350" u="sng" dirty="0">
-                <a:solidFill>
-                  <a:srgbClr val="333333"/>
-                </a:solidFill>
-              </a:rPr>
-              <a:t>Network Centrality</a:t>
-            </a:r>
-            <a:pPr indent="0" marL="0">
-              <a:buNone/>
-            </a:pPr>
-            <a:r>
-              <a:rPr lang="en-US" sz="1350" dirty="0">
-                <a:solidFill>
-                  <a:srgbClr val="333333"/>
-                </a:solidFill>
-              </a:rPr>
-              <a:t>: Metrik penghukuman pada aset pasar yang letaknya terpusat untuk menekan probabilitas </a:t>
-            </a:r>
-            <a:pPr indent="0" marL="0">
-              <a:buNone/>
-            </a:pPr>
-            <a:r>
-              <a:rPr lang="en-US" sz="1350" b="1" dirty="0">
-                <a:solidFill>
-                  <a:srgbClr val="333333"/>
-                </a:solidFill>
-              </a:rPr>
-              <a:t>risiko penularan</a:t>
-            </a:r>
-            <a:pPr indent="0" marL="0">
-              <a:buNone/>
-            </a:pPr>
-            <a:r>
-              <a:rPr lang="en-US" sz="1350" dirty="0">
-                <a:solidFill>
-                  <a:srgbClr val="333333"/>
-                </a:solidFill>
-              </a:rPr>
-              <a:t> letupan harga yang sistemik.</a:t>
-            </a:r>
-            <a:endParaRPr lang="en-US" sz="1350" dirty="0"/>
+              <a:rPr lang="en-US" sz="2000" b="1" u="sng" dirty="0">
+                <a:solidFill>
+                  <a:srgbClr val="333333"/>
+                </a:solidFill>
+              </a:rPr>
+              <a:t>Centrality</a:t>
+            </a:r>
+            <a:pPr indent="0" marL="0">
+              <a:buNone/>
+            </a:pPr>
+            <a:r>
+              <a:rPr lang="en-US" sz="2000" dirty="0">
+                <a:solidFill>
+                  <a:srgbClr val="333333"/>
+                </a:solidFill>
+              </a:rPr>
+              <a:t>: Metrik risiko penularan sistemik.</a:t>
+            </a:r>
+            <a:endParaRPr lang="en-US" sz="2000" dirty="0"/>
           </a:p>
         </p:txBody>
       </p:sp>
@@ -11201,7 +11652,7 @@
                   <a:srgbClr val="333333"/>
                 </a:solidFill>
               </a:rPr>
-              <a:t>RMT dan MST</a:t>
+              <a:t>RMT (Random Matrix Theory)</a:t>
             </a:r>
             <a:pPr indent="0" marL="0">
               <a:buNone/>
@@ -11212,6 +11663,28 @@
                   <a:srgbClr val="333333"/>
                 </a:solidFill>
               </a:rPr>
+              <a:t> dan </a:t>
+            </a:r>
+            <a:pPr indent="0" marL="0">
+              <a:buNone/>
+            </a:pPr>
+            <a:r>
+              <a:rPr lang="en-US" sz="1600" b="1" dirty="0">
+                <a:solidFill>
+                  <a:srgbClr val="333333"/>
+                </a:solidFill>
+              </a:rPr>
+              <a:t>MST (Minimum Spanning Tree)</a:t>
+            </a:r>
+            <a:pPr indent="0" marL="0">
+              <a:buNone/>
+            </a:pPr>
+            <a:r>
+              <a:rPr lang="en-US" sz="1600" dirty="0">
+                <a:solidFill>
+                  <a:srgbClr val="333333"/>
+                </a:solidFill>
+              </a:rPr>
               <a:t> di kripto.</a:t>
             </a:r>
             <a:endParaRPr lang="en-US" sz="1600" dirty="0"/>
@@ -11290,7 +11763,7 @@
                   <a:srgbClr val="333333"/>
                 </a:solidFill>
               </a:rPr>
-              <a:t>Pemilihan koin topologi MST mengalahkan </a:t>
+              <a:t>Pemilihan koin topologi MST (Minimum Spanning Tree) mengalahkan </a:t>
             </a:r>
             <a:pPr indent="0" marL="0">
               <a:buNone/>
@@ -11390,7 +11863,7 @@
                   <a:srgbClr val="333333"/>
                 </a:solidFill>
               </a:rPr>
-              <a:t>Penggabungan Network-MPT memberikan </a:t>
+              <a:t>Penggabungan Network-MPT (Modern Portfolio Theory) memberikan </a:t>
             </a:r>
             <a:pPr indent="0" marL="0">
               <a:buNone/>
@@ -11481,7 +11954,7 @@
       </p:sp>
       <p:pic>
         <p:nvPicPr>
-          <p:cNvPr id="3" name="Image 0" descr="e:/ProjectNodeJs/temp_doc_build/framwrok.jpg">    </p:cNvPr>
+          <p:cNvPr id="3" name="Image 0" descr="framwrok.jpg">    </p:cNvPr>
           <p:cNvPicPr>
             <a:picLocks noChangeAspect="1"/>
           </p:cNvPicPr>
@@ -13626,199 +14099,144 @@
               <a:buNone/>
             </a:pPr>
             <a:r>
-              <a:rPr lang="en-US" sz="1600" b="1" dirty="0">
-                <a:solidFill>
-                  <a:srgbClr val="2C3E50"/>
+              <a:rPr lang="en-US" sz="2200" b="1" dirty="0">
+                <a:solidFill>
+                  <a:srgbClr val="003366"/>
                 </a:solidFill>
               </a:rPr>
               <a:t>1. Kelompok Baseline:</a:t>
             </a:r>
-            <a:endParaRPr lang="en-US" sz="1600" dirty="0"/>
-          </a:p>
-          <a:p>
-            <a:pPr indent="0" marL="0">
-              <a:buNone/>
-            </a:pPr>
-            <a:r>
-              <a:rPr lang="en-US" sz="1600" b="1" dirty="0">
-                <a:solidFill>
-                  <a:srgbClr val="333333"/>
-                </a:solidFill>
-              </a:rPr>
-              <a:t>   • EW (Equally Weighted): </a:t>
-            </a:r>
-            <a:pPr indent="0" marL="0">
-              <a:buNone/>
-            </a:pPr>
-            <a:r>
-              <a:rPr lang="en-US" sz="1600" dirty="0">
-                <a:solidFill>
-                  <a:srgbClr val="333333"/>
-                </a:solidFill>
-              </a:rPr>
-              <a:t>Portofolio naif 1/N sebagai pembanding dasar.</a:t>
-            </a:r>
-            <a:endParaRPr lang="en-US" sz="1600" dirty="0"/>
-          </a:p>
-          <a:p>
-            <a:pPr indent="0" marL="0">
-              <a:buNone/>
-            </a:pPr>
-            <a:r>
-              <a:rPr lang="en-US" sz="1600" b="1" dirty="0">
-                <a:solidFill>
-                  <a:srgbClr val="333333"/>
-                </a:solidFill>
-              </a:rPr>
-              <a:t>   • CM (Classical Markowitz): </a:t>
-            </a:r>
-            <a:pPr indent="0" marL="0">
-              <a:buNone/>
-            </a:pPr>
-            <a:r>
-              <a:rPr lang="en-US" sz="1600" dirty="0">
-                <a:solidFill>
-                  <a:srgbClr val="333333"/>
-                </a:solidFill>
-              </a:rPr>
-              <a:t>Optimasi Mean-Variance tradisional tanpa filter noise.</a:t>
-            </a:r>
-            <a:endParaRPr lang="en-US" sz="1600" dirty="0"/>
-          </a:p>
-          <a:p>
-            <a:pPr indent="0" marL="0">
-              <a:buNone/>
-            </a:pPr>
-            <a:endParaRPr lang="en-US" sz="1600" dirty="0"/>
-          </a:p>
-          <a:p>
-            <a:pPr indent="0" marL="0">
-              <a:buNone/>
-            </a:pPr>
-            <a:r>
-              <a:rPr lang="en-US" sz="1600" b="1" dirty="0">
-                <a:solidFill>
-                  <a:srgbClr val="2C3E50"/>
+            <a:endParaRPr lang="en-US" sz="2200" dirty="0"/>
+          </a:p>
+          <a:p>
+            <a:pPr indent="0" marL="0">
+              <a:buNone/>
+            </a:pPr>
+            <a:r>
+              <a:rPr lang="en-US" sz="2200" dirty="0">
+                <a:solidFill>
+                  <a:srgbClr val="333333"/>
+                </a:solidFill>
+              </a:rPr>
+              <a:t>   • EW (Equally Weighted)</a:t>
+            </a:r>
+            <a:endParaRPr lang="en-US" sz="2200" dirty="0"/>
+          </a:p>
+          <a:p>
+            <a:pPr indent="0" marL="0">
+              <a:buNone/>
+            </a:pPr>
+            <a:r>
+              <a:rPr lang="en-US" sz="2200" dirty="0">
+                <a:solidFill>
+                  <a:srgbClr val="333333"/>
+                </a:solidFill>
+              </a:rPr>
+              <a:t>   • CM (Classical Markowitz)</a:t>
+            </a:r>
+            <a:endParaRPr lang="en-US" sz="2200" dirty="0"/>
+          </a:p>
+          <a:p>
+            <a:pPr indent="0" marL="0">
+              <a:buNone/>
+            </a:pPr>
+            <a:endParaRPr lang="en-US" sz="2200" dirty="0"/>
+          </a:p>
+          <a:p>
+            <a:pPr indent="0" marL="0">
+              <a:buNone/>
+            </a:pPr>
+            <a:r>
+              <a:rPr lang="en-US" sz="2200" b="1" dirty="0">
+                <a:solidFill>
+                  <a:srgbClr val="003366"/>
                 </a:solidFill>
               </a:rPr>
               <a:t>2. Kelompok Regularisasi:</a:t>
             </a:r>
-            <a:endParaRPr lang="en-US" sz="1600" dirty="0"/>
-          </a:p>
-          <a:p>
-            <a:pPr indent="0" marL="0">
-              <a:buNone/>
-            </a:pPr>
-            <a:r>
-              <a:rPr lang="en-US" sz="1600" b="1" dirty="0">
-                <a:solidFill>
-                  <a:srgbClr val="333333"/>
-                </a:solidFill>
-              </a:rPr>
-              <a:t>   • GM (Glasso Markowitz): </a:t>
-            </a:r>
-            <a:pPr indent="0" marL="0">
-              <a:buNone/>
-            </a:pPr>
-            <a:r>
-              <a:rPr lang="en-US" sz="1600" dirty="0">
-                <a:solidFill>
-                  <a:srgbClr val="333333"/>
-                </a:solidFill>
-              </a:rPr>
-              <a:t>Menggunakan Graphical Lasso (L1) pada matriks kovarians.</a:t>
-            </a:r>
-            <a:endParaRPr lang="en-US" sz="1600" dirty="0"/>
-          </a:p>
-          <a:p>
-            <a:pPr indent="0" marL="0">
-              <a:buNone/>
-            </a:pPr>
-            <a:endParaRPr lang="en-US" sz="1600" dirty="0"/>
-          </a:p>
-          <a:p>
-            <a:pPr indent="0" marL="0">
-              <a:buNone/>
-            </a:pPr>
-            <a:r>
-              <a:rPr lang="en-US" sz="1600" b="1" dirty="0">
-                <a:solidFill>
-                  <a:srgbClr val="2C3E50"/>
+            <a:endParaRPr lang="en-US" sz="2200" dirty="0"/>
+          </a:p>
+          <a:p>
+            <a:pPr indent="0" marL="0">
+              <a:buNone/>
+            </a:pPr>
+            <a:r>
+              <a:rPr lang="en-US" sz="2200" dirty="0">
+                <a:solidFill>
+                  <a:srgbClr val="333333"/>
+                </a:solidFill>
+              </a:rPr>
+              <a:t>   • GM (Glasso Markowitz)</a:t>
+            </a:r>
+            <a:endParaRPr lang="en-US" sz="2200" dirty="0"/>
+          </a:p>
+          <a:p>
+            <a:pPr indent="0" marL="0">
+              <a:buNone/>
+            </a:pPr>
+            <a:endParaRPr lang="en-US" sz="2200" dirty="0"/>
+          </a:p>
+          <a:p>
+            <a:pPr indent="0" marL="0">
+              <a:buNone/>
+            </a:pPr>
+            <a:r>
+              <a:rPr lang="en-US" sz="2200" b="1" dirty="0">
+                <a:solidFill>
+                  <a:srgbClr val="003366"/>
                 </a:solidFill>
               </a:rPr>
               <a:t>3. Kelompok Network (Statis):</a:t>
             </a:r>
-            <a:endParaRPr lang="en-US" sz="1600" dirty="0"/>
-          </a:p>
-          <a:p>
-            <a:pPr indent="0" marL="0">
-              <a:buNone/>
-            </a:pPr>
-            <a:r>
-              <a:rPr lang="en-US" sz="1600" b="1" dirty="0">
-                <a:solidFill>
-                  <a:srgbClr val="333333"/>
-                </a:solidFill>
-              </a:rPr>
-              <a:t>   • NW Statis: </a:t>
-            </a:r>
-            <a:pPr indent="0" marL="0">
-              <a:buNone/>
-            </a:pPr>
-            <a:r>
-              <a:rPr lang="en-US" sz="1600" dirty="0">
-                <a:solidFill>
-                  <a:srgbClr val="333333"/>
-                </a:solidFill>
-              </a:rPr>
-              <a:t>Parameter penalti gamma (γ) tetap: 0, 1.0, dan 2.0.</a:t>
-            </a:r>
-            <a:endParaRPr lang="en-US" sz="1600" dirty="0"/>
-          </a:p>
-          <a:p>
-            <a:pPr indent="0" marL="0">
-              <a:buNone/>
-            </a:pPr>
-            <a:endParaRPr lang="en-US" sz="1600" dirty="0"/>
-          </a:p>
-          <a:p>
-            <a:pPr indent="0" marL="0">
-              <a:buNone/>
-            </a:pPr>
-            <a:r>
-              <a:rPr lang="en-US" sz="1600" b="1" dirty="0">
-                <a:solidFill>
-                  <a:srgbClr val="2C3E50"/>
+            <a:endParaRPr lang="en-US" sz="2200" dirty="0"/>
+          </a:p>
+          <a:p>
+            <a:pPr indent="0" marL="0">
+              <a:buNone/>
+            </a:pPr>
+            <a:r>
+              <a:rPr lang="en-US" sz="2200" dirty="0">
+                <a:solidFill>
+                  <a:srgbClr val="333333"/>
+                </a:solidFill>
+              </a:rPr>
+              <a:t>   • NW Statis (γ fixed)</a:t>
+            </a:r>
+            <a:endParaRPr lang="en-US" sz="2200" dirty="0"/>
+          </a:p>
+          <a:p>
+            <a:pPr indent="0" marL="0">
+              <a:buNone/>
+            </a:pPr>
+            <a:endParaRPr lang="en-US" sz="2200" dirty="0"/>
+          </a:p>
+          <a:p>
+            <a:pPr indent="0" marL="0">
+              <a:buNone/>
+            </a:pPr>
+            <a:r>
+              <a:rPr lang="en-US" sz="2200" b="1" dirty="0">
+                <a:solidFill>
+                  <a:srgbClr val="003366"/>
                 </a:solidFill>
               </a:rPr>
               <a:t>4. Kelompok Network (Adaptif):</a:t>
             </a:r>
-            <a:endParaRPr lang="en-US" sz="1600" dirty="0"/>
-          </a:p>
-          <a:p>
-            <a:pPr indent="0" marL="0">
-              <a:buNone/>
-            </a:pPr>
-            <a:r>
-              <a:rPr lang="en-US" sz="1600" b="1" dirty="0">
-                <a:solidFill>
-                  <a:srgbClr val="333333"/>
-                </a:solidFill>
-              </a:rPr>
-              <a:t>   • NW Adaptif (Grid Search): </a:t>
-            </a:r>
-            <a:pPr indent="0" marL="0">
-              <a:buNone/>
-            </a:pPr>
-            <a:r>
-              <a:rPr lang="en-US" sz="1600" dirty="0">
-                <a:solidFill>
-                  <a:srgbClr val="333333"/>
-                </a:solidFill>
-              </a:rPr>
-              <a:t>Optimasi penalti dinamis dengan Jendela Rolling (30, 60, 90, 120 hari).</a:t>
-            </a:r>
-            <a:endParaRPr lang="en-US" sz="1600" dirty="0"/>
+            <a:endParaRPr lang="en-US" sz="2200" dirty="0"/>
+          </a:p>
+          <a:p>
+            <a:pPr indent="0" marL="0">
+              <a:buNone/>
+            </a:pPr>
+            <a:r>
+              <a:rPr lang="en-US" sz="2200" dirty="0">
+                <a:solidFill>
+                  <a:srgbClr val="333333"/>
+                </a:solidFill>
+              </a:rPr>
+              <a:t>   • NW Adaptif (Grid Search)</a:t>
+            </a:r>
+            <a:endParaRPr lang="en-US" sz="2200" dirty="0"/>
           </a:p>
         </p:txBody>
       </p:sp>
@@ -13877,7 +14295,7 @@
                   <a:srgbClr val="003366"/>
                 </a:solidFill>
               </a:rPr>
-              <a:t>1. Equally Weighted (EW)</a:t>
+              <a:t>1.1. Equally Weighted (EW)</a:t>
             </a:r>
             <a:endParaRPr lang="en-US" sz="2800" dirty="0"/>
           </a:p>

</xml_diff>

<commit_message>
feat: add Equally Weighted (EW) example slide to presentation
</commit_message>
<xml_diff>
--- a/Presentasi_Proposal_Update.pptx
+++ b/Presentasi_Proposal_Update.pptx
@@ -40,9 +40,12 @@
     <p:sldId id="288" r:id="rId34"/>
     <p:sldId id="289" r:id="rId35"/>
     <p:sldId id="290" r:id="rId36"/>
+    <p:sldId id="291" r:id="rId37"/>
+    <p:sldId id="292" r:id="rId38"/>
+    <p:sldId id="293" r:id="rId39"/>
   </p:sldIdLst>
   <p:notesMasterIdLst>
-    <p:notesMasterId r:id="rId37"/>
+    <p:notesMasterId r:id="rId40"/>
   </p:notesMasterIdLst>
   <p:sldSz cx="9144000" cy="5143500"/>
   <p:notesSz cx="5143500" cy="9144000"/>
@@ -3024,6 +3027,270 @@
             <a:fld id="{F7021451-1387-4CA6-816F-3879F97B5CBC}" type="slidenum">
               <a:rPr lang="en-US"/>
               <a:t>35</a:t>
+            </a:fld>
+            <a:endParaRPr lang="en-US"/>
+          </a:p>
+        </p:txBody>
+      </p:sp>
+    </p:spTree>
+    <p:extLst>
+      <p:ext uri="{BB962C8B-B14F-4D97-AF65-F5344CB8AC3E}">
+        <p14:creationId xmlns:p14="http://schemas.microsoft.com/office/powerpoint/2010/main" val="1024086991"/>
+      </p:ext>
+    </p:extLst>
+  </p:cSld>
+  <p:clrMapOvr>
+    <a:masterClrMapping/>
+  </p:clrMapOvr>
+</p:notes>
+</file>
+
+<file path=ppt/notesSlides/notesSlide36.xml><?xml version="1.0" encoding="utf-8"?>
+<p:notes xmlns:a="http://schemas.openxmlformats.org/drawingml/2006/main" xmlns:r="http://schemas.openxmlformats.org/officeDocument/2006/relationships" xmlns:p="http://schemas.openxmlformats.org/presentationml/2006/main">
+  <p:cSld>
+    <p:spTree>
+      <p:nvGrpSpPr>
+        <p:cNvPr id="1" name=""/>
+        <p:cNvGrpSpPr/>
+        <p:nvPr/>
+      </p:nvGrpSpPr>
+      <p:grpSpPr>
+        <a:xfrm>
+          <a:off x="0" y="0"/>
+          <a:ext cx="0" cy="0"/>
+          <a:chOff x="0" y="0"/>
+          <a:chExt cx="0" cy="0"/>
+        </a:xfrm>
+      </p:grpSpPr>
+      <p:sp>
+        <p:nvSpPr>
+          <p:cNvPr id="2" name="Slide Image Placeholder 1"/>
+          <p:cNvSpPr>
+            <a:spLocks noGrp="1" noRot="1" noChangeAspect="1"/>
+          </p:cNvSpPr>
+          <p:nvPr>
+            <p:ph type="sldImg"/>
+          </p:nvPr>
+        </p:nvSpPr>
+        <p:spPr/>
+      </p:sp>
+      <p:sp>
+        <p:nvSpPr>
+          <p:cNvPr id="3" name="Notes Placeholder 2"/>
+          <p:cNvSpPr>
+            <a:spLocks noGrp="1"/>
+          </p:cNvSpPr>
+          <p:nvPr>
+            <p:ph type="body" idx="1"/>
+          </p:nvPr>
+        </p:nvSpPr>
+        <p:spPr/>
+        <p:txBody>
+          <a:bodyPr/>
+          <a:lstStyle/>
+          <a:p>
+            <a:r>
+              <a:rPr lang="en-US" dirty="0"/>
+              <a:t/>
+            </a:r>
+            <a:endParaRPr lang="en-US" dirty="0"/>
+          </a:p>
+        </p:txBody>
+      </p:sp>
+      <p:sp>
+        <p:nvSpPr>
+          <p:cNvPr id="4" name="Slide Number Placeholder 3"/>
+          <p:cNvSpPr>
+            <a:spLocks noGrp="1"/>
+          </p:cNvSpPr>
+          <p:nvPr>
+            <p:ph type="sldNum" sz="quarter" idx="10"/>
+          </p:nvPr>
+        </p:nvSpPr>
+        <p:spPr/>
+        <p:txBody>
+          <a:bodyPr/>
+          <a:lstStyle/>
+          <a:p>
+            <a:fld id="{F7021451-1387-4CA6-816F-3879F97B5CBC}" type="slidenum">
+              <a:rPr lang="en-US"/>
+              <a:t>36</a:t>
+            </a:fld>
+            <a:endParaRPr lang="en-US"/>
+          </a:p>
+        </p:txBody>
+      </p:sp>
+    </p:spTree>
+    <p:extLst>
+      <p:ext uri="{BB962C8B-B14F-4D97-AF65-F5344CB8AC3E}">
+        <p14:creationId xmlns:p14="http://schemas.microsoft.com/office/powerpoint/2010/main" val="1024086991"/>
+      </p:ext>
+    </p:extLst>
+  </p:cSld>
+  <p:clrMapOvr>
+    <a:masterClrMapping/>
+  </p:clrMapOvr>
+</p:notes>
+</file>
+
+<file path=ppt/notesSlides/notesSlide37.xml><?xml version="1.0" encoding="utf-8"?>
+<p:notes xmlns:a="http://schemas.openxmlformats.org/drawingml/2006/main" xmlns:r="http://schemas.openxmlformats.org/officeDocument/2006/relationships" xmlns:p="http://schemas.openxmlformats.org/presentationml/2006/main">
+  <p:cSld>
+    <p:spTree>
+      <p:nvGrpSpPr>
+        <p:cNvPr id="1" name=""/>
+        <p:cNvGrpSpPr/>
+        <p:nvPr/>
+      </p:nvGrpSpPr>
+      <p:grpSpPr>
+        <a:xfrm>
+          <a:off x="0" y="0"/>
+          <a:ext cx="0" cy="0"/>
+          <a:chOff x="0" y="0"/>
+          <a:chExt cx="0" cy="0"/>
+        </a:xfrm>
+      </p:grpSpPr>
+      <p:sp>
+        <p:nvSpPr>
+          <p:cNvPr id="2" name="Slide Image Placeholder 1"/>
+          <p:cNvSpPr>
+            <a:spLocks noGrp="1" noRot="1" noChangeAspect="1"/>
+          </p:cNvSpPr>
+          <p:nvPr>
+            <p:ph type="sldImg"/>
+          </p:nvPr>
+        </p:nvSpPr>
+        <p:spPr/>
+      </p:sp>
+      <p:sp>
+        <p:nvSpPr>
+          <p:cNvPr id="3" name="Notes Placeholder 2"/>
+          <p:cNvSpPr>
+            <a:spLocks noGrp="1"/>
+          </p:cNvSpPr>
+          <p:nvPr>
+            <p:ph type="body" idx="1"/>
+          </p:nvPr>
+        </p:nvSpPr>
+        <p:spPr/>
+        <p:txBody>
+          <a:bodyPr/>
+          <a:lstStyle/>
+          <a:p>
+            <a:r>
+              <a:rPr lang="en-US" dirty="0"/>
+              <a:t/>
+            </a:r>
+            <a:endParaRPr lang="en-US" dirty="0"/>
+          </a:p>
+        </p:txBody>
+      </p:sp>
+      <p:sp>
+        <p:nvSpPr>
+          <p:cNvPr id="4" name="Slide Number Placeholder 3"/>
+          <p:cNvSpPr>
+            <a:spLocks noGrp="1"/>
+          </p:cNvSpPr>
+          <p:nvPr>
+            <p:ph type="sldNum" sz="quarter" idx="10"/>
+          </p:nvPr>
+        </p:nvSpPr>
+        <p:spPr/>
+        <p:txBody>
+          <a:bodyPr/>
+          <a:lstStyle/>
+          <a:p>
+            <a:fld id="{F7021451-1387-4CA6-816F-3879F97B5CBC}" type="slidenum">
+              <a:rPr lang="en-US"/>
+              <a:t>37</a:t>
+            </a:fld>
+            <a:endParaRPr lang="en-US"/>
+          </a:p>
+        </p:txBody>
+      </p:sp>
+    </p:spTree>
+    <p:extLst>
+      <p:ext uri="{BB962C8B-B14F-4D97-AF65-F5344CB8AC3E}">
+        <p14:creationId xmlns:p14="http://schemas.microsoft.com/office/powerpoint/2010/main" val="1024086991"/>
+      </p:ext>
+    </p:extLst>
+  </p:cSld>
+  <p:clrMapOvr>
+    <a:masterClrMapping/>
+  </p:clrMapOvr>
+</p:notes>
+</file>
+
+<file path=ppt/notesSlides/notesSlide38.xml><?xml version="1.0" encoding="utf-8"?>
+<p:notes xmlns:a="http://schemas.openxmlformats.org/drawingml/2006/main" xmlns:r="http://schemas.openxmlformats.org/officeDocument/2006/relationships" xmlns:p="http://schemas.openxmlformats.org/presentationml/2006/main">
+  <p:cSld>
+    <p:spTree>
+      <p:nvGrpSpPr>
+        <p:cNvPr id="1" name=""/>
+        <p:cNvGrpSpPr/>
+        <p:nvPr/>
+      </p:nvGrpSpPr>
+      <p:grpSpPr>
+        <a:xfrm>
+          <a:off x="0" y="0"/>
+          <a:ext cx="0" cy="0"/>
+          <a:chOff x="0" y="0"/>
+          <a:chExt cx="0" cy="0"/>
+        </a:xfrm>
+      </p:grpSpPr>
+      <p:sp>
+        <p:nvSpPr>
+          <p:cNvPr id="2" name="Slide Image Placeholder 1"/>
+          <p:cNvSpPr>
+            <a:spLocks noGrp="1" noRot="1" noChangeAspect="1"/>
+          </p:cNvSpPr>
+          <p:nvPr>
+            <p:ph type="sldImg"/>
+          </p:nvPr>
+        </p:nvSpPr>
+        <p:spPr/>
+      </p:sp>
+      <p:sp>
+        <p:nvSpPr>
+          <p:cNvPr id="3" name="Notes Placeholder 2"/>
+          <p:cNvSpPr>
+            <a:spLocks noGrp="1"/>
+          </p:cNvSpPr>
+          <p:nvPr>
+            <p:ph type="body" idx="1"/>
+          </p:nvPr>
+        </p:nvSpPr>
+        <p:spPr/>
+        <p:txBody>
+          <a:bodyPr/>
+          <a:lstStyle/>
+          <a:p>
+            <a:r>
+              <a:rPr lang="en-US" dirty="0"/>
+              <a:t/>
+            </a:r>
+            <a:endParaRPr lang="en-US" dirty="0"/>
+          </a:p>
+        </p:txBody>
+      </p:sp>
+      <p:sp>
+        <p:nvSpPr>
+          <p:cNvPr id="4" name="Slide Number Placeholder 3"/>
+          <p:cNvSpPr>
+            <a:spLocks noGrp="1"/>
+          </p:cNvSpPr>
+          <p:nvPr>
+            <p:ph type="sldNum" sz="quarter" idx="10"/>
+          </p:nvPr>
+        </p:nvSpPr>
+        <p:spPr/>
+        <p:txBody>
+          <a:bodyPr/>
+          <a:lstStyle/>
+          <a:p>
+            <a:fld id="{F7021451-1387-4CA6-816F-3879F97B5CBC}" type="slidenum">
+              <a:rPr lang="en-US"/>
+              <a:t>38</a:t>
             </a:fld>
             <a:endParaRPr lang="en-US"/>
           </a:p>
@@ -9134,7 +9401,7 @@
                   <a:srgbClr val="003366"/>
                 </a:solidFill>
               </a:rPr>
-              <a:t>Lampiran: Simulasi Sederhana Classical Markowitz (2 Aset)</a:t>
+              <a:t>Lampiran: Contoh Sederhana Equally Weighted (EW)</a:t>
             </a:r>
             <a:endParaRPr lang="en-US" sz="2400" dirty="0"/>
           </a:p>
@@ -9165,262 +9432,212 @@
               <a:buNone/>
             </a:pPr>
             <a:r>
-              <a:rPr lang="en-US" sz="1600" b="1" dirty="0">
-                <a:solidFill>
-                  <a:srgbClr val="333333"/>
-                </a:solidFill>
-              </a:rPr>
-              <a:t>Tujuan: Mencari bobot (w) untuk risiko terendah (Minimum Variance).</a:t>
-            </a:r>
-            <a:endParaRPr lang="en-US" sz="1600" dirty="0"/>
-          </a:p>
-          <a:p>
-            <a:pPr indent="0" marL="0">
-              <a:buNone/>
-            </a:pPr>
-            <a:r>
-              <a:rPr lang="en-US" sz="1600" b="1" dirty="0">
+              <a:rPr lang="en-US" sz="1800" b="1" dirty="0">
+                <a:solidFill>
+                  <a:srgbClr val="333333"/>
+                </a:solidFill>
+              </a:rPr>
+              <a:t>Strategi 1/N: Alokasi Tanpa Rumit</a:t>
+            </a:r>
+            <a:endParaRPr lang="en-US" sz="1800" dirty="0"/>
+          </a:p>
+          <a:p>
+            <a:pPr indent="0" marL="0">
+              <a:buNone/>
+            </a:pPr>
+            <a:r>
+              <a:rPr lang="en-US" sz="1800" b="1" dirty="0">
                 <a:solidFill>
                   <a:srgbClr val="003366"/>
                 </a:solidFill>
               </a:rPr>
-              <a:t>1. Data Input (Dummy):</a:t>
-            </a:r>
-            <a:endParaRPr lang="en-US" sz="1600" dirty="0"/>
-          </a:p>
-          <a:p>
-            <a:pPr indent="0" marL="0">
-              <a:buNone/>
-            </a:pPr>
-            <a:r>
-              <a:rPr lang="en-US" sz="1600" dirty="0">
-                <a:solidFill>
-                  <a:srgbClr val="333333"/>
-                </a:solidFill>
-              </a:rPr>
-              <a:t>   • Aset A (BTC): Volatilitas (σ₁) = 20% (0.20)</a:t>
-            </a:r>
-            <a:endParaRPr lang="en-US" sz="1600" dirty="0"/>
-          </a:p>
-          <a:p>
-            <a:pPr indent="0" marL="0">
-              <a:buNone/>
-            </a:pPr>
-            <a:r>
-              <a:rPr lang="en-US" sz="1600" dirty="0">
-                <a:solidFill>
-                  <a:srgbClr val="333333"/>
-                </a:solidFill>
-              </a:rPr>
-              <a:t>   • Aset B (ETH): Volatilitas (σ₂) = 30% (0.30)</a:t>
-            </a:r>
-            <a:endParaRPr lang="en-US" sz="1600" dirty="0"/>
-          </a:p>
-          <a:p>
-            <a:pPr indent="0" marL="0">
-              <a:buNone/>
-            </a:pPr>
-            <a:r>
-              <a:rPr lang="en-US" sz="1600" dirty="0">
-                <a:solidFill>
-                  <a:srgbClr val="333333"/>
-                </a:solidFill>
-              </a:rPr>
-              <a:t>   • Korelasi (ρ₁₂): 0.50 (Didapat dari return harian historis)</a:t>
-            </a:r>
-            <a:endParaRPr lang="en-US" sz="1600" dirty="0"/>
-          </a:p>
-          <a:p>
-            <a:pPr indent="0" marL="0">
-              <a:buNone/>
-            </a:pPr>
-            <a:r>
-              <a:rPr lang="en-US" sz="1600" b="1" dirty="0">
-                <a:solidFill>
-                  <a:srgbClr val="333333"/>
-                </a:solidFill>
-              </a:rPr>
-              <a:t>   • Kovarians (σ₁₂): </a:t>
-            </a:r>
-            <a:pPr indent="0" marL="0">
-              <a:buNone/>
-            </a:pPr>
-            <a:r>
-              <a:rPr lang="en-US" sz="1600" i="1" dirty="0">
-                <a:solidFill>
-                  <a:srgbClr val="333333"/>
-                </a:solidFill>
-              </a:rPr>
-              <a:t>ρ₁₂ × σ₁ × σ₂</a:t>
-            </a:r>
-            <a:pPr indent="0" marL="0">
-              <a:buNone/>
-            </a:pPr>
-            <a:r>
-              <a:rPr lang="en-US" sz="1600" dirty="0">
-                <a:solidFill>
-                  <a:srgbClr val="333333"/>
-                </a:solidFill>
-              </a:rPr>
-              <a:t> = 0.50 × 0.20 × 0.30 = </a:t>
-            </a:r>
-            <a:pPr indent="0" marL="0">
-              <a:buNone/>
-            </a:pPr>
-            <a:r>
-              <a:rPr lang="en-US" sz="1600" b="1" dirty="0">
-                <a:solidFill>
-                  <a:srgbClr val="333333"/>
-                </a:solidFill>
-              </a:rPr>
-              <a:t>0.03</a:t>
-            </a:r>
-            <a:endParaRPr lang="en-US" sz="1600" dirty="0"/>
-          </a:p>
-          <a:p>
-            <a:pPr indent="0" marL="0">
-              <a:buNone/>
-            </a:pPr>
-            <a:r>
-              <a:rPr lang="en-US" sz="1600" b="1" dirty="0">
+              <a:t>1. Logika Dasar:</a:t>
+            </a:r>
+            <a:endParaRPr lang="en-US" sz="1800" dirty="0"/>
+          </a:p>
+          <a:p>
+            <a:pPr indent="0" marL="0">
+              <a:buNone/>
+            </a:pPr>
+            <a:r>
+              <a:rPr lang="en-US" sz="1800" dirty="0">
+                <a:solidFill>
+                  <a:srgbClr val="333333"/>
+                </a:solidFill>
+              </a:rPr>
+              <a:t>   Membagi seluruh modal secara merata tanpa melihat performa masa lalu.</a:t>
+            </a:r>
+            <a:endParaRPr lang="en-US" sz="1800" dirty="0"/>
+          </a:p>
+          <a:p>
+            <a:pPr indent="0" marL="0">
+              <a:buNone/>
+            </a:pPr>
+            <a:r>
+              <a:rPr lang="en-US" sz="1800" b="1" dirty="0">
                 <a:solidFill>
                   <a:srgbClr val="003366"/>
                 </a:solidFill>
               </a:rPr>
-              <a:t>2. Rumus Bobot Aset A (w₁):</a:t>
-            </a:r>
-            <a:endParaRPr lang="en-US" sz="1600" dirty="0"/>
-          </a:p>
-          <a:p>
-            <a:pPr indent="0" marL="0">
-              <a:buNone/>
-            </a:pPr>
-            <a:r>
-              <a:rPr lang="en-US" sz="1600" b="1" dirty="0">
+              <a:t>2. Simulasi (Dummy):</a:t>
+            </a:r>
+            <a:endParaRPr lang="en-US" sz="1800" dirty="0"/>
+          </a:p>
+          <a:p>
+            <a:pPr indent="0" marL="0">
+              <a:buNone/>
+            </a:pPr>
+            <a:r>
+              <a:rPr lang="en-US" sz="1800" dirty="0">
+                <a:solidFill>
+                  <a:srgbClr val="333333"/>
+                </a:solidFill>
+              </a:rPr>
+              <a:t>   • Total Modal: Rp 100.000.000</a:t>
+            </a:r>
+            <a:endParaRPr lang="en-US" sz="1800" dirty="0"/>
+          </a:p>
+          <a:p>
+            <a:pPr indent="0" marL="0">
+              <a:buNone/>
+            </a:pPr>
+            <a:r>
+              <a:rPr lang="en-US" sz="1800" dirty="0">
+                <a:solidFill>
+                  <a:srgbClr val="333333"/>
+                </a:solidFill>
+              </a:rPr>
+              <a:t>   • Jumlah Aset (N): 5 (BTC, ETH, XRP, LTC, USDT)</a:t>
+            </a:r>
+            <a:endParaRPr lang="en-US" sz="1800" dirty="0"/>
+          </a:p>
+          <a:p>
+            <a:pPr indent="0" marL="0">
+              <a:buNone/>
+            </a:pPr>
+            <a:r>
+              <a:rPr lang="en-US" sz="1800" dirty="0">
+                <a:solidFill>
+                  <a:srgbClr val="333333"/>
+                </a:solidFill>
+              </a:rPr>
+              <a:t>   • Bobot Tiap Aset: 1/5 = </a:t>
+            </a:r>
+            <a:pPr indent="0" marL="0">
+              <a:buNone/>
+            </a:pPr>
+            <a:r>
+              <a:rPr lang="en-US" sz="1800" b="1" dirty="0">
+                <a:solidFill>
+                  <a:srgbClr val="27AE60"/>
+                </a:solidFill>
+              </a:rPr>
+              <a:t>20%</a:t>
+            </a:r>
+            <a:pPr indent="0" marL="0">
+              <a:buNone/>
+            </a:pPr>
+            <a:r>
+              <a:rPr lang="en-US" sz="1800" dirty="0">
+                <a:solidFill>
+                  <a:srgbClr val="333333"/>
+                </a:solidFill>
+              </a:rPr>
+              <a:t> (Tetap)</a:t>
+            </a:r>
+            <a:endParaRPr lang="en-US" sz="1800" dirty="0"/>
+          </a:p>
+          <a:p>
+            <a:pPr indent="0" marL="0">
+              <a:buNone/>
+            </a:pPr>
+            <a:r>
+              <a:rPr lang="en-US" sz="1800" b="1" dirty="0">
+                <a:solidFill>
+                  <a:srgbClr val="003366"/>
+                </a:solidFill>
+              </a:rPr>
+              <a:t>3. Sebaran Modal:</a:t>
+            </a:r>
+            <a:endParaRPr lang="en-US" sz="1800" dirty="0"/>
+          </a:p>
+          <a:p>
+            <a:pPr indent="0" marL="0">
+              <a:buNone/>
+            </a:pPr>
+            <a:r>
+              <a:rPr lang="en-US" sz="1800" dirty="0">
+                <a:solidFill>
+                  <a:srgbClr val="333333"/>
+                </a:solidFill>
+              </a:rPr>
+              <a:t>   • BTC: Rp 20jt | ETH: Rp 20jt | XRP: Rp 20jt | dst.</a:t>
+            </a:r>
+            <a:endParaRPr lang="en-US" sz="1800" dirty="0"/>
+          </a:p>
+          <a:p>
+            <a:pPr indent="0" marL="0">
+              <a:buNone/>
+            </a:pPr>
+            <a:r>
+              <a:rPr lang="en-US" sz="1800" b="1" dirty="0">
                 <a:solidFill>
                   <a:srgbClr val="C0392B"/>
                 </a:solidFill>
-                <a:latin typeface="Courier New" pitchFamily="34" charset="0"/>
-                <a:ea typeface="Courier New" pitchFamily="34" charset="-122"/>
-                <a:cs typeface="Courier New" pitchFamily="34" charset="-120"/>
-              </a:rPr>
-              <a:t>   w₁ = (σ₂² - Cov) / (σ₁² + σ₂² - 2·Cov)</a:t>
-            </a:r>
-            <a:endParaRPr lang="en-US" sz="1600" dirty="0"/>
-          </a:p>
-          <a:p>
-            <a:pPr indent="0" marL="0">
-              <a:buNone/>
-            </a:pPr>
-            <a:r>
-              <a:rPr lang="en-US" sz="1600" dirty="0">
-                <a:solidFill>
-                  <a:srgbClr val="333333"/>
-                </a:solidFill>
-                <a:latin typeface="Courier New" pitchFamily="34" charset="0"/>
-                <a:ea typeface="Courier New" pitchFamily="34" charset="-122"/>
-                <a:cs typeface="Courier New" pitchFamily="34" charset="-120"/>
-              </a:rPr>
-              <a:t>   w₁ = (0.09 - 0.03) / (0.04 + 0.09 - 0.06)</a:t>
-            </a:r>
-            <a:endParaRPr lang="en-US" sz="1600" dirty="0"/>
-          </a:p>
-          <a:p>
-            <a:pPr indent="0" marL="0">
-              <a:buNone/>
-            </a:pPr>
-            <a:r>
-              <a:rPr lang="en-US" sz="1600" dirty="0">
-                <a:solidFill>
-                  <a:srgbClr val="333333"/>
-                </a:solidFill>
-                <a:latin typeface="Courier New" pitchFamily="34" charset="0"/>
-                <a:ea typeface="Courier New" pitchFamily="34" charset="-122"/>
-                <a:cs typeface="Courier New" pitchFamily="34" charset="-120"/>
-              </a:rPr>
-              <a:t>   w₁ = 0.06 / 0.07 ≈ </a:t>
-            </a:r>
-            <a:pPr indent="0" marL="0">
-              <a:buNone/>
-            </a:pPr>
-            <a:r>
-              <a:rPr lang="en-US" sz="1600" b="1" dirty="0">
-                <a:solidFill>
-                  <a:srgbClr val="27AE60"/>
-                </a:solidFill>
-              </a:rPr>
-              <a:t>0.85 (85%)</a:t>
-            </a:r>
-            <a:endParaRPr lang="en-US" sz="1600" dirty="0"/>
-          </a:p>
-          <a:p>
-            <a:pPr indent="0" marL="0">
-              <a:buNone/>
-            </a:pPr>
-            <a:r>
-              <a:rPr lang="en-US" sz="1600" b="1" dirty="0">
-                <a:solidFill>
-                  <a:srgbClr val="003366"/>
-                </a:solidFill>
-              </a:rPr>
-              <a:t>3. Hasil Alokasi:</a:t>
-            </a:r>
-            <a:endParaRPr lang="en-US" sz="1600" dirty="0"/>
-          </a:p>
-          <a:p>
-            <a:pPr marL="342900" indent="-342900">
-              <a:buSzPct val="100000"/>
-              <a:buChar char="•"/>
-            </a:pPr>
-            <a:r>
-              <a:rPr lang="en-US" sz="1600" dirty="0">
-                <a:solidFill>
-                  <a:srgbClr val="333333"/>
-                </a:solidFill>
-              </a:rPr>
-              <a:t>   • Bobot BTC: 85%</a:t>
-            </a:r>
-            <a:endParaRPr lang="en-US" sz="1600" dirty="0"/>
-          </a:p>
-          <a:p>
-            <a:pPr marL="342900" indent="-342900">
-              <a:buSzPct val="100000"/>
-              <a:buChar char="•"/>
-            </a:pPr>
-            <a:r>
-              <a:rPr lang="en-US" sz="1600" dirty="0">
-                <a:solidFill>
-                  <a:srgbClr val="333333"/>
-                </a:solidFill>
-              </a:rPr>
-              <a:t>   • Bobot ETH: 15%</a:t>
-            </a:r>
-            <a:pPr indent="0" marL="0">
-              <a:buNone/>
-            </a:pPr>
-            <a:r>
-              <a:rPr lang="en-US" sz="1600" b="1" dirty="0">
-                <a:solidFill>
-                  <a:srgbClr val="C0392B"/>
-                </a:solidFill>
-              </a:rPr>
-              <a:t>Kesimpulan Klasik:</a:t>
-            </a:r>
-            <a:endParaRPr lang="en-US" sz="1600" dirty="0"/>
-          </a:p>
-          <a:p>
-            <a:pPr indent="0" marL="0">
-              <a:buNone/>
-            </a:pPr>
-            <a:r>
-              <a:rPr lang="en-US" sz="1600" i="1" dirty="0">
-                <a:solidFill>
-                  <a:srgbClr val="333333"/>
-                </a:solidFill>
-              </a:rPr>
-              <a:t>Markowitz akan memilih aset dengan volatilitas lebih rendah (BTC) secara dominan. Namun, jika angka σ₁ dan σ₂ ini mengandung "noise", maka alokasi ini menjadi tidak optimal (Over-concentration).</a:t>
-            </a:r>
-            <a:endParaRPr lang="en-US" sz="1600" dirty="0"/>
+              </a:rPr>
+              <a:t>4. Mengapa EW Masuk Baseline?</a:t>
+            </a:r>
+            <a:endParaRPr lang="en-US" sz="1800" dirty="0"/>
+          </a:p>
+          <a:p>
+            <a:pPr indent="0" marL="0">
+              <a:buNone/>
+            </a:pPr>
+            <a:r>
+              <a:rPr lang="en-US" sz="1800" dirty="0">
+                <a:solidFill>
+                  <a:srgbClr val="333333"/>
+                </a:solidFill>
+              </a:rPr>
+              <a:t>   • Tidak menderita </a:t>
+            </a:r>
+            <a:pPr indent="0" marL="0">
+              <a:buNone/>
+            </a:pPr>
+            <a:r>
+              <a:rPr lang="en-US" sz="1800" b="1" dirty="0">
+                <a:solidFill>
+                  <a:srgbClr val="333333"/>
+                </a:solidFill>
+              </a:rPr>
+              <a:t>error estimasi</a:t>
+            </a:r>
+            <a:pPr indent="0" marL="0">
+              <a:buNone/>
+            </a:pPr>
+            <a:r>
+              <a:rPr lang="en-US" sz="1800" dirty="0">
+                <a:solidFill>
+                  <a:srgbClr val="333333"/>
+                </a:solidFill>
+              </a:rPr>
+              <a:t> karena tidak menghitung korelasi.</a:t>
+            </a:r>
+            <a:endParaRPr lang="en-US" sz="1800" dirty="0"/>
+          </a:p>
+          <a:p>
+            <a:pPr indent="0" marL="0">
+              <a:buNone/>
+            </a:pPr>
+            <a:r>
+              <a:rPr lang="en-US" sz="1800" i="1" dirty="0">
+                <a:solidFill>
+                  <a:srgbClr val="333333"/>
+                </a:solidFill>
+              </a:rPr>
+              <a:t>   • Benchmark yang sangat tangguh; model kompleks harus bisa mengalahkan EW untuk dianggap valid.</a:t>
+            </a:r>
+            <a:endParaRPr lang="en-US" sz="1800" dirty="0"/>
           </a:p>
         </p:txBody>
       </p:sp>
@@ -9825,14 +10042,14 @@
               <a:buNone/>
             </a:pPr>
             <a:r>
-              <a:rPr lang="en-US" sz="2600" b="1" dirty="0">
+              <a:rPr lang="en-US" sz="2400" b="1" dirty="0">
                 <a:solidFill>
                   <a:srgbClr val="003366"/>
                 </a:solidFill>
               </a:rPr>
-              <a:t>Lampiran: Dua Tipe Pendekatan Grid Search</a:t>
-            </a:r>
-            <a:endParaRPr lang="en-US" sz="2600" dirty="0"/>
+              <a:t>Lampiran: Simulasi Sederhana Classical Markowitz (2 Aset)</a:t>
+            </a:r>
+            <a:endParaRPr lang="en-US" sz="2400" dirty="0"/>
           </a:p>
         </p:txBody>
       </p:sp>
@@ -9861,28 +10078,207 @@
               <a:buNone/>
             </a:pPr>
             <a:r>
-              <a:rPr lang="en-US" sz="1800" b="1" dirty="0">
-                <a:solidFill>
-                  <a:srgbClr val="333333"/>
-                </a:solidFill>
-              </a:rPr>
-              <a:t>Dua Objektif Optimasi (Return vs Risk):</a:t>
-            </a:r>
-            <a:endParaRPr lang="en-US" sz="1800" dirty="0"/>
-          </a:p>
-          <a:p>
-            <a:pPr indent="0" marL="0">
-              <a:buNone/>
-            </a:pPr>
-            <a:r>
-              <a:rPr lang="en-US" sz="1800" b="1" dirty="0">
+              <a:rPr lang="en-US" sz="1600" b="1" dirty="0">
+                <a:solidFill>
+                  <a:srgbClr val="333333"/>
+                </a:solidFill>
+              </a:rPr>
+              <a:t>Tujuan: Mencari bobot (w) untuk risiko terendah (Minimum Variance).</a:t>
+            </a:r>
+            <a:endParaRPr lang="en-US" sz="1600" dirty="0"/>
+          </a:p>
+          <a:p>
+            <a:pPr indent="0" marL="0">
+              <a:buNone/>
+            </a:pPr>
+            <a:r>
+              <a:rPr lang="en-US" sz="1600" b="1" dirty="0">
+                <a:solidFill>
+                  <a:srgbClr val="003366"/>
+                </a:solidFill>
+              </a:rPr>
+              <a:t>1. Data Input (Dummy):</a:t>
+            </a:r>
+            <a:endParaRPr lang="en-US" sz="1600" dirty="0"/>
+          </a:p>
+          <a:p>
+            <a:pPr indent="0" marL="0">
+              <a:buNone/>
+            </a:pPr>
+            <a:r>
+              <a:rPr lang="en-US" sz="1600" dirty="0">
+                <a:solidFill>
+                  <a:srgbClr val="333333"/>
+                </a:solidFill>
+              </a:rPr>
+              <a:t>   • Aset A (BTC): Volatilitas (σ₁) = 20% (0.20)</a:t>
+            </a:r>
+            <a:endParaRPr lang="en-US" sz="1600" dirty="0"/>
+          </a:p>
+          <a:p>
+            <a:pPr indent="0" marL="0">
+              <a:buNone/>
+            </a:pPr>
+            <a:r>
+              <a:rPr lang="en-US" sz="1600" dirty="0">
+                <a:solidFill>
+                  <a:srgbClr val="333333"/>
+                </a:solidFill>
+              </a:rPr>
+              <a:t>   • Aset B (ETH): Volatilitas (σ₂) = 30% (0.30)</a:t>
+            </a:r>
+            <a:endParaRPr lang="en-US" sz="1600" dirty="0"/>
+          </a:p>
+          <a:p>
+            <a:pPr indent="0" marL="0">
+              <a:buNone/>
+            </a:pPr>
+            <a:r>
+              <a:rPr lang="en-US" sz="1600" dirty="0">
+                <a:solidFill>
+                  <a:srgbClr val="333333"/>
+                </a:solidFill>
+              </a:rPr>
+              <a:t>   • Korelasi (ρ₁₂): 0.50 (Didapat dari return harian historis)</a:t>
+            </a:r>
+            <a:endParaRPr lang="en-US" sz="1600" dirty="0"/>
+          </a:p>
+          <a:p>
+            <a:pPr indent="0" marL="0">
+              <a:buNone/>
+            </a:pPr>
+            <a:r>
+              <a:rPr lang="en-US" sz="1600" b="1" dirty="0">
+                <a:solidFill>
+                  <a:srgbClr val="333333"/>
+                </a:solidFill>
+              </a:rPr>
+              <a:t>   • Kovarians (σ₁₂): </a:t>
+            </a:r>
+            <a:pPr indent="0" marL="0">
+              <a:buNone/>
+            </a:pPr>
+            <a:r>
+              <a:rPr lang="en-US" sz="1600" i="1" dirty="0">
+                <a:solidFill>
+                  <a:srgbClr val="333333"/>
+                </a:solidFill>
+              </a:rPr>
+              <a:t>ρ₁₂ × σ₁ × σ₂</a:t>
+            </a:r>
+            <a:pPr indent="0" marL="0">
+              <a:buNone/>
+            </a:pPr>
+            <a:r>
+              <a:rPr lang="en-US" sz="1600" dirty="0">
+                <a:solidFill>
+                  <a:srgbClr val="333333"/>
+                </a:solidFill>
+              </a:rPr>
+              <a:t> = 0.50 × 0.20 × 0.30 = </a:t>
+            </a:r>
+            <a:pPr indent="0" marL="0">
+              <a:buNone/>
+            </a:pPr>
+            <a:r>
+              <a:rPr lang="en-US" sz="1600" b="1" dirty="0">
+                <a:solidFill>
+                  <a:srgbClr val="333333"/>
+                </a:solidFill>
+              </a:rPr>
+              <a:t>0.03</a:t>
+            </a:r>
+            <a:endParaRPr lang="en-US" sz="1600" dirty="0"/>
+          </a:p>
+          <a:p>
+            <a:pPr indent="0" marL="0">
+              <a:buNone/>
+            </a:pPr>
+            <a:r>
+              <a:rPr lang="en-US" sz="1600" b="1" dirty="0">
+                <a:solidFill>
+                  <a:srgbClr val="003366"/>
+                </a:solidFill>
+              </a:rPr>
+              <a:t>2. Rumus Bobot Aset A (w₁):</a:t>
+            </a:r>
+            <a:endParaRPr lang="en-US" sz="1600" dirty="0"/>
+          </a:p>
+          <a:p>
+            <a:pPr indent="0" marL="0">
+              <a:buNone/>
+            </a:pPr>
+            <a:r>
+              <a:rPr lang="en-US" sz="1600" b="1" dirty="0">
+                <a:solidFill>
+                  <a:srgbClr val="C0392B"/>
+                </a:solidFill>
+                <a:latin typeface="Courier New" pitchFamily="34" charset="0"/>
+                <a:ea typeface="Courier New" pitchFamily="34" charset="-122"/>
+                <a:cs typeface="Courier New" pitchFamily="34" charset="-120"/>
+              </a:rPr>
+              <a:t>   w₁ = (σ₂² - Cov) / (σ₁² + σ₂² - 2·Cov)</a:t>
+            </a:r>
+            <a:endParaRPr lang="en-US" sz="1600" dirty="0"/>
+          </a:p>
+          <a:p>
+            <a:pPr indent="0" marL="0">
+              <a:buNone/>
+            </a:pPr>
+            <a:r>
+              <a:rPr lang="en-US" sz="1600" dirty="0">
+                <a:solidFill>
+                  <a:srgbClr val="333333"/>
+                </a:solidFill>
+                <a:latin typeface="Courier New" pitchFamily="34" charset="0"/>
+                <a:ea typeface="Courier New" pitchFamily="34" charset="-122"/>
+                <a:cs typeface="Courier New" pitchFamily="34" charset="-120"/>
+              </a:rPr>
+              <a:t>   w₁ = (0.09 - 0.03) / (0.04 + 0.09 - 0.06)</a:t>
+            </a:r>
+            <a:endParaRPr lang="en-US" sz="1600" dirty="0"/>
+          </a:p>
+          <a:p>
+            <a:pPr indent="0" marL="0">
+              <a:buNone/>
+            </a:pPr>
+            <a:r>
+              <a:rPr lang="en-US" sz="1600" dirty="0">
+                <a:solidFill>
+                  <a:srgbClr val="333333"/>
+                </a:solidFill>
+                <a:latin typeface="Courier New" pitchFamily="34" charset="0"/>
+                <a:ea typeface="Courier New" pitchFamily="34" charset="-122"/>
+                <a:cs typeface="Courier New" pitchFamily="34" charset="-120"/>
+              </a:rPr>
+              <a:t>   w₁ = 0.06 / 0.07 ≈ </a:t>
+            </a:r>
+            <a:pPr indent="0" marL="0">
+              <a:buNone/>
+            </a:pPr>
+            <a:r>
+              <a:rPr lang="en-US" sz="1600" b="1" dirty="0">
                 <a:solidFill>
                   <a:srgbClr val="27AE60"/>
                 </a:solidFill>
               </a:rPr>
-              <a:t>1. Network Markowitz dengan Target Return (NW - Return Grid Search):</a:t>
-            </a:r>
-            <a:endParaRPr lang="en-US" sz="1800" dirty="0"/>
+              <a:t>0.85 (85%)</a:t>
+            </a:r>
+            <a:endParaRPr lang="en-US" sz="1600" dirty="0"/>
+          </a:p>
+          <a:p>
+            <a:pPr indent="0" marL="0">
+              <a:buNone/>
+            </a:pPr>
+            <a:r>
+              <a:rPr lang="en-US" sz="1600" b="1" dirty="0">
+                <a:solidFill>
+                  <a:srgbClr val="003366"/>
+                </a:solidFill>
+              </a:rPr>
+              <a:t>3. Hasil Alokasi:</a:t>
+            </a:r>
+            <a:endParaRPr lang="en-US" sz="1600" dirty="0"/>
           </a:p>
           <a:p>
             <a:pPr marL="342900" indent="-342900">
@@ -9890,36 +10286,14 @@
               <a:buChar char="•"/>
             </a:pPr>
             <a:r>
-              <a:rPr lang="en-US" sz="1800" dirty="0">
-                <a:solidFill>
-                  <a:srgbClr val="333333"/>
-                </a:solidFill>
-              </a:rPr>
-              <a:t>Memaksimalkan capaian </a:t>
-            </a:r>
-            <a:pPr indent="0" marL="0">
-              <a:buNone/>
-            </a:pPr>
-            <a:r>
-              <a:rPr lang="en-US" sz="1800" b="1" dirty="0">
-                <a:solidFill>
-                  <a:srgbClr val="333333"/>
-                </a:solidFill>
-              </a:rPr>
-              <a:t>imbal hasil</a:t>
-            </a:r>
-            <a:pPr indent="0" marL="0">
-              <a:buNone/>
-            </a:pPr>
-            <a:r>
-              <a:rPr lang="en-US" sz="1800" dirty="0">
-                <a:solidFill>
-                  <a:srgbClr val="333333"/>
-                </a:solidFill>
-              </a:rPr>
-              <a:t> portofolio.</a:t>
-            </a:r>
-            <a:endParaRPr lang="en-US" sz="1800" dirty="0"/>
+              <a:rPr lang="en-US" sz="1600" dirty="0">
+                <a:solidFill>
+                  <a:srgbClr val="333333"/>
+                </a:solidFill>
+              </a:rPr>
+              <a:t>   • Bobot BTC: 85%</a:t>
+            </a:r>
+            <a:endParaRPr lang="en-US" sz="1600" dirty="0"/>
           </a:p>
           <a:p>
             <a:pPr marL="342900" indent="-342900">
@@ -9927,124 +10301,39 @@
               <a:buChar char="•"/>
             </a:pPr>
             <a:r>
-              <a:rPr lang="en-US" sz="1800" dirty="0">
-                <a:solidFill>
-                  <a:srgbClr val="333333"/>
-                </a:solidFill>
-              </a:rPr>
-              <a:t>Lebih Agresif untuk mengeksploitasi reli pada pasar </a:t>
-            </a:r>
-            <a:pPr indent="0" marL="0">
-              <a:buNone/>
-            </a:pPr>
-            <a:r>
-              <a:rPr lang="en-US" sz="1800" b="1" dirty="0">
-                <a:solidFill>
-                  <a:srgbClr val="333333"/>
-                </a:solidFill>
-              </a:rPr>
-              <a:t>Bullish</a:t>
-            </a:r>
-            <a:pPr indent="0" marL="0">
-              <a:buNone/>
-            </a:pPr>
-            <a:r>
-              <a:rPr lang="en-US" sz="1800" dirty="0">
-                <a:solidFill>
-                  <a:srgbClr val="333333"/>
-                </a:solidFill>
-              </a:rPr>
-              <a:t>.</a:t>
-            </a:r>
-            <a:endParaRPr lang="en-US" sz="1800" dirty="0"/>
-          </a:p>
-          <a:p>
-            <a:pPr indent="0" marL="0">
-              <a:buNone/>
-            </a:pPr>
-            <a:r>
-              <a:rPr lang="en-US" sz="1800" b="1" dirty="0">
+              <a:rPr lang="en-US" sz="1600" dirty="0">
+                <a:solidFill>
+                  <a:srgbClr val="333333"/>
+                </a:solidFill>
+              </a:rPr>
+              <a:t>   • Bobot ETH: 15%</a:t>
+            </a:r>
+            <a:pPr indent="0" marL="0">
+              <a:buNone/>
+            </a:pPr>
+            <a:r>
+              <a:rPr lang="en-US" sz="1600" b="1" dirty="0">
                 <a:solidFill>
                   <a:srgbClr val="C0392B"/>
                 </a:solidFill>
               </a:rPr>
-              <a:t>2. Network Markowitz dengan Target Risiko (NW - Risk Grid Search):</a:t>
-            </a:r>
-            <a:endParaRPr lang="en-US" sz="1800" dirty="0"/>
-          </a:p>
-          <a:p>
-            <a:pPr marL="342900" indent="-342900">
-              <a:buSzPct val="100000"/>
-              <a:buChar char="•"/>
-            </a:pPr>
-            <a:r>
-              <a:rPr lang="en-US" sz="1800" dirty="0">
-                <a:solidFill>
-                  <a:srgbClr val="333333"/>
-                </a:solidFill>
-              </a:rPr>
-              <a:t>Menekan parameter </a:t>
-            </a:r>
-            <a:pPr indent="0" marL="0">
-              <a:buNone/>
-            </a:pPr>
-            <a:r>
-              <a:rPr lang="en-US" sz="1800" b="1" dirty="0">
-                <a:solidFill>
-                  <a:srgbClr val="333333"/>
-                </a:solidFill>
-              </a:rPr>
-              <a:t>risiko total</a:t>
-            </a:r>
-            <a:pPr indent="0" marL="0">
-              <a:buNone/>
-            </a:pPr>
-            <a:r>
-              <a:rPr lang="en-US" sz="1800" dirty="0">
-                <a:solidFill>
-                  <a:srgbClr val="333333"/>
-                </a:solidFill>
-              </a:rPr>
-              <a:t> hingga minimal.</a:t>
-            </a:r>
-            <a:endParaRPr lang="en-US" sz="1800" dirty="0"/>
-          </a:p>
-          <a:p>
-            <a:pPr marL="342900" indent="-342900">
-              <a:buSzPct val="100000"/>
-              <a:buChar char="•"/>
-            </a:pPr>
-            <a:r>
-              <a:rPr lang="en-US" sz="1800" dirty="0">
-                <a:solidFill>
-                  <a:srgbClr val="333333"/>
-                </a:solidFill>
-              </a:rPr>
-              <a:t>Lebih Defensif untuk meredam fluktuasi saat </a:t>
-            </a:r>
-            <a:pPr indent="0" marL="0">
-              <a:buNone/>
-            </a:pPr>
-            <a:r>
-              <a:rPr lang="en-US" sz="1800" b="1" dirty="0">
-                <a:solidFill>
-                  <a:srgbClr val="333333"/>
-                </a:solidFill>
-              </a:rPr>
-              <a:t>Crypto Winter</a:t>
-            </a:r>
-            <a:pPr indent="0" marL="0">
-              <a:buNone/>
-            </a:pPr>
-            <a:r>
-              <a:rPr lang="en-US" sz="1800" dirty="0">
-                <a:solidFill>
-                  <a:srgbClr val="333333"/>
-                </a:solidFill>
-              </a:rPr>
-              <a:t>.</a:t>
-            </a:r>
-            <a:endParaRPr lang="en-US" sz="1800" dirty="0"/>
+              <a:t>Kesimpulan Klasik:</a:t>
+            </a:r>
+            <a:endParaRPr lang="en-US" sz="1600" dirty="0"/>
+          </a:p>
+          <a:p>
+            <a:pPr indent="0" marL="0">
+              <a:buNone/>
+            </a:pPr>
+            <a:r>
+              <a:rPr lang="en-US" sz="1600" i="1" dirty="0">
+                <a:solidFill>
+                  <a:srgbClr val="333333"/>
+                </a:solidFill>
+              </a:rPr>
+              <a:t>Markowitz akan memilih aset dengan volatilitas lebih rendah (BTC) secara dominan. Namun, jika angka σ₁ dan σ₂ ini mengandung "noise", maka alokasi ini menjadi tidak optimal (Over-concentration).</a:t>
+            </a:r>
+            <a:endParaRPr lang="en-US" sz="1600" dirty="0"/>
           </a:p>
         </p:txBody>
       </p:sp>
@@ -10098,14 +10387,14 @@
               <a:buNone/>
             </a:pPr>
             <a:r>
-              <a:rPr lang="en-US" sz="2600" b="1" dirty="0">
+              <a:rPr lang="en-US" sz="2400" b="1" dirty="0">
                 <a:solidFill>
                   <a:srgbClr val="003366"/>
                 </a:solidFill>
               </a:rPr>
-              <a:t>Lampiran: Penanganan Data Kosong (Missing Values)</a:t>
-            </a:r>
-            <a:endParaRPr lang="en-US" sz="2600" dirty="0"/>
+              <a:t>Lampiran: Contoh GLasso (1/2: Korelasi)</a:t>
+            </a:r>
+            <a:endParaRPr lang="en-US" sz="2400" dirty="0"/>
           </a:p>
         </p:txBody>
       </p:sp>
@@ -10134,183 +10423,206 @@
               <a:buNone/>
             </a:pPr>
             <a:r>
-              <a:rPr lang="en-US" sz="1800" b="1" dirty="0">
-                <a:solidFill>
-                  <a:srgbClr val="C0392B"/>
-                </a:solidFill>
-              </a:rPr>
-              <a:t>Pertanyaan: </a:t>
-            </a:r>
-            <a:pPr indent="0" marL="0">
-              <a:buNone/>
-            </a:pPr>
-            <a:r>
-              <a:rPr lang="en-US" sz="1800" i="1" dirty="0">
-                <a:solidFill>
-                  <a:srgbClr val="333333"/>
-                </a:solidFill>
-              </a:rPr>
-              <a:t>"Beberapa koin seperti Binance/EOS belum rilis di awal 2017 sehingga datanya kosong. Bukankah backward-fill memalsukan harga dan merusak matriks?"</a:t>
-            </a:r>
-            <a:endParaRPr lang="en-US" sz="1800" dirty="0"/>
-          </a:p>
-          <a:p>
-            <a:pPr indent="0" marL="0">
-              <a:buNone/>
-            </a:pPr>
-            <a:r>
-              <a:rPr lang="en-US" sz="1800" b="1" dirty="0">
+              <a:rPr lang="en-US" sz="1600" b="1" dirty="0">
+                <a:solidFill>
+                  <a:srgbClr val="333333"/>
+                </a:solidFill>
+              </a:rPr>
+              <a:t>Tujuan: Membuang korelasi palsu (noise) untuk mendapatkan sinyal pasar murni.</a:t>
+            </a:r>
+            <a:endParaRPr lang="en-US" sz="1600" dirty="0"/>
+          </a:p>
+          <a:p>
+            <a:pPr indent="0" marL="0">
+              <a:buNone/>
+            </a:pPr>
+            <a:r>
+              <a:rPr lang="en-US" sz="1600" b="1" dirty="0">
+                <a:solidFill>
+                  <a:srgbClr val="003366"/>
+                </a:solidFill>
+              </a:rPr>
+              <a:t>1. Matriks Korelasi Sebelum GLasso (Dirty):</a:t>
+            </a:r>
+            <a:endParaRPr lang="en-US" sz="1600" dirty="0"/>
+          </a:p>
+          <a:p>
+            <a:pPr indent="0" marL="0">
+              <a:buNone/>
+            </a:pPr>
+            <a:r>
+              <a:rPr lang="en-US" sz="1600" dirty="0">
+                <a:solidFill>
+                  <a:srgbClr val="333333"/>
+                </a:solidFill>
+                <a:latin typeface="Courier New" pitchFamily="34" charset="0"/>
+                <a:ea typeface="Courier New" pitchFamily="34" charset="-122"/>
+                <a:cs typeface="Courier New" pitchFamily="34" charset="-120"/>
+              </a:rPr>
+              <a:t>          BTC    ETH    DOGE</a:t>
+            </a:r>
+            <a:endParaRPr lang="en-US" sz="1600" dirty="0"/>
+          </a:p>
+          <a:p>
+            <a:pPr indent="0" marL="0">
+              <a:buNone/>
+            </a:pPr>
+            <a:r>
+              <a:rPr lang="en-US" sz="1600" dirty="0">
+                <a:solidFill>
+                  <a:srgbClr val="333333"/>
+                </a:solidFill>
+                <a:latin typeface="Courier New" pitchFamily="34" charset="0"/>
+                <a:ea typeface="Courier New" pitchFamily="34" charset="-122"/>
+                <a:cs typeface="Courier New" pitchFamily="34" charset="-120"/>
+              </a:rPr>
+              <a:t>   BTC  [ 1.00   0.70   0.08 ]  &lt;-- 0.08 (Noise)</a:t>
+            </a:r>
+            <a:endParaRPr lang="en-US" sz="1600" dirty="0"/>
+          </a:p>
+          <a:p>
+            <a:pPr indent="0" marL="0">
+              <a:buNone/>
+            </a:pPr>
+            <a:r>
+              <a:rPr lang="en-US" sz="1600" dirty="0">
+                <a:solidFill>
+                  <a:srgbClr val="333333"/>
+                </a:solidFill>
+                <a:latin typeface="Courier New" pitchFamily="34" charset="0"/>
+                <a:ea typeface="Courier New" pitchFamily="34" charset="-122"/>
+                <a:cs typeface="Courier New" pitchFamily="34" charset="-120"/>
+              </a:rPr>
+              <a:t>   ETH  [ 0.70   1.00   0.05 ]  &lt;-- 0.05 (Noise)</a:t>
+            </a:r>
+            <a:endParaRPr lang="en-US" sz="1600" dirty="0"/>
+          </a:p>
+          <a:p>
+            <a:pPr indent="0" marL="0">
+              <a:buNone/>
+            </a:pPr>
+            <a:r>
+              <a:rPr lang="en-US" sz="1600" dirty="0">
+                <a:solidFill>
+                  <a:srgbClr val="333333"/>
+                </a:solidFill>
+                <a:latin typeface="Courier New" pitchFamily="34" charset="0"/>
+                <a:ea typeface="Courier New" pitchFamily="34" charset="-122"/>
+                <a:cs typeface="Courier New" pitchFamily="34" charset="-120"/>
+              </a:rPr>
+              <a:t>   DOGE [ 0.08   0.05   1.00 ]</a:t>
+            </a:r>
+            <a:endParaRPr lang="en-US" sz="1600" dirty="0"/>
+          </a:p>
+          <a:p>
+            <a:pPr indent="0" marL="0">
+              <a:buNone/>
+            </a:pPr>
+            <a:r>
+              <a:rPr lang="en-US" sz="1600" b="1" dirty="0">
+                <a:solidFill>
+                  <a:srgbClr val="003366"/>
+                </a:solidFill>
+              </a:rPr>
+              <a:t>2. Proses Penalti (λ):</a:t>
+            </a:r>
+            <a:endParaRPr lang="en-US" sz="1600" dirty="0"/>
+          </a:p>
+          <a:p>
+            <a:pPr indent="0" marL="0">
+              <a:buNone/>
+            </a:pPr>
+            <a:r>
+              <a:rPr lang="en-US" sz="1600" dirty="0">
+                <a:solidFill>
+                  <a:srgbClr val="333333"/>
+                </a:solidFill>
+              </a:rPr>
+              <a:t>   Algoritma GLasso menekan korelasi lemah menjadi nol.</a:t>
+            </a:r>
+            <a:endParaRPr lang="en-US" sz="1600" dirty="0"/>
+          </a:p>
+          <a:p>
+            <a:pPr indent="0" marL="0">
+              <a:buNone/>
+            </a:pPr>
+            <a:r>
+              <a:rPr lang="en-US" sz="1600" b="1" dirty="0">
+                <a:solidFill>
+                  <a:srgbClr val="003366"/>
+                </a:solidFill>
+              </a:rPr>
+              <a:t>3. Matriks Hasil GLasso (Clean/Sparse):</a:t>
+            </a:r>
+            <a:endParaRPr lang="en-US" sz="1600" dirty="0"/>
+          </a:p>
+          <a:p>
+            <a:pPr indent="0" marL="0">
+              <a:buNone/>
+            </a:pPr>
+            <a:r>
+              <a:rPr lang="en-US" sz="1600" dirty="0">
                 <a:solidFill>
                   <a:srgbClr val="27AE60"/>
                 </a:solidFill>
-              </a:rPr>
-              <a:t>Jawaban (Kenapa RMT sangat Krusial):</a:t>
-            </a:r>
-            <a:endParaRPr lang="en-US" sz="1800" dirty="0"/>
-          </a:p>
-          <a:p>
-            <a:pPr indent="0" marL="0">
-              <a:buNone/>
-            </a:pPr>
-            <a:r>
-              <a:rPr lang="en-US" sz="1800" dirty="0">
-                <a:solidFill>
-                  <a:srgbClr val="333333"/>
-                </a:solidFill>
-              </a:rPr>
-              <a:t>   1. Praktik pengisian data diam (</a:t>
-            </a:r>
-            <a:pPr indent="0" marL="0">
-              <a:buNone/>
-            </a:pPr>
-            <a:r>
-              <a:rPr lang="en-US" sz="1800" b="1" i="1" dirty="0">
-                <a:solidFill>
-                  <a:srgbClr val="333333"/>
-                </a:solidFill>
-              </a:rPr>
-              <a:t>backward fill</a:t>
-            </a:r>
-            <a:pPr indent="0" marL="0">
-              <a:buNone/>
-            </a:pPr>
-            <a:r>
-              <a:rPr lang="en-US" sz="1800" dirty="0">
-                <a:solidFill>
-                  <a:srgbClr val="333333"/>
-                </a:solidFill>
-              </a:rPr>
-              <a:t>) memang menciptakan rentetan nilai harga yang statis.</a:t>
-            </a:r>
-            <a:endParaRPr lang="en-US" sz="1800" dirty="0"/>
-          </a:p>
-          <a:p>
-            <a:pPr indent="0" marL="0">
-              <a:buNone/>
-            </a:pPr>
-            <a:r>
-              <a:rPr lang="en-US" sz="1800" dirty="0">
-                <a:solidFill>
-                  <a:srgbClr val="333333"/>
-                </a:solidFill>
-              </a:rPr>
-              <a:t>   2. Namun, kehebatan </a:t>
-            </a:r>
-            <a:pPr indent="0" marL="0">
-              <a:buNone/>
-            </a:pPr>
-            <a:r>
-              <a:rPr lang="en-US" sz="1800" b="1" dirty="0">
-                <a:solidFill>
-                  <a:srgbClr val="333333"/>
-                </a:solidFill>
-              </a:rPr>
-              <a:t>Random Matrix Theory (RMT)</a:t>
-            </a:r>
-            <a:pPr indent="0" marL="0">
-              <a:buNone/>
-            </a:pPr>
-            <a:r>
-              <a:rPr lang="en-US" sz="1800" dirty="0">
-                <a:solidFill>
-                  <a:srgbClr val="333333"/>
-                </a:solidFill>
-              </a:rPr>
-              <a:t> diuji di sini! Karena data yang datar sama sekali tidak punya korelasi nyata.</a:t>
-            </a:r>
-            <a:endParaRPr lang="en-US" sz="1800" dirty="0"/>
-          </a:p>
-          <a:p>
-            <a:pPr indent="0" marL="0">
-              <a:buNone/>
-            </a:pPr>
-            <a:r>
-              <a:rPr lang="en-US" sz="1800" dirty="0">
-                <a:solidFill>
-                  <a:srgbClr val="333333"/>
-                </a:solidFill>
-              </a:rPr>
-              <a:t>   3. RMT otomatis akan mendeteksi korelasi buatan tersebut sebagai probabilitas </a:t>
-            </a:r>
-            <a:pPr indent="0" marL="0">
-              <a:buNone/>
-            </a:pPr>
-            <a:r>
-              <a:rPr lang="en-US" sz="1800" b="1" i="1" dirty="0">
-                <a:solidFill>
-                  <a:srgbClr val="333333"/>
-                </a:solidFill>
-              </a:rPr>
-              <a:t>Noise Acak</a:t>
-            </a:r>
-            <a:pPr indent="0" marL="0">
-              <a:buNone/>
-            </a:pPr>
-            <a:r>
-              <a:rPr lang="en-US" sz="1800" dirty="0">
-                <a:solidFill>
-                  <a:srgbClr val="333333"/>
-                </a:solidFill>
-              </a:rPr>
-              <a:t>, lalu membuangnya menjadi 0.</a:t>
-            </a:r>
-            <a:endParaRPr lang="en-US" sz="1800" dirty="0"/>
-          </a:p>
-          <a:p>
-            <a:pPr indent="0" marL="0">
-              <a:buNone/>
-            </a:pPr>
-            <a:r>
-              <a:rPr lang="en-US" sz="1800" dirty="0">
-                <a:solidFill>
-                  <a:srgbClr val="333333"/>
-                </a:solidFill>
-              </a:rPr>
-              <a:t>   4. Hasilnya, matriks korelasi </a:t>
-            </a:r>
-            <a:pPr indent="0" marL="0">
-              <a:buNone/>
-            </a:pPr>
-            <a:r>
-              <a:rPr lang="en-US" sz="1800" b="1" dirty="0">
-                <a:solidFill>
-                  <a:srgbClr val="333333"/>
-                </a:solidFill>
-              </a:rPr>
-              <a:t>terselamatkan</a:t>
-            </a:r>
-            <a:pPr indent="0" marL="0">
-              <a:buNone/>
-            </a:pPr>
-            <a:r>
-              <a:rPr lang="en-US" sz="1800" dirty="0">
-                <a:solidFill>
-                  <a:srgbClr val="333333"/>
-                </a:solidFill>
-              </a:rPr>
-              <a:t> dan tidak tercemar oleh cacat kelengkapan data.</a:t>
-            </a:r>
-            <a:endParaRPr lang="en-US" sz="1800" dirty="0"/>
+                <a:latin typeface="Courier New" pitchFamily="34" charset="0"/>
+                <a:ea typeface="Courier New" pitchFamily="34" charset="-122"/>
+                <a:cs typeface="Courier New" pitchFamily="34" charset="-120"/>
+              </a:rPr>
+              <a:t>          BTC    ETH    DOGE</a:t>
+            </a:r>
+            <a:endParaRPr lang="en-US" sz="1600" dirty="0"/>
+          </a:p>
+          <a:p>
+            <a:pPr indent="0" marL="0">
+              <a:buNone/>
+            </a:pPr>
+            <a:r>
+              <a:rPr lang="en-US" sz="1600" dirty="0">
+                <a:solidFill>
+                  <a:srgbClr val="27AE60"/>
+                </a:solidFill>
+                <a:latin typeface="Courier New" pitchFamily="34" charset="0"/>
+                <a:ea typeface="Courier New" pitchFamily="34" charset="-122"/>
+                <a:cs typeface="Courier New" pitchFamily="34" charset="-120"/>
+              </a:rPr>
+              <a:t>   BTC  [ 1.00   0.65   0.00 ]</a:t>
+            </a:r>
+            <a:endParaRPr lang="en-US" sz="1600" dirty="0"/>
+          </a:p>
+          <a:p>
+            <a:pPr indent="0" marL="0">
+              <a:buNone/>
+            </a:pPr>
+            <a:r>
+              <a:rPr lang="en-US" sz="1600" dirty="0">
+                <a:solidFill>
+                  <a:srgbClr val="27AE60"/>
+                </a:solidFill>
+                <a:latin typeface="Courier New" pitchFamily="34" charset="0"/>
+                <a:ea typeface="Courier New" pitchFamily="34" charset="-122"/>
+                <a:cs typeface="Courier New" pitchFamily="34" charset="-120"/>
+              </a:rPr>
+              <a:t>   ETH  [ 0.65   1.00   0.00 ]</a:t>
+            </a:r>
+            <a:endParaRPr lang="en-US" sz="1600" dirty="0"/>
+          </a:p>
+          <a:p>
+            <a:pPr indent="0" marL="0">
+              <a:buNone/>
+            </a:pPr>
+            <a:r>
+              <a:rPr lang="en-US" sz="1600" dirty="0">
+                <a:solidFill>
+                  <a:srgbClr val="27AE60"/>
+                </a:solidFill>
+                <a:latin typeface="Courier New" pitchFamily="34" charset="0"/>
+                <a:ea typeface="Courier New" pitchFamily="34" charset="-122"/>
+                <a:cs typeface="Courier New" pitchFamily="34" charset="-120"/>
+              </a:rPr>
+              <a:t>   DOGE [ 0.00   0.00   1.00 ]</a:t>
+            </a:r>
+            <a:endParaRPr lang="en-US" sz="1600" dirty="0"/>
           </a:p>
         </p:txBody>
       </p:sp>
@@ -10364,14 +10676,14 @@
               <a:buNone/>
             </a:pPr>
             <a:r>
-              <a:rPr lang="en-US" sz="2600" b="1" dirty="0">
+              <a:rPr lang="en-US" sz="2400" b="1" dirty="0">
                 <a:solidFill>
                   <a:srgbClr val="003366"/>
                 </a:solidFill>
               </a:rPr>
-              <a:t>Lampiran: Mengapa Menyertakan Tether (USDT)? (1/2)</a:t>
-            </a:r>
-            <a:endParaRPr lang="en-US" sz="2600" dirty="0"/>
+              <a:t>Lampiran: Contoh GLasso (2/2: Dampak Bobot)</a:t>
+            </a:r>
+            <a:endParaRPr lang="en-US" sz="2400" dirty="0"/>
           </a:p>
         </p:txBody>
       </p:sp>
@@ -10402,11 +10714,142 @@
             <a:r>
               <a:rPr lang="en-US" sz="1800" b="1" dirty="0">
                 <a:solidFill>
+                  <a:srgbClr val="333333"/>
+                </a:solidFill>
+              </a:rPr>
+              <a:t>Bagaimana 'Pembersihan' mengubah alokasi modal?</a:t>
+            </a:r>
+            <a:endParaRPr lang="en-US" sz="1800" dirty="0"/>
+          </a:p>
+          <a:p>
+            <a:pPr indent="0" marL="0">
+              <a:buNone/>
+            </a:pPr>
+            <a:r>
+              <a:rPr lang="en-US" sz="1800" b="1" dirty="0">
+                <a:solidFill>
+                  <a:srgbClr val="003366"/>
+                </a:solidFill>
+              </a:rPr>
+              <a:t>4. Simulasi Perubahan Bobot (Weight Shift):</a:t>
+            </a:r>
+            <a:endParaRPr lang="en-US" sz="1800" dirty="0"/>
+          </a:p>
+          <a:p>
+            <a:pPr indent="0" marL="0">
+              <a:buNone/>
+            </a:pPr>
+            <a:r>
+              <a:rPr lang="en-US" sz="1800" b="1" dirty="0">
+                <a:solidFill>
+                  <a:srgbClr val="333333"/>
+                </a:solidFill>
+              </a:rPr>
+              <a:t>   • Alokasi Tanpa GLasso:</a:t>
+            </a:r>
+            <a:endParaRPr lang="en-US" sz="1800" dirty="0"/>
+          </a:p>
+          <a:p>
+            <a:pPr indent="0" marL="0">
+              <a:buNone/>
+            </a:pPr>
+            <a:r>
+              <a:rPr lang="en-US" sz="1800" dirty="0">
+                <a:solidFill>
+                  <a:srgbClr val="333333"/>
+                </a:solidFill>
+              </a:rPr>
+              <a:t>     BTC: 60%, ETH: 30%, </a:t>
+            </a:r>
+            <a:pPr indent="0" marL="0">
+              <a:buNone/>
+            </a:pPr>
+            <a:r>
+              <a:rPr lang="en-US" sz="1800" b="1" dirty="0">
+                <a:solidFill>
                   <a:srgbClr val="C0392B"/>
                 </a:solidFill>
               </a:rPr>
-              <a:t>Pertanyaan: </a:t>
-            </a:r>
+              <a:t>DOGE: 10%</a:t>
+            </a:r>
+            <a:pPr indent="0" marL="0">
+              <a:buNone/>
+            </a:pPr>
+            <a:r>
+              <a:rPr lang="en-US" sz="1800" dirty="0">
+                <a:solidFill>
+                  <a:srgbClr val="333333"/>
+                </a:solidFill>
+              </a:rPr>
+              <a:t> (Tertipu korelasi palsu).</a:t>
+            </a:r>
+            <a:endParaRPr lang="en-US" sz="1800" dirty="0"/>
+          </a:p>
+          <a:p>
+            <a:pPr indent="0" marL="0">
+              <a:buNone/>
+            </a:pPr>
+            <a:r>
+              <a:rPr lang="en-US" sz="1800" b="1" dirty="0">
+                <a:solidFill>
+                  <a:srgbClr val="333333"/>
+                </a:solidFill>
+              </a:rPr>
+              <a:t>   • Alokasi Dengan GLasso:</a:t>
+            </a:r>
+            <a:endParaRPr lang="en-US" sz="1800" dirty="0"/>
+          </a:p>
+          <a:p>
+            <a:pPr indent="0" marL="0">
+              <a:buNone/>
+            </a:pPr>
+            <a:r>
+              <a:rPr lang="en-US" sz="1800" dirty="0">
+                <a:solidFill>
+                  <a:srgbClr val="333333"/>
+                </a:solidFill>
+              </a:rPr>
+              <a:t>     BTC: 65%, ETH: 35%, </a:t>
+            </a:r>
+            <a:pPr indent="0" marL="0">
+              <a:buNone/>
+            </a:pPr>
+            <a:r>
+              <a:rPr lang="en-US" sz="1800" b="1" dirty="0">
+                <a:solidFill>
+                  <a:srgbClr val="27AE60"/>
+                </a:solidFill>
+              </a:rPr>
+              <a:t>DOGE: 0%</a:t>
+            </a:r>
+            <a:pPr indent="0" marL="0">
+              <a:buNone/>
+            </a:pPr>
+            <a:r>
+              <a:rPr lang="en-US" sz="1800" dirty="0">
+                <a:solidFill>
+                  <a:srgbClr val="333333"/>
+                </a:solidFill>
+              </a:rPr>
+              <a:t> (Fokus pada korelasi sejati).</a:t>
+            </a:r>
+            <a:endParaRPr lang="en-US" sz="1800" dirty="0"/>
+          </a:p>
+          <a:p>
+            <a:pPr indent="0" marL="0">
+              <a:buNone/>
+            </a:pPr>
+            <a:r>
+              <a:rPr lang="en-US" sz="1800" b="1" dirty="0">
+                <a:solidFill>
+                  <a:srgbClr val="27AE60"/>
+                </a:solidFill>
+              </a:rPr>
+              <a:t>Kesimpulan &amp; Manfaat:</a:t>
+            </a:r>
+            <a:endParaRPr lang="en-US" sz="1800" dirty="0"/>
+          </a:p>
+          <a:p>
             <a:pPr indent="0" marL="0">
               <a:buNone/>
             </a:pPr>
@@ -10416,95 +10859,7 @@
                   <a:srgbClr val="333333"/>
                 </a:solidFill>
               </a:rPr>
-              <a:t>"Tether (USDT) itu stablecoin yang nilainya selalu fix ke 1 USD. Apakah tidak berbuat curang?"</a:t>
-            </a:r>
-            <a:endParaRPr lang="en-US" sz="1800" dirty="0"/>
-          </a:p>
-          <a:p>
-            <a:pPr indent="0" marL="0">
-              <a:buNone/>
-            </a:pPr>
-            <a:r>
-              <a:rPr lang="en-US" sz="1800" b="1" dirty="0">
-                <a:solidFill>
-                  <a:srgbClr val="27AE60"/>
-                </a:solidFill>
-              </a:rPr>
-              <a:t>Jawaban (Dinamika Portofolio Cerdas):</a:t>
-            </a:r>
-            <a:endParaRPr lang="en-US" sz="1800" dirty="0"/>
-          </a:p>
-          <a:p>
-            <a:pPr marL="342900" indent="-342900">
-              <a:buSzPct val="100000"/>
-              <a:buChar char="•"/>
-            </a:pPr>
-            <a:r>
-              <a:rPr lang="en-US" sz="1800" dirty="0">
-                <a:solidFill>
-                  <a:srgbClr val="333333"/>
-                </a:solidFill>
-              </a:rPr>
-              <a:t>Model ini mensimulasikan perilaku </a:t>
-            </a:r>
-            <a:pPr indent="0" marL="0">
-              <a:buNone/>
-            </a:pPr>
-            <a:r>
-              <a:rPr lang="en-US" sz="1800" b="1" i="1" dirty="0">
-                <a:solidFill>
-                  <a:srgbClr val="333333"/>
-                </a:solidFill>
-              </a:rPr>
-              <a:t>Robo-Advisory</a:t>
-            </a:r>
-            <a:pPr indent="0" marL="0">
-              <a:buNone/>
-            </a:pPr>
-            <a:r>
-              <a:rPr lang="en-US" sz="1800" dirty="0">
-                <a:solidFill>
-                  <a:srgbClr val="333333"/>
-                </a:solidFill>
-              </a:rPr>
-              <a:t> institusional.</a:t>
-            </a:r>
-            <a:endParaRPr lang="en-US" sz="1800" dirty="0"/>
-          </a:p>
-          <a:p>
-            <a:pPr marL="342900" indent="-342900">
-              <a:buSzPct val="100000"/>
-              <a:buChar char="•"/>
-            </a:pPr>
-            <a:r>
-              <a:rPr lang="en-US" sz="1800" dirty="0">
-                <a:solidFill>
-                  <a:srgbClr val="333333"/>
-                </a:solidFill>
-              </a:rPr>
-              <a:t>Ketika pasar anjlok ekstrem, investor akan melarikan senjatanya ke posisi </a:t>
-            </a:r>
-            <a:pPr indent="0" marL="0">
-              <a:buNone/>
-            </a:pPr>
-            <a:r>
-              <a:rPr lang="en-US" sz="1800" b="1" dirty="0">
-                <a:solidFill>
-                  <a:srgbClr val="333333"/>
-                </a:solidFill>
-              </a:rPr>
-              <a:t>tunai (USDT)</a:t>
-            </a:r>
-            <a:pPr indent="0" marL="0">
-              <a:buNone/>
-            </a:pPr>
-            <a:r>
-              <a:rPr lang="en-US" sz="1800" dirty="0">
-                <a:solidFill>
-                  <a:srgbClr val="333333"/>
-                </a:solidFill>
-              </a:rPr>
-              <a:t> sebagai evakuasi risiko.</a:t>
+              <a:t>Pembersihan noise melalui GLasso memastikan modal tidak dialokasikan ke aset yang hanya terlihat menguntungkan secara statistik sesaat (spurious divergence), melainkan tetap pada struktur pasar yang kokoh.</a:t>
             </a:r>
             <a:endParaRPr lang="en-US" sz="1800" dirty="0"/>
           </a:p>
@@ -10565,7 +10920,7 @@
                   <a:srgbClr val="003366"/>
                 </a:solidFill>
               </a:rPr>
-              <a:t>Lampiran: Mengapa Menyertakan Tether (USDT)? (2/2)</a:t>
+              <a:t>Lampiran: Dua Tipe Pendekatan Grid Search</a:t>
             </a:r>
             <a:endParaRPr lang="en-US" sz="2600" dirty="0"/>
           </a:p>
@@ -10596,12 +10951,41 @@
               <a:buNone/>
             </a:pPr>
             <a:r>
+              <a:rPr lang="en-US" sz="1800" b="1" dirty="0">
+                <a:solidFill>
+                  <a:srgbClr val="333333"/>
+                </a:solidFill>
+              </a:rPr>
+              <a:t>Dua Objektif Optimasi (Return vs Risk):</a:t>
+            </a:r>
+            <a:endParaRPr lang="en-US" sz="1800" dirty="0"/>
+          </a:p>
+          <a:p>
+            <a:pPr indent="0" marL="0">
+              <a:buNone/>
+            </a:pPr>
+            <a:r>
+              <a:rPr lang="en-US" sz="1800" b="1" dirty="0">
+                <a:solidFill>
+                  <a:srgbClr val="27AE60"/>
+                </a:solidFill>
+              </a:rPr>
+              <a:t>1. Network Markowitz dengan Target Return (NW - Return Grid Search):</a:t>
+            </a:r>
+            <a:endParaRPr lang="en-US" sz="1800" dirty="0"/>
+          </a:p>
+          <a:p>
+            <a:pPr marL="342900" indent="-342900">
+              <a:buSzPct val="100000"/>
+              <a:buChar char="•"/>
+            </a:pPr>
+            <a:r>
               <a:rPr lang="en-US" sz="1800" dirty="0">
                 <a:solidFill>
                   <a:srgbClr val="333333"/>
                 </a:solidFill>
               </a:rPr>
-              <a:t>3. Algoritma jaringan </a:t>
+              <a:t>Memaksimalkan capaian </a:t>
             </a:r>
             <a:pPr indent="0" marL="0">
               <a:buNone/>
@@ -10612,7 +10996,7 @@
                   <a:srgbClr val="333333"/>
                 </a:solidFill>
               </a:rPr>
-              <a:t>Network Markowitz GS (Grid Search)</a:t>
+              <a:t>imbal hasil</a:t>
             </a:r>
             <a:pPr indent="0" marL="0">
               <a:buNone/>
@@ -10623,7 +11007,22 @@
                   <a:srgbClr val="333333"/>
                 </a:solidFill>
               </a:rPr>
-              <a:t> dilatih secara matematis; jika mendeteksi korelasi ancaman kolaps merambat ke semua altcoin, ia akan melempar alokasi modalnya menuju node </a:t>
+              <a:t> portofolio.</a:t>
+            </a:r>
+            <a:endParaRPr lang="en-US" sz="1800" dirty="0"/>
+          </a:p>
+          <a:p>
+            <a:pPr marL="342900" indent="-342900">
+              <a:buSzPct val="100000"/>
+              <a:buChar char="•"/>
+            </a:pPr>
+            <a:r>
+              <a:rPr lang="en-US" sz="1800" dirty="0">
+                <a:solidFill>
+                  <a:srgbClr val="333333"/>
+                </a:solidFill>
+              </a:rPr>
+              <a:t>Lebih Agresif untuk mengeksploitasi reli pada pasar </a:t>
             </a:r>
             <a:pPr indent="0" marL="0">
               <a:buNone/>
@@ -10634,7 +11033,7 @@
                   <a:srgbClr val="333333"/>
                 </a:solidFill>
               </a:rPr>
-              <a:t>USDT (Tether)</a:t>
+              <a:t>Bullish</a:t>
             </a:r>
             <a:pPr indent="0" marL="0">
               <a:buNone/>
@@ -10645,21 +11044,28 @@
                   <a:srgbClr val="333333"/>
                 </a:solidFill>
               </a:rPr>
-              <a:t> sebagai langkah </a:t>
-            </a:r>
+              <a:t>.</a:t>
+            </a:r>
+            <a:endParaRPr lang="en-US" sz="1800" dirty="0"/>
+          </a:p>
+          <a:p>
             <a:pPr indent="0" marL="0">
               <a:buNone/>
             </a:pPr>
             <a:r>
               <a:rPr lang="en-US" sz="1800" b="1" dirty="0">
                 <a:solidFill>
-                  <a:srgbClr val="333333"/>
-                </a:solidFill>
-              </a:rPr>
-              <a:t>evakuasi otomatis</a:t>
-            </a:r>
-            <a:pPr indent="0" marL="0">
-              <a:buNone/>
+                  <a:srgbClr val="C0392B"/>
+                </a:solidFill>
+              </a:rPr>
+              <a:t>2. Network Markowitz dengan Target Risiko (NW - Risk Grid Search):</a:t>
+            </a:r>
+            <a:endParaRPr lang="en-US" sz="1800" dirty="0"/>
+          </a:p>
+          <a:p>
+            <a:pPr marL="342900" indent="-342900">
+              <a:buSzPct val="100000"/>
+              <a:buChar char="•"/>
             </a:pPr>
             <a:r>
               <a:rPr lang="en-US" sz="1800" dirty="0">
@@ -10667,13 +11073,36 @@
                   <a:srgbClr val="333333"/>
                 </a:solidFill>
               </a:rPr>
-              <a:t> (Shock-Absorber).</a:t>
+              <a:t>Menekan parameter </a:t>
+            </a:r>
+            <a:pPr indent="0" marL="0">
+              <a:buNone/>
+            </a:pPr>
+            <a:r>
+              <a:rPr lang="en-US" sz="1800" b="1" dirty="0">
+                <a:solidFill>
+                  <a:srgbClr val="333333"/>
+                </a:solidFill>
+              </a:rPr>
+              <a:t>risiko total</a:t>
+            </a:r>
+            <a:pPr indent="0" marL="0">
+              <a:buNone/>
+            </a:pPr>
+            <a:r>
+              <a:rPr lang="en-US" sz="1800" dirty="0">
+                <a:solidFill>
+                  <a:srgbClr val="333333"/>
+                </a:solidFill>
+              </a:rPr>
+              <a:t> hingga minimal.</a:t>
             </a:r>
             <a:endParaRPr lang="en-US" sz="1800" dirty="0"/>
           </a:p>
           <a:p>
-            <a:pPr indent="0" marL="0">
-              <a:buNone/>
+            <a:pPr marL="342900" indent="-342900">
+              <a:buSzPct val="100000"/>
+              <a:buChar char="•"/>
             </a:pPr>
             <a:r>
               <a:rPr lang="en-US" sz="1800" dirty="0">
@@ -10681,7 +11110,7 @@
                   <a:srgbClr val="333333"/>
                 </a:solidFill>
               </a:rPr>
-              <a:t>   4. Hal ini yang membuat performa Risk-GS (Grid Search) sangat </a:t>
+              <a:t>Lebih Defensif untuk meredam fluktuasi saat </a:t>
             </a:r>
             <a:pPr indent="0" marL="0">
               <a:buNone/>
@@ -10692,7 +11121,7 @@
                   <a:srgbClr val="333333"/>
                 </a:solidFill>
               </a:rPr>
-              <a:t>tangguh</a:t>
+              <a:t>Crypto Winter</a:t>
             </a:r>
             <a:pPr indent="0" marL="0">
               <a:buNone/>
@@ -10703,7 +11132,7 @@
                   <a:srgbClr val="333333"/>
                 </a:solidFill>
               </a:rPr>
-              <a:t> dari serangan Crypto Winter, suatu kapabilitas pertahanan yang tidak dipahami oleh model ortodoks murni Markowitz.</a:t>
+              <a:t>.</a:t>
             </a:r>
             <a:endParaRPr lang="en-US" sz="1800" dirty="0"/>
           </a:p>
@@ -10764,7 +11193,7 @@
                   <a:srgbClr val="003366"/>
                 </a:solidFill>
               </a:rPr>
-              <a:t>Lampiran: Bukti Empiris Non-Stationarity Pasar</a:t>
+              <a:t>Lampiran: Penanganan Data Kosong (Missing Values)</a:t>
             </a:r>
             <a:endParaRPr lang="en-US" sz="2600" dirty="0"/>
           </a:p>
@@ -10800,7 +11229,7 @@
                   <a:srgbClr val="C0392B"/>
                 </a:solidFill>
               </a:rPr>
-              <a:t>Masalah: </a:t>
+              <a:t>Pertanyaan: </a:t>
             </a:r>
             <a:pPr indent="0" marL="0">
               <a:buNone/>
@@ -10811,7 +11240,7 @@
                   <a:srgbClr val="333333"/>
                 </a:solidFill>
               </a:rPr>
-              <a:t>Kenapa harus menggunakan model Adaptif (Dynamic Gamma)?</a:t>
+              <a:t>"Beberapa koin seperti Binance/EOS belum rilis di awal 2017 sehingga datanya kosong. Bukankah backward-fill memalsukan harga dan merusak matriks?"</a:t>
             </a:r>
             <a:endParaRPr lang="en-US" sz="1800" dirty="0"/>
           </a:p>
@@ -10825,14 +11254,13 @@
                   <a:srgbClr val="27AE60"/>
                 </a:solidFill>
               </a:rPr>
-              <a:t>Bukti dari Grid Search:</a:t>
+              <a:t>Jawaban (Kenapa RMT sangat Krusial):</a:t>
             </a:r>
             <a:endParaRPr lang="en-US" sz="1800" dirty="0"/>
           </a:p>
           <a:p>
-            <a:pPr marL="342900" indent="-342900">
-              <a:buSzPct val="100000"/>
-              <a:buChar char="•"/>
+            <a:pPr indent="0" marL="0">
+              <a:buNone/>
             </a:pPr>
             <a:r>
               <a:rPr lang="en-US" sz="1800" dirty="0">
@@ -10840,7 +11268,43 @@
                   <a:srgbClr val="333333"/>
                 </a:solidFill>
               </a:rPr>
-              <a:t>Data menunjukkan nilai Gamma (γ) optimal </a:t>
+              <a:t>   1. Praktik pengisian data diam (</a:t>
+            </a:r>
+            <a:pPr indent="0" marL="0">
+              <a:buNone/>
+            </a:pPr>
+            <a:r>
+              <a:rPr lang="en-US" sz="1800" b="1" i="1" dirty="0">
+                <a:solidFill>
+                  <a:srgbClr val="333333"/>
+                </a:solidFill>
+              </a:rPr>
+              <a:t>backward fill</a:t>
+            </a:r>
+            <a:pPr indent="0" marL="0">
+              <a:buNone/>
+            </a:pPr>
+            <a:r>
+              <a:rPr lang="en-US" sz="1800" dirty="0">
+                <a:solidFill>
+                  <a:srgbClr val="333333"/>
+                </a:solidFill>
+              </a:rPr>
+              <a:t>) memang menciptakan rentetan nilai harga yang statis.</a:t>
+            </a:r>
+            <a:endParaRPr lang="en-US" sz="1800" dirty="0"/>
+          </a:p>
+          <a:p>
+            <a:pPr indent="0" marL="0">
+              <a:buNone/>
+            </a:pPr>
+            <a:r>
+              <a:rPr lang="en-US" sz="1800" dirty="0">
+                <a:solidFill>
+                  <a:srgbClr val="333333"/>
+                </a:solidFill>
+              </a:rPr>
+              <a:t>   2. Namun, kehebatan </a:t>
             </a:r>
             <a:pPr indent="0" marL="0">
               <a:buNone/>
@@ -10851,7 +11315,7 @@
                   <a:srgbClr val="333333"/>
                 </a:solidFill>
               </a:rPr>
-              <a:t>terus bergeser</a:t>
+              <a:t>Random Matrix Theory (RMT)</a:t>
             </a:r>
             <a:pPr indent="0" marL="0">
               <a:buNone/>
@@ -10862,14 +11326,13 @@
                   <a:srgbClr val="333333"/>
                 </a:solidFill>
               </a:rPr>
-              <a:t> setiap periode rebalancing.</a:t>
+              <a:t> diuji di sini! Karena data yang datar sama sekali tidak punya korelasi nyata.</a:t>
             </a:r>
             <a:endParaRPr lang="en-US" sz="1800" dirty="0"/>
           </a:p>
           <a:p>
-            <a:pPr marL="342900" indent="-342900">
-              <a:buSzPct val="100000"/>
-              <a:buChar char="•"/>
+            <a:pPr indent="0" marL="0">
+              <a:buNone/>
             </a:pPr>
             <a:r>
               <a:rPr lang="en-US" sz="1800" dirty="0">
@@ -10877,7 +11340,43 @@
                   <a:srgbClr val="333333"/>
                 </a:solidFill>
               </a:rPr>
-              <a:t>Penggunaan γ statis tidak cukup untuk menangkap perubahan </a:t>
+              <a:t>   3. RMT otomatis akan mendeteksi korelasi buatan tersebut sebagai probabilitas </a:t>
+            </a:r>
+            <a:pPr indent="0" marL="0">
+              <a:buNone/>
+            </a:pPr>
+            <a:r>
+              <a:rPr lang="en-US" sz="1800" b="1" i="1" dirty="0">
+                <a:solidFill>
+                  <a:srgbClr val="333333"/>
+                </a:solidFill>
+              </a:rPr>
+              <a:t>Noise Acak</a:t>
+            </a:r>
+            <a:pPr indent="0" marL="0">
+              <a:buNone/>
+            </a:pPr>
+            <a:r>
+              <a:rPr lang="en-US" sz="1800" dirty="0">
+                <a:solidFill>
+                  <a:srgbClr val="333333"/>
+                </a:solidFill>
+              </a:rPr>
+              <a:t>, lalu membuangnya menjadi 0.</a:t>
+            </a:r>
+            <a:endParaRPr lang="en-US" sz="1800" dirty="0"/>
+          </a:p>
+          <a:p>
+            <a:pPr indent="0" marL="0">
+              <a:buNone/>
+            </a:pPr>
+            <a:r>
+              <a:rPr lang="en-US" sz="1800" dirty="0">
+                <a:solidFill>
+                  <a:srgbClr val="333333"/>
+                </a:solidFill>
+              </a:rPr>
+              <a:t>   4. Hasilnya, matriks korelasi </a:t>
             </a:r>
             <a:pPr indent="0" marL="0">
               <a:buNone/>
@@ -10888,7 +11387,7 @@
                   <a:srgbClr val="333333"/>
                 </a:solidFill>
               </a:rPr>
-              <a:t>struktur korelasi</a:t>
+              <a:t>terselamatkan</a:t>
             </a:r>
             <a:pPr indent="0" marL="0">
               <a:buNone/>
@@ -10899,44 +11398,7 @@
                   <a:srgbClr val="333333"/>
                 </a:solidFill>
               </a:rPr>
-              <a:t> yang sangat cepat di pasar kripto.</a:t>
-            </a:r>
-            <a:endParaRPr lang="en-US" sz="1800" dirty="0"/>
-          </a:p>
-          <a:p>
-            <a:pPr marL="342900" indent="-342900">
-              <a:buSzPct val="100000"/>
-              <a:buChar char="•"/>
-            </a:pPr>
-            <a:r>
-              <a:rPr lang="en-US" sz="1800" dirty="0">
-                <a:solidFill>
-                  <a:srgbClr val="333333"/>
-                </a:solidFill>
-              </a:rPr>
-              <a:t>Ini membenarkan bahwa pasar kripto membutuhkan </a:t>
-            </a:r>
-            <a:pPr indent="0" marL="0">
-              <a:buNone/>
-            </a:pPr>
-            <a:r>
-              <a:rPr lang="en-US" sz="1800" b="1" dirty="0">
-                <a:solidFill>
-                  <a:srgbClr val="333333"/>
-                </a:solidFill>
-              </a:rPr>
-              <a:t>kalibrasi otomatis</a:t>
-            </a:r>
-            <a:pPr indent="0" marL="0">
-              <a:buNone/>
-            </a:pPr>
-            <a:r>
-              <a:rPr lang="en-US" sz="1800" dirty="0">
-                <a:solidFill>
-                  <a:srgbClr val="333333"/>
-                </a:solidFill>
-              </a:rPr>
-              <a:t> secara temporal.</a:t>
+              <a:t> dan tidak tercemar oleh cacat kelengkapan data.</a:t>
             </a:r>
             <a:endParaRPr lang="en-US" sz="1800" dirty="0"/>
           </a:p>
@@ -10953,6 +11415,634 @@
 <file path=ppt/slides/slide35.xml><?xml version="1.0" encoding="utf-8"?>
 <p:sld xmlns:a="http://schemas.openxmlformats.org/drawingml/2006/main" xmlns:r="http://schemas.openxmlformats.org/officeDocument/2006/relationships" xmlns:p="http://schemas.openxmlformats.org/presentationml/2006/main">
   <p:cSld name="Slide 35">
+    <p:spTree>
+      <p:nvGrpSpPr>
+        <p:cNvPr id="1" name=""/>
+        <p:cNvGrpSpPr/>
+        <p:nvPr/>
+      </p:nvGrpSpPr>
+      <p:grpSpPr>
+        <a:xfrm>
+          <a:off x="0" y="0"/>
+          <a:ext cx="0" cy="0"/>
+          <a:chOff x="0" y="0"/>
+          <a:chExt cx="0" cy="0"/>
+        </a:xfrm>
+      </p:grpSpPr>
+      <p:sp>
+        <p:nvSpPr>
+          <p:cNvPr id="2" name="Text 0"/>
+          <p:cNvSpPr/>
+          <p:nvPr/>
+        </p:nvSpPr>
+        <p:spPr>
+          <a:xfrm>
+            <a:off x="457200" y="457200"/>
+            <a:ext cx="8229600" cy="0"/>
+          </a:xfrm>
+          <a:prstGeom prst="rect">
+            <a:avLst/>
+          </a:prstGeom>
+          <a:noFill/>
+          <a:ln/>
+        </p:spPr>
+        <p:txBody>
+          <a:bodyPr wrap="square" rtlCol="0" anchor="ctr"/>
+          <a:lstStyle/>
+          <a:p>
+            <a:pPr indent="0" marL="0">
+              <a:buNone/>
+            </a:pPr>
+            <a:r>
+              <a:rPr lang="en-US" sz="2600" b="1" dirty="0">
+                <a:solidFill>
+                  <a:srgbClr val="003366"/>
+                </a:solidFill>
+              </a:rPr>
+              <a:t>Lampiran: Mengapa Menyertakan Tether (USDT)? (1/2)</a:t>
+            </a:r>
+            <a:endParaRPr lang="en-US" sz="2600" dirty="0"/>
+          </a:p>
+        </p:txBody>
+      </p:sp>
+      <p:sp>
+        <p:nvSpPr>
+          <p:cNvPr id="3" name="Text 1"/>
+          <p:cNvSpPr/>
+          <p:nvPr/>
+        </p:nvSpPr>
+        <p:spPr>
+          <a:xfrm>
+            <a:off x="457200" y="1005840"/>
+            <a:ext cx="8229600" cy="5029200"/>
+          </a:xfrm>
+          <a:prstGeom prst="rect">
+            <a:avLst/>
+          </a:prstGeom>
+          <a:noFill/>
+          <a:ln/>
+        </p:spPr>
+        <p:txBody>
+          <a:bodyPr wrap="square" rtlCol="0" anchor="t"/>
+          <a:lstStyle/>
+          <a:p>
+            <a:pPr indent="0" marL="0">
+              <a:buNone/>
+            </a:pPr>
+            <a:r>
+              <a:rPr lang="en-US" sz="1800" b="1" dirty="0">
+                <a:solidFill>
+                  <a:srgbClr val="C0392B"/>
+                </a:solidFill>
+              </a:rPr>
+              <a:t>Pertanyaan: </a:t>
+            </a:r>
+            <a:pPr indent="0" marL="0">
+              <a:buNone/>
+            </a:pPr>
+            <a:r>
+              <a:rPr lang="en-US" sz="1800" i="1" dirty="0">
+                <a:solidFill>
+                  <a:srgbClr val="333333"/>
+                </a:solidFill>
+              </a:rPr>
+              <a:t>"Tether (USDT) itu stablecoin yang nilainya selalu fix ke 1 USD. Apakah tidak berbuat curang?"</a:t>
+            </a:r>
+            <a:endParaRPr lang="en-US" sz="1800" dirty="0"/>
+          </a:p>
+          <a:p>
+            <a:pPr indent="0" marL="0">
+              <a:buNone/>
+            </a:pPr>
+            <a:r>
+              <a:rPr lang="en-US" sz="1800" b="1" dirty="0">
+                <a:solidFill>
+                  <a:srgbClr val="27AE60"/>
+                </a:solidFill>
+              </a:rPr>
+              <a:t>Jawaban (Dinamika Portofolio Cerdas):</a:t>
+            </a:r>
+            <a:endParaRPr lang="en-US" sz="1800" dirty="0"/>
+          </a:p>
+          <a:p>
+            <a:pPr marL="342900" indent="-342900">
+              <a:buSzPct val="100000"/>
+              <a:buChar char="•"/>
+            </a:pPr>
+            <a:r>
+              <a:rPr lang="en-US" sz="1800" dirty="0">
+                <a:solidFill>
+                  <a:srgbClr val="333333"/>
+                </a:solidFill>
+              </a:rPr>
+              <a:t>Model ini mensimulasikan perilaku </a:t>
+            </a:r>
+            <a:pPr indent="0" marL="0">
+              <a:buNone/>
+            </a:pPr>
+            <a:r>
+              <a:rPr lang="en-US" sz="1800" b="1" i="1" dirty="0">
+                <a:solidFill>
+                  <a:srgbClr val="333333"/>
+                </a:solidFill>
+              </a:rPr>
+              <a:t>Robo-Advisory</a:t>
+            </a:r>
+            <a:pPr indent="0" marL="0">
+              <a:buNone/>
+            </a:pPr>
+            <a:r>
+              <a:rPr lang="en-US" sz="1800" dirty="0">
+                <a:solidFill>
+                  <a:srgbClr val="333333"/>
+                </a:solidFill>
+              </a:rPr>
+              <a:t> institusional.</a:t>
+            </a:r>
+            <a:endParaRPr lang="en-US" sz="1800" dirty="0"/>
+          </a:p>
+          <a:p>
+            <a:pPr marL="342900" indent="-342900">
+              <a:buSzPct val="100000"/>
+              <a:buChar char="•"/>
+            </a:pPr>
+            <a:r>
+              <a:rPr lang="en-US" sz="1800" dirty="0">
+                <a:solidFill>
+                  <a:srgbClr val="333333"/>
+                </a:solidFill>
+              </a:rPr>
+              <a:t>Ketika pasar anjlok ekstrem, investor akan melarikan senjatanya ke posisi </a:t>
+            </a:r>
+            <a:pPr indent="0" marL="0">
+              <a:buNone/>
+            </a:pPr>
+            <a:r>
+              <a:rPr lang="en-US" sz="1800" b="1" dirty="0">
+                <a:solidFill>
+                  <a:srgbClr val="333333"/>
+                </a:solidFill>
+              </a:rPr>
+              <a:t>tunai (USDT)</a:t>
+            </a:r>
+            <a:pPr indent="0" marL="0">
+              <a:buNone/>
+            </a:pPr>
+            <a:r>
+              <a:rPr lang="en-US" sz="1800" dirty="0">
+                <a:solidFill>
+                  <a:srgbClr val="333333"/>
+                </a:solidFill>
+              </a:rPr>
+              <a:t> sebagai evakuasi risiko.</a:t>
+            </a:r>
+            <a:endParaRPr lang="en-US" sz="1800" dirty="0"/>
+          </a:p>
+        </p:txBody>
+      </p:sp>
+    </p:spTree>
+  </p:cSld>
+  <p:clrMapOvr>
+    <a:masterClrMapping/>
+  </p:clrMapOvr>
+</p:sld>
+</file>
+
+<file path=ppt/slides/slide36.xml><?xml version="1.0" encoding="utf-8"?>
+<p:sld xmlns:a="http://schemas.openxmlformats.org/drawingml/2006/main" xmlns:r="http://schemas.openxmlformats.org/officeDocument/2006/relationships" xmlns:p="http://schemas.openxmlformats.org/presentationml/2006/main">
+  <p:cSld name="Slide 36">
+    <p:spTree>
+      <p:nvGrpSpPr>
+        <p:cNvPr id="1" name=""/>
+        <p:cNvGrpSpPr/>
+        <p:nvPr/>
+      </p:nvGrpSpPr>
+      <p:grpSpPr>
+        <a:xfrm>
+          <a:off x="0" y="0"/>
+          <a:ext cx="0" cy="0"/>
+          <a:chOff x="0" y="0"/>
+          <a:chExt cx="0" cy="0"/>
+        </a:xfrm>
+      </p:grpSpPr>
+      <p:sp>
+        <p:nvSpPr>
+          <p:cNvPr id="2" name="Text 0"/>
+          <p:cNvSpPr/>
+          <p:nvPr/>
+        </p:nvSpPr>
+        <p:spPr>
+          <a:xfrm>
+            <a:off x="457200" y="457200"/>
+            <a:ext cx="8229600" cy="0"/>
+          </a:xfrm>
+          <a:prstGeom prst="rect">
+            <a:avLst/>
+          </a:prstGeom>
+          <a:noFill/>
+          <a:ln/>
+        </p:spPr>
+        <p:txBody>
+          <a:bodyPr wrap="square" rtlCol="0" anchor="ctr"/>
+          <a:lstStyle/>
+          <a:p>
+            <a:pPr indent="0" marL="0">
+              <a:buNone/>
+            </a:pPr>
+            <a:r>
+              <a:rPr lang="en-US" sz="2600" b="1" dirty="0">
+                <a:solidFill>
+                  <a:srgbClr val="003366"/>
+                </a:solidFill>
+              </a:rPr>
+              <a:t>Lampiran: Mengapa Menyertakan Tether (USDT)? (2/2)</a:t>
+            </a:r>
+            <a:endParaRPr lang="en-US" sz="2600" dirty="0"/>
+          </a:p>
+        </p:txBody>
+      </p:sp>
+      <p:sp>
+        <p:nvSpPr>
+          <p:cNvPr id="3" name="Text 1"/>
+          <p:cNvSpPr/>
+          <p:nvPr/>
+        </p:nvSpPr>
+        <p:spPr>
+          <a:xfrm>
+            <a:off x="457200" y="1005840"/>
+            <a:ext cx="8229600" cy="5029200"/>
+          </a:xfrm>
+          <a:prstGeom prst="rect">
+            <a:avLst/>
+          </a:prstGeom>
+          <a:noFill/>
+          <a:ln/>
+        </p:spPr>
+        <p:txBody>
+          <a:bodyPr wrap="square" rtlCol="0" anchor="t"/>
+          <a:lstStyle/>
+          <a:p>
+            <a:pPr indent="0" marL="0">
+              <a:buNone/>
+            </a:pPr>
+            <a:r>
+              <a:rPr lang="en-US" sz="1800" dirty="0">
+                <a:solidFill>
+                  <a:srgbClr val="333333"/>
+                </a:solidFill>
+              </a:rPr>
+              <a:t>3. Algoritma jaringan </a:t>
+            </a:r>
+            <a:pPr indent="0" marL="0">
+              <a:buNone/>
+            </a:pPr>
+            <a:r>
+              <a:rPr lang="en-US" sz="1800" b="1" dirty="0">
+                <a:solidFill>
+                  <a:srgbClr val="333333"/>
+                </a:solidFill>
+              </a:rPr>
+              <a:t>Network Markowitz GS (Grid Search)</a:t>
+            </a:r>
+            <a:pPr indent="0" marL="0">
+              <a:buNone/>
+            </a:pPr>
+            <a:r>
+              <a:rPr lang="en-US" sz="1800" dirty="0">
+                <a:solidFill>
+                  <a:srgbClr val="333333"/>
+                </a:solidFill>
+              </a:rPr>
+              <a:t> dilatih secara matematis; jika mendeteksi korelasi ancaman kolaps merambat ke semua altcoin, ia akan melempar alokasi modalnya menuju node </a:t>
+            </a:r>
+            <a:pPr indent="0" marL="0">
+              <a:buNone/>
+            </a:pPr>
+            <a:r>
+              <a:rPr lang="en-US" sz="1800" b="1" dirty="0">
+                <a:solidFill>
+                  <a:srgbClr val="333333"/>
+                </a:solidFill>
+              </a:rPr>
+              <a:t>USDT (Tether)</a:t>
+            </a:r>
+            <a:pPr indent="0" marL="0">
+              <a:buNone/>
+            </a:pPr>
+            <a:r>
+              <a:rPr lang="en-US" sz="1800" dirty="0">
+                <a:solidFill>
+                  <a:srgbClr val="333333"/>
+                </a:solidFill>
+              </a:rPr>
+              <a:t> sebagai langkah </a:t>
+            </a:r>
+            <a:pPr indent="0" marL="0">
+              <a:buNone/>
+            </a:pPr>
+            <a:r>
+              <a:rPr lang="en-US" sz="1800" b="1" dirty="0">
+                <a:solidFill>
+                  <a:srgbClr val="333333"/>
+                </a:solidFill>
+              </a:rPr>
+              <a:t>evakuasi otomatis</a:t>
+            </a:r>
+            <a:pPr indent="0" marL="0">
+              <a:buNone/>
+            </a:pPr>
+            <a:r>
+              <a:rPr lang="en-US" sz="1800" dirty="0">
+                <a:solidFill>
+                  <a:srgbClr val="333333"/>
+                </a:solidFill>
+              </a:rPr>
+              <a:t> (Shock-Absorber).</a:t>
+            </a:r>
+            <a:endParaRPr lang="en-US" sz="1800" dirty="0"/>
+          </a:p>
+          <a:p>
+            <a:pPr indent="0" marL="0">
+              <a:buNone/>
+            </a:pPr>
+            <a:r>
+              <a:rPr lang="en-US" sz="1800" dirty="0">
+                <a:solidFill>
+                  <a:srgbClr val="333333"/>
+                </a:solidFill>
+              </a:rPr>
+              <a:t>   4. Hal ini yang membuat performa Risk-GS (Grid Search) sangat </a:t>
+            </a:r>
+            <a:pPr indent="0" marL="0">
+              <a:buNone/>
+            </a:pPr>
+            <a:r>
+              <a:rPr lang="en-US" sz="1800" b="1" dirty="0">
+                <a:solidFill>
+                  <a:srgbClr val="333333"/>
+                </a:solidFill>
+              </a:rPr>
+              <a:t>tangguh</a:t>
+            </a:r>
+            <a:pPr indent="0" marL="0">
+              <a:buNone/>
+            </a:pPr>
+            <a:r>
+              <a:rPr lang="en-US" sz="1800" dirty="0">
+                <a:solidFill>
+                  <a:srgbClr val="333333"/>
+                </a:solidFill>
+              </a:rPr>
+              <a:t> dari serangan Crypto Winter, suatu kapabilitas pertahanan yang tidak dipahami oleh model ortodoks murni Markowitz.</a:t>
+            </a:r>
+            <a:endParaRPr lang="en-US" sz="1800" dirty="0"/>
+          </a:p>
+        </p:txBody>
+      </p:sp>
+    </p:spTree>
+  </p:cSld>
+  <p:clrMapOvr>
+    <a:masterClrMapping/>
+  </p:clrMapOvr>
+</p:sld>
+</file>
+
+<file path=ppt/slides/slide37.xml><?xml version="1.0" encoding="utf-8"?>
+<p:sld xmlns:a="http://schemas.openxmlformats.org/drawingml/2006/main" xmlns:r="http://schemas.openxmlformats.org/officeDocument/2006/relationships" xmlns:p="http://schemas.openxmlformats.org/presentationml/2006/main">
+  <p:cSld name="Slide 37">
+    <p:spTree>
+      <p:nvGrpSpPr>
+        <p:cNvPr id="1" name=""/>
+        <p:cNvGrpSpPr/>
+        <p:nvPr/>
+      </p:nvGrpSpPr>
+      <p:grpSpPr>
+        <a:xfrm>
+          <a:off x="0" y="0"/>
+          <a:ext cx="0" cy="0"/>
+          <a:chOff x="0" y="0"/>
+          <a:chExt cx="0" cy="0"/>
+        </a:xfrm>
+      </p:grpSpPr>
+      <p:sp>
+        <p:nvSpPr>
+          <p:cNvPr id="2" name="Text 0"/>
+          <p:cNvSpPr/>
+          <p:nvPr/>
+        </p:nvSpPr>
+        <p:spPr>
+          <a:xfrm>
+            <a:off x="457200" y="457200"/>
+            <a:ext cx="8229600" cy="0"/>
+          </a:xfrm>
+          <a:prstGeom prst="rect">
+            <a:avLst/>
+          </a:prstGeom>
+          <a:noFill/>
+          <a:ln/>
+        </p:spPr>
+        <p:txBody>
+          <a:bodyPr wrap="square" rtlCol="0" anchor="ctr"/>
+          <a:lstStyle/>
+          <a:p>
+            <a:pPr indent="0" marL="0">
+              <a:buNone/>
+            </a:pPr>
+            <a:r>
+              <a:rPr lang="en-US" sz="2600" b="1" dirty="0">
+                <a:solidFill>
+                  <a:srgbClr val="003366"/>
+                </a:solidFill>
+              </a:rPr>
+              <a:t>Lampiran: Bukti Empiris Non-Stationarity Pasar</a:t>
+            </a:r>
+            <a:endParaRPr lang="en-US" sz="2600" dirty="0"/>
+          </a:p>
+        </p:txBody>
+      </p:sp>
+      <p:sp>
+        <p:nvSpPr>
+          <p:cNvPr id="3" name="Text 1"/>
+          <p:cNvSpPr/>
+          <p:nvPr/>
+        </p:nvSpPr>
+        <p:spPr>
+          <a:xfrm>
+            <a:off x="457200" y="1005840"/>
+            <a:ext cx="8229600" cy="5029200"/>
+          </a:xfrm>
+          <a:prstGeom prst="rect">
+            <a:avLst/>
+          </a:prstGeom>
+          <a:noFill/>
+          <a:ln/>
+        </p:spPr>
+        <p:txBody>
+          <a:bodyPr wrap="square" rtlCol="0" anchor="t"/>
+          <a:lstStyle/>
+          <a:p>
+            <a:pPr indent="0" marL="0">
+              <a:buNone/>
+            </a:pPr>
+            <a:r>
+              <a:rPr lang="en-US" sz="1800" b="1" dirty="0">
+                <a:solidFill>
+                  <a:srgbClr val="C0392B"/>
+                </a:solidFill>
+              </a:rPr>
+              <a:t>Masalah: </a:t>
+            </a:r>
+            <a:pPr indent="0" marL="0">
+              <a:buNone/>
+            </a:pPr>
+            <a:r>
+              <a:rPr lang="en-US" sz="1800" i="1" dirty="0">
+                <a:solidFill>
+                  <a:srgbClr val="333333"/>
+                </a:solidFill>
+              </a:rPr>
+              <a:t>Kenapa harus menggunakan model Adaptif (Dynamic Gamma)?</a:t>
+            </a:r>
+            <a:endParaRPr lang="en-US" sz="1800" dirty="0"/>
+          </a:p>
+          <a:p>
+            <a:pPr indent="0" marL="0">
+              <a:buNone/>
+            </a:pPr>
+            <a:r>
+              <a:rPr lang="en-US" sz="1800" b="1" dirty="0">
+                <a:solidFill>
+                  <a:srgbClr val="27AE60"/>
+                </a:solidFill>
+              </a:rPr>
+              <a:t>Bukti dari Grid Search:</a:t>
+            </a:r>
+            <a:endParaRPr lang="en-US" sz="1800" dirty="0"/>
+          </a:p>
+          <a:p>
+            <a:pPr marL="342900" indent="-342900">
+              <a:buSzPct val="100000"/>
+              <a:buChar char="•"/>
+            </a:pPr>
+            <a:r>
+              <a:rPr lang="en-US" sz="1800" dirty="0">
+                <a:solidFill>
+                  <a:srgbClr val="333333"/>
+                </a:solidFill>
+              </a:rPr>
+              <a:t>Data menunjukkan nilai Gamma (γ) optimal </a:t>
+            </a:r>
+            <a:pPr indent="0" marL="0">
+              <a:buNone/>
+            </a:pPr>
+            <a:r>
+              <a:rPr lang="en-US" sz="1800" b="1" dirty="0">
+                <a:solidFill>
+                  <a:srgbClr val="333333"/>
+                </a:solidFill>
+              </a:rPr>
+              <a:t>terus bergeser</a:t>
+            </a:r>
+            <a:pPr indent="0" marL="0">
+              <a:buNone/>
+            </a:pPr>
+            <a:r>
+              <a:rPr lang="en-US" sz="1800" dirty="0">
+                <a:solidFill>
+                  <a:srgbClr val="333333"/>
+                </a:solidFill>
+              </a:rPr>
+              <a:t> setiap periode rebalancing.</a:t>
+            </a:r>
+            <a:endParaRPr lang="en-US" sz="1800" dirty="0"/>
+          </a:p>
+          <a:p>
+            <a:pPr marL="342900" indent="-342900">
+              <a:buSzPct val="100000"/>
+              <a:buChar char="•"/>
+            </a:pPr>
+            <a:r>
+              <a:rPr lang="en-US" sz="1800" dirty="0">
+                <a:solidFill>
+                  <a:srgbClr val="333333"/>
+                </a:solidFill>
+              </a:rPr>
+              <a:t>Penggunaan γ statis tidak cukup untuk menangkap perubahan </a:t>
+            </a:r>
+            <a:pPr indent="0" marL="0">
+              <a:buNone/>
+            </a:pPr>
+            <a:r>
+              <a:rPr lang="en-US" sz="1800" b="1" dirty="0">
+                <a:solidFill>
+                  <a:srgbClr val="333333"/>
+                </a:solidFill>
+              </a:rPr>
+              <a:t>struktur korelasi</a:t>
+            </a:r>
+            <a:pPr indent="0" marL="0">
+              <a:buNone/>
+            </a:pPr>
+            <a:r>
+              <a:rPr lang="en-US" sz="1800" dirty="0">
+                <a:solidFill>
+                  <a:srgbClr val="333333"/>
+                </a:solidFill>
+              </a:rPr>
+              <a:t> yang sangat cepat di pasar kripto.</a:t>
+            </a:r>
+            <a:endParaRPr lang="en-US" sz="1800" dirty="0"/>
+          </a:p>
+          <a:p>
+            <a:pPr marL="342900" indent="-342900">
+              <a:buSzPct val="100000"/>
+              <a:buChar char="•"/>
+            </a:pPr>
+            <a:r>
+              <a:rPr lang="en-US" sz="1800" dirty="0">
+                <a:solidFill>
+                  <a:srgbClr val="333333"/>
+                </a:solidFill>
+              </a:rPr>
+              <a:t>Ini membenarkan bahwa pasar kripto membutuhkan </a:t>
+            </a:r>
+            <a:pPr indent="0" marL="0">
+              <a:buNone/>
+            </a:pPr>
+            <a:r>
+              <a:rPr lang="en-US" sz="1800" b="1" dirty="0">
+                <a:solidFill>
+                  <a:srgbClr val="333333"/>
+                </a:solidFill>
+              </a:rPr>
+              <a:t>kalibrasi otomatis</a:t>
+            </a:r>
+            <a:pPr indent="0" marL="0">
+              <a:buNone/>
+            </a:pPr>
+            <a:r>
+              <a:rPr lang="en-US" sz="1800" dirty="0">
+                <a:solidFill>
+                  <a:srgbClr val="333333"/>
+                </a:solidFill>
+              </a:rPr>
+              <a:t> secara temporal.</a:t>
+            </a:r>
+            <a:endParaRPr lang="en-US" sz="1800" dirty="0"/>
+          </a:p>
+        </p:txBody>
+      </p:sp>
+    </p:spTree>
+  </p:cSld>
+  <p:clrMapOvr>
+    <a:masterClrMapping/>
+  </p:clrMapOvr>
+</p:sld>
+</file>
+
+<file path=ppt/slides/slide38.xml><?xml version="1.0" encoding="utf-8"?>
+<p:sld xmlns:a="http://schemas.openxmlformats.org/drawingml/2006/main" xmlns:r="http://schemas.openxmlformats.org/officeDocument/2006/relationships" xmlns:p="http://schemas.openxmlformats.org/presentationml/2006/main">
+  <p:cSld name="Slide 38">
     <p:spTree>
       <p:nvGrpSpPr>
         <p:cNvPr id="1" name=""/>

</xml_diff>

<commit_message>
feat: add Network Markowitz (NW) simple example slide
</commit_message>
<xml_diff>
--- a/Presentasi_Proposal_Update.pptx
+++ b/Presentasi_Proposal_Update.pptx
@@ -43,9 +43,10 @@
     <p:sldId id="291" r:id="rId37"/>
     <p:sldId id="292" r:id="rId38"/>
     <p:sldId id="293" r:id="rId39"/>
+    <p:sldId id="294" r:id="rId40"/>
   </p:sldIdLst>
   <p:notesMasterIdLst>
-    <p:notesMasterId r:id="rId40"/>
+    <p:notesMasterId r:id="rId41"/>
   </p:notesMasterIdLst>
   <p:sldSz cx="9144000" cy="5143500"/>
   <p:notesSz cx="5143500" cy="9144000"/>
@@ -3291,6 +3292,94 @@
             <a:fld id="{F7021451-1387-4CA6-816F-3879F97B5CBC}" type="slidenum">
               <a:rPr lang="en-US"/>
               <a:t>38</a:t>
+            </a:fld>
+            <a:endParaRPr lang="en-US"/>
+          </a:p>
+        </p:txBody>
+      </p:sp>
+    </p:spTree>
+    <p:extLst>
+      <p:ext uri="{BB962C8B-B14F-4D97-AF65-F5344CB8AC3E}">
+        <p14:creationId xmlns:p14="http://schemas.microsoft.com/office/powerpoint/2010/main" val="1024086991"/>
+      </p:ext>
+    </p:extLst>
+  </p:cSld>
+  <p:clrMapOvr>
+    <a:masterClrMapping/>
+  </p:clrMapOvr>
+</p:notes>
+</file>
+
+<file path=ppt/notesSlides/notesSlide39.xml><?xml version="1.0" encoding="utf-8"?>
+<p:notes xmlns:a="http://schemas.openxmlformats.org/drawingml/2006/main" xmlns:r="http://schemas.openxmlformats.org/officeDocument/2006/relationships" xmlns:p="http://schemas.openxmlformats.org/presentationml/2006/main">
+  <p:cSld>
+    <p:spTree>
+      <p:nvGrpSpPr>
+        <p:cNvPr id="1" name=""/>
+        <p:cNvGrpSpPr/>
+        <p:nvPr/>
+      </p:nvGrpSpPr>
+      <p:grpSpPr>
+        <a:xfrm>
+          <a:off x="0" y="0"/>
+          <a:ext cx="0" cy="0"/>
+          <a:chOff x="0" y="0"/>
+          <a:chExt cx="0" cy="0"/>
+        </a:xfrm>
+      </p:grpSpPr>
+      <p:sp>
+        <p:nvSpPr>
+          <p:cNvPr id="2" name="Slide Image Placeholder 1"/>
+          <p:cNvSpPr>
+            <a:spLocks noGrp="1" noRot="1" noChangeAspect="1"/>
+          </p:cNvSpPr>
+          <p:nvPr>
+            <p:ph type="sldImg"/>
+          </p:nvPr>
+        </p:nvSpPr>
+        <p:spPr/>
+      </p:sp>
+      <p:sp>
+        <p:nvSpPr>
+          <p:cNvPr id="3" name="Notes Placeholder 2"/>
+          <p:cNvSpPr>
+            <a:spLocks noGrp="1"/>
+          </p:cNvSpPr>
+          <p:nvPr>
+            <p:ph type="body" idx="1"/>
+          </p:nvPr>
+        </p:nvSpPr>
+        <p:spPr/>
+        <p:txBody>
+          <a:bodyPr/>
+          <a:lstStyle/>
+          <a:p>
+            <a:r>
+              <a:rPr lang="en-US" dirty="0"/>
+              <a:t/>
+            </a:r>
+            <a:endParaRPr lang="en-US" dirty="0"/>
+          </a:p>
+        </p:txBody>
+      </p:sp>
+      <p:sp>
+        <p:nvSpPr>
+          <p:cNvPr id="4" name="Slide Number Placeholder 3"/>
+          <p:cNvSpPr>
+            <a:spLocks noGrp="1"/>
+          </p:cNvSpPr>
+          <p:nvPr>
+            <p:ph type="sldNum" sz="quarter" idx="10"/>
+          </p:nvPr>
+        </p:nvSpPr>
+        <p:spPr/>
+        <p:txBody>
+          <a:bodyPr/>
+          <a:lstStyle/>
+          <a:p>
+            <a:fld id="{F7021451-1387-4CA6-816F-3879F97B5CBC}" type="slidenum">
+              <a:rPr lang="en-US"/>
+              <a:t>39</a:t>
             </a:fld>
             <a:endParaRPr lang="en-US"/>
           </a:p>
@@ -10915,14 +11004,14 @@
               <a:buNone/>
             </a:pPr>
             <a:r>
-              <a:rPr lang="en-US" sz="2600" b="1" dirty="0">
+              <a:rPr lang="en-US" sz="2400" b="1" dirty="0">
                 <a:solidFill>
                   <a:srgbClr val="003366"/>
                 </a:solidFill>
               </a:rPr>
-              <a:t>Lampiran: Dua Tipe Pendekatan Grid Search</a:t>
-            </a:r>
-            <a:endParaRPr lang="en-US" sz="2600" dirty="0"/>
+              <a:t>Lampiran: Contoh Sederhana Network Markowitz (NW)</a:t>
+            </a:r>
+            <a:endParaRPr lang="en-US" sz="2400" dirty="0"/>
           </a:p>
         </p:txBody>
       </p:sp>
@@ -10951,190 +11040,237 @@
               <a:buNone/>
             </a:pPr>
             <a:r>
-              <a:rPr lang="en-US" sz="1800" b="1" dirty="0">
-                <a:solidFill>
-                  <a:srgbClr val="333333"/>
-                </a:solidFill>
-              </a:rPr>
-              <a:t>Dua Objektif Optimasi (Return vs Risk):</a:t>
-            </a:r>
-            <a:endParaRPr lang="en-US" sz="1800" dirty="0"/>
-          </a:p>
-          <a:p>
-            <a:pPr indent="0" marL="0">
-              <a:buNone/>
-            </a:pPr>
-            <a:r>
-              <a:rPr lang="en-US" sz="1800" b="1" dirty="0">
+              <a:rPr lang="en-US" sz="1600" b="1" dirty="0">
+                <a:solidFill>
+                  <a:srgbClr val="333333"/>
+                </a:solidFill>
+              </a:rPr>
+              <a:t>Tujuan: Mengurangi risiko sistemik dengan menghukum koin 'pusat' (hub).</a:t>
+            </a:r>
+            <a:endParaRPr lang="en-US" sz="1600" dirty="0"/>
+          </a:p>
+          <a:p>
+            <a:pPr indent="0" marL="0">
+              <a:buNone/>
+            </a:pPr>
+            <a:r>
+              <a:rPr lang="en-US" sz="1600" b="1" dirty="0">
+                <a:solidFill>
+                  <a:srgbClr val="003366"/>
+                </a:solidFill>
+              </a:rPr>
+              <a:t>1. Skenario Jaringan (MST):</a:t>
+            </a:r>
+            <a:endParaRPr lang="en-US" sz="1600" dirty="0"/>
+          </a:p>
+          <a:p>
+            <a:pPr indent="0" marL="0">
+              <a:buNone/>
+            </a:pPr>
+            <a:r>
+              <a:rPr lang="en-US" sz="1600" dirty="0">
+                <a:solidFill>
+                  <a:srgbClr val="333333"/>
+                </a:solidFill>
+              </a:rPr>
+              <a:t>   Bayangkan 3 Koin: BTC, ETH, dan ADA.</a:t>
+            </a:r>
+            <a:endParaRPr lang="en-US" sz="1600" dirty="0"/>
+          </a:p>
+          <a:p>
+            <a:pPr indent="0" marL="0">
+              <a:buNone/>
+            </a:pPr>
+            <a:r>
+              <a:rPr lang="en-US" sz="1600" dirty="0">
+                <a:solidFill>
+                  <a:srgbClr val="333333"/>
+                </a:solidFill>
+              </a:rPr>
+              <a:t>   • BTC terhubung ke ETH dan ADA (BTC adalah </a:t>
+            </a:r>
+            <a:pPr indent="0" marL="0">
+              <a:buNone/>
+            </a:pPr>
+            <a:r>
+              <a:rPr lang="en-US" sz="1600" b="1" dirty="0">
+                <a:solidFill>
+                  <a:srgbClr val="333333"/>
+                </a:solidFill>
+              </a:rPr>
+              <a:t>Hub utama</a:t>
+            </a:r>
+            <a:pPr indent="0" marL="0">
+              <a:buNone/>
+            </a:pPr>
+            <a:r>
+              <a:rPr lang="en-US" sz="1600" dirty="0">
+                <a:solidFill>
+                  <a:srgbClr val="333333"/>
+                </a:solidFill>
+              </a:rPr>
+              <a:t>).</a:t>
+            </a:r>
+            <a:endParaRPr lang="en-US" sz="1600" dirty="0"/>
+          </a:p>
+          <a:p>
+            <a:pPr indent="0" marL="0">
+              <a:buNone/>
+            </a:pPr>
+            <a:r>
+              <a:rPr lang="en-US" sz="1600" dirty="0">
+                <a:solidFill>
+                  <a:srgbClr val="333333"/>
+                </a:solidFill>
+              </a:rPr>
+              <a:t>   • Centrality (EC): BTC=0.8, ETH=0.4, ADA=0.4.</a:t>
+            </a:r>
+            <a:endParaRPr lang="en-US" sz="1600" dirty="0"/>
+          </a:p>
+          <a:p>
+            <a:pPr indent="0" marL="0">
+              <a:buNone/>
+            </a:pPr>
+            <a:r>
+              <a:rPr lang="en-US" sz="1600" b="1" dirty="0">
+                <a:solidFill>
+                  <a:srgbClr val="003366"/>
+                </a:solidFill>
+              </a:rPr>
+              <a:t>2. Perbandingan Alokasi:</a:t>
+            </a:r>
+            <a:endParaRPr lang="en-US" sz="1600" dirty="0"/>
+          </a:p>
+          <a:p>
+            <a:pPr indent="0" marL="0">
+              <a:buNone/>
+            </a:pPr>
+            <a:r>
+              <a:rPr lang="en-US" sz="1600" dirty="0">
+                <a:solidFill>
+                  <a:srgbClr val="333333"/>
+                </a:solidFill>
+              </a:rPr>
+              <a:t>   • Classical Markowitz: Melirik BTC karena paling stabil, bobot bisa </a:t>
+            </a:r>
+            <a:pPr indent="0" marL="0">
+              <a:buNone/>
+            </a:pPr>
+            <a:r>
+              <a:rPr lang="en-US" sz="1600" b="1" dirty="0">
+                <a:solidFill>
+                  <a:srgbClr val="C0392B"/>
+                </a:solidFill>
+              </a:rPr>
+              <a:t>70%</a:t>
+            </a:r>
+            <a:pPr indent="0" marL="0">
+              <a:buNone/>
+            </a:pPr>
+            <a:r>
+              <a:rPr lang="en-US" sz="1600" dirty="0">
+                <a:solidFill>
+                  <a:srgbClr val="333333"/>
+                </a:solidFill>
+              </a:rPr>
+              <a:t>.</a:t>
+            </a:r>
+            <a:endParaRPr lang="en-US" sz="1600" dirty="0"/>
+          </a:p>
+          <a:p>
+            <a:pPr indent="0" marL="0">
+              <a:buNone/>
+            </a:pPr>
+            <a:r>
+              <a:rPr lang="en-US" sz="1600" dirty="0">
+                <a:solidFill>
+                  <a:srgbClr val="333333"/>
+                </a:solidFill>
+              </a:rPr>
+              <a:t>   • Network Markowitz (γ=1.0): Mendeteksi BTC sebagai titik bahaya penularan. Bobot BTC dipangkas menjadi </a:t>
+            </a:r>
+            <a:pPr indent="0" marL="0">
+              <a:buNone/>
+            </a:pPr>
+            <a:r>
+              <a:rPr lang="en-US" sz="1600" b="1" dirty="0">
                 <a:solidFill>
                   <a:srgbClr val="27AE60"/>
                 </a:solidFill>
               </a:rPr>
-              <a:t>1. Network Markowitz dengan Target Return (NW - Return Grid Search):</a:t>
-            </a:r>
-            <a:endParaRPr lang="en-US" sz="1800" dirty="0"/>
-          </a:p>
-          <a:p>
-            <a:pPr marL="342900" indent="-342900">
-              <a:buSzPct val="100000"/>
-              <a:buChar char="•"/>
-            </a:pPr>
-            <a:r>
-              <a:rPr lang="en-US" sz="1800" dirty="0">
-                <a:solidFill>
-                  <a:srgbClr val="333333"/>
-                </a:solidFill>
-              </a:rPr>
-              <a:t>Memaksimalkan capaian </a:t>
-            </a:r>
-            <a:pPr indent="0" marL="0">
-              <a:buNone/>
-            </a:pPr>
-            <a:r>
-              <a:rPr lang="en-US" sz="1800" b="1" dirty="0">
-                <a:solidFill>
-                  <a:srgbClr val="333333"/>
-                </a:solidFill>
-              </a:rPr>
-              <a:t>imbal hasil</a:t>
-            </a:r>
-            <a:pPr indent="0" marL="0">
-              <a:buNone/>
-            </a:pPr>
-            <a:r>
-              <a:rPr lang="en-US" sz="1800" dirty="0">
-                <a:solidFill>
-                  <a:srgbClr val="333333"/>
-                </a:solidFill>
-              </a:rPr>
-              <a:t> portofolio.</a:t>
-            </a:r>
-            <a:endParaRPr lang="en-US" sz="1800" dirty="0"/>
-          </a:p>
-          <a:p>
-            <a:pPr marL="342900" indent="-342900">
-              <a:buSzPct val="100000"/>
-              <a:buChar char="•"/>
-            </a:pPr>
-            <a:r>
-              <a:rPr lang="en-US" sz="1800" dirty="0">
-                <a:solidFill>
-                  <a:srgbClr val="333333"/>
-                </a:solidFill>
-              </a:rPr>
-              <a:t>Lebih Agresif untuk mengeksploitasi reli pada pasar </a:t>
-            </a:r>
-            <a:pPr indent="0" marL="0">
-              <a:buNone/>
-            </a:pPr>
-            <a:r>
-              <a:rPr lang="en-US" sz="1800" b="1" dirty="0">
-                <a:solidFill>
-                  <a:srgbClr val="333333"/>
-                </a:solidFill>
-              </a:rPr>
-              <a:t>Bullish</a:t>
-            </a:r>
-            <a:pPr indent="0" marL="0">
-              <a:buNone/>
-            </a:pPr>
-            <a:r>
-              <a:rPr lang="en-US" sz="1800" dirty="0">
+              <a:t>45%</a:t>
+            </a:r>
+            <a:pPr indent="0" marL="0">
+              <a:buNone/>
+            </a:pPr>
+            <a:r>
+              <a:rPr lang="en-US" sz="1600" dirty="0">
                 <a:solidFill>
                   <a:srgbClr val="333333"/>
                 </a:solidFill>
               </a:rPr>
               <a:t>.</a:t>
             </a:r>
-            <a:endParaRPr lang="en-US" sz="1800" dirty="0"/>
-          </a:p>
-          <a:p>
-            <a:pPr indent="0" marL="0">
-              <a:buNone/>
-            </a:pPr>
-            <a:r>
-              <a:rPr lang="en-US" sz="1800" b="1" dirty="0">
-                <a:solidFill>
-                  <a:srgbClr val="C0392B"/>
-                </a:solidFill>
-              </a:rPr>
-              <a:t>2. Network Markowitz dengan Target Risiko (NW - Risk Grid Search):</a:t>
-            </a:r>
-            <a:endParaRPr lang="en-US" sz="1800" dirty="0"/>
-          </a:p>
-          <a:p>
-            <a:pPr marL="342900" indent="-342900">
-              <a:buSzPct val="100000"/>
-              <a:buChar char="•"/>
-            </a:pPr>
-            <a:r>
-              <a:rPr lang="en-US" sz="1800" dirty="0">
-                <a:solidFill>
-                  <a:srgbClr val="333333"/>
-                </a:solidFill>
-              </a:rPr>
-              <a:t>Menekan parameter </a:t>
-            </a:r>
-            <a:pPr indent="0" marL="0">
-              <a:buNone/>
-            </a:pPr>
-            <a:r>
-              <a:rPr lang="en-US" sz="1800" b="1" dirty="0">
-                <a:solidFill>
-                  <a:srgbClr val="333333"/>
-                </a:solidFill>
-              </a:rPr>
-              <a:t>risiko total</a:t>
-            </a:r>
-            <a:pPr indent="0" marL="0">
-              <a:buNone/>
-            </a:pPr>
-            <a:r>
-              <a:rPr lang="en-US" sz="1800" dirty="0">
-                <a:solidFill>
-                  <a:srgbClr val="333333"/>
-                </a:solidFill>
-              </a:rPr>
-              <a:t> hingga minimal.</a:t>
-            </a:r>
-            <a:endParaRPr lang="en-US" sz="1800" dirty="0"/>
-          </a:p>
-          <a:p>
-            <a:pPr marL="342900" indent="-342900">
-              <a:buSzPct val="100000"/>
-              <a:buChar char="•"/>
-            </a:pPr>
-            <a:r>
-              <a:rPr lang="en-US" sz="1800" dirty="0">
-                <a:solidFill>
-                  <a:srgbClr val="333333"/>
-                </a:solidFill>
-              </a:rPr>
-              <a:t>Lebih Defensif untuk meredam fluktuasi saat </a:t>
-            </a:r>
-            <a:pPr indent="0" marL="0">
-              <a:buNone/>
-            </a:pPr>
-            <a:r>
-              <a:rPr lang="en-US" sz="1800" b="1" dirty="0">
-                <a:solidFill>
-                  <a:srgbClr val="333333"/>
-                </a:solidFill>
-              </a:rPr>
-              <a:t>Crypto Winter</a:t>
-            </a:r>
-            <a:pPr indent="0" marL="0">
-              <a:buNone/>
-            </a:pPr>
-            <a:r>
-              <a:rPr lang="en-US" sz="1800" dirty="0">
-                <a:solidFill>
-                  <a:srgbClr val="333333"/>
-                </a:solidFill>
-              </a:rPr>
-              <a:t>.</a:t>
-            </a:r>
-            <a:endParaRPr lang="en-US" sz="1800" dirty="0"/>
+            <a:endParaRPr lang="en-US" sz="1600" dirty="0"/>
+          </a:p>
+          <a:p>
+            <a:pPr indent="0" marL="0">
+              <a:buNone/>
+            </a:pPr>
+            <a:r>
+              <a:rPr lang="en-US" sz="1600" b="1" dirty="0">
+                <a:solidFill>
+                  <a:srgbClr val="003366"/>
+                </a:solidFill>
+              </a:rPr>
+              <a:t>3. Mekanisme 'Hukuman' (Penalty):</a:t>
+            </a:r>
+            <a:endParaRPr lang="en-US" sz="1600" dirty="0"/>
+          </a:p>
+          <a:p>
+            <a:pPr indent="0" marL="0">
+              <a:buNone/>
+            </a:pPr>
+            <a:r>
+              <a:rPr lang="en-US" sz="1600" b="1" dirty="0">
+                <a:solidFill>
+                  <a:srgbClr val="8E44AD"/>
+                </a:solidFill>
+                <a:latin typeface="Courier New" pitchFamily="34" charset="0"/>
+                <a:ea typeface="Courier New" pitchFamily="34" charset="-122"/>
+                <a:cs typeface="Courier New" pitchFamily="34" charset="-120"/>
+              </a:rPr>
+              <a:t>   Risiko Baru = Risiko Harga + (γ × Centrality)</a:t>
+            </a:r>
+            <a:endParaRPr lang="en-US" sz="1600" dirty="0"/>
+          </a:p>
+          <a:p>
+            <a:pPr indent="0" marL="0">
+              <a:buNone/>
+            </a:pPr>
+            <a:r>
+              <a:rPr lang="en-US" sz="1600" b="1" dirty="0">
+                <a:solidFill>
+                  <a:srgbClr val="27AE60"/>
+                </a:solidFill>
+              </a:rPr>
+              <a:t>Hasil Akhir:</a:t>
+            </a:r>
+            <a:endParaRPr lang="en-US" sz="1600" dirty="0"/>
+          </a:p>
+          <a:p>
+            <a:pPr indent="0" marL="0">
+              <a:buNone/>
+            </a:pPr>
+            <a:r>
+              <a:rPr lang="en-US" sz="1600" i="1" dirty="0">
+                <a:solidFill>
+                  <a:srgbClr val="333333"/>
+                </a:solidFill>
+              </a:rPr>
+              <a:t>Modal dialihkan ke ETH/ADA yang lebih 'pinggiran' (peripheral). Portofolio tidak hancur total jika 'Hub' (BTC) mengalami crash ekstrem.</a:t>
+            </a:r>
+            <a:endParaRPr lang="en-US" sz="1600" dirty="0"/>
           </a:p>
         </p:txBody>
       </p:sp>
@@ -11193,7 +11329,7 @@
                   <a:srgbClr val="003366"/>
                 </a:solidFill>
               </a:rPr>
-              <a:t>Lampiran: Penanganan Data Kosong (Missing Values)</a:t>
+              <a:t>Lampiran: Dua Tipe Pendekatan Grid Search</a:t>
             </a:r>
             <a:endParaRPr lang="en-US" sz="2600" dirty="0"/>
           </a:p>
@@ -11226,41 +11362,156 @@
             <a:r>
               <a:rPr lang="en-US" sz="1800" b="1" dirty="0">
                 <a:solidFill>
+                  <a:srgbClr val="333333"/>
+                </a:solidFill>
+              </a:rPr>
+              <a:t>Dua Objektif Optimasi (Return vs Risk):</a:t>
+            </a:r>
+            <a:endParaRPr lang="en-US" sz="1800" dirty="0"/>
+          </a:p>
+          <a:p>
+            <a:pPr indent="0" marL="0">
+              <a:buNone/>
+            </a:pPr>
+            <a:r>
+              <a:rPr lang="en-US" sz="1800" b="1" dirty="0">
+                <a:solidFill>
+                  <a:srgbClr val="27AE60"/>
+                </a:solidFill>
+              </a:rPr>
+              <a:t>1. Network Markowitz dengan Target Return (NW - Return Grid Search):</a:t>
+            </a:r>
+            <a:endParaRPr lang="en-US" sz="1800" dirty="0"/>
+          </a:p>
+          <a:p>
+            <a:pPr marL="342900" indent="-342900">
+              <a:buSzPct val="100000"/>
+              <a:buChar char="•"/>
+            </a:pPr>
+            <a:r>
+              <a:rPr lang="en-US" sz="1800" dirty="0">
+                <a:solidFill>
+                  <a:srgbClr val="333333"/>
+                </a:solidFill>
+              </a:rPr>
+              <a:t>Memaksimalkan capaian </a:t>
+            </a:r>
+            <a:pPr indent="0" marL="0">
+              <a:buNone/>
+            </a:pPr>
+            <a:r>
+              <a:rPr lang="en-US" sz="1800" b="1" dirty="0">
+                <a:solidFill>
+                  <a:srgbClr val="333333"/>
+                </a:solidFill>
+              </a:rPr>
+              <a:t>imbal hasil</a:t>
+            </a:r>
+            <a:pPr indent="0" marL="0">
+              <a:buNone/>
+            </a:pPr>
+            <a:r>
+              <a:rPr lang="en-US" sz="1800" dirty="0">
+                <a:solidFill>
+                  <a:srgbClr val="333333"/>
+                </a:solidFill>
+              </a:rPr>
+              <a:t> portofolio.</a:t>
+            </a:r>
+            <a:endParaRPr lang="en-US" sz="1800" dirty="0"/>
+          </a:p>
+          <a:p>
+            <a:pPr marL="342900" indent="-342900">
+              <a:buSzPct val="100000"/>
+              <a:buChar char="•"/>
+            </a:pPr>
+            <a:r>
+              <a:rPr lang="en-US" sz="1800" dirty="0">
+                <a:solidFill>
+                  <a:srgbClr val="333333"/>
+                </a:solidFill>
+              </a:rPr>
+              <a:t>Lebih Agresif untuk mengeksploitasi reli pada pasar </a:t>
+            </a:r>
+            <a:pPr indent="0" marL="0">
+              <a:buNone/>
+            </a:pPr>
+            <a:r>
+              <a:rPr lang="en-US" sz="1800" b="1" dirty="0">
+                <a:solidFill>
+                  <a:srgbClr val="333333"/>
+                </a:solidFill>
+              </a:rPr>
+              <a:t>Bullish</a:t>
+            </a:r>
+            <a:pPr indent="0" marL="0">
+              <a:buNone/>
+            </a:pPr>
+            <a:r>
+              <a:rPr lang="en-US" sz="1800" dirty="0">
+                <a:solidFill>
+                  <a:srgbClr val="333333"/>
+                </a:solidFill>
+              </a:rPr>
+              <a:t>.</a:t>
+            </a:r>
+            <a:endParaRPr lang="en-US" sz="1800" dirty="0"/>
+          </a:p>
+          <a:p>
+            <a:pPr indent="0" marL="0">
+              <a:buNone/>
+            </a:pPr>
+            <a:r>
+              <a:rPr lang="en-US" sz="1800" b="1" dirty="0">
+                <a:solidFill>
                   <a:srgbClr val="C0392B"/>
                 </a:solidFill>
               </a:rPr>
-              <a:t>Pertanyaan: </a:t>
-            </a:r>
-            <a:pPr indent="0" marL="0">
-              <a:buNone/>
-            </a:pPr>
-            <a:r>
-              <a:rPr lang="en-US" sz="1800" i="1" dirty="0">
-                <a:solidFill>
-                  <a:srgbClr val="333333"/>
-                </a:solidFill>
-              </a:rPr>
-              <a:t>"Beberapa koin seperti Binance/EOS belum rilis di awal 2017 sehingga datanya kosong. Bukankah backward-fill memalsukan harga dan merusak matriks?"</a:t>
+              <a:t>2. Network Markowitz dengan Target Risiko (NW - Risk Grid Search):</a:t>
             </a:r>
             <a:endParaRPr lang="en-US" sz="1800" dirty="0"/>
           </a:p>
           <a:p>
+            <a:pPr marL="342900" indent="-342900">
+              <a:buSzPct val="100000"/>
+              <a:buChar char="•"/>
+            </a:pPr>
+            <a:r>
+              <a:rPr lang="en-US" sz="1800" dirty="0">
+                <a:solidFill>
+                  <a:srgbClr val="333333"/>
+                </a:solidFill>
+              </a:rPr>
+              <a:t>Menekan parameter </a:t>
+            </a:r>
             <a:pPr indent="0" marL="0">
               <a:buNone/>
             </a:pPr>
             <a:r>
               <a:rPr lang="en-US" sz="1800" b="1" dirty="0">
                 <a:solidFill>
-                  <a:srgbClr val="27AE60"/>
-                </a:solidFill>
-              </a:rPr>
-              <a:t>Jawaban (Kenapa RMT sangat Krusial):</a:t>
+                  <a:srgbClr val="333333"/>
+                </a:solidFill>
+              </a:rPr>
+              <a:t>risiko total</a:t>
+            </a:r>
+            <a:pPr indent="0" marL="0">
+              <a:buNone/>
+            </a:pPr>
+            <a:r>
+              <a:rPr lang="en-US" sz="1800" dirty="0">
+                <a:solidFill>
+                  <a:srgbClr val="333333"/>
+                </a:solidFill>
+              </a:rPr>
+              <a:t> hingga minimal.</a:t>
             </a:r>
             <a:endParaRPr lang="en-US" sz="1800" dirty="0"/>
           </a:p>
           <a:p>
-            <a:pPr indent="0" marL="0">
-              <a:buNone/>
+            <a:pPr marL="342900" indent="-342900">
+              <a:buSzPct val="100000"/>
+              <a:buChar char="•"/>
             </a:pPr>
             <a:r>
               <a:rPr lang="en-US" sz="1800" dirty="0">
@@ -11268,18 +11519,18 @@
                   <a:srgbClr val="333333"/>
                 </a:solidFill>
               </a:rPr>
-              <a:t>   1. Praktik pengisian data diam (</a:t>
-            </a:r>
-            <a:pPr indent="0" marL="0">
-              <a:buNone/>
-            </a:pPr>
-            <a:r>
-              <a:rPr lang="en-US" sz="1800" b="1" i="1" dirty="0">
-                <a:solidFill>
-                  <a:srgbClr val="333333"/>
-                </a:solidFill>
-              </a:rPr>
-              <a:t>backward fill</a:t>
+              <a:t>Lebih Defensif untuk meredam fluktuasi saat </a:t>
+            </a:r>
+            <a:pPr indent="0" marL="0">
+              <a:buNone/>
+            </a:pPr>
+            <a:r>
+              <a:rPr lang="en-US" sz="1800" b="1" dirty="0">
+                <a:solidFill>
+                  <a:srgbClr val="333333"/>
+                </a:solidFill>
+              </a:rPr>
+              <a:t>Crypto Winter</a:t>
             </a:r>
             <a:pPr indent="0" marL="0">
               <a:buNone/>
@@ -11290,115 +11541,7 @@
                   <a:srgbClr val="333333"/>
                 </a:solidFill>
               </a:rPr>
-              <a:t>) memang menciptakan rentetan nilai harga yang statis.</a:t>
-            </a:r>
-            <a:endParaRPr lang="en-US" sz="1800" dirty="0"/>
-          </a:p>
-          <a:p>
-            <a:pPr indent="0" marL="0">
-              <a:buNone/>
-            </a:pPr>
-            <a:r>
-              <a:rPr lang="en-US" sz="1800" dirty="0">
-                <a:solidFill>
-                  <a:srgbClr val="333333"/>
-                </a:solidFill>
-              </a:rPr>
-              <a:t>   2. Namun, kehebatan </a:t>
-            </a:r>
-            <a:pPr indent="0" marL="0">
-              <a:buNone/>
-            </a:pPr>
-            <a:r>
-              <a:rPr lang="en-US" sz="1800" b="1" dirty="0">
-                <a:solidFill>
-                  <a:srgbClr val="333333"/>
-                </a:solidFill>
-              </a:rPr>
-              <a:t>Random Matrix Theory (RMT)</a:t>
-            </a:r>
-            <a:pPr indent="0" marL="0">
-              <a:buNone/>
-            </a:pPr>
-            <a:r>
-              <a:rPr lang="en-US" sz="1800" dirty="0">
-                <a:solidFill>
-                  <a:srgbClr val="333333"/>
-                </a:solidFill>
-              </a:rPr>
-              <a:t> diuji di sini! Karena data yang datar sama sekali tidak punya korelasi nyata.</a:t>
-            </a:r>
-            <a:endParaRPr lang="en-US" sz="1800" dirty="0"/>
-          </a:p>
-          <a:p>
-            <a:pPr indent="0" marL="0">
-              <a:buNone/>
-            </a:pPr>
-            <a:r>
-              <a:rPr lang="en-US" sz="1800" dirty="0">
-                <a:solidFill>
-                  <a:srgbClr val="333333"/>
-                </a:solidFill>
-              </a:rPr>
-              <a:t>   3. RMT otomatis akan mendeteksi korelasi buatan tersebut sebagai probabilitas </a:t>
-            </a:r>
-            <a:pPr indent="0" marL="0">
-              <a:buNone/>
-            </a:pPr>
-            <a:r>
-              <a:rPr lang="en-US" sz="1800" b="1" i="1" dirty="0">
-                <a:solidFill>
-                  <a:srgbClr val="333333"/>
-                </a:solidFill>
-              </a:rPr>
-              <a:t>Noise Acak</a:t>
-            </a:r>
-            <a:pPr indent="0" marL="0">
-              <a:buNone/>
-            </a:pPr>
-            <a:r>
-              <a:rPr lang="en-US" sz="1800" dirty="0">
-                <a:solidFill>
-                  <a:srgbClr val="333333"/>
-                </a:solidFill>
-              </a:rPr>
-              <a:t>, lalu membuangnya menjadi 0.</a:t>
-            </a:r>
-            <a:endParaRPr lang="en-US" sz="1800" dirty="0"/>
-          </a:p>
-          <a:p>
-            <a:pPr indent="0" marL="0">
-              <a:buNone/>
-            </a:pPr>
-            <a:r>
-              <a:rPr lang="en-US" sz="1800" dirty="0">
-                <a:solidFill>
-                  <a:srgbClr val="333333"/>
-                </a:solidFill>
-              </a:rPr>
-              <a:t>   4. Hasilnya, matriks korelasi </a:t>
-            </a:r>
-            <a:pPr indent="0" marL="0">
-              <a:buNone/>
-            </a:pPr>
-            <a:r>
-              <a:rPr lang="en-US" sz="1800" b="1" dirty="0">
-                <a:solidFill>
-                  <a:srgbClr val="333333"/>
-                </a:solidFill>
-              </a:rPr>
-              <a:t>terselamatkan</a:t>
-            </a:r>
-            <a:pPr indent="0" marL="0">
-              <a:buNone/>
-            </a:pPr>
-            <a:r>
-              <a:rPr lang="en-US" sz="1800" dirty="0">
-                <a:solidFill>
-                  <a:srgbClr val="333333"/>
-                </a:solidFill>
-              </a:rPr>
-              <a:t> dan tidak tercemar oleh cacat kelengkapan data.</a:t>
+              <a:t>.</a:t>
             </a:r>
             <a:endParaRPr lang="en-US" sz="1800" dirty="0"/>
           </a:p>
@@ -11459,7 +11602,7 @@
                   <a:srgbClr val="003366"/>
                 </a:solidFill>
               </a:rPr>
-              <a:t>Lampiran: Mengapa Menyertakan Tether (USDT)? (1/2)</a:t>
+              <a:t>Lampiran: Penanganan Data Kosong (Missing Values)</a:t>
             </a:r>
             <a:endParaRPr lang="en-US" sz="2600" dirty="0"/>
           </a:p>
@@ -11506,7 +11649,7 @@
                   <a:srgbClr val="333333"/>
                 </a:solidFill>
               </a:rPr>
-              <a:t>"Tether (USDT) itu stablecoin yang nilainya selalu fix ke 1 USD. Apakah tidak berbuat curang?"</a:t>
+              <a:t>"Beberapa koin seperti Binance/EOS belum rilis di awal 2017 sehingga datanya kosong. Bukankah backward-fill memalsukan harga dan merusak matriks?"</a:t>
             </a:r>
             <a:endParaRPr lang="en-US" sz="1800" dirty="0"/>
           </a:p>
@@ -11520,14 +11663,13 @@
                   <a:srgbClr val="27AE60"/>
                 </a:solidFill>
               </a:rPr>
-              <a:t>Jawaban (Dinamika Portofolio Cerdas):</a:t>
+              <a:t>Jawaban (Kenapa RMT sangat Krusial):</a:t>
             </a:r>
             <a:endParaRPr lang="en-US" sz="1800" dirty="0"/>
           </a:p>
           <a:p>
-            <a:pPr marL="342900" indent="-342900">
-              <a:buSzPct val="100000"/>
-              <a:buChar char="•"/>
+            <a:pPr indent="0" marL="0">
+              <a:buNone/>
             </a:pPr>
             <a:r>
               <a:rPr lang="en-US" sz="1800" dirty="0">
@@ -11535,7 +11677,7 @@
                   <a:srgbClr val="333333"/>
                 </a:solidFill>
               </a:rPr>
-              <a:t>Model ini mensimulasikan perilaku </a:t>
+              <a:t>   1. Praktik pengisian data diam (</a:t>
             </a:r>
             <a:pPr indent="0" marL="0">
               <a:buNone/>
@@ -11546,7 +11688,7 @@
                   <a:srgbClr val="333333"/>
                 </a:solidFill>
               </a:rPr>
-              <a:t>Robo-Advisory</a:t>
+              <a:t>backward fill</a:t>
             </a:r>
             <a:pPr indent="0" marL="0">
               <a:buNone/>
@@ -11557,14 +11699,13 @@
                   <a:srgbClr val="333333"/>
                 </a:solidFill>
               </a:rPr>
-              <a:t> institusional.</a:t>
+              <a:t>) memang menciptakan rentetan nilai harga yang statis.</a:t>
             </a:r>
             <a:endParaRPr lang="en-US" sz="1800" dirty="0"/>
           </a:p>
           <a:p>
-            <a:pPr marL="342900" indent="-342900">
-              <a:buSzPct val="100000"/>
-              <a:buChar char="•"/>
+            <a:pPr indent="0" marL="0">
+              <a:buNone/>
             </a:pPr>
             <a:r>
               <a:rPr lang="en-US" sz="1800" dirty="0">
@@ -11572,7 +11713,7 @@
                   <a:srgbClr val="333333"/>
                 </a:solidFill>
               </a:rPr>
-              <a:t>Ketika pasar anjlok ekstrem, investor akan melarikan senjatanya ke posisi </a:t>
+              <a:t>   2. Namun, kehebatan </a:t>
             </a:r>
             <a:pPr indent="0" marL="0">
               <a:buNone/>
@@ -11583,7 +11724,7 @@
                   <a:srgbClr val="333333"/>
                 </a:solidFill>
               </a:rPr>
-              <a:t>tunai (USDT)</a:t>
+              <a:t>Random Matrix Theory (RMT)</a:t>
             </a:r>
             <a:pPr indent="0" marL="0">
               <a:buNone/>
@@ -11594,7 +11735,79 @@
                   <a:srgbClr val="333333"/>
                 </a:solidFill>
               </a:rPr>
-              <a:t> sebagai evakuasi risiko.</a:t>
+              <a:t> diuji di sini! Karena data yang datar sama sekali tidak punya korelasi nyata.</a:t>
+            </a:r>
+            <a:endParaRPr lang="en-US" sz="1800" dirty="0"/>
+          </a:p>
+          <a:p>
+            <a:pPr indent="0" marL="0">
+              <a:buNone/>
+            </a:pPr>
+            <a:r>
+              <a:rPr lang="en-US" sz="1800" dirty="0">
+                <a:solidFill>
+                  <a:srgbClr val="333333"/>
+                </a:solidFill>
+              </a:rPr>
+              <a:t>   3. RMT otomatis akan mendeteksi korelasi buatan tersebut sebagai probabilitas </a:t>
+            </a:r>
+            <a:pPr indent="0" marL="0">
+              <a:buNone/>
+            </a:pPr>
+            <a:r>
+              <a:rPr lang="en-US" sz="1800" b="1" i="1" dirty="0">
+                <a:solidFill>
+                  <a:srgbClr val="333333"/>
+                </a:solidFill>
+              </a:rPr>
+              <a:t>Noise Acak</a:t>
+            </a:r>
+            <a:pPr indent="0" marL="0">
+              <a:buNone/>
+            </a:pPr>
+            <a:r>
+              <a:rPr lang="en-US" sz="1800" dirty="0">
+                <a:solidFill>
+                  <a:srgbClr val="333333"/>
+                </a:solidFill>
+              </a:rPr>
+              <a:t>, lalu membuangnya menjadi 0.</a:t>
+            </a:r>
+            <a:endParaRPr lang="en-US" sz="1800" dirty="0"/>
+          </a:p>
+          <a:p>
+            <a:pPr indent="0" marL="0">
+              <a:buNone/>
+            </a:pPr>
+            <a:r>
+              <a:rPr lang="en-US" sz="1800" dirty="0">
+                <a:solidFill>
+                  <a:srgbClr val="333333"/>
+                </a:solidFill>
+              </a:rPr>
+              <a:t>   4. Hasilnya, matriks korelasi </a:t>
+            </a:r>
+            <a:pPr indent="0" marL="0">
+              <a:buNone/>
+            </a:pPr>
+            <a:r>
+              <a:rPr lang="en-US" sz="1800" b="1" dirty="0">
+                <a:solidFill>
+                  <a:srgbClr val="333333"/>
+                </a:solidFill>
+              </a:rPr>
+              <a:t>terselamatkan</a:t>
+            </a:r>
+            <a:pPr indent="0" marL="0">
+              <a:buNone/>
+            </a:pPr>
+            <a:r>
+              <a:rPr lang="en-US" sz="1800" dirty="0">
+                <a:solidFill>
+                  <a:srgbClr val="333333"/>
+                </a:solidFill>
+              </a:rPr>
+              <a:t> dan tidak tercemar oleh cacat kelengkapan data.</a:t>
             </a:r>
             <a:endParaRPr lang="en-US" sz="1800" dirty="0"/>
           </a:p>
@@ -11655,7 +11868,7 @@
                   <a:srgbClr val="003366"/>
                 </a:solidFill>
               </a:rPr>
-              <a:t>Lampiran: Mengapa Menyertakan Tether (USDT)? (2/2)</a:t>
+              <a:t>Lampiran: Mengapa Menyertakan Tether (USDT)? (1/2)</a:t>
             </a:r>
             <a:endParaRPr lang="en-US" sz="2600" dirty="0"/>
           </a:p>
@@ -11686,12 +11899,89 @@
               <a:buNone/>
             </a:pPr>
             <a:r>
+              <a:rPr lang="en-US" sz="1800" b="1" dirty="0">
+                <a:solidFill>
+                  <a:srgbClr val="C0392B"/>
+                </a:solidFill>
+              </a:rPr>
+              <a:t>Pertanyaan: </a:t>
+            </a:r>
+            <a:pPr indent="0" marL="0">
+              <a:buNone/>
+            </a:pPr>
+            <a:r>
+              <a:rPr lang="en-US" sz="1800" i="1" dirty="0">
+                <a:solidFill>
+                  <a:srgbClr val="333333"/>
+                </a:solidFill>
+              </a:rPr>
+              <a:t>"Tether (USDT) itu stablecoin yang nilainya selalu fix ke 1 USD. Apakah tidak berbuat curang?"</a:t>
+            </a:r>
+            <a:endParaRPr lang="en-US" sz="1800" dirty="0"/>
+          </a:p>
+          <a:p>
+            <a:pPr indent="0" marL="0">
+              <a:buNone/>
+            </a:pPr>
+            <a:r>
+              <a:rPr lang="en-US" sz="1800" b="1" dirty="0">
+                <a:solidFill>
+                  <a:srgbClr val="27AE60"/>
+                </a:solidFill>
+              </a:rPr>
+              <a:t>Jawaban (Dinamika Portofolio Cerdas):</a:t>
+            </a:r>
+            <a:endParaRPr lang="en-US" sz="1800" dirty="0"/>
+          </a:p>
+          <a:p>
+            <a:pPr marL="342900" indent="-342900">
+              <a:buSzPct val="100000"/>
+              <a:buChar char="•"/>
+            </a:pPr>
+            <a:r>
               <a:rPr lang="en-US" sz="1800" dirty="0">
                 <a:solidFill>
                   <a:srgbClr val="333333"/>
                 </a:solidFill>
               </a:rPr>
-              <a:t>3. Algoritma jaringan </a:t>
+              <a:t>Model ini mensimulasikan perilaku </a:t>
+            </a:r>
+            <a:pPr indent="0" marL="0">
+              <a:buNone/>
+            </a:pPr>
+            <a:r>
+              <a:rPr lang="en-US" sz="1800" b="1" i="1" dirty="0">
+                <a:solidFill>
+                  <a:srgbClr val="333333"/>
+                </a:solidFill>
+              </a:rPr>
+              <a:t>Robo-Advisory</a:t>
+            </a:r>
+            <a:pPr indent="0" marL="0">
+              <a:buNone/>
+            </a:pPr>
+            <a:r>
+              <a:rPr lang="en-US" sz="1800" dirty="0">
+                <a:solidFill>
+                  <a:srgbClr val="333333"/>
+                </a:solidFill>
+              </a:rPr>
+              <a:t> institusional.</a:t>
+            </a:r>
+            <a:endParaRPr lang="en-US" sz="1800" dirty="0"/>
+          </a:p>
+          <a:p>
+            <a:pPr marL="342900" indent="-342900">
+              <a:buSzPct val="100000"/>
+              <a:buChar char="•"/>
+            </a:pPr>
+            <a:r>
+              <a:rPr lang="en-US" sz="1800" dirty="0">
+                <a:solidFill>
+                  <a:srgbClr val="333333"/>
+                </a:solidFill>
+              </a:rPr>
+              <a:t>Ketika pasar anjlok ekstrem, investor akan melarikan senjatanya ke posisi </a:t>
             </a:r>
             <a:pPr indent="0" marL="0">
               <a:buNone/>
@@ -11702,7 +11992,7 @@
                   <a:srgbClr val="333333"/>
                 </a:solidFill>
               </a:rPr>
-              <a:t>Network Markowitz GS (Grid Search)</a:t>
+              <a:t>tunai (USDT)</a:t>
             </a:r>
             <a:pPr indent="0" marL="0">
               <a:buNone/>
@@ -11713,87 +12003,7 @@
                   <a:srgbClr val="333333"/>
                 </a:solidFill>
               </a:rPr>
-              <a:t> dilatih secara matematis; jika mendeteksi korelasi ancaman kolaps merambat ke semua altcoin, ia akan melempar alokasi modalnya menuju node </a:t>
-            </a:r>
-            <a:pPr indent="0" marL="0">
-              <a:buNone/>
-            </a:pPr>
-            <a:r>
-              <a:rPr lang="en-US" sz="1800" b="1" dirty="0">
-                <a:solidFill>
-                  <a:srgbClr val="333333"/>
-                </a:solidFill>
-              </a:rPr>
-              <a:t>USDT (Tether)</a:t>
-            </a:r>
-            <a:pPr indent="0" marL="0">
-              <a:buNone/>
-            </a:pPr>
-            <a:r>
-              <a:rPr lang="en-US" sz="1800" dirty="0">
-                <a:solidFill>
-                  <a:srgbClr val="333333"/>
-                </a:solidFill>
-              </a:rPr>
-              <a:t> sebagai langkah </a:t>
-            </a:r>
-            <a:pPr indent="0" marL="0">
-              <a:buNone/>
-            </a:pPr>
-            <a:r>
-              <a:rPr lang="en-US" sz="1800" b="1" dirty="0">
-                <a:solidFill>
-                  <a:srgbClr val="333333"/>
-                </a:solidFill>
-              </a:rPr>
-              <a:t>evakuasi otomatis</a:t>
-            </a:r>
-            <a:pPr indent="0" marL="0">
-              <a:buNone/>
-            </a:pPr>
-            <a:r>
-              <a:rPr lang="en-US" sz="1800" dirty="0">
-                <a:solidFill>
-                  <a:srgbClr val="333333"/>
-                </a:solidFill>
-              </a:rPr>
-              <a:t> (Shock-Absorber).</a:t>
-            </a:r>
-            <a:endParaRPr lang="en-US" sz="1800" dirty="0"/>
-          </a:p>
-          <a:p>
-            <a:pPr indent="0" marL="0">
-              <a:buNone/>
-            </a:pPr>
-            <a:r>
-              <a:rPr lang="en-US" sz="1800" dirty="0">
-                <a:solidFill>
-                  <a:srgbClr val="333333"/>
-                </a:solidFill>
-              </a:rPr>
-              <a:t>   4. Hal ini yang membuat performa Risk-GS (Grid Search) sangat </a:t>
-            </a:r>
-            <a:pPr indent="0" marL="0">
-              <a:buNone/>
-            </a:pPr>
-            <a:r>
-              <a:rPr lang="en-US" sz="1800" b="1" dirty="0">
-                <a:solidFill>
-                  <a:srgbClr val="333333"/>
-                </a:solidFill>
-              </a:rPr>
-              <a:t>tangguh</a:t>
-            </a:r>
-            <a:pPr indent="0" marL="0">
-              <a:buNone/>
-            </a:pPr>
-            <a:r>
-              <a:rPr lang="en-US" sz="1800" dirty="0">
-                <a:solidFill>
-                  <a:srgbClr val="333333"/>
-                </a:solidFill>
-              </a:rPr>
-              <a:t> dari serangan Crypto Winter, suatu kapabilitas pertahanan yang tidak dipahami oleh model ortodoks murni Markowitz.</a:t>
+              <a:t> sebagai evakuasi risiko.</a:t>
             </a:r>
             <a:endParaRPr lang="en-US" sz="1800" dirty="0"/>
           </a:p>
@@ -11854,7 +12064,7 @@
                   <a:srgbClr val="003366"/>
                 </a:solidFill>
               </a:rPr>
-              <a:t>Lampiran: Bukti Empiris Non-Stationarity Pasar</a:t>
+              <a:t>Lampiran: Mengapa Menyertakan Tether (USDT)? (2/2)</a:t>
             </a:r>
             <a:endParaRPr lang="en-US" sz="2600" dirty="0"/>
           </a:p>
@@ -11885,23 +12095,78 @@
               <a:buNone/>
             </a:pPr>
             <a:r>
+              <a:rPr lang="en-US" sz="1800" dirty="0">
+                <a:solidFill>
+                  <a:srgbClr val="333333"/>
+                </a:solidFill>
+              </a:rPr>
+              <a:t>3. Algoritma jaringan </a:t>
+            </a:r>
+            <a:pPr indent="0" marL="0">
+              <a:buNone/>
+            </a:pPr>
+            <a:r>
               <a:rPr lang="en-US" sz="1800" b="1" dirty="0">
                 <a:solidFill>
-                  <a:srgbClr val="C0392B"/>
-                </a:solidFill>
-              </a:rPr>
-              <a:t>Masalah: </a:t>
-            </a:r>
-            <a:pPr indent="0" marL="0">
-              <a:buNone/>
-            </a:pPr>
-            <a:r>
-              <a:rPr lang="en-US" sz="1800" i="1" dirty="0">
-                <a:solidFill>
-                  <a:srgbClr val="333333"/>
-                </a:solidFill>
-              </a:rPr>
-              <a:t>Kenapa harus menggunakan model Adaptif (Dynamic Gamma)?</a:t>
+                  <a:srgbClr val="333333"/>
+                </a:solidFill>
+              </a:rPr>
+              <a:t>Network Markowitz GS (Grid Search)</a:t>
+            </a:r>
+            <a:pPr indent="0" marL="0">
+              <a:buNone/>
+            </a:pPr>
+            <a:r>
+              <a:rPr lang="en-US" sz="1800" dirty="0">
+                <a:solidFill>
+                  <a:srgbClr val="333333"/>
+                </a:solidFill>
+              </a:rPr>
+              <a:t> dilatih secara matematis; jika mendeteksi korelasi ancaman kolaps merambat ke semua altcoin, ia akan melempar alokasi modalnya menuju node </a:t>
+            </a:r>
+            <a:pPr indent="0" marL="0">
+              <a:buNone/>
+            </a:pPr>
+            <a:r>
+              <a:rPr lang="en-US" sz="1800" b="1" dirty="0">
+                <a:solidFill>
+                  <a:srgbClr val="333333"/>
+                </a:solidFill>
+              </a:rPr>
+              <a:t>USDT (Tether)</a:t>
+            </a:r>
+            <a:pPr indent="0" marL="0">
+              <a:buNone/>
+            </a:pPr>
+            <a:r>
+              <a:rPr lang="en-US" sz="1800" dirty="0">
+                <a:solidFill>
+                  <a:srgbClr val="333333"/>
+                </a:solidFill>
+              </a:rPr>
+              <a:t> sebagai langkah </a:t>
+            </a:r>
+            <a:pPr indent="0" marL="0">
+              <a:buNone/>
+            </a:pPr>
+            <a:r>
+              <a:rPr lang="en-US" sz="1800" b="1" dirty="0">
+                <a:solidFill>
+                  <a:srgbClr val="333333"/>
+                </a:solidFill>
+              </a:rPr>
+              <a:t>evakuasi otomatis</a:t>
+            </a:r>
+            <a:pPr indent="0" marL="0">
+              <a:buNone/>
+            </a:pPr>
+            <a:r>
+              <a:rPr lang="en-US" sz="1800" dirty="0">
+                <a:solidFill>
+                  <a:srgbClr val="333333"/>
+                </a:solidFill>
+              </a:rPr>
+              <a:t> (Shock-Absorber).</a:t>
             </a:r>
             <a:endParaRPr lang="en-US" sz="1800" dirty="0"/>
           </a:p>
@@ -11910,19 +12175,26 @@
               <a:buNone/>
             </a:pPr>
             <a:r>
+              <a:rPr lang="en-US" sz="1800" dirty="0">
+                <a:solidFill>
+                  <a:srgbClr val="333333"/>
+                </a:solidFill>
+              </a:rPr>
+              <a:t>   4. Hal ini yang membuat performa Risk-GS (Grid Search) sangat </a:t>
+            </a:r>
+            <a:pPr indent="0" marL="0">
+              <a:buNone/>
+            </a:pPr>
+            <a:r>
               <a:rPr lang="en-US" sz="1800" b="1" dirty="0">
                 <a:solidFill>
-                  <a:srgbClr val="27AE60"/>
-                </a:solidFill>
-              </a:rPr>
-              <a:t>Bukti dari Grid Search:</a:t>
-            </a:r>
-            <a:endParaRPr lang="en-US" sz="1800" dirty="0"/>
-          </a:p>
-          <a:p>
-            <a:pPr marL="342900" indent="-342900">
-              <a:buSzPct val="100000"/>
-              <a:buChar char="•"/>
+                  <a:srgbClr val="333333"/>
+                </a:solidFill>
+              </a:rPr>
+              <a:t>tangguh</a:t>
+            </a:r>
+            <a:pPr indent="0" marL="0">
+              <a:buNone/>
             </a:pPr>
             <a:r>
               <a:rPr lang="en-US" sz="1800" dirty="0">
@@ -11930,103 +12202,7 @@
                   <a:srgbClr val="333333"/>
                 </a:solidFill>
               </a:rPr>
-              <a:t>Data menunjukkan nilai Gamma (γ) optimal </a:t>
-            </a:r>
-            <a:pPr indent="0" marL="0">
-              <a:buNone/>
-            </a:pPr>
-            <a:r>
-              <a:rPr lang="en-US" sz="1800" b="1" dirty="0">
-                <a:solidFill>
-                  <a:srgbClr val="333333"/>
-                </a:solidFill>
-              </a:rPr>
-              <a:t>terus bergeser</a:t>
-            </a:r>
-            <a:pPr indent="0" marL="0">
-              <a:buNone/>
-            </a:pPr>
-            <a:r>
-              <a:rPr lang="en-US" sz="1800" dirty="0">
-                <a:solidFill>
-                  <a:srgbClr val="333333"/>
-                </a:solidFill>
-              </a:rPr>
-              <a:t> setiap periode rebalancing.</a:t>
-            </a:r>
-            <a:endParaRPr lang="en-US" sz="1800" dirty="0"/>
-          </a:p>
-          <a:p>
-            <a:pPr marL="342900" indent="-342900">
-              <a:buSzPct val="100000"/>
-              <a:buChar char="•"/>
-            </a:pPr>
-            <a:r>
-              <a:rPr lang="en-US" sz="1800" dirty="0">
-                <a:solidFill>
-                  <a:srgbClr val="333333"/>
-                </a:solidFill>
-              </a:rPr>
-              <a:t>Penggunaan γ statis tidak cukup untuk menangkap perubahan </a:t>
-            </a:r>
-            <a:pPr indent="0" marL="0">
-              <a:buNone/>
-            </a:pPr>
-            <a:r>
-              <a:rPr lang="en-US" sz="1800" b="1" dirty="0">
-                <a:solidFill>
-                  <a:srgbClr val="333333"/>
-                </a:solidFill>
-              </a:rPr>
-              <a:t>struktur korelasi</a:t>
-            </a:r>
-            <a:pPr indent="0" marL="0">
-              <a:buNone/>
-            </a:pPr>
-            <a:r>
-              <a:rPr lang="en-US" sz="1800" dirty="0">
-                <a:solidFill>
-                  <a:srgbClr val="333333"/>
-                </a:solidFill>
-              </a:rPr>
-              <a:t> yang sangat cepat di pasar kripto.</a:t>
-            </a:r>
-            <a:endParaRPr lang="en-US" sz="1800" dirty="0"/>
-          </a:p>
-          <a:p>
-            <a:pPr marL="342900" indent="-342900">
-              <a:buSzPct val="100000"/>
-              <a:buChar char="•"/>
-            </a:pPr>
-            <a:r>
-              <a:rPr lang="en-US" sz="1800" dirty="0">
-                <a:solidFill>
-                  <a:srgbClr val="333333"/>
-                </a:solidFill>
-              </a:rPr>
-              <a:t>Ini membenarkan bahwa pasar kripto membutuhkan </a:t>
-            </a:r>
-            <a:pPr indent="0" marL="0">
-              <a:buNone/>
-            </a:pPr>
-            <a:r>
-              <a:rPr lang="en-US" sz="1800" b="1" dirty="0">
-                <a:solidFill>
-                  <a:srgbClr val="333333"/>
-                </a:solidFill>
-              </a:rPr>
-              <a:t>kalibrasi otomatis</a:t>
-            </a:r>
-            <a:pPr indent="0" marL="0">
-              <a:buNone/>
-            </a:pPr>
-            <a:r>
-              <a:rPr lang="en-US" sz="1800" dirty="0">
-                <a:solidFill>
-                  <a:srgbClr val="333333"/>
-                </a:solidFill>
-              </a:rPr>
-              <a:t> secara temporal.</a:t>
+              <a:t> dari serangan Crypto Winter, suatu kapabilitas pertahanan yang tidak dipahami oleh model ortodoks murni Markowitz.</a:t>
             </a:r>
             <a:endParaRPr lang="en-US" sz="1800" dirty="0"/>
           </a:p>
@@ -12043,6 +12219,239 @@
 <file path=ppt/slides/slide38.xml><?xml version="1.0" encoding="utf-8"?>
 <p:sld xmlns:a="http://schemas.openxmlformats.org/drawingml/2006/main" xmlns:r="http://schemas.openxmlformats.org/officeDocument/2006/relationships" xmlns:p="http://schemas.openxmlformats.org/presentationml/2006/main">
   <p:cSld name="Slide 38">
+    <p:spTree>
+      <p:nvGrpSpPr>
+        <p:cNvPr id="1" name=""/>
+        <p:cNvGrpSpPr/>
+        <p:nvPr/>
+      </p:nvGrpSpPr>
+      <p:grpSpPr>
+        <a:xfrm>
+          <a:off x="0" y="0"/>
+          <a:ext cx="0" cy="0"/>
+          <a:chOff x="0" y="0"/>
+          <a:chExt cx="0" cy="0"/>
+        </a:xfrm>
+      </p:grpSpPr>
+      <p:sp>
+        <p:nvSpPr>
+          <p:cNvPr id="2" name="Text 0"/>
+          <p:cNvSpPr/>
+          <p:nvPr/>
+        </p:nvSpPr>
+        <p:spPr>
+          <a:xfrm>
+            <a:off x="457200" y="457200"/>
+            <a:ext cx="8229600" cy="0"/>
+          </a:xfrm>
+          <a:prstGeom prst="rect">
+            <a:avLst/>
+          </a:prstGeom>
+          <a:noFill/>
+          <a:ln/>
+        </p:spPr>
+        <p:txBody>
+          <a:bodyPr wrap="square" rtlCol="0" anchor="ctr"/>
+          <a:lstStyle/>
+          <a:p>
+            <a:pPr indent="0" marL="0">
+              <a:buNone/>
+            </a:pPr>
+            <a:r>
+              <a:rPr lang="en-US" sz="2600" b="1" dirty="0">
+                <a:solidFill>
+                  <a:srgbClr val="003366"/>
+                </a:solidFill>
+              </a:rPr>
+              <a:t>Lampiran: Bukti Empiris Non-Stationarity Pasar</a:t>
+            </a:r>
+            <a:endParaRPr lang="en-US" sz="2600" dirty="0"/>
+          </a:p>
+        </p:txBody>
+      </p:sp>
+      <p:sp>
+        <p:nvSpPr>
+          <p:cNvPr id="3" name="Text 1"/>
+          <p:cNvSpPr/>
+          <p:nvPr/>
+        </p:nvSpPr>
+        <p:spPr>
+          <a:xfrm>
+            <a:off x="457200" y="1005840"/>
+            <a:ext cx="8229600" cy="5029200"/>
+          </a:xfrm>
+          <a:prstGeom prst="rect">
+            <a:avLst/>
+          </a:prstGeom>
+          <a:noFill/>
+          <a:ln/>
+        </p:spPr>
+        <p:txBody>
+          <a:bodyPr wrap="square" rtlCol="0" anchor="t"/>
+          <a:lstStyle/>
+          <a:p>
+            <a:pPr indent="0" marL="0">
+              <a:buNone/>
+            </a:pPr>
+            <a:r>
+              <a:rPr lang="en-US" sz="1800" b="1" dirty="0">
+                <a:solidFill>
+                  <a:srgbClr val="C0392B"/>
+                </a:solidFill>
+              </a:rPr>
+              <a:t>Masalah: </a:t>
+            </a:r>
+            <a:pPr indent="0" marL="0">
+              <a:buNone/>
+            </a:pPr>
+            <a:r>
+              <a:rPr lang="en-US" sz="1800" i="1" dirty="0">
+                <a:solidFill>
+                  <a:srgbClr val="333333"/>
+                </a:solidFill>
+              </a:rPr>
+              <a:t>Kenapa harus menggunakan model Adaptif (Dynamic Gamma)?</a:t>
+            </a:r>
+            <a:endParaRPr lang="en-US" sz="1800" dirty="0"/>
+          </a:p>
+          <a:p>
+            <a:pPr indent="0" marL="0">
+              <a:buNone/>
+            </a:pPr>
+            <a:r>
+              <a:rPr lang="en-US" sz="1800" b="1" dirty="0">
+                <a:solidFill>
+                  <a:srgbClr val="27AE60"/>
+                </a:solidFill>
+              </a:rPr>
+              <a:t>Bukti dari Grid Search:</a:t>
+            </a:r>
+            <a:endParaRPr lang="en-US" sz="1800" dirty="0"/>
+          </a:p>
+          <a:p>
+            <a:pPr marL="342900" indent="-342900">
+              <a:buSzPct val="100000"/>
+              <a:buChar char="•"/>
+            </a:pPr>
+            <a:r>
+              <a:rPr lang="en-US" sz="1800" dirty="0">
+                <a:solidFill>
+                  <a:srgbClr val="333333"/>
+                </a:solidFill>
+              </a:rPr>
+              <a:t>Data menunjukkan nilai Gamma (γ) optimal </a:t>
+            </a:r>
+            <a:pPr indent="0" marL="0">
+              <a:buNone/>
+            </a:pPr>
+            <a:r>
+              <a:rPr lang="en-US" sz="1800" b="1" dirty="0">
+                <a:solidFill>
+                  <a:srgbClr val="333333"/>
+                </a:solidFill>
+              </a:rPr>
+              <a:t>terus bergeser</a:t>
+            </a:r>
+            <a:pPr indent="0" marL="0">
+              <a:buNone/>
+            </a:pPr>
+            <a:r>
+              <a:rPr lang="en-US" sz="1800" dirty="0">
+                <a:solidFill>
+                  <a:srgbClr val="333333"/>
+                </a:solidFill>
+              </a:rPr>
+              <a:t> setiap periode rebalancing.</a:t>
+            </a:r>
+            <a:endParaRPr lang="en-US" sz="1800" dirty="0"/>
+          </a:p>
+          <a:p>
+            <a:pPr marL="342900" indent="-342900">
+              <a:buSzPct val="100000"/>
+              <a:buChar char="•"/>
+            </a:pPr>
+            <a:r>
+              <a:rPr lang="en-US" sz="1800" dirty="0">
+                <a:solidFill>
+                  <a:srgbClr val="333333"/>
+                </a:solidFill>
+              </a:rPr>
+              <a:t>Penggunaan γ statis tidak cukup untuk menangkap perubahan </a:t>
+            </a:r>
+            <a:pPr indent="0" marL="0">
+              <a:buNone/>
+            </a:pPr>
+            <a:r>
+              <a:rPr lang="en-US" sz="1800" b="1" dirty="0">
+                <a:solidFill>
+                  <a:srgbClr val="333333"/>
+                </a:solidFill>
+              </a:rPr>
+              <a:t>struktur korelasi</a:t>
+            </a:r>
+            <a:pPr indent="0" marL="0">
+              <a:buNone/>
+            </a:pPr>
+            <a:r>
+              <a:rPr lang="en-US" sz="1800" dirty="0">
+                <a:solidFill>
+                  <a:srgbClr val="333333"/>
+                </a:solidFill>
+              </a:rPr>
+              <a:t> yang sangat cepat di pasar kripto.</a:t>
+            </a:r>
+            <a:endParaRPr lang="en-US" sz="1800" dirty="0"/>
+          </a:p>
+          <a:p>
+            <a:pPr marL="342900" indent="-342900">
+              <a:buSzPct val="100000"/>
+              <a:buChar char="•"/>
+            </a:pPr>
+            <a:r>
+              <a:rPr lang="en-US" sz="1800" dirty="0">
+                <a:solidFill>
+                  <a:srgbClr val="333333"/>
+                </a:solidFill>
+              </a:rPr>
+              <a:t>Ini membenarkan bahwa pasar kripto membutuhkan </a:t>
+            </a:r>
+            <a:pPr indent="0" marL="0">
+              <a:buNone/>
+            </a:pPr>
+            <a:r>
+              <a:rPr lang="en-US" sz="1800" b="1" dirty="0">
+                <a:solidFill>
+                  <a:srgbClr val="333333"/>
+                </a:solidFill>
+              </a:rPr>
+              <a:t>kalibrasi otomatis</a:t>
+            </a:r>
+            <a:pPr indent="0" marL="0">
+              <a:buNone/>
+            </a:pPr>
+            <a:r>
+              <a:rPr lang="en-US" sz="1800" dirty="0">
+                <a:solidFill>
+                  <a:srgbClr val="333333"/>
+                </a:solidFill>
+              </a:rPr>
+              <a:t> secara temporal.</a:t>
+            </a:r>
+            <a:endParaRPr lang="en-US" sz="1800" dirty="0"/>
+          </a:p>
+        </p:txBody>
+      </p:sp>
+    </p:spTree>
+  </p:cSld>
+  <p:clrMapOvr>
+    <a:masterClrMapping/>
+  </p:clrMapOvr>
+</p:sld>
+</file>
+
+<file path=ppt/slides/slide39.xml><?xml version="1.0" encoding="utf-8"?>
+<p:sld xmlns:a="http://schemas.openxmlformats.org/drawingml/2006/main" xmlns:r="http://schemas.openxmlformats.org/officeDocument/2006/relationships" xmlns:p="http://schemas.openxmlformats.org/presentationml/2006/main">
+  <p:cSld name="Slide 39">
     <p:spTree>
       <p:nvGrpSpPr>
         <p:cNvPr id="1" name=""/>

</xml_diff>

<commit_message>
feat: add detailed calculation slide for Network Markowitz weights
</commit_message>
<xml_diff>
--- a/Presentasi_Proposal_Update.pptx
+++ b/Presentasi_Proposal_Update.pptx
@@ -44,9 +44,10 @@
     <p:sldId id="292" r:id="rId38"/>
     <p:sldId id="293" r:id="rId39"/>
     <p:sldId id="294" r:id="rId40"/>
+    <p:sldId id="295" r:id="rId41"/>
   </p:sldIdLst>
   <p:notesMasterIdLst>
-    <p:notesMasterId r:id="rId41"/>
+    <p:notesMasterId r:id="rId42"/>
   </p:notesMasterIdLst>
   <p:sldSz cx="9144000" cy="5143500"/>
   <p:notesSz cx="5143500" cy="9144000"/>
@@ -3468,6 +3469,94 @@
             <a:fld id="{F7021451-1387-4CA6-816F-3879F97B5CBC}" type="slidenum">
               <a:rPr lang="en-US"/>
               <a:t>4</a:t>
+            </a:fld>
+            <a:endParaRPr lang="en-US"/>
+          </a:p>
+        </p:txBody>
+      </p:sp>
+    </p:spTree>
+    <p:extLst>
+      <p:ext uri="{BB962C8B-B14F-4D97-AF65-F5344CB8AC3E}">
+        <p14:creationId xmlns:p14="http://schemas.microsoft.com/office/powerpoint/2010/main" val="1024086991"/>
+      </p:ext>
+    </p:extLst>
+  </p:cSld>
+  <p:clrMapOvr>
+    <a:masterClrMapping/>
+  </p:clrMapOvr>
+</p:notes>
+</file>
+
+<file path=ppt/notesSlides/notesSlide40.xml><?xml version="1.0" encoding="utf-8"?>
+<p:notes xmlns:a="http://schemas.openxmlformats.org/drawingml/2006/main" xmlns:r="http://schemas.openxmlformats.org/officeDocument/2006/relationships" xmlns:p="http://schemas.openxmlformats.org/presentationml/2006/main">
+  <p:cSld>
+    <p:spTree>
+      <p:nvGrpSpPr>
+        <p:cNvPr id="1" name=""/>
+        <p:cNvGrpSpPr/>
+        <p:nvPr/>
+      </p:nvGrpSpPr>
+      <p:grpSpPr>
+        <a:xfrm>
+          <a:off x="0" y="0"/>
+          <a:ext cx="0" cy="0"/>
+          <a:chOff x="0" y="0"/>
+          <a:chExt cx="0" cy="0"/>
+        </a:xfrm>
+      </p:grpSpPr>
+      <p:sp>
+        <p:nvSpPr>
+          <p:cNvPr id="2" name="Slide Image Placeholder 1"/>
+          <p:cNvSpPr>
+            <a:spLocks noGrp="1" noRot="1" noChangeAspect="1"/>
+          </p:cNvSpPr>
+          <p:nvPr>
+            <p:ph type="sldImg"/>
+          </p:nvPr>
+        </p:nvSpPr>
+        <p:spPr/>
+      </p:sp>
+      <p:sp>
+        <p:nvSpPr>
+          <p:cNvPr id="3" name="Notes Placeholder 2"/>
+          <p:cNvSpPr>
+            <a:spLocks noGrp="1"/>
+          </p:cNvSpPr>
+          <p:nvPr>
+            <p:ph type="body" idx="1"/>
+          </p:nvPr>
+        </p:nvSpPr>
+        <p:spPr/>
+        <p:txBody>
+          <a:bodyPr/>
+          <a:lstStyle/>
+          <a:p>
+            <a:r>
+              <a:rPr lang="en-US" dirty="0"/>
+              <a:t/>
+            </a:r>
+            <a:endParaRPr lang="en-US" dirty="0"/>
+          </a:p>
+        </p:txBody>
+      </p:sp>
+      <p:sp>
+        <p:nvSpPr>
+          <p:cNvPr id="4" name="Slide Number Placeholder 3"/>
+          <p:cNvSpPr>
+            <a:spLocks noGrp="1"/>
+          </p:cNvSpPr>
+          <p:nvPr>
+            <p:ph type="sldNum" sz="quarter" idx="10"/>
+          </p:nvPr>
+        </p:nvSpPr>
+        <p:spPr/>
+        <p:txBody>
+          <a:bodyPr/>
+          <a:lstStyle/>
+          <a:p>
+            <a:fld id="{F7021451-1387-4CA6-816F-3879F97B5CBC}" type="slidenum">
+              <a:rPr lang="en-US"/>
+              <a:t>40</a:t>
             </a:fld>
             <a:endParaRPr lang="en-US"/>
           </a:p>
@@ -11324,14 +11413,14 @@
               <a:buNone/>
             </a:pPr>
             <a:r>
-              <a:rPr lang="en-US" sz="2600" b="1" dirty="0">
+              <a:rPr lang="en-US" sz="2400" b="1" dirty="0">
                 <a:solidFill>
                   <a:srgbClr val="003366"/>
                 </a:solidFill>
               </a:rPr>
-              <a:t>Lampiran: Dua Tipe Pendekatan Grid Search</a:t>
-            </a:r>
-            <a:endParaRPr lang="en-US" sz="2600" dirty="0"/>
+              <a:t>Lampiran: Detail Kalkulasi Penentuan Bobot NW</a:t>
+            </a:r>
+            <a:endParaRPr lang="en-US" sz="2400" dirty="0"/>
           </a:p>
         </p:txBody>
       </p:sp>
@@ -11360,190 +11449,226 @@
               <a:buNone/>
             </a:pPr>
             <a:r>
-              <a:rPr lang="en-US" sz="1800" b="1" dirty="0">
-                <a:solidFill>
-                  <a:srgbClr val="333333"/>
-                </a:solidFill>
-              </a:rPr>
-              <a:t>Dua Objektif Optimasi (Return vs Risk):</a:t>
-            </a:r>
-            <a:endParaRPr lang="en-US" sz="1800" dirty="0"/>
-          </a:p>
-          <a:p>
-            <a:pPr indent="0" marL="0">
-              <a:buNone/>
-            </a:pPr>
-            <a:r>
-              <a:rPr lang="en-US" sz="1800" b="1" dirty="0">
+              <a:rPr lang="en-US" sz="1600" b="1" dirty="0">
+                <a:solidFill>
+                  <a:srgbClr val="333333"/>
+                </a:solidFill>
+              </a:rPr>
+              <a:t>Bagaimana 'Penalti' mengubah angka bobot secara konkret?</a:t>
+            </a:r>
+            <a:endParaRPr lang="en-US" sz="1600" dirty="0"/>
+          </a:p>
+          <a:p>
+            <a:pPr indent="0" marL="0">
+              <a:buNone/>
+            </a:pPr>
+            <a:r>
+              <a:rPr lang="en-US" sz="1600" b="1" dirty="0">
+                <a:solidFill>
+                  <a:srgbClr val="003366"/>
+                </a:solidFill>
+              </a:rPr>
+              <a:t>1. Data Aset (Dummy):</a:t>
+            </a:r>
+            <a:endParaRPr lang="en-US" sz="1600" dirty="0"/>
+          </a:p>
+          <a:p>
+            <a:pPr indent="0" marL="0">
+              <a:buNone/>
+            </a:pPr>
+            <a:r>
+              <a:rPr lang="en-US" sz="1600" dirty="0">
+                <a:solidFill>
+                  <a:srgbClr val="333333"/>
+                </a:solidFill>
+              </a:rPr>
+              <a:t>   • Aset A (Hub): Volatilitas = 20%, Centrality (EC) = 0.8</a:t>
+            </a:r>
+            <a:endParaRPr lang="en-US" sz="1600" dirty="0"/>
+          </a:p>
+          <a:p>
+            <a:pPr indent="0" marL="0">
+              <a:buNone/>
+            </a:pPr>
+            <a:r>
+              <a:rPr lang="en-US" sz="1600" dirty="0">
+                <a:solidFill>
+                  <a:srgbClr val="333333"/>
+                </a:solidFill>
+              </a:rPr>
+              <a:t>   • Aset B (Peripheral): Volatilitas = 30%, Centrality (EC) = 0.2</a:t>
+            </a:r>
+            <a:endParaRPr lang="en-US" sz="1600" dirty="0"/>
+          </a:p>
+          <a:p>
+            <a:pPr indent="0" marL="0">
+              <a:buNone/>
+            </a:pPr>
+            <a:r>
+              <a:rPr lang="en-US" sz="1600" dirty="0">
+                <a:solidFill>
+                  <a:srgbClr val="333333"/>
+                </a:solidFill>
+              </a:rPr>
+              <a:t>   • Parameter Gamma (γ) = 0.5</a:t>
+            </a:r>
+            <a:endParaRPr lang="en-US" sz="1600" dirty="0"/>
+          </a:p>
+          <a:p>
+            <a:pPr indent="0" marL="0">
+              <a:buNone/>
+            </a:pPr>
+            <a:r>
+              <a:rPr lang="en-US" sz="1600" b="1" dirty="0">
+                <a:solidFill>
+                  <a:srgbClr val="003366"/>
+                </a:solidFill>
+              </a:rPr>
+              <a:t>2. Perhitungan Risiko Penyesuaian (Adjusted Risk):</a:t>
+            </a:r>
+            <a:endParaRPr lang="en-US" sz="1600" dirty="0"/>
+          </a:p>
+          <a:p>
+            <a:pPr indent="0" marL="0">
+              <a:buNone/>
+            </a:pPr>
+            <a:r>
+              <a:rPr lang="en-US" sz="1600" dirty="0">
+                <a:solidFill>
+                  <a:srgbClr val="333333"/>
+                </a:solidFill>
+              </a:rPr>
+              <a:t>   • Risiko A = 0.20 + (0.5 × 0.8) = </a:t>
+            </a:r>
+            <a:pPr indent="0" marL="0">
+              <a:buNone/>
+            </a:pPr>
+            <a:r>
+              <a:rPr lang="en-US" sz="1600" b="1" dirty="0">
+                <a:solidFill>
+                  <a:srgbClr val="C0392B"/>
+                </a:solidFill>
+              </a:rPr>
+              <a:t>0.60 (Meningkat)</a:t>
+            </a:r>
+            <a:endParaRPr lang="en-US" sz="1600" dirty="0"/>
+          </a:p>
+          <a:p>
+            <a:pPr indent="0" marL="0">
+              <a:buNone/>
+            </a:pPr>
+            <a:r>
+              <a:rPr lang="en-US" sz="1600" dirty="0">
+                <a:solidFill>
+                  <a:srgbClr val="333333"/>
+                </a:solidFill>
+              </a:rPr>
+              <a:t>   • Risiko B = 0.30 + (0.5 × 0.2) = </a:t>
+            </a:r>
+            <a:pPr indent="0" marL="0">
+              <a:buNone/>
+            </a:pPr>
+            <a:r>
+              <a:rPr lang="en-US" sz="1600" b="1" dirty="0">
                 <a:solidFill>
                   <a:srgbClr val="27AE60"/>
                 </a:solidFill>
               </a:rPr>
-              <a:t>1. Network Markowitz dengan Target Return (NW - Return Grid Search):</a:t>
-            </a:r>
-            <a:endParaRPr lang="en-US" sz="1800" dirty="0"/>
-          </a:p>
-          <a:p>
-            <a:pPr marL="342900" indent="-342900">
-              <a:buSzPct val="100000"/>
-              <a:buChar char="•"/>
-            </a:pPr>
-            <a:r>
-              <a:rPr lang="en-US" sz="1800" dirty="0">
-                <a:solidFill>
-                  <a:srgbClr val="333333"/>
-                </a:solidFill>
-              </a:rPr>
-              <a:t>Memaksimalkan capaian </a:t>
-            </a:r>
-            <a:pPr indent="0" marL="0">
-              <a:buNone/>
-            </a:pPr>
-            <a:r>
-              <a:rPr lang="en-US" sz="1800" b="1" dirty="0">
-                <a:solidFill>
-                  <a:srgbClr val="333333"/>
-                </a:solidFill>
-              </a:rPr>
-              <a:t>imbal hasil</a:t>
-            </a:r>
-            <a:pPr indent="0" marL="0">
-              <a:buNone/>
-            </a:pPr>
-            <a:r>
-              <a:rPr lang="en-US" sz="1800" dirty="0">
-                <a:solidFill>
-                  <a:srgbClr val="333333"/>
-                </a:solidFill>
-              </a:rPr>
-              <a:t> portofolio.</a:t>
-            </a:r>
-            <a:endParaRPr lang="en-US" sz="1800" dirty="0"/>
-          </a:p>
-          <a:p>
-            <a:pPr marL="342900" indent="-342900">
-              <a:buSzPct val="100000"/>
-              <a:buChar char="•"/>
-            </a:pPr>
-            <a:r>
-              <a:rPr lang="en-US" sz="1800" dirty="0">
-                <a:solidFill>
-                  <a:srgbClr val="333333"/>
-                </a:solidFill>
-              </a:rPr>
-              <a:t>Lebih Agresif untuk mengeksploitasi reli pada pasar </a:t>
-            </a:r>
-            <a:pPr indent="0" marL="0">
-              <a:buNone/>
-            </a:pPr>
-            <a:r>
-              <a:rPr lang="en-US" sz="1800" b="1" dirty="0">
-                <a:solidFill>
-                  <a:srgbClr val="333333"/>
-                </a:solidFill>
-              </a:rPr>
-              <a:t>Bullish</a:t>
-            </a:r>
-            <a:pPr indent="0" marL="0">
-              <a:buNone/>
-            </a:pPr>
-            <a:r>
-              <a:rPr lang="en-US" sz="1800" dirty="0">
-                <a:solidFill>
-                  <a:srgbClr val="333333"/>
-                </a:solidFill>
-              </a:rPr>
-              <a:t>.</a:t>
-            </a:r>
-            <a:endParaRPr lang="en-US" sz="1800" dirty="0"/>
-          </a:p>
-          <a:p>
-            <a:pPr indent="0" marL="0">
-              <a:buNone/>
-            </a:pPr>
-            <a:r>
-              <a:rPr lang="en-US" sz="1800" b="1" dirty="0">
+              <a:t>0.40 (Relatif Stabil)</a:t>
+            </a:r>
+            <a:endParaRPr lang="en-US" sz="1600" dirty="0"/>
+          </a:p>
+          <a:p>
+            <a:pPr indent="0" marL="0">
+              <a:buNone/>
+            </a:pPr>
+            <a:r>
+              <a:rPr lang="en-US" sz="1600" b="1" dirty="0">
+                <a:solidFill>
+                  <a:srgbClr val="003366"/>
+                </a:solidFill>
+              </a:rPr>
+              <a:t>3. Pergeseran Bobot (Weight Shift):</a:t>
+            </a:r>
+            <a:endParaRPr lang="en-US" sz="1600" dirty="0"/>
+          </a:p>
+          <a:p>
+            <a:pPr indent="0" marL="0">
+              <a:buNone/>
+            </a:pPr>
+            <a:r>
+              <a:rPr lang="en-US" sz="1600" dirty="0">
+                <a:solidFill>
+                  <a:srgbClr val="333333"/>
+                </a:solidFill>
+              </a:rPr>
+              <a:t>   • Bobot A (Kuno): </a:t>
+            </a:r>
+            <a:pPr indent="0" marL="0">
+              <a:buNone/>
+            </a:pPr>
+            <a:r>
+              <a:rPr lang="en-US" sz="1600" b="1" dirty="0">
                 <a:solidFill>
                   <a:srgbClr val="C0392B"/>
                 </a:solidFill>
               </a:rPr>
-              <a:t>2. Network Markowitz dengan Target Risiko (NW - Risk Grid Search):</a:t>
-            </a:r>
-            <a:endParaRPr lang="en-US" sz="1800" dirty="0"/>
-          </a:p>
-          <a:p>
-            <a:pPr marL="342900" indent="-342900">
-              <a:buSzPct val="100000"/>
-              <a:buChar char="•"/>
-            </a:pPr>
-            <a:r>
-              <a:rPr lang="en-US" sz="1800" dirty="0">
-                <a:solidFill>
-                  <a:srgbClr val="333333"/>
-                </a:solidFill>
-              </a:rPr>
-              <a:t>Menekan parameter </a:t>
-            </a:r>
-            <a:pPr indent="0" marL="0">
-              <a:buNone/>
-            </a:pPr>
-            <a:r>
-              <a:rPr lang="en-US" sz="1800" b="1" dirty="0">
-                <a:solidFill>
-                  <a:srgbClr val="333333"/>
-                </a:solidFill>
-              </a:rPr>
-              <a:t>risiko total</a:t>
-            </a:r>
-            <a:pPr indent="0" marL="0">
-              <a:buNone/>
-            </a:pPr>
-            <a:r>
-              <a:rPr lang="en-US" sz="1800" dirty="0">
-                <a:solidFill>
-                  <a:srgbClr val="333333"/>
-                </a:solidFill>
-              </a:rPr>
-              <a:t> hingga minimal.</a:t>
-            </a:r>
-            <a:endParaRPr lang="en-US" sz="1800" dirty="0"/>
-          </a:p>
-          <a:p>
-            <a:pPr marL="342900" indent="-342900">
-              <a:buSzPct val="100000"/>
-              <a:buChar char="•"/>
-            </a:pPr>
-            <a:r>
-              <a:rPr lang="en-US" sz="1800" dirty="0">
-                <a:solidFill>
-                  <a:srgbClr val="333333"/>
-                </a:solidFill>
-              </a:rPr>
-              <a:t>Lebih Defensif untuk meredam fluktuasi saat </a:t>
-            </a:r>
-            <a:pPr indent="0" marL="0">
-              <a:buNone/>
-            </a:pPr>
-            <a:r>
-              <a:rPr lang="en-US" sz="1800" b="1" dirty="0">
-                <a:solidFill>
-                  <a:srgbClr val="333333"/>
-                </a:solidFill>
-              </a:rPr>
-              <a:t>Crypto Winter</a:t>
-            </a:r>
-            <a:pPr indent="0" marL="0">
-              <a:buNone/>
-            </a:pPr>
-            <a:r>
-              <a:rPr lang="en-US" sz="1800" dirty="0">
-                <a:solidFill>
-                  <a:srgbClr val="333333"/>
-                </a:solidFill>
-              </a:rPr>
-              <a:t>.</a:t>
-            </a:r>
-            <a:endParaRPr lang="en-US" sz="1800" dirty="0"/>
+              <a:t>60% → 40% (NW)</a:t>
+            </a:r>
+            <a:endParaRPr lang="en-US" sz="1600" dirty="0"/>
+          </a:p>
+          <a:p>
+            <a:pPr indent="0" marL="0">
+              <a:buNone/>
+            </a:pPr>
+            <a:r>
+              <a:rPr lang="en-US" sz="1600" dirty="0">
+                <a:solidFill>
+                  <a:srgbClr val="333333"/>
+                </a:solidFill>
+              </a:rPr>
+              <a:t>   • Bobot B (Kuno): </a:t>
+            </a:r>
+            <a:pPr indent="0" marL="0">
+              <a:buNone/>
+            </a:pPr>
+            <a:r>
+              <a:rPr lang="en-US" sz="1600" b="1" dirty="0">
+                <a:solidFill>
+                  <a:srgbClr val="27AE60"/>
+                </a:solidFill>
+              </a:rPr>
+              <a:t>40% → 60% (NW)</a:t>
+            </a:r>
+            <a:endParaRPr lang="en-US" sz="1600" dirty="0"/>
+          </a:p>
+          <a:p>
+            <a:pPr indent="0" marL="0">
+              <a:buNone/>
+            </a:pPr>
+            <a:r>
+              <a:rPr lang="en-US" sz="1600" b="1" dirty="0">
+                <a:solidFill>
+                  <a:srgbClr val="8E44AD"/>
+                </a:solidFill>
+              </a:rPr>
+              <a:t>Inti Logika NW:</a:t>
+            </a:r>
+            <a:endParaRPr lang="en-US" sz="1600" dirty="0"/>
+          </a:p>
+          <a:p>
+            <a:pPr indent="0" marL="0">
+              <a:buNone/>
+            </a:pPr>
+            <a:r>
+              <a:rPr lang="en-US" sz="1600" i="1" dirty="0">
+                <a:solidFill>
+                  <a:srgbClr val="333333"/>
+                </a:solidFill>
+              </a:rPr>
+              <a:t>Aset A dihukum bukan karena harganya tidak stabil, tapi karena ia adalah 'pusat kemacetan' risiko. Model secara matematis memindahkan modal ke Aset B untuk proteksi sistemik.</a:t>
+            </a:r>
+            <a:endParaRPr lang="en-US" sz="1600" dirty="0"/>
           </a:p>
         </p:txBody>
       </p:sp>
@@ -11602,7 +11727,7 @@
                   <a:srgbClr val="003366"/>
                 </a:solidFill>
               </a:rPr>
-              <a:t>Lampiran: Penanganan Data Kosong (Missing Values)</a:t>
+              <a:t>Lampiran: Dua Tipe Pendekatan Grid Search</a:t>
             </a:r>
             <a:endParaRPr lang="en-US" sz="2600" dirty="0"/>
           </a:p>
@@ -11635,41 +11760,156 @@
             <a:r>
               <a:rPr lang="en-US" sz="1800" b="1" dirty="0">
                 <a:solidFill>
+                  <a:srgbClr val="333333"/>
+                </a:solidFill>
+              </a:rPr>
+              <a:t>Dua Objektif Optimasi (Return vs Risk):</a:t>
+            </a:r>
+            <a:endParaRPr lang="en-US" sz="1800" dirty="0"/>
+          </a:p>
+          <a:p>
+            <a:pPr indent="0" marL="0">
+              <a:buNone/>
+            </a:pPr>
+            <a:r>
+              <a:rPr lang="en-US" sz="1800" b="1" dirty="0">
+                <a:solidFill>
+                  <a:srgbClr val="27AE60"/>
+                </a:solidFill>
+              </a:rPr>
+              <a:t>1. Network Markowitz dengan Target Return (NW - Return Grid Search):</a:t>
+            </a:r>
+            <a:endParaRPr lang="en-US" sz="1800" dirty="0"/>
+          </a:p>
+          <a:p>
+            <a:pPr marL="342900" indent="-342900">
+              <a:buSzPct val="100000"/>
+              <a:buChar char="•"/>
+            </a:pPr>
+            <a:r>
+              <a:rPr lang="en-US" sz="1800" dirty="0">
+                <a:solidFill>
+                  <a:srgbClr val="333333"/>
+                </a:solidFill>
+              </a:rPr>
+              <a:t>Memaksimalkan capaian </a:t>
+            </a:r>
+            <a:pPr indent="0" marL="0">
+              <a:buNone/>
+            </a:pPr>
+            <a:r>
+              <a:rPr lang="en-US" sz="1800" b="1" dirty="0">
+                <a:solidFill>
+                  <a:srgbClr val="333333"/>
+                </a:solidFill>
+              </a:rPr>
+              <a:t>imbal hasil</a:t>
+            </a:r>
+            <a:pPr indent="0" marL="0">
+              <a:buNone/>
+            </a:pPr>
+            <a:r>
+              <a:rPr lang="en-US" sz="1800" dirty="0">
+                <a:solidFill>
+                  <a:srgbClr val="333333"/>
+                </a:solidFill>
+              </a:rPr>
+              <a:t> portofolio.</a:t>
+            </a:r>
+            <a:endParaRPr lang="en-US" sz="1800" dirty="0"/>
+          </a:p>
+          <a:p>
+            <a:pPr marL="342900" indent="-342900">
+              <a:buSzPct val="100000"/>
+              <a:buChar char="•"/>
+            </a:pPr>
+            <a:r>
+              <a:rPr lang="en-US" sz="1800" dirty="0">
+                <a:solidFill>
+                  <a:srgbClr val="333333"/>
+                </a:solidFill>
+              </a:rPr>
+              <a:t>Lebih Agresif untuk mengeksploitasi reli pada pasar </a:t>
+            </a:r>
+            <a:pPr indent="0" marL="0">
+              <a:buNone/>
+            </a:pPr>
+            <a:r>
+              <a:rPr lang="en-US" sz="1800" b="1" dirty="0">
+                <a:solidFill>
+                  <a:srgbClr val="333333"/>
+                </a:solidFill>
+              </a:rPr>
+              <a:t>Bullish</a:t>
+            </a:r>
+            <a:pPr indent="0" marL="0">
+              <a:buNone/>
+            </a:pPr>
+            <a:r>
+              <a:rPr lang="en-US" sz="1800" dirty="0">
+                <a:solidFill>
+                  <a:srgbClr val="333333"/>
+                </a:solidFill>
+              </a:rPr>
+              <a:t>.</a:t>
+            </a:r>
+            <a:endParaRPr lang="en-US" sz="1800" dirty="0"/>
+          </a:p>
+          <a:p>
+            <a:pPr indent="0" marL="0">
+              <a:buNone/>
+            </a:pPr>
+            <a:r>
+              <a:rPr lang="en-US" sz="1800" b="1" dirty="0">
+                <a:solidFill>
                   <a:srgbClr val="C0392B"/>
                 </a:solidFill>
               </a:rPr>
-              <a:t>Pertanyaan: </a:t>
-            </a:r>
-            <a:pPr indent="0" marL="0">
-              <a:buNone/>
-            </a:pPr>
-            <a:r>
-              <a:rPr lang="en-US" sz="1800" i="1" dirty="0">
-                <a:solidFill>
-                  <a:srgbClr val="333333"/>
-                </a:solidFill>
-              </a:rPr>
-              <a:t>"Beberapa koin seperti Binance/EOS belum rilis di awal 2017 sehingga datanya kosong. Bukankah backward-fill memalsukan harga dan merusak matriks?"</a:t>
+              <a:t>2. Network Markowitz dengan Target Risiko (NW - Risk Grid Search):</a:t>
             </a:r>
             <a:endParaRPr lang="en-US" sz="1800" dirty="0"/>
           </a:p>
           <a:p>
+            <a:pPr marL="342900" indent="-342900">
+              <a:buSzPct val="100000"/>
+              <a:buChar char="•"/>
+            </a:pPr>
+            <a:r>
+              <a:rPr lang="en-US" sz="1800" dirty="0">
+                <a:solidFill>
+                  <a:srgbClr val="333333"/>
+                </a:solidFill>
+              </a:rPr>
+              <a:t>Menekan parameter </a:t>
+            </a:r>
             <a:pPr indent="0" marL="0">
               <a:buNone/>
             </a:pPr>
             <a:r>
               <a:rPr lang="en-US" sz="1800" b="1" dirty="0">
                 <a:solidFill>
-                  <a:srgbClr val="27AE60"/>
-                </a:solidFill>
-              </a:rPr>
-              <a:t>Jawaban (Kenapa RMT sangat Krusial):</a:t>
+                  <a:srgbClr val="333333"/>
+                </a:solidFill>
+              </a:rPr>
+              <a:t>risiko total</a:t>
+            </a:r>
+            <a:pPr indent="0" marL="0">
+              <a:buNone/>
+            </a:pPr>
+            <a:r>
+              <a:rPr lang="en-US" sz="1800" dirty="0">
+                <a:solidFill>
+                  <a:srgbClr val="333333"/>
+                </a:solidFill>
+              </a:rPr>
+              <a:t> hingga minimal.</a:t>
             </a:r>
             <a:endParaRPr lang="en-US" sz="1800" dirty="0"/>
           </a:p>
           <a:p>
-            <a:pPr indent="0" marL="0">
-              <a:buNone/>
+            <a:pPr marL="342900" indent="-342900">
+              <a:buSzPct val="100000"/>
+              <a:buChar char="•"/>
             </a:pPr>
             <a:r>
               <a:rPr lang="en-US" sz="1800" dirty="0">
@@ -11677,18 +11917,18 @@
                   <a:srgbClr val="333333"/>
                 </a:solidFill>
               </a:rPr>
-              <a:t>   1. Praktik pengisian data diam (</a:t>
-            </a:r>
-            <a:pPr indent="0" marL="0">
-              <a:buNone/>
-            </a:pPr>
-            <a:r>
-              <a:rPr lang="en-US" sz="1800" b="1" i="1" dirty="0">
-                <a:solidFill>
-                  <a:srgbClr val="333333"/>
-                </a:solidFill>
-              </a:rPr>
-              <a:t>backward fill</a:t>
+              <a:t>Lebih Defensif untuk meredam fluktuasi saat </a:t>
+            </a:r>
+            <a:pPr indent="0" marL="0">
+              <a:buNone/>
+            </a:pPr>
+            <a:r>
+              <a:rPr lang="en-US" sz="1800" b="1" dirty="0">
+                <a:solidFill>
+                  <a:srgbClr val="333333"/>
+                </a:solidFill>
+              </a:rPr>
+              <a:t>Crypto Winter</a:t>
             </a:r>
             <a:pPr indent="0" marL="0">
               <a:buNone/>
@@ -11699,115 +11939,7 @@
                   <a:srgbClr val="333333"/>
                 </a:solidFill>
               </a:rPr>
-              <a:t>) memang menciptakan rentetan nilai harga yang statis.</a:t>
-            </a:r>
-            <a:endParaRPr lang="en-US" sz="1800" dirty="0"/>
-          </a:p>
-          <a:p>
-            <a:pPr indent="0" marL="0">
-              <a:buNone/>
-            </a:pPr>
-            <a:r>
-              <a:rPr lang="en-US" sz="1800" dirty="0">
-                <a:solidFill>
-                  <a:srgbClr val="333333"/>
-                </a:solidFill>
-              </a:rPr>
-              <a:t>   2. Namun, kehebatan </a:t>
-            </a:r>
-            <a:pPr indent="0" marL="0">
-              <a:buNone/>
-            </a:pPr>
-            <a:r>
-              <a:rPr lang="en-US" sz="1800" b="1" dirty="0">
-                <a:solidFill>
-                  <a:srgbClr val="333333"/>
-                </a:solidFill>
-              </a:rPr>
-              <a:t>Random Matrix Theory (RMT)</a:t>
-            </a:r>
-            <a:pPr indent="0" marL="0">
-              <a:buNone/>
-            </a:pPr>
-            <a:r>
-              <a:rPr lang="en-US" sz="1800" dirty="0">
-                <a:solidFill>
-                  <a:srgbClr val="333333"/>
-                </a:solidFill>
-              </a:rPr>
-              <a:t> diuji di sini! Karena data yang datar sama sekali tidak punya korelasi nyata.</a:t>
-            </a:r>
-            <a:endParaRPr lang="en-US" sz="1800" dirty="0"/>
-          </a:p>
-          <a:p>
-            <a:pPr indent="0" marL="0">
-              <a:buNone/>
-            </a:pPr>
-            <a:r>
-              <a:rPr lang="en-US" sz="1800" dirty="0">
-                <a:solidFill>
-                  <a:srgbClr val="333333"/>
-                </a:solidFill>
-              </a:rPr>
-              <a:t>   3. RMT otomatis akan mendeteksi korelasi buatan tersebut sebagai probabilitas </a:t>
-            </a:r>
-            <a:pPr indent="0" marL="0">
-              <a:buNone/>
-            </a:pPr>
-            <a:r>
-              <a:rPr lang="en-US" sz="1800" b="1" i="1" dirty="0">
-                <a:solidFill>
-                  <a:srgbClr val="333333"/>
-                </a:solidFill>
-              </a:rPr>
-              <a:t>Noise Acak</a:t>
-            </a:r>
-            <a:pPr indent="0" marL="0">
-              <a:buNone/>
-            </a:pPr>
-            <a:r>
-              <a:rPr lang="en-US" sz="1800" dirty="0">
-                <a:solidFill>
-                  <a:srgbClr val="333333"/>
-                </a:solidFill>
-              </a:rPr>
-              <a:t>, lalu membuangnya menjadi 0.</a:t>
-            </a:r>
-            <a:endParaRPr lang="en-US" sz="1800" dirty="0"/>
-          </a:p>
-          <a:p>
-            <a:pPr indent="0" marL="0">
-              <a:buNone/>
-            </a:pPr>
-            <a:r>
-              <a:rPr lang="en-US" sz="1800" dirty="0">
-                <a:solidFill>
-                  <a:srgbClr val="333333"/>
-                </a:solidFill>
-              </a:rPr>
-              <a:t>   4. Hasilnya, matriks korelasi </a:t>
-            </a:r>
-            <a:pPr indent="0" marL="0">
-              <a:buNone/>
-            </a:pPr>
-            <a:r>
-              <a:rPr lang="en-US" sz="1800" b="1" dirty="0">
-                <a:solidFill>
-                  <a:srgbClr val="333333"/>
-                </a:solidFill>
-              </a:rPr>
-              <a:t>terselamatkan</a:t>
-            </a:r>
-            <a:pPr indent="0" marL="0">
-              <a:buNone/>
-            </a:pPr>
-            <a:r>
-              <a:rPr lang="en-US" sz="1800" dirty="0">
-                <a:solidFill>
-                  <a:srgbClr val="333333"/>
-                </a:solidFill>
-              </a:rPr>
-              <a:t> dan tidak tercemar oleh cacat kelengkapan data.</a:t>
+              <a:t>.</a:t>
             </a:r>
             <a:endParaRPr lang="en-US" sz="1800" dirty="0"/>
           </a:p>
@@ -11868,7 +12000,7 @@
                   <a:srgbClr val="003366"/>
                 </a:solidFill>
               </a:rPr>
-              <a:t>Lampiran: Mengapa Menyertakan Tether (USDT)? (1/2)</a:t>
+              <a:t>Lampiran: Penanganan Data Kosong (Missing Values)</a:t>
             </a:r>
             <a:endParaRPr lang="en-US" sz="2600" dirty="0"/>
           </a:p>
@@ -11915,7 +12047,7 @@
                   <a:srgbClr val="333333"/>
                 </a:solidFill>
               </a:rPr>
-              <a:t>"Tether (USDT) itu stablecoin yang nilainya selalu fix ke 1 USD. Apakah tidak berbuat curang?"</a:t>
+              <a:t>"Beberapa koin seperti Binance/EOS belum rilis di awal 2017 sehingga datanya kosong. Bukankah backward-fill memalsukan harga dan merusak matriks?"</a:t>
             </a:r>
             <a:endParaRPr lang="en-US" sz="1800" dirty="0"/>
           </a:p>
@@ -11929,14 +12061,13 @@
                   <a:srgbClr val="27AE60"/>
                 </a:solidFill>
               </a:rPr>
-              <a:t>Jawaban (Dinamika Portofolio Cerdas):</a:t>
+              <a:t>Jawaban (Kenapa RMT sangat Krusial):</a:t>
             </a:r>
             <a:endParaRPr lang="en-US" sz="1800" dirty="0"/>
           </a:p>
           <a:p>
-            <a:pPr marL="342900" indent="-342900">
-              <a:buSzPct val="100000"/>
-              <a:buChar char="•"/>
+            <a:pPr indent="0" marL="0">
+              <a:buNone/>
             </a:pPr>
             <a:r>
               <a:rPr lang="en-US" sz="1800" dirty="0">
@@ -11944,7 +12075,7 @@
                   <a:srgbClr val="333333"/>
                 </a:solidFill>
               </a:rPr>
-              <a:t>Model ini mensimulasikan perilaku </a:t>
+              <a:t>   1. Praktik pengisian data diam (</a:t>
             </a:r>
             <a:pPr indent="0" marL="0">
               <a:buNone/>
@@ -11955,7 +12086,7 @@
                   <a:srgbClr val="333333"/>
                 </a:solidFill>
               </a:rPr>
-              <a:t>Robo-Advisory</a:t>
+              <a:t>backward fill</a:t>
             </a:r>
             <a:pPr indent="0" marL="0">
               <a:buNone/>
@@ -11966,14 +12097,13 @@
                   <a:srgbClr val="333333"/>
                 </a:solidFill>
               </a:rPr>
-              <a:t> institusional.</a:t>
+              <a:t>) memang menciptakan rentetan nilai harga yang statis.</a:t>
             </a:r>
             <a:endParaRPr lang="en-US" sz="1800" dirty="0"/>
           </a:p>
           <a:p>
-            <a:pPr marL="342900" indent="-342900">
-              <a:buSzPct val="100000"/>
-              <a:buChar char="•"/>
+            <a:pPr indent="0" marL="0">
+              <a:buNone/>
             </a:pPr>
             <a:r>
               <a:rPr lang="en-US" sz="1800" dirty="0">
@@ -11981,7 +12111,7 @@
                   <a:srgbClr val="333333"/>
                 </a:solidFill>
               </a:rPr>
-              <a:t>Ketika pasar anjlok ekstrem, investor akan melarikan senjatanya ke posisi </a:t>
+              <a:t>   2. Namun, kehebatan </a:t>
             </a:r>
             <a:pPr indent="0" marL="0">
               <a:buNone/>
@@ -11992,7 +12122,7 @@
                   <a:srgbClr val="333333"/>
                 </a:solidFill>
               </a:rPr>
-              <a:t>tunai (USDT)</a:t>
+              <a:t>Random Matrix Theory (RMT)</a:t>
             </a:r>
             <a:pPr indent="0" marL="0">
               <a:buNone/>
@@ -12003,7 +12133,79 @@
                   <a:srgbClr val="333333"/>
                 </a:solidFill>
               </a:rPr>
-              <a:t> sebagai evakuasi risiko.</a:t>
+              <a:t> diuji di sini! Karena data yang datar sama sekali tidak punya korelasi nyata.</a:t>
+            </a:r>
+            <a:endParaRPr lang="en-US" sz="1800" dirty="0"/>
+          </a:p>
+          <a:p>
+            <a:pPr indent="0" marL="0">
+              <a:buNone/>
+            </a:pPr>
+            <a:r>
+              <a:rPr lang="en-US" sz="1800" dirty="0">
+                <a:solidFill>
+                  <a:srgbClr val="333333"/>
+                </a:solidFill>
+              </a:rPr>
+              <a:t>   3. RMT otomatis akan mendeteksi korelasi buatan tersebut sebagai probabilitas </a:t>
+            </a:r>
+            <a:pPr indent="0" marL="0">
+              <a:buNone/>
+            </a:pPr>
+            <a:r>
+              <a:rPr lang="en-US" sz="1800" b="1" i="1" dirty="0">
+                <a:solidFill>
+                  <a:srgbClr val="333333"/>
+                </a:solidFill>
+              </a:rPr>
+              <a:t>Noise Acak</a:t>
+            </a:r>
+            <a:pPr indent="0" marL="0">
+              <a:buNone/>
+            </a:pPr>
+            <a:r>
+              <a:rPr lang="en-US" sz="1800" dirty="0">
+                <a:solidFill>
+                  <a:srgbClr val="333333"/>
+                </a:solidFill>
+              </a:rPr>
+              <a:t>, lalu membuangnya menjadi 0.</a:t>
+            </a:r>
+            <a:endParaRPr lang="en-US" sz="1800" dirty="0"/>
+          </a:p>
+          <a:p>
+            <a:pPr indent="0" marL="0">
+              <a:buNone/>
+            </a:pPr>
+            <a:r>
+              <a:rPr lang="en-US" sz="1800" dirty="0">
+                <a:solidFill>
+                  <a:srgbClr val="333333"/>
+                </a:solidFill>
+              </a:rPr>
+              <a:t>   4. Hasilnya, matriks korelasi </a:t>
+            </a:r>
+            <a:pPr indent="0" marL="0">
+              <a:buNone/>
+            </a:pPr>
+            <a:r>
+              <a:rPr lang="en-US" sz="1800" b="1" dirty="0">
+                <a:solidFill>
+                  <a:srgbClr val="333333"/>
+                </a:solidFill>
+              </a:rPr>
+              <a:t>terselamatkan</a:t>
+            </a:r>
+            <a:pPr indent="0" marL="0">
+              <a:buNone/>
+            </a:pPr>
+            <a:r>
+              <a:rPr lang="en-US" sz="1800" dirty="0">
+                <a:solidFill>
+                  <a:srgbClr val="333333"/>
+                </a:solidFill>
+              </a:rPr>
+              <a:t> dan tidak tercemar oleh cacat kelengkapan data.</a:t>
             </a:r>
             <a:endParaRPr lang="en-US" sz="1800" dirty="0"/>
           </a:p>
@@ -12064,7 +12266,7 @@
                   <a:srgbClr val="003366"/>
                 </a:solidFill>
               </a:rPr>
-              <a:t>Lampiran: Mengapa Menyertakan Tether (USDT)? (2/2)</a:t>
+              <a:t>Lampiran: Mengapa Menyertakan Tether (USDT)? (1/2)</a:t>
             </a:r>
             <a:endParaRPr lang="en-US" sz="2600" dirty="0"/>
           </a:p>
@@ -12095,12 +12297,89 @@
               <a:buNone/>
             </a:pPr>
             <a:r>
+              <a:rPr lang="en-US" sz="1800" b="1" dirty="0">
+                <a:solidFill>
+                  <a:srgbClr val="C0392B"/>
+                </a:solidFill>
+              </a:rPr>
+              <a:t>Pertanyaan: </a:t>
+            </a:r>
+            <a:pPr indent="0" marL="0">
+              <a:buNone/>
+            </a:pPr>
+            <a:r>
+              <a:rPr lang="en-US" sz="1800" i="1" dirty="0">
+                <a:solidFill>
+                  <a:srgbClr val="333333"/>
+                </a:solidFill>
+              </a:rPr>
+              <a:t>"Tether (USDT) itu stablecoin yang nilainya selalu fix ke 1 USD. Apakah tidak berbuat curang?"</a:t>
+            </a:r>
+            <a:endParaRPr lang="en-US" sz="1800" dirty="0"/>
+          </a:p>
+          <a:p>
+            <a:pPr indent="0" marL="0">
+              <a:buNone/>
+            </a:pPr>
+            <a:r>
+              <a:rPr lang="en-US" sz="1800" b="1" dirty="0">
+                <a:solidFill>
+                  <a:srgbClr val="27AE60"/>
+                </a:solidFill>
+              </a:rPr>
+              <a:t>Jawaban (Dinamika Portofolio Cerdas):</a:t>
+            </a:r>
+            <a:endParaRPr lang="en-US" sz="1800" dirty="0"/>
+          </a:p>
+          <a:p>
+            <a:pPr marL="342900" indent="-342900">
+              <a:buSzPct val="100000"/>
+              <a:buChar char="•"/>
+            </a:pPr>
+            <a:r>
               <a:rPr lang="en-US" sz="1800" dirty="0">
                 <a:solidFill>
                   <a:srgbClr val="333333"/>
                 </a:solidFill>
               </a:rPr>
-              <a:t>3. Algoritma jaringan </a:t>
+              <a:t>Model ini mensimulasikan perilaku </a:t>
+            </a:r>
+            <a:pPr indent="0" marL="0">
+              <a:buNone/>
+            </a:pPr>
+            <a:r>
+              <a:rPr lang="en-US" sz="1800" b="1" i="1" dirty="0">
+                <a:solidFill>
+                  <a:srgbClr val="333333"/>
+                </a:solidFill>
+              </a:rPr>
+              <a:t>Robo-Advisory</a:t>
+            </a:r>
+            <a:pPr indent="0" marL="0">
+              <a:buNone/>
+            </a:pPr>
+            <a:r>
+              <a:rPr lang="en-US" sz="1800" dirty="0">
+                <a:solidFill>
+                  <a:srgbClr val="333333"/>
+                </a:solidFill>
+              </a:rPr>
+              <a:t> institusional.</a:t>
+            </a:r>
+            <a:endParaRPr lang="en-US" sz="1800" dirty="0"/>
+          </a:p>
+          <a:p>
+            <a:pPr marL="342900" indent="-342900">
+              <a:buSzPct val="100000"/>
+              <a:buChar char="•"/>
+            </a:pPr>
+            <a:r>
+              <a:rPr lang="en-US" sz="1800" dirty="0">
+                <a:solidFill>
+                  <a:srgbClr val="333333"/>
+                </a:solidFill>
+              </a:rPr>
+              <a:t>Ketika pasar anjlok ekstrem, investor akan melarikan senjatanya ke posisi </a:t>
             </a:r>
             <a:pPr indent="0" marL="0">
               <a:buNone/>
@@ -12111,7 +12390,7 @@
                   <a:srgbClr val="333333"/>
                 </a:solidFill>
               </a:rPr>
-              <a:t>Network Markowitz GS (Grid Search)</a:t>
+              <a:t>tunai (USDT)</a:t>
             </a:r>
             <a:pPr indent="0" marL="0">
               <a:buNone/>
@@ -12122,87 +12401,7 @@
                   <a:srgbClr val="333333"/>
                 </a:solidFill>
               </a:rPr>
-              <a:t> dilatih secara matematis; jika mendeteksi korelasi ancaman kolaps merambat ke semua altcoin, ia akan melempar alokasi modalnya menuju node </a:t>
-            </a:r>
-            <a:pPr indent="0" marL="0">
-              <a:buNone/>
-            </a:pPr>
-            <a:r>
-              <a:rPr lang="en-US" sz="1800" b="1" dirty="0">
-                <a:solidFill>
-                  <a:srgbClr val="333333"/>
-                </a:solidFill>
-              </a:rPr>
-              <a:t>USDT (Tether)</a:t>
-            </a:r>
-            <a:pPr indent="0" marL="0">
-              <a:buNone/>
-            </a:pPr>
-            <a:r>
-              <a:rPr lang="en-US" sz="1800" dirty="0">
-                <a:solidFill>
-                  <a:srgbClr val="333333"/>
-                </a:solidFill>
-              </a:rPr>
-              <a:t> sebagai langkah </a:t>
-            </a:r>
-            <a:pPr indent="0" marL="0">
-              <a:buNone/>
-            </a:pPr>
-            <a:r>
-              <a:rPr lang="en-US" sz="1800" b="1" dirty="0">
-                <a:solidFill>
-                  <a:srgbClr val="333333"/>
-                </a:solidFill>
-              </a:rPr>
-              <a:t>evakuasi otomatis</a:t>
-            </a:r>
-            <a:pPr indent="0" marL="0">
-              <a:buNone/>
-            </a:pPr>
-            <a:r>
-              <a:rPr lang="en-US" sz="1800" dirty="0">
-                <a:solidFill>
-                  <a:srgbClr val="333333"/>
-                </a:solidFill>
-              </a:rPr>
-              <a:t> (Shock-Absorber).</a:t>
-            </a:r>
-            <a:endParaRPr lang="en-US" sz="1800" dirty="0"/>
-          </a:p>
-          <a:p>
-            <a:pPr indent="0" marL="0">
-              <a:buNone/>
-            </a:pPr>
-            <a:r>
-              <a:rPr lang="en-US" sz="1800" dirty="0">
-                <a:solidFill>
-                  <a:srgbClr val="333333"/>
-                </a:solidFill>
-              </a:rPr>
-              <a:t>   4. Hal ini yang membuat performa Risk-GS (Grid Search) sangat </a:t>
-            </a:r>
-            <a:pPr indent="0" marL="0">
-              <a:buNone/>
-            </a:pPr>
-            <a:r>
-              <a:rPr lang="en-US" sz="1800" b="1" dirty="0">
-                <a:solidFill>
-                  <a:srgbClr val="333333"/>
-                </a:solidFill>
-              </a:rPr>
-              <a:t>tangguh</a:t>
-            </a:r>
-            <a:pPr indent="0" marL="0">
-              <a:buNone/>
-            </a:pPr>
-            <a:r>
-              <a:rPr lang="en-US" sz="1800" dirty="0">
-                <a:solidFill>
-                  <a:srgbClr val="333333"/>
-                </a:solidFill>
-              </a:rPr>
-              <a:t> dari serangan Crypto Winter, suatu kapabilitas pertahanan yang tidak dipahami oleh model ortodoks murni Markowitz.</a:t>
+              <a:t> sebagai evakuasi risiko.</a:t>
             </a:r>
             <a:endParaRPr lang="en-US" sz="1800" dirty="0"/>
           </a:p>
@@ -12263,7 +12462,7 @@
                   <a:srgbClr val="003366"/>
                 </a:solidFill>
               </a:rPr>
-              <a:t>Lampiran: Bukti Empiris Non-Stationarity Pasar</a:t>
+              <a:t>Lampiran: Mengapa Menyertakan Tether (USDT)? (2/2)</a:t>
             </a:r>
             <a:endParaRPr lang="en-US" sz="2600" dirty="0"/>
           </a:p>
@@ -12294,23 +12493,78 @@
               <a:buNone/>
             </a:pPr>
             <a:r>
+              <a:rPr lang="en-US" sz="1800" dirty="0">
+                <a:solidFill>
+                  <a:srgbClr val="333333"/>
+                </a:solidFill>
+              </a:rPr>
+              <a:t>3. Algoritma jaringan </a:t>
+            </a:r>
+            <a:pPr indent="0" marL="0">
+              <a:buNone/>
+            </a:pPr>
+            <a:r>
               <a:rPr lang="en-US" sz="1800" b="1" dirty="0">
                 <a:solidFill>
-                  <a:srgbClr val="C0392B"/>
-                </a:solidFill>
-              </a:rPr>
-              <a:t>Masalah: </a:t>
-            </a:r>
-            <a:pPr indent="0" marL="0">
-              <a:buNone/>
-            </a:pPr>
-            <a:r>
-              <a:rPr lang="en-US" sz="1800" i="1" dirty="0">
-                <a:solidFill>
-                  <a:srgbClr val="333333"/>
-                </a:solidFill>
-              </a:rPr>
-              <a:t>Kenapa harus menggunakan model Adaptif (Dynamic Gamma)?</a:t>
+                  <a:srgbClr val="333333"/>
+                </a:solidFill>
+              </a:rPr>
+              <a:t>Network Markowitz GS (Grid Search)</a:t>
+            </a:r>
+            <a:pPr indent="0" marL="0">
+              <a:buNone/>
+            </a:pPr>
+            <a:r>
+              <a:rPr lang="en-US" sz="1800" dirty="0">
+                <a:solidFill>
+                  <a:srgbClr val="333333"/>
+                </a:solidFill>
+              </a:rPr>
+              <a:t> dilatih secara matematis; jika mendeteksi korelasi ancaman kolaps merambat ke semua altcoin, ia akan melempar alokasi modalnya menuju node </a:t>
+            </a:r>
+            <a:pPr indent="0" marL="0">
+              <a:buNone/>
+            </a:pPr>
+            <a:r>
+              <a:rPr lang="en-US" sz="1800" b="1" dirty="0">
+                <a:solidFill>
+                  <a:srgbClr val="333333"/>
+                </a:solidFill>
+              </a:rPr>
+              <a:t>USDT (Tether)</a:t>
+            </a:r>
+            <a:pPr indent="0" marL="0">
+              <a:buNone/>
+            </a:pPr>
+            <a:r>
+              <a:rPr lang="en-US" sz="1800" dirty="0">
+                <a:solidFill>
+                  <a:srgbClr val="333333"/>
+                </a:solidFill>
+              </a:rPr>
+              <a:t> sebagai langkah </a:t>
+            </a:r>
+            <a:pPr indent="0" marL="0">
+              <a:buNone/>
+            </a:pPr>
+            <a:r>
+              <a:rPr lang="en-US" sz="1800" b="1" dirty="0">
+                <a:solidFill>
+                  <a:srgbClr val="333333"/>
+                </a:solidFill>
+              </a:rPr>
+              <a:t>evakuasi otomatis</a:t>
+            </a:r>
+            <a:pPr indent="0" marL="0">
+              <a:buNone/>
+            </a:pPr>
+            <a:r>
+              <a:rPr lang="en-US" sz="1800" dirty="0">
+                <a:solidFill>
+                  <a:srgbClr val="333333"/>
+                </a:solidFill>
+              </a:rPr>
+              <a:t> (Shock-Absorber).</a:t>
             </a:r>
             <a:endParaRPr lang="en-US" sz="1800" dirty="0"/>
           </a:p>
@@ -12319,19 +12573,26 @@
               <a:buNone/>
             </a:pPr>
             <a:r>
+              <a:rPr lang="en-US" sz="1800" dirty="0">
+                <a:solidFill>
+                  <a:srgbClr val="333333"/>
+                </a:solidFill>
+              </a:rPr>
+              <a:t>   4. Hal ini yang membuat performa Risk-GS (Grid Search) sangat </a:t>
+            </a:r>
+            <a:pPr indent="0" marL="0">
+              <a:buNone/>
+            </a:pPr>
+            <a:r>
               <a:rPr lang="en-US" sz="1800" b="1" dirty="0">
                 <a:solidFill>
-                  <a:srgbClr val="27AE60"/>
-                </a:solidFill>
-              </a:rPr>
-              <a:t>Bukti dari Grid Search:</a:t>
-            </a:r>
-            <a:endParaRPr lang="en-US" sz="1800" dirty="0"/>
-          </a:p>
-          <a:p>
-            <a:pPr marL="342900" indent="-342900">
-              <a:buSzPct val="100000"/>
-              <a:buChar char="•"/>
+                  <a:srgbClr val="333333"/>
+                </a:solidFill>
+              </a:rPr>
+              <a:t>tangguh</a:t>
+            </a:r>
+            <a:pPr indent="0" marL="0">
+              <a:buNone/>
             </a:pPr>
             <a:r>
               <a:rPr lang="en-US" sz="1800" dirty="0">
@@ -12339,103 +12600,7 @@
                   <a:srgbClr val="333333"/>
                 </a:solidFill>
               </a:rPr>
-              <a:t>Data menunjukkan nilai Gamma (γ) optimal </a:t>
-            </a:r>
-            <a:pPr indent="0" marL="0">
-              <a:buNone/>
-            </a:pPr>
-            <a:r>
-              <a:rPr lang="en-US" sz="1800" b="1" dirty="0">
-                <a:solidFill>
-                  <a:srgbClr val="333333"/>
-                </a:solidFill>
-              </a:rPr>
-              <a:t>terus bergeser</a:t>
-            </a:r>
-            <a:pPr indent="0" marL="0">
-              <a:buNone/>
-            </a:pPr>
-            <a:r>
-              <a:rPr lang="en-US" sz="1800" dirty="0">
-                <a:solidFill>
-                  <a:srgbClr val="333333"/>
-                </a:solidFill>
-              </a:rPr>
-              <a:t> setiap periode rebalancing.</a:t>
-            </a:r>
-            <a:endParaRPr lang="en-US" sz="1800" dirty="0"/>
-          </a:p>
-          <a:p>
-            <a:pPr marL="342900" indent="-342900">
-              <a:buSzPct val="100000"/>
-              <a:buChar char="•"/>
-            </a:pPr>
-            <a:r>
-              <a:rPr lang="en-US" sz="1800" dirty="0">
-                <a:solidFill>
-                  <a:srgbClr val="333333"/>
-                </a:solidFill>
-              </a:rPr>
-              <a:t>Penggunaan γ statis tidak cukup untuk menangkap perubahan </a:t>
-            </a:r>
-            <a:pPr indent="0" marL="0">
-              <a:buNone/>
-            </a:pPr>
-            <a:r>
-              <a:rPr lang="en-US" sz="1800" b="1" dirty="0">
-                <a:solidFill>
-                  <a:srgbClr val="333333"/>
-                </a:solidFill>
-              </a:rPr>
-              <a:t>struktur korelasi</a:t>
-            </a:r>
-            <a:pPr indent="0" marL="0">
-              <a:buNone/>
-            </a:pPr>
-            <a:r>
-              <a:rPr lang="en-US" sz="1800" dirty="0">
-                <a:solidFill>
-                  <a:srgbClr val="333333"/>
-                </a:solidFill>
-              </a:rPr>
-              <a:t> yang sangat cepat di pasar kripto.</a:t>
-            </a:r>
-            <a:endParaRPr lang="en-US" sz="1800" dirty="0"/>
-          </a:p>
-          <a:p>
-            <a:pPr marL="342900" indent="-342900">
-              <a:buSzPct val="100000"/>
-              <a:buChar char="•"/>
-            </a:pPr>
-            <a:r>
-              <a:rPr lang="en-US" sz="1800" dirty="0">
-                <a:solidFill>
-                  <a:srgbClr val="333333"/>
-                </a:solidFill>
-              </a:rPr>
-              <a:t>Ini membenarkan bahwa pasar kripto membutuhkan </a:t>
-            </a:r>
-            <a:pPr indent="0" marL="0">
-              <a:buNone/>
-            </a:pPr>
-            <a:r>
-              <a:rPr lang="en-US" sz="1800" b="1" dirty="0">
-                <a:solidFill>
-                  <a:srgbClr val="333333"/>
-                </a:solidFill>
-              </a:rPr>
-              <a:t>kalibrasi otomatis</a:t>
-            </a:r>
-            <a:pPr indent="0" marL="0">
-              <a:buNone/>
-            </a:pPr>
-            <a:r>
-              <a:rPr lang="en-US" sz="1800" dirty="0">
-                <a:solidFill>
-                  <a:srgbClr val="333333"/>
-                </a:solidFill>
-              </a:rPr>
-              <a:t> secara temporal.</a:t>
+              <a:t> dari serangan Crypto Winter, suatu kapabilitas pertahanan yang tidak dipahami oleh model ortodoks murni Markowitz.</a:t>
             </a:r>
             <a:endParaRPr lang="en-US" sz="1800" dirty="0"/>
           </a:p>
@@ -12496,7 +12661,7 @@
                   <a:srgbClr val="003366"/>
                 </a:solidFill>
               </a:rPr>
-              <a:t>Lampiran: Jaringan sebagai 'Shock-Absorber'</a:t>
+              <a:t>Lampiran: Bukti Empiris Non-Stationarity Pasar</a:t>
             </a:r>
             <a:endParaRPr lang="en-US" sz="2600" dirty="0"/>
           </a:p>
@@ -12529,10 +12694,35 @@
             <a:r>
               <a:rPr lang="en-US" sz="1800" b="1" dirty="0">
                 <a:solidFill>
+                  <a:srgbClr val="C0392B"/>
+                </a:solidFill>
+              </a:rPr>
+              <a:t>Masalah: </a:t>
+            </a:r>
+            <a:pPr indent="0" marL="0">
+              <a:buNone/>
+            </a:pPr>
+            <a:r>
+              <a:rPr lang="en-US" sz="1800" i="1" dirty="0">
+                <a:solidFill>
+                  <a:srgbClr val="333333"/>
+                </a:solidFill>
+              </a:rPr>
+              <a:t>Kenapa harus menggunakan model Adaptif (Dynamic Gamma)?</a:t>
+            </a:r>
+            <a:endParaRPr lang="en-US" sz="1800" dirty="0"/>
+          </a:p>
+          <a:p>
+            <a:pPr indent="0" marL="0">
+              <a:buNone/>
+            </a:pPr>
+            <a:r>
+              <a:rPr lang="en-US" sz="1800" b="1" dirty="0">
+                <a:solidFill>
                   <a:srgbClr val="27AE60"/>
                 </a:solidFill>
               </a:rPr>
-              <a:t>Konsep Teoritis:</a:t>
+              <a:t>Bukti dari Grid Search:</a:t>
             </a:r>
             <a:endParaRPr lang="en-US" sz="1800" dirty="0"/>
           </a:p>
@@ -12547,7 +12737,7 @@
                   <a:srgbClr val="333333"/>
                 </a:solidFill>
               </a:rPr>
-              <a:t>Eigenvector Centrality mengidentifikasi koin yang menjadi </a:t>
+              <a:t>Data menunjukkan nilai Gamma (γ) optimal </a:t>
             </a:r>
             <a:pPr indent="0" marL="0">
               <a:buNone/>
@@ -12558,7 +12748,7 @@
                   <a:srgbClr val="333333"/>
                 </a:solidFill>
               </a:rPr>
-              <a:t>hub risiko</a:t>
+              <a:t>terus bergeser</a:t>
             </a:r>
             <a:pPr indent="0" marL="0">
               <a:buNone/>
@@ -12569,7 +12759,7 @@
                   <a:srgbClr val="333333"/>
                 </a:solidFill>
               </a:rPr>
-              <a:t>.</a:t>
+              <a:t> setiap periode rebalancing.</a:t>
             </a:r>
             <a:endParaRPr lang="en-US" sz="1800" dirty="0"/>
           </a:p>
@@ -12584,7 +12774,7 @@
                   <a:srgbClr val="333333"/>
                 </a:solidFill>
               </a:rPr>
-              <a:t>Penalti Gamma memaksa portofolio </a:t>
+              <a:t>Penggunaan γ statis tidak cukup untuk menangkap perubahan </a:t>
             </a:r>
             <a:pPr indent="0" marL="0">
               <a:buNone/>
@@ -12595,7 +12785,7 @@
                   <a:srgbClr val="333333"/>
                 </a:solidFill>
               </a:rPr>
-              <a:t>menjauhi aset</a:t>
+              <a:t>struktur korelasi</a:t>
             </a:r>
             <a:pPr indent="0" marL="0">
               <a:buNone/>
@@ -12606,7 +12796,7 @@
                   <a:srgbClr val="333333"/>
                 </a:solidFill>
               </a:rPr>
-              <a:t> yang terlalu dominan secara sistemik saat volatilitas tinggi.</a:t>
+              <a:t> yang sangat cepat di pasar kripto.</a:t>
             </a:r>
             <a:endParaRPr lang="en-US" sz="1800" dirty="0"/>
           </a:p>
@@ -12621,7 +12811,7 @@
                   <a:srgbClr val="333333"/>
                 </a:solidFill>
               </a:rPr>
-              <a:t>Hasil pada </a:t>
+              <a:t>Ini membenarkan bahwa pasar kripto membutuhkan </a:t>
             </a:r>
             <a:pPr indent="0" marL="0">
               <a:buNone/>
@@ -12632,7 +12822,7 @@
                   <a:srgbClr val="333333"/>
                 </a:solidFill>
               </a:rPr>
-              <a:t>Tabel 5</a:t>
+              <a:t>kalibrasi otomatis</a:t>
             </a:r>
             <a:pPr indent="0" marL="0">
               <a:buNone/>
@@ -12643,44 +12833,7 @@
                   <a:srgbClr val="333333"/>
                 </a:solidFill>
               </a:rPr>
-              <a:t> membuktikan bahwa saat crash, distribusi kerugian ekor model NW (Network Markowitz) jauh lebih terjaga.</a:t>
-            </a:r>
-            <a:endParaRPr lang="en-US" sz="1800" dirty="0"/>
-          </a:p>
-          <a:p>
-            <a:pPr marL="342900" indent="-342900">
-              <a:buSzPct val="100000"/>
-              <a:buChar char="•"/>
-            </a:pPr>
-            <a:r>
-              <a:rPr lang="en-US" sz="1800" dirty="0">
-                <a:solidFill>
-                  <a:srgbClr val="333333"/>
-                </a:solidFill>
-              </a:rPr>
-              <a:t>Kesimpulan: Topologi jaringan memberikan sinyal </a:t>
-            </a:r>
-            <a:pPr indent="0" marL="0">
-              <a:buNone/>
-            </a:pPr>
-            <a:r>
-              <a:rPr lang="en-US" sz="1800" b="1" dirty="0">
-                <a:solidFill>
-                  <a:srgbClr val="333333"/>
-                </a:solidFill>
-              </a:rPr>
-              <a:t>diversifikasi akurat</a:t>
-            </a:r>
-            <a:pPr indent="0" marL="0">
-              <a:buNone/>
-            </a:pPr>
-            <a:r>
-              <a:rPr lang="en-US" sz="1800" dirty="0">
-                <a:solidFill>
-                  <a:srgbClr val="333333"/>
-                </a:solidFill>
-              </a:rPr>
-              <a:t> daripada sekadar variansi harga.</a:t>
+              <a:t> secara temporal.</a:t>
             </a:r>
             <a:endParaRPr lang="en-US" sz="1800" dirty="0"/>
           </a:p>
@@ -13032,6 +13185,251 @@
               <a:t>: Metrik risiko penularan sistemik.</a:t>
             </a:r>
             <a:endParaRPr lang="en-US" sz="2000" dirty="0"/>
+          </a:p>
+        </p:txBody>
+      </p:sp>
+    </p:spTree>
+  </p:cSld>
+  <p:clrMapOvr>
+    <a:masterClrMapping/>
+  </p:clrMapOvr>
+</p:sld>
+</file>
+
+<file path=ppt/slides/slide40.xml><?xml version="1.0" encoding="utf-8"?>
+<p:sld xmlns:a="http://schemas.openxmlformats.org/drawingml/2006/main" xmlns:r="http://schemas.openxmlformats.org/officeDocument/2006/relationships" xmlns:p="http://schemas.openxmlformats.org/presentationml/2006/main">
+  <p:cSld name="Slide 40">
+    <p:spTree>
+      <p:nvGrpSpPr>
+        <p:cNvPr id="1" name=""/>
+        <p:cNvGrpSpPr/>
+        <p:nvPr/>
+      </p:nvGrpSpPr>
+      <p:grpSpPr>
+        <a:xfrm>
+          <a:off x="0" y="0"/>
+          <a:ext cx="0" cy="0"/>
+          <a:chOff x="0" y="0"/>
+          <a:chExt cx="0" cy="0"/>
+        </a:xfrm>
+      </p:grpSpPr>
+      <p:sp>
+        <p:nvSpPr>
+          <p:cNvPr id="2" name="Text 0"/>
+          <p:cNvSpPr/>
+          <p:nvPr/>
+        </p:nvSpPr>
+        <p:spPr>
+          <a:xfrm>
+            <a:off x="457200" y="457200"/>
+            <a:ext cx="8229600" cy="0"/>
+          </a:xfrm>
+          <a:prstGeom prst="rect">
+            <a:avLst/>
+          </a:prstGeom>
+          <a:noFill/>
+          <a:ln/>
+        </p:spPr>
+        <p:txBody>
+          <a:bodyPr wrap="square" rtlCol="0" anchor="ctr"/>
+          <a:lstStyle/>
+          <a:p>
+            <a:pPr indent="0" marL="0">
+              <a:buNone/>
+            </a:pPr>
+            <a:r>
+              <a:rPr lang="en-US" sz="2600" b="1" dirty="0">
+                <a:solidFill>
+                  <a:srgbClr val="003366"/>
+                </a:solidFill>
+              </a:rPr>
+              <a:t>Lampiran: Jaringan sebagai 'Shock-Absorber'</a:t>
+            </a:r>
+            <a:endParaRPr lang="en-US" sz="2600" dirty="0"/>
+          </a:p>
+        </p:txBody>
+      </p:sp>
+      <p:sp>
+        <p:nvSpPr>
+          <p:cNvPr id="3" name="Text 1"/>
+          <p:cNvSpPr/>
+          <p:nvPr/>
+        </p:nvSpPr>
+        <p:spPr>
+          <a:xfrm>
+            <a:off x="457200" y="1005840"/>
+            <a:ext cx="8229600" cy="5029200"/>
+          </a:xfrm>
+          <a:prstGeom prst="rect">
+            <a:avLst/>
+          </a:prstGeom>
+          <a:noFill/>
+          <a:ln/>
+        </p:spPr>
+        <p:txBody>
+          <a:bodyPr wrap="square" rtlCol="0" anchor="t"/>
+          <a:lstStyle/>
+          <a:p>
+            <a:pPr indent="0" marL="0">
+              <a:buNone/>
+            </a:pPr>
+            <a:r>
+              <a:rPr lang="en-US" sz="1800" b="1" dirty="0">
+                <a:solidFill>
+                  <a:srgbClr val="27AE60"/>
+                </a:solidFill>
+              </a:rPr>
+              <a:t>Konsep Teoritis:</a:t>
+            </a:r>
+            <a:endParaRPr lang="en-US" sz="1800" dirty="0"/>
+          </a:p>
+          <a:p>
+            <a:pPr marL="342900" indent="-342900">
+              <a:buSzPct val="100000"/>
+              <a:buChar char="•"/>
+            </a:pPr>
+            <a:r>
+              <a:rPr lang="en-US" sz="1800" dirty="0">
+                <a:solidFill>
+                  <a:srgbClr val="333333"/>
+                </a:solidFill>
+              </a:rPr>
+              <a:t>Eigenvector Centrality mengidentifikasi koin yang menjadi </a:t>
+            </a:r>
+            <a:pPr indent="0" marL="0">
+              <a:buNone/>
+            </a:pPr>
+            <a:r>
+              <a:rPr lang="en-US" sz="1800" b="1" dirty="0">
+                <a:solidFill>
+                  <a:srgbClr val="333333"/>
+                </a:solidFill>
+              </a:rPr>
+              <a:t>hub risiko</a:t>
+            </a:r>
+            <a:pPr indent="0" marL="0">
+              <a:buNone/>
+            </a:pPr>
+            <a:r>
+              <a:rPr lang="en-US" sz="1800" dirty="0">
+                <a:solidFill>
+                  <a:srgbClr val="333333"/>
+                </a:solidFill>
+              </a:rPr>
+              <a:t>.</a:t>
+            </a:r>
+            <a:endParaRPr lang="en-US" sz="1800" dirty="0"/>
+          </a:p>
+          <a:p>
+            <a:pPr marL="342900" indent="-342900">
+              <a:buSzPct val="100000"/>
+              <a:buChar char="•"/>
+            </a:pPr>
+            <a:r>
+              <a:rPr lang="en-US" sz="1800" dirty="0">
+                <a:solidFill>
+                  <a:srgbClr val="333333"/>
+                </a:solidFill>
+              </a:rPr>
+              <a:t>Penalti Gamma memaksa portofolio </a:t>
+            </a:r>
+            <a:pPr indent="0" marL="0">
+              <a:buNone/>
+            </a:pPr>
+            <a:r>
+              <a:rPr lang="en-US" sz="1800" b="1" dirty="0">
+                <a:solidFill>
+                  <a:srgbClr val="333333"/>
+                </a:solidFill>
+              </a:rPr>
+              <a:t>menjauhi aset</a:t>
+            </a:r>
+            <a:pPr indent="0" marL="0">
+              <a:buNone/>
+            </a:pPr>
+            <a:r>
+              <a:rPr lang="en-US" sz="1800" dirty="0">
+                <a:solidFill>
+                  <a:srgbClr val="333333"/>
+                </a:solidFill>
+              </a:rPr>
+              <a:t> yang terlalu dominan secara sistemik saat volatilitas tinggi.</a:t>
+            </a:r>
+            <a:endParaRPr lang="en-US" sz="1800" dirty="0"/>
+          </a:p>
+          <a:p>
+            <a:pPr marL="342900" indent="-342900">
+              <a:buSzPct val="100000"/>
+              <a:buChar char="•"/>
+            </a:pPr>
+            <a:r>
+              <a:rPr lang="en-US" sz="1800" dirty="0">
+                <a:solidFill>
+                  <a:srgbClr val="333333"/>
+                </a:solidFill>
+              </a:rPr>
+              <a:t>Hasil pada </a:t>
+            </a:r>
+            <a:pPr indent="0" marL="0">
+              <a:buNone/>
+            </a:pPr>
+            <a:r>
+              <a:rPr lang="en-US" sz="1800" b="1" dirty="0">
+                <a:solidFill>
+                  <a:srgbClr val="333333"/>
+                </a:solidFill>
+              </a:rPr>
+              <a:t>Tabel 5</a:t>
+            </a:r>
+            <a:pPr indent="0" marL="0">
+              <a:buNone/>
+            </a:pPr>
+            <a:r>
+              <a:rPr lang="en-US" sz="1800" dirty="0">
+                <a:solidFill>
+                  <a:srgbClr val="333333"/>
+                </a:solidFill>
+              </a:rPr>
+              <a:t> membuktikan bahwa saat crash, distribusi kerugian ekor model NW (Network Markowitz) jauh lebih terjaga.</a:t>
+            </a:r>
+            <a:endParaRPr lang="en-US" sz="1800" dirty="0"/>
+          </a:p>
+          <a:p>
+            <a:pPr marL="342900" indent="-342900">
+              <a:buSzPct val="100000"/>
+              <a:buChar char="•"/>
+            </a:pPr>
+            <a:r>
+              <a:rPr lang="en-US" sz="1800" dirty="0">
+                <a:solidFill>
+                  <a:srgbClr val="333333"/>
+                </a:solidFill>
+              </a:rPr>
+              <a:t>Kesimpulan: Topologi jaringan memberikan sinyal </a:t>
+            </a:r>
+            <a:pPr indent="0" marL="0">
+              <a:buNone/>
+            </a:pPr>
+            <a:r>
+              <a:rPr lang="en-US" sz="1800" b="1" dirty="0">
+                <a:solidFill>
+                  <a:srgbClr val="333333"/>
+                </a:solidFill>
+              </a:rPr>
+              <a:t>diversifikasi akurat</a:t>
+            </a:r>
+            <a:pPr indent="0" marL="0">
+              <a:buNone/>
+            </a:pPr>
+            <a:r>
+              <a:rPr lang="en-US" sz="1800" dirty="0">
+                <a:solidFill>
+                  <a:srgbClr val="333333"/>
+                </a:solidFill>
+              </a:rPr>
+              <a:t> daripada sekadar variansi harga.</a:t>
+            </a:r>
+            <a:endParaRPr lang="en-US" sz="1800" dirty="0"/>
           </a:p>
         </p:txBody>
       </p:sp>

</xml_diff>

<commit_message>
feat: add math breakdown slide for 60/40 weight split
</commit_message>
<xml_diff>
--- a/Presentasi_Proposal_Update.pptx
+++ b/Presentasi_Proposal_Update.pptx
@@ -45,9 +45,10 @@
     <p:sldId id="293" r:id="rId39"/>
     <p:sldId id="294" r:id="rId40"/>
     <p:sldId id="295" r:id="rId41"/>
+    <p:sldId id="296" r:id="rId42"/>
   </p:sldIdLst>
   <p:notesMasterIdLst>
-    <p:notesMasterId r:id="rId42"/>
+    <p:notesMasterId r:id="rId43"/>
   </p:notesMasterIdLst>
   <p:sldSz cx="9144000" cy="5143500"/>
   <p:notesSz cx="5143500" cy="9144000"/>
@@ -3557,6 +3558,94 @@
             <a:fld id="{F7021451-1387-4CA6-816F-3879F97B5CBC}" type="slidenum">
               <a:rPr lang="en-US"/>
               <a:t>40</a:t>
+            </a:fld>
+            <a:endParaRPr lang="en-US"/>
+          </a:p>
+        </p:txBody>
+      </p:sp>
+    </p:spTree>
+    <p:extLst>
+      <p:ext uri="{BB962C8B-B14F-4D97-AF65-F5344CB8AC3E}">
+        <p14:creationId xmlns:p14="http://schemas.microsoft.com/office/powerpoint/2010/main" val="1024086991"/>
+      </p:ext>
+    </p:extLst>
+  </p:cSld>
+  <p:clrMapOvr>
+    <a:masterClrMapping/>
+  </p:clrMapOvr>
+</p:notes>
+</file>
+
+<file path=ppt/notesSlides/notesSlide41.xml><?xml version="1.0" encoding="utf-8"?>
+<p:notes xmlns:a="http://schemas.openxmlformats.org/drawingml/2006/main" xmlns:r="http://schemas.openxmlformats.org/officeDocument/2006/relationships" xmlns:p="http://schemas.openxmlformats.org/presentationml/2006/main">
+  <p:cSld>
+    <p:spTree>
+      <p:nvGrpSpPr>
+        <p:cNvPr id="1" name=""/>
+        <p:cNvGrpSpPr/>
+        <p:nvPr/>
+      </p:nvGrpSpPr>
+      <p:grpSpPr>
+        <a:xfrm>
+          <a:off x="0" y="0"/>
+          <a:ext cx="0" cy="0"/>
+          <a:chOff x="0" y="0"/>
+          <a:chExt cx="0" cy="0"/>
+        </a:xfrm>
+      </p:grpSpPr>
+      <p:sp>
+        <p:nvSpPr>
+          <p:cNvPr id="2" name="Slide Image Placeholder 1"/>
+          <p:cNvSpPr>
+            <a:spLocks noGrp="1" noRot="1" noChangeAspect="1"/>
+          </p:cNvSpPr>
+          <p:nvPr>
+            <p:ph type="sldImg"/>
+          </p:nvPr>
+        </p:nvSpPr>
+        <p:spPr/>
+      </p:sp>
+      <p:sp>
+        <p:nvSpPr>
+          <p:cNvPr id="3" name="Notes Placeholder 2"/>
+          <p:cNvSpPr>
+            <a:spLocks noGrp="1"/>
+          </p:cNvSpPr>
+          <p:nvPr>
+            <p:ph type="body" idx="1"/>
+          </p:nvPr>
+        </p:nvSpPr>
+        <p:spPr/>
+        <p:txBody>
+          <a:bodyPr/>
+          <a:lstStyle/>
+          <a:p>
+            <a:r>
+              <a:rPr lang="en-US" dirty="0"/>
+              <a:t/>
+            </a:r>
+            <a:endParaRPr lang="en-US" dirty="0"/>
+          </a:p>
+        </p:txBody>
+      </p:sp>
+      <p:sp>
+        <p:nvSpPr>
+          <p:cNvPr id="4" name="Slide Number Placeholder 3"/>
+          <p:cNvSpPr>
+            <a:spLocks noGrp="1"/>
+          </p:cNvSpPr>
+          <p:nvPr>
+            <p:ph type="sldNum" sz="quarter" idx="10"/>
+          </p:nvPr>
+        </p:nvSpPr>
+        <p:spPr/>
+        <p:txBody>
+          <a:bodyPr/>
+          <a:lstStyle/>
+          <a:p>
+            <a:fld id="{F7021451-1387-4CA6-816F-3879F97B5CBC}" type="slidenum">
+              <a:rPr lang="en-US"/>
+              <a:t>41</a:t>
             </a:fld>
             <a:endParaRPr lang="en-US"/>
           </a:p>
@@ -11722,14 +11811,14 @@
               <a:buNone/>
             </a:pPr>
             <a:r>
-              <a:rPr lang="en-US" sz="2600" b="1" dirty="0">
+              <a:rPr lang="en-US" sz="2400" b="1" dirty="0">
                 <a:solidFill>
                   <a:srgbClr val="003366"/>
                 </a:solidFill>
               </a:rPr>
-              <a:t>Lampiran: Dua Tipe Pendekatan Grid Search</a:t>
-            </a:r>
-            <a:endParaRPr lang="en-US" sz="2600" dirty="0"/>
+              <a:t>Lampiran: Rumus &amp; Penjabaran Bobot (60% vs 40%)</a:t>
+            </a:r>
+            <a:endParaRPr lang="en-US" sz="2400" dirty="0"/>
           </a:p>
         </p:txBody>
       </p:sp>
@@ -11758,190 +11847,278 @@
               <a:buNone/>
             </a:pPr>
             <a:r>
-              <a:rPr lang="en-US" sz="1800" b="1" dirty="0">
-                <a:solidFill>
-                  <a:srgbClr val="333333"/>
-                </a:solidFill>
-              </a:rPr>
-              <a:t>Dua Objektif Optimasi (Return vs Risk):</a:t>
-            </a:r>
-            <a:endParaRPr lang="en-US" sz="1800" dirty="0"/>
-          </a:p>
-          <a:p>
-            <a:pPr indent="0" marL="0">
-              <a:buNone/>
-            </a:pPr>
-            <a:r>
-              <a:rPr lang="en-US" sz="1800" b="1" dirty="0">
+              <a:rPr lang="en-US" sz="1600" b="1" dirty="0">
+                <a:solidFill>
+                  <a:srgbClr val="333333"/>
+                </a:solidFill>
+              </a:rPr>
+              <a:t>Menggunakan Metode Alokasi Volatilitas Terbalik (Inverse Volatility):</a:t>
+            </a:r>
+            <a:endParaRPr lang="en-US" sz="1600" dirty="0"/>
+          </a:p>
+          <a:p>
+            <a:pPr indent="0" marL="0">
+              <a:buNone/>
+            </a:pPr>
+            <a:r>
+              <a:rPr lang="en-US" sz="1600" i="1" dirty="0">
+                <a:solidFill>
+                  <a:srgbClr val="003366"/>
+                </a:solidFill>
+              </a:rPr>
+              <a:t>Rumus: Bobot (w) = (1 / Risiko) / Total (1 / Risiko)</a:t>
+            </a:r>
+            <a:endParaRPr lang="en-US" sz="1600" dirty="0"/>
+          </a:p>
+          <a:p>
+            <a:pPr indent="0" marL="0">
+              <a:buNone/>
+            </a:pPr>
+            <a:r>
+              <a:rPr lang="en-US" sz="1600" b="1" dirty="0">
+                <a:solidFill>
+                  <a:srgbClr val="2C3E50"/>
+                </a:solidFill>
+              </a:rPr>
+              <a:t>1. Perhitungan Skenario Klasik (Tanpa Penalti):</a:t>
+            </a:r>
+            <a:endParaRPr lang="en-US" sz="1600" dirty="0"/>
+          </a:p>
+          <a:p>
+            <a:pPr indent="0" marL="0">
+              <a:buNone/>
+            </a:pPr>
+            <a:r>
+              <a:rPr lang="en-US" sz="1600" dirty="0">
+                <a:solidFill>
+                  <a:srgbClr val="333333"/>
+                </a:solidFill>
+              </a:rPr>
+              <a:t>   • Aset A (Risiko 0.20) → 1 / 0.20 = </a:t>
+            </a:r>
+            <a:pPr indent="0" marL="0">
+              <a:buNone/>
+            </a:pPr>
+            <a:r>
+              <a:rPr lang="en-US" sz="1600" b="1" dirty="0">
+                <a:solidFill>
+                  <a:srgbClr val="333333"/>
+                </a:solidFill>
+              </a:rPr>
+              <a:t>5.00</a:t>
+            </a:r>
+            <a:pPr indent="0" marL="0">
+              <a:buNone/>
+            </a:pPr>
+            <a:r>
+              <a:rPr lang="en-US" sz="1600" dirty="0">
+                <a:solidFill>
+                  <a:srgbClr val="333333"/>
+                </a:solidFill>
+              </a:rPr>
+              <a:t> (Daya Tarik)</a:t>
+            </a:r>
+            <a:endParaRPr lang="en-US" sz="1600" dirty="0"/>
+          </a:p>
+          <a:p>
+            <a:pPr indent="0" marL="0">
+              <a:buNone/>
+            </a:pPr>
+            <a:r>
+              <a:rPr lang="en-US" sz="1600" dirty="0">
+                <a:solidFill>
+                  <a:srgbClr val="333333"/>
+                </a:solidFill>
+              </a:rPr>
+              <a:t>   • Aset B (Risiko 0.30) → 1 / 0.30 = </a:t>
+            </a:r>
+            <a:pPr indent="0" marL="0">
+              <a:buNone/>
+            </a:pPr>
+            <a:r>
+              <a:rPr lang="en-US" sz="1600" b="1" dirty="0">
+                <a:solidFill>
+                  <a:srgbClr val="333333"/>
+                </a:solidFill>
+              </a:rPr>
+              <a:t>3.33</a:t>
+            </a:r>
+            <a:pPr indent="0" marL="0">
+              <a:buNone/>
+            </a:pPr>
+            <a:r>
+              <a:rPr lang="en-US" sz="1600" dirty="0">
+                <a:solidFill>
+                  <a:srgbClr val="333333"/>
+                </a:solidFill>
+              </a:rPr>
+              <a:t> (Daya Tarik)</a:t>
+            </a:r>
+            <a:endParaRPr lang="en-US" sz="1600" dirty="0"/>
+          </a:p>
+          <a:p>
+            <a:pPr indent="0" marL="0">
+              <a:buNone/>
+            </a:pPr>
+            <a:r>
+              <a:rPr lang="en-US" sz="1600" dirty="0">
+                <a:solidFill>
+                  <a:srgbClr val="333333"/>
+                </a:solidFill>
+              </a:rPr>
+              <a:t>   • Bobot A = 5.00 / (5.00 + 3.33) = 5.00 / 8.33 ≈ </a:t>
+            </a:r>
+            <a:pPr indent="0" marL="0">
+              <a:buNone/>
+            </a:pPr>
+            <a:r>
+              <a:rPr lang="en-US" sz="1600" b="1" dirty="0">
+                <a:solidFill>
+                  <a:srgbClr val="C0392B"/>
+                </a:solidFill>
+              </a:rPr>
+              <a:t>60%</a:t>
+            </a:r>
+            <a:endParaRPr lang="en-US" sz="1600" dirty="0"/>
+          </a:p>
+          <a:p>
+            <a:pPr indent="0" marL="0">
+              <a:buNone/>
+            </a:pPr>
+            <a:r>
+              <a:rPr lang="en-US" sz="1600" b="1" dirty="0">
+                <a:solidFill>
+                  <a:srgbClr val="2C3E50"/>
+                </a:solidFill>
+              </a:rPr>
+              <a:t>2. Perhitungan Skenario Network (Gamma 0.5):</a:t>
+            </a:r>
+            <a:endParaRPr lang="en-US" sz="1600" dirty="0"/>
+          </a:p>
+          <a:p>
+            <a:pPr indent="0" marL="0">
+              <a:buNone/>
+            </a:pPr>
+            <a:r>
+              <a:rPr lang="en-US" sz="1600" dirty="0">
+                <a:solidFill>
+                  <a:srgbClr val="333333"/>
+                </a:solidFill>
+              </a:rPr>
+              <a:t>   • Aset A (Risiko 0.60) → 1 / 0.60 = </a:t>
+            </a:r>
+            <a:pPr indent="0" marL="0">
+              <a:buNone/>
+            </a:pPr>
+            <a:r>
+              <a:rPr lang="en-US" sz="1600" b="1" dirty="0">
+                <a:solidFill>
+                  <a:srgbClr val="333333"/>
+                </a:solidFill>
+              </a:rPr>
+              <a:t>1.67</a:t>
+            </a:r>
+            <a:pPr indent="0" marL="0">
+              <a:buNone/>
+            </a:pPr>
+            <a:r>
+              <a:rPr lang="en-US" sz="1600" dirty="0">
+                <a:solidFill>
+                  <a:srgbClr val="333333"/>
+                </a:solidFill>
+              </a:rPr>
+              <a:t> (Daya Tarik Turun)</a:t>
+            </a:r>
+            <a:endParaRPr lang="en-US" sz="1600" dirty="0"/>
+          </a:p>
+          <a:p>
+            <a:pPr indent="0" marL="0">
+              <a:buNone/>
+            </a:pPr>
+            <a:r>
+              <a:rPr lang="en-US" sz="1600" dirty="0">
+                <a:solidFill>
+                  <a:srgbClr val="333333"/>
+                </a:solidFill>
+              </a:rPr>
+              <a:t>   • Aset B (Risiko 0.40) → 1 / 0.40 = </a:t>
+            </a:r>
+            <a:pPr indent="0" marL="0">
+              <a:buNone/>
+            </a:pPr>
+            <a:r>
+              <a:rPr lang="en-US" sz="1600" b="1" dirty="0">
+                <a:solidFill>
+                  <a:srgbClr val="333333"/>
+                </a:solidFill>
+              </a:rPr>
+              <a:t>2.50</a:t>
+            </a:r>
+            <a:pPr indent="0" marL="0">
+              <a:buNone/>
+            </a:pPr>
+            <a:r>
+              <a:rPr lang="en-US" sz="1600" dirty="0">
+                <a:solidFill>
+                  <a:srgbClr val="333333"/>
+                </a:solidFill>
+              </a:rPr>
+              <a:t> (Daya Tarik Naik)</a:t>
+            </a:r>
+            <a:endParaRPr lang="en-US" sz="1600" dirty="0"/>
+          </a:p>
+          <a:p>
+            <a:pPr indent="0" marL="0">
+              <a:buNone/>
+            </a:pPr>
+            <a:r>
+              <a:rPr lang="en-US" sz="1600" dirty="0">
+                <a:solidFill>
+                  <a:srgbClr val="333333"/>
+                </a:solidFill>
+              </a:rPr>
+              <a:t>   • Bobot A = 1.67 / (1.67 + 2.50) = 1.67 / 4.17 ≈ </a:t>
+            </a:r>
+            <a:pPr indent="0" marL="0">
+              <a:buNone/>
+            </a:pPr>
+            <a:r>
+              <a:rPr lang="en-US" sz="1600" b="1" dirty="0">
                 <a:solidFill>
                   <a:srgbClr val="27AE60"/>
                 </a:solidFill>
               </a:rPr>
-              <a:t>1. Network Markowitz dengan Target Return (NW - Return Grid Search):</a:t>
-            </a:r>
-            <a:endParaRPr lang="en-US" sz="1800" dirty="0"/>
-          </a:p>
-          <a:p>
-            <a:pPr marL="342900" indent="-342900">
-              <a:buSzPct val="100000"/>
-              <a:buChar char="•"/>
-            </a:pPr>
-            <a:r>
-              <a:rPr lang="en-US" sz="1800" dirty="0">
-                <a:solidFill>
-                  <a:srgbClr val="333333"/>
-                </a:solidFill>
-              </a:rPr>
-              <a:t>Memaksimalkan capaian </a:t>
-            </a:r>
-            <a:pPr indent="0" marL="0">
-              <a:buNone/>
-            </a:pPr>
-            <a:r>
-              <a:rPr lang="en-US" sz="1800" b="1" dirty="0">
-                <a:solidFill>
-                  <a:srgbClr val="333333"/>
-                </a:solidFill>
-              </a:rPr>
-              <a:t>imbal hasil</a:t>
-            </a:r>
-            <a:pPr indent="0" marL="0">
-              <a:buNone/>
-            </a:pPr>
-            <a:r>
-              <a:rPr lang="en-US" sz="1800" dirty="0">
-                <a:solidFill>
-                  <a:srgbClr val="333333"/>
-                </a:solidFill>
-              </a:rPr>
-              <a:t> portofolio.</a:t>
-            </a:r>
-            <a:endParaRPr lang="en-US" sz="1800" dirty="0"/>
-          </a:p>
-          <a:p>
-            <a:pPr marL="342900" indent="-342900">
-              <a:buSzPct val="100000"/>
-              <a:buChar char="•"/>
-            </a:pPr>
-            <a:r>
-              <a:rPr lang="en-US" sz="1800" dirty="0">
-                <a:solidFill>
-                  <a:srgbClr val="333333"/>
-                </a:solidFill>
-              </a:rPr>
-              <a:t>Lebih Agresif untuk mengeksploitasi reli pada pasar </a:t>
-            </a:r>
-            <a:pPr indent="0" marL="0">
-              <a:buNone/>
-            </a:pPr>
-            <a:r>
-              <a:rPr lang="en-US" sz="1800" b="1" dirty="0">
-                <a:solidFill>
-                  <a:srgbClr val="333333"/>
-                </a:solidFill>
-              </a:rPr>
-              <a:t>Bullish</a:t>
-            </a:r>
-            <a:pPr indent="0" marL="0">
-              <a:buNone/>
-            </a:pPr>
-            <a:r>
-              <a:rPr lang="en-US" sz="1800" dirty="0">
-                <a:solidFill>
-                  <a:srgbClr val="333333"/>
-                </a:solidFill>
-              </a:rPr>
-              <a:t>.</a:t>
-            </a:r>
-            <a:endParaRPr lang="en-US" sz="1800" dirty="0"/>
-          </a:p>
-          <a:p>
-            <a:pPr indent="0" marL="0">
-              <a:buNone/>
-            </a:pPr>
-            <a:r>
-              <a:rPr lang="en-US" sz="1800" b="1" dirty="0">
-                <a:solidFill>
-                  <a:srgbClr val="C0392B"/>
-                </a:solidFill>
-              </a:rPr>
-              <a:t>2. Network Markowitz dengan Target Risiko (NW - Risk Grid Search):</a:t>
-            </a:r>
-            <a:endParaRPr lang="en-US" sz="1800" dirty="0"/>
-          </a:p>
-          <a:p>
-            <a:pPr marL="342900" indent="-342900">
-              <a:buSzPct val="100000"/>
-              <a:buChar char="•"/>
-            </a:pPr>
-            <a:r>
-              <a:rPr lang="en-US" sz="1800" dirty="0">
-                <a:solidFill>
-                  <a:srgbClr val="333333"/>
-                </a:solidFill>
-              </a:rPr>
-              <a:t>Menekan parameter </a:t>
-            </a:r>
-            <a:pPr indent="0" marL="0">
-              <a:buNone/>
-            </a:pPr>
-            <a:r>
-              <a:rPr lang="en-US" sz="1800" b="1" dirty="0">
-                <a:solidFill>
-                  <a:srgbClr val="333333"/>
-                </a:solidFill>
-              </a:rPr>
-              <a:t>risiko total</a:t>
-            </a:r>
-            <a:pPr indent="0" marL="0">
-              <a:buNone/>
-            </a:pPr>
-            <a:r>
-              <a:rPr lang="en-US" sz="1800" dirty="0">
-                <a:solidFill>
-                  <a:srgbClr val="333333"/>
-                </a:solidFill>
-              </a:rPr>
-              <a:t> hingga minimal.</a:t>
-            </a:r>
-            <a:endParaRPr lang="en-US" sz="1800" dirty="0"/>
-          </a:p>
-          <a:p>
-            <a:pPr marL="342900" indent="-342900">
-              <a:buSzPct val="100000"/>
-              <a:buChar char="•"/>
-            </a:pPr>
-            <a:r>
-              <a:rPr lang="en-US" sz="1800" dirty="0">
-                <a:solidFill>
-                  <a:srgbClr val="333333"/>
-                </a:solidFill>
-              </a:rPr>
-              <a:t>Lebih Defensif untuk meredam fluktuasi saat </a:t>
-            </a:r>
-            <a:pPr indent="0" marL="0">
-              <a:buNone/>
-            </a:pPr>
-            <a:r>
-              <a:rPr lang="en-US" sz="1800" b="1" dirty="0">
-                <a:solidFill>
-                  <a:srgbClr val="333333"/>
-                </a:solidFill>
-              </a:rPr>
-              <a:t>Crypto Winter</a:t>
-            </a:r>
-            <a:pPr indent="0" marL="0">
-              <a:buNone/>
-            </a:pPr>
-            <a:r>
-              <a:rPr lang="en-US" sz="1800" dirty="0">
-                <a:solidFill>
-                  <a:srgbClr val="333333"/>
-                </a:solidFill>
-              </a:rPr>
-              <a:t>.</a:t>
-            </a:r>
-            <a:endParaRPr lang="en-US" sz="1800" dirty="0"/>
+              <a:t>40%</a:t>
+            </a:r>
+            <a:endParaRPr lang="en-US" sz="1600" dirty="0"/>
+          </a:p>
+          <a:p>
+            <a:pPr indent="0" marL="0">
+              <a:buNone/>
+            </a:pPr>
+            <a:r>
+              <a:rPr lang="en-US" sz="1600" b="1" dirty="0">
+                <a:solidFill>
+                  <a:srgbClr val="8E44AD"/>
+                </a:solidFill>
+              </a:rPr>
+              <a:t>Kesimpulan Matematis:</a:t>
+            </a:r>
+            <a:endParaRPr lang="en-US" sz="1600" dirty="0"/>
+          </a:p>
+          <a:p>
+            <a:pPr indent="0" marL="0">
+              <a:buNone/>
+            </a:pPr>
+            <a:r>
+              <a:rPr lang="en-US" sz="1600" i="1" dirty="0">
+                <a:solidFill>
+                  <a:srgbClr val="333333"/>
+                </a:solidFill>
+              </a:rPr>
+              <a:t>Model ini secara adil memberikan porsi lebih besar pada aset yang memiliki skor gabungan 'Risiko + Penalti' yang paling kecil.</a:t>
+            </a:r>
+            <a:endParaRPr lang="en-US" sz="1600" dirty="0"/>
           </a:p>
         </p:txBody>
       </p:sp>
@@ -12000,7 +12177,7 @@
                   <a:srgbClr val="003366"/>
                 </a:solidFill>
               </a:rPr>
-              <a:t>Lampiran: Penanganan Data Kosong (Missing Values)</a:t>
+              <a:t>Lampiran: Dua Tipe Pendekatan Grid Search</a:t>
             </a:r>
             <a:endParaRPr lang="en-US" sz="2600" dirty="0"/>
           </a:p>
@@ -12033,41 +12210,156 @@
             <a:r>
               <a:rPr lang="en-US" sz="1800" b="1" dirty="0">
                 <a:solidFill>
+                  <a:srgbClr val="333333"/>
+                </a:solidFill>
+              </a:rPr>
+              <a:t>Dua Objektif Optimasi (Return vs Risk):</a:t>
+            </a:r>
+            <a:endParaRPr lang="en-US" sz="1800" dirty="0"/>
+          </a:p>
+          <a:p>
+            <a:pPr indent="0" marL="0">
+              <a:buNone/>
+            </a:pPr>
+            <a:r>
+              <a:rPr lang="en-US" sz="1800" b="1" dirty="0">
+                <a:solidFill>
+                  <a:srgbClr val="27AE60"/>
+                </a:solidFill>
+              </a:rPr>
+              <a:t>1. Network Markowitz dengan Target Return (NW - Return Grid Search):</a:t>
+            </a:r>
+            <a:endParaRPr lang="en-US" sz="1800" dirty="0"/>
+          </a:p>
+          <a:p>
+            <a:pPr marL="342900" indent="-342900">
+              <a:buSzPct val="100000"/>
+              <a:buChar char="•"/>
+            </a:pPr>
+            <a:r>
+              <a:rPr lang="en-US" sz="1800" dirty="0">
+                <a:solidFill>
+                  <a:srgbClr val="333333"/>
+                </a:solidFill>
+              </a:rPr>
+              <a:t>Memaksimalkan capaian </a:t>
+            </a:r>
+            <a:pPr indent="0" marL="0">
+              <a:buNone/>
+            </a:pPr>
+            <a:r>
+              <a:rPr lang="en-US" sz="1800" b="1" dirty="0">
+                <a:solidFill>
+                  <a:srgbClr val="333333"/>
+                </a:solidFill>
+              </a:rPr>
+              <a:t>imbal hasil</a:t>
+            </a:r>
+            <a:pPr indent="0" marL="0">
+              <a:buNone/>
+            </a:pPr>
+            <a:r>
+              <a:rPr lang="en-US" sz="1800" dirty="0">
+                <a:solidFill>
+                  <a:srgbClr val="333333"/>
+                </a:solidFill>
+              </a:rPr>
+              <a:t> portofolio.</a:t>
+            </a:r>
+            <a:endParaRPr lang="en-US" sz="1800" dirty="0"/>
+          </a:p>
+          <a:p>
+            <a:pPr marL="342900" indent="-342900">
+              <a:buSzPct val="100000"/>
+              <a:buChar char="•"/>
+            </a:pPr>
+            <a:r>
+              <a:rPr lang="en-US" sz="1800" dirty="0">
+                <a:solidFill>
+                  <a:srgbClr val="333333"/>
+                </a:solidFill>
+              </a:rPr>
+              <a:t>Lebih Agresif untuk mengeksploitasi reli pada pasar </a:t>
+            </a:r>
+            <a:pPr indent="0" marL="0">
+              <a:buNone/>
+            </a:pPr>
+            <a:r>
+              <a:rPr lang="en-US" sz="1800" b="1" dirty="0">
+                <a:solidFill>
+                  <a:srgbClr val="333333"/>
+                </a:solidFill>
+              </a:rPr>
+              <a:t>Bullish</a:t>
+            </a:r>
+            <a:pPr indent="0" marL="0">
+              <a:buNone/>
+            </a:pPr>
+            <a:r>
+              <a:rPr lang="en-US" sz="1800" dirty="0">
+                <a:solidFill>
+                  <a:srgbClr val="333333"/>
+                </a:solidFill>
+              </a:rPr>
+              <a:t>.</a:t>
+            </a:r>
+            <a:endParaRPr lang="en-US" sz="1800" dirty="0"/>
+          </a:p>
+          <a:p>
+            <a:pPr indent="0" marL="0">
+              <a:buNone/>
+            </a:pPr>
+            <a:r>
+              <a:rPr lang="en-US" sz="1800" b="1" dirty="0">
+                <a:solidFill>
                   <a:srgbClr val="C0392B"/>
                 </a:solidFill>
               </a:rPr>
-              <a:t>Pertanyaan: </a:t>
-            </a:r>
-            <a:pPr indent="0" marL="0">
-              <a:buNone/>
-            </a:pPr>
-            <a:r>
-              <a:rPr lang="en-US" sz="1800" i="1" dirty="0">
-                <a:solidFill>
-                  <a:srgbClr val="333333"/>
-                </a:solidFill>
-              </a:rPr>
-              <a:t>"Beberapa koin seperti Binance/EOS belum rilis di awal 2017 sehingga datanya kosong. Bukankah backward-fill memalsukan harga dan merusak matriks?"</a:t>
+              <a:t>2. Network Markowitz dengan Target Risiko (NW - Risk Grid Search):</a:t>
             </a:r>
             <a:endParaRPr lang="en-US" sz="1800" dirty="0"/>
           </a:p>
           <a:p>
+            <a:pPr marL="342900" indent="-342900">
+              <a:buSzPct val="100000"/>
+              <a:buChar char="•"/>
+            </a:pPr>
+            <a:r>
+              <a:rPr lang="en-US" sz="1800" dirty="0">
+                <a:solidFill>
+                  <a:srgbClr val="333333"/>
+                </a:solidFill>
+              </a:rPr>
+              <a:t>Menekan parameter </a:t>
+            </a:r>
             <a:pPr indent="0" marL="0">
               <a:buNone/>
             </a:pPr>
             <a:r>
               <a:rPr lang="en-US" sz="1800" b="1" dirty="0">
                 <a:solidFill>
-                  <a:srgbClr val="27AE60"/>
-                </a:solidFill>
-              </a:rPr>
-              <a:t>Jawaban (Kenapa RMT sangat Krusial):</a:t>
+                  <a:srgbClr val="333333"/>
+                </a:solidFill>
+              </a:rPr>
+              <a:t>risiko total</a:t>
+            </a:r>
+            <a:pPr indent="0" marL="0">
+              <a:buNone/>
+            </a:pPr>
+            <a:r>
+              <a:rPr lang="en-US" sz="1800" dirty="0">
+                <a:solidFill>
+                  <a:srgbClr val="333333"/>
+                </a:solidFill>
+              </a:rPr>
+              <a:t> hingga minimal.</a:t>
             </a:r>
             <a:endParaRPr lang="en-US" sz="1800" dirty="0"/>
           </a:p>
           <a:p>
-            <a:pPr indent="0" marL="0">
-              <a:buNone/>
+            <a:pPr marL="342900" indent="-342900">
+              <a:buSzPct val="100000"/>
+              <a:buChar char="•"/>
             </a:pPr>
             <a:r>
               <a:rPr lang="en-US" sz="1800" dirty="0">
@@ -12075,18 +12367,18 @@
                   <a:srgbClr val="333333"/>
                 </a:solidFill>
               </a:rPr>
-              <a:t>   1. Praktik pengisian data diam (</a:t>
-            </a:r>
-            <a:pPr indent="0" marL="0">
-              <a:buNone/>
-            </a:pPr>
-            <a:r>
-              <a:rPr lang="en-US" sz="1800" b="1" i="1" dirty="0">
-                <a:solidFill>
-                  <a:srgbClr val="333333"/>
-                </a:solidFill>
-              </a:rPr>
-              <a:t>backward fill</a:t>
+              <a:t>Lebih Defensif untuk meredam fluktuasi saat </a:t>
+            </a:r>
+            <a:pPr indent="0" marL="0">
+              <a:buNone/>
+            </a:pPr>
+            <a:r>
+              <a:rPr lang="en-US" sz="1800" b="1" dirty="0">
+                <a:solidFill>
+                  <a:srgbClr val="333333"/>
+                </a:solidFill>
+              </a:rPr>
+              <a:t>Crypto Winter</a:t>
             </a:r>
             <a:pPr indent="0" marL="0">
               <a:buNone/>
@@ -12097,115 +12389,7 @@
                   <a:srgbClr val="333333"/>
                 </a:solidFill>
               </a:rPr>
-              <a:t>) memang menciptakan rentetan nilai harga yang statis.</a:t>
-            </a:r>
-            <a:endParaRPr lang="en-US" sz="1800" dirty="0"/>
-          </a:p>
-          <a:p>
-            <a:pPr indent="0" marL="0">
-              <a:buNone/>
-            </a:pPr>
-            <a:r>
-              <a:rPr lang="en-US" sz="1800" dirty="0">
-                <a:solidFill>
-                  <a:srgbClr val="333333"/>
-                </a:solidFill>
-              </a:rPr>
-              <a:t>   2. Namun, kehebatan </a:t>
-            </a:r>
-            <a:pPr indent="0" marL="0">
-              <a:buNone/>
-            </a:pPr>
-            <a:r>
-              <a:rPr lang="en-US" sz="1800" b="1" dirty="0">
-                <a:solidFill>
-                  <a:srgbClr val="333333"/>
-                </a:solidFill>
-              </a:rPr>
-              <a:t>Random Matrix Theory (RMT)</a:t>
-            </a:r>
-            <a:pPr indent="0" marL="0">
-              <a:buNone/>
-            </a:pPr>
-            <a:r>
-              <a:rPr lang="en-US" sz="1800" dirty="0">
-                <a:solidFill>
-                  <a:srgbClr val="333333"/>
-                </a:solidFill>
-              </a:rPr>
-              <a:t> diuji di sini! Karena data yang datar sama sekali tidak punya korelasi nyata.</a:t>
-            </a:r>
-            <a:endParaRPr lang="en-US" sz="1800" dirty="0"/>
-          </a:p>
-          <a:p>
-            <a:pPr indent="0" marL="0">
-              <a:buNone/>
-            </a:pPr>
-            <a:r>
-              <a:rPr lang="en-US" sz="1800" dirty="0">
-                <a:solidFill>
-                  <a:srgbClr val="333333"/>
-                </a:solidFill>
-              </a:rPr>
-              <a:t>   3. RMT otomatis akan mendeteksi korelasi buatan tersebut sebagai probabilitas </a:t>
-            </a:r>
-            <a:pPr indent="0" marL="0">
-              <a:buNone/>
-            </a:pPr>
-            <a:r>
-              <a:rPr lang="en-US" sz="1800" b="1" i="1" dirty="0">
-                <a:solidFill>
-                  <a:srgbClr val="333333"/>
-                </a:solidFill>
-              </a:rPr>
-              <a:t>Noise Acak</a:t>
-            </a:r>
-            <a:pPr indent="0" marL="0">
-              <a:buNone/>
-            </a:pPr>
-            <a:r>
-              <a:rPr lang="en-US" sz="1800" dirty="0">
-                <a:solidFill>
-                  <a:srgbClr val="333333"/>
-                </a:solidFill>
-              </a:rPr>
-              <a:t>, lalu membuangnya menjadi 0.</a:t>
-            </a:r>
-            <a:endParaRPr lang="en-US" sz="1800" dirty="0"/>
-          </a:p>
-          <a:p>
-            <a:pPr indent="0" marL="0">
-              <a:buNone/>
-            </a:pPr>
-            <a:r>
-              <a:rPr lang="en-US" sz="1800" dirty="0">
-                <a:solidFill>
-                  <a:srgbClr val="333333"/>
-                </a:solidFill>
-              </a:rPr>
-              <a:t>   4. Hasilnya, matriks korelasi </a:t>
-            </a:r>
-            <a:pPr indent="0" marL="0">
-              <a:buNone/>
-            </a:pPr>
-            <a:r>
-              <a:rPr lang="en-US" sz="1800" b="1" dirty="0">
-                <a:solidFill>
-                  <a:srgbClr val="333333"/>
-                </a:solidFill>
-              </a:rPr>
-              <a:t>terselamatkan</a:t>
-            </a:r>
-            <a:pPr indent="0" marL="0">
-              <a:buNone/>
-            </a:pPr>
-            <a:r>
-              <a:rPr lang="en-US" sz="1800" dirty="0">
-                <a:solidFill>
-                  <a:srgbClr val="333333"/>
-                </a:solidFill>
-              </a:rPr>
-              <a:t> dan tidak tercemar oleh cacat kelengkapan data.</a:t>
+              <a:t>.</a:t>
             </a:r>
             <a:endParaRPr lang="en-US" sz="1800" dirty="0"/>
           </a:p>
@@ -12266,7 +12450,7 @@
                   <a:srgbClr val="003366"/>
                 </a:solidFill>
               </a:rPr>
-              <a:t>Lampiran: Mengapa Menyertakan Tether (USDT)? (1/2)</a:t>
+              <a:t>Lampiran: Penanganan Data Kosong (Missing Values)</a:t>
             </a:r>
             <a:endParaRPr lang="en-US" sz="2600" dirty="0"/>
           </a:p>
@@ -12313,7 +12497,7 @@
                   <a:srgbClr val="333333"/>
                 </a:solidFill>
               </a:rPr>
-              <a:t>"Tether (USDT) itu stablecoin yang nilainya selalu fix ke 1 USD. Apakah tidak berbuat curang?"</a:t>
+              <a:t>"Beberapa koin seperti Binance/EOS belum rilis di awal 2017 sehingga datanya kosong. Bukankah backward-fill memalsukan harga dan merusak matriks?"</a:t>
             </a:r>
             <a:endParaRPr lang="en-US" sz="1800" dirty="0"/>
           </a:p>
@@ -12327,14 +12511,13 @@
                   <a:srgbClr val="27AE60"/>
                 </a:solidFill>
               </a:rPr>
-              <a:t>Jawaban (Dinamika Portofolio Cerdas):</a:t>
+              <a:t>Jawaban (Kenapa RMT sangat Krusial):</a:t>
             </a:r>
             <a:endParaRPr lang="en-US" sz="1800" dirty="0"/>
           </a:p>
           <a:p>
-            <a:pPr marL="342900" indent="-342900">
-              <a:buSzPct val="100000"/>
-              <a:buChar char="•"/>
+            <a:pPr indent="0" marL="0">
+              <a:buNone/>
             </a:pPr>
             <a:r>
               <a:rPr lang="en-US" sz="1800" dirty="0">
@@ -12342,7 +12525,7 @@
                   <a:srgbClr val="333333"/>
                 </a:solidFill>
               </a:rPr>
-              <a:t>Model ini mensimulasikan perilaku </a:t>
+              <a:t>   1. Praktik pengisian data diam (</a:t>
             </a:r>
             <a:pPr indent="0" marL="0">
               <a:buNone/>
@@ -12353,7 +12536,7 @@
                   <a:srgbClr val="333333"/>
                 </a:solidFill>
               </a:rPr>
-              <a:t>Robo-Advisory</a:t>
+              <a:t>backward fill</a:t>
             </a:r>
             <a:pPr indent="0" marL="0">
               <a:buNone/>
@@ -12364,14 +12547,13 @@
                   <a:srgbClr val="333333"/>
                 </a:solidFill>
               </a:rPr>
-              <a:t> institusional.</a:t>
+              <a:t>) memang menciptakan rentetan nilai harga yang statis.</a:t>
             </a:r>
             <a:endParaRPr lang="en-US" sz="1800" dirty="0"/>
           </a:p>
           <a:p>
-            <a:pPr marL="342900" indent="-342900">
-              <a:buSzPct val="100000"/>
-              <a:buChar char="•"/>
+            <a:pPr indent="0" marL="0">
+              <a:buNone/>
             </a:pPr>
             <a:r>
               <a:rPr lang="en-US" sz="1800" dirty="0">
@@ -12379,7 +12561,7 @@
                   <a:srgbClr val="333333"/>
                 </a:solidFill>
               </a:rPr>
-              <a:t>Ketika pasar anjlok ekstrem, investor akan melarikan senjatanya ke posisi </a:t>
+              <a:t>   2. Namun, kehebatan </a:t>
             </a:r>
             <a:pPr indent="0" marL="0">
               <a:buNone/>
@@ -12390,7 +12572,7 @@
                   <a:srgbClr val="333333"/>
                 </a:solidFill>
               </a:rPr>
-              <a:t>tunai (USDT)</a:t>
+              <a:t>Random Matrix Theory (RMT)</a:t>
             </a:r>
             <a:pPr indent="0" marL="0">
               <a:buNone/>
@@ -12401,7 +12583,79 @@
                   <a:srgbClr val="333333"/>
                 </a:solidFill>
               </a:rPr>
-              <a:t> sebagai evakuasi risiko.</a:t>
+              <a:t> diuji di sini! Karena data yang datar sama sekali tidak punya korelasi nyata.</a:t>
+            </a:r>
+            <a:endParaRPr lang="en-US" sz="1800" dirty="0"/>
+          </a:p>
+          <a:p>
+            <a:pPr indent="0" marL="0">
+              <a:buNone/>
+            </a:pPr>
+            <a:r>
+              <a:rPr lang="en-US" sz="1800" dirty="0">
+                <a:solidFill>
+                  <a:srgbClr val="333333"/>
+                </a:solidFill>
+              </a:rPr>
+              <a:t>   3. RMT otomatis akan mendeteksi korelasi buatan tersebut sebagai probabilitas </a:t>
+            </a:r>
+            <a:pPr indent="0" marL="0">
+              <a:buNone/>
+            </a:pPr>
+            <a:r>
+              <a:rPr lang="en-US" sz="1800" b="1" i="1" dirty="0">
+                <a:solidFill>
+                  <a:srgbClr val="333333"/>
+                </a:solidFill>
+              </a:rPr>
+              <a:t>Noise Acak</a:t>
+            </a:r>
+            <a:pPr indent="0" marL="0">
+              <a:buNone/>
+            </a:pPr>
+            <a:r>
+              <a:rPr lang="en-US" sz="1800" dirty="0">
+                <a:solidFill>
+                  <a:srgbClr val="333333"/>
+                </a:solidFill>
+              </a:rPr>
+              <a:t>, lalu membuangnya menjadi 0.</a:t>
+            </a:r>
+            <a:endParaRPr lang="en-US" sz="1800" dirty="0"/>
+          </a:p>
+          <a:p>
+            <a:pPr indent="0" marL="0">
+              <a:buNone/>
+            </a:pPr>
+            <a:r>
+              <a:rPr lang="en-US" sz="1800" dirty="0">
+                <a:solidFill>
+                  <a:srgbClr val="333333"/>
+                </a:solidFill>
+              </a:rPr>
+              <a:t>   4. Hasilnya, matriks korelasi </a:t>
+            </a:r>
+            <a:pPr indent="0" marL="0">
+              <a:buNone/>
+            </a:pPr>
+            <a:r>
+              <a:rPr lang="en-US" sz="1800" b="1" dirty="0">
+                <a:solidFill>
+                  <a:srgbClr val="333333"/>
+                </a:solidFill>
+              </a:rPr>
+              <a:t>terselamatkan</a:t>
+            </a:r>
+            <a:pPr indent="0" marL="0">
+              <a:buNone/>
+            </a:pPr>
+            <a:r>
+              <a:rPr lang="en-US" sz="1800" dirty="0">
+                <a:solidFill>
+                  <a:srgbClr val="333333"/>
+                </a:solidFill>
+              </a:rPr>
+              <a:t> dan tidak tercemar oleh cacat kelengkapan data.</a:t>
             </a:r>
             <a:endParaRPr lang="en-US" sz="1800" dirty="0"/>
           </a:p>
@@ -12462,7 +12716,7 @@
                   <a:srgbClr val="003366"/>
                 </a:solidFill>
               </a:rPr>
-              <a:t>Lampiran: Mengapa Menyertakan Tether (USDT)? (2/2)</a:t>
+              <a:t>Lampiran: Mengapa Menyertakan Tether (USDT)? (1/2)</a:t>
             </a:r>
             <a:endParaRPr lang="en-US" sz="2600" dirty="0"/>
           </a:p>
@@ -12493,12 +12747,89 @@
               <a:buNone/>
             </a:pPr>
             <a:r>
+              <a:rPr lang="en-US" sz="1800" b="1" dirty="0">
+                <a:solidFill>
+                  <a:srgbClr val="C0392B"/>
+                </a:solidFill>
+              </a:rPr>
+              <a:t>Pertanyaan: </a:t>
+            </a:r>
+            <a:pPr indent="0" marL="0">
+              <a:buNone/>
+            </a:pPr>
+            <a:r>
+              <a:rPr lang="en-US" sz="1800" i="1" dirty="0">
+                <a:solidFill>
+                  <a:srgbClr val="333333"/>
+                </a:solidFill>
+              </a:rPr>
+              <a:t>"Tether (USDT) itu stablecoin yang nilainya selalu fix ke 1 USD. Apakah tidak berbuat curang?"</a:t>
+            </a:r>
+            <a:endParaRPr lang="en-US" sz="1800" dirty="0"/>
+          </a:p>
+          <a:p>
+            <a:pPr indent="0" marL="0">
+              <a:buNone/>
+            </a:pPr>
+            <a:r>
+              <a:rPr lang="en-US" sz="1800" b="1" dirty="0">
+                <a:solidFill>
+                  <a:srgbClr val="27AE60"/>
+                </a:solidFill>
+              </a:rPr>
+              <a:t>Jawaban (Dinamika Portofolio Cerdas):</a:t>
+            </a:r>
+            <a:endParaRPr lang="en-US" sz="1800" dirty="0"/>
+          </a:p>
+          <a:p>
+            <a:pPr marL="342900" indent="-342900">
+              <a:buSzPct val="100000"/>
+              <a:buChar char="•"/>
+            </a:pPr>
+            <a:r>
               <a:rPr lang="en-US" sz="1800" dirty="0">
                 <a:solidFill>
                   <a:srgbClr val="333333"/>
                 </a:solidFill>
               </a:rPr>
-              <a:t>3. Algoritma jaringan </a:t>
+              <a:t>Model ini mensimulasikan perilaku </a:t>
+            </a:r>
+            <a:pPr indent="0" marL="0">
+              <a:buNone/>
+            </a:pPr>
+            <a:r>
+              <a:rPr lang="en-US" sz="1800" b="1" i="1" dirty="0">
+                <a:solidFill>
+                  <a:srgbClr val="333333"/>
+                </a:solidFill>
+              </a:rPr>
+              <a:t>Robo-Advisory</a:t>
+            </a:r>
+            <a:pPr indent="0" marL="0">
+              <a:buNone/>
+            </a:pPr>
+            <a:r>
+              <a:rPr lang="en-US" sz="1800" dirty="0">
+                <a:solidFill>
+                  <a:srgbClr val="333333"/>
+                </a:solidFill>
+              </a:rPr>
+              <a:t> institusional.</a:t>
+            </a:r>
+            <a:endParaRPr lang="en-US" sz="1800" dirty="0"/>
+          </a:p>
+          <a:p>
+            <a:pPr marL="342900" indent="-342900">
+              <a:buSzPct val="100000"/>
+              <a:buChar char="•"/>
+            </a:pPr>
+            <a:r>
+              <a:rPr lang="en-US" sz="1800" dirty="0">
+                <a:solidFill>
+                  <a:srgbClr val="333333"/>
+                </a:solidFill>
+              </a:rPr>
+              <a:t>Ketika pasar anjlok ekstrem, investor akan melarikan senjatanya ke posisi </a:t>
             </a:r>
             <a:pPr indent="0" marL="0">
               <a:buNone/>
@@ -12509,7 +12840,7 @@
                   <a:srgbClr val="333333"/>
                 </a:solidFill>
               </a:rPr>
-              <a:t>Network Markowitz GS (Grid Search)</a:t>
+              <a:t>tunai (USDT)</a:t>
             </a:r>
             <a:pPr indent="0" marL="0">
               <a:buNone/>
@@ -12520,87 +12851,7 @@
                   <a:srgbClr val="333333"/>
                 </a:solidFill>
               </a:rPr>
-              <a:t> dilatih secara matematis; jika mendeteksi korelasi ancaman kolaps merambat ke semua altcoin, ia akan melempar alokasi modalnya menuju node </a:t>
-            </a:r>
-            <a:pPr indent="0" marL="0">
-              <a:buNone/>
-            </a:pPr>
-            <a:r>
-              <a:rPr lang="en-US" sz="1800" b="1" dirty="0">
-                <a:solidFill>
-                  <a:srgbClr val="333333"/>
-                </a:solidFill>
-              </a:rPr>
-              <a:t>USDT (Tether)</a:t>
-            </a:r>
-            <a:pPr indent="0" marL="0">
-              <a:buNone/>
-            </a:pPr>
-            <a:r>
-              <a:rPr lang="en-US" sz="1800" dirty="0">
-                <a:solidFill>
-                  <a:srgbClr val="333333"/>
-                </a:solidFill>
-              </a:rPr>
-              <a:t> sebagai langkah </a:t>
-            </a:r>
-            <a:pPr indent="0" marL="0">
-              <a:buNone/>
-            </a:pPr>
-            <a:r>
-              <a:rPr lang="en-US" sz="1800" b="1" dirty="0">
-                <a:solidFill>
-                  <a:srgbClr val="333333"/>
-                </a:solidFill>
-              </a:rPr>
-              <a:t>evakuasi otomatis</a:t>
-            </a:r>
-            <a:pPr indent="0" marL="0">
-              <a:buNone/>
-            </a:pPr>
-            <a:r>
-              <a:rPr lang="en-US" sz="1800" dirty="0">
-                <a:solidFill>
-                  <a:srgbClr val="333333"/>
-                </a:solidFill>
-              </a:rPr>
-              <a:t> (Shock-Absorber).</a:t>
-            </a:r>
-            <a:endParaRPr lang="en-US" sz="1800" dirty="0"/>
-          </a:p>
-          <a:p>
-            <a:pPr indent="0" marL="0">
-              <a:buNone/>
-            </a:pPr>
-            <a:r>
-              <a:rPr lang="en-US" sz="1800" dirty="0">
-                <a:solidFill>
-                  <a:srgbClr val="333333"/>
-                </a:solidFill>
-              </a:rPr>
-              <a:t>   4. Hal ini yang membuat performa Risk-GS (Grid Search) sangat </a:t>
-            </a:r>
-            <a:pPr indent="0" marL="0">
-              <a:buNone/>
-            </a:pPr>
-            <a:r>
-              <a:rPr lang="en-US" sz="1800" b="1" dirty="0">
-                <a:solidFill>
-                  <a:srgbClr val="333333"/>
-                </a:solidFill>
-              </a:rPr>
-              <a:t>tangguh</a:t>
-            </a:r>
-            <a:pPr indent="0" marL="0">
-              <a:buNone/>
-            </a:pPr>
-            <a:r>
-              <a:rPr lang="en-US" sz="1800" dirty="0">
-                <a:solidFill>
-                  <a:srgbClr val="333333"/>
-                </a:solidFill>
-              </a:rPr>
-              <a:t> dari serangan Crypto Winter, suatu kapabilitas pertahanan yang tidak dipahami oleh model ortodoks murni Markowitz.</a:t>
+              <a:t> sebagai evakuasi risiko.</a:t>
             </a:r>
             <a:endParaRPr lang="en-US" sz="1800" dirty="0"/>
           </a:p>
@@ -12661,7 +12912,7 @@
                   <a:srgbClr val="003366"/>
                 </a:solidFill>
               </a:rPr>
-              <a:t>Lampiran: Bukti Empiris Non-Stationarity Pasar</a:t>
+              <a:t>Lampiran: Mengapa Menyertakan Tether (USDT)? (2/2)</a:t>
             </a:r>
             <a:endParaRPr lang="en-US" sz="2600" dirty="0"/>
           </a:p>
@@ -12692,23 +12943,78 @@
               <a:buNone/>
             </a:pPr>
             <a:r>
+              <a:rPr lang="en-US" sz="1800" dirty="0">
+                <a:solidFill>
+                  <a:srgbClr val="333333"/>
+                </a:solidFill>
+              </a:rPr>
+              <a:t>3. Algoritma jaringan </a:t>
+            </a:r>
+            <a:pPr indent="0" marL="0">
+              <a:buNone/>
+            </a:pPr>
+            <a:r>
               <a:rPr lang="en-US" sz="1800" b="1" dirty="0">
                 <a:solidFill>
-                  <a:srgbClr val="C0392B"/>
-                </a:solidFill>
-              </a:rPr>
-              <a:t>Masalah: </a:t>
-            </a:r>
-            <a:pPr indent="0" marL="0">
-              <a:buNone/>
-            </a:pPr>
-            <a:r>
-              <a:rPr lang="en-US" sz="1800" i="1" dirty="0">
-                <a:solidFill>
-                  <a:srgbClr val="333333"/>
-                </a:solidFill>
-              </a:rPr>
-              <a:t>Kenapa harus menggunakan model Adaptif (Dynamic Gamma)?</a:t>
+                  <a:srgbClr val="333333"/>
+                </a:solidFill>
+              </a:rPr>
+              <a:t>Network Markowitz GS (Grid Search)</a:t>
+            </a:r>
+            <a:pPr indent="0" marL="0">
+              <a:buNone/>
+            </a:pPr>
+            <a:r>
+              <a:rPr lang="en-US" sz="1800" dirty="0">
+                <a:solidFill>
+                  <a:srgbClr val="333333"/>
+                </a:solidFill>
+              </a:rPr>
+              <a:t> dilatih secara matematis; jika mendeteksi korelasi ancaman kolaps merambat ke semua altcoin, ia akan melempar alokasi modalnya menuju node </a:t>
+            </a:r>
+            <a:pPr indent="0" marL="0">
+              <a:buNone/>
+            </a:pPr>
+            <a:r>
+              <a:rPr lang="en-US" sz="1800" b="1" dirty="0">
+                <a:solidFill>
+                  <a:srgbClr val="333333"/>
+                </a:solidFill>
+              </a:rPr>
+              <a:t>USDT (Tether)</a:t>
+            </a:r>
+            <a:pPr indent="0" marL="0">
+              <a:buNone/>
+            </a:pPr>
+            <a:r>
+              <a:rPr lang="en-US" sz="1800" dirty="0">
+                <a:solidFill>
+                  <a:srgbClr val="333333"/>
+                </a:solidFill>
+              </a:rPr>
+              <a:t> sebagai langkah </a:t>
+            </a:r>
+            <a:pPr indent="0" marL="0">
+              <a:buNone/>
+            </a:pPr>
+            <a:r>
+              <a:rPr lang="en-US" sz="1800" b="1" dirty="0">
+                <a:solidFill>
+                  <a:srgbClr val="333333"/>
+                </a:solidFill>
+              </a:rPr>
+              <a:t>evakuasi otomatis</a:t>
+            </a:r>
+            <a:pPr indent="0" marL="0">
+              <a:buNone/>
+            </a:pPr>
+            <a:r>
+              <a:rPr lang="en-US" sz="1800" dirty="0">
+                <a:solidFill>
+                  <a:srgbClr val="333333"/>
+                </a:solidFill>
+              </a:rPr>
+              <a:t> (Shock-Absorber).</a:t>
             </a:r>
             <a:endParaRPr lang="en-US" sz="1800" dirty="0"/>
           </a:p>
@@ -12717,19 +13023,26 @@
               <a:buNone/>
             </a:pPr>
             <a:r>
+              <a:rPr lang="en-US" sz="1800" dirty="0">
+                <a:solidFill>
+                  <a:srgbClr val="333333"/>
+                </a:solidFill>
+              </a:rPr>
+              <a:t>   4. Hal ini yang membuat performa Risk-GS (Grid Search) sangat </a:t>
+            </a:r>
+            <a:pPr indent="0" marL="0">
+              <a:buNone/>
+            </a:pPr>
+            <a:r>
               <a:rPr lang="en-US" sz="1800" b="1" dirty="0">
                 <a:solidFill>
-                  <a:srgbClr val="27AE60"/>
-                </a:solidFill>
-              </a:rPr>
-              <a:t>Bukti dari Grid Search:</a:t>
-            </a:r>
-            <a:endParaRPr lang="en-US" sz="1800" dirty="0"/>
-          </a:p>
-          <a:p>
-            <a:pPr marL="342900" indent="-342900">
-              <a:buSzPct val="100000"/>
-              <a:buChar char="•"/>
+                  <a:srgbClr val="333333"/>
+                </a:solidFill>
+              </a:rPr>
+              <a:t>tangguh</a:t>
+            </a:r>
+            <a:pPr indent="0" marL="0">
+              <a:buNone/>
             </a:pPr>
             <a:r>
               <a:rPr lang="en-US" sz="1800" dirty="0">
@@ -12737,103 +13050,7 @@
                   <a:srgbClr val="333333"/>
                 </a:solidFill>
               </a:rPr>
-              <a:t>Data menunjukkan nilai Gamma (γ) optimal </a:t>
-            </a:r>
-            <a:pPr indent="0" marL="0">
-              <a:buNone/>
-            </a:pPr>
-            <a:r>
-              <a:rPr lang="en-US" sz="1800" b="1" dirty="0">
-                <a:solidFill>
-                  <a:srgbClr val="333333"/>
-                </a:solidFill>
-              </a:rPr>
-              <a:t>terus bergeser</a:t>
-            </a:r>
-            <a:pPr indent="0" marL="0">
-              <a:buNone/>
-            </a:pPr>
-            <a:r>
-              <a:rPr lang="en-US" sz="1800" dirty="0">
-                <a:solidFill>
-                  <a:srgbClr val="333333"/>
-                </a:solidFill>
-              </a:rPr>
-              <a:t> setiap periode rebalancing.</a:t>
-            </a:r>
-            <a:endParaRPr lang="en-US" sz="1800" dirty="0"/>
-          </a:p>
-          <a:p>
-            <a:pPr marL="342900" indent="-342900">
-              <a:buSzPct val="100000"/>
-              <a:buChar char="•"/>
-            </a:pPr>
-            <a:r>
-              <a:rPr lang="en-US" sz="1800" dirty="0">
-                <a:solidFill>
-                  <a:srgbClr val="333333"/>
-                </a:solidFill>
-              </a:rPr>
-              <a:t>Penggunaan γ statis tidak cukup untuk menangkap perubahan </a:t>
-            </a:r>
-            <a:pPr indent="0" marL="0">
-              <a:buNone/>
-            </a:pPr>
-            <a:r>
-              <a:rPr lang="en-US" sz="1800" b="1" dirty="0">
-                <a:solidFill>
-                  <a:srgbClr val="333333"/>
-                </a:solidFill>
-              </a:rPr>
-              <a:t>struktur korelasi</a:t>
-            </a:r>
-            <a:pPr indent="0" marL="0">
-              <a:buNone/>
-            </a:pPr>
-            <a:r>
-              <a:rPr lang="en-US" sz="1800" dirty="0">
-                <a:solidFill>
-                  <a:srgbClr val="333333"/>
-                </a:solidFill>
-              </a:rPr>
-              <a:t> yang sangat cepat di pasar kripto.</a:t>
-            </a:r>
-            <a:endParaRPr lang="en-US" sz="1800" dirty="0"/>
-          </a:p>
-          <a:p>
-            <a:pPr marL="342900" indent="-342900">
-              <a:buSzPct val="100000"/>
-              <a:buChar char="•"/>
-            </a:pPr>
-            <a:r>
-              <a:rPr lang="en-US" sz="1800" dirty="0">
-                <a:solidFill>
-                  <a:srgbClr val="333333"/>
-                </a:solidFill>
-              </a:rPr>
-              <a:t>Ini membenarkan bahwa pasar kripto membutuhkan </a:t>
-            </a:r>
-            <a:pPr indent="0" marL="0">
-              <a:buNone/>
-            </a:pPr>
-            <a:r>
-              <a:rPr lang="en-US" sz="1800" b="1" dirty="0">
-                <a:solidFill>
-                  <a:srgbClr val="333333"/>
-                </a:solidFill>
-              </a:rPr>
-              <a:t>kalibrasi otomatis</a:t>
-            </a:r>
-            <a:pPr indent="0" marL="0">
-              <a:buNone/>
-            </a:pPr>
-            <a:r>
-              <a:rPr lang="en-US" sz="1800" dirty="0">
-                <a:solidFill>
-                  <a:srgbClr val="333333"/>
-                </a:solidFill>
-              </a:rPr>
-              <a:t> secara temporal.</a:t>
+              <a:t> dari serangan Crypto Winter, suatu kapabilitas pertahanan yang tidak dipahami oleh model ortodoks murni Markowitz.</a:t>
             </a:r>
             <a:endParaRPr lang="en-US" sz="1800" dirty="0"/>
           </a:p>
@@ -13199,6 +13416,239 @@
 <file path=ppt/slides/slide40.xml><?xml version="1.0" encoding="utf-8"?>
 <p:sld xmlns:a="http://schemas.openxmlformats.org/drawingml/2006/main" xmlns:r="http://schemas.openxmlformats.org/officeDocument/2006/relationships" xmlns:p="http://schemas.openxmlformats.org/presentationml/2006/main">
   <p:cSld name="Slide 40">
+    <p:spTree>
+      <p:nvGrpSpPr>
+        <p:cNvPr id="1" name=""/>
+        <p:cNvGrpSpPr/>
+        <p:nvPr/>
+      </p:nvGrpSpPr>
+      <p:grpSpPr>
+        <a:xfrm>
+          <a:off x="0" y="0"/>
+          <a:ext cx="0" cy="0"/>
+          <a:chOff x="0" y="0"/>
+          <a:chExt cx="0" cy="0"/>
+        </a:xfrm>
+      </p:grpSpPr>
+      <p:sp>
+        <p:nvSpPr>
+          <p:cNvPr id="2" name="Text 0"/>
+          <p:cNvSpPr/>
+          <p:nvPr/>
+        </p:nvSpPr>
+        <p:spPr>
+          <a:xfrm>
+            <a:off x="457200" y="457200"/>
+            <a:ext cx="8229600" cy="0"/>
+          </a:xfrm>
+          <a:prstGeom prst="rect">
+            <a:avLst/>
+          </a:prstGeom>
+          <a:noFill/>
+          <a:ln/>
+        </p:spPr>
+        <p:txBody>
+          <a:bodyPr wrap="square" rtlCol="0" anchor="ctr"/>
+          <a:lstStyle/>
+          <a:p>
+            <a:pPr indent="0" marL="0">
+              <a:buNone/>
+            </a:pPr>
+            <a:r>
+              <a:rPr lang="en-US" sz="2600" b="1" dirty="0">
+                <a:solidFill>
+                  <a:srgbClr val="003366"/>
+                </a:solidFill>
+              </a:rPr>
+              <a:t>Lampiran: Bukti Empiris Non-Stationarity Pasar</a:t>
+            </a:r>
+            <a:endParaRPr lang="en-US" sz="2600" dirty="0"/>
+          </a:p>
+        </p:txBody>
+      </p:sp>
+      <p:sp>
+        <p:nvSpPr>
+          <p:cNvPr id="3" name="Text 1"/>
+          <p:cNvSpPr/>
+          <p:nvPr/>
+        </p:nvSpPr>
+        <p:spPr>
+          <a:xfrm>
+            <a:off x="457200" y="1005840"/>
+            <a:ext cx="8229600" cy="5029200"/>
+          </a:xfrm>
+          <a:prstGeom prst="rect">
+            <a:avLst/>
+          </a:prstGeom>
+          <a:noFill/>
+          <a:ln/>
+        </p:spPr>
+        <p:txBody>
+          <a:bodyPr wrap="square" rtlCol="0" anchor="t"/>
+          <a:lstStyle/>
+          <a:p>
+            <a:pPr indent="0" marL="0">
+              <a:buNone/>
+            </a:pPr>
+            <a:r>
+              <a:rPr lang="en-US" sz="1800" b="1" dirty="0">
+                <a:solidFill>
+                  <a:srgbClr val="C0392B"/>
+                </a:solidFill>
+              </a:rPr>
+              <a:t>Masalah: </a:t>
+            </a:r>
+            <a:pPr indent="0" marL="0">
+              <a:buNone/>
+            </a:pPr>
+            <a:r>
+              <a:rPr lang="en-US" sz="1800" i="1" dirty="0">
+                <a:solidFill>
+                  <a:srgbClr val="333333"/>
+                </a:solidFill>
+              </a:rPr>
+              <a:t>Kenapa harus menggunakan model Adaptif (Dynamic Gamma)?</a:t>
+            </a:r>
+            <a:endParaRPr lang="en-US" sz="1800" dirty="0"/>
+          </a:p>
+          <a:p>
+            <a:pPr indent="0" marL="0">
+              <a:buNone/>
+            </a:pPr>
+            <a:r>
+              <a:rPr lang="en-US" sz="1800" b="1" dirty="0">
+                <a:solidFill>
+                  <a:srgbClr val="27AE60"/>
+                </a:solidFill>
+              </a:rPr>
+              <a:t>Bukti dari Grid Search:</a:t>
+            </a:r>
+            <a:endParaRPr lang="en-US" sz="1800" dirty="0"/>
+          </a:p>
+          <a:p>
+            <a:pPr marL="342900" indent="-342900">
+              <a:buSzPct val="100000"/>
+              <a:buChar char="•"/>
+            </a:pPr>
+            <a:r>
+              <a:rPr lang="en-US" sz="1800" dirty="0">
+                <a:solidFill>
+                  <a:srgbClr val="333333"/>
+                </a:solidFill>
+              </a:rPr>
+              <a:t>Data menunjukkan nilai Gamma (γ) optimal </a:t>
+            </a:r>
+            <a:pPr indent="0" marL="0">
+              <a:buNone/>
+            </a:pPr>
+            <a:r>
+              <a:rPr lang="en-US" sz="1800" b="1" dirty="0">
+                <a:solidFill>
+                  <a:srgbClr val="333333"/>
+                </a:solidFill>
+              </a:rPr>
+              <a:t>terus bergeser</a:t>
+            </a:r>
+            <a:pPr indent="0" marL="0">
+              <a:buNone/>
+            </a:pPr>
+            <a:r>
+              <a:rPr lang="en-US" sz="1800" dirty="0">
+                <a:solidFill>
+                  <a:srgbClr val="333333"/>
+                </a:solidFill>
+              </a:rPr>
+              <a:t> setiap periode rebalancing.</a:t>
+            </a:r>
+            <a:endParaRPr lang="en-US" sz="1800" dirty="0"/>
+          </a:p>
+          <a:p>
+            <a:pPr marL="342900" indent="-342900">
+              <a:buSzPct val="100000"/>
+              <a:buChar char="•"/>
+            </a:pPr>
+            <a:r>
+              <a:rPr lang="en-US" sz="1800" dirty="0">
+                <a:solidFill>
+                  <a:srgbClr val="333333"/>
+                </a:solidFill>
+              </a:rPr>
+              <a:t>Penggunaan γ statis tidak cukup untuk menangkap perubahan </a:t>
+            </a:r>
+            <a:pPr indent="0" marL="0">
+              <a:buNone/>
+            </a:pPr>
+            <a:r>
+              <a:rPr lang="en-US" sz="1800" b="1" dirty="0">
+                <a:solidFill>
+                  <a:srgbClr val="333333"/>
+                </a:solidFill>
+              </a:rPr>
+              <a:t>struktur korelasi</a:t>
+            </a:r>
+            <a:pPr indent="0" marL="0">
+              <a:buNone/>
+            </a:pPr>
+            <a:r>
+              <a:rPr lang="en-US" sz="1800" dirty="0">
+                <a:solidFill>
+                  <a:srgbClr val="333333"/>
+                </a:solidFill>
+              </a:rPr>
+              <a:t> yang sangat cepat di pasar kripto.</a:t>
+            </a:r>
+            <a:endParaRPr lang="en-US" sz="1800" dirty="0"/>
+          </a:p>
+          <a:p>
+            <a:pPr marL="342900" indent="-342900">
+              <a:buSzPct val="100000"/>
+              <a:buChar char="•"/>
+            </a:pPr>
+            <a:r>
+              <a:rPr lang="en-US" sz="1800" dirty="0">
+                <a:solidFill>
+                  <a:srgbClr val="333333"/>
+                </a:solidFill>
+              </a:rPr>
+              <a:t>Ini membenarkan bahwa pasar kripto membutuhkan </a:t>
+            </a:r>
+            <a:pPr indent="0" marL="0">
+              <a:buNone/>
+            </a:pPr>
+            <a:r>
+              <a:rPr lang="en-US" sz="1800" b="1" dirty="0">
+                <a:solidFill>
+                  <a:srgbClr val="333333"/>
+                </a:solidFill>
+              </a:rPr>
+              <a:t>kalibrasi otomatis</a:t>
+            </a:r>
+            <a:pPr indent="0" marL="0">
+              <a:buNone/>
+            </a:pPr>
+            <a:r>
+              <a:rPr lang="en-US" sz="1800" dirty="0">
+                <a:solidFill>
+                  <a:srgbClr val="333333"/>
+                </a:solidFill>
+              </a:rPr>
+              <a:t> secara temporal.</a:t>
+            </a:r>
+            <a:endParaRPr lang="en-US" sz="1800" dirty="0"/>
+          </a:p>
+        </p:txBody>
+      </p:sp>
+    </p:spTree>
+  </p:cSld>
+  <p:clrMapOvr>
+    <a:masterClrMapping/>
+  </p:clrMapOvr>
+</p:sld>
+</file>
+
+<file path=ppt/slides/slide41.xml><?xml version="1.0" encoding="utf-8"?>
+<p:sld xmlns:a="http://schemas.openxmlformats.org/drawingml/2006/main" xmlns:r="http://schemas.openxmlformats.org/officeDocument/2006/relationships" xmlns:p="http://schemas.openxmlformats.org/presentationml/2006/main">
+  <p:cSld name="Slide 41">
     <p:spTree>
       <p:nvGrpSpPr>
         <p:cNvPr id="1" name=""/>

</xml_diff>

<commit_message>
feat: add NW vs CM correlation relationship clarification slide
</commit_message>
<xml_diff>
--- a/Presentasi_Proposal_Update.pptx
+++ b/Presentasi_Proposal_Update.pptx
@@ -46,9 +46,10 @@
     <p:sldId id="294" r:id="rId40"/>
     <p:sldId id="295" r:id="rId41"/>
     <p:sldId id="296" r:id="rId42"/>
+    <p:sldId id="297" r:id="rId43"/>
   </p:sldIdLst>
   <p:notesMasterIdLst>
-    <p:notesMasterId r:id="rId43"/>
+    <p:notesMasterId r:id="rId44"/>
   </p:notesMasterIdLst>
   <p:sldSz cx="9144000" cy="5143500"/>
   <p:notesSz cx="5143500" cy="9144000"/>
@@ -3646,6 +3647,94 @@
             <a:fld id="{F7021451-1387-4CA6-816F-3879F97B5CBC}" type="slidenum">
               <a:rPr lang="en-US"/>
               <a:t>41</a:t>
+            </a:fld>
+            <a:endParaRPr lang="en-US"/>
+          </a:p>
+        </p:txBody>
+      </p:sp>
+    </p:spTree>
+    <p:extLst>
+      <p:ext uri="{BB962C8B-B14F-4D97-AF65-F5344CB8AC3E}">
+        <p14:creationId xmlns:p14="http://schemas.microsoft.com/office/powerpoint/2010/main" val="1024086991"/>
+      </p:ext>
+    </p:extLst>
+  </p:cSld>
+  <p:clrMapOvr>
+    <a:masterClrMapping/>
+  </p:clrMapOvr>
+</p:notes>
+</file>
+
+<file path=ppt/notesSlides/notesSlide42.xml><?xml version="1.0" encoding="utf-8"?>
+<p:notes xmlns:a="http://schemas.openxmlformats.org/drawingml/2006/main" xmlns:r="http://schemas.openxmlformats.org/officeDocument/2006/relationships" xmlns:p="http://schemas.openxmlformats.org/presentationml/2006/main">
+  <p:cSld>
+    <p:spTree>
+      <p:nvGrpSpPr>
+        <p:cNvPr id="1" name=""/>
+        <p:cNvGrpSpPr/>
+        <p:nvPr/>
+      </p:nvGrpSpPr>
+      <p:grpSpPr>
+        <a:xfrm>
+          <a:off x="0" y="0"/>
+          <a:ext cx="0" cy="0"/>
+          <a:chOff x="0" y="0"/>
+          <a:chExt cx="0" cy="0"/>
+        </a:xfrm>
+      </p:grpSpPr>
+      <p:sp>
+        <p:nvSpPr>
+          <p:cNvPr id="2" name="Slide Image Placeholder 1"/>
+          <p:cNvSpPr>
+            <a:spLocks noGrp="1" noRot="1" noChangeAspect="1"/>
+          </p:cNvSpPr>
+          <p:nvPr>
+            <p:ph type="sldImg"/>
+          </p:nvPr>
+        </p:nvSpPr>
+        <p:spPr/>
+      </p:sp>
+      <p:sp>
+        <p:nvSpPr>
+          <p:cNvPr id="3" name="Notes Placeholder 2"/>
+          <p:cNvSpPr>
+            <a:spLocks noGrp="1"/>
+          </p:cNvSpPr>
+          <p:nvPr>
+            <p:ph type="body" idx="1"/>
+          </p:nvPr>
+        </p:nvSpPr>
+        <p:spPr/>
+        <p:txBody>
+          <a:bodyPr/>
+          <a:lstStyle/>
+          <a:p>
+            <a:r>
+              <a:rPr lang="en-US" dirty="0"/>
+              <a:t/>
+            </a:r>
+            <a:endParaRPr lang="en-US" dirty="0"/>
+          </a:p>
+        </p:txBody>
+      </p:sp>
+      <p:sp>
+        <p:nvSpPr>
+          <p:cNvPr id="4" name="Slide Number Placeholder 3"/>
+          <p:cNvSpPr>
+            <a:spLocks noGrp="1"/>
+          </p:cNvSpPr>
+          <p:nvPr>
+            <p:ph type="sldNum" sz="quarter" idx="10"/>
+          </p:nvPr>
+        </p:nvSpPr>
+        <p:spPr/>
+        <p:txBody>
+          <a:bodyPr/>
+          <a:lstStyle/>
+          <a:p>
+            <a:fld id="{F7021451-1387-4CA6-816F-3879F97B5CBC}" type="slidenum">
+              <a:rPr lang="en-US"/>
+              <a:t>42</a:t>
             </a:fld>
             <a:endParaRPr lang="en-US"/>
           </a:p>
@@ -12172,14 +12261,14 @@
               <a:buNone/>
             </a:pPr>
             <a:r>
-              <a:rPr lang="en-US" sz="2600" b="1" dirty="0">
+              <a:rPr lang="en-US" sz="2400" b="1" dirty="0">
                 <a:solidFill>
                   <a:srgbClr val="003366"/>
                 </a:solidFill>
               </a:rPr>
-              <a:t>Lampiran: Dua Tipe Pendekatan Grid Search</a:t>
-            </a:r>
-            <a:endParaRPr lang="en-US" sz="2600" dirty="0"/>
+              <a:t>Lampiran: NW vs CM - Hubungan dengan Korelasi</a:t>
+            </a:r>
+            <a:endParaRPr lang="en-US" sz="2400" dirty="0"/>
           </a:p>
         </p:txBody>
       </p:sp>
@@ -12210,10 +12299,10 @@
             <a:r>
               <a:rPr lang="en-US" sz="1800" b="1" dirty="0">
                 <a:solidFill>
-                  <a:srgbClr val="333333"/>
-                </a:solidFill>
-              </a:rPr>
-              <a:t>Dua Objektif Optimasi (Return vs Risk):</a:t>
+                  <a:srgbClr val="C0392B"/>
+                </a:solidFill>
+              </a:rPr>
+              <a:t>Pertanyaan Penting: Apakah NW mengesampingkan korelasi?</a:t>
             </a:r>
             <a:endParaRPr lang="en-US" sz="1800" dirty="0"/>
           </a:p>
@@ -12227,14 +12316,41 @@
                   <a:srgbClr val="27AE60"/>
                 </a:solidFill>
               </a:rPr>
-              <a:t>1. Network Markowitz dengan Target Return (NW - Return Grid Search):</a:t>
+              <a:t>Jawaban: TIDAK. NW justru menggunakan korelasi secara lebih cerdas.</a:t>
             </a:r>
             <a:endParaRPr lang="en-US" sz="1800" dirty="0"/>
           </a:p>
           <a:p>
-            <a:pPr marL="342900" indent="-342900">
-              <a:buSzPct val="100000"/>
-              <a:buChar char="•"/>
+            <a:pPr indent="0" marL="0">
+              <a:buNone/>
+            </a:pPr>
+            <a:r>
+              <a:rPr lang="en-US" sz="1800" b="1" dirty="0">
+                <a:solidFill>
+                  <a:srgbClr val="003366"/>
+                </a:solidFill>
+              </a:rPr>
+              <a:t>Perbandingan Alur Kerja:</a:t>
+            </a:r>
+            <a:endParaRPr lang="en-US" sz="1800" dirty="0"/>
+          </a:p>
+          <a:p>
+            <a:pPr indent="0" marL="0">
+              <a:buNone/>
+            </a:pPr>
+            <a:r>
+              <a:rPr lang="en-US" sz="1800" b="1" dirty="0">
+                <a:solidFill>
+                  <a:srgbClr val="333333"/>
+                </a:solidFill>
+              </a:rPr>
+              <a:t>❑ Classical Markowitz (CM):</a:t>
+            </a:r>
+            <a:endParaRPr lang="en-US" sz="1800" dirty="0"/>
+          </a:p>
+          <a:p>
+            <a:pPr indent="0" marL="0">
+              <a:buNone/>
             </a:pPr>
             <a:r>
               <a:rPr lang="en-US" sz="1800" dirty="0">
@@ -12242,8 +12358,11 @@
                   <a:srgbClr val="333333"/>
                 </a:solidFill>
               </a:rPr>
-              <a:t>Memaksimalkan capaian </a:t>
-            </a:r>
+              <a:t>   Korelasi Mentah → Matriks Kovarians → Bobot Portofolio.</a:t>
+            </a:r>
+            <a:endParaRPr lang="en-US" sz="1800" dirty="0"/>
+          </a:p>
+          <a:p>
             <a:pPr indent="0" marL="0">
               <a:buNone/>
             </a:pPr>
@@ -12253,8 +12372,11 @@
                   <a:srgbClr val="333333"/>
                 </a:solidFill>
               </a:rPr>
-              <a:t>imbal hasil</a:t>
-            </a:r>
+              <a:t>❑ Network Markowitz (NW):</a:t>
+            </a:r>
+            <a:endParaRPr lang="en-US" sz="1800" dirty="0"/>
+          </a:p>
+          <a:p>
             <a:pPr indent="0" marL="0">
               <a:buNone/>
             </a:pPr>
@@ -12264,14 +12386,35 @@
                   <a:srgbClr val="333333"/>
                 </a:solidFill>
               </a:rPr>
-              <a:t> portofolio.</a:t>
+              <a:t>   1. Korelasi Mentah → </a:t>
+            </a:r>
+            <a:pPr indent="0" marL="0">
+              <a:buNone/>
+            </a:pPr>
+            <a:r>
+              <a:rPr lang="en-US" sz="1800" b="1" dirty="0">
+                <a:solidFill>
+                  <a:srgbClr val="8E44AD"/>
+                </a:solidFill>
+              </a:rPr>
+              <a:t>Saring Noise (RMT)</a:t>
+            </a:r>
+            <a:pPr indent="0" marL="0">
+              <a:buNone/>
+            </a:pPr>
+            <a:r>
+              <a:rPr lang="en-US" sz="1800" dirty="0">
+                <a:solidFill>
+                  <a:srgbClr val="333333"/>
+                </a:solidFill>
+              </a:rPr>
+              <a:t> (Membersihkan korelasi palsu).</a:t>
             </a:r>
             <a:endParaRPr lang="en-US" sz="1800" dirty="0"/>
           </a:p>
           <a:p>
-            <a:pPr marL="342900" indent="-342900">
-              <a:buSzPct val="100000"/>
-              <a:buChar char="•"/>
+            <a:pPr indent="0" marL="0">
+              <a:buNone/>
             </a:pPr>
             <a:r>
               <a:rPr lang="en-US" sz="1800" dirty="0">
@@ -12279,7 +12422,7 @@
                   <a:srgbClr val="333333"/>
                 </a:solidFill>
               </a:rPr>
-              <a:t>Lebih Agresif untuk mengeksploitasi reli pada pasar </a:t>
+              <a:t>   2. Korelasi Bersih → </a:t>
             </a:r>
             <a:pPr indent="0" marL="0">
               <a:buNone/>
@@ -12287,10 +12430,10 @@
             <a:r>
               <a:rPr lang="en-US" sz="1800" b="1" dirty="0">
                 <a:solidFill>
-                  <a:srgbClr val="333333"/>
-                </a:solidFill>
-              </a:rPr>
-              <a:t>Bullish</a:t>
+                  <a:srgbClr val="8E44AD"/>
+                </a:solidFill>
+              </a:rPr>
+              <a:t>Bangun MST (Network)</a:t>
             </a:r>
             <a:pPr indent="0" marL="0">
               <a:buNone/>
@@ -12301,7 +12444,7 @@
                   <a:srgbClr val="333333"/>
                 </a:solidFill>
               </a:rPr>
-              <a:t>.</a:t>
+              <a:t> (Melihat peta hubungan antar koin).</a:t>
             </a:r>
             <a:endParaRPr lang="en-US" sz="1800" dirty="0"/>
           </a:p>
@@ -12310,19 +12453,40 @@
               <a:buNone/>
             </a:pPr>
             <a:r>
+              <a:rPr lang="en-US" sz="1800" dirty="0">
+                <a:solidFill>
+                  <a:srgbClr val="333333"/>
+                </a:solidFill>
+              </a:rPr>
+              <a:t>   3. Struktur Network → </a:t>
+            </a:r>
+            <a:pPr indent="0" marL="0">
+              <a:buNone/>
+            </a:pPr>
+            <a:r>
               <a:rPr lang="en-US" sz="1800" b="1" dirty="0">
                 <a:solidFill>
-                  <a:srgbClr val="C0392B"/>
-                </a:solidFill>
-              </a:rPr>
-              <a:t>2. Network Markowitz dengan Target Risiko (NW - Risk Grid Search):</a:t>
+                  <a:srgbClr val="8E44AD"/>
+                </a:solidFill>
+              </a:rPr>
+              <a:t>Penalty Centrality</a:t>
+            </a:r>
+            <a:pPr indent="0" marL="0">
+              <a:buNone/>
+            </a:pPr>
+            <a:r>
+              <a:rPr lang="en-US" sz="1800" dirty="0">
+                <a:solidFill>
+                  <a:srgbClr val="333333"/>
+                </a:solidFill>
+              </a:rPr>
+              <a:t> (Menimbang risiko penularan).</a:t>
             </a:r>
             <a:endParaRPr lang="en-US" sz="1800" dirty="0"/>
           </a:p>
           <a:p>
-            <a:pPr marL="342900" indent="-342900">
-              <a:buSzPct val="100000"/>
-              <a:buChar char="•"/>
+            <a:pPr indent="0" marL="0">
+              <a:buNone/>
             </a:pPr>
             <a:r>
               <a:rPr lang="en-US" sz="1800" dirty="0">
@@ -12330,66 +12494,35 @@
                   <a:srgbClr val="333333"/>
                 </a:solidFill>
               </a:rPr>
-              <a:t>Menekan parameter </a:t>
-            </a:r>
+              <a:t>   4. Gabungan → Optimasi Markowitz Akhir.</a:t>
+            </a:r>
+            <a:endParaRPr lang="en-US" sz="1800" dirty="0"/>
+          </a:p>
+          <a:p>
             <a:pPr indent="0" marL="0">
               <a:buNone/>
             </a:pPr>
             <a:r>
               <a:rPr lang="en-US" sz="1800" b="1" dirty="0">
                 <a:solidFill>
-                  <a:srgbClr val="333333"/>
-                </a:solidFill>
-              </a:rPr>
-              <a:t>risiko total</a:t>
-            </a:r>
-            <a:pPr indent="0" marL="0">
-              <a:buNone/>
-            </a:pPr>
-            <a:r>
-              <a:rPr lang="en-US" sz="1800" dirty="0">
-                <a:solidFill>
-                  <a:srgbClr val="333333"/>
-                </a:solidFill>
-              </a:rPr>
-              <a:t> hingga minimal.</a:t>
+                  <a:srgbClr val="2C3E50"/>
+                </a:solidFill>
+              </a:rPr>
+              <a:t>Kesimpulan:</a:t>
             </a:r>
             <a:endParaRPr lang="en-US" sz="1800" dirty="0"/>
           </a:p>
           <a:p>
-            <a:pPr marL="342900" indent="-342900">
-              <a:buSzPct val="100000"/>
-              <a:buChar char="•"/>
-            </a:pPr>
-            <a:r>
-              <a:rPr lang="en-US" sz="1800" dirty="0">
-                <a:solidFill>
-                  <a:srgbClr val="333333"/>
-                </a:solidFill>
-              </a:rPr>
-              <a:t>Lebih Defensif untuk meredam fluktuasi saat </a:t>
-            </a:r>
-            <a:pPr indent="0" marL="0">
-              <a:buNone/>
-            </a:pPr>
-            <a:r>
-              <a:rPr lang="en-US" sz="1800" b="1" dirty="0">
-                <a:solidFill>
-                  <a:srgbClr val="333333"/>
-                </a:solidFill>
-              </a:rPr>
-              <a:t>Crypto Winter</a:t>
-            </a:r>
-            <a:pPr indent="0" marL="0">
-              <a:buNone/>
-            </a:pPr>
-            <a:r>
-              <a:rPr lang="en-US" sz="1800" dirty="0">
-                <a:solidFill>
-                  <a:srgbClr val="333333"/>
-                </a:solidFill>
-              </a:rPr>
-              <a:t>.</a:t>
+            <a:pPr indent="0" marL="0">
+              <a:buNone/>
+            </a:pPr>
+            <a:r>
+              <a:rPr lang="en-US" sz="1800" i="1" dirty="0">
+                <a:solidFill>
+                  <a:srgbClr val="333333"/>
+                </a:solidFill>
+              </a:rPr>
+              <a:t>NW tidak membuang korelasi; ia 'mengolah' korelasi menjadi peta jaringan untuk mendeteksi risiko sistemik yang tidak terlihat oleh CM biasa.</a:t>
             </a:r>
             <a:endParaRPr lang="en-US" sz="1800" dirty="0"/>
           </a:p>
@@ -12450,7 +12583,7 @@
                   <a:srgbClr val="003366"/>
                 </a:solidFill>
               </a:rPr>
-              <a:t>Lampiran: Penanganan Data Kosong (Missing Values)</a:t>
+              <a:t>Lampiran: Dua Tipe Pendekatan Grid Search</a:t>
             </a:r>
             <a:endParaRPr lang="en-US" sz="2600" dirty="0"/>
           </a:p>
@@ -12483,41 +12616,156 @@
             <a:r>
               <a:rPr lang="en-US" sz="1800" b="1" dirty="0">
                 <a:solidFill>
+                  <a:srgbClr val="333333"/>
+                </a:solidFill>
+              </a:rPr>
+              <a:t>Dua Objektif Optimasi (Return vs Risk):</a:t>
+            </a:r>
+            <a:endParaRPr lang="en-US" sz="1800" dirty="0"/>
+          </a:p>
+          <a:p>
+            <a:pPr indent="0" marL="0">
+              <a:buNone/>
+            </a:pPr>
+            <a:r>
+              <a:rPr lang="en-US" sz="1800" b="1" dirty="0">
+                <a:solidFill>
+                  <a:srgbClr val="27AE60"/>
+                </a:solidFill>
+              </a:rPr>
+              <a:t>1. Network Markowitz dengan Target Return (NW - Return Grid Search):</a:t>
+            </a:r>
+            <a:endParaRPr lang="en-US" sz="1800" dirty="0"/>
+          </a:p>
+          <a:p>
+            <a:pPr marL="342900" indent="-342900">
+              <a:buSzPct val="100000"/>
+              <a:buChar char="•"/>
+            </a:pPr>
+            <a:r>
+              <a:rPr lang="en-US" sz="1800" dirty="0">
+                <a:solidFill>
+                  <a:srgbClr val="333333"/>
+                </a:solidFill>
+              </a:rPr>
+              <a:t>Memaksimalkan capaian </a:t>
+            </a:r>
+            <a:pPr indent="0" marL="0">
+              <a:buNone/>
+            </a:pPr>
+            <a:r>
+              <a:rPr lang="en-US" sz="1800" b="1" dirty="0">
+                <a:solidFill>
+                  <a:srgbClr val="333333"/>
+                </a:solidFill>
+              </a:rPr>
+              <a:t>imbal hasil</a:t>
+            </a:r>
+            <a:pPr indent="0" marL="0">
+              <a:buNone/>
+            </a:pPr>
+            <a:r>
+              <a:rPr lang="en-US" sz="1800" dirty="0">
+                <a:solidFill>
+                  <a:srgbClr val="333333"/>
+                </a:solidFill>
+              </a:rPr>
+              <a:t> portofolio.</a:t>
+            </a:r>
+            <a:endParaRPr lang="en-US" sz="1800" dirty="0"/>
+          </a:p>
+          <a:p>
+            <a:pPr marL="342900" indent="-342900">
+              <a:buSzPct val="100000"/>
+              <a:buChar char="•"/>
+            </a:pPr>
+            <a:r>
+              <a:rPr lang="en-US" sz="1800" dirty="0">
+                <a:solidFill>
+                  <a:srgbClr val="333333"/>
+                </a:solidFill>
+              </a:rPr>
+              <a:t>Lebih Agresif untuk mengeksploitasi reli pada pasar </a:t>
+            </a:r>
+            <a:pPr indent="0" marL="0">
+              <a:buNone/>
+            </a:pPr>
+            <a:r>
+              <a:rPr lang="en-US" sz="1800" b="1" dirty="0">
+                <a:solidFill>
+                  <a:srgbClr val="333333"/>
+                </a:solidFill>
+              </a:rPr>
+              <a:t>Bullish</a:t>
+            </a:r>
+            <a:pPr indent="0" marL="0">
+              <a:buNone/>
+            </a:pPr>
+            <a:r>
+              <a:rPr lang="en-US" sz="1800" dirty="0">
+                <a:solidFill>
+                  <a:srgbClr val="333333"/>
+                </a:solidFill>
+              </a:rPr>
+              <a:t>.</a:t>
+            </a:r>
+            <a:endParaRPr lang="en-US" sz="1800" dirty="0"/>
+          </a:p>
+          <a:p>
+            <a:pPr indent="0" marL="0">
+              <a:buNone/>
+            </a:pPr>
+            <a:r>
+              <a:rPr lang="en-US" sz="1800" b="1" dirty="0">
+                <a:solidFill>
                   <a:srgbClr val="C0392B"/>
                 </a:solidFill>
               </a:rPr>
-              <a:t>Pertanyaan: </a:t>
-            </a:r>
-            <a:pPr indent="0" marL="0">
-              <a:buNone/>
-            </a:pPr>
-            <a:r>
-              <a:rPr lang="en-US" sz="1800" i="1" dirty="0">
-                <a:solidFill>
-                  <a:srgbClr val="333333"/>
-                </a:solidFill>
-              </a:rPr>
-              <a:t>"Beberapa koin seperti Binance/EOS belum rilis di awal 2017 sehingga datanya kosong. Bukankah backward-fill memalsukan harga dan merusak matriks?"</a:t>
+              <a:t>2. Network Markowitz dengan Target Risiko (NW - Risk Grid Search):</a:t>
             </a:r>
             <a:endParaRPr lang="en-US" sz="1800" dirty="0"/>
           </a:p>
           <a:p>
+            <a:pPr marL="342900" indent="-342900">
+              <a:buSzPct val="100000"/>
+              <a:buChar char="•"/>
+            </a:pPr>
+            <a:r>
+              <a:rPr lang="en-US" sz="1800" dirty="0">
+                <a:solidFill>
+                  <a:srgbClr val="333333"/>
+                </a:solidFill>
+              </a:rPr>
+              <a:t>Menekan parameter </a:t>
+            </a:r>
             <a:pPr indent="0" marL="0">
               <a:buNone/>
             </a:pPr>
             <a:r>
               <a:rPr lang="en-US" sz="1800" b="1" dirty="0">
                 <a:solidFill>
-                  <a:srgbClr val="27AE60"/>
-                </a:solidFill>
-              </a:rPr>
-              <a:t>Jawaban (Kenapa RMT sangat Krusial):</a:t>
+                  <a:srgbClr val="333333"/>
+                </a:solidFill>
+              </a:rPr>
+              <a:t>risiko total</a:t>
+            </a:r>
+            <a:pPr indent="0" marL="0">
+              <a:buNone/>
+            </a:pPr>
+            <a:r>
+              <a:rPr lang="en-US" sz="1800" dirty="0">
+                <a:solidFill>
+                  <a:srgbClr val="333333"/>
+                </a:solidFill>
+              </a:rPr>
+              <a:t> hingga minimal.</a:t>
             </a:r>
             <a:endParaRPr lang="en-US" sz="1800" dirty="0"/>
           </a:p>
           <a:p>
-            <a:pPr indent="0" marL="0">
-              <a:buNone/>
+            <a:pPr marL="342900" indent="-342900">
+              <a:buSzPct val="100000"/>
+              <a:buChar char="•"/>
             </a:pPr>
             <a:r>
               <a:rPr lang="en-US" sz="1800" dirty="0">
@@ -12525,18 +12773,18 @@
                   <a:srgbClr val="333333"/>
                 </a:solidFill>
               </a:rPr>
-              <a:t>   1. Praktik pengisian data diam (</a:t>
-            </a:r>
-            <a:pPr indent="0" marL="0">
-              <a:buNone/>
-            </a:pPr>
-            <a:r>
-              <a:rPr lang="en-US" sz="1800" b="1" i="1" dirty="0">
-                <a:solidFill>
-                  <a:srgbClr val="333333"/>
-                </a:solidFill>
-              </a:rPr>
-              <a:t>backward fill</a:t>
+              <a:t>Lebih Defensif untuk meredam fluktuasi saat </a:t>
+            </a:r>
+            <a:pPr indent="0" marL="0">
+              <a:buNone/>
+            </a:pPr>
+            <a:r>
+              <a:rPr lang="en-US" sz="1800" b="1" dirty="0">
+                <a:solidFill>
+                  <a:srgbClr val="333333"/>
+                </a:solidFill>
+              </a:rPr>
+              <a:t>Crypto Winter</a:t>
             </a:r>
             <a:pPr indent="0" marL="0">
               <a:buNone/>
@@ -12547,115 +12795,7 @@
                   <a:srgbClr val="333333"/>
                 </a:solidFill>
               </a:rPr>
-              <a:t>) memang menciptakan rentetan nilai harga yang statis.</a:t>
-            </a:r>
-            <a:endParaRPr lang="en-US" sz="1800" dirty="0"/>
-          </a:p>
-          <a:p>
-            <a:pPr indent="0" marL="0">
-              <a:buNone/>
-            </a:pPr>
-            <a:r>
-              <a:rPr lang="en-US" sz="1800" dirty="0">
-                <a:solidFill>
-                  <a:srgbClr val="333333"/>
-                </a:solidFill>
-              </a:rPr>
-              <a:t>   2. Namun, kehebatan </a:t>
-            </a:r>
-            <a:pPr indent="0" marL="0">
-              <a:buNone/>
-            </a:pPr>
-            <a:r>
-              <a:rPr lang="en-US" sz="1800" b="1" dirty="0">
-                <a:solidFill>
-                  <a:srgbClr val="333333"/>
-                </a:solidFill>
-              </a:rPr>
-              <a:t>Random Matrix Theory (RMT)</a:t>
-            </a:r>
-            <a:pPr indent="0" marL="0">
-              <a:buNone/>
-            </a:pPr>
-            <a:r>
-              <a:rPr lang="en-US" sz="1800" dirty="0">
-                <a:solidFill>
-                  <a:srgbClr val="333333"/>
-                </a:solidFill>
-              </a:rPr>
-              <a:t> diuji di sini! Karena data yang datar sama sekali tidak punya korelasi nyata.</a:t>
-            </a:r>
-            <a:endParaRPr lang="en-US" sz="1800" dirty="0"/>
-          </a:p>
-          <a:p>
-            <a:pPr indent="0" marL="0">
-              <a:buNone/>
-            </a:pPr>
-            <a:r>
-              <a:rPr lang="en-US" sz="1800" dirty="0">
-                <a:solidFill>
-                  <a:srgbClr val="333333"/>
-                </a:solidFill>
-              </a:rPr>
-              <a:t>   3. RMT otomatis akan mendeteksi korelasi buatan tersebut sebagai probabilitas </a:t>
-            </a:r>
-            <a:pPr indent="0" marL="0">
-              <a:buNone/>
-            </a:pPr>
-            <a:r>
-              <a:rPr lang="en-US" sz="1800" b="1" i="1" dirty="0">
-                <a:solidFill>
-                  <a:srgbClr val="333333"/>
-                </a:solidFill>
-              </a:rPr>
-              <a:t>Noise Acak</a:t>
-            </a:r>
-            <a:pPr indent="0" marL="0">
-              <a:buNone/>
-            </a:pPr>
-            <a:r>
-              <a:rPr lang="en-US" sz="1800" dirty="0">
-                <a:solidFill>
-                  <a:srgbClr val="333333"/>
-                </a:solidFill>
-              </a:rPr>
-              <a:t>, lalu membuangnya menjadi 0.</a:t>
-            </a:r>
-            <a:endParaRPr lang="en-US" sz="1800" dirty="0"/>
-          </a:p>
-          <a:p>
-            <a:pPr indent="0" marL="0">
-              <a:buNone/>
-            </a:pPr>
-            <a:r>
-              <a:rPr lang="en-US" sz="1800" dirty="0">
-                <a:solidFill>
-                  <a:srgbClr val="333333"/>
-                </a:solidFill>
-              </a:rPr>
-              <a:t>   4. Hasilnya, matriks korelasi </a:t>
-            </a:r>
-            <a:pPr indent="0" marL="0">
-              <a:buNone/>
-            </a:pPr>
-            <a:r>
-              <a:rPr lang="en-US" sz="1800" b="1" dirty="0">
-                <a:solidFill>
-                  <a:srgbClr val="333333"/>
-                </a:solidFill>
-              </a:rPr>
-              <a:t>terselamatkan</a:t>
-            </a:r>
-            <a:pPr indent="0" marL="0">
-              <a:buNone/>
-            </a:pPr>
-            <a:r>
-              <a:rPr lang="en-US" sz="1800" dirty="0">
-                <a:solidFill>
-                  <a:srgbClr val="333333"/>
-                </a:solidFill>
-              </a:rPr>
-              <a:t> dan tidak tercemar oleh cacat kelengkapan data.</a:t>
+              <a:t>.</a:t>
             </a:r>
             <a:endParaRPr lang="en-US" sz="1800" dirty="0"/>
           </a:p>
@@ -12716,7 +12856,7 @@
                   <a:srgbClr val="003366"/>
                 </a:solidFill>
               </a:rPr>
-              <a:t>Lampiran: Mengapa Menyertakan Tether (USDT)? (1/2)</a:t>
+              <a:t>Lampiran: Penanganan Data Kosong (Missing Values)</a:t>
             </a:r>
             <a:endParaRPr lang="en-US" sz="2600" dirty="0"/>
           </a:p>
@@ -12763,7 +12903,7 @@
                   <a:srgbClr val="333333"/>
                 </a:solidFill>
               </a:rPr>
-              <a:t>"Tether (USDT) itu stablecoin yang nilainya selalu fix ke 1 USD. Apakah tidak berbuat curang?"</a:t>
+              <a:t>"Beberapa koin seperti Binance/EOS belum rilis di awal 2017 sehingga datanya kosong. Bukankah backward-fill memalsukan harga dan merusak matriks?"</a:t>
             </a:r>
             <a:endParaRPr lang="en-US" sz="1800" dirty="0"/>
           </a:p>
@@ -12777,14 +12917,13 @@
                   <a:srgbClr val="27AE60"/>
                 </a:solidFill>
               </a:rPr>
-              <a:t>Jawaban (Dinamika Portofolio Cerdas):</a:t>
+              <a:t>Jawaban (Kenapa RMT sangat Krusial):</a:t>
             </a:r>
             <a:endParaRPr lang="en-US" sz="1800" dirty="0"/>
           </a:p>
           <a:p>
-            <a:pPr marL="342900" indent="-342900">
-              <a:buSzPct val="100000"/>
-              <a:buChar char="•"/>
+            <a:pPr indent="0" marL="0">
+              <a:buNone/>
             </a:pPr>
             <a:r>
               <a:rPr lang="en-US" sz="1800" dirty="0">
@@ -12792,7 +12931,7 @@
                   <a:srgbClr val="333333"/>
                 </a:solidFill>
               </a:rPr>
-              <a:t>Model ini mensimulasikan perilaku </a:t>
+              <a:t>   1. Praktik pengisian data diam (</a:t>
             </a:r>
             <a:pPr indent="0" marL="0">
               <a:buNone/>
@@ -12803,7 +12942,7 @@
                   <a:srgbClr val="333333"/>
                 </a:solidFill>
               </a:rPr>
-              <a:t>Robo-Advisory</a:t>
+              <a:t>backward fill</a:t>
             </a:r>
             <a:pPr indent="0" marL="0">
               <a:buNone/>
@@ -12814,14 +12953,13 @@
                   <a:srgbClr val="333333"/>
                 </a:solidFill>
               </a:rPr>
-              <a:t> institusional.</a:t>
+              <a:t>) memang menciptakan rentetan nilai harga yang statis.</a:t>
             </a:r>
             <a:endParaRPr lang="en-US" sz="1800" dirty="0"/>
           </a:p>
           <a:p>
-            <a:pPr marL="342900" indent="-342900">
-              <a:buSzPct val="100000"/>
-              <a:buChar char="•"/>
+            <a:pPr indent="0" marL="0">
+              <a:buNone/>
             </a:pPr>
             <a:r>
               <a:rPr lang="en-US" sz="1800" dirty="0">
@@ -12829,7 +12967,7 @@
                   <a:srgbClr val="333333"/>
                 </a:solidFill>
               </a:rPr>
-              <a:t>Ketika pasar anjlok ekstrem, investor akan melarikan senjatanya ke posisi </a:t>
+              <a:t>   2. Namun, kehebatan </a:t>
             </a:r>
             <a:pPr indent="0" marL="0">
               <a:buNone/>
@@ -12840,7 +12978,7 @@
                   <a:srgbClr val="333333"/>
                 </a:solidFill>
               </a:rPr>
-              <a:t>tunai (USDT)</a:t>
+              <a:t>Random Matrix Theory (RMT)</a:t>
             </a:r>
             <a:pPr indent="0" marL="0">
               <a:buNone/>
@@ -12851,7 +12989,79 @@
                   <a:srgbClr val="333333"/>
                 </a:solidFill>
               </a:rPr>
-              <a:t> sebagai evakuasi risiko.</a:t>
+              <a:t> diuji di sini! Karena data yang datar sama sekali tidak punya korelasi nyata.</a:t>
+            </a:r>
+            <a:endParaRPr lang="en-US" sz="1800" dirty="0"/>
+          </a:p>
+          <a:p>
+            <a:pPr indent="0" marL="0">
+              <a:buNone/>
+            </a:pPr>
+            <a:r>
+              <a:rPr lang="en-US" sz="1800" dirty="0">
+                <a:solidFill>
+                  <a:srgbClr val="333333"/>
+                </a:solidFill>
+              </a:rPr>
+              <a:t>   3. RMT otomatis akan mendeteksi korelasi buatan tersebut sebagai probabilitas </a:t>
+            </a:r>
+            <a:pPr indent="0" marL="0">
+              <a:buNone/>
+            </a:pPr>
+            <a:r>
+              <a:rPr lang="en-US" sz="1800" b="1" i="1" dirty="0">
+                <a:solidFill>
+                  <a:srgbClr val="333333"/>
+                </a:solidFill>
+              </a:rPr>
+              <a:t>Noise Acak</a:t>
+            </a:r>
+            <a:pPr indent="0" marL="0">
+              <a:buNone/>
+            </a:pPr>
+            <a:r>
+              <a:rPr lang="en-US" sz="1800" dirty="0">
+                <a:solidFill>
+                  <a:srgbClr val="333333"/>
+                </a:solidFill>
+              </a:rPr>
+              <a:t>, lalu membuangnya menjadi 0.</a:t>
+            </a:r>
+            <a:endParaRPr lang="en-US" sz="1800" dirty="0"/>
+          </a:p>
+          <a:p>
+            <a:pPr indent="0" marL="0">
+              <a:buNone/>
+            </a:pPr>
+            <a:r>
+              <a:rPr lang="en-US" sz="1800" dirty="0">
+                <a:solidFill>
+                  <a:srgbClr val="333333"/>
+                </a:solidFill>
+              </a:rPr>
+              <a:t>   4. Hasilnya, matriks korelasi </a:t>
+            </a:r>
+            <a:pPr indent="0" marL="0">
+              <a:buNone/>
+            </a:pPr>
+            <a:r>
+              <a:rPr lang="en-US" sz="1800" b="1" dirty="0">
+                <a:solidFill>
+                  <a:srgbClr val="333333"/>
+                </a:solidFill>
+              </a:rPr>
+              <a:t>terselamatkan</a:t>
+            </a:r>
+            <a:pPr indent="0" marL="0">
+              <a:buNone/>
+            </a:pPr>
+            <a:r>
+              <a:rPr lang="en-US" sz="1800" dirty="0">
+                <a:solidFill>
+                  <a:srgbClr val="333333"/>
+                </a:solidFill>
+              </a:rPr>
+              <a:t> dan tidak tercemar oleh cacat kelengkapan data.</a:t>
             </a:r>
             <a:endParaRPr lang="en-US" sz="1800" dirty="0"/>
           </a:p>
@@ -12912,7 +13122,7 @@
                   <a:srgbClr val="003366"/>
                 </a:solidFill>
               </a:rPr>
-              <a:t>Lampiran: Mengapa Menyertakan Tether (USDT)? (2/2)</a:t>
+              <a:t>Lampiran: Mengapa Menyertakan Tether (USDT)? (1/2)</a:t>
             </a:r>
             <a:endParaRPr lang="en-US" sz="2600" dirty="0"/>
           </a:p>
@@ -12943,12 +13153,89 @@
               <a:buNone/>
             </a:pPr>
             <a:r>
+              <a:rPr lang="en-US" sz="1800" b="1" dirty="0">
+                <a:solidFill>
+                  <a:srgbClr val="C0392B"/>
+                </a:solidFill>
+              </a:rPr>
+              <a:t>Pertanyaan: </a:t>
+            </a:r>
+            <a:pPr indent="0" marL="0">
+              <a:buNone/>
+            </a:pPr>
+            <a:r>
+              <a:rPr lang="en-US" sz="1800" i="1" dirty="0">
+                <a:solidFill>
+                  <a:srgbClr val="333333"/>
+                </a:solidFill>
+              </a:rPr>
+              <a:t>"Tether (USDT) itu stablecoin yang nilainya selalu fix ke 1 USD. Apakah tidak berbuat curang?"</a:t>
+            </a:r>
+            <a:endParaRPr lang="en-US" sz="1800" dirty="0"/>
+          </a:p>
+          <a:p>
+            <a:pPr indent="0" marL="0">
+              <a:buNone/>
+            </a:pPr>
+            <a:r>
+              <a:rPr lang="en-US" sz="1800" b="1" dirty="0">
+                <a:solidFill>
+                  <a:srgbClr val="27AE60"/>
+                </a:solidFill>
+              </a:rPr>
+              <a:t>Jawaban (Dinamika Portofolio Cerdas):</a:t>
+            </a:r>
+            <a:endParaRPr lang="en-US" sz="1800" dirty="0"/>
+          </a:p>
+          <a:p>
+            <a:pPr marL="342900" indent="-342900">
+              <a:buSzPct val="100000"/>
+              <a:buChar char="•"/>
+            </a:pPr>
+            <a:r>
               <a:rPr lang="en-US" sz="1800" dirty="0">
                 <a:solidFill>
                   <a:srgbClr val="333333"/>
                 </a:solidFill>
               </a:rPr>
-              <a:t>3. Algoritma jaringan </a:t>
+              <a:t>Model ini mensimulasikan perilaku </a:t>
+            </a:r>
+            <a:pPr indent="0" marL="0">
+              <a:buNone/>
+            </a:pPr>
+            <a:r>
+              <a:rPr lang="en-US" sz="1800" b="1" i="1" dirty="0">
+                <a:solidFill>
+                  <a:srgbClr val="333333"/>
+                </a:solidFill>
+              </a:rPr>
+              <a:t>Robo-Advisory</a:t>
+            </a:r>
+            <a:pPr indent="0" marL="0">
+              <a:buNone/>
+            </a:pPr>
+            <a:r>
+              <a:rPr lang="en-US" sz="1800" dirty="0">
+                <a:solidFill>
+                  <a:srgbClr val="333333"/>
+                </a:solidFill>
+              </a:rPr>
+              <a:t> institusional.</a:t>
+            </a:r>
+            <a:endParaRPr lang="en-US" sz="1800" dirty="0"/>
+          </a:p>
+          <a:p>
+            <a:pPr marL="342900" indent="-342900">
+              <a:buSzPct val="100000"/>
+              <a:buChar char="•"/>
+            </a:pPr>
+            <a:r>
+              <a:rPr lang="en-US" sz="1800" dirty="0">
+                <a:solidFill>
+                  <a:srgbClr val="333333"/>
+                </a:solidFill>
+              </a:rPr>
+              <a:t>Ketika pasar anjlok ekstrem, investor akan melarikan senjatanya ke posisi </a:t>
             </a:r>
             <a:pPr indent="0" marL="0">
               <a:buNone/>
@@ -12959,7 +13246,7 @@
                   <a:srgbClr val="333333"/>
                 </a:solidFill>
               </a:rPr>
-              <a:t>Network Markowitz GS (Grid Search)</a:t>
+              <a:t>tunai (USDT)</a:t>
             </a:r>
             <a:pPr indent="0" marL="0">
               <a:buNone/>
@@ -12970,87 +13257,7 @@
                   <a:srgbClr val="333333"/>
                 </a:solidFill>
               </a:rPr>
-              <a:t> dilatih secara matematis; jika mendeteksi korelasi ancaman kolaps merambat ke semua altcoin, ia akan melempar alokasi modalnya menuju node </a:t>
-            </a:r>
-            <a:pPr indent="0" marL="0">
-              <a:buNone/>
-            </a:pPr>
-            <a:r>
-              <a:rPr lang="en-US" sz="1800" b="1" dirty="0">
-                <a:solidFill>
-                  <a:srgbClr val="333333"/>
-                </a:solidFill>
-              </a:rPr>
-              <a:t>USDT (Tether)</a:t>
-            </a:r>
-            <a:pPr indent="0" marL="0">
-              <a:buNone/>
-            </a:pPr>
-            <a:r>
-              <a:rPr lang="en-US" sz="1800" dirty="0">
-                <a:solidFill>
-                  <a:srgbClr val="333333"/>
-                </a:solidFill>
-              </a:rPr>
-              <a:t> sebagai langkah </a:t>
-            </a:r>
-            <a:pPr indent="0" marL="0">
-              <a:buNone/>
-            </a:pPr>
-            <a:r>
-              <a:rPr lang="en-US" sz="1800" b="1" dirty="0">
-                <a:solidFill>
-                  <a:srgbClr val="333333"/>
-                </a:solidFill>
-              </a:rPr>
-              <a:t>evakuasi otomatis</a:t>
-            </a:r>
-            <a:pPr indent="0" marL="0">
-              <a:buNone/>
-            </a:pPr>
-            <a:r>
-              <a:rPr lang="en-US" sz="1800" dirty="0">
-                <a:solidFill>
-                  <a:srgbClr val="333333"/>
-                </a:solidFill>
-              </a:rPr>
-              <a:t> (Shock-Absorber).</a:t>
-            </a:r>
-            <a:endParaRPr lang="en-US" sz="1800" dirty="0"/>
-          </a:p>
-          <a:p>
-            <a:pPr indent="0" marL="0">
-              <a:buNone/>
-            </a:pPr>
-            <a:r>
-              <a:rPr lang="en-US" sz="1800" dirty="0">
-                <a:solidFill>
-                  <a:srgbClr val="333333"/>
-                </a:solidFill>
-              </a:rPr>
-              <a:t>   4. Hal ini yang membuat performa Risk-GS (Grid Search) sangat </a:t>
-            </a:r>
-            <a:pPr indent="0" marL="0">
-              <a:buNone/>
-            </a:pPr>
-            <a:r>
-              <a:rPr lang="en-US" sz="1800" b="1" dirty="0">
-                <a:solidFill>
-                  <a:srgbClr val="333333"/>
-                </a:solidFill>
-              </a:rPr>
-              <a:t>tangguh</a:t>
-            </a:r>
-            <a:pPr indent="0" marL="0">
-              <a:buNone/>
-            </a:pPr>
-            <a:r>
-              <a:rPr lang="en-US" sz="1800" dirty="0">
-                <a:solidFill>
-                  <a:srgbClr val="333333"/>
-                </a:solidFill>
-              </a:rPr>
-              <a:t> dari serangan Crypto Winter, suatu kapabilitas pertahanan yang tidak dipahami oleh model ortodoks murni Markowitz.</a:t>
+              <a:t> sebagai evakuasi risiko.</a:t>
             </a:r>
             <a:endParaRPr lang="en-US" sz="1800" dirty="0"/>
           </a:p>
@@ -13460,7 +13667,7 @@
                   <a:srgbClr val="003366"/>
                 </a:solidFill>
               </a:rPr>
-              <a:t>Lampiran: Bukti Empiris Non-Stationarity Pasar</a:t>
+              <a:t>Lampiran: Mengapa Menyertakan Tether (USDT)? (2/2)</a:t>
             </a:r>
             <a:endParaRPr lang="en-US" sz="2600" dirty="0"/>
           </a:p>
@@ -13491,23 +13698,78 @@
               <a:buNone/>
             </a:pPr>
             <a:r>
+              <a:rPr lang="en-US" sz="1800" dirty="0">
+                <a:solidFill>
+                  <a:srgbClr val="333333"/>
+                </a:solidFill>
+              </a:rPr>
+              <a:t>3. Algoritma jaringan </a:t>
+            </a:r>
+            <a:pPr indent="0" marL="0">
+              <a:buNone/>
+            </a:pPr>
+            <a:r>
               <a:rPr lang="en-US" sz="1800" b="1" dirty="0">
                 <a:solidFill>
-                  <a:srgbClr val="C0392B"/>
-                </a:solidFill>
-              </a:rPr>
-              <a:t>Masalah: </a:t>
-            </a:r>
-            <a:pPr indent="0" marL="0">
-              <a:buNone/>
-            </a:pPr>
-            <a:r>
-              <a:rPr lang="en-US" sz="1800" i="1" dirty="0">
-                <a:solidFill>
-                  <a:srgbClr val="333333"/>
-                </a:solidFill>
-              </a:rPr>
-              <a:t>Kenapa harus menggunakan model Adaptif (Dynamic Gamma)?</a:t>
+                  <a:srgbClr val="333333"/>
+                </a:solidFill>
+              </a:rPr>
+              <a:t>Network Markowitz GS (Grid Search)</a:t>
+            </a:r>
+            <a:pPr indent="0" marL="0">
+              <a:buNone/>
+            </a:pPr>
+            <a:r>
+              <a:rPr lang="en-US" sz="1800" dirty="0">
+                <a:solidFill>
+                  <a:srgbClr val="333333"/>
+                </a:solidFill>
+              </a:rPr>
+              <a:t> dilatih secara matematis; jika mendeteksi korelasi ancaman kolaps merambat ke semua altcoin, ia akan melempar alokasi modalnya menuju node </a:t>
+            </a:r>
+            <a:pPr indent="0" marL="0">
+              <a:buNone/>
+            </a:pPr>
+            <a:r>
+              <a:rPr lang="en-US" sz="1800" b="1" dirty="0">
+                <a:solidFill>
+                  <a:srgbClr val="333333"/>
+                </a:solidFill>
+              </a:rPr>
+              <a:t>USDT (Tether)</a:t>
+            </a:r>
+            <a:pPr indent="0" marL="0">
+              <a:buNone/>
+            </a:pPr>
+            <a:r>
+              <a:rPr lang="en-US" sz="1800" dirty="0">
+                <a:solidFill>
+                  <a:srgbClr val="333333"/>
+                </a:solidFill>
+              </a:rPr>
+              <a:t> sebagai langkah </a:t>
+            </a:r>
+            <a:pPr indent="0" marL="0">
+              <a:buNone/>
+            </a:pPr>
+            <a:r>
+              <a:rPr lang="en-US" sz="1800" b="1" dirty="0">
+                <a:solidFill>
+                  <a:srgbClr val="333333"/>
+                </a:solidFill>
+              </a:rPr>
+              <a:t>evakuasi otomatis</a:t>
+            </a:r>
+            <a:pPr indent="0" marL="0">
+              <a:buNone/>
+            </a:pPr>
+            <a:r>
+              <a:rPr lang="en-US" sz="1800" dirty="0">
+                <a:solidFill>
+                  <a:srgbClr val="333333"/>
+                </a:solidFill>
+              </a:rPr>
+              <a:t> (Shock-Absorber).</a:t>
             </a:r>
             <a:endParaRPr lang="en-US" sz="1800" dirty="0"/>
           </a:p>
@@ -13516,19 +13778,26 @@
               <a:buNone/>
             </a:pPr>
             <a:r>
+              <a:rPr lang="en-US" sz="1800" dirty="0">
+                <a:solidFill>
+                  <a:srgbClr val="333333"/>
+                </a:solidFill>
+              </a:rPr>
+              <a:t>   4. Hal ini yang membuat performa Risk-GS (Grid Search) sangat </a:t>
+            </a:r>
+            <a:pPr indent="0" marL="0">
+              <a:buNone/>
+            </a:pPr>
+            <a:r>
               <a:rPr lang="en-US" sz="1800" b="1" dirty="0">
                 <a:solidFill>
-                  <a:srgbClr val="27AE60"/>
-                </a:solidFill>
-              </a:rPr>
-              <a:t>Bukti dari Grid Search:</a:t>
-            </a:r>
-            <a:endParaRPr lang="en-US" sz="1800" dirty="0"/>
-          </a:p>
-          <a:p>
-            <a:pPr marL="342900" indent="-342900">
-              <a:buSzPct val="100000"/>
-              <a:buChar char="•"/>
+                  <a:srgbClr val="333333"/>
+                </a:solidFill>
+              </a:rPr>
+              <a:t>tangguh</a:t>
+            </a:r>
+            <a:pPr indent="0" marL="0">
+              <a:buNone/>
             </a:pPr>
             <a:r>
               <a:rPr lang="en-US" sz="1800" dirty="0">
@@ -13536,103 +13805,7 @@
                   <a:srgbClr val="333333"/>
                 </a:solidFill>
               </a:rPr>
-              <a:t>Data menunjukkan nilai Gamma (γ) optimal </a:t>
-            </a:r>
-            <a:pPr indent="0" marL="0">
-              <a:buNone/>
-            </a:pPr>
-            <a:r>
-              <a:rPr lang="en-US" sz="1800" b="1" dirty="0">
-                <a:solidFill>
-                  <a:srgbClr val="333333"/>
-                </a:solidFill>
-              </a:rPr>
-              <a:t>terus bergeser</a:t>
-            </a:r>
-            <a:pPr indent="0" marL="0">
-              <a:buNone/>
-            </a:pPr>
-            <a:r>
-              <a:rPr lang="en-US" sz="1800" dirty="0">
-                <a:solidFill>
-                  <a:srgbClr val="333333"/>
-                </a:solidFill>
-              </a:rPr>
-              <a:t> setiap periode rebalancing.</a:t>
-            </a:r>
-            <a:endParaRPr lang="en-US" sz="1800" dirty="0"/>
-          </a:p>
-          <a:p>
-            <a:pPr marL="342900" indent="-342900">
-              <a:buSzPct val="100000"/>
-              <a:buChar char="•"/>
-            </a:pPr>
-            <a:r>
-              <a:rPr lang="en-US" sz="1800" dirty="0">
-                <a:solidFill>
-                  <a:srgbClr val="333333"/>
-                </a:solidFill>
-              </a:rPr>
-              <a:t>Penggunaan γ statis tidak cukup untuk menangkap perubahan </a:t>
-            </a:r>
-            <a:pPr indent="0" marL="0">
-              <a:buNone/>
-            </a:pPr>
-            <a:r>
-              <a:rPr lang="en-US" sz="1800" b="1" dirty="0">
-                <a:solidFill>
-                  <a:srgbClr val="333333"/>
-                </a:solidFill>
-              </a:rPr>
-              <a:t>struktur korelasi</a:t>
-            </a:r>
-            <a:pPr indent="0" marL="0">
-              <a:buNone/>
-            </a:pPr>
-            <a:r>
-              <a:rPr lang="en-US" sz="1800" dirty="0">
-                <a:solidFill>
-                  <a:srgbClr val="333333"/>
-                </a:solidFill>
-              </a:rPr>
-              <a:t> yang sangat cepat di pasar kripto.</a:t>
-            </a:r>
-            <a:endParaRPr lang="en-US" sz="1800" dirty="0"/>
-          </a:p>
-          <a:p>
-            <a:pPr marL="342900" indent="-342900">
-              <a:buSzPct val="100000"/>
-              <a:buChar char="•"/>
-            </a:pPr>
-            <a:r>
-              <a:rPr lang="en-US" sz="1800" dirty="0">
-                <a:solidFill>
-                  <a:srgbClr val="333333"/>
-                </a:solidFill>
-              </a:rPr>
-              <a:t>Ini membenarkan bahwa pasar kripto membutuhkan </a:t>
-            </a:r>
-            <a:pPr indent="0" marL="0">
-              <a:buNone/>
-            </a:pPr>
-            <a:r>
-              <a:rPr lang="en-US" sz="1800" b="1" dirty="0">
-                <a:solidFill>
-                  <a:srgbClr val="333333"/>
-                </a:solidFill>
-              </a:rPr>
-              <a:t>kalibrasi otomatis</a:t>
-            </a:r>
-            <a:pPr indent="0" marL="0">
-              <a:buNone/>
-            </a:pPr>
-            <a:r>
-              <a:rPr lang="en-US" sz="1800" dirty="0">
-                <a:solidFill>
-                  <a:srgbClr val="333333"/>
-                </a:solidFill>
-              </a:rPr>
-              <a:t> secara temporal.</a:t>
+              <a:t> dari serangan Crypto Winter, suatu kapabilitas pertahanan yang tidak dipahami oleh model ortodoks murni Markowitz.</a:t>
             </a:r>
             <a:endParaRPr lang="en-US" sz="1800" dirty="0"/>
           </a:p>
@@ -13649,6 +13822,239 @@
 <file path=ppt/slides/slide41.xml><?xml version="1.0" encoding="utf-8"?>
 <p:sld xmlns:a="http://schemas.openxmlformats.org/drawingml/2006/main" xmlns:r="http://schemas.openxmlformats.org/officeDocument/2006/relationships" xmlns:p="http://schemas.openxmlformats.org/presentationml/2006/main">
   <p:cSld name="Slide 41">
+    <p:spTree>
+      <p:nvGrpSpPr>
+        <p:cNvPr id="1" name=""/>
+        <p:cNvGrpSpPr/>
+        <p:nvPr/>
+      </p:nvGrpSpPr>
+      <p:grpSpPr>
+        <a:xfrm>
+          <a:off x="0" y="0"/>
+          <a:ext cx="0" cy="0"/>
+          <a:chOff x="0" y="0"/>
+          <a:chExt cx="0" cy="0"/>
+        </a:xfrm>
+      </p:grpSpPr>
+      <p:sp>
+        <p:nvSpPr>
+          <p:cNvPr id="2" name="Text 0"/>
+          <p:cNvSpPr/>
+          <p:nvPr/>
+        </p:nvSpPr>
+        <p:spPr>
+          <a:xfrm>
+            <a:off x="457200" y="457200"/>
+            <a:ext cx="8229600" cy="0"/>
+          </a:xfrm>
+          <a:prstGeom prst="rect">
+            <a:avLst/>
+          </a:prstGeom>
+          <a:noFill/>
+          <a:ln/>
+        </p:spPr>
+        <p:txBody>
+          <a:bodyPr wrap="square" rtlCol="0" anchor="ctr"/>
+          <a:lstStyle/>
+          <a:p>
+            <a:pPr indent="0" marL="0">
+              <a:buNone/>
+            </a:pPr>
+            <a:r>
+              <a:rPr lang="en-US" sz="2600" b="1" dirty="0">
+                <a:solidFill>
+                  <a:srgbClr val="003366"/>
+                </a:solidFill>
+              </a:rPr>
+              <a:t>Lampiran: Bukti Empiris Non-Stationarity Pasar</a:t>
+            </a:r>
+            <a:endParaRPr lang="en-US" sz="2600" dirty="0"/>
+          </a:p>
+        </p:txBody>
+      </p:sp>
+      <p:sp>
+        <p:nvSpPr>
+          <p:cNvPr id="3" name="Text 1"/>
+          <p:cNvSpPr/>
+          <p:nvPr/>
+        </p:nvSpPr>
+        <p:spPr>
+          <a:xfrm>
+            <a:off x="457200" y="1005840"/>
+            <a:ext cx="8229600" cy="5029200"/>
+          </a:xfrm>
+          <a:prstGeom prst="rect">
+            <a:avLst/>
+          </a:prstGeom>
+          <a:noFill/>
+          <a:ln/>
+        </p:spPr>
+        <p:txBody>
+          <a:bodyPr wrap="square" rtlCol="0" anchor="t"/>
+          <a:lstStyle/>
+          <a:p>
+            <a:pPr indent="0" marL="0">
+              <a:buNone/>
+            </a:pPr>
+            <a:r>
+              <a:rPr lang="en-US" sz="1800" b="1" dirty="0">
+                <a:solidFill>
+                  <a:srgbClr val="C0392B"/>
+                </a:solidFill>
+              </a:rPr>
+              <a:t>Masalah: </a:t>
+            </a:r>
+            <a:pPr indent="0" marL="0">
+              <a:buNone/>
+            </a:pPr>
+            <a:r>
+              <a:rPr lang="en-US" sz="1800" i="1" dirty="0">
+                <a:solidFill>
+                  <a:srgbClr val="333333"/>
+                </a:solidFill>
+              </a:rPr>
+              <a:t>Kenapa harus menggunakan model Adaptif (Dynamic Gamma)?</a:t>
+            </a:r>
+            <a:endParaRPr lang="en-US" sz="1800" dirty="0"/>
+          </a:p>
+          <a:p>
+            <a:pPr indent="0" marL="0">
+              <a:buNone/>
+            </a:pPr>
+            <a:r>
+              <a:rPr lang="en-US" sz="1800" b="1" dirty="0">
+                <a:solidFill>
+                  <a:srgbClr val="27AE60"/>
+                </a:solidFill>
+              </a:rPr>
+              <a:t>Bukti dari Grid Search:</a:t>
+            </a:r>
+            <a:endParaRPr lang="en-US" sz="1800" dirty="0"/>
+          </a:p>
+          <a:p>
+            <a:pPr marL="342900" indent="-342900">
+              <a:buSzPct val="100000"/>
+              <a:buChar char="•"/>
+            </a:pPr>
+            <a:r>
+              <a:rPr lang="en-US" sz="1800" dirty="0">
+                <a:solidFill>
+                  <a:srgbClr val="333333"/>
+                </a:solidFill>
+              </a:rPr>
+              <a:t>Data menunjukkan nilai Gamma (γ) optimal </a:t>
+            </a:r>
+            <a:pPr indent="0" marL="0">
+              <a:buNone/>
+            </a:pPr>
+            <a:r>
+              <a:rPr lang="en-US" sz="1800" b="1" dirty="0">
+                <a:solidFill>
+                  <a:srgbClr val="333333"/>
+                </a:solidFill>
+              </a:rPr>
+              <a:t>terus bergeser</a:t>
+            </a:r>
+            <a:pPr indent="0" marL="0">
+              <a:buNone/>
+            </a:pPr>
+            <a:r>
+              <a:rPr lang="en-US" sz="1800" dirty="0">
+                <a:solidFill>
+                  <a:srgbClr val="333333"/>
+                </a:solidFill>
+              </a:rPr>
+              <a:t> setiap periode rebalancing.</a:t>
+            </a:r>
+            <a:endParaRPr lang="en-US" sz="1800" dirty="0"/>
+          </a:p>
+          <a:p>
+            <a:pPr marL="342900" indent="-342900">
+              <a:buSzPct val="100000"/>
+              <a:buChar char="•"/>
+            </a:pPr>
+            <a:r>
+              <a:rPr lang="en-US" sz="1800" dirty="0">
+                <a:solidFill>
+                  <a:srgbClr val="333333"/>
+                </a:solidFill>
+              </a:rPr>
+              <a:t>Penggunaan γ statis tidak cukup untuk menangkap perubahan </a:t>
+            </a:r>
+            <a:pPr indent="0" marL="0">
+              <a:buNone/>
+            </a:pPr>
+            <a:r>
+              <a:rPr lang="en-US" sz="1800" b="1" dirty="0">
+                <a:solidFill>
+                  <a:srgbClr val="333333"/>
+                </a:solidFill>
+              </a:rPr>
+              <a:t>struktur korelasi</a:t>
+            </a:r>
+            <a:pPr indent="0" marL="0">
+              <a:buNone/>
+            </a:pPr>
+            <a:r>
+              <a:rPr lang="en-US" sz="1800" dirty="0">
+                <a:solidFill>
+                  <a:srgbClr val="333333"/>
+                </a:solidFill>
+              </a:rPr>
+              <a:t> yang sangat cepat di pasar kripto.</a:t>
+            </a:r>
+            <a:endParaRPr lang="en-US" sz="1800" dirty="0"/>
+          </a:p>
+          <a:p>
+            <a:pPr marL="342900" indent="-342900">
+              <a:buSzPct val="100000"/>
+              <a:buChar char="•"/>
+            </a:pPr>
+            <a:r>
+              <a:rPr lang="en-US" sz="1800" dirty="0">
+                <a:solidFill>
+                  <a:srgbClr val="333333"/>
+                </a:solidFill>
+              </a:rPr>
+              <a:t>Ini membenarkan bahwa pasar kripto membutuhkan </a:t>
+            </a:r>
+            <a:pPr indent="0" marL="0">
+              <a:buNone/>
+            </a:pPr>
+            <a:r>
+              <a:rPr lang="en-US" sz="1800" b="1" dirty="0">
+                <a:solidFill>
+                  <a:srgbClr val="333333"/>
+                </a:solidFill>
+              </a:rPr>
+              <a:t>kalibrasi otomatis</a:t>
+            </a:r>
+            <a:pPr indent="0" marL="0">
+              <a:buNone/>
+            </a:pPr>
+            <a:r>
+              <a:rPr lang="en-US" sz="1800" dirty="0">
+                <a:solidFill>
+                  <a:srgbClr val="333333"/>
+                </a:solidFill>
+              </a:rPr>
+              <a:t> secara temporal.</a:t>
+            </a:r>
+            <a:endParaRPr lang="en-US" sz="1800" dirty="0"/>
+          </a:p>
+        </p:txBody>
+      </p:sp>
+    </p:spTree>
+  </p:cSld>
+  <p:clrMapOvr>
+    <a:masterClrMapping/>
+  </p:clrMapOvr>
+</p:sld>
+</file>
+
+<file path=ppt/slides/slide42.xml><?xml version="1.0" encoding="utf-8"?>
+<p:sld xmlns:a="http://schemas.openxmlformats.org/drawingml/2006/main" xmlns:r="http://schemas.openxmlformats.org/officeDocument/2006/relationships" xmlns:p="http://schemas.openxmlformats.org/presentationml/2006/main">
+  <p:cSld name="Slide 42">
     <p:spTree>
       <p:nvGrpSpPr>
         <p:cNvPr id="1" name=""/>

</xml_diff>

<commit_message>
feat: add detailed RMT noise filtering example slide
</commit_message>
<xml_diff>
--- a/Presentasi_Proposal_Update.pptx
+++ b/Presentasi_Proposal_Update.pptx
@@ -47,9 +47,10 @@
     <p:sldId id="295" r:id="rId41"/>
     <p:sldId id="296" r:id="rId42"/>
     <p:sldId id="297" r:id="rId43"/>
+    <p:sldId id="298" r:id="rId44"/>
   </p:sldIdLst>
   <p:notesMasterIdLst>
-    <p:notesMasterId r:id="rId44"/>
+    <p:notesMasterId r:id="rId45"/>
   </p:notesMasterIdLst>
   <p:sldSz cx="9144000" cy="5143500"/>
   <p:notesSz cx="5143500" cy="9144000"/>
@@ -3735,6 +3736,94 @@
             <a:fld id="{F7021451-1387-4CA6-816F-3879F97B5CBC}" type="slidenum">
               <a:rPr lang="en-US"/>
               <a:t>42</a:t>
+            </a:fld>
+            <a:endParaRPr lang="en-US"/>
+          </a:p>
+        </p:txBody>
+      </p:sp>
+    </p:spTree>
+    <p:extLst>
+      <p:ext uri="{BB962C8B-B14F-4D97-AF65-F5344CB8AC3E}">
+        <p14:creationId xmlns:p14="http://schemas.microsoft.com/office/powerpoint/2010/main" val="1024086991"/>
+      </p:ext>
+    </p:extLst>
+  </p:cSld>
+  <p:clrMapOvr>
+    <a:masterClrMapping/>
+  </p:clrMapOvr>
+</p:notes>
+</file>
+
+<file path=ppt/notesSlides/notesSlide43.xml><?xml version="1.0" encoding="utf-8"?>
+<p:notes xmlns:a="http://schemas.openxmlformats.org/drawingml/2006/main" xmlns:r="http://schemas.openxmlformats.org/officeDocument/2006/relationships" xmlns:p="http://schemas.openxmlformats.org/presentationml/2006/main">
+  <p:cSld>
+    <p:spTree>
+      <p:nvGrpSpPr>
+        <p:cNvPr id="1" name=""/>
+        <p:cNvGrpSpPr/>
+        <p:nvPr/>
+      </p:nvGrpSpPr>
+      <p:grpSpPr>
+        <a:xfrm>
+          <a:off x="0" y="0"/>
+          <a:ext cx="0" cy="0"/>
+          <a:chOff x="0" y="0"/>
+          <a:chExt cx="0" cy="0"/>
+        </a:xfrm>
+      </p:grpSpPr>
+      <p:sp>
+        <p:nvSpPr>
+          <p:cNvPr id="2" name="Slide Image Placeholder 1"/>
+          <p:cNvSpPr>
+            <a:spLocks noGrp="1" noRot="1" noChangeAspect="1"/>
+          </p:cNvSpPr>
+          <p:nvPr>
+            <p:ph type="sldImg"/>
+          </p:nvPr>
+        </p:nvSpPr>
+        <p:spPr/>
+      </p:sp>
+      <p:sp>
+        <p:nvSpPr>
+          <p:cNvPr id="3" name="Notes Placeholder 2"/>
+          <p:cNvSpPr>
+            <a:spLocks noGrp="1"/>
+          </p:cNvSpPr>
+          <p:nvPr>
+            <p:ph type="body" idx="1"/>
+          </p:nvPr>
+        </p:nvSpPr>
+        <p:spPr/>
+        <p:txBody>
+          <a:bodyPr/>
+          <a:lstStyle/>
+          <a:p>
+            <a:r>
+              <a:rPr lang="en-US" dirty="0"/>
+              <a:t/>
+            </a:r>
+            <a:endParaRPr lang="en-US" dirty="0"/>
+          </a:p>
+        </p:txBody>
+      </p:sp>
+      <p:sp>
+        <p:nvSpPr>
+          <p:cNvPr id="4" name="Slide Number Placeholder 3"/>
+          <p:cNvSpPr>
+            <a:spLocks noGrp="1"/>
+          </p:cNvSpPr>
+          <p:nvPr>
+            <p:ph type="sldNum" sz="quarter" idx="10"/>
+          </p:nvPr>
+        </p:nvSpPr>
+        <p:spPr/>
+        <p:txBody>
+          <a:bodyPr/>
+          <a:lstStyle/>
+          <a:p>
+            <a:fld id="{F7021451-1387-4CA6-816F-3879F97B5CBC}" type="slidenum">
+              <a:rPr lang="en-US"/>
+              <a:t>43</a:t>
             </a:fld>
             <a:endParaRPr lang="en-US"/>
           </a:p>
@@ -12578,14 +12667,14 @@
               <a:buNone/>
             </a:pPr>
             <a:r>
-              <a:rPr lang="en-US" sz="2600" b="1" dirty="0">
+              <a:rPr lang="en-US" sz="2400" b="1" dirty="0">
                 <a:solidFill>
                   <a:srgbClr val="003366"/>
                 </a:solidFill>
               </a:rPr>
-              <a:t>Lampiran: Dua Tipe Pendekatan Grid Search</a:t>
-            </a:r>
-            <a:endParaRPr lang="en-US" sz="2600" dirty="0"/>
+              <a:t>Lampiran: Contoh Detail Filter RMT (Pembersihan Noise)</a:t>
+            </a:r>
+            <a:endParaRPr lang="en-US" sz="2400" dirty="0"/>
           </a:p>
         </p:txBody>
       </p:sp>
@@ -12614,190 +12703,284 @@
               <a:buNone/>
             </a:pPr>
             <a:r>
-              <a:rPr lang="en-US" sz="1800" b="1" dirty="0">
-                <a:solidFill>
-                  <a:srgbClr val="333333"/>
-                </a:solidFill>
-              </a:rPr>
-              <a:t>Dua Objektif Optimasi (Return vs Risk):</a:t>
-            </a:r>
-            <a:endParaRPr lang="en-US" sz="1800" dirty="0"/>
-          </a:p>
-          <a:p>
-            <a:pPr indent="0" marL="0">
-              <a:buNone/>
-            </a:pPr>
-            <a:r>
-              <a:rPr lang="en-US" sz="1800" b="1" dirty="0">
+              <a:rPr lang="en-US" sz="1600" b="1" dirty="0">
+                <a:solidFill>
+                  <a:srgbClr val="333333"/>
+                </a:solidFill>
+              </a:rPr>
+              <a:t>Analogi: Menghilangkan suara 'kresek' radio agar lagu terdengar jernih.</a:t>
+            </a:r>
+            <a:endParaRPr lang="en-US" sz="1600" dirty="0"/>
+          </a:p>
+          <a:p>
+            <a:pPr indent="0" marL="0">
+              <a:buNone/>
+            </a:pPr>
+            <a:r>
+              <a:rPr lang="en-US" sz="1600" b="1" dirty="0">
+                <a:solidFill>
+                  <a:srgbClr val="003366"/>
+                </a:solidFill>
+              </a:rPr>
+              <a:t>1. Skenario Korelasi Mentah (Dirty Matrix):</a:t>
+            </a:r>
+            <a:endParaRPr lang="en-US" sz="1600" dirty="0"/>
+          </a:p>
+          <a:p>
+            <a:pPr indent="0" marL="0">
+              <a:buNone/>
+            </a:pPr>
+            <a:r>
+              <a:rPr lang="en-US" sz="1600" dirty="0">
+                <a:solidFill>
+                  <a:srgbClr val="333333"/>
+                </a:solidFill>
+              </a:rPr>
+              <a:t>   • BTC vs ETH   : 0.75 (Ikatan Fundamental)</a:t>
+            </a:r>
+            <a:endParaRPr lang="en-US" sz="1600" dirty="0"/>
+          </a:p>
+          <a:p>
+            <a:pPr indent="0" marL="0">
+              <a:buNone/>
+            </a:pPr>
+            <a:r>
+              <a:rPr lang="en-US" sz="1600" dirty="0">
+                <a:solidFill>
+                  <a:srgbClr val="333333"/>
+                </a:solidFill>
+              </a:rPr>
+              <a:t>   • BTC vs DOGE  : 0.12 (Kebetulan Spekulatif/Noise)</a:t>
+            </a:r>
+            <a:endParaRPr lang="en-US" sz="1600" dirty="0"/>
+          </a:p>
+          <a:p>
+            <a:pPr indent="0" marL="0">
+              <a:buNone/>
+            </a:pPr>
+            <a:r>
+              <a:rPr lang="en-US" sz="1600" dirty="0">
+                <a:solidFill>
+                  <a:srgbClr val="333333"/>
+                </a:solidFill>
+              </a:rPr>
+              <a:t>   • ETH vs PEPE  : 0.08 (Kebetulan Spekulatif/Noise)</a:t>
+            </a:r>
+            <a:endParaRPr lang="en-US" sz="1600" dirty="0"/>
+          </a:p>
+          <a:p>
+            <a:pPr indent="0" marL="0">
+              <a:buNone/>
+            </a:pPr>
+            <a:r>
+              <a:rPr lang="en-US" sz="1600" b="1" dirty="0">
+                <a:solidFill>
+                  <a:srgbClr val="003366"/>
+                </a:solidFill>
+              </a:rPr>
+              <a:t>2. Uji Batas RMT (Marchenko-Pastur Distribution):</a:t>
+            </a:r>
+            <a:endParaRPr lang="en-US" sz="1600" dirty="0"/>
+          </a:p>
+          <a:p>
+            <a:pPr indent="0" marL="0">
+              <a:buNone/>
+            </a:pPr>
+            <a:r>
+              <a:rPr lang="en-US" sz="1600" dirty="0">
+                <a:solidFill>
+                  <a:srgbClr val="333333"/>
+                </a:solidFill>
+              </a:rPr>
+              <a:t>   Rumus RMT menghitung 'Ambang Batas Keacakan' (Threshold).</a:t>
+            </a:r>
+            <a:endParaRPr lang="en-US" sz="1600" dirty="0"/>
+          </a:p>
+          <a:p>
+            <a:pPr indent="0" marL="0">
+              <a:buNone/>
+            </a:pPr>
+            <a:r>
+              <a:rPr lang="en-US" sz="1600" dirty="0">
+                <a:solidFill>
+                  <a:srgbClr val="333333"/>
+                </a:solidFill>
+              </a:rPr>
+              <a:t>   Misalkan hasil hitung batas noise (λ_max) = </a:t>
+            </a:r>
+            <a:pPr indent="0" marL="0">
+              <a:buNone/>
+            </a:pPr>
+            <a:r>
+              <a:rPr lang="en-US" sz="1600" b="1" dirty="0">
+                <a:solidFill>
+                  <a:srgbClr val="C0392B"/>
+                </a:solidFill>
+              </a:rPr>
+              <a:t>0.15</a:t>
+            </a:r>
+            <a:pPr indent="0" marL="0">
+              <a:buNone/>
+            </a:pPr>
+            <a:r>
+              <a:rPr lang="en-US" sz="1600" dirty="0">
+                <a:solidFill>
+                  <a:srgbClr val="333333"/>
+                </a:solidFill>
+              </a:rPr>
+              <a:t>.</a:t>
+            </a:r>
+            <a:endParaRPr lang="en-US" sz="1600" dirty="0"/>
+          </a:p>
+          <a:p>
+            <a:pPr indent="0" marL="0">
+              <a:buNone/>
+            </a:pPr>
+            <a:r>
+              <a:rPr lang="en-US" sz="1600" b="1" dirty="0">
+                <a:solidFill>
+                  <a:srgbClr val="003366"/>
+                </a:solidFill>
+              </a:rPr>
+              <a:t>3. Proses Pembersihan (Filtering):</a:t>
+            </a:r>
+            <a:endParaRPr lang="en-US" sz="1600" dirty="0"/>
+          </a:p>
+          <a:p>
+            <a:pPr indent="0" marL="0">
+              <a:buNone/>
+            </a:pPr>
+            <a:r>
+              <a:rPr lang="en-US" sz="1600" dirty="0">
+                <a:solidFill>
+                  <a:srgbClr val="333333"/>
+                </a:solidFill>
+              </a:rPr>
+              <a:t>   • 0.75 &gt; 0.15  → </a:t>
+            </a:r>
+            <a:pPr indent="0" marL="0">
+              <a:buNone/>
+            </a:pPr>
+            <a:r>
+              <a:rPr lang="en-US" sz="1600" b="1" dirty="0">
                 <a:solidFill>
                   <a:srgbClr val="27AE60"/>
                 </a:solidFill>
               </a:rPr>
-              <a:t>1. Network Markowitz dengan Target Return (NW - Return Grid Search):</a:t>
-            </a:r>
-            <a:endParaRPr lang="en-US" sz="1800" dirty="0"/>
-          </a:p>
-          <a:p>
-            <a:pPr marL="342900" indent="-342900">
-              <a:buSzPct val="100000"/>
-              <a:buChar char="•"/>
-            </a:pPr>
-            <a:r>
-              <a:rPr lang="en-US" sz="1800" dirty="0">
-                <a:solidFill>
-                  <a:srgbClr val="333333"/>
-                </a:solidFill>
-              </a:rPr>
-              <a:t>Memaksimalkan capaian </a:t>
-            </a:r>
-            <a:pPr indent="0" marL="0">
-              <a:buNone/>
-            </a:pPr>
-            <a:r>
-              <a:rPr lang="en-US" sz="1800" b="1" dirty="0">
-                <a:solidFill>
-                  <a:srgbClr val="333333"/>
-                </a:solidFill>
-              </a:rPr>
-              <a:t>imbal hasil</a:t>
-            </a:r>
-            <a:pPr indent="0" marL="0">
-              <a:buNone/>
-            </a:pPr>
-            <a:r>
-              <a:rPr lang="en-US" sz="1800" dirty="0">
-                <a:solidFill>
-                  <a:srgbClr val="333333"/>
-                </a:solidFill>
-              </a:rPr>
-              <a:t> portofolio.</a:t>
-            </a:r>
-            <a:endParaRPr lang="en-US" sz="1800" dirty="0"/>
-          </a:p>
-          <a:p>
-            <a:pPr marL="342900" indent="-342900">
-              <a:buSzPct val="100000"/>
-              <a:buChar char="•"/>
-            </a:pPr>
-            <a:r>
-              <a:rPr lang="en-US" sz="1800" dirty="0">
-                <a:solidFill>
-                  <a:srgbClr val="333333"/>
-                </a:solidFill>
-              </a:rPr>
-              <a:t>Lebih Agresif untuk mengeksploitasi reli pada pasar </a:t>
-            </a:r>
-            <a:pPr indent="0" marL="0">
-              <a:buNone/>
-            </a:pPr>
-            <a:r>
-              <a:rPr lang="en-US" sz="1800" b="1" dirty="0">
-                <a:solidFill>
-                  <a:srgbClr val="333333"/>
-                </a:solidFill>
-              </a:rPr>
-              <a:t>Bullish</a:t>
-            </a:r>
-            <a:pPr indent="0" marL="0">
-              <a:buNone/>
-            </a:pPr>
-            <a:r>
-              <a:rPr lang="en-US" sz="1800" dirty="0">
-                <a:solidFill>
-                  <a:srgbClr val="333333"/>
-                </a:solidFill>
-              </a:rPr>
-              <a:t>.</a:t>
-            </a:r>
-            <a:endParaRPr lang="en-US" sz="1800" dirty="0"/>
-          </a:p>
-          <a:p>
-            <a:pPr indent="0" marL="0">
-              <a:buNone/>
-            </a:pPr>
-            <a:r>
-              <a:rPr lang="en-US" sz="1800" b="1" dirty="0">
+              <a:t>DIJAGA</a:t>
+            </a:r>
+            <a:pPr indent="0" marL="0">
+              <a:buNone/>
+            </a:pPr>
+            <a:r>
+              <a:rPr lang="en-US" sz="1600" dirty="0">
+                <a:solidFill>
+                  <a:srgbClr val="333333"/>
+                </a:solidFill>
+              </a:rPr>
+              <a:t> (Ini adalah Sinyal Pasar).</a:t>
+            </a:r>
+            <a:endParaRPr lang="en-US" sz="1600" dirty="0"/>
+          </a:p>
+          <a:p>
+            <a:pPr indent="0" marL="0">
+              <a:buNone/>
+            </a:pPr>
+            <a:r>
+              <a:rPr lang="en-US" sz="1600" dirty="0">
+                <a:solidFill>
+                  <a:srgbClr val="333333"/>
+                </a:solidFill>
+              </a:rPr>
+              <a:t>   • 0.12 &lt; 0.15  → </a:t>
+            </a:r>
+            <a:pPr indent="0" marL="0">
+              <a:buNone/>
+            </a:pPr>
+            <a:r>
+              <a:rPr lang="en-US" sz="1600" b="1" dirty="0">
                 <a:solidFill>
                   <a:srgbClr val="C0392B"/>
                 </a:solidFill>
               </a:rPr>
-              <a:t>2. Network Markowitz dengan Target Risiko (NW - Risk Grid Search):</a:t>
-            </a:r>
-            <a:endParaRPr lang="en-US" sz="1800" dirty="0"/>
-          </a:p>
-          <a:p>
-            <a:pPr marL="342900" indent="-342900">
-              <a:buSzPct val="100000"/>
-              <a:buChar char="•"/>
-            </a:pPr>
-            <a:r>
-              <a:rPr lang="en-US" sz="1800" dirty="0">
-                <a:solidFill>
-                  <a:srgbClr val="333333"/>
-                </a:solidFill>
-              </a:rPr>
-              <a:t>Menekan parameter </a:t>
-            </a:r>
-            <a:pPr indent="0" marL="0">
-              <a:buNone/>
-            </a:pPr>
-            <a:r>
-              <a:rPr lang="en-US" sz="1800" b="1" dirty="0">
-                <a:solidFill>
-                  <a:srgbClr val="333333"/>
-                </a:solidFill>
-              </a:rPr>
-              <a:t>risiko total</a:t>
-            </a:r>
-            <a:pPr indent="0" marL="0">
-              <a:buNone/>
-            </a:pPr>
-            <a:r>
-              <a:rPr lang="en-US" sz="1800" dirty="0">
-                <a:solidFill>
-                  <a:srgbClr val="333333"/>
-                </a:solidFill>
-              </a:rPr>
-              <a:t> hingga minimal.</a:t>
-            </a:r>
-            <a:endParaRPr lang="en-US" sz="1800" dirty="0"/>
-          </a:p>
-          <a:p>
-            <a:pPr marL="342900" indent="-342900">
-              <a:buSzPct val="100000"/>
-              <a:buChar char="•"/>
-            </a:pPr>
-            <a:r>
-              <a:rPr lang="en-US" sz="1800" dirty="0">
-                <a:solidFill>
-                  <a:srgbClr val="333333"/>
-                </a:solidFill>
-              </a:rPr>
-              <a:t>Lebih Defensif untuk meredam fluktuasi saat </a:t>
-            </a:r>
-            <a:pPr indent="0" marL="0">
-              <a:buNone/>
-            </a:pPr>
-            <a:r>
-              <a:rPr lang="en-US" sz="1800" b="1" dirty="0">
-                <a:solidFill>
-                  <a:srgbClr val="333333"/>
-                </a:solidFill>
-              </a:rPr>
-              <a:t>Crypto Winter</a:t>
-            </a:r>
-            <a:pPr indent="0" marL="0">
-              <a:buNone/>
-            </a:pPr>
-            <a:r>
-              <a:rPr lang="en-US" sz="1800" dirty="0">
-                <a:solidFill>
-                  <a:srgbClr val="333333"/>
-                </a:solidFill>
-              </a:rPr>
-              <a:t>.</a:t>
-            </a:r>
-            <a:endParaRPr lang="en-US" sz="1800" dirty="0"/>
+              <a:t>DIBUANG (JADI 0)</a:t>
+            </a:r>
+            <a:pPr indent="0" marL="0">
+              <a:buNone/>
+            </a:pPr>
+            <a:r>
+              <a:rPr lang="en-US" sz="1600" dirty="0">
+                <a:solidFill>
+                  <a:srgbClr val="333333"/>
+                </a:solidFill>
+              </a:rPr>
+              <a:t> (Ini adalah Noise).</a:t>
+            </a:r>
+            <a:endParaRPr lang="en-US" sz="1600" dirty="0"/>
+          </a:p>
+          <a:p>
+            <a:pPr indent="0" marL="0">
+              <a:buNone/>
+            </a:pPr>
+            <a:r>
+              <a:rPr lang="en-US" sz="1600" dirty="0">
+                <a:solidFill>
+                  <a:srgbClr val="333333"/>
+                </a:solidFill>
+              </a:rPr>
+              <a:t>   • 0.08 &lt; 0.15  → </a:t>
+            </a:r>
+            <a:pPr indent="0" marL="0">
+              <a:buNone/>
+            </a:pPr>
+            <a:r>
+              <a:rPr lang="en-US" sz="1600" b="1" dirty="0">
+                <a:solidFill>
+                  <a:srgbClr val="C0392B"/>
+                </a:solidFill>
+              </a:rPr>
+              <a:t>DIBUANG (JADI 0)</a:t>
+            </a:r>
+            <a:pPr indent="0" marL="0">
+              <a:buNone/>
+            </a:pPr>
+            <a:r>
+              <a:rPr lang="en-US" sz="1600" dirty="0">
+                <a:solidFill>
+                  <a:srgbClr val="333333"/>
+                </a:solidFill>
+              </a:rPr>
+              <a:t> (Ini adalah Noise).</a:t>
+            </a:r>
+            <a:endParaRPr lang="en-US" sz="1600" dirty="0"/>
+          </a:p>
+          <a:p>
+            <a:pPr indent="0" marL="0">
+              <a:buNone/>
+            </a:pPr>
+            <a:r>
+              <a:rPr lang="en-US" sz="1600" b="1" dirty="0">
+                <a:solidFill>
+                  <a:srgbClr val="8E44AD"/>
+                </a:solidFill>
+              </a:rPr>
+              <a:t>Kesimpulan Akhir:</a:t>
+            </a:r>
+            <a:endParaRPr lang="en-US" sz="1600" dirty="0"/>
+          </a:p>
+          <a:p>
+            <a:pPr indent="0" marL="0">
+              <a:buNone/>
+            </a:pPr>
+            <a:r>
+              <a:rPr lang="en-US" sz="1600" i="1" dirty="0">
+                <a:solidFill>
+                  <a:srgbClr val="333333"/>
+                </a:solidFill>
+              </a:rPr>
+              <a:t>Dengan RMT, model hanya akan membangun portofolio berdasarkan 'Gema Fundamental' aset, bukan berdasarkan 'Kebetulan Statistik' yang sering menjebak investor di pasar kripto.</a:t>
+            </a:r>
+            <a:endParaRPr lang="en-US" sz="1600" dirty="0"/>
           </a:p>
         </p:txBody>
       </p:sp>
@@ -12856,7 +13039,7 @@
                   <a:srgbClr val="003366"/>
                 </a:solidFill>
               </a:rPr>
-              <a:t>Lampiran: Penanganan Data Kosong (Missing Values)</a:t>
+              <a:t>Lampiran: Dua Tipe Pendekatan Grid Search</a:t>
             </a:r>
             <a:endParaRPr lang="en-US" sz="2600" dirty="0"/>
           </a:p>
@@ -12889,41 +13072,156 @@
             <a:r>
               <a:rPr lang="en-US" sz="1800" b="1" dirty="0">
                 <a:solidFill>
+                  <a:srgbClr val="333333"/>
+                </a:solidFill>
+              </a:rPr>
+              <a:t>Dua Objektif Optimasi (Return vs Risk):</a:t>
+            </a:r>
+            <a:endParaRPr lang="en-US" sz="1800" dirty="0"/>
+          </a:p>
+          <a:p>
+            <a:pPr indent="0" marL="0">
+              <a:buNone/>
+            </a:pPr>
+            <a:r>
+              <a:rPr lang="en-US" sz="1800" b="1" dirty="0">
+                <a:solidFill>
+                  <a:srgbClr val="27AE60"/>
+                </a:solidFill>
+              </a:rPr>
+              <a:t>1. Network Markowitz dengan Target Return (NW - Return Grid Search):</a:t>
+            </a:r>
+            <a:endParaRPr lang="en-US" sz="1800" dirty="0"/>
+          </a:p>
+          <a:p>
+            <a:pPr marL="342900" indent="-342900">
+              <a:buSzPct val="100000"/>
+              <a:buChar char="•"/>
+            </a:pPr>
+            <a:r>
+              <a:rPr lang="en-US" sz="1800" dirty="0">
+                <a:solidFill>
+                  <a:srgbClr val="333333"/>
+                </a:solidFill>
+              </a:rPr>
+              <a:t>Memaksimalkan capaian </a:t>
+            </a:r>
+            <a:pPr indent="0" marL="0">
+              <a:buNone/>
+            </a:pPr>
+            <a:r>
+              <a:rPr lang="en-US" sz="1800" b="1" dirty="0">
+                <a:solidFill>
+                  <a:srgbClr val="333333"/>
+                </a:solidFill>
+              </a:rPr>
+              <a:t>imbal hasil</a:t>
+            </a:r>
+            <a:pPr indent="0" marL="0">
+              <a:buNone/>
+            </a:pPr>
+            <a:r>
+              <a:rPr lang="en-US" sz="1800" dirty="0">
+                <a:solidFill>
+                  <a:srgbClr val="333333"/>
+                </a:solidFill>
+              </a:rPr>
+              <a:t> portofolio.</a:t>
+            </a:r>
+            <a:endParaRPr lang="en-US" sz="1800" dirty="0"/>
+          </a:p>
+          <a:p>
+            <a:pPr marL="342900" indent="-342900">
+              <a:buSzPct val="100000"/>
+              <a:buChar char="•"/>
+            </a:pPr>
+            <a:r>
+              <a:rPr lang="en-US" sz="1800" dirty="0">
+                <a:solidFill>
+                  <a:srgbClr val="333333"/>
+                </a:solidFill>
+              </a:rPr>
+              <a:t>Lebih Agresif untuk mengeksploitasi reli pada pasar </a:t>
+            </a:r>
+            <a:pPr indent="0" marL="0">
+              <a:buNone/>
+            </a:pPr>
+            <a:r>
+              <a:rPr lang="en-US" sz="1800" b="1" dirty="0">
+                <a:solidFill>
+                  <a:srgbClr val="333333"/>
+                </a:solidFill>
+              </a:rPr>
+              <a:t>Bullish</a:t>
+            </a:r>
+            <a:pPr indent="0" marL="0">
+              <a:buNone/>
+            </a:pPr>
+            <a:r>
+              <a:rPr lang="en-US" sz="1800" dirty="0">
+                <a:solidFill>
+                  <a:srgbClr val="333333"/>
+                </a:solidFill>
+              </a:rPr>
+              <a:t>.</a:t>
+            </a:r>
+            <a:endParaRPr lang="en-US" sz="1800" dirty="0"/>
+          </a:p>
+          <a:p>
+            <a:pPr indent="0" marL="0">
+              <a:buNone/>
+            </a:pPr>
+            <a:r>
+              <a:rPr lang="en-US" sz="1800" b="1" dirty="0">
+                <a:solidFill>
                   <a:srgbClr val="C0392B"/>
                 </a:solidFill>
               </a:rPr>
-              <a:t>Pertanyaan: </a:t>
-            </a:r>
-            <a:pPr indent="0" marL="0">
-              <a:buNone/>
-            </a:pPr>
-            <a:r>
-              <a:rPr lang="en-US" sz="1800" i="1" dirty="0">
-                <a:solidFill>
-                  <a:srgbClr val="333333"/>
-                </a:solidFill>
-              </a:rPr>
-              <a:t>"Beberapa koin seperti Binance/EOS belum rilis di awal 2017 sehingga datanya kosong. Bukankah backward-fill memalsukan harga dan merusak matriks?"</a:t>
+              <a:t>2. Network Markowitz dengan Target Risiko (NW - Risk Grid Search):</a:t>
             </a:r>
             <a:endParaRPr lang="en-US" sz="1800" dirty="0"/>
           </a:p>
           <a:p>
+            <a:pPr marL="342900" indent="-342900">
+              <a:buSzPct val="100000"/>
+              <a:buChar char="•"/>
+            </a:pPr>
+            <a:r>
+              <a:rPr lang="en-US" sz="1800" dirty="0">
+                <a:solidFill>
+                  <a:srgbClr val="333333"/>
+                </a:solidFill>
+              </a:rPr>
+              <a:t>Menekan parameter </a:t>
+            </a:r>
             <a:pPr indent="0" marL="0">
               <a:buNone/>
             </a:pPr>
             <a:r>
               <a:rPr lang="en-US" sz="1800" b="1" dirty="0">
                 <a:solidFill>
-                  <a:srgbClr val="27AE60"/>
-                </a:solidFill>
-              </a:rPr>
-              <a:t>Jawaban (Kenapa RMT sangat Krusial):</a:t>
+                  <a:srgbClr val="333333"/>
+                </a:solidFill>
+              </a:rPr>
+              <a:t>risiko total</a:t>
+            </a:r>
+            <a:pPr indent="0" marL="0">
+              <a:buNone/>
+            </a:pPr>
+            <a:r>
+              <a:rPr lang="en-US" sz="1800" dirty="0">
+                <a:solidFill>
+                  <a:srgbClr val="333333"/>
+                </a:solidFill>
+              </a:rPr>
+              <a:t> hingga minimal.</a:t>
             </a:r>
             <a:endParaRPr lang="en-US" sz="1800" dirty="0"/>
           </a:p>
           <a:p>
-            <a:pPr indent="0" marL="0">
-              <a:buNone/>
+            <a:pPr marL="342900" indent="-342900">
+              <a:buSzPct val="100000"/>
+              <a:buChar char="•"/>
             </a:pPr>
             <a:r>
               <a:rPr lang="en-US" sz="1800" dirty="0">
@@ -12931,18 +13229,18 @@
                   <a:srgbClr val="333333"/>
                 </a:solidFill>
               </a:rPr>
-              <a:t>   1. Praktik pengisian data diam (</a:t>
-            </a:r>
-            <a:pPr indent="0" marL="0">
-              <a:buNone/>
-            </a:pPr>
-            <a:r>
-              <a:rPr lang="en-US" sz="1800" b="1" i="1" dirty="0">
-                <a:solidFill>
-                  <a:srgbClr val="333333"/>
-                </a:solidFill>
-              </a:rPr>
-              <a:t>backward fill</a:t>
+              <a:t>Lebih Defensif untuk meredam fluktuasi saat </a:t>
+            </a:r>
+            <a:pPr indent="0" marL="0">
+              <a:buNone/>
+            </a:pPr>
+            <a:r>
+              <a:rPr lang="en-US" sz="1800" b="1" dirty="0">
+                <a:solidFill>
+                  <a:srgbClr val="333333"/>
+                </a:solidFill>
+              </a:rPr>
+              <a:t>Crypto Winter</a:t>
             </a:r>
             <a:pPr indent="0" marL="0">
               <a:buNone/>
@@ -12953,115 +13251,7 @@
                   <a:srgbClr val="333333"/>
                 </a:solidFill>
               </a:rPr>
-              <a:t>) memang menciptakan rentetan nilai harga yang statis.</a:t>
-            </a:r>
-            <a:endParaRPr lang="en-US" sz="1800" dirty="0"/>
-          </a:p>
-          <a:p>
-            <a:pPr indent="0" marL="0">
-              <a:buNone/>
-            </a:pPr>
-            <a:r>
-              <a:rPr lang="en-US" sz="1800" dirty="0">
-                <a:solidFill>
-                  <a:srgbClr val="333333"/>
-                </a:solidFill>
-              </a:rPr>
-              <a:t>   2. Namun, kehebatan </a:t>
-            </a:r>
-            <a:pPr indent="0" marL="0">
-              <a:buNone/>
-            </a:pPr>
-            <a:r>
-              <a:rPr lang="en-US" sz="1800" b="1" dirty="0">
-                <a:solidFill>
-                  <a:srgbClr val="333333"/>
-                </a:solidFill>
-              </a:rPr>
-              <a:t>Random Matrix Theory (RMT)</a:t>
-            </a:r>
-            <a:pPr indent="0" marL="0">
-              <a:buNone/>
-            </a:pPr>
-            <a:r>
-              <a:rPr lang="en-US" sz="1800" dirty="0">
-                <a:solidFill>
-                  <a:srgbClr val="333333"/>
-                </a:solidFill>
-              </a:rPr>
-              <a:t> diuji di sini! Karena data yang datar sama sekali tidak punya korelasi nyata.</a:t>
-            </a:r>
-            <a:endParaRPr lang="en-US" sz="1800" dirty="0"/>
-          </a:p>
-          <a:p>
-            <a:pPr indent="0" marL="0">
-              <a:buNone/>
-            </a:pPr>
-            <a:r>
-              <a:rPr lang="en-US" sz="1800" dirty="0">
-                <a:solidFill>
-                  <a:srgbClr val="333333"/>
-                </a:solidFill>
-              </a:rPr>
-              <a:t>   3. RMT otomatis akan mendeteksi korelasi buatan tersebut sebagai probabilitas </a:t>
-            </a:r>
-            <a:pPr indent="0" marL="0">
-              <a:buNone/>
-            </a:pPr>
-            <a:r>
-              <a:rPr lang="en-US" sz="1800" b="1" i="1" dirty="0">
-                <a:solidFill>
-                  <a:srgbClr val="333333"/>
-                </a:solidFill>
-              </a:rPr>
-              <a:t>Noise Acak</a:t>
-            </a:r>
-            <a:pPr indent="0" marL="0">
-              <a:buNone/>
-            </a:pPr>
-            <a:r>
-              <a:rPr lang="en-US" sz="1800" dirty="0">
-                <a:solidFill>
-                  <a:srgbClr val="333333"/>
-                </a:solidFill>
-              </a:rPr>
-              <a:t>, lalu membuangnya menjadi 0.</a:t>
-            </a:r>
-            <a:endParaRPr lang="en-US" sz="1800" dirty="0"/>
-          </a:p>
-          <a:p>
-            <a:pPr indent="0" marL="0">
-              <a:buNone/>
-            </a:pPr>
-            <a:r>
-              <a:rPr lang="en-US" sz="1800" dirty="0">
-                <a:solidFill>
-                  <a:srgbClr val="333333"/>
-                </a:solidFill>
-              </a:rPr>
-              <a:t>   4. Hasilnya, matriks korelasi </a:t>
-            </a:r>
-            <a:pPr indent="0" marL="0">
-              <a:buNone/>
-            </a:pPr>
-            <a:r>
-              <a:rPr lang="en-US" sz="1800" b="1" dirty="0">
-                <a:solidFill>
-                  <a:srgbClr val="333333"/>
-                </a:solidFill>
-              </a:rPr>
-              <a:t>terselamatkan</a:t>
-            </a:r>
-            <a:pPr indent="0" marL="0">
-              <a:buNone/>
-            </a:pPr>
-            <a:r>
-              <a:rPr lang="en-US" sz="1800" dirty="0">
-                <a:solidFill>
-                  <a:srgbClr val="333333"/>
-                </a:solidFill>
-              </a:rPr>
-              <a:t> dan tidak tercemar oleh cacat kelengkapan data.</a:t>
+              <a:t>.</a:t>
             </a:r>
             <a:endParaRPr lang="en-US" sz="1800" dirty="0"/>
           </a:p>
@@ -13122,7 +13312,7 @@
                   <a:srgbClr val="003366"/>
                 </a:solidFill>
               </a:rPr>
-              <a:t>Lampiran: Mengapa Menyertakan Tether (USDT)? (1/2)</a:t>
+              <a:t>Lampiran: Penanganan Data Kosong (Missing Values)</a:t>
             </a:r>
             <a:endParaRPr lang="en-US" sz="2600" dirty="0"/>
           </a:p>
@@ -13169,7 +13359,7 @@
                   <a:srgbClr val="333333"/>
                 </a:solidFill>
               </a:rPr>
-              <a:t>"Tether (USDT) itu stablecoin yang nilainya selalu fix ke 1 USD. Apakah tidak berbuat curang?"</a:t>
+              <a:t>"Beberapa koin seperti Binance/EOS belum rilis di awal 2017 sehingga datanya kosong. Bukankah backward-fill memalsukan harga dan merusak matriks?"</a:t>
             </a:r>
             <a:endParaRPr lang="en-US" sz="1800" dirty="0"/>
           </a:p>
@@ -13183,14 +13373,13 @@
                   <a:srgbClr val="27AE60"/>
                 </a:solidFill>
               </a:rPr>
-              <a:t>Jawaban (Dinamika Portofolio Cerdas):</a:t>
+              <a:t>Jawaban (Kenapa RMT sangat Krusial):</a:t>
             </a:r>
             <a:endParaRPr lang="en-US" sz="1800" dirty="0"/>
           </a:p>
           <a:p>
-            <a:pPr marL="342900" indent="-342900">
-              <a:buSzPct val="100000"/>
-              <a:buChar char="•"/>
+            <a:pPr indent="0" marL="0">
+              <a:buNone/>
             </a:pPr>
             <a:r>
               <a:rPr lang="en-US" sz="1800" dirty="0">
@@ -13198,7 +13387,7 @@
                   <a:srgbClr val="333333"/>
                 </a:solidFill>
               </a:rPr>
-              <a:t>Model ini mensimulasikan perilaku </a:t>
+              <a:t>   1. Praktik pengisian data diam (</a:t>
             </a:r>
             <a:pPr indent="0" marL="0">
               <a:buNone/>
@@ -13209,7 +13398,7 @@
                   <a:srgbClr val="333333"/>
                 </a:solidFill>
               </a:rPr>
-              <a:t>Robo-Advisory</a:t>
+              <a:t>backward fill</a:t>
             </a:r>
             <a:pPr indent="0" marL="0">
               <a:buNone/>
@@ -13220,14 +13409,13 @@
                   <a:srgbClr val="333333"/>
                 </a:solidFill>
               </a:rPr>
-              <a:t> institusional.</a:t>
+              <a:t>) memang menciptakan rentetan nilai harga yang statis.</a:t>
             </a:r>
             <a:endParaRPr lang="en-US" sz="1800" dirty="0"/>
           </a:p>
           <a:p>
-            <a:pPr marL="342900" indent="-342900">
-              <a:buSzPct val="100000"/>
-              <a:buChar char="•"/>
+            <a:pPr indent="0" marL="0">
+              <a:buNone/>
             </a:pPr>
             <a:r>
               <a:rPr lang="en-US" sz="1800" dirty="0">
@@ -13235,7 +13423,7 @@
                   <a:srgbClr val="333333"/>
                 </a:solidFill>
               </a:rPr>
-              <a:t>Ketika pasar anjlok ekstrem, investor akan melarikan senjatanya ke posisi </a:t>
+              <a:t>   2. Namun, kehebatan </a:t>
             </a:r>
             <a:pPr indent="0" marL="0">
               <a:buNone/>
@@ -13246,7 +13434,7 @@
                   <a:srgbClr val="333333"/>
                 </a:solidFill>
               </a:rPr>
-              <a:t>tunai (USDT)</a:t>
+              <a:t>Random Matrix Theory (RMT)</a:t>
             </a:r>
             <a:pPr indent="0" marL="0">
               <a:buNone/>
@@ -13257,7 +13445,79 @@
                   <a:srgbClr val="333333"/>
                 </a:solidFill>
               </a:rPr>
-              <a:t> sebagai evakuasi risiko.</a:t>
+              <a:t> diuji di sini! Karena data yang datar sama sekali tidak punya korelasi nyata.</a:t>
+            </a:r>
+            <a:endParaRPr lang="en-US" sz="1800" dirty="0"/>
+          </a:p>
+          <a:p>
+            <a:pPr indent="0" marL="0">
+              <a:buNone/>
+            </a:pPr>
+            <a:r>
+              <a:rPr lang="en-US" sz="1800" dirty="0">
+                <a:solidFill>
+                  <a:srgbClr val="333333"/>
+                </a:solidFill>
+              </a:rPr>
+              <a:t>   3. RMT otomatis akan mendeteksi korelasi buatan tersebut sebagai probabilitas </a:t>
+            </a:r>
+            <a:pPr indent="0" marL="0">
+              <a:buNone/>
+            </a:pPr>
+            <a:r>
+              <a:rPr lang="en-US" sz="1800" b="1" i="1" dirty="0">
+                <a:solidFill>
+                  <a:srgbClr val="333333"/>
+                </a:solidFill>
+              </a:rPr>
+              <a:t>Noise Acak</a:t>
+            </a:r>
+            <a:pPr indent="0" marL="0">
+              <a:buNone/>
+            </a:pPr>
+            <a:r>
+              <a:rPr lang="en-US" sz="1800" dirty="0">
+                <a:solidFill>
+                  <a:srgbClr val="333333"/>
+                </a:solidFill>
+              </a:rPr>
+              <a:t>, lalu membuangnya menjadi 0.</a:t>
+            </a:r>
+            <a:endParaRPr lang="en-US" sz="1800" dirty="0"/>
+          </a:p>
+          <a:p>
+            <a:pPr indent="0" marL="0">
+              <a:buNone/>
+            </a:pPr>
+            <a:r>
+              <a:rPr lang="en-US" sz="1800" dirty="0">
+                <a:solidFill>
+                  <a:srgbClr val="333333"/>
+                </a:solidFill>
+              </a:rPr>
+              <a:t>   4. Hasilnya, matriks korelasi </a:t>
+            </a:r>
+            <a:pPr indent="0" marL="0">
+              <a:buNone/>
+            </a:pPr>
+            <a:r>
+              <a:rPr lang="en-US" sz="1800" b="1" dirty="0">
+                <a:solidFill>
+                  <a:srgbClr val="333333"/>
+                </a:solidFill>
+              </a:rPr>
+              <a:t>terselamatkan</a:t>
+            </a:r>
+            <a:pPr indent="0" marL="0">
+              <a:buNone/>
+            </a:pPr>
+            <a:r>
+              <a:rPr lang="en-US" sz="1800" dirty="0">
+                <a:solidFill>
+                  <a:srgbClr val="333333"/>
+                </a:solidFill>
+              </a:rPr>
+              <a:t> dan tidak tercemar oleh cacat kelengkapan data.</a:t>
             </a:r>
             <a:endParaRPr lang="en-US" sz="1800" dirty="0"/>
           </a:p>
@@ -13667,7 +13927,7 @@
                   <a:srgbClr val="003366"/>
                 </a:solidFill>
               </a:rPr>
-              <a:t>Lampiran: Mengapa Menyertakan Tether (USDT)? (2/2)</a:t>
+              <a:t>Lampiran: Mengapa Menyertakan Tether (USDT)? (1/2)</a:t>
             </a:r>
             <a:endParaRPr lang="en-US" sz="2600" dirty="0"/>
           </a:p>
@@ -13698,12 +13958,89 @@
               <a:buNone/>
             </a:pPr>
             <a:r>
+              <a:rPr lang="en-US" sz="1800" b="1" dirty="0">
+                <a:solidFill>
+                  <a:srgbClr val="C0392B"/>
+                </a:solidFill>
+              </a:rPr>
+              <a:t>Pertanyaan: </a:t>
+            </a:r>
+            <a:pPr indent="0" marL="0">
+              <a:buNone/>
+            </a:pPr>
+            <a:r>
+              <a:rPr lang="en-US" sz="1800" i="1" dirty="0">
+                <a:solidFill>
+                  <a:srgbClr val="333333"/>
+                </a:solidFill>
+              </a:rPr>
+              <a:t>"Tether (USDT) itu stablecoin yang nilainya selalu fix ke 1 USD. Apakah tidak berbuat curang?"</a:t>
+            </a:r>
+            <a:endParaRPr lang="en-US" sz="1800" dirty="0"/>
+          </a:p>
+          <a:p>
+            <a:pPr indent="0" marL="0">
+              <a:buNone/>
+            </a:pPr>
+            <a:r>
+              <a:rPr lang="en-US" sz="1800" b="1" dirty="0">
+                <a:solidFill>
+                  <a:srgbClr val="27AE60"/>
+                </a:solidFill>
+              </a:rPr>
+              <a:t>Jawaban (Dinamika Portofolio Cerdas):</a:t>
+            </a:r>
+            <a:endParaRPr lang="en-US" sz="1800" dirty="0"/>
+          </a:p>
+          <a:p>
+            <a:pPr marL="342900" indent="-342900">
+              <a:buSzPct val="100000"/>
+              <a:buChar char="•"/>
+            </a:pPr>
+            <a:r>
               <a:rPr lang="en-US" sz="1800" dirty="0">
                 <a:solidFill>
                   <a:srgbClr val="333333"/>
                 </a:solidFill>
               </a:rPr>
-              <a:t>3. Algoritma jaringan </a:t>
+              <a:t>Model ini mensimulasikan perilaku </a:t>
+            </a:r>
+            <a:pPr indent="0" marL="0">
+              <a:buNone/>
+            </a:pPr>
+            <a:r>
+              <a:rPr lang="en-US" sz="1800" b="1" i="1" dirty="0">
+                <a:solidFill>
+                  <a:srgbClr val="333333"/>
+                </a:solidFill>
+              </a:rPr>
+              <a:t>Robo-Advisory</a:t>
+            </a:r>
+            <a:pPr indent="0" marL="0">
+              <a:buNone/>
+            </a:pPr>
+            <a:r>
+              <a:rPr lang="en-US" sz="1800" dirty="0">
+                <a:solidFill>
+                  <a:srgbClr val="333333"/>
+                </a:solidFill>
+              </a:rPr>
+              <a:t> institusional.</a:t>
+            </a:r>
+            <a:endParaRPr lang="en-US" sz="1800" dirty="0"/>
+          </a:p>
+          <a:p>
+            <a:pPr marL="342900" indent="-342900">
+              <a:buSzPct val="100000"/>
+              <a:buChar char="•"/>
+            </a:pPr>
+            <a:r>
+              <a:rPr lang="en-US" sz="1800" dirty="0">
+                <a:solidFill>
+                  <a:srgbClr val="333333"/>
+                </a:solidFill>
+              </a:rPr>
+              <a:t>Ketika pasar anjlok ekstrem, investor akan melarikan senjatanya ke posisi </a:t>
             </a:r>
             <a:pPr indent="0" marL="0">
               <a:buNone/>
@@ -13714,7 +14051,7 @@
                   <a:srgbClr val="333333"/>
                 </a:solidFill>
               </a:rPr>
-              <a:t>Network Markowitz GS (Grid Search)</a:t>
+              <a:t>tunai (USDT)</a:t>
             </a:r>
             <a:pPr indent="0" marL="0">
               <a:buNone/>
@@ -13725,87 +14062,7 @@
                   <a:srgbClr val="333333"/>
                 </a:solidFill>
               </a:rPr>
-              <a:t> dilatih secara matematis; jika mendeteksi korelasi ancaman kolaps merambat ke semua altcoin, ia akan melempar alokasi modalnya menuju node </a:t>
-            </a:r>
-            <a:pPr indent="0" marL="0">
-              <a:buNone/>
-            </a:pPr>
-            <a:r>
-              <a:rPr lang="en-US" sz="1800" b="1" dirty="0">
-                <a:solidFill>
-                  <a:srgbClr val="333333"/>
-                </a:solidFill>
-              </a:rPr>
-              <a:t>USDT (Tether)</a:t>
-            </a:r>
-            <a:pPr indent="0" marL="0">
-              <a:buNone/>
-            </a:pPr>
-            <a:r>
-              <a:rPr lang="en-US" sz="1800" dirty="0">
-                <a:solidFill>
-                  <a:srgbClr val="333333"/>
-                </a:solidFill>
-              </a:rPr>
-              <a:t> sebagai langkah </a:t>
-            </a:r>
-            <a:pPr indent="0" marL="0">
-              <a:buNone/>
-            </a:pPr>
-            <a:r>
-              <a:rPr lang="en-US" sz="1800" b="1" dirty="0">
-                <a:solidFill>
-                  <a:srgbClr val="333333"/>
-                </a:solidFill>
-              </a:rPr>
-              <a:t>evakuasi otomatis</a:t>
-            </a:r>
-            <a:pPr indent="0" marL="0">
-              <a:buNone/>
-            </a:pPr>
-            <a:r>
-              <a:rPr lang="en-US" sz="1800" dirty="0">
-                <a:solidFill>
-                  <a:srgbClr val="333333"/>
-                </a:solidFill>
-              </a:rPr>
-              <a:t> (Shock-Absorber).</a:t>
-            </a:r>
-            <a:endParaRPr lang="en-US" sz="1800" dirty="0"/>
-          </a:p>
-          <a:p>
-            <a:pPr indent="0" marL="0">
-              <a:buNone/>
-            </a:pPr>
-            <a:r>
-              <a:rPr lang="en-US" sz="1800" dirty="0">
-                <a:solidFill>
-                  <a:srgbClr val="333333"/>
-                </a:solidFill>
-              </a:rPr>
-              <a:t>   4. Hal ini yang membuat performa Risk-GS (Grid Search) sangat </a:t>
-            </a:r>
-            <a:pPr indent="0" marL="0">
-              <a:buNone/>
-            </a:pPr>
-            <a:r>
-              <a:rPr lang="en-US" sz="1800" b="1" dirty="0">
-                <a:solidFill>
-                  <a:srgbClr val="333333"/>
-                </a:solidFill>
-              </a:rPr>
-              <a:t>tangguh</a:t>
-            </a:r>
-            <a:pPr indent="0" marL="0">
-              <a:buNone/>
-            </a:pPr>
-            <a:r>
-              <a:rPr lang="en-US" sz="1800" dirty="0">
-                <a:solidFill>
-                  <a:srgbClr val="333333"/>
-                </a:solidFill>
-              </a:rPr>
-              <a:t> dari serangan Crypto Winter, suatu kapabilitas pertahanan yang tidak dipahami oleh model ortodoks murni Markowitz.</a:t>
+              <a:t> sebagai evakuasi risiko.</a:t>
             </a:r>
             <a:endParaRPr lang="en-US" sz="1800" dirty="0"/>
           </a:p>
@@ -13866,7 +14123,7 @@
                   <a:srgbClr val="003366"/>
                 </a:solidFill>
               </a:rPr>
-              <a:t>Lampiran: Bukti Empiris Non-Stationarity Pasar</a:t>
+              <a:t>Lampiran: Mengapa Menyertakan Tether (USDT)? (2/2)</a:t>
             </a:r>
             <a:endParaRPr lang="en-US" sz="2600" dirty="0"/>
           </a:p>
@@ -13897,23 +14154,78 @@
               <a:buNone/>
             </a:pPr>
             <a:r>
+              <a:rPr lang="en-US" sz="1800" dirty="0">
+                <a:solidFill>
+                  <a:srgbClr val="333333"/>
+                </a:solidFill>
+              </a:rPr>
+              <a:t>3. Algoritma jaringan </a:t>
+            </a:r>
+            <a:pPr indent="0" marL="0">
+              <a:buNone/>
+            </a:pPr>
+            <a:r>
               <a:rPr lang="en-US" sz="1800" b="1" dirty="0">
                 <a:solidFill>
-                  <a:srgbClr val="C0392B"/>
-                </a:solidFill>
-              </a:rPr>
-              <a:t>Masalah: </a:t>
-            </a:r>
-            <a:pPr indent="0" marL="0">
-              <a:buNone/>
-            </a:pPr>
-            <a:r>
-              <a:rPr lang="en-US" sz="1800" i="1" dirty="0">
-                <a:solidFill>
-                  <a:srgbClr val="333333"/>
-                </a:solidFill>
-              </a:rPr>
-              <a:t>Kenapa harus menggunakan model Adaptif (Dynamic Gamma)?</a:t>
+                  <a:srgbClr val="333333"/>
+                </a:solidFill>
+              </a:rPr>
+              <a:t>Network Markowitz GS (Grid Search)</a:t>
+            </a:r>
+            <a:pPr indent="0" marL="0">
+              <a:buNone/>
+            </a:pPr>
+            <a:r>
+              <a:rPr lang="en-US" sz="1800" dirty="0">
+                <a:solidFill>
+                  <a:srgbClr val="333333"/>
+                </a:solidFill>
+              </a:rPr>
+              <a:t> dilatih secara matematis; jika mendeteksi korelasi ancaman kolaps merambat ke semua altcoin, ia akan melempar alokasi modalnya menuju node </a:t>
+            </a:r>
+            <a:pPr indent="0" marL="0">
+              <a:buNone/>
+            </a:pPr>
+            <a:r>
+              <a:rPr lang="en-US" sz="1800" b="1" dirty="0">
+                <a:solidFill>
+                  <a:srgbClr val="333333"/>
+                </a:solidFill>
+              </a:rPr>
+              <a:t>USDT (Tether)</a:t>
+            </a:r>
+            <a:pPr indent="0" marL="0">
+              <a:buNone/>
+            </a:pPr>
+            <a:r>
+              <a:rPr lang="en-US" sz="1800" dirty="0">
+                <a:solidFill>
+                  <a:srgbClr val="333333"/>
+                </a:solidFill>
+              </a:rPr>
+              <a:t> sebagai langkah </a:t>
+            </a:r>
+            <a:pPr indent="0" marL="0">
+              <a:buNone/>
+            </a:pPr>
+            <a:r>
+              <a:rPr lang="en-US" sz="1800" b="1" dirty="0">
+                <a:solidFill>
+                  <a:srgbClr val="333333"/>
+                </a:solidFill>
+              </a:rPr>
+              <a:t>evakuasi otomatis</a:t>
+            </a:r>
+            <a:pPr indent="0" marL="0">
+              <a:buNone/>
+            </a:pPr>
+            <a:r>
+              <a:rPr lang="en-US" sz="1800" dirty="0">
+                <a:solidFill>
+                  <a:srgbClr val="333333"/>
+                </a:solidFill>
+              </a:rPr>
+              <a:t> (Shock-Absorber).</a:t>
             </a:r>
             <a:endParaRPr lang="en-US" sz="1800" dirty="0"/>
           </a:p>
@@ -13922,19 +14234,26 @@
               <a:buNone/>
             </a:pPr>
             <a:r>
+              <a:rPr lang="en-US" sz="1800" dirty="0">
+                <a:solidFill>
+                  <a:srgbClr val="333333"/>
+                </a:solidFill>
+              </a:rPr>
+              <a:t>   4. Hal ini yang membuat performa Risk-GS (Grid Search) sangat </a:t>
+            </a:r>
+            <a:pPr indent="0" marL="0">
+              <a:buNone/>
+            </a:pPr>
+            <a:r>
               <a:rPr lang="en-US" sz="1800" b="1" dirty="0">
                 <a:solidFill>
-                  <a:srgbClr val="27AE60"/>
-                </a:solidFill>
-              </a:rPr>
-              <a:t>Bukti dari Grid Search:</a:t>
-            </a:r>
-            <a:endParaRPr lang="en-US" sz="1800" dirty="0"/>
-          </a:p>
-          <a:p>
-            <a:pPr marL="342900" indent="-342900">
-              <a:buSzPct val="100000"/>
-              <a:buChar char="•"/>
+                  <a:srgbClr val="333333"/>
+                </a:solidFill>
+              </a:rPr>
+              <a:t>tangguh</a:t>
+            </a:r>
+            <a:pPr indent="0" marL="0">
+              <a:buNone/>
             </a:pPr>
             <a:r>
               <a:rPr lang="en-US" sz="1800" dirty="0">
@@ -13942,103 +14261,7 @@
                   <a:srgbClr val="333333"/>
                 </a:solidFill>
               </a:rPr>
-              <a:t>Data menunjukkan nilai Gamma (γ) optimal </a:t>
-            </a:r>
-            <a:pPr indent="0" marL="0">
-              <a:buNone/>
-            </a:pPr>
-            <a:r>
-              <a:rPr lang="en-US" sz="1800" b="1" dirty="0">
-                <a:solidFill>
-                  <a:srgbClr val="333333"/>
-                </a:solidFill>
-              </a:rPr>
-              <a:t>terus bergeser</a:t>
-            </a:r>
-            <a:pPr indent="0" marL="0">
-              <a:buNone/>
-            </a:pPr>
-            <a:r>
-              <a:rPr lang="en-US" sz="1800" dirty="0">
-                <a:solidFill>
-                  <a:srgbClr val="333333"/>
-                </a:solidFill>
-              </a:rPr>
-              <a:t> setiap periode rebalancing.</a:t>
-            </a:r>
-            <a:endParaRPr lang="en-US" sz="1800" dirty="0"/>
-          </a:p>
-          <a:p>
-            <a:pPr marL="342900" indent="-342900">
-              <a:buSzPct val="100000"/>
-              <a:buChar char="•"/>
-            </a:pPr>
-            <a:r>
-              <a:rPr lang="en-US" sz="1800" dirty="0">
-                <a:solidFill>
-                  <a:srgbClr val="333333"/>
-                </a:solidFill>
-              </a:rPr>
-              <a:t>Penggunaan γ statis tidak cukup untuk menangkap perubahan </a:t>
-            </a:r>
-            <a:pPr indent="0" marL="0">
-              <a:buNone/>
-            </a:pPr>
-            <a:r>
-              <a:rPr lang="en-US" sz="1800" b="1" dirty="0">
-                <a:solidFill>
-                  <a:srgbClr val="333333"/>
-                </a:solidFill>
-              </a:rPr>
-              <a:t>struktur korelasi</a:t>
-            </a:r>
-            <a:pPr indent="0" marL="0">
-              <a:buNone/>
-            </a:pPr>
-            <a:r>
-              <a:rPr lang="en-US" sz="1800" dirty="0">
-                <a:solidFill>
-                  <a:srgbClr val="333333"/>
-                </a:solidFill>
-              </a:rPr>
-              <a:t> yang sangat cepat di pasar kripto.</a:t>
-            </a:r>
-            <a:endParaRPr lang="en-US" sz="1800" dirty="0"/>
-          </a:p>
-          <a:p>
-            <a:pPr marL="342900" indent="-342900">
-              <a:buSzPct val="100000"/>
-              <a:buChar char="•"/>
-            </a:pPr>
-            <a:r>
-              <a:rPr lang="en-US" sz="1800" dirty="0">
-                <a:solidFill>
-                  <a:srgbClr val="333333"/>
-                </a:solidFill>
-              </a:rPr>
-              <a:t>Ini membenarkan bahwa pasar kripto membutuhkan </a:t>
-            </a:r>
-            <a:pPr indent="0" marL="0">
-              <a:buNone/>
-            </a:pPr>
-            <a:r>
-              <a:rPr lang="en-US" sz="1800" b="1" dirty="0">
-                <a:solidFill>
-                  <a:srgbClr val="333333"/>
-                </a:solidFill>
-              </a:rPr>
-              <a:t>kalibrasi otomatis</a:t>
-            </a:r>
-            <a:pPr indent="0" marL="0">
-              <a:buNone/>
-            </a:pPr>
-            <a:r>
-              <a:rPr lang="en-US" sz="1800" dirty="0">
-                <a:solidFill>
-                  <a:srgbClr val="333333"/>
-                </a:solidFill>
-              </a:rPr>
-              <a:t> secara temporal.</a:t>
+              <a:t> dari serangan Crypto Winter, suatu kapabilitas pertahanan yang tidak dipahami oleh model ortodoks murni Markowitz.</a:t>
             </a:r>
             <a:endParaRPr lang="en-US" sz="1800" dirty="0"/>
           </a:p>
@@ -14055,6 +14278,239 @@
 <file path=ppt/slides/slide42.xml><?xml version="1.0" encoding="utf-8"?>
 <p:sld xmlns:a="http://schemas.openxmlformats.org/drawingml/2006/main" xmlns:r="http://schemas.openxmlformats.org/officeDocument/2006/relationships" xmlns:p="http://schemas.openxmlformats.org/presentationml/2006/main">
   <p:cSld name="Slide 42">
+    <p:spTree>
+      <p:nvGrpSpPr>
+        <p:cNvPr id="1" name=""/>
+        <p:cNvGrpSpPr/>
+        <p:nvPr/>
+      </p:nvGrpSpPr>
+      <p:grpSpPr>
+        <a:xfrm>
+          <a:off x="0" y="0"/>
+          <a:ext cx="0" cy="0"/>
+          <a:chOff x="0" y="0"/>
+          <a:chExt cx="0" cy="0"/>
+        </a:xfrm>
+      </p:grpSpPr>
+      <p:sp>
+        <p:nvSpPr>
+          <p:cNvPr id="2" name="Text 0"/>
+          <p:cNvSpPr/>
+          <p:nvPr/>
+        </p:nvSpPr>
+        <p:spPr>
+          <a:xfrm>
+            <a:off x="457200" y="457200"/>
+            <a:ext cx="8229600" cy="0"/>
+          </a:xfrm>
+          <a:prstGeom prst="rect">
+            <a:avLst/>
+          </a:prstGeom>
+          <a:noFill/>
+          <a:ln/>
+        </p:spPr>
+        <p:txBody>
+          <a:bodyPr wrap="square" rtlCol="0" anchor="ctr"/>
+          <a:lstStyle/>
+          <a:p>
+            <a:pPr indent="0" marL="0">
+              <a:buNone/>
+            </a:pPr>
+            <a:r>
+              <a:rPr lang="en-US" sz="2600" b="1" dirty="0">
+                <a:solidFill>
+                  <a:srgbClr val="003366"/>
+                </a:solidFill>
+              </a:rPr>
+              <a:t>Lampiran: Bukti Empiris Non-Stationarity Pasar</a:t>
+            </a:r>
+            <a:endParaRPr lang="en-US" sz="2600" dirty="0"/>
+          </a:p>
+        </p:txBody>
+      </p:sp>
+      <p:sp>
+        <p:nvSpPr>
+          <p:cNvPr id="3" name="Text 1"/>
+          <p:cNvSpPr/>
+          <p:nvPr/>
+        </p:nvSpPr>
+        <p:spPr>
+          <a:xfrm>
+            <a:off x="457200" y="1005840"/>
+            <a:ext cx="8229600" cy="5029200"/>
+          </a:xfrm>
+          <a:prstGeom prst="rect">
+            <a:avLst/>
+          </a:prstGeom>
+          <a:noFill/>
+          <a:ln/>
+        </p:spPr>
+        <p:txBody>
+          <a:bodyPr wrap="square" rtlCol="0" anchor="t"/>
+          <a:lstStyle/>
+          <a:p>
+            <a:pPr indent="0" marL="0">
+              <a:buNone/>
+            </a:pPr>
+            <a:r>
+              <a:rPr lang="en-US" sz="1800" b="1" dirty="0">
+                <a:solidFill>
+                  <a:srgbClr val="C0392B"/>
+                </a:solidFill>
+              </a:rPr>
+              <a:t>Masalah: </a:t>
+            </a:r>
+            <a:pPr indent="0" marL="0">
+              <a:buNone/>
+            </a:pPr>
+            <a:r>
+              <a:rPr lang="en-US" sz="1800" i="1" dirty="0">
+                <a:solidFill>
+                  <a:srgbClr val="333333"/>
+                </a:solidFill>
+              </a:rPr>
+              <a:t>Kenapa harus menggunakan model Adaptif (Dynamic Gamma)?</a:t>
+            </a:r>
+            <a:endParaRPr lang="en-US" sz="1800" dirty="0"/>
+          </a:p>
+          <a:p>
+            <a:pPr indent="0" marL="0">
+              <a:buNone/>
+            </a:pPr>
+            <a:r>
+              <a:rPr lang="en-US" sz="1800" b="1" dirty="0">
+                <a:solidFill>
+                  <a:srgbClr val="27AE60"/>
+                </a:solidFill>
+              </a:rPr>
+              <a:t>Bukti dari Grid Search:</a:t>
+            </a:r>
+            <a:endParaRPr lang="en-US" sz="1800" dirty="0"/>
+          </a:p>
+          <a:p>
+            <a:pPr marL="342900" indent="-342900">
+              <a:buSzPct val="100000"/>
+              <a:buChar char="•"/>
+            </a:pPr>
+            <a:r>
+              <a:rPr lang="en-US" sz="1800" dirty="0">
+                <a:solidFill>
+                  <a:srgbClr val="333333"/>
+                </a:solidFill>
+              </a:rPr>
+              <a:t>Data menunjukkan nilai Gamma (γ) optimal </a:t>
+            </a:r>
+            <a:pPr indent="0" marL="0">
+              <a:buNone/>
+            </a:pPr>
+            <a:r>
+              <a:rPr lang="en-US" sz="1800" b="1" dirty="0">
+                <a:solidFill>
+                  <a:srgbClr val="333333"/>
+                </a:solidFill>
+              </a:rPr>
+              <a:t>terus bergeser</a:t>
+            </a:r>
+            <a:pPr indent="0" marL="0">
+              <a:buNone/>
+            </a:pPr>
+            <a:r>
+              <a:rPr lang="en-US" sz="1800" dirty="0">
+                <a:solidFill>
+                  <a:srgbClr val="333333"/>
+                </a:solidFill>
+              </a:rPr>
+              <a:t> setiap periode rebalancing.</a:t>
+            </a:r>
+            <a:endParaRPr lang="en-US" sz="1800" dirty="0"/>
+          </a:p>
+          <a:p>
+            <a:pPr marL="342900" indent="-342900">
+              <a:buSzPct val="100000"/>
+              <a:buChar char="•"/>
+            </a:pPr>
+            <a:r>
+              <a:rPr lang="en-US" sz="1800" dirty="0">
+                <a:solidFill>
+                  <a:srgbClr val="333333"/>
+                </a:solidFill>
+              </a:rPr>
+              <a:t>Penggunaan γ statis tidak cukup untuk menangkap perubahan </a:t>
+            </a:r>
+            <a:pPr indent="0" marL="0">
+              <a:buNone/>
+            </a:pPr>
+            <a:r>
+              <a:rPr lang="en-US" sz="1800" b="1" dirty="0">
+                <a:solidFill>
+                  <a:srgbClr val="333333"/>
+                </a:solidFill>
+              </a:rPr>
+              <a:t>struktur korelasi</a:t>
+            </a:r>
+            <a:pPr indent="0" marL="0">
+              <a:buNone/>
+            </a:pPr>
+            <a:r>
+              <a:rPr lang="en-US" sz="1800" dirty="0">
+                <a:solidFill>
+                  <a:srgbClr val="333333"/>
+                </a:solidFill>
+              </a:rPr>
+              <a:t> yang sangat cepat di pasar kripto.</a:t>
+            </a:r>
+            <a:endParaRPr lang="en-US" sz="1800" dirty="0"/>
+          </a:p>
+          <a:p>
+            <a:pPr marL="342900" indent="-342900">
+              <a:buSzPct val="100000"/>
+              <a:buChar char="•"/>
+            </a:pPr>
+            <a:r>
+              <a:rPr lang="en-US" sz="1800" dirty="0">
+                <a:solidFill>
+                  <a:srgbClr val="333333"/>
+                </a:solidFill>
+              </a:rPr>
+              <a:t>Ini membenarkan bahwa pasar kripto membutuhkan </a:t>
+            </a:r>
+            <a:pPr indent="0" marL="0">
+              <a:buNone/>
+            </a:pPr>
+            <a:r>
+              <a:rPr lang="en-US" sz="1800" b="1" dirty="0">
+                <a:solidFill>
+                  <a:srgbClr val="333333"/>
+                </a:solidFill>
+              </a:rPr>
+              <a:t>kalibrasi otomatis</a:t>
+            </a:r>
+            <a:pPr indent="0" marL="0">
+              <a:buNone/>
+            </a:pPr>
+            <a:r>
+              <a:rPr lang="en-US" sz="1800" dirty="0">
+                <a:solidFill>
+                  <a:srgbClr val="333333"/>
+                </a:solidFill>
+              </a:rPr>
+              <a:t> secara temporal.</a:t>
+            </a:r>
+            <a:endParaRPr lang="en-US" sz="1800" dirty="0"/>
+          </a:p>
+        </p:txBody>
+      </p:sp>
+    </p:spTree>
+  </p:cSld>
+  <p:clrMapOvr>
+    <a:masterClrMapping/>
+  </p:clrMapOvr>
+</p:sld>
+</file>
+
+<file path=ppt/slides/slide43.xml><?xml version="1.0" encoding="utf-8"?>
+<p:sld xmlns:a="http://schemas.openxmlformats.org/drawingml/2006/main" xmlns:r="http://schemas.openxmlformats.org/officeDocument/2006/relationships" xmlns:p="http://schemas.openxmlformats.org/presentationml/2006/main">
+  <p:cSld name="Slide 43">
     <p:spTree>
       <p:nvGrpSpPr>
         <p:cNvPr id="1" name=""/>

</xml_diff>

<commit_message>
feat: add noise boundary calculation slide for RMT
</commit_message>
<xml_diff>
--- a/Presentasi_Proposal_Update.pptx
+++ b/Presentasi_Proposal_Update.pptx
@@ -48,9 +48,10 @@
     <p:sldId id="296" r:id="rId42"/>
     <p:sldId id="297" r:id="rId43"/>
     <p:sldId id="298" r:id="rId44"/>
+    <p:sldId id="299" r:id="rId45"/>
   </p:sldIdLst>
   <p:notesMasterIdLst>
-    <p:notesMasterId r:id="rId45"/>
+    <p:notesMasterId r:id="rId46"/>
   </p:notesMasterIdLst>
   <p:sldSz cx="9144000" cy="5143500"/>
   <p:notesSz cx="5143500" cy="9144000"/>
@@ -3824,6 +3825,94 @@
             <a:fld id="{F7021451-1387-4CA6-816F-3879F97B5CBC}" type="slidenum">
               <a:rPr lang="en-US"/>
               <a:t>43</a:t>
+            </a:fld>
+            <a:endParaRPr lang="en-US"/>
+          </a:p>
+        </p:txBody>
+      </p:sp>
+    </p:spTree>
+    <p:extLst>
+      <p:ext uri="{BB962C8B-B14F-4D97-AF65-F5344CB8AC3E}">
+        <p14:creationId xmlns:p14="http://schemas.microsoft.com/office/powerpoint/2010/main" val="1024086991"/>
+      </p:ext>
+    </p:extLst>
+  </p:cSld>
+  <p:clrMapOvr>
+    <a:masterClrMapping/>
+  </p:clrMapOvr>
+</p:notes>
+</file>
+
+<file path=ppt/notesSlides/notesSlide44.xml><?xml version="1.0" encoding="utf-8"?>
+<p:notes xmlns:a="http://schemas.openxmlformats.org/drawingml/2006/main" xmlns:r="http://schemas.openxmlformats.org/officeDocument/2006/relationships" xmlns:p="http://schemas.openxmlformats.org/presentationml/2006/main">
+  <p:cSld>
+    <p:spTree>
+      <p:nvGrpSpPr>
+        <p:cNvPr id="1" name=""/>
+        <p:cNvGrpSpPr/>
+        <p:nvPr/>
+      </p:nvGrpSpPr>
+      <p:grpSpPr>
+        <a:xfrm>
+          <a:off x="0" y="0"/>
+          <a:ext cx="0" cy="0"/>
+          <a:chOff x="0" y="0"/>
+          <a:chExt cx="0" cy="0"/>
+        </a:xfrm>
+      </p:grpSpPr>
+      <p:sp>
+        <p:nvSpPr>
+          <p:cNvPr id="2" name="Slide Image Placeholder 1"/>
+          <p:cNvSpPr>
+            <a:spLocks noGrp="1" noRot="1" noChangeAspect="1"/>
+          </p:cNvSpPr>
+          <p:nvPr>
+            <p:ph type="sldImg"/>
+          </p:nvPr>
+        </p:nvSpPr>
+        <p:spPr/>
+      </p:sp>
+      <p:sp>
+        <p:nvSpPr>
+          <p:cNvPr id="3" name="Notes Placeholder 2"/>
+          <p:cNvSpPr>
+            <a:spLocks noGrp="1"/>
+          </p:cNvSpPr>
+          <p:nvPr>
+            <p:ph type="body" idx="1"/>
+          </p:nvPr>
+        </p:nvSpPr>
+        <p:spPr/>
+        <p:txBody>
+          <a:bodyPr/>
+          <a:lstStyle/>
+          <a:p>
+            <a:r>
+              <a:rPr lang="en-US" dirty="0"/>
+              <a:t/>
+            </a:r>
+            <a:endParaRPr lang="en-US" dirty="0"/>
+          </a:p>
+        </p:txBody>
+      </p:sp>
+      <p:sp>
+        <p:nvSpPr>
+          <p:cNvPr id="4" name="Slide Number Placeholder 3"/>
+          <p:cNvSpPr>
+            <a:spLocks noGrp="1"/>
+          </p:cNvSpPr>
+          <p:nvPr>
+            <p:ph type="sldNum" sz="quarter" idx="10"/>
+          </p:nvPr>
+        </p:nvSpPr>
+        <p:spPr/>
+        <p:txBody>
+          <a:bodyPr/>
+          <a:lstStyle/>
+          <a:p>
+            <a:fld id="{F7021451-1387-4CA6-816F-3879F97B5CBC}" type="slidenum">
+              <a:rPr lang="en-US"/>
+              <a:t>44</a:t>
             </a:fld>
             <a:endParaRPr lang="en-US"/>
           </a:p>
@@ -13034,14 +13123,14 @@
               <a:buNone/>
             </a:pPr>
             <a:r>
-              <a:rPr lang="en-US" sz="2600" b="1" dirty="0">
+              <a:rPr lang="en-US" sz="2400" b="1" dirty="0">
                 <a:solidFill>
                   <a:srgbClr val="003366"/>
                 </a:solidFill>
               </a:rPr>
-              <a:t>Lampiran: Dua Tipe Pendekatan Grid Search</a:t>
-            </a:r>
-            <a:endParaRPr lang="en-US" sz="2600" dirty="0"/>
+              <a:t>Lampiran: Cara Menghitung Batas Noise (λ_max)</a:t>
+            </a:r>
+            <a:endParaRPr lang="en-US" sz="2400" dirty="0"/>
           </a:p>
         </p:txBody>
       </p:sp>
@@ -13070,190 +13159,221 @@
               <a:buNone/>
             </a:pPr>
             <a:r>
-              <a:rPr lang="en-US" sz="1800" b="1" dirty="0">
-                <a:solidFill>
-                  <a:srgbClr val="333333"/>
-                </a:solidFill>
-              </a:rPr>
-              <a:t>Dua Objektif Optimasi (Return vs Risk):</a:t>
-            </a:r>
-            <a:endParaRPr lang="en-US" sz="1800" dirty="0"/>
-          </a:p>
-          <a:p>
-            <a:pPr indent="0" marL="0">
-              <a:buNone/>
-            </a:pPr>
-            <a:r>
-              <a:rPr lang="en-US" sz="1800" b="1" dirty="0">
+              <a:rPr lang="en-US" sz="1600" b="1" dirty="0">
+                <a:solidFill>
+                  <a:srgbClr val="333333"/>
+                </a:solidFill>
+              </a:rPr>
+              <a:t>Batas ini ditentukan menggunakan Distribusi Marchenko-Pastur:</a:t>
+            </a:r>
+            <a:endParaRPr lang="en-US" sz="1600" dirty="0"/>
+          </a:p>
+          <a:p>
+            <a:pPr indent="0" marL="0">
+              <a:buNone/>
+            </a:pPr>
+            <a:r>
+              <a:rPr lang="en-US" sz="1600" b="1" dirty="0">
+                <a:solidFill>
+                  <a:srgbClr val="C0392B"/>
+                </a:solidFill>
+                <a:latin typeface="Courier New" pitchFamily="34" charset="0"/>
+                <a:ea typeface="Courier New" pitchFamily="34" charset="-122"/>
+                <a:cs typeface="Courier New" pitchFamily="34" charset="-120"/>
+              </a:rPr>
+              <a:t>Rumus: λ_max = σ² × (1 + √(1/Q))²</a:t>
+            </a:r>
+            <a:endParaRPr lang="en-US" sz="1600" dirty="0"/>
+          </a:p>
+          <a:p>
+            <a:pPr indent="0" marL="0">
+              <a:buNone/>
+            </a:pPr>
+            <a:r>
+              <a:rPr lang="en-US" sz="1600" b="1" dirty="0">
+                <a:solidFill>
+                  <a:srgbClr val="003366"/>
+                </a:solidFill>
+              </a:rPr>
+              <a:t>Komponen Rasio Q:</a:t>
+            </a:r>
+            <a:endParaRPr lang="en-US" sz="1600" dirty="0"/>
+          </a:p>
+          <a:p>
+            <a:pPr indent="0" marL="0">
+              <a:buNone/>
+            </a:pPr>
+            <a:r>
+              <a:rPr lang="en-US" sz="1600" dirty="0">
+                <a:solidFill>
+                  <a:srgbClr val="333333"/>
+                </a:solidFill>
+                <a:latin typeface="Courier New" pitchFamily="34" charset="0"/>
+                <a:ea typeface="Courier New" pitchFamily="34" charset="-122"/>
+                <a:cs typeface="Courier New" pitchFamily="34" charset="-120"/>
+              </a:rPr>
+              <a:t>   • Q = T / N</a:t>
+            </a:r>
+            <a:endParaRPr lang="en-US" sz="1600" dirty="0"/>
+          </a:p>
+          <a:p>
+            <a:pPr indent="0" marL="0">
+              <a:buNone/>
+            </a:pPr>
+            <a:r>
+              <a:rPr lang="en-US" sz="1600" dirty="0">
+                <a:solidFill>
+                  <a:srgbClr val="333333"/>
+                </a:solidFill>
+              </a:rPr>
+              <a:t>   • T = Jumlah hari (Observasi)</a:t>
+            </a:r>
+            <a:endParaRPr lang="en-US" sz="1600" dirty="0"/>
+          </a:p>
+          <a:p>
+            <a:pPr indent="0" marL="0">
+              <a:buNone/>
+            </a:pPr>
+            <a:r>
+              <a:rPr lang="en-US" sz="1600" dirty="0">
+                <a:solidFill>
+                  <a:srgbClr val="333333"/>
+                </a:solidFill>
+              </a:rPr>
+              <a:t>   • N = Jumlah koin (Aset)</a:t>
+            </a:r>
+            <a:endParaRPr lang="en-US" sz="1600" dirty="0"/>
+          </a:p>
+          <a:p>
+            <a:pPr indent="0" marL="0">
+              <a:buNone/>
+            </a:pPr>
+            <a:r>
+              <a:rPr lang="en-US" sz="1600" b="1" dirty="0">
+                <a:solidFill>
+                  <a:srgbClr val="003366"/>
+                </a:solidFill>
+              </a:rPr>
+              <a:t>Contoh Simulasi:</a:t>
+            </a:r>
+            <a:endParaRPr lang="en-US" sz="1600" dirty="0"/>
+          </a:p>
+          <a:p>
+            <a:pPr indent="0" marL="0">
+              <a:buNone/>
+            </a:pPr>
+            <a:r>
+              <a:rPr lang="en-US" sz="1600" dirty="0">
+                <a:solidFill>
+                  <a:srgbClr val="333333"/>
+                </a:solidFill>
+              </a:rPr>
+              <a:t>   Kita punya data 10 koin (N=10) selama 1000 hari (T=1000).</a:t>
+            </a:r>
+            <a:endParaRPr lang="en-US" sz="1600" dirty="0"/>
+          </a:p>
+          <a:p>
+            <a:pPr indent="0" marL="0">
+              <a:buNone/>
+            </a:pPr>
+            <a:r>
+              <a:rPr lang="en-US" sz="1600" dirty="0">
+                <a:solidFill>
+                  <a:srgbClr val="333333"/>
+                </a:solidFill>
+              </a:rPr>
+              <a:t>   1. Hitung Q: 1000 / 10 = </a:t>
+            </a:r>
+            <a:pPr indent="0" marL="0">
+              <a:buNone/>
+            </a:pPr>
+            <a:r>
+              <a:rPr lang="en-US" sz="1600" b="1" dirty="0">
+                <a:solidFill>
+                  <a:srgbClr val="333333"/>
+                </a:solidFill>
+              </a:rPr>
+              <a:t>100</a:t>
+            </a:r>
+            <a:endParaRPr lang="en-US" sz="1600" dirty="0"/>
+          </a:p>
+          <a:p>
+            <a:pPr indent="0" marL="0">
+              <a:buNone/>
+            </a:pPr>
+            <a:r>
+              <a:rPr lang="en-US" sz="1600" dirty="0">
+                <a:solidFill>
+                  <a:srgbClr val="333333"/>
+                </a:solidFill>
+              </a:rPr>
+              <a:t>   2. Hitung Akar: √(1/100) = </a:t>
+            </a:r>
+            <a:pPr indent="0" marL="0">
+              <a:buNone/>
+            </a:pPr>
+            <a:r>
+              <a:rPr lang="en-US" sz="1600" b="1" dirty="0">
+                <a:solidFill>
+                  <a:srgbClr val="333333"/>
+                </a:solidFill>
+              </a:rPr>
+              <a:t>0.1</a:t>
+            </a:r>
+            <a:endParaRPr lang="en-US" sz="1600" dirty="0"/>
+          </a:p>
+          <a:p>
+            <a:pPr indent="0" marL="0">
+              <a:buNone/>
+            </a:pPr>
+            <a:r>
+              <a:rPr lang="en-US" sz="1600" dirty="0">
+                <a:solidFill>
+                  <a:srgbClr val="333333"/>
+                </a:solidFill>
+              </a:rPr>
+              <a:t>   3. Hitung λ_max: (1 + 0.1)² = 1.1² = </a:t>
+            </a:r>
+            <a:pPr indent="0" marL="0">
+              <a:buNone/>
+            </a:pPr>
+            <a:r>
+              <a:rPr lang="en-US" sz="1600" b="1" dirty="0">
                 <a:solidFill>
                   <a:srgbClr val="27AE60"/>
                 </a:solidFill>
               </a:rPr>
-              <a:t>1. Network Markowitz dengan Target Return (NW - Return Grid Search):</a:t>
-            </a:r>
-            <a:endParaRPr lang="en-US" sz="1800" dirty="0"/>
-          </a:p>
-          <a:p>
-            <a:pPr marL="342900" indent="-342900">
-              <a:buSzPct val="100000"/>
-              <a:buChar char="•"/>
-            </a:pPr>
-            <a:r>
-              <a:rPr lang="en-US" sz="1800" dirty="0">
-                <a:solidFill>
-                  <a:srgbClr val="333333"/>
-                </a:solidFill>
-              </a:rPr>
-              <a:t>Memaksimalkan capaian </a:t>
-            </a:r>
-            <a:pPr indent="0" marL="0">
-              <a:buNone/>
-            </a:pPr>
-            <a:r>
-              <a:rPr lang="en-US" sz="1800" b="1" dirty="0">
-                <a:solidFill>
-                  <a:srgbClr val="333333"/>
-                </a:solidFill>
-              </a:rPr>
-              <a:t>imbal hasil</a:t>
-            </a:r>
-            <a:pPr indent="0" marL="0">
-              <a:buNone/>
-            </a:pPr>
-            <a:r>
-              <a:rPr lang="en-US" sz="1800" dirty="0">
-                <a:solidFill>
-                  <a:srgbClr val="333333"/>
-                </a:solidFill>
-              </a:rPr>
-              <a:t> portofolio.</a:t>
-            </a:r>
-            <a:endParaRPr lang="en-US" sz="1800" dirty="0"/>
-          </a:p>
-          <a:p>
-            <a:pPr marL="342900" indent="-342900">
-              <a:buSzPct val="100000"/>
-              <a:buChar char="•"/>
-            </a:pPr>
-            <a:r>
-              <a:rPr lang="en-US" sz="1800" dirty="0">
-                <a:solidFill>
-                  <a:srgbClr val="333333"/>
-                </a:solidFill>
-              </a:rPr>
-              <a:t>Lebih Agresif untuk mengeksploitasi reli pada pasar </a:t>
-            </a:r>
-            <a:pPr indent="0" marL="0">
-              <a:buNone/>
-            </a:pPr>
-            <a:r>
-              <a:rPr lang="en-US" sz="1800" b="1" dirty="0">
-                <a:solidFill>
-                  <a:srgbClr val="333333"/>
-                </a:solidFill>
-              </a:rPr>
-              <a:t>Bullish</a:t>
-            </a:r>
-            <a:pPr indent="0" marL="0">
-              <a:buNone/>
-            </a:pPr>
-            <a:r>
-              <a:rPr lang="en-US" sz="1800" dirty="0">
-                <a:solidFill>
-                  <a:srgbClr val="333333"/>
-                </a:solidFill>
-              </a:rPr>
-              <a:t>.</a:t>
-            </a:r>
-            <a:endParaRPr lang="en-US" sz="1800" dirty="0"/>
-          </a:p>
-          <a:p>
-            <a:pPr indent="0" marL="0">
-              <a:buNone/>
-            </a:pPr>
-            <a:r>
-              <a:rPr lang="en-US" sz="1800" b="1" dirty="0">
-                <a:solidFill>
-                  <a:srgbClr val="C0392B"/>
-                </a:solidFill>
-              </a:rPr>
-              <a:t>2. Network Markowitz dengan Target Risiko (NW - Risk Grid Search):</a:t>
-            </a:r>
-            <a:endParaRPr lang="en-US" sz="1800" dirty="0"/>
-          </a:p>
-          <a:p>
-            <a:pPr marL="342900" indent="-342900">
-              <a:buSzPct val="100000"/>
-              <a:buChar char="•"/>
-            </a:pPr>
-            <a:r>
-              <a:rPr lang="en-US" sz="1800" dirty="0">
-                <a:solidFill>
-                  <a:srgbClr val="333333"/>
-                </a:solidFill>
-              </a:rPr>
-              <a:t>Menekan parameter </a:t>
-            </a:r>
-            <a:pPr indent="0" marL="0">
-              <a:buNone/>
-            </a:pPr>
-            <a:r>
-              <a:rPr lang="en-US" sz="1800" b="1" dirty="0">
-                <a:solidFill>
-                  <a:srgbClr val="333333"/>
-                </a:solidFill>
-              </a:rPr>
-              <a:t>risiko total</a:t>
-            </a:r>
-            <a:pPr indent="0" marL="0">
-              <a:buNone/>
-            </a:pPr>
-            <a:r>
-              <a:rPr lang="en-US" sz="1800" dirty="0">
-                <a:solidFill>
-                  <a:srgbClr val="333333"/>
-                </a:solidFill>
-              </a:rPr>
-              <a:t> hingga minimal.</a:t>
-            </a:r>
-            <a:endParaRPr lang="en-US" sz="1800" dirty="0"/>
-          </a:p>
-          <a:p>
-            <a:pPr marL="342900" indent="-342900">
-              <a:buSzPct val="100000"/>
-              <a:buChar char="•"/>
-            </a:pPr>
-            <a:r>
-              <a:rPr lang="en-US" sz="1800" dirty="0">
-                <a:solidFill>
-                  <a:srgbClr val="333333"/>
-                </a:solidFill>
-              </a:rPr>
-              <a:t>Lebih Defensif untuk meredam fluktuasi saat </a:t>
-            </a:r>
-            <a:pPr indent="0" marL="0">
-              <a:buNone/>
-            </a:pPr>
-            <a:r>
-              <a:rPr lang="en-US" sz="1800" b="1" dirty="0">
-                <a:solidFill>
-                  <a:srgbClr val="333333"/>
-                </a:solidFill>
-              </a:rPr>
-              <a:t>Crypto Winter</a:t>
-            </a:r>
-            <a:pPr indent="0" marL="0">
-              <a:buNone/>
-            </a:pPr>
-            <a:r>
-              <a:rPr lang="en-US" sz="1800" dirty="0">
-                <a:solidFill>
-                  <a:srgbClr val="333333"/>
-                </a:solidFill>
-              </a:rPr>
-              <a:t>.</a:t>
-            </a:r>
-            <a:endParaRPr lang="en-US" sz="1800" dirty="0"/>
+              <a:t>1.21</a:t>
+            </a:r>
+            <a:endParaRPr lang="en-US" sz="1600" dirty="0"/>
+          </a:p>
+          <a:p>
+            <a:pPr indent="0" marL="0">
+              <a:buNone/>
+            </a:pPr>
+            <a:r>
+              <a:rPr lang="en-US" sz="1600" b="1" dirty="0">
+                <a:solidFill>
+                  <a:srgbClr val="8E44AD"/>
+                </a:solidFill>
+              </a:rPr>
+              <a:t>Penerapan:</a:t>
+            </a:r>
+            <a:endParaRPr lang="en-US" sz="1600" dirty="0"/>
+          </a:p>
+          <a:p>
+            <a:pPr indent="0" marL="0">
+              <a:buNone/>
+            </a:pPr>
+            <a:r>
+              <a:rPr lang="en-US" sz="1600" i="1" dirty="0">
+                <a:solidFill>
+                  <a:srgbClr val="333333"/>
+                </a:solidFill>
+              </a:rPr>
+              <a:t>Setiap Nilai Eigen dari matriks korelasi yang nilainya di bawah 1.21 akan dianggap sebagai noise dan dibersihkan dari model.</a:t>
+            </a:r>
+            <a:endParaRPr lang="en-US" sz="1600" dirty="0"/>
           </a:p>
         </p:txBody>
       </p:sp>
@@ -13312,7 +13432,7 @@
                   <a:srgbClr val="003366"/>
                 </a:solidFill>
               </a:rPr>
-              <a:t>Lampiran: Penanganan Data Kosong (Missing Values)</a:t>
+              <a:t>Lampiran: Dua Tipe Pendekatan Grid Search</a:t>
             </a:r>
             <a:endParaRPr lang="en-US" sz="2600" dirty="0"/>
           </a:p>
@@ -13345,41 +13465,156 @@
             <a:r>
               <a:rPr lang="en-US" sz="1800" b="1" dirty="0">
                 <a:solidFill>
+                  <a:srgbClr val="333333"/>
+                </a:solidFill>
+              </a:rPr>
+              <a:t>Dua Objektif Optimasi (Return vs Risk):</a:t>
+            </a:r>
+            <a:endParaRPr lang="en-US" sz="1800" dirty="0"/>
+          </a:p>
+          <a:p>
+            <a:pPr indent="0" marL="0">
+              <a:buNone/>
+            </a:pPr>
+            <a:r>
+              <a:rPr lang="en-US" sz="1800" b="1" dirty="0">
+                <a:solidFill>
+                  <a:srgbClr val="27AE60"/>
+                </a:solidFill>
+              </a:rPr>
+              <a:t>1. Network Markowitz dengan Target Return (NW - Return Grid Search):</a:t>
+            </a:r>
+            <a:endParaRPr lang="en-US" sz="1800" dirty="0"/>
+          </a:p>
+          <a:p>
+            <a:pPr marL="342900" indent="-342900">
+              <a:buSzPct val="100000"/>
+              <a:buChar char="•"/>
+            </a:pPr>
+            <a:r>
+              <a:rPr lang="en-US" sz="1800" dirty="0">
+                <a:solidFill>
+                  <a:srgbClr val="333333"/>
+                </a:solidFill>
+              </a:rPr>
+              <a:t>Memaksimalkan capaian </a:t>
+            </a:r>
+            <a:pPr indent="0" marL="0">
+              <a:buNone/>
+            </a:pPr>
+            <a:r>
+              <a:rPr lang="en-US" sz="1800" b="1" dirty="0">
+                <a:solidFill>
+                  <a:srgbClr val="333333"/>
+                </a:solidFill>
+              </a:rPr>
+              <a:t>imbal hasil</a:t>
+            </a:r>
+            <a:pPr indent="0" marL="0">
+              <a:buNone/>
+            </a:pPr>
+            <a:r>
+              <a:rPr lang="en-US" sz="1800" dirty="0">
+                <a:solidFill>
+                  <a:srgbClr val="333333"/>
+                </a:solidFill>
+              </a:rPr>
+              <a:t> portofolio.</a:t>
+            </a:r>
+            <a:endParaRPr lang="en-US" sz="1800" dirty="0"/>
+          </a:p>
+          <a:p>
+            <a:pPr marL="342900" indent="-342900">
+              <a:buSzPct val="100000"/>
+              <a:buChar char="•"/>
+            </a:pPr>
+            <a:r>
+              <a:rPr lang="en-US" sz="1800" dirty="0">
+                <a:solidFill>
+                  <a:srgbClr val="333333"/>
+                </a:solidFill>
+              </a:rPr>
+              <a:t>Lebih Agresif untuk mengeksploitasi reli pada pasar </a:t>
+            </a:r>
+            <a:pPr indent="0" marL="0">
+              <a:buNone/>
+            </a:pPr>
+            <a:r>
+              <a:rPr lang="en-US" sz="1800" b="1" dirty="0">
+                <a:solidFill>
+                  <a:srgbClr val="333333"/>
+                </a:solidFill>
+              </a:rPr>
+              <a:t>Bullish</a:t>
+            </a:r>
+            <a:pPr indent="0" marL="0">
+              <a:buNone/>
+            </a:pPr>
+            <a:r>
+              <a:rPr lang="en-US" sz="1800" dirty="0">
+                <a:solidFill>
+                  <a:srgbClr val="333333"/>
+                </a:solidFill>
+              </a:rPr>
+              <a:t>.</a:t>
+            </a:r>
+            <a:endParaRPr lang="en-US" sz="1800" dirty="0"/>
+          </a:p>
+          <a:p>
+            <a:pPr indent="0" marL="0">
+              <a:buNone/>
+            </a:pPr>
+            <a:r>
+              <a:rPr lang="en-US" sz="1800" b="1" dirty="0">
+                <a:solidFill>
                   <a:srgbClr val="C0392B"/>
                 </a:solidFill>
               </a:rPr>
-              <a:t>Pertanyaan: </a:t>
-            </a:r>
-            <a:pPr indent="0" marL="0">
-              <a:buNone/>
-            </a:pPr>
-            <a:r>
-              <a:rPr lang="en-US" sz="1800" i="1" dirty="0">
-                <a:solidFill>
-                  <a:srgbClr val="333333"/>
-                </a:solidFill>
-              </a:rPr>
-              <a:t>"Beberapa koin seperti Binance/EOS belum rilis di awal 2017 sehingga datanya kosong. Bukankah backward-fill memalsukan harga dan merusak matriks?"</a:t>
+              <a:t>2. Network Markowitz dengan Target Risiko (NW - Risk Grid Search):</a:t>
             </a:r>
             <a:endParaRPr lang="en-US" sz="1800" dirty="0"/>
           </a:p>
           <a:p>
+            <a:pPr marL="342900" indent="-342900">
+              <a:buSzPct val="100000"/>
+              <a:buChar char="•"/>
+            </a:pPr>
+            <a:r>
+              <a:rPr lang="en-US" sz="1800" dirty="0">
+                <a:solidFill>
+                  <a:srgbClr val="333333"/>
+                </a:solidFill>
+              </a:rPr>
+              <a:t>Menekan parameter </a:t>
+            </a:r>
             <a:pPr indent="0" marL="0">
               <a:buNone/>
             </a:pPr>
             <a:r>
               <a:rPr lang="en-US" sz="1800" b="1" dirty="0">
                 <a:solidFill>
-                  <a:srgbClr val="27AE60"/>
-                </a:solidFill>
-              </a:rPr>
-              <a:t>Jawaban (Kenapa RMT sangat Krusial):</a:t>
+                  <a:srgbClr val="333333"/>
+                </a:solidFill>
+              </a:rPr>
+              <a:t>risiko total</a:t>
+            </a:r>
+            <a:pPr indent="0" marL="0">
+              <a:buNone/>
+            </a:pPr>
+            <a:r>
+              <a:rPr lang="en-US" sz="1800" dirty="0">
+                <a:solidFill>
+                  <a:srgbClr val="333333"/>
+                </a:solidFill>
+              </a:rPr>
+              <a:t> hingga minimal.</a:t>
             </a:r>
             <a:endParaRPr lang="en-US" sz="1800" dirty="0"/>
           </a:p>
           <a:p>
-            <a:pPr indent="0" marL="0">
-              <a:buNone/>
+            <a:pPr marL="342900" indent="-342900">
+              <a:buSzPct val="100000"/>
+              <a:buChar char="•"/>
             </a:pPr>
             <a:r>
               <a:rPr lang="en-US" sz="1800" dirty="0">
@@ -13387,18 +13622,18 @@
                   <a:srgbClr val="333333"/>
                 </a:solidFill>
               </a:rPr>
-              <a:t>   1. Praktik pengisian data diam (</a:t>
-            </a:r>
-            <a:pPr indent="0" marL="0">
-              <a:buNone/>
-            </a:pPr>
-            <a:r>
-              <a:rPr lang="en-US" sz="1800" b="1" i="1" dirty="0">
-                <a:solidFill>
-                  <a:srgbClr val="333333"/>
-                </a:solidFill>
-              </a:rPr>
-              <a:t>backward fill</a:t>
+              <a:t>Lebih Defensif untuk meredam fluktuasi saat </a:t>
+            </a:r>
+            <a:pPr indent="0" marL="0">
+              <a:buNone/>
+            </a:pPr>
+            <a:r>
+              <a:rPr lang="en-US" sz="1800" b="1" dirty="0">
+                <a:solidFill>
+                  <a:srgbClr val="333333"/>
+                </a:solidFill>
+              </a:rPr>
+              <a:t>Crypto Winter</a:t>
             </a:r>
             <a:pPr indent="0" marL="0">
               <a:buNone/>
@@ -13409,115 +13644,7 @@
                   <a:srgbClr val="333333"/>
                 </a:solidFill>
               </a:rPr>
-              <a:t>) memang menciptakan rentetan nilai harga yang statis.</a:t>
-            </a:r>
-            <a:endParaRPr lang="en-US" sz="1800" dirty="0"/>
-          </a:p>
-          <a:p>
-            <a:pPr indent="0" marL="0">
-              <a:buNone/>
-            </a:pPr>
-            <a:r>
-              <a:rPr lang="en-US" sz="1800" dirty="0">
-                <a:solidFill>
-                  <a:srgbClr val="333333"/>
-                </a:solidFill>
-              </a:rPr>
-              <a:t>   2. Namun, kehebatan </a:t>
-            </a:r>
-            <a:pPr indent="0" marL="0">
-              <a:buNone/>
-            </a:pPr>
-            <a:r>
-              <a:rPr lang="en-US" sz="1800" b="1" dirty="0">
-                <a:solidFill>
-                  <a:srgbClr val="333333"/>
-                </a:solidFill>
-              </a:rPr>
-              <a:t>Random Matrix Theory (RMT)</a:t>
-            </a:r>
-            <a:pPr indent="0" marL="0">
-              <a:buNone/>
-            </a:pPr>
-            <a:r>
-              <a:rPr lang="en-US" sz="1800" dirty="0">
-                <a:solidFill>
-                  <a:srgbClr val="333333"/>
-                </a:solidFill>
-              </a:rPr>
-              <a:t> diuji di sini! Karena data yang datar sama sekali tidak punya korelasi nyata.</a:t>
-            </a:r>
-            <a:endParaRPr lang="en-US" sz="1800" dirty="0"/>
-          </a:p>
-          <a:p>
-            <a:pPr indent="0" marL="0">
-              <a:buNone/>
-            </a:pPr>
-            <a:r>
-              <a:rPr lang="en-US" sz="1800" dirty="0">
-                <a:solidFill>
-                  <a:srgbClr val="333333"/>
-                </a:solidFill>
-              </a:rPr>
-              <a:t>   3. RMT otomatis akan mendeteksi korelasi buatan tersebut sebagai probabilitas </a:t>
-            </a:r>
-            <a:pPr indent="0" marL="0">
-              <a:buNone/>
-            </a:pPr>
-            <a:r>
-              <a:rPr lang="en-US" sz="1800" b="1" i="1" dirty="0">
-                <a:solidFill>
-                  <a:srgbClr val="333333"/>
-                </a:solidFill>
-              </a:rPr>
-              <a:t>Noise Acak</a:t>
-            </a:r>
-            <a:pPr indent="0" marL="0">
-              <a:buNone/>
-            </a:pPr>
-            <a:r>
-              <a:rPr lang="en-US" sz="1800" dirty="0">
-                <a:solidFill>
-                  <a:srgbClr val="333333"/>
-                </a:solidFill>
-              </a:rPr>
-              <a:t>, lalu membuangnya menjadi 0.</a:t>
-            </a:r>
-            <a:endParaRPr lang="en-US" sz="1800" dirty="0"/>
-          </a:p>
-          <a:p>
-            <a:pPr indent="0" marL="0">
-              <a:buNone/>
-            </a:pPr>
-            <a:r>
-              <a:rPr lang="en-US" sz="1800" dirty="0">
-                <a:solidFill>
-                  <a:srgbClr val="333333"/>
-                </a:solidFill>
-              </a:rPr>
-              <a:t>   4. Hasilnya, matriks korelasi </a:t>
-            </a:r>
-            <a:pPr indent="0" marL="0">
-              <a:buNone/>
-            </a:pPr>
-            <a:r>
-              <a:rPr lang="en-US" sz="1800" b="1" dirty="0">
-                <a:solidFill>
-                  <a:srgbClr val="333333"/>
-                </a:solidFill>
-              </a:rPr>
-              <a:t>terselamatkan</a:t>
-            </a:r>
-            <a:pPr indent="0" marL="0">
-              <a:buNone/>
-            </a:pPr>
-            <a:r>
-              <a:rPr lang="en-US" sz="1800" dirty="0">
-                <a:solidFill>
-                  <a:srgbClr val="333333"/>
-                </a:solidFill>
-              </a:rPr>
-              <a:t> dan tidak tercemar oleh cacat kelengkapan data.</a:t>
+              <a:t>.</a:t>
             </a:r>
             <a:endParaRPr lang="en-US" sz="1800" dirty="0"/>
           </a:p>
@@ -13927,7 +14054,7 @@
                   <a:srgbClr val="003366"/>
                 </a:solidFill>
               </a:rPr>
-              <a:t>Lampiran: Mengapa Menyertakan Tether (USDT)? (1/2)</a:t>
+              <a:t>Lampiran: Penanganan Data Kosong (Missing Values)</a:t>
             </a:r>
             <a:endParaRPr lang="en-US" sz="2600" dirty="0"/>
           </a:p>
@@ -13974,7 +14101,7 @@
                   <a:srgbClr val="333333"/>
                 </a:solidFill>
               </a:rPr>
-              <a:t>"Tether (USDT) itu stablecoin yang nilainya selalu fix ke 1 USD. Apakah tidak berbuat curang?"</a:t>
+              <a:t>"Beberapa koin seperti Binance/EOS belum rilis di awal 2017 sehingga datanya kosong. Bukankah backward-fill memalsukan harga dan merusak matriks?"</a:t>
             </a:r>
             <a:endParaRPr lang="en-US" sz="1800" dirty="0"/>
           </a:p>
@@ -13988,14 +14115,13 @@
                   <a:srgbClr val="27AE60"/>
                 </a:solidFill>
               </a:rPr>
-              <a:t>Jawaban (Dinamika Portofolio Cerdas):</a:t>
+              <a:t>Jawaban (Kenapa RMT sangat Krusial):</a:t>
             </a:r>
             <a:endParaRPr lang="en-US" sz="1800" dirty="0"/>
           </a:p>
           <a:p>
-            <a:pPr marL="342900" indent="-342900">
-              <a:buSzPct val="100000"/>
-              <a:buChar char="•"/>
+            <a:pPr indent="0" marL="0">
+              <a:buNone/>
             </a:pPr>
             <a:r>
               <a:rPr lang="en-US" sz="1800" dirty="0">
@@ -14003,7 +14129,7 @@
                   <a:srgbClr val="333333"/>
                 </a:solidFill>
               </a:rPr>
-              <a:t>Model ini mensimulasikan perilaku </a:t>
+              <a:t>   1. Praktik pengisian data diam (</a:t>
             </a:r>
             <a:pPr indent="0" marL="0">
               <a:buNone/>
@@ -14014,7 +14140,7 @@
                   <a:srgbClr val="333333"/>
                 </a:solidFill>
               </a:rPr>
-              <a:t>Robo-Advisory</a:t>
+              <a:t>backward fill</a:t>
             </a:r>
             <a:pPr indent="0" marL="0">
               <a:buNone/>
@@ -14025,14 +14151,13 @@
                   <a:srgbClr val="333333"/>
                 </a:solidFill>
               </a:rPr>
-              <a:t> institusional.</a:t>
+              <a:t>) memang menciptakan rentetan nilai harga yang statis.</a:t>
             </a:r>
             <a:endParaRPr lang="en-US" sz="1800" dirty="0"/>
           </a:p>
           <a:p>
-            <a:pPr marL="342900" indent="-342900">
-              <a:buSzPct val="100000"/>
-              <a:buChar char="•"/>
+            <a:pPr indent="0" marL="0">
+              <a:buNone/>
             </a:pPr>
             <a:r>
               <a:rPr lang="en-US" sz="1800" dirty="0">
@@ -14040,7 +14165,7 @@
                   <a:srgbClr val="333333"/>
                 </a:solidFill>
               </a:rPr>
-              <a:t>Ketika pasar anjlok ekstrem, investor akan melarikan senjatanya ke posisi </a:t>
+              <a:t>   2. Namun, kehebatan </a:t>
             </a:r>
             <a:pPr indent="0" marL="0">
               <a:buNone/>
@@ -14051,7 +14176,7 @@
                   <a:srgbClr val="333333"/>
                 </a:solidFill>
               </a:rPr>
-              <a:t>tunai (USDT)</a:t>
+              <a:t>Random Matrix Theory (RMT)</a:t>
             </a:r>
             <a:pPr indent="0" marL="0">
               <a:buNone/>
@@ -14062,7 +14187,79 @@
                   <a:srgbClr val="333333"/>
                 </a:solidFill>
               </a:rPr>
-              <a:t> sebagai evakuasi risiko.</a:t>
+              <a:t> diuji di sini! Karena data yang datar sama sekali tidak punya korelasi nyata.</a:t>
+            </a:r>
+            <a:endParaRPr lang="en-US" sz="1800" dirty="0"/>
+          </a:p>
+          <a:p>
+            <a:pPr indent="0" marL="0">
+              <a:buNone/>
+            </a:pPr>
+            <a:r>
+              <a:rPr lang="en-US" sz="1800" dirty="0">
+                <a:solidFill>
+                  <a:srgbClr val="333333"/>
+                </a:solidFill>
+              </a:rPr>
+              <a:t>   3. RMT otomatis akan mendeteksi korelasi buatan tersebut sebagai probabilitas </a:t>
+            </a:r>
+            <a:pPr indent="0" marL="0">
+              <a:buNone/>
+            </a:pPr>
+            <a:r>
+              <a:rPr lang="en-US" sz="1800" b="1" i="1" dirty="0">
+                <a:solidFill>
+                  <a:srgbClr val="333333"/>
+                </a:solidFill>
+              </a:rPr>
+              <a:t>Noise Acak</a:t>
+            </a:r>
+            <a:pPr indent="0" marL="0">
+              <a:buNone/>
+            </a:pPr>
+            <a:r>
+              <a:rPr lang="en-US" sz="1800" dirty="0">
+                <a:solidFill>
+                  <a:srgbClr val="333333"/>
+                </a:solidFill>
+              </a:rPr>
+              <a:t>, lalu membuangnya menjadi 0.</a:t>
+            </a:r>
+            <a:endParaRPr lang="en-US" sz="1800" dirty="0"/>
+          </a:p>
+          <a:p>
+            <a:pPr indent="0" marL="0">
+              <a:buNone/>
+            </a:pPr>
+            <a:r>
+              <a:rPr lang="en-US" sz="1800" dirty="0">
+                <a:solidFill>
+                  <a:srgbClr val="333333"/>
+                </a:solidFill>
+              </a:rPr>
+              <a:t>   4. Hasilnya, matriks korelasi </a:t>
+            </a:r>
+            <a:pPr indent="0" marL="0">
+              <a:buNone/>
+            </a:pPr>
+            <a:r>
+              <a:rPr lang="en-US" sz="1800" b="1" dirty="0">
+                <a:solidFill>
+                  <a:srgbClr val="333333"/>
+                </a:solidFill>
+              </a:rPr>
+              <a:t>terselamatkan</a:t>
+            </a:r>
+            <a:pPr indent="0" marL="0">
+              <a:buNone/>
+            </a:pPr>
+            <a:r>
+              <a:rPr lang="en-US" sz="1800" dirty="0">
+                <a:solidFill>
+                  <a:srgbClr val="333333"/>
+                </a:solidFill>
+              </a:rPr>
+              <a:t> dan tidak tercemar oleh cacat kelengkapan data.</a:t>
             </a:r>
             <a:endParaRPr lang="en-US" sz="1800" dirty="0"/>
           </a:p>
@@ -14123,7 +14320,7 @@
                   <a:srgbClr val="003366"/>
                 </a:solidFill>
               </a:rPr>
-              <a:t>Lampiran: Mengapa Menyertakan Tether (USDT)? (2/2)</a:t>
+              <a:t>Lampiran: Mengapa Menyertakan Tether (USDT)? (1/2)</a:t>
             </a:r>
             <a:endParaRPr lang="en-US" sz="2600" dirty="0"/>
           </a:p>
@@ -14154,12 +14351,89 @@
               <a:buNone/>
             </a:pPr>
             <a:r>
+              <a:rPr lang="en-US" sz="1800" b="1" dirty="0">
+                <a:solidFill>
+                  <a:srgbClr val="C0392B"/>
+                </a:solidFill>
+              </a:rPr>
+              <a:t>Pertanyaan: </a:t>
+            </a:r>
+            <a:pPr indent="0" marL="0">
+              <a:buNone/>
+            </a:pPr>
+            <a:r>
+              <a:rPr lang="en-US" sz="1800" i="1" dirty="0">
+                <a:solidFill>
+                  <a:srgbClr val="333333"/>
+                </a:solidFill>
+              </a:rPr>
+              <a:t>"Tether (USDT) itu stablecoin yang nilainya selalu fix ke 1 USD. Apakah tidak berbuat curang?"</a:t>
+            </a:r>
+            <a:endParaRPr lang="en-US" sz="1800" dirty="0"/>
+          </a:p>
+          <a:p>
+            <a:pPr indent="0" marL="0">
+              <a:buNone/>
+            </a:pPr>
+            <a:r>
+              <a:rPr lang="en-US" sz="1800" b="1" dirty="0">
+                <a:solidFill>
+                  <a:srgbClr val="27AE60"/>
+                </a:solidFill>
+              </a:rPr>
+              <a:t>Jawaban (Dinamika Portofolio Cerdas):</a:t>
+            </a:r>
+            <a:endParaRPr lang="en-US" sz="1800" dirty="0"/>
+          </a:p>
+          <a:p>
+            <a:pPr marL="342900" indent="-342900">
+              <a:buSzPct val="100000"/>
+              <a:buChar char="•"/>
+            </a:pPr>
+            <a:r>
               <a:rPr lang="en-US" sz="1800" dirty="0">
                 <a:solidFill>
                   <a:srgbClr val="333333"/>
                 </a:solidFill>
               </a:rPr>
-              <a:t>3. Algoritma jaringan </a:t>
+              <a:t>Model ini mensimulasikan perilaku </a:t>
+            </a:r>
+            <a:pPr indent="0" marL="0">
+              <a:buNone/>
+            </a:pPr>
+            <a:r>
+              <a:rPr lang="en-US" sz="1800" b="1" i="1" dirty="0">
+                <a:solidFill>
+                  <a:srgbClr val="333333"/>
+                </a:solidFill>
+              </a:rPr>
+              <a:t>Robo-Advisory</a:t>
+            </a:r>
+            <a:pPr indent="0" marL="0">
+              <a:buNone/>
+            </a:pPr>
+            <a:r>
+              <a:rPr lang="en-US" sz="1800" dirty="0">
+                <a:solidFill>
+                  <a:srgbClr val="333333"/>
+                </a:solidFill>
+              </a:rPr>
+              <a:t> institusional.</a:t>
+            </a:r>
+            <a:endParaRPr lang="en-US" sz="1800" dirty="0"/>
+          </a:p>
+          <a:p>
+            <a:pPr marL="342900" indent="-342900">
+              <a:buSzPct val="100000"/>
+              <a:buChar char="•"/>
+            </a:pPr>
+            <a:r>
+              <a:rPr lang="en-US" sz="1800" dirty="0">
+                <a:solidFill>
+                  <a:srgbClr val="333333"/>
+                </a:solidFill>
+              </a:rPr>
+              <a:t>Ketika pasar anjlok ekstrem, investor akan melarikan senjatanya ke posisi </a:t>
             </a:r>
             <a:pPr indent="0" marL="0">
               <a:buNone/>
@@ -14170,7 +14444,7 @@
                   <a:srgbClr val="333333"/>
                 </a:solidFill>
               </a:rPr>
-              <a:t>Network Markowitz GS (Grid Search)</a:t>
+              <a:t>tunai (USDT)</a:t>
             </a:r>
             <a:pPr indent="0" marL="0">
               <a:buNone/>
@@ -14181,87 +14455,7 @@
                   <a:srgbClr val="333333"/>
                 </a:solidFill>
               </a:rPr>
-              <a:t> dilatih secara matematis; jika mendeteksi korelasi ancaman kolaps merambat ke semua altcoin, ia akan melempar alokasi modalnya menuju node </a:t>
-            </a:r>
-            <a:pPr indent="0" marL="0">
-              <a:buNone/>
-            </a:pPr>
-            <a:r>
-              <a:rPr lang="en-US" sz="1800" b="1" dirty="0">
-                <a:solidFill>
-                  <a:srgbClr val="333333"/>
-                </a:solidFill>
-              </a:rPr>
-              <a:t>USDT (Tether)</a:t>
-            </a:r>
-            <a:pPr indent="0" marL="0">
-              <a:buNone/>
-            </a:pPr>
-            <a:r>
-              <a:rPr lang="en-US" sz="1800" dirty="0">
-                <a:solidFill>
-                  <a:srgbClr val="333333"/>
-                </a:solidFill>
-              </a:rPr>
-              <a:t> sebagai langkah </a:t>
-            </a:r>
-            <a:pPr indent="0" marL="0">
-              <a:buNone/>
-            </a:pPr>
-            <a:r>
-              <a:rPr lang="en-US" sz="1800" b="1" dirty="0">
-                <a:solidFill>
-                  <a:srgbClr val="333333"/>
-                </a:solidFill>
-              </a:rPr>
-              <a:t>evakuasi otomatis</a:t>
-            </a:r>
-            <a:pPr indent="0" marL="0">
-              <a:buNone/>
-            </a:pPr>
-            <a:r>
-              <a:rPr lang="en-US" sz="1800" dirty="0">
-                <a:solidFill>
-                  <a:srgbClr val="333333"/>
-                </a:solidFill>
-              </a:rPr>
-              <a:t> (Shock-Absorber).</a:t>
-            </a:r>
-            <a:endParaRPr lang="en-US" sz="1800" dirty="0"/>
-          </a:p>
-          <a:p>
-            <a:pPr indent="0" marL="0">
-              <a:buNone/>
-            </a:pPr>
-            <a:r>
-              <a:rPr lang="en-US" sz="1800" dirty="0">
-                <a:solidFill>
-                  <a:srgbClr val="333333"/>
-                </a:solidFill>
-              </a:rPr>
-              <a:t>   4. Hal ini yang membuat performa Risk-GS (Grid Search) sangat </a:t>
-            </a:r>
-            <a:pPr indent="0" marL="0">
-              <a:buNone/>
-            </a:pPr>
-            <a:r>
-              <a:rPr lang="en-US" sz="1800" b="1" dirty="0">
-                <a:solidFill>
-                  <a:srgbClr val="333333"/>
-                </a:solidFill>
-              </a:rPr>
-              <a:t>tangguh</a:t>
-            </a:r>
-            <a:pPr indent="0" marL="0">
-              <a:buNone/>
-            </a:pPr>
-            <a:r>
-              <a:rPr lang="en-US" sz="1800" dirty="0">
-                <a:solidFill>
-                  <a:srgbClr val="333333"/>
-                </a:solidFill>
-              </a:rPr>
-              <a:t> dari serangan Crypto Winter, suatu kapabilitas pertahanan yang tidak dipahami oleh model ortodoks murni Markowitz.</a:t>
+              <a:t> sebagai evakuasi risiko.</a:t>
             </a:r>
             <a:endParaRPr lang="en-US" sz="1800" dirty="0"/>
           </a:p>
@@ -14322,7 +14516,7 @@
                   <a:srgbClr val="003366"/>
                 </a:solidFill>
               </a:rPr>
-              <a:t>Lampiran: Bukti Empiris Non-Stationarity Pasar</a:t>
+              <a:t>Lampiran: Mengapa Menyertakan Tether (USDT)? (2/2)</a:t>
             </a:r>
             <a:endParaRPr lang="en-US" sz="2600" dirty="0"/>
           </a:p>
@@ -14353,23 +14547,78 @@
               <a:buNone/>
             </a:pPr>
             <a:r>
+              <a:rPr lang="en-US" sz="1800" dirty="0">
+                <a:solidFill>
+                  <a:srgbClr val="333333"/>
+                </a:solidFill>
+              </a:rPr>
+              <a:t>3. Algoritma jaringan </a:t>
+            </a:r>
+            <a:pPr indent="0" marL="0">
+              <a:buNone/>
+            </a:pPr>
+            <a:r>
               <a:rPr lang="en-US" sz="1800" b="1" dirty="0">
                 <a:solidFill>
-                  <a:srgbClr val="C0392B"/>
-                </a:solidFill>
-              </a:rPr>
-              <a:t>Masalah: </a:t>
-            </a:r>
-            <a:pPr indent="0" marL="0">
-              <a:buNone/>
-            </a:pPr>
-            <a:r>
-              <a:rPr lang="en-US" sz="1800" i="1" dirty="0">
-                <a:solidFill>
-                  <a:srgbClr val="333333"/>
-                </a:solidFill>
-              </a:rPr>
-              <a:t>Kenapa harus menggunakan model Adaptif (Dynamic Gamma)?</a:t>
+                  <a:srgbClr val="333333"/>
+                </a:solidFill>
+              </a:rPr>
+              <a:t>Network Markowitz GS (Grid Search)</a:t>
+            </a:r>
+            <a:pPr indent="0" marL="0">
+              <a:buNone/>
+            </a:pPr>
+            <a:r>
+              <a:rPr lang="en-US" sz="1800" dirty="0">
+                <a:solidFill>
+                  <a:srgbClr val="333333"/>
+                </a:solidFill>
+              </a:rPr>
+              <a:t> dilatih secara matematis; jika mendeteksi korelasi ancaman kolaps merambat ke semua altcoin, ia akan melempar alokasi modalnya menuju node </a:t>
+            </a:r>
+            <a:pPr indent="0" marL="0">
+              <a:buNone/>
+            </a:pPr>
+            <a:r>
+              <a:rPr lang="en-US" sz="1800" b="1" dirty="0">
+                <a:solidFill>
+                  <a:srgbClr val="333333"/>
+                </a:solidFill>
+              </a:rPr>
+              <a:t>USDT (Tether)</a:t>
+            </a:r>
+            <a:pPr indent="0" marL="0">
+              <a:buNone/>
+            </a:pPr>
+            <a:r>
+              <a:rPr lang="en-US" sz="1800" dirty="0">
+                <a:solidFill>
+                  <a:srgbClr val="333333"/>
+                </a:solidFill>
+              </a:rPr>
+              <a:t> sebagai langkah </a:t>
+            </a:r>
+            <a:pPr indent="0" marL="0">
+              <a:buNone/>
+            </a:pPr>
+            <a:r>
+              <a:rPr lang="en-US" sz="1800" b="1" dirty="0">
+                <a:solidFill>
+                  <a:srgbClr val="333333"/>
+                </a:solidFill>
+              </a:rPr>
+              <a:t>evakuasi otomatis</a:t>
+            </a:r>
+            <a:pPr indent="0" marL="0">
+              <a:buNone/>
+            </a:pPr>
+            <a:r>
+              <a:rPr lang="en-US" sz="1800" dirty="0">
+                <a:solidFill>
+                  <a:srgbClr val="333333"/>
+                </a:solidFill>
+              </a:rPr>
+              <a:t> (Shock-Absorber).</a:t>
             </a:r>
             <a:endParaRPr lang="en-US" sz="1800" dirty="0"/>
           </a:p>
@@ -14378,19 +14627,26 @@
               <a:buNone/>
             </a:pPr>
             <a:r>
+              <a:rPr lang="en-US" sz="1800" dirty="0">
+                <a:solidFill>
+                  <a:srgbClr val="333333"/>
+                </a:solidFill>
+              </a:rPr>
+              <a:t>   4. Hal ini yang membuat performa Risk-GS (Grid Search) sangat </a:t>
+            </a:r>
+            <a:pPr indent="0" marL="0">
+              <a:buNone/>
+            </a:pPr>
+            <a:r>
               <a:rPr lang="en-US" sz="1800" b="1" dirty="0">
                 <a:solidFill>
-                  <a:srgbClr val="27AE60"/>
-                </a:solidFill>
-              </a:rPr>
-              <a:t>Bukti dari Grid Search:</a:t>
-            </a:r>
-            <a:endParaRPr lang="en-US" sz="1800" dirty="0"/>
-          </a:p>
-          <a:p>
-            <a:pPr marL="342900" indent="-342900">
-              <a:buSzPct val="100000"/>
-              <a:buChar char="•"/>
+                  <a:srgbClr val="333333"/>
+                </a:solidFill>
+              </a:rPr>
+              <a:t>tangguh</a:t>
+            </a:r>
+            <a:pPr indent="0" marL="0">
+              <a:buNone/>
             </a:pPr>
             <a:r>
               <a:rPr lang="en-US" sz="1800" dirty="0">
@@ -14398,103 +14654,7 @@
                   <a:srgbClr val="333333"/>
                 </a:solidFill>
               </a:rPr>
-              <a:t>Data menunjukkan nilai Gamma (γ) optimal </a:t>
-            </a:r>
-            <a:pPr indent="0" marL="0">
-              <a:buNone/>
-            </a:pPr>
-            <a:r>
-              <a:rPr lang="en-US" sz="1800" b="1" dirty="0">
-                <a:solidFill>
-                  <a:srgbClr val="333333"/>
-                </a:solidFill>
-              </a:rPr>
-              <a:t>terus bergeser</a:t>
-            </a:r>
-            <a:pPr indent="0" marL="0">
-              <a:buNone/>
-            </a:pPr>
-            <a:r>
-              <a:rPr lang="en-US" sz="1800" dirty="0">
-                <a:solidFill>
-                  <a:srgbClr val="333333"/>
-                </a:solidFill>
-              </a:rPr>
-              <a:t> setiap periode rebalancing.</a:t>
-            </a:r>
-            <a:endParaRPr lang="en-US" sz="1800" dirty="0"/>
-          </a:p>
-          <a:p>
-            <a:pPr marL="342900" indent="-342900">
-              <a:buSzPct val="100000"/>
-              <a:buChar char="•"/>
-            </a:pPr>
-            <a:r>
-              <a:rPr lang="en-US" sz="1800" dirty="0">
-                <a:solidFill>
-                  <a:srgbClr val="333333"/>
-                </a:solidFill>
-              </a:rPr>
-              <a:t>Penggunaan γ statis tidak cukup untuk menangkap perubahan </a:t>
-            </a:r>
-            <a:pPr indent="0" marL="0">
-              <a:buNone/>
-            </a:pPr>
-            <a:r>
-              <a:rPr lang="en-US" sz="1800" b="1" dirty="0">
-                <a:solidFill>
-                  <a:srgbClr val="333333"/>
-                </a:solidFill>
-              </a:rPr>
-              <a:t>struktur korelasi</a:t>
-            </a:r>
-            <a:pPr indent="0" marL="0">
-              <a:buNone/>
-            </a:pPr>
-            <a:r>
-              <a:rPr lang="en-US" sz="1800" dirty="0">
-                <a:solidFill>
-                  <a:srgbClr val="333333"/>
-                </a:solidFill>
-              </a:rPr>
-              <a:t> yang sangat cepat di pasar kripto.</a:t>
-            </a:r>
-            <a:endParaRPr lang="en-US" sz="1800" dirty="0"/>
-          </a:p>
-          <a:p>
-            <a:pPr marL="342900" indent="-342900">
-              <a:buSzPct val="100000"/>
-              <a:buChar char="•"/>
-            </a:pPr>
-            <a:r>
-              <a:rPr lang="en-US" sz="1800" dirty="0">
-                <a:solidFill>
-                  <a:srgbClr val="333333"/>
-                </a:solidFill>
-              </a:rPr>
-              <a:t>Ini membenarkan bahwa pasar kripto membutuhkan </a:t>
-            </a:r>
-            <a:pPr indent="0" marL="0">
-              <a:buNone/>
-            </a:pPr>
-            <a:r>
-              <a:rPr lang="en-US" sz="1800" b="1" dirty="0">
-                <a:solidFill>
-                  <a:srgbClr val="333333"/>
-                </a:solidFill>
-              </a:rPr>
-              <a:t>kalibrasi otomatis</a:t>
-            </a:r>
-            <a:pPr indent="0" marL="0">
-              <a:buNone/>
-            </a:pPr>
-            <a:r>
-              <a:rPr lang="en-US" sz="1800" dirty="0">
-                <a:solidFill>
-                  <a:srgbClr val="333333"/>
-                </a:solidFill>
-              </a:rPr>
-              <a:t> secara temporal.</a:t>
+              <a:t> dari serangan Crypto Winter, suatu kapabilitas pertahanan yang tidak dipahami oleh model ortodoks murni Markowitz.</a:t>
             </a:r>
             <a:endParaRPr lang="en-US" sz="1800" dirty="0"/>
           </a:p>
@@ -14511,6 +14671,239 @@
 <file path=ppt/slides/slide43.xml><?xml version="1.0" encoding="utf-8"?>
 <p:sld xmlns:a="http://schemas.openxmlformats.org/drawingml/2006/main" xmlns:r="http://schemas.openxmlformats.org/officeDocument/2006/relationships" xmlns:p="http://schemas.openxmlformats.org/presentationml/2006/main">
   <p:cSld name="Slide 43">
+    <p:spTree>
+      <p:nvGrpSpPr>
+        <p:cNvPr id="1" name=""/>
+        <p:cNvGrpSpPr/>
+        <p:nvPr/>
+      </p:nvGrpSpPr>
+      <p:grpSpPr>
+        <a:xfrm>
+          <a:off x="0" y="0"/>
+          <a:ext cx="0" cy="0"/>
+          <a:chOff x="0" y="0"/>
+          <a:chExt cx="0" cy="0"/>
+        </a:xfrm>
+      </p:grpSpPr>
+      <p:sp>
+        <p:nvSpPr>
+          <p:cNvPr id="2" name="Text 0"/>
+          <p:cNvSpPr/>
+          <p:nvPr/>
+        </p:nvSpPr>
+        <p:spPr>
+          <a:xfrm>
+            <a:off x="457200" y="457200"/>
+            <a:ext cx="8229600" cy="0"/>
+          </a:xfrm>
+          <a:prstGeom prst="rect">
+            <a:avLst/>
+          </a:prstGeom>
+          <a:noFill/>
+          <a:ln/>
+        </p:spPr>
+        <p:txBody>
+          <a:bodyPr wrap="square" rtlCol="0" anchor="ctr"/>
+          <a:lstStyle/>
+          <a:p>
+            <a:pPr indent="0" marL="0">
+              <a:buNone/>
+            </a:pPr>
+            <a:r>
+              <a:rPr lang="en-US" sz="2600" b="1" dirty="0">
+                <a:solidFill>
+                  <a:srgbClr val="003366"/>
+                </a:solidFill>
+              </a:rPr>
+              <a:t>Lampiran: Bukti Empiris Non-Stationarity Pasar</a:t>
+            </a:r>
+            <a:endParaRPr lang="en-US" sz="2600" dirty="0"/>
+          </a:p>
+        </p:txBody>
+      </p:sp>
+      <p:sp>
+        <p:nvSpPr>
+          <p:cNvPr id="3" name="Text 1"/>
+          <p:cNvSpPr/>
+          <p:nvPr/>
+        </p:nvSpPr>
+        <p:spPr>
+          <a:xfrm>
+            <a:off x="457200" y="1005840"/>
+            <a:ext cx="8229600" cy="5029200"/>
+          </a:xfrm>
+          <a:prstGeom prst="rect">
+            <a:avLst/>
+          </a:prstGeom>
+          <a:noFill/>
+          <a:ln/>
+        </p:spPr>
+        <p:txBody>
+          <a:bodyPr wrap="square" rtlCol="0" anchor="t"/>
+          <a:lstStyle/>
+          <a:p>
+            <a:pPr indent="0" marL="0">
+              <a:buNone/>
+            </a:pPr>
+            <a:r>
+              <a:rPr lang="en-US" sz="1800" b="1" dirty="0">
+                <a:solidFill>
+                  <a:srgbClr val="C0392B"/>
+                </a:solidFill>
+              </a:rPr>
+              <a:t>Masalah: </a:t>
+            </a:r>
+            <a:pPr indent="0" marL="0">
+              <a:buNone/>
+            </a:pPr>
+            <a:r>
+              <a:rPr lang="en-US" sz="1800" i="1" dirty="0">
+                <a:solidFill>
+                  <a:srgbClr val="333333"/>
+                </a:solidFill>
+              </a:rPr>
+              <a:t>Kenapa harus menggunakan model Adaptif (Dynamic Gamma)?</a:t>
+            </a:r>
+            <a:endParaRPr lang="en-US" sz="1800" dirty="0"/>
+          </a:p>
+          <a:p>
+            <a:pPr indent="0" marL="0">
+              <a:buNone/>
+            </a:pPr>
+            <a:r>
+              <a:rPr lang="en-US" sz="1800" b="1" dirty="0">
+                <a:solidFill>
+                  <a:srgbClr val="27AE60"/>
+                </a:solidFill>
+              </a:rPr>
+              <a:t>Bukti dari Grid Search:</a:t>
+            </a:r>
+            <a:endParaRPr lang="en-US" sz="1800" dirty="0"/>
+          </a:p>
+          <a:p>
+            <a:pPr marL="342900" indent="-342900">
+              <a:buSzPct val="100000"/>
+              <a:buChar char="•"/>
+            </a:pPr>
+            <a:r>
+              <a:rPr lang="en-US" sz="1800" dirty="0">
+                <a:solidFill>
+                  <a:srgbClr val="333333"/>
+                </a:solidFill>
+              </a:rPr>
+              <a:t>Data menunjukkan nilai Gamma (γ) optimal </a:t>
+            </a:r>
+            <a:pPr indent="0" marL="0">
+              <a:buNone/>
+            </a:pPr>
+            <a:r>
+              <a:rPr lang="en-US" sz="1800" b="1" dirty="0">
+                <a:solidFill>
+                  <a:srgbClr val="333333"/>
+                </a:solidFill>
+              </a:rPr>
+              <a:t>terus bergeser</a:t>
+            </a:r>
+            <a:pPr indent="0" marL="0">
+              <a:buNone/>
+            </a:pPr>
+            <a:r>
+              <a:rPr lang="en-US" sz="1800" dirty="0">
+                <a:solidFill>
+                  <a:srgbClr val="333333"/>
+                </a:solidFill>
+              </a:rPr>
+              <a:t> setiap periode rebalancing.</a:t>
+            </a:r>
+            <a:endParaRPr lang="en-US" sz="1800" dirty="0"/>
+          </a:p>
+          <a:p>
+            <a:pPr marL="342900" indent="-342900">
+              <a:buSzPct val="100000"/>
+              <a:buChar char="•"/>
+            </a:pPr>
+            <a:r>
+              <a:rPr lang="en-US" sz="1800" dirty="0">
+                <a:solidFill>
+                  <a:srgbClr val="333333"/>
+                </a:solidFill>
+              </a:rPr>
+              <a:t>Penggunaan γ statis tidak cukup untuk menangkap perubahan </a:t>
+            </a:r>
+            <a:pPr indent="0" marL="0">
+              <a:buNone/>
+            </a:pPr>
+            <a:r>
+              <a:rPr lang="en-US" sz="1800" b="1" dirty="0">
+                <a:solidFill>
+                  <a:srgbClr val="333333"/>
+                </a:solidFill>
+              </a:rPr>
+              <a:t>struktur korelasi</a:t>
+            </a:r>
+            <a:pPr indent="0" marL="0">
+              <a:buNone/>
+            </a:pPr>
+            <a:r>
+              <a:rPr lang="en-US" sz="1800" dirty="0">
+                <a:solidFill>
+                  <a:srgbClr val="333333"/>
+                </a:solidFill>
+              </a:rPr>
+              <a:t> yang sangat cepat di pasar kripto.</a:t>
+            </a:r>
+            <a:endParaRPr lang="en-US" sz="1800" dirty="0"/>
+          </a:p>
+          <a:p>
+            <a:pPr marL="342900" indent="-342900">
+              <a:buSzPct val="100000"/>
+              <a:buChar char="•"/>
+            </a:pPr>
+            <a:r>
+              <a:rPr lang="en-US" sz="1800" dirty="0">
+                <a:solidFill>
+                  <a:srgbClr val="333333"/>
+                </a:solidFill>
+              </a:rPr>
+              <a:t>Ini membenarkan bahwa pasar kripto membutuhkan </a:t>
+            </a:r>
+            <a:pPr indent="0" marL="0">
+              <a:buNone/>
+            </a:pPr>
+            <a:r>
+              <a:rPr lang="en-US" sz="1800" b="1" dirty="0">
+                <a:solidFill>
+                  <a:srgbClr val="333333"/>
+                </a:solidFill>
+              </a:rPr>
+              <a:t>kalibrasi otomatis</a:t>
+            </a:r>
+            <a:pPr indent="0" marL="0">
+              <a:buNone/>
+            </a:pPr>
+            <a:r>
+              <a:rPr lang="en-US" sz="1800" dirty="0">
+                <a:solidFill>
+                  <a:srgbClr val="333333"/>
+                </a:solidFill>
+              </a:rPr>
+              <a:t> secara temporal.</a:t>
+            </a:r>
+            <a:endParaRPr lang="en-US" sz="1800" dirty="0"/>
+          </a:p>
+        </p:txBody>
+      </p:sp>
+    </p:spTree>
+  </p:cSld>
+  <p:clrMapOvr>
+    <a:masterClrMapping/>
+  </p:clrMapOvr>
+</p:sld>
+</file>
+
+<file path=ppt/slides/slide44.xml><?xml version="1.0" encoding="utf-8"?>
+<p:sld xmlns:a="http://schemas.openxmlformats.org/drawingml/2006/main" xmlns:r="http://schemas.openxmlformats.org/officeDocument/2006/relationships" xmlns:p="http://schemas.openxmlformats.org/presentationml/2006/main">
+  <p:cSld name="Slide 44">
     <p:spTree>
       <p:nvGrpSpPr>
         <p:cNvPr id="1" name=""/>

</xml_diff>

<commit_message>
feat: add MST construction example slide
</commit_message>
<xml_diff>
--- a/Presentasi_Proposal_Update.pptx
+++ b/Presentasi_Proposal_Update.pptx
@@ -49,9 +49,10 @@
     <p:sldId id="297" r:id="rId43"/>
     <p:sldId id="298" r:id="rId44"/>
     <p:sldId id="299" r:id="rId45"/>
+    <p:sldId id="300" r:id="rId46"/>
   </p:sldIdLst>
   <p:notesMasterIdLst>
-    <p:notesMasterId r:id="rId46"/>
+    <p:notesMasterId r:id="rId47"/>
   </p:notesMasterIdLst>
   <p:sldSz cx="9144000" cy="5143500"/>
   <p:notesSz cx="5143500" cy="9144000"/>
@@ -3913,6 +3914,94 @@
             <a:fld id="{F7021451-1387-4CA6-816F-3879F97B5CBC}" type="slidenum">
               <a:rPr lang="en-US"/>
               <a:t>44</a:t>
+            </a:fld>
+            <a:endParaRPr lang="en-US"/>
+          </a:p>
+        </p:txBody>
+      </p:sp>
+    </p:spTree>
+    <p:extLst>
+      <p:ext uri="{BB962C8B-B14F-4D97-AF65-F5344CB8AC3E}">
+        <p14:creationId xmlns:p14="http://schemas.microsoft.com/office/powerpoint/2010/main" val="1024086991"/>
+      </p:ext>
+    </p:extLst>
+  </p:cSld>
+  <p:clrMapOvr>
+    <a:masterClrMapping/>
+  </p:clrMapOvr>
+</p:notes>
+</file>
+
+<file path=ppt/notesSlides/notesSlide45.xml><?xml version="1.0" encoding="utf-8"?>
+<p:notes xmlns:a="http://schemas.openxmlformats.org/drawingml/2006/main" xmlns:r="http://schemas.openxmlformats.org/officeDocument/2006/relationships" xmlns:p="http://schemas.openxmlformats.org/presentationml/2006/main">
+  <p:cSld>
+    <p:spTree>
+      <p:nvGrpSpPr>
+        <p:cNvPr id="1" name=""/>
+        <p:cNvGrpSpPr/>
+        <p:nvPr/>
+      </p:nvGrpSpPr>
+      <p:grpSpPr>
+        <a:xfrm>
+          <a:off x="0" y="0"/>
+          <a:ext cx="0" cy="0"/>
+          <a:chOff x="0" y="0"/>
+          <a:chExt cx="0" cy="0"/>
+        </a:xfrm>
+      </p:grpSpPr>
+      <p:sp>
+        <p:nvSpPr>
+          <p:cNvPr id="2" name="Slide Image Placeholder 1"/>
+          <p:cNvSpPr>
+            <a:spLocks noGrp="1" noRot="1" noChangeAspect="1"/>
+          </p:cNvSpPr>
+          <p:nvPr>
+            <p:ph type="sldImg"/>
+          </p:nvPr>
+        </p:nvSpPr>
+        <p:spPr/>
+      </p:sp>
+      <p:sp>
+        <p:nvSpPr>
+          <p:cNvPr id="3" name="Notes Placeholder 2"/>
+          <p:cNvSpPr>
+            <a:spLocks noGrp="1"/>
+          </p:cNvSpPr>
+          <p:nvPr>
+            <p:ph type="body" idx="1"/>
+          </p:nvPr>
+        </p:nvSpPr>
+        <p:spPr/>
+        <p:txBody>
+          <a:bodyPr/>
+          <a:lstStyle/>
+          <a:p>
+            <a:r>
+              <a:rPr lang="en-US" dirty="0"/>
+              <a:t/>
+            </a:r>
+            <a:endParaRPr lang="en-US" dirty="0"/>
+          </a:p>
+        </p:txBody>
+      </p:sp>
+      <p:sp>
+        <p:nvSpPr>
+          <p:cNvPr id="4" name="Slide Number Placeholder 3"/>
+          <p:cNvSpPr>
+            <a:spLocks noGrp="1"/>
+          </p:cNvSpPr>
+          <p:nvPr>
+            <p:ph type="sldNum" sz="quarter" idx="10"/>
+          </p:nvPr>
+        </p:nvSpPr>
+        <p:spPr/>
+        <p:txBody>
+          <a:bodyPr/>
+          <a:lstStyle/>
+          <a:p>
+            <a:fld id="{F7021451-1387-4CA6-816F-3879F97B5CBC}" type="slidenum">
+              <a:rPr lang="en-US"/>
+              <a:t>45</a:t>
             </a:fld>
             <a:endParaRPr lang="en-US"/>
           </a:p>
@@ -13427,14 +13516,14 @@
               <a:buNone/>
             </a:pPr>
             <a:r>
-              <a:rPr lang="en-US" sz="2600" b="1" dirty="0">
+              <a:rPr lang="en-US" sz="2400" b="1" dirty="0">
                 <a:solidFill>
                   <a:srgbClr val="003366"/>
                 </a:solidFill>
               </a:rPr>
-              <a:t>Lampiran: Dua Tipe Pendekatan Grid Search</a:t>
-            </a:r>
-            <a:endParaRPr lang="en-US" sz="2600" dirty="0"/>
+              <a:t>Lampiran: Contoh Membangun MST (Network Mapping)</a:t>
+            </a:r>
+            <a:endParaRPr lang="en-US" sz="2400" dirty="0"/>
           </a:p>
         </p:txBody>
       </p:sp>
@@ -13463,190 +13552,201 @@
               <a:buNone/>
             </a:pPr>
             <a:r>
-              <a:rPr lang="en-US" sz="1800" b="1" dirty="0">
-                <a:solidFill>
-                  <a:srgbClr val="333333"/>
-                </a:solidFill>
-              </a:rPr>
-              <a:t>Dua Objektif Optimasi (Return vs Risk):</a:t>
-            </a:r>
-            <a:endParaRPr lang="en-US" sz="1800" dirty="0"/>
-          </a:p>
-          <a:p>
-            <a:pPr indent="0" marL="0">
-              <a:buNone/>
-            </a:pPr>
-            <a:r>
-              <a:rPr lang="en-US" sz="1800" b="1" dirty="0">
+              <a:rPr lang="en-US" sz="1600" b="1" dirty="0">
+                <a:solidFill>
+                  <a:srgbClr val="333333"/>
+                </a:solidFill>
+              </a:rPr>
+              <a:t>Bagaimana korelasi berubah menjadi peta jaringan?</a:t>
+            </a:r>
+            <a:endParaRPr lang="en-US" sz="1600" dirty="0"/>
+          </a:p>
+          <a:p>
+            <a:pPr indent="0" marL="0">
+              <a:buNone/>
+            </a:pPr>
+            <a:r>
+              <a:rPr lang="en-US" sz="1600" b="1" dirty="0">
+                <a:solidFill>
+                  <a:srgbClr val="003366"/>
+                </a:solidFill>
+              </a:rPr>
+              <a:t>1. Konversi Korelasi ke Jarak (Metric Distance):</a:t>
+            </a:r>
+            <a:endParaRPr lang="en-US" sz="1600" dirty="0"/>
+          </a:p>
+          <a:p>
+            <a:pPr indent="0" marL="0">
+              <a:buNone/>
+            </a:pPr>
+            <a:r>
+              <a:rPr lang="en-US" sz="1600" dirty="0">
+                <a:solidFill>
+                  <a:srgbClr val="333333"/>
+                </a:solidFill>
+              </a:rPr>
+              <a:t>   Semakin tinggi korelasi → Semakin dekat jaraknya (riferensi: Mantegna, 1999).</a:t>
+            </a:r>
+            <a:endParaRPr lang="en-US" sz="1600" dirty="0"/>
+          </a:p>
+          <a:p>
+            <a:pPr indent="0" marL="0">
+              <a:buNone/>
+            </a:pPr>
+            <a:r>
+              <a:rPr lang="en-US" sz="1600" dirty="0">
+                <a:solidFill>
+                  <a:srgbClr val="333333"/>
+                </a:solidFill>
+              </a:rPr>
+              <a:t>   • BTC - ETH (Korelasi 0.90) → Jarak: </a:t>
+            </a:r>
+            <a:pPr indent="0" marL="0">
+              <a:buNone/>
+            </a:pPr>
+            <a:r>
+              <a:rPr lang="en-US" sz="1600" b="1" dirty="0">
                 <a:solidFill>
                   <a:srgbClr val="27AE60"/>
                 </a:solidFill>
               </a:rPr>
-              <a:t>1. Network Markowitz dengan Target Return (NW - Return Grid Search):</a:t>
-            </a:r>
-            <a:endParaRPr lang="en-US" sz="1800" dirty="0"/>
-          </a:p>
-          <a:p>
-            <a:pPr marL="342900" indent="-342900">
-              <a:buSzPct val="100000"/>
-              <a:buChar char="•"/>
-            </a:pPr>
-            <a:r>
-              <a:rPr lang="en-US" sz="1800" dirty="0">
-                <a:solidFill>
-                  <a:srgbClr val="333333"/>
-                </a:solidFill>
-              </a:rPr>
-              <a:t>Memaksimalkan capaian </a:t>
-            </a:r>
-            <a:pPr indent="0" marL="0">
-              <a:buNone/>
-            </a:pPr>
-            <a:r>
-              <a:rPr lang="en-US" sz="1800" b="1" dirty="0">
-                <a:solidFill>
-                  <a:srgbClr val="333333"/>
-                </a:solidFill>
-              </a:rPr>
-              <a:t>imbal hasil</a:t>
-            </a:r>
-            <a:pPr indent="0" marL="0">
-              <a:buNone/>
-            </a:pPr>
-            <a:r>
-              <a:rPr lang="en-US" sz="1800" dirty="0">
-                <a:solidFill>
-                  <a:srgbClr val="333333"/>
-                </a:solidFill>
-              </a:rPr>
-              <a:t> portofolio.</a:t>
-            </a:r>
-            <a:endParaRPr lang="en-US" sz="1800" dirty="0"/>
-          </a:p>
-          <a:p>
-            <a:pPr marL="342900" indent="-342900">
-              <a:buSzPct val="100000"/>
-              <a:buChar char="•"/>
-            </a:pPr>
-            <a:r>
-              <a:rPr lang="en-US" sz="1800" dirty="0">
-                <a:solidFill>
-                  <a:srgbClr val="333333"/>
-                </a:solidFill>
-              </a:rPr>
-              <a:t>Lebih Agresif untuk mengeksploitasi reli pada pasar </a:t>
-            </a:r>
-            <a:pPr indent="0" marL="0">
-              <a:buNone/>
-            </a:pPr>
-            <a:r>
-              <a:rPr lang="en-US" sz="1800" b="1" dirty="0">
-                <a:solidFill>
-                  <a:srgbClr val="333333"/>
-                </a:solidFill>
-              </a:rPr>
-              <a:t>Bullish</a:t>
-            </a:r>
-            <a:pPr indent="0" marL="0">
-              <a:buNone/>
-            </a:pPr>
-            <a:r>
-              <a:rPr lang="en-US" sz="1800" dirty="0">
-                <a:solidFill>
-                  <a:srgbClr val="333333"/>
-                </a:solidFill>
-              </a:rPr>
-              <a:t>.</a:t>
-            </a:r>
-            <a:endParaRPr lang="en-US" sz="1800" dirty="0"/>
-          </a:p>
-          <a:p>
-            <a:pPr indent="0" marL="0">
-              <a:buNone/>
-            </a:pPr>
-            <a:r>
-              <a:rPr lang="en-US" sz="1800" b="1" dirty="0">
+              <a:t>0.45 (Sangat Dekat)</a:t>
+            </a:r>
+            <a:endParaRPr lang="en-US" sz="1600" dirty="0"/>
+          </a:p>
+          <a:p>
+            <a:pPr indent="0" marL="0">
+              <a:buNone/>
+            </a:pPr>
+            <a:r>
+              <a:rPr lang="en-US" sz="1600" dirty="0">
+                <a:solidFill>
+                  <a:srgbClr val="333333"/>
+                </a:solidFill>
+              </a:rPr>
+              <a:t>   • BTC - LTC (Korelasi 0.85) → Jarak: </a:t>
+            </a:r>
+            <a:pPr indent="0" marL="0">
+              <a:buNone/>
+            </a:pPr>
+            <a:r>
+              <a:rPr lang="en-US" sz="1600" b="1" dirty="0">
+                <a:solidFill>
+                  <a:srgbClr val="27AE60"/>
+                </a:solidFill>
+              </a:rPr>
+              <a:t>0.55 (Dekat)</a:t>
+            </a:r>
+            <a:endParaRPr lang="en-US" sz="1600" dirty="0"/>
+          </a:p>
+          <a:p>
+            <a:pPr indent="0" marL="0">
+              <a:buNone/>
+            </a:pPr>
+            <a:r>
+              <a:rPr lang="en-US" sz="1600" dirty="0">
+                <a:solidFill>
+                  <a:srgbClr val="333333"/>
+                </a:solidFill>
+              </a:rPr>
+              <a:t>   • ETH - XRP (Korelasi 0.40) → Jarak: </a:t>
+            </a:r>
+            <a:pPr indent="0" marL="0">
+              <a:buNone/>
+            </a:pPr>
+            <a:r>
+              <a:rPr lang="en-US" sz="1600" b="1" dirty="0">
                 <a:solidFill>
                   <a:srgbClr val="C0392B"/>
                 </a:solidFill>
               </a:rPr>
-              <a:t>2. Network Markowitz dengan Target Risiko (NW - Risk Grid Search):</a:t>
-            </a:r>
-            <a:endParaRPr lang="en-US" sz="1800" dirty="0"/>
-          </a:p>
-          <a:p>
-            <a:pPr marL="342900" indent="-342900">
-              <a:buSzPct val="100000"/>
-              <a:buChar char="•"/>
-            </a:pPr>
-            <a:r>
-              <a:rPr lang="en-US" sz="1800" dirty="0">
-                <a:solidFill>
-                  <a:srgbClr val="333333"/>
-                </a:solidFill>
-              </a:rPr>
-              <a:t>Menekan parameter </a:t>
-            </a:r>
-            <a:pPr indent="0" marL="0">
-              <a:buNone/>
-            </a:pPr>
-            <a:r>
-              <a:rPr lang="en-US" sz="1800" b="1" dirty="0">
-                <a:solidFill>
-                  <a:srgbClr val="333333"/>
-                </a:solidFill>
-              </a:rPr>
-              <a:t>risiko total</a:t>
-            </a:r>
-            <a:pPr indent="0" marL="0">
-              <a:buNone/>
-            </a:pPr>
-            <a:r>
-              <a:rPr lang="en-US" sz="1800" dirty="0">
-                <a:solidFill>
-                  <a:srgbClr val="333333"/>
-                </a:solidFill>
-              </a:rPr>
-              <a:t> hingga minimal.</a:t>
-            </a:r>
-            <a:endParaRPr lang="en-US" sz="1800" dirty="0"/>
-          </a:p>
-          <a:p>
-            <a:pPr marL="342900" indent="-342900">
-              <a:buSzPct val="100000"/>
-              <a:buChar char="•"/>
-            </a:pPr>
-            <a:r>
-              <a:rPr lang="en-US" sz="1800" dirty="0">
-                <a:solidFill>
-                  <a:srgbClr val="333333"/>
-                </a:solidFill>
-              </a:rPr>
-              <a:t>Lebih Defensif untuk meredam fluktuasi saat </a:t>
-            </a:r>
-            <a:pPr indent="0" marL="0">
-              <a:buNone/>
-            </a:pPr>
-            <a:r>
-              <a:rPr lang="en-US" sz="1800" b="1" dirty="0">
-                <a:solidFill>
-                  <a:srgbClr val="333333"/>
-                </a:solidFill>
-              </a:rPr>
-              <a:t>Crypto Winter</a:t>
-            </a:r>
-            <a:pPr indent="0" marL="0">
-              <a:buNone/>
-            </a:pPr>
-            <a:r>
-              <a:rPr lang="en-US" sz="1800" dirty="0">
-                <a:solidFill>
-                  <a:srgbClr val="333333"/>
-                </a:solidFill>
-              </a:rPr>
-              <a:t>.</a:t>
-            </a:r>
-            <a:endParaRPr lang="en-US" sz="1800" dirty="0"/>
+              <a:t>1.10 (Jauh)</a:t>
+            </a:r>
+            <a:endParaRPr lang="en-US" sz="1600" dirty="0"/>
+          </a:p>
+          <a:p>
+            <a:pPr indent="0" marL="0">
+              <a:buNone/>
+            </a:pPr>
+            <a:r>
+              <a:rPr lang="en-US" sz="1600" b="1" dirty="0">
+                <a:solidFill>
+                  <a:srgbClr val="003366"/>
+                </a:solidFill>
+              </a:rPr>
+              <a:t>2. Menghubungkan Titik (Kruskal's Algorithm):</a:t>
+            </a:r>
+            <a:endParaRPr lang="en-US" sz="1600" dirty="0"/>
+          </a:p>
+          <a:p>
+            <a:pPr indent="0" marL="0">
+              <a:buNone/>
+            </a:pPr>
+            <a:r>
+              <a:rPr lang="en-US" sz="1600" dirty="0">
+                <a:solidFill>
+                  <a:srgbClr val="333333"/>
+                </a:solidFill>
+              </a:rPr>
+              <a:t>   • Langkah 1: Hubungkan BTC &amp; ETH (Jalur Terkuat).</a:t>
+            </a:r>
+            <a:endParaRPr lang="en-US" sz="1600" dirty="0"/>
+          </a:p>
+          <a:p>
+            <a:pPr indent="0" marL="0">
+              <a:buNone/>
+            </a:pPr>
+            <a:r>
+              <a:rPr lang="en-US" sz="1600" dirty="0">
+                <a:solidFill>
+                  <a:srgbClr val="333333"/>
+                </a:solidFill>
+              </a:rPr>
+              <a:t>   • Langkah 2: Hubungkan BTC &amp; LTC (Jalur Kedua).</a:t>
+            </a:r>
+            <a:endParaRPr lang="en-US" sz="1600" dirty="0"/>
+          </a:p>
+          <a:p>
+            <a:pPr indent="0" marL="0">
+              <a:buNone/>
+            </a:pPr>
+            <a:r>
+              <a:rPr lang="en-US" sz="1600" dirty="0">
+                <a:solidFill>
+                  <a:srgbClr val="333333"/>
+                </a:solidFill>
+              </a:rPr>
+              <a:t>   • Langkah 3: Hubungkan ETH &amp; XRP (Jalur Ketiga).</a:t>
+            </a:r>
+            <a:endParaRPr lang="en-US" sz="1600" dirty="0"/>
+          </a:p>
+          <a:p>
+            <a:pPr indent="0" marL="0">
+              <a:buNone/>
+            </a:pPr>
+            <a:r>
+              <a:rPr lang="en-US" sz="1600" b="1" dirty="0">
+                <a:solidFill>
+                  <a:srgbClr val="8E44AD"/>
+                </a:solidFill>
+              </a:rPr>
+              <a:t>Ciri Khas MST:</a:t>
+            </a:r>
+            <a:endParaRPr lang="en-US" sz="1600" dirty="0"/>
+          </a:p>
+          <a:p>
+            <a:pPr indent="0" marL="0">
+              <a:buNone/>
+            </a:pPr>
+            <a:r>
+              <a:rPr lang="en-US" sz="1600" i="1" dirty="0">
+                <a:solidFill>
+                  <a:srgbClr val="333333"/>
+                </a:solidFill>
+              </a:rPr>
+              <a:t>Hanya menyisakan (N-1) koneksi terkuat dan dilarang membentuk loop. Di sini terlihat BTC menjadi 'Hub' karena ia yang menghubungkan banyak koin.</a:t>
+            </a:r>
+            <a:endParaRPr lang="en-US" sz="1600" dirty="0"/>
           </a:p>
         </p:txBody>
       </p:sp>
@@ -14054,7 +14154,7 @@
                   <a:srgbClr val="003366"/>
                 </a:solidFill>
               </a:rPr>
-              <a:t>Lampiran: Penanganan Data Kosong (Missing Values)</a:t>
+              <a:t>Lampiran: Dua Tipe Pendekatan Grid Search</a:t>
             </a:r>
             <a:endParaRPr lang="en-US" sz="2600" dirty="0"/>
           </a:p>
@@ -14087,41 +14187,156 @@
             <a:r>
               <a:rPr lang="en-US" sz="1800" b="1" dirty="0">
                 <a:solidFill>
+                  <a:srgbClr val="333333"/>
+                </a:solidFill>
+              </a:rPr>
+              <a:t>Dua Objektif Optimasi (Return vs Risk):</a:t>
+            </a:r>
+            <a:endParaRPr lang="en-US" sz="1800" dirty="0"/>
+          </a:p>
+          <a:p>
+            <a:pPr indent="0" marL="0">
+              <a:buNone/>
+            </a:pPr>
+            <a:r>
+              <a:rPr lang="en-US" sz="1800" b="1" dirty="0">
+                <a:solidFill>
+                  <a:srgbClr val="27AE60"/>
+                </a:solidFill>
+              </a:rPr>
+              <a:t>1. Network Markowitz dengan Target Return (NW - Return Grid Search):</a:t>
+            </a:r>
+            <a:endParaRPr lang="en-US" sz="1800" dirty="0"/>
+          </a:p>
+          <a:p>
+            <a:pPr marL="342900" indent="-342900">
+              <a:buSzPct val="100000"/>
+              <a:buChar char="•"/>
+            </a:pPr>
+            <a:r>
+              <a:rPr lang="en-US" sz="1800" dirty="0">
+                <a:solidFill>
+                  <a:srgbClr val="333333"/>
+                </a:solidFill>
+              </a:rPr>
+              <a:t>Memaksimalkan capaian </a:t>
+            </a:r>
+            <a:pPr indent="0" marL="0">
+              <a:buNone/>
+            </a:pPr>
+            <a:r>
+              <a:rPr lang="en-US" sz="1800" b="1" dirty="0">
+                <a:solidFill>
+                  <a:srgbClr val="333333"/>
+                </a:solidFill>
+              </a:rPr>
+              <a:t>imbal hasil</a:t>
+            </a:r>
+            <a:pPr indent="0" marL="0">
+              <a:buNone/>
+            </a:pPr>
+            <a:r>
+              <a:rPr lang="en-US" sz="1800" dirty="0">
+                <a:solidFill>
+                  <a:srgbClr val="333333"/>
+                </a:solidFill>
+              </a:rPr>
+              <a:t> portofolio.</a:t>
+            </a:r>
+            <a:endParaRPr lang="en-US" sz="1800" dirty="0"/>
+          </a:p>
+          <a:p>
+            <a:pPr marL="342900" indent="-342900">
+              <a:buSzPct val="100000"/>
+              <a:buChar char="•"/>
+            </a:pPr>
+            <a:r>
+              <a:rPr lang="en-US" sz="1800" dirty="0">
+                <a:solidFill>
+                  <a:srgbClr val="333333"/>
+                </a:solidFill>
+              </a:rPr>
+              <a:t>Lebih Agresif untuk mengeksploitasi reli pada pasar </a:t>
+            </a:r>
+            <a:pPr indent="0" marL="0">
+              <a:buNone/>
+            </a:pPr>
+            <a:r>
+              <a:rPr lang="en-US" sz="1800" b="1" dirty="0">
+                <a:solidFill>
+                  <a:srgbClr val="333333"/>
+                </a:solidFill>
+              </a:rPr>
+              <a:t>Bullish</a:t>
+            </a:r>
+            <a:pPr indent="0" marL="0">
+              <a:buNone/>
+            </a:pPr>
+            <a:r>
+              <a:rPr lang="en-US" sz="1800" dirty="0">
+                <a:solidFill>
+                  <a:srgbClr val="333333"/>
+                </a:solidFill>
+              </a:rPr>
+              <a:t>.</a:t>
+            </a:r>
+            <a:endParaRPr lang="en-US" sz="1800" dirty="0"/>
+          </a:p>
+          <a:p>
+            <a:pPr indent="0" marL="0">
+              <a:buNone/>
+            </a:pPr>
+            <a:r>
+              <a:rPr lang="en-US" sz="1800" b="1" dirty="0">
+                <a:solidFill>
                   <a:srgbClr val="C0392B"/>
                 </a:solidFill>
               </a:rPr>
-              <a:t>Pertanyaan: </a:t>
-            </a:r>
-            <a:pPr indent="0" marL="0">
-              <a:buNone/>
-            </a:pPr>
-            <a:r>
-              <a:rPr lang="en-US" sz="1800" i="1" dirty="0">
-                <a:solidFill>
-                  <a:srgbClr val="333333"/>
-                </a:solidFill>
-              </a:rPr>
-              <a:t>"Beberapa koin seperti Binance/EOS belum rilis di awal 2017 sehingga datanya kosong. Bukankah backward-fill memalsukan harga dan merusak matriks?"</a:t>
+              <a:t>2. Network Markowitz dengan Target Risiko (NW - Risk Grid Search):</a:t>
             </a:r>
             <a:endParaRPr lang="en-US" sz="1800" dirty="0"/>
           </a:p>
           <a:p>
+            <a:pPr marL="342900" indent="-342900">
+              <a:buSzPct val="100000"/>
+              <a:buChar char="•"/>
+            </a:pPr>
+            <a:r>
+              <a:rPr lang="en-US" sz="1800" dirty="0">
+                <a:solidFill>
+                  <a:srgbClr val="333333"/>
+                </a:solidFill>
+              </a:rPr>
+              <a:t>Menekan parameter </a:t>
+            </a:r>
             <a:pPr indent="0" marL="0">
               <a:buNone/>
             </a:pPr>
             <a:r>
               <a:rPr lang="en-US" sz="1800" b="1" dirty="0">
                 <a:solidFill>
-                  <a:srgbClr val="27AE60"/>
-                </a:solidFill>
-              </a:rPr>
-              <a:t>Jawaban (Kenapa RMT sangat Krusial):</a:t>
+                  <a:srgbClr val="333333"/>
+                </a:solidFill>
+              </a:rPr>
+              <a:t>risiko total</a:t>
+            </a:r>
+            <a:pPr indent="0" marL="0">
+              <a:buNone/>
+            </a:pPr>
+            <a:r>
+              <a:rPr lang="en-US" sz="1800" dirty="0">
+                <a:solidFill>
+                  <a:srgbClr val="333333"/>
+                </a:solidFill>
+              </a:rPr>
+              <a:t> hingga minimal.</a:t>
             </a:r>
             <a:endParaRPr lang="en-US" sz="1800" dirty="0"/>
           </a:p>
           <a:p>
-            <a:pPr indent="0" marL="0">
-              <a:buNone/>
+            <a:pPr marL="342900" indent="-342900">
+              <a:buSzPct val="100000"/>
+              <a:buChar char="•"/>
             </a:pPr>
             <a:r>
               <a:rPr lang="en-US" sz="1800" dirty="0">
@@ -14129,18 +14344,18 @@
                   <a:srgbClr val="333333"/>
                 </a:solidFill>
               </a:rPr>
-              <a:t>   1. Praktik pengisian data diam (</a:t>
-            </a:r>
-            <a:pPr indent="0" marL="0">
-              <a:buNone/>
-            </a:pPr>
-            <a:r>
-              <a:rPr lang="en-US" sz="1800" b="1" i="1" dirty="0">
-                <a:solidFill>
-                  <a:srgbClr val="333333"/>
-                </a:solidFill>
-              </a:rPr>
-              <a:t>backward fill</a:t>
+              <a:t>Lebih Defensif untuk meredam fluktuasi saat </a:t>
+            </a:r>
+            <a:pPr indent="0" marL="0">
+              <a:buNone/>
+            </a:pPr>
+            <a:r>
+              <a:rPr lang="en-US" sz="1800" b="1" dirty="0">
+                <a:solidFill>
+                  <a:srgbClr val="333333"/>
+                </a:solidFill>
+              </a:rPr>
+              <a:t>Crypto Winter</a:t>
             </a:r>
             <a:pPr indent="0" marL="0">
               <a:buNone/>
@@ -14151,115 +14366,7 @@
                   <a:srgbClr val="333333"/>
                 </a:solidFill>
               </a:rPr>
-              <a:t>) memang menciptakan rentetan nilai harga yang statis.</a:t>
-            </a:r>
-            <a:endParaRPr lang="en-US" sz="1800" dirty="0"/>
-          </a:p>
-          <a:p>
-            <a:pPr indent="0" marL="0">
-              <a:buNone/>
-            </a:pPr>
-            <a:r>
-              <a:rPr lang="en-US" sz="1800" dirty="0">
-                <a:solidFill>
-                  <a:srgbClr val="333333"/>
-                </a:solidFill>
-              </a:rPr>
-              <a:t>   2. Namun, kehebatan </a:t>
-            </a:r>
-            <a:pPr indent="0" marL="0">
-              <a:buNone/>
-            </a:pPr>
-            <a:r>
-              <a:rPr lang="en-US" sz="1800" b="1" dirty="0">
-                <a:solidFill>
-                  <a:srgbClr val="333333"/>
-                </a:solidFill>
-              </a:rPr>
-              <a:t>Random Matrix Theory (RMT)</a:t>
-            </a:r>
-            <a:pPr indent="0" marL="0">
-              <a:buNone/>
-            </a:pPr>
-            <a:r>
-              <a:rPr lang="en-US" sz="1800" dirty="0">
-                <a:solidFill>
-                  <a:srgbClr val="333333"/>
-                </a:solidFill>
-              </a:rPr>
-              <a:t> diuji di sini! Karena data yang datar sama sekali tidak punya korelasi nyata.</a:t>
-            </a:r>
-            <a:endParaRPr lang="en-US" sz="1800" dirty="0"/>
-          </a:p>
-          <a:p>
-            <a:pPr indent="0" marL="0">
-              <a:buNone/>
-            </a:pPr>
-            <a:r>
-              <a:rPr lang="en-US" sz="1800" dirty="0">
-                <a:solidFill>
-                  <a:srgbClr val="333333"/>
-                </a:solidFill>
-              </a:rPr>
-              <a:t>   3. RMT otomatis akan mendeteksi korelasi buatan tersebut sebagai probabilitas </a:t>
-            </a:r>
-            <a:pPr indent="0" marL="0">
-              <a:buNone/>
-            </a:pPr>
-            <a:r>
-              <a:rPr lang="en-US" sz="1800" b="1" i="1" dirty="0">
-                <a:solidFill>
-                  <a:srgbClr val="333333"/>
-                </a:solidFill>
-              </a:rPr>
-              <a:t>Noise Acak</a:t>
-            </a:r>
-            <a:pPr indent="0" marL="0">
-              <a:buNone/>
-            </a:pPr>
-            <a:r>
-              <a:rPr lang="en-US" sz="1800" dirty="0">
-                <a:solidFill>
-                  <a:srgbClr val="333333"/>
-                </a:solidFill>
-              </a:rPr>
-              <a:t>, lalu membuangnya menjadi 0.</a:t>
-            </a:r>
-            <a:endParaRPr lang="en-US" sz="1800" dirty="0"/>
-          </a:p>
-          <a:p>
-            <a:pPr indent="0" marL="0">
-              <a:buNone/>
-            </a:pPr>
-            <a:r>
-              <a:rPr lang="en-US" sz="1800" dirty="0">
-                <a:solidFill>
-                  <a:srgbClr val="333333"/>
-                </a:solidFill>
-              </a:rPr>
-              <a:t>   4. Hasilnya, matriks korelasi </a:t>
-            </a:r>
-            <a:pPr indent="0" marL="0">
-              <a:buNone/>
-            </a:pPr>
-            <a:r>
-              <a:rPr lang="en-US" sz="1800" b="1" dirty="0">
-                <a:solidFill>
-                  <a:srgbClr val="333333"/>
-                </a:solidFill>
-              </a:rPr>
-              <a:t>terselamatkan</a:t>
-            </a:r>
-            <a:pPr indent="0" marL="0">
-              <a:buNone/>
-            </a:pPr>
-            <a:r>
-              <a:rPr lang="en-US" sz="1800" dirty="0">
-                <a:solidFill>
-                  <a:srgbClr val="333333"/>
-                </a:solidFill>
-              </a:rPr>
-              <a:t> dan tidak tercemar oleh cacat kelengkapan data.</a:t>
+              <a:t>.</a:t>
             </a:r>
             <a:endParaRPr lang="en-US" sz="1800" dirty="0"/>
           </a:p>
@@ -14320,7 +14427,7 @@
                   <a:srgbClr val="003366"/>
                 </a:solidFill>
               </a:rPr>
-              <a:t>Lampiran: Mengapa Menyertakan Tether (USDT)? (1/2)</a:t>
+              <a:t>Lampiran: Penanganan Data Kosong (Missing Values)</a:t>
             </a:r>
             <a:endParaRPr lang="en-US" sz="2600" dirty="0"/>
           </a:p>
@@ -14367,7 +14474,7 @@
                   <a:srgbClr val="333333"/>
                 </a:solidFill>
               </a:rPr>
-              <a:t>"Tether (USDT) itu stablecoin yang nilainya selalu fix ke 1 USD. Apakah tidak berbuat curang?"</a:t>
+              <a:t>"Beberapa koin seperti Binance/EOS belum rilis di awal 2017 sehingga datanya kosong. Bukankah backward-fill memalsukan harga dan merusak matriks?"</a:t>
             </a:r>
             <a:endParaRPr lang="en-US" sz="1800" dirty="0"/>
           </a:p>
@@ -14381,14 +14488,13 @@
                   <a:srgbClr val="27AE60"/>
                 </a:solidFill>
               </a:rPr>
-              <a:t>Jawaban (Dinamika Portofolio Cerdas):</a:t>
+              <a:t>Jawaban (Kenapa RMT sangat Krusial):</a:t>
             </a:r>
             <a:endParaRPr lang="en-US" sz="1800" dirty="0"/>
           </a:p>
           <a:p>
-            <a:pPr marL="342900" indent="-342900">
-              <a:buSzPct val="100000"/>
-              <a:buChar char="•"/>
+            <a:pPr indent="0" marL="0">
+              <a:buNone/>
             </a:pPr>
             <a:r>
               <a:rPr lang="en-US" sz="1800" dirty="0">
@@ -14396,7 +14502,7 @@
                   <a:srgbClr val="333333"/>
                 </a:solidFill>
               </a:rPr>
-              <a:t>Model ini mensimulasikan perilaku </a:t>
+              <a:t>   1. Praktik pengisian data diam (</a:t>
             </a:r>
             <a:pPr indent="0" marL="0">
               <a:buNone/>
@@ -14407,7 +14513,7 @@
                   <a:srgbClr val="333333"/>
                 </a:solidFill>
               </a:rPr>
-              <a:t>Robo-Advisory</a:t>
+              <a:t>backward fill</a:t>
             </a:r>
             <a:pPr indent="0" marL="0">
               <a:buNone/>
@@ -14418,14 +14524,13 @@
                   <a:srgbClr val="333333"/>
                 </a:solidFill>
               </a:rPr>
-              <a:t> institusional.</a:t>
+              <a:t>) memang menciptakan rentetan nilai harga yang statis.</a:t>
             </a:r>
             <a:endParaRPr lang="en-US" sz="1800" dirty="0"/>
           </a:p>
           <a:p>
-            <a:pPr marL="342900" indent="-342900">
-              <a:buSzPct val="100000"/>
-              <a:buChar char="•"/>
+            <a:pPr indent="0" marL="0">
+              <a:buNone/>
             </a:pPr>
             <a:r>
               <a:rPr lang="en-US" sz="1800" dirty="0">
@@ -14433,7 +14538,7 @@
                   <a:srgbClr val="333333"/>
                 </a:solidFill>
               </a:rPr>
-              <a:t>Ketika pasar anjlok ekstrem, investor akan melarikan senjatanya ke posisi </a:t>
+              <a:t>   2. Namun, kehebatan </a:t>
             </a:r>
             <a:pPr indent="0" marL="0">
               <a:buNone/>
@@ -14444,7 +14549,7 @@
                   <a:srgbClr val="333333"/>
                 </a:solidFill>
               </a:rPr>
-              <a:t>tunai (USDT)</a:t>
+              <a:t>Random Matrix Theory (RMT)</a:t>
             </a:r>
             <a:pPr indent="0" marL="0">
               <a:buNone/>
@@ -14455,7 +14560,79 @@
                   <a:srgbClr val="333333"/>
                 </a:solidFill>
               </a:rPr>
-              <a:t> sebagai evakuasi risiko.</a:t>
+              <a:t> diuji di sini! Karena data yang datar sama sekali tidak punya korelasi nyata.</a:t>
+            </a:r>
+            <a:endParaRPr lang="en-US" sz="1800" dirty="0"/>
+          </a:p>
+          <a:p>
+            <a:pPr indent="0" marL="0">
+              <a:buNone/>
+            </a:pPr>
+            <a:r>
+              <a:rPr lang="en-US" sz="1800" dirty="0">
+                <a:solidFill>
+                  <a:srgbClr val="333333"/>
+                </a:solidFill>
+              </a:rPr>
+              <a:t>   3. RMT otomatis akan mendeteksi korelasi buatan tersebut sebagai probabilitas </a:t>
+            </a:r>
+            <a:pPr indent="0" marL="0">
+              <a:buNone/>
+            </a:pPr>
+            <a:r>
+              <a:rPr lang="en-US" sz="1800" b="1" i="1" dirty="0">
+                <a:solidFill>
+                  <a:srgbClr val="333333"/>
+                </a:solidFill>
+              </a:rPr>
+              <a:t>Noise Acak</a:t>
+            </a:r>
+            <a:pPr indent="0" marL="0">
+              <a:buNone/>
+            </a:pPr>
+            <a:r>
+              <a:rPr lang="en-US" sz="1800" dirty="0">
+                <a:solidFill>
+                  <a:srgbClr val="333333"/>
+                </a:solidFill>
+              </a:rPr>
+              <a:t>, lalu membuangnya menjadi 0.</a:t>
+            </a:r>
+            <a:endParaRPr lang="en-US" sz="1800" dirty="0"/>
+          </a:p>
+          <a:p>
+            <a:pPr indent="0" marL="0">
+              <a:buNone/>
+            </a:pPr>
+            <a:r>
+              <a:rPr lang="en-US" sz="1800" dirty="0">
+                <a:solidFill>
+                  <a:srgbClr val="333333"/>
+                </a:solidFill>
+              </a:rPr>
+              <a:t>   4. Hasilnya, matriks korelasi </a:t>
+            </a:r>
+            <a:pPr indent="0" marL="0">
+              <a:buNone/>
+            </a:pPr>
+            <a:r>
+              <a:rPr lang="en-US" sz="1800" b="1" dirty="0">
+                <a:solidFill>
+                  <a:srgbClr val="333333"/>
+                </a:solidFill>
+              </a:rPr>
+              <a:t>terselamatkan</a:t>
+            </a:r>
+            <a:pPr indent="0" marL="0">
+              <a:buNone/>
+            </a:pPr>
+            <a:r>
+              <a:rPr lang="en-US" sz="1800" dirty="0">
+                <a:solidFill>
+                  <a:srgbClr val="333333"/>
+                </a:solidFill>
+              </a:rPr>
+              <a:t> dan tidak tercemar oleh cacat kelengkapan data.</a:t>
             </a:r>
             <a:endParaRPr lang="en-US" sz="1800" dirty="0"/>
           </a:p>
@@ -14516,7 +14693,7 @@
                   <a:srgbClr val="003366"/>
                 </a:solidFill>
               </a:rPr>
-              <a:t>Lampiran: Mengapa Menyertakan Tether (USDT)? (2/2)</a:t>
+              <a:t>Lampiran: Mengapa Menyertakan Tether (USDT)? (1/2)</a:t>
             </a:r>
             <a:endParaRPr lang="en-US" sz="2600" dirty="0"/>
           </a:p>
@@ -14547,12 +14724,89 @@
               <a:buNone/>
             </a:pPr>
             <a:r>
+              <a:rPr lang="en-US" sz="1800" b="1" dirty="0">
+                <a:solidFill>
+                  <a:srgbClr val="C0392B"/>
+                </a:solidFill>
+              </a:rPr>
+              <a:t>Pertanyaan: </a:t>
+            </a:r>
+            <a:pPr indent="0" marL="0">
+              <a:buNone/>
+            </a:pPr>
+            <a:r>
+              <a:rPr lang="en-US" sz="1800" i="1" dirty="0">
+                <a:solidFill>
+                  <a:srgbClr val="333333"/>
+                </a:solidFill>
+              </a:rPr>
+              <a:t>"Tether (USDT) itu stablecoin yang nilainya selalu fix ke 1 USD. Apakah tidak berbuat curang?"</a:t>
+            </a:r>
+            <a:endParaRPr lang="en-US" sz="1800" dirty="0"/>
+          </a:p>
+          <a:p>
+            <a:pPr indent="0" marL="0">
+              <a:buNone/>
+            </a:pPr>
+            <a:r>
+              <a:rPr lang="en-US" sz="1800" b="1" dirty="0">
+                <a:solidFill>
+                  <a:srgbClr val="27AE60"/>
+                </a:solidFill>
+              </a:rPr>
+              <a:t>Jawaban (Dinamika Portofolio Cerdas):</a:t>
+            </a:r>
+            <a:endParaRPr lang="en-US" sz="1800" dirty="0"/>
+          </a:p>
+          <a:p>
+            <a:pPr marL="342900" indent="-342900">
+              <a:buSzPct val="100000"/>
+              <a:buChar char="•"/>
+            </a:pPr>
+            <a:r>
               <a:rPr lang="en-US" sz="1800" dirty="0">
                 <a:solidFill>
                   <a:srgbClr val="333333"/>
                 </a:solidFill>
               </a:rPr>
-              <a:t>3. Algoritma jaringan </a:t>
+              <a:t>Model ini mensimulasikan perilaku </a:t>
+            </a:r>
+            <a:pPr indent="0" marL="0">
+              <a:buNone/>
+            </a:pPr>
+            <a:r>
+              <a:rPr lang="en-US" sz="1800" b="1" i="1" dirty="0">
+                <a:solidFill>
+                  <a:srgbClr val="333333"/>
+                </a:solidFill>
+              </a:rPr>
+              <a:t>Robo-Advisory</a:t>
+            </a:r>
+            <a:pPr indent="0" marL="0">
+              <a:buNone/>
+            </a:pPr>
+            <a:r>
+              <a:rPr lang="en-US" sz="1800" dirty="0">
+                <a:solidFill>
+                  <a:srgbClr val="333333"/>
+                </a:solidFill>
+              </a:rPr>
+              <a:t> institusional.</a:t>
+            </a:r>
+            <a:endParaRPr lang="en-US" sz="1800" dirty="0"/>
+          </a:p>
+          <a:p>
+            <a:pPr marL="342900" indent="-342900">
+              <a:buSzPct val="100000"/>
+              <a:buChar char="•"/>
+            </a:pPr>
+            <a:r>
+              <a:rPr lang="en-US" sz="1800" dirty="0">
+                <a:solidFill>
+                  <a:srgbClr val="333333"/>
+                </a:solidFill>
+              </a:rPr>
+              <a:t>Ketika pasar anjlok ekstrem, investor akan melarikan senjatanya ke posisi </a:t>
             </a:r>
             <a:pPr indent="0" marL="0">
               <a:buNone/>
@@ -14563,7 +14817,7 @@
                   <a:srgbClr val="333333"/>
                 </a:solidFill>
               </a:rPr>
-              <a:t>Network Markowitz GS (Grid Search)</a:t>
+              <a:t>tunai (USDT)</a:t>
             </a:r>
             <a:pPr indent="0" marL="0">
               <a:buNone/>
@@ -14574,87 +14828,7 @@
                   <a:srgbClr val="333333"/>
                 </a:solidFill>
               </a:rPr>
-              <a:t> dilatih secara matematis; jika mendeteksi korelasi ancaman kolaps merambat ke semua altcoin, ia akan melempar alokasi modalnya menuju node </a:t>
-            </a:r>
-            <a:pPr indent="0" marL="0">
-              <a:buNone/>
-            </a:pPr>
-            <a:r>
-              <a:rPr lang="en-US" sz="1800" b="1" dirty="0">
-                <a:solidFill>
-                  <a:srgbClr val="333333"/>
-                </a:solidFill>
-              </a:rPr>
-              <a:t>USDT (Tether)</a:t>
-            </a:r>
-            <a:pPr indent="0" marL="0">
-              <a:buNone/>
-            </a:pPr>
-            <a:r>
-              <a:rPr lang="en-US" sz="1800" dirty="0">
-                <a:solidFill>
-                  <a:srgbClr val="333333"/>
-                </a:solidFill>
-              </a:rPr>
-              <a:t> sebagai langkah </a:t>
-            </a:r>
-            <a:pPr indent="0" marL="0">
-              <a:buNone/>
-            </a:pPr>
-            <a:r>
-              <a:rPr lang="en-US" sz="1800" b="1" dirty="0">
-                <a:solidFill>
-                  <a:srgbClr val="333333"/>
-                </a:solidFill>
-              </a:rPr>
-              <a:t>evakuasi otomatis</a:t>
-            </a:r>
-            <a:pPr indent="0" marL="0">
-              <a:buNone/>
-            </a:pPr>
-            <a:r>
-              <a:rPr lang="en-US" sz="1800" dirty="0">
-                <a:solidFill>
-                  <a:srgbClr val="333333"/>
-                </a:solidFill>
-              </a:rPr>
-              <a:t> (Shock-Absorber).</a:t>
-            </a:r>
-            <a:endParaRPr lang="en-US" sz="1800" dirty="0"/>
-          </a:p>
-          <a:p>
-            <a:pPr indent="0" marL="0">
-              <a:buNone/>
-            </a:pPr>
-            <a:r>
-              <a:rPr lang="en-US" sz="1800" dirty="0">
-                <a:solidFill>
-                  <a:srgbClr val="333333"/>
-                </a:solidFill>
-              </a:rPr>
-              <a:t>   4. Hal ini yang membuat performa Risk-GS (Grid Search) sangat </a:t>
-            </a:r>
-            <a:pPr indent="0" marL="0">
-              <a:buNone/>
-            </a:pPr>
-            <a:r>
-              <a:rPr lang="en-US" sz="1800" b="1" dirty="0">
-                <a:solidFill>
-                  <a:srgbClr val="333333"/>
-                </a:solidFill>
-              </a:rPr>
-              <a:t>tangguh</a:t>
-            </a:r>
-            <a:pPr indent="0" marL="0">
-              <a:buNone/>
-            </a:pPr>
-            <a:r>
-              <a:rPr lang="en-US" sz="1800" dirty="0">
-                <a:solidFill>
-                  <a:srgbClr val="333333"/>
-                </a:solidFill>
-              </a:rPr>
-              <a:t> dari serangan Crypto Winter, suatu kapabilitas pertahanan yang tidak dipahami oleh model ortodoks murni Markowitz.</a:t>
+              <a:t> sebagai evakuasi risiko.</a:t>
             </a:r>
             <a:endParaRPr lang="en-US" sz="1800" dirty="0"/>
           </a:p>
@@ -14715,7 +14889,7 @@
                   <a:srgbClr val="003366"/>
                 </a:solidFill>
               </a:rPr>
-              <a:t>Lampiran: Bukti Empiris Non-Stationarity Pasar</a:t>
+              <a:t>Lampiran: Mengapa Menyertakan Tether (USDT)? (2/2)</a:t>
             </a:r>
             <a:endParaRPr lang="en-US" sz="2600" dirty="0"/>
           </a:p>
@@ -14746,23 +14920,78 @@
               <a:buNone/>
             </a:pPr>
             <a:r>
+              <a:rPr lang="en-US" sz="1800" dirty="0">
+                <a:solidFill>
+                  <a:srgbClr val="333333"/>
+                </a:solidFill>
+              </a:rPr>
+              <a:t>3. Algoritma jaringan </a:t>
+            </a:r>
+            <a:pPr indent="0" marL="0">
+              <a:buNone/>
+            </a:pPr>
+            <a:r>
               <a:rPr lang="en-US" sz="1800" b="1" dirty="0">
                 <a:solidFill>
-                  <a:srgbClr val="C0392B"/>
-                </a:solidFill>
-              </a:rPr>
-              <a:t>Masalah: </a:t>
-            </a:r>
-            <a:pPr indent="0" marL="0">
-              <a:buNone/>
-            </a:pPr>
-            <a:r>
-              <a:rPr lang="en-US" sz="1800" i="1" dirty="0">
-                <a:solidFill>
-                  <a:srgbClr val="333333"/>
-                </a:solidFill>
-              </a:rPr>
-              <a:t>Kenapa harus menggunakan model Adaptif (Dynamic Gamma)?</a:t>
+                  <a:srgbClr val="333333"/>
+                </a:solidFill>
+              </a:rPr>
+              <a:t>Network Markowitz GS (Grid Search)</a:t>
+            </a:r>
+            <a:pPr indent="0" marL="0">
+              <a:buNone/>
+            </a:pPr>
+            <a:r>
+              <a:rPr lang="en-US" sz="1800" dirty="0">
+                <a:solidFill>
+                  <a:srgbClr val="333333"/>
+                </a:solidFill>
+              </a:rPr>
+              <a:t> dilatih secara matematis; jika mendeteksi korelasi ancaman kolaps merambat ke semua altcoin, ia akan melempar alokasi modalnya menuju node </a:t>
+            </a:r>
+            <a:pPr indent="0" marL="0">
+              <a:buNone/>
+            </a:pPr>
+            <a:r>
+              <a:rPr lang="en-US" sz="1800" b="1" dirty="0">
+                <a:solidFill>
+                  <a:srgbClr val="333333"/>
+                </a:solidFill>
+              </a:rPr>
+              <a:t>USDT (Tether)</a:t>
+            </a:r>
+            <a:pPr indent="0" marL="0">
+              <a:buNone/>
+            </a:pPr>
+            <a:r>
+              <a:rPr lang="en-US" sz="1800" dirty="0">
+                <a:solidFill>
+                  <a:srgbClr val="333333"/>
+                </a:solidFill>
+              </a:rPr>
+              <a:t> sebagai langkah </a:t>
+            </a:r>
+            <a:pPr indent="0" marL="0">
+              <a:buNone/>
+            </a:pPr>
+            <a:r>
+              <a:rPr lang="en-US" sz="1800" b="1" dirty="0">
+                <a:solidFill>
+                  <a:srgbClr val="333333"/>
+                </a:solidFill>
+              </a:rPr>
+              <a:t>evakuasi otomatis</a:t>
+            </a:r>
+            <a:pPr indent="0" marL="0">
+              <a:buNone/>
+            </a:pPr>
+            <a:r>
+              <a:rPr lang="en-US" sz="1800" dirty="0">
+                <a:solidFill>
+                  <a:srgbClr val="333333"/>
+                </a:solidFill>
+              </a:rPr>
+              <a:t> (Shock-Absorber).</a:t>
             </a:r>
             <a:endParaRPr lang="en-US" sz="1800" dirty="0"/>
           </a:p>
@@ -14771,19 +15000,26 @@
               <a:buNone/>
             </a:pPr>
             <a:r>
+              <a:rPr lang="en-US" sz="1800" dirty="0">
+                <a:solidFill>
+                  <a:srgbClr val="333333"/>
+                </a:solidFill>
+              </a:rPr>
+              <a:t>   4. Hal ini yang membuat performa Risk-GS (Grid Search) sangat </a:t>
+            </a:r>
+            <a:pPr indent="0" marL="0">
+              <a:buNone/>
+            </a:pPr>
+            <a:r>
               <a:rPr lang="en-US" sz="1800" b="1" dirty="0">
                 <a:solidFill>
-                  <a:srgbClr val="27AE60"/>
-                </a:solidFill>
-              </a:rPr>
-              <a:t>Bukti dari Grid Search:</a:t>
-            </a:r>
-            <a:endParaRPr lang="en-US" sz="1800" dirty="0"/>
-          </a:p>
-          <a:p>
-            <a:pPr marL="342900" indent="-342900">
-              <a:buSzPct val="100000"/>
-              <a:buChar char="•"/>
+                  <a:srgbClr val="333333"/>
+                </a:solidFill>
+              </a:rPr>
+              <a:t>tangguh</a:t>
+            </a:r>
+            <a:pPr indent="0" marL="0">
+              <a:buNone/>
             </a:pPr>
             <a:r>
               <a:rPr lang="en-US" sz="1800" dirty="0">
@@ -14791,103 +15027,7 @@
                   <a:srgbClr val="333333"/>
                 </a:solidFill>
               </a:rPr>
-              <a:t>Data menunjukkan nilai Gamma (γ) optimal </a:t>
-            </a:r>
-            <a:pPr indent="0" marL="0">
-              <a:buNone/>
-            </a:pPr>
-            <a:r>
-              <a:rPr lang="en-US" sz="1800" b="1" dirty="0">
-                <a:solidFill>
-                  <a:srgbClr val="333333"/>
-                </a:solidFill>
-              </a:rPr>
-              <a:t>terus bergeser</a:t>
-            </a:r>
-            <a:pPr indent="0" marL="0">
-              <a:buNone/>
-            </a:pPr>
-            <a:r>
-              <a:rPr lang="en-US" sz="1800" dirty="0">
-                <a:solidFill>
-                  <a:srgbClr val="333333"/>
-                </a:solidFill>
-              </a:rPr>
-              <a:t> setiap periode rebalancing.</a:t>
-            </a:r>
-            <a:endParaRPr lang="en-US" sz="1800" dirty="0"/>
-          </a:p>
-          <a:p>
-            <a:pPr marL="342900" indent="-342900">
-              <a:buSzPct val="100000"/>
-              <a:buChar char="•"/>
-            </a:pPr>
-            <a:r>
-              <a:rPr lang="en-US" sz="1800" dirty="0">
-                <a:solidFill>
-                  <a:srgbClr val="333333"/>
-                </a:solidFill>
-              </a:rPr>
-              <a:t>Penggunaan γ statis tidak cukup untuk menangkap perubahan </a:t>
-            </a:r>
-            <a:pPr indent="0" marL="0">
-              <a:buNone/>
-            </a:pPr>
-            <a:r>
-              <a:rPr lang="en-US" sz="1800" b="1" dirty="0">
-                <a:solidFill>
-                  <a:srgbClr val="333333"/>
-                </a:solidFill>
-              </a:rPr>
-              <a:t>struktur korelasi</a:t>
-            </a:r>
-            <a:pPr indent="0" marL="0">
-              <a:buNone/>
-            </a:pPr>
-            <a:r>
-              <a:rPr lang="en-US" sz="1800" dirty="0">
-                <a:solidFill>
-                  <a:srgbClr val="333333"/>
-                </a:solidFill>
-              </a:rPr>
-              <a:t> yang sangat cepat di pasar kripto.</a:t>
-            </a:r>
-            <a:endParaRPr lang="en-US" sz="1800" dirty="0"/>
-          </a:p>
-          <a:p>
-            <a:pPr marL="342900" indent="-342900">
-              <a:buSzPct val="100000"/>
-              <a:buChar char="•"/>
-            </a:pPr>
-            <a:r>
-              <a:rPr lang="en-US" sz="1800" dirty="0">
-                <a:solidFill>
-                  <a:srgbClr val="333333"/>
-                </a:solidFill>
-              </a:rPr>
-              <a:t>Ini membenarkan bahwa pasar kripto membutuhkan </a:t>
-            </a:r>
-            <a:pPr indent="0" marL="0">
-              <a:buNone/>
-            </a:pPr>
-            <a:r>
-              <a:rPr lang="en-US" sz="1800" b="1" dirty="0">
-                <a:solidFill>
-                  <a:srgbClr val="333333"/>
-                </a:solidFill>
-              </a:rPr>
-              <a:t>kalibrasi otomatis</a:t>
-            </a:r>
-            <a:pPr indent="0" marL="0">
-              <a:buNone/>
-            </a:pPr>
-            <a:r>
-              <a:rPr lang="en-US" sz="1800" dirty="0">
-                <a:solidFill>
-                  <a:srgbClr val="333333"/>
-                </a:solidFill>
-              </a:rPr>
-              <a:t> secara temporal.</a:t>
+              <a:t> dari serangan Crypto Winter, suatu kapabilitas pertahanan yang tidak dipahami oleh model ortodoks murni Markowitz.</a:t>
             </a:r>
             <a:endParaRPr lang="en-US" sz="1800" dirty="0"/>
           </a:p>
@@ -14904,6 +15044,239 @@
 <file path=ppt/slides/slide44.xml><?xml version="1.0" encoding="utf-8"?>
 <p:sld xmlns:a="http://schemas.openxmlformats.org/drawingml/2006/main" xmlns:r="http://schemas.openxmlformats.org/officeDocument/2006/relationships" xmlns:p="http://schemas.openxmlformats.org/presentationml/2006/main">
   <p:cSld name="Slide 44">
+    <p:spTree>
+      <p:nvGrpSpPr>
+        <p:cNvPr id="1" name=""/>
+        <p:cNvGrpSpPr/>
+        <p:nvPr/>
+      </p:nvGrpSpPr>
+      <p:grpSpPr>
+        <a:xfrm>
+          <a:off x="0" y="0"/>
+          <a:ext cx="0" cy="0"/>
+          <a:chOff x="0" y="0"/>
+          <a:chExt cx="0" cy="0"/>
+        </a:xfrm>
+      </p:grpSpPr>
+      <p:sp>
+        <p:nvSpPr>
+          <p:cNvPr id="2" name="Text 0"/>
+          <p:cNvSpPr/>
+          <p:nvPr/>
+        </p:nvSpPr>
+        <p:spPr>
+          <a:xfrm>
+            <a:off x="457200" y="457200"/>
+            <a:ext cx="8229600" cy="0"/>
+          </a:xfrm>
+          <a:prstGeom prst="rect">
+            <a:avLst/>
+          </a:prstGeom>
+          <a:noFill/>
+          <a:ln/>
+        </p:spPr>
+        <p:txBody>
+          <a:bodyPr wrap="square" rtlCol="0" anchor="ctr"/>
+          <a:lstStyle/>
+          <a:p>
+            <a:pPr indent="0" marL="0">
+              <a:buNone/>
+            </a:pPr>
+            <a:r>
+              <a:rPr lang="en-US" sz="2600" b="1" dirty="0">
+                <a:solidFill>
+                  <a:srgbClr val="003366"/>
+                </a:solidFill>
+              </a:rPr>
+              <a:t>Lampiran: Bukti Empiris Non-Stationarity Pasar</a:t>
+            </a:r>
+            <a:endParaRPr lang="en-US" sz="2600" dirty="0"/>
+          </a:p>
+        </p:txBody>
+      </p:sp>
+      <p:sp>
+        <p:nvSpPr>
+          <p:cNvPr id="3" name="Text 1"/>
+          <p:cNvSpPr/>
+          <p:nvPr/>
+        </p:nvSpPr>
+        <p:spPr>
+          <a:xfrm>
+            <a:off x="457200" y="1005840"/>
+            <a:ext cx="8229600" cy="5029200"/>
+          </a:xfrm>
+          <a:prstGeom prst="rect">
+            <a:avLst/>
+          </a:prstGeom>
+          <a:noFill/>
+          <a:ln/>
+        </p:spPr>
+        <p:txBody>
+          <a:bodyPr wrap="square" rtlCol="0" anchor="t"/>
+          <a:lstStyle/>
+          <a:p>
+            <a:pPr indent="0" marL="0">
+              <a:buNone/>
+            </a:pPr>
+            <a:r>
+              <a:rPr lang="en-US" sz="1800" b="1" dirty="0">
+                <a:solidFill>
+                  <a:srgbClr val="C0392B"/>
+                </a:solidFill>
+              </a:rPr>
+              <a:t>Masalah: </a:t>
+            </a:r>
+            <a:pPr indent="0" marL="0">
+              <a:buNone/>
+            </a:pPr>
+            <a:r>
+              <a:rPr lang="en-US" sz="1800" i="1" dirty="0">
+                <a:solidFill>
+                  <a:srgbClr val="333333"/>
+                </a:solidFill>
+              </a:rPr>
+              <a:t>Kenapa harus menggunakan model Adaptif (Dynamic Gamma)?</a:t>
+            </a:r>
+            <a:endParaRPr lang="en-US" sz="1800" dirty="0"/>
+          </a:p>
+          <a:p>
+            <a:pPr indent="0" marL="0">
+              <a:buNone/>
+            </a:pPr>
+            <a:r>
+              <a:rPr lang="en-US" sz="1800" b="1" dirty="0">
+                <a:solidFill>
+                  <a:srgbClr val="27AE60"/>
+                </a:solidFill>
+              </a:rPr>
+              <a:t>Bukti dari Grid Search:</a:t>
+            </a:r>
+            <a:endParaRPr lang="en-US" sz="1800" dirty="0"/>
+          </a:p>
+          <a:p>
+            <a:pPr marL="342900" indent="-342900">
+              <a:buSzPct val="100000"/>
+              <a:buChar char="•"/>
+            </a:pPr>
+            <a:r>
+              <a:rPr lang="en-US" sz="1800" dirty="0">
+                <a:solidFill>
+                  <a:srgbClr val="333333"/>
+                </a:solidFill>
+              </a:rPr>
+              <a:t>Data menunjukkan nilai Gamma (γ) optimal </a:t>
+            </a:r>
+            <a:pPr indent="0" marL="0">
+              <a:buNone/>
+            </a:pPr>
+            <a:r>
+              <a:rPr lang="en-US" sz="1800" b="1" dirty="0">
+                <a:solidFill>
+                  <a:srgbClr val="333333"/>
+                </a:solidFill>
+              </a:rPr>
+              <a:t>terus bergeser</a:t>
+            </a:r>
+            <a:pPr indent="0" marL="0">
+              <a:buNone/>
+            </a:pPr>
+            <a:r>
+              <a:rPr lang="en-US" sz="1800" dirty="0">
+                <a:solidFill>
+                  <a:srgbClr val="333333"/>
+                </a:solidFill>
+              </a:rPr>
+              <a:t> setiap periode rebalancing.</a:t>
+            </a:r>
+            <a:endParaRPr lang="en-US" sz="1800" dirty="0"/>
+          </a:p>
+          <a:p>
+            <a:pPr marL="342900" indent="-342900">
+              <a:buSzPct val="100000"/>
+              <a:buChar char="•"/>
+            </a:pPr>
+            <a:r>
+              <a:rPr lang="en-US" sz="1800" dirty="0">
+                <a:solidFill>
+                  <a:srgbClr val="333333"/>
+                </a:solidFill>
+              </a:rPr>
+              <a:t>Penggunaan γ statis tidak cukup untuk menangkap perubahan </a:t>
+            </a:r>
+            <a:pPr indent="0" marL="0">
+              <a:buNone/>
+            </a:pPr>
+            <a:r>
+              <a:rPr lang="en-US" sz="1800" b="1" dirty="0">
+                <a:solidFill>
+                  <a:srgbClr val="333333"/>
+                </a:solidFill>
+              </a:rPr>
+              <a:t>struktur korelasi</a:t>
+            </a:r>
+            <a:pPr indent="0" marL="0">
+              <a:buNone/>
+            </a:pPr>
+            <a:r>
+              <a:rPr lang="en-US" sz="1800" dirty="0">
+                <a:solidFill>
+                  <a:srgbClr val="333333"/>
+                </a:solidFill>
+              </a:rPr>
+              <a:t> yang sangat cepat di pasar kripto.</a:t>
+            </a:r>
+            <a:endParaRPr lang="en-US" sz="1800" dirty="0"/>
+          </a:p>
+          <a:p>
+            <a:pPr marL="342900" indent="-342900">
+              <a:buSzPct val="100000"/>
+              <a:buChar char="•"/>
+            </a:pPr>
+            <a:r>
+              <a:rPr lang="en-US" sz="1800" dirty="0">
+                <a:solidFill>
+                  <a:srgbClr val="333333"/>
+                </a:solidFill>
+              </a:rPr>
+              <a:t>Ini membenarkan bahwa pasar kripto membutuhkan </a:t>
+            </a:r>
+            <a:pPr indent="0" marL="0">
+              <a:buNone/>
+            </a:pPr>
+            <a:r>
+              <a:rPr lang="en-US" sz="1800" b="1" dirty="0">
+                <a:solidFill>
+                  <a:srgbClr val="333333"/>
+                </a:solidFill>
+              </a:rPr>
+              <a:t>kalibrasi otomatis</a:t>
+            </a:r>
+            <a:pPr indent="0" marL="0">
+              <a:buNone/>
+            </a:pPr>
+            <a:r>
+              <a:rPr lang="en-US" sz="1800" dirty="0">
+                <a:solidFill>
+                  <a:srgbClr val="333333"/>
+                </a:solidFill>
+              </a:rPr>
+              <a:t> secara temporal.</a:t>
+            </a:r>
+            <a:endParaRPr lang="en-US" sz="1800" dirty="0"/>
+          </a:p>
+        </p:txBody>
+      </p:sp>
+    </p:spTree>
+  </p:cSld>
+  <p:clrMapOvr>
+    <a:masterClrMapping/>
+  </p:clrMapOvr>
+</p:sld>
+</file>
+
+<file path=ppt/slides/slide45.xml><?xml version="1.0" encoding="utf-8"?>
+<p:sld xmlns:a="http://schemas.openxmlformats.org/drawingml/2006/main" xmlns:r="http://schemas.openxmlformats.org/officeDocument/2006/relationships" xmlns:p="http://schemas.openxmlformats.org/presentationml/2006/main">
+  <p:cSld name="Slide 45">
     <p:spTree>
       <p:nvGrpSpPr>
         <p:cNvPr id="1" name=""/>

</xml_diff>

<commit_message>
feat: add correlation-to-distance conversion formula slide
</commit_message>
<xml_diff>
--- a/Presentasi_Proposal_Update.pptx
+++ b/Presentasi_Proposal_Update.pptx
@@ -50,9 +50,10 @@
     <p:sldId id="298" r:id="rId44"/>
     <p:sldId id="299" r:id="rId45"/>
     <p:sldId id="300" r:id="rId46"/>
+    <p:sldId id="301" r:id="rId47"/>
   </p:sldIdLst>
   <p:notesMasterIdLst>
-    <p:notesMasterId r:id="rId47"/>
+    <p:notesMasterId r:id="rId48"/>
   </p:notesMasterIdLst>
   <p:sldSz cx="9144000" cy="5143500"/>
   <p:notesSz cx="5143500" cy="9144000"/>
@@ -4002,6 +4003,94 @@
             <a:fld id="{F7021451-1387-4CA6-816F-3879F97B5CBC}" type="slidenum">
               <a:rPr lang="en-US"/>
               <a:t>45</a:t>
+            </a:fld>
+            <a:endParaRPr lang="en-US"/>
+          </a:p>
+        </p:txBody>
+      </p:sp>
+    </p:spTree>
+    <p:extLst>
+      <p:ext uri="{BB962C8B-B14F-4D97-AF65-F5344CB8AC3E}">
+        <p14:creationId xmlns:p14="http://schemas.microsoft.com/office/powerpoint/2010/main" val="1024086991"/>
+      </p:ext>
+    </p:extLst>
+  </p:cSld>
+  <p:clrMapOvr>
+    <a:masterClrMapping/>
+  </p:clrMapOvr>
+</p:notes>
+</file>
+
+<file path=ppt/notesSlides/notesSlide46.xml><?xml version="1.0" encoding="utf-8"?>
+<p:notes xmlns:a="http://schemas.openxmlformats.org/drawingml/2006/main" xmlns:r="http://schemas.openxmlformats.org/officeDocument/2006/relationships" xmlns:p="http://schemas.openxmlformats.org/presentationml/2006/main">
+  <p:cSld>
+    <p:spTree>
+      <p:nvGrpSpPr>
+        <p:cNvPr id="1" name=""/>
+        <p:cNvGrpSpPr/>
+        <p:nvPr/>
+      </p:nvGrpSpPr>
+      <p:grpSpPr>
+        <a:xfrm>
+          <a:off x="0" y="0"/>
+          <a:ext cx="0" cy="0"/>
+          <a:chOff x="0" y="0"/>
+          <a:chExt cx="0" cy="0"/>
+        </a:xfrm>
+      </p:grpSpPr>
+      <p:sp>
+        <p:nvSpPr>
+          <p:cNvPr id="2" name="Slide Image Placeholder 1"/>
+          <p:cNvSpPr>
+            <a:spLocks noGrp="1" noRot="1" noChangeAspect="1"/>
+          </p:cNvSpPr>
+          <p:nvPr>
+            <p:ph type="sldImg"/>
+          </p:nvPr>
+        </p:nvSpPr>
+        <p:spPr/>
+      </p:sp>
+      <p:sp>
+        <p:nvSpPr>
+          <p:cNvPr id="3" name="Notes Placeholder 2"/>
+          <p:cNvSpPr>
+            <a:spLocks noGrp="1"/>
+          </p:cNvSpPr>
+          <p:nvPr>
+            <p:ph type="body" idx="1"/>
+          </p:nvPr>
+        </p:nvSpPr>
+        <p:spPr/>
+        <p:txBody>
+          <a:bodyPr/>
+          <a:lstStyle/>
+          <a:p>
+            <a:r>
+              <a:rPr lang="en-US" dirty="0"/>
+              <a:t/>
+            </a:r>
+            <a:endParaRPr lang="en-US" dirty="0"/>
+          </a:p>
+        </p:txBody>
+      </p:sp>
+      <p:sp>
+        <p:nvSpPr>
+          <p:cNvPr id="4" name="Slide Number Placeholder 3"/>
+          <p:cNvSpPr>
+            <a:spLocks noGrp="1"/>
+          </p:cNvSpPr>
+          <p:nvPr>
+            <p:ph type="sldNum" sz="quarter" idx="10"/>
+          </p:nvPr>
+        </p:nvSpPr>
+        <p:spPr/>
+        <p:txBody>
+          <a:bodyPr/>
+          <a:lstStyle/>
+          <a:p>
+            <a:fld id="{F7021451-1387-4CA6-816F-3879F97B5CBC}" type="slidenum">
+              <a:rPr lang="en-US"/>
+              <a:t>46</a:t>
             </a:fld>
             <a:endParaRPr lang="en-US"/>
           </a:p>
@@ -14149,14 +14238,14 @@
               <a:buNone/>
             </a:pPr>
             <a:r>
-              <a:rPr lang="en-US" sz="2600" b="1" dirty="0">
+              <a:rPr lang="en-US" sz="2400" b="1" dirty="0">
                 <a:solidFill>
                   <a:srgbClr val="003366"/>
                 </a:solidFill>
               </a:rPr>
-              <a:t>Lampiran: Dua Tipe Pendekatan Grid Search</a:t>
-            </a:r>
-            <a:endParaRPr lang="en-US" sz="2600" dirty="0"/>
+              <a:t>Lampiran: Rumus Konversi Korelasi ke Jarak</a:t>
+            </a:r>
+            <a:endParaRPr lang="en-US" sz="2400" dirty="0"/>
           </a:p>
         </p:txBody>
       </p:sp>
@@ -14190,7 +14279,7 @@
                   <a:srgbClr val="333333"/>
                 </a:solidFill>
               </a:rPr>
-              <a:t>Dua Objektif Optimasi (Return vs Risk):</a:t>
+              <a:t>Untuk membangun jaringan, korelasi harus diubah menjadi skor jarak (Metric Space).</a:t>
             </a:r>
             <a:endParaRPr lang="en-US" sz="1800" dirty="0"/>
           </a:p>
@@ -14201,10 +14290,141 @@
             <a:r>
               <a:rPr lang="en-US" sz="1800" b="1" dirty="0">
                 <a:solidFill>
+                  <a:srgbClr val="C0392B"/>
+                </a:solidFill>
+                <a:latin typeface="Courier New" pitchFamily="34" charset="0"/>
+                <a:ea typeface="Courier New" pitchFamily="34" charset="-122"/>
+                <a:cs typeface="Courier New" pitchFamily="34" charset="-120"/>
+              </a:rPr>
+              <a:t>Rumus (Mantegna, 1999): d_ij = √(2(1 - ρ_ij))</a:t>
+            </a:r>
+            <a:endParaRPr lang="en-US" sz="1800" dirty="0"/>
+          </a:p>
+          <a:p>
+            <a:pPr indent="0" marL="0">
+              <a:buNone/>
+            </a:pPr>
+            <a:r>
+              <a:rPr lang="en-US" sz="1800" b="1" dirty="0">
+                <a:solidFill>
+                  <a:srgbClr val="003366"/>
+                </a:solidFill>
+              </a:rPr>
+              <a:t>Simulasi Tabel Jarak:</a:t>
+            </a:r>
+            <a:endParaRPr lang="en-US" sz="1800" dirty="0"/>
+          </a:p>
+          <a:p>
+            <a:pPr indent="0" marL="0">
+              <a:buNone/>
+            </a:pPr>
+            <a:r>
+              <a:rPr lang="en-US" sz="1800" dirty="0">
+                <a:solidFill>
+                  <a:srgbClr val="333333"/>
+                </a:solidFill>
+              </a:rPr>
+              <a:t>   • Korelasi 1.00 (Identik) → d = √(2(1-1)) = </a:t>
+            </a:r>
+            <a:pPr indent="0" marL="0">
+              <a:buNone/>
+            </a:pPr>
+            <a:r>
+              <a:rPr lang="en-US" sz="1800" b="1" dirty="0">
+                <a:solidFill>
                   <a:srgbClr val="27AE60"/>
                 </a:solidFill>
               </a:rPr>
-              <a:t>1. Network Markowitz dengan Target Return (NW - Return Grid Search):</a:t>
+              <a:t>0</a:t>
+            </a:r>
+            <a:endParaRPr lang="en-US" sz="1800" dirty="0"/>
+          </a:p>
+          <a:p>
+            <a:pPr indent="0" marL="0">
+              <a:buNone/>
+            </a:pPr>
+            <a:r>
+              <a:rPr lang="en-US" sz="1800" dirty="0">
+                <a:solidFill>
+                  <a:srgbClr val="333333"/>
+                </a:solidFill>
+              </a:rPr>
+              <a:t>   • Korelasi 0.50 (Kuat) → d = √(2(1-0.5)) = √(1) = </a:t>
+            </a:r>
+            <a:pPr indent="0" marL="0">
+              <a:buNone/>
+            </a:pPr>
+            <a:r>
+              <a:rPr lang="en-US" sz="1800" b="1" dirty="0">
+                <a:solidFill>
+                  <a:srgbClr val="2C3E50"/>
+                </a:solidFill>
+              </a:rPr>
+              <a:t>1.00</a:t>
+            </a:r>
+            <a:endParaRPr lang="en-US" sz="1800" dirty="0"/>
+          </a:p>
+          <a:p>
+            <a:pPr indent="0" marL="0">
+              <a:buNone/>
+            </a:pPr>
+            <a:r>
+              <a:rPr lang="en-US" sz="1800" dirty="0">
+                <a:solidFill>
+                  <a:srgbClr val="333333"/>
+                </a:solidFill>
+              </a:rPr>
+              <a:t>   • Korelasi 0.00 (Acak) → d = √(2(1-0)) = √(2) ≈ </a:t>
+            </a:r>
+            <a:pPr indent="0" marL="0">
+              <a:buNone/>
+            </a:pPr>
+            <a:r>
+              <a:rPr lang="en-US" sz="1800" b="1" dirty="0">
+                <a:solidFill>
+                  <a:srgbClr val="C0392B"/>
+                </a:solidFill>
+              </a:rPr>
+              <a:t>1.41</a:t>
+            </a:r>
+            <a:endParaRPr lang="en-US" sz="1800" dirty="0"/>
+          </a:p>
+          <a:p>
+            <a:pPr indent="0" marL="0">
+              <a:buNone/>
+            </a:pPr>
+            <a:r>
+              <a:rPr lang="en-US" sz="1800" dirty="0">
+                <a:solidFill>
+                  <a:srgbClr val="333333"/>
+                </a:solidFill>
+              </a:rPr>
+              <a:t>   • Korelasi -1.00 (Berlawanan) → d = √(2(1-(-1))) = √(4) = </a:t>
+            </a:r>
+            <a:pPr indent="0" marL="0">
+              <a:buNone/>
+            </a:pPr>
+            <a:r>
+              <a:rPr lang="en-US" sz="1800" b="1" dirty="0">
+                <a:solidFill>
+                  <a:srgbClr val="C0392B"/>
+                </a:solidFill>
+              </a:rPr>
+              <a:t>2.00</a:t>
+            </a:r>
+            <a:endParaRPr lang="en-US" sz="1800" dirty="0"/>
+          </a:p>
+          <a:p>
+            <a:pPr indent="0" marL="0">
+              <a:buNone/>
+            </a:pPr>
+            <a:r>
+              <a:rPr lang="en-US" sz="1800" b="1" dirty="0">
+                <a:solidFill>
+                  <a:srgbClr val="8E44AD"/>
+                </a:solidFill>
+              </a:rPr>
+              <a:t>Logika Utama:</a:t>
             </a:r>
             <a:endParaRPr lang="en-US" sz="1800" dirty="0"/>
           </a:p>
@@ -14219,29 +14439,7 @@
                   <a:srgbClr val="333333"/>
                 </a:solidFill>
               </a:rPr>
-              <a:t>Memaksimalkan capaian </a:t>
-            </a:r>
-            <a:pPr indent="0" marL="0">
-              <a:buNone/>
-            </a:pPr>
-            <a:r>
-              <a:rPr lang="en-US" sz="1800" b="1" dirty="0">
-                <a:solidFill>
-                  <a:srgbClr val="333333"/>
-                </a:solidFill>
-              </a:rPr>
-              <a:t>imbal hasil</a:t>
-            </a:r>
-            <a:pPr indent="0" marL="0">
-              <a:buNone/>
-            </a:pPr>
-            <a:r>
-              <a:rPr lang="en-US" sz="1800" dirty="0">
-                <a:solidFill>
-                  <a:srgbClr val="333333"/>
-                </a:solidFill>
-              </a:rPr>
-              <a:t> portofolio.</a:t>
+              <a:t>1. Hubungan searah → Jarak Pendek (Aset sering bergerak bersama).</a:t>
             </a:r>
             <a:endParaRPr lang="en-US" sz="1800" dirty="0"/>
           </a:p>
@@ -14256,117 +14454,18 @@
                   <a:srgbClr val="333333"/>
                 </a:solidFill>
               </a:rPr>
-              <a:t>Lebih Agresif untuk mengeksploitasi reli pada pasar </a:t>
-            </a:r>
-            <a:pPr indent="0" marL="0">
-              <a:buNone/>
-            </a:pPr>
-            <a:r>
-              <a:rPr lang="en-US" sz="1800" b="1" dirty="0">
-                <a:solidFill>
-                  <a:srgbClr val="333333"/>
-                </a:solidFill>
-              </a:rPr>
-              <a:t>Bullish</a:t>
-            </a:r>
-            <a:pPr indent="0" marL="0">
-              <a:buNone/>
-            </a:pPr>
-            <a:r>
-              <a:rPr lang="en-US" sz="1800" dirty="0">
-                <a:solidFill>
-                  <a:srgbClr val="333333"/>
-                </a:solidFill>
-              </a:rPr>
-              <a:t>.</a:t>
-            </a:r>
-            <a:endParaRPr lang="en-US" sz="1800" dirty="0"/>
-          </a:p>
-          <a:p>
-            <a:pPr indent="0" marL="0">
-              <a:buNone/>
-            </a:pPr>
-            <a:r>
-              <a:rPr lang="en-US" sz="1800" b="1" dirty="0">
-                <a:solidFill>
-                  <a:srgbClr val="C0392B"/>
-                </a:solidFill>
-              </a:rPr>
-              <a:t>2. Network Markowitz dengan Target Risiko (NW - Risk Grid Search):</a:t>
-            </a:r>
-            <a:endParaRPr lang="en-US" sz="1800" dirty="0"/>
-          </a:p>
-          <a:p>
-            <a:pPr marL="342900" indent="-342900">
-              <a:buSzPct val="100000"/>
-              <a:buChar char="•"/>
-            </a:pPr>
-            <a:r>
-              <a:rPr lang="en-US" sz="1800" dirty="0">
-                <a:solidFill>
-                  <a:srgbClr val="333333"/>
-                </a:solidFill>
-              </a:rPr>
-              <a:t>Menekan parameter </a:t>
-            </a:r>
-            <a:pPr indent="0" marL="0">
-              <a:buNone/>
-            </a:pPr>
-            <a:r>
-              <a:rPr lang="en-US" sz="1800" b="1" dirty="0">
-                <a:solidFill>
-                  <a:srgbClr val="333333"/>
-                </a:solidFill>
-              </a:rPr>
-              <a:t>risiko total</a:t>
-            </a:r>
-            <a:pPr indent="0" marL="0">
-              <a:buNone/>
-            </a:pPr>
-            <a:r>
-              <a:rPr lang="en-US" sz="1800" dirty="0">
-                <a:solidFill>
-                  <a:srgbClr val="333333"/>
-                </a:solidFill>
-              </a:rPr>
-              <a:t> hingga minimal.</a:t>
-            </a:r>
-            <a:endParaRPr lang="en-US" sz="1800" dirty="0"/>
-          </a:p>
-          <a:p>
-            <a:pPr marL="342900" indent="-342900">
-              <a:buSzPct val="100000"/>
-              <a:buChar char="•"/>
-            </a:pPr>
-            <a:r>
-              <a:rPr lang="en-US" sz="1800" dirty="0">
-                <a:solidFill>
-                  <a:srgbClr val="333333"/>
-                </a:solidFill>
-              </a:rPr>
-              <a:t>Lebih Defensif untuk meredam fluktuasi saat </a:t>
-            </a:r>
-            <a:pPr indent="0" marL="0">
-              <a:buNone/>
-            </a:pPr>
-            <a:r>
-              <a:rPr lang="en-US" sz="1800" b="1" dirty="0">
-                <a:solidFill>
-                  <a:srgbClr val="333333"/>
-                </a:solidFill>
-              </a:rPr>
-              <a:t>Crypto Winter</a:t>
-            </a:r>
-            <a:pPr indent="0" marL="0">
-              <a:buNone/>
-            </a:pPr>
-            <a:r>
-              <a:rPr lang="en-US" sz="1800" dirty="0">
-                <a:solidFill>
-                  <a:srgbClr val="333333"/>
-                </a:solidFill>
-              </a:rPr>
-              <a:t>.</a:t>
+              <a:t>2. Hubungan berlawanan → Jarak Jauh (Aset saling menjauh).</a:t>
+            </a:r>
+            <a:pPr indent="0" marL="0">
+              <a:buNone/>
+            </a:pPr>
+            <a:r>
+              <a:rPr lang="en-US" sz="1800" i="1" dirty="0">
+                <a:solidFill>
+                  <a:srgbClr val="333333"/>
+                </a:solidFill>
+              </a:rPr>
+              <a:t>MST hanya mengambil jalur-jalur dengan Jarak (d) paling kecil agar efisien.</a:t>
             </a:r>
             <a:endParaRPr lang="en-US" sz="1800" dirty="0"/>
           </a:p>
@@ -14427,7 +14526,7 @@
                   <a:srgbClr val="003366"/>
                 </a:solidFill>
               </a:rPr>
-              <a:t>Lampiran: Penanganan Data Kosong (Missing Values)</a:t>
+              <a:t>Lampiran: Dua Tipe Pendekatan Grid Search</a:t>
             </a:r>
             <a:endParaRPr lang="en-US" sz="2600" dirty="0"/>
           </a:p>
@@ -14460,41 +14559,156 @@
             <a:r>
               <a:rPr lang="en-US" sz="1800" b="1" dirty="0">
                 <a:solidFill>
+                  <a:srgbClr val="333333"/>
+                </a:solidFill>
+              </a:rPr>
+              <a:t>Dua Objektif Optimasi (Return vs Risk):</a:t>
+            </a:r>
+            <a:endParaRPr lang="en-US" sz="1800" dirty="0"/>
+          </a:p>
+          <a:p>
+            <a:pPr indent="0" marL="0">
+              <a:buNone/>
+            </a:pPr>
+            <a:r>
+              <a:rPr lang="en-US" sz="1800" b="1" dirty="0">
+                <a:solidFill>
+                  <a:srgbClr val="27AE60"/>
+                </a:solidFill>
+              </a:rPr>
+              <a:t>1. Network Markowitz dengan Target Return (NW - Return Grid Search):</a:t>
+            </a:r>
+            <a:endParaRPr lang="en-US" sz="1800" dirty="0"/>
+          </a:p>
+          <a:p>
+            <a:pPr marL="342900" indent="-342900">
+              <a:buSzPct val="100000"/>
+              <a:buChar char="•"/>
+            </a:pPr>
+            <a:r>
+              <a:rPr lang="en-US" sz="1800" dirty="0">
+                <a:solidFill>
+                  <a:srgbClr val="333333"/>
+                </a:solidFill>
+              </a:rPr>
+              <a:t>Memaksimalkan capaian </a:t>
+            </a:r>
+            <a:pPr indent="0" marL="0">
+              <a:buNone/>
+            </a:pPr>
+            <a:r>
+              <a:rPr lang="en-US" sz="1800" b="1" dirty="0">
+                <a:solidFill>
+                  <a:srgbClr val="333333"/>
+                </a:solidFill>
+              </a:rPr>
+              <a:t>imbal hasil</a:t>
+            </a:r>
+            <a:pPr indent="0" marL="0">
+              <a:buNone/>
+            </a:pPr>
+            <a:r>
+              <a:rPr lang="en-US" sz="1800" dirty="0">
+                <a:solidFill>
+                  <a:srgbClr val="333333"/>
+                </a:solidFill>
+              </a:rPr>
+              <a:t> portofolio.</a:t>
+            </a:r>
+            <a:endParaRPr lang="en-US" sz="1800" dirty="0"/>
+          </a:p>
+          <a:p>
+            <a:pPr marL="342900" indent="-342900">
+              <a:buSzPct val="100000"/>
+              <a:buChar char="•"/>
+            </a:pPr>
+            <a:r>
+              <a:rPr lang="en-US" sz="1800" dirty="0">
+                <a:solidFill>
+                  <a:srgbClr val="333333"/>
+                </a:solidFill>
+              </a:rPr>
+              <a:t>Lebih Agresif untuk mengeksploitasi reli pada pasar </a:t>
+            </a:r>
+            <a:pPr indent="0" marL="0">
+              <a:buNone/>
+            </a:pPr>
+            <a:r>
+              <a:rPr lang="en-US" sz="1800" b="1" dirty="0">
+                <a:solidFill>
+                  <a:srgbClr val="333333"/>
+                </a:solidFill>
+              </a:rPr>
+              <a:t>Bullish</a:t>
+            </a:r>
+            <a:pPr indent="0" marL="0">
+              <a:buNone/>
+            </a:pPr>
+            <a:r>
+              <a:rPr lang="en-US" sz="1800" dirty="0">
+                <a:solidFill>
+                  <a:srgbClr val="333333"/>
+                </a:solidFill>
+              </a:rPr>
+              <a:t>.</a:t>
+            </a:r>
+            <a:endParaRPr lang="en-US" sz="1800" dirty="0"/>
+          </a:p>
+          <a:p>
+            <a:pPr indent="0" marL="0">
+              <a:buNone/>
+            </a:pPr>
+            <a:r>
+              <a:rPr lang="en-US" sz="1800" b="1" dirty="0">
+                <a:solidFill>
                   <a:srgbClr val="C0392B"/>
                 </a:solidFill>
               </a:rPr>
-              <a:t>Pertanyaan: </a:t>
-            </a:r>
-            <a:pPr indent="0" marL="0">
-              <a:buNone/>
-            </a:pPr>
-            <a:r>
-              <a:rPr lang="en-US" sz="1800" i="1" dirty="0">
-                <a:solidFill>
-                  <a:srgbClr val="333333"/>
-                </a:solidFill>
-              </a:rPr>
-              <a:t>"Beberapa koin seperti Binance/EOS belum rilis di awal 2017 sehingga datanya kosong. Bukankah backward-fill memalsukan harga dan merusak matriks?"</a:t>
+              <a:t>2. Network Markowitz dengan Target Risiko (NW - Risk Grid Search):</a:t>
             </a:r>
             <a:endParaRPr lang="en-US" sz="1800" dirty="0"/>
           </a:p>
           <a:p>
+            <a:pPr marL="342900" indent="-342900">
+              <a:buSzPct val="100000"/>
+              <a:buChar char="•"/>
+            </a:pPr>
+            <a:r>
+              <a:rPr lang="en-US" sz="1800" dirty="0">
+                <a:solidFill>
+                  <a:srgbClr val="333333"/>
+                </a:solidFill>
+              </a:rPr>
+              <a:t>Menekan parameter </a:t>
+            </a:r>
             <a:pPr indent="0" marL="0">
               <a:buNone/>
             </a:pPr>
             <a:r>
               <a:rPr lang="en-US" sz="1800" b="1" dirty="0">
                 <a:solidFill>
-                  <a:srgbClr val="27AE60"/>
-                </a:solidFill>
-              </a:rPr>
-              <a:t>Jawaban (Kenapa RMT sangat Krusial):</a:t>
+                  <a:srgbClr val="333333"/>
+                </a:solidFill>
+              </a:rPr>
+              <a:t>risiko total</a:t>
+            </a:r>
+            <a:pPr indent="0" marL="0">
+              <a:buNone/>
+            </a:pPr>
+            <a:r>
+              <a:rPr lang="en-US" sz="1800" dirty="0">
+                <a:solidFill>
+                  <a:srgbClr val="333333"/>
+                </a:solidFill>
+              </a:rPr>
+              <a:t> hingga minimal.</a:t>
             </a:r>
             <a:endParaRPr lang="en-US" sz="1800" dirty="0"/>
           </a:p>
           <a:p>
-            <a:pPr indent="0" marL="0">
-              <a:buNone/>
+            <a:pPr marL="342900" indent="-342900">
+              <a:buSzPct val="100000"/>
+              <a:buChar char="•"/>
             </a:pPr>
             <a:r>
               <a:rPr lang="en-US" sz="1800" dirty="0">
@@ -14502,18 +14716,18 @@
                   <a:srgbClr val="333333"/>
                 </a:solidFill>
               </a:rPr>
-              <a:t>   1. Praktik pengisian data diam (</a:t>
-            </a:r>
-            <a:pPr indent="0" marL="0">
-              <a:buNone/>
-            </a:pPr>
-            <a:r>
-              <a:rPr lang="en-US" sz="1800" b="1" i="1" dirty="0">
-                <a:solidFill>
-                  <a:srgbClr val="333333"/>
-                </a:solidFill>
-              </a:rPr>
-              <a:t>backward fill</a:t>
+              <a:t>Lebih Defensif untuk meredam fluktuasi saat </a:t>
+            </a:r>
+            <a:pPr indent="0" marL="0">
+              <a:buNone/>
+            </a:pPr>
+            <a:r>
+              <a:rPr lang="en-US" sz="1800" b="1" dirty="0">
+                <a:solidFill>
+                  <a:srgbClr val="333333"/>
+                </a:solidFill>
+              </a:rPr>
+              <a:t>Crypto Winter</a:t>
             </a:r>
             <a:pPr indent="0" marL="0">
               <a:buNone/>
@@ -14524,115 +14738,7 @@
                   <a:srgbClr val="333333"/>
                 </a:solidFill>
               </a:rPr>
-              <a:t>) memang menciptakan rentetan nilai harga yang statis.</a:t>
-            </a:r>
-            <a:endParaRPr lang="en-US" sz="1800" dirty="0"/>
-          </a:p>
-          <a:p>
-            <a:pPr indent="0" marL="0">
-              <a:buNone/>
-            </a:pPr>
-            <a:r>
-              <a:rPr lang="en-US" sz="1800" dirty="0">
-                <a:solidFill>
-                  <a:srgbClr val="333333"/>
-                </a:solidFill>
-              </a:rPr>
-              <a:t>   2. Namun, kehebatan </a:t>
-            </a:r>
-            <a:pPr indent="0" marL="0">
-              <a:buNone/>
-            </a:pPr>
-            <a:r>
-              <a:rPr lang="en-US" sz="1800" b="1" dirty="0">
-                <a:solidFill>
-                  <a:srgbClr val="333333"/>
-                </a:solidFill>
-              </a:rPr>
-              <a:t>Random Matrix Theory (RMT)</a:t>
-            </a:r>
-            <a:pPr indent="0" marL="0">
-              <a:buNone/>
-            </a:pPr>
-            <a:r>
-              <a:rPr lang="en-US" sz="1800" dirty="0">
-                <a:solidFill>
-                  <a:srgbClr val="333333"/>
-                </a:solidFill>
-              </a:rPr>
-              <a:t> diuji di sini! Karena data yang datar sama sekali tidak punya korelasi nyata.</a:t>
-            </a:r>
-            <a:endParaRPr lang="en-US" sz="1800" dirty="0"/>
-          </a:p>
-          <a:p>
-            <a:pPr indent="0" marL="0">
-              <a:buNone/>
-            </a:pPr>
-            <a:r>
-              <a:rPr lang="en-US" sz="1800" dirty="0">
-                <a:solidFill>
-                  <a:srgbClr val="333333"/>
-                </a:solidFill>
-              </a:rPr>
-              <a:t>   3. RMT otomatis akan mendeteksi korelasi buatan tersebut sebagai probabilitas </a:t>
-            </a:r>
-            <a:pPr indent="0" marL="0">
-              <a:buNone/>
-            </a:pPr>
-            <a:r>
-              <a:rPr lang="en-US" sz="1800" b="1" i="1" dirty="0">
-                <a:solidFill>
-                  <a:srgbClr val="333333"/>
-                </a:solidFill>
-              </a:rPr>
-              <a:t>Noise Acak</a:t>
-            </a:r>
-            <a:pPr indent="0" marL="0">
-              <a:buNone/>
-            </a:pPr>
-            <a:r>
-              <a:rPr lang="en-US" sz="1800" dirty="0">
-                <a:solidFill>
-                  <a:srgbClr val="333333"/>
-                </a:solidFill>
-              </a:rPr>
-              <a:t>, lalu membuangnya menjadi 0.</a:t>
-            </a:r>
-            <a:endParaRPr lang="en-US" sz="1800" dirty="0"/>
-          </a:p>
-          <a:p>
-            <a:pPr indent="0" marL="0">
-              <a:buNone/>
-            </a:pPr>
-            <a:r>
-              <a:rPr lang="en-US" sz="1800" dirty="0">
-                <a:solidFill>
-                  <a:srgbClr val="333333"/>
-                </a:solidFill>
-              </a:rPr>
-              <a:t>   4. Hasilnya, matriks korelasi </a:t>
-            </a:r>
-            <a:pPr indent="0" marL="0">
-              <a:buNone/>
-            </a:pPr>
-            <a:r>
-              <a:rPr lang="en-US" sz="1800" b="1" dirty="0">
-                <a:solidFill>
-                  <a:srgbClr val="333333"/>
-                </a:solidFill>
-              </a:rPr>
-              <a:t>terselamatkan</a:t>
-            </a:r>
-            <a:pPr indent="0" marL="0">
-              <a:buNone/>
-            </a:pPr>
-            <a:r>
-              <a:rPr lang="en-US" sz="1800" dirty="0">
-                <a:solidFill>
-                  <a:srgbClr val="333333"/>
-                </a:solidFill>
-              </a:rPr>
-              <a:t> dan tidak tercemar oleh cacat kelengkapan data.</a:t>
+              <a:t>.</a:t>
             </a:r>
             <a:endParaRPr lang="en-US" sz="1800" dirty="0"/>
           </a:p>
@@ -14693,7 +14799,7 @@
                   <a:srgbClr val="003366"/>
                 </a:solidFill>
               </a:rPr>
-              <a:t>Lampiran: Mengapa Menyertakan Tether (USDT)? (1/2)</a:t>
+              <a:t>Lampiran: Penanganan Data Kosong (Missing Values)</a:t>
             </a:r>
             <a:endParaRPr lang="en-US" sz="2600" dirty="0"/>
           </a:p>
@@ -14740,7 +14846,7 @@
                   <a:srgbClr val="333333"/>
                 </a:solidFill>
               </a:rPr>
-              <a:t>"Tether (USDT) itu stablecoin yang nilainya selalu fix ke 1 USD. Apakah tidak berbuat curang?"</a:t>
+              <a:t>"Beberapa koin seperti Binance/EOS belum rilis di awal 2017 sehingga datanya kosong. Bukankah backward-fill memalsukan harga dan merusak matriks?"</a:t>
             </a:r>
             <a:endParaRPr lang="en-US" sz="1800" dirty="0"/>
           </a:p>
@@ -14754,14 +14860,13 @@
                   <a:srgbClr val="27AE60"/>
                 </a:solidFill>
               </a:rPr>
-              <a:t>Jawaban (Dinamika Portofolio Cerdas):</a:t>
+              <a:t>Jawaban (Kenapa RMT sangat Krusial):</a:t>
             </a:r>
             <a:endParaRPr lang="en-US" sz="1800" dirty="0"/>
           </a:p>
           <a:p>
-            <a:pPr marL="342900" indent="-342900">
-              <a:buSzPct val="100000"/>
-              <a:buChar char="•"/>
+            <a:pPr indent="0" marL="0">
+              <a:buNone/>
             </a:pPr>
             <a:r>
               <a:rPr lang="en-US" sz="1800" dirty="0">
@@ -14769,7 +14874,7 @@
                   <a:srgbClr val="333333"/>
                 </a:solidFill>
               </a:rPr>
-              <a:t>Model ini mensimulasikan perilaku </a:t>
+              <a:t>   1. Praktik pengisian data diam (</a:t>
             </a:r>
             <a:pPr indent="0" marL="0">
               <a:buNone/>
@@ -14780,7 +14885,7 @@
                   <a:srgbClr val="333333"/>
                 </a:solidFill>
               </a:rPr>
-              <a:t>Robo-Advisory</a:t>
+              <a:t>backward fill</a:t>
             </a:r>
             <a:pPr indent="0" marL="0">
               <a:buNone/>
@@ -14791,14 +14896,13 @@
                   <a:srgbClr val="333333"/>
                 </a:solidFill>
               </a:rPr>
-              <a:t> institusional.</a:t>
+              <a:t>) memang menciptakan rentetan nilai harga yang statis.</a:t>
             </a:r>
             <a:endParaRPr lang="en-US" sz="1800" dirty="0"/>
           </a:p>
           <a:p>
-            <a:pPr marL="342900" indent="-342900">
-              <a:buSzPct val="100000"/>
-              <a:buChar char="•"/>
+            <a:pPr indent="0" marL="0">
+              <a:buNone/>
             </a:pPr>
             <a:r>
               <a:rPr lang="en-US" sz="1800" dirty="0">
@@ -14806,7 +14910,7 @@
                   <a:srgbClr val="333333"/>
                 </a:solidFill>
               </a:rPr>
-              <a:t>Ketika pasar anjlok ekstrem, investor akan melarikan senjatanya ke posisi </a:t>
+              <a:t>   2. Namun, kehebatan </a:t>
             </a:r>
             <a:pPr indent="0" marL="0">
               <a:buNone/>
@@ -14817,7 +14921,7 @@
                   <a:srgbClr val="333333"/>
                 </a:solidFill>
               </a:rPr>
-              <a:t>tunai (USDT)</a:t>
+              <a:t>Random Matrix Theory (RMT)</a:t>
             </a:r>
             <a:pPr indent="0" marL="0">
               <a:buNone/>
@@ -14828,7 +14932,79 @@
                   <a:srgbClr val="333333"/>
                 </a:solidFill>
               </a:rPr>
-              <a:t> sebagai evakuasi risiko.</a:t>
+              <a:t> diuji di sini! Karena data yang datar sama sekali tidak punya korelasi nyata.</a:t>
+            </a:r>
+            <a:endParaRPr lang="en-US" sz="1800" dirty="0"/>
+          </a:p>
+          <a:p>
+            <a:pPr indent="0" marL="0">
+              <a:buNone/>
+            </a:pPr>
+            <a:r>
+              <a:rPr lang="en-US" sz="1800" dirty="0">
+                <a:solidFill>
+                  <a:srgbClr val="333333"/>
+                </a:solidFill>
+              </a:rPr>
+              <a:t>   3. RMT otomatis akan mendeteksi korelasi buatan tersebut sebagai probabilitas </a:t>
+            </a:r>
+            <a:pPr indent="0" marL="0">
+              <a:buNone/>
+            </a:pPr>
+            <a:r>
+              <a:rPr lang="en-US" sz="1800" b="1" i="1" dirty="0">
+                <a:solidFill>
+                  <a:srgbClr val="333333"/>
+                </a:solidFill>
+              </a:rPr>
+              <a:t>Noise Acak</a:t>
+            </a:r>
+            <a:pPr indent="0" marL="0">
+              <a:buNone/>
+            </a:pPr>
+            <a:r>
+              <a:rPr lang="en-US" sz="1800" dirty="0">
+                <a:solidFill>
+                  <a:srgbClr val="333333"/>
+                </a:solidFill>
+              </a:rPr>
+              <a:t>, lalu membuangnya menjadi 0.</a:t>
+            </a:r>
+            <a:endParaRPr lang="en-US" sz="1800" dirty="0"/>
+          </a:p>
+          <a:p>
+            <a:pPr indent="0" marL="0">
+              <a:buNone/>
+            </a:pPr>
+            <a:r>
+              <a:rPr lang="en-US" sz="1800" dirty="0">
+                <a:solidFill>
+                  <a:srgbClr val="333333"/>
+                </a:solidFill>
+              </a:rPr>
+              <a:t>   4. Hasilnya, matriks korelasi </a:t>
+            </a:r>
+            <a:pPr indent="0" marL="0">
+              <a:buNone/>
+            </a:pPr>
+            <a:r>
+              <a:rPr lang="en-US" sz="1800" b="1" dirty="0">
+                <a:solidFill>
+                  <a:srgbClr val="333333"/>
+                </a:solidFill>
+              </a:rPr>
+              <a:t>terselamatkan</a:t>
+            </a:r>
+            <a:pPr indent="0" marL="0">
+              <a:buNone/>
+            </a:pPr>
+            <a:r>
+              <a:rPr lang="en-US" sz="1800" dirty="0">
+                <a:solidFill>
+                  <a:srgbClr val="333333"/>
+                </a:solidFill>
+              </a:rPr>
+              <a:t> dan tidak tercemar oleh cacat kelengkapan data.</a:t>
             </a:r>
             <a:endParaRPr lang="en-US" sz="1800" dirty="0"/>
           </a:p>
@@ -14889,7 +15065,7 @@
                   <a:srgbClr val="003366"/>
                 </a:solidFill>
               </a:rPr>
-              <a:t>Lampiran: Mengapa Menyertakan Tether (USDT)? (2/2)</a:t>
+              <a:t>Lampiran: Mengapa Menyertakan Tether (USDT)? (1/2)</a:t>
             </a:r>
             <a:endParaRPr lang="en-US" sz="2600" dirty="0"/>
           </a:p>
@@ -14920,12 +15096,89 @@
               <a:buNone/>
             </a:pPr>
             <a:r>
+              <a:rPr lang="en-US" sz="1800" b="1" dirty="0">
+                <a:solidFill>
+                  <a:srgbClr val="C0392B"/>
+                </a:solidFill>
+              </a:rPr>
+              <a:t>Pertanyaan: </a:t>
+            </a:r>
+            <a:pPr indent="0" marL="0">
+              <a:buNone/>
+            </a:pPr>
+            <a:r>
+              <a:rPr lang="en-US" sz="1800" i="1" dirty="0">
+                <a:solidFill>
+                  <a:srgbClr val="333333"/>
+                </a:solidFill>
+              </a:rPr>
+              <a:t>"Tether (USDT) itu stablecoin yang nilainya selalu fix ke 1 USD. Apakah tidak berbuat curang?"</a:t>
+            </a:r>
+            <a:endParaRPr lang="en-US" sz="1800" dirty="0"/>
+          </a:p>
+          <a:p>
+            <a:pPr indent="0" marL="0">
+              <a:buNone/>
+            </a:pPr>
+            <a:r>
+              <a:rPr lang="en-US" sz="1800" b="1" dirty="0">
+                <a:solidFill>
+                  <a:srgbClr val="27AE60"/>
+                </a:solidFill>
+              </a:rPr>
+              <a:t>Jawaban (Dinamika Portofolio Cerdas):</a:t>
+            </a:r>
+            <a:endParaRPr lang="en-US" sz="1800" dirty="0"/>
+          </a:p>
+          <a:p>
+            <a:pPr marL="342900" indent="-342900">
+              <a:buSzPct val="100000"/>
+              <a:buChar char="•"/>
+            </a:pPr>
+            <a:r>
               <a:rPr lang="en-US" sz="1800" dirty="0">
                 <a:solidFill>
                   <a:srgbClr val="333333"/>
                 </a:solidFill>
               </a:rPr>
-              <a:t>3. Algoritma jaringan </a:t>
+              <a:t>Model ini mensimulasikan perilaku </a:t>
+            </a:r>
+            <a:pPr indent="0" marL="0">
+              <a:buNone/>
+            </a:pPr>
+            <a:r>
+              <a:rPr lang="en-US" sz="1800" b="1" i="1" dirty="0">
+                <a:solidFill>
+                  <a:srgbClr val="333333"/>
+                </a:solidFill>
+              </a:rPr>
+              <a:t>Robo-Advisory</a:t>
+            </a:r>
+            <a:pPr indent="0" marL="0">
+              <a:buNone/>
+            </a:pPr>
+            <a:r>
+              <a:rPr lang="en-US" sz="1800" dirty="0">
+                <a:solidFill>
+                  <a:srgbClr val="333333"/>
+                </a:solidFill>
+              </a:rPr>
+              <a:t> institusional.</a:t>
+            </a:r>
+            <a:endParaRPr lang="en-US" sz="1800" dirty="0"/>
+          </a:p>
+          <a:p>
+            <a:pPr marL="342900" indent="-342900">
+              <a:buSzPct val="100000"/>
+              <a:buChar char="•"/>
+            </a:pPr>
+            <a:r>
+              <a:rPr lang="en-US" sz="1800" dirty="0">
+                <a:solidFill>
+                  <a:srgbClr val="333333"/>
+                </a:solidFill>
+              </a:rPr>
+              <a:t>Ketika pasar anjlok ekstrem, investor akan melarikan senjatanya ke posisi </a:t>
             </a:r>
             <a:pPr indent="0" marL="0">
               <a:buNone/>
@@ -14936,7 +15189,7 @@
                   <a:srgbClr val="333333"/>
                 </a:solidFill>
               </a:rPr>
-              <a:t>Network Markowitz GS (Grid Search)</a:t>
+              <a:t>tunai (USDT)</a:t>
             </a:r>
             <a:pPr indent="0" marL="0">
               <a:buNone/>
@@ -14947,87 +15200,7 @@
                   <a:srgbClr val="333333"/>
                 </a:solidFill>
               </a:rPr>
-              <a:t> dilatih secara matematis; jika mendeteksi korelasi ancaman kolaps merambat ke semua altcoin, ia akan melempar alokasi modalnya menuju node </a:t>
-            </a:r>
-            <a:pPr indent="0" marL="0">
-              <a:buNone/>
-            </a:pPr>
-            <a:r>
-              <a:rPr lang="en-US" sz="1800" b="1" dirty="0">
-                <a:solidFill>
-                  <a:srgbClr val="333333"/>
-                </a:solidFill>
-              </a:rPr>
-              <a:t>USDT (Tether)</a:t>
-            </a:r>
-            <a:pPr indent="0" marL="0">
-              <a:buNone/>
-            </a:pPr>
-            <a:r>
-              <a:rPr lang="en-US" sz="1800" dirty="0">
-                <a:solidFill>
-                  <a:srgbClr val="333333"/>
-                </a:solidFill>
-              </a:rPr>
-              <a:t> sebagai langkah </a:t>
-            </a:r>
-            <a:pPr indent="0" marL="0">
-              <a:buNone/>
-            </a:pPr>
-            <a:r>
-              <a:rPr lang="en-US" sz="1800" b="1" dirty="0">
-                <a:solidFill>
-                  <a:srgbClr val="333333"/>
-                </a:solidFill>
-              </a:rPr>
-              <a:t>evakuasi otomatis</a:t>
-            </a:r>
-            <a:pPr indent="0" marL="0">
-              <a:buNone/>
-            </a:pPr>
-            <a:r>
-              <a:rPr lang="en-US" sz="1800" dirty="0">
-                <a:solidFill>
-                  <a:srgbClr val="333333"/>
-                </a:solidFill>
-              </a:rPr>
-              <a:t> (Shock-Absorber).</a:t>
-            </a:r>
-            <a:endParaRPr lang="en-US" sz="1800" dirty="0"/>
-          </a:p>
-          <a:p>
-            <a:pPr indent="0" marL="0">
-              <a:buNone/>
-            </a:pPr>
-            <a:r>
-              <a:rPr lang="en-US" sz="1800" dirty="0">
-                <a:solidFill>
-                  <a:srgbClr val="333333"/>
-                </a:solidFill>
-              </a:rPr>
-              <a:t>   4. Hal ini yang membuat performa Risk-GS (Grid Search) sangat </a:t>
-            </a:r>
-            <a:pPr indent="0" marL="0">
-              <a:buNone/>
-            </a:pPr>
-            <a:r>
-              <a:rPr lang="en-US" sz="1800" b="1" dirty="0">
-                <a:solidFill>
-                  <a:srgbClr val="333333"/>
-                </a:solidFill>
-              </a:rPr>
-              <a:t>tangguh</a:t>
-            </a:r>
-            <a:pPr indent="0" marL="0">
-              <a:buNone/>
-            </a:pPr>
-            <a:r>
-              <a:rPr lang="en-US" sz="1800" dirty="0">
-                <a:solidFill>
-                  <a:srgbClr val="333333"/>
-                </a:solidFill>
-              </a:rPr>
-              <a:t> dari serangan Crypto Winter, suatu kapabilitas pertahanan yang tidak dipahami oleh model ortodoks murni Markowitz.</a:t>
+              <a:t> sebagai evakuasi risiko.</a:t>
             </a:r>
             <a:endParaRPr lang="en-US" sz="1800" dirty="0"/>
           </a:p>
@@ -15088,7 +15261,7 @@
                   <a:srgbClr val="003366"/>
                 </a:solidFill>
               </a:rPr>
-              <a:t>Lampiran: Bukti Empiris Non-Stationarity Pasar</a:t>
+              <a:t>Lampiran: Mengapa Menyertakan Tether (USDT)? (2/2)</a:t>
             </a:r>
             <a:endParaRPr lang="en-US" sz="2600" dirty="0"/>
           </a:p>
@@ -15119,23 +15292,78 @@
               <a:buNone/>
             </a:pPr>
             <a:r>
+              <a:rPr lang="en-US" sz="1800" dirty="0">
+                <a:solidFill>
+                  <a:srgbClr val="333333"/>
+                </a:solidFill>
+              </a:rPr>
+              <a:t>3. Algoritma jaringan </a:t>
+            </a:r>
+            <a:pPr indent="0" marL="0">
+              <a:buNone/>
+            </a:pPr>
+            <a:r>
               <a:rPr lang="en-US" sz="1800" b="1" dirty="0">
                 <a:solidFill>
-                  <a:srgbClr val="C0392B"/>
-                </a:solidFill>
-              </a:rPr>
-              <a:t>Masalah: </a:t>
-            </a:r>
-            <a:pPr indent="0" marL="0">
-              <a:buNone/>
-            </a:pPr>
-            <a:r>
-              <a:rPr lang="en-US" sz="1800" i="1" dirty="0">
-                <a:solidFill>
-                  <a:srgbClr val="333333"/>
-                </a:solidFill>
-              </a:rPr>
-              <a:t>Kenapa harus menggunakan model Adaptif (Dynamic Gamma)?</a:t>
+                  <a:srgbClr val="333333"/>
+                </a:solidFill>
+              </a:rPr>
+              <a:t>Network Markowitz GS (Grid Search)</a:t>
+            </a:r>
+            <a:pPr indent="0" marL="0">
+              <a:buNone/>
+            </a:pPr>
+            <a:r>
+              <a:rPr lang="en-US" sz="1800" dirty="0">
+                <a:solidFill>
+                  <a:srgbClr val="333333"/>
+                </a:solidFill>
+              </a:rPr>
+              <a:t> dilatih secara matematis; jika mendeteksi korelasi ancaman kolaps merambat ke semua altcoin, ia akan melempar alokasi modalnya menuju node </a:t>
+            </a:r>
+            <a:pPr indent="0" marL="0">
+              <a:buNone/>
+            </a:pPr>
+            <a:r>
+              <a:rPr lang="en-US" sz="1800" b="1" dirty="0">
+                <a:solidFill>
+                  <a:srgbClr val="333333"/>
+                </a:solidFill>
+              </a:rPr>
+              <a:t>USDT (Tether)</a:t>
+            </a:r>
+            <a:pPr indent="0" marL="0">
+              <a:buNone/>
+            </a:pPr>
+            <a:r>
+              <a:rPr lang="en-US" sz="1800" dirty="0">
+                <a:solidFill>
+                  <a:srgbClr val="333333"/>
+                </a:solidFill>
+              </a:rPr>
+              <a:t> sebagai langkah </a:t>
+            </a:r>
+            <a:pPr indent="0" marL="0">
+              <a:buNone/>
+            </a:pPr>
+            <a:r>
+              <a:rPr lang="en-US" sz="1800" b="1" dirty="0">
+                <a:solidFill>
+                  <a:srgbClr val="333333"/>
+                </a:solidFill>
+              </a:rPr>
+              <a:t>evakuasi otomatis</a:t>
+            </a:r>
+            <a:pPr indent="0" marL="0">
+              <a:buNone/>
+            </a:pPr>
+            <a:r>
+              <a:rPr lang="en-US" sz="1800" dirty="0">
+                <a:solidFill>
+                  <a:srgbClr val="333333"/>
+                </a:solidFill>
+              </a:rPr>
+              <a:t> (Shock-Absorber).</a:t>
             </a:r>
             <a:endParaRPr lang="en-US" sz="1800" dirty="0"/>
           </a:p>
@@ -15144,19 +15372,26 @@
               <a:buNone/>
             </a:pPr>
             <a:r>
+              <a:rPr lang="en-US" sz="1800" dirty="0">
+                <a:solidFill>
+                  <a:srgbClr val="333333"/>
+                </a:solidFill>
+              </a:rPr>
+              <a:t>   4. Hal ini yang membuat performa Risk-GS (Grid Search) sangat </a:t>
+            </a:r>
+            <a:pPr indent="0" marL="0">
+              <a:buNone/>
+            </a:pPr>
+            <a:r>
               <a:rPr lang="en-US" sz="1800" b="1" dirty="0">
                 <a:solidFill>
-                  <a:srgbClr val="27AE60"/>
-                </a:solidFill>
-              </a:rPr>
-              <a:t>Bukti dari Grid Search:</a:t>
-            </a:r>
-            <a:endParaRPr lang="en-US" sz="1800" dirty="0"/>
-          </a:p>
-          <a:p>
-            <a:pPr marL="342900" indent="-342900">
-              <a:buSzPct val="100000"/>
-              <a:buChar char="•"/>
+                  <a:srgbClr val="333333"/>
+                </a:solidFill>
+              </a:rPr>
+              <a:t>tangguh</a:t>
+            </a:r>
+            <a:pPr indent="0" marL="0">
+              <a:buNone/>
             </a:pPr>
             <a:r>
               <a:rPr lang="en-US" sz="1800" dirty="0">
@@ -15164,103 +15399,7 @@
                   <a:srgbClr val="333333"/>
                 </a:solidFill>
               </a:rPr>
-              <a:t>Data menunjukkan nilai Gamma (γ) optimal </a:t>
-            </a:r>
-            <a:pPr indent="0" marL="0">
-              <a:buNone/>
-            </a:pPr>
-            <a:r>
-              <a:rPr lang="en-US" sz="1800" b="1" dirty="0">
-                <a:solidFill>
-                  <a:srgbClr val="333333"/>
-                </a:solidFill>
-              </a:rPr>
-              <a:t>terus bergeser</a:t>
-            </a:r>
-            <a:pPr indent="0" marL="0">
-              <a:buNone/>
-            </a:pPr>
-            <a:r>
-              <a:rPr lang="en-US" sz="1800" dirty="0">
-                <a:solidFill>
-                  <a:srgbClr val="333333"/>
-                </a:solidFill>
-              </a:rPr>
-              <a:t> setiap periode rebalancing.</a:t>
-            </a:r>
-            <a:endParaRPr lang="en-US" sz="1800" dirty="0"/>
-          </a:p>
-          <a:p>
-            <a:pPr marL="342900" indent="-342900">
-              <a:buSzPct val="100000"/>
-              <a:buChar char="•"/>
-            </a:pPr>
-            <a:r>
-              <a:rPr lang="en-US" sz="1800" dirty="0">
-                <a:solidFill>
-                  <a:srgbClr val="333333"/>
-                </a:solidFill>
-              </a:rPr>
-              <a:t>Penggunaan γ statis tidak cukup untuk menangkap perubahan </a:t>
-            </a:r>
-            <a:pPr indent="0" marL="0">
-              <a:buNone/>
-            </a:pPr>
-            <a:r>
-              <a:rPr lang="en-US" sz="1800" b="1" dirty="0">
-                <a:solidFill>
-                  <a:srgbClr val="333333"/>
-                </a:solidFill>
-              </a:rPr>
-              <a:t>struktur korelasi</a:t>
-            </a:r>
-            <a:pPr indent="0" marL="0">
-              <a:buNone/>
-            </a:pPr>
-            <a:r>
-              <a:rPr lang="en-US" sz="1800" dirty="0">
-                <a:solidFill>
-                  <a:srgbClr val="333333"/>
-                </a:solidFill>
-              </a:rPr>
-              <a:t> yang sangat cepat di pasar kripto.</a:t>
-            </a:r>
-            <a:endParaRPr lang="en-US" sz="1800" dirty="0"/>
-          </a:p>
-          <a:p>
-            <a:pPr marL="342900" indent="-342900">
-              <a:buSzPct val="100000"/>
-              <a:buChar char="•"/>
-            </a:pPr>
-            <a:r>
-              <a:rPr lang="en-US" sz="1800" dirty="0">
-                <a:solidFill>
-                  <a:srgbClr val="333333"/>
-                </a:solidFill>
-              </a:rPr>
-              <a:t>Ini membenarkan bahwa pasar kripto membutuhkan </a:t>
-            </a:r>
-            <a:pPr indent="0" marL="0">
-              <a:buNone/>
-            </a:pPr>
-            <a:r>
-              <a:rPr lang="en-US" sz="1800" b="1" dirty="0">
-                <a:solidFill>
-                  <a:srgbClr val="333333"/>
-                </a:solidFill>
-              </a:rPr>
-              <a:t>kalibrasi otomatis</a:t>
-            </a:r>
-            <a:pPr indent="0" marL="0">
-              <a:buNone/>
-            </a:pPr>
-            <a:r>
-              <a:rPr lang="en-US" sz="1800" dirty="0">
-                <a:solidFill>
-                  <a:srgbClr val="333333"/>
-                </a:solidFill>
-              </a:rPr>
-              <a:t> secara temporal.</a:t>
+              <a:t> dari serangan Crypto Winter, suatu kapabilitas pertahanan yang tidak dipahami oleh model ortodoks murni Markowitz.</a:t>
             </a:r>
             <a:endParaRPr lang="en-US" sz="1800" dirty="0"/>
           </a:p>
@@ -15277,6 +15416,239 @@
 <file path=ppt/slides/slide45.xml><?xml version="1.0" encoding="utf-8"?>
 <p:sld xmlns:a="http://schemas.openxmlformats.org/drawingml/2006/main" xmlns:r="http://schemas.openxmlformats.org/officeDocument/2006/relationships" xmlns:p="http://schemas.openxmlformats.org/presentationml/2006/main">
   <p:cSld name="Slide 45">
+    <p:spTree>
+      <p:nvGrpSpPr>
+        <p:cNvPr id="1" name=""/>
+        <p:cNvGrpSpPr/>
+        <p:nvPr/>
+      </p:nvGrpSpPr>
+      <p:grpSpPr>
+        <a:xfrm>
+          <a:off x="0" y="0"/>
+          <a:ext cx="0" cy="0"/>
+          <a:chOff x="0" y="0"/>
+          <a:chExt cx="0" cy="0"/>
+        </a:xfrm>
+      </p:grpSpPr>
+      <p:sp>
+        <p:nvSpPr>
+          <p:cNvPr id="2" name="Text 0"/>
+          <p:cNvSpPr/>
+          <p:nvPr/>
+        </p:nvSpPr>
+        <p:spPr>
+          <a:xfrm>
+            <a:off x="457200" y="457200"/>
+            <a:ext cx="8229600" cy="0"/>
+          </a:xfrm>
+          <a:prstGeom prst="rect">
+            <a:avLst/>
+          </a:prstGeom>
+          <a:noFill/>
+          <a:ln/>
+        </p:spPr>
+        <p:txBody>
+          <a:bodyPr wrap="square" rtlCol="0" anchor="ctr"/>
+          <a:lstStyle/>
+          <a:p>
+            <a:pPr indent="0" marL="0">
+              <a:buNone/>
+            </a:pPr>
+            <a:r>
+              <a:rPr lang="en-US" sz="2600" b="1" dirty="0">
+                <a:solidFill>
+                  <a:srgbClr val="003366"/>
+                </a:solidFill>
+              </a:rPr>
+              <a:t>Lampiran: Bukti Empiris Non-Stationarity Pasar</a:t>
+            </a:r>
+            <a:endParaRPr lang="en-US" sz="2600" dirty="0"/>
+          </a:p>
+        </p:txBody>
+      </p:sp>
+      <p:sp>
+        <p:nvSpPr>
+          <p:cNvPr id="3" name="Text 1"/>
+          <p:cNvSpPr/>
+          <p:nvPr/>
+        </p:nvSpPr>
+        <p:spPr>
+          <a:xfrm>
+            <a:off x="457200" y="1005840"/>
+            <a:ext cx="8229600" cy="5029200"/>
+          </a:xfrm>
+          <a:prstGeom prst="rect">
+            <a:avLst/>
+          </a:prstGeom>
+          <a:noFill/>
+          <a:ln/>
+        </p:spPr>
+        <p:txBody>
+          <a:bodyPr wrap="square" rtlCol="0" anchor="t"/>
+          <a:lstStyle/>
+          <a:p>
+            <a:pPr indent="0" marL="0">
+              <a:buNone/>
+            </a:pPr>
+            <a:r>
+              <a:rPr lang="en-US" sz="1800" b="1" dirty="0">
+                <a:solidFill>
+                  <a:srgbClr val="C0392B"/>
+                </a:solidFill>
+              </a:rPr>
+              <a:t>Masalah: </a:t>
+            </a:r>
+            <a:pPr indent="0" marL="0">
+              <a:buNone/>
+            </a:pPr>
+            <a:r>
+              <a:rPr lang="en-US" sz="1800" i="1" dirty="0">
+                <a:solidFill>
+                  <a:srgbClr val="333333"/>
+                </a:solidFill>
+              </a:rPr>
+              <a:t>Kenapa harus menggunakan model Adaptif (Dynamic Gamma)?</a:t>
+            </a:r>
+            <a:endParaRPr lang="en-US" sz="1800" dirty="0"/>
+          </a:p>
+          <a:p>
+            <a:pPr indent="0" marL="0">
+              <a:buNone/>
+            </a:pPr>
+            <a:r>
+              <a:rPr lang="en-US" sz="1800" b="1" dirty="0">
+                <a:solidFill>
+                  <a:srgbClr val="27AE60"/>
+                </a:solidFill>
+              </a:rPr>
+              <a:t>Bukti dari Grid Search:</a:t>
+            </a:r>
+            <a:endParaRPr lang="en-US" sz="1800" dirty="0"/>
+          </a:p>
+          <a:p>
+            <a:pPr marL="342900" indent="-342900">
+              <a:buSzPct val="100000"/>
+              <a:buChar char="•"/>
+            </a:pPr>
+            <a:r>
+              <a:rPr lang="en-US" sz="1800" dirty="0">
+                <a:solidFill>
+                  <a:srgbClr val="333333"/>
+                </a:solidFill>
+              </a:rPr>
+              <a:t>Data menunjukkan nilai Gamma (γ) optimal </a:t>
+            </a:r>
+            <a:pPr indent="0" marL="0">
+              <a:buNone/>
+            </a:pPr>
+            <a:r>
+              <a:rPr lang="en-US" sz="1800" b="1" dirty="0">
+                <a:solidFill>
+                  <a:srgbClr val="333333"/>
+                </a:solidFill>
+              </a:rPr>
+              <a:t>terus bergeser</a:t>
+            </a:r>
+            <a:pPr indent="0" marL="0">
+              <a:buNone/>
+            </a:pPr>
+            <a:r>
+              <a:rPr lang="en-US" sz="1800" dirty="0">
+                <a:solidFill>
+                  <a:srgbClr val="333333"/>
+                </a:solidFill>
+              </a:rPr>
+              <a:t> setiap periode rebalancing.</a:t>
+            </a:r>
+            <a:endParaRPr lang="en-US" sz="1800" dirty="0"/>
+          </a:p>
+          <a:p>
+            <a:pPr marL="342900" indent="-342900">
+              <a:buSzPct val="100000"/>
+              <a:buChar char="•"/>
+            </a:pPr>
+            <a:r>
+              <a:rPr lang="en-US" sz="1800" dirty="0">
+                <a:solidFill>
+                  <a:srgbClr val="333333"/>
+                </a:solidFill>
+              </a:rPr>
+              <a:t>Penggunaan γ statis tidak cukup untuk menangkap perubahan </a:t>
+            </a:r>
+            <a:pPr indent="0" marL="0">
+              <a:buNone/>
+            </a:pPr>
+            <a:r>
+              <a:rPr lang="en-US" sz="1800" b="1" dirty="0">
+                <a:solidFill>
+                  <a:srgbClr val="333333"/>
+                </a:solidFill>
+              </a:rPr>
+              <a:t>struktur korelasi</a:t>
+            </a:r>
+            <a:pPr indent="0" marL="0">
+              <a:buNone/>
+            </a:pPr>
+            <a:r>
+              <a:rPr lang="en-US" sz="1800" dirty="0">
+                <a:solidFill>
+                  <a:srgbClr val="333333"/>
+                </a:solidFill>
+              </a:rPr>
+              <a:t> yang sangat cepat di pasar kripto.</a:t>
+            </a:r>
+            <a:endParaRPr lang="en-US" sz="1800" dirty="0"/>
+          </a:p>
+          <a:p>
+            <a:pPr marL="342900" indent="-342900">
+              <a:buSzPct val="100000"/>
+              <a:buChar char="•"/>
+            </a:pPr>
+            <a:r>
+              <a:rPr lang="en-US" sz="1800" dirty="0">
+                <a:solidFill>
+                  <a:srgbClr val="333333"/>
+                </a:solidFill>
+              </a:rPr>
+              <a:t>Ini membenarkan bahwa pasar kripto membutuhkan </a:t>
+            </a:r>
+            <a:pPr indent="0" marL="0">
+              <a:buNone/>
+            </a:pPr>
+            <a:r>
+              <a:rPr lang="en-US" sz="1800" b="1" dirty="0">
+                <a:solidFill>
+                  <a:srgbClr val="333333"/>
+                </a:solidFill>
+              </a:rPr>
+              <a:t>kalibrasi otomatis</a:t>
+            </a:r>
+            <a:pPr indent="0" marL="0">
+              <a:buNone/>
+            </a:pPr>
+            <a:r>
+              <a:rPr lang="en-US" sz="1800" dirty="0">
+                <a:solidFill>
+                  <a:srgbClr val="333333"/>
+                </a:solidFill>
+              </a:rPr>
+              <a:t> secara temporal.</a:t>
+            </a:r>
+            <a:endParaRPr lang="en-US" sz="1800" dirty="0"/>
+          </a:p>
+        </p:txBody>
+      </p:sp>
+    </p:spTree>
+  </p:cSld>
+  <p:clrMapOvr>
+    <a:masterClrMapping/>
+  </p:clrMapOvr>
+</p:sld>
+</file>
+
+<file path=ppt/slides/slide46.xml><?xml version="1.0" encoding="utf-8"?>
+<p:sld xmlns:a="http://schemas.openxmlformats.org/drawingml/2006/main" xmlns:r="http://schemas.openxmlformats.org/officeDocument/2006/relationships" xmlns:p="http://schemas.openxmlformats.org/presentationml/2006/main">
+  <p:cSld name="Slide 46">
     <p:spTree>
       <p:nvGrpSpPr>
         <p:cNvPr id="1" name=""/>

</xml_diff>

<commit_message>
feat: add network topology dynamics slide (Star vs Distributed)
</commit_message>
<xml_diff>
--- a/Presentasi_Proposal_Update.pptx
+++ b/Presentasi_Proposal_Update.pptx
@@ -51,9 +51,10 @@
     <p:sldId id="299" r:id="rId45"/>
     <p:sldId id="300" r:id="rId46"/>
     <p:sldId id="301" r:id="rId47"/>
+    <p:sldId id="302" r:id="rId48"/>
   </p:sldIdLst>
   <p:notesMasterIdLst>
-    <p:notesMasterId r:id="rId48"/>
+    <p:notesMasterId r:id="rId49"/>
   </p:notesMasterIdLst>
   <p:sldSz cx="9144000" cy="5143500"/>
   <p:notesSz cx="5143500" cy="9144000"/>
@@ -4091,6 +4092,94 @@
             <a:fld id="{F7021451-1387-4CA6-816F-3879F97B5CBC}" type="slidenum">
               <a:rPr lang="en-US"/>
               <a:t>46</a:t>
+            </a:fld>
+            <a:endParaRPr lang="en-US"/>
+          </a:p>
+        </p:txBody>
+      </p:sp>
+    </p:spTree>
+    <p:extLst>
+      <p:ext uri="{BB962C8B-B14F-4D97-AF65-F5344CB8AC3E}">
+        <p14:creationId xmlns:p14="http://schemas.microsoft.com/office/powerpoint/2010/main" val="1024086991"/>
+      </p:ext>
+    </p:extLst>
+  </p:cSld>
+  <p:clrMapOvr>
+    <a:masterClrMapping/>
+  </p:clrMapOvr>
+</p:notes>
+</file>
+
+<file path=ppt/notesSlides/notesSlide47.xml><?xml version="1.0" encoding="utf-8"?>
+<p:notes xmlns:a="http://schemas.openxmlformats.org/drawingml/2006/main" xmlns:r="http://schemas.openxmlformats.org/officeDocument/2006/relationships" xmlns:p="http://schemas.openxmlformats.org/presentationml/2006/main">
+  <p:cSld>
+    <p:spTree>
+      <p:nvGrpSpPr>
+        <p:cNvPr id="1" name=""/>
+        <p:cNvGrpSpPr/>
+        <p:nvPr/>
+      </p:nvGrpSpPr>
+      <p:grpSpPr>
+        <a:xfrm>
+          <a:off x="0" y="0"/>
+          <a:ext cx="0" cy="0"/>
+          <a:chOff x="0" y="0"/>
+          <a:chExt cx="0" cy="0"/>
+        </a:xfrm>
+      </p:grpSpPr>
+      <p:sp>
+        <p:nvSpPr>
+          <p:cNvPr id="2" name="Slide Image Placeholder 1"/>
+          <p:cNvSpPr>
+            <a:spLocks noGrp="1" noRot="1" noChangeAspect="1"/>
+          </p:cNvSpPr>
+          <p:nvPr>
+            <p:ph type="sldImg"/>
+          </p:nvPr>
+        </p:nvSpPr>
+        <p:spPr/>
+      </p:sp>
+      <p:sp>
+        <p:nvSpPr>
+          <p:cNvPr id="3" name="Notes Placeholder 2"/>
+          <p:cNvSpPr>
+            <a:spLocks noGrp="1"/>
+          </p:cNvSpPr>
+          <p:nvPr>
+            <p:ph type="body" idx="1"/>
+          </p:nvPr>
+        </p:nvSpPr>
+        <p:spPr/>
+        <p:txBody>
+          <a:bodyPr/>
+          <a:lstStyle/>
+          <a:p>
+            <a:r>
+              <a:rPr lang="en-US" dirty="0"/>
+              <a:t/>
+            </a:r>
+            <a:endParaRPr lang="en-US" dirty="0"/>
+          </a:p>
+        </p:txBody>
+      </p:sp>
+      <p:sp>
+        <p:nvSpPr>
+          <p:cNvPr id="4" name="Slide Number Placeholder 3"/>
+          <p:cNvSpPr>
+            <a:spLocks noGrp="1"/>
+          </p:cNvSpPr>
+          <p:nvPr>
+            <p:ph type="sldNum" sz="quarter" idx="10"/>
+          </p:nvPr>
+        </p:nvSpPr>
+        <p:spPr/>
+        <p:txBody>
+          <a:bodyPr/>
+          <a:lstStyle/>
+          <a:p>
+            <a:fld id="{F7021451-1387-4CA6-816F-3879F97B5CBC}" type="slidenum">
+              <a:rPr lang="en-US"/>
+              <a:t>47</a:t>
             </a:fld>
             <a:endParaRPr lang="en-US"/>
           </a:p>
@@ -14521,14 +14610,14 @@
               <a:buNone/>
             </a:pPr>
             <a:r>
-              <a:rPr lang="en-US" sz="2600" b="1" dirty="0">
+              <a:rPr lang="en-US" sz="2400" b="1" dirty="0">
                 <a:solidFill>
                   <a:srgbClr val="003366"/>
                 </a:solidFill>
               </a:rPr>
-              <a:t>Lampiran: Dua Tipe Pendekatan Grid Search</a:t>
-            </a:r>
-            <a:endParaRPr lang="en-US" sz="2600" dirty="0"/>
+              <a:t>Lampiran: Apakah Jaringan Selalu Berbentuk Star?</a:t>
+            </a:r>
+            <a:endParaRPr lang="en-US" sz="2400" dirty="0"/>
           </a:p>
         </p:txBody>
       </p:sp>
@@ -14559,10 +14648,10 @@
             <a:r>
               <a:rPr lang="en-US" sz="1800" b="1" dirty="0">
                 <a:solidFill>
-                  <a:srgbClr val="333333"/>
-                </a:solidFill>
-              </a:rPr>
-              <a:t>Dua Objektif Optimasi (Return vs Risk):</a:t>
+                  <a:srgbClr val="C0392B"/>
+                </a:solidFill>
+              </a:rPr>
+              <a:t>Jawaban: TIDAK. Topologi jaringan bersifat dinamis mengikuti rezim pasar.</a:t>
             </a:r>
             <a:endParaRPr lang="en-US" sz="1800" dirty="0"/>
           </a:p>
@@ -14573,17 +14662,16 @@
             <a:r>
               <a:rPr lang="en-US" sz="1800" b="1" dirty="0">
                 <a:solidFill>
-                  <a:srgbClr val="27AE60"/>
-                </a:solidFill>
-              </a:rPr>
-              <a:t>1. Network Markowitz dengan Target Return (NW - Return Grid Search):</a:t>
+                  <a:srgbClr val="003366"/>
+                </a:solidFill>
+              </a:rPr>
+              <a:t>1. Tipe Star (Sentralistik):</a:t>
             </a:r>
             <a:endParaRPr lang="en-US" sz="1800" dirty="0"/>
           </a:p>
           <a:p>
-            <a:pPr marL="342900" indent="-342900">
-              <a:buSzPct val="100000"/>
-              <a:buChar char="•"/>
+            <a:pPr indent="0" marL="0">
+              <a:buNone/>
             </a:pPr>
             <a:r>
               <a:rPr lang="en-US" sz="1800" dirty="0">
@@ -14591,19 +14679,53 @@
                   <a:srgbClr val="333333"/>
                 </a:solidFill>
               </a:rPr>
-              <a:t>Memaksimalkan capaian </a:t>
-            </a:r>
+              <a:t>   • Muncul saat pasar panik atau crash.</a:t>
+            </a:r>
+            <a:endParaRPr lang="en-US" sz="1800" dirty="0"/>
+          </a:p>
+          <a:p>
+            <a:pPr indent="0" marL="0">
+              <a:buNone/>
+            </a:pPr>
+            <a:r>
+              <a:rPr lang="en-US" sz="1800" dirty="0">
+                <a:solidFill>
+                  <a:srgbClr val="333333"/>
+                </a:solidFill>
+              </a:rPr>
+              <a:t>   • Semua aset mengekor pada satu koin dominan (Hub).</a:t>
+            </a:r>
+            <a:endParaRPr lang="en-US" sz="1800" dirty="0"/>
+          </a:p>
+          <a:p>
+            <a:pPr indent="0" marL="0">
+              <a:buNone/>
+            </a:pPr>
+            <a:r>
+              <a:rPr lang="en-US" sz="1800" dirty="0">
+                <a:solidFill>
+                  <a:srgbClr val="333333"/>
+                </a:solidFill>
+              </a:rPr>
+              <a:t>   • Penalti NW akan sangat berat pada koin pusat tersebut.</a:t>
+            </a:r>
+            <a:endParaRPr lang="en-US" sz="1800" dirty="0"/>
+          </a:p>
+          <a:p>
             <a:pPr indent="0" marL="0">
               <a:buNone/>
             </a:pPr>
             <a:r>
               <a:rPr lang="en-US" sz="1800" b="1" dirty="0">
                 <a:solidFill>
-                  <a:srgbClr val="333333"/>
-                </a:solidFill>
-              </a:rPr>
-              <a:t>imbal hasil</a:t>
-            </a:r>
+                  <a:srgbClr val="003366"/>
+                </a:solidFill>
+              </a:rPr>
+              <a:t>2. Tipe Terdistribusi (Cluster):</a:t>
+            </a:r>
+            <a:endParaRPr lang="en-US" sz="1800" dirty="0"/>
+          </a:p>
+          <a:p>
             <a:pPr indent="0" marL="0">
               <a:buNone/>
             </a:pPr>
@@ -14613,14 +14735,13 @@
                   <a:srgbClr val="333333"/>
                 </a:solidFill>
               </a:rPr>
-              <a:t> portofolio.</a:t>
+              <a:t>   • Muncul saat pasar tenang atau aset memiliki 'narasi' berbeda.</a:t>
             </a:r>
             <a:endParaRPr lang="en-US" sz="1800" dirty="0"/>
           </a:p>
           <a:p>
-            <a:pPr marL="342900" indent="-342900">
-              <a:buSzPct val="100000"/>
-              <a:buChar char="•"/>
+            <a:pPr indent="0" marL="0">
+              <a:buNone/>
             </a:pPr>
             <a:r>
               <a:rPr lang="en-US" sz="1800" dirty="0">
@@ -14628,29 +14749,35 @@
                   <a:srgbClr val="333333"/>
                 </a:solidFill>
               </a:rPr>
-              <a:t>Lebih Agresif untuk mengeksploitasi reli pada pasar </a:t>
-            </a:r>
+              <a:t>   • Hubungan terbagi ke beberapa kelompok (misal: DeFi Group, Stablecoin Group).</a:t>
+            </a:r>
+            <a:endParaRPr lang="en-US" sz="1800" dirty="0"/>
+          </a:p>
+          <a:p>
+            <a:pPr indent="0" marL="0">
+              <a:buNone/>
+            </a:pPr>
+            <a:r>
+              <a:rPr lang="en-US" sz="1800" dirty="0">
+                <a:solidFill>
+                  <a:srgbClr val="333333"/>
+                </a:solidFill>
+              </a:rPr>
+              <a:t>   • Penalti NW akan lebih menyebar dan diversifikasi lebih alami.</a:t>
+            </a:r>
+            <a:endParaRPr lang="en-US" sz="1800" dirty="0"/>
+          </a:p>
+          <a:p>
             <a:pPr indent="0" marL="0">
               <a:buNone/>
             </a:pPr>
             <a:r>
               <a:rPr lang="en-US" sz="1800" b="1" dirty="0">
                 <a:solidFill>
-                  <a:srgbClr val="333333"/>
-                </a:solidFill>
-              </a:rPr>
-              <a:t>Bullish</a:t>
-            </a:r>
-            <a:pPr indent="0" marL="0">
-              <a:buNone/>
-            </a:pPr>
-            <a:r>
-              <a:rPr lang="en-US" sz="1800" dirty="0">
-                <a:solidFill>
-                  <a:srgbClr val="333333"/>
-                </a:solidFill>
-              </a:rPr>
-              <a:t>.</a:t>
+                  <a:srgbClr val="8E44AD"/>
+                </a:solidFill>
+              </a:rPr>
+              <a:t>Dinamika dalam NW:</a:t>
             </a:r>
             <a:endParaRPr lang="en-US" sz="1800" dirty="0"/>
           </a:p>
@@ -14659,86 +14786,12 @@
               <a:buNone/>
             </a:pPr>
             <a:r>
-              <a:rPr lang="en-US" sz="1800" b="1" dirty="0">
-                <a:solidFill>
-                  <a:srgbClr val="C0392B"/>
-                </a:solidFill>
-              </a:rPr>
-              <a:t>2. Network Markowitz dengan Target Risiko (NW - Risk Grid Search):</a:t>
-            </a:r>
-            <a:endParaRPr lang="en-US" sz="1800" dirty="0"/>
-          </a:p>
-          <a:p>
-            <a:pPr marL="342900" indent="-342900">
-              <a:buSzPct val="100000"/>
-              <a:buChar char="•"/>
-            </a:pPr>
-            <a:r>
-              <a:rPr lang="en-US" sz="1800" dirty="0">
-                <a:solidFill>
-                  <a:srgbClr val="333333"/>
-                </a:solidFill>
-              </a:rPr>
-              <a:t>Menekan parameter </a:t>
-            </a:r>
-            <a:pPr indent="0" marL="0">
-              <a:buNone/>
-            </a:pPr>
-            <a:r>
-              <a:rPr lang="en-US" sz="1800" b="1" dirty="0">
-                <a:solidFill>
-                  <a:srgbClr val="333333"/>
-                </a:solidFill>
-              </a:rPr>
-              <a:t>risiko total</a:t>
-            </a:r>
-            <a:pPr indent="0" marL="0">
-              <a:buNone/>
-            </a:pPr>
-            <a:r>
-              <a:rPr lang="en-US" sz="1800" dirty="0">
-                <a:solidFill>
-                  <a:srgbClr val="333333"/>
-                </a:solidFill>
-              </a:rPr>
-              <a:t> hingga minimal.</a:t>
-            </a:r>
-            <a:endParaRPr lang="en-US" sz="1800" dirty="0"/>
-          </a:p>
-          <a:p>
-            <a:pPr marL="342900" indent="-342900">
-              <a:buSzPct val="100000"/>
-              <a:buChar char="•"/>
-            </a:pPr>
-            <a:r>
-              <a:rPr lang="en-US" sz="1800" dirty="0">
-                <a:solidFill>
-                  <a:srgbClr val="333333"/>
-                </a:solidFill>
-              </a:rPr>
-              <a:t>Lebih Defensif untuk meredam fluktuasi saat </a:t>
-            </a:r>
-            <a:pPr indent="0" marL="0">
-              <a:buNone/>
-            </a:pPr>
-            <a:r>
-              <a:rPr lang="en-US" sz="1800" b="1" dirty="0">
-                <a:solidFill>
-                  <a:srgbClr val="333333"/>
-                </a:solidFill>
-              </a:rPr>
-              <a:t>Crypto Winter</a:t>
-            </a:r>
-            <a:pPr indent="0" marL="0">
-              <a:buNone/>
-            </a:pPr>
-            <a:r>
-              <a:rPr lang="en-US" sz="1800" dirty="0">
-                <a:solidFill>
-                  <a:srgbClr val="333333"/>
-                </a:solidFill>
-              </a:rPr>
-              <a:t>.</a:t>
+              <a:rPr lang="en-US" sz="1800" i="1" dirty="0">
+                <a:solidFill>
+                  <a:srgbClr val="333333"/>
+                </a:solidFill>
+              </a:rPr>
+              <a:t>Kekuatan Network Markowitz adalah kemampuannya mendeteksi transisi bentuk ini secara real-time melalui data historis.</a:t>
             </a:r>
             <a:endParaRPr lang="en-US" sz="1800" dirty="0"/>
           </a:p>
@@ -14799,7 +14852,7 @@
                   <a:srgbClr val="003366"/>
                 </a:solidFill>
               </a:rPr>
-              <a:t>Lampiran: Penanganan Data Kosong (Missing Values)</a:t>
+              <a:t>Lampiran: Dua Tipe Pendekatan Grid Search</a:t>
             </a:r>
             <a:endParaRPr lang="en-US" sz="2600" dirty="0"/>
           </a:p>
@@ -14832,41 +14885,156 @@
             <a:r>
               <a:rPr lang="en-US" sz="1800" b="1" dirty="0">
                 <a:solidFill>
+                  <a:srgbClr val="333333"/>
+                </a:solidFill>
+              </a:rPr>
+              <a:t>Dua Objektif Optimasi (Return vs Risk):</a:t>
+            </a:r>
+            <a:endParaRPr lang="en-US" sz="1800" dirty="0"/>
+          </a:p>
+          <a:p>
+            <a:pPr indent="0" marL="0">
+              <a:buNone/>
+            </a:pPr>
+            <a:r>
+              <a:rPr lang="en-US" sz="1800" b="1" dirty="0">
+                <a:solidFill>
+                  <a:srgbClr val="27AE60"/>
+                </a:solidFill>
+              </a:rPr>
+              <a:t>1. Network Markowitz dengan Target Return (NW - Return Grid Search):</a:t>
+            </a:r>
+            <a:endParaRPr lang="en-US" sz="1800" dirty="0"/>
+          </a:p>
+          <a:p>
+            <a:pPr marL="342900" indent="-342900">
+              <a:buSzPct val="100000"/>
+              <a:buChar char="•"/>
+            </a:pPr>
+            <a:r>
+              <a:rPr lang="en-US" sz="1800" dirty="0">
+                <a:solidFill>
+                  <a:srgbClr val="333333"/>
+                </a:solidFill>
+              </a:rPr>
+              <a:t>Memaksimalkan capaian </a:t>
+            </a:r>
+            <a:pPr indent="0" marL="0">
+              <a:buNone/>
+            </a:pPr>
+            <a:r>
+              <a:rPr lang="en-US" sz="1800" b="1" dirty="0">
+                <a:solidFill>
+                  <a:srgbClr val="333333"/>
+                </a:solidFill>
+              </a:rPr>
+              <a:t>imbal hasil</a:t>
+            </a:r>
+            <a:pPr indent="0" marL="0">
+              <a:buNone/>
+            </a:pPr>
+            <a:r>
+              <a:rPr lang="en-US" sz="1800" dirty="0">
+                <a:solidFill>
+                  <a:srgbClr val="333333"/>
+                </a:solidFill>
+              </a:rPr>
+              <a:t> portofolio.</a:t>
+            </a:r>
+            <a:endParaRPr lang="en-US" sz="1800" dirty="0"/>
+          </a:p>
+          <a:p>
+            <a:pPr marL="342900" indent="-342900">
+              <a:buSzPct val="100000"/>
+              <a:buChar char="•"/>
+            </a:pPr>
+            <a:r>
+              <a:rPr lang="en-US" sz="1800" dirty="0">
+                <a:solidFill>
+                  <a:srgbClr val="333333"/>
+                </a:solidFill>
+              </a:rPr>
+              <a:t>Lebih Agresif untuk mengeksploitasi reli pada pasar </a:t>
+            </a:r>
+            <a:pPr indent="0" marL="0">
+              <a:buNone/>
+            </a:pPr>
+            <a:r>
+              <a:rPr lang="en-US" sz="1800" b="1" dirty="0">
+                <a:solidFill>
+                  <a:srgbClr val="333333"/>
+                </a:solidFill>
+              </a:rPr>
+              <a:t>Bullish</a:t>
+            </a:r>
+            <a:pPr indent="0" marL="0">
+              <a:buNone/>
+            </a:pPr>
+            <a:r>
+              <a:rPr lang="en-US" sz="1800" dirty="0">
+                <a:solidFill>
+                  <a:srgbClr val="333333"/>
+                </a:solidFill>
+              </a:rPr>
+              <a:t>.</a:t>
+            </a:r>
+            <a:endParaRPr lang="en-US" sz="1800" dirty="0"/>
+          </a:p>
+          <a:p>
+            <a:pPr indent="0" marL="0">
+              <a:buNone/>
+            </a:pPr>
+            <a:r>
+              <a:rPr lang="en-US" sz="1800" b="1" dirty="0">
+                <a:solidFill>
                   <a:srgbClr val="C0392B"/>
                 </a:solidFill>
               </a:rPr>
-              <a:t>Pertanyaan: </a:t>
-            </a:r>
-            <a:pPr indent="0" marL="0">
-              <a:buNone/>
-            </a:pPr>
-            <a:r>
-              <a:rPr lang="en-US" sz="1800" i="1" dirty="0">
-                <a:solidFill>
-                  <a:srgbClr val="333333"/>
-                </a:solidFill>
-              </a:rPr>
-              <a:t>"Beberapa koin seperti Binance/EOS belum rilis di awal 2017 sehingga datanya kosong. Bukankah backward-fill memalsukan harga dan merusak matriks?"</a:t>
+              <a:t>2. Network Markowitz dengan Target Risiko (NW - Risk Grid Search):</a:t>
             </a:r>
             <a:endParaRPr lang="en-US" sz="1800" dirty="0"/>
           </a:p>
           <a:p>
+            <a:pPr marL="342900" indent="-342900">
+              <a:buSzPct val="100000"/>
+              <a:buChar char="•"/>
+            </a:pPr>
+            <a:r>
+              <a:rPr lang="en-US" sz="1800" dirty="0">
+                <a:solidFill>
+                  <a:srgbClr val="333333"/>
+                </a:solidFill>
+              </a:rPr>
+              <a:t>Menekan parameter </a:t>
+            </a:r>
             <a:pPr indent="0" marL="0">
               <a:buNone/>
             </a:pPr>
             <a:r>
               <a:rPr lang="en-US" sz="1800" b="1" dirty="0">
                 <a:solidFill>
-                  <a:srgbClr val="27AE60"/>
-                </a:solidFill>
-              </a:rPr>
-              <a:t>Jawaban (Kenapa RMT sangat Krusial):</a:t>
+                  <a:srgbClr val="333333"/>
+                </a:solidFill>
+              </a:rPr>
+              <a:t>risiko total</a:t>
+            </a:r>
+            <a:pPr indent="0" marL="0">
+              <a:buNone/>
+            </a:pPr>
+            <a:r>
+              <a:rPr lang="en-US" sz="1800" dirty="0">
+                <a:solidFill>
+                  <a:srgbClr val="333333"/>
+                </a:solidFill>
+              </a:rPr>
+              <a:t> hingga minimal.</a:t>
             </a:r>
             <a:endParaRPr lang="en-US" sz="1800" dirty="0"/>
           </a:p>
           <a:p>
-            <a:pPr indent="0" marL="0">
-              <a:buNone/>
+            <a:pPr marL="342900" indent="-342900">
+              <a:buSzPct val="100000"/>
+              <a:buChar char="•"/>
             </a:pPr>
             <a:r>
               <a:rPr lang="en-US" sz="1800" dirty="0">
@@ -14874,18 +15042,18 @@
                   <a:srgbClr val="333333"/>
                 </a:solidFill>
               </a:rPr>
-              <a:t>   1. Praktik pengisian data diam (</a:t>
-            </a:r>
-            <a:pPr indent="0" marL="0">
-              <a:buNone/>
-            </a:pPr>
-            <a:r>
-              <a:rPr lang="en-US" sz="1800" b="1" i="1" dirty="0">
-                <a:solidFill>
-                  <a:srgbClr val="333333"/>
-                </a:solidFill>
-              </a:rPr>
-              <a:t>backward fill</a:t>
+              <a:t>Lebih Defensif untuk meredam fluktuasi saat </a:t>
+            </a:r>
+            <a:pPr indent="0" marL="0">
+              <a:buNone/>
+            </a:pPr>
+            <a:r>
+              <a:rPr lang="en-US" sz="1800" b="1" dirty="0">
+                <a:solidFill>
+                  <a:srgbClr val="333333"/>
+                </a:solidFill>
+              </a:rPr>
+              <a:t>Crypto Winter</a:t>
             </a:r>
             <a:pPr indent="0" marL="0">
               <a:buNone/>
@@ -14896,115 +15064,7 @@
                   <a:srgbClr val="333333"/>
                 </a:solidFill>
               </a:rPr>
-              <a:t>) memang menciptakan rentetan nilai harga yang statis.</a:t>
-            </a:r>
-            <a:endParaRPr lang="en-US" sz="1800" dirty="0"/>
-          </a:p>
-          <a:p>
-            <a:pPr indent="0" marL="0">
-              <a:buNone/>
-            </a:pPr>
-            <a:r>
-              <a:rPr lang="en-US" sz="1800" dirty="0">
-                <a:solidFill>
-                  <a:srgbClr val="333333"/>
-                </a:solidFill>
-              </a:rPr>
-              <a:t>   2. Namun, kehebatan </a:t>
-            </a:r>
-            <a:pPr indent="0" marL="0">
-              <a:buNone/>
-            </a:pPr>
-            <a:r>
-              <a:rPr lang="en-US" sz="1800" b="1" dirty="0">
-                <a:solidFill>
-                  <a:srgbClr val="333333"/>
-                </a:solidFill>
-              </a:rPr>
-              <a:t>Random Matrix Theory (RMT)</a:t>
-            </a:r>
-            <a:pPr indent="0" marL="0">
-              <a:buNone/>
-            </a:pPr>
-            <a:r>
-              <a:rPr lang="en-US" sz="1800" dirty="0">
-                <a:solidFill>
-                  <a:srgbClr val="333333"/>
-                </a:solidFill>
-              </a:rPr>
-              <a:t> diuji di sini! Karena data yang datar sama sekali tidak punya korelasi nyata.</a:t>
-            </a:r>
-            <a:endParaRPr lang="en-US" sz="1800" dirty="0"/>
-          </a:p>
-          <a:p>
-            <a:pPr indent="0" marL="0">
-              <a:buNone/>
-            </a:pPr>
-            <a:r>
-              <a:rPr lang="en-US" sz="1800" dirty="0">
-                <a:solidFill>
-                  <a:srgbClr val="333333"/>
-                </a:solidFill>
-              </a:rPr>
-              <a:t>   3. RMT otomatis akan mendeteksi korelasi buatan tersebut sebagai probabilitas </a:t>
-            </a:r>
-            <a:pPr indent="0" marL="0">
-              <a:buNone/>
-            </a:pPr>
-            <a:r>
-              <a:rPr lang="en-US" sz="1800" b="1" i="1" dirty="0">
-                <a:solidFill>
-                  <a:srgbClr val="333333"/>
-                </a:solidFill>
-              </a:rPr>
-              <a:t>Noise Acak</a:t>
-            </a:r>
-            <a:pPr indent="0" marL="0">
-              <a:buNone/>
-            </a:pPr>
-            <a:r>
-              <a:rPr lang="en-US" sz="1800" dirty="0">
-                <a:solidFill>
-                  <a:srgbClr val="333333"/>
-                </a:solidFill>
-              </a:rPr>
-              <a:t>, lalu membuangnya menjadi 0.</a:t>
-            </a:r>
-            <a:endParaRPr lang="en-US" sz="1800" dirty="0"/>
-          </a:p>
-          <a:p>
-            <a:pPr indent="0" marL="0">
-              <a:buNone/>
-            </a:pPr>
-            <a:r>
-              <a:rPr lang="en-US" sz="1800" dirty="0">
-                <a:solidFill>
-                  <a:srgbClr val="333333"/>
-                </a:solidFill>
-              </a:rPr>
-              <a:t>   4. Hasilnya, matriks korelasi </a:t>
-            </a:r>
-            <a:pPr indent="0" marL="0">
-              <a:buNone/>
-            </a:pPr>
-            <a:r>
-              <a:rPr lang="en-US" sz="1800" b="1" dirty="0">
-                <a:solidFill>
-                  <a:srgbClr val="333333"/>
-                </a:solidFill>
-              </a:rPr>
-              <a:t>terselamatkan</a:t>
-            </a:r>
-            <a:pPr indent="0" marL="0">
-              <a:buNone/>
-            </a:pPr>
-            <a:r>
-              <a:rPr lang="en-US" sz="1800" dirty="0">
-                <a:solidFill>
-                  <a:srgbClr val="333333"/>
-                </a:solidFill>
-              </a:rPr>
-              <a:t> dan tidak tercemar oleh cacat kelengkapan data.</a:t>
+              <a:t>.</a:t>
             </a:r>
             <a:endParaRPr lang="en-US" sz="1800" dirty="0"/>
           </a:p>
@@ -15065,7 +15125,7 @@
                   <a:srgbClr val="003366"/>
                 </a:solidFill>
               </a:rPr>
-              <a:t>Lampiran: Mengapa Menyertakan Tether (USDT)? (1/2)</a:t>
+              <a:t>Lampiran: Penanganan Data Kosong (Missing Values)</a:t>
             </a:r>
             <a:endParaRPr lang="en-US" sz="2600" dirty="0"/>
           </a:p>
@@ -15112,7 +15172,7 @@
                   <a:srgbClr val="333333"/>
                 </a:solidFill>
               </a:rPr>
-              <a:t>"Tether (USDT) itu stablecoin yang nilainya selalu fix ke 1 USD. Apakah tidak berbuat curang?"</a:t>
+              <a:t>"Beberapa koin seperti Binance/EOS belum rilis di awal 2017 sehingga datanya kosong. Bukankah backward-fill memalsukan harga dan merusak matriks?"</a:t>
             </a:r>
             <a:endParaRPr lang="en-US" sz="1800" dirty="0"/>
           </a:p>
@@ -15126,14 +15186,13 @@
                   <a:srgbClr val="27AE60"/>
                 </a:solidFill>
               </a:rPr>
-              <a:t>Jawaban (Dinamika Portofolio Cerdas):</a:t>
+              <a:t>Jawaban (Kenapa RMT sangat Krusial):</a:t>
             </a:r>
             <a:endParaRPr lang="en-US" sz="1800" dirty="0"/>
           </a:p>
           <a:p>
-            <a:pPr marL="342900" indent="-342900">
-              <a:buSzPct val="100000"/>
-              <a:buChar char="•"/>
+            <a:pPr indent="0" marL="0">
+              <a:buNone/>
             </a:pPr>
             <a:r>
               <a:rPr lang="en-US" sz="1800" dirty="0">
@@ -15141,7 +15200,7 @@
                   <a:srgbClr val="333333"/>
                 </a:solidFill>
               </a:rPr>
-              <a:t>Model ini mensimulasikan perilaku </a:t>
+              <a:t>   1. Praktik pengisian data diam (</a:t>
             </a:r>
             <a:pPr indent="0" marL="0">
               <a:buNone/>
@@ -15152,7 +15211,7 @@
                   <a:srgbClr val="333333"/>
                 </a:solidFill>
               </a:rPr>
-              <a:t>Robo-Advisory</a:t>
+              <a:t>backward fill</a:t>
             </a:r>
             <a:pPr indent="0" marL="0">
               <a:buNone/>
@@ -15163,14 +15222,13 @@
                   <a:srgbClr val="333333"/>
                 </a:solidFill>
               </a:rPr>
-              <a:t> institusional.</a:t>
+              <a:t>) memang menciptakan rentetan nilai harga yang statis.</a:t>
             </a:r>
             <a:endParaRPr lang="en-US" sz="1800" dirty="0"/>
           </a:p>
           <a:p>
-            <a:pPr marL="342900" indent="-342900">
-              <a:buSzPct val="100000"/>
-              <a:buChar char="•"/>
+            <a:pPr indent="0" marL="0">
+              <a:buNone/>
             </a:pPr>
             <a:r>
               <a:rPr lang="en-US" sz="1800" dirty="0">
@@ -15178,7 +15236,7 @@
                   <a:srgbClr val="333333"/>
                 </a:solidFill>
               </a:rPr>
-              <a:t>Ketika pasar anjlok ekstrem, investor akan melarikan senjatanya ke posisi </a:t>
+              <a:t>   2. Namun, kehebatan </a:t>
             </a:r>
             <a:pPr indent="0" marL="0">
               <a:buNone/>
@@ -15189,7 +15247,7 @@
                   <a:srgbClr val="333333"/>
                 </a:solidFill>
               </a:rPr>
-              <a:t>tunai (USDT)</a:t>
+              <a:t>Random Matrix Theory (RMT)</a:t>
             </a:r>
             <a:pPr indent="0" marL="0">
               <a:buNone/>
@@ -15200,7 +15258,79 @@
                   <a:srgbClr val="333333"/>
                 </a:solidFill>
               </a:rPr>
-              <a:t> sebagai evakuasi risiko.</a:t>
+              <a:t> diuji di sini! Karena data yang datar sama sekali tidak punya korelasi nyata.</a:t>
+            </a:r>
+            <a:endParaRPr lang="en-US" sz="1800" dirty="0"/>
+          </a:p>
+          <a:p>
+            <a:pPr indent="0" marL="0">
+              <a:buNone/>
+            </a:pPr>
+            <a:r>
+              <a:rPr lang="en-US" sz="1800" dirty="0">
+                <a:solidFill>
+                  <a:srgbClr val="333333"/>
+                </a:solidFill>
+              </a:rPr>
+              <a:t>   3. RMT otomatis akan mendeteksi korelasi buatan tersebut sebagai probabilitas </a:t>
+            </a:r>
+            <a:pPr indent="0" marL="0">
+              <a:buNone/>
+            </a:pPr>
+            <a:r>
+              <a:rPr lang="en-US" sz="1800" b="1" i="1" dirty="0">
+                <a:solidFill>
+                  <a:srgbClr val="333333"/>
+                </a:solidFill>
+              </a:rPr>
+              <a:t>Noise Acak</a:t>
+            </a:r>
+            <a:pPr indent="0" marL="0">
+              <a:buNone/>
+            </a:pPr>
+            <a:r>
+              <a:rPr lang="en-US" sz="1800" dirty="0">
+                <a:solidFill>
+                  <a:srgbClr val="333333"/>
+                </a:solidFill>
+              </a:rPr>
+              <a:t>, lalu membuangnya menjadi 0.</a:t>
+            </a:r>
+            <a:endParaRPr lang="en-US" sz="1800" dirty="0"/>
+          </a:p>
+          <a:p>
+            <a:pPr indent="0" marL="0">
+              <a:buNone/>
+            </a:pPr>
+            <a:r>
+              <a:rPr lang="en-US" sz="1800" dirty="0">
+                <a:solidFill>
+                  <a:srgbClr val="333333"/>
+                </a:solidFill>
+              </a:rPr>
+              <a:t>   4. Hasilnya, matriks korelasi </a:t>
+            </a:r>
+            <a:pPr indent="0" marL="0">
+              <a:buNone/>
+            </a:pPr>
+            <a:r>
+              <a:rPr lang="en-US" sz="1800" b="1" dirty="0">
+                <a:solidFill>
+                  <a:srgbClr val="333333"/>
+                </a:solidFill>
+              </a:rPr>
+              <a:t>terselamatkan</a:t>
+            </a:r>
+            <a:pPr indent="0" marL="0">
+              <a:buNone/>
+            </a:pPr>
+            <a:r>
+              <a:rPr lang="en-US" sz="1800" dirty="0">
+                <a:solidFill>
+                  <a:srgbClr val="333333"/>
+                </a:solidFill>
+              </a:rPr>
+              <a:t> dan tidak tercemar oleh cacat kelengkapan data.</a:t>
             </a:r>
             <a:endParaRPr lang="en-US" sz="1800" dirty="0"/>
           </a:p>
@@ -15261,7 +15391,7 @@
                   <a:srgbClr val="003366"/>
                 </a:solidFill>
               </a:rPr>
-              <a:t>Lampiran: Mengapa Menyertakan Tether (USDT)? (2/2)</a:t>
+              <a:t>Lampiran: Mengapa Menyertakan Tether (USDT)? (1/2)</a:t>
             </a:r>
             <a:endParaRPr lang="en-US" sz="2600" dirty="0"/>
           </a:p>
@@ -15292,12 +15422,89 @@
               <a:buNone/>
             </a:pPr>
             <a:r>
+              <a:rPr lang="en-US" sz="1800" b="1" dirty="0">
+                <a:solidFill>
+                  <a:srgbClr val="C0392B"/>
+                </a:solidFill>
+              </a:rPr>
+              <a:t>Pertanyaan: </a:t>
+            </a:r>
+            <a:pPr indent="0" marL="0">
+              <a:buNone/>
+            </a:pPr>
+            <a:r>
+              <a:rPr lang="en-US" sz="1800" i="1" dirty="0">
+                <a:solidFill>
+                  <a:srgbClr val="333333"/>
+                </a:solidFill>
+              </a:rPr>
+              <a:t>"Tether (USDT) itu stablecoin yang nilainya selalu fix ke 1 USD. Apakah tidak berbuat curang?"</a:t>
+            </a:r>
+            <a:endParaRPr lang="en-US" sz="1800" dirty="0"/>
+          </a:p>
+          <a:p>
+            <a:pPr indent="0" marL="0">
+              <a:buNone/>
+            </a:pPr>
+            <a:r>
+              <a:rPr lang="en-US" sz="1800" b="1" dirty="0">
+                <a:solidFill>
+                  <a:srgbClr val="27AE60"/>
+                </a:solidFill>
+              </a:rPr>
+              <a:t>Jawaban (Dinamika Portofolio Cerdas):</a:t>
+            </a:r>
+            <a:endParaRPr lang="en-US" sz="1800" dirty="0"/>
+          </a:p>
+          <a:p>
+            <a:pPr marL="342900" indent="-342900">
+              <a:buSzPct val="100000"/>
+              <a:buChar char="•"/>
+            </a:pPr>
+            <a:r>
               <a:rPr lang="en-US" sz="1800" dirty="0">
                 <a:solidFill>
                   <a:srgbClr val="333333"/>
                 </a:solidFill>
               </a:rPr>
-              <a:t>3. Algoritma jaringan </a:t>
+              <a:t>Model ini mensimulasikan perilaku </a:t>
+            </a:r>
+            <a:pPr indent="0" marL="0">
+              <a:buNone/>
+            </a:pPr>
+            <a:r>
+              <a:rPr lang="en-US" sz="1800" b="1" i="1" dirty="0">
+                <a:solidFill>
+                  <a:srgbClr val="333333"/>
+                </a:solidFill>
+              </a:rPr>
+              <a:t>Robo-Advisory</a:t>
+            </a:r>
+            <a:pPr indent="0" marL="0">
+              <a:buNone/>
+            </a:pPr>
+            <a:r>
+              <a:rPr lang="en-US" sz="1800" dirty="0">
+                <a:solidFill>
+                  <a:srgbClr val="333333"/>
+                </a:solidFill>
+              </a:rPr>
+              <a:t> institusional.</a:t>
+            </a:r>
+            <a:endParaRPr lang="en-US" sz="1800" dirty="0"/>
+          </a:p>
+          <a:p>
+            <a:pPr marL="342900" indent="-342900">
+              <a:buSzPct val="100000"/>
+              <a:buChar char="•"/>
+            </a:pPr>
+            <a:r>
+              <a:rPr lang="en-US" sz="1800" dirty="0">
+                <a:solidFill>
+                  <a:srgbClr val="333333"/>
+                </a:solidFill>
+              </a:rPr>
+              <a:t>Ketika pasar anjlok ekstrem, investor akan melarikan senjatanya ke posisi </a:t>
             </a:r>
             <a:pPr indent="0" marL="0">
               <a:buNone/>
@@ -15308,7 +15515,7 @@
                   <a:srgbClr val="333333"/>
                 </a:solidFill>
               </a:rPr>
-              <a:t>Network Markowitz GS (Grid Search)</a:t>
+              <a:t>tunai (USDT)</a:t>
             </a:r>
             <a:pPr indent="0" marL="0">
               <a:buNone/>
@@ -15319,87 +15526,7 @@
                   <a:srgbClr val="333333"/>
                 </a:solidFill>
               </a:rPr>
-              <a:t> dilatih secara matematis; jika mendeteksi korelasi ancaman kolaps merambat ke semua altcoin, ia akan melempar alokasi modalnya menuju node </a:t>
-            </a:r>
-            <a:pPr indent="0" marL="0">
-              <a:buNone/>
-            </a:pPr>
-            <a:r>
-              <a:rPr lang="en-US" sz="1800" b="1" dirty="0">
-                <a:solidFill>
-                  <a:srgbClr val="333333"/>
-                </a:solidFill>
-              </a:rPr>
-              <a:t>USDT (Tether)</a:t>
-            </a:r>
-            <a:pPr indent="0" marL="0">
-              <a:buNone/>
-            </a:pPr>
-            <a:r>
-              <a:rPr lang="en-US" sz="1800" dirty="0">
-                <a:solidFill>
-                  <a:srgbClr val="333333"/>
-                </a:solidFill>
-              </a:rPr>
-              <a:t> sebagai langkah </a:t>
-            </a:r>
-            <a:pPr indent="0" marL="0">
-              <a:buNone/>
-            </a:pPr>
-            <a:r>
-              <a:rPr lang="en-US" sz="1800" b="1" dirty="0">
-                <a:solidFill>
-                  <a:srgbClr val="333333"/>
-                </a:solidFill>
-              </a:rPr>
-              <a:t>evakuasi otomatis</a:t>
-            </a:r>
-            <a:pPr indent="0" marL="0">
-              <a:buNone/>
-            </a:pPr>
-            <a:r>
-              <a:rPr lang="en-US" sz="1800" dirty="0">
-                <a:solidFill>
-                  <a:srgbClr val="333333"/>
-                </a:solidFill>
-              </a:rPr>
-              <a:t> (Shock-Absorber).</a:t>
-            </a:r>
-            <a:endParaRPr lang="en-US" sz="1800" dirty="0"/>
-          </a:p>
-          <a:p>
-            <a:pPr indent="0" marL="0">
-              <a:buNone/>
-            </a:pPr>
-            <a:r>
-              <a:rPr lang="en-US" sz="1800" dirty="0">
-                <a:solidFill>
-                  <a:srgbClr val="333333"/>
-                </a:solidFill>
-              </a:rPr>
-              <a:t>   4. Hal ini yang membuat performa Risk-GS (Grid Search) sangat </a:t>
-            </a:r>
-            <a:pPr indent="0" marL="0">
-              <a:buNone/>
-            </a:pPr>
-            <a:r>
-              <a:rPr lang="en-US" sz="1800" b="1" dirty="0">
-                <a:solidFill>
-                  <a:srgbClr val="333333"/>
-                </a:solidFill>
-              </a:rPr>
-              <a:t>tangguh</a:t>
-            </a:r>
-            <a:pPr indent="0" marL="0">
-              <a:buNone/>
-            </a:pPr>
-            <a:r>
-              <a:rPr lang="en-US" sz="1800" dirty="0">
-                <a:solidFill>
-                  <a:srgbClr val="333333"/>
-                </a:solidFill>
-              </a:rPr>
-              <a:t> dari serangan Crypto Winter, suatu kapabilitas pertahanan yang tidak dipahami oleh model ortodoks murni Markowitz.</a:t>
+              <a:t> sebagai evakuasi risiko.</a:t>
             </a:r>
             <a:endParaRPr lang="en-US" sz="1800" dirty="0"/>
           </a:p>
@@ -15460,7 +15587,7 @@
                   <a:srgbClr val="003366"/>
                 </a:solidFill>
               </a:rPr>
-              <a:t>Lampiran: Bukti Empiris Non-Stationarity Pasar</a:t>
+              <a:t>Lampiran: Mengapa Menyertakan Tether (USDT)? (2/2)</a:t>
             </a:r>
             <a:endParaRPr lang="en-US" sz="2600" dirty="0"/>
           </a:p>
@@ -15491,23 +15618,78 @@
               <a:buNone/>
             </a:pPr>
             <a:r>
+              <a:rPr lang="en-US" sz="1800" dirty="0">
+                <a:solidFill>
+                  <a:srgbClr val="333333"/>
+                </a:solidFill>
+              </a:rPr>
+              <a:t>3. Algoritma jaringan </a:t>
+            </a:r>
+            <a:pPr indent="0" marL="0">
+              <a:buNone/>
+            </a:pPr>
+            <a:r>
               <a:rPr lang="en-US" sz="1800" b="1" dirty="0">
                 <a:solidFill>
-                  <a:srgbClr val="C0392B"/>
-                </a:solidFill>
-              </a:rPr>
-              <a:t>Masalah: </a:t>
-            </a:r>
-            <a:pPr indent="0" marL="0">
-              <a:buNone/>
-            </a:pPr>
-            <a:r>
-              <a:rPr lang="en-US" sz="1800" i="1" dirty="0">
-                <a:solidFill>
-                  <a:srgbClr val="333333"/>
-                </a:solidFill>
-              </a:rPr>
-              <a:t>Kenapa harus menggunakan model Adaptif (Dynamic Gamma)?</a:t>
+                  <a:srgbClr val="333333"/>
+                </a:solidFill>
+              </a:rPr>
+              <a:t>Network Markowitz GS (Grid Search)</a:t>
+            </a:r>
+            <a:pPr indent="0" marL="0">
+              <a:buNone/>
+            </a:pPr>
+            <a:r>
+              <a:rPr lang="en-US" sz="1800" dirty="0">
+                <a:solidFill>
+                  <a:srgbClr val="333333"/>
+                </a:solidFill>
+              </a:rPr>
+              <a:t> dilatih secara matematis; jika mendeteksi korelasi ancaman kolaps merambat ke semua altcoin, ia akan melempar alokasi modalnya menuju node </a:t>
+            </a:r>
+            <a:pPr indent="0" marL="0">
+              <a:buNone/>
+            </a:pPr>
+            <a:r>
+              <a:rPr lang="en-US" sz="1800" b="1" dirty="0">
+                <a:solidFill>
+                  <a:srgbClr val="333333"/>
+                </a:solidFill>
+              </a:rPr>
+              <a:t>USDT (Tether)</a:t>
+            </a:r>
+            <a:pPr indent="0" marL="0">
+              <a:buNone/>
+            </a:pPr>
+            <a:r>
+              <a:rPr lang="en-US" sz="1800" dirty="0">
+                <a:solidFill>
+                  <a:srgbClr val="333333"/>
+                </a:solidFill>
+              </a:rPr>
+              <a:t> sebagai langkah </a:t>
+            </a:r>
+            <a:pPr indent="0" marL="0">
+              <a:buNone/>
+            </a:pPr>
+            <a:r>
+              <a:rPr lang="en-US" sz="1800" b="1" dirty="0">
+                <a:solidFill>
+                  <a:srgbClr val="333333"/>
+                </a:solidFill>
+              </a:rPr>
+              <a:t>evakuasi otomatis</a:t>
+            </a:r>
+            <a:pPr indent="0" marL="0">
+              <a:buNone/>
+            </a:pPr>
+            <a:r>
+              <a:rPr lang="en-US" sz="1800" dirty="0">
+                <a:solidFill>
+                  <a:srgbClr val="333333"/>
+                </a:solidFill>
+              </a:rPr>
+              <a:t> (Shock-Absorber).</a:t>
             </a:r>
             <a:endParaRPr lang="en-US" sz="1800" dirty="0"/>
           </a:p>
@@ -15516,19 +15698,26 @@
               <a:buNone/>
             </a:pPr>
             <a:r>
+              <a:rPr lang="en-US" sz="1800" dirty="0">
+                <a:solidFill>
+                  <a:srgbClr val="333333"/>
+                </a:solidFill>
+              </a:rPr>
+              <a:t>   4. Hal ini yang membuat performa Risk-GS (Grid Search) sangat </a:t>
+            </a:r>
+            <a:pPr indent="0" marL="0">
+              <a:buNone/>
+            </a:pPr>
+            <a:r>
               <a:rPr lang="en-US" sz="1800" b="1" dirty="0">
                 <a:solidFill>
-                  <a:srgbClr val="27AE60"/>
-                </a:solidFill>
-              </a:rPr>
-              <a:t>Bukti dari Grid Search:</a:t>
-            </a:r>
-            <a:endParaRPr lang="en-US" sz="1800" dirty="0"/>
-          </a:p>
-          <a:p>
-            <a:pPr marL="342900" indent="-342900">
-              <a:buSzPct val="100000"/>
-              <a:buChar char="•"/>
+                  <a:srgbClr val="333333"/>
+                </a:solidFill>
+              </a:rPr>
+              <a:t>tangguh</a:t>
+            </a:r>
+            <a:pPr indent="0" marL="0">
+              <a:buNone/>
             </a:pPr>
             <a:r>
               <a:rPr lang="en-US" sz="1800" dirty="0">
@@ -15536,103 +15725,7 @@
                   <a:srgbClr val="333333"/>
                 </a:solidFill>
               </a:rPr>
-              <a:t>Data menunjukkan nilai Gamma (γ) optimal </a:t>
-            </a:r>
-            <a:pPr indent="0" marL="0">
-              <a:buNone/>
-            </a:pPr>
-            <a:r>
-              <a:rPr lang="en-US" sz="1800" b="1" dirty="0">
-                <a:solidFill>
-                  <a:srgbClr val="333333"/>
-                </a:solidFill>
-              </a:rPr>
-              <a:t>terus bergeser</a:t>
-            </a:r>
-            <a:pPr indent="0" marL="0">
-              <a:buNone/>
-            </a:pPr>
-            <a:r>
-              <a:rPr lang="en-US" sz="1800" dirty="0">
-                <a:solidFill>
-                  <a:srgbClr val="333333"/>
-                </a:solidFill>
-              </a:rPr>
-              <a:t> setiap periode rebalancing.</a:t>
-            </a:r>
-            <a:endParaRPr lang="en-US" sz="1800" dirty="0"/>
-          </a:p>
-          <a:p>
-            <a:pPr marL="342900" indent="-342900">
-              <a:buSzPct val="100000"/>
-              <a:buChar char="•"/>
-            </a:pPr>
-            <a:r>
-              <a:rPr lang="en-US" sz="1800" dirty="0">
-                <a:solidFill>
-                  <a:srgbClr val="333333"/>
-                </a:solidFill>
-              </a:rPr>
-              <a:t>Penggunaan γ statis tidak cukup untuk menangkap perubahan </a:t>
-            </a:r>
-            <a:pPr indent="0" marL="0">
-              <a:buNone/>
-            </a:pPr>
-            <a:r>
-              <a:rPr lang="en-US" sz="1800" b="1" dirty="0">
-                <a:solidFill>
-                  <a:srgbClr val="333333"/>
-                </a:solidFill>
-              </a:rPr>
-              <a:t>struktur korelasi</a:t>
-            </a:r>
-            <a:pPr indent="0" marL="0">
-              <a:buNone/>
-            </a:pPr>
-            <a:r>
-              <a:rPr lang="en-US" sz="1800" dirty="0">
-                <a:solidFill>
-                  <a:srgbClr val="333333"/>
-                </a:solidFill>
-              </a:rPr>
-              <a:t> yang sangat cepat di pasar kripto.</a:t>
-            </a:r>
-            <a:endParaRPr lang="en-US" sz="1800" dirty="0"/>
-          </a:p>
-          <a:p>
-            <a:pPr marL="342900" indent="-342900">
-              <a:buSzPct val="100000"/>
-              <a:buChar char="•"/>
-            </a:pPr>
-            <a:r>
-              <a:rPr lang="en-US" sz="1800" dirty="0">
-                <a:solidFill>
-                  <a:srgbClr val="333333"/>
-                </a:solidFill>
-              </a:rPr>
-              <a:t>Ini membenarkan bahwa pasar kripto membutuhkan </a:t>
-            </a:r>
-            <a:pPr indent="0" marL="0">
-              <a:buNone/>
-            </a:pPr>
-            <a:r>
-              <a:rPr lang="en-US" sz="1800" b="1" dirty="0">
-                <a:solidFill>
-                  <a:srgbClr val="333333"/>
-                </a:solidFill>
-              </a:rPr>
-              <a:t>kalibrasi otomatis</a:t>
-            </a:r>
-            <a:pPr indent="0" marL="0">
-              <a:buNone/>
-            </a:pPr>
-            <a:r>
-              <a:rPr lang="en-US" sz="1800" dirty="0">
-                <a:solidFill>
-                  <a:srgbClr val="333333"/>
-                </a:solidFill>
-              </a:rPr>
-              <a:t> secara temporal.</a:t>
+              <a:t> dari serangan Crypto Winter, suatu kapabilitas pertahanan yang tidak dipahami oleh model ortodoks murni Markowitz.</a:t>
             </a:r>
             <a:endParaRPr lang="en-US" sz="1800" dirty="0"/>
           </a:p>
@@ -15649,6 +15742,239 @@
 <file path=ppt/slides/slide46.xml><?xml version="1.0" encoding="utf-8"?>
 <p:sld xmlns:a="http://schemas.openxmlformats.org/drawingml/2006/main" xmlns:r="http://schemas.openxmlformats.org/officeDocument/2006/relationships" xmlns:p="http://schemas.openxmlformats.org/presentationml/2006/main">
   <p:cSld name="Slide 46">
+    <p:spTree>
+      <p:nvGrpSpPr>
+        <p:cNvPr id="1" name=""/>
+        <p:cNvGrpSpPr/>
+        <p:nvPr/>
+      </p:nvGrpSpPr>
+      <p:grpSpPr>
+        <a:xfrm>
+          <a:off x="0" y="0"/>
+          <a:ext cx="0" cy="0"/>
+          <a:chOff x="0" y="0"/>
+          <a:chExt cx="0" cy="0"/>
+        </a:xfrm>
+      </p:grpSpPr>
+      <p:sp>
+        <p:nvSpPr>
+          <p:cNvPr id="2" name="Text 0"/>
+          <p:cNvSpPr/>
+          <p:nvPr/>
+        </p:nvSpPr>
+        <p:spPr>
+          <a:xfrm>
+            <a:off x="457200" y="457200"/>
+            <a:ext cx="8229600" cy="0"/>
+          </a:xfrm>
+          <a:prstGeom prst="rect">
+            <a:avLst/>
+          </a:prstGeom>
+          <a:noFill/>
+          <a:ln/>
+        </p:spPr>
+        <p:txBody>
+          <a:bodyPr wrap="square" rtlCol="0" anchor="ctr"/>
+          <a:lstStyle/>
+          <a:p>
+            <a:pPr indent="0" marL="0">
+              <a:buNone/>
+            </a:pPr>
+            <a:r>
+              <a:rPr lang="en-US" sz="2600" b="1" dirty="0">
+                <a:solidFill>
+                  <a:srgbClr val="003366"/>
+                </a:solidFill>
+              </a:rPr>
+              <a:t>Lampiran: Bukti Empiris Non-Stationarity Pasar</a:t>
+            </a:r>
+            <a:endParaRPr lang="en-US" sz="2600" dirty="0"/>
+          </a:p>
+        </p:txBody>
+      </p:sp>
+      <p:sp>
+        <p:nvSpPr>
+          <p:cNvPr id="3" name="Text 1"/>
+          <p:cNvSpPr/>
+          <p:nvPr/>
+        </p:nvSpPr>
+        <p:spPr>
+          <a:xfrm>
+            <a:off x="457200" y="1005840"/>
+            <a:ext cx="8229600" cy="5029200"/>
+          </a:xfrm>
+          <a:prstGeom prst="rect">
+            <a:avLst/>
+          </a:prstGeom>
+          <a:noFill/>
+          <a:ln/>
+        </p:spPr>
+        <p:txBody>
+          <a:bodyPr wrap="square" rtlCol="0" anchor="t"/>
+          <a:lstStyle/>
+          <a:p>
+            <a:pPr indent="0" marL="0">
+              <a:buNone/>
+            </a:pPr>
+            <a:r>
+              <a:rPr lang="en-US" sz="1800" b="1" dirty="0">
+                <a:solidFill>
+                  <a:srgbClr val="C0392B"/>
+                </a:solidFill>
+              </a:rPr>
+              <a:t>Masalah: </a:t>
+            </a:r>
+            <a:pPr indent="0" marL="0">
+              <a:buNone/>
+            </a:pPr>
+            <a:r>
+              <a:rPr lang="en-US" sz="1800" i="1" dirty="0">
+                <a:solidFill>
+                  <a:srgbClr val="333333"/>
+                </a:solidFill>
+              </a:rPr>
+              <a:t>Kenapa harus menggunakan model Adaptif (Dynamic Gamma)?</a:t>
+            </a:r>
+            <a:endParaRPr lang="en-US" sz="1800" dirty="0"/>
+          </a:p>
+          <a:p>
+            <a:pPr indent="0" marL="0">
+              <a:buNone/>
+            </a:pPr>
+            <a:r>
+              <a:rPr lang="en-US" sz="1800" b="1" dirty="0">
+                <a:solidFill>
+                  <a:srgbClr val="27AE60"/>
+                </a:solidFill>
+              </a:rPr>
+              <a:t>Bukti dari Grid Search:</a:t>
+            </a:r>
+            <a:endParaRPr lang="en-US" sz="1800" dirty="0"/>
+          </a:p>
+          <a:p>
+            <a:pPr marL="342900" indent="-342900">
+              <a:buSzPct val="100000"/>
+              <a:buChar char="•"/>
+            </a:pPr>
+            <a:r>
+              <a:rPr lang="en-US" sz="1800" dirty="0">
+                <a:solidFill>
+                  <a:srgbClr val="333333"/>
+                </a:solidFill>
+              </a:rPr>
+              <a:t>Data menunjukkan nilai Gamma (γ) optimal </a:t>
+            </a:r>
+            <a:pPr indent="0" marL="0">
+              <a:buNone/>
+            </a:pPr>
+            <a:r>
+              <a:rPr lang="en-US" sz="1800" b="1" dirty="0">
+                <a:solidFill>
+                  <a:srgbClr val="333333"/>
+                </a:solidFill>
+              </a:rPr>
+              <a:t>terus bergeser</a:t>
+            </a:r>
+            <a:pPr indent="0" marL="0">
+              <a:buNone/>
+            </a:pPr>
+            <a:r>
+              <a:rPr lang="en-US" sz="1800" dirty="0">
+                <a:solidFill>
+                  <a:srgbClr val="333333"/>
+                </a:solidFill>
+              </a:rPr>
+              <a:t> setiap periode rebalancing.</a:t>
+            </a:r>
+            <a:endParaRPr lang="en-US" sz="1800" dirty="0"/>
+          </a:p>
+          <a:p>
+            <a:pPr marL="342900" indent="-342900">
+              <a:buSzPct val="100000"/>
+              <a:buChar char="•"/>
+            </a:pPr>
+            <a:r>
+              <a:rPr lang="en-US" sz="1800" dirty="0">
+                <a:solidFill>
+                  <a:srgbClr val="333333"/>
+                </a:solidFill>
+              </a:rPr>
+              <a:t>Penggunaan γ statis tidak cukup untuk menangkap perubahan </a:t>
+            </a:r>
+            <a:pPr indent="0" marL="0">
+              <a:buNone/>
+            </a:pPr>
+            <a:r>
+              <a:rPr lang="en-US" sz="1800" b="1" dirty="0">
+                <a:solidFill>
+                  <a:srgbClr val="333333"/>
+                </a:solidFill>
+              </a:rPr>
+              <a:t>struktur korelasi</a:t>
+            </a:r>
+            <a:pPr indent="0" marL="0">
+              <a:buNone/>
+            </a:pPr>
+            <a:r>
+              <a:rPr lang="en-US" sz="1800" dirty="0">
+                <a:solidFill>
+                  <a:srgbClr val="333333"/>
+                </a:solidFill>
+              </a:rPr>
+              <a:t> yang sangat cepat di pasar kripto.</a:t>
+            </a:r>
+            <a:endParaRPr lang="en-US" sz="1800" dirty="0"/>
+          </a:p>
+          <a:p>
+            <a:pPr marL="342900" indent="-342900">
+              <a:buSzPct val="100000"/>
+              <a:buChar char="•"/>
+            </a:pPr>
+            <a:r>
+              <a:rPr lang="en-US" sz="1800" dirty="0">
+                <a:solidFill>
+                  <a:srgbClr val="333333"/>
+                </a:solidFill>
+              </a:rPr>
+              <a:t>Ini membenarkan bahwa pasar kripto membutuhkan </a:t>
+            </a:r>
+            <a:pPr indent="0" marL="0">
+              <a:buNone/>
+            </a:pPr>
+            <a:r>
+              <a:rPr lang="en-US" sz="1800" b="1" dirty="0">
+                <a:solidFill>
+                  <a:srgbClr val="333333"/>
+                </a:solidFill>
+              </a:rPr>
+              <a:t>kalibrasi otomatis</a:t>
+            </a:r>
+            <a:pPr indent="0" marL="0">
+              <a:buNone/>
+            </a:pPr>
+            <a:r>
+              <a:rPr lang="en-US" sz="1800" dirty="0">
+                <a:solidFill>
+                  <a:srgbClr val="333333"/>
+                </a:solidFill>
+              </a:rPr>
+              <a:t> secara temporal.</a:t>
+            </a:r>
+            <a:endParaRPr lang="en-US" sz="1800" dirty="0"/>
+          </a:p>
+        </p:txBody>
+      </p:sp>
+    </p:spTree>
+  </p:cSld>
+  <p:clrMapOvr>
+    <a:masterClrMapping/>
+  </p:clrMapOvr>
+</p:sld>
+</file>
+
+<file path=ppt/slides/slide47.xml><?xml version="1.0" encoding="utf-8"?>
+<p:sld xmlns:a="http://schemas.openxmlformats.org/drawingml/2006/main" xmlns:r="http://schemas.openxmlformats.org/officeDocument/2006/relationships" xmlns:p="http://schemas.openxmlformats.org/presentationml/2006/main">
+  <p:cSld name="Slide 47">
     <p:spTree>
       <p:nvGrpSpPr>
         <p:cNvPr id="1" name=""/>

</xml_diff>

<commit_message>
feat: add correlation combination calculation slide (45 for 10 assets)
</commit_message>
<xml_diff>
--- a/Presentasi_Proposal_Update.pptx
+++ b/Presentasi_Proposal_Update.pptx
@@ -52,9 +52,10 @@
     <p:sldId id="300" r:id="rId46"/>
     <p:sldId id="301" r:id="rId47"/>
     <p:sldId id="302" r:id="rId48"/>
+    <p:sldId id="303" r:id="rId49"/>
   </p:sldIdLst>
   <p:notesMasterIdLst>
-    <p:notesMasterId r:id="rId49"/>
+    <p:notesMasterId r:id="rId50"/>
   </p:notesMasterIdLst>
   <p:sldSz cx="9144000" cy="5143500"/>
   <p:notesSz cx="5143500" cy="9144000"/>
@@ -4180,6 +4181,94 @@
             <a:fld id="{F7021451-1387-4CA6-816F-3879F97B5CBC}" type="slidenum">
               <a:rPr lang="en-US"/>
               <a:t>47</a:t>
+            </a:fld>
+            <a:endParaRPr lang="en-US"/>
+          </a:p>
+        </p:txBody>
+      </p:sp>
+    </p:spTree>
+    <p:extLst>
+      <p:ext uri="{BB962C8B-B14F-4D97-AF65-F5344CB8AC3E}">
+        <p14:creationId xmlns:p14="http://schemas.microsoft.com/office/powerpoint/2010/main" val="1024086991"/>
+      </p:ext>
+    </p:extLst>
+  </p:cSld>
+  <p:clrMapOvr>
+    <a:masterClrMapping/>
+  </p:clrMapOvr>
+</p:notes>
+</file>
+
+<file path=ppt/notesSlides/notesSlide48.xml><?xml version="1.0" encoding="utf-8"?>
+<p:notes xmlns:a="http://schemas.openxmlformats.org/drawingml/2006/main" xmlns:r="http://schemas.openxmlformats.org/officeDocument/2006/relationships" xmlns:p="http://schemas.openxmlformats.org/presentationml/2006/main">
+  <p:cSld>
+    <p:spTree>
+      <p:nvGrpSpPr>
+        <p:cNvPr id="1" name=""/>
+        <p:cNvGrpSpPr/>
+        <p:nvPr/>
+      </p:nvGrpSpPr>
+      <p:grpSpPr>
+        <a:xfrm>
+          <a:off x="0" y="0"/>
+          <a:ext cx="0" cy="0"/>
+          <a:chOff x="0" y="0"/>
+          <a:chExt cx="0" cy="0"/>
+        </a:xfrm>
+      </p:grpSpPr>
+      <p:sp>
+        <p:nvSpPr>
+          <p:cNvPr id="2" name="Slide Image Placeholder 1"/>
+          <p:cNvSpPr>
+            <a:spLocks noGrp="1" noRot="1" noChangeAspect="1"/>
+          </p:cNvSpPr>
+          <p:nvPr>
+            <p:ph type="sldImg"/>
+          </p:nvPr>
+        </p:nvSpPr>
+        <p:spPr/>
+      </p:sp>
+      <p:sp>
+        <p:nvSpPr>
+          <p:cNvPr id="3" name="Notes Placeholder 2"/>
+          <p:cNvSpPr>
+            <a:spLocks noGrp="1"/>
+          </p:cNvSpPr>
+          <p:nvPr>
+            <p:ph type="body" idx="1"/>
+          </p:nvPr>
+        </p:nvSpPr>
+        <p:spPr/>
+        <p:txBody>
+          <a:bodyPr/>
+          <a:lstStyle/>
+          <a:p>
+            <a:r>
+              <a:rPr lang="en-US" dirty="0"/>
+              <a:t/>
+            </a:r>
+            <a:endParaRPr lang="en-US" dirty="0"/>
+          </a:p>
+        </p:txBody>
+      </p:sp>
+      <p:sp>
+        <p:nvSpPr>
+          <p:cNvPr id="4" name="Slide Number Placeholder 3"/>
+          <p:cNvSpPr>
+            <a:spLocks noGrp="1"/>
+          </p:cNvSpPr>
+          <p:nvPr>
+            <p:ph type="sldNum" sz="quarter" idx="10"/>
+          </p:nvPr>
+        </p:nvSpPr>
+        <p:spPr/>
+        <p:txBody>
+          <a:bodyPr/>
+          <a:lstStyle/>
+          <a:p>
+            <a:fld id="{F7021451-1387-4CA6-816F-3879F97B5CBC}" type="slidenum">
+              <a:rPr lang="en-US"/>
+              <a:t>48</a:t>
             </a:fld>
             <a:endParaRPr lang="en-US"/>
           </a:p>
@@ -14847,14 +14936,14 @@
               <a:buNone/>
             </a:pPr>
             <a:r>
-              <a:rPr lang="en-US" sz="2600" b="1" dirty="0">
+              <a:rPr lang="en-US" sz="2400" b="1" dirty="0">
                 <a:solidFill>
                   <a:srgbClr val="003366"/>
                 </a:solidFill>
               </a:rPr>
-              <a:t>Lampiran: Dua Tipe Pendekatan Grid Search</a:t>
-            </a:r>
-            <a:endParaRPr lang="en-US" sz="2600" dirty="0"/>
+              <a:t>Lampiran: Berapa Banyak Perhitungan Korelasi?</a:t>
+            </a:r>
+            <a:endParaRPr lang="en-US" sz="2400" dirty="0"/>
           </a:p>
         </p:txBody>
       </p:sp>
@@ -14883,190 +14972,190 @@
               <a:buNone/>
             </a:pPr>
             <a:r>
-              <a:rPr lang="en-US" sz="1800" b="1" dirty="0">
-                <a:solidFill>
-                  <a:srgbClr val="333333"/>
-                </a:solidFill>
-              </a:rPr>
-              <a:t>Dua Objektif Optimasi (Return vs Risk):</a:t>
-            </a:r>
-            <a:endParaRPr lang="en-US" sz="1800" dirty="0"/>
-          </a:p>
-          <a:p>
-            <a:pPr indent="0" marL="0">
-              <a:buNone/>
-            </a:pPr>
-            <a:r>
-              <a:rPr lang="en-US" sz="1800" b="1" dirty="0">
+              <a:rPr lang="en-US" sz="1600" b="1" dirty="0">
+                <a:solidFill>
+                  <a:srgbClr val="333333"/>
+                </a:solidFill>
+              </a:rPr>
+              <a:t>Untuk membangun satu matriks utuh, setiap aset harus dipasangkan satu sama lain.</a:t>
+            </a:r>
+            <a:endParaRPr lang="en-US" sz="1600" dirty="0"/>
+          </a:p>
+          <a:p>
+            <a:pPr indent="0" marL="0">
+              <a:buNone/>
+            </a:pPr>
+            <a:r>
+              <a:rPr lang="en-US" sz="1600" b="1" dirty="0">
+                <a:solidFill>
+                  <a:srgbClr val="C0392B"/>
+                </a:solidFill>
+                <a:latin typeface="Courier New" pitchFamily="34" charset="0"/>
+                <a:ea typeface="Courier New" pitchFamily="34" charset="-122"/>
+                <a:cs typeface="Courier New" pitchFamily="34" charset="-120"/>
+              </a:rPr>
+              <a:t>Rumus Kombinasi: C(N,2) = (N × (N - 1)) / 2</a:t>
+            </a:r>
+            <a:endParaRPr lang="en-US" sz="1600" dirty="0"/>
+          </a:p>
+          <a:p>
+            <a:pPr indent="0" marL="0">
+              <a:buNone/>
+            </a:pPr>
+            <a:r>
+              <a:rPr lang="en-US" sz="1600" b="1" dirty="0">
+                <a:solidFill>
+                  <a:srgbClr val="003366"/>
+                </a:solidFill>
+              </a:rPr>
+              <a:t>Simulasi untuk 10 Aset (N=10):</a:t>
+            </a:r>
+            <a:endParaRPr lang="en-US" sz="1600" dirty="0"/>
+          </a:p>
+          <a:p>
+            <a:pPr indent="0" marL="0">
+              <a:buNone/>
+            </a:pPr>
+            <a:r>
+              <a:rPr lang="en-US" sz="1600" dirty="0">
+                <a:solidFill>
+                  <a:srgbClr val="333333"/>
+                </a:solidFill>
+              </a:rPr>
+              <a:t>   Jumlah Pasangan Unik = (10 × 9) / 2 = </a:t>
+            </a:r>
+            <a:pPr indent="0" marL="0">
+              <a:buNone/>
+            </a:pPr>
+            <a:r>
+              <a:rPr lang="en-US" sz="1600" b="1" dirty="0">
                 <a:solidFill>
                   <a:srgbClr val="27AE60"/>
                 </a:solidFill>
               </a:rPr>
-              <a:t>1. Network Markowitz dengan Target Return (NW - Return Grid Search):</a:t>
-            </a:r>
-            <a:endParaRPr lang="en-US" sz="1800" dirty="0"/>
-          </a:p>
-          <a:p>
-            <a:pPr marL="342900" indent="-342900">
-              <a:buSzPct val="100000"/>
-              <a:buChar char="•"/>
-            </a:pPr>
-            <a:r>
-              <a:rPr lang="en-US" sz="1800" dirty="0">
-                <a:solidFill>
-                  <a:srgbClr val="333333"/>
-                </a:solidFill>
-              </a:rPr>
-              <a:t>Memaksimalkan capaian </a:t>
-            </a:r>
-            <a:pPr indent="0" marL="0">
-              <a:buNone/>
-            </a:pPr>
-            <a:r>
-              <a:rPr lang="en-US" sz="1800" b="1" dirty="0">
-                <a:solidFill>
-                  <a:srgbClr val="333333"/>
-                </a:solidFill>
-              </a:rPr>
-              <a:t>imbal hasil</a:t>
-            </a:r>
-            <a:pPr indent="0" marL="0">
-              <a:buNone/>
-            </a:pPr>
-            <a:r>
-              <a:rPr lang="en-US" sz="1800" dirty="0">
-                <a:solidFill>
-                  <a:srgbClr val="333333"/>
-                </a:solidFill>
-              </a:rPr>
-              <a:t> portofolio.</a:t>
-            </a:r>
-            <a:endParaRPr lang="en-US" sz="1800" dirty="0"/>
-          </a:p>
-          <a:p>
-            <a:pPr marL="342900" indent="-342900">
-              <a:buSzPct val="100000"/>
-              <a:buChar char="•"/>
-            </a:pPr>
-            <a:r>
-              <a:rPr lang="en-US" sz="1800" dirty="0">
-                <a:solidFill>
-                  <a:srgbClr val="333333"/>
-                </a:solidFill>
-              </a:rPr>
-              <a:t>Lebih Agresif untuk mengeksploitasi reli pada pasar </a:t>
-            </a:r>
-            <a:pPr indent="0" marL="0">
-              <a:buNone/>
-            </a:pPr>
-            <a:r>
-              <a:rPr lang="en-US" sz="1800" b="1" dirty="0">
-                <a:solidFill>
-                  <a:srgbClr val="333333"/>
-                </a:solidFill>
-              </a:rPr>
-              <a:t>Bullish</a:t>
-            </a:r>
-            <a:pPr indent="0" marL="0">
-              <a:buNone/>
-            </a:pPr>
-            <a:r>
-              <a:rPr lang="en-US" sz="1800" dirty="0">
-                <a:solidFill>
-                  <a:srgbClr val="333333"/>
-                </a:solidFill>
-              </a:rPr>
-              <a:t>.</a:t>
-            </a:r>
-            <a:endParaRPr lang="en-US" sz="1800" dirty="0"/>
-          </a:p>
-          <a:p>
-            <a:pPr indent="0" marL="0">
-              <a:buNone/>
-            </a:pPr>
-            <a:r>
-              <a:rPr lang="en-US" sz="1800" b="1" dirty="0">
-                <a:solidFill>
-                  <a:srgbClr val="C0392B"/>
-                </a:solidFill>
-              </a:rPr>
-              <a:t>2. Network Markowitz dengan Target Risiko (NW - Risk Grid Search):</a:t>
-            </a:r>
-            <a:endParaRPr lang="en-US" sz="1800" dirty="0"/>
-          </a:p>
-          <a:p>
-            <a:pPr marL="342900" indent="-342900">
-              <a:buSzPct val="100000"/>
-              <a:buChar char="•"/>
-            </a:pPr>
-            <a:r>
-              <a:rPr lang="en-US" sz="1800" dirty="0">
-                <a:solidFill>
-                  <a:srgbClr val="333333"/>
-                </a:solidFill>
-              </a:rPr>
-              <a:t>Menekan parameter </a:t>
-            </a:r>
-            <a:pPr indent="0" marL="0">
-              <a:buNone/>
-            </a:pPr>
-            <a:r>
-              <a:rPr lang="en-US" sz="1800" b="1" dirty="0">
-                <a:solidFill>
-                  <a:srgbClr val="333333"/>
-                </a:solidFill>
-              </a:rPr>
-              <a:t>risiko total</a:t>
-            </a:r>
-            <a:pPr indent="0" marL="0">
-              <a:buNone/>
-            </a:pPr>
-            <a:r>
-              <a:rPr lang="en-US" sz="1800" dirty="0">
-                <a:solidFill>
-                  <a:srgbClr val="333333"/>
-                </a:solidFill>
-              </a:rPr>
-              <a:t> hingga minimal.</a:t>
-            </a:r>
-            <a:endParaRPr lang="en-US" sz="1800" dirty="0"/>
-          </a:p>
-          <a:p>
-            <a:pPr marL="342900" indent="-342900">
-              <a:buSzPct val="100000"/>
-              <a:buChar char="•"/>
-            </a:pPr>
-            <a:r>
-              <a:rPr lang="en-US" sz="1800" dirty="0">
-                <a:solidFill>
-                  <a:srgbClr val="333333"/>
-                </a:solidFill>
-              </a:rPr>
-              <a:t>Lebih Defensif untuk meredam fluktuasi saat </a:t>
-            </a:r>
-            <a:pPr indent="0" marL="0">
-              <a:buNone/>
-            </a:pPr>
-            <a:r>
-              <a:rPr lang="en-US" sz="1800" b="1" dirty="0">
-                <a:solidFill>
-                  <a:srgbClr val="333333"/>
-                </a:solidFill>
-              </a:rPr>
-              <a:t>Crypto Winter</a:t>
-            </a:r>
-            <a:pPr indent="0" marL="0">
-              <a:buNone/>
-            </a:pPr>
-            <a:r>
-              <a:rPr lang="en-US" sz="1800" dirty="0">
-                <a:solidFill>
-                  <a:srgbClr val="333333"/>
-                </a:solidFill>
-              </a:rPr>
-              <a:t>.</a:t>
-            </a:r>
-            <a:endParaRPr lang="en-US" sz="1800" dirty="0"/>
+              <a:t>45 Perhitungan</a:t>
+            </a:r>
+            <a:endParaRPr lang="en-US" sz="1600" dirty="0"/>
+          </a:p>
+          <a:p>
+            <a:pPr indent="0" marL="0">
+              <a:buNone/>
+            </a:pPr>
+            <a:r>
+              <a:rPr lang="en-US" sz="1600" b="1" dirty="0">
+                <a:solidFill>
+                  <a:srgbClr val="003366"/>
+                </a:solidFill>
+              </a:rPr>
+              <a:t>Detail Penjabaran:</a:t>
+            </a:r>
+            <a:endParaRPr lang="en-US" sz="1600" dirty="0"/>
+          </a:p>
+          <a:p>
+            <a:pPr indent="0" marL="0">
+              <a:buNone/>
+            </a:pPr>
+            <a:r>
+              <a:rPr lang="en-US" sz="1600" dirty="0">
+                <a:solidFill>
+                  <a:srgbClr val="333333"/>
+                </a:solidFill>
+              </a:rPr>
+              <a:t>   • Koin ke-1 (BTC) berpasangan dengan 9 koin lainnya.</a:t>
+            </a:r>
+            <a:endParaRPr lang="en-US" sz="1600" dirty="0"/>
+          </a:p>
+          <a:p>
+            <a:pPr indent="0" marL="0">
+              <a:buNone/>
+            </a:pPr>
+            <a:r>
+              <a:rPr lang="en-US" sz="1600" dirty="0">
+                <a:solidFill>
+                  <a:srgbClr val="333333"/>
+                </a:solidFill>
+              </a:rPr>
+              <a:t>   • Koin ke-2 (ETH) berpasangan dengan 8 koin sisa.</a:t>
+            </a:r>
+            <a:endParaRPr lang="en-US" sz="1600" dirty="0"/>
+          </a:p>
+          <a:p>
+            <a:pPr indent="0" marL="0">
+              <a:buNone/>
+            </a:pPr>
+            <a:r>
+              <a:rPr lang="en-US" sz="1600" dirty="0">
+                <a:solidFill>
+                  <a:srgbClr val="333333"/>
+                </a:solidFill>
+              </a:rPr>
+              <a:t>   • Koin ke-3 (XRP) berpasangan dengan 7 koin sisa.</a:t>
+            </a:r>
+            <a:endParaRPr lang="en-US" sz="1600" dirty="0"/>
+          </a:p>
+          <a:p>
+            <a:pPr indent="0" marL="0">
+              <a:buNone/>
+            </a:pPr>
+            <a:r>
+              <a:rPr lang="en-US" sz="1600" dirty="0">
+                <a:solidFill>
+                  <a:srgbClr val="333333"/>
+                </a:solidFill>
+              </a:rPr>
+              <a:t>   • ... Seterusnya.</a:t>
+            </a:r>
+            <a:endParaRPr lang="en-US" sz="1600" dirty="0"/>
+          </a:p>
+          <a:p>
+            <a:pPr indent="0" marL="0">
+              <a:buNone/>
+            </a:pPr>
+            <a:r>
+              <a:rPr lang="en-US" sz="1600" dirty="0">
+                <a:solidFill>
+                  <a:srgbClr val="333333"/>
+                </a:solidFill>
+              </a:rPr>
+              <a:t>   • Total: 9 + 8 + 7 + 6 + 5 + 4 + 3 + 2 + 1 = </a:t>
+            </a:r>
+            <a:pPr indent="0" marL="0">
+              <a:buNone/>
+            </a:pPr>
+            <a:r>
+              <a:rPr lang="en-US" sz="1600" b="1" dirty="0">
+                <a:solidFill>
+                  <a:srgbClr val="333333"/>
+                </a:solidFill>
+              </a:rPr>
+              <a:t>45</a:t>
+            </a:r>
+            <a:pPr indent="0" marL="0">
+              <a:buNone/>
+            </a:pPr>
+            <a:r>
+              <a:rPr lang="en-US" sz="1600" b="1" dirty="0">
+                <a:solidFill>
+                  <a:srgbClr val="8E44AD"/>
+                </a:solidFill>
+              </a:rPr>
+              <a:t>Fakta Matriks 10x10:</a:t>
+            </a:r>
+            <a:endParaRPr lang="en-US" sz="1600" dirty="0"/>
+          </a:p>
+          <a:p>
+            <a:pPr indent="0" marL="0">
+              <a:buNone/>
+            </a:pPr>
+            <a:r>
+              <a:rPr lang="en-US" sz="1600" i="1" dirty="0">
+                <a:solidFill>
+                  <a:srgbClr val="333333"/>
+                </a:solidFill>
+              </a:rPr>
+              <a:t>Meskipun ada 100 kotak di matriks, komputer hanya perlu menghitung 45 angka unik karena korelasi bersifat cermin (A-B sama dengan B-A) dan tengahnya selalu 1 (A-A).</a:t>
+            </a:r>
+            <a:endParaRPr lang="en-US" sz="1600" dirty="0"/>
           </a:p>
         </p:txBody>
       </p:sp>
@@ -15125,7 +15214,7 @@
                   <a:srgbClr val="003366"/>
                 </a:solidFill>
               </a:rPr>
-              <a:t>Lampiran: Penanganan Data Kosong (Missing Values)</a:t>
+              <a:t>Lampiran: Dua Tipe Pendekatan Grid Search</a:t>
             </a:r>
             <a:endParaRPr lang="en-US" sz="2600" dirty="0"/>
           </a:p>
@@ -15158,41 +15247,156 @@
             <a:r>
               <a:rPr lang="en-US" sz="1800" b="1" dirty="0">
                 <a:solidFill>
+                  <a:srgbClr val="333333"/>
+                </a:solidFill>
+              </a:rPr>
+              <a:t>Dua Objektif Optimasi (Return vs Risk):</a:t>
+            </a:r>
+            <a:endParaRPr lang="en-US" sz="1800" dirty="0"/>
+          </a:p>
+          <a:p>
+            <a:pPr indent="0" marL="0">
+              <a:buNone/>
+            </a:pPr>
+            <a:r>
+              <a:rPr lang="en-US" sz="1800" b="1" dirty="0">
+                <a:solidFill>
+                  <a:srgbClr val="27AE60"/>
+                </a:solidFill>
+              </a:rPr>
+              <a:t>1. Network Markowitz dengan Target Return (NW - Return Grid Search):</a:t>
+            </a:r>
+            <a:endParaRPr lang="en-US" sz="1800" dirty="0"/>
+          </a:p>
+          <a:p>
+            <a:pPr marL="342900" indent="-342900">
+              <a:buSzPct val="100000"/>
+              <a:buChar char="•"/>
+            </a:pPr>
+            <a:r>
+              <a:rPr lang="en-US" sz="1800" dirty="0">
+                <a:solidFill>
+                  <a:srgbClr val="333333"/>
+                </a:solidFill>
+              </a:rPr>
+              <a:t>Memaksimalkan capaian </a:t>
+            </a:r>
+            <a:pPr indent="0" marL="0">
+              <a:buNone/>
+            </a:pPr>
+            <a:r>
+              <a:rPr lang="en-US" sz="1800" b="1" dirty="0">
+                <a:solidFill>
+                  <a:srgbClr val="333333"/>
+                </a:solidFill>
+              </a:rPr>
+              <a:t>imbal hasil</a:t>
+            </a:r>
+            <a:pPr indent="0" marL="0">
+              <a:buNone/>
+            </a:pPr>
+            <a:r>
+              <a:rPr lang="en-US" sz="1800" dirty="0">
+                <a:solidFill>
+                  <a:srgbClr val="333333"/>
+                </a:solidFill>
+              </a:rPr>
+              <a:t> portofolio.</a:t>
+            </a:r>
+            <a:endParaRPr lang="en-US" sz="1800" dirty="0"/>
+          </a:p>
+          <a:p>
+            <a:pPr marL="342900" indent="-342900">
+              <a:buSzPct val="100000"/>
+              <a:buChar char="•"/>
+            </a:pPr>
+            <a:r>
+              <a:rPr lang="en-US" sz="1800" dirty="0">
+                <a:solidFill>
+                  <a:srgbClr val="333333"/>
+                </a:solidFill>
+              </a:rPr>
+              <a:t>Lebih Agresif untuk mengeksploitasi reli pada pasar </a:t>
+            </a:r>
+            <a:pPr indent="0" marL="0">
+              <a:buNone/>
+            </a:pPr>
+            <a:r>
+              <a:rPr lang="en-US" sz="1800" b="1" dirty="0">
+                <a:solidFill>
+                  <a:srgbClr val="333333"/>
+                </a:solidFill>
+              </a:rPr>
+              <a:t>Bullish</a:t>
+            </a:r>
+            <a:pPr indent="0" marL="0">
+              <a:buNone/>
+            </a:pPr>
+            <a:r>
+              <a:rPr lang="en-US" sz="1800" dirty="0">
+                <a:solidFill>
+                  <a:srgbClr val="333333"/>
+                </a:solidFill>
+              </a:rPr>
+              <a:t>.</a:t>
+            </a:r>
+            <a:endParaRPr lang="en-US" sz="1800" dirty="0"/>
+          </a:p>
+          <a:p>
+            <a:pPr indent="0" marL="0">
+              <a:buNone/>
+            </a:pPr>
+            <a:r>
+              <a:rPr lang="en-US" sz="1800" b="1" dirty="0">
+                <a:solidFill>
                   <a:srgbClr val="C0392B"/>
                 </a:solidFill>
               </a:rPr>
-              <a:t>Pertanyaan: </a:t>
-            </a:r>
-            <a:pPr indent="0" marL="0">
-              <a:buNone/>
-            </a:pPr>
-            <a:r>
-              <a:rPr lang="en-US" sz="1800" i="1" dirty="0">
-                <a:solidFill>
-                  <a:srgbClr val="333333"/>
-                </a:solidFill>
-              </a:rPr>
-              <a:t>"Beberapa koin seperti Binance/EOS belum rilis di awal 2017 sehingga datanya kosong. Bukankah backward-fill memalsukan harga dan merusak matriks?"</a:t>
+              <a:t>2. Network Markowitz dengan Target Risiko (NW - Risk Grid Search):</a:t>
             </a:r>
             <a:endParaRPr lang="en-US" sz="1800" dirty="0"/>
           </a:p>
           <a:p>
+            <a:pPr marL="342900" indent="-342900">
+              <a:buSzPct val="100000"/>
+              <a:buChar char="•"/>
+            </a:pPr>
+            <a:r>
+              <a:rPr lang="en-US" sz="1800" dirty="0">
+                <a:solidFill>
+                  <a:srgbClr val="333333"/>
+                </a:solidFill>
+              </a:rPr>
+              <a:t>Menekan parameter </a:t>
+            </a:r>
             <a:pPr indent="0" marL="0">
               <a:buNone/>
             </a:pPr>
             <a:r>
               <a:rPr lang="en-US" sz="1800" b="1" dirty="0">
                 <a:solidFill>
-                  <a:srgbClr val="27AE60"/>
-                </a:solidFill>
-              </a:rPr>
-              <a:t>Jawaban (Kenapa RMT sangat Krusial):</a:t>
+                  <a:srgbClr val="333333"/>
+                </a:solidFill>
+              </a:rPr>
+              <a:t>risiko total</a:t>
+            </a:r>
+            <a:pPr indent="0" marL="0">
+              <a:buNone/>
+            </a:pPr>
+            <a:r>
+              <a:rPr lang="en-US" sz="1800" dirty="0">
+                <a:solidFill>
+                  <a:srgbClr val="333333"/>
+                </a:solidFill>
+              </a:rPr>
+              <a:t> hingga minimal.</a:t>
             </a:r>
             <a:endParaRPr lang="en-US" sz="1800" dirty="0"/>
           </a:p>
           <a:p>
-            <a:pPr indent="0" marL="0">
-              <a:buNone/>
+            <a:pPr marL="342900" indent="-342900">
+              <a:buSzPct val="100000"/>
+              <a:buChar char="•"/>
             </a:pPr>
             <a:r>
               <a:rPr lang="en-US" sz="1800" dirty="0">
@@ -15200,18 +15404,18 @@
                   <a:srgbClr val="333333"/>
                 </a:solidFill>
               </a:rPr>
-              <a:t>   1. Praktik pengisian data diam (</a:t>
-            </a:r>
-            <a:pPr indent="0" marL="0">
-              <a:buNone/>
-            </a:pPr>
-            <a:r>
-              <a:rPr lang="en-US" sz="1800" b="1" i="1" dirty="0">
-                <a:solidFill>
-                  <a:srgbClr val="333333"/>
-                </a:solidFill>
-              </a:rPr>
-              <a:t>backward fill</a:t>
+              <a:t>Lebih Defensif untuk meredam fluktuasi saat </a:t>
+            </a:r>
+            <a:pPr indent="0" marL="0">
+              <a:buNone/>
+            </a:pPr>
+            <a:r>
+              <a:rPr lang="en-US" sz="1800" b="1" dirty="0">
+                <a:solidFill>
+                  <a:srgbClr val="333333"/>
+                </a:solidFill>
+              </a:rPr>
+              <a:t>Crypto Winter</a:t>
             </a:r>
             <a:pPr indent="0" marL="0">
               <a:buNone/>
@@ -15222,115 +15426,7 @@
                   <a:srgbClr val="333333"/>
                 </a:solidFill>
               </a:rPr>
-              <a:t>) memang menciptakan rentetan nilai harga yang statis.</a:t>
-            </a:r>
-            <a:endParaRPr lang="en-US" sz="1800" dirty="0"/>
-          </a:p>
-          <a:p>
-            <a:pPr indent="0" marL="0">
-              <a:buNone/>
-            </a:pPr>
-            <a:r>
-              <a:rPr lang="en-US" sz="1800" dirty="0">
-                <a:solidFill>
-                  <a:srgbClr val="333333"/>
-                </a:solidFill>
-              </a:rPr>
-              <a:t>   2. Namun, kehebatan </a:t>
-            </a:r>
-            <a:pPr indent="0" marL="0">
-              <a:buNone/>
-            </a:pPr>
-            <a:r>
-              <a:rPr lang="en-US" sz="1800" b="1" dirty="0">
-                <a:solidFill>
-                  <a:srgbClr val="333333"/>
-                </a:solidFill>
-              </a:rPr>
-              <a:t>Random Matrix Theory (RMT)</a:t>
-            </a:r>
-            <a:pPr indent="0" marL="0">
-              <a:buNone/>
-            </a:pPr>
-            <a:r>
-              <a:rPr lang="en-US" sz="1800" dirty="0">
-                <a:solidFill>
-                  <a:srgbClr val="333333"/>
-                </a:solidFill>
-              </a:rPr>
-              <a:t> diuji di sini! Karena data yang datar sama sekali tidak punya korelasi nyata.</a:t>
-            </a:r>
-            <a:endParaRPr lang="en-US" sz="1800" dirty="0"/>
-          </a:p>
-          <a:p>
-            <a:pPr indent="0" marL="0">
-              <a:buNone/>
-            </a:pPr>
-            <a:r>
-              <a:rPr lang="en-US" sz="1800" dirty="0">
-                <a:solidFill>
-                  <a:srgbClr val="333333"/>
-                </a:solidFill>
-              </a:rPr>
-              <a:t>   3. RMT otomatis akan mendeteksi korelasi buatan tersebut sebagai probabilitas </a:t>
-            </a:r>
-            <a:pPr indent="0" marL="0">
-              <a:buNone/>
-            </a:pPr>
-            <a:r>
-              <a:rPr lang="en-US" sz="1800" b="1" i="1" dirty="0">
-                <a:solidFill>
-                  <a:srgbClr val="333333"/>
-                </a:solidFill>
-              </a:rPr>
-              <a:t>Noise Acak</a:t>
-            </a:r>
-            <a:pPr indent="0" marL="0">
-              <a:buNone/>
-            </a:pPr>
-            <a:r>
-              <a:rPr lang="en-US" sz="1800" dirty="0">
-                <a:solidFill>
-                  <a:srgbClr val="333333"/>
-                </a:solidFill>
-              </a:rPr>
-              <a:t>, lalu membuangnya menjadi 0.</a:t>
-            </a:r>
-            <a:endParaRPr lang="en-US" sz="1800" dirty="0"/>
-          </a:p>
-          <a:p>
-            <a:pPr indent="0" marL="0">
-              <a:buNone/>
-            </a:pPr>
-            <a:r>
-              <a:rPr lang="en-US" sz="1800" dirty="0">
-                <a:solidFill>
-                  <a:srgbClr val="333333"/>
-                </a:solidFill>
-              </a:rPr>
-              <a:t>   4. Hasilnya, matriks korelasi </a:t>
-            </a:r>
-            <a:pPr indent="0" marL="0">
-              <a:buNone/>
-            </a:pPr>
-            <a:r>
-              <a:rPr lang="en-US" sz="1800" b="1" dirty="0">
-                <a:solidFill>
-                  <a:srgbClr val="333333"/>
-                </a:solidFill>
-              </a:rPr>
-              <a:t>terselamatkan</a:t>
-            </a:r>
-            <a:pPr indent="0" marL="0">
-              <a:buNone/>
-            </a:pPr>
-            <a:r>
-              <a:rPr lang="en-US" sz="1800" dirty="0">
-                <a:solidFill>
-                  <a:srgbClr val="333333"/>
-                </a:solidFill>
-              </a:rPr>
-              <a:t> dan tidak tercemar oleh cacat kelengkapan data.</a:t>
+              <a:t>.</a:t>
             </a:r>
             <a:endParaRPr lang="en-US" sz="1800" dirty="0"/>
           </a:p>
@@ -15391,7 +15487,7 @@
                   <a:srgbClr val="003366"/>
                 </a:solidFill>
               </a:rPr>
-              <a:t>Lampiran: Mengapa Menyertakan Tether (USDT)? (1/2)</a:t>
+              <a:t>Lampiran: Penanganan Data Kosong (Missing Values)</a:t>
             </a:r>
             <a:endParaRPr lang="en-US" sz="2600" dirty="0"/>
           </a:p>
@@ -15438,7 +15534,7 @@
                   <a:srgbClr val="333333"/>
                 </a:solidFill>
               </a:rPr>
-              <a:t>"Tether (USDT) itu stablecoin yang nilainya selalu fix ke 1 USD. Apakah tidak berbuat curang?"</a:t>
+              <a:t>"Beberapa koin seperti Binance/EOS belum rilis di awal 2017 sehingga datanya kosong. Bukankah backward-fill memalsukan harga dan merusak matriks?"</a:t>
             </a:r>
             <a:endParaRPr lang="en-US" sz="1800" dirty="0"/>
           </a:p>
@@ -15452,14 +15548,13 @@
                   <a:srgbClr val="27AE60"/>
                 </a:solidFill>
               </a:rPr>
-              <a:t>Jawaban (Dinamika Portofolio Cerdas):</a:t>
+              <a:t>Jawaban (Kenapa RMT sangat Krusial):</a:t>
             </a:r>
             <a:endParaRPr lang="en-US" sz="1800" dirty="0"/>
           </a:p>
           <a:p>
-            <a:pPr marL="342900" indent="-342900">
-              <a:buSzPct val="100000"/>
-              <a:buChar char="•"/>
+            <a:pPr indent="0" marL="0">
+              <a:buNone/>
             </a:pPr>
             <a:r>
               <a:rPr lang="en-US" sz="1800" dirty="0">
@@ -15467,7 +15562,7 @@
                   <a:srgbClr val="333333"/>
                 </a:solidFill>
               </a:rPr>
-              <a:t>Model ini mensimulasikan perilaku </a:t>
+              <a:t>   1. Praktik pengisian data diam (</a:t>
             </a:r>
             <a:pPr indent="0" marL="0">
               <a:buNone/>
@@ -15478,7 +15573,7 @@
                   <a:srgbClr val="333333"/>
                 </a:solidFill>
               </a:rPr>
-              <a:t>Robo-Advisory</a:t>
+              <a:t>backward fill</a:t>
             </a:r>
             <a:pPr indent="0" marL="0">
               <a:buNone/>
@@ -15489,14 +15584,13 @@
                   <a:srgbClr val="333333"/>
                 </a:solidFill>
               </a:rPr>
-              <a:t> institusional.</a:t>
+              <a:t>) memang menciptakan rentetan nilai harga yang statis.</a:t>
             </a:r>
             <a:endParaRPr lang="en-US" sz="1800" dirty="0"/>
           </a:p>
           <a:p>
-            <a:pPr marL="342900" indent="-342900">
-              <a:buSzPct val="100000"/>
-              <a:buChar char="•"/>
+            <a:pPr indent="0" marL="0">
+              <a:buNone/>
             </a:pPr>
             <a:r>
               <a:rPr lang="en-US" sz="1800" dirty="0">
@@ -15504,7 +15598,7 @@
                   <a:srgbClr val="333333"/>
                 </a:solidFill>
               </a:rPr>
-              <a:t>Ketika pasar anjlok ekstrem, investor akan melarikan senjatanya ke posisi </a:t>
+              <a:t>   2. Namun, kehebatan </a:t>
             </a:r>
             <a:pPr indent="0" marL="0">
               <a:buNone/>
@@ -15515,7 +15609,7 @@
                   <a:srgbClr val="333333"/>
                 </a:solidFill>
               </a:rPr>
-              <a:t>tunai (USDT)</a:t>
+              <a:t>Random Matrix Theory (RMT)</a:t>
             </a:r>
             <a:pPr indent="0" marL="0">
               <a:buNone/>
@@ -15526,7 +15620,79 @@
                   <a:srgbClr val="333333"/>
                 </a:solidFill>
               </a:rPr>
-              <a:t> sebagai evakuasi risiko.</a:t>
+              <a:t> diuji di sini! Karena data yang datar sama sekali tidak punya korelasi nyata.</a:t>
+            </a:r>
+            <a:endParaRPr lang="en-US" sz="1800" dirty="0"/>
+          </a:p>
+          <a:p>
+            <a:pPr indent="0" marL="0">
+              <a:buNone/>
+            </a:pPr>
+            <a:r>
+              <a:rPr lang="en-US" sz="1800" dirty="0">
+                <a:solidFill>
+                  <a:srgbClr val="333333"/>
+                </a:solidFill>
+              </a:rPr>
+              <a:t>   3. RMT otomatis akan mendeteksi korelasi buatan tersebut sebagai probabilitas </a:t>
+            </a:r>
+            <a:pPr indent="0" marL="0">
+              <a:buNone/>
+            </a:pPr>
+            <a:r>
+              <a:rPr lang="en-US" sz="1800" b="1" i="1" dirty="0">
+                <a:solidFill>
+                  <a:srgbClr val="333333"/>
+                </a:solidFill>
+              </a:rPr>
+              <a:t>Noise Acak</a:t>
+            </a:r>
+            <a:pPr indent="0" marL="0">
+              <a:buNone/>
+            </a:pPr>
+            <a:r>
+              <a:rPr lang="en-US" sz="1800" dirty="0">
+                <a:solidFill>
+                  <a:srgbClr val="333333"/>
+                </a:solidFill>
+              </a:rPr>
+              <a:t>, lalu membuangnya menjadi 0.</a:t>
+            </a:r>
+            <a:endParaRPr lang="en-US" sz="1800" dirty="0"/>
+          </a:p>
+          <a:p>
+            <a:pPr indent="0" marL="0">
+              <a:buNone/>
+            </a:pPr>
+            <a:r>
+              <a:rPr lang="en-US" sz="1800" dirty="0">
+                <a:solidFill>
+                  <a:srgbClr val="333333"/>
+                </a:solidFill>
+              </a:rPr>
+              <a:t>   4. Hasilnya, matriks korelasi </a:t>
+            </a:r>
+            <a:pPr indent="0" marL="0">
+              <a:buNone/>
+            </a:pPr>
+            <a:r>
+              <a:rPr lang="en-US" sz="1800" b="1" dirty="0">
+                <a:solidFill>
+                  <a:srgbClr val="333333"/>
+                </a:solidFill>
+              </a:rPr>
+              <a:t>terselamatkan</a:t>
+            </a:r>
+            <a:pPr indent="0" marL="0">
+              <a:buNone/>
+            </a:pPr>
+            <a:r>
+              <a:rPr lang="en-US" sz="1800" dirty="0">
+                <a:solidFill>
+                  <a:srgbClr val="333333"/>
+                </a:solidFill>
+              </a:rPr>
+              <a:t> dan tidak tercemar oleh cacat kelengkapan data.</a:t>
             </a:r>
             <a:endParaRPr lang="en-US" sz="1800" dirty="0"/>
           </a:p>
@@ -15587,7 +15753,7 @@
                   <a:srgbClr val="003366"/>
                 </a:solidFill>
               </a:rPr>
-              <a:t>Lampiran: Mengapa Menyertakan Tether (USDT)? (2/2)</a:t>
+              <a:t>Lampiran: Mengapa Menyertakan Tether (USDT)? (1/2)</a:t>
             </a:r>
             <a:endParaRPr lang="en-US" sz="2600" dirty="0"/>
           </a:p>
@@ -15618,12 +15784,89 @@
               <a:buNone/>
             </a:pPr>
             <a:r>
+              <a:rPr lang="en-US" sz="1800" b="1" dirty="0">
+                <a:solidFill>
+                  <a:srgbClr val="C0392B"/>
+                </a:solidFill>
+              </a:rPr>
+              <a:t>Pertanyaan: </a:t>
+            </a:r>
+            <a:pPr indent="0" marL="0">
+              <a:buNone/>
+            </a:pPr>
+            <a:r>
+              <a:rPr lang="en-US" sz="1800" i="1" dirty="0">
+                <a:solidFill>
+                  <a:srgbClr val="333333"/>
+                </a:solidFill>
+              </a:rPr>
+              <a:t>"Tether (USDT) itu stablecoin yang nilainya selalu fix ke 1 USD. Apakah tidak berbuat curang?"</a:t>
+            </a:r>
+            <a:endParaRPr lang="en-US" sz="1800" dirty="0"/>
+          </a:p>
+          <a:p>
+            <a:pPr indent="0" marL="0">
+              <a:buNone/>
+            </a:pPr>
+            <a:r>
+              <a:rPr lang="en-US" sz="1800" b="1" dirty="0">
+                <a:solidFill>
+                  <a:srgbClr val="27AE60"/>
+                </a:solidFill>
+              </a:rPr>
+              <a:t>Jawaban (Dinamika Portofolio Cerdas):</a:t>
+            </a:r>
+            <a:endParaRPr lang="en-US" sz="1800" dirty="0"/>
+          </a:p>
+          <a:p>
+            <a:pPr marL="342900" indent="-342900">
+              <a:buSzPct val="100000"/>
+              <a:buChar char="•"/>
+            </a:pPr>
+            <a:r>
               <a:rPr lang="en-US" sz="1800" dirty="0">
                 <a:solidFill>
                   <a:srgbClr val="333333"/>
                 </a:solidFill>
               </a:rPr>
-              <a:t>3. Algoritma jaringan </a:t>
+              <a:t>Model ini mensimulasikan perilaku </a:t>
+            </a:r>
+            <a:pPr indent="0" marL="0">
+              <a:buNone/>
+            </a:pPr>
+            <a:r>
+              <a:rPr lang="en-US" sz="1800" b="1" i="1" dirty="0">
+                <a:solidFill>
+                  <a:srgbClr val="333333"/>
+                </a:solidFill>
+              </a:rPr>
+              <a:t>Robo-Advisory</a:t>
+            </a:r>
+            <a:pPr indent="0" marL="0">
+              <a:buNone/>
+            </a:pPr>
+            <a:r>
+              <a:rPr lang="en-US" sz="1800" dirty="0">
+                <a:solidFill>
+                  <a:srgbClr val="333333"/>
+                </a:solidFill>
+              </a:rPr>
+              <a:t> institusional.</a:t>
+            </a:r>
+            <a:endParaRPr lang="en-US" sz="1800" dirty="0"/>
+          </a:p>
+          <a:p>
+            <a:pPr marL="342900" indent="-342900">
+              <a:buSzPct val="100000"/>
+              <a:buChar char="•"/>
+            </a:pPr>
+            <a:r>
+              <a:rPr lang="en-US" sz="1800" dirty="0">
+                <a:solidFill>
+                  <a:srgbClr val="333333"/>
+                </a:solidFill>
+              </a:rPr>
+              <a:t>Ketika pasar anjlok ekstrem, investor akan melarikan senjatanya ke posisi </a:t>
             </a:r>
             <a:pPr indent="0" marL="0">
               <a:buNone/>
@@ -15634,7 +15877,7 @@
                   <a:srgbClr val="333333"/>
                 </a:solidFill>
               </a:rPr>
-              <a:t>Network Markowitz GS (Grid Search)</a:t>
+              <a:t>tunai (USDT)</a:t>
             </a:r>
             <a:pPr indent="0" marL="0">
               <a:buNone/>
@@ -15645,87 +15888,7 @@
                   <a:srgbClr val="333333"/>
                 </a:solidFill>
               </a:rPr>
-              <a:t> dilatih secara matematis; jika mendeteksi korelasi ancaman kolaps merambat ke semua altcoin, ia akan melempar alokasi modalnya menuju node </a:t>
-            </a:r>
-            <a:pPr indent="0" marL="0">
-              <a:buNone/>
-            </a:pPr>
-            <a:r>
-              <a:rPr lang="en-US" sz="1800" b="1" dirty="0">
-                <a:solidFill>
-                  <a:srgbClr val="333333"/>
-                </a:solidFill>
-              </a:rPr>
-              <a:t>USDT (Tether)</a:t>
-            </a:r>
-            <a:pPr indent="0" marL="0">
-              <a:buNone/>
-            </a:pPr>
-            <a:r>
-              <a:rPr lang="en-US" sz="1800" dirty="0">
-                <a:solidFill>
-                  <a:srgbClr val="333333"/>
-                </a:solidFill>
-              </a:rPr>
-              <a:t> sebagai langkah </a:t>
-            </a:r>
-            <a:pPr indent="0" marL="0">
-              <a:buNone/>
-            </a:pPr>
-            <a:r>
-              <a:rPr lang="en-US" sz="1800" b="1" dirty="0">
-                <a:solidFill>
-                  <a:srgbClr val="333333"/>
-                </a:solidFill>
-              </a:rPr>
-              <a:t>evakuasi otomatis</a:t>
-            </a:r>
-            <a:pPr indent="0" marL="0">
-              <a:buNone/>
-            </a:pPr>
-            <a:r>
-              <a:rPr lang="en-US" sz="1800" dirty="0">
-                <a:solidFill>
-                  <a:srgbClr val="333333"/>
-                </a:solidFill>
-              </a:rPr>
-              <a:t> (Shock-Absorber).</a:t>
-            </a:r>
-            <a:endParaRPr lang="en-US" sz="1800" dirty="0"/>
-          </a:p>
-          <a:p>
-            <a:pPr indent="0" marL="0">
-              <a:buNone/>
-            </a:pPr>
-            <a:r>
-              <a:rPr lang="en-US" sz="1800" dirty="0">
-                <a:solidFill>
-                  <a:srgbClr val="333333"/>
-                </a:solidFill>
-              </a:rPr>
-              <a:t>   4. Hal ini yang membuat performa Risk-GS (Grid Search) sangat </a:t>
-            </a:r>
-            <a:pPr indent="0" marL="0">
-              <a:buNone/>
-            </a:pPr>
-            <a:r>
-              <a:rPr lang="en-US" sz="1800" b="1" dirty="0">
-                <a:solidFill>
-                  <a:srgbClr val="333333"/>
-                </a:solidFill>
-              </a:rPr>
-              <a:t>tangguh</a:t>
-            </a:r>
-            <a:pPr indent="0" marL="0">
-              <a:buNone/>
-            </a:pPr>
-            <a:r>
-              <a:rPr lang="en-US" sz="1800" dirty="0">
-                <a:solidFill>
-                  <a:srgbClr val="333333"/>
-                </a:solidFill>
-              </a:rPr>
-              <a:t> dari serangan Crypto Winter, suatu kapabilitas pertahanan yang tidak dipahami oleh model ortodoks murni Markowitz.</a:t>
+              <a:t> sebagai evakuasi risiko.</a:t>
             </a:r>
             <a:endParaRPr lang="en-US" sz="1800" dirty="0"/>
           </a:p>
@@ -15786,7 +15949,7 @@
                   <a:srgbClr val="003366"/>
                 </a:solidFill>
               </a:rPr>
-              <a:t>Lampiran: Bukti Empiris Non-Stationarity Pasar</a:t>
+              <a:t>Lampiran: Mengapa Menyertakan Tether (USDT)? (2/2)</a:t>
             </a:r>
             <a:endParaRPr lang="en-US" sz="2600" dirty="0"/>
           </a:p>
@@ -15817,23 +15980,78 @@
               <a:buNone/>
             </a:pPr>
             <a:r>
+              <a:rPr lang="en-US" sz="1800" dirty="0">
+                <a:solidFill>
+                  <a:srgbClr val="333333"/>
+                </a:solidFill>
+              </a:rPr>
+              <a:t>3. Algoritma jaringan </a:t>
+            </a:r>
+            <a:pPr indent="0" marL="0">
+              <a:buNone/>
+            </a:pPr>
+            <a:r>
               <a:rPr lang="en-US" sz="1800" b="1" dirty="0">
                 <a:solidFill>
-                  <a:srgbClr val="C0392B"/>
-                </a:solidFill>
-              </a:rPr>
-              <a:t>Masalah: </a:t>
-            </a:r>
-            <a:pPr indent="0" marL="0">
-              <a:buNone/>
-            </a:pPr>
-            <a:r>
-              <a:rPr lang="en-US" sz="1800" i="1" dirty="0">
-                <a:solidFill>
-                  <a:srgbClr val="333333"/>
-                </a:solidFill>
-              </a:rPr>
-              <a:t>Kenapa harus menggunakan model Adaptif (Dynamic Gamma)?</a:t>
+                  <a:srgbClr val="333333"/>
+                </a:solidFill>
+              </a:rPr>
+              <a:t>Network Markowitz GS (Grid Search)</a:t>
+            </a:r>
+            <a:pPr indent="0" marL="0">
+              <a:buNone/>
+            </a:pPr>
+            <a:r>
+              <a:rPr lang="en-US" sz="1800" dirty="0">
+                <a:solidFill>
+                  <a:srgbClr val="333333"/>
+                </a:solidFill>
+              </a:rPr>
+              <a:t> dilatih secara matematis; jika mendeteksi korelasi ancaman kolaps merambat ke semua altcoin, ia akan melempar alokasi modalnya menuju node </a:t>
+            </a:r>
+            <a:pPr indent="0" marL="0">
+              <a:buNone/>
+            </a:pPr>
+            <a:r>
+              <a:rPr lang="en-US" sz="1800" b="1" dirty="0">
+                <a:solidFill>
+                  <a:srgbClr val="333333"/>
+                </a:solidFill>
+              </a:rPr>
+              <a:t>USDT (Tether)</a:t>
+            </a:r>
+            <a:pPr indent="0" marL="0">
+              <a:buNone/>
+            </a:pPr>
+            <a:r>
+              <a:rPr lang="en-US" sz="1800" dirty="0">
+                <a:solidFill>
+                  <a:srgbClr val="333333"/>
+                </a:solidFill>
+              </a:rPr>
+              <a:t> sebagai langkah </a:t>
+            </a:r>
+            <a:pPr indent="0" marL="0">
+              <a:buNone/>
+            </a:pPr>
+            <a:r>
+              <a:rPr lang="en-US" sz="1800" b="1" dirty="0">
+                <a:solidFill>
+                  <a:srgbClr val="333333"/>
+                </a:solidFill>
+              </a:rPr>
+              <a:t>evakuasi otomatis</a:t>
+            </a:r>
+            <a:pPr indent="0" marL="0">
+              <a:buNone/>
+            </a:pPr>
+            <a:r>
+              <a:rPr lang="en-US" sz="1800" dirty="0">
+                <a:solidFill>
+                  <a:srgbClr val="333333"/>
+                </a:solidFill>
+              </a:rPr>
+              <a:t> (Shock-Absorber).</a:t>
             </a:r>
             <a:endParaRPr lang="en-US" sz="1800" dirty="0"/>
           </a:p>
@@ -15842,19 +16060,26 @@
               <a:buNone/>
             </a:pPr>
             <a:r>
+              <a:rPr lang="en-US" sz="1800" dirty="0">
+                <a:solidFill>
+                  <a:srgbClr val="333333"/>
+                </a:solidFill>
+              </a:rPr>
+              <a:t>   4. Hal ini yang membuat performa Risk-GS (Grid Search) sangat </a:t>
+            </a:r>
+            <a:pPr indent="0" marL="0">
+              <a:buNone/>
+            </a:pPr>
+            <a:r>
               <a:rPr lang="en-US" sz="1800" b="1" dirty="0">
                 <a:solidFill>
-                  <a:srgbClr val="27AE60"/>
-                </a:solidFill>
-              </a:rPr>
-              <a:t>Bukti dari Grid Search:</a:t>
-            </a:r>
-            <a:endParaRPr lang="en-US" sz="1800" dirty="0"/>
-          </a:p>
-          <a:p>
-            <a:pPr marL="342900" indent="-342900">
-              <a:buSzPct val="100000"/>
-              <a:buChar char="•"/>
+                  <a:srgbClr val="333333"/>
+                </a:solidFill>
+              </a:rPr>
+              <a:t>tangguh</a:t>
+            </a:r>
+            <a:pPr indent="0" marL="0">
+              <a:buNone/>
             </a:pPr>
             <a:r>
               <a:rPr lang="en-US" sz="1800" dirty="0">
@@ -15862,103 +16087,7 @@
                   <a:srgbClr val="333333"/>
                 </a:solidFill>
               </a:rPr>
-              <a:t>Data menunjukkan nilai Gamma (γ) optimal </a:t>
-            </a:r>
-            <a:pPr indent="0" marL="0">
-              <a:buNone/>
-            </a:pPr>
-            <a:r>
-              <a:rPr lang="en-US" sz="1800" b="1" dirty="0">
-                <a:solidFill>
-                  <a:srgbClr val="333333"/>
-                </a:solidFill>
-              </a:rPr>
-              <a:t>terus bergeser</a:t>
-            </a:r>
-            <a:pPr indent="0" marL="0">
-              <a:buNone/>
-            </a:pPr>
-            <a:r>
-              <a:rPr lang="en-US" sz="1800" dirty="0">
-                <a:solidFill>
-                  <a:srgbClr val="333333"/>
-                </a:solidFill>
-              </a:rPr>
-              <a:t> setiap periode rebalancing.</a:t>
-            </a:r>
-            <a:endParaRPr lang="en-US" sz="1800" dirty="0"/>
-          </a:p>
-          <a:p>
-            <a:pPr marL="342900" indent="-342900">
-              <a:buSzPct val="100000"/>
-              <a:buChar char="•"/>
-            </a:pPr>
-            <a:r>
-              <a:rPr lang="en-US" sz="1800" dirty="0">
-                <a:solidFill>
-                  <a:srgbClr val="333333"/>
-                </a:solidFill>
-              </a:rPr>
-              <a:t>Penggunaan γ statis tidak cukup untuk menangkap perubahan </a:t>
-            </a:r>
-            <a:pPr indent="0" marL="0">
-              <a:buNone/>
-            </a:pPr>
-            <a:r>
-              <a:rPr lang="en-US" sz="1800" b="1" dirty="0">
-                <a:solidFill>
-                  <a:srgbClr val="333333"/>
-                </a:solidFill>
-              </a:rPr>
-              <a:t>struktur korelasi</a:t>
-            </a:r>
-            <a:pPr indent="0" marL="0">
-              <a:buNone/>
-            </a:pPr>
-            <a:r>
-              <a:rPr lang="en-US" sz="1800" dirty="0">
-                <a:solidFill>
-                  <a:srgbClr val="333333"/>
-                </a:solidFill>
-              </a:rPr>
-              <a:t> yang sangat cepat di pasar kripto.</a:t>
-            </a:r>
-            <a:endParaRPr lang="en-US" sz="1800" dirty="0"/>
-          </a:p>
-          <a:p>
-            <a:pPr marL="342900" indent="-342900">
-              <a:buSzPct val="100000"/>
-              <a:buChar char="•"/>
-            </a:pPr>
-            <a:r>
-              <a:rPr lang="en-US" sz="1800" dirty="0">
-                <a:solidFill>
-                  <a:srgbClr val="333333"/>
-                </a:solidFill>
-              </a:rPr>
-              <a:t>Ini membenarkan bahwa pasar kripto membutuhkan </a:t>
-            </a:r>
-            <a:pPr indent="0" marL="0">
-              <a:buNone/>
-            </a:pPr>
-            <a:r>
-              <a:rPr lang="en-US" sz="1800" b="1" dirty="0">
-                <a:solidFill>
-                  <a:srgbClr val="333333"/>
-                </a:solidFill>
-              </a:rPr>
-              <a:t>kalibrasi otomatis</a:t>
-            </a:r>
-            <a:pPr indent="0" marL="0">
-              <a:buNone/>
-            </a:pPr>
-            <a:r>
-              <a:rPr lang="en-US" sz="1800" dirty="0">
-                <a:solidFill>
-                  <a:srgbClr val="333333"/>
-                </a:solidFill>
-              </a:rPr>
-              <a:t> secara temporal.</a:t>
+              <a:t> dari serangan Crypto Winter, suatu kapabilitas pertahanan yang tidak dipahami oleh model ortodoks murni Markowitz.</a:t>
             </a:r>
             <a:endParaRPr lang="en-US" sz="1800" dirty="0"/>
           </a:p>
@@ -15975,6 +16104,239 @@
 <file path=ppt/slides/slide47.xml><?xml version="1.0" encoding="utf-8"?>
 <p:sld xmlns:a="http://schemas.openxmlformats.org/drawingml/2006/main" xmlns:r="http://schemas.openxmlformats.org/officeDocument/2006/relationships" xmlns:p="http://schemas.openxmlformats.org/presentationml/2006/main">
   <p:cSld name="Slide 47">
+    <p:spTree>
+      <p:nvGrpSpPr>
+        <p:cNvPr id="1" name=""/>
+        <p:cNvGrpSpPr/>
+        <p:nvPr/>
+      </p:nvGrpSpPr>
+      <p:grpSpPr>
+        <a:xfrm>
+          <a:off x="0" y="0"/>
+          <a:ext cx="0" cy="0"/>
+          <a:chOff x="0" y="0"/>
+          <a:chExt cx="0" cy="0"/>
+        </a:xfrm>
+      </p:grpSpPr>
+      <p:sp>
+        <p:nvSpPr>
+          <p:cNvPr id="2" name="Text 0"/>
+          <p:cNvSpPr/>
+          <p:nvPr/>
+        </p:nvSpPr>
+        <p:spPr>
+          <a:xfrm>
+            <a:off x="457200" y="457200"/>
+            <a:ext cx="8229600" cy="0"/>
+          </a:xfrm>
+          <a:prstGeom prst="rect">
+            <a:avLst/>
+          </a:prstGeom>
+          <a:noFill/>
+          <a:ln/>
+        </p:spPr>
+        <p:txBody>
+          <a:bodyPr wrap="square" rtlCol="0" anchor="ctr"/>
+          <a:lstStyle/>
+          <a:p>
+            <a:pPr indent="0" marL="0">
+              <a:buNone/>
+            </a:pPr>
+            <a:r>
+              <a:rPr lang="en-US" sz="2600" b="1" dirty="0">
+                <a:solidFill>
+                  <a:srgbClr val="003366"/>
+                </a:solidFill>
+              </a:rPr>
+              <a:t>Lampiran: Bukti Empiris Non-Stationarity Pasar</a:t>
+            </a:r>
+            <a:endParaRPr lang="en-US" sz="2600" dirty="0"/>
+          </a:p>
+        </p:txBody>
+      </p:sp>
+      <p:sp>
+        <p:nvSpPr>
+          <p:cNvPr id="3" name="Text 1"/>
+          <p:cNvSpPr/>
+          <p:nvPr/>
+        </p:nvSpPr>
+        <p:spPr>
+          <a:xfrm>
+            <a:off x="457200" y="1005840"/>
+            <a:ext cx="8229600" cy="5029200"/>
+          </a:xfrm>
+          <a:prstGeom prst="rect">
+            <a:avLst/>
+          </a:prstGeom>
+          <a:noFill/>
+          <a:ln/>
+        </p:spPr>
+        <p:txBody>
+          <a:bodyPr wrap="square" rtlCol="0" anchor="t"/>
+          <a:lstStyle/>
+          <a:p>
+            <a:pPr indent="0" marL="0">
+              <a:buNone/>
+            </a:pPr>
+            <a:r>
+              <a:rPr lang="en-US" sz="1800" b="1" dirty="0">
+                <a:solidFill>
+                  <a:srgbClr val="C0392B"/>
+                </a:solidFill>
+              </a:rPr>
+              <a:t>Masalah: </a:t>
+            </a:r>
+            <a:pPr indent="0" marL="0">
+              <a:buNone/>
+            </a:pPr>
+            <a:r>
+              <a:rPr lang="en-US" sz="1800" i="1" dirty="0">
+                <a:solidFill>
+                  <a:srgbClr val="333333"/>
+                </a:solidFill>
+              </a:rPr>
+              <a:t>Kenapa harus menggunakan model Adaptif (Dynamic Gamma)?</a:t>
+            </a:r>
+            <a:endParaRPr lang="en-US" sz="1800" dirty="0"/>
+          </a:p>
+          <a:p>
+            <a:pPr indent="0" marL="0">
+              <a:buNone/>
+            </a:pPr>
+            <a:r>
+              <a:rPr lang="en-US" sz="1800" b="1" dirty="0">
+                <a:solidFill>
+                  <a:srgbClr val="27AE60"/>
+                </a:solidFill>
+              </a:rPr>
+              <a:t>Bukti dari Grid Search:</a:t>
+            </a:r>
+            <a:endParaRPr lang="en-US" sz="1800" dirty="0"/>
+          </a:p>
+          <a:p>
+            <a:pPr marL="342900" indent="-342900">
+              <a:buSzPct val="100000"/>
+              <a:buChar char="•"/>
+            </a:pPr>
+            <a:r>
+              <a:rPr lang="en-US" sz="1800" dirty="0">
+                <a:solidFill>
+                  <a:srgbClr val="333333"/>
+                </a:solidFill>
+              </a:rPr>
+              <a:t>Data menunjukkan nilai Gamma (γ) optimal </a:t>
+            </a:r>
+            <a:pPr indent="0" marL="0">
+              <a:buNone/>
+            </a:pPr>
+            <a:r>
+              <a:rPr lang="en-US" sz="1800" b="1" dirty="0">
+                <a:solidFill>
+                  <a:srgbClr val="333333"/>
+                </a:solidFill>
+              </a:rPr>
+              <a:t>terus bergeser</a:t>
+            </a:r>
+            <a:pPr indent="0" marL="0">
+              <a:buNone/>
+            </a:pPr>
+            <a:r>
+              <a:rPr lang="en-US" sz="1800" dirty="0">
+                <a:solidFill>
+                  <a:srgbClr val="333333"/>
+                </a:solidFill>
+              </a:rPr>
+              <a:t> setiap periode rebalancing.</a:t>
+            </a:r>
+            <a:endParaRPr lang="en-US" sz="1800" dirty="0"/>
+          </a:p>
+          <a:p>
+            <a:pPr marL="342900" indent="-342900">
+              <a:buSzPct val="100000"/>
+              <a:buChar char="•"/>
+            </a:pPr>
+            <a:r>
+              <a:rPr lang="en-US" sz="1800" dirty="0">
+                <a:solidFill>
+                  <a:srgbClr val="333333"/>
+                </a:solidFill>
+              </a:rPr>
+              <a:t>Penggunaan γ statis tidak cukup untuk menangkap perubahan </a:t>
+            </a:r>
+            <a:pPr indent="0" marL="0">
+              <a:buNone/>
+            </a:pPr>
+            <a:r>
+              <a:rPr lang="en-US" sz="1800" b="1" dirty="0">
+                <a:solidFill>
+                  <a:srgbClr val="333333"/>
+                </a:solidFill>
+              </a:rPr>
+              <a:t>struktur korelasi</a:t>
+            </a:r>
+            <a:pPr indent="0" marL="0">
+              <a:buNone/>
+            </a:pPr>
+            <a:r>
+              <a:rPr lang="en-US" sz="1800" dirty="0">
+                <a:solidFill>
+                  <a:srgbClr val="333333"/>
+                </a:solidFill>
+              </a:rPr>
+              <a:t> yang sangat cepat di pasar kripto.</a:t>
+            </a:r>
+            <a:endParaRPr lang="en-US" sz="1800" dirty="0"/>
+          </a:p>
+          <a:p>
+            <a:pPr marL="342900" indent="-342900">
+              <a:buSzPct val="100000"/>
+              <a:buChar char="•"/>
+            </a:pPr>
+            <a:r>
+              <a:rPr lang="en-US" sz="1800" dirty="0">
+                <a:solidFill>
+                  <a:srgbClr val="333333"/>
+                </a:solidFill>
+              </a:rPr>
+              <a:t>Ini membenarkan bahwa pasar kripto membutuhkan </a:t>
+            </a:r>
+            <a:pPr indent="0" marL="0">
+              <a:buNone/>
+            </a:pPr>
+            <a:r>
+              <a:rPr lang="en-US" sz="1800" b="1" dirty="0">
+                <a:solidFill>
+                  <a:srgbClr val="333333"/>
+                </a:solidFill>
+              </a:rPr>
+              <a:t>kalibrasi otomatis</a:t>
+            </a:r>
+            <a:pPr indent="0" marL="0">
+              <a:buNone/>
+            </a:pPr>
+            <a:r>
+              <a:rPr lang="en-US" sz="1800" dirty="0">
+                <a:solidFill>
+                  <a:srgbClr val="333333"/>
+                </a:solidFill>
+              </a:rPr>
+              <a:t> secara temporal.</a:t>
+            </a:r>
+            <a:endParaRPr lang="en-US" sz="1800" dirty="0"/>
+          </a:p>
+        </p:txBody>
+      </p:sp>
+    </p:spTree>
+  </p:cSld>
+  <p:clrMapOvr>
+    <a:masterClrMapping/>
+  </p:clrMapOvr>
+</p:sld>
+</file>
+
+<file path=ppt/slides/slide48.xml><?xml version="1.0" encoding="utf-8"?>
+<p:sld xmlns:a="http://schemas.openxmlformats.org/drawingml/2006/main" xmlns:r="http://schemas.openxmlformats.org/officeDocument/2006/relationships" xmlns:p="http://schemas.openxmlformats.org/presentationml/2006/main">
+  <p:cSld name="Slide 48">
     <p:spTree>
       <p:nvGrpSpPr>
         <p:cNvPr id="1" name=""/>

</xml_diff>

<commit_message>
feat: add transformation pipeline slide (Corr -> Distance -> NW)
</commit_message>
<xml_diff>
--- a/Presentasi_Proposal_Update.pptx
+++ b/Presentasi_Proposal_Update.pptx
@@ -53,9 +53,10 @@
     <p:sldId id="301" r:id="rId47"/>
     <p:sldId id="302" r:id="rId48"/>
     <p:sldId id="303" r:id="rId49"/>
+    <p:sldId id="304" r:id="rId50"/>
   </p:sldIdLst>
   <p:notesMasterIdLst>
-    <p:notesMasterId r:id="rId50"/>
+    <p:notesMasterId r:id="rId51"/>
   </p:notesMasterIdLst>
   <p:sldSz cx="9144000" cy="5143500"/>
   <p:notesSz cx="5143500" cy="9144000"/>
@@ -4269,6 +4270,94 @@
             <a:fld id="{F7021451-1387-4CA6-816F-3879F97B5CBC}" type="slidenum">
               <a:rPr lang="en-US"/>
               <a:t>48</a:t>
+            </a:fld>
+            <a:endParaRPr lang="en-US"/>
+          </a:p>
+        </p:txBody>
+      </p:sp>
+    </p:spTree>
+    <p:extLst>
+      <p:ext uri="{BB962C8B-B14F-4D97-AF65-F5344CB8AC3E}">
+        <p14:creationId xmlns:p14="http://schemas.microsoft.com/office/powerpoint/2010/main" val="1024086991"/>
+      </p:ext>
+    </p:extLst>
+  </p:cSld>
+  <p:clrMapOvr>
+    <a:masterClrMapping/>
+  </p:clrMapOvr>
+</p:notes>
+</file>
+
+<file path=ppt/notesSlides/notesSlide49.xml><?xml version="1.0" encoding="utf-8"?>
+<p:notes xmlns:a="http://schemas.openxmlformats.org/drawingml/2006/main" xmlns:r="http://schemas.openxmlformats.org/officeDocument/2006/relationships" xmlns:p="http://schemas.openxmlformats.org/presentationml/2006/main">
+  <p:cSld>
+    <p:spTree>
+      <p:nvGrpSpPr>
+        <p:cNvPr id="1" name=""/>
+        <p:cNvGrpSpPr/>
+        <p:nvPr/>
+      </p:nvGrpSpPr>
+      <p:grpSpPr>
+        <a:xfrm>
+          <a:off x="0" y="0"/>
+          <a:ext cx="0" cy="0"/>
+          <a:chOff x="0" y="0"/>
+          <a:chExt cx="0" cy="0"/>
+        </a:xfrm>
+      </p:grpSpPr>
+      <p:sp>
+        <p:nvSpPr>
+          <p:cNvPr id="2" name="Slide Image Placeholder 1"/>
+          <p:cNvSpPr>
+            <a:spLocks noGrp="1" noRot="1" noChangeAspect="1"/>
+          </p:cNvSpPr>
+          <p:nvPr>
+            <p:ph type="sldImg"/>
+          </p:nvPr>
+        </p:nvSpPr>
+        <p:spPr/>
+      </p:sp>
+      <p:sp>
+        <p:nvSpPr>
+          <p:cNvPr id="3" name="Notes Placeholder 2"/>
+          <p:cNvSpPr>
+            <a:spLocks noGrp="1"/>
+          </p:cNvSpPr>
+          <p:nvPr>
+            <p:ph type="body" idx="1"/>
+          </p:nvPr>
+        </p:nvSpPr>
+        <p:spPr/>
+        <p:txBody>
+          <a:bodyPr/>
+          <a:lstStyle/>
+          <a:p>
+            <a:r>
+              <a:rPr lang="en-US" dirty="0"/>
+              <a:t/>
+            </a:r>
+            <a:endParaRPr lang="en-US" dirty="0"/>
+          </a:p>
+        </p:txBody>
+      </p:sp>
+      <p:sp>
+        <p:nvSpPr>
+          <p:cNvPr id="4" name="Slide Number Placeholder 3"/>
+          <p:cNvSpPr>
+            <a:spLocks noGrp="1"/>
+          </p:cNvSpPr>
+          <p:nvPr>
+            <p:ph type="sldNum" sz="quarter" idx="10"/>
+          </p:nvPr>
+        </p:nvSpPr>
+        <p:spPr/>
+        <p:txBody>
+          <a:bodyPr/>
+          <a:lstStyle/>
+          <a:p>
+            <a:fld id="{F7021451-1387-4CA6-816F-3879F97B5CBC}" type="slidenum">
+              <a:rPr lang="en-US"/>
+              <a:t>49</a:t>
             </a:fld>
             <a:endParaRPr lang="en-US"/>
           </a:p>
@@ -15209,14 +15298,14 @@
               <a:buNone/>
             </a:pPr>
             <a:r>
-              <a:rPr lang="en-US" sz="2600" b="1" dirty="0">
+              <a:rPr lang="en-US" sz="2400" b="1" dirty="0">
                 <a:solidFill>
                   <a:srgbClr val="003366"/>
                 </a:solidFill>
               </a:rPr>
-              <a:t>Lampiran: Dua Tipe Pendekatan Grid Search</a:t>
-            </a:r>
-            <a:endParaRPr lang="en-US" sz="2600" dirty="0"/>
+              <a:t>Lampiran: Alur Transformasi Matriks</a:t>
+            </a:r>
+            <a:endParaRPr lang="en-US" sz="2400" dirty="0"/>
           </a:p>
         </p:txBody>
       </p:sp>
@@ -15250,7 +15339,7 @@
                   <a:srgbClr val="333333"/>
                 </a:solidFill>
               </a:rPr>
-              <a:t>Dua Objektif Optimasi (Return vs Risk):</a:t>
+              <a:t>Proses ini memastikan data statistik mentah bisa divisualisasikan menjadi peta risiko.</a:t>
             </a:r>
             <a:endParaRPr lang="en-US" sz="1800" dirty="0"/>
           </a:p>
@@ -15261,172 +15350,108 @@
             <a:r>
               <a:rPr lang="en-US" sz="1800" b="1" dirty="0">
                 <a:solidFill>
+                  <a:srgbClr val="003366"/>
+                </a:solidFill>
+              </a:rPr>
+              <a:t>Langkah 1: Matriks Korelasi (Pearson)</a:t>
+            </a:r>
+            <a:endParaRPr lang="en-US" sz="1800" dirty="0"/>
+          </a:p>
+          <a:p>
+            <a:pPr indent="0" marL="0">
+              <a:buNone/>
+            </a:pPr>
+            <a:r>
+              <a:rPr lang="en-US" sz="1800" dirty="0">
+                <a:solidFill>
+                  <a:srgbClr val="333333"/>
+                </a:solidFill>
+              </a:rPr>
+              <a:t>   Berisi angka -1 s/d 1. Menunjukkan 'Kemiripan' gerak aset.</a:t>
+            </a:r>
+            <a:endParaRPr lang="en-US" sz="1800" dirty="0"/>
+          </a:p>
+          <a:p>
+            <a:pPr indent="0" marL="0">
+              <a:buNone/>
+            </a:pPr>
+            <a:r>
+              <a:rPr lang="en-US" sz="1800" b="1" dirty="0">
+                <a:solidFill>
+                  <a:srgbClr val="003366"/>
+                </a:solidFill>
+              </a:rPr>
+              <a:t>Langkah 2: Matriks Jarak (Metric Distance)</a:t>
+            </a:r>
+            <a:endParaRPr lang="en-US" sz="1800" dirty="0"/>
+          </a:p>
+          <a:p>
+            <a:pPr indent="0" marL="0">
+              <a:buNone/>
+            </a:pPr>
+            <a:r>
+              <a:rPr lang="en-US" sz="1800" dirty="0">
+                <a:solidFill>
+                  <a:srgbClr val="333333"/>
+                </a:solidFill>
+              </a:rPr>
+              <a:t>   Angka korelasi diubah menjadi angka 0 s/d 2 (Jarak). Semakin mirip aset, semakin 'nempel' (jarak mendekati 0).</a:t>
+            </a:r>
+            <a:endParaRPr lang="en-US" sz="1800" dirty="0"/>
+          </a:p>
+          <a:p>
+            <a:pPr indent="0" marL="0">
+              <a:buNone/>
+            </a:pPr>
+            <a:r>
+              <a:rPr lang="en-US" sz="1800" b="1" dirty="0">
+                <a:solidFill>
+                  <a:srgbClr val="003366"/>
+                </a:solidFill>
+              </a:rPr>
+              <a:t>Langkah 3: Bangun Jaringan (MST Algorithm)</a:t>
+            </a:r>
+            <a:endParaRPr lang="en-US" sz="1800" dirty="0"/>
+          </a:p>
+          <a:p>
+            <a:pPr indent="0" marL="0">
+              <a:buNone/>
+            </a:pPr>
+            <a:r>
+              <a:rPr lang="en-US" sz="1800" dirty="0">
+                <a:solidFill>
+                  <a:srgbClr val="333333"/>
+                </a:solidFill>
+              </a:rPr>
+              <a:t>   Komputer membaca Matriks Jarak sebagai peta jalan tol, lalu memilih rute terpendek untuk menghubungkan seluruh aset.</a:t>
+            </a:r>
+            <a:endParaRPr lang="en-US" sz="1800" dirty="0"/>
+          </a:p>
+          <a:p>
+            <a:pPr indent="0" marL="0">
+              <a:buNone/>
+            </a:pPr>
+            <a:r>
+              <a:rPr lang="en-US" sz="1800" b="1" dirty="0">
+                <a:solidFill>
                   <a:srgbClr val="27AE60"/>
                 </a:solidFill>
               </a:rPr>
-              <a:t>1. Network Markowitz dengan Target Return (NW - Return Grid Search):</a:t>
+              <a:t>Hasil Akhir:</a:t>
             </a:r>
             <a:endParaRPr lang="en-US" sz="1800" dirty="0"/>
           </a:p>
           <a:p>
-            <a:pPr marL="342900" indent="-342900">
-              <a:buSzPct val="100000"/>
-              <a:buChar char="•"/>
-            </a:pPr>
-            <a:r>
-              <a:rPr lang="en-US" sz="1800" dirty="0">
-                <a:solidFill>
-                  <a:srgbClr val="333333"/>
-                </a:solidFill>
-              </a:rPr>
-              <a:t>Memaksimalkan capaian </a:t>
-            </a:r>
-            <a:pPr indent="0" marL="0">
-              <a:buNone/>
-            </a:pPr>
-            <a:r>
-              <a:rPr lang="en-US" sz="1800" b="1" dirty="0">
-                <a:solidFill>
-                  <a:srgbClr val="333333"/>
-                </a:solidFill>
-              </a:rPr>
-              <a:t>imbal hasil</a:t>
-            </a:r>
-            <a:pPr indent="0" marL="0">
-              <a:buNone/>
-            </a:pPr>
-            <a:r>
-              <a:rPr lang="en-US" sz="1800" dirty="0">
-                <a:solidFill>
-                  <a:srgbClr val="333333"/>
-                </a:solidFill>
-              </a:rPr>
-              <a:t> portofolio.</a:t>
-            </a:r>
-            <a:endParaRPr lang="en-US" sz="1800" dirty="0"/>
-          </a:p>
-          <a:p>
-            <a:pPr marL="342900" indent="-342900">
-              <a:buSzPct val="100000"/>
-              <a:buChar char="•"/>
-            </a:pPr>
-            <a:r>
-              <a:rPr lang="en-US" sz="1800" dirty="0">
-                <a:solidFill>
-                  <a:srgbClr val="333333"/>
-                </a:solidFill>
-              </a:rPr>
-              <a:t>Lebih Agresif untuk mengeksploitasi reli pada pasar </a:t>
-            </a:r>
-            <a:pPr indent="0" marL="0">
-              <a:buNone/>
-            </a:pPr>
-            <a:r>
-              <a:rPr lang="en-US" sz="1800" b="1" dirty="0">
-                <a:solidFill>
-                  <a:srgbClr val="333333"/>
-                </a:solidFill>
-              </a:rPr>
-              <a:t>Bullish</a:t>
-            </a:r>
-            <a:pPr indent="0" marL="0">
-              <a:buNone/>
-            </a:pPr>
-            <a:r>
-              <a:rPr lang="en-US" sz="1800" dirty="0">
-                <a:solidFill>
-                  <a:srgbClr val="333333"/>
-                </a:solidFill>
-              </a:rPr>
-              <a:t>.</a:t>
-            </a:r>
-            <a:endParaRPr lang="en-US" sz="1800" dirty="0"/>
-          </a:p>
-          <a:p>
-            <a:pPr indent="0" marL="0">
-              <a:buNone/>
-            </a:pPr>
-            <a:r>
-              <a:rPr lang="en-US" sz="1800" b="1" dirty="0">
-                <a:solidFill>
-                  <a:srgbClr val="C0392B"/>
-                </a:solidFill>
-              </a:rPr>
-              <a:t>2. Network Markowitz dengan Target Risiko (NW - Risk Grid Search):</a:t>
-            </a:r>
-            <a:endParaRPr lang="en-US" sz="1800" dirty="0"/>
-          </a:p>
-          <a:p>
-            <a:pPr marL="342900" indent="-342900">
-              <a:buSzPct val="100000"/>
-              <a:buChar char="•"/>
-            </a:pPr>
-            <a:r>
-              <a:rPr lang="en-US" sz="1800" dirty="0">
-                <a:solidFill>
-                  <a:srgbClr val="333333"/>
-                </a:solidFill>
-              </a:rPr>
-              <a:t>Menekan parameter </a:t>
-            </a:r>
-            <a:pPr indent="0" marL="0">
-              <a:buNone/>
-            </a:pPr>
-            <a:r>
-              <a:rPr lang="en-US" sz="1800" b="1" dirty="0">
-                <a:solidFill>
-                  <a:srgbClr val="333333"/>
-                </a:solidFill>
-              </a:rPr>
-              <a:t>risiko total</a:t>
-            </a:r>
-            <a:pPr indent="0" marL="0">
-              <a:buNone/>
-            </a:pPr>
-            <a:r>
-              <a:rPr lang="en-US" sz="1800" dirty="0">
-                <a:solidFill>
-                  <a:srgbClr val="333333"/>
-                </a:solidFill>
-              </a:rPr>
-              <a:t> hingga minimal.</a:t>
-            </a:r>
-            <a:endParaRPr lang="en-US" sz="1800" dirty="0"/>
-          </a:p>
-          <a:p>
-            <a:pPr marL="342900" indent="-342900">
-              <a:buSzPct val="100000"/>
-              <a:buChar char="•"/>
-            </a:pPr>
-            <a:r>
-              <a:rPr lang="en-US" sz="1800" dirty="0">
-                <a:solidFill>
-                  <a:srgbClr val="333333"/>
-                </a:solidFill>
-              </a:rPr>
-              <a:t>Lebih Defensif untuk meredam fluktuasi saat </a:t>
-            </a:r>
-            <a:pPr indent="0" marL="0">
-              <a:buNone/>
-            </a:pPr>
-            <a:r>
-              <a:rPr lang="en-US" sz="1800" b="1" dirty="0">
-                <a:solidFill>
-                  <a:srgbClr val="333333"/>
-                </a:solidFill>
-              </a:rPr>
-              <a:t>Crypto Winter</a:t>
-            </a:r>
-            <a:pPr indent="0" marL="0">
-              <a:buNone/>
-            </a:pPr>
-            <a:r>
-              <a:rPr lang="en-US" sz="1800" dirty="0">
-                <a:solidFill>
-                  <a:srgbClr val="333333"/>
-                </a:solidFill>
-              </a:rPr>
-              <a:t>.</a:t>
+            <a:pPr indent="0" marL="0">
+              <a:buNone/>
+            </a:pPr>
+            <a:r>
+              <a:rPr lang="en-US" sz="1800" i="1" dirty="0">
+                <a:solidFill>
+                  <a:srgbClr val="333333"/>
+                </a:solidFill>
+              </a:rPr>
+              <a:t>Jaringan (Network) yang siap digunakan untuk menghitung skor penalti penularan risiko sistemik.</a:t>
             </a:r>
             <a:endParaRPr lang="en-US" sz="1800" dirty="0"/>
           </a:p>
@@ -15487,7 +15512,7 @@
                   <a:srgbClr val="003366"/>
                 </a:solidFill>
               </a:rPr>
-              <a:t>Lampiran: Penanganan Data Kosong (Missing Values)</a:t>
+              <a:t>Lampiran: Dua Tipe Pendekatan Grid Search</a:t>
             </a:r>
             <a:endParaRPr lang="en-US" sz="2600" dirty="0"/>
           </a:p>
@@ -15520,41 +15545,156 @@
             <a:r>
               <a:rPr lang="en-US" sz="1800" b="1" dirty="0">
                 <a:solidFill>
+                  <a:srgbClr val="333333"/>
+                </a:solidFill>
+              </a:rPr>
+              <a:t>Dua Objektif Optimasi (Return vs Risk):</a:t>
+            </a:r>
+            <a:endParaRPr lang="en-US" sz="1800" dirty="0"/>
+          </a:p>
+          <a:p>
+            <a:pPr indent="0" marL="0">
+              <a:buNone/>
+            </a:pPr>
+            <a:r>
+              <a:rPr lang="en-US" sz="1800" b="1" dirty="0">
+                <a:solidFill>
+                  <a:srgbClr val="27AE60"/>
+                </a:solidFill>
+              </a:rPr>
+              <a:t>1. Network Markowitz dengan Target Return (NW - Return Grid Search):</a:t>
+            </a:r>
+            <a:endParaRPr lang="en-US" sz="1800" dirty="0"/>
+          </a:p>
+          <a:p>
+            <a:pPr marL="342900" indent="-342900">
+              <a:buSzPct val="100000"/>
+              <a:buChar char="•"/>
+            </a:pPr>
+            <a:r>
+              <a:rPr lang="en-US" sz="1800" dirty="0">
+                <a:solidFill>
+                  <a:srgbClr val="333333"/>
+                </a:solidFill>
+              </a:rPr>
+              <a:t>Memaksimalkan capaian </a:t>
+            </a:r>
+            <a:pPr indent="0" marL="0">
+              <a:buNone/>
+            </a:pPr>
+            <a:r>
+              <a:rPr lang="en-US" sz="1800" b="1" dirty="0">
+                <a:solidFill>
+                  <a:srgbClr val="333333"/>
+                </a:solidFill>
+              </a:rPr>
+              <a:t>imbal hasil</a:t>
+            </a:r>
+            <a:pPr indent="0" marL="0">
+              <a:buNone/>
+            </a:pPr>
+            <a:r>
+              <a:rPr lang="en-US" sz="1800" dirty="0">
+                <a:solidFill>
+                  <a:srgbClr val="333333"/>
+                </a:solidFill>
+              </a:rPr>
+              <a:t> portofolio.</a:t>
+            </a:r>
+            <a:endParaRPr lang="en-US" sz="1800" dirty="0"/>
+          </a:p>
+          <a:p>
+            <a:pPr marL="342900" indent="-342900">
+              <a:buSzPct val="100000"/>
+              <a:buChar char="•"/>
+            </a:pPr>
+            <a:r>
+              <a:rPr lang="en-US" sz="1800" dirty="0">
+                <a:solidFill>
+                  <a:srgbClr val="333333"/>
+                </a:solidFill>
+              </a:rPr>
+              <a:t>Lebih Agresif untuk mengeksploitasi reli pada pasar </a:t>
+            </a:r>
+            <a:pPr indent="0" marL="0">
+              <a:buNone/>
+            </a:pPr>
+            <a:r>
+              <a:rPr lang="en-US" sz="1800" b="1" dirty="0">
+                <a:solidFill>
+                  <a:srgbClr val="333333"/>
+                </a:solidFill>
+              </a:rPr>
+              <a:t>Bullish</a:t>
+            </a:r>
+            <a:pPr indent="0" marL="0">
+              <a:buNone/>
+            </a:pPr>
+            <a:r>
+              <a:rPr lang="en-US" sz="1800" dirty="0">
+                <a:solidFill>
+                  <a:srgbClr val="333333"/>
+                </a:solidFill>
+              </a:rPr>
+              <a:t>.</a:t>
+            </a:r>
+            <a:endParaRPr lang="en-US" sz="1800" dirty="0"/>
+          </a:p>
+          <a:p>
+            <a:pPr indent="0" marL="0">
+              <a:buNone/>
+            </a:pPr>
+            <a:r>
+              <a:rPr lang="en-US" sz="1800" b="1" dirty="0">
+                <a:solidFill>
                   <a:srgbClr val="C0392B"/>
                 </a:solidFill>
               </a:rPr>
-              <a:t>Pertanyaan: </a:t>
-            </a:r>
-            <a:pPr indent="0" marL="0">
-              <a:buNone/>
-            </a:pPr>
-            <a:r>
-              <a:rPr lang="en-US" sz="1800" i="1" dirty="0">
-                <a:solidFill>
-                  <a:srgbClr val="333333"/>
-                </a:solidFill>
-              </a:rPr>
-              <a:t>"Beberapa koin seperti Binance/EOS belum rilis di awal 2017 sehingga datanya kosong. Bukankah backward-fill memalsukan harga dan merusak matriks?"</a:t>
+              <a:t>2. Network Markowitz dengan Target Risiko (NW - Risk Grid Search):</a:t>
             </a:r>
             <a:endParaRPr lang="en-US" sz="1800" dirty="0"/>
           </a:p>
           <a:p>
+            <a:pPr marL="342900" indent="-342900">
+              <a:buSzPct val="100000"/>
+              <a:buChar char="•"/>
+            </a:pPr>
+            <a:r>
+              <a:rPr lang="en-US" sz="1800" dirty="0">
+                <a:solidFill>
+                  <a:srgbClr val="333333"/>
+                </a:solidFill>
+              </a:rPr>
+              <a:t>Menekan parameter </a:t>
+            </a:r>
             <a:pPr indent="0" marL="0">
               <a:buNone/>
             </a:pPr>
             <a:r>
               <a:rPr lang="en-US" sz="1800" b="1" dirty="0">
                 <a:solidFill>
-                  <a:srgbClr val="27AE60"/>
-                </a:solidFill>
-              </a:rPr>
-              <a:t>Jawaban (Kenapa RMT sangat Krusial):</a:t>
+                  <a:srgbClr val="333333"/>
+                </a:solidFill>
+              </a:rPr>
+              <a:t>risiko total</a:t>
+            </a:r>
+            <a:pPr indent="0" marL="0">
+              <a:buNone/>
+            </a:pPr>
+            <a:r>
+              <a:rPr lang="en-US" sz="1800" dirty="0">
+                <a:solidFill>
+                  <a:srgbClr val="333333"/>
+                </a:solidFill>
+              </a:rPr>
+              <a:t> hingga minimal.</a:t>
             </a:r>
             <a:endParaRPr lang="en-US" sz="1800" dirty="0"/>
           </a:p>
           <a:p>
-            <a:pPr indent="0" marL="0">
-              <a:buNone/>
+            <a:pPr marL="342900" indent="-342900">
+              <a:buSzPct val="100000"/>
+              <a:buChar char="•"/>
             </a:pPr>
             <a:r>
               <a:rPr lang="en-US" sz="1800" dirty="0">
@@ -15562,18 +15702,18 @@
                   <a:srgbClr val="333333"/>
                 </a:solidFill>
               </a:rPr>
-              <a:t>   1. Praktik pengisian data diam (</a:t>
-            </a:r>
-            <a:pPr indent="0" marL="0">
-              <a:buNone/>
-            </a:pPr>
-            <a:r>
-              <a:rPr lang="en-US" sz="1800" b="1" i="1" dirty="0">
-                <a:solidFill>
-                  <a:srgbClr val="333333"/>
-                </a:solidFill>
-              </a:rPr>
-              <a:t>backward fill</a:t>
+              <a:t>Lebih Defensif untuk meredam fluktuasi saat </a:t>
+            </a:r>
+            <a:pPr indent="0" marL="0">
+              <a:buNone/>
+            </a:pPr>
+            <a:r>
+              <a:rPr lang="en-US" sz="1800" b="1" dirty="0">
+                <a:solidFill>
+                  <a:srgbClr val="333333"/>
+                </a:solidFill>
+              </a:rPr>
+              <a:t>Crypto Winter</a:t>
             </a:r>
             <a:pPr indent="0" marL="0">
               <a:buNone/>
@@ -15584,115 +15724,7 @@
                   <a:srgbClr val="333333"/>
                 </a:solidFill>
               </a:rPr>
-              <a:t>) memang menciptakan rentetan nilai harga yang statis.</a:t>
-            </a:r>
-            <a:endParaRPr lang="en-US" sz="1800" dirty="0"/>
-          </a:p>
-          <a:p>
-            <a:pPr indent="0" marL="0">
-              <a:buNone/>
-            </a:pPr>
-            <a:r>
-              <a:rPr lang="en-US" sz="1800" dirty="0">
-                <a:solidFill>
-                  <a:srgbClr val="333333"/>
-                </a:solidFill>
-              </a:rPr>
-              <a:t>   2. Namun, kehebatan </a:t>
-            </a:r>
-            <a:pPr indent="0" marL="0">
-              <a:buNone/>
-            </a:pPr>
-            <a:r>
-              <a:rPr lang="en-US" sz="1800" b="1" dirty="0">
-                <a:solidFill>
-                  <a:srgbClr val="333333"/>
-                </a:solidFill>
-              </a:rPr>
-              <a:t>Random Matrix Theory (RMT)</a:t>
-            </a:r>
-            <a:pPr indent="0" marL="0">
-              <a:buNone/>
-            </a:pPr>
-            <a:r>
-              <a:rPr lang="en-US" sz="1800" dirty="0">
-                <a:solidFill>
-                  <a:srgbClr val="333333"/>
-                </a:solidFill>
-              </a:rPr>
-              <a:t> diuji di sini! Karena data yang datar sama sekali tidak punya korelasi nyata.</a:t>
-            </a:r>
-            <a:endParaRPr lang="en-US" sz="1800" dirty="0"/>
-          </a:p>
-          <a:p>
-            <a:pPr indent="0" marL="0">
-              <a:buNone/>
-            </a:pPr>
-            <a:r>
-              <a:rPr lang="en-US" sz="1800" dirty="0">
-                <a:solidFill>
-                  <a:srgbClr val="333333"/>
-                </a:solidFill>
-              </a:rPr>
-              <a:t>   3. RMT otomatis akan mendeteksi korelasi buatan tersebut sebagai probabilitas </a:t>
-            </a:r>
-            <a:pPr indent="0" marL="0">
-              <a:buNone/>
-            </a:pPr>
-            <a:r>
-              <a:rPr lang="en-US" sz="1800" b="1" i="1" dirty="0">
-                <a:solidFill>
-                  <a:srgbClr val="333333"/>
-                </a:solidFill>
-              </a:rPr>
-              <a:t>Noise Acak</a:t>
-            </a:r>
-            <a:pPr indent="0" marL="0">
-              <a:buNone/>
-            </a:pPr>
-            <a:r>
-              <a:rPr lang="en-US" sz="1800" dirty="0">
-                <a:solidFill>
-                  <a:srgbClr val="333333"/>
-                </a:solidFill>
-              </a:rPr>
-              <a:t>, lalu membuangnya menjadi 0.</a:t>
-            </a:r>
-            <a:endParaRPr lang="en-US" sz="1800" dirty="0"/>
-          </a:p>
-          <a:p>
-            <a:pPr indent="0" marL="0">
-              <a:buNone/>
-            </a:pPr>
-            <a:r>
-              <a:rPr lang="en-US" sz="1800" dirty="0">
-                <a:solidFill>
-                  <a:srgbClr val="333333"/>
-                </a:solidFill>
-              </a:rPr>
-              <a:t>   4. Hasilnya, matriks korelasi </a:t>
-            </a:r>
-            <a:pPr indent="0" marL="0">
-              <a:buNone/>
-            </a:pPr>
-            <a:r>
-              <a:rPr lang="en-US" sz="1800" b="1" dirty="0">
-                <a:solidFill>
-                  <a:srgbClr val="333333"/>
-                </a:solidFill>
-              </a:rPr>
-              <a:t>terselamatkan</a:t>
-            </a:r>
-            <a:pPr indent="0" marL="0">
-              <a:buNone/>
-            </a:pPr>
-            <a:r>
-              <a:rPr lang="en-US" sz="1800" dirty="0">
-                <a:solidFill>
-                  <a:srgbClr val="333333"/>
-                </a:solidFill>
-              </a:rPr>
-              <a:t> dan tidak tercemar oleh cacat kelengkapan data.</a:t>
+              <a:t>.</a:t>
             </a:r>
             <a:endParaRPr lang="en-US" sz="1800" dirty="0"/>
           </a:p>
@@ -15753,7 +15785,7 @@
                   <a:srgbClr val="003366"/>
                 </a:solidFill>
               </a:rPr>
-              <a:t>Lampiran: Mengapa Menyertakan Tether (USDT)? (1/2)</a:t>
+              <a:t>Lampiran: Penanganan Data Kosong (Missing Values)</a:t>
             </a:r>
             <a:endParaRPr lang="en-US" sz="2600" dirty="0"/>
           </a:p>
@@ -15800,7 +15832,7 @@
                   <a:srgbClr val="333333"/>
                 </a:solidFill>
               </a:rPr>
-              <a:t>"Tether (USDT) itu stablecoin yang nilainya selalu fix ke 1 USD. Apakah tidak berbuat curang?"</a:t>
+              <a:t>"Beberapa koin seperti Binance/EOS belum rilis di awal 2017 sehingga datanya kosong. Bukankah backward-fill memalsukan harga dan merusak matriks?"</a:t>
             </a:r>
             <a:endParaRPr lang="en-US" sz="1800" dirty="0"/>
           </a:p>
@@ -15814,14 +15846,13 @@
                   <a:srgbClr val="27AE60"/>
                 </a:solidFill>
               </a:rPr>
-              <a:t>Jawaban (Dinamika Portofolio Cerdas):</a:t>
+              <a:t>Jawaban (Kenapa RMT sangat Krusial):</a:t>
             </a:r>
             <a:endParaRPr lang="en-US" sz="1800" dirty="0"/>
           </a:p>
           <a:p>
-            <a:pPr marL="342900" indent="-342900">
-              <a:buSzPct val="100000"/>
-              <a:buChar char="•"/>
+            <a:pPr indent="0" marL="0">
+              <a:buNone/>
             </a:pPr>
             <a:r>
               <a:rPr lang="en-US" sz="1800" dirty="0">
@@ -15829,7 +15860,7 @@
                   <a:srgbClr val="333333"/>
                 </a:solidFill>
               </a:rPr>
-              <a:t>Model ini mensimulasikan perilaku </a:t>
+              <a:t>   1. Praktik pengisian data diam (</a:t>
             </a:r>
             <a:pPr indent="0" marL="0">
               <a:buNone/>
@@ -15840,7 +15871,7 @@
                   <a:srgbClr val="333333"/>
                 </a:solidFill>
               </a:rPr>
-              <a:t>Robo-Advisory</a:t>
+              <a:t>backward fill</a:t>
             </a:r>
             <a:pPr indent="0" marL="0">
               <a:buNone/>
@@ -15851,14 +15882,13 @@
                   <a:srgbClr val="333333"/>
                 </a:solidFill>
               </a:rPr>
-              <a:t> institusional.</a:t>
+              <a:t>) memang menciptakan rentetan nilai harga yang statis.</a:t>
             </a:r>
             <a:endParaRPr lang="en-US" sz="1800" dirty="0"/>
           </a:p>
           <a:p>
-            <a:pPr marL="342900" indent="-342900">
-              <a:buSzPct val="100000"/>
-              <a:buChar char="•"/>
+            <a:pPr indent="0" marL="0">
+              <a:buNone/>
             </a:pPr>
             <a:r>
               <a:rPr lang="en-US" sz="1800" dirty="0">
@@ -15866,7 +15896,7 @@
                   <a:srgbClr val="333333"/>
                 </a:solidFill>
               </a:rPr>
-              <a:t>Ketika pasar anjlok ekstrem, investor akan melarikan senjatanya ke posisi </a:t>
+              <a:t>   2. Namun, kehebatan </a:t>
             </a:r>
             <a:pPr indent="0" marL="0">
               <a:buNone/>
@@ -15877,7 +15907,7 @@
                   <a:srgbClr val="333333"/>
                 </a:solidFill>
               </a:rPr>
-              <a:t>tunai (USDT)</a:t>
+              <a:t>Random Matrix Theory (RMT)</a:t>
             </a:r>
             <a:pPr indent="0" marL="0">
               <a:buNone/>
@@ -15888,7 +15918,79 @@
                   <a:srgbClr val="333333"/>
                 </a:solidFill>
               </a:rPr>
-              <a:t> sebagai evakuasi risiko.</a:t>
+              <a:t> diuji di sini! Karena data yang datar sama sekali tidak punya korelasi nyata.</a:t>
+            </a:r>
+            <a:endParaRPr lang="en-US" sz="1800" dirty="0"/>
+          </a:p>
+          <a:p>
+            <a:pPr indent="0" marL="0">
+              <a:buNone/>
+            </a:pPr>
+            <a:r>
+              <a:rPr lang="en-US" sz="1800" dirty="0">
+                <a:solidFill>
+                  <a:srgbClr val="333333"/>
+                </a:solidFill>
+              </a:rPr>
+              <a:t>   3. RMT otomatis akan mendeteksi korelasi buatan tersebut sebagai probabilitas </a:t>
+            </a:r>
+            <a:pPr indent="0" marL="0">
+              <a:buNone/>
+            </a:pPr>
+            <a:r>
+              <a:rPr lang="en-US" sz="1800" b="1" i="1" dirty="0">
+                <a:solidFill>
+                  <a:srgbClr val="333333"/>
+                </a:solidFill>
+              </a:rPr>
+              <a:t>Noise Acak</a:t>
+            </a:r>
+            <a:pPr indent="0" marL="0">
+              <a:buNone/>
+            </a:pPr>
+            <a:r>
+              <a:rPr lang="en-US" sz="1800" dirty="0">
+                <a:solidFill>
+                  <a:srgbClr val="333333"/>
+                </a:solidFill>
+              </a:rPr>
+              <a:t>, lalu membuangnya menjadi 0.</a:t>
+            </a:r>
+            <a:endParaRPr lang="en-US" sz="1800" dirty="0"/>
+          </a:p>
+          <a:p>
+            <a:pPr indent="0" marL="0">
+              <a:buNone/>
+            </a:pPr>
+            <a:r>
+              <a:rPr lang="en-US" sz="1800" dirty="0">
+                <a:solidFill>
+                  <a:srgbClr val="333333"/>
+                </a:solidFill>
+              </a:rPr>
+              <a:t>   4. Hasilnya, matriks korelasi </a:t>
+            </a:r>
+            <a:pPr indent="0" marL="0">
+              <a:buNone/>
+            </a:pPr>
+            <a:r>
+              <a:rPr lang="en-US" sz="1800" b="1" dirty="0">
+                <a:solidFill>
+                  <a:srgbClr val="333333"/>
+                </a:solidFill>
+              </a:rPr>
+              <a:t>terselamatkan</a:t>
+            </a:r>
+            <a:pPr indent="0" marL="0">
+              <a:buNone/>
+            </a:pPr>
+            <a:r>
+              <a:rPr lang="en-US" sz="1800" dirty="0">
+                <a:solidFill>
+                  <a:srgbClr val="333333"/>
+                </a:solidFill>
+              </a:rPr>
+              <a:t> dan tidak tercemar oleh cacat kelengkapan data.</a:t>
             </a:r>
             <a:endParaRPr lang="en-US" sz="1800" dirty="0"/>
           </a:p>
@@ -15949,7 +16051,7 @@
                   <a:srgbClr val="003366"/>
                 </a:solidFill>
               </a:rPr>
-              <a:t>Lampiran: Mengapa Menyertakan Tether (USDT)? (2/2)</a:t>
+              <a:t>Lampiran: Mengapa Menyertakan Tether (USDT)? (1/2)</a:t>
             </a:r>
             <a:endParaRPr lang="en-US" sz="2600" dirty="0"/>
           </a:p>
@@ -15980,12 +16082,89 @@
               <a:buNone/>
             </a:pPr>
             <a:r>
+              <a:rPr lang="en-US" sz="1800" b="1" dirty="0">
+                <a:solidFill>
+                  <a:srgbClr val="C0392B"/>
+                </a:solidFill>
+              </a:rPr>
+              <a:t>Pertanyaan: </a:t>
+            </a:r>
+            <a:pPr indent="0" marL="0">
+              <a:buNone/>
+            </a:pPr>
+            <a:r>
+              <a:rPr lang="en-US" sz="1800" i="1" dirty="0">
+                <a:solidFill>
+                  <a:srgbClr val="333333"/>
+                </a:solidFill>
+              </a:rPr>
+              <a:t>"Tether (USDT) itu stablecoin yang nilainya selalu fix ke 1 USD. Apakah tidak berbuat curang?"</a:t>
+            </a:r>
+            <a:endParaRPr lang="en-US" sz="1800" dirty="0"/>
+          </a:p>
+          <a:p>
+            <a:pPr indent="0" marL="0">
+              <a:buNone/>
+            </a:pPr>
+            <a:r>
+              <a:rPr lang="en-US" sz="1800" b="1" dirty="0">
+                <a:solidFill>
+                  <a:srgbClr val="27AE60"/>
+                </a:solidFill>
+              </a:rPr>
+              <a:t>Jawaban (Dinamika Portofolio Cerdas):</a:t>
+            </a:r>
+            <a:endParaRPr lang="en-US" sz="1800" dirty="0"/>
+          </a:p>
+          <a:p>
+            <a:pPr marL="342900" indent="-342900">
+              <a:buSzPct val="100000"/>
+              <a:buChar char="•"/>
+            </a:pPr>
+            <a:r>
               <a:rPr lang="en-US" sz="1800" dirty="0">
                 <a:solidFill>
                   <a:srgbClr val="333333"/>
                 </a:solidFill>
               </a:rPr>
-              <a:t>3. Algoritma jaringan </a:t>
+              <a:t>Model ini mensimulasikan perilaku </a:t>
+            </a:r>
+            <a:pPr indent="0" marL="0">
+              <a:buNone/>
+            </a:pPr>
+            <a:r>
+              <a:rPr lang="en-US" sz="1800" b="1" i="1" dirty="0">
+                <a:solidFill>
+                  <a:srgbClr val="333333"/>
+                </a:solidFill>
+              </a:rPr>
+              <a:t>Robo-Advisory</a:t>
+            </a:r>
+            <a:pPr indent="0" marL="0">
+              <a:buNone/>
+            </a:pPr>
+            <a:r>
+              <a:rPr lang="en-US" sz="1800" dirty="0">
+                <a:solidFill>
+                  <a:srgbClr val="333333"/>
+                </a:solidFill>
+              </a:rPr>
+              <a:t> institusional.</a:t>
+            </a:r>
+            <a:endParaRPr lang="en-US" sz="1800" dirty="0"/>
+          </a:p>
+          <a:p>
+            <a:pPr marL="342900" indent="-342900">
+              <a:buSzPct val="100000"/>
+              <a:buChar char="•"/>
+            </a:pPr>
+            <a:r>
+              <a:rPr lang="en-US" sz="1800" dirty="0">
+                <a:solidFill>
+                  <a:srgbClr val="333333"/>
+                </a:solidFill>
+              </a:rPr>
+              <a:t>Ketika pasar anjlok ekstrem, investor akan melarikan senjatanya ke posisi </a:t>
             </a:r>
             <a:pPr indent="0" marL="0">
               <a:buNone/>
@@ -15996,7 +16175,7 @@
                   <a:srgbClr val="333333"/>
                 </a:solidFill>
               </a:rPr>
-              <a:t>Network Markowitz GS (Grid Search)</a:t>
+              <a:t>tunai (USDT)</a:t>
             </a:r>
             <a:pPr indent="0" marL="0">
               <a:buNone/>
@@ -16007,87 +16186,7 @@
                   <a:srgbClr val="333333"/>
                 </a:solidFill>
               </a:rPr>
-              <a:t> dilatih secara matematis; jika mendeteksi korelasi ancaman kolaps merambat ke semua altcoin, ia akan melempar alokasi modalnya menuju node </a:t>
-            </a:r>
-            <a:pPr indent="0" marL="0">
-              <a:buNone/>
-            </a:pPr>
-            <a:r>
-              <a:rPr lang="en-US" sz="1800" b="1" dirty="0">
-                <a:solidFill>
-                  <a:srgbClr val="333333"/>
-                </a:solidFill>
-              </a:rPr>
-              <a:t>USDT (Tether)</a:t>
-            </a:r>
-            <a:pPr indent="0" marL="0">
-              <a:buNone/>
-            </a:pPr>
-            <a:r>
-              <a:rPr lang="en-US" sz="1800" dirty="0">
-                <a:solidFill>
-                  <a:srgbClr val="333333"/>
-                </a:solidFill>
-              </a:rPr>
-              <a:t> sebagai langkah </a:t>
-            </a:r>
-            <a:pPr indent="0" marL="0">
-              <a:buNone/>
-            </a:pPr>
-            <a:r>
-              <a:rPr lang="en-US" sz="1800" b="1" dirty="0">
-                <a:solidFill>
-                  <a:srgbClr val="333333"/>
-                </a:solidFill>
-              </a:rPr>
-              <a:t>evakuasi otomatis</a:t>
-            </a:r>
-            <a:pPr indent="0" marL="0">
-              <a:buNone/>
-            </a:pPr>
-            <a:r>
-              <a:rPr lang="en-US" sz="1800" dirty="0">
-                <a:solidFill>
-                  <a:srgbClr val="333333"/>
-                </a:solidFill>
-              </a:rPr>
-              <a:t> (Shock-Absorber).</a:t>
-            </a:r>
-            <a:endParaRPr lang="en-US" sz="1800" dirty="0"/>
-          </a:p>
-          <a:p>
-            <a:pPr indent="0" marL="0">
-              <a:buNone/>
-            </a:pPr>
-            <a:r>
-              <a:rPr lang="en-US" sz="1800" dirty="0">
-                <a:solidFill>
-                  <a:srgbClr val="333333"/>
-                </a:solidFill>
-              </a:rPr>
-              <a:t>   4. Hal ini yang membuat performa Risk-GS (Grid Search) sangat </a:t>
-            </a:r>
-            <a:pPr indent="0" marL="0">
-              <a:buNone/>
-            </a:pPr>
-            <a:r>
-              <a:rPr lang="en-US" sz="1800" b="1" dirty="0">
-                <a:solidFill>
-                  <a:srgbClr val="333333"/>
-                </a:solidFill>
-              </a:rPr>
-              <a:t>tangguh</a:t>
-            </a:r>
-            <a:pPr indent="0" marL="0">
-              <a:buNone/>
-            </a:pPr>
-            <a:r>
-              <a:rPr lang="en-US" sz="1800" dirty="0">
-                <a:solidFill>
-                  <a:srgbClr val="333333"/>
-                </a:solidFill>
-              </a:rPr>
-              <a:t> dari serangan Crypto Winter, suatu kapabilitas pertahanan yang tidak dipahami oleh model ortodoks murni Markowitz.</a:t>
+              <a:t> sebagai evakuasi risiko.</a:t>
             </a:r>
             <a:endParaRPr lang="en-US" sz="1800" dirty="0"/>
           </a:p>
@@ -16148,7 +16247,7 @@
                   <a:srgbClr val="003366"/>
                 </a:solidFill>
               </a:rPr>
-              <a:t>Lampiran: Bukti Empiris Non-Stationarity Pasar</a:t>
+              <a:t>Lampiran: Mengapa Menyertakan Tether (USDT)? (2/2)</a:t>
             </a:r>
             <a:endParaRPr lang="en-US" sz="2600" dirty="0"/>
           </a:p>
@@ -16179,23 +16278,78 @@
               <a:buNone/>
             </a:pPr>
             <a:r>
+              <a:rPr lang="en-US" sz="1800" dirty="0">
+                <a:solidFill>
+                  <a:srgbClr val="333333"/>
+                </a:solidFill>
+              </a:rPr>
+              <a:t>3. Algoritma jaringan </a:t>
+            </a:r>
+            <a:pPr indent="0" marL="0">
+              <a:buNone/>
+            </a:pPr>
+            <a:r>
               <a:rPr lang="en-US" sz="1800" b="1" dirty="0">
                 <a:solidFill>
-                  <a:srgbClr val="C0392B"/>
-                </a:solidFill>
-              </a:rPr>
-              <a:t>Masalah: </a:t>
-            </a:r>
-            <a:pPr indent="0" marL="0">
-              <a:buNone/>
-            </a:pPr>
-            <a:r>
-              <a:rPr lang="en-US" sz="1800" i="1" dirty="0">
-                <a:solidFill>
-                  <a:srgbClr val="333333"/>
-                </a:solidFill>
-              </a:rPr>
-              <a:t>Kenapa harus menggunakan model Adaptif (Dynamic Gamma)?</a:t>
+                  <a:srgbClr val="333333"/>
+                </a:solidFill>
+              </a:rPr>
+              <a:t>Network Markowitz GS (Grid Search)</a:t>
+            </a:r>
+            <a:pPr indent="0" marL="0">
+              <a:buNone/>
+            </a:pPr>
+            <a:r>
+              <a:rPr lang="en-US" sz="1800" dirty="0">
+                <a:solidFill>
+                  <a:srgbClr val="333333"/>
+                </a:solidFill>
+              </a:rPr>
+              <a:t> dilatih secara matematis; jika mendeteksi korelasi ancaman kolaps merambat ke semua altcoin, ia akan melempar alokasi modalnya menuju node </a:t>
+            </a:r>
+            <a:pPr indent="0" marL="0">
+              <a:buNone/>
+            </a:pPr>
+            <a:r>
+              <a:rPr lang="en-US" sz="1800" b="1" dirty="0">
+                <a:solidFill>
+                  <a:srgbClr val="333333"/>
+                </a:solidFill>
+              </a:rPr>
+              <a:t>USDT (Tether)</a:t>
+            </a:r>
+            <a:pPr indent="0" marL="0">
+              <a:buNone/>
+            </a:pPr>
+            <a:r>
+              <a:rPr lang="en-US" sz="1800" dirty="0">
+                <a:solidFill>
+                  <a:srgbClr val="333333"/>
+                </a:solidFill>
+              </a:rPr>
+              <a:t> sebagai langkah </a:t>
+            </a:r>
+            <a:pPr indent="0" marL="0">
+              <a:buNone/>
+            </a:pPr>
+            <a:r>
+              <a:rPr lang="en-US" sz="1800" b="1" dirty="0">
+                <a:solidFill>
+                  <a:srgbClr val="333333"/>
+                </a:solidFill>
+              </a:rPr>
+              <a:t>evakuasi otomatis</a:t>
+            </a:r>
+            <a:pPr indent="0" marL="0">
+              <a:buNone/>
+            </a:pPr>
+            <a:r>
+              <a:rPr lang="en-US" sz="1800" dirty="0">
+                <a:solidFill>
+                  <a:srgbClr val="333333"/>
+                </a:solidFill>
+              </a:rPr>
+              <a:t> (Shock-Absorber).</a:t>
             </a:r>
             <a:endParaRPr lang="en-US" sz="1800" dirty="0"/>
           </a:p>
@@ -16204,19 +16358,26 @@
               <a:buNone/>
             </a:pPr>
             <a:r>
+              <a:rPr lang="en-US" sz="1800" dirty="0">
+                <a:solidFill>
+                  <a:srgbClr val="333333"/>
+                </a:solidFill>
+              </a:rPr>
+              <a:t>   4. Hal ini yang membuat performa Risk-GS (Grid Search) sangat </a:t>
+            </a:r>
+            <a:pPr indent="0" marL="0">
+              <a:buNone/>
+            </a:pPr>
+            <a:r>
               <a:rPr lang="en-US" sz="1800" b="1" dirty="0">
                 <a:solidFill>
-                  <a:srgbClr val="27AE60"/>
-                </a:solidFill>
-              </a:rPr>
-              <a:t>Bukti dari Grid Search:</a:t>
-            </a:r>
-            <a:endParaRPr lang="en-US" sz="1800" dirty="0"/>
-          </a:p>
-          <a:p>
-            <a:pPr marL="342900" indent="-342900">
-              <a:buSzPct val="100000"/>
-              <a:buChar char="•"/>
+                  <a:srgbClr val="333333"/>
+                </a:solidFill>
+              </a:rPr>
+              <a:t>tangguh</a:t>
+            </a:r>
+            <a:pPr indent="0" marL="0">
+              <a:buNone/>
             </a:pPr>
             <a:r>
               <a:rPr lang="en-US" sz="1800" dirty="0">
@@ -16224,103 +16385,7 @@
                   <a:srgbClr val="333333"/>
                 </a:solidFill>
               </a:rPr>
-              <a:t>Data menunjukkan nilai Gamma (γ) optimal </a:t>
-            </a:r>
-            <a:pPr indent="0" marL="0">
-              <a:buNone/>
-            </a:pPr>
-            <a:r>
-              <a:rPr lang="en-US" sz="1800" b="1" dirty="0">
-                <a:solidFill>
-                  <a:srgbClr val="333333"/>
-                </a:solidFill>
-              </a:rPr>
-              <a:t>terus bergeser</a:t>
-            </a:r>
-            <a:pPr indent="0" marL="0">
-              <a:buNone/>
-            </a:pPr>
-            <a:r>
-              <a:rPr lang="en-US" sz="1800" dirty="0">
-                <a:solidFill>
-                  <a:srgbClr val="333333"/>
-                </a:solidFill>
-              </a:rPr>
-              <a:t> setiap periode rebalancing.</a:t>
-            </a:r>
-            <a:endParaRPr lang="en-US" sz="1800" dirty="0"/>
-          </a:p>
-          <a:p>
-            <a:pPr marL="342900" indent="-342900">
-              <a:buSzPct val="100000"/>
-              <a:buChar char="•"/>
-            </a:pPr>
-            <a:r>
-              <a:rPr lang="en-US" sz="1800" dirty="0">
-                <a:solidFill>
-                  <a:srgbClr val="333333"/>
-                </a:solidFill>
-              </a:rPr>
-              <a:t>Penggunaan γ statis tidak cukup untuk menangkap perubahan </a:t>
-            </a:r>
-            <a:pPr indent="0" marL="0">
-              <a:buNone/>
-            </a:pPr>
-            <a:r>
-              <a:rPr lang="en-US" sz="1800" b="1" dirty="0">
-                <a:solidFill>
-                  <a:srgbClr val="333333"/>
-                </a:solidFill>
-              </a:rPr>
-              <a:t>struktur korelasi</a:t>
-            </a:r>
-            <a:pPr indent="0" marL="0">
-              <a:buNone/>
-            </a:pPr>
-            <a:r>
-              <a:rPr lang="en-US" sz="1800" dirty="0">
-                <a:solidFill>
-                  <a:srgbClr val="333333"/>
-                </a:solidFill>
-              </a:rPr>
-              <a:t> yang sangat cepat di pasar kripto.</a:t>
-            </a:r>
-            <a:endParaRPr lang="en-US" sz="1800" dirty="0"/>
-          </a:p>
-          <a:p>
-            <a:pPr marL="342900" indent="-342900">
-              <a:buSzPct val="100000"/>
-              <a:buChar char="•"/>
-            </a:pPr>
-            <a:r>
-              <a:rPr lang="en-US" sz="1800" dirty="0">
-                <a:solidFill>
-                  <a:srgbClr val="333333"/>
-                </a:solidFill>
-              </a:rPr>
-              <a:t>Ini membenarkan bahwa pasar kripto membutuhkan </a:t>
-            </a:r>
-            <a:pPr indent="0" marL="0">
-              <a:buNone/>
-            </a:pPr>
-            <a:r>
-              <a:rPr lang="en-US" sz="1800" b="1" dirty="0">
-                <a:solidFill>
-                  <a:srgbClr val="333333"/>
-                </a:solidFill>
-              </a:rPr>
-              <a:t>kalibrasi otomatis</a:t>
-            </a:r>
-            <a:pPr indent="0" marL="0">
-              <a:buNone/>
-            </a:pPr>
-            <a:r>
-              <a:rPr lang="en-US" sz="1800" dirty="0">
-                <a:solidFill>
-                  <a:srgbClr val="333333"/>
-                </a:solidFill>
-              </a:rPr>
-              <a:t> secara temporal.</a:t>
+              <a:t> dari serangan Crypto Winter, suatu kapabilitas pertahanan yang tidak dipahami oleh model ortodoks murni Markowitz.</a:t>
             </a:r>
             <a:endParaRPr lang="en-US" sz="1800" dirty="0"/>
           </a:p>
@@ -16337,6 +16402,239 @@
 <file path=ppt/slides/slide48.xml><?xml version="1.0" encoding="utf-8"?>
 <p:sld xmlns:a="http://schemas.openxmlformats.org/drawingml/2006/main" xmlns:r="http://schemas.openxmlformats.org/officeDocument/2006/relationships" xmlns:p="http://schemas.openxmlformats.org/presentationml/2006/main">
   <p:cSld name="Slide 48">
+    <p:spTree>
+      <p:nvGrpSpPr>
+        <p:cNvPr id="1" name=""/>
+        <p:cNvGrpSpPr/>
+        <p:nvPr/>
+      </p:nvGrpSpPr>
+      <p:grpSpPr>
+        <a:xfrm>
+          <a:off x="0" y="0"/>
+          <a:ext cx="0" cy="0"/>
+          <a:chOff x="0" y="0"/>
+          <a:chExt cx="0" cy="0"/>
+        </a:xfrm>
+      </p:grpSpPr>
+      <p:sp>
+        <p:nvSpPr>
+          <p:cNvPr id="2" name="Text 0"/>
+          <p:cNvSpPr/>
+          <p:nvPr/>
+        </p:nvSpPr>
+        <p:spPr>
+          <a:xfrm>
+            <a:off x="457200" y="457200"/>
+            <a:ext cx="8229600" cy="0"/>
+          </a:xfrm>
+          <a:prstGeom prst="rect">
+            <a:avLst/>
+          </a:prstGeom>
+          <a:noFill/>
+          <a:ln/>
+        </p:spPr>
+        <p:txBody>
+          <a:bodyPr wrap="square" rtlCol="0" anchor="ctr"/>
+          <a:lstStyle/>
+          <a:p>
+            <a:pPr indent="0" marL="0">
+              <a:buNone/>
+            </a:pPr>
+            <a:r>
+              <a:rPr lang="en-US" sz="2600" b="1" dirty="0">
+                <a:solidFill>
+                  <a:srgbClr val="003366"/>
+                </a:solidFill>
+              </a:rPr>
+              <a:t>Lampiran: Bukti Empiris Non-Stationarity Pasar</a:t>
+            </a:r>
+            <a:endParaRPr lang="en-US" sz="2600" dirty="0"/>
+          </a:p>
+        </p:txBody>
+      </p:sp>
+      <p:sp>
+        <p:nvSpPr>
+          <p:cNvPr id="3" name="Text 1"/>
+          <p:cNvSpPr/>
+          <p:nvPr/>
+        </p:nvSpPr>
+        <p:spPr>
+          <a:xfrm>
+            <a:off x="457200" y="1005840"/>
+            <a:ext cx="8229600" cy="5029200"/>
+          </a:xfrm>
+          <a:prstGeom prst="rect">
+            <a:avLst/>
+          </a:prstGeom>
+          <a:noFill/>
+          <a:ln/>
+        </p:spPr>
+        <p:txBody>
+          <a:bodyPr wrap="square" rtlCol="0" anchor="t"/>
+          <a:lstStyle/>
+          <a:p>
+            <a:pPr indent="0" marL="0">
+              <a:buNone/>
+            </a:pPr>
+            <a:r>
+              <a:rPr lang="en-US" sz="1800" b="1" dirty="0">
+                <a:solidFill>
+                  <a:srgbClr val="C0392B"/>
+                </a:solidFill>
+              </a:rPr>
+              <a:t>Masalah: </a:t>
+            </a:r>
+            <a:pPr indent="0" marL="0">
+              <a:buNone/>
+            </a:pPr>
+            <a:r>
+              <a:rPr lang="en-US" sz="1800" i="1" dirty="0">
+                <a:solidFill>
+                  <a:srgbClr val="333333"/>
+                </a:solidFill>
+              </a:rPr>
+              <a:t>Kenapa harus menggunakan model Adaptif (Dynamic Gamma)?</a:t>
+            </a:r>
+            <a:endParaRPr lang="en-US" sz="1800" dirty="0"/>
+          </a:p>
+          <a:p>
+            <a:pPr indent="0" marL="0">
+              <a:buNone/>
+            </a:pPr>
+            <a:r>
+              <a:rPr lang="en-US" sz="1800" b="1" dirty="0">
+                <a:solidFill>
+                  <a:srgbClr val="27AE60"/>
+                </a:solidFill>
+              </a:rPr>
+              <a:t>Bukti dari Grid Search:</a:t>
+            </a:r>
+            <a:endParaRPr lang="en-US" sz="1800" dirty="0"/>
+          </a:p>
+          <a:p>
+            <a:pPr marL="342900" indent="-342900">
+              <a:buSzPct val="100000"/>
+              <a:buChar char="•"/>
+            </a:pPr>
+            <a:r>
+              <a:rPr lang="en-US" sz="1800" dirty="0">
+                <a:solidFill>
+                  <a:srgbClr val="333333"/>
+                </a:solidFill>
+              </a:rPr>
+              <a:t>Data menunjukkan nilai Gamma (γ) optimal </a:t>
+            </a:r>
+            <a:pPr indent="0" marL="0">
+              <a:buNone/>
+            </a:pPr>
+            <a:r>
+              <a:rPr lang="en-US" sz="1800" b="1" dirty="0">
+                <a:solidFill>
+                  <a:srgbClr val="333333"/>
+                </a:solidFill>
+              </a:rPr>
+              <a:t>terus bergeser</a:t>
+            </a:r>
+            <a:pPr indent="0" marL="0">
+              <a:buNone/>
+            </a:pPr>
+            <a:r>
+              <a:rPr lang="en-US" sz="1800" dirty="0">
+                <a:solidFill>
+                  <a:srgbClr val="333333"/>
+                </a:solidFill>
+              </a:rPr>
+              <a:t> setiap periode rebalancing.</a:t>
+            </a:r>
+            <a:endParaRPr lang="en-US" sz="1800" dirty="0"/>
+          </a:p>
+          <a:p>
+            <a:pPr marL="342900" indent="-342900">
+              <a:buSzPct val="100000"/>
+              <a:buChar char="•"/>
+            </a:pPr>
+            <a:r>
+              <a:rPr lang="en-US" sz="1800" dirty="0">
+                <a:solidFill>
+                  <a:srgbClr val="333333"/>
+                </a:solidFill>
+              </a:rPr>
+              <a:t>Penggunaan γ statis tidak cukup untuk menangkap perubahan </a:t>
+            </a:r>
+            <a:pPr indent="0" marL="0">
+              <a:buNone/>
+            </a:pPr>
+            <a:r>
+              <a:rPr lang="en-US" sz="1800" b="1" dirty="0">
+                <a:solidFill>
+                  <a:srgbClr val="333333"/>
+                </a:solidFill>
+              </a:rPr>
+              <a:t>struktur korelasi</a:t>
+            </a:r>
+            <a:pPr indent="0" marL="0">
+              <a:buNone/>
+            </a:pPr>
+            <a:r>
+              <a:rPr lang="en-US" sz="1800" dirty="0">
+                <a:solidFill>
+                  <a:srgbClr val="333333"/>
+                </a:solidFill>
+              </a:rPr>
+              <a:t> yang sangat cepat di pasar kripto.</a:t>
+            </a:r>
+            <a:endParaRPr lang="en-US" sz="1800" dirty="0"/>
+          </a:p>
+          <a:p>
+            <a:pPr marL="342900" indent="-342900">
+              <a:buSzPct val="100000"/>
+              <a:buChar char="•"/>
+            </a:pPr>
+            <a:r>
+              <a:rPr lang="en-US" sz="1800" dirty="0">
+                <a:solidFill>
+                  <a:srgbClr val="333333"/>
+                </a:solidFill>
+              </a:rPr>
+              <a:t>Ini membenarkan bahwa pasar kripto membutuhkan </a:t>
+            </a:r>
+            <a:pPr indent="0" marL="0">
+              <a:buNone/>
+            </a:pPr>
+            <a:r>
+              <a:rPr lang="en-US" sz="1800" b="1" dirty="0">
+                <a:solidFill>
+                  <a:srgbClr val="333333"/>
+                </a:solidFill>
+              </a:rPr>
+              <a:t>kalibrasi otomatis</a:t>
+            </a:r>
+            <a:pPr indent="0" marL="0">
+              <a:buNone/>
+            </a:pPr>
+            <a:r>
+              <a:rPr lang="en-US" sz="1800" dirty="0">
+                <a:solidFill>
+                  <a:srgbClr val="333333"/>
+                </a:solidFill>
+              </a:rPr>
+              <a:t> secara temporal.</a:t>
+            </a:r>
+            <a:endParaRPr lang="en-US" sz="1800" dirty="0"/>
+          </a:p>
+        </p:txBody>
+      </p:sp>
+    </p:spTree>
+  </p:cSld>
+  <p:clrMapOvr>
+    <a:masterClrMapping/>
+  </p:clrMapOvr>
+</p:sld>
+</file>
+
+<file path=ppt/slides/slide49.xml><?xml version="1.0" encoding="utf-8"?>
+<p:sld xmlns:a="http://schemas.openxmlformats.org/drawingml/2006/main" xmlns:r="http://schemas.openxmlformats.org/officeDocument/2006/relationships" xmlns:p="http://schemas.openxmlformats.org/presentationml/2006/main">
+  <p:cSld name="Slide 49">
     <p:spTree>
       <p:nvGrpSpPr>
         <p:cNvPr id="1" name=""/>

</xml_diff>

<commit_message>
feat: add penalty centrality mechanism slide (contagion risk)
</commit_message>
<xml_diff>
--- a/Presentasi_Proposal_Update.pptx
+++ b/Presentasi_Proposal_Update.pptx
@@ -54,9 +54,10 @@
     <p:sldId id="302" r:id="rId48"/>
     <p:sldId id="303" r:id="rId49"/>
     <p:sldId id="304" r:id="rId50"/>
+    <p:sldId id="305" r:id="rId51"/>
   </p:sldIdLst>
   <p:notesMasterIdLst>
-    <p:notesMasterId r:id="rId51"/>
+    <p:notesMasterId r:id="rId52"/>
   </p:notesMasterIdLst>
   <p:sldSz cx="9144000" cy="5143500"/>
   <p:notesSz cx="5143500" cy="9144000"/>
@@ -4446,6 +4447,94 @@
             <a:fld id="{F7021451-1387-4CA6-816F-3879F97B5CBC}" type="slidenum">
               <a:rPr lang="en-US"/>
               <a:t>5</a:t>
+            </a:fld>
+            <a:endParaRPr lang="en-US"/>
+          </a:p>
+        </p:txBody>
+      </p:sp>
+    </p:spTree>
+    <p:extLst>
+      <p:ext uri="{BB962C8B-B14F-4D97-AF65-F5344CB8AC3E}">
+        <p14:creationId xmlns:p14="http://schemas.microsoft.com/office/powerpoint/2010/main" val="1024086991"/>
+      </p:ext>
+    </p:extLst>
+  </p:cSld>
+  <p:clrMapOvr>
+    <a:masterClrMapping/>
+  </p:clrMapOvr>
+</p:notes>
+</file>
+
+<file path=ppt/notesSlides/notesSlide50.xml><?xml version="1.0" encoding="utf-8"?>
+<p:notes xmlns:a="http://schemas.openxmlformats.org/drawingml/2006/main" xmlns:r="http://schemas.openxmlformats.org/officeDocument/2006/relationships" xmlns:p="http://schemas.openxmlformats.org/presentationml/2006/main">
+  <p:cSld>
+    <p:spTree>
+      <p:nvGrpSpPr>
+        <p:cNvPr id="1" name=""/>
+        <p:cNvGrpSpPr/>
+        <p:nvPr/>
+      </p:nvGrpSpPr>
+      <p:grpSpPr>
+        <a:xfrm>
+          <a:off x="0" y="0"/>
+          <a:ext cx="0" cy="0"/>
+          <a:chOff x="0" y="0"/>
+          <a:chExt cx="0" cy="0"/>
+        </a:xfrm>
+      </p:grpSpPr>
+      <p:sp>
+        <p:nvSpPr>
+          <p:cNvPr id="2" name="Slide Image Placeholder 1"/>
+          <p:cNvSpPr>
+            <a:spLocks noGrp="1" noRot="1" noChangeAspect="1"/>
+          </p:cNvSpPr>
+          <p:nvPr>
+            <p:ph type="sldImg"/>
+          </p:nvPr>
+        </p:nvSpPr>
+        <p:spPr/>
+      </p:sp>
+      <p:sp>
+        <p:nvSpPr>
+          <p:cNvPr id="3" name="Notes Placeholder 2"/>
+          <p:cNvSpPr>
+            <a:spLocks noGrp="1"/>
+          </p:cNvSpPr>
+          <p:nvPr>
+            <p:ph type="body" idx="1"/>
+          </p:nvPr>
+        </p:nvSpPr>
+        <p:spPr/>
+        <p:txBody>
+          <a:bodyPr/>
+          <a:lstStyle/>
+          <a:p>
+            <a:r>
+              <a:rPr lang="en-US" dirty="0"/>
+              <a:t/>
+            </a:r>
+            <a:endParaRPr lang="en-US" dirty="0"/>
+          </a:p>
+        </p:txBody>
+      </p:sp>
+      <p:sp>
+        <p:nvSpPr>
+          <p:cNvPr id="4" name="Slide Number Placeholder 3"/>
+          <p:cNvSpPr>
+            <a:spLocks noGrp="1"/>
+          </p:cNvSpPr>
+          <p:nvPr>
+            <p:ph type="sldNum" sz="quarter" idx="10"/>
+          </p:nvPr>
+        </p:nvSpPr>
+        <p:spPr/>
+        <p:txBody>
+          <a:bodyPr/>
+          <a:lstStyle/>
+          <a:p>
+            <a:fld id="{F7021451-1387-4CA6-816F-3879F97B5CBC}" type="slidenum">
+              <a:rPr lang="en-US"/>
+              <a:t>50</a:t>
             </a:fld>
             <a:endParaRPr lang="en-US"/>
           </a:p>
@@ -15507,14 +15596,14 @@
               <a:buNone/>
             </a:pPr>
             <a:r>
-              <a:rPr lang="en-US" sz="2600" b="1" dirty="0">
+              <a:rPr lang="en-US" sz="2400" b="1" dirty="0">
                 <a:solidFill>
                   <a:srgbClr val="003366"/>
                 </a:solidFill>
               </a:rPr>
-              <a:t>Lampiran: Dua Tipe Pendekatan Grid Search</a:t>
-            </a:r>
-            <a:endParaRPr lang="en-US" sz="2600" dirty="0"/>
+              <a:t>Lampiran: Mekanisme Penalty Centrality (Risiko Penularan)</a:t>
+            </a:r>
+            <a:endParaRPr lang="en-US" sz="2400" dirty="0"/>
           </a:p>
         </p:txBody>
       </p:sp>
@@ -15548,7 +15637,7 @@
                   <a:srgbClr val="333333"/>
                 </a:solidFill>
               </a:rPr>
-              <a:t>Dua Objektif Optimasi (Return vs Risk):</a:t>
+              <a:t>Kenapa koin yang 'populer' di jaringan justru diberi hukuman (penalti)?</a:t>
             </a:r>
             <a:endParaRPr lang="en-US" sz="1800" dirty="0"/>
           </a:p>
@@ -15559,17 +15648,16 @@
             <a:r>
               <a:rPr lang="en-US" sz="1800" b="1" dirty="0">
                 <a:solidFill>
-                  <a:srgbClr val="27AE60"/>
-                </a:solidFill>
-              </a:rPr>
-              <a:t>1. Network Markowitz dengan Target Return (NW - Return Grid Search):</a:t>
+                  <a:srgbClr val="003366"/>
+                </a:solidFill>
+              </a:rPr>
+              <a:t>Analogi Bandara Transit (Hub):</a:t>
             </a:r>
             <a:endParaRPr lang="en-US" sz="1800" dirty="0"/>
           </a:p>
           <a:p>
-            <a:pPr marL="342900" indent="-342900">
-              <a:buSzPct val="100000"/>
-              <a:buChar char="•"/>
+            <a:pPr indent="0" marL="0">
+              <a:buNone/>
             </a:pPr>
             <a:r>
               <a:rPr lang="en-US" sz="1800" dirty="0">
@@ -15577,19 +15665,25 @@
                   <a:srgbClr val="333333"/>
                 </a:solidFill>
               </a:rPr>
-              <a:t>Memaksimalkan capaian </a:t>
-            </a:r>
+              <a:t>   Jika Bandara transit utama (misal: Singapura) terkena badai, maka seluruh penerbangan di Asia Tenggara akan ikut kacau. Singapura adalah 'Hub' dengan Centrality tinggi.</a:t>
+            </a:r>
+            <a:endParaRPr lang="en-US" sz="1800" dirty="0"/>
+          </a:p>
+          <a:p>
             <a:pPr indent="0" marL="0">
               <a:buNone/>
             </a:pPr>
             <a:r>
               <a:rPr lang="en-US" sz="1800" b="1" dirty="0">
                 <a:solidFill>
-                  <a:srgbClr val="333333"/>
-                </a:solidFill>
-              </a:rPr>
-              <a:t>imbal hasil</a:t>
-            </a:r>
+                  <a:srgbClr val="003366"/>
+                </a:solidFill>
+              </a:rPr>
+              <a:t>Skenario di Kripto (Dominasi BTC):</a:t>
+            </a:r>
+            <a:endParaRPr lang="en-US" sz="1800" dirty="0"/>
+          </a:p>
+          <a:p>
             <a:pPr indent="0" marL="0">
               <a:buNone/>
             </a:pPr>
@@ -15599,14 +15693,13 @@
                   <a:srgbClr val="333333"/>
                 </a:solidFill>
               </a:rPr>
-              <a:t> portofolio.</a:t>
+              <a:t>   • BTC terhubung ke semua koin lain dalam MST.</a:t>
             </a:r>
             <a:endParaRPr lang="en-US" sz="1800" dirty="0"/>
           </a:p>
           <a:p>
-            <a:pPr marL="342900" indent="-342900">
-              <a:buSzPct val="100000"/>
-              <a:buChar char="•"/>
+            <a:pPr indent="0" marL="0">
+              <a:buNone/>
             </a:pPr>
             <a:r>
               <a:rPr lang="en-US" sz="1800" dirty="0">
@@ -15614,7 +15707,7 @@
                   <a:srgbClr val="333333"/>
                 </a:solidFill>
               </a:rPr>
-              <a:t>Lebih Agresif untuk mengeksploitasi reli pada pasar </a:t>
+              <a:t>   • Skor Centrality BTC = </a:t>
             </a:r>
             <a:pPr indent="0" marL="0">
               <a:buNone/>
@@ -15622,10 +15715,10 @@
             <a:r>
               <a:rPr lang="en-US" sz="1800" b="1" dirty="0">
                 <a:solidFill>
-                  <a:srgbClr val="333333"/>
-                </a:solidFill>
-              </a:rPr>
-              <a:t>Bullish</a:t>
+                  <a:srgbClr val="C0392B"/>
+                </a:solidFill>
+              </a:rPr>
+              <a:t>1.00</a:t>
             </a:r>
             <a:pPr indent="0" marL="0">
               <a:buNone/>
@@ -15636,7 +15729,7 @@
                   <a:srgbClr val="333333"/>
                 </a:solidFill>
               </a:rPr>
-              <a:t>.</a:t>
+              <a:t> (Maksimal).</a:t>
             </a:r>
             <a:endParaRPr lang="en-US" sz="1800" dirty="0"/>
           </a:p>
@@ -15647,84 +15740,74 @@
             <a:r>
               <a:rPr lang="en-US" sz="1800" b="1" dirty="0">
                 <a:solidFill>
+                  <a:srgbClr val="003366"/>
+                </a:solidFill>
+              </a:rPr>
+              <a:t>Cara Model NW Menghitung Risiko:</a:t>
+            </a:r>
+            <a:endParaRPr lang="en-US" sz="1800" dirty="0"/>
+          </a:p>
+          <a:p>
+            <a:pPr indent="0" marL="0">
+              <a:buNone/>
+            </a:pPr>
+            <a:r>
+              <a:rPr lang="en-US" sz="1800" dirty="0">
+                <a:solidFill>
+                  <a:srgbClr val="333333"/>
+                </a:solidFill>
+              </a:rPr>
+              <a:t>   Risiko Baru = Risiko Harga + (γ × </a:t>
+            </a:r>
+            <a:pPr indent="0" marL="0">
+              <a:buNone/>
+            </a:pPr>
+            <a:r>
+              <a:rPr lang="en-US" sz="1800" b="1" dirty="0">
+                <a:solidFill>
                   <a:srgbClr val="C0392B"/>
                 </a:solidFill>
               </a:rPr>
-              <a:t>2. Network Markowitz dengan Target Risiko (NW - Risk Grid Search):</a:t>
+              <a:t>1.00</a:t>
+            </a:r>
+            <a:pPr indent="0" marL="0">
+              <a:buNone/>
+            </a:pPr>
+            <a:r>
+              <a:rPr lang="en-US" sz="1800" dirty="0">
+                <a:solidFill>
+                  <a:srgbClr val="333333"/>
+                </a:solidFill>
+              </a:rPr>
+              <a:t>)</a:t>
             </a:r>
             <a:endParaRPr lang="en-US" sz="1800" dirty="0"/>
           </a:p>
           <a:p>
-            <a:pPr marL="342900" indent="-342900">
-              <a:buSzPct val="100000"/>
-              <a:buChar char="•"/>
-            </a:pPr>
-            <a:r>
-              <a:rPr lang="en-US" sz="1800" dirty="0">
-                <a:solidFill>
-                  <a:srgbClr val="333333"/>
-                </a:solidFill>
-              </a:rPr>
-              <a:t>Menekan parameter </a:t>
-            </a:r>
             <a:pPr indent="0" marL="0">
               <a:buNone/>
             </a:pPr>
             <a:r>
               <a:rPr lang="en-US" sz="1800" b="1" dirty="0">
                 <a:solidFill>
-                  <a:srgbClr val="333333"/>
-                </a:solidFill>
-              </a:rPr>
-              <a:t>risiko total</a:t>
-            </a:r>
-            <a:pPr indent="0" marL="0">
-              <a:buNone/>
-            </a:pPr>
-            <a:r>
-              <a:rPr lang="en-US" sz="1800" dirty="0">
-                <a:solidFill>
-                  <a:srgbClr val="333333"/>
-                </a:solidFill>
-              </a:rPr>
-              <a:t> hingga minimal.</a:t>
+                  <a:srgbClr val="8E44AD"/>
+                </a:solidFill>
+              </a:rPr>
+              <a:t>Tujuan Penalti:</a:t>
             </a:r>
             <a:endParaRPr lang="en-US" sz="1800" dirty="0"/>
           </a:p>
           <a:p>
-            <a:pPr marL="342900" indent="-342900">
-              <a:buSzPct val="100000"/>
-              <a:buChar char="•"/>
-            </a:pPr>
-            <a:r>
-              <a:rPr lang="en-US" sz="1800" dirty="0">
-                <a:solidFill>
-                  <a:srgbClr val="333333"/>
-                </a:solidFill>
-              </a:rPr>
-              <a:t>Lebih Defensif untuk meredam fluktuasi saat </a:t>
-            </a:r>
-            <a:pPr indent="0" marL="0">
-              <a:buNone/>
-            </a:pPr>
-            <a:r>
-              <a:rPr lang="en-US" sz="1800" b="1" dirty="0">
-                <a:solidFill>
-                  <a:srgbClr val="333333"/>
-                </a:solidFill>
-              </a:rPr>
-              <a:t>Crypto Winter</a:t>
-            </a:r>
-            <a:pPr indent="0" marL="0">
-              <a:buNone/>
-            </a:pPr>
-            <a:r>
-              <a:rPr lang="en-US" sz="1800" dirty="0">
-                <a:solidFill>
-                  <a:srgbClr val="333333"/>
-                </a:solidFill>
-              </a:rPr>
-              <a:t>.</a:t>
+            <a:pPr indent="0" marL="0">
+              <a:buNone/>
+            </a:pPr>
+            <a:r>
+              <a:rPr lang="en-US" sz="1800" i="1" dirty="0">
+                <a:solidFill>
+                  <a:srgbClr val="333333"/>
+                </a:solidFill>
+              </a:rPr>
+              <a:t>Agar portofolio tidak menaruh terlalu banyak modal pada koin yang bisa memicu 'Efek Domino'. Jika BTC rontok, penalti memastikan kita sudah punya cadangan di koin-koin 'pinggiran' (peripheral) yang lebih mandiri.</a:t>
             </a:r>
             <a:endParaRPr lang="en-US" sz="1800" dirty="0"/>
           </a:p>
@@ -15785,7 +15868,7 @@
                   <a:srgbClr val="003366"/>
                 </a:solidFill>
               </a:rPr>
-              <a:t>Lampiran: Penanganan Data Kosong (Missing Values)</a:t>
+              <a:t>Lampiran: Dua Tipe Pendekatan Grid Search</a:t>
             </a:r>
             <a:endParaRPr lang="en-US" sz="2600" dirty="0"/>
           </a:p>
@@ -15818,41 +15901,156 @@
             <a:r>
               <a:rPr lang="en-US" sz="1800" b="1" dirty="0">
                 <a:solidFill>
+                  <a:srgbClr val="333333"/>
+                </a:solidFill>
+              </a:rPr>
+              <a:t>Dua Objektif Optimasi (Return vs Risk):</a:t>
+            </a:r>
+            <a:endParaRPr lang="en-US" sz="1800" dirty="0"/>
+          </a:p>
+          <a:p>
+            <a:pPr indent="0" marL="0">
+              <a:buNone/>
+            </a:pPr>
+            <a:r>
+              <a:rPr lang="en-US" sz="1800" b="1" dirty="0">
+                <a:solidFill>
+                  <a:srgbClr val="27AE60"/>
+                </a:solidFill>
+              </a:rPr>
+              <a:t>1. Network Markowitz dengan Target Return (NW - Return Grid Search):</a:t>
+            </a:r>
+            <a:endParaRPr lang="en-US" sz="1800" dirty="0"/>
+          </a:p>
+          <a:p>
+            <a:pPr marL="342900" indent="-342900">
+              <a:buSzPct val="100000"/>
+              <a:buChar char="•"/>
+            </a:pPr>
+            <a:r>
+              <a:rPr lang="en-US" sz="1800" dirty="0">
+                <a:solidFill>
+                  <a:srgbClr val="333333"/>
+                </a:solidFill>
+              </a:rPr>
+              <a:t>Memaksimalkan capaian </a:t>
+            </a:r>
+            <a:pPr indent="0" marL="0">
+              <a:buNone/>
+            </a:pPr>
+            <a:r>
+              <a:rPr lang="en-US" sz="1800" b="1" dirty="0">
+                <a:solidFill>
+                  <a:srgbClr val="333333"/>
+                </a:solidFill>
+              </a:rPr>
+              <a:t>imbal hasil</a:t>
+            </a:r>
+            <a:pPr indent="0" marL="0">
+              <a:buNone/>
+            </a:pPr>
+            <a:r>
+              <a:rPr lang="en-US" sz="1800" dirty="0">
+                <a:solidFill>
+                  <a:srgbClr val="333333"/>
+                </a:solidFill>
+              </a:rPr>
+              <a:t> portofolio.</a:t>
+            </a:r>
+            <a:endParaRPr lang="en-US" sz="1800" dirty="0"/>
+          </a:p>
+          <a:p>
+            <a:pPr marL="342900" indent="-342900">
+              <a:buSzPct val="100000"/>
+              <a:buChar char="•"/>
+            </a:pPr>
+            <a:r>
+              <a:rPr lang="en-US" sz="1800" dirty="0">
+                <a:solidFill>
+                  <a:srgbClr val="333333"/>
+                </a:solidFill>
+              </a:rPr>
+              <a:t>Lebih Agresif untuk mengeksploitasi reli pada pasar </a:t>
+            </a:r>
+            <a:pPr indent="0" marL="0">
+              <a:buNone/>
+            </a:pPr>
+            <a:r>
+              <a:rPr lang="en-US" sz="1800" b="1" dirty="0">
+                <a:solidFill>
+                  <a:srgbClr val="333333"/>
+                </a:solidFill>
+              </a:rPr>
+              <a:t>Bullish</a:t>
+            </a:r>
+            <a:pPr indent="0" marL="0">
+              <a:buNone/>
+            </a:pPr>
+            <a:r>
+              <a:rPr lang="en-US" sz="1800" dirty="0">
+                <a:solidFill>
+                  <a:srgbClr val="333333"/>
+                </a:solidFill>
+              </a:rPr>
+              <a:t>.</a:t>
+            </a:r>
+            <a:endParaRPr lang="en-US" sz="1800" dirty="0"/>
+          </a:p>
+          <a:p>
+            <a:pPr indent="0" marL="0">
+              <a:buNone/>
+            </a:pPr>
+            <a:r>
+              <a:rPr lang="en-US" sz="1800" b="1" dirty="0">
+                <a:solidFill>
                   <a:srgbClr val="C0392B"/>
                 </a:solidFill>
               </a:rPr>
-              <a:t>Pertanyaan: </a:t>
-            </a:r>
-            <a:pPr indent="0" marL="0">
-              <a:buNone/>
-            </a:pPr>
-            <a:r>
-              <a:rPr lang="en-US" sz="1800" i="1" dirty="0">
-                <a:solidFill>
-                  <a:srgbClr val="333333"/>
-                </a:solidFill>
-              </a:rPr>
-              <a:t>"Beberapa koin seperti Binance/EOS belum rilis di awal 2017 sehingga datanya kosong. Bukankah backward-fill memalsukan harga dan merusak matriks?"</a:t>
+              <a:t>2. Network Markowitz dengan Target Risiko (NW - Risk Grid Search):</a:t>
             </a:r>
             <a:endParaRPr lang="en-US" sz="1800" dirty="0"/>
           </a:p>
           <a:p>
+            <a:pPr marL="342900" indent="-342900">
+              <a:buSzPct val="100000"/>
+              <a:buChar char="•"/>
+            </a:pPr>
+            <a:r>
+              <a:rPr lang="en-US" sz="1800" dirty="0">
+                <a:solidFill>
+                  <a:srgbClr val="333333"/>
+                </a:solidFill>
+              </a:rPr>
+              <a:t>Menekan parameter </a:t>
+            </a:r>
             <a:pPr indent="0" marL="0">
               <a:buNone/>
             </a:pPr>
             <a:r>
               <a:rPr lang="en-US" sz="1800" b="1" dirty="0">
                 <a:solidFill>
-                  <a:srgbClr val="27AE60"/>
-                </a:solidFill>
-              </a:rPr>
-              <a:t>Jawaban (Kenapa RMT sangat Krusial):</a:t>
+                  <a:srgbClr val="333333"/>
+                </a:solidFill>
+              </a:rPr>
+              <a:t>risiko total</a:t>
+            </a:r>
+            <a:pPr indent="0" marL="0">
+              <a:buNone/>
+            </a:pPr>
+            <a:r>
+              <a:rPr lang="en-US" sz="1800" dirty="0">
+                <a:solidFill>
+                  <a:srgbClr val="333333"/>
+                </a:solidFill>
+              </a:rPr>
+              <a:t> hingga minimal.</a:t>
             </a:r>
             <a:endParaRPr lang="en-US" sz="1800" dirty="0"/>
           </a:p>
           <a:p>
-            <a:pPr indent="0" marL="0">
-              <a:buNone/>
+            <a:pPr marL="342900" indent="-342900">
+              <a:buSzPct val="100000"/>
+              <a:buChar char="•"/>
             </a:pPr>
             <a:r>
               <a:rPr lang="en-US" sz="1800" dirty="0">
@@ -15860,18 +16058,18 @@
                   <a:srgbClr val="333333"/>
                 </a:solidFill>
               </a:rPr>
-              <a:t>   1. Praktik pengisian data diam (</a:t>
-            </a:r>
-            <a:pPr indent="0" marL="0">
-              <a:buNone/>
-            </a:pPr>
-            <a:r>
-              <a:rPr lang="en-US" sz="1800" b="1" i="1" dirty="0">
-                <a:solidFill>
-                  <a:srgbClr val="333333"/>
-                </a:solidFill>
-              </a:rPr>
-              <a:t>backward fill</a:t>
+              <a:t>Lebih Defensif untuk meredam fluktuasi saat </a:t>
+            </a:r>
+            <a:pPr indent="0" marL="0">
+              <a:buNone/>
+            </a:pPr>
+            <a:r>
+              <a:rPr lang="en-US" sz="1800" b="1" dirty="0">
+                <a:solidFill>
+                  <a:srgbClr val="333333"/>
+                </a:solidFill>
+              </a:rPr>
+              <a:t>Crypto Winter</a:t>
             </a:r>
             <a:pPr indent="0" marL="0">
               <a:buNone/>
@@ -15882,115 +16080,7 @@
                   <a:srgbClr val="333333"/>
                 </a:solidFill>
               </a:rPr>
-              <a:t>) memang menciptakan rentetan nilai harga yang statis.</a:t>
-            </a:r>
-            <a:endParaRPr lang="en-US" sz="1800" dirty="0"/>
-          </a:p>
-          <a:p>
-            <a:pPr indent="0" marL="0">
-              <a:buNone/>
-            </a:pPr>
-            <a:r>
-              <a:rPr lang="en-US" sz="1800" dirty="0">
-                <a:solidFill>
-                  <a:srgbClr val="333333"/>
-                </a:solidFill>
-              </a:rPr>
-              <a:t>   2. Namun, kehebatan </a:t>
-            </a:r>
-            <a:pPr indent="0" marL="0">
-              <a:buNone/>
-            </a:pPr>
-            <a:r>
-              <a:rPr lang="en-US" sz="1800" b="1" dirty="0">
-                <a:solidFill>
-                  <a:srgbClr val="333333"/>
-                </a:solidFill>
-              </a:rPr>
-              <a:t>Random Matrix Theory (RMT)</a:t>
-            </a:r>
-            <a:pPr indent="0" marL="0">
-              <a:buNone/>
-            </a:pPr>
-            <a:r>
-              <a:rPr lang="en-US" sz="1800" dirty="0">
-                <a:solidFill>
-                  <a:srgbClr val="333333"/>
-                </a:solidFill>
-              </a:rPr>
-              <a:t> diuji di sini! Karena data yang datar sama sekali tidak punya korelasi nyata.</a:t>
-            </a:r>
-            <a:endParaRPr lang="en-US" sz="1800" dirty="0"/>
-          </a:p>
-          <a:p>
-            <a:pPr indent="0" marL="0">
-              <a:buNone/>
-            </a:pPr>
-            <a:r>
-              <a:rPr lang="en-US" sz="1800" dirty="0">
-                <a:solidFill>
-                  <a:srgbClr val="333333"/>
-                </a:solidFill>
-              </a:rPr>
-              <a:t>   3. RMT otomatis akan mendeteksi korelasi buatan tersebut sebagai probabilitas </a:t>
-            </a:r>
-            <a:pPr indent="0" marL="0">
-              <a:buNone/>
-            </a:pPr>
-            <a:r>
-              <a:rPr lang="en-US" sz="1800" b="1" i="1" dirty="0">
-                <a:solidFill>
-                  <a:srgbClr val="333333"/>
-                </a:solidFill>
-              </a:rPr>
-              <a:t>Noise Acak</a:t>
-            </a:r>
-            <a:pPr indent="0" marL="0">
-              <a:buNone/>
-            </a:pPr>
-            <a:r>
-              <a:rPr lang="en-US" sz="1800" dirty="0">
-                <a:solidFill>
-                  <a:srgbClr val="333333"/>
-                </a:solidFill>
-              </a:rPr>
-              <a:t>, lalu membuangnya menjadi 0.</a:t>
-            </a:r>
-            <a:endParaRPr lang="en-US" sz="1800" dirty="0"/>
-          </a:p>
-          <a:p>
-            <a:pPr indent="0" marL="0">
-              <a:buNone/>
-            </a:pPr>
-            <a:r>
-              <a:rPr lang="en-US" sz="1800" dirty="0">
-                <a:solidFill>
-                  <a:srgbClr val="333333"/>
-                </a:solidFill>
-              </a:rPr>
-              <a:t>   4. Hasilnya, matriks korelasi </a:t>
-            </a:r>
-            <a:pPr indent="0" marL="0">
-              <a:buNone/>
-            </a:pPr>
-            <a:r>
-              <a:rPr lang="en-US" sz="1800" b="1" dirty="0">
-                <a:solidFill>
-                  <a:srgbClr val="333333"/>
-                </a:solidFill>
-              </a:rPr>
-              <a:t>terselamatkan</a:t>
-            </a:r>
-            <a:pPr indent="0" marL="0">
-              <a:buNone/>
-            </a:pPr>
-            <a:r>
-              <a:rPr lang="en-US" sz="1800" dirty="0">
-                <a:solidFill>
-                  <a:srgbClr val="333333"/>
-                </a:solidFill>
-              </a:rPr>
-              <a:t> dan tidak tercemar oleh cacat kelengkapan data.</a:t>
+              <a:t>.</a:t>
             </a:r>
             <a:endParaRPr lang="en-US" sz="1800" dirty="0"/>
           </a:p>
@@ -16051,7 +16141,7 @@
                   <a:srgbClr val="003366"/>
                 </a:solidFill>
               </a:rPr>
-              <a:t>Lampiran: Mengapa Menyertakan Tether (USDT)? (1/2)</a:t>
+              <a:t>Lampiran: Penanganan Data Kosong (Missing Values)</a:t>
             </a:r>
             <a:endParaRPr lang="en-US" sz="2600" dirty="0"/>
           </a:p>
@@ -16098,7 +16188,7 @@
                   <a:srgbClr val="333333"/>
                 </a:solidFill>
               </a:rPr>
-              <a:t>"Tether (USDT) itu stablecoin yang nilainya selalu fix ke 1 USD. Apakah tidak berbuat curang?"</a:t>
+              <a:t>"Beberapa koin seperti Binance/EOS belum rilis di awal 2017 sehingga datanya kosong. Bukankah backward-fill memalsukan harga dan merusak matriks?"</a:t>
             </a:r>
             <a:endParaRPr lang="en-US" sz="1800" dirty="0"/>
           </a:p>
@@ -16112,14 +16202,13 @@
                   <a:srgbClr val="27AE60"/>
                 </a:solidFill>
               </a:rPr>
-              <a:t>Jawaban (Dinamika Portofolio Cerdas):</a:t>
+              <a:t>Jawaban (Kenapa RMT sangat Krusial):</a:t>
             </a:r>
             <a:endParaRPr lang="en-US" sz="1800" dirty="0"/>
           </a:p>
           <a:p>
-            <a:pPr marL="342900" indent="-342900">
-              <a:buSzPct val="100000"/>
-              <a:buChar char="•"/>
+            <a:pPr indent="0" marL="0">
+              <a:buNone/>
             </a:pPr>
             <a:r>
               <a:rPr lang="en-US" sz="1800" dirty="0">
@@ -16127,7 +16216,7 @@
                   <a:srgbClr val="333333"/>
                 </a:solidFill>
               </a:rPr>
-              <a:t>Model ini mensimulasikan perilaku </a:t>
+              <a:t>   1. Praktik pengisian data diam (</a:t>
             </a:r>
             <a:pPr indent="0" marL="0">
               <a:buNone/>
@@ -16138,7 +16227,7 @@
                   <a:srgbClr val="333333"/>
                 </a:solidFill>
               </a:rPr>
-              <a:t>Robo-Advisory</a:t>
+              <a:t>backward fill</a:t>
             </a:r>
             <a:pPr indent="0" marL="0">
               <a:buNone/>
@@ -16149,14 +16238,13 @@
                   <a:srgbClr val="333333"/>
                 </a:solidFill>
               </a:rPr>
-              <a:t> institusional.</a:t>
+              <a:t>) memang menciptakan rentetan nilai harga yang statis.</a:t>
             </a:r>
             <a:endParaRPr lang="en-US" sz="1800" dirty="0"/>
           </a:p>
           <a:p>
-            <a:pPr marL="342900" indent="-342900">
-              <a:buSzPct val="100000"/>
-              <a:buChar char="•"/>
+            <a:pPr indent="0" marL="0">
+              <a:buNone/>
             </a:pPr>
             <a:r>
               <a:rPr lang="en-US" sz="1800" dirty="0">
@@ -16164,7 +16252,7 @@
                   <a:srgbClr val="333333"/>
                 </a:solidFill>
               </a:rPr>
-              <a:t>Ketika pasar anjlok ekstrem, investor akan melarikan senjatanya ke posisi </a:t>
+              <a:t>   2. Namun, kehebatan </a:t>
             </a:r>
             <a:pPr indent="0" marL="0">
               <a:buNone/>
@@ -16175,7 +16263,7 @@
                   <a:srgbClr val="333333"/>
                 </a:solidFill>
               </a:rPr>
-              <a:t>tunai (USDT)</a:t>
+              <a:t>Random Matrix Theory (RMT)</a:t>
             </a:r>
             <a:pPr indent="0" marL="0">
               <a:buNone/>
@@ -16186,7 +16274,79 @@
                   <a:srgbClr val="333333"/>
                 </a:solidFill>
               </a:rPr>
-              <a:t> sebagai evakuasi risiko.</a:t>
+              <a:t> diuji di sini! Karena data yang datar sama sekali tidak punya korelasi nyata.</a:t>
+            </a:r>
+            <a:endParaRPr lang="en-US" sz="1800" dirty="0"/>
+          </a:p>
+          <a:p>
+            <a:pPr indent="0" marL="0">
+              <a:buNone/>
+            </a:pPr>
+            <a:r>
+              <a:rPr lang="en-US" sz="1800" dirty="0">
+                <a:solidFill>
+                  <a:srgbClr val="333333"/>
+                </a:solidFill>
+              </a:rPr>
+              <a:t>   3. RMT otomatis akan mendeteksi korelasi buatan tersebut sebagai probabilitas </a:t>
+            </a:r>
+            <a:pPr indent="0" marL="0">
+              <a:buNone/>
+            </a:pPr>
+            <a:r>
+              <a:rPr lang="en-US" sz="1800" b="1" i="1" dirty="0">
+                <a:solidFill>
+                  <a:srgbClr val="333333"/>
+                </a:solidFill>
+              </a:rPr>
+              <a:t>Noise Acak</a:t>
+            </a:r>
+            <a:pPr indent="0" marL="0">
+              <a:buNone/>
+            </a:pPr>
+            <a:r>
+              <a:rPr lang="en-US" sz="1800" dirty="0">
+                <a:solidFill>
+                  <a:srgbClr val="333333"/>
+                </a:solidFill>
+              </a:rPr>
+              <a:t>, lalu membuangnya menjadi 0.</a:t>
+            </a:r>
+            <a:endParaRPr lang="en-US" sz="1800" dirty="0"/>
+          </a:p>
+          <a:p>
+            <a:pPr indent="0" marL="0">
+              <a:buNone/>
+            </a:pPr>
+            <a:r>
+              <a:rPr lang="en-US" sz="1800" dirty="0">
+                <a:solidFill>
+                  <a:srgbClr val="333333"/>
+                </a:solidFill>
+              </a:rPr>
+              <a:t>   4. Hasilnya, matriks korelasi </a:t>
+            </a:r>
+            <a:pPr indent="0" marL="0">
+              <a:buNone/>
+            </a:pPr>
+            <a:r>
+              <a:rPr lang="en-US" sz="1800" b="1" dirty="0">
+                <a:solidFill>
+                  <a:srgbClr val="333333"/>
+                </a:solidFill>
+              </a:rPr>
+              <a:t>terselamatkan</a:t>
+            </a:r>
+            <a:pPr indent="0" marL="0">
+              <a:buNone/>
+            </a:pPr>
+            <a:r>
+              <a:rPr lang="en-US" sz="1800" dirty="0">
+                <a:solidFill>
+                  <a:srgbClr val="333333"/>
+                </a:solidFill>
+              </a:rPr>
+              <a:t> dan tidak tercemar oleh cacat kelengkapan data.</a:t>
             </a:r>
             <a:endParaRPr lang="en-US" sz="1800" dirty="0"/>
           </a:p>
@@ -16247,7 +16407,7 @@
                   <a:srgbClr val="003366"/>
                 </a:solidFill>
               </a:rPr>
-              <a:t>Lampiran: Mengapa Menyertakan Tether (USDT)? (2/2)</a:t>
+              <a:t>Lampiran: Mengapa Menyertakan Tether (USDT)? (1/2)</a:t>
             </a:r>
             <a:endParaRPr lang="en-US" sz="2600" dirty="0"/>
           </a:p>
@@ -16278,12 +16438,89 @@
               <a:buNone/>
             </a:pPr>
             <a:r>
+              <a:rPr lang="en-US" sz="1800" b="1" dirty="0">
+                <a:solidFill>
+                  <a:srgbClr val="C0392B"/>
+                </a:solidFill>
+              </a:rPr>
+              <a:t>Pertanyaan: </a:t>
+            </a:r>
+            <a:pPr indent="0" marL="0">
+              <a:buNone/>
+            </a:pPr>
+            <a:r>
+              <a:rPr lang="en-US" sz="1800" i="1" dirty="0">
+                <a:solidFill>
+                  <a:srgbClr val="333333"/>
+                </a:solidFill>
+              </a:rPr>
+              <a:t>"Tether (USDT) itu stablecoin yang nilainya selalu fix ke 1 USD. Apakah tidak berbuat curang?"</a:t>
+            </a:r>
+            <a:endParaRPr lang="en-US" sz="1800" dirty="0"/>
+          </a:p>
+          <a:p>
+            <a:pPr indent="0" marL="0">
+              <a:buNone/>
+            </a:pPr>
+            <a:r>
+              <a:rPr lang="en-US" sz="1800" b="1" dirty="0">
+                <a:solidFill>
+                  <a:srgbClr val="27AE60"/>
+                </a:solidFill>
+              </a:rPr>
+              <a:t>Jawaban (Dinamika Portofolio Cerdas):</a:t>
+            </a:r>
+            <a:endParaRPr lang="en-US" sz="1800" dirty="0"/>
+          </a:p>
+          <a:p>
+            <a:pPr marL="342900" indent="-342900">
+              <a:buSzPct val="100000"/>
+              <a:buChar char="•"/>
+            </a:pPr>
+            <a:r>
               <a:rPr lang="en-US" sz="1800" dirty="0">
                 <a:solidFill>
                   <a:srgbClr val="333333"/>
                 </a:solidFill>
               </a:rPr>
-              <a:t>3. Algoritma jaringan </a:t>
+              <a:t>Model ini mensimulasikan perilaku </a:t>
+            </a:r>
+            <a:pPr indent="0" marL="0">
+              <a:buNone/>
+            </a:pPr>
+            <a:r>
+              <a:rPr lang="en-US" sz="1800" b="1" i="1" dirty="0">
+                <a:solidFill>
+                  <a:srgbClr val="333333"/>
+                </a:solidFill>
+              </a:rPr>
+              <a:t>Robo-Advisory</a:t>
+            </a:r>
+            <a:pPr indent="0" marL="0">
+              <a:buNone/>
+            </a:pPr>
+            <a:r>
+              <a:rPr lang="en-US" sz="1800" dirty="0">
+                <a:solidFill>
+                  <a:srgbClr val="333333"/>
+                </a:solidFill>
+              </a:rPr>
+              <a:t> institusional.</a:t>
+            </a:r>
+            <a:endParaRPr lang="en-US" sz="1800" dirty="0"/>
+          </a:p>
+          <a:p>
+            <a:pPr marL="342900" indent="-342900">
+              <a:buSzPct val="100000"/>
+              <a:buChar char="•"/>
+            </a:pPr>
+            <a:r>
+              <a:rPr lang="en-US" sz="1800" dirty="0">
+                <a:solidFill>
+                  <a:srgbClr val="333333"/>
+                </a:solidFill>
+              </a:rPr>
+              <a:t>Ketika pasar anjlok ekstrem, investor akan melarikan senjatanya ke posisi </a:t>
             </a:r>
             <a:pPr indent="0" marL="0">
               <a:buNone/>
@@ -16294,7 +16531,7 @@
                   <a:srgbClr val="333333"/>
                 </a:solidFill>
               </a:rPr>
-              <a:t>Network Markowitz GS (Grid Search)</a:t>
+              <a:t>tunai (USDT)</a:t>
             </a:r>
             <a:pPr indent="0" marL="0">
               <a:buNone/>
@@ -16305,87 +16542,7 @@
                   <a:srgbClr val="333333"/>
                 </a:solidFill>
               </a:rPr>
-              <a:t> dilatih secara matematis; jika mendeteksi korelasi ancaman kolaps merambat ke semua altcoin, ia akan melempar alokasi modalnya menuju node </a:t>
-            </a:r>
-            <a:pPr indent="0" marL="0">
-              <a:buNone/>
-            </a:pPr>
-            <a:r>
-              <a:rPr lang="en-US" sz="1800" b="1" dirty="0">
-                <a:solidFill>
-                  <a:srgbClr val="333333"/>
-                </a:solidFill>
-              </a:rPr>
-              <a:t>USDT (Tether)</a:t>
-            </a:r>
-            <a:pPr indent="0" marL="0">
-              <a:buNone/>
-            </a:pPr>
-            <a:r>
-              <a:rPr lang="en-US" sz="1800" dirty="0">
-                <a:solidFill>
-                  <a:srgbClr val="333333"/>
-                </a:solidFill>
-              </a:rPr>
-              <a:t> sebagai langkah </a:t>
-            </a:r>
-            <a:pPr indent="0" marL="0">
-              <a:buNone/>
-            </a:pPr>
-            <a:r>
-              <a:rPr lang="en-US" sz="1800" b="1" dirty="0">
-                <a:solidFill>
-                  <a:srgbClr val="333333"/>
-                </a:solidFill>
-              </a:rPr>
-              <a:t>evakuasi otomatis</a:t>
-            </a:r>
-            <a:pPr indent="0" marL="0">
-              <a:buNone/>
-            </a:pPr>
-            <a:r>
-              <a:rPr lang="en-US" sz="1800" dirty="0">
-                <a:solidFill>
-                  <a:srgbClr val="333333"/>
-                </a:solidFill>
-              </a:rPr>
-              <a:t> (Shock-Absorber).</a:t>
-            </a:r>
-            <a:endParaRPr lang="en-US" sz="1800" dirty="0"/>
-          </a:p>
-          <a:p>
-            <a:pPr indent="0" marL="0">
-              <a:buNone/>
-            </a:pPr>
-            <a:r>
-              <a:rPr lang="en-US" sz="1800" dirty="0">
-                <a:solidFill>
-                  <a:srgbClr val="333333"/>
-                </a:solidFill>
-              </a:rPr>
-              <a:t>   4. Hal ini yang membuat performa Risk-GS (Grid Search) sangat </a:t>
-            </a:r>
-            <a:pPr indent="0" marL="0">
-              <a:buNone/>
-            </a:pPr>
-            <a:r>
-              <a:rPr lang="en-US" sz="1800" b="1" dirty="0">
-                <a:solidFill>
-                  <a:srgbClr val="333333"/>
-                </a:solidFill>
-              </a:rPr>
-              <a:t>tangguh</a:t>
-            </a:r>
-            <a:pPr indent="0" marL="0">
-              <a:buNone/>
-            </a:pPr>
-            <a:r>
-              <a:rPr lang="en-US" sz="1800" dirty="0">
-                <a:solidFill>
-                  <a:srgbClr val="333333"/>
-                </a:solidFill>
-              </a:rPr>
-              <a:t> dari serangan Crypto Winter, suatu kapabilitas pertahanan yang tidak dipahami oleh model ortodoks murni Markowitz.</a:t>
+              <a:t> sebagai evakuasi risiko.</a:t>
             </a:r>
             <a:endParaRPr lang="en-US" sz="1800" dirty="0"/>
           </a:p>
@@ -16446,7 +16603,7 @@
                   <a:srgbClr val="003366"/>
                 </a:solidFill>
               </a:rPr>
-              <a:t>Lampiran: Bukti Empiris Non-Stationarity Pasar</a:t>
+              <a:t>Lampiran: Mengapa Menyertakan Tether (USDT)? (2/2)</a:t>
             </a:r>
             <a:endParaRPr lang="en-US" sz="2600" dirty="0"/>
           </a:p>
@@ -16477,23 +16634,78 @@
               <a:buNone/>
             </a:pPr>
             <a:r>
+              <a:rPr lang="en-US" sz="1800" dirty="0">
+                <a:solidFill>
+                  <a:srgbClr val="333333"/>
+                </a:solidFill>
+              </a:rPr>
+              <a:t>3. Algoritma jaringan </a:t>
+            </a:r>
+            <a:pPr indent="0" marL="0">
+              <a:buNone/>
+            </a:pPr>
+            <a:r>
               <a:rPr lang="en-US" sz="1800" b="1" dirty="0">
                 <a:solidFill>
-                  <a:srgbClr val="C0392B"/>
-                </a:solidFill>
-              </a:rPr>
-              <a:t>Masalah: </a:t>
-            </a:r>
-            <a:pPr indent="0" marL="0">
-              <a:buNone/>
-            </a:pPr>
-            <a:r>
-              <a:rPr lang="en-US" sz="1800" i="1" dirty="0">
-                <a:solidFill>
-                  <a:srgbClr val="333333"/>
-                </a:solidFill>
-              </a:rPr>
-              <a:t>Kenapa harus menggunakan model Adaptif (Dynamic Gamma)?</a:t>
+                  <a:srgbClr val="333333"/>
+                </a:solidFill>
+              </a:rPr>
+              <a:t>Network Markowitz GS (Grid Search)</a:t>
+            </a:r>
+            <a:pPr indent="0" marL="0">
+              <a:buNone/>
+            </a:pPr>
+            <a:r>
+              <a:rPr lang="en-US" sz="1800" dirty="0">
+                <a:solidFill>
+                  <a:srgbClr val="333333"/>
+                </a:solidFill>
+              </a:rPr>
+              <a:t> dilatih secara matematis; jika mendeteksi korelasi ancaman kolaps merambat ke semua altcoin, ia akan melempar alokasi modalnya menuju node </a:t>
+            </a:r>
+            <a:pPr indent="0" marL="0">
+              <a:buNone/>
+            </a:pPr>
+            <a:r>
+              <a:rPr lang="en-US" sz="1800" b="1" dirty="0">
+                <a:solidFill>
+                  <a:srgbClr val="333333"/>
+                </a:solidFill>
+              </a:rPr>
+              <a:t>USDT (Tether)</a:t>
+            </a:r>
+            <a:pPr indent="0" marL="0">
+              <a:buNone/>
+            </a:pPr>
+            <a:r>
+              <a:rPr lang="en-US" sz="1800" dirty="0">
+                <a:solidFill>
+                  <a:srgbClr val="333333"/>
+                </a:solidFill>
+              </a:rPr>
+              <a:t> sebagai langkah </a:t>
+            </a:r>
+            <a:pPr indent="0" marL="0">
+              <a:buNone/>
+            </a:pPr>
+            <a:r>
+              <a:rPr lang="en-US" sz="1800" b="1" dirty="0">
+                <a:solidFill>
+                  <a:srgbClr val="333333"/>
+                </a:solidFill>
+              </a:rPr>
+              <a:t>evakuasi otomatis</a:t>
+            </a:r>
+            <a:pPr indent="0" marL="0">
+              <a:buNone/>
+            </a:pPr>
+            <a:r>
+              <a:rPr lang="en-US" sz="1800" dirty="0">
+                <a:solidFill>
+                  <a:srgbClr val="333333"/>
+                </a:solidFill>
+              </a:rPr>
+              <a:t> (Shock-Absorber).</a:t>
             </a:r>
             <a:endParaRPr lang="en-US" sz="1800" dirty="0"/>
           </a:p>
@@ -16502,19 +16714,26 @@
               <a:buNone/>
             </a:pPr>
             <a:r>
+              <a:rPr lang="en-US" sz="1800" dirty="0">
+                <a:solidFill>
+                  <a:srgbClr val="333333"/>
+                </a:solidFill>
+              </a:rPr>
+              <a:t>   4. Hal ini yang membuat performa Risk-GS (Grid Search) sangat </a:t>
+            </a:r>
+            <a:pPr indent="0" marL="0">
+              <a:buNone/>
+            </a:pPr>
+            <a:r>
               <a:rPr lang="en-US" sz="1800" b="1" dirty="0">
                 <a:solidFill>
-                  <a:srgbClr val="27AE60"/>
-                </a:solidFill>
-              </a:rPr>
-              <a:t>Bukti dari Grid Search:</a:t>
-            </a:r>
-            <a:endParaRPr lang="en-US" sz="1800" dirty="0"/>
-          </a:p>
-          <a:p>
-            <a:pPr marL="342900" indent="-342900">
-              <a:buSzPct val="100000"/>
-              <a:buChar char="•"/>
+                  <a:srgbClr val="333333"/>
+                </a:solidFill>
+              </a:rPr>
+              <a:t>tangguh</a:t>
+            </a:r>
+            <a:pPr indent="0" marL="0">
+              <a:buNone/>
             </a:pPr>
             <a:r>
               <a:rPr lang="en-US" sz="1800" dirty="0">
@@ -16522,103 +16741,7 @@
                   <a:srgbClr val="333333"/>
                 </a:solidFill>
               </a:rPr>
-              <a:t>Data menunjukkan nilai Gamma (γ) optimal </a:t>
-            </a:r>
-            <a:pPr indent="0" marL="0">
-              <a:buNone/>
-            </a:pPr>
-            <a:r>
-              <a:rPr lang="en-US" sz="1800" b="1" dirty="0">
-                <a:solidFill>
-                  <a:srgbClr val="333333"/>
-                </a:solidFill>
-              </a:rPr>
-              <a:t>terus bergeser</a:t>
-            </a:r>
-            <a:pPr indent="0" marL="0">
-              <a:buNone/>
-            </a:pPr>
-            <a:r>
-              <a:rPr lang="en-US" sz="1800" dirty="0">
-                <a:solidFill>
-                  <a:srgbClr val="333333"/>
-                </a:solidFill>
-              </a:rPr>
-              <a:t> setiap periode rebalancing.</a:t>
-            </a:r>
-            <a:endParaRPr lang="en-US" sz="1800" dirty="0"/>
-          </a:p>
-          <a:p>
-            <a:pPr marL="342900" indent="-342900">
-              <a:buSzPct val="100000"/>
-              <a:buChar char="•"/>
-            </a:pPr>
-            <a:r>
-              <a:rPr lang="en-US" sz="1800" dirty="0">
-                <a:solidFill>
-                  <a:srgbClr val="333333"/>
-                </a:solidFill>
-              </a:rPr>
-              <a:t>Penggunaan γ statis tidak cukup untuk menangkap perubahan </a:t>
-            </a:r>
-            <a:pPr indent="0" marL="0">
-              <a:buNone/>
-            </a:pPr>
-            <a:r>
-              <a:rPr lang="en-US" sz="1800" b="1" dirty="0">
-                <a:solidFill>
-                  <a:srgbClr val="333333"/>
-                </a:solidFill>
-              </a:rPr>
-              <a:t>struktur korelasi</a:t>
-            </a:r>
-            <a:pPr indent="0" marL="0">
-              <a:buNone/>
-            </a:pPr>
-            <a:r>
-              <a:rPr lang="en-US" sz="1800" dirty="0">
-                <a:solidFill>
-                  <a:srgbClr val="333333"/>
-                </a:solidFill>
-              </a:rPr>
-              <a:t> yang sangat cepat di pasar kripto.</a:t>
-            </a:r>
-            <a:endParaRPr lang="en-US" sz="1800" dirty="0"/>
-          </a:p>
-          <a:p>
-            <a:pPr marL="342900" indent="-342900">
-              <a:buSzPct val="100000"/>
-              <a:buChar char="•"/>
-            </a:pPr>
-            <a:r>
-              <a:rPr lang="en-US" sz="1800" dirty="0">
-                <a:solidFill>
-                  <a:srgbClr val="333333"/>
-                </a:solidFill>
-              </a:rPr>
-              <a:t>Ini membenarkan bahwa pasar kripto membutuhkan </a:t>
-            </a:r>
-            <a:pPr indent="0" marL="0">
-              <a:buNone/>
-            </a:pPr>
-            <a:r>
-              <a:rPr lang="en-US" sz="1800" b="1" dirty="0">
-                <a:solidFill>
-                  <a:srgbClr val="333333"/>
-                </a:solidFill>
-              </a:rPr>
-              <a:t>kalibrasi otomatis</a:t>
-            </a:r>
-            <a:pPr indent="0" marL="0">
-              <a:buNone/>
-            </a:pPr>
-            <a:r>
-              <a:rPr lang="en-US" sz="1800" dirty="0">
-                <a:solidFill>
-                  <a:srgbClr val="333333"/>
-                </a:solidFill>
-              </a:rPr>
-              <a:t> secara temporal.</a:t>
+              <a:t> dari serangan Crypto Winter, suatu kapabilitas pertahanan yang tidak dipahami oleh model ortodoks murni Markowitz.</a:t>
             </a:r>
             <a:endParaRPr lang="en-US" sz="1800" dirty="0"/>
           </a:p>
@@ -16679,7 +16802,7 @@
                   <a:srgbClr val="003366"/>
                 </a:solidFill>
               </a:rPr>
-              <a:t>Lampiran: Jaringan sebagai 'Shock-Absorber'</a:t>
+              <a:t>Lampiran: Bukti Empiris Non-Stationarity Pasar</a:t>
             </a:r>
             <a:endParaRPr lang="en-US" sz="2600" dirty="0"/>
           </a:p>
@@ -16712,10 +16835,35 @@
             <a:r>
               <a:rPr lang="en-US" sz="1800" b="1" dirty="0">
                 <a:solidFill>
+                  <a:srgbClr val="C0392B"/>
+                </a:solidFill>
+              </a:rPr>
+              <a:t>Masalah: </a:t>
+            </a:r>
+            <a:pPr indent="0" marL="0">
+              <a:buNone/>
+            </a:pPr>
+            <a:r>
+              <a:rPr lang="en-US" sz="1800" i="1" dirty="0">
+                <a:solidFill>
+                  <a:srgbClr val="333333"/>
+                </a:solidFill>
+              </a:rPr>
+              <a:t>Kenapa harus menggunakan model Adaptif (Dynamic Gamma)?</a:t>
+            </a:r>
+            <a:endParaRPr lang="en-US" sz="1800" dirty="0"/>
+          </a:p>
+          <a:p>
+            <a:pPr indent="0" marL="0">
+              <a:buNone/>
+            </a:pPr>
+            <a:r>
+              <a:rPr lang="en-US" sz="1800" b="1" dirty="0">
+                <a:solidFill>
                   <a:srgbClr val="27AE60"/>
                 </a:solidFill>
               </a:rPr>
-              <a:t>Konsep Teoritis:</a:t>
+              <a:t>Bukti dari Grid Search:</a:t>
             </a:r>
             <a:endParaRPr lang="en-US" sz="1800" dirty="0"/>
           </a:p>
@@ -16730,7 +16878,7 @@
                   <a:srgbClr val="333333"/>
                 </a:solidFill>
               </a:rPr>
-              <a:t>Eigenvector Centrality mengidentifikasi koin yang menjadi </a:t>
+              <a:t>Data menunjukkan nilai Gamma (γ) optimal </a:t>
             </a:r>
             <a:pPr indent="0" marL="0">
               <a:buNone/>
@@ -16741,7 +16889,7 @@
                   <a:srgbClr val="333333"/>
                 </a:solidFill>
               </a:rPr>
-              <a:t>hub risiko</a:t>
+              <a:t>terus bergeser</a:t>
             </a:r>
             <a:pPr indent="0" marL="0">
               <a:buNone/>
@@ -16752,7 +16900,7 @@
                   <a:srgbClr val="333333"/>
                 </a:solidFill>
               </a:rPr>
-              <a:t>.</a:t>
+              <a:t> setiap periode rebalancing.</a:t>
             </a:r>
             <a:endParaRPr lang="en-US" sz="1800" dirty="0"/>
           </a:p>
@@ -16767,7 +16915,7 @@
                   <a:srgbClr val="333333"/>
                 </a:solidFill>
               </a:rPr>
-              <a:t>Penalti Gamma memaksa portofolio </a:t>
+              <a:t>Penggunaan γ statis tidak cukup untuk menangkap perubahan </a:t>
             </a:r>
             <a:pPr indent="0" marL="0">
               <a:buNone/>
@@ -16778,7 +16926,7 @@
                   <a:srgbClr val="333333"/>
                 </a:solidFill>
               </a:rPr>
-              <a:t>menjauhi aset</a:t>
+              <a:t>struktur korelasi</a:t>
             </a:r>
             <a:pPr indent="0" marL="0">
               <a:buNone/>
@@ -16789,7 +16937,7 @@
                   <a:srgbClr val="333333"/>
                 </a:solidFill>
               </a:rPr>
-              <a:t> yang terlalu dominan secara sistemik saat volatilitas tinggi.</a:t>
+              <a:t> yang sangat cepat di pasar kripto.</a:t>
             </a:r>
             <a:endParaRPr lang="en-US" sz="1800" dirty="0"/>
           </a:p>
@@ -16804,7 +16952,7 @@
                   <a:srgbClr val="333333"/>
                 </a:solidFill>
               </a:rPr>
-              <a:t>Hasil pada </a:t>
+              <a:t>Ini membenarkan bahwa pasar kripto membutuhkan </a:t>
             </a:r>
             <a:pPr indent="0" marL="0">
               <a:buNone/>
@@ -16815,7 +16963,7 @@
                   <a:srgbClr val="333333"/>
                 </a:solidFill>
               </a:rPr>
-              <a:t>Tabel 5</a:t>
+              <a:t>kalibrasi otomatis</a:t>
             </a:r>
             <a:pPr indent="0" marL="0">
               <a:buNone/>
@@ -16826,44 +16974,7 @@
                   <a:srgbClr val="333333"/>
                 </a:solidFill>
               </a:rPr>
-              <a:t> membuktikan bahwa saat crash, distribusi kerugian ekor model NW (Network Markowitz) jauh lebih terjaga.</a:t>
-            </a:r>
-            <a:endParaRPr lang="en-US" sz="1800" dirty="0"/>
-          </a:p>
-          <a:p>
-            <a:pPr marL="342900" indent="-342900">
-              <a:buSzPct val="100000"/>
-              <a:buChar char="•"/>
-            </a:pPr>
-            <a:r>
-              <a:rPr lang="en-US" sz="1800" dirty="0">
-                <a:solidFill>
-                  <a:srgbClr val="333333"/>
-                </a:solidFill>
-              </a:rPr>
-              <a:t>Kesimpulan: Topologi jaringan memberikan sinyal </a:t>
-            </a:r>
-            <a:pPr indent="0" marL="0">
-              <a:buNone/>
-            </a:pPr>
-            <a:r>
-              <a:rPr lang="en-US" sz="1800" b="1" dirty="0">
-                <a:solidFill>
-                  <a:srgbClr val="333333"/>
-                </a:solidFill>
-              </a:rPr>
-              <a:t>diversifikasi akurat</a:t>
-            </a:r>
-            <a:pPr indent="0" marL="0">
-              <a:buNone/>
-            </a:pPr>
-            <a:r>
-              <a:rPr lang="en-US" sz="1800" dirty="0">
-                <a:solidFill>
-                  <a:srgbClr val="333333"/>
-                </a:solidFill>
-              </a:rPr>
-              <a:t> daripada sekadar variansi harga.</a:t>
+              <a:t> secara temporal.</a:t>
             </a:r>
             <a:endParaRPr lang="en-US" sz="1800" dirty="0"/>
           </a:p>
@@ -17221,6 +17332,251 @@
               <a:t> di fase terbaru.</a:t>
             </a:r>
             <a:endParaRPr lang="en-US" sz="1600" dirty="0"/>
+          </a:p>
+        </p:txBody>
+      </p:sp>
+    </p:spTree>
+  </p:cSld>
+  <p:clrMapOvr>
+    <a:masterClrMapping/>
+  </p:clrMapOvr>
+</p:sld>
+</file>
+
+<file path=ppt/slides/slide50.xml><?xml version="1.0" encoding="utf-8"?>
+<p:sld xmlns:a="http://schemas.openxmlformats.org/drawingml/2006/main" xmlns:r="http://schemas.openxmlformats.org/officeDocument/2006/relationships" xmlns:p="http://schemas.openxmlformats.org/presentationml/2006/main">
+  <p:cSld name="Slide 50">
+    <p:spTree>
+      <p:nvGrpSpPr>
+        <p:cNvPr id="1" name=""/>
+        <p:cNvGrpSpPr/>
+        <p:nvPr/>
+      </p:nvGrpSpPr>
+      <p:grpSpPr>
+        <a:xfrm>
+          <a:off x="0" y="0"/>
+          <a:ext cx="0" cy="0"/>
+          <a:chOff x="0" y="0"/>
+          <a:chExt cx="0" cy="0"/>
+        </a:xfrm>
+      </p:grpSpPr>
+      <p:sp>
+        <p:nvSpPr>
+          <p:cNvPr id="2" name="Text 0"/>
+          <p:cNvSpPr/>
+          <p:nvPr/>
+        </p:nvSpPr>
+        <p:spPr>
+          <a:xfrm>
+            <a:off x="457200" y="457200"/>
+            <a:ext cx="8229600" cy="0"/>
+          </a:xfrm>
+          <a:prstGeom prst="rect">
+            <a:avLst/>
+          </a:prstGeom>
+          <a:noFill/>
+          <a:ln/>
+        </p:spPr>
+        <p:txBody>
+          <a:bodyPr wrap="square" rtlCol="0" anchor="ctr"/>
+          <a:lstStyle/>
+          <a:p>
+            <a:pPr indent="0" marL="0">
+              <a:buNone/>
+            </a:pPr>
+            <a:r>
+              <a:rPr lang="en-US" sz="2600" b="1" dirty="0">
+                <a:solidFill>
+                  <a:srgbClr val="003366"/>
+                </a:solidFill>
+              </a:rPr>
+              <a:t>Lampiran: Jaringan sebagai 'Shock-Absorber'</a:t>
+            </a:r>
+            <a:endParaRPr lang="en-US" sz="2600" dirty="0"/>
+          </a:p>
+        </p:txBody>
+      </p:sp>
+      <p:sp>
+        <p:nvSpPr>
+          <p:cNvPr id="3" name="Text 1"/>
+          <p:cNvSpPr/>
+          <p:nvPr/>
+        </p:nvSpPr>
+        <p:spPr>
+          <a:xfrm>
+            <a:off x="457200" y="1005840"/>
+            <a:ext cx="8229600" cy="5029200"/>
+          </a:xfrm>
+          <a:prstGeom prst="rect">
+            <a:avLst/>
+          </a:prstGeom>
+          <a:noFill/>
+          <a:ln/>
+        </p:spPr>
+        <p:txBody>
+          <a:bodyPr wrap="square" rtlCol="0" anchor="t"/>
+          <a:lstStyle/>
+          <a:p>
+            <a:pPr indent="0" marL="0">
+              <a:buNone/>
+            </a:pPr>
+            <a:r>
+              <a:rPr lang="en-US" sz="1800" b="1" dirty="0">
+                <a:solidFill>
+                  <a:srgbClr val="27AE60"/>
+                </a:solidFill>
+              </a:rPr>
+              <a:t>Konsep Teoritis:</a:t>
+            </a:r>
+            <a:endParaRPr lang="en-US" sz="1800" dirty="0"/>
+          </a:p>
+          <a:p>
+            <a:pPr marL="342900" indent="-342900">
+              <a:buSzPct val="100000"/>
+              <a:buChar char="•"/>
+            </a:pPr>
+            <a:r>
+              <a:rPr lang="en-US" sz="1800" dirty="0">
+                <a:solidFill>
+                  <a:srgbClr val="333333"/>
+                </a:solidFill>
+              </a:rPr>
+              <a:t>Eigenvector Centrality mengidentifikasi koin yang menjadi </a:t>
+            </a:r>
+            <a:pPr indent="0" marL="0">
+              <a:buNone/>
+            </a:pPr>
+            <a:r>
+              <a:rPr lang="en-US" sz="1800" b="1" dirty="0">
+                <a:solidFill>
+                  <a:srgbClr val="333333"/>
+                </a:solidFill>
+              </a:rPr>
+              <a:t>hub risiko</a:t>
+            </a:r>
+            <a:pPr indent="0" marL="0">
+              <a:buNone/>
+            </a:pPr>
+            <a:r>
+              <a:rPr lang="en-US" sz="1800" dirty="0">
+                <a:solidFill>
+                  <a:srgbClr val="333333"/>
+                </a:solidFill>
+              </a:rPr>
+              <a:t>.</a:t>
+            </a:r>
+            <a:endParaRPr lang="en-US" sz="1800" dirty="0"/>
+          </a:p>
+          <a:p>
+            <a:pPr marL="342900" indent="-342900">
+              <a:buSzPct val="100000"/>
+              <a:buChar char="•"/>
+            </a:pPr>
+            <a:r>
+              <a:rPr lang="en-US" sz="1800" dirty="0">
+                <a:solidFill>
+                  <a:srgbClr val="333333"/>
+                </a:solidFill>
+              </a:rPr>
+              <a:t>Penalti Gamma memaksa portofolio </a:t>
+            </a:r>
+            <a:pPr indent="0" marL="0">
+              <a:buNone/>
+            </a:pPr>
+            <a:r>
+              <a:rPr lang="en-US" sz="1800" b="1" dirty="0">
+                <a:solidFill>
+                  <a:srgbClr val="333333"/>
+                </a:solidFill>
+              </a:rPr>
+              <a:t>menjauhi aset</a:t>
+            </a:r>
+            <a:pPr indent="0" marL="0">
+              <a:buNone/>
+            </a:pPr>
+            <a:r>
+              <a:rPr lang="en-US" sz="1800" dirty="0">
+                <a:solidFill>
+                  <a:srgbClr val="333333"/>
+                </a:solidFill>
+              </a:rPr>
+              <a:t> yang terlalu dominan secara sistemik saat volatilitas tinggi.</a:t>
+            </a:r>
+            <a:endParaRPr lang="en-US" sz="1800" dirty="0"/>
+          </a:p>
+          <a:p>
+            <a:pPr marL="342900" indent="-342900">
+              <a:buSzPct val="100000"/>
+              <a:buChar char="•"/>
+            </a:pPr>
+            <a:r>
+              <a:rPr lang="en-US" sz="1800" dirty="0">
+                <a:solidFill>
+                  <a:srgbClr val="333333"/>
+                </a:solidFill>
+              </a:rPr>
+              <a:t>Hasil pada </a:t>
+            </a:r>
+            <a:pPr indent="0" marL="0">
+              <a:buNone/>
+            </a:pPr>
+            <a:r>
+              <a:rPr lang="en-US" sz="1800" b="1" dirty="0">
+                <a:solidFill>
+                  <a:srgbClr val="333333"/>
+                </a:solidFill>
+              </a:rPr>
+              <a:t>Tabel 5</a:t>
+            </a:r>
+            <a:pPr indent="0" marL="0">
+              <a:buNone/>
+            </a:pPr>
+            <a:r>
+              <a:rPr lang="en-US" sz="1800" dirty="0">
+                <a:solidFill>
+                  <a:srgbClr val="333333"/>
+                </a:solidFill>
+              </a:rPr>
+              <a:t> membuktikan bahwa saat crash, distribusi kerugian ekor model NW (Network Markowitz) jauh lebih terjaga.</a:t>
+            </a:r>
+            <a:endParaRPr lang="en-US" sz="1800" dirty="0"/>
+          </a:p>
+          <a:p>
+            <a:pPr marL="342900" indent="-342900">
+              <a:buSzPct val="100000"/>
+              <a:buChar char="•"/>
+            </a:pPr>
+            <a:r>
+              <a:rPr lang="en-US" sz="1800" dirty="0">
+                <a:solidFill>
+                  <a:srgbClr val="333333"/>
+                </a:solidFill>
+              </a:rPr>
+              <a:t>Kesimpulan: Topologi jaringan memberikan sinyal </a:t>
+            </a:r>
+            <a:pPr indent="0" marL="0">
+              <a:buNone/>
+            </a:pPr>
+            <a:r>
+              <a:rPr lang="en-US" sz="1800" b="1" dirty="0">
+                <a:solidFill>
+                  <a:srgbClr val="333333"/>
+                </a:solidFill>
+              </a:rPr>
+              <a:t>diversifikasi akurat</a:t>
+            </a:r>
+            <a:pPr indent="0" marL="0">
+              <a:buNone/>
+            </a:pPr>
+            <a:r>
+              <a:rPr lang="en-US" sz="1800" dirty="0">
+                <a:solidFill>
+                  <a:srgbClr val="333333"/>
+                </a:solidFill>
+              </a:rPr>
+              <a:t> daripada sekadar variansi harga.</a:t>
+            </a:r>
+            <a:endParaRPr lang="en-US" sz="1800" dirty="0"/>
           </a:p>
         </p:txBody>
       </p:sp>

</xml_diff>

<commit_message>
feat: add Degree Centrality calculation example slide
</commit_message>
<xml_diff>
--- a/Presentasi_Proposal_Update.pptx
+++ b/Presentasi_Proposal_Update.pptx
@@ -55,9 +55,10 @@
     <p:sldId id="303" r:id="rId49"/>
     <p:sldId id="304" r:id="rId50"/>
     <p:sldId id="305" r:id="rId51"/>
+    <p:sldId id="306" r:id="rId52"/>
   </p:sldIdLst>
   <p:notesMasterIdLst>
-    <p:notesMasterId r:id="rId52"/>
+    <p:notesMasterId r:id="rId53"/>
   </p:notesMasterIdLst>
   <p:sldSz cx="9144000" cy="5143500"/>
   <p:notesSz cx="5143500" cy="9144000"/>
@@ -4535,6 +4536,94 @@
             <a:fld id="{F7021451-1387-4CA6-816F-3879F97B5CBC}" type="slidenum">
               <a:rPr lang="en-US"/>
               <a:t>50</a:t>
+            </a:fld>
+            <a:endParaRPr lang="en-US"/>
+          </a:p>
+        </p:txBody>
+      </p:sp>
+    </p:spTree>
+    <p:extLst>
+      <p:ext uri="{BB962C8B-B14F-4D97-AF65-F5344CB8AC3E}">
+        <p14:creationId xmlns:p14="http://schemas.microsoft.com/office/powerpoint/2010/main" val="1024086991"/>
+      </p:ext>
+    </p:extLst>
+  </p:cSld>
+  <p:clrMapOvr>
+    <a:masterClrMapping/>
+  </p:clrMapOvr>
+</p:notes>
+</file>
+
+<file path=ppt/notesSlides/notesSlide51.xml><?xml version="1.0" encoding="utf-8"?>
+<p:notes xmlns:a="http://schemas.openxmlformats.org/drawingml/2006/main" xmlns:r="http://schemas.openxmlformats.org/officeDocument/2006/relationships" xmlns:p="http://schemas.openxmlformats.org/presentationml/2006/main">
+  <p:cSld>
+    <p:spTree>
+      <p:nvGrpSpPr>
+        <p:cNvPr id="1" name=""/>
+        <p:cNvGrpSpPr/>
+        <p:nvPr/>
+      </p:nvGrpSpPr>
+      <p:grpSpPr>
+        <a:xfrm>
+          <a:off x="0" y="0"/>
+          <a:ext cx="0" cy="0"/>
+          <a:chOff x="0" y="0"/>
+          <a:chExt cx="0" cy="0"/>
+        </a:xfrm>
+      </p:grpSpPr>
+      <p:sp>
+        <p:nvSpPr>
+          <p:cNvPr id="2" name="Slide Image Placeholder 1"/>
+          <p:cNvSpPr>
+            <a:spLocks noGrp="1" noRot="1" noChangeAspect="1"/>
+          </p:cNvSpPr>
+          <p:nvPr>
+            <p:ph type="sldImg"/>
+          </p:nvPr>
+        </p:nvSpPr>
+        <p:spPr/>
+      </p:sp>
+      <p:sp>
+        <p:nvSpPr>
+          <p:cNvPr id="3" name="Notes Placeholder 2"/>
+          <p:cNvSpPr>
+            <a:spLocks noGrp="1"/>
+          </p:cNvSpPr>
+          <p:nvPr>
+            <p:ph type="body" idx="1"/>
+          </p:nvPr>
+        </p:nvSpPr>
+        <p:spPr/>
+        <p:txBody>
+          <a:bodyPr/>
+          <a:lstStyle/>
+          <a:p>
+            <a:r>
+              <a:rPr lang="en-US" dirty="0"/>
+              <a:t/>
+            </a:r>
+            <a:endParaRPr lang="en-US" dirty="0"/>
+          </a:p>
+        </p:txBody>
+      </p:sp>
+      <p:sp>
+        <p:nvSpPr>
+          <p:cNvPr id="4" name="Slide Number Placeholder 3"/>
+          <p:cNvSpPr>
+            <a:spLocks noGrp="1"/>
+          </p:cNvSpPr>
+          <p:nvPr>
+            <p:ph type="sldNum" sz="quarter" idx="10"/>
+          </p:nvPr>
+        </p:nvSpPr>
+        <p:spPr/>
+        <p:txBody>
+          <a:bodyPr/>
+          <a:lstStyle/>
+          <a:p>
+            <a:fld id="{F7021451-1387-4CA6-816F-3879F97B5CBC}" type="slidenum">
+              <a:rPr lang="en-US"/>
+              <a:t>51</a:t>
             </a:fld>
             <a:endParaRPr lang="en-US"/>
           </a:p>
@@ -15863,14 +15952,14 @@
               <a:buNone/>
             </a:pPr>
             <a:r>
-              <a:rPr lang="en-US" sz="2600" b="1" dirty="0">
+              <a:rPr lang="en-US" sz="2400" b="1" dirty="0">
                 <a:solidFill>
                   <a:srgbClr val="003366"/>
                 </a:solidFill>
               </a:rPr>
-              <a:t>Lampiran: Dua Tipe Pendekatan Grid Search</a:t>
-            </a:r>
-            <a:endParaRPr lang="en-US" sz="2600" dirty="0"/>
+              <a:t>Lampiran: Cara Menghitung Centrality (Degree Centrality)</a:t>
+            </a:r>
+            <a:endParaRPr lang="en-US" sz="2400" dirty="0"/>
           </a:p>
         </p:txBody>
       </p:sp>
@@ -15899,190 +15988,204 @@
               <a:buNone/>
             </a:pPr>
             <a:r>
-              <a:rPr lang="en-US" sz="1800" b="1" dirty="0">
-                <a:solidFill>
-                  <a:srgbClr val="333333"/>
-                </a:solidFill>
-              </a:rPr>
-              <a:t>Dua Objektif Optimasi (Return vs Risk):</a:t>
-            </a:r>
-            <a:endParaRPr lang="en-US" sz="1800" dirty="0"/>
-          </a:p>
-          <a:p>
-            <a:pPr indent="0" marL="0">
-              <a:buNone/>
-            </a:pPr>
-            <a:r>
-              <a:rPr lang="en-US" sz="1800" b="1" dirty="0">
+              <a:rPr lang="en-US" sz="1600" b="1" dirty="0">
+                <a:solidFill>
+                  <a:srgbClr val="333333"/>
+                </a:solidFill>
+              </a:rPr>
+              <a:t>Metode Degree Centrality mengukur seberapa banyak 'tangan' yang dimiliki sebuah aset untuk memegang aset lain.</a:t>
+            </a:r>
+            <a:endParaRPr lang="en-US" sz="1600" dirty="0"/>
+          </a:p>
+          <a:p>
+            <a:pPr indent="0" marL="0">
+              <a:buNone/>
+            </a:pPr>
+            <a:r>
+              <a:rPr lang="en-US" sz="1600" b="1" dirty="0">
+                <a:solidFill>
+                  <a:srgbClr val="C0392B"/>
+                </a:solidFill>
+                <a:latin typeface="Courier New" pitchFamily="34" charset="0"/>
+                <a:ea typeface="Courier New" pitchFamily="34" charset="-122"/>
+                <a:cs typeface="Courier New" pitchFamily="34" charset="-120"/>
+              </a:rPr>
+              <a:t>Rumus: Centrality = Jumlah Koneksi / (N - 1)</a:t>
+            </a:r>
+            <a:endParaRPr lang="en-US" sz="1600" dirty="0"/>
+          </a:p>
+          <a:p>
+            <a:pPr indent="0" marL="0">
+              <a:buNone/>
+            </a:pPr>
+            <a:r>
+              <a:rPr lang="en-US" sz="1600" b="1" dirty="0">
+                <a:solidFill>
+                  <a:srgbClr val="003366"/>
+                </a:solidFill>
+              </a:rPr>
+              <a:t>Simulasi untuk 5 Aset (BTC, ETH, XRP, LTC, USDT):</a:t>
+            </a:r>
+            <a:endParaRPr lang="en-US" sz="1600" dirty="0"/>
+          </a:p>
+          <a:p>
+            <a:pPr indent="0" marL="0">
+              <a:buNone/>
+            </a:pPr>
+            <a:r>
+              <a:rPr lang="en-US" sz="1600" dirty="0">
+                <a:solidFill>
+                  <a:srgbClr val="333333"/>
+                </a:solidFill>
+              </a:rPr>
+              <a:t>   • Aset Utama (N) = 5. Pembagi (N-1) = 4.</a:t>
+            </a:r>
+            <a:endParaRPr lang="en-US" sz="1600" dirty="0"/>
+          </a:p>
+          <a:p>
+            <a:pPr indent="0" marL="0">
+              <a:buNone/>
+            </a:pPr>
+            <a:r>
+              <a:rPr lang="en-US" sz="1600" dirty="0">
+                <a:solidFill>
+                  <a:srgbClr val="333333"/>
+                </a:solidFill>
+              </a:rPr>
+              <a:t>1. Aset BTC (Terkoneksi ke ETH, XRP, LTC):</a:t>
+            </a:r>
+            <a:endParaRPr lang="en-US" sz="1600" dirty="0"/>
+          </a:p>
+          <a:p>
+            <a:pPr indent="0" marL="0">
+              <a:buNone/>
+            </a:pPr>
+            <a:r>
+              <a:rPr lang="en-US" sz="1600" dirty="0">
+                <a:solidFill>
+                  <a:srgbClr val="333333"/>
+                </a:solidFill>
+              </a:rPr>
+              <a:t>   3 Koneksi / 4 = </a:t>
+            </a:r>
+            <a:pPr indent="0" marL="0">
+              <a:buNone/>
+            </a:pPr>
+            <a:r>
+              <a:rPr lang="en-US" sz="1600" b="1" dirty="0">
+                <a:solidFill>
+                  <a:srgbClr val="C0392B"/>
+                </a:solidFill>
+              </a:rPr>
+              <a:t>0.75 (Centrality Tinggi)</a:t>
+            </a:r>
+            <a:endParaRPr lang="en-US" sz="1600" dirty="0"/>
+          </a:p>
+          <a:p>
+            <a:pPr indent="0" marL="0">
+              <a:buNone/>
+            </a:pPr>
+            <a:r>
+              <a:rPr lang="en-US" sz="1600" dirty="0">
+                <a:solidFill>
+                  <a:srgbClr val="333333"/>
+                </a:solidFill>
+              </a:rPr>
+              <a:t>2. Aset LTC (Terkoneksi ke BTC &amp; USDT):</a:t>
+            </a:r>
+            <a:endParaRPr lang="en-US" sz="1600" dirty="0"/>
+          </a:p>
+          <a:p>
+            <a:pPr indent="0" marL="0">
+              <a:buNone/>
+            </a:pPr>
+            <a:r>
+              <a:rPr lang="en-US" sz="1600" dirty="0">
+                <a:solidFill>
+                  <a:srgbClr val="333333"/>
+                </a:solidFill>
+              </a:rPr>
+              <a:t>   2 Koneksi / 4 = </a:t>
+            </a:r>
+            <a:pPr indent="0" marL="0">
+              <a:buNone/>
+            </a:pPr>
+            <a:r>
+              <a:rPr lang="en-US" sz="1600" b="1" dirty="0">
+                <a:solidFill>
+                  <a:srgbClr val="F39C12"/>
+                </a:solidFill>
+              </a:rPr>
+              <a:t>0.50 (Centrality Sedang)</a:t>
+            </a:r>
+            <a:endParaRPr lang="en-US" sz="1600" dirty="0"/>
+          </a:p>
+          <a:p>
+            <a:pPr indent="0" marL="0">
+              <a:buNone/>
+            </a:pPr>
+            <a:r>
+              <a:rPr lang="en-US" sz="1600" dirty="0">
+                <a:solidFill>
+                  <a:srgbClr val="333333"/>
+                </a:solidFill>
+              </a:rPr>
+              <a:t>3. Aset ETH, XRP, USDT (Hanya 1 Koneksi):</a:t>
+            </a:r>
+            <a:endParaRPr lang="en-US" sz="1600" dirty="0"/>
+          </a:p>
+          <a:p>
+            <a:pPr indent="0" marL="0">
+              <a:buNone/>
+            </a:pPr>
+            <a:r>
+              <a:rPr lang="en-US" sz="1600" dirty="0">
+                <a:solidFill>
+                  <a:srgbClr val="333333"/>
+                </a:solidFill>
+              </a:rPr>
+              <a:t>   1 Koneksi / 4 = </a:t>
+            </a:r>
+            <a:pPr indent="0" marL="0">
+              <a:buNone/>
+            </a:pPr>
+            <a:r>
+              <a:rPr lang="en-US" sz="1600" b="1" dirty="0">
                 <a:solidFill>
                   <a:srgbClr val="27AE60"/>
                 </a:solidFill>
               </a:rPr>
-              <a:t>1. Network Markowitz dengan Target Return (NW - Return Grid Search):</a:t>
-            </a:r>
-            <a:endParaRPr lang="en-US" sz="1800" dirty="0"/>
-          </a:p>
-          <a:p>
-            <a:pPr marL="342900" indent="-342900">
-              <a:buSzPct val="100000"/>
-              <a:buChar char="•"/>
-            </a:pPr>
-            <a:r>
-              <a:rPr lang="en-US" sz="1800" dirty="0">
-                <a:solidFill>
-                  <a:srgbClr val="333333"/>
-                </a:solidFill>
-              </a:rPr>
-              <a:t>Memaksimalkan capaian </a:t>
-            </a:r>
-            <a:pPr indent="0" marL="0">
-              <a:buNone/>
-            </a:pPr>
-            <a:r>
-              <a:rPr lang="en-US" sz="1800" b="1" dirty="0">
-                <a:solidFill>
-                  <a:srgbClr val="333333"/>
-                </a:solidFill>
-              </a:rPr>
-              <a:t>imbal hasil</a:t>
-            </a:r>
-            <a:pPr indent="0" marL="0">
-              <a:buNone/>
-            </a:pPr>
-            <a:r>
-              <a:rPr lang="en-US" sz="1800" dirty="0">
-                <a:solidFill>
-                  <a:srgbClr val="333333"/>
-                </a:solidFill>
-              </a:rPr>
-              <a:t> portofolio.</a:t>
-            </a:r>
-            <a:endParaRPr lang="en-US" sz="1800" dirty="0"/>
-          </a:p>
-          <a:p>
-            <a:pPr marL="342900" indent="-342900">
-              <a:buSzPct val="100000"/>
-              <a:buChar char="•"/>
-            </a:pPr>
-            <a:r>
-              <a:rPr lang="en-US" sz="1800" dirty="0">
-                <a:solidFill>
-                  <a:srgbClr val="333333"/>
-                </a:solidFill>
-              </a:rPr>
-              <a:t>Lebih Agresif untuk mengeksploitasi reli pada pasar </a:t>
-            </a:r>
-            <a:pPr indent="0" marL="0">
-              <a:buNone/>
-            </a:pPr>
-            <a:r>
-              <a:rPr lang="en-US" sz="1800" b="1" dirty="0">
-                <a:solidFill>
-                  <a:srgbClr val="333333"/>
-                </a:solidFill>
-              </a:rPr>
-              <a:t>Bullish</a:t>
-            </a:r>
-            <a:pPr indent="0" marL="0">
-              <a:buNone/>
-            </a:pPr>
-            <a:r>
-              <a:rPr lang="en-US" sz="1800" dirty="0">
-                <a:solidFill>
-                  <a:srgbClr val="333333"/>
-                </a:solidFill>
-              </a:rPr>
-              <a:t>.</a:t>
-            </a:r>
-            <a:endParaRPr lang="en-US" sz="1800" dirty="0"/>
-          </a:p>
-          <a:p>
-            <a:pPr indent="0" marL="0">
-              <a:buNone/>
-            </a:pPr>
-            <a:r>
-              <a:rPr lang="en-US" sz="1800" b="1" dirty="0">
-                <a:solidFill>
-                  <a:srgbClr val="C0392B"/>
-                </a:solidFill>
-              </a:rPr>
-              <a:t>2. Network Markowitz dengan Target Risiko (NW - Risk Grid Search):</a:t>
-            </a:r>
-            <a:endParaRPr lang="en-US" sz="1800" dirty="0"/>
-          </a:p>
-          <a:p>
-            <a:pPr marL="342900" indent="-342900">
-              <a:buSzPct val="100000"/>
-              <a:buChar char="•"/>
-            </a:pPr>
-            <a:r>
-              <a:rPr lang="en-US" sz="1800" dirty="0">
-                <a:solidFill>
-                  <a:srgbClr val="333333"/>
-                </a:solidFill>
-              </a:rPr>
-              <a:t>Menekan parameter </a:t>
-            </a:r>
-            <a:pPr indent="0" marL="0">
-              <a:buNone/>
-            </a:pPr>
-            <a:r>
-              <a:rPr lang="en-US" sz="1800" b="1" dirty="0">
-                <a:solidFill>
-                  <a:srgbClr val="333333"/>
-                </a:solidFill>
-              </a:rPr>
-              <a:t>risiko total</a:t>
-            </a:r>
-            <a:pPr indent="0" marL="0">
-              <a:buNone/>
-            </a:pPr>
-            <a:r>
-              <a:rPr lang="en-US" sz="1800" dirty="0">
-                <a:solidFill>
-                  <a:srgbClr val="333333"/>
-                </a:solidFill>
-              </a:rPr>
-              <a:t> hingga minimal.</a:t>
-            </a:r>
-            <a:endParaRPr lang="en-US" sz="1800" dirty="0"/>
-          </a:p>
-          <a:p>
-            <a:pPr marL="342900" indent="-342900">
-              <a:buSzPct val="100000"/>
-              <a:buChar char="•"/>
-            </a:pPr>
-            <a:r>
-              <a:rPr lang="en-US" sz="1800" dirty="0">
-                <a:solidFill>
-                  <a:srgbClr val="333333"/>
-                </a:solidFill>
-              </a:rPr>
-              <a:t>Lebih Defensif untuk meredam fluktuasi saat </a:t>
-            </a:r>
-            <a:pPr indent="0" marL="0">
-              <a:buNone/>
-            </a:pPr>
-            <a:r>
-              <a:rPr lang="en-US" sz="1800" b="1" dirty="0">
-                <a:solidFill>
-                  <a:srgbClr val="333333"/>
-                </a:solidFill>
-              </a:rPr>
-              <a:t>Crypto Winter</a:t>
-            </a:r>
-            <a:pPr indent="0" marL="0">
-              <a:buNone/>
-            </a:pPr>
-            <a:r>
-              <a:rPr lang="en-US" sz="1800" dirty="0">
-                <a:solidFill>
-                  <a:srgbClr val="333333"/>
-                </a:solidFill>
-              </a:rPr>
-              <a:t>.</a:t>
-            </a:r>
-            <a:endParaRPr lang="en-US" sz="1800" dirty="0"/>
+              <a:t>0.25 (Centrality Rendah)</a:t>
+            </a:r>
+            <a:endParaRPr lang="en-US" sz="1600" dirty="0"/>
+          </a:p>
+          <a:p>
+            <a:pPr indent="0" marL="0">
+              <a:buNone/>
+            </a:pPr>
+            <a:r>
+              <a:rPr lang="en-US" sz="1600" b="1" dirty="0">
+                <a:solidFill>
+                  <a:srgbClr val="8E44AD"/>
+                </a:solidFill>
+              </a:rPr>
+              <a:t>Dampak Penalti NW:</a:t>
+            </a:r>
+            <a:endParaRPr lang="en-US" sz="1600" dirty="0"/>
+          </a:p>
+          <a:p>
+            <a:pPr indent="0" marL="0">
+              <a:buNone/>
+            </a:pPr>
+            <a:r>
+              <a:rPr lang="en-US" sz="1600" i="1" dirty="0">
+                <a:solidFill>
+                  <a:srgbClr val="333333"/>
+                </a:solidFill>
+              </a:rPr>
+              <a:t>Karena BTC memiliki skor 0.75, ia akan menerima penalti 3x lebih besar daripada ETH (0.25). Ini menjaga portofolio tetap terdiversifikasi dari pusat jaringan.</a:t>
+            </a:r>
+            <a:endParaRPr lang="en-US" sz="1600" dirty="0"/>
           </a:p>
         </p:txBody>
       </p:sp>
@@ -16141,7 +16244,7 @@
                   <a:srgbClr val="003366"/>
                 </a:solidFill>
               </a:rPr>
-              <a:t>Lampiran: Penanganan Data Kosong (Missing Values)</a:t>
+              <a:t>Lampiran: Dua Tipe Pendekatan Grid Search</a:t>
             </a:r>
             <a:endParaRPr lang="en-US" sz="2600" dirty="0"/>
           </a:p>
@@ -16174,41 +16277,156 @@
             <a:r>
               <a:rPr lang="en-US" sz="1800" b="1" dirty="0">
                 <a:solidFill>
+                  <a:srgbClr val="333333"/>
+                </a:solidFill>
+              </a:rPr>
+              <a:t>Dua Objektif Optimasi (Return vs Risk):</a:t>
+            </a:r>
+            <a:endParaRPr lang="en-US" sz="1800" dirty="0"/>
+          </a:p>
+          <a:p>
+            <a:pPr indent="0" marL="0">
+              <a:buNone/>
+            </a:pPr>
+            <a:r>
+              <a:rPr lang="en-US" sz="1800" b="1" dirty="0">
+                <a:solidFill>
+                  <a:srgbClr val="27AE60"/>
+                </a:solidFill>
+              </a:rPr>
+              <a:t>1. Network Markowitz dengan Target Return (NW - Return Grid Search):</a:t>
+            </a:r>
+            <a:endParaRPr lang="en-US" sz="1800" dirty="0"/>
+          </a:p>
+          <a:p>
+            <a:pPr marL="342900" indent="-342900">
+              <a:buSzPct val="100000"/>
+              <a:buChar char="•"/>
+            </a:pPr>
+            <a:r>
+              <a:rPr lang="en-US" sz="1800" dirty="0">
+                <a:solidFill>
+                  <a:srgbClr val="333333"/>
+                </a:solidFill>
+              </a:rPr>
+              <a:t>Memaksimalkan capaian </a:t>
+            </a:r>
+            <a:pPr indent="0" marL="0">
+              <a:buNone/>
+            </a:pPr>
+            <a:r>
+              <a:rPr lang="en-US" sz="1800" b="1" dirty="0">
+                <a:solidFill>
+                  <a:srgbClr val="333333"/>
+                </a:solidFill>
+              </a:rPr>
+              <a:t>imbal hasil</a:t>
+            </a:r>
+            <a:pPr indent="0" marL="0">
+              <a:buNone/>
+            </a:pPr>
+            <a:r>
+              <a:rPr lang="en-US" sz="1800" dirty="0">
+                <a:solidFill>
+                  <a:srgbClr val="333333"/>
+                </a:solidFill>
+              </a:rPr>
+              <a:t> portofolio.</a:t>
+            </a:r>
+            <a:endParaRPr lang="en-US" sz="1800" dirty="0"/>
+          </a:p>
+          <a:p>
+            <a:pPr marL="342900" indent="-342900">
+              <a:buSzPct val="100000"/>
+              <a:buChar char="•"/>
+            </a:pPr>
+            <a:r>
+              <a:rPr lang="en-US" sz="1800" dirty="0">
+                <a:solidFill>
+                  <a:srgbClr val="333333"/>
+                </a:solidFill>
+              </a:rPr>
+              <a:t>Lebih Agresif untuk mengeksploitasi reli pada pasar </a:t>
+            </a:r>
+            <a:pPr indent="0" marL="0">
+              <a:buNone/>
+            </a:pPr>
+            <a:r>
+              <a:rPr lang="en-US" sz="1800" b="1" dirty="0">
+                <a:solidFill>
+                  <a:srgbClr val="333333"/>
+                </a:solidFill>
+              </a:rPr>
+              <a:t>Bullish</a:t>
+            </a:r>
+            <a:pPr indent="0" marL="0">
+              <a:buNone/>
+            </a:pPr>
+            <a:r>
+              <a:rPr lang="en-US" sz="1800" dirty="0">
+                <a:solidFill>
+                  <a:srgbClr val="333333"/>
+                </a:solidFill>
+              </a:rPr>
+              <a:t>.</a:t>
+            </a:r>
+            <a:endParaRPr lang="en-US" sz="1800" dirty="0"/>
+          </a:p>
+          <a:p>
+            <a:pPr indent="0" marL="0">
+              <a:buNone/>
+            </a:pPr>
+            <a:r>
+              <a:rPr lang="en-US" sz="1800" b="1" dirty="0">
+                <a:solidFill>
                   <a:srgbClr val="C0392B"/>
                 </a:solidFill>
               </a:rPr>
-              <a:t>Pertanyaan: </a:t>
-            </a:r>
-            <a:pPr indent="0" marL="0">
-              <a:buNone/>
-            </a:pPr>
-            <a:r>
-              <a:rPr lang="en-US" sz="1800" i="1" dirty="0">
-                <a:solidFill>
-                  <a:srgbClr val="333333"/>
-                </a:solidFill>
-              </a:rPr>
-              <a:t>"Beberapa koin seperti Binance/EOS belum rilis di awal 2017 sehingga datanya kosong. Bukankah backward-fill memalsukan harga dan merusak matriks?"</a:t>
+              <a:t>2. Network Markowitz dengan Target Risiko (NW - Risk Grid Search):</a:t>
             </a:r>
             <a:endParaRPr lang="en-US" sz="1800" dirty="0"/>
           </a:p>
           <a:p>
+            <a:pPr marL="342900" indent="-342900">
+              <a:buSzPct val="100000"/>
+              <a:buChar char="•"/>
+            </a:pPr>
+            <a:r>
+              <a:rPr lang="en-US" sz="1800" dirty="0">
+                <a:solidFill>
+                  <a:srgbClr val="333333"/>
+                </a:solidFill>
+              </a:rPr>
+              <a:t>Menekan parameter </a:t>
+            </a:r>
             <a:pPr indent="0" marL="0">
               <a:buNone/>
             </a:pPr>
             <a:r>
               <a:rPr lang="en-US" sz="1800" b="1" dirty="0">
                 <a:solidFill>
-                  <a:srgbClr val="27AE60"/>
-                </a:solidFill>
-              </a:rPr>
-              <a:t>Jawaban (Kenapa RMT sangat Krusial):</a:t>
+                  <a:srgbClr val="333333"/>
+                </a:solidFill>
+              </a:rPr>
+              <a:t>risiko total</a:t>
+            </a:r>
+            <a:pPr indent="0" marL="0">
+              <a:buNone/>
+            </a:pPr>
+            <a:r>
+              <a:rPr lang="en-US" sz="1800" dirty="0">
+                <a:solidFill>
+                  <a:srgbClr val="333333"/>
+                </a:solidFill>
+              </a:rPr>
+              <a:t> hingga minimal.</a:t>
             </a:r>
             <a:endParaRPr lang="en-US" sz="1800" dirty="0"/>
           </a:p>
           <a:p>
-            <a:pPr indent="0" marL="0">
-              <a:buNone/>
+            <a:pPr marL="342900" indent="-342900">
+              <a:buSzPct val="100000"/>
+              <a:buChar char="•"/>
             </a:pPr>
             <a:r>
               <a:rPr lang="en-US" sz="1800" dirty="0">
@@ -16216,18 +16434,18 @@
                   <a:srgbClr val="333333"/>
                 </a:solidFill>
               </a:rPr>
-              <a:t>   1. Praktik pengisian data diam (</a:t>
-            </a:r>
-            <a:pPr indent="0" marL="0">
-              <a:buNone/>
-            </a:pPr>
-            <a:r>
-              <a:rPr lang="en-US" sz="1800" b="1" i="1" dirty="0">
-                <a:solidFill>
-                  <a:srgbClr val="333333"/>
-                </a:solidFill>
-              </a:rPr>
-              <a:t>backward fill</a:t>
+              <a:t>Lebih Defensif untuk meredam fluktuasi saat </a:t>
+            </a:r>
+            <a:pPr indent="0" marL="0">
+              <a:buNone/>
+            </a:pPr>
+            <a:r>
+              <a:rPr lang="en-US" sz="1800" b="1" dirty="0">
+                <a:solidFill>
+                  <a:srgbClr val="333333"/>
+                </a:solidFill>
+              </a:rPr>
+              <a:t>Crypto Winter</a:t>
             </a:r>
             <a:pPr indent="0" marL="0">
               <a:buNone/>
@@ -16238,115 +16456,7 @@
                   <a:srgbClr val="333333"/>
                 </a:solidFill>
               </a:rPr>
-              <a:t>) memang menciptakan rentetan nilai harga yang statis.</a:t>
-            </a:r>
-            <a:endParaRPr lang="en-US" sz="1800" dirty="0"/>
-          </a:p>
-          <a:p>
-            <a:pPr indent="0" marL="0">
-              <a:buNone/>
-            </a:pPr>
-            <a:r>
-              <a:rPr lang="en-US" sz="1800" dirty="0">
-                <a:solidFill>
-                  <a:srgbClr val="333333"/>
-                </a:solidFill>
-              </a:rPr>
-              <a:t>   2. Namun, kehebatan </a:t>
-            </a:r>
-            <a:pPr indent="0" marL="0">
-              <a:buNone/>
-            </a:pPr>
-            <a:r>
-              <a:rPr lang="en-US" sz="1800" b="1" dirty="0">
-                <a:solidFill>
-                  <a:srgbClr val="333333"/>
-                </a:solidFill>
-              </a:rPr>
-              <a:t>Random Matrix Theory (RMT)</a:t>
-            </a:r>
-            <a:pPr indent="0" marL="0">
-              <a:buNone/>
-            </a:pPr>
-            <a:r>
-              <a:rPr lang="en-US" sz="1800" dirty="0">
-                <a:solidFill>
-                  <a:srgbClr val="333333"/>
-                </a:solidFill>
-              </a:rPr>
-              <a:t> diuji di sini! Karena data yang datar sama sekali tidak punya korelasi nyata.</a:t>
-            </a:r>
-            <a:endParaRPr lang="en-US" sz="1800" dirty="0"/>
-          </a:p>
-          <a:p>
-            <a:pPr indent="0" marL="0">
-              <a:buNone/>
-            </a:pPr>
-            <a:r>
-              <a:rPr lang="en-US" sz="1800" dirty="0">
-                <a:solidFill>
-                  <a:srgbClr val="333333"/>
-                </a:solidFill>
-              </a:rPr>
-              <a:t>   3. RMT otomatis akan mendeteksi korelasi buatan tersebut sebagai probabilitas </a:t>
-            </a:r>
-            <a:pPr indent="0" marL="0">
-              <a:buNone/>
-            </a:pPr>
-            <a:r>
-              <a:rPr lang="en-US" sz="1800" b="1" i="1" dirty="0">
-                <a:solidFill>
-                  <a:srgbClr val="333333"/>
-                </a:solidFill>
-              </a:rPr>
-              <a:t>Noise Acak</a:t>
-            </a:r>
-            <a:pPr indent="0" marL="0">
-              <a:buNone/>
-            </a:pPr>
-            <a:r>
-              <a:rPr lang="en-US" sz="1800" dirty="0">
-                <a:solidFill>
-                  <a:srgbClr val="333333"/>
-                </a:solidFill>
-              </a:rPr>
-              <a:t>, lalu membuangnya menjadi 0.</a:t>
-            </a:r>
-            <a:endParaRPr lang="en-US" sz="1800" dirty="0"/>
-          </a:p>
-          <a:p>
-            <a:pPr indent="0" marL="0">
-              <a:buNone/>
-            </a:pPr>
-            <a:r>
-              <a:rPr lang="en-US" sz="1800" dirty="0">
-                <a:solidFill>
-                  <a:srgbClr val="333333"/>
-                </a:solidFill>
-              </a:rPr>
-              <a:t>   4. Hasilnya, matriks korelasi </a:t>
-            </a:r>
-            <a:pPr indent="0" marL="0">
-              <a:buNone/>
-            </a:pPr>
-            <a:r>
-              <a:rPr lang="en-US" sz="1800" b="1" dirty="0">
-                <a:solidFill>
-                  <a:srgbClr val="333333"/>
-                </a:solidFill>
-              </a:rPr>
-              <a:t>terselamatkan</a:t>
-            </a:r>
-            <a:pPr indent="0" marL="0">
-              <a:buNone/>
-            </a:pPr>
-            <a:r>
-              <a:rPr lang="en-US" sz="1800" dirty="0">
-                <a:solidFill>
-                  <a:srgbClr val="333333"/>
-                </a:solidFill>
-              </a:rPr>
-              <a:t> dan tidak tercemar oleh cacat kelengkapan data.</a:t>
+              <a:t>.</a:t>
             </a:r>
             <a:endParaRPr lang="en-US" sz="1800" dirty="0"/>
           </a:p>
@@ -16407,7 +16517,7 @@
                   <a:srgbClr val="003366"/>
                 </a:solidFill>
               </a:rPr>
-              <a:t>Lampiran: Mengapa Menyertakan Tether (USDT)? (1/2)</a:t>
+              <a:t>Lampiran: Penanganan Data Kosong (Missing Values)</a:t>
             </a:r>
             <a:endParaRPr lang="en-US" sz="2600" dirty="0"/>
           </a:p>
@@ -16454,7 +16564,7 @@
                   <a:srgbClr val="333333"/>
                 </a:solidFill>
               </a:rPr>
-              <a:t>"Tether (USDT) itu stablecoin yang nilainya selalu fix ke 1 USD. Apakah tidak berbuat curang?"</a:t>
+              <a:t>"Beberapa koin seperti Binance/EOS belum rilis di awal 2017 sehingga datanya kosong. Bukankah backward-fill memalsukan harga dan merusak matriks?"</a:t>
             </a:r>
             <a:endParaRPr lang="en-US" sz="1800" dirty="0"/>
           </a:p>
@@ -16468,14 +16578,13 @@
                   <a:srgbClr val="27AE60"/>
                 </a:solidFill>
               </a:rPr>
-              <a:t>Jawaban (Dinamika Portofolio Cerdas):</a:t>
+              <a:t>Jawaban (Kenapa RMT sangat Krusial):</a:t>
             </a:r>
             <a:endParaRPr lang="en-US" sz="1800" dirty="0"/>
           </a:p>
           <a:p>
-            <a:pPr marL="342900" indent="-342900">
-              <a:buSzPct val="100000"/>
-              <a:buChar char="•"/>
+            <a:pPr indent="0" marL="0">
+              <a:buNone/>
             </a:pPr>
             <a:r>
               <a:rPr lang="en-US" sz="1800" dirty="0">
@@ -16483,7 +16592,7 @@
                   <a:srgbClr val="333333"/>
                 </a:solidFill>
               </a:rPr>
-              <a:t>Model ini mensimulasikan perilaku </a:t>
+              <a:t>   1. Praktik pengisian data diam (</a:t>
             </a:r>
             <a:pPr indent="0" marL="0">
               <a:buNone/>
@@ -16494,7 +16603,7 @@
                   <a:srgbClr val="333333"/>
                 </a:solidFill>
               </a:rPr>
-              <a:t>Robo-Advisory</a:t>
+              <a:t>backward fill</a:t>
             </a:r>
             <a:pPr indent="0" marL="0">
               <a:buNone/>
@@ -16505,14 +16614,13 @@
                   <a:srgbClr val="333333"/>
                 </a:solidFill>
               </a:rPr>
-              <a:t> institusional.</a:t>
+              <a:t>) memang menciptakan rentetan nilai harga yang statis.</a:t>
             </a:r>
             <a:endParaRPr lang="en-US" sz="1800" dirty="0"/>
           </a:p>
           <a:p>
-            <a:pPr marL="342900" indent="-342900">
-              <a:buSzPct val="100000"/>
-              <a:buChar char="•"/>
+            <a:pPr indent="0" marL="0">
+              <a:buNone/>
             </a:pPr>
             <a:r>
               <a:rPr lang="en-US" sz="1800" dirty="0">
@@ -16520,7 +16628,7 @@
                   <a:srgbClr val="333333"/>
                 </a:solidFill>
               </a:rPr>
-              <a:t>Ketika pasar anjlok ekstrem, investor akan melarikan senjatanya ke posisi </a:t>
+              <a:t>   2. Namun, kehebatan </a:t>
             </a:r>
             <a:pPr indent="0" marL="0">
               <a:buNone/>
@@ -16531,7 +16639,7 @@
                   <a:srgbClr val="333333"/>
                 </a:solidFill>
               </a:rPr>
-              <a:t>tunai (USDT)</a:t>
+              <a:t>Random Matrix Theory (RMT)</a:t>
             </a:r>
             <a:pPr indent="0" marL="0">
               <a:buNone/>
@@ -16542,7 +16650,79 @@
                   <a:srgbClr val="333333"/>
                 </a:solidFill>
               </a:rPr>
-              <a:t> sebagai evakuasi risiko.</a:t>
+              <a:t> diuji di sini! Karena data yang datar sama sekali tidak punya korelasi nyata.</a:t>
+            </a:r>
+            <a:endParaRPr lang="en-US" sz="1800" dirty="0"/>
+          </a:p>
+          <a:p>
+            <a:pPr indent="0" marL="0">
+              <a:buNone/>
+            </a:pPr>
+            <a:r>
+              <a:rPr lang="en-US" sz="1800" dirty="0">
+                <a:solidFill>
+                  <a:srgbClr val="333333"/>
+                </a:solidFill>
+              </a:rPr>
+              <a:t>   3. RMT otomatis akan mendeteksi korelasi buatan tersebut sebagai probabilitas </a:t>
+            </a:r>
+            <a:pPr indent="0" marL="0">
+              <a:buNone/>
+            </a:pPr>
+            <a:r>
+              <a:rPr lang="en-US" sz="1800" b="1" i="1" dirty="0">
+                <a:solidFill>
+                  <a:srgbClr val="333333"/>
+                </a:solidFill>
+              </a:rPr>
+              <a:t>Noise Acak</a:t>
+            </a:r>
+            <a:pPr indent="0" marL="0">
+              <a:buNone/>
+            </a:pPr>
+            <a:r>
+              <a:rPr lang="en-US" sz="1800" dirty="0">
+                <a:solidFill>
+                  <a:srgbClr val="333333"/>
+                </a:solidFill>
+              </a:rPr>
+              <a:t>, lalu membuangnya menjadi 0.</a:t>
+            </a:r>
+            <a:endParaRPr lang="en-US" sz="1800" dirty="0"/>
+          </a:p>
+          <a:p>
+            <a:pPr indent="0" marL="0">
+              <a:buNone/>
+            </a:pPr>
+            <a:r>
+              <a:rPr lang="en-US" sz="1800" dirty="0">
+                <a:solidFill>
+                  <a:srgbClr val="333333"/>
+                </a:solidFill>
+              </a:rPr>
+              <a:t>   4. Hasilnya, matriks korelasi </a:t>
+            </a:r>
+            <a:pPr indent="0" marL="0">
+              <a:buNone/>
+            </a:pPr>
+            <a:r>
+              <a:rPr lang="en-US" sz="1800" b="1" dirty="0">
+                <a:solidFill>
+                  <a:srgbClr val="333333"/>
+                </a:solidFill>
+              </a:rPr>
+              <a:t>terselamatkan</a:t>
+            </a:r>
+            <a:pPr indent="0" marL="0">
+              <a:buNone/>
+            </a:pPr>
+            <a:r>
+              <a:rPr lang="en-US" sz="1800" dirty="0">
+                <a:solidFill>
+                  <a:srgbClr val="333333"/>
+                </a:solidFill>
+              </a:rPr>
+              <a:t> dan tidak tercemar oleh cacat kelengkapan data.</a:t>
             </a:r>
             <a:endParaRPr lang="en-US" sz="1800" dirty="0"/>
           </a:p>
@@ -16603,7 +16783,7 @@
                   <a:srgbClr val="003366"/>
                 </a:solidFill>
               </a:rPr>
-              <a:t>Lampiran: Mengapa Menyertakan Tether (USDT)? (2/2)</a:t>
+              <a:t>Lampiran: Mengapa Menyertakan Tether (USDT)? (1/2)</a:t>
             </a:r>
             <a:endParaRPr lang="en-US" sz="2600" dirty="0"/>
           </a:p>
@@ -16634,12 +16814,89 @@
               <a:buNone/>
             </a:pPr>
             <a:r>
+              <a:rPr lang="en-US" sz="1800" b="1" dirty="0">
+                <a:solidFill>
+                  <a:srgbClr val="C0392B"/>
+                </a:solidFill>
+              </a:rPr>
+              <a:t>Pertanyaan: </a:t>
+            </a:r>
+            <a:pPr indent="0" marL="0">
+              <a:buNone/>
+            </a:pPr>
+            <a:r>
+              <a:rPr lang="en-US" sz="1800" i="1" dirty="0">
+                <a:solidFill>
+                  <a:srgbClr val="333333"/>
+                </a:solidFill>
+              </a:rPr>
+              <a:t>"Tether (USDT) itu stablecoin yang nilainya selalu fix ke 1 USD. Apakah tidak berbuat curang?"</a:t>
+            </a:r>
+            <a:endParaRPr lang="en-US" sz="1800" dirty="0"/>
+          </a:p>
+          <a:p>
+            <a:pPr indent="0" marL="0">
+              <a:buNone/>
+            </a:pPr>
+            <a:r>
+              <a:rPr lang="en-US" sz="1800" b="1" dirty="0">
+                <a:solidFill>
+                  <a:srgbClr val="27AE60"/>
+                </a:solidFill>
+              </a:rPr>
+              <a:t>Jawaban (Dinamika Portofolio Cerdas):</a:t>
+            </a:r>
+            <a:endParaRPr lang="en-US" sz="1800" dirty="0"/>
+          </a:p>
+          <a:p>
+            <a:pPr marL="342900" indent="-342900">
+              <a:buSzPct val="100000"/>
+              <a:buChar char="•"/>
+            </a:pPr>
+            <a:r>
               <a:rPr lang="en-US" sz="1800" dirty="0">
                 <a:solidFill>
                   <a:srgbClr val="333333"/>
                 </a:solidFill>
               </a:rPr>
-              <a:t>3. Algoritma jaringan </a:t>
+              <a:t>Model ini mensimulasikan perilaku </a:t>
+            </a:r>
+            <a:pPr indent="0" marL="0">
+              <a:buNone/>
+            </a:pPr>
+            <a:r>
+              <a:rPr lang="en-US" sz="1800" b="1" i="1" dirty="0">
+                <a:solidFill>
+                  <a:srgbClr val="333333"/>
+                </a:solidFill>
+              </a:rPr>
+              <a:t>Robo-Advisory</a:t>
+            </a:r>
+            <a:pPr indent="0" marL="0">
+              <a:buNone/>
+            </a:pPr>
+            <a:r>
+              <a:rPr lang="en-US" sz="1800" dirty="0">
+                <a:solidFill>
+                  <a:srgbClr val="333333"/>
+                </a:solidFill>
+              </a:rPr>
+              <a:t> institusional.</a:t>
+            </a:r>
+            <a:endParaRPr lang="en-US" sz="1800" dirty="0"/>
+          </a:p>
+          <a:p>
+            <a:pPr marL="342900" indent="-342900">
+              <a:buSzPct val="100000"/>
+              <a:buChar char="•"/>
+            </a:pPr>
+            <a:r>
+              <a:rPr lang="en-US" sz="1800" dirty="0">
+                <a:solidFill>
+                  <a:srgbClr val="333333"/>
+                </a:solidFill>
+              </a:rPr>
+              <a:t>Ketika pasar anjlok ekstrem, investor akan melarikan senjatanya ke posisi </a:t>
             </a:r>
             <a:pPr indent="0" marL="0">
               <a:buNone/>
@@ -16650,7 +16907,7 @@
                   <a:srgbClr val="333333"/>
                 </a:solidFill>
               </a:rPr>
-              <a:t>Network Markowitz GS (Grid Search)</a:t>
+              <a:t>tunai (USDT)</a:t>
             </a:r>
             <a:pPr indent="0" marL="0">
               <a:buNone/>
@@ -16661,87 +16918,7 @@
                   <a:srgbClr val="333333"/>
                 </a:solidFill>
               </a:rPr>
-              <a:t> dilatih secara matematis; jika mendeteksi korelasi ancaman kolaps merambat ke semua altcoin, ia akan melempar alokasi modalnya menuju node </a:t>
-            </a:r>
-            <a:pPr indent="0" marL="0">
-              <a:buNone/>
-            </a:pPr>
-            <a:r>
-              <a:rPr lang="en-US" sz="1800" b="1" dirty="0">
-                <a:solidFill>
-                  <a:srgbClr val="333333"/>
-                </a:solidFill>
-              </a:rPr>
-              <a:t>USDT (Tether)</a:t>
-            </a:r>
-            <a:pPr indent="0" marL="0">
-              <a:buNone/>
-            </a:pPr>
-            <a:r>
-              <a:rPr lang="en-US" sz="1800" dirty="0">
-                <a:solidFill>
-                  <a:srgbClr val="333333"/>
-                </a:solidFill>
-              </a:rPr>
-              <a:t> sebagai langkah </a:t>
-            </a:r>
-            <a:pPr indent="0" marL="0">
-              <a:buNone/>
-            </a:pPr>
-            <a:r>
-              <a:rPr lang="en-US" sz="1800" b="1" dirty="0">
-                <a:solidFill>
-                  <a:srgbClr val="333333"/>
-                </a:solidFill>
-              </a:rPr>
-              <a:t>evakuasi otomatis</a:t>
-            </a:r>
-            <a:pPr indent="0" marL="0">
-              <a:buNone/>
-            </a:pPr>
-            <a:r>
-              <a:rPr lang="en-US" sz="1800" dirty="0">
-                <a:solidFill>
-                  <a:srgbClr val="333333"/>
-                </a:solidFill>
-              </a:rPr>
-              <a:t> (Shock-Absorber).</a:t>
-            </a:r>
-            <a:endParaRPr lang="en-US" sz="1800" dirty="0"/>
-          </a:p>
-          <a:p>
-            <a:pPr indent="0" marL="0">
-              <a:buNone/>
-            </a:pPr>
-            <a:r>
-              <a:rPr lang="en-US" sz="1800" dirty="0">
-                <a:solidFill>
-                  <a:srgbClr val="333333"/>
-                </a:solidFill>
-              </a:rPr>
-              <a:t>   4. Hal ini yang membuat performa Risk-GS (Grid Search) sangat </a:t>
-            </a:r>
-            <a:pPr indent="0" marL="0">
-              <a:buNone/>
-            </a:pPr>
-            <a:r>
-              <a:rPr lang="en-US" sz="1800" b="1" dirty="0">
-                <a:solidFill>
-                  <a:srgbClr val="333333"/>
-                </a:solidFill>
-              </a:rPr>
-              <a:t>tangguh</a:t>
-            </a:r>
-            <a:pPr indent="0" marL="0">
-              <a:buNone/>
-            </a:pPr>
-            <a:r>
-              <a:rPr lang="en-US" sz="1800" dirty="0">
-                <a:solidFill>
-                  <a:srgbClr val="333333"/>
-                </a:solidFill>
-              </a:rPr>
-              <a:t> dari serangan Crypto Winter, suatu kapabilitas pertahanan yang tidak dipahami oleh model ortodoks murni Markowitz.</a:t>
+              <a:t> sebagai evakuasi risiko.</a:t>
             </a:r>
             <a:endParaRPr lang="en-US" sz="1800" dirty="0"/>
           </a:p>
@@ -16802,7 +16979,7 @@
                   <a:srgbClr val="003366"/>
                 </a:solidFill>
               </a:rPr>
-              <a:t>Lampiran: Bukti Empiris Non-Stationarity Pasar</a:t>
+              <a:t>Lampiran: Mengapa Menyertakan Tether (USDT)? (2/2)</a:t>
             </a:r>
             <a:endParaRPr lang="en-US" sz="2600" dirty="0"/>
           </a:p>
@@ -16833,23 +17010,78 @@
               <a:buNone/>
             </a:pPr>
             <a:r>
+              <a:rPr lang="en-US" sz="1800" dirty="0">
+                <a:solidFill>
+                  <a:srgbClr val="333333"/>
+                </a:solidFill>
+              </a:rPr>
+              <a:t>3. Algoritma jaringan </a:t>
+            </a:r>
+            <a:pPr indent="0" marL="0">
+              <a:buNone/>
+            </a:pPr>
+            <a:r>
               <a:rPr lang="en-US" sz="1800" b="1" dirty="0">
                 <a:solidFill>
-                  <a:srgbClr val="C0392B"/>
-                </a:solidFill>
-              </a:rPr>
-              <a:t>Masalah: </a:t>
-            </a:r>
-            <a:pPr indent="0" marL="0">
-              <a:buNone/>
-            </a:pPr>
-            <a:r>
-              <a:rPr lang="en-US" sz="1800" i="1" dirty="0">
-                <a:solidFill>
-                  <a:srgbClr val="333333"/>
-                </a:solidFill>
-              </a:rPr>
-              <a:t>Kenapa harus menggunakan model Adaptif (Dynamic Gamma)?</a:t>
+                  <a:srgbClr val="333333"/>
+                </a:solidFill>
+              </a:rPr>
+              <a:t>Network Markowitz GS (Grid Search)</a:t>
+            </a:r>
+            <a:pPr indent="0" marL="0">
+              <a:buNone/>
+            </a:pPr>
+            <a:r>
+              <a:rPr lang="en-US" sz="1800" dirty="0">
+                <a:solidFill>
+                  <a:srgbClr val="333333"/>
+                </a:solidFill>
+              </a:rPr>
+              <a:t> dilatih secara matematis; jika mendeteksi korelasi ancaman kolaps merambat ke semua altcoin, ia akan melempar alokasi modalnya menuju node </a:t>
+            </a:r>
+            <a:pPr indent="0" marL="0">
+              <a:buNone/>
+            </a:pPr>
+            <a:r>
+              <a:rPr lang="en-US" sz="1800" b="1" dirty="0">
+                <a:solidFill>
+                  <a:srgbClr val="333333"/>
+                </a:solidFill>
+              </a:rPr>
+              <a:t>USDT (Tether)</a:t>
+            </a:r>
+            <a:pPr indent="0" marL="0">
+              <a:buNone/>
+            </a:pPr>
+            <a:r>
+              <a:rPr lang="en-US" sz="1800" dirty="0">
+                <a:solidFill>
+                  <a:srgbClr val="333333"/>
+                </a:solidFill>
+              </a:rPr>
+              <a:t> sebagai langkah </a:t>
+            </a:r>
+            <a:pPr indent="0" marL="0">
+              <a:buNone/>
+            </a:pPr>
+            <a:r>
+              <a:rPr lang="en-US" sz="1800" b="1" dirty="0">
+                <a:solidFill>
+                  <a:srgbClr val="333333"/>
+                </a:solidFill>
+              </a:rPr>
+              <a:t>evakuasi otomatis</a:t>
+            </a:r>
+            <a:pPr indent="0" marL="0">
+              <a:buNone/>
+            </a:pPr>
+            <a:r>
+              <a:rPr lang="en-US" sz="1800" dirty="0">
+                <a:solidFill>
+                  <a:srgbClr val="333333"/>
+                </a:solidFill>
+              </a:rPr>
+              <a:t> (Shock-Absorber).</a:t>
             </a:r>
             <a:endParaRPr lang="en-US" sz="1800" dirty="0"/>
           </a:p>
@@ -16858,19 +17090,26 @@
               <a:buNone/>
             </a:pPr>
             <a:r>
+              <a:rPr lang="en-US" sz="1800" dirty="0">
+                <a:solidFill>
+                  <a:srgbClr val="333333"/>
+                </a:solidFill>
+              </a:rPr>
+              <a:t>   4. Hal ini yang membuat performa Risk-GS (Grid Search) sangat </a:t>
+            </a:r>
+            <a:pPr indent="0" marL="0">
+              <a:buNone/>
+            </a:pPr>
+            <a:r>
               <a:rPr lang="en-US" sz="1800" b="1" dirty="0">
                 <a:solidFill>
-                  <a:srgbClr val="27AE60"/>
-                </a:solidFill>
-              </a:rPr>
-              <a:t>Bukti dari Grid Search:</a:t>
-            </a:r>
-            <a:endParaRPr lang="en-US" sz="1800" dirty="0"/>
-          </a:p>
-          <a:p>
-            <a:pPr marL="342900" indent="-342900">
-              <a:buSzPct val="100000"/>
-              <a:buChar char="•"/>
+                  <a:srgbClr val="333333"/>
+                </a:solidFill>
+              </a:rPr>
+              <a:t>tangguh</a:t>
+            </a:r>
+            <a:pPr indent="0" marL="0">
+              <a:buNone/>
             </a:pPr>
             <a:r>
               <a:rPr lang="en-US" sz="1800" dirty="0">
@@ -16878,103 +17117,7 @@
                   <a:srgbClr val="333333"/>
                 </a:solidFill>
               </a:rPr>
-              <a:t>Data menunjukkan nilai Gamma (γ) optimal </a:t>
-            </a:r>
-            <a:pPr indent="0" marL="0">
-              <a:buNone/>
-            </a:pPr>
-            <a:r>
-              <a:rPr lang="en-US" sz="1800" b="1" dirty="0">
-                <a:solidFill>
-                  <a:srgbClr val="333333"/>
-                </a:solidFill>
-              </a:rPr>
-              <a:t>terus bergeser</a:t>
-            </a:r>
-            <a:pPr indent="0" marL="0">
-              <a:buNone/>
-            </a:pPr>
-            <a:r>
-              <a:rPr lang="en-US" sz="1800" dirty="0">
-                <a:solidFill>
-                  <a:srgbClr val="333333"/>
-                </a:solidFill>
-              </a:rPr>
-              <a:t> setiap periode rebalancing.</a:t>
-            </a:r>
-            <a:endParaRPr lang="en-US" sz="1800" dirty="0"/>
-          </a:p>
-          <a:p>
-            <a:pPr marL="342900" indent="-342900">
-              <a:buSzPct val="100000"/>
-              <a:buChar char="•"/>
-            </a:pPr>
-            <a:r>
-              <a:rPr lang="en-US" sz="1800" dirty="0">
-                <a:solidFill>
-                  <a:srgbClr val="333333"/>
-                </a:solidFill>
-              </a:rPr>
-              <a:t>Penggunaan γ statis tidak cukup untuk menangkap perubahan </a:t>
-            </a:r>
-            <a:pPr indent="0" marL="0">
-              <a:buNone/>
-            </a:pPr>
-            <a:r>
-              <a:rPr lang="en-US" sz="1800" b="1" dirty="0">
-                <a:solidFill>
-                  <a:srgbClr val="333333"/>
-                </a:solidFill>
-              </a:rPr>
-              <a:t>struktur korelasi</a:t>
-            </a:r>
-            <a:pPr indent="0" marL="0">
-              <a:buNone/>
-            </a:pPr>
-            <a:r>
-              <a:rPr lang="en-US" sz="1800" dirty="0">
-                <a:solidFill>
-                  <a:srgbClr val="333333"/>
-                </a:solidFill>
-              </a:rPr>
-              <a:t> yang sangat cepat di pasar kripto.</a:t>
-            </a:r>
-            <a:endParaRPr lang="en-US" sz="1800" dirty="0"/>
-          </a:p>
-          <a:p>
-            <a:pPr marL="342900" indent="-342900">
-              <a:buSzPct val="100000"/>
-              <a:buChar char="•"/>
-            </a:pPr>
-            <a:r>
-              <a:rPr lang="en-US" sz="1800" dirty="0">
-                <a:solidFill>
-                  <a:srgbClr val="333333"/>
-                </a:solidFill>
-              </a:rPr>
-              <a:t>Ini membenarkan bahwa pasar kripto membutuhkan </a:t>
-            </a:r>
-            <a:pPr indent="0" marL="0">
-              <a:buNone/>
-            </a:pPr>
-            <a:r>
-              <a:rPr lang="en-US" sz="1800" b="1" dirty="0">
-                <a:solidFill>
-                  <a:srgbClr val="333333"/>
-                </a:solidFill>
-              </a:rPr>
-              <a:t>kalibrasi otomatis</a:t>
-            </a:r>
-            <a:pPr indent="0" marL="0">
-              <a:buNone/>
-            </a:pPr>
-            <a:r>
-              <a:rPr lang="en-US" sz="1800" dirty="0">
-                <a:solidFill>
-                  <a:srgbClr val="333333"/>
-                </a:solidFill>
-              </a:rPr>
-              <a:t> secara temporal.</a:t>
+              <a:t> dari serangan Crypto Winter, suatu kapabilitas pertahanan yang tidak dipahami oleh model ortodoks murni Markowitz.</a:t>
             </a:r>
             <a:endParaRPr lang="en-US" sz="1800" dirty="0"/>
           </a:p>
@@ -17346,6 +17489,239 @@
 <file path=ppt/slides/slide50.xml><?xml version="1.0" encoding="utf-8"?>
 <p:sld xmlns:a="http://schemas.openxmlformats.org/drawingml/2006/main" xmlns:r="http://schemas.openxmlformats.org/officeDocument/2006/relationships" xmlns:p="http://schemas.openxmlformats.org/presentationml/2006/main">
   <p:cSld name="Slide 50">
+    <p:spTree>
+      <p:nvGrpSpPr>
+        <p:cNvPr id="1" name=""/>
+        <p:cNvGrpSpPr/>
+        <p:nvPr/>
+      </p:nvGrpSpPr>
+      <p:grpSpPr>
+        <a:xfrm>
+          <a:off x="0" y="0"/>
+          <a:ext cx="0" cy="0"/>
+          <a:chOff x="0" y="0"/>
+          <a:chExt cx="0" cy="0"/>
+        </a:xfrm>
+      </p:grpSpPr>
+      <p:sp>
+        <p:nvSpPr>
+          <p:cNvPr id="2" name="Text 0"/>
+          <p:cNvSpPr/>
+          <p:nvPr/>
+        </p:nvSpPr>
+        <p:spPr>
+          <a:xfrm>
+            <a:off x="457200" y="457200"/>
+            <a:ext cx="8229600" cy="0"/>
+          </a:xfrm>
+          <a:prstGeom prst="rect">
+            <a:avLst/>
+          </a:prstGeom>
+          <a:noFill/>
+          <a:ln/>
+        </p:spPr>
+        <p:txBody>
+          <a:bodyPr wrap="square" rtlCol="0" anchor="ctr"/>
+          <a:lstStyle/>
+          <a:p>
+            <a:pPr indent="0" marL="0">
+              <a:buNone/>
+            </a:pPr>
+            <a:r>
+              <a:rPr lang="en-US" sz="2600" b="1" dirty="0">
+                <a:solidFill>
+                  <a:srgbClr val="003366"/>
+                </a:solidFill>
+              </a:rPr>
+              <a:t>Lampiran: Bukti Empiris Non-Stationarity Pasar</a:t>
+            </a:r>
+            <a:endParaRPr lang="en-US" sz="2600" dirty="0"/>
+          </a:p>
+        </p:txBody>
+      </p:sp>
+      <p:sp>
+        <p:nvSpPr>
+          <p:cNvPr id="3" name="Text 1"/>
+          <p:cNvSpPr/>
+          <p:nvPr/>
+        </p:nvSpPr>
+        <p:spPr>
+          <a:xfrm>
+            <a:off x="457200" y="1005840"/>
+            <a:ext cx="8229600" cy="5029200"/>
+          </a:xfrm>
+          <a:prstGeom prst="rect">
+            <a:avLst/>
+          </a:prstGeom>
+          <a:noFill/>
+          <a:ln/>
+        </p:spPr>
+        <p:txBody>
+          <a:bodyPr wrap="square" rtlCol="0" anchor="t"/>
+          <a:lstStyle/>
+          <a:p>
+            <a:pPr indent="0" marL="0">
+              <a:buNone/>
+            </a:pPr>
+            <a:r>
+              <a:rPr lang="en-US" sz="1800" b="1" dirty="0">
+                <a:solidFill>
+                  <a:srgbClr val="C0392B"/>
+                </a:solidFill>
+              </a:rPr>
+              <a:t>Masalah: </a:t>
+            </a:r>
+            <a:pPr indent="0" marL="0">
+              <a:buNone/>
+            </a:pPr>
+            <a:r>
+              <a:rPr lang="en-US" sz="1800" i="1" dirty="0">
+                <a:solidFill>
+                  <a:srgbClr val="333333"/>
+                </a:solidFill>
+              </a:rPr>
+              <a:t>Kenapa harus menggunakan model Adaptif (Dynamic Gamma)?</a:t>
+            </a:r>
+            <a:endParaRPr lang="en-US" sz="1800" dirty="0"/>
+          </a:p>
+          <a:p>
+            <a:pPr indent="0" marL="0">
+              <a:buNone/>
+            </a:pPr>
+            <a:r>
+              <a:rPr lang="en-US" sz="1800" b="1" dirty="0">
+                <a:solidFill>
+                  <a:srgbClr val="27AE60"/>
+                </a:solidFill>
+              </a:rPr>
+              <a:t>Bukti dari Grid Search:</a:t>
+            </a:r>
+            <a:endParaRPr lang="en-US" sz="1800" dirty="0"/>
+          </a:p>
+          <a:p>
+            <a:pPr marL="342900" indent="-342900">
+              <a:buSzPct val="100000"/>
+              <a:buChar char="•"/>
+            </a:pPr>
+            <a:r>
+              <a:rPr lang="en-US" sz="1800" dirty="0">
+                <a:solidFill>
+                  <a:srgbClr val="333333"/>
+                </a:solidFill>
+              </a:rPr>
+              <a:t>Data menunjukkan nilai Gamma (γ) optimal </a:t>
+            </a:r>
+            <a:pPr indent="0" marL="0">
+              <a:buNone/>
+            </a:pPr>
+            <a:r>
+              <a:rPr lang="en-US" sz="1800" b="1" dirty="0">
+                <a:solidFill>
+                  <a:srgbClr val="333333"/>
+                </a:solidFill>
+              </a:rPr>
+              <a:t>terus bergeser</a:t>
+            </a:r>
+            <a:pPr indent="0" marL="0">
+              <a:buNone/>
+            </a:pPr>
+            <a:r>
+              <a:rPr lang="en-US" sz="1800" dirty="0">
+                <a:solidFill>
+                  <a:srgbClr val="333333"/>
+                </a:solidFill>
+              </a:rPr>
+              <a:t> setiap periode rebalancing.</a:t>
+            </a:r>
+            <a:endParaRPr lang="en-US" sz="1800" dirty="0"/>
+          </a:p>
+          <a:p>
+            <a:pPr marL="342900" indent="-342900">
+              <a:buSzPct val="100000"/>
+              <a:buChar char="•"/>
+            </a:pPr>
+            <a:r>
+              <a:rPr lang="en-US" sz="1800" dirty="0">
+                <a:solidFill>
+                  <a:srgbClr val="333333"/>
+                </a:solidFill>
+              </a:rPr>
+              <a:t>Penggunaan γ statis tidak cukup untuk menangkap perubahan </a:t>
+            </a:r>
+            <a:pPr indent="0" marL="0">
+              <a:buNone/>
+            </a:pPr>
+            <a:r>
+              <a:rPr lang="en-US" sz="1800" b="1" dirty="0">
+                <a:solidFill>
+                  <a:srgbClr val="333333"/>
+                </a:solidFill>
+              </a:rPr>
+              <a:t>struktur korelasi</a:t>
+            </a:r>
+            <a:pPr indent="0" marL="0">
+              <a:buNone/>
+            </a:pPr>
+            <a:r>
+              <a:rPr lang="en-US" sz="1800" dirty="0">
+                <a:solidFill>
+                  <a:srgbClr val="333333"/>
+                </a:solidFill>
+              </a:rPr>
+              <a:t> yang sangat cepat di pasar kripto.</a:t>
+            </a:r>
+            <a:endParaRPr lang="en-US" sz="1800" dirty="0"/>
+          </a:p>
+          <a:p>
+            <a:pPr marL="342900" indent="-342900">
+              <a:buSzPct val="100000"/>
+              <a:buChar char="•"/>
+            </a:pPr>
+            <a:r>
+              <a:rPr lang="en-US" sz="1800" dirty="0">
+                <a:solidFill>
+                  <a:srgbClr val="333333"/>
+                </a:solidFill>
+              </a:rPr>
+              <a:t>Ini membenarkan bahwa pasar kripto membutuhkan </a:t>
+            </a:r>
+            <a:pPr indent="0" marL="0">
+              <a:buNone/>
+            </a:pPr>
+            <a:r>
+              <a:rPr lang="en-US" sz="1800" b="1" dirty="0">
+                <a:solidFill>
+                  <a:srgbClr val="333333"/>
+                </a:solidFill>
+              </a:rPr>
+              <a:t>kalibrasi otomatis</a:t>
+            </a:r>
+            <a:pPr indent="0" marL="0">
+              <a:buNone/>
+            </a:pPr>
+            <a:r>
+              <a:rPr lang="en-US" sz="1800" dirty="0">
+                <a:solidFill>
+                  <a:srgbClr val="333333"/>
+                </a:solidFill>
+              </a:rPr>
+              <a:t> secara temporal.</a:t>
+            </a:r>
+            <a:endParaRPr lang="en-US" sz="1800" dirty="0"/>
+          </a:p>
+        </p:txBody>
+      </p:sp>
+    </p:spTree>
+  </p:cSld>
+  <p:clrMapOvr>
+    <a:masterClrMapping/>
+  </p:clrMapOvr>
+</p:sld>
+</file>
+
+<file path=ppt/slides/slide51.xml><?xml version="1.0" encoding="utf-8"?>
+<p:sld xmlns:a="http://schemas.openxmlformats.org/drawingml/2006/main" xmlns:r="http://schemas.openxmlformats.org/officeDocument/2006/relationships" xmlns:p="http://schemas.openxmlformats.org/presentationml/2006/main">
+  <p:cSld name="Slide 51">
     <p:spTree>
       <p:nvGrpSpPr>
         <p:cNvPr id="1" name=""/>

</xml_diff>

<commit_message>
feat: add navigation hyperlinks from main slides to appendix slides
</commit_message>
<xml_diff>
--- a/Presentasi_Proposal_Update.pptx
+++ b/Presentasi_Proposal_Update.pptx
@@ -5716,6 +5716,33 @@
             </a:r>
             <a:endParaRPr lang="en-US" sz="2000" dirty="0"/>
           </a:p>
+          <a:p>
+            <a:pPr indent="0" marL="0">
+              <a:buNone/>
+            </a:pPr>
+            <a:endParaRPr lang="en-US" sz="2000" dirty="0"/>
+          </a:p>
+          <a:p>
+            <a:pPr indent="0" marL="0">
+              <a:buNone/>
+            </a:pPr>
+            <a:r>
+              <a:rPr lang="en-US" sz="1400" u="sng" dirty="0">
+                <a:solidFill>
+                  <a:srgbClr val="0563C1"/>
+                </a:solidFill>
+                <a:hlinkClick r:id="rId1" action="ppaction://hlinksldjump" tooltip="">
+                  <a:extLst>
+                    <a:ext uri="{A12FA001-AC4F-418D-AE19-62706E023703}">
+                      <ahyp:hlinkClr xmlns:ahyp="http://schemas.microsoft.com/office/drawing/2018/hyperlinkcolor" val="tx"/>
+                    </a:ext>
+                  </a:extLst>
+                </a:hlinkClick>
+              </a:rPr>
+              <a:t>[Lihat Detail Simulasi Lampiran]</a:t>
+            </a:r>
+            <a:endParaRPr lang="en-US" sz="2000" dirty="0"/>
+          </a:p>
         </p:txBody>
       </p:sp>
     </p:spTree>
@@ -5938,6 +5965,33 @@
             </a:r>
             <a:endParaRPr lang="en-US" sz="2000" dirty="0"/>
           </a:p>
+          <a:p>
+            <a:pPr indent="0" marL="0">
+              <a:buNone/>
+            </a:pPr>
+            <a:endParaRPr lang="en-US" sz="2000" dirty="0"/>
+          </a:p>
+          <a:p>
+            <a:pPr indent="0" marL="0">
+              <a:buNone/>
+            </a:pPr>
+            <a:r>
+              <a:rPr lang="en-US" sz="1400" u="sng" dirty="0">
+                <a:solidFill>
+                  <a:srgbClr val="0563C1"/>
+                </a:solidFill>
+                <a:hlinkClick r:id="rId1" action="ppaction://hlinksldjump" tooltip="">
+                  <a:extLst>
+                    <a:ext uri="{A12FA001-AC4F-418D-AE19-62706E023703}">
+                      <ahyp:hlinkClr xmlns:ahyp="http://schemas.microsoft.com/office/drawing/2018/hyperlinkcolor" val="tx"/>
+                    </a:ext>
+                  </a:extLst>
+                </a:hlinkClick>
+              </a:rPr>
+              <a:t>[Lihat Detail Simulasi Lampiran]</a:t>
+            </a:r>
+            <a:endParaRPr lang="en-US" sz="2000" dirty="0"/>
+          </a:p>
         </p:txBody>
       </p:sp>
     </p:spTree>
@@ -6182,6 +6236,33 @@
             </a:r>
             <a:endParaRPr lang="en-US" sz="2000" dirty="0"/>
           </a:p>
+          <a:p>
+            <a:pPr indent="0" marL="0">
+              <a:buNone/>
+            </a:pPr>
+            <a:endParaRPr lang="en-US" sz="2000" dirty="0"/>
+          </a:p>
+          <a:p>
+            <a:pPr indent="0" marL="0">
+              <a:buNone/>
+            </a:pPr>
+            <a:r>
+              <a:rPr lang="en-US" sz="1400" u="sng" dirty="0">
+                <a:solidFill>
+                  <a:srgbClr val="0563C1"/>
+                </a:solidFill>
+                <a:hlinkClick r:id="rId1" action="ppaction://hlinksldjump" tooltip="">
+                  <a:extLst>
+                    <a:ext uri="{A12FA001-AC4F-418D-AE19-62706E023703}">
+                      <ahyp:hlinkClr xmlns:ahyp="http://schemas.microsoft.com/office/drawing/2018/hyperlinkcolor" val="tx"/>
+                    </a:ext>
+                  </a:extLst>
+                </a:hlinkClick>
+              </a:rPr>
+              <a:t>[Lihat Detail Simulasi Lampiran]</a:t>
+            </a:r>
+            <a:endParaRPr lang="en-US" sz="2000" dirty="0"/>
+          </a:p>
         </p:txBody>
       </p:sp>
     </p:spTree>
@@ -6424,6 +6505,33 @@
                 </a:solidFill>
               </a:rPr>
               <a:t>❑ Tujuan: Adaptasi rezim pasar.</a:t>
+            </a:r>
+            <a:endParaRPr lang="en-US" sz="2000" dirty="0"/>
+          </a:p>
+          <a:p>
+            <a:pPr indent="0" marL="0">
+              <a:buNone/>
+            </a:pPr>
+            <a:endParaRPr lang="en-US" sz="2000" dirty="0"/>
+          </a:p>
+          <a:p>
+            <a:pPr indent="0" marL="0">
+              <a:buNone/>
+            </a:pPr>
+            <a:r>
+              <a:rPr lang="en-US" sz="1400" u="sng" dirty="0">
+                <a:solidFill>
+                  <a:srgbClr val="0563C1"/>
+                </a:solidFill>
+                <a:hlinkClick r:id="rId1" action="ppaction://hlinksldjump" tooltip="">
+                  <a:extLst>
+                    <a:ext uri="{A12FA001-AC4F-418D-AE19-62706E023703}">
+                      <ahyp:hlinkClr xmlns:ahyp="http://schemas.microsoft.com/office/drawing/2018/hyperlinkcolor" val="tx"/>
+                    </a:ext>
+                  </a:extLst>
+                </a:hlinkClick>
+              </a:rPr>
+              <a:t>[Lihat Detail Simulasi &amp; Kalkulasi Lampiran]</a:t>
             </a:r>
             <a:endParaRPr lang="en-US" sz="2000" dirty="0"/>
           </a:p>
@@ -20547,6 +20655,33 @@
             </a:r>
             <a:endParaRPr lang="en-US" sz="2000" dirty="0"/>
           </a:p>
+          <a:p>
+            <a:pPr indent="0" marL="0">
+              <a:buNone/>
+            </a:pPr>
+            <a:endParaRPr lang="en-US" sz="2000" dirty="0"/>
+          </a:p>
+          <a:p>
+            <a:pPr indent="0" marL="0">
+              <a:buNone/>
+            </a:pPr>
+            <a:r>
+              <a:rPr lang="en-US" sz="1400" u="sng" dirty="0">
+                <a:solidFill>
+                  <a:srgbClr val="0563C1"/>
+                </a:solidFill>
+                <a:hlinkClick r:id="rId1" action="ppaction://hlinksldjump" tooltip="">
+                  <a:extLst>
+                    <a:ext uri="{A12FA001-AC4F-418D-AE19-62706E023703}">
+                      <ahyp:hlinkClr xmlns:ahyp="http://schemas.microsoft.com/office/drawing/2018/hyperlinkcolor" val="tx"/>
+                    </a:ext>
+                  </a:extLst>
+                </a:hlinkClick>
+              </a:rPr>
+              <a:t>[Lihat Detail Simulasi Lampiran]</a:t>
+            </a:r>
+            <a:endParaRPr lang="en-US" sz="2000" dirty="0"/>
+          </a:p>
         </p:txBody>
       </p:sp>
     </p:spTree>

</xml_diff>

<commit_message>
feat: add internal hyperlinks to strategy summary slide
</commit_message>
<xml_diff>
--- a/Presentasi_Proposal_Update.pptx
+++ b/Presentasi_Proposal_Update.pptx
@@ -20291,8 +20291,29 @@
                   <a:srgbClr val="333333"/>
                 </a:solidFill>
               </a:rPr>
-              <a:t>   • EW (Equally Weighted)</a:t>
-            </a:r>
+              <a:t>   • </a:t>
+            </a:r>
+            <a:pPr indent="0" marL="0">
+              <a:buNone/>
+            </a:pPr>
+            <a:r>
+              <a:rPr lang="en-US" sz="2200" u="sng" dirty="0">
+                <a:solidFill>
+                  <a:srgbClr val="0563C1"/>
+                </a:solidFill>
+                <a:hlinkClick r:id="rId1" action="ppaction://hlinksldjump" tooltip="">
+                  <a:extLst>
+                    <a:ext uri="{A12FA001-AC4F-418D-AE19-62706E023703}">
+                      <ahyp:hlinkClr xmlns:ahyp="http://schemas.microsoft.com/office/drawing/2018/hyperlinkcolor" val="tx"/>
+                    </a:ext>
+                  </a:extLst>
+                </a:hlinkClick>
+              </a:rPr>
+              <a:t>EW (Equally Weighted)</a:t>
+            </a:r>
+            <a:pPr indent="0" marL="0">
+              <a:buNone/>
+            </a:pPr>
             <a:endParaRPr lang="en-US" sz="2200" dirty="0"/>
           </a:p>
           <a:p>
@@ -20305,14 +20326,43 @@
                   <a:srgbClr val="333333"/>
                 </a:solidFill>
               </a:rPr>
-              <a:t>   • CM (Classical Markowitz)</a:t>
-            </a:r>
+              <a:t>   • </a:t>
+            </a:r>
+            <a:pPr indent="0" marL="0">
+              <a:buNone/>
+            </a:pPr>
+            <a:r>
+              <a:rPr lang="en-US" sz="2200" u="sng" dirty="0">
+                <a:solidFill>
+                  <a:srgbClr val="0563C1"/>
+                </a:solidFill>
+                <a:hlinkClick r:id="rId2" action="ppaction://hlinksldjump" tooltip="">
+                  <a:extLst>
+                    <a:ext uri="{A12FA001-AC4F-418D-AE19-62706E023703}">
+                      <ahyp:hlinkClr xmlns:ahyp="http://schemas.microsoft.com/office/drawing/2018/hyperlinkcolor" val="tx"/>
+                    </a:ext>
+                  </a:extLst>
+                </a:hlinkClick>
+              </a:rPr>
+              <a:t>CM (Classical Markowitz)</a:t>
+            </a:r>
+            <a:pPr indent="0" marL="0">
+              <a:buNone/>
+            </a:pPr>
             <a:endParaRPr lang="en-US" sz="2200" dirty="0"/>
           </a:p>
           <a:p>
             <a:pPr indent="0" marL="0">
               <a:buNone/>
             </a:pPr>
+            <a:r>
+              <a:rPr lang="en-US" sz="2200" b="1" dirty="0">
+                <a:solidFill>
+                  <a:srgbClr val="003366"/>
+                </a:solidFill>
+              </a:rPr>
+              <a:t>2. Kelompok Regularisasi:</a:t>
+            </a:r>
             <a:endParaRPr lang="en-US" sz="2200" dirty="0"/>
           </a:p>
           <a:p>
@@ -20320,12 +20370,47 @@
               <a:buNone/>
             </a:pPr>
             <a:r>
+              <a:rPr lang="en-US" sz="2200" dirty="0">
+                <a:solidFill>
+                  <a:srgbClr val="333333"/>
+                </a:solidFill>
+              </a:rPr>
+              <a:t>   • </a:t>
+            </a:r>
+            <a:pPr indent="0" marL="0">
+              <a:buNone/>
+            </a:pPr>
+            <a:r>
+              <a:rPr lang="en-US" sz="2200" u="sng" dirty="0">
+                <a:solidFill>
+                  <a:srgbClr val="0563C1"/>
+                </a:solidFill>
+                <a:hlinkClick r:id="rId3" action="ppaction://hlinksldjump" tooltip="">
+                  <a:extLst>
+                    <a:ext uri="{A12FA001-AC4F-418D-AE19-62706E023703}">
+                      <ahyp:hlinkClr xmlns:ahyp="http://schemas.microsoft.com/office/drawing/2018/hyperlinkcolor" val="tx"/>
+                    </a:ext>
+                  </a:extLst>
+                </a:hlinkClick>
+              </a:rPr>
+              <a:t>GM (Glasso Markowitz)</a:t>
+            </a:r>
+            <a:pPr indent="0" marL="0">
+              <a:buNone/>
+            </a:pPr>
+            <a:endParaRPr lang="en-US" sz="2200" dirty="0"/>
+          </a:p>
+          <a:p>
+            <a:pPr indent="0" marL="0">
+              <a:buNone/>
+            </a:pPr>
+            <a:r>
               <a:rPr lang="en-US" sz="2200" b="1" dirty="0">
                 <a:solidFill>
                   <a:srgbClr val="003366"/>
                 </a:solidFill>
               </a:rPr>
-              <a:t>2. Kelompok Regularisasi:</a:t>
+              <a:t>3. Kelompok Network (Statis):</a:t>
             </a:r>
             <a:endParaRPr lang="en-US" sz="2200" dirty="0"/>
           </a:p>
@@ -20339,14 +20424,43 @@
                   <a:srgbClr val="333333"/>
                 </a:solidFill>
               </a:rPr>
-              <a:t>   • GM (Glasso Markowitz)</a:t>
-            </a:r>
+              <a:t>   • </a:t>
+            </a:r>
+            <a:pPr indent="0" marL="0">
+              <a:buNone/>
+            </a:pPr>
+            <a:r>
+              <a:rPr lang="en-US" sz="2200" u="sng" dirty="0">
+                <a:solidFill>
+                  <a:srgbClr val="0563C1"/>
+                </a:solidFill>
+                <a:hlinkClick r:id="rId4" action="ppaction://hlinksldjump" tooltip="">
+                  <a:extLst>
+                    <a:ext uri="{A12FA001-AC4F-418D-AE19-62706E023703}">
+                      <ahyp:hlinkClr xmlns:ahyp="http://schemas.microsoft.com/office/drawing/2018/hyperlinkcolor" val="tx"/>
+                    </a:ext>
+                  </a:extLst>
+                </a:hlinkClick>
+              </a:rPr>
+              <a:t>NW Statis (γ fixed)</a:t>
+            </a:r>
+            <a:pPr indent="0" marL="0">
+              <a:buNone/>
+            </a:pPr>
             <a:endParaRPr lang="en-US" sz="2200" dirty="0"/>
           </a:p>
           <a:p>
             <a:pPr indent="0" marL="0">
               <a:buNone/>
             </a:pPr>
+            <a:r>
+              <a:rPr lang="en-US" sz="2200" b="1" dirty="0">
+                <a:solidFill>
+                  <a:srgbClr val="003366"/>
+                </a:solidFill>
+              </a:rPr>
+              <a:t>4. Kelompok Network (Adaptif):</a:t>
+            </a:r>
             <a:endParaRPr lang="en-US" sz="2200" dirty="0"/>
           </a:p>
           <a:p>
@@ -20354,60 +20468,30 @@
               <a:buNone/>
             </a:pPr>
             <a:r>
-              <a:rPr lang="en-US" sz="2200" b="1" dirty="0">
-                <a:solidFill>
-                  <a:srgbClr val="003366"/>
-                </a:solidFill>
-              </a:rPr>
-              <a:t>3. Kelompok Network (Statis):</a:t>
-            </a:r>
-            <a:endParaRPr lang="en-US" sz="2200" dirty="0"/>
-          </a:p>
-          <a:p>
-            <a:pPr indent="0" marL="0">
-              <a:buNone/>
-            </a:pPr>
-            <a:r>
               <a:rPr lang="en-US" sz="2200" dirty="0">
                 <a:solidFill>
                   <a:srgbClr val="333333"/>
                 </a:solidFill>
               </a:rPr>
-              <a:t>   • NW Statis (γ fixed)</a:t>
-            </a:r>
-            <a:endParaRPr lang="en-US" sz="2200" dirty="0"/>
-          </a:p>
-          <a:p>
-            <a:pPr indent="0" marL="0">
-              <a:buNone/>
-            </a:pPr>
-            <a:endParaRPr lang="en-US" sz="2200" dirty="0"/>
-          </a:p>
-          <a:p>
-            <a:pPr indent="0" marL="0">
-              <a:buNone/>
-            </a:pPr>
-            <a:r>
-              <a:rPr lang="en-US" sz="2200" b="1" dirty="0">
-                <a:solidFill>
-                  <a:srgbClr val="003366"/>
-                </a:solidFill>
-              </a:rPr>
-              <a:t>4. Kelompok Network (Adaptif):</a:t>
-            </a:r>
-            <a:endParaRPr lang="en-US" sz="2200" dirty="0"/>
-          </a:p>
-          <a:p>
-            <a:pPr indent="0" marL="0">
-              <a:buNone/>
-            </a:pPr>
-            <a:r>
-              <a:rPr lang="en-US" sz="2200" dirty="0">
-                <a:solidFill>
-                  <a:srgbClr val="333333"/>
-                </a:solidFill>
-              </a:rPr>
-              <a:t>   • NW Adaptif (Grid Search)</a:t>
+              <a:t>   • </a:t>
+            </a:r>
+            <a:pPr indent="0" marL="0">
+              <a:buNone/>
+            </a:pPr>
+            <a:r>
+              <a:rPr lang="en-US" sz="2200" u="sng" dirty="0">
+                <a:solidFill>
+                  <a:srgbClr val="0563C1"/>
+                </a:solidFill>
+                <a:hlinkClick r:id="rId5" action="ppaction://hlinksldjump" tooltip="">
+                  <a:extLst>
+                    <a:ext uri="{A12FA001-AC4F-418D-AE19-62706E023703}">
+                      <ahyp:hlinkClr xmlns:ahyp="http://schemas.microsoft.com/office/drawing/2018/hyperlinkcolor" val="tx"/>
+                    </a:ext>
+                  </a:extLst>
+                </a:hlinkClick>
+              </a:rPr>
+              <a:t>NW Adaptif (Grid Search)</a:t>
             </a:r>
             <a:endParaRPr lang="en-US" sz="2200" dirty="0"/>
           </a:p>

</xml_diff>

<commit_message>
feat: enhance Table of Contents with detailed sub-topics and two-column layout
</commit_message>
<xml_diff>
--- a/Presentasi_Proposal_Update.pptx
+++ b/Presentasi_Proposal_Update.pptx
@@ -8196,7 +8196,7 @@
                   <a:srgbClr val="003366"/>
                 </a:solidFill>
               </a:rPr>
-              <a:t>Daftar Isi</a:t>
+              <a:t>Daftar Isi (Detailed Outline)</a:t>
             </a:r>
             <a:endParaRPr lang="en-US" sz="2800" dirty="0"/>
           </a:p>
@@ -8211,7 +8211,7 @@
         <p:spPr>
           <a:xfrm>
             <a:off x="457200" y="1005840"/>
-            <a:ext cx="8229600" cy="4572000"/>
+            <a:ext cx="4114800" cy="4572000"/>
           </a:xfrm>
           <a:prstGeom prst="rect">
             <a:avLst/>
@@ -8227,9 +8227,34 @@
               <a:buNone/>
             </a:pPr>
             <a:r>
-              <a:rPr lang="en-US" sz="2200" u="sng" dirty="0">
-                <a:solidFill>
-                  <a:srgbClr val="0563C1"/>
+              <a:rPr lang="en-US" sz="1800" b="1" dirty="0">
+                <a:solidFill>
+                  <a:srgbClr val="003366"/>
+                </a:solidFill>
+              </a:rPr>
+              <a:t>I. PENDAHULUAN</a:t>
+            </a:r>
+            <a:endParaRPr lang="en-US" sz="1800" dirty="0"/>
+          </a:p>
+          <a:p>
+            <a:pPr indent="0" marL="0">
+              <a:buNone/>
+            </a:pPr>
+            <a:r>
+              <a:rPr lang="en-US" sz="1800" dirty="0">
+                <a:solidFill>
+                  <a:srgbClr val="333333"/>
+                </a:solidFill>
+              </a:rPr>
+              <a:t>   • </a:t>
+            </a:r>
+            <a:pPr indent="0" marL="0">
+              <a:buNone/>
+            </a:pPr>
+            <a:r>
+              <a:rPr lang="en-US" sz="1600" u="sng" dirty="0">
+                <a:solidFill>
+                  <a:srgbClr val="333333"/>
                 </a:solidFill>
                 <a:hlinkClick r:id="rId1" action="ppaction://hlinksldjump" tooltip="">
                   <a:extLst>
@@ -8239,32 +8264,32 @@
                   </a:extLst>
                 </a:hlinkClick>
               </a:rPr>
-              <a:t>1. Pendahuluan &amp; Latar Belakang</a:t>
-            </a:r>
-            <a:endParaRPr lang="en-US" sz="2200" dirty="0"/>
-          </a:p>
-          <a:p>
-            <a:pPr indent="0" marL="0">
-              <a:buNone/>
-            </a:pPr>
-            <a:r>
-              <a:rPr lang="en-US" sz="1600" dirty="0">
-                <a:solidFill>
-                  <a:srgbClr val="7F8C8D"/>
-                </a:solidFill>
-              </a:rPr>
-              <a:t>   • Motivasi, Noise, &amp; Landasan Teori</a:t>
-            </a:r>
-            <a:endParaRPr lang="en-US" sz="2200" dirty="0"/>
-          </a:p>
-          <a:p>
-            <a:pPr indent="0" marL="0">
-              <a:buNone/>
-            </a:pPr>
-            <a:r>
-              <a:rPr lang="en-US" sz="2200" u="sng" dirty="0">
-                <a:solidFill>
-                  <a:srgbClr val="0563C1"/>
+              <a:t>Latar Belakang &amp; Motivasi</a:t>
+            </a:r>
+            <a:pPr indent="0" marL="0">
+              <a:buNone/>
+            </a:pPr>
+            <a:endParaRPr lang="en-US" sz="1800" dirty="0"/>
+          </a:p>
+          <a:p>
+            <a:pPr indent="0" marL="0">
+              <a:buNone/>
+            </a:pPr>
+            <a:r>
+              <a:rPr lang="en-US" sz="1800" dirty="0">
+                <a:solidFill>
+                  <a:srgbClr val="333333"/>
+                </a:solidFill>
+              </a:rPr>
+              <a:t>   • </a:t>
+            </a:r>
+            <a:pPr indent="0" marL="0">
+              <a:buNone/>
+            </a:pPr>
+            <a:r>
+              <a:rPr lang="en-US" sz="1600" u="sng" dirty="0">
+                <a:solidFill>
+                  <a:srgbClr val="333333"/>
                 </a:solidFill>
                 <a:hlinkClick r:id="rId2" action="ppaction://hlinksldjump" tooltip="">
                   <a:extLst>
@@ -8274,32 +8299,32 @@
                   </a:extLst>
                 </a:hlinkClick>
               </a:rPr>
-              <a:t>2. Strategi Portofolio yang Disimulasikan</a:t>
-            </a:r>
-            <a:endParaRPr lang="en-US" sz="2200" dirty="0"/>
-          </a:p>
-          <a:p>
-            <a:pPr indent="0" marL="0">
-              <a:buNone/>
-            </a:pPr>
-            <a:r>
-              <a:rPr lang="en-US" sz="1600" dirty="0">
-                <a:solidFill>
-                  <a:srgbClr val="7F8C8D"/>
-                </a:solidFill>
-              </a:rPr>
-              <a:t>   • EW, CM, GM, &amp; Network Markowitz</a:t>
-            </a:r>
-            <a:endParaRPr lang="en-US" sz="2200" dirty="0"/>
-          </a:p>
-          <a:p>
-            <a:pPr indent="0" marL="0">
-              <a:buNone/>
-            </a:pPr>
-            <a:r>
-              <a:rPr lang="en-US" sz="2200" u="sng" dirty="0">
-                <a:solidFill>
-                  <a:srgbClr val="0563C1"/>
+              <a:t>Masalah "Noise" di Kripto</a:t>
+            </a:r>
+            <a:pPr indent="0" marL="0">
+              <a:buNone/>
+            </a:pPr>
+            <a:endParaRPr lang="en-US" sz="1800" dirty="0"/>
+          </a:p>
+          <a:p>
+            <a:pPr indent="0" marL="0">
+              <a:buNone/>
+            </a:pPr>
+            <a:r>
+              <a:rPr lang="en-US" sz="1800" dirty="0">
+                <a:solidFill>
+                  <a:srgbClr val="333333"/>
+                </a:solidFill>
+              </a:rPr>
+              <a:t>   • </a:t>
+            </a:r>
+            <a:pPr indent="0" marL="0">
+              <a:buNone/>
+            </a:pPr>
+            <a:r>
+              <a:rPr lang="en-US" sz="1600" u="sng" dirty="0">
+                <a:solidFill>
+                  <a:srgbClr val="333333"/>
                 </a:solidFill>
                 <a:hlinkClick r:id="rId3" action="ppaction://hlinksldjump" tooltip="">
                   <a:extLst>
@@ -8309,32 +8334,46 @@
                   </a:extLst>
                 </a:hlinkClick>
               </a:rPr>
-              <a:t>3. Metodologi &amp; Evaluasi Performa</a:t>
-            </a:r>
-            <a:endParaRPr lang="en-US" sz="2200" dirty="0"/>
-          </a:p>
-          <a:p>
-            <a:pPr indent="0" marL="0">
-              <a:buNone/>
-            </a:pPr>
-            <a:r>
-              <a:rPr lang="en-US" sz="1600" dirty="0">
-                <a:solidFill>
-                  <a:srgbClr val="7F8C8D"/>
-                </a:solidFill>
-              </a:rPr>
-              <a:t>   • Sharpe, VaR, &amp; Rachev Ratio</a:t>
-            </a:r>
-            <a:endParaRPr lang="en-US" sz="2200" dirty="0"/>
-          </a:p>
-          <a:p>
-            <a:pPr indent="0" marL="0">
-              <a:buNone/>
-            </a:pPr>
-            <a:r>
-              <a:rPr lang="en-US" sz="2200" u="sng" dirty="0">
-                <a:solidFill>
-                  <a:srgbClr val="0563C1"/>
+              <a:t>Landasan Teori &amp; Literatur</a:t>
+            </a:r>
+            <a:pPr indent="0" marL="0">
+              <a:buNone/>
+            </a:pPr>
+            <a:endParaRPr lang="en-US" sz="1800" dirty="0"/>
+          </a:p>
+          <a:p>
+            <a:pPr indent="0" marL="0">
+              <a:buNone/>
+            </a:pPr>
+            <a:r>
+              <a:rPr lang="en-US" sz="1800" b="1" dirty="0">
+                <a:solidFill>
+                  <a:srgbClr val="003366"/>
+                </a:solidFill>
+              </a:rPr>
+              <a:t>II. STRATEGI PORTOFOLIO</a:t>
+            </a:r>
+            <a:endParaRPr lang="en-US" sz="1800" dirty="0"/>
+          </a:p>
+          <a:p>
+            <a:pPr indent="0" marL="0">
+              <a:buNone/>
+            </a:pPr>
+            <a:r>
+              <a:rPr lang="en-US" sz="1800" dirty="0">
+                <a:solidFill>
+                  <a:srgbClr val="333333"/>
+                </a:solidFill>
+              </a:rPr>
+              <a:t>   • </a:t>
+            </a:r>
+            <a:pPr indent="0" marL="0">
+              <a:buNone/>
+            </a:pPr>
+            <a:r>
+              <a:rPr lang="en-US" sz="1600" u="sng" dirty="0">
+                <a:solidFill>
+                  <a:srgbClr val="333333"/>
                 </a:solidFill>
                 <a:hlinkClick r:id="rId4" action="ppaction://hlinksldjump" tooltip="">
                   <a:extLst>
@@ -8344,23 +8383,385 @@
                   </a:extLst>
                 </a:hlinkClick>
               </a:rPr>
-              <a:t>4. Lampiran Teknis &amp; Simulasi (Appendix)</a:t>
-            </a:r>
-            <a:endParaRPr lang="en-US" sz="2200" dirty="0"/>
-          </a:p>
-          <a:p>
-            <a:pPr indent="0" marL="0">
-              <a:buNone/>
-            </a:pPr>
-            <a:r>
-              <a:rPr lang="en-US" sz="1600" dirty="0">
-                <a:solidFill>
-                  <a:srgbClr val="7F8C8D"/>
-                </a:solidFill>
-              </a:rPr>
-              <a:t>   • Detail RMT, MST, &amp; Penalty Centrality</a:t>
-            </a:r>
-            <a:endParaRPr lang="en-US" sz="2200" dirty="0"/>
+              <a:t>Equally Weighted (EW)</a:t>
+            </a:r>
+            <a:pPr indent="0" marL="0">
+              <a:buNone/>
+            </a:pPr>
+            <a:endParaRPr lang="en-US" sz="1800" dirty="0"/>
+          </a:p>
+          <a:p>
+            <a:pPr indent="0" marL="0">
+              <a:buNone/>
+            </a:pPr>
+            <a:r>
+              <a:rPr lang="en-US" sz="1800" dirty="0">
+                <a:solidFill>
+                  <a:srgbClr val="333333"/>
+                </a:solidFill>
+              </a:rPr>
+              <a:t>   • </a:t>
+            </a:r>
+            <a:pPr indent="0" marL="0">
+              <a:buNone/>
+            </a:pPr>
+            <a:r>
+              <a:rPr lang="en-US" sz="1600" u="sng" dirty="0">
+                <a:solidFill>
+                  <a:srgbClr val="333333"/>
+                </a:solidFill>
+                <a:hlinkClick r:id="rId5" action="ppaction://hlinksldjump" tooltip="">
+                  <a:extLst>
+                    <a:ext uri="{A12FA001-AC4F-418D-AE19-62706E023703}">
+                      <ahyp:hlinkClr xmlns:ahyp="http://schemas.microsoft.com/office/drawing/2018/hyperlinkcolor" val="tx"/>
+                    </a:ext>
+                  </a:extLst>
+                </a:hlinkClick>
+              </a:rPr>
+              <a:t>Classical Markowitz (CM)</a:t>
+            </a:r>
+            <a:pPr indent="0" marL="0">
+              <a:buNone/>
+            </a:pPr>
+            <a:endParaRPr lang="en-US" sz="1800" dirty="0"/>
+          </a:p>
+          <a:p>
+            <a:pPr indent="0" marL="0">
+              <a:buNone/>
+            </a:pPr>
+            <a:r>
+              <a:rPr lang="en-US" sz="1800" dirty="0">
+                <a:solidFill>
+                  <a:srgbClr val="333333"/>
+                </a:solidFill>
+              </a:rPr>
+              <a:t>   • </a:t>
+            </a:r>
+            <a:pPr indent="0" marL="0">
+              <a:buNone/>
+            </a:pPr>
+            <a:r>
+              <a:rPr lang="en-US" sz="1600" u="sng" dirty="0">
+                <a:solidFill>
+                  <a:srgbClr val="333333"/>
+                </a:solidFill>
+                <a:hlinkClick r:id="rId6" action="ppaction://hlinksldjump" tooltip="">
+                  <a:extLst>
+                    <a:ext uri="{A12FA001-AC4F-418D-AE19-62706E023703}">
+                      <ahyp:hlinkClr xmlns:ahyp="http://schemas.microsoft.com/office/drawing/2018/hyperlinkcolor" val="tx"/>
+                    </a:ext>
+                  </a:extLst>
+                </a:hlinkClick>
+              </a:rPr>
+              <a:t>Graphical Lasso (GM)</a:t>
+            </a:r>
+            <a:pPr indent="0" marL="0">
+              <a:buNone/>
+            </a:pPr>
+            <a:endParaRPr lang="en-US" sz="1800" dirty="0"/>
+          </a:p>
+          <a:p>
+            <a:pPr indent="0" marL="0">
+              <a:buNone/>
+            </a:pPr>
+            <a:r>
+              <a:rPr lang="en-US" sz="1800" dirty="0">
+                <a:solidFill>
+                  <a:srgbClr val="333333"/>
+                </a:solidFill>
+              </a:rPr>
+              <a:t>   • </a:t>
+            </a:r>
+            <a:pPr indent="0" marL="0">
+              <a:buNone/>
+            </a:pPr>
+            <a:r>
+              <a:rPr lang="en-US" sz="1600" u="sng" dirty="0">
+                <a:solidFill>
+                  <a:srgbClr val="333333"/>
+                </a:solidFill>
+                <a:hlinkClick r:id="rId7" action="ppaction://hlinksldjump" tooltip="">
+                  <a:extLst>
+                    <a:ext uri="{A12FA001-AC4F-418D-AE19-62706E023703}">
+                      <ahyp:hlinkClr xmlns:ahyp="http://schemas.microsoft.com/office/drawing/2018/hyperlinkcolor" val="tx"/>
+                    </a:ext>
+                  </a:extLst>
+                </a:hlinkClick>
+              </a:rPr>
+              <a:t>Network Markowitz (Adaptif)</a:t>
+            </a:r>
+            <a:endParaRPr lang="en-US" sz="1800" dirty="0"/>
+          </a:p>
+        </p:txBody>
+      </p:sp>
+      <p:sp>
+        <p:nvSpPr>
+          <p:cNvPr id="4" name="Text 2"/>
+          <p:cNvSpPr/>
+          <p:nvPr/>
+        </p:nvSpPr>
+        <p:spPr>
+          <a:xfrm>
+            <a:off x="4754880" y="1005840"/>
+            <a:ext cx="4114800" cy="4572000"/>
+          </a:xfrm>
+          <a:prstGeom prst="rect">
+            <a:avLst/>
+          </a:prstGeom>
+          <a:noFill/>
+          <a:ln/>
+        </p:spPr>
+        <p:txBody>
+          <a:bodyPr wrap="square" rtlCol="0" anchor="t"/>
+          <a:lstStyle/>
+          <a:p>
+            <a:pPr indent="0" marL="0">
+              <a:buNone/>
+            </a:pPr>
+            <a:r>
+              <a:rPr lang="en-US" sz="1800" b="1" dirty="0">
+                <a:solidFill>
+                  <a:srgbClr val="003366"/>
+                </a:solidFill>
+              </a:rPr>
+              <a:t>III. EVALUASI PERFORMA</a:t>
+            </a:r>
+            <a:endParaRPr lang="en-US" sz="1800" dirty="0"/>
+          </a:p>
+          <a:p>
+            <a:pPr indent="0" marL="0">
+              <a:buNone/>
+            </a:pPr>
+            <a:r>
+              <a:rPr lang="en-US" sz="1800" dirty="0">
+                <a:solidFill>
+                  <a:srgbClr val="333333"/>
+                </a:solidFill>
+              </a:rPr>
+              <a:t>   • </a:t>
+            </a:r>
+            <a:pPr indent="0" marL="0">
+              <a:buNone/>
+            </a:pPr>
+            <a:r>
+              <a:rPr lang="en-US" sz="1600" u="sng" dirty="0">
+                <a:solidFill>
+                  <a:srgbClr val="333333"/>
+                </a:solidFill>
+                <a:hlinkClick r:id="rId8" action="ppaction://hlinksldjump" tooltip="">
+                  <a:extLst>
+                    <a:ext uri="{A12FA001-AC4F-418D-AE19-62706E023703}">
+                      <ahyp:hlinkClr xmlns:ahyp="http://schemas.microsoft.com/office/drawing/2018/hyperlinkcolor" val="tx"/>
+                    </a:ext>
+                  </a:extLst>
+                </a:hlinkClick>
+              </a:rPr>
+              <a:t>Matriks Sharpe, VaR, Rachev</a:t>
+            </a:r>
+            <a:pPr indent="0" marL="0">
+              <a:buNone/>
+            </a:pPr>
+            <a:endParaRPr lang="en-US" sz="1800" dirty="0"/>
+          </a:p>
+          <a:p>
+            <a:pPr indent="0" marL="0">
+              <a:buNone/>
+            </a:pPr>
+            <a:r>
+              <a:rPr lang="en-US" sz="1800" b="1" dirty="0">
+                <a:solidFill>
+                  <a:srgbClr val="003366"/>
+                </a:solidFill>
+              </a:rPr>
+              <a:t>IV. LAMPIRAN TEKNIS (APPENDIX)</a:t>
+            </a:r>
+            <a:endParaRPr lang="en-US" sz="1800" dirty="0"/>
+          </a:p>
+          <a:p>
+            <a:pPr indent="0" marL="0">
+              <a:buNone/>
+            </a:pPr>
+            <a:r>
+              <a:rPr lang="en-US" sz="1800" dirty="0">
+                <a:solidFill>
+                  <a:srgbClr val="333333"/>
+                </a:solidFill>
+              </a:rPr>
+              <a:t>   • </a:t>
+            </a:r>
+            <a:pPr indent="0" marL="0">
+              <a:buNone/>
+            </a:pPr>
+            <a:r>
+              <a:rPr lang="en-US" sz="1600" u="sng" dirty="0">
+                <a:solidFill>
+                  <a:srgbClr val="333333"/>
+                </a:solidFill>
+                <a:hlinkClick r:id="rId9" action="ppaction://hlinksldjump" tooltip="">
+                  <a:extLst>
+                    <a:ext uri="{A12FA001-AC4F-418D-AE19-62706E023703}">
+                      <ahyp:hlinkClr xmlns:ahyp="http://schemas.microsoft.com/office/drawing/2018/hyperlinkcolor" val="tx"/>
+                    </a:ext>
+                  </a:extLst>
+                </a:hlinkClick>
+              </a:rPr>
+              <a:t>Random Matrix Theory (RMT)</a:t>
+            </a:r>
+            <a:pPr indent="0" marL="0">
+              <a:buNone/>
+            </a:pPr>
+            <a:endParaRPr lang="en-US" sz="1800" dirty="0"/>
+          </a:p>
+          <a:p>
+            <a:pPr indent="0" marL="0">
+              <a:buNone/>
+            </a:pPr>
+            <a:r>
+              <a:rPr lang="en-US" sz="1800" dirty="0">
+                <a:solidFill>
+                  <a:srgbClr val="333333"/>
+                </a:solidFill>
+              </a:rPr>
+              <a:t>   • </a:t>
+            </a:r>
+            <a:pPr indent="0" marL="0">
+              <a:buNone/>
+            </a:pPr>
+            <a:r>
+              <a:rPr lang="en-US" sz="1600" u="sng" dirty="0">
+                <a:solidFill>
+                  <a:srgbClr val="333333"/>
+                </a:solidFill>
+                <a:hlinkClick r:id="rId10" action="ppaction://hlinksldjump" tooltip="">
+                  <a:extLst>
+                    <a:ext uri="{A12FA001-AC4F-418D-AE19-62706E023703}">
+                      <ahyp:hlinkClr xmlns:ahyp="http://schemas.microsoft.com/office/drawing/2018/hyperlinkcolor" val="tx"/>
+                    </a:ext>
+                  </a:extLst>
+                </a:hlinkClick>
+              </a:rPr>
+              <a:t>Minimum Spanning Tree (MST)</a:t>
+            </a:r>
+            <a:pPr indent="0" marL="0">
+              <a:buNone/>
+            </a:pPr>
+            <a:endParaRPr lang="en-US" sz="1800" dirty="0"/>
+          </a:p>
+          <a:p>
+            <a:pPr indent="0" marL="0">
+              <a:buNone/>
+            </a:pPr>
+            <a:r>
+              <a:rPr lang="en-US" sz="1800" dirty="0">
+                <a:solidFill>
+                  <a:srgbClr val="333333"/>
+                </a:solidFill>
+              </a:rPr>
+              <a:t>   • </a:t>
+            </a:r>
+            <a:pPr indent="0" marL="0">
+              <a:buNone/>
+            </a:pPr>
+            <a:r>
+              <a:rPr lang="en-US" sz="1600" u="sng" dirty="0">
+                <a:solidFill>
+                  <a:srgbClr val="333333"/>
+                </a:solidFill>
+                <a:hlinkClick r:id="rId11" action="ppaction://hlinksldjump" tooltip="">
+                  <a:extLst>
+                    <a:ext uri="{A12FA001-AC4F-418D-AE19-62706E023703}">
+                      <ahyp:hlinkClr xmlns:ahyp="http://schemas.microsoft.com/office/drawing/2018/hyperlinkcolor" val="tx"/>
+                    </a:ext>
+                  </a:extLst>
+                </a:hlinkClick>
+              </a:rPr>
+              <a:t>Penalty &amp; Centrality Logic</a:t>
+            </a:r>
+            <a:pPr indent="0" marL="0">
+              <a:buNone/>
+            </a:pPr>
+            <a:endParaRPr lang="en-US" sz="1800" dirty="0"/>
+          </a:p>
+          <a:p>
+            <a:pPr indent="0" marL="0">
+              <a:buNone/>
+            </a:pPr>
+            <a:r>
+              <a:rPr lang="en-US" sz="1800" dirty="0">
+                <a:solidFill>
+                  <a:srgbClr val="333333"/>
+                </a:solidFill>
+              </a:rPr>
+              <a:t>   • </a:t>
+            </a:r>
+            <a:pPr indent="0" marL="0">
+              <a:buNone/>
+            </a:pPr>
+            <a:r>
+              <a:rPr lang="en-US" sz="1600" u="sng" dirty="0">
+                <a:solidFill>
+                  <a:srgbClr val="333333"/>
+                </a:solidFill>
+                <a:hlinkClick r:id="rId12" action="ppaction://hlinksldjump" tooltip="">
+                  <a:extLst>
+                    <a:ext uri="{A12FA001-AC4F-418D-AE19-62706E023703}">
+                      <ahyp:hlinkClr xmlns:ahyp="http://schemas.microsoft.com/office/drawing/2018/hyperlinkcolor" val="tx"/>
+                    </a:ext>
+                  </a:extLst>
+                </a:hlinkClick>
+              </a:rPr>
+              <a:t>Simulasi 60/40 Weight Shift</a:t>
+            </a:r>
+            <a:pPr indent="0" marL="0">
+              <a:buNone/>
+            </a:pPr>
+            <a:endParaRPr lang="en-US" sz="1800" dirty="0"/>
+          </a:p>
+          <a:p>
+            <a:pPr indent="0" marL="0">
+              <a:buNone/>
+            </a:pPr>
+            <a:r>
+              <a:rPr lang="en-US" sz="1800" b="1" dirty="0">
+                <a:solidFill>
+                  <a:srgbClr val="003366"/>
+                </a:solidFill>
+              </a:rPr>
+              <a:t>V. PENUTUP</a:t>
+            </a:r>
+            <a:endParaRPr lang="en-US" sz="1800" dirty="0"/>
+          </a:p>
+          <a:p>
+            <a:pPr indent="0" marL="0">
+              <a:buNone/>
+            </a:pPr>
+            <a:r>
+              <a:rPr lang="en-US" sz="1800" dirty="0">
+                <a:solidFill>
+                  <a:srgbClr val="333333"/>
+                </a:solidFill>
+              </a:rPr>
+              <a:t>   • </a:t>
+            </a:r>
+            <a:pPr indent="0" marL="0">
+              <a:buNone/>
+            </a:pPr>
+            <a:r>
+              <a:rPr lang="en-US" sz="1600" u="sng" dirty="0">
+                <a:solidFill>
+                  <a:srgbClr val="333333"/>
+                </a:solidFill>
+                <a:hlinkClick r:id="rId13" action="ppaction://hlinksldjump" tooltip="">
+                  <a:extLst>
+                    <a:ext uri="{A12FA001-AC4F-418D-AE19-62706E023703}">
+                      <ahyp:hlinkClr xmlns:ahyp="http://schemas.microsoft.com/office/drawing/2018/hyperlinkcolor" val="tx"/>
+                    </a:ext>
+                  </a:extLst>
+                </a:hlinkClick>
+              </a:rPr>
+              <a:t>Sesi Tanya Jawab (Q&amp;A)</a:t>
+            </a:r>
+            <a:endParaRPr lang="en-US" sz="1800" dirty="0"/>
           </a:p>
         </p:txBody>
       </p:sp>

</xml_diff>

<commit_message>
feat: add EW Simulation link to Table of Contents appendix section
</commit_message>
<xml_diff>
--- a/Presentasi_Proposal_Update.pptx
+++ b/Presentasi_Proposal_Update.pptx
@@ -8605,7 +8605,7 @@
                   </a:extLst>
                 </a:hlinkClick>
               </a:rPr>
-              <a:t>Random Matrix Theory (RMT)</a:t>
+              <a:t>Simulasi Strategi EW</a:t>
             </a:r>
             <a:pPr indent="0" marL="0">
               <a:buNone/>
@@ -8640,7 +8640,7 @@
                   </a:extLst>
                 </a:hlinkClick>
               </a:rPr>
-              <a:t>Minimum Spanning Tree (MST)</a:t>
+              <a:t>Random Matrix Theory (RMT)</a:t>
             </a:r>
             <a:pPr indent="0" marL="0">
               <a:buNone/>
@@ -8675,7 +8675,7 @@
                   </a:extLst>
                 </a:hlinkClick>
               </a:rPr>
-              <a:t>Penalty &amp; Centrality Logic</a:t>
+              <a:t>Minimum Spanning Tree (MST)</a:t>
             </a:r>
             <a:pPr indent="0" marL="0">
               <a:buNone/>
@@ -8710,6 +8710,41 @@
                   </a:extLst>
                 </a:hlinkClick>
               </a:rPr>
+              <a:t>Penalty &amp; Centrality Logic</a:t>
+            </a:r>
+            <a:pPr indent="0" marL="0">
+              <a:buNone/>
+            </a:pPr>
+            <a:endParaRPr lang="en-US" sz="1800" dirty="0"/>
+          </a:p>
+          <a:p>
+            <a:pPr indent="0" marL="0">
+              <a:buNone/>
+            </a:pPr>
+            <a:r>
+              <a:rPr lang="en-US" sz="1800" dirty="0">
+                <a:solidFill>
+                  <a:srgbClr val="333333"/>
+                </a:solidFill>
+              </a:rPr>
+              <a:t>   • </a:t>
+            </a:r>
+            <a:pPr indent="0" marL="0">
+              <a:buNone/>
+            </a:pPr>
+            <a:r>
+              <a:rPr lang="en-US" sz="1600" u="sng" dirty="0">
+                <a:solidFill>
+                  <a:srgbClr val="333333"/>
+                </a:solidFill>
+                <a:hlinkClick r:id="rId13" action="ppaction://hlinksldjump" tooltip="">
+                  <a:extLst>
+                    <a:ext uri="{A12FA001-AC4F-418D-AE19-62706E023703}">
+                      <ahyp:hlinkClr xmlns:ahyp="http://schemas.microsoft.com/office/drawing/2018/hyperlinkcolor" val="tx"/>
+                    </a:ext>
+                  </a:extLst>
+                </a:hlinkClick>
+              </a:rPr>
               <a:t>Simulasi 60/40 Weight Shift</a:t>
             </a:r>
             <a:pPr indent="0" marL="0">
@@ -8751,7 +8786,7 @@
                 <a:solidFill>
                   <a:srgbClr val="333333"/>
                 </a:solidFill>
-                <a:hlinkClick r:id="rId13" action="ppaction://hlinksldjump" tooltip="">
+                <a:hlinkClick r:id="rId14" action="ppaction://hlinksldjump" tooltip="">
                   <a:extLst>
                     <a:ext uri="{A12FA001-AC4F-418D-AE19-62706E023703}">
                       <ahyp:hlinkClr xmlns:ahyp="http://schemas.microsoft.com/office/drawing/2018/hyperlinkcolor" val="tx"/>

</xml_diff>

<commit_message>
feat: add Classical Markowitz Simulation link to Table of Contents
</commit_message>
<xml_diff>
--- a/Presentasi_Proposal_Update.pptx
+++ b/Presentasi_Proposal_Update.pptx
@@ -8640,7 +8640,7 @@
                   </a:extLst>
                 </a:hlinkClick>
               </a:rPr>
-              <a:t>Random Matrix Theory (RMT)</a:t>
+              <a:t>Simulasi Strategi CM</a:t>
             </a:r>
             <a:pPr indent="0" marL="0">
               <a:buNone/>
@@ -8675,7 +8675,7 @@
                   </a:extLst>
                 </a:hlinkClick>
               </a:rPr>
-              <a:t>Minimum Spanning Tree (MST)</a:t>
+              <a:t>Random Matrix Theory (RMT)</a:t>
             </a:r>
             <a:pPr indent="0" marL="0">
               <a:buNone/>
@@ -8710,7 +8710,7 @@
                   </a:extLst>
                 </a:hlinkClick>
               </a:rPr>
-              <a:t>Penalty &amp; Centrality Logic</a:t>
+              <a:t>Minimum Spanning Tree (MST)</a:t>
             </a:r>
             <a:pPr indent="0" marL="0">
               <a:buNone/>
@@ -8745,6 +8745,41 @@
                   </a:extLst>
                 </a:hlinkClick>
               </a:rPr>
+              <a:t>Penalty &amp; Centrality Logic</a:t>
+            </a:r>
+            <a:pPr indent="0" marL="0">
+              <a:buNone/>
+            </a:pPr>
+            <a:endParaRPr lang="en-US" sz="1800" dirty="0"/>
+          </a:p>
+          <a:p>
+            <a:pPr indent="0" marL="0">
+              <a:buNone/>
+            </a:pPr>
+            <a:r>
+              <a:rPr lang="en-US" sz="1800" dirty="0">
+                <a:solidFill>
+                  <a:srgbClr val="333333"/>
+                </a:solidFill>
+              </a:rPr>
+              <a:t>   • </a:t>
+            </a:r>
+            <a:pPr indent="0" marL="0">
+              <a:buNone/>
+            </a:pPr>
+            <a:r>
+              <a:rPr lang="en-US" sz="1600" u="sng" dirty="0">
+                <a:solidFill>
+                  <a:srgbClr val="333333"/>
+                </a:solidFill>
+                <a:hlinkClick r:id="rId14" action="ppaction://hlinksldjump" tooltip="">
+                  <a:extLst>
+                    <a:ext uri="{A12FA001-AC4F-418D-AE19-62706E023703}">
+                      <ahyp:hlinkClr xmlns:ahyp="http://schemas.microsoft.com/office/drawing/2018/hyperlinkcolor" val="tx"/>
+                    </a:ext>
+                  </a:extLst>
+                </a:hlinkClick>
+              </a:rPr>
               <a:t>Simulasi 60/40 Weight Shift</a:t>
             </a:r>
             <a:pPr indent="0" marL="0">
@@ -8786,7 +8821,7 @@
                 <a:solidFill>
                   <a:srgbClr val="333333"/>
                 </a:solidFill>
-                <a:hlinkClick r:id="rId14" action="ppaction://hlinksldjump" tooltip="">
+                <a:hlinkClick r:id="rId15" action="ppaction://hlinksldjump" tooltip="">
                   <a:extLst>
                     <a:ext uri="{A12FA001-AC4F-418D-AE19-62706E023703}">
                       <ahyp:hlinkClr xmlns:ahyp="http://schemas.microsoft.com/office/drawing/2018/hyperlinkcolor" val="tx"/>

</xml_diff>

<commit_message>
feat: add GLasso Simulation link to Table of Contents
</commit_message>
<xml_diff>
--- a/Presentasi_Proposal_Update.pptx
+++ b/Presentasi_Proposal_Update.pptx
@@ -8675,7 +8675,7 @@
                   </a:extLst>
                 </a:hlinkClick>
               </a:rPr>
-              <a:t>Random Matrix Theory (RMT)</a:t>
+              <a:t>Simulasi Strategi GLasso</a:t>
             </a:r>
             <a:pPr indent="0" marL="0">
               <a:buNone/>
@@ -8710,7 +8710,7 @@
                   </a:extLst>
                 </a:hlinkClick>
               </a:rPr>
-              <a:t>Minimum Spanning Tree (MST)</a:t>
+              <a:t>Random Matrix Theory (RMT)</a:t>
             </a:r>
             <a:pPr indent="0" marL="0">
               <a:buNone/>
@@ -8745,7 +8745,7 @@
                   </a:extLst>
                 </a:hlinkClick>
               </a:rPr>
-              <a:t>Penalty &amp; Centrality Logic</a:t>
+              <a:t>Minimum Spanning Tree (MST)</a:t>
             </a:r>
             <a:pPr indent="0" marL="0">
               <a:buNone/>
@@ -8780,6 +8780,41 @@
                   </a:extLst>
                 </a:hlinkClick>
               </a:rPr>
+              <a:t>Penalty &amp; Centrality Logic</a:t>
+            </a:r>
+            <a:pPr indent="0" marL="0">
+              <a:buNone/>
+            </a:pPr>
+            <a:endParaRPr lang="en-US" sz="1800" dirty="0"/>
+          </a:p>
+          <a:p>
+            <a:pPr indent="0" marL="0">
+              <a:buNone/>
+            </a:pPr>
+            <a:r>
+              <a:rPr lang="en-US" sz="1800" dirty="0">
+                <a:solidFill>
+                  <a:srgbClr val="333333"/>
+                </a:solidFill>
+              </a:rPr>
+              <a:t>   • </a:t>
+            </a:r>
+            <a:pPr indent="0" marL="0">
+              <a:buNone/>
+            </a:pPr>
+            <a:r>
+              <a:rPr lang="en-US" sz="1600" u="sng" dirty="0">
+                <a:solidFill>
+                  <a:srgbClr val="333333"/>
+                </a:solidFill>
+                <a:hlinkClick r:id="rId15" action="ppaction://hlinksldjump" tooltip="">
+                  <a:extLst>
+                    <a:ext uri="{A12FA001-AC4F-418D-AE19-62706E023703}">
+                      <ahyp:hlinkClr xmlns:ahyp="http://schemas.microsoft.com/office/drawing/2018/hyperlinkcolor" val="tx"/>
+                    </a:ext>
+                  </a:extLst>
+                </a:hlinkClick>
+              </a:rPr>
               <a:t>Simulasi 60/40 Weight Shift</a:t>
             </a:r>
             <a:pPr indent="0" marL="0">
@@ -8821,7 +8856,7 @@
                 <a:solidFill>
                   <a:srgbClr val="333333"/>
                 </a:solidFill>
-                <a:hlinkClick r:id="rId15" action="ppaction://hlinksldjump" tooltip="">
+                <a:hlinkClick r:id="rId16" action="ppaction://hlinksldjump" tooltip="">
                   <a:extLst>
                     <a:ext uri="{A12FA001-AC4F-418D-AE19-62706E023703}">
                       <ahyp:hlinkClr xmlns:ahyp="http://schemas.microsoft.com/office/drawing/2018/hyperlinkcolor" val="tx"/>

</xml_diff>

<commit_message>
feat: add Network Markowitz Simulation link to Table of Contents
</commit_message>
<xml_diff>
--- a/Presentasi_Proposal_Update.pptx
+++ b/Presentasi_Proposal_Update.pptx
@@ -8710,7 +8710,7 @@
                   </a:extLst>
                 </a:hlinkClick>
               </a:rPr>
-              <a:t>Random Matrix Theory (RMT)</a:t>
+              <a:t>Simulasi Strategi NW</a:t>
             </a:r>
             <a:pPr indent="0" marL="0">
               <a:buNone/>
@@ -8745,7 +8745,7 @@
                   </a:extLst>
                 </a:hlinkClick>
               </a:rPr>
-              <a:t>Minimum Spanning Tree (MST)</a:t>
+              <a:t>Random Matrix Theory (RMT)</a:t>
             </a:r>
             <a:pPr indent="0" marL="0">
               <a:buNone/>
@@ -8780,7 +8780,7 @@
                   </a:extLst>
                 </a:hlinkClick>
               </a:rPr>
-              <a:t>Penalty &amp; Centrality Logic</a:t>
+              <a:t>Minimum Spanning Tree (MST)</a:t>
             </a:r>
             <a:pPr indent="0" marL="0">
               <a:buNone/>
@@ -8815,6 +8815,41 @@
                   </a:extLst>
                 </a:hlinkClick>
               </a:rPr>
+              <a:t>Penalty &amp; Centrality Logic</a:t>
+            </a:r>
+            <a:pPr indent="0" marL="0">
+              <a:buNone/>
+            </a:pPr>
+            <a:endParaRPr lang="en-US" sz="1800" dirty="0"/>
+          </a:p>
+          <a:p>
+            <a:pPr indent="0" marL="0">
+              <a:buNone/>
+            </a:pPr>
+            <a:r>
+              <a:rPr lang="en-US" sz="1800" dirty="0">
+                <a:solidFill>
+                  <a:srgbClr val="333333"/>
+                </a:solidFill>
+              </a:rPr>
+              <a:t>   • </a:t>
+            </a:r>
+            <a:pPr indent="0" marL="0">
+              <a:buNone/>
+            </a:pPr>
+            <a:r>
+              <a:rPr lang="en-US" sz="1600" u="sng" dirty="0">
+                <a:solidFill>
+                  <a:srgbClr val="333333"/>
+                </a:solidFill>
+                <a:hlinkClick r:id="rId16" action="ppaction://hlinksldjump" tooltip="">
+                  <a:extLst>
+                    <a:ext uri="{A12FA001-AC4F-418D-AE19-62706E023703}">
+                      <ahyp:hlinkClr xmlns:ahyp="http://schemas.microsoft.com/office/drawing/2018/hyperlinkcolor" val="tx"/>
+                    </a:ext>
+                  </a:extLst>
+                </a:hlinkClick>
+              </a:rPr>
               <a:t>Simulasi 60/40 Weight Shift</a:t>
             </a:r>
             <a:pPr indent="0" marL="0">
@@ -8856,7 +8891,7 @@
                 <a:solidFill>
                   <a:srgbClr val="333333"/>
                 </a:solidFill>
-                <a:hlinkClick r:id="rId16" action="ppaction://hlinksldjump" tooltip="">
+                <a:hlinkClick r:id="rId17" action="ppaction://hlinksldjump" tooltip="">
                   <a:extLst>
                     <a:ext uri="{A12FA001-AC4F-418D-AE19-62706E023703}">
                       <ahyp:hlinkClr xmlns:ahyp="http://schemas.microsoft.com/office/drawing/2018/hyperlinkcolor" val="tx"/>

</xml_diff>

<commit_message>
feat: add 'Back to TOC' navigation link to all slides
</commit_message>
<xml_diff>
--- a/Presentasi_Proposal_Update.pptx
+++ b/Presentasi_Proposal_Update.pptx
@@ -5834,6 +5834,51 @@
           </a:p>
         </p:txBody>
       </p:sp>
+      <p:sp>
+        <p:nvSpPr>
+          <p:cNvPr id="4" name="Text 2">
+            <a:hlinkClick r:id="rId2" tooltip="" action="ppaction://hlinksldjump"/>
+          </p:cNvPr>
+          <p:cNvSpPr/>
+          <p:nvPr/>
+        </p:nvSpPr>
+        <p:spPr>
+          <a:xfrm>
+            <a:off x="7772400" y="4846320"/>
+            <a:ext cx="1097280" cy="0"/>
+          </a:xfrm>
+          <a:prstGeom prst="rect">
+            <a:avLst/>
+          </a:prstGeom>
+          <a:noFill/>
+          <a:ln/>
+        </p:spPr>
+        <p:txBody>
+          <a:bodyPr wrap="square" rtlCol="0" anchor="ctr"/>
+          <a:lstStyle/>
+          <a:p>
+            <a:pPr algn="r" indent="0" marL="0">
+              <a:buNone/>
+            </a:pPr>
+            <a:r>
+              <a:rPr lang="en-US" sz="1000" u="sng" dirty="0">
+                <a:solidFill>
+                  <a:srgbClr val="0563C1"/>
+                </a:solidFill>
+                <a:hlinkClick r:id="rId2" action="ppaction://hlinksldjump" tooltip="">
+                  <a:extLst>
+                    <a:ext uri="{A12FA001-AC4F-418D-AE19-62706E023703}">
+                      <ahyp:hlinkClr xmlns:ahyp="http://schemas.microsoft.com/office/drawing/2018/hyperlinkcolor" val="tx"/>
+                    </a:ext>
+                  </a:extLst>
+                </a:hlinkClick>
+              </a:rPr>
+              <a:t>🏠 Daftar Isi</a:t>
+            </a:r>
+            <a:endParaRPr lang="en-US" sz="1000" dirty="0"/>
+          </a:p>
+        </p:txBody>
+      </p:sp>
     </p:spTree>
   </p:cSld>
   <p:clrMapOvr>
@@ -6105,6 +6150,51 @@
           </a:p>
         </p:txBody>
       </p:sp>
+      <p:sp>
+        <p:nvSpPr>
+          <p:cNvPr id="4" name="Text 2">
+            <a:hlinkClick r:id="rId2" tooltip="" action="ppaction://hlinksldjump"/>
+          </p:cNvPr>
+          <p:cNvSpPr/>
+          <p:nvPr/>
+        </p:nvSpPr>
+        <p:spPr>
+          <a:xfrm>
+            <a:off x="7772400" y="4846320"/>
+            <a:ext cx="1097280" cy="0"/>
+          </a:xfrm>
+          <a:prstGeom prst="rect">
+            <a:avLst/>
+          </a:prstGeom>
+          <a:noFill/>
+          <a:ln/>
+        </p:spPr>
+        <p:txBody>
+          <a:bodyPr wrap="square" rtlCol="0" anchor="ctr"/>
+          <a:lstStyle/>
+          <a:p>
+            <a:pPr algn="r" indent="0" marL="0">
+              <a:buNone/>
+            </a:pPr>
+            <a:r>
+              <a:rPr lang="en-US" sz="1000" u="sng" dirty="0">
+                <a:solidFill>
+                  <a:srgbClr val="0563C1"/>
+                </a:solidFill>
+                <a:hlinkClick r:id="rId2" action="ppaction://hlinksldjump" tooltip="">
+                  <a:extLst>
+                    <a:ext uri="{A12FA001-AC4F-418D-AE19-62706E023703}">
+                      <ahyp:hlinkClr xmlns:ahyp="http://schemas.microsoft.com/office/drawing/2018/hyperlinkcolor" val="tx"/>
+                    </a:ext>
+                  </a:extLst>
+                </a:hlinkClick>
+              </a:rPr>
+              <a:t>🏠 Daftar Isi</a:t>
+            </a:r>
+            <a:endParaRPr lang="en-US" sz="1000" dirty="0"/>
+          </a:p>
+        </p:txBody>
+      </p:sp>
     </p:spTree>
   </p:cSld>
   <p:clrMapOvr>
@@ -6354,6 +6444,51 @@
           </a:p>
         </p:txBody>
       </p:sp>
+      <p:sp>
+        <p:nvSpPr>
+          <p:cNvPr id="4" name="Text 2">
+            <a:hlinkClick r:id="rId2" tooltip="" action="ppaction://hlinksldjump"/>
+          </p:cNvPr>
+          <p:cNvSpPr/>
+          <p:nvPr/>
+        </p:nvSpPr>
+        <p:spPr>
+          <a:xfrm>
+            <a:off x="7772400" y="4846320"/>
+            <a:ext cx="1097280" cy="0"/>
+          </a:xfrm>
+          <a:prstGeom prst="rect">
+            <a:avLst/>
+          </a:prstGeom>
+          <a:noFill/>
+          <a:ln/>
+        </p:spPr>
+        <p:txBody>
+          <a:bodyPr wrap="square" rtlCol="0" anchor="ctr"/>
+          <a:lstStyle/>
+          <a:p>
+            <a:pPr algn="r" indent="0" marL="0">
+              <a:buNone/>
+            </a:pPr>
+            <a:r>
+              <a:rPr lang="en-US" sz="1000" u="sng" dirty="0">
+                <a:solidFill>
+                  <a:srgbClr val="0563C1"/>
+                </a:solidFill>
+                <a:hlinkClick r:id="rId2" action="ppaction://hlinksldjump" tooltip="">
+                  <a:extLst>
+                    <a:ext uri="{A12FA001-AC4F-418D-AE19-62706E023703}">
+                      <ahyp:hlinkClr xmlns:ahyp="http://schemas.microsoft.com/office/drawing/2018/hyperlinkcolor" val="tx"/>
+                    </a:ext>
+                  </a:extLst>
+                </a:hlinkClick>
+              </a:rPr>
+              <a:t>🏠 Daftar Isi</a:t>
+            </a:r>
+            <a:endParaRPr lang="en-US" sz="1000" dirty="0"/>
+          </a:p>
+        </p:txBody>
+      </p:sp>
     </p:spTree>
   </p:cSld>
   <p:clrMapOvr>
@@ -6625,6 +6760,51 @@
           </a:p>
         </p:txBody>
       </p:sp>
+      <p:sp>
+        <p:nvSpPr>
+          <p:cNvPr id="4" name="Text 2">
+            <a:hlinkClick r:id="rId2" tooltip="" action="ppaction://hlinksldjump"/>
+          </p:cNvPr>
+          <p:cNvSpPr/>
+          <p:nvPr/>
+        </p:nvSpPr>
+        <p:spPr>
+          <a:xfrm>
+            <a:off x="7772400" y="4846320"/>
+            <a:ext cx="1097280" cy="0"/>
+          </a:xfrm>
+          <a:prstGeom prst="rect">
+            <a:avLst/>
+          </a:prstGeom>
+          <a:noFill/>
+          <a:ln/>
+        </p:spPr>
+        <p:txBody>
+          <a:bodyPr wrap="square" rtlCol="0" anchor="ctr"/>
+          <a:lstStyle/>
+          <a:p>
+            <a:pPr algn="r" indent="0" marL="0">
+              <a:buNone/>
+            </a:pPr>
+            <a:r>
+              <a:rPr lang="en-US" sz="1000" u="sng" dirty="0">
+                <a:solidFill>
+                  <a:srgbClr val="0563C1"/>
+                </a:solidFill>
+                <a:hlinkClick r:id="rId2" action="ppaction://hlinksldjump" tooltip="">
+                  <a:extLst>
+                    <a:ext uri="{A12FA001-AC4F-418D-AE19-62706E023703}">
+                      <ahyp:hlinkClr xmlns:ahyp="http://schemas.microsoft.com/office/drawing/2018/hyperlinkcolor" val="tx"/>
+                    </a:ext>
+                  </a:extLst>
+                </a:hlinkClick>
+              </a:rPr>
+              <a:t>🏠 Daftar Isi</a:t>
+            </a:r>
+            <a:endParaRPr lang="en-US" sz="1000" dirty="0"/>
+          </a:p>
+        </p:txBody>
+      </p:sp>
     </p:spTree>
   </p:cSld>
   <p:clrMapOvr>
@@ -6897,6 +7077,51 @@
           </a:p>
         </p:txBody>
       </p:sp>
+      <p:sp>
+        <p:nvSpPr>
+          <p:cNvPr id="5" name="Text 3">
+            <a:hlinkClick r:id="rId2" tooltip="" action="ppaction://hlinksldjump"/>
+          </p:cNvPr>
+          <p:cNvSpPr/>
+          <p:nvPr/>
+        </p:nvSpPr>
+        <p:spPr>
+          <a:xfrm>
+            <a:off x="7772400" y="4846320"/>
+            <a:ext cx="1097280" cy="0"/>
+          </a:xfrm>
+          <a:prstGeom prst="rect">
+            <a:avLst/>
+          </a:prstGeom>
+          <a:noFill/>
+          <a:ln/>
+        </p:spPr>
+        <p:txBody>
+          <a:bodyPr wrap="square" rtlCol="0" anchor="ctr"/>
+          <a:lstStyle/>
+          <a:p>
+            <a:pPr algn="r" indent="0" marL="0">
+              <a:buNone/>
+            </a:pPr>
+            <a:r>
+              <a:rPr lang="en-US" sz="1000" u="sng" dirty="0">
+                <a:solidFill>
+                  <a:srgbClr val="0563C1"/>
+                </a:solidFill>
+                <a:hlinkClick r:id="rId2" action="ppaction://hlinksldjump" tooltip="">
+                  <a:extLst>
+                    <a:ext uri="{A12FA001-AC4F-418D-AE19-62706E023703}">
+                      <ahyp:hlinkClr xmlns:ahyp="http://schemas.microsoft.com/office/drawing/2018/hyperlinkcolor" val="tx"/>
+                    </a:ext>
+                  </a:extLst>
+                </a:hlinkClick>
+              </a:rPr>
+              <a:t>🏠 Daftar Isi</a:t>
+            </a:r>
+            <a:endParaRPr lang="en-US" sz="1000" dirty="0"/>
+          </a:p>
+        </p:txBody>
+      </p:sp>
     </p:spTree>
   </p:cSld>
   <p:clrMapOvr>
@@ -7130,6 +7355,51 @@
           </a:p>
         </p:txBody>
       </p:sp>
+      <p:sp>
+        <p:nvSpPr>
+          <p:cNvPr id="4" name="Text 2">
+            <a:hlinkClick r:id="rId1" tooltip="" action="ppaction://hlinksldjump"/>
+          </p:cNvPr>
+          <p:cNvSpPr/>
+          <p:nvPr/>
+        </p:nvSpPr>
+        <p:spPr>
+          <a:xfrm>
+            <a:off x="7772400" y="4846320"/>
+            <a:ext cx="1097280" cy="0"/>
+          </a:xfrm>
+          <a:prstGeom prst="rect">
+            <a:avLst/>
+          </a:prstGeom>
+          <a:noFill/>
+          <a:ln/>
+        </p:spPr>
+        <p:txBody>
+          <a:bodyPr wrap="square" rtlCol="0" anchor="ctr"/>
+          <a:lstStyle/>
+          <a:p>
+            <a:pPr algn="r" indent="0" marL="0">
+              <a:buNone/>
+            </a:pPr>
+            <a:r>
+              <a:rPr lang="en-US" sz="1000" u="sng" dirty="0">
+                <a:solidFill>
+                  <a:srgbClr val="0563C1"/>
+                </a:solidFill>
+                <a:hlinkClick r:id="rId1" action="ppaction://hlinksldjump" tooltip="">
+                  <a:extLst>
+                    <a:ext uri="{A12FA001-AC4F-418D-AE19-62706E023703}">
+                      <ahyp:hlinkClr xmlns:ahyp="http://schemas.microsoft.com/office/drawing/2018/hyperlinkcolor" val="tx"/>
+                    </a:ext>
+                  </a:extLst>
+                </a:hlinkClick>
+              </a:rPr>
+              <a:t>🏠 Daftar Isi</a:t>
+            </a:r>
+            <a:endParaRPr lang="en-US" sz="1000" dirty="0"/>
+          </a:p>
+        </p:txBody>
+      </p:sp>
     </p:spTree>
   </p:cSld>
   <p:clrMapOvr>
@@ -9512,6 +9782,51 @@
           </a:p>
         </p:txBody>
       </p:sp>
+      <p:sp>
+        <p:nvSpPr>
+          <p:cNvPr id="4" name="Text 2">
+            <a:hlinkClick r:id="rId1" tooltip="" action="ppaction://hlinksldjump"/>
+          </p:cNvPr>
+          <p:cNvSpPr/>
+          <p:nvPr/>
+        </p:nvSpPr>
+        <p:spPr>
+          <a:xfrm>
+            <a:off x="7772400" y="4846320"/>
+            <a:ext cx="1097280" cy="0"/>
+          </a:xfrm>
+          <a:prstGeom prst="rect">
+            <a:avLst/>
+          </a:prstGeom>
+          <a:noFill/>
+          <a:ln/>
+        </p:spPr>
+        <p:txBody>
+          <a:bodyPr wrap="square" rtlCol="0" anchor="ctr"/>
+          <a:lstStyle/>
+          <a:p>
+            <a:pPr algn="r" indent="0" marL="0">
+              <a:buNone/>
+            </a:pPr>
+            <a:r>
+              <a:rPr lang="en-US" sz="1000" u="sng" dirty="0">
+                <a:solidFill>
+                  <a:srgbClr val="0563C1"/>
+                </a:solidFill>
+                <a:hlinkClick r:id="rId1" action="ppaction://hlinksldjump" tooltip="">
+                  <a:extLst>
+                    <a:ext uri="{A12FA001-AC4F-418D-AE19-62706E023703}">
+                      <ahyp:hlinkClr xmlns:ahyp="http://schemas.microsoft.com/office/drawing/2018/hyperlinkcolor" val="tx"/>
+                    </a:ext>
+                  </a:extLst>
+                </a:hlinkClick>
+              </a:rPr>
+              <a:t>🏠 Daftar Isi</a:t>
+            </a:r>
+            <a:endParaRPr lang="en-US" sz="1000" dirty="0"/>
+          </a:p>
+        </p:txBody>
+      </p:sp>
     </p:spTree>
   </p:cSld>
   <p:clrMapOvr>
@@ -9771,6 +10086,51 @@
           </a:p>
         </p:txBody>
       </p:sp>
+      <p:sp>
+        <p:nvSpPr>
+          <p:cNvPr id="4" name="Text 2">
+            <a:hlinkClick r:id="rId1" tooltip="" action="ppaction://hlinksldjump"/>
+          </p:cNvPr>
+          <p:cNvSpPr/>
+          <p:nvPr/>
+        </p:nvSpPr>
+        <p:spPr>
+          <a:xfrm>
+            <a:off x="7772400" y="4846320"/>
+            <a:ext cx="1097280" cy="0"/>
+          </a:xfrm>
+          <a:prstGeom prst="rect">
+            <a:avLst/>
+          </a:prstGeom>
+          <a:noFill/>
+          <a:ln/>
+        </p:spPr>
+        <p:txBody>
+          <a:bodyPr wrap="square" rtlCol="0" anchor="ctr"/>
+          <a:lstStyle/>
+          <a:p>
+            <a:pPr algn="r" indent="0" marL="0">
+              <a:buNone/>
+            </a:pPr>
+            <a:r>
+              <a:rPr lang="en-US" sz="1000" u="sng" dirty="0">
+                <a:solidFill>
+                  <a:srgbClr val="0563C1"/>
+                </a:solidFill>
+                <a:hlinkClick r:id="rId1" action="ppaction://hlinksldjump" tooltip="">
+                  <a:extLst>
+                    <a:ext uri="{A12FA001-AC4F-418D-AE19-62706E023703}">
+                      <ahyp:hlinkClr xmlns:ahyp="http://schemas.microsoft.com/office/drawing/2018/hyperlinkcolor" val="tx"/>
+                    </a:ext>
+                  </a:extLst>
+                </a:hlinkClick>
+              </a:rPr>
+              <a:t>🏠 Daftar Isi</a:t>
+            </a:r>
+            <a:endParaRPr lang="en-US" sz="1000" dirty="0"/>
+          </a:p>
+        </p:txBody>
+      </p:sp>
     </p:spTree>
   </p:cSld>
   <p:clrMapOvr>
@@ -10060,6 +10420,51 @@
           </a:p>
         </p:txBody>
       </p:sp>
+      <p:sp>
+        <p:nvSpPr>
+          <p:cNvPr id="4" name="Text 2">
+            <a:hlinkClick r:id="rId1" tooltip="" action="ppaction://hlinksldjump"/>
+          </p:cNvPr>
+          <p:cNvSpPr/>
+          <p:nvPr/>
+        </p:nvSpPr>
+        <p:spPr>
+          <a:xfrm>
+            <a:off x="7772400" y="4846320"/>
+            <a:ext cx="1097280" cy="0"/>
+          </a:xfrm>
+          <a:prstGeom prst="rect">
+            <a:avLst/>
+          </a:prstGeom>
+          <a:noFill/>
+          <a:ln/>
+        </p:spPr>
+        <p:txBody>
+          <a:bodyPr wrap="square" rtlCol="0" anchor="ctr"/>
+          <a:lstStyle/>
+          <a:p>
+            <a:pPr algn="r" indent="0" marL="0">
+              <a:buNone/>
+            </a:pPr>
+            <a:r>
+              <a:rPr lang="en-US" sz="1000" u="sng" dirty="0">
+                <a:solidFill>
+                  <a:srgbClr val="0563C1"/>
+                </a:solidFill>
+                <a:hlinkClick r:id="rId1" action="ppaction://hlinksldjump" tooltip="">
+                  <a:extLst>
+                    <a:ext uri="{A12FA001-AC4F-418D-AE19-62706E023703}">
+                      <ahyp:hlinkClr xmlns:ahyp="http://schemas.microsoft.com/office/drawing/2018/hyperlinkcolor" val="tx"/>
+                    </a:ext>
+                  </a:extLst>
+                </a:hlinkClick>
+              </a:rPr>
+              <a:t>🏠 Daftar Isi</a:t>
+            </a:r>
+            <a:endParaRPr lang="en-US" sz="1000" dirty="0"/>
+          </a:p>
+        </p:txBody>
+      </p:sp>
     </p:spTree>
   </p:cSld>
   <p:clrMapOvr>
@@ -10268,6 +10673,51 @@
           </a:p>
         </p:txBody>
       </p:sp>
+      <p:sp>
+        <p:nvSpPr>
+          <p:cNvPr id="4" name="Text 2">
+            <a:hlinkClick r:id="rId1" tooltip="" action="ppaction://hlinksldjump"/>
+          </p:cNvPr>
+          <p:cNvSpPr/>
+          <p:nvPr/>
+        </p:nvSpPr>
+        <p:spPr>
+          <a:xfrm>
+            <a:off x="7772400" y="4846320"/>
+            <a:ext cx="1097280" cy="0"/>
+          </a:xfrm>
+          <a:prstGeom prst="rect">
+            <a:avLst/>
+          </a:prstGeom>
+          <a:noFill/>
+          <a:ln/>
+        </p:spPr>
+        <p:txBody>
+          <a:bodyPr wrap="square" rtlCol="0" anchor="ctr"/>
+          <a:lstStyle/>
+          <a:p>
+            <a:pPr algn="r" indent="0" marL="0">
+              <a:buNone/>
+            </a:pPr>
+            <a:r>
+              <a:rPr lang="en-US" sz="1000" u="sng" dirty="0">
+                <a:solidFill>
+                  <a:srgbClr val="0563C1"/>
+                </a:solidFill>
+                <a:hlinkClick r:id="rId1" action="ppaction://hlinksldjump" tooltip="">
+                  <a:extLst>
+                    <a:ext uri="{A12FA001-AC4F-418D-AE19-62706E023703}">
+                      <ahyp:hlinkClr xmlns:ahyp="http://schemas.microsoft.com/office/drawing/2018/hyperlinkcolor" val="tx"/>
+                    </a:ext>
+                  </a:extLst>
+                </a:hlinkClick>
+              </a:rPr>
+              <a:t>🏠 Daftar Isi</a:t>
+            </a:r>
+            <a:endParaRPr lang="en-US" sz="1000" dirty="0"/>
+          </a:p>
+        </p:txBody>
+      </p:sp>
     </p:spTree>
   </p:cSld>
   <p:clrMapOvr>
@@ -10490,6 +10940,51 @@
           </a:p>
         </p:txBody>
       </p:sp>
+      <p:sp>
+        <p:nvSpPr>
+          <p:cNvPr id="4" name="Text 2">
+            <a:hlinkClick r:id="rId1" tooltip="" action="ppaction://hlinksldjump"/>
+          </p:cNvPr>
+          <p:cNvSpPr/>
+          <p:nvPr/>
+        </p:nvSpPr>
+        <p:spPr>
+          <a:xfrm>
+            <a:off x="7772400" y="4846320"/>
+            <a:ext cx="1097280" cy="0"/>
+          </a:xfrm>
+          <a:prstGeom prst="rect">
+            <a:avLst/>
+          </a:prstGeom>
+          <a:noFill/>
+          <a:ln/>
+        </p:spPr>
+        <p:txBody>
+          <a:bodyPr wrap="square" rtlCol="0" anchor="ctr"/>
+          <a:lstStyle/>
+          <a:p>
+            <a:pPr algn="r" indent="0" marL="0">
+              <a:buNone/>
+            </a:pPr>
+            <a:r>
+              <a:rPr lang="en-US" sz="1000" u="sng" dirty="0">
+                <a:solidFill>
+                  <a:srgbClr val="0563C1"/>
+                </a:solidFill>
+                <a:hlinkClick r:id="rId1" action="ppaction://hlinksldjump" tooltip="">
+                  <a:extLst>
+                    <a:ext uri="{A12FA001-AC4F-418D-AE19-62706E023703}">
+                      <ahyp:hlinkClr xmlns:ahyp="http://schemas.microsoft.com/office/drawing/2018/hyperlinkcolor" val="tx"/>
+                    </a:ext>
+                  </a:extLst>
+                </a:hlinkClick>
+              </a:rPr>
+              <a:t>🏠 Daftar Isi</a:t>
+            </a:r>
+            <a:endParaRPr lang="en-US" sz="1000" dirty="0"/>
+          </a:p>
+        </p:txBody>
+      </p:sp>
     </p:spTree>
   </p:cSld>
   <p:clrMapOvr>
@@ -10777,6 +11272,51 @@
           </a:p>
         </p:txBody>
       </p:sp>
+      <p:sp>
+        <p:nvSpPr>
+          <p:cNvPr id="4" name="Text 2">
+            <a:hlinkClick r:id="rId1" tooltip="" action="ppaction://hlinksldjump"/>
+          </p:cNvPr>
+          <p:cNvSpPr/>
+          <p:nvPr/>
+        </p:nvSpPr>
+        <p:spPr>
+          <a:xfrm>
+            <a:off x="7772400" y="4846320"/>
+            <a:ext cx="1097280" cy="0"/>
+          </a:xfrm>
+          <a:prstGeom prst="rect">
+            <a:avLst/>
+          </a:prstGeom>
+          <a:noFill/>
+          <a:ln/>
+        </p:spPr>
+        <p:txBody>
+          <a:bodyPr wrap="square" rtlCol="0" anchor="ctr"/>
+          <a:lstStyle/>
+          <a:p>
+            <a:pPr algn="r" indent="0" marL="0">
+              <a:buNone/>
+            </a:pPr>
+            <a:r>
+              <a:rPr lang="en-US" sz="1000" u="sng" dirty="0">
+                <a:solidFill>
+                  <a:srgbClr val="0563C1"/>
+                </a:solidFill>
+                <a:hlinkClick r:id="rId1" action="ppaction://hlinksldjump" tooltip="">
+                  <a:extLst>
+                    <a:ext uri="{A12FA001-AC4F-418D-AE19-62706E023703}">
+                      <ahyp:hlinkClr xmlns:ahyp="http://schemas.microsoft.com/office/drawing/2018/hyperlinkcolor" val="tx"/>
+                    </a:ext>
+                  </a:extLst>
+                </a:hlinkClick>
+              </a:rPr>
+              <a:t>🏠 Daftar Isi</a:t>
+            </a:r>
+            <a:endParaRPr lang="en-US" sz="1000" dirty="0"/>
+          </a:p>
+        </p:txBody>
+      </p:sp>
     </p:spTree>
   </p:cSld>
   <p:clrMapOvr>
@@ -11004,6 +11544,51 @@
           </a:p>
         </p:txBody>
       </p:sp>
+      <p:sp>
+        <p:nvSpPr>
+          <p:cNvPr id="4" name="Text 2">
+            <a:hlinkClick r:id="rId1" tooltip="" action="ppaction://hlinksldjump"/>
+          </p:cNvPr>
+          <p:cNvSpPr/>
+          <p:nvPr/>
+        </p:nvSpPr>
+        <p:spPr>
+          <a:xfrm>
+            <a:off x="7772400" y="4846320"/>
+            <a:ext cx="1097280" cy="0"/>
+          </a:xfrm>
+          <a:prstGeom prst="rect">
+            <a:avLst/>
+          </a:prstGeom>
+          <a:noFill/>
+          <a:ln/>
+        </p:spPr>
+        <p:txBody>
+          <a:bodyPr wrap="square" rtlCol="0" anchor="ctr"/>
+          <a:lstStyle/>
+          <a:p>
+            <a:pPr algn="r" indent="0" marL="0">
+              <a:buNone/>
+            </a:pPr>
+            <a:r>
+              <a:rPr lang="en-US" sz="1000" u="sng" dirty="0">
+                <a:solidFill>
+                  <a:srgbClr val="0563C1"/>
+                </a:solidFill>
+                <a:hlinkClick r:id="rId1" action="ppaction://hlinksldjump" tooltip="">
+                  <a:extLst>
+                    <a:ext uri="{A12FA001-AC4F-418D-AE19-62706E023703}">
+                      <ahyp:hlinkClr xmlns:ahyp="http://schemas.microsoft.com/office/drawing/2018/hyperlinkcolor" val="tx"/>
+                    </a:ext>
+                  </a:extLst>
+                </a:hlinkClick>
+              </a:rPr>
+              <a:t>🏠 Daftar Isi</a:t>
+            </a:r>
+            <a:endParaRPr lang="en-US" sz="1000" dirty="0"/>
+          </a:p>
+        </p:txBody>
+      </p:sp>
     </p:spTree>
   </p:cSld>
   <p:clrMapOvr>
@@ -11735,6 +12320,51 @@
           </a:p>
         </p:txBody>
       </p:sp>
+      <p:sp>
+        <p:nvSpPr>
+          <p:cNvPr id="4" name="Text 2">
+            <a:hlinkClick r:id="rId1" tooltip="" action="ppaction://hlinksldjump"/>
+          </p:cNvPr>
+          <p:cNvSpPr/>
+          <p:nvPr/>
+        </p:nvSpPr>
+        <p:spPr>
+          <a:xfrm>
+            <a:off x="7772400" y="4846320"/>
+            <a:ext cx="1097280" cy="0"/>
+          </a:xfrm>
+          <a:prstGeom prst="rect">
+            <a:avLst/>
+          </a:prstGeom>
+          <a:noFill/>
+          <a:ln/>
+        </p:spPr>
+        <p:txBody>
+          <a:bodyPr wrap="square" rtlCol="0" anchor="ctr"/>
+          <a:lstStyle/>
+          <a:p>
+            <a:pPr algn="r" indent="0" marL="0">
+              <a:buNone/>
+            </a:pPr>
+            <a:r>
+              <a:rPr lang="en-US" sz="1000" u="sng" dirty="0">
+                <a:solidFill>
+                  <a:srgbClr val="0563C1"/>
+                </a:solidFill>
+                <a:hlinkClick r:id="rId1" action="ppaction://hlinksldjump" tooltip="">
+                  <a:extLst>
+                    <a:ext uri="{A12FA001-AC4F-418D-AE19-62706E023703}">
+                      <ahyp:hlinkClr xmlns:ahyp="http://schemas.microsoft.com/office/drawing/2018/hyperlinkcolor" val="tx"/>
+                    </a:ext>
+                  </a:extLst>
+                </a:hlinkClick>
+              </a:rPr>
+              <a:t>🏠 Daftar Isi</a:t>
+            </a:r>
+            <a:endParaRPr lang="en-US" sz="1000" dirty="0"/>
+          </a:p>
+        </p:txBody>
+      </p:sp>
     </p:spTree>
   </p:cSld>
   <p:clrMapOvr>
@@ -12030,6 +12660,51 @@
           </a:p>
         </p:txBody>
       </p:sp>
+      <p:sp>
+        <p:nvSpPr>
+          <p:cNvPr id="4" name="Text 2">
+            <a:hlinkClick r:id="rId1" tooltip="" action="ppaction://hlinksldjump"/>
+          </p:cNvPr>
+          <p:cNvSpPr/>
+          <p:nvPr/>
+        </p:nvSpPr>
+        <p:spPr>
+          <a:xfrm>
+            <a:off x="7772400" y="4846320"/>
+            <a:ext cx="1097280" cy="0"/>
+          </a:xfrm>
+          <a:prstGeom prst="rect">
+            <a:avLst/>
+          </a:prstGeom>
+          <a:noFill/>
+          <a:ln/>
+        </p:spPr>
+        <p:txBody>
+          <a:bodyPr wrap="square" rtlCol="0" anchor="ctr"/>
+          <a:lstStyle/>
+          <a:p>
+            <a:pPr algn="r" indent="0" marL="0">
+              <a:buNone/>
+            </a:pPr>
+            <a:r>
+              <a:rPr lang="en-US" sz="1000" u="sng" dirty="0">
+                <a:solidFill>
+                  <a:srgbClr val="0563C1"/>
+                </a:solidFill>
+                <a:hlinkClick r:id="rId1" action="ppaction://hlinksldjump" tooltip="">
+                  <a:extLst>
+                    <a:ext uri="{A12FA001-AC4F-418D-AE19-62706E023703}">
+                      <ahyp:hlinkClr xmlns:ahyp="http://schemas.microsoft.com/office/drawing/2018/hyperlinkcolor" val="tx"/>
+                    </a:ext>
+                  </a:extLst>
+                </a:hlinkClick>
+              </a:rPr>
+              <a:t>🏠 Daftar Isi</a:t>
+            </a:r>
+            <a:endParaRPr lang="en-US" sz="1000" dirty="0"/>
+          </a:p>
+        </p:txBody>
+      </p:sp>
     </p:spTree>
   </p:cSld>
   <p:clrMapOvr>
@@ -13223,6 +13898,51 @@
           </a:p>
         </p:txBody>
       </p:sp>
+      <p:sp>
+        <p:nvSpPr>
+          <p:cNvPr id="4" name="Text 2">
+            <a:hlinkClick r:id="rId1" tooltip="" action="ppaction://hlinksldjump"/>
+          </p:cNvPr>
+          <p:cNvSpPr/>
+          <p:nvPr/>
+        </p:nvSpPr>
+        <p:spPr>
+          <a:xfrm>
+            <a:off x="7772400" y="4846320"/>
+            <a:ext cx="1097280" cy="0"/>
+          </a:xfrm>
+          <a:prstGeom prst="rect">
+            <a:avLst/>
+          </a:prstGeom>
+          <a:noFill/>
+          <a:ln/>
+        </p:spPr>
+        <p:txBody>
+          <a:bodyPr wrap="square" rtlCol="0" anchor="ctr"/>
+          <a:lstStyle/>
+          <a:p>
+            <a:pPr algn="r" indent="0" marL="0">
+              <a:buNone/>
+            </a:pPr>
+            <a:r>
+              <a:rPr lang="en-US" sz="1000" u="sng" dirty="0">
+                <a:solidFill>
+                  <a:srgbClr val="0563C1"/>
+                </a:solidFill>
+                <a:hlinkClick r:id="rId1" action="ppaction://hlinksldjump" tooltip="">
+                  <a:extLst>
+                    <a:ext uri="{A12FA001-AC4F-418D-AE19-62706E023703}">
+                      <ahyp:hlinkClr xmlns:ahyp="http://schemas.microsoft.com/office/drawing/2018/hyperlinkcolor" val="tx"/>
+                    </a:ext>
+                  </a:extLst>
+                </a:hlinkClick>
+              </a:rPr>
+              <a:t>🏠 Daftar Isi</a:t>
+            </a:r>
+            <a:endParaRPr lang="en-US" sz="1000" dirty="0"/>
+          </a:p>
+        </p:txBody>
+      </p:sp>
     </p:spTree>
   </p:cSld>
   <p:clrMapOvr>
@@ -15232,6 +15952,51 @@
           </a:p>
         </p:txBody>
       </p:sp>
+      <p:sp>
+        <p:nvSpPr>
+          <p:cNvPr id="4" name="Text 2">
+            <a:hlinkClick r:id="rId2" tooltip="" action="ppaction://hlinksldjump"/>
+          </p:cNvPr>
+          <p:cNvSpPr/>
+          <p:nvPr/>
+        </p:nvSpPr>
+        <p:spPr>
+          <a:xfrm>
+            <a:off x="7772400" y="4846320"/>
+            <a:ext cx="1097280" cy="0"/>
+          </a:xfrm>
+          <a:prstGeom prst="rect">
+            <a:avLst/>
+          </a:prstGeom>
+          <a:noFill/>
+          <a:ln/>
+        </p:spPr>
+        <p:txBody>
+          <a:bodyPr wrap="square" rtlCol="0" anchor="ctr"/>
+          <a:lstStyle/>
+          <a:p>
+            <a:pPr algn="r" indent="0" marL="0">
+              <a:buNone/>
+            </a:pPr>
+            <a:r>
+              <a:rPr lang="en-US" sz="1000" u="sng" dirty="0">
+                <a:solidFill>
+                  <a:srgbClr val="0563C1"/>
+                </a:solidFill>
+                <a:hlinkClick r:id="rId2" action="ppaction://hlinksldjump" tooltip="">
+                  <a:extLst>
+                    <a:ext uri="{A12FA001-AC4F-418D-AE19-62706E023703}">
+                      <ahyp:hlinkClr xmlns:ahyp="http://schemas.microsoft.com/office/drawing/2018/hyperlinkcolor" val="tx"/>
+                    </a:ext>
+                  </a:extLst>
+                </a:hlinkClick>
+              </a:rPr>
+              <a:t>🏠 Daftar Isi</a:t>
+            </a:r>
+            <a:endParaRPr lang="en-US" sz="1000" dirty="0"/>
+          </a:p>
+        </p:txBody>
+      </p:sp>
     </p:spTree>
   </p:cSld>
   <p:clrMapOvr>
@@ -18156,6 +18921,51 @@
           </a:p>
         </p:txBody>
       </p:sp>
+      <p:sp>
+        <p:nvSpPr>
+          <p:cNvPr id="5" name="Text 3">
+            <a:hlinkClick r:id="rId1" tooltip="" action="ppaction://hlinksldjump"/>
+          </p:cNvPr>
+          <p:cNvSpPr/>
+          <p:nvPr/>
+        </p:nvSpPr>
+        <p:spPr>
+          <a:xfrm>
+            <a:off x="7772400" y="4846320"/>
+            <a:ext cx="1097280" cy="0"/>
+          </a:xfrm>
+          <a:prstGeom prst="rect">
+            <a:avLst/>
+          </a:prstGeom>
+          <a:noFill/>
+          <a:ln/>
+        </p:spPr>
+        <p:txBody>
+          <a:bodyPr wrap="square" rtlCol="0" anchor="ctr"/>
+          <a:lstStyle/>
+          <a:p>
+            <a:pPr algn="r" indent="0" marL="0">
+              <a:buNone/>
+            </a:pPr>
+            <a:r>
+              <a:rPr lang="en-US" sz="1000" u="sng" dirty="0">
+                <a:solidFill>
+                  <a:srgbClr val="0563C1"/>
+                </a:solidFill>
+                <a:hlinkClick r:id="rId1" action="ppaction://hlinksldjump" tooltip="">
+                  <a:extLst>
+                    <a:ext uri="{A12FA001-AC4F-418D-AE19-62706E023703}">
+                      <ahyp:hlinkClr xmlns:ahyp="http://schemas.microsoft.com/office/drawing/2018/hyperlinkcolor" val="tx"/>
+                    </a:ext>
+                  </a:extLst>
+                </a:hlinkClick>
+              </a:rPr>
+              <a:t>🏠 Daftar Isi</a:t>
+            </a:r>
+            <a:endParaRPr lang="en-US" sz="1000" dirty="0"/>
+          </a:p>
+        </p:txBody>
+      </p:sp>
     </p:spTree>
   </p:cSld>
   <p:clrMapOvr>
@@ -19188,6 +19998,51 @@
           </a:p>
         </p:txBody>
       </p:sp>
+      <p:sp>
+        <p:nvSpPr>
+          <p:cNvPr id="4" name="Text 2">
+            <a:hlinkClick r:id="rId1" tooltip="" action="ppaction://hlinksldjump"/>
+          </p:cNvPr>
+          <p:cNvSpPr/>
+          <p:nvPr/>
+        </p:nvSpPr>
+        <p:spPr>
+          <a:xfrm>
+            <a:off x="7772400" y="4846320"/>
+            <a:ext cx="1097280" cy="0"/>
+          </a:xfrm>
+          <a:prstGeom prst="rect">
+            <a:avLst/>
+          </a:prstGeom>
+          <a:noFill/>
+          <a:ln/>
+        </p:spPr>
+        <p:txBody>
+          <a:bodyPr wrap="square" rtlCol="0" anchor="ctr"/>
+          <a:lstStyle/>
+          <a:p>
+            <a:pPr algn="r" indent="0" marL="0">
+              <a:buNone/>
+            </a:pPr>
+            <a:r>
+              <a:rPr lang="en-US" sz="1000" u="sng" dirty="0">
+                <a:solidFill>
+                  <a:srgbClr val="0563C1"/>
+                </a:solidFill>
+                <a:hlinkClick r:id="rId1" action="ppaction://hlinksldjump" tooltip="">
+                  <a:extLst>
+                    <a:ext uri="{A12FA001-AC4F-418D-AE19-62706E023703}">
+                      <ahyp:hlinkClr xmlns:ahyp="http://schemas.microsoft.com/office/drawing/2018/hyperlinkcolor" val="tx"/>
+                    </a:ext>
+                  </a:extLst>
+                </a:hlinkClick>
+              </a:rPr>
+              <a:t>🏠 Daftar Isi</a:t>
+            </a:r>
+            <a:endParaRPr lang="en-US" sz="1000" dirty="0"/>
+          </a:p>
+        </p:txBody>
+      </p:sp>
     </p:spTree>
   </p:cSld>
   <p:clrMapOvr>
@@ -19273,6 +20128,51 @@
           </a:prstGeom>
         </p:spPr>
       </p:pic>
+      <p:sp>
+        <p:nvSpPr>
+          <p:cNvPr id="4" name="Text 1">
+            <a:hlinkClick r:id="rId2" tooltip="" action="ppaction://hlinksldjump"/>
+          </p:cNvPr>
+          <p:cNvSpPr/>
+          <p:nvPr/>
+        </p:nvSpPr>
+        <p:spPr>
+          <a:xfrm>
+            <a:off x="7772400" y="4846320"/>
+            <a:ext cx="1097280" cy="0"/>
+          </a:xfrm>
+          <a:prstGeom prst="rect">
+            <a:avLst/>
+          </a:prstGeom>
+          <a:noFill/>
+          <a:ln/>
+        </p:spPr>
+        <p:txBody>
+          <a:bodyPr wrap="square" rtlCol="0" anchor="ctr"/>
+          <a:lstStyle/>
+          <a:p>
+            <a:pPr algn="r" indent="0" marL="0">
+              <a:buNone/>
+            </a:pPr>
+            <a:r>
+              <a:rPr lang="en-US" sz="1000" u="sng" dirty="0">
+                <a:solidFill>
+                  <a:srgbClr val="0563C1"/>
+                </a:solidFill>
+                <a:hlinkClick r:id="rId2" action="ppaction://hlinksldjump" tooltip="">
+                  <a:extLst>
+                    <a:ext uri="{A12FA001-AC4F-418D-AE19-62706E023703}">
+                      <ahyp:hlinkClr xmlns:ahyp="http://schemas.microsoft.com/office/drawing/2018/hyperlinkcolor" val="tx"/>
+                    </a:ext>
+                  </a:extLst>
+                </a:hlinkClick>
+              </a:rPr>
+              <a:t>🏠 Daftar Isi</a:t>
+            </a:r>
+            <a:endParaRPr lang="en-US" sz="1000" dirty="0"/>
+          </a:p>
+        </p:txBody>
+      </p:sp>
     </p:spTree>
   </p:cSld>
   <p:clrMapOvr>
@@ -21310,6 +22210,51 @@
           </a:graphicData>
         </a:graphic>
       </p:graphicFrame>
+      <p:sp>
+        <p:nvSpPr>
+          <p:cNvPr id="4" name="Text 1">
+            <a:hlinkClick r:id="rId1" tooltip="" action="ppaction://hlinksldjump"/>
+          </p:cNvPr>
+          <p:cNvSpPr/>
+          <p:nvPr/>
+        </p:nvSpPr>
+        <p:spPr>
+          <a:xfrm>
+            <a:off x="7772400" y="4846320"/>
+            <a:ext cx="1097280" cy="0"/>
+          </a:xfrm>
+          <a:prstGeom prst="rect">
+            <a:avLst/>
+          </a:prstGeom>
+          <a:noFill/>
+          <a:ln/>
+        </p:spPr>
+        <p:txBody>
+          <a:bodyPr wrap="square" rtlCol="0" anchor="ctr"/>
+          <a:lstStyle/>
+          <a:p>
+            <a:pPr algn="r" indent="0" marL="0">
+              <a:buNone/>
+            </a:pPr>
+            <a:r>
+              <a:rPr lang="en-US" sz="1000" u="sng" dirty="0">
+                <a:solidFill>
+                  <a:srgbClr val="0563C1"/>
+                </a:solidFill>
+                <a:hlinkClick r:id="rId1" action="ppaction://hlinksldjump" tooltip="">
+                  <a:extLst>
+                    <a:ext uri="{A12FA001-AC4F-418D-AE19-62706E023703}">
+                      <ahyp:hlinkClr xmlns:ahyp="http://schemas.microsoft.com/office/drawing/2018/hyperlinkcolor" val="tx"/>
+                    </a:ext>
+                  </a:extLst>
+                </a:hlinkClick>
+              </a:rPr>
+              <a:t>🏠 Daftar Isi</a:t>
+            </a:r>
+            <a:endParaRPr lang="en-US" sz="1000" dirty="0"/>
+          </a:p>
+        </p:txBody>
+      </p:sp>
     </p:spTree>
   </p:cSld>
   <p:clrMapOvr>
@@ -21618,6 +22563,51 @@
               <a:t>NW Adaptif (Grid Search)</a:t>
             </a:r>
             <a:endParaRPr lang="en-US" sz="2200" dirty="0"/>
+          </a:p>
+        </p:txBody>
+      </p:sp>
+      <p:sp>
+        <p:nvSpPr>
+          <p:cNvPr id="4" name="Text 2">
+            <a:hlinkClick r:id="rId6" tooltip="" action="ppaction://hlinksldjump"/>
+          </p:cNvPr>
+          <p:cNvSpPr/>
+          <p:nvPr/>
+        </p:nvSpPr>
+        <p:spPr>
+          <a:xfrm>
+            <a:off x="7772400" y="4846320"/>
+            <a:ext cx="1097280" cy="0"/>
+          </a:xfrm>
+          <a:prstGeom prst="rect">
+            <a:avLst/>
+          </a:prstGeom>
+          <a:noFill/>
+          <a:ln/>
+        </p:spPr>
+        <p:txBody>
+          <a:bodyPr wrap="square" rtlCol="0" anchor="ctr"/>
+          <a:lstStyle/>
+          <a:p>
+            <a:pPr algn="r" indent="0" marL="0">
+              <a:buNone/>
+            </a:pPr>
+            <a:r>
+              <a:rPr lang="en-US" sz="1000" u="sng" dirty="0">
+                <a:solidFill>
+                  <a:srgbClr val="0563C1"/>
+                </a:solidFill>
+                <a:hlinkClick r:id="rId6" action="ppaction://hlinksldjump" tooltip="">
+                  <a:extLst>
+                    <a:ext uri="{A12FA001-AC4F-418D-AE19-62706E023703}">
+                      <ahyp:hlinkClr xmlns:ahyp="http://schemas.microsoft.com/office/drawing/2018/hyperlinkcolor" val="tx"/>
+                    </a:ext>
+                  </a:extLst>
+                </a:hlinkClick>
+              </a:rPr>
+              <a:t>🏠 Daftar Isi</a:t>
+            </a:r>
+            <a:endParaRPr lang="en-US" sz="1000" dirty="0"/>
           </a:p>
         </p:txBody>
       </p:sp>

</xml_diff>

<commit_message>
fix: ensure 100% of non-title slides have navigation link to Table of Contents
</commit_message>
<xml_diff>
--- a/Presentasi_Proposal_Update.pptx
+++ b/Presentasi_Proposal_Update.pptx
@@ -7800,6 +7800,51 @@
           </a:p>
         </p:txBody>
       </p:sp>
+      <p:sp>
+        <p:nvSpPr>
+          <p:cNvPr id="4" name="Text 2">
+            <a:hlinkClick r:id="rId2" tooltip="" action="ppaction://hlinksldjump"/>
+          </p:cNvPr>
+          <p:cNvSpPr/>
+          <p:nvPr/>
+        </p:nvSpPr>
+        <p:spPr>
+          <a:xfrm>
+            <a:off x="7772400" y="4846320"/>
+            <a:ext cx="1097280" cy="0"/>
+          </a:xfrm>
+          <a:prstGeom prst="rect">
+            <a:avLst/>
+          </a:prstGeom>
+          <a:noFill/>
+          <a:ln/>
+        </p:spPr>
+        <p:txBody>
+          <a:bodyPr wrap="square" rtlCol="0" anchor="ctr"/>
+          <a:lstStyle/>
+          <a:p>
+            <a:pPr algn="r" indent="0" marL="0">
+              <a:buNone/>
+            </a:pPr>
+            <a:r>
+              <a:rPr lang="en-US" sz="1000" u="sng" dirty="0">
+                <a:solidFill>
+                  <a:srgbClr val="0563C1"/>
+                </a:solidFill>
+                <a:hlinkClick r:id="rId2" action="ppaction://hlinksldjump" tooltip="">
+                  <a:extLst>
+                    <a:ext uri="{A12FA001-AC4F-418D-AE19-62706E023703}">
+                      <ahyp:hlinkClr xmlns:ahyp="http://schemas.microsoft.com/office/drawing/2018/hyperlinkcolor" val="tx"/>
+                    </a:ext>
+                  </a:extLst>
+                </a:hlinkClick>
+              </a:rPr>
+              <a:t>🏠 Daftar Isi</a:t>
+            </a:r>
+            <a:endParaRPr lang="en-US" sz="1000" dirty="0"/>
+          </a:p>
+        </p:txBody>
+      </p:sp>
     </p:spTree>
   </p:cSld>
   <p:clrMapOvr>
@@ -8124,6 +8169,51 @@
           </a:p>
         </p:txBody>
       </p:sp>
+      <p:sp>
+        <p:nvSpPr>
+          <p:cNvPr id="4" name="Text 2">
+            <a:hlinkClick r:id="rId1" tooltip="" action="ppaction://hlinksldjump"/>
+          </p:cNvPr>
+          <p:cNvSpPr/>
+          <p:nvPr/>
+        </p:nvSpPr>
+        <p:spPr>
+          <a:xfrm>
+            <a:off x="7772400" y="4846320"/>
+            <a:ext cx="1097280" cy="0"/>
+          </a:xfrm>
+          <a:prstGeom prst="rect">
+            <a:avLst/>
+          </a:prstGeom>
+          <a:noFill/>
+          <a:ln/>
+        </p:spPr>
+        <p:txBody>
+          <a:bodyPr wrap="square" rtlCol="0" anchor="ctr"/>
+          <a:lstStyle/>
+          <a:p>
+            <a:pPr algn="r" indent="0" marL="0">
+              <a:buNone/>
+            </a:pPr>
+            <a:r>
+              <a:rPr lang="en-US" sz="1000" u="sng" dirty="0">
+                <a:solidFill>
+                  <a:srgbClr val="0563C1"/>
+                </a:solidFill>
+                <a:hlinkClick r:id="rId1" action="ppaction://hlinksldjump" tooltip="">
+                  <a:extLst>
+                    <a:ext uri="{A12FA001-AC4F-418D-AE19-62706E023703}">
+                      <ahyp:hlinkClr xmlns:ahyp="http://schemas.microsoft.com/office/drawing/2018/hyperlinkcolor" val="tx"/>
+                    </a:ext>
+                  </a:extLst>
+                </a:hlinkClick>
+              </a:rPr>
+              <a:t>🏠 Daftar Isi</a:t>
+            </a:r>
+            <a:endParaRPr lang="en-US" sz="1000" dirty="0"/>
+          </a:p>
+        </p:txBody>
+      </p:sp>
     </p:spTree>
   </p:cSld>
   <p:clrMapOvr>
@@ -8411,6 +8501,51 @@
           </a:p>
         </p:txBody>
       </p:sp>
+      <p:sp>
+        <p:nvSpPr>
+          <p:cNvPr id="4" name="Text 2">
+            <a:hlinkClick r:id="rId1" tooltip="" action="ppaction://hlinksldjump"/>
+          </p:cNvPr>
+          <p:cNvSpPr/>
+          <p:nvPr/>
+        </p:nvSpPr>
+        <p:spPr>
+          <a:xfrm>
+            <a:off x="7772400" y="4846320"/>
+            <a:ext cx="1097280" cy="0"/>
+          </a:xfrm>
+          <a:prstGeom prst="rect">
+            <a:avLst/>
+          </a:prstGeom>
+          <a:noFill/>
+          <a:ln/>
+        </p:spPr>
+        <p:txBody>
+          <a:bodyPr wrap="square" rtlCol="0" anchor="ctr"/>
+          <a:lstStyle/>
+          <a:p>
+            <a:pPr algn="r" indent="0" marL="0">
+              <a:buNone/>
+            </a:pPr>
+            <a:r>
+              <a:rPr lang="en-US" sz="1000" u="sng" dirty="0">
+                <a:solidFill>
+                  <a:srgbClr val="0563C1"/>
+                </a:solidFill>
+                <a:hlinkClick r:id="rId1" action="ppaction://hlinksldjump" tooltip="">
+                  <a:extLst>
+                    <a:ext uri="{A12FA001-AC4F-418D-AE19-62706E023703}">
+                      <ahyp:hlinkClr xmlns:ahyp="http://schemas.microsoft.com/office/drawing/2018/hyperlinkcolor" val="tx"/>
+                    </a:ext>
+                  </a:extLst>
+                </a:hlinkClick>
+              </a:rPr>
+              <a:t>🏠 Daftar Isi</a:t>
+            </a:r>
+            <a:endParaRPr lang="en-US" sz="1000" dirty="0"/>
+          </a:p>
+        </p:txBody>
+      </p:sp>
     </p:spTree>
   </p:cSld>
   <p:clrMapOvr>
@@ -9515,6 +9650,51 @@
           </a:p>
         </p:txBody>
       </p:sp>
+      <p:sp>
+        <p:nvSpPr>
+          <p:cNvPr id="4" name="Text 2">
+            <a:hlinkClick r:id="rId1" tooltip="" action="ppaction://hlinksldjump"/>
+          </p:cNvPr>
+          <p:cNvSpPr/>
+          <p:nvPr/>
+        </p:nvSpPr>
+        <p:spPr>
+          <a:xfrm>
+            <a:off x="7772400" y="4846320"/>
+            <a:ext cx="1097280" cy="0"/>
+          </a:xfrm>
+          <a:prstGeom prst="rect">
+            <a:avLst/>
+          </a:prstGeom>
+          <a:noFill/>
+          <a:ln/>
+        </p:spPr>
+        <p:txBody>
+          <a:bodyPr wrap="square" rtlCol="0" anchor="ctr"/>
+          <a:lstStyle/>
+          <a:p>
+            <a:pPr algn="r" indent="0" marL="0">
+              <a:buNone/>
+            </a:pPr>
+            <a:r>
+              <a:rPr lang="en-US" sz="1000" u="sng" dirty="0">
+                <a:solidFill>
+                  <a:srgbClr val="0563C1"/>
+                </a:solidFill>
+                <a:hlinkClick r:id="rId1" action="ppaction://hlinksldjump" tooltip="">
+                  <a:extLst>
+                    <a:ext uri="{A12FA001-AC4F-418D-AE19-62706E023703}">
+                      <ahyp:hlinkClr xmlns:ahyp="http://schemas.microsoft.com/office/drawing/2018/hyperlinkcolor" val="tx"/>
+                    </a:ext>
+                  </a:extLst>
+                </a:hlinkClick>
+              </a:rPr>
+              <a:t>🏠 Daftar Isi</a:t>
+            </a:r>
+            <a:endParaRPr lang="en-US" sz="1000" dirty="0"/>
+          </a:p>
+        </p:txBody>
+      </p:sp>
     </p:spTree>
   </p:cSld>
   <p:clrMapOvr>
@@ -11811,6 +11991,51 @@
           </a:p>
         </p:txBody>
       </p:sp>
+      <p:sp>
+        <p:nvSpPr>
+          <p:cNvPr id="4" name="Text 2">
+            <a:hlinkClick r:id="rId1" tooltip="" action="ppaction://hlinksldjump"/>
+          </p:cNvPr>
+          <p:cNvSpPr/>
+          <p:nvPr/>
+        </p:nvSpPr>
+        <p:spPr>
+          <a:xfrm>
+            <a:off x="7772400" y="4846320"/>
+            <a:ext cx="1097280" cy="0"/>
+          </a:xfrm>
+          <a:prstGeom prst="rect">
+            <a:avLst/>
+          </a:prstGeom>
+          <a:noFill/>
+          <a:ln/>
+        </p:spPr>
+        <p:txBody>
+          <a:bodyPr wrap="square" rtlCol="0" anchor="ctr"/>
+          <a:lstStyle/>
+          <a:p>
+            <a:pPr algn="r" indent="0" marL="0">
+              <a:buNone/>
+            </a:pPr>
+            <a:r>
+              <a:rPr lang="en-US" sz="1000" u="sng" dirty="0">
+                <a:solidFill>
+                  <a:srgbClr val="0563C1"/>
+                </a:solidFill>
+                <a:hlinkClick r:id="rId1" action="ppaction://hlinksldjump" tooltip="">
+                  <a:extLst>
+                    <a:ext uri="{A12FA001-AC4F-418D-AE19-62706E023703}">
+                      <ahyp:hlinkClr xmlns:ahyp="http://schemas.microsoft.com/office/drawing/2018/hyperlinkcolor" val="tx"/>
+                    </a:ext>
+                  </a:extLst>
+                </a:hlinkClick>
+              </a:rPr>
+              <a:t>🏠 Daftar Isi</a:t>
+            </a:r>
+            <a:endParaRPr lang="en-US" sz="1000" dirty="0"/>
+          </a:p>
+        </p:txBody>
+      </p:sp>
     </p:spTree>
   </p:cSld>
   <p:clrMapOvr>
@@ -12126,6 +12351,51 @@
           </a:p>
         </p:txBody>
       </p:sp>
+      <p:sp>
+        <p:nvSpPr>
+          <p:cNvPr id="4" name="Text 2">
+            <a:hlinkClick r:id="rId1" tooltip="" action="ppaction://hlinksldjump"/>
+          </p:cNvPr>
+          <p:cNvSpPr/>
+          <p:nvPr/>
+        </p:nvSpPr>
+        <p:spPr>
+          <a:xfrm>
+            <a:off x="7772400" y="4846320"/>
+            <a:ext cx="1097280" cy="0"/>
+          </a:xfrm>
+          <a:prstGeom prst="rect">
+            <a:avLst/>
+          </a:prstGeom>
+          <a:noFill/>
+          <a:ln/>
+        </p:spPr>
+        <p:txBody>
+          <a:bodyPr wrap="square" rtlCol="0" anchor="ctr"/>
+          <a:lstStyle/>
+          <a:p>
+            <a:pPr algn="r" indent="0" marL="0">
+              <a:buNone/>
+            </a:pPr>
+            <a:r>
+              <a:rPr lang="en-US" sz="1000" u="sng" dirty="0">
+                <a:solidFill>
+                  <a:srgbClr val="0563C1"/>
+                </a:solidFill>
+                <a:hlinkClick r:id="rId1" action="ppaction://hlinksldjump" tooltip="">
+                  <a:extLst>
+                    <a:ext uri="{A12FA001-AC4F-418D-AE19-62706E023703}">
+                      <ahyp:hlinkClr xmlns:ahyp="http://schemas.microsoft.com/office/drawing/2018/hyperlinkcolor" val="tx"/>
+                    </a:ext>
+                  </a:extLst>
+                </a:hlinkClick>
+              </a:rPr>
+              <a:t>🏠 Daftar Isi</a:t>
+            </a:r>
+            <a:endParaRPr lang="en-US" sz="1000" dirty="0"/>
+          </a:p>
+        </p:txBody>
+      </p:sp>
     </p:spTree>
   </p:cSld>
   <p:clrMapOvr>
@@ -13050,6 +13320,51 @@
           </a:p>
         </p:txBody>
       </p:sp>
+      <p:sp>
+        <p:nvSpPr>
+          <p:cNvPr id="4" name="Text 2">
+            <a:hlinkClick r:id="rId1" tooltip="" action="ppaction://hlinksldjump"/>
+          </p:cNvPr>
+          <p:cNvSpPr/>
+          <p:nvPr/>
+        </p:nvSpPr>
+        <p:spPr>
+          <a:xfrm>
+            <a:off x="7772400" y="4846320"/>
+            <a:ext cx="1097280" cy="0"/>
+          </a:xfrm>
+          <a:prstGeom prst="rect">
+            <a:avLst/>
+          </a:prstGeom>
+          <a:noFill/>
+          <a:ln/>
+        </p:spPr>
+        <p:txBody>
+          <a:bodyPr wrap="square" rtlCol="0" anchor="ctr"/>
+          <a:lstStyle/>
+          <a:p>
+            <a:pPr algn="r" indent="0" marL="0">
+              <a:buNone/>
+            </a:pPr>
+            <a:r>
+              <a:rPr lang="en-US" sz="1000" u="sng" dirty="0">
+                <a:solidFill>
+                  <a:srgbClr val="0563C1"/>
+                </a:solidFill>
+                <a:hlinkClick r:id="rId1" action="ppaction://hlinksldjump" tooltip="">
+                  <a:extLst>
+                    <a:ext uri="{A12FA001-AC4F-418D-AE19-62706E023703}">
+                      <ahyp:hlinkClr xmlns:ahyp="http://schemas.microsoft.com/office/drawing/2018/hyperlinkcolor" val="tx"/>
+                    </a:ext>
+                  </a:extLst>
+                </a:hlinkClick>
+              </a:rPr>
+              <a:t>🏠 Daftar Isi</a:t>
+            </a:r>
+            <a:endParaRPr lang="en-US" sz="1000" dirty="0"/>
+          </a:p>
+        </p:txBody>
+      </p:sp>
     </p:spTree>
   </p:cSld>
   <p:clrMapOvr>
@@ -13339,6 +13654,51 @@
           </a:p>
         </p:txBody>
       </p:sp>
+      <p:sp>
+        <p:nvSpPr>
+          <p:cNvPr id="4" name="Text 2">
+            <a:hlinkClick r:id="rId1" tooltip="" action="ppaction://hlinksldjump"/>
+          </p:cNvPr>
+          <p:cNvSpPr/>
+          <p:nvPr/>
+        </p:nvSpPr>
+        <p:spPr>
+          <a:xfrm>
+            <a:off x="7772400" y="4846320"/>
+            <a:ext cx="1097280" cy="0"/>
+          </a:xfrm>
+          <a:prstGeom prst="rect">
+            <a:avLst/>
+          </a:prstGeom>
+          <a:noFill/>
+          <a:ln/>
+        </p:spPr>
+        <p:txBody>
+          <a:bodyPr wrap="square" rtlCol="0" anchor="ctr"/>
+          <a:lstStyle/>
+          <a:p>
+            <a:pPr algn="r" indent="0" marL="0">
+              <a:buNone/>
+            </a:pPr>
+            <a:r>
+              <a:rPr lang="en-US" sz="1000" u="sng" dirty="0">
+                <a:solidFill>
+                  <a:srgbClr val="0563C1"/>
+                </a:solidFill>
+                <a:hlinkClick r:id="rId1" action="ppaction://hlinksldjump" tooltip="">
+                  <a:extLst>
+                    <a:ext uri="{A12FA001-AC4F-418D-AE19-62706E023703}">
+                      <ahyp:hlinkClr xmlns:ahyp="http://schemas.microsoft.com/office/drawing/2018/hyperlinkcolor" val="tx"/>
+                    </a:ext>
+                  </a:extLst>
+                </a:hlinkClick>
+              </a:rPr>
+              <a:t>🏠 Daftar Isi</a:t>
+            </a:r>
+            <a:endParaRPr lang="en-US" sz="1000" dirty="0"/>
+          </a:p>
+        </p:txBody>
+      </p:sp>
     </p:spTree>
   </p:cSld>
   <p:clrMapOvr>
@@ -13578,6 +13938,51 @@
           </a:p>
         </p:txBody>
       </p:sp>
+      <p:sp>
+        <p:nvSpPr>
+          <p:cNvPr id="4" name="Text 2">
+            <a:hlinkClick r:id="rId1" tooltip="" action="ppaction://hlinksldjump"/>
+          </p:cNvPr>
+          <p:cNvSpPr/>
+          <p:nvPr/>
+        </p:nvSpPr>
+        <p:spPr>
+          <a:xfrm>
+            <a:off x="7772400" y="4846320"/>
+            <a:ext cx="1097280" cy="0"/>
+          </a:xfrm>
+          <a:prstGeom prst="rect">
+            <a:avLst/>
+          </a:prstGeom>
+          <a:noFill/>
+          <a:ln/>
+        </p:spPr>
+        <p:txBody>
+          <a:bodyPr wrap="square" rtlCol="0" anchor="ctr"/>
+          <a:lstStyle/>
+          <a:p>
+            <a:pPr algn="r" indent="0" marL="0">
+              <a:buNone/>
+            </a:pPr>
+            <a:r>
+              <a:rPr lang="en-US" sz="1000" u="sng" dirty="0">
+                <a:solidFill>
+                  <a:srgbClr val="0563C1"/>
+                </a:solidFill>
+                <a:hlinkClick r:id="rId1" action="ppaction://hlinksldjump" tooltip="">
+                  <a:extLst>
+                    <a:ext uri="{A12FA001-AC4F-418D-AE19-62706E023703}">
+                      <ahyp:hlinkClr xmlns:ahyp="http://schemas.microsoft.com/office/drawing/2018/hyperlinkcolor" val="tx"/>
+                    </a:ext>
+                  </a:extLst>
+                </a:hlinkClick>
+              </a:rPr>
+              <a:t>🏠 Daftar Isi</a:t>
+            </a:r>
+            <a:endParaRPr lang="en-US" sz="1000" dirty="0"/>
+          </a:p>
+        </p:txBody>
+      </p:sp>
     </p:spTree>
   </p:cSld>
   <p:clrMapOvr>
@@ -14252,6 +14657,51 @@
           </a:p>
         </p:txBody>
       </p:sp>
+      <p:sp>
+        <p:nvSpPr>
+          <p:cNvPr id="4" name="Text 2">
+            <a:hlinkClick r:id="rId1" tooltip="" action="ppaction://hlinksldjump"/>
+          </p:cNvPr>
+          <p:cNvSpPr/>
+          <p:nvPr/>
+        </p:nvSpPr>
+        <p:spPr>
+          <a:xfrm>
+            <a:off x="7772400" y="4846320"/>
+            <a:ext cx="1097280" cy="0"/>
+          </a:xfrm>
+          <a:prstGeom prst="rect">
+            <a:avLst/>
+          </a:prstGeom>
+          <a:noFill/>
+          <a:ln/>
+        </p:spPr>
+        <p:txBody>
+          <a:bodyPr wrap="square" rtlCol="0" anchor="ctr"/>
+          <a:lstStyle/>
+          <a:p>
+            <a:pPr algn="r" indent="0" marL="0">
+              <a:buNone/>
+            </a:pPr>
+            <a:r>
+              <a:rPr lang="en-US" sz="1000" u="sng" dirty="0">
+                <a:solidFill>
+                  <a:srgbClr val="0563C1"/>
+                </a:solidFill>
+                <a:hlinkClick r:id="rId1" action="ppaction://hlinksldjump" tooltip="">
+                  <a:extLst>
+                    <a:ext uri="{A12FA001-AC4F-418D-AE19-62706E023703}">
+                      <ahyp:hlinkClr xmlns:ahyp="http://schemas.microsoft.com/office/drawing/2018/hyperlinkcolor" val="tx"/>
+                    </a:ext>
+                  </a:extLst>
+                </a:hlinkClick>
+              </a:rPr>
+              <a:t>🏠 Daftar Isi</a:t>
+            </a:r>
+            <a:endParaRPr lang="en-US" sz="1000" dirty="0"/>
+          </a:p>
+        </p:txBody>
+      </p:sp>
     </p:spTree>
   </p:cSld>
   <p:clrMapOvr>
@@ -14613,6 +15063,51 @@
           </a:p>
         </p:txBody>
       </p:sp>
+      <p:sp>
+        <p:nvSpPr>
+          <p:cNvPr id="4" name="Text 2">
+            <a:hlinkClick r:id="rId1" tooltip="" action="ppaction://hlinksldjump"/>
+          </p:cNvPr>
+          <p:cNvSpPr/>
+          <p:nvPr/>
+        </p:nvSpPr>
+        <p:spPr>
+          <a:xfrm>
+            <a:off x="7772400" y="4846320"/>
+            <a:ext cx="1097280" cy="0"/>
+          </a:xfrm>
+          <a:prstGeom prst="rect">
+            <a:avLst/>
+          </a:prstGeom>
+          <a:noFill/>
+          <a:ln/>
+        </p:spPr>
+        <p:txBody>
+          <a:bodyPr wrap="square" rtlCol="0" anchor="ctr"/>
+          <a:lstStyle/>
+          <a:p>
+            <a:pPr algn="r" indent="0" marL="0">
+              <a:buNone/>
+            </a:pPr>
+            <a:r>
+              <a:rPr lang="en-US" sz="1000" u="sng" dirty="0">
+                <a:solidFill>
+                  <a:srgbClr val="0563C1"/>
+                </a:solidFill>
+                <a:hlinkClick r:id="rId1" action="ppaction://hlinksldjump" tooltip="">
+                  <a:extLst>
+                    <a:ext uri="{A12FA001-AC4F-418D-AE19-62706E023703}">
+                      <ahyp:hlinkClr xmlns:ahyp="http://schemas.microsoft.com/office/drawing/2018/hyperlinkcolor" val="tx"/>
+                    </a:ext>
+                  </a:extLst>
+                </a:hlinkClick>
+              </a:rPr>
+              <a:t>🏠 Daftar Isi</a:t>
+            </a:r>
+            <a:endParaRPr lang="en-US" sz="1000" dirty="0"/>
+          </a:p>
+        </p:txBody>
+      </p:sp>
     </p:spTree>
   </p:cSld>
   <p:clrMapOvr>
@@ -14930,6 +15425,51 @@
           </a:p>
         </p:txBody>
       </p:sp>
+      <p:sp>
+        <p:nvSpPr>
+          <p:cNvPr id="4" name="Text 2">
+            <a:hlinkClick r:id="rId1" tooltip="" action="ppaction://hlinksldjump"/>
+          </p:cNvPr>
+          <p:cNvSpPr/>
+          <p:nvPr/>
+        </p:nvSpPr>
+        <p:spPr>
+          <a:xfrm>
+            <a:off x="7772400" y="4846320"/>
+            <a:ext cx="1097280" cy="0"/>
+          </a:xfrm>
+          <a:prstGeom prst="rect">
+            <a:avLst/>
+          </a:prstGeom>
+          <a:noFill/>
+          <a:ln/>
+        </p:spPr>
+        <p:txBody>
+          <a:bodyPr wrap="square" rtlCol="0" anchor="ctr"/>
+          <a:lstStyle/>
+          <a:p>
+            <a:pPr algn="r" indent="0" marL="0">
+              <a:buNone/>
+            </a:pPr>
+            <a:r>
+              <a:rPr lang="en-US" sz="1000" u="sng" dirty="0">
+                <a:solidFill>
+                  <a:srgbClr val="0563C1"/>
+                </a:solidFill>
+                <a:hlinkClick r:id="rId1" action="ppaction://hlinksldjump" tooltip="">
+                  <a:extLst>
+                    <a:ext uri="{A12FA001-AC4F-418D-AE19-62706E023703}">
+                      <ahyp:hlinkClr xmlns:ahyp="http://schemas.microsoft.com/office/drawing/2018/hyperlinkcolor" val="tx"/>
+                    </a:ext>
+                  </a:extLst>
+                </a:hlinkClick>
+              </a:rPr>
+              <a:t>🏠 Daftar Isi</a:t>
+            </a:r>
+            <a:endParaRPr lang="en-US" sz="1000" dirty="0"/>
+          </a:p>
+        </p:txBody>
+      </p:sp>
     </p:spTree>
   </p:cSld>
   <p:clrMapOvr>
@@ -15297,6 +15837,51 @@
           </a:p>
         </p:txBody>
       </p:sp>
+      <p:sp>
+        <p:nvSpPr>
+          <p:cNvPr id="4" name="Text 2">
+            <a:hlinkClick r:id="rId1" tooltip="" action="ppaction://hlinksldjump"/>
+          </p:cNvPr>
+          <p:cNvSpPr/>
+          <p:nvPr/>
+        </p:nvSpPr>
+        <p:spPr>
+          <a:xfrm>
+            <a:off x="7772400" y="4846320"/>
+            <a:ext cx="1097280" cy="0"/>
+          </a:xfrm>
+          <a:prstGeom prst="rect">
+            <a:avLst/>
+          </a:prstGeom>
+          <a:noFill/>
+          <a:ln/>
+        </p:spPr>
+        <p:txBody>
+          <a:bodyPr wrap="square" rtlCol="0" anchor="ctr"/>
+          <a:lstStyle/>
+          <a:p>
+            <a:pPr algn="r" indent="0" marL="0">
+              <a:buNone/>
+            </a:pPr>
+            <a:r>
+              <a:rPr lang="en-US" sz="1000" u="sng" dirty="0">
+                <a:solidFill>
+                  <a:srgbClr val="0563C1"/>
+                </a:solidFill>
+                <a:hlinkClick r:id="rId1" action="ppaction://hlinksldjump" tooltip="">
+                  <a:extLst>
+                    <a:ext uri="{A12FA001-AC4F-418D-AE19-62706E023703}">
+                      <ahyp:hlinkClr xmlns:ahyp="http://schemas.microsoft.com/office/drawing/2018/hyperlinkcolor" val="tx"/>
+                    </a:ext>
+                  </a:extLst>
+                </a:hlinkClick>
+              </a:rPr>
+              <a:t>🏠 Daftar Isi</a:t>
+            </a:r>
+            <a:endParaRPr lang="en-US" sz="1000" dirty="0"/>
+          </a:p>
+        </p:txBody>
+      </p:sp>
     </p:spTree>
   </p:cSld>
   <p:clrMapOvr>
@@ -15601,6 +16186,51 @@
           </a:p>
         </p:txBody>
       </p:sp>
+      <p:sp>
+        <p:nvSpPr>
+          <p:cNvPr id="4" name="Text 2">
+            <a:hlinkClick r:id="rId1" tooltip="" action="ppaction://hlinksldjump"/>
+          </p:cNvPr>
+          <p:cNvSpPr/>
+          <p:nvPr/>
+        </p:nvSpPr>
+        <p:spPr>
+          <a:xfrm>
+            <a:off x="7772400" y="4846320"/>
+            <a:ext cx="1097280" cy="0"/>
+          </a:xfrm>
+          <a:prstGeom prst="rect">
+            <a:avLst/>
+          </a:prstGeom>
+          <a:noFill/>
+          <a:ln/>
+        </p:spPr>
+        <p:txBody>
+          <a:bodyPr wrap="square" rtlCol="0" anchor="ctr"/>
+          <a:lstStyle/>
+          <a:p>
+            <a:pPr algn="r" indent="0" marL="0">
+              <a:buNone/>
+            </a:pPr>
+            <a:r>
+              <a:rPr lang="en-US" sz="1000" u="sng" dirty="0">
+                <a:solidFill>
+                  <a:srgbClr val="0563C1"/>
+                </a:solidFill>
+                <a:hlinkClick r:id="rId1" action="ppaction://hlinksldjump" tooltip="">
+                  <a:extLst>
+                    <a:ext uri="{A12FA001-AC4F-418D-AE19-62706E023703}">
+                      <ahyp:hlinkClr xmlns:ahyp="http://schemas.microsoft.com/office/drawing/2018/hyperlinkcolor" val="tx"/>
+                    </a:ext>
+                  </a:extLst>
+                </a:hlinkClick>
+              </a:rPr>
+              <a:t>🏠 Daftar Isi</a:t>
+            </a:r>
+            <a:endParaRPr lang="en-US" sz="1000" dirty="0"/>
+          </a:p>
+        </p:txBody>
+      </p:sp>
     </p:spTree>
   </p:cSld>
   <p:clrMapOvr>
@@ -16281,6 +16911,51 @@
           </a:p>
         </p:txBody>
       </p:sp>
+      <p:sp>
+        <p:nvSpPr>
+          <p:cNvPr id="4" name="Text 2">
+            <a:hlinkClick r:id="rId1" tooltip="" action="ppaction://hlinksldjump"/>
+          </p:cNvPr>
+          <p:cNvSpPr/>
+          <p:nvPr/>
+        </p:nvSpPr>
+        <p:spPr>
+          <a:xfrm>
+            <a:off x="7772400" y="4846320"/>
+            <a:ext cx="1097280" cy="0"/>
+          </a:xfrm>
+          <a:prstGeom prst="rect">
+            <a:avLst/>
+          </a:prstGeom>
+          <a:noFill/>
+          <a:ln/>
+        </p:spPr>
+        <p:txBody>
+          <a:bodyPr wrap="square" rtlCol="0" anchor="ctr"/>
+          <a:lstStyle/>
+          <a:p>
+            <a:pPr algn="r" indent="0" marL="0">
+              <a:buNone/>
+            </a:pPr>
+            <a:r>
+              <a:rPr lang="en-US" sz="1000" u="sng" dirty="0">
+                <a:solidFill>
+                  <a:srgbClr val="0563C1"/>
+                </a:solidFill>
+                <a:hlinkClick r:id="rId1" action="ppaction://hlinksldjump" tooltip="">
+                  <a:extLst>
+                    <a:ext uri="{A12FA001-AC4F-418D-AE19-62706E023703}">
+                      <ahyp:hlinkClr xmlns:ahyp="http://schemas.microsoft.com/office/drawing/2018/hyperlinkcolor" val="tx"/>
+                    </a:ext>
+                  </a:extLst>
+                </a:hlinkClick>
+              </a:rPr>
+              <a:t>🏠 Daftar Isi</a:t>
+            </a:r>
+            <a:endParaRPr lang="en-US" sz="1000" dirty="0"/>
+          </a:p>
+        </p:txBody>
+      </p:sp>
     </p:spTree>
   </p:cSld>
   <p:clrMapOvr>
@@ -16564,6 +17239,51 @@
           </a:p>
         </p:txBody>
       </p:sp>
+      <p:sp>
+        <p:nvSpPr>
+          <p:cNvPr id="4" name="Text 2">
+            <a:hlinkClick r:id="rId1" tooltip="" action="ppaction://hlinksldjump"/>
+          </p:cNvPr>
+          <p:cNvSpPr/>
+          <p:nvPr/>
+        </p:nvSpPr>
+        <p:spPr>
+          <a:xfrm>
+            <a:off x="7772400" y="4846320"/>
+            <a:ext cx="1097280" cy="0"/>
+          </a:xfrm>
+          <a:prstGeom prst="rect">
+            <a:avLst/>
+          </a:prstGeom>
+          <a:noFill/>
+          <a:ln/>
+        </p:spPr>
+        <p:txBody>
+          <a:bodyPr wrap="square" rtlCol="0" anchor="ctr"/>
+          <a:lstStyle/>
+          <a:p>
+            <a:pPr algn="r" indent="0" marL="0">
+              <a:buNone/>
+            </a:pPr>
+            <a:r>
+              <a:rPr lang="en-US" sz="1000" u="sng" dirty="0">
+                <a:solidFill>
+                  <a:srgbClr val="0563C1"/>
+                </a:solidFill>
+                <a:hlinkClick r:id="rId1" action="ppaction://hlinksldjump" tooltip="">
+                  <a:extLst>
+                    <a:ext uri="{A12FA001-AC4F-418D-AE19-62706E023703}">
+                      <ahyp:hlinkClr xmlns:ahyp="http://schemas.microsoft.com/office/drawing/2018/hyperlinkcolor" val="tx"/>
+                    </a:ext>
+                  </a:extLst>
+                </a:hlinkClick>
+              </a:rPr>
+              <a:t>🏠 Daftar Isi</a:t>
+            </a:r>
+            <a:endParaRPr lang="en-US" sz="1000" dirty="0"/>
+          </a:p>
+        </p:txBody>
+      </p:sp>
     </p:spTree>
   </p:cSld>
   <p:clrMapOvr>
@@ -16801,6 +17521,51 @@
           </a:p>
         </p:txBody>
       </p:sp>
+      <p:sp>
+        <p:nvSpPr>
+          <p:cNvPr id="4" name="Text 2">
+            <a:hlinkClick r:id="rId1" tooltip="" action="ppaction://hlinksldjump"/>
+          </p:cNvPr>
+          <p:cNvSpPr/>
+          <p:nvPr/>
+        </p:nvSpPr>
+        <p:spPr>
+          <a:xfrm>
+            <a:off x="7772400" y="4846320"/>
+            <a:ext cx="1097280" cy="0"/>
+          </a:xfrm>
+          <a:prstGeom prst="rect">
+            <a:avLst/>
+          </a:prstGeom>
+          <a:noFill/>
+          <a:ln/>
+        </p:spPr>
+        <p:txBody>
+          <a:bodyPr wrap="square" rtlCol="0" anchor="ctr"/>
+          <a:lstStyle/>
+          <a:p>
+            <a:pPr algn="r" indent="0" marL="0">
+              <a:buNone/>
+            </a:pPr>
+            <a:r>
+              <a:rPr lang="en-US" sz="1000" u="sng" dirty="0">
+                <a:solidFill>
+                  <a:srgbClr val="0563C1"/>
+                </a:solidFill>
+                <a:hlinkClick r:id="rId1" action="ppaction://hlinksldjump" tooltip="">
+                  <a:extLst>
+                    <a:ext uri="{A12FA001-AC4F-418D-AE19-62706E023703}">
+                      <ahyp:hlinkClr xmlns:ahyp="http://schemas.microsoft.com/office/drawing/2018/hyperlinkcolor" val="tx"/>
+                    </a:ext>
+                  </a:extLst>
+                </a:hlinkClick>
+              </a:rPr>
+              <a:t>🏠 Daftar Isi</a:t>
+            </a:r>
+            <a:endParaRPr lang="en-US" sz="1000" dirty="0"/>
+          </a:p>
+        </p:txBody>
+      </p:sp>
     </p:spTree>
   </p:cSld>
   <p:clrMapOvr>
@@ -17074,6 +17839,51 @@
           </a:p>
         </p:txBody>
       </p:sp>
+      <p:sp>
+        <p:nvSpPr>
+          <p:cNvPr id="4" name="Text 2">
+            <a:hlinkClick r:id="rId1" tooltip="" action="ppaction://hlinksldjump"/>
+          </p:cNvPr>
+          <p:cNvSpPr/>
+          <p:nvPr/>
+        </p:nvSpPr>
+        <p:spPr>
+          <a:xfrm>
+            <a:off x="7772400" y="4846320"/>
+            <a:ext cx="1097280" cy="0"/>
+          </a:xfrm>
+          <a:prstGeom prst="rect">
+            <a:avLst/>
+          </a:prstGeom>
+          <a:noFill/>
+          <a:ln/>
+        </p:spPr>
+        <p:txBody>
+          <a:bodyPr wrap="square" rtlCol="0" anchor="ctr"/>
+          <a:lstStyle/>
+          <a:p>
+            <a:pPr algn="r" indent="0" marL="0">
+              <a:buNone/>
+            </a:pPr>
+            <a:r>
+              <a:rPr lang="en-US" sz="1000" u="sng" dirty="0">
+                <a:solidFill>
+                  <a:srgbClr val="0563C1"/>
+                </a:solidFill>
+                <a:hlinkClick r:id="rId1" action="ppaction://hlinksldjump" tooltip="">
+                  <a:extLst>
+                    <a:ext uri="{A12FA001-AC4F-418D-AE19-62706E023703}">
+                      <ahyp:hlinkClr xmlns:ahyp="http://schemas.microsoft.com/office/drawing/2018/hyperlinkcolor" val="tx"/>
+                    </a:ext>
+                  </a:extLst>
+                </a:hlinkClick>
+              </a:rPr>
+              <a:t>🏠 Daftar Isi</a:t>
+            </a:r>
+            <a:endParaRPr lang="en-US" sz="1000" dirty="0"/>
+          </a:p>
+        </p:txBody>
+      </p:sp>
     </p:spTree>
   </p:cSld>
   <p:clrMapOvr>
@@ -17283,6 +18093,51 @@
           </a:p>
         </p:txBody>
       </p:sp>
+      <p:sp>
+        <p:nvSpPr>
+          <p:cNvPr id="4" name="Text 2">
+            <a:hlinkClick r:id="rId1" tooltip="" action="ppaction://hlinksldjump"/>
+          </p:cNvPr>
+          <p:cNvSpPr/>
+          <p:nvPr/>
+        </p:nvSpPr>
+        <p:spPr>
+          <a:xfrm>
+            <a:off x="7772400" y="4846320"/>
+            <a:ext cx="1097280" cy="0"/>
+          </a:xfrm>
+          <a:prstGeom prst="rect">
+            <a:avLst/>
+          </a:prstGeom>
+          <a:noFill/>
+          <a:ln/>
+        </p:spPr>
+        <p:txBody>
+          <a:bodyPr wrap="square" rtlCol="0" anchor="ctr"/>
+          <a:lstStyle/>
+          <a:p>
+            <a:pPr algn="r" indent="0" marL="0">
+              <a:buNone/>
+            </a:pPr>
+            <a:r>
+              <a:rPr lang="en-US" sz="1000" u="sng" dirty="0">
+                <a:solidFill>
+                  <a:srgbClr val="0563C1"/>
+                </a:solidFill>
+                <a:hlinkClick r:id="rId1" action="ppaction://hlinksldjump" tooltip="">
+                  <a:extLst>
+                    <a:ext uri="{A12FA001-AC4F-418D-AE19-62706E023703}">
+                      <ahyp:hlinkClr xmlns:ahyp="http://schemas.microsoft.com/office/drawing/2018/hyperlinkcolor" val="tx"/>
+                    </a:ext>
+                  </a:extLst>
+                </a:hlinkClick>
+              </a:rPr>
+              <a:t>🏠 Daftar Isi</a:t>
+            </a:r>
+            <a:endParaRPr lang="en-US" sz="1000" dirty="0"/>
+          </a:p>
+        </p:txBody>
+      </p:sp>
     </p:spTree>
   </p:cSld>
   <p:clrMapOvr>
@@ -17550,6 +18405,51 @@
           </a:p>
         </p:txBody>
       </p:sp>
+      <p:sp>
+        <p:nvSpPr>
+          <p:cNvPr id="4" name="Text 2">
+            <a:hlinkClick r:id="rId1" tooltip="" action="ppaction://hlinksldjump"/>
+          </p:cNvPr>
+          <p:cNvSpPr/>
+          <p:nvPr/>
+        </p:nvSpPr>
+        <p:spPr>
+          <a:xfrm>
+            <a:off x="7772400" y="4846320"/>
+            <a:ext cx="1097280" cy="0"/>
+          </a:xfrm>
+          <a:prstGeom prst="rect">
+            <a:avLst/>
+          </a:prstGeom>
+          <a:noFill/>
+          <a:ln/>
+        </p:spPr>
+        <p:txBody>
+          <a:bodyPr wrap="square" rtlCol="0" anchor="ctr"/>
+          <a:lstStyle/>
+          <a:p>
+            <a:pPr algn="r" indent="0" marL="0">
+              <a:buNone/>
+            </a:pPr>
+            <a:r>
+              <a:rPr lang="en-US" sz="1000" u="sng" dirty="0">
+                <a:solidFill>
+                  <a:srgbClr val="0563C1"/>
+                </a:solidFill>
+                <a:hlinkClick r:id="rId1" action="ppaction://hlinksldjump" tooltip="">
+                  <a:extLst>
+                    <a:ext uri="{A12FA001-AC4F-418D-AE19-62706E023703}">
+                      <ahyp:hlinkClr xmlns:ahyp="http://schemas.microsoft.com/office/drawing/2018/hyperlinkcolor" val="tx"/>
+                    </a:ext>
+                  </a:extLst>
+                </a:hlinkClick>
+              </a:rPr>
+              <a:t>🏠 Daftar Isi</a:t>
+            </a:r>
+            <a:endParaRPr lang="en-US" sz="1000" dirty="0"/>
+          </a:p>
+        </p:txBody>
+      </p:sp>
     </p:spTree>
   </p:cSld>
   <p:clrMapOvr>
@@ -17837,6 +18737,51 @@
           </a:p>
         </p:txBody>
       </p:sp>
+      <p:sp>
+        <p:nvSpPr>
+          <p:cNvPr id="4" name="Text 2">
+            <a:hlinkClick r:id="rId1" tooltip="" action="ppaction://hlinksldjump"/>
+          </p:cNvPr>
+          <p:cNvSpPr/>
+          <p:nvPr/>
+        </p:nvSpPr>
+        <p:spPr>
+          <a:xfrm>
+            <a:off x="7772400" y="4846320"/>
+            <a:ext cx="1097280" cy="0"/>
+          </a:xfrm>
+          <a:prstGeom prst="rect">
+            <a:avLst/>
+          </a:prstGeom>
+          <a:noFill/>
+          <a:ln/>
+        </p:spPr>
+        <p:txBody>
+          <a:bodyPr wrap="square" rtlCol="0" anchor="ctr"/>
+          <a:lstStyle/>
+          <a:p>
+            <a:pPr algn="r" indent="0" marL="0">
+              <a:buNone/>
+            </a:pPr>
+            <a:r>
+              <a:rPr lang="en-US" sz="1000" u="sng" dirty="0">
+                <a:solidFill>
+                  <a:srgbClr val="0563C1"/>
+                </a:solidFill>
+                <a:hlinkClick r:id="rId1" action="ppaction://hlinksldjump" tooltip="">
+                  <a:extLst>
+                    <a:ext uri="{A12FA001-AC4F-418D-AE19-62706E023703}">
+                      <ahyp:hlinkClr xmlns:ahyp="http://schemas.microsoft.com/office/drawing/2018/hyperlinkcolor" val="tx"/>
+                    </a:ext>
+                  </a:extLst>
+                </a:hlinkClick>
+              </a:rPr>
+              <a:t>🏠 Daftar Isi</a:t>
+            </a:r>
+            <a:endParaRPr lang="en-US" sz="1000" dirty="0"/>
+          </a:p>
+        </p:txBody>
+      </p:sp>
     </p:spTree>
   </p:cSld>
   <p:clrMapOvr>
@@ -18110,6 +19055,51 @@
           </a:p>
         </p:txBody>
       </p:sp>
+      <p:sp>
+        <p:nvSpPr>
+          <p:cNvPr id="4" name="Text 2">
+            <a:hlinkClick r:id="rId1" tooltip="" action="ppaction://hlinksldjump"/>
+          </p:cNvPr>
+          <p:cNvSpPr/>
+          <p:nvPr/>
+        </p:nvSpPr>
+        <p:spPr>
+          <a:xfrm>
+            <a:off x="7772400" y="4846320"/>
+            <a:ext cx="1097280" cy="0"/>
+          </a:xfrm>
+          <a:prstGeom prst="rect">
+            <a:avLst/>
+          </a:prstGeom>
+          <a:noFill/>
+          <a:ln/>
+        </p:spPr>
+        <p:txBody>
+          <a:bodyPr wrap="square" rtlCol="0" anchor="ctr"/>
+          <a:lstStyle/>
+          <a:p>
+            <a:pPr algn="r" indent="0" marL="0">
+              <a:buNone/>
+            </a:pPr>
+            <a:r>
+              <a:rPr lang="en-US" sz="1000" u="sng" dirty="0">
+                <a:solidFill>
+                  <a:srgbClr val="0563C1"/>
+                </a:solidFill>
+                <a:hlinkClick r:id="rId1" action="ppaction://hlinksldjump" tooltip="">
+                  <a:extLst>
+                    <a:ext uri="{A12FA001-AC4F-418D-AE19-62706E023703}">
+                      <ahyp:hlinkClr xmlns:ahyp="http://schemas.microsoft.com/office/drawing/2018/hyperlinkcolor" val="tx"/>
+                    </a:ext>
+                  </a:extLst>
+                </a:hlinkClick>
+              </a:rPr>
+              <a:t>🏠 Daftar Isi</a:t>
+            </a:r>
+            <a:endParaRPr lang="en-US" sz="1000" dirty="0"/>
+          </a:p>
+        </p:txBody>
+      </p:sp>
     </p:spTree>
   </p:cSld>
   <p:clrMapOvr>
@@ -18376,6 +19366,51 @@
           </a:p>
         </p:txBody>
       </p:sp>
+      <p:sp>
+        <p:nvSpPr>
+          <p:cNvPr id="4" name="Text 2">
+            <a:hlinkClick r:id="rId1" tooltip="" action="ppaction://hlinksldjump"/>
+          </p:cNvPr>
+          <p:cNvSpPr/>
+          <p:nvPr/>
+        </p:nvSpPr>
+        <p:spPr>
+          <a:xfrm>
+            <a:off x="7772400" y="4846320"/>
+            <a:ext cx="1097280" cy="0"/>
+          </a:xfrm>
+          <a:prstGeom prst="rect">
+            <a:avLst/>
+          </a:prstGeom>
+          <a:noFill/>
+          <a:ln/>
+        </p:spPr>
+        <p:txBody>
+          <a:bodyPr wrap="square" rtlCol="0" anchor="ctr"/>
+          <a:lstStyle/>
+          <a:p>
+            <a:pPr algn="r" indent="0" marL="0">
+              <a:buNone/>
+            </a:pPr>
+            <a:r>
+              <a:rPr lang="en-US" sz="1000" u="sng" dirty="0">
+                <a:solidFill>
+                  <a:srgbClr val="0563C1"/>
+                </a:solidFill>
+                <a:hlinkClick r:id="rId1" action="ppaction://hlinksldjump" tooltip="">
+                  <a:extLst>
+                    <a:ext uri="{A12FA001-AC4F-418D-AE19-62706E023703}">
+                      <ahyp:hlinkClr xmlns:ahyp="http://schemas.microsoft.com/office/drawing/2018/hyperlinkcolor" val="tx"/>
+                    </a:ext>
+                  </a:extLst>
+                </a:hlinkClick>
+              </a:rPr>
+              <a:t>🏠 Daftar Isi</a:t>
+            </a:r>
+            <a:endParaRPr lang="en-US" sz="1000" dirty="0"/>
+          </a:p>
+        </p:txBody>
+      </p:sp>
     </p:spTree>
   </p:cSld>
   <p:clrMapOvr>
@@ -18572,6 +19607,51 @@
           </a:p>
         </p:txBody>
       </p:sp>
+      <p:sp>
+        <p:nvSpPr>
+          <p:cNvPr id="4" name="Text 2">
+            <a:hlinkClick r:id="rId1" tooltip="" action="ppaction://hlinksldjump"/>
+          </p:cNvPr>
+          <p:cNvSpPr/>
+          <p:nvPr/>
+        </p:nvSpPr>
+        <p:spPr>
+          <a:xfrm>
+            <a:off x="7772400" y="4846320"/>
+            <a:ext cx="1097280" cy="0"/>
+          </a:xfrm>
+          <a:prstGeom prst="rect">
+            <a:avLst/>
+          </a:prstGeom>
+          <a:noFill/>
+          <a:ln/>
+        </p:spPr>
+        <p:txBody>
+          <a:bodyPr wrap="square" rtlCol="0" anchor="ctr"/>
+          <a:lstStyle/>
+          <a:p>
+            <a:pPr algn="r" indent="0" marL="0">
+              <a:buNone/>
+            </a:pPr>
+            <a:r>
+              <a:rPr lang="en-US" sz="1000" u="sng" dirty="0">
+                <a:solidFill>
+                  <a:srgbClr val="0563C1"/>
+                </a:solidFill>
+                <a:hlinkClick r:id="rId1" action="ppaction://hlinksldjump" tooltip="">
+                  <a:extLst>
+                    <a:ext uri="{A12FA001-AC4F-418D-AE19-62706E023703}">
+                      <ahyp:hlinkClr xmlns:ahyp="http://schemas.microsoft.com/office/drawing/2018/hyperlinkcolor" val="tx"/>
+                    </a:ext>
+                  </a:extLst>
+                </a:hlinkClick>
+              </a:rPr>
+              <a:t>🏠 Daftar Isi</a:t>
+            </a:r>
+            <a:endParaRPr lang="en-US" sz="1000" dirty="0"/>
+          </a:p>
+        </p:txBody>
+      </p:sp>
     </p:spTree>
   </p:cSld>
   <p:clrMapOvr>
@@ -19165,6 +20245,51 @@
           </a:p>
         </p:txBody>
       </p:sp>
+      <p:sp>
+        <p:nvSpPr>
+          <p:cNvPr id="4" name="Text 2">
+            <a:hlinkClick r:id="rId1" tooltip="" action="ppaction://hlinksldjump"/>
+          </p:cNvPr>
+          <p:cNvSpPr/>
+          <p:nvPr/>
+        </p:nvSpPr>
+        <p:spPr>
+          <a:xfrm>
+            <a:off x="7772400" y="4846320"/>
+            <a:ext cx="1097280" cy="0"/>
+          </a:xfrm>
+          <a:prstGeom prst="rect">
+            <a:avLst/>
+          </a:prstGeom>
+          <a:noFill/>
+          <a:ln/>
+        </p:spPr>
+        <p:txBody>
+          <a:bodyPr wrap="square" rtlCol="0" anchor="ctr"/>
+          <a:lstStyle/>
+          <a:p>
+            <a:pPr algn="r" indent="0" marL="0">
+              <a:buNone/>
+            </a:pPr>
+            <a:r>
+              <a:rPr lang="en-US" sz="1000" u="sng" dirty="0">
+                <a:solidFill>
+                  <a:srgbClr val="0563C1"/>
+                </a:solidFill>
+                <a:hlinkClick r:id="rId1" action="ppaction://hlinksldjump" tooltip="">
+                  <a:extLst>
+                    <a:ext uri="{A12FA001-AC4F-418D-AE19-62706E023703}">
+                      <ahyp:hlinkClr xmlns:ahyp="http://schemas.microsoft.com/office/drawing/2018/hyperlinkcolor" val="tx"/>
+                    </a:ext>
+                  </a:extLst>
+                </a:hlinkClick>
+              </a:rPr>
+              <a:t>🏠 Daftar Isi</a:t>
+            </a:r>
+            <a:endParaRPr lang="en-US" sz="1000" dirty="0"/>
+          </a:p>
+        </p:txBody>
+      </p:sp>
     </p:spTree>
   </p:cSld>
   <p:clrMapOvr>
@@ -19398,6 +20523,51 @@
           </a:p>
         </p:txBody>
       </p:sp>
+      <p:sp>
+        <p:nvSpPr>
+          <p:cNvPr id="4" name="Text 2">
+            <a:hlinkClick r:id="rId1" tooltip="" action="ppaction://hlinksldjump"/>
+          </p:cNvPr>
+          <p:cNvSpPr/>
+          <p:nvPr/>
+        </p:nvSpPr>
+        <p:spPr>
+          <a:xfrm>
+            <a:off x="7772400" y="4846320"/>
+            <a:ext cx="1097280" cy="0"/>
+          </a:xfrm>
+          <a:prstGeom prst="rect">
+            <a:avLst/>
+          </a:prstGeom>
+          <a:noFill/>
+          <a:ln/>
+        </p:spPr>
+        <p:txBody>
+          <a:bodyPr wrap="square" rtlCol="0" anchor="ctr"/>
+          <a:lstStyle/>
+          <a:p>
+            <a:pPr algn="r" indent="0" marL="0">
+              <a:buNone/>
+            </a:pPr>
+            <a:r>
+              <a:rPr lang="en-US" sz="1000" u="sng" dirty="0">
+                <a:solidFill>
+                  <a:srgbClr val="0563C1"/>
+                </a:solidFill>
+                <a:hlinkClick r:id="rId1" action="ppaction://hlinksldjump" tooltip="">
+                  <a:extLst>
+                    <a:ext uri="{A12FA001-AC4F-418D-AE19-62706E023703}">
+                      <ahyp:hlinkClr xmlns:ahyp="http://schemas.microsoft.com/office/drawing/2018/hyperlinkcolor" val="tx"/>
+                    </a:ext>
+                  </a:extLst>
+                </a:hlinkClick>
+              </a:rPr>
+              <a:t>🏠 Daftar Isi</a:t>
+            </a:r>
+            <a:endParaRPr lang="en-US" sz="1000" dirty="0"/>
+          </a:p>
+        </p:txBody>
+      </p:sp>
     </p:spTree>
   </p:cSld>
   <p:clrMapOvr>
@@ -19640,6 +20810,51 @@
               <a:t> daripada sekadar variansi harga.</a:t>
             </a:r>
             <a:endParaRPr lang="en-US" sz="1800" dirty="0"/>
+          </a:p>
+        </p:txBody>
+      </p:sp>
+      <p:sp>
+        <p:nvSpPr>
+          <p:cNvPr id="4" name="Text 2">
+            <a:hlinkClick r:id="rId1" tooltip="" action="ppaction://hlinksldjump"/>
+          </p:cNvPr>
+          <p:cNvSpPr/>
+          <p:nvPr/>
+        </p:nvSpPr>
+        <p:spPr>
+          <a:xfrm>
+            <a:off x="7772400" y="4846320"/>
+            <a:ext cx="1097280" cy="0"/>
+          </a:xfrm>
+          <a:prstGeom prst="rect">
+            <a:avLst/>
+          </a:prstGeom>
+          <a:noFill/>
+          <a:ln/>
+        </p:spPr>
+        <p:txBody>
+          <a:bodyPr wrap="square" rtlCol="0" anchor="ctr"/>
+          <a:lstStyle/>
+          <a:p>
+            <a:pPr algn="r" indent="0" marL="0">
+              <a:buNone/>
+            </a:pPr>
+            <a:r>
+              <a:rPr lang="en-US" sz="1000" u="sng" dirty="0">
+                <a:solidFill>
+                  <a:srgbClr val="0563C1"/>
+                </a:solidFill>
+                <a:hlinkClick r:id="rId1" action="ppaction://hlinksldjump" tooltip="">
+                  <a:extLst>
+                    <a:ext uri="{A12FA001-AC4F-418D-AE19-62706E023703}">
+                      <ahyp:hlinkClr xmlns:ahyp="http://schemas.microsoft.com/office/drawing/2018/hyperlinkcolor" val="tx"/>
+                    </a:ext>
+                  </a:extLst>
+                </a:hlinkClick>
+              </a:rPr>
+              <a:t>🏠 Daftar Isi</a:t>
+            </a:r>
+            <a:endParaRPr lang="en-US" sz="1000" dirty="0"/>
           </a:p>
         </p:txBody>
       </p:sp>

</xml_diff>

<commit_message>
feat: add simple Rolling Window Grid Search explanation slide
</commit_message>
<xml_diff>
--- a/Presentasi_Proposal_Update.pptx
+++ b/Presentasi_Proposal_Update.pptx
@@ -57,9 +57,10 @@
     <p:sldId id="305" r:id="rId51"/>
     <p:sldId id="306" r:id="rId52"/>
     <p:sldId id="307" r:id="rId53"/>
+    <p:sldId id="308" r:id="rId54"/>
   </p:sldIdLst>
   <p:notesMasterIdLst>
-    <p:notesMasterId r:id="rId54"/>
+    <p:notesMasterId r:id="rId55"/>
   </p:notesMasterIdLst>
   <p:sldSz cx="9144000" cy="5143500"/>
   <p:notesSz cx="5143500" cy="9144000"/>
@@ -4713,6 +4714,94 @@
             <a:fld id="{F7021451-1387-4CA6-816F-3879F97B5CBC}" type="slidenum">
               <a:rPr lang="en-US"/>
               <a:t>52</a:t>
+            </a:fld>
+            <a:endParaRPr lang="en-US"/>
+          </a:p>
+        </p:txBody>
+      </p:sp>
+    </p:spTree>
+    <p:extLst>
+      <p:ext uri="{BB962C8B-B14F-4D97-AF65-F5344CB8AC3E}">
+        <p14:creationId xmlns:p14="http://schemas.microsoft.com/office/powerpoint/2010/main" val="1024086991"/>
+      </p:ext>
+    </p:extLst>
+  </p:cSld>
+  <p:clrMapOvr>
+    <a:masterClrMapping/>
+  </p:clrMapOvr>
+</p:notes>
+</file>
+
+<file path=ppt/notesSlides/notesSlide53.xml><?xml version="1.0" encoding="utf-8"?>
+<p:notes xmlns:a="http://schemas.openxmlformats.org/drawingml/2006/main" xmlns:r="http://schemas.openxmlformats.org/officeDocument/2006/relationships" xmlns:p="http://schemas.openxmlformats.org/presentationml/2006/main">
+  <p:cSld>
+    <p:spTree>
+      <p:nvGrpSpPr>
+        <p:cNvPr id="1" name=""/>
+        <p:cNvGrpSpPr/>
+        <p:nvPr/>
+      </p:nvGrpSpPr>
+      <p:grpSpPr>
+        <a:xfrm>
+          <a:off x="0" y="0"/>
+          <a:ext cx="0" cy="0"/>
+          <a:chOff x="0" y="0"/>
+          <a:chExt cx="0" cy="0"/>
+        </a:xfrm>
+      </p:grpSpPr>
+      <p:sp>
+        <p:nvSpPr>
+          <p:cNvPr id="2" name="Slide Image Placeholder 1"/>
+          <p:cNvSpPr>
+            <a:spLocks noGrp="1" noRot="1" noChangeAspect="1"/>
+          </p:cNvSpPr>
+          <p:nvPr>
+            <p:ph type="sldImg"/>
+          </p:nvPr>
+        </p:nvSpPr>
+        <p:spPr/>
+      </p:sp>
+      <p:sp>
+        <p:nvSpPr>
+          <p:cNvPr id="3" name="Notes Placeholder 2"/>
+          <p:cNvSpPr>
+            <a:spLocks noGrp="1"/>
+          </p:cNvSpPr>
+          <p:nvPr>
+            <p:ph type="body" idx="1"/>
+          </p:nvPr>
+        </p:nvSpPr>
+        <p:spPr/>
+        <p:txBody>
+          <a:bodyPr/>
+          <a:lstStyle/>
+          <a:p>
+            <a:r>
+              <a:rPr lang="en-US" dirty="0"/>
+              <a:t/>
+            </a:r>
+            <a:endParaRPr lang="en-US" dirty="0"/>
+          </a:p>
+        </p:txBody>
+      </p:sp>
+      <p:sp>
+        <p:nvSpPr>
+          <p:cNvPr id="4" name="Slide Number Placeholder 3"/>
+          <p:cNvSpPr>
+            <a:spLocks noGrp="1"/>
+          </p:cNvSpPr>
+          <p:nvPr>
+            <p:ph type="sldNum" sz="quarter" idx="10"/>
+          </p:nvPr>
+        </p:nvSpPr>
+        <p:spPr/>
+        <p:txBody>
+          <a:bodyPr/>
+          <a:lstStyle/>
+          <a:p>
+            <a:fld id="{F7021451-1387-4CA6-816F-3879F97B5CBC}" type="slidenum">
+              <a:rPr lang="en-US"/>
+              <a:t>53</a:t>
             </a:fld>
             <a:endParaRPr lang="en-US"/>
           </a:p>
@@ -18782,6 +18871,51 @@
           </a:p>
         </p:txBody>
       </p:sp>
+      <p:sp>
+        <p:nvSpPr>
+          <p:cNvPr id="5" name="Text 3">
+            <a:hlinkClick r:id="rId2" tooltip="" action="ppaction://hlinksldjump"/>
+          </p:cNvPr>
+          <p:cNvSpPr/>
+          <p:nvPr/>
+        </p:nvSpPr>
+        <p:spPr>
+          <a:xfrm>
+            <a:off x="7772400" y="4846320"/>
+            <a:ext cx="1097280" cy="0"/>
+          </a:xfrm>
+          <a:prstGeom prst="rect">
+            <a:avLst/>
+          </a:prstGeom>
+          <a:noFill/>
+          <a:ln/>
+        </p:spPr>
+        <p:txBody>
+          <a:bodyPr wrap="square" rtlCol="0" anchor="ctr"/>
+          <a:lstStyle/>
+          <a:p>
+            <a:pPr algn="r" indent="0" marL="0">
+              <a:buNone/>
+            </a:pPr>
+            <a:r>
+              <a:rPr lang="en-US" sz="1000" u="sng" dirty="0">
+                <a:solidFill>
+                  <a:srgbClr val="0563C1"/>
+                </a:solidFill>
+                <a:hlinkClick r:id="rId2" action="ppaction://hlinksldjump" tooltip="">
+                  <a:extLst>
+                    <a:ext uri="{A12FA001-AC4F-418D-AE19-62706E023703}">
+                      <ahyp:hlinkClr xmlns:ahyp="http://schemas.microsoft.com/office/drawing/2018/hyperlinkcolor" val="tx"/>
+                    </a:ext>
+                  </a:extLst>
+                </a:hlinkClick>
+              </a:rPr>
+              <a:t>🏠 Daftar Isi</a:t>
+            </a:r>
+            <a:endParaRPr lang="en-US" sz="1000" dirty="0"/>
+          </a:p>
+        </p:txBody>
+      </p:sp>
     </p:spTree>
   </p:cSld>
   <p:clrMapOvr>
@@ -18832,14 +18966,14 @@
               <a:buNone/>
             </a:pPr>
             <a:r>
-              <a:rPr lang="en-US" sz="2600" b="1" dirty="0">
+              <a:rPr lang="en-US" sz="2400" b="1" dirty="0">
                 <a:solidFill>
                   <a:srgbClr val="003366"/>
                 </a:solidFill>
               </a:rPr>
-              <a:t>Lampiran: Dua Tipe Pendekatan Grid Search</a:t>
-            </a:r>
-            <a:endParaRPr lang="en-US" sz="2600" dirty="0"/>
+              <a:t>Lampiran: Contoh Sederhana Rolling Window Grid Search</a:t>
+            </a:r>
+            <a:endParaRPr lang="en-US" sz="2400" dirty="0"/>
           </a:p>
         </p:txBody>
       </p:sp>
@@ -18868,190 +19002,196 @@
               <a:buNone/>
             </a:pPr>
             <a:r>
-              <a:rPr lang="en-US" sz="1800" b="1" dirty="0">
-                <a:solidFill>
-                  <a:srgbClr val="333333"/>
-                </a:solidFill>
-              </a:rPr>
-              <a:t>Dua Objektif Optimasi (Return vs Risk):</a:t>
-            </a:r>
-            <a:endParaRPr lang="en-US" sz="1800" dirty="0"/>
-          </a:p>
-          <a:p>
-            <a:pPr indent="0" marL="0">
-              <a:buNone/>
-            </a:pPr>
-            <a:r>
-              <a:rPr lang="en-US" sz="1800" b="1" dirty="0">
+              <a:rPr lang="en-US" sz="1600" b="1" dirty="0">
+                <a:solidFill>
+                  <a:srgbClr val="333333"/>
+                </a:solidFill>
+              </a:rPr>
+              <a:t>Tujuan: Memilih 'Hukuman' (Gamma) terbaik secara otomatis untuk kondisi pasar saat ini.</a:t>
+            </a:r>
+            <a:endParaRPr lang="en-US" sz="1600" dirty="0"/>
+          </a:p>
+          <a:p>
+            <a:pPr indent="0" marL="0">
+              <a:buNone/>
+            </a:pPr>
+            <a:r>
+              <a:rPr lang="en-US" sz="1600" b="1" dirty="0">
+                <a:solidFill>
+                  <a:srgbClr val="003366"/>
+                </a:solidFill>
+              </a:rPr>
+              <a:t>1. Siapkan Kandidat (The Grid):</a:t>
+            </a:r>
+            <a:endParaRPr lang="en-US" sz="1600" dirty="0"/>
+          </a:p>
+          <a:p>
+            <a:pPr indent="0" marL="0">
+              <a:buNone/>
+            </a:pPr>
+            <a:r>
+              <a:rPr lang="en-US" sz="1600" dirty="0">
+                <a:solidFill>
+                  <a:srgbClr val="333333"/>
+                </a:solidFill>
+              </a:rPr>
+              <a:t>   Komputer mencoba 3 nilai: γ=0.0 (Tanpa Penalti), γ=0.5 (Sedang), γ=1.0 (Keras).</a:t>
+            </a:r>
+            <a:endParaRPr lang="en-US" sz="1600" dirty="0"/>
+          </a:p>
+          <a:p>
+            <a:pPr indent="0" marL="0">
+              <a:buNone/>
+            </a:pPr>
+            <a:r>
+              <a:rPr lang="en-US" sz="1600" b="1" dirty="0">
+                <a:solidFill>
+                  <a:srgbClr val="003366"/>
+                </a:solidFill>
+              </a:rPr>
+              <a:t>2. Simulasi Masa Lalu (Lookback Window):</a:t>
+            </a:r>
+            <a:endParaRPr lang="en-US" sz="1600" dirty="0"/>
+          </a:p>
+          <a:p>
+            <a:pPr indent="0" marL="0">
+              <a:buNone/>
+            </a:pPr>
+            <a:r>
+              <a:rPr lang="en-US" sz="1600" dirty="0">
+                <a:solidFill>
+                  <a:srgbClr val="333333"/>
+                </a:solidFill>
+              </a:rPr>
+              <a:t>   Maju ke belakang 30 hari, lalu hitung performa jika kita memakai nilai tersebut:</a:t>
+            </a:r>
+            <a:endParaRPr lang="en-US" sz="1600" dirty="0"/>
+          </a:p>
+          <a:p>
+            <a:pPr indent="0" marL="0">
+              <a:buNone/>
+            </a:pPr>
+            <a:r>
+              <a:rPr lang="en-US" sz="1600" dirty="0">
+                <a:solidFill>
+                  <a:srgbClr val="333333"/>
+                </a:solidFill>
+              </a:rPr>
+              <a:t>   • Jika pakai γ=0.0 → Sharpe Ratio: 0.85</a:t>
+            </a:r>
+            <a:endParaRPr lang="en-US" sz="1600" dirty="0"/>
+          </a:p>
+          <a:p>
+            <a:pPr indent="0" marL="0">
+              <a:buNone/>
+            </a:pPr>
+            <a:r>
+              <a:rPr lang="en-US" sz="1600" b="1" dirty="0">
                 <a:solidFill>
                   <a:srgbClr val="27AE60"/>
                 </a:solidFill>
               </a:rPr>
-              <a:t>1. Network Markowitz dengan Target Return (NW - Return Grid Search):</a:t>
-            </a:r>
-            <a:endParaRPr lang="en-US" sz="1800" dirty="0"/>
-          </a:p>
-          <a:p>
-            <a:pPr marL="342900" indent="-342900">
-              <a:buSzPct val="100000"/>
-              <a:buChar char="•"/>
-            </a:pPr>
-            <a:r>
-              <a:rPr lang="en-US" sz="1800" dirty="0">
-                <a:solidFill>
-                  <a:srgbClr val="333333"/>
-                </a:solidFill>
-              </a:rPr>
-              <a:t>Memaksimalkan capaian </a:t>
-            </a:r>
-            <a:pPr indent="0" marL="0">
-              <a:buNone/>
-            </a:pPr>
-            <a:r>
-              <a:rPr lang="en-US" sz="1800" b="1" dirty="0">
-                <a:solidFill>
-                  <a:srgbClr val="333333"/>
-                </a:solidFill>
-              </a:rPr>
-              <a:t>imbal hasil</a:t>
-            </a:r>
-            <a:pPr indent="0" marL="0">
-              <a:buNone/>
-            </a:pPr>
-            <a:r>
-              <a:rPr lang="en-US" sz="1800" dirty="0">
-                <a:solidFill>
-                  <a:srgbClr val="333333"/>
-                </a:solidFill>
-              </a:rPr>
-              <a:t> portofolio.</a:t>
-            </a:r>
-            <a:endParaRPr lang="en-US" sz="1800" dirty="0"/>
-          </a:p>
-          <a:p>
-            <a:pPr marL="342900" indent="-342900">
-              <a:buSzPct val="100000"/>
-              <a:buChar char="•"/>
-            </a:pPr>
-            <a:r>
-              <a:rPr lang="en-US" sz="1800" dirty="0">
-                <a:solidFill>
-                  <a:srgbClr val="333333"/>
-                </a:solidFill>
-              </a:rPr>
-              <a:t>Lebih Agresif untuk mengeksploitasi reli pada pasar </a:t>
-            </a:r>
-            <a:pPr indent="0" marL="0">
-              <a:buNone/>
-            </a:pPr>
-            <a:r>
-              <a:rPr lang="en-US" sz="1800" b="1" dirty="0">
-                <a:solidFill>
-                  <a:srgbClr val="333333"/>
-                </a:solidFill>
-              </a:rPr>
-              <a:t>Bullish</a:t>
-            </a:r>
-            <a:pPr indent="0" marL="0">
-              <a:buNone/>
-            </a:pPr>
-            <a:r>
-              <a:rPr lang="en-US" sz="1800" dirty="0">
-                <a:solidFill>
-                  <a:srgbClr val="333333"/>
-                </a:solidFill>
-              </a:rPr>
-              <a:t>.</a:t>
-            </a:r>
-            <a:endParaRPr lang="en-US" sz="1800" dirty="0"/>
-          </a:p>
-          <a:p>
-            <a:pPr indent="0" marL="0">
-              <a:buNone/>
-            </a:pPr>
-            <a:r>
-              <a:rPr lang="en-US" sz="1800" b="1" dirty="0">
-                <a:solidFill>
-                  <a:srgbClr val="C0392B"/>
-                </a:solidFill>
-              </a:rPr>
-              <a:t>2. Network Markowitz dengan Target Risiko (NW - Risk Grid Search):</a:t>
-            </a:r>
-            <a:endParaRPr lang="en-US" sz="1800" dirty="0"/>
-          </a:p>
-          <a:p>
-            <a:pPr marL="342900" indent="-342900">
-              <a:buSzPct val="100000"/>
-              <a:buChar char="•"/>
-            </a:pPr>
-            <a:r>
-              <a:rPr lang="en-US" sz="1800" dirty="0">
-                <a:solidFill>
-                  <a:srgbClr val="333333"/>
-                </a:solidFill>
-              </a:rPr>
-              <a:t>Menekan parameter </a:t>
-            </a:r>
-            <a:pPr indent="0" marL="0">
-              <a:buNone/>
-            </a:pPr>
-            <a:r>
-              <a:rPr lang="en-US" sz="1800" b="1" dirty="0">
-                <a:solidFill>
-                  <a:srgbClr val="333333"/>
-                </a:solidFill>
-              </a:rPr>
-              <a:t>risiko total</a:t>
-            </a:r>
-            <a:pPr indent="0" marL="0">
-              <a:buNone/>
-            </a:pPr>
-            <a:r>
-              <a:rPr lang="en-US" sz="1800" dirty="0">
-                <a:solidFill>
-                  <a:srgbClr val="333333"/>
-                </a:solidFill>
-              </a:rPr>
-              <a:t> hingga minimal.</a:t>
-            </a:r>
-            <a:endParaRPr lang="en-US" sz="1800" dirty="0"/>
-          </a:p>
-          <a:p>
-            <a:pPr marL="342900" indent="-342900">
-              <a:buSzPct val="100000"/>
-              <a:buChar char="•"/>
-            </a:pPr>
-            <a:r>
-              <a:rPr lang="en-US" sz="1800" dirty="0">
-                <a:solidFill>
-                  <a:srgbClr val="333333"/>
-                </a:solidFill>
-              </a:rPr>
-              <a:t>Lebih Defensif untuk meredam fluktuasi saat </a:t>
-            </a:r>
-            <a:pPr indent="0" marL="0">
-              <a:buNone/>
-            </a:pPr>
-            <a:r>
-              <a:rPr lang="en-US" sz="1800" b="1" dirty="0">
-                <a:solidFill>
-                  <a:srgbClr val="333333"/>
-                </a:solidFill>
-              </a:rPr>
-              <a:t>Crypto Winter</a:t>
-            </a:r>
-            <a:pPr indent="0" marL="0">
-              <a:buNone/>
-            </a:pPr>
-            <a:r>
-              <a:rPr lang="en-US" sz="1800" dirty="0">
-                <a:solidFill>
-                  <a:srgbClr val="333333"/>
-                </a:solidFill>
-              </a:rPr>
-              <a:t>.</a:t>
-            </a:r>
-            <a:endParaRPr lang="en-US" sz="1800" dirty="0"/>
+              <a:t>   • Jika pakai γ=0.5 → Sharpe Ratio: 1.10 (TERBAIK)</a:t>
+            </a:r>
+            <a:endParaRPr lang="en-US" sz="1600" dirty="0"/>
+          </a:p>
+          <a:p>
+            <a:pPr indent="0" marL="0">
+              <a:buNone/>
+            </a:pPr>
+            <a:r>
+              <a:rPr lang="en-US" sz="1600" dirty="0">
+                <a:solidFill>
+                  <a:srgbClr val="333333"/>
+                </a:solidFill>
+              </a:rPr>
+              <a:t>   • Jika pakai γ=1.0 → Sharpe Ratio: 0.95</a:t>
+            </a:r>
+            <a:endParaRPr lang="en-US" sz="1600" dirty="0"/>
+          </a:p>
+          <a:p>
+            <a:pPr indent="0" marL="0">
+              <a:buNone/>
+            </a:pPr>
+            <a:r>
+              <a:rPr lang="en-US" sz="1600" b="1" dirty="0">
+                <a:solidFill>
+                  <a:srgbClr val="003366"/>
+                </a:solidFill>
+              </a:rPr>
+              <a:t>3. Penentuan Pemenang (The Best Gamma):</a:t>
+            </a:r>
+            <a:endParaRPr lang="en-US" sz="1600" dirty="0"/>
+          </a:p>
+          <a:p>
+            <a:pPr indent="0" marL="0">
+              <a:buNone/>
+            </a:pPr>
+            <a:r>
+              <a:rPr lang="en-US" sz="1600" dirty="0">
+                <a:solidFill>
+                  <a:srgbClr val="333333"/>
+                </a:solidFill>
+              </a:rPr>
+              <a:t>   Karena γ=0.5 menghasilkan efisiensi terbaik di 30 hari terakhir, ia terpilih sebagai pemenang.</a:t>
+            </a:r>
+            <a:endParaRPr lang="en-US" sz="1600" dirty="0"/>
+          </a:p>
+          <a:p>
+            <a:pPr indent="0" marL="0">
+              <a:buNone/>
+            </a:pPr>
+            <a:r>
+              <a:rPr lang="en-US" sz="1600" b="1" dirty="0">
+                <a:solidFill>
+                  <a:srgbClr val="003366"/>
+                </a:solidFill>
+              </a:rPr>
+              <a:t>4. Penerapan (Actual Trade):</a:t>
+            </a:r>
+            <a:endParaRPr lang="en-US" sz="1600" dirty="0"/>
+          </a:p>
+          <a:p>
+            <a:pPr indent="0" marL="0">
+              <a:buNone/>
+            </a:pPr>
+            <a:r>
+              <a:rPr lang="en-US" sz="1600" dirty="0">
+                <a:solidFill>
+                  <a:srgbClr val="333333"/>
+                </a:solidFill>
+              </a:rPr>
+              <a:t>   Gunakan γ=0.5 untuk menghitung bobot portofolio asli di minggu depan.</a:t>
+            </a:r>
+            <a:endParaRPr lang="en-US" sz="1600" dirty="0"/>
+          </a:p>
+          <a:p>
+            <a:pPr indent="0" marL="0">
+              <a:buNone/>
+            </a:pPr>
+            <a:r>
+              <a:rPr lang="en-US" sz="1600" b="1" dirty="0">
+                <a:solidFill>
+                  <a:srgbClr val="8E44AD"/>
+                </a:solidFill>
+              </a:rPr>
+              <a:t>Kesimpulan Adaptif:</a:t>
+            </a:r>
+            <a:endParaRPr lang="en-US" sz="1600" dirty="0"/>
+          </a:p>
+          <a:p>
+            <a:pPr indent="0" marL="0">
+              <a:buNone/>
+            </a:pPr>
+            <a:r>
+              <a:rPr lang="en-US" sz="1600" i="1" dirty="0">
+                <a:solidFill>
+                  <a:srgbClr val="333333"/>
+                </a:solidFill>
+              </a:rPr>
+              <a:t>Minggu depan, proses ini diulang kembali. Jika pasar berubah kacau, mungkin γ=1.0 yang akan menang. Inilah cara model menyesuaikan diri tanpa campur tangan manusia.</a:t>
+            </a:r>
+            <a:endParaRPr lang="en-US" sz="1600" dirty="0"/>
           </a:p>
         </p:txBody>
       </p:sp>
@@ -19155,7 +19295,7 @@
                   <a:srgbClr val="003366"/>
                 </a:solidFill>
               </a:rPr>
-              <a:t>Lampiran: Penanganan Data Kosong (Missing Values)</a:t>
+              <a:t>Lampiran: Dua Tipe Pendekatan Grid Search</a:t>
             </a:r>
             <a:endParaRPr lang="en-US" sz="2600" dirty="0"/>
           </a:p>
@@ -19188,41 +19328,156 @@
             <a:r>
               <a:rPr lang="en-US" sz="1800" b="1" dirty="0">
                 <a:solidFill>
+                  <a:srgbClr val="333333"/>
+                </a:solidFill>
+              </a:rPr>
+              <a:t>Dua Objektif Optimasi (Return vs Risk):</a:t>
+            </a:r>
+            <a:endParaRPr lang="en-US" sz="1800" dirty="0"/>
+          </a:p>
+          <a:p>
+            <a:pPr indent="0" marL="0">
+              <a:buNone/>
+            </a:pPr>
+            <a:r>
+              <a:rPr lang="en-US" sz="1800" b="1" dirty="0">
+                <a:solidFill>
+                  <a:srgbClr val="27AE60"/>
+                </a:solidFill>
+              </a:rPr>
+              <a:t>1. Network Markowitz dengan Target Return (NW - Return Grid Search):</a:t>
+            </a:r>
+            <a:endParaRPr lang="en-US" sz="1800" dirty="0"/>
+          </a:p>
+          <a:p>
+            <a:pPr marL="342900" indent="-342900">
+              <a:buSzPct val="100000"/>
+              <a:buChar char="•"/>
+            </a:pPr>
+            <a:r>
+              <a:rPr lang="en-US" sz="1800" dirty="0">
+                <a:solidFill>
+                  <a:srgbClr val="333333"/>
+                </a:solidFill>
+              </a:rPr>
+              <a:t>Memaksimalkan capaian </a:t>
+            </a:r>
+            <a:pPr indent="0" marL="0">
+              <a:buNone/>
+            </a:pPr>
+            <a:r>
+              <a:rPr lang="en-US" sz="1800" b="1" dirty="0">
+                <a:solidFill>
+                  <a:srgbClr val="333333"/>
+                </a:solidFill>
+              </a:rPr>
+              <a:t>imbal hasil</a:t>
+            </a:r>
+            <a:pPr indent="0" marL="0">
+              <a:buNone/>
+            </a:pPr>
+            <a:r>
+              <a:rPr lang="en-US" sz="1800" dirty="0">
+                <a:solidFill>
+                  <a:srgbClr val="333333"/>
+                </a:solidFill>
+              </a:rPr>
+              <a:t> portofolio.</a:t>
+            </a:r>
+            <a:endParaRPr lang="en-US" sz="1800" dirty="0"/>
+          </a:p>
+          <a:p>
+            <a:pPr marL="342900" indent="-342900">
+              <a:buSzPct val="100000"/>
+              <a:buChar char="•"/>
+            </a:pPr>
+            <a:r>
+              <a:rPr lang="en-US" sz="1800" dirty="0">
+                <a:solidFill>
+                  <a:srgbClr val="333333"/>
+                </a:solidFill>
+              </a:rPr>
+              <a:t>Lebih Agresif untuk mengeksploitasi reli pada pasar </a:t>
+            </a:r>
+            <a:pPr indent="0" marL="0">
+              <a:buNone/>
+            </a:pPr>
+            <a:r>
+              <a:rPr lang="en-US" sz="1800" b="1" dirty="0">
+                <a:solidFill>
+                  <a:srgbClr val="333333"/>
+                </a:solidFill>
+              </a:rPr>
+              <a:t>Bullish</a:t>
+            </a:r>
+            <a:pPr indent="0" marL="0">
+              <a:buNone/>
+            </a:pPr>
+            <a:r>
+              <a:rPr lang="en-US" sz="1800" dirty="0">
+                <a:solidFill>
+                  <a:srgbClr val="333333"/>
+                </a:solidFill>
+              </a:rPr>
+              <a:t>.</a:t>
+            </a:r>
+            <a:endParaRPr lang="en-US" sz="1800" dirty="0"/>
+          </a:p>
+          <a:p>
+            <a:pPr indent="0" marL="0">
+              <a:buNone/>
+            </a:pPr>
+            <a:r>
+              <a:rPr lang="en-US" sz="1800" b="1" dirty="0">
+                <a:solidFill>
                   <a:srgbClr val="C0392B"/>
                 </a:solidFill>
               </a:rPr>
-              <a:t>Pertanyaan: </a:t>
-            </a:r>
-            <a:pPr indent="0" marL="0">
-              <a:buNone/>
-            </a:pPr>
-            <a:r>
-              <a:rPr lang="en-US" sz="1800" i="1" dirty="0">
-                <a:solidFill>
-                  <a:srgbClr val="333333"/>
-                </a:solidFill>
-              </a:rPr>
-              <a:t>"Beberapa koin seperti Binance/EOS belum rilis di awal 2017 sehingga datanya kosong. Bukankah backward-fill memalsukan harga dan merusak matriks?"</a:t>
+              <a:t>2. Network Markowitz dengan Target Risiko (NW - Risk Grid Search):</a:t>
             </a:r>
             <a:endParaRPr lang="en-US" sz="1800" dirty="0"/>
           </a:p>
           <a:p>
+            <a:pPr marL="342900" indent="-342900">
+              <a:buSzPct val="100000"/>
+              <a:buChar char="•"/>
+            </a:pPr>
+            <a:r>
+              <a:rPr lang="en-US" sz="1800" dirty="0">
+                <a:solidFill>
+                  <a:srgbClr val="333333"/>
+                </a:solidFill>
+              </a:rPr>
+              <a:t>Menekan parameter </a:t>
+            </a:r>
             <a:pPr indent="0" marL="0">
               <a:buNone/>
             </a:pPr>
             <a:r>
               <a:rPr lang="en-US" sz="1800" b="1" dirty="0">
                 <a:solidFill>
-                  <a:srgbClr val="27AE60"/>
-                </a:solidFill>
-              </a:rPr>
-              <a:t>Jawaban (Kenapa RMT sangat Krusial):</a:t>
+                  <a:srgbClr val="333333"/>
+                </a:solidFill>
+              </a:rPr>
+              <a:t>risiko total</a:t>
+            </a:r>
+            <a:pPr indent="0" marL="0">
+              <a:buNone/>
+            </a:pPr>
+            <a:r>
+              <a:rPr lang="en-US" sz="1800" dirty="0">
+                <a:solidFill>
+                  <a:srgbClr val="333333"/>
+                </a:solidFill>
+              </a:rPr>
+              <a:t> hingga minimal.</a:t>
             </a:r>
             <a:endParaRPr lang="en-US" sz="1800" dirty="0"/>
           </a:p>
           <a:p>
-            <a:pPr indent="0" marL="0">
-              <a:buNone/>
+            <a:pPr marL="342900" indent="-342900">
+              <a:buSzPct val="100000"/>
+              <a:buChar char="•"/>
             </a:pPr>
             <a:r>
               <a:rPr lang="en-US" sz="1800" dirty="0">
@@ -19230,18 +19485,18 @@
                   <a:srgbClr val="333333"/>
                 </a:solidFill>
               </a:rPr>
-              <a:t>   1. Praktik pengisian data diam (</a:t>
-            </a:r>
-            <a:pPr indent="0" marL="0">
-              <a:buNone/>
-            </a:pPr>
-            <a:r>
-              <a:rPr lang="en-US" sz="1800" b="1" i="1" dirty="0">
-                <a:solidFill>
-                  <a:srgbClr val="333333"/>
-                </a:solidFill>
-              </a:rPr>
-              <a:t>backward fill</a:t>
+              <a:t>Lebih Defensif untuk meredam fluktuasi saat </a:t>
+            </a:r>
+            <a:pPr indent="0" marL="0">
+              <a:buNone/>
+            </a:pPr>
+            <a:r>
+              <a:rPr lang="en-US" sz="1800" b="1" dirty="0">
+                <a:solidFill>
+                  <a:srgbClr val="333333"/>
+                </a:solidFill>
+              </a:rPr>
+              <a:t>Crypto Winter</a:t>
             </a:r>
             <a:pPr indent="0" marL="0">
               <a:buNone/>
@@ -19252,115 +19507,7 @@
                   <a:srgbClr val="333333"/>
                 </a:solidFill>
               </a:rPr>
-              <a:t>) memang menciptakan rentetan nilai harga yang statis.</a:t>
-            </a:r>
-            <a:endParaRPr lang="en-US" sz="1800" dirty="0"/>
-          </a:p>
-          <a:p>
-            <a:pPr indent="0" marL="0">
-              <a:buNone/>
-            </a:pPr>
-            <a:r>
-              <a:rPr lang="en-US" sz="1800" dirty="0">
-                <a:solidFill>
-                  <a:srgbClr val="333333"/>
-                </a:solidFill>
-              </a:rPr>
-              <a:t>   2. Namun, kehebatan </a:t>
-            </a:r>
-            <a:pPr indent="0" marL="0">
-              <a:buNone/>
-            </a:pPr>
-            <a:r>
-              <a:rPr lang="en-US" sz="1800" b="1" dirty="0">
-                <a:solidFill>
-                  <a:srgbClr val="333333"/>
-                </a:solidFill>
-              </a:rPr>
-              <a:t>Random Matrix Theory (RMT)</a:t>
-            </a:r>
-            <a:pPr indent="0" marL="0">
-              <a:buNone/>
-            </a:pPr>
-            <a:r>
-              <a:rPr lang="en-US" sz="1800" dirty="0">
-                <a:solidFill>
-                  <a:srgbClr val="333333"/>
-                </a:solidFill>
-              </a:rPr>
-              <a:t> diuji di sini! Karena data yang datar sama sekali tidak punya korelasi nyata.</a:t>
-            </a:r>
-            <a:endParaRPr lang="en-US" sz="1800" dirty="0"/>
-          </a:p>
-          <a:p>
-            <a:pPr indent="0" marL="0">
-              <a:buNone/>
-            </a:pPr>
-            <a:r>
-              <a:rPr lang="en-US" sz="1800" dirty="0">
-                <a:solidFill>
-                  <a:srgbClr val="333333"/>
-                </a:solidFill>
-              </a:rPr>
-              <a:t>   3. RMT otomatis akan mendeteksi korelasi buatan tersebut sebagai probabilitas </a:t>
-            </a:r>
-            <a:pPr indent="0" marL="0">
-              <a:buNone/>
-            </a:pPr>
-            <a:r>
-              <a:rPr lang="en-US" sz="1800" b="1" i="1" dirty="0">
-                <a:solidFill>
-                  <a:srgbClr val="333333"/>
-                </a:solidFill>
-              </a:rPr>
-              <a:t>Noise Acak</a:t>
-            </a:r>
-            <a:pPr indent="0" marL="0">
-              <a:buNone/>
-            </a:pPr>
-            <a:r>
-              <a:rPr lang="en-US" sz="1800" dirty="0">
-                <a:solidFill>
-                  <a:srgbClr val="333333"/>
-                </a:solidFill>
-              </a:rPr>
-              <a:t>, lalu membuangnya menjadi 0.</a:t>
-            </a:r>
-            <a:endParaRPr lang="en-US" sz="1800" dirty="0"/>
-          </a:p>
-          <a:p>
-            <a:pPr indent="0" marL="0">
-              <a:buNone/>
-            </a:pPr>
-            <a:r>
-              <a:rPr lang="en-US" sz="1800" dirty="0">
-                <a:solidFill>
-                  <a:srgbClr val="333333"/>
-                </a:solidFill>
-              </a:rPr>
-              <a:t>   4. Hasilnya, matriks korelasi </a:t>
-            </a:r>
-            <a:pPr indent="0" marL="0">
-              <a:buNone/>
-            </a:pPr>
-            <a:r>
-              <a:rPr lang="en-US" sz="1800" b="1" dirty="0">
-                <a:solidFill>
-                  <a:srgbClr val="333333"/>
-                </a:solidFill>
-              </a:rPr>
-              <a:t>terselamatkan</a:t>
-            </a:r>
-            <a:pPr indent="0" marL="0">
-              <a:buNone/>
-            </a:pPr>
-            <a:r>
-              <a:rPr lang="en-US" sz="1800" dirty="0">
-                <a:solidFill>
-                  <a:srgbClr val="333333"/>
-                </a:solidFill>
-              </a:rPr>
-              <a:t> dan tidak tercemar oleh cacat kelengkapan data.</a:t>
+              <a:t>.</a:t>
             </a:r>
             <a:endParaRPr lang="en-US" sz="1800" dirty="0"/>
           </a:p>
@@ -19466,7 +19613,7 @@
                   <a:srgbClr val="003366"/>
                 </a:solidFill>
               </a:rPr>
-              <a:t>Lampiran: Mengapa Menyertakan Tether (USDT)? (1/2)</a:t>
+              <a:t>Lampiran: Penanganan Data Kosong (Missing Values)</a:t>
             </a:r>
             <a:endParaRPr lang="en-US" sz="2600" dirty="0"/>
           </a:p>
@@ -19513,7 +19660,7 @@
                   <a:srgbClr val="333333"/>
                 </a:solidFill>
               </a:rPr>
-              <a:t>"Tether (USDT) itu stablecoin yang nilainya selalu fix ke 1 USD. Apakah tidak berbuat curang?"</a:t>
+              <a:t>"Beberapa koin seperti Binance/EOS belum rilis di awal 2017 sehingga datanya kosong. Bukankah backward-fill memalsukan harga dan merusak matriks?"</a:t>
             </a:r>
             <a:endParaRPr lang="en-US" sz="1800" dirty="0"/>
           </a:p>
@@ -19527,14 +19674,13 @@
                   <a:srgbClr val="27AE60"/>
                 </a:solidFill>
               </a:rPr>
-              <a:t>Jawaban (Dinamika Portofolio Cerdas):</a:t>
+              <a:t>Jawaban (Kenapa RMT sangat Krusial):</a:t>
             </a:r>
             <a:endParaRPr lang="en-US" sz="1800" dirty="0"/>
           </a:p>
           <a:p>
-            <a:pPr marL="342900" indent="-342900">
-              <a:buSzPct val="100000"/>
-              <a:buChar char="•"/>
+            <a:pPr indent="0" marL="0">
+              <a:buNone/>
             </a:pPr>
             <a:r>
               <a:rPr lang="en-US" sz="1800" dirty="0">
@@ -19542,7 +19688,7 @@
                   <a:srgbClr val="333333"/>
                 </a:solidFill>
               </a:rPr>
-              <a:t>Model ini mensimulasikan perilaku </a:t>
+              <a:t>   1. Praktik pengisian data diam (</a:t>
             </a:r>
             <a:pPr indent="0" marL="0">
               <a:buNone/>
@@ -19553,7 +19699,7 @@
                   <a:srgbClr val="333333"/>
                 </a:solidFill>
               </a:rPr>
-              <a:t>Robo-Advisory</a:t>
+              <a:t>backward fill</a:t>
             </a:r>
             <a:pPr indent="0" marL="0">
               <a:buNone/>
@@ -19564,14 +19710,13 @@
                   <a:srgbClr val="333333"/>
                 </a:solidFill>
               </a:rPr>
-              <a:t> institusional.</a:t>
+              <a:t>) memang menciptakan rentetan nilai harga yang statis.</a:t>
             </a:r>
             <a:endParaRPr lang="en-US" sz="1800" dirty="0"/>
           </a:p>
           <a:p>
-            <a:pPr marL="342900" indent="-342900">
-              <a:buSzPct val="100000"/>
-              <a:buChar char="•"/>
+            <a:pPr indent="0" marL="0">
+              <a:buNone/>
             </a:pPr>
             <a:r>
               <a:rPr lang="en-US" sz="1800" dirty="0">
@@ -19579,7 +19724,7 @@
                   <a:srgbClr val="333333"/>
                 </a:solidFill>
               </a:rPr>
-              <a:t>Ketika pasar anjlok ekstrem, investor akan melarikan senjatanya ke posisi </a:t>
+              <a:t>   2. Namun, kehebatan </a:t>
             </a:r>
             <a:pPr indent="0" marL="0">
               <a:buNone/>
@@ -19590,7 +19735,7 @@
                   <a:srgbClr val="333333"/>
                 </a:solidFill>
               </a:rPr>
-              <a:t>tunai (USDT)</a:t>
+              <a:t>Random Matrix Theory (RMT)</a:t>
             </a:r>
             <a:pPr indent="0" marL="0">
               <a:buNone/>
@@ -19601,7 +19746,79 @@
                   <a:srgbClr val="333333"/>
                 </a:solidFill>
               </a:rPr>
-              <a:t> sebagai evakuasi risiko.</a:t>
+              <a:t> diuji di sini! Karena data yang datar sama sekali tidak punya korelasi nyata.</a:t>
+            </a:r>
+            <a:endParaRPr lang="en-US" sz="1800" dirty="0"/>
+          </a:p>
+          <a:p>
+            <a:pPr indent="0" marL="0">
+              <a:buNone/>
+            </a:pPr>
+            <a:r>
+              <a:rPr lang="en-US" sz="1800" dirty="0">
+                <a:solidFill>
+                  <a:srgbClr val="333333"/>
+                </a:solidFill>
+              </a:rPr>
+              <a:t>   3. RMT otomatis akan mendeteksi korelasi buatan tersebut sebagai probabilitas </a:t>
+            </a:r>
+            <a:pPr indent="0" marL="0">
+              <a:buNone/>
+            </a:pPr>
+            <a:r>
+              <a:rPr lang="en-US" sz="1800" b="1" i="1" dirty="0">
+                <a:solidFill>
+                  <a:srgbClr val="333333"/>
+                </a:solidFill>
+              </a:rPr>
+              <a:t>Noise Acak</a:t>
+            </a:r>
+            <a:pPr indent="0" marL="0">
+              <a:buNone/>
+            </a:pPr>
+            <a:r>
+              <a:rPr lang="en-US" sz="1800" dirty="0">
+                <a:solidFill>
+                  <a:srgbClr val="333333"/>
+                </a:solidFill>
+              </a:rPr>
+              <a:t>, lalu membuangnya menjadi 0.</a:t>
+            </a:r>
+            <a:endParaRPr lang="en-US" sz="1800" dirty="0"/>
+          </a:p>
+          <a:p>
+            <a:pPr indent="0" marL="0">
+              <a:buNone/>
+            </a:pPr>
+            <a:r>
+              <a:rPr lang="en-US" sz="1800" dirty="0">
+                <a:solidFill>
+                  <a:srgbClr val="333333"/>
+                </a:solidFill>
+              </a:rPr>
+              <a:t>   4. Hasilnya, matriks korelasi </a:t>
+            </a:r>
+            <a:pPr indent="0" marL="0">
+              <a:buNone/>
+            </a:pPr>
+            <a:r>
+              <a:rPr lang="en-US" sz="1800" b="1" dirty="0">
+                <a:solidFill>
+                  <a:srgbClr val="333333"/>
+                </a:solidFill>
+              </a:rPr>
+              <a:t>terselamatkan</a:t>
+            </a:r>
+            <a:pPr indent="0" marL="0">
+              <a:buNone/>
+            </a:pPr>
+            <a:r>
+              <a:rPr lang="en-US" sz="1800" dirty="0">
+                <a:solidFill>
+                  <a:srgbClr val="333333"/>
+                </a:solidFill>
+              </a:rPr>
+              <a:t> dan tidak tercemar oleh cacat kelengkapan data.</a:t>
             </a:r>
             <a:endParaRPr lang="en-US" sz="1800" dirty="0"/>
           </a:p>
@@ -20101,7 +20318,7 @@
                   <a:srgbClr val="003366"/>
                 </a:solidFill>
               </a:rPr>
-              <a:t>Lampiran: Mengapa Menyertakan Tether (USDT)? (2/2)</a:t>
+              <a:t>Lampiran: Mengapa Menyertakan Tether (USDT)? (1/2)</a:t>
             </a:r>
             <a:endParaRPr lang="en-US" sz="2600" dirty="0"/>
           </a:p>
@@ -20132,12 +20349,89 @@
               <a:buNone/>
             </a:pPr>
             <a:r>
+              <a:rPr lang="en-US" sz="1800" b="1" dirty="0">
+                <a:solidFill>
+                  <a:srgbClr val="C0392B"/>
+                </a:solidFill>
+              </a:rPr>
+              <a:t>Pertanyaan: </a:t>
+            </a:r>
+            <a:pPr indent="0" marL="0">
+              <a:buNone/>
+            </a:pPr>
+            <a:r>
+              <a:rPr lang="en-US" sz="1800" i="1" dirty="0">
+                <a:solidFill>
+                  <a:srgbClr val="333333"/>
+                </a:solidFill>
+              </a:rPr>
+              <a:t>"Tether (USDT) itu stablecoin yang nilainya selalu fix ke 1 USD. Apakah tidak berbuat curang?"</a:t>
+            </a:r>
+            <a:endParaRPr lang="en-US" sz="1800" dirty="0"/>
+          </a:p>
+          <a:p>
+            <a:pPr indent="0" marL="0">
+              <a:buNone/>
+            </a:pPr>
+            <a:r>
+              <a:rPr lang="en-US" sz="1800" b="1" dirty="0">
+                <a:solidFill>
+                  <a:srgbClr val="27AE60"/>
+                </a:solidFill>
+              </a:rPr>
+              <a:t>Jawaban (Dinamika Portofolio Cerdas):</a:t>
+            </a:r>
+            <a:endParaRPr lang="en-US" sz="1800" dirty="0"/>
+          </a:p>
+          <a:p>
+            <a:pPr marL="342900" indent="-342900">
+              <a:buSzPct val="100000"/>
+              <a:buChar char="•"/>
+            </a:pPr>
+            <a:r>
               <a:rPr lang="en-US" sz="1800" dirty="0">
                 <a:solidFill>
                   <a:srgbClr val="333333"/>
                 </a:solidFill>
               </a:rPr>
-              <a:t>3. Algoritma jaringan </a:t>
+              <a:t>Model ini mensimulasikan perilaku </a:t>
+            </a:r>
+            <a:pPr indent="0" marL="0">
+              <a:buNone/>
+            </a:pPr>
+            <a:r>
+              <a:rPr lang="en-US" sz="1800" b="1" i="1" dirty="0">
+                <a:solidFill>
+                  <a:srgbClr val="333333"/>
+                </a:solidFill>
+              </a:rPr>
+              <a:t>Robo-Advisory</a:t>
+            </a:r>
+            <a:pPr indent="0" marL="0">
+              <a:buNone/>
+            </a:pPr>
+            <a:r>
+              <a:rPr lang="en-US" sz="1800" dirty="0">
+                <a:solidFill>
+                  <a:srgbClr val="333333"/>
+                </a:solidFill>
+              </a:rPr>
+              <a:t> institusional.</a:t>
+            </a:r>
+            <a:endParaRPr lang="en-US" sz="1800" dirty="0"/>
+          </a:p>
+          <a:p>
+            <a:pPr marL="342900" indent="-342900">
+              <a:buSzPct val="100000"/>
+              <a:buChar char="•"/>
+            </a:pPr>
+            <a:r>
+              <a:rPr lang="en-US" sz="1800" dirty="0">
+                <a:solidFill>
+                  <a:srgbClr val="333333"/>
+                </a:solidFill>
+              </a:rPr>
+              <a:t>Ketika pasar anjlok ekstrem, investor akan melarikan senjatanya ke posisi </a:t>
             </a:r>
             <a:pPr indent="0" marL="0">
               <a:buNone/>
@@ -20148,7 +20442,7 @@
                   <a:srgbClr val="333333"/>
                 </a:solidFill>
               </a:rPr>
-              <a:t>Network Markowitz GS (Grid Search)</a:t>
+              <a:t>tunai (USDT)</a:t>
             </a:r>
             <a:pPr indent="0" marL="0">
               <a:buNone/>
@@ -20159,87 +20453,7 @@
                   <a:srgbClr val="333333"/>
                 </a:solidFill>
               </a:rPr>
-              <a:t> dilatih secara matematis; jika mendeteksi korelasi ancaman kolaps merambat ke semua altcoin, ia akan melempar alokasi modalnya menuju node </a:t>
-            </a:r>
-            <a:pPr indent="0" marL="0">
-              <a:buNone/>
-            </a:pPr>
-            <a:r>
-              <a:rPr lang="en-US" sz="1800" b="1" dirty="0">
-                <a:solidFill>
-                  <a:srgbClr val="333333"/>
-                </a:solidFill>
-              </a:rPr>
-              <a:t>USDT (Tether)</a:t>
-            </a:r>
-            <a:pPr indent="0" marL="0">
-              <a:buNone/>
-            </a:pPr>
-            <a:r>
-              <a:rPr lang="en-US" sz="1800" dirty="0">
-                <a:solidFill>
-                  <a:srgbClr val="333333"/>
-                </a:solidFill>
-              </a:rPr>
-              <a:t> sebagai langkah </a:t>
-            </a:r>
-            <a:pPr indent="0" marL="0">
-              <a:buNone/>
-            </a:pPr>
-            <a:r>
-              <a:rPr lang="en-US" sz="1800" b="1" dirty="0">
-                <a:solidFill>
-                  <a:srgbClr val="333333"/>
-                </a:solidFill>
-              </a:rPr>
-              <a:t>evakuasi otomatis</a:t>
-            </a:r>
-            <a:pPr indent="0" marL="0">
-              <a:buNone/>
-            </a:pPr>
-            <a:r>
-              <a:rPr lang="en-US" sz="1800" dirty="0">
-                <a:solidFill>
-                  <a:srgbClr val="333333"/>
-                </a:solidFill>
-              </a:rPr>
-              <a:t> (Shock-Absorber).</a:t>
-            </a:r>
-            <a:endParaRPr lang="en-US" sz="1800" dirty="0"/>
-          </a:p>
-          <a:p>
-            <a:pPr indent="0" marL="0">
-              <a:buNone/>
-            </a:pPr>
-            <a:r>
-              <a:rPr lang="en-US" sz="1800" dirty="0">
-                <a:solidFill>
-                  <a:srgbClr val="333333"/>
-                </a:solidFill>
-              </a:rPr>
-              <a:t>   4. Hal ini yang membuat performa Risk-GS (Grid Search) sangat </a:t>
-            </a:r>
-            <a:pPr indent="0" marL="0">
-              <a:buNone/>
-            </a:pPr>
-            <a:r>
-              <a:rPr lang="en-US" sz="1800" b="1" dirty="0">
-                <a:solidFill>
-                  <a:srgbClr val="333333"/>
-                </a:solidFill>
-              </a:rPr>
-              <a:t>tangguh</a:t>
-            </a:r>
-            <a:pPr indent="0" marL="0">
-              <a:buNone/>
-            </a:pPr>
-            <a:r>
-              <a:rPr lang="en-US" sz="1800" dirty="0">
-                <a:solidFill>
-                  <a:srgbClr val="333333"/>
-                </a:solidFill>
-              </a:rPr>
-              <a:t> dari serangan Crypto Winter, suatu kapabilitas pertahanan yang tidak dipahami oleh model ortodoks murni Markowitz.</a:t>
+              <a:t> sebagai evakuasi risiko.</a:t>
             </a:r>
             <a:endParaRPr lang="en-US" sz="1800" dirty="0"/>
           </a:p>
@@ -20345,7 +20559,7 @@
                   <a:srgbClr val="003366"/>
                 </a:solidFill>
               </a:rPr>
-              <a:t>Lampiran: Bukti Empiris Non-Stationarity Pasar</a:t>
+              <a:t>Lampiran: Mengapa Menyertakan Tether (USDT)? (2/2)</a:t>
             </a:r>
             <a:endParaRPr lang="en-US" sz="2600" dirty="0"/>
           </a:p>
@@ -20376,23 +20590,78 @@
               <a:buNone/>
             </a:pPr>
             <a:r>
+              <a:rPr lang="en-US" sz="1800" dirty="0">
+                <a:solidFill>
+                  <a:srgbClr val="333333"/>
+                </a:solidFill>
+              </a:rPr>
+              <a:t>3. Algoritma jaringan </a:t>
+            </a:r>
+            <a:pPr indent="0" marL="0">
+              <a:buNone/>
+            </a:pPr>
+            <a:r>
               <a:rPr lang="en-US" sz="1800" b="1" dirty="0">
                 <a:solidFill>
-                  <a:srgbClr val="C0392B"/>
-                </a:solidFill>
-              </a:rPr>
-              <a:t>Masalah: </a:t>
-            </a:r>
-            <a:pPr indent="0" marL="0">
-              <a:buNone/>
-            </a:pPr>
-            <a:r>
-              <a:rPr lang="en-US" sz="1800" i="1" dirty="0">
-                <a:solidFill>
-                  <a:srgbClr val="333333"/>
-                </a:solidFill>
-              </a:rPr>
-              <a:t>Kenapa harus menggunakan model Adaptif (Dynamic Gamma)?</a:t>
+                  <a:srgbClr val="333333"/>
+                </a:solidFill>
+              </a:rPr>
+              <a:t>Network Markowitz GS (Grid Search)</a:t>
+            </a:r>
+            <a:pPr indent="0" marL="0">
+              <a:buNone/>
+            </a:pPr>
+            <a:r>
+              <a:rPr lang="en-US" sz="1800" dirty="0">
+                <a:solidFill>
+                  <a:srgbClr val="333333"/>
+                </a:solidFill>
+              </a:rPr>
+              <a:t> dilatih secara matematis; jika mendeteksi korelasi ancaman kolaps merambat ke semua altcoin, ia akan melempar alokasi modalnya menuju node </a:t>
+            </a:r>
+            <a:pPr indent="0" marL="0">
+              <a:buNone/>
+            </a:pPr>
+            <a:r>
+              <a:rPr lang="en-US" sz="1800" b="1" dirty="0">
+                <a:solidFill>
+                  <a:srgbClr val="333333"/>
+                </a:solidFill>
+              </a:rPr>
+              <a:t>USDT (Tether)</a:t>
+            </a:r>
+            <a:pPr indent="0" marL="0">
+              <a:buNone/>
+            </a:pPr>
+            <a:r>
+              <a:rPr lang="en-US" sz="1800" dirty="0">
+                <a:solidFill>
+                  <a:srgbClr val="333333"/>
+                </a:solidFill>
+              </a:rPr>
+              <a:t> sebagai langkah </a:t>
+            </a:r>
+            <a:pPr indent="0" marL="0">
+              <a:buNone/>
+            </a:pPr>
+            <a:r>
+              <a:rPr lang="en-US" sz="1800" b="1" dirty="0">
+                <a:solidFill>
+                  <a:srgbClr val="333333"/>
+                </a:solidFill>
+              </a:rPr>
+              <a:t>evakuasi otomatis</a:t>
+            </a:r>
+            <a:pPr indent="0" marL="0">
+              <a:buNone/>
+            </a:pPr>
+            <a:r>
+              <a:rPr lang="en-US" sz="1800" dirty="0">
+                <a:solidFill>
+                  <a:srgbClr val="333333"/>
+                </a:solidFill>
+              </a:rPr>
+              <a:t> (Shock-Absorber).</a:t>
             </a:r>
             <a:endParaRPr lang="en-US" sz="1800" dirty="0"/>
           </a:p>
@@ -20401,19 +20670,26 @@
               <a:buNone/>
             </a:pPr>
             <a:r>
+              <a:rPr lang="en-US" sz="1800" dirty="0">
+                <a:solidFill>
+                  <a:srgbClr val="333333"/>
+                </a:solidFill>
+              </a:rPr>
+              <a:t>   4. Hal ini yang membuat performa Risk-GS (Grid Search) sangat </a:t>
+            </a:r>
+            <a:pPr indent="0" marL="0">
+              <a:buNone/>
+            </a:pPr>
+            <a:r>
               <a:rPr lang="en-US" sz="1800" b="1" dirty="0">
                 <a:solidFill>
-                  <a:srgbClr val="27AE60"/>
-                </a:solidFill>
-              </a:rPr>
-              <a:t>Bukti dari Grid Search:</a:t>
-            </a:r>
-            <a:endParaRPr lang="en-US" sz="1800" dirty="0"/>
-          </a:p>
-          <a:p>
-            <a:pPr marL="342900" indent="-342900">
-              <a:buSzPct val="100000"/>
-              <a:buChar char="•"/>
+                  <a:srgbClr val="333333"/>
+                </a:solidFill>
+              </a:rPr>
+              <a:t>tangguh</a:t>
+            </a:r>
+            <a:pPr indent="0" marL="0">
+              <a:buNone/>
             </a:pPr>
             <a:r>
               <a:rPr lang="en-US" sz="1800" dirty="0">
@@ -20421,103 +20697,7 @@
                   <a:srgbClr val="333333"/>
                 </a:solidFill>
               </a:rPr>
-              <a:t>Data menunjukkan nilai Gamma (γ) optimal </a:t>
-            </a:r>
-            <a:pPr indent="0" marL="0">
-              <a:buNone/>
-            </a:pPr>
-            <a:r>
-              <a:rPr lang="en-US" sz="1800" b="1" dirty="0">
-                <a:solidFill>
-                  <a:srgbClr val="333333"/>
-                </a:solidFill>
-              </a:rPr>
-              <a:t>terus bergeser</a:t>
-            </a:r>
-            <a:pPr indent="0" marL="0">
-              <a:buNone/>
-            </a:pPr>
-            <a:r>
-              <a:rPr lang="en-US" sz="1800" dirty="0">
-                <a:solidFill>
-                  <a:srgbClr val="333333"/>
-                </a:solidFill>
-              </a:rPr>
-              <a:t> setiap periode rebalancing.</a:t>
-            </a:r>
-            <a:endParaRPr lang="en-US" sz="1800" dirty="0"/>
-          </a:p>
-          <a:p>
-            <a:pPr marL="342900" indent="-342900">
-              <a:buSzPct val="100000"/>
-              <a:buChar char="•"/>
-            </a:pPr>
-            <a:r>
-              <a:rPr lang="en-US" sz="1800" dirty="0">
-                <a:solidFill>
-                  <a:srgbClr val="333333"/>
-                </a:solidFill>
-              </a:rPr>
-              <a:t>Penggunaan γ statis tidak cukup untuk menangkap perubahan </a:t>
-            </a:r>
-            <a:pPr indent="0" marL="0">
-              <a:buNone/>
-            </a:pPr>
-            <a:r>
-              <a:rPr lang="en-US" sz="1800" b="1" dirty="0">
-                <a:solidFill>
-                  <a:srgbClr val="333333"/>
-                </a:solidFill>
-              </a:rPr>
-              <a:t>struktur korelasi</a:t>
-            </a:r>
-            <a:pPr indent="0" marL="0">
-              <a:buNone/>
-            </a:pPr>
-            <a:r>
-              <a:rPr lang="en-US" sz="1800" dirty="0">
-                <a:solidFill>
-                  <a:srgbClr val="333333"/>
-                </a:solidFill>
-              </a:rPr>
-              <a:t> yang sangat cepat di pasar kripto.</a:t>
-            </a:r>
-            <a:endParaRPr lang="en-US" sz="1800" dirty="0"/>
-          </a:p>
-          <a:p>
-            <a:pPr marL="342900" indent="-342900">
-              <a:buSzPct val="100000"/>
-              <a:buChar char="•"/>
-            </a:pPr>
-            <a:r>
-              <a:rPr lang="en-US" sz="1800" dirty="0">
-                <a:solidFill>
-                  <a:srgbClr val="333333"/>
-                </a:solidFill>
-              </a:rPr>
-              <a:t>Ini membenarkan bahwa pasar kripto membutuhkan </a:t>
-            </a:r>
-            <a:pPr indent="0" marL="0">
-              <a:buNone/>
-            </a:pPr>
-            <a:r>
-              <a:rPr lang="en-US" sz="1800" b="1" dirty="0">
-                <a:solidFill>
-                  <a:srgbClr val="333333"/>
-                </a:solidFill>
-              </a:rPr>
-              <a:t>kalibrasi otomatis</a:t>
-            </a:r>
-            <a:pPr indent="0" marL="0">
-              <a:buNone/>
-            </a:pPr>
-            <a:r>
-              <a:rPr lang="en-US" sz="1800" dirty="0">
-                <a:solidFill>
-                  <a:srgbClr val="333333"/>
-                </a:solidFill>
-              </a:rPr>
-              <a:t> secara temporal.</a:t>
+              <a:t> dari serangan Crypto Winter, suatu kapabilitas pertahanan yang tidak dipahami oleh model ortodoks murni Markowitz.</a:t>
             </a:r>
             <a:endParaRPr lang="en-US" sz="1800" dirty="0"/>
           </a:p>
@@ -20579,6 +20759,284 @@
 <file path=ppt/slides/slide52.xml><?xml version="1.0" encoding="utf-8"?>
 <p:sld xmlns:a="http://schemas.openxmlformats.org/drawingml/2006/main" xmlns:r="http://schemas.openxmlformats.org/officeDocument/2006/relationships" xmlns:p="http://schemas.openxmlformats.org/presentationml/2006/main">
   <p:cSld name="Slide 52">
+    <p:spTree>
+      <p:nvGrpSpPr>
+        <p:cNvPr id="1" name=""/>
+        <p:cNvGrpSpPr/>
+        <p:nvPr/>
+      </p:nvGrpSpPr>
+      <p:grpSpPr>
+        <a:xfrm>
+          <a:off x="0" y="0"/>
+          <a:ext cx="0" cy="0"/>
+          <a:chOff x="0" y="0"/>
+          <a:chExt cx="0" cy="0"/>
+        </a:xfrm>
+      </p:grpSpPr>
+      <p:sp>
+        <p:nvSpPr>
+          <p:cNvPr id="2" name="Text 0"/>
+          <p:cNvSpPr/>
+          <p:nvPr/>
+        </p:nvSpPr>
+        <p:spPr>
+          <a:xfrm>
+            <a:off x="457200" y="457200"/>
+            <a:ext cx="8229600" cy="0"/>
+          </a:xfrm>
+          <a:prstGeom prst="rect">
+            <a:avLst/>
+          </a:prstGeom>
+          <a:noFill/>
+          <a:ln/>
+        </p:spPr>
+        <p:txBody>
+          <a:bodyPr wrap="square" rtlCol="0" anchor="ctr"/>
+          <a:lstStyle/>
+          <a:p>
+            <a:pPr indent="0" marL="0">
+              <a:buNone/>
+            </a:pPr>
+            <a:r>
+              <a:rPr lang="en-US" sz="2600" b="1" dirty="0">
+                <a:solidFill>
+                  <a:srgbClr val="003366"/>
+                </a:solidFill>
+              </a:rPr>
+              <a:t>Lampiran: Bukti Empiris Non-Stationarity Pasar</a:t>
+            </a:r>
+            <a:endParaRPr lang="en-US" sz="2600" dirty="0"/>
+          </a:p>
+        </p:txBody>
+      </p:sp>
+      <p:sp>
+        <p:nvSpPr>
+          <p:cNvPr id="3" name="Text 1"/>
+          <p:cNvSpPr/>
+          <p:nvPr/>
+        </p:nvSpPr>
+        <p:spPr>
+          <a:xfrm>
+            <a:off x="457200" y="1005840"/>
+            <a:ext cx="8229600" cy="5029200"/>
+          </a:xfrm>
+          <a:prstGeom prst="rect">
+            <a:avLst/>
+          </a:prstGeom>
+          <a:noFill/>
+          <a:ln/>
+        </p:spPr>
+        <p:txBody>
+          <a:bodyPr wrap="square" rtlCol="0" anchor="t"/>
+          <a:lstStyle/>
+          <a:p>
+            <a:pPr indent="0" marL="0">
+              <a:buNone/>
+            </a:pPr>
+            <a:r>
+              <a:rPr lang="en-US" sz="1800" b="1" dirty="0">
+                <a:solidFill>
+                  <a:srgbClr val="C0392B"/>
+                </a:solidFill>
+              </a:rPr>
+              <a:t>Masalah: </a:t>
+            </a:r>
+            <a:pPr indent="0" marL="0">
+              <a:buNone/>
+            </a:pPr>
+            <a:r>
+              <a:rPr lang="en-US" sz="1800" i="1" dirty="0">
+                <a:solidFill>
+                  <a:srgbClr val="333333"/>
+                </a:solidFill>
+              </a:rPr>
+              <a:t>Kenapa harus menggunakan model Adaptif (Dynamic Gamma)?</a:t>
+            </a:r>
+            <a:endParaRPr lang="en-US" sz="1800" dirty="0"/>
+          </a:p>
+          <a:p>
+            <a:pPr indent="0" marL="0">
+              <a:buNone/>
+            </a:pPr>
+            <a:r>
+              <a:rPr lang="en-US" sz="1800" b="1" dirty="0">
+                <a:solidFill>
+                  <a:srgbClr val="27AE60"/>
+                </a:solidFill>
+              </a:rPr>
+              <a:t>Bukti dari Grid Search:</a:t>
+            </a:r>
+            <a:endParaRPr lang="en-US" sz="1800" dirty="0"/>
+          </a:p>
+          <a:p>
+            <a:pPr marL="342900" indent="-342900">
+              <a:buSzPct val="100000"/>
+              <a:buChar char="•"/>
+            </a:pPr>
+            <a:r>
+              <a:rPr lang="en-US" sz="1800" dirty="0">
+                <a:solidFill>
+                  <a:srgbClr val="333333"/>
+                </a:solidFill>
+              </a:rPr>
+              <a:t>Data menunjukkan nilai Gamma (γ) optimal </a:t>
+            </a:r>
+            <a:pPr indent="0" marL="0">
+              <a:buNone/>
+            </a:pPr>
+            <a:r>
+              <a:rPr lang="en-US" sz="1800" b="1" dirty="0">
+                <a:solidFill>
+                  <a:srgbClr val="333333"/>
+                </a:solidFill>
+              </a:rPr>
+              <a:t>terus bergeser</a:t>
+            </a:r>
+            <a:pPr indent="0" marL="0">
+              <a:buNone/>
+            </a:pPr>
+            <a:r>
+              <a:rPr lang="en-US" sz="1800" dirty="0">
+                <a:solidFill>
+                  <a:srgbClr val="333333"/>
+                </a:solidFill>
+              </a:rPr>
+              <a:t> setiap periode rebalancing.</a:t>
+            </a:r>
+            <a:endParaRPr lang="en-US" sz="1800" dirty="0"/>
+          </a:p>
+          <a:p>
+            <a:pPr marL="342900" indent="-342900">
+              <a:buSzPct val="100000"/>
+              <a:buChar char="•"/>
+            </a:pPr>
+            <a:r>
+              <a:rPr lang="en-US" sz="1800" dirty="0">
+                <a:solidFill>
+                  <a:srgbClr val="333333"/>
+                </a:solidFill>
+              </a:rPr>
+              <a:t>Penggunaan γ statis tidak cukup untuk menangkap perubahan </a:t>
+            </a:r>
+            <a:pPr indent="0" marL="0">
+              <a:buNone/>
+            </a:pPr>
+            <a:r>
+              <a:rPr lang="en-US" sz="1800" b="1" dirty="0">
+                <a:solidFill>
+                  <a:srgbClr val="333333"/>
+                </a:solidFill>
+              </a:rPr>
+              <a:t>struktur korelasi</a:t>
+            </a:r>
+            <a:pPr indent="0" marL="0">
+              <a:buNone/>
+            </a:pPr>
+            <a:r>
+              <a:rPr lang="en-US" sz="1800" dirty="0">
+                <a:solidFill>
+                  <a:srgbClr val="333333"/>
+                </a:solidFill>
+              </a:rPr>
+              <a:t> yang sangat cepat di pasar kripto.</a:t>
+            </a:r>
+            <a:endParaRPr lang="en-US" sz="1800" dirty="0"/>
+          </a:p>
+          <a:p>
+            <a:pPr marL="342900" indent="-342900">
+              <a:buSzPct val="100000"/>
+              <a:buChar char="•"/>
+            </a:pPr>
+            <a:r>
+              <a:rPr lang="en-US" sz="1800" dirty="0">
+                <a:solidFill>
+                  <a:srgbClr val="333333"/>
+                </a:solidFill>
+              </a:rPr>
+              <a:t>Ini membenarkan bahwa pasar kripto membutuhkan </a:t>
+            </a:r>
+            <a:pPr indent="0" marL="0">
+              <a:buNone/>
+            </a:pPr>
+            <a:r>
+              <a:rPr lang="en-US" sz="1800" b="1" dirty="0">
+                <a:solidFill>
+                  <a:srgbClr val="333333"/>
+                </a:solidFill>
+              </a:rPr>
+              <a:t>kalibrasi otomatis</a:t>
+            </a:r>
+            <a:pPr indent="0" marL="0">
+              <a:buNone/>
+            </a:pPr>
+            <a:r>
+              <a:rPr lang="en-US" sz="1800" dirty="0">
+                <a:solidFill>
+                  <a:srgbClr val="333333"/>
+                </a:solidFill>
+              </a:rPr>
+              <a:t> secara temporal.</a:t>
+            </a:r>
+            <a:endParaRPr lang="en-US" sz="1800" dirty="0"/>
+          </a:p>
+        </p:txBody>
+      </p:sp>
+      <p:sp>
+        <p:nvSpPr>
+          <p:cNvPr id="4" name="Text 2">
+            <a:hlinkClick r:id="rId1" tooltip="" action="ppaction://hlinksldjump"/>
+          </p:cNvPr>
+          <p:cNvSpPr/>
+          <p:nvPr/>
+        </p:nvSpPr>
+        <p:spPr>
+          <a:xfrm>
+            <a:off x="7772400" y="4846320"/>
+            <a:ext cx="1097280" cy="0"/>
+          </a:xfrm>
+          <a:prstGeom prst="rect">
+            <a:avLst/>
+          </a:prstGeom>
+          <a:noFill/>
+          <a:ln/>
+        </p:spPr>
+        <p:txBody>
+          <a:bodyPr wrap="square" rtlCol="0" anchor="ctr"/>
+          <a:lstStyle/>
+          <a:p>
+            <a:pPr algn="r" indent="0" marL="0">
+              <a:buNone/>
+            </a:pPr>
+            <a:r>
+              <a:rPr lang="en-US" sz="1000" u="sng" dirty="0">
+                <a:solidFill>
+                  <a:srgbClr val="0563C1"/>
+                </a:solidFill>
+                <a:hlinkClick r:id="rId1" action="ppaction://hlinksldjump" tooltip="">
+                  <a:extLst>
+                    <a:ext uri="{A12FA001-AC4F-418D-AE19-62706E023703}">
+                      <ahyp:hlinkClr xmlns:ahyp="http://schemas.microsoft.com/office/drawing/2018/hyperlinkcolor" val="tx"/>
+                    </a:ext>
+                  </a:extLst>
+                </a:hlinkClick>
+              </a:rPr>
+              <a:t>🏠 Daftar Isi</a:t>
+            </a:r>
+            <a:endParaRPr lang="en-US" sz="1000" dirty="0"/>
+          </a:p>
+        </p:txBody>
+      </p:sp>
+    </p:spTree>
+  </p:cSld>
+  <p:clrMapOvr>
+    <a:masterClrMapping/>
+  </p:clrMapOvr>
+</p:sld>
+</file>
+
+<file path=ppt/slides/slide53.xml><?xml version="1.0" encoding="utf-8"?>
+<p:sld xmlns:a="http://schemas.openxmlformats.org/drawingml/2006/main" xmlns:r="http://schemas.openxmlformats.org/officeDocument/2006/relationships" xmlns:p="http://schemas.openxmlformats.org/presentationml/2006/main">
+  <p:cSld name="Slide 53">
     <p:spTree>
       <p:nvGrpSpPr>
         <p:cNvPr id="1" name=""/>

</xml_diff>

<commit_message>
feat: add Grid Search simulation to Table of Contents
</commit_message>
<xml_diff>
--- a/Presentasi_Proposal_Update.pptx
+++ b/Presentasi_Proposal_Update.pptx
@@ -9356,6 +9356,41 @@
               <a:buNone/>
             </a:pPr>
             <a:r>
+              <a:rPr lang="en-US" sz="1800" dirty="0">
+                <a:solidFill>
+                  <a:srgbClr val="333333"/>
+                </a:solidFill>
+              </a:rPr>
+              <a:t>   • </a:t>
+            </a:r>
+            <a:pPr indent="0" marL="0">
+              <a:buNone/>
+            </a:pPr>
+            <a:r>
+              <a:rPr lang="en-US" sz="1600" u="sng" dirty="0">
+                <a:solidFill>
+                  <a:srgbClr val="333333"/>
+                </a:solidFill>
+                <a:hlinkClick r:id="rId17" action="ppaction://hlinksldjump" tooltip="">
+                  <a:extLst>
+                    <a:ext uri="{A12FA001-AC4F-418D-AE19-62706E023703}">
+                      <ahyp:hlinkClr xmlns:ahyp="http://schemas.microsoft.com/office/drawing/2018/hyperlinkcolor" val="tx"/>
+                    </a:ext>
+                  </a:extLst>
+                </a:hlinkClick>
+              </a:rPr>
+              <a:t>Simulasi Grid Search</a:t>
+            </a:r>
+            <a:pPr indent="0" marL="0">
+              <a:buNone/>
+            </a:pPr>
+            <a:endParaRPr lang="en-US" sz="1800" dirty="0"/>
+          </a:p>
+          <a:p>
+            <a:pPr indent="0" marL="0">
+              <a:buNone/>
+            </a:pPr>
+            <a:r>
               <a:rPr lang="en-US" sz="1800" b="1" dirty="0">
                 <a:solidFill>
                   <a:srgbClr val="003366"/>
@@ -9385,7 +9420,7 @@
                 <a:solidFill>
                   <a:srgbClr val="333333"/>
                 </a:solidFill>
-                <a:hlinkClick r:id="rId17" action="ppaction://hlinksldjump" tooltip="">
+                <a:hlinkClick r:id="rId18" action="ppaction://hlinksldjump" tooltip="">
                   <a:extLst>
                     <a:ext uri="{A12FA001-AC4F-418D-AE19-62706E023703}">
                       <ahyp:hlinkClr xmlns:ahyp="http://schemas.microsoft.com/office/drawing/2018/hyperlinkcolor" val="tx"/>

</xml_diff>

<commit_message>
feat: add rolling window justification slide and update TOC
</commit_message>
<xml_diff>
--- a/Presentasi_Proposal_Update.pptx
+++ b/Presentasi_Proposal_Update.pptx
@@ -58,9 +58,10 @@
     <p:sldId id="306" r:id="rId52"/>
     <p:sldId id="307" r:id="rId53"/>
     <p:sldId id="308" r:id="rId54"/>
+    <p:sldId id="309" r:id="rId55"/>
   </p:sldIdLst>
   <p:notesMasterIdLst>
-    <p:notesMasterId r:id="rId55"/>
+    <p:notesMasterId r:id="rId56"/>
   </p:notesMasterIdLst>
   <p:sldSz cx="9144000" cy="5143500"/>
   <p:notesSz cx="5143500" cy="9144000"/>
@@ -4802,6 +4803,94 @@
             <a:fld id="{F7021451-1387-4CA6-816F-3879F97B5CBC}" type="slidenum">
               <a:rPr lang="en-US"/>
               <a:t>53</a:t>
+            </a:fld>
+            <a:endParaRPr lang="en-US"/>
+          </a:p>
+        </p:txBody>
+      </p:sp>
+    </p:spTree>
+    <p:extLst>
+      <p:ext uri="{BB962C8B-B14F-4D97-AF65-F5344CB8AC3E}">
+        <p14:creationId xmlns:p14="http://schemas.microsoft.com/office/powerpoint/2010/main" val="1024086991"/>
+      </p:ext>
+    </p:extLst>
+  </p:cSld>
+  <p:clrMapOvr>
+    <a:masterClrMapping/>
+  </p:clrMapOvr>
+</p:notes>
+</file>
+
+<file path=ppt/notesSlides/notesSlide54.xml><?xml version="1.0" encoding="utf-8"?>
+<p:notes xmlns:a="http://schemas.openxmlformats.org/drawingml/2006/main" xmlns:r="http://schemas.openxmlformats.org/officeDocument/2006/relationships" xmlns:p="http://schemas.openxmlformats.org/presentationml/2006/main">
+  <p:cSld>
+    <p:spTree>
+      <p:nvGrpSpPr>
+        <p:cNvPr id="1" name=""/>
+        <p:cNvGrpSpPr/>
+        <p:nvPr/>
+      </p:nvGrpSpPr>
+      <p:grpSpPr>
+        <a:xfrm>
+          <a:off x="0" y="0"/>
+          <a:ext cx="0" cy="0"/>
+          <a:chOff x="0" y="0"/>
+          <a:chExt cx="0" cy="0"/>
+        </a:xfrm>
+      </p:grpSpPr>
+      <p:sp>
+        <p:nvSpPr>
+          <p:cNvPr id="2" name="Slide Image Placeholder 1"/>
+          <p:cNvSpPr>
+            <a:spLocks noGrp="1" noRot="1" noChangeAspect="1"/>
+          </p:cNvSpPr>
+          <p:nvPr>
+            <p:ph type="sldImg"/>
+          </p:nvPr>
+        </p:nvSpPr>
+        <p:spPr/>
+      </p:sp>
+      <p:sp>
+        <p:nvSpPr>
+          <p:cNvPr id="3" name="Notes Placeholder 2"/>
+          <p:cNvSpPr>
+            <a:spLocks noGrp="1"/>
+          </p:cNvSpPr>
+          <p:nvPr>
+            <p:ph type="body" idx="1"/>
+          </p:nvPr>
+        </p:nvSpPr>
+        <p:spPr/>
+        <p:txBody>
+          <a:bodyPr/>
+          <a:lstStyle/>
+          <a:p>
+            <a:r>
+              <a:rPr lang="en-US" dirty="0"/>
+              <a:t/>
+            </a:r>
+            <a:endParaRPr lang="en-US" dirty="0"/>
+          </a:p>
+        </p:txBody>
+      </p:sp>
+      <p:sp>
+        <p:nvSpPr>
+          <p:cNvPr id="4" name="Slide Number Placeholder 3"/>
+          <p:cNvSpPr>
+            <a:spLocks noGrp="1"/>
+          </p:cNvSpPr>
+          <p:nvPr>
+            <p:ph type="sldNum" sz="quarter" idx="10"/>
+          </p:nvPr>
+        </p:nvSpPr>
+        <p:spPr/>
+        <p:txBody>
+          <a:bodyPr/>
+          <a:lstStyle/>
+          <a:p>
+            <a:fld id="{F7021451-1387-4CA6-816F-3879F97B5CBC}" type="slidenum">
+              <a:rPr lang="en-US"/>
+              <a:t>54</a:t>
             </a:fld>
             <a:endParaRPr lang="en-US"/>
           </a:p>
@@ -9391,6 +9480,41 @@
               <a:buNone/>
             </a:pPr>
             <a:r>
+              <a:rPr lang="en-US" sz="1800" dirty="0">
+                <a:solidFill>
+                  <a:srgbClr val="333333"/>
+                </a:solidFill>
+              </a:rPr>
+              <a:t>   • </a:t>
+            </a:r>
+            <a:pPr indent="0" marL="0">
+              <a:buNone/>
+            </a:pPr>
+            <a:r>
+              <a:rPr lang="en-US" sz="1600" u="sng" dirty="0">
+                <a:solidFill>
+                  <a:srgbClr val="333333"/>
+                </a:solidFill>
+                <a:hlinkClick r:id="rId18" action="ppaction://hlinksldjump" tooltip="">
+                  <a:extLst>
+                    <a:ext uri="{A12FA001-AC4F-418D-AE19-62706E023703}">
+                      <ahyp:hlinkClr xmlns:ahyp="http://schemas.microsoft.com/office/drawing/2018/hyperlinkcolor" val="tx"/>
+                    </a:ext>
+                  </a:extLst>
+                </a:hlinkClick>
+              </a:rPr>
+              <a:t>Justifikasi Rolling Window</a:t>
+            </a:r>
+            <a:pPr indent="0" marL="0">
+              <a:buNone/>
+            </a:pPr>
+            <a:endParaRPr lang="en-US" sz="1800" dirty="0"/>
+          </a:p>
+          <a:p>
+            <a:pPr indent="0" marL="0">
+              <a:buNone/>
+            </a:pPr>
+            <a:r>
               <a:rPr lang="en-US" sz="1800" b="1" dirty="0">
                 <a:solidFill>
                   <a:srgbClr val="003366"/>
@@ -9420,7 +9544,7 @@
                 <a:solidFill>
                   <a:srgbClr val="333333"/>
                 </a:solidFill>
-                <a:hlinkClick r:id="rId18" action="ppaction://hlinksldjump" tooltip="">
+                <a:hlinkClick r:id="rId19" action="ppaction://hlinksldjump" tooltip="">
                   <a:extLst>
                     <a:ext uri="{A12FA001-AC4F-418D-AE19-62706E023703}">
                       <ahyp:hlinkClr xmlns:ahyp="http://schemas.microsoft.com/office/drawing/2018/hyperlinkcolor" val="tx"/>
@@ -19325,14 +19449,14 @@
               <a:buNone/>
             </a:pPr>
             <a:r>
-              <a:rPr lang="en-US" sz="2600" b="1" dirty="0">
+              <a:rPr lang="en-US" sz="2400" b="1" dirty="0">
                 <a:solidFill>
                   <a:srgbClr val="003366"/>
                 </a:solidFill>
               </a:rPr>
-              <a:t>Lampiran: Dua Tipe Pendekatan Grid Search</a:t>
-            </a:r>
-            <a:endParaRPr lang="en-US" sz="2600" dirty="0"/>
+              <a:t>Lampiran: Justifikasi Pemilihan Rolling Window</a:t>
+            </a:r>
+            <a:endParaRPr lang="en-US" sz="2400" dirty="0"/>
           </a:p>
         </p:txBody>
       </p:sp>
@@ -19361,190 +19485,182 @@
               <a:buNone/>
             </a:pPr>
             <a:r>
-              <a:rPr lang="en-US" sz="1800" b="1" dirty="0">
-                <a:solidFill>
-                  <a:srgbClr val="333333"/>
-                </a:solidFill>
-              </a:rPr>
-              <a:t>Dua Objektif Optimasi (Return vs Risk):</a:t>
-            </a:r>
-            <a:endParaRPr lang="en-US" sz="1800" dirty="0"/>
-          </a:p>
-          <a:p>
-            <a:pPr indent="0" marL="0">
-              <a:buNone/>
-            </a:pPr>
-            <a:r>
-              <a:rPr lang="en-US" sz="1800" b="1" dirty="0">
+              <a:rPr lang="en-US" sz="1600" b="1" dirty="0">
+                <a:solidFill>
+                  <a:srgbClr val="333333"/>
+                </a:solidFill>
+              </a:rPr>
+              <a:t>Kenapa rentang 30 s/d 60 hari dipilih sebagai 'Sweet Spot'?</a:t>
+            </a:r>
+            <a:endParaRPr lang="en-US" sz="1600" dirty="0"/>
+          </a:p>
+          <a:p>
+            <a:pPr indent="0" marL="0">
+              <a:buNone/>
+            </a:pPr>
+            <a:r>
+              <a:rPr lang="en-US" sz="1600" b="1" dirty="0">
+                <a:solidFill>
+                  <a:srgbClr val="C0392B"/>
+                </a:solidFill>
+              </a:rPr>
+              <a:t>1. Alasan Teknis (Kenapa Tidak &lt; 30 Hari?):</a:t>
+            </a:r>
+            <a:endParaRPr lang="en-US" sz="1600" dirty="0"/>
+          </a:p>
+          <a:p>
+            <a:pPr indent="0" marL="0">
+              <a:buNone/>
+            </a:pPr>
+            <a:r>
+              <a:rPr lang="en-US" sz="1600" dirty="0">
+                <a:solidFill>
+                  <a:srgbClr val="333333"/>
+                </a:solidFill>
+              </a:rPr>
+              <a:t>   • Ill-Conditioned Matrix: Data terlalu sedikit (T ≈ N) membuat kalkulasi bobot tidak stabil dan acak.</a:t>
+            </a:r>
+            <a:endParaRPr lang="en-US" sz="1600" dirty="0"/>
+          </a:p>
+          <a:p>
+            <a:pPr indent="0" marL="0">
+              <a:buNone/>
+            </a:pPr>
+            <a:r>
+              <a:rPr lang="en-US" sz="1600" dirty="0">
+                <a:solidFill>
+                  <a:srgbClr val="333333"/>
+                </a:solidFill>
+              </a:rPr>
+              <a:t>   • RMT Failure: Batas noise menjadi sangat lebar, filter RMT akan menghapus hampir semua sinyal pasar.</a:t>
+            </a:r>
+            <a:endParaRPr lang="en-US" sz="1600" dirty="0"/>
+          </a:p>
+          <a:p>
+            <a:pPr indent="0" marL="0">
+              <a:buNone/>
+            </a:pPr>
+            <a:r>
+              <a:rPr lang="en-US" sz="1600" dirty="0">
+                <a:solidFill>
+                  <a:srgbClr val="333333"/>
+                </a:solidFill>
+              </a:rPr>
+              <a:t>   • High Turnover: Bobot berubah terlalu liar, keuntungan habis dimakan biaya transaksi (fees).</a:t>
+            </a:r>
+            <a:endParaRPr lang="en-US" sz="1600" dirty="0"/>
+          </a:p>
+          <a:p>
+            <a:pPr indent="0" marL="0">
+              <a:buNone/>
+            </a:pPr>
+            <a:r>
+              <a:rPr lang="en-US" sz="1600" b="1" dirty="0">
+                <a:solidFill>
+                  <a:srgbClr val="F39C12"/>
+                </a:solidFill>
+              </a:rPr>
+              <a:t>2. Alasan Strategis (Kenapa Tidak &gt; 120 Hari?):</a:t>
+            </a:r>
+            <a:endParaRPr lang="en-US" sz="1600" dirty="0"/>
+          </a:p>
+          <a:p>
+            <a:pPr indent="0" marL="0">
+              <a:buNone/>
+            </a:pPr>
+            <a:r>
+              <a:rPr lang="en-US" sz="1600" dirty="0">
+                <a:solidFill>
+                  <a:srgbClr val="333333"/>
+                </a:solidFill>
+              </a:rPr>
+              <a:t>   • Information Lag: Model terlambat mendeteksi crash atau perubahan rezim karena terbebani data setahun lalu.</a:t>
+            </a:r>
+            <a:endParaRPr lang="en-US" sz="1600" dirty="0"/>
+          </a:p>
+          <a:p>
+            <a:pPr indent="0" marL="0">
+              <a:buNone/>
+            </a:pPr>
+            <a:r>
+              <a:rPr lang="en-US" sz="1600" dirty="0">
+                <a:solidFill>
+                  <a:srgbClr val="333333"/>
+                </a:solidFill>
+              </a:rPr>
+              <a:t>   • Regime Blurring: Mencampur data Bull &amp; Bear Market dalam satu hitungan mengaburkan risiko asli saat ini.</a:t>
+            </a:r>
+            <a:endParaRPr lang="en-US" sz="1600" dirty="0"/>
+          </a:p>
+          <a:p>
+            <a:pPr indent="0" marL="0">
+              <a:buNone/>
+            </a:pPr>
+            <a:r>
+              <a:rPr lang="en-US" sz="1600" b="1" dirty="0">
                 <a:solidFill>
                   <a:srgbClr val="27AE60"/>
                 </a:solidFill>
               </a:rPr>
-              <a:t>1. Network Markowitz dengan Target Return (NW - Return Grid Search):</a:t>
-            </a:r>
-            <a:endParaRPr lang="en-US" sz="1800" dirty="0"/>
-          </a:p>
-          <a:p>
-            <a:pPr marL="342900" indent="-342900">
-              <a:buSzPct val="100000"/>
-              <a:buChar char="•"/>
-            </a:pPr>
-            <a:r>
-              <a:rPr lang="en-US" sz="1800" dirty="0">
-                <a:solidFill>
-                  <a:srgbClr val="333333"/>
-                </a:solidFill>
-              </a:rPr>
-              <a:t>Memaksimalkan capaian </a:t>
-            </a:r>
-            <a:pPr indent="0" marL="0">
-              <a:buNone/>
-            </a:pPr>
-            <a:r>
-              <a:rPr lang="en-US" sz="1800" b="1" dirty="0">
-                <a:solidFill>
-                  <a:srgbClr val="333333"/>
-                </a:solidFill>
-              </a:rPr>
-              <a:t>imbal hasil</a:t>
-            </a:r>
-            <a:pPr indent="0" marL="0">
-              <a:buNone/>
-            </a:pPr>
-            <a:r>
-              <a:rPr lang="en-US" sz="1800" dirty="0">
-                <a:solidFill>
-                  <a:srgbClr val="333333"/>
-                </a:solidFill>
-              </a:rPr>
-              <a:t> portofolio.</a:t>
-            </a:r>
-            <a:endParaRPr lang="en-US" sz="1800" dirty="0"/>
-          </a:p>
-          <a:p>
-            <a:pPr marL="342900" indent="-342900">
-              <a:buSzPct val="100000"/>
-              <a:buChar char="•"/>
-            </a:pPr>
-            <a:r>
-              <a:rPr lang="en-US" sz="1800" dirty="0">
-                <a:solidFill>
-                  <a:srgbClr val="333333"/>
-                </a:solidFill>
-              </a:rPr>
-              <a:t>Lebih Agresif untuk mengeksploitasi reli pada pasar </a:t>
-            </a:r>
-            <a:pPr indent="0" marL="0">
-              <a:buNone/>
-            </a:pPr>
-            <a:r>
-              <a:rPr lang="en-US" sz="1800" b="1" dirty="0">
-                <a:solidFill>
-                  <a:srgbClr val="333333"/>
-                </a:solidFill>
-              </a:rPr>
-              <a:t>Bullish</a:t>
-            </a:r>
-            <a:pPr indent="0" marL="0">
-              <a:buNone/>
-            </a:pPr>
-            <a:r>
-              <a:rPr lang="en-US" sz="1800" dirty="0">
-                <a:solidFill>
-                  <a:srgbClr val="333333"/>
-                </a:solidFill>
-              </a:rPr>
-              <a:t>.</a:t>
-            </a:r>
-            <a:endParaRPr lang="en-US" sz="1800" dirty="0"/>
-          </a:p>
-          <a:p>
-            <a:pPr indent="0" marL="0">
-              <a:buNone/>
-            </a:pPr>
-            <a:r>
-              <a:rPr lang="en-US" sz="1800" b="1" dirty="0">
-                <a:solidFill>
-                  <a:srgbClr val="C0392B"/>
-                </a:solidFill>
-              </a:rPr>
-              <a:t>2. Network Markowitz dengan Target Risiko (NW - Risk Grid Search):</a:t>
-            </a:r>
-            <a:endParaRPr lang="en-US" sz="1800" dirty="0"/>
-          </a:p>
-          <a:p>
-            <a:pPr marL="342900" indent="-342900">
-              <a:buSzPct val="100000"/>
-              <a:buChar char="•"/>
-            </a:pPr>
-            <a:r>
-              <a:rPr lang="en-US" sz="1800" dirty="0">
-                <a:solidFill>
-                  <a:srgbClr val="333333"/>
-                </a:solidFill>
-              </a:rPr>
-              <a:t>Menekan parameter </a:t>
-            </a:r>
-            <a:pPr indent="0" marL="0">
-              <a:buNone/>
-            </a:pPr>
-            <a:r>
-              <a:rPr lang="en-US" sz="1800" b="1" dirty="0">
-                <a:solidFill>
-                  <a:srgbClr val="333333"/>
-                </a:solidFill>
-              </a:rPr>
-              <a:t>risiko total</a:t>
-            </a:r>
-            <a:pPr indent="0" marL="0">
-              <a:buNone/>
-            </a:pPr>
-            <a:r>
-              <a:rPr lang="en-US" sz="1800" dirty="0">
-                <a:solidFill>
-                  <a:srgbClr val="333333"/>
-                </a:solidFill>
-              </a:rPr>
-              <a:t> hingga minimal.</a:t>
-            </a:r>
-            <a:endParaRPr lang="en-US" sz="1800" dirty="0"/>
-          </a:p>
-          <a:p>
-            <a:pPr marL="342900" indent="-342900">
-              <a:buSzPct val="100000"/>
-              <a:buChar char="•"/>
-            </a:pPr>
-            <a:r>
-              <a:rPr lang="en-US" sz="1800" dirty="0">
-                <a:solidFill>
-                  <a:srgbClr val="333333"/>
-                </a:solidFill>
-              </a:rPr>
-              <a:t>Lebih Defensif untuk meredam fluktuasi saat </a:t>
-            </a:r>
-            <a:pPr indent="0" marL="0">
-              <a:buNone/>
-            </a:pPr>
-            <a:r>
-              <a:rPr lang="en-US" sz="1800" b="1" dirty="0">
-                <a:solidFill>
-                  <a:srgbClr val="333333"/>
-                </a:solidFill>
-              </a:rPr>
-              <a:t>Crypto Winter</a:t>
-            </a:r>
-            <a:pPr indent="0" marL="0">
-              <a:buNone/>
-            </a:pPr>
-            <a:r>
-              <a:rPr lang="en-US" sz="1800" dirty="0">
-                <a:solidFill>
-                  <a:srgbClr val="333333"/>
-                </a:solidFill>
-              </a:rPr>
-              <a:t>.</a:t>
-            </a:r>
-            <a:endParaRPr lang="en-US" sz="1800" dirty="0"/>
+              <a:t>3. Solusi 30-60 Hari (Optimal):</a:t>
+            </a:r>
+            <a:endParaRPr lang="en-US" sz="1600" dirty="0"/>
+          </a:p>
+          <a:p>
+            <a:pPr indent="0" marL="0">
+              <a:buNone/>
+            </a:pPr>
+            <a:r>
+              <a:rPr lang="en-US" sz="1600" dirty="0">
+                <a:solidFill>
+                  <a:srgbClr val="333333"/>
+                </a:solidFill>
+              </a:rPr>
+              <a:t>   • Responsif: Cepat menangkap narasi pasar baru (misal: siklus Altcoin).</a:t>
+            </a:r>
+            <a:endParaRPr lang="en-US" sz="1600" dirty="0"/>
+          </a:p>
+          <a:p>
+            <a:pPr indent="0" marL="0">
+              <a:buNone/>
+            </a:pPr>
+            <a:r>
+              <a:rPr lang="en-US" sz="1600" dirty="0">
+                <a:solidFill>
+                  <a:srgbClr val="333333"/>
+                </a:solidFill>
+              </a:rPr>
+              <a:t>   • Stabil: Cukup data untuk menghasilkan peta jaringan MST yang jujur dan korelasi yang valid.</a:t>
+            </a:r>
+            <a:endParaRPr lang="en-US" sz="1600" dirty="0"/>
+          </a:p>
+          <a:p>
+            <a:pPr indent="0" marL="0">
+              <a:buNone/>
+            </a:pPr>
+            <a:r>
+              <a:rPr lang="en-US" sz="1600" b="1" dirty="0">
+                <a:solidFill>
+                  <a:srgbClr val="003366"/>
+                </a:solidFill>
+              </a:rPr>
+              <a:t>Kesimpulan:</a:t>
+            </a:r>
+            <a:endParaRPr lang="en-US" sz="1600" dirty="0"/>
+          </a:p>
+          <a:p>
+            <a:pPr indent="0" marL="0">
+              <a:buNone/>
+            </a:pPr>
+            <a:r>
+              <a:rPr lang="en-US" sz="1600" i="1" dirty="0">
+                <a:solidFill>
+                  <a:srgbClr val="333333"/>
+                </a:solidFill>
+              </a:rPr>
+              <a:t>Window 30-60 hari adalah keseimbangan antara akurasi statistik dan kecepatan respons pasar.</a:t>
+            </a:r>
+            <a:endParaRPr lang="en-US" sz="1600" dirty="0"/>
           </a:p>
         </p:txBody>
       </p:sp>
@@ -19648,7 +19764,7 @@
                   <a:srgbClr val="003366"/>
                 </a:solidFill>
               </a:rPr>
-              <a:t>Lampiran: Penanganan Data Kosong (Missing Values)</a:t>
+              <a:t>Lampiran: Dua Tipe Pendekatan Grid Search</a:t>
             </a:r>
             <a:endParaRPr lang="en-US" sz="2600" dirty="0"/>
           </a:p>
@@ -19681,41 +19797,156 @@
             <a:r>
               <a:rPr lang="en-US" sz="1800" b="1" dirty="0">
                 <a:solidFill>
+                  <a:srgbClr val="333333"/>
+                </a:solidFill>
+              </a:rPr>
+              <a:t>Dua Objektif Optimasi (Return vs Risk):</a:t>
+            </a:r>
+            <a:endParaRPr lang="en-US" sz="1800" dirty="0"/>
+          </a:p>
+          <a:p>
+            <a:pPr indent="0" marL="0">
+              <a:buNone/>
+            </a:pPr>
+            <a:r>
+              <a:rPr lang="en-US" sz="1800" b="1" dirty="0">
+                <a:solidFill>
+                  <a:srgbClr val="27AE60"/>
+                </a:solidFill>
+              </a:rPr>
+              <a:t>1. Network Markowitz dengan Target Return (NW - Return Grid Search):</a:t>
+            </a:r>
+            <a:endParaRPr lang="en-US" sz="1800" dirty="0"/>
+          </a:p>
+          <a:p>
+            <a:pPr marL="342900" indent="-342900">
+              <a:buSzPct val="100000"/>
+              <a:buChar char="•"/>
+            </a:pPr>
+            <a:r>
+              <a:rPr lang="en-US" sz="1800" dirty="0">
+                <a:solidFill>
+                  <a:srgbClr val="333333"/>
+                </a:solidFill>
+              </a:rPr>
+              <a:t>Memaksimalkan capaian </a:t>
+            </a:r>
+            <a:pPr indent="0" marL="0">
+              <a:buNone/>
+            </a:pPr>
+            <a:r>
+              <a:rPr lang="en-US" sz="1800" b="1" dirty="0">
+                <a:solidFill>
+                  <a:srgbClr val="333333"/>
+                </a:solidFill>
+              </a:rPr>
+              <a:t>imbal hasil</a:t>
+            </a:r>
+            <a:pPr indent="0" marL="0">
+              <a:buNone/>
+            </a:pPr>
+            <a:r>
+              <a:rPr lang="en-US" sz="1800" dirty="0">
+                <a:solidFill>
+                  <a:srgbClr val="333333"/>
+                </a:solidFill>
+              </a:rPr>
+              <a:t> portofolio.</a:t>
+            </a:r>
+            <a:endParaRPr lang="en-US" sz="1800" dirty="0"/>
+          </a:p>
+          <a:p>
+            <a:pPr marL="342900" indent="-342900">
+              <a:buSzPct val="100000"/>
+              <a:buChar char="•"/>
+            </a:pPr>
+            <a:r>
+              <a:rPr lang="en-US" sz="1800" dirty="0">
+                <a:solidFill>
+                  <a:srgbClr val="333333"/>
+                </a:solidFill>
+              </a:rPr>
+              <a:t>Lebih Agresif untuk mengeksploitasi reli pada pasar </a:t>
+            </a:r>
+            <a:pPr indent="0" marL="0">
+              <a:buNone/>
+            </a:pPr>
+            <a:r>
+              <a:rPr lang="en-US" sz="1800" b="1" dirty="0">
+                <a:solidFill>
+                  <a:srgbClr val="333333"/>
+                </a:solidFill>
+              </a:rPr>
+              <a:t>Bullish</a:t>
+            </a:r>
+            <a:pPr indent="0" marL="0">
+              <a:buNone/>
+            </a:pPr>
+            <a:r>
+              <a:rPr lang="en-US" sz="1800" dirty="0">
+                <a:solidFill>
+                  <a:srgbClr val="333333"/>
+                </a:solidFill>
+              </a:rPr>
+              <a:t>.</a:t>
+            </a:r>
+            <a:endParaRPr lang="en-US" sz="1800" dirty="0"/>
+          </a:p>
+          <a:p>
+            <a:pPr indent="0" marL="0">
+              <a:buNone/>
+            </a:pPr>
+            <a:r>
+              <a:rPr lang="en-US" sz="1800" b="1" dirty="0">
+                <a:solidFill>
                   <a:srgbClr val="C0392B"/>
                 </a:solidFill>
               </a:rPr>
-              <a:t>Pertanyaan: </a:t>
-            </a:r>
-            <a:pPr indent="0" marL="0">
-              <a:buNone/>
-            </a:pPr>
-            <a:r>
-              <a:rPr lang="en-US" sz="1800" i="1" dirty="0">
-                <a:solidFill>
-                  <a:srgbClr val="333333"/>
-                </a:solidFill>
-              </a:rPr>
-              <a:t>"Beberapa koin seperti Binance/EOS belum rilis di awal 2017 sehingga datanya kosong. Bukankah backward-fill memalsukan harga dan merusak matriks?"</a:t>
+              <a:t>2. Network Markowitz dengan Target Risiko (NW - Risk Grid Search):</a:t>
             </a:r>
             <a:endParaRPr lang="en-US" sz="1800" dirty="0"/>
           </a:p>
           <a:p>
+            <a:pPr marL="342900" indent="-342900">
+              <a:buSzPct val="100000"/>
+              <a:buChar char="•"/>
+            </a:pPr>
+            <a:r>
+              <a:rPr lang="en-US" sz="1800" dirty="0">
+                <a:solidFill>
+                  <a:srgbClr val="333333"/>
+                </a:solidFill>
+              </a:rPr>
+              <a:t>Menekan parameter </a:t>
+            </a:r>
             <a:pPr indent="0" marL="0">
               <a:buNone/>
             </a:pPr>
             <a:r>
               <a:rPr lang="en-US" sz="1800" b="1" dirty="0">
                 <a:solidFill>
-                  <a:srgbClr val="27AE60"/>
-                </a:solidFill>
-              </a:rPr>
-              <a:t>Jawaban (Kenapa RMT sangat Krusial):</a:t>
+                  <a:srgbClr val="333333"/>
+                </a:solidFill>
+              </a:rPr>
+              <a:t>risiko total</a:t>
+            </a:r>
+            <a:pPr indent="0" marL="0">
+              <a:buNone/>
+            </a:pPr>
+            <a:r>
+              <a:rPr lang="en-US" sz="1800" dirty="0">
+                <a:solidFill>
+                  <a:srgbClr val="333333"/>
+                </a:solidFill>
+              </a:rPr>
+              <a:t> hingga minimal.</a:t>
             </a:r>
             <a:endParaRPr lang="en-US" sz="1800" dirty="0"/>
           </a:p>
           <a:p>
-            <a:pPr indent="0" marL="0">
-              <a:buNone/>
+            <a:pPr marL="342900" indent="-342900">
+              <a:buSzPct val="100000"/>
+              <a:buChar char="•"/>
             </a:pPr>
             <a:r>
               <a:rPr lang="en-US" sz="1800" dirty="0">
@@ -19723,18 +19954,18 @@
                   <a:srgbClr val="333333"/>
                 </a:solidFill>
               </a:rPr>
-              <a:t>   1. Praktik pengisian data diam (</a:t>
-            </a:r>
-            <a:pPr indent="0" marL="0">
-              <a:buNone/>
-            </a:pPr>
-            <a:r>
-              <a:rPr lang="en-US" sz="1800" b="1" i="1" dirty="0">
-                <a:solidFill>
-                  <a:srgbClr val="333333"/>
-                </a:solidFill>
-              </a:rPr>
-              <a:t>backward fill</a:t>
+              <a:t>Lebih Defensif untuk meredam fluktuasi saat </a:t>
+            </a:r>
+            <a:pPr indent="0" marL="0">
+              <a:buNone/>
+            </a:pPr>
+            <a:r>
+              <a:rPr lang="en-US" sz="1800" b="1" dirty="0">
+                <a:solidFill>
+                  <a:srgbClr val="333333"/>
+                </a:solidFill>
+              </a:rPr>
+              <a:t>Crypto Winter</a:t>
             </a:r>
             <a:pPr indent="0" marL="0">
               <a:buNone/>
@@ -19745,115 +19976,7 @@
                   <a:srgbClr val="333333"/>
                 </a:solidFill>
               </a:rPr>
-              <a:t>) memang menciptakan rentetan nilai harga yang statis.</a:t>
-            </a:r>
-            <a:endParaRPr lang="en-US" sz="1800" dirty="0"/>
-          </a:p>
-          <a:p>
-            <a:pPr indent="0" marL="0">
-              <a:buNone/>
-            </a:pPr>
-            <a:r>
-              <a:rPr lang="en-US" sz="1800" dirty="0">
-                <a:solidFill>
-                  <a:srgbClr val="333333"/>
-                </a:solidFill>
-              </a:rPr>
-              <a:t>   2. Namun, kehebatan </a:t>
-            </a:r>
-            <a:pPr indent="0" marL="0">
-              <a:buNone/>
-            </a:pPr>
-            <a:r>
-              <a:rPr lang="en-US" sz="1800" b="1" dirty="0">
-                <a:solidFill>
-                  <a:srgbClr val="333333"/>
-                </a:solidFill>
-              </a:rPr>
-              <a:t>Random Matrix Theory (RMT)</a:t>
-            </a:r>
-            <a:pPr indent="0" marL="0">
-              <a:buNone/>
-            </a:pPr>
-            <a:r>
-              <a:rPr lang="en-US" sz="1800" dirty="0">
-                <a:solidFill>
-                  <a:srgbClr val="333333"/>
-                </a:solidFill>
-              </a:rPr>
-              <a:t> diuji di sini! Karena data yang datar sama sekali tidak punya korelasi nyata.</a:t>
-            </a:r>
-            <a:endParaRPr lang="en-US" sz="1800" dirty="0"/>
-          </a:p>
-          <a:p>
-            <a:pPr indent="0" marL="0">
-              <a:buNone/>
-            </a:pPr>
-            <a:r>
-              <a:rPr lang="en-US" sz="1800" dirty="0">
-                <a:solidFill>
-                  <a:srgbClr val="333333"/>
-                </a:solidFill>
-              </a:rPr>
-              <a:t>   3. RMT otomatis akan mendeteksi korelasi buatan tersebut sebagai probabilitas </a:t>
-            </a:r>
-            <a:pPr indent="0" marL="0">
-              <a:buNone/>
-            </a:pPr>
-            <a:r>
-              <a:rPr lang="en-US" sz="1800" b="1" i="1" dirty="0">
-                <a:solidFill>
-                  <a:srgbClr val="333333"/>
-                </a:solidFill>
-              </a:rPr>
-              <a:t>Noise Acak</a:t>
-            </a:r>
-            <a:pPr indent="0" marL="0">
-              <a:buNone/>
-            </a:pPr>
-            <a:r>
-              <a:rPr lang="en-US" sz="1800" dirty="0">
-                <a:solidFill>
-                  <a:srgbClr val="333333"/>
-                </a:solidFill>
-              </a:rPr>
-              <a:t>, lalu membuangnya menjadi 0.</a:t>
-            </a:r>
-            <a:endParaRPr lang="en-US" sz="1800" dirty="0"/>
-          </a:p>
-          <a:p>
-            <a:pPr indent="0" marL="0">
-              <a:buNone/>
-            </a:pPr>
-            <a:r>
-              <a:rPr lang="en-US" sz="1800" dirty="0">
-                <a:solidFill>
-                  <a:srgbClr val="333333"/>
-                </a:solidFill>
-              </a:rPr>
-              <a:t>   4. Hasilnya, matriks korelasi </a:t>
-            </a:r>
-            <a:pPr indent="0" marL="0">
-              <a:buNone/>
-            </a:pPr>
-            <a:r>
-              <a:rPr lang="en-US" sz="1800" b="1" dirty="0">
-                <a:solidFill>
-                  <a:srgbClr val="333333"/>
-                </a:solidFill>
-              </a:rPr>
-              <a:t>terselamatkan</a:t>
-            </a:r>
-            <a:pPr indent="0" marL="0">
-              <a:buNone/>
-            </a:pPr>
-            <a:r>
-              <a:rPr lang="en-US" sz="1800" dirty="0">
-                <a:solidFill>
-                  <a:srgbClr val="333333"/>
-                </a:solidFill>
-              </a:rPr>
-              <a:t> dan tidak tercemar oleh cacat kelengkapan data.</a:t>
+              <a:t>.</a:t>
             </a:r>
             <a:endParaRPr lang="en-US" sz="1800" dirty="0"/>
           </a:p>
@@ -20353,7 +20476,7 @@
                   <a:srgbClr val="003366"/>
                 </a:solidFill>
               </a:rPr>
-              <a:t>Lampiran: Mengapa Menyertakan Tether (USDT)? (1/2)</a:t>
+              <a:t>Lampiran: Penanganan Data Kosong (Missing Values)</a:t>
             </a:r>
             <a:endParaRPr lang="en-US" sz="2600" dirty="0"/>
           </a:p>
@@ -20400,7 +20523,7 @@
                   <a:srgbClr val="333333"/>
                 </a:solidFill>
               </a:rPr>
-              <a:t>"Tether (USDT) itu stablecoin yang nilainya selalu fix ke 1 USD. Apakah tidak berbuat curang?"</a:t>
+              <a:t>"Beberapa koin seperti Binance/EOS belum rilis di awal 2017 sehingga datanya kosong. Bukankah backward-fill memalsukan harga dan merusak matriks?"</a:t>
             </a:r>
             <a:endParaRPr lang="en-US" sz="1800" dirty="0"/>
           </a:p>
@@ -20414,14 +20537,13 @@
                   <a:srgbClr val="27AE60"/>
                 </a:solidFill>
               </a:rPr>
-              <a:t>Jawaban (Dinamika Portofolio Cerdas):</a:t>
+              <a:t>Jawaban (Kenapa RMT sangat Krusial):</a:t>
             </a:r>
             <a:endParaRPr lang="en-US" sz="1800" dirty="0"/>
           </a:p>
           <a:p>
-            <a:pPr marL="342900" indent="-342900">
-              <a:buSzPct val="100000"/>
-              <a:buChar char="•"/>
+            <a:pPr indent="0" marL="0">
+              <a:buNone/>
             </a:pPr>
             <a:r>
               <a:rPr lang="en-US" sz="1800" dirty="0">
@@ -20429,7 +20551,7 @@
                   <a:srgbClr val="333333"/>
                 </a:solidFill>
               </a:rPr>
-              <a:t>Model ini mensimulasikan perilaku </a:t>
+              <a:t>   1. Praktik pengisian data diam (</a:t>
             </a:r>
             <a:pPr indent="0" marL="0">
               <a:buNone/>
@@ -20440,7 +20562,7 @@
                   <a:srgbClr val="333333"/>
                 </a:solidFill>
               </a:rPr>
-              <a:t>Robo-Advisory</a:t>
+              <a:t>backward fill</a:t>
             </a:r>
             <a:pPr indent="0" marL="0">
               <a:buNone/>
@@ -20451,14 +20573,13 @@
                   <a:srgbClr val="333333"/>
                 </a:solidFill>
               </a:rPr>
-              <a:t> institusional.</a:t>
+              <a:t>) memang menciptakan rentetan nilai harga yang statis.</a:t>
             </a:r>
             <a:endParaRPr lang="en-US" sz="1800" dirty="0"/>
           </a:p>
           <a:p>
-            <a:pPr marL="342900" indent="-342900">
-              <a:buSzPct val="100000"/>
-              <a:buChar char="•"/>
+            <a:pPr indent="0" marL="0">
+              <a:buNone/>
             </a:pPr>
             <a:r>
               <a:rPr lang="en-US" sz="1800" dirty="0">
@@ -20466,7 +20587,7 @@
                   <a:srgbClr val="333333"/>
                 </a:solidFill>
               </a:rPr>
-              <a:t>Ketika pasar anjlok ekstrem, investor akan melarikan senjatanya ke posisi </a:t>
+              <a:t>   2. Namun, kehebatan </a:t>
             </a:r>
             <a:pPr indent="0" marL="0">
               <a:buNone/>
@@ -20477,7 +20598,7 @@
                   <a:srgbClr val="333333"/>
                 </a:solidFill>
               </a:rPr>
-              <a:t>tunai (USDT)</a:t>
+              <a:t>Random Matrix Theory (RMT)</a:t>
             </a:r>
             <a:pPr indent="0" marL="0">
               <a:buNone/>
@@ -20488,7 +20609,79 @@
                   <a:srgbClr val="333333"/>
                 </a:solidFill>
               </a:rPr>
-              <a:t> sebagai evakuasi risiko.</a:t>
+              <a:t> diuji di sini! Karena data yang datar sama sekali tidak punya korelasi nyata.</a:t>
+            </a:r>
+            <a:endParaRPr lang="en-US" sz="1800" dirty="0"/>
+          </a:p>
+          <a:p>
+            <a:pPr indent="0" marL="0">
+              <a:buNone/>
+            </a:pPr>
+            <a:r>
+              <a:rPr lang="en-US" sz="1800" dirty="0">
+                <a:solidFill>
+                  <a:srgbClr val="333333"/>
+                </a:solidFill>
+              </a:rPr>
+              <a:t>   3. RMT otomatis akan mendeteksi korelasi buatan tersebut sebagai probabilitas </a:t>
+            </a:r>
+            <a:pPr indent="0" marL="0">
+              <a:buNone/>
+            </a:pPr>
+            <a:r>
+              <a:rPr lang="en-US" sz="1800" b="1" i="1" dirty="0">
+                <a:solidFill>
+                  <a:srgbClr val="333333"/>
+                </a:solidFill>
+              </a:rPr>
+              <a:t>Noise Acak</a:t>
+            </a:r>
+            <a:pPr indent="0" marL="0">
+              <a:buNone/>
+            </a:pPr>
+            <a:r>
+              <a:rPr lang="en-US" sz="1800" dirty="0">
+                <a:solidFill>
+                  <a:srgbClr val="333333"/>
+                </a:solidFill>
+              </a:rPr>
+              <a:t>, lalu membuangnya menjadi 0.</a:t>
+            </a:r>
+            <a:endParaRPr lang="en-US" sz="1800" dirty="0"/>
+          </a:p>
+          <a:p>
+            <a:pPr indent="0" marL="0">
+              <a:buNone/>
+            </a:pPr>
+            <a:r>
+              <a:rPr lang="en-US" sz="1800" dirty="0">
+                <a:solidFill>
+                  <a:srgbClr val="333333"/>
+                </a:solidFill>
+              </a:rPr>
+              <a:t>   4. Hasilnya, matriks korelasi </a:t>
+            </a:r>
+            <a:pPr indent="0" marL="0">
+              <a:buNone/>
+            </a:pPr>
+            <a:r>
+              <a:rPr lang="en-US" sz="1800" b="1" dirty="0">
+                <a:solidFill>
+                  <a:srgbClr val="333333"/>
+                </a:solidFill>
+              </a:rPr>
+              <a:t>terselamatkan</a:t>
+            </a:r>
+            <a:pPr indent="0" marL="0">
+              <a:buNone/>
+            </a:pPr>
+            <a:r>
+              <a:rPr lang="en-US" sz="1800" dirty="0">
+                <a:solidFill>
+                  <a:srgbClr val="333333"/>
+                </a:solidFill>
+              </a:rPr>
+              <a:t> dan tidak tercemar oleh cacat kelengkapan data.</a:t>
             </a:r>
             <a:endParaRPr lang="en-US" sz="1800" dirty="0"/>
           </a:p>
@@ -20594,7 +20787,7 @@
                   <a:srgbClr val="003366"/>
                 </a:solidFill>
               </a:rPr>
-              <a:t>Lampiran: Mengapa Menyertakan Tether (USDT)? (2/2)</a:t>
+              <a:t>Lampiran: Mengapa Menyertakan Tether (USDT)? (1/2)</a:t>
             </a:r>
             <a:endParaRPr lang="en-US" sz="2600" dirty="0"/>
           </a:p>
@@ -20625,12 +20818,89 @@
               <a:buNone/>
             </a:pPr>
             <a:r>
+              <a:rPr lang="en-US" sz="1800" b="1" dirty="0">
+                <a:solidFill>
+                  <a:srgbClr val="C0392B"/>
+                </a:solidFill>
+              </a:rPr>
+              <a:t>Pertanyaan: </a:t>
+            </a:r>
+            <a:pPr indent="0" marL="0">
+              <a:buNone/>
+            </a:pPr>
+            <a:r>
+              <a:rPr lang="en-US" sz="1800" i="1" dirty="0">
+                <a:solidFill>
+                  <a:srgbClr val="333333"/>
+                </a:solidFill>
+              </a:rPr>
+              <a:t>"Tether (USDT) itu stablecoin yang nilainya selalu fix ke 1 USD. Apakah tidak berbuat curang?"</a:t>
+            </a:r>
+            <a:endParaRPr lang="en-US" sz="1800" dirty="0"/>
+          </a:p>
+          <a:p>
+            <a:pPr indent="0" marL="0">
+              <a:buNone/>
+            </a:pPr>
+            <a:r>
+              <a:rPr lang="en-US" sz="1800" b="1" dirty="0">
+                <a:solidFill>
+                  <a:srgbClr val="27AE60"/>
+                </a:solidFill>
+              </a:rPr>
+              <a:t>Jawaban (Dinamika Portofolio Cerdas):</a:t>
+            </a:r>
+            <a:endParaRPr lang="en-US" sz="1800" dirty="0"/>
+          </a:p>
+          <a:p>
+            <a:pPr marL="342900" indent="-342900">
+              <a:buSzPct val="100000"/>
+              <a:buChar char="•"/>
+            </a:pPr>
+            <a:r>
               <a:rPr lang="en-US" sz="1800" dirty="0">
                 <a:solidFill>
                   <a:srgbClr val="333333"/>
                 </a:solidFill>
               </a:rPr>
-              <a:t>3. Algoritma jaringan </a:t>
+              <a:t>Model ini mensimulasikan perilaku </a:t>
+            </a:r>
+            <a:pPr indent="0" marL="0">
+              <a:buNone/>
+            </a:pPr>
+            <a:r>
+              <a:rPr lang="en-US" sz="1800" b="1" i="1" dirty="0">
+                <a:solidFill>
+                  <a:srgbClr val="333333"/>
+                </a:solidFill>
+              </a:rPr>
+              <a:t>Robo-Advisory</a:t>
+            </a:r>
+            <a:pPr indent="0" marL="0">
+              <a:buNone/>
+            </a:pPr>
+            <a:r>
+              <a:rPr lang="en-US" sz="1800" dirty="0">
+                <a:solidFill>
+                  <a:srgbClr val="333333"/>
+                </a:solidFill>
+              </a:rPr>
+              <a:t> institusional.</a:t>
+            </a:r>
+            <a:endParaRPr lang="en-US" sz="1800" dirty="0"/>
+          </a:p>
+          <a:p>
+            <a:pPr marL="342900" indent="-342900">
+              <a:buSzPct val="100000"/>
+              <a:buChar char="•"/>
+            </a:pPr>
+            <a:r>
+              <a:rPr lang="en-US" sz="1800" dirty="0">
+                <a:solidFill>
+                  <a:srgbClr val="333333"/>
+                </a:solidFill>
+              </a:rPr>
+              <a:t>Ketika pasar anjlok ekstrem, investor akan melarikan senjatanya ke posisi </a:t>
             </a:r>
             <a:pPr indent="0" marL="0">
               <a:buNone/>
@@ -20641,7 +20911,7 @@
                   <a:srgbClr val="333333"/>
                 </a:solidFill>
               </a:rPr>
-              <a:t>Network Markowitz GS (Grid Search)</a:t>
+              <a:t>tunai (USDT)</a:t>
             </a:r>
             <a:pPr indent="0" marL="0">
               <a:buNone/>
@@ -20652,87 +20922,7 @@
                   <a:srgbClr val="333333"/>
                 </a:solidFill>
               </a:rPr>
-              <a:t> dilatih secara matematis; jika mendeteksi korelasi ancaman kolaps merambat ke semua altcoin, ia akan melempar alokasi modalnya menuju node </a:t>
-            </a:r>
-            <a:pPr indent="0" marL="0">
-              <a:buNone/>
-            </a:pPr>
-            <a:r>
-              <a:rPr lang="en-US" sz="1800" b="1" dirty="0">
-                <a:solidFill>
-                  <a:srgbClr val="333333"/>
-                </a:solidFill>
-              </a:rPr>
-              <a:t>USDT (Tether)</a:t>
-            </a:r>
-            <a:pPr indent="0" marL="0">
-              <a:buNone/>
-            </a:pPr>
-            <a:r>
-              <a:rPr lang="en-US" sz="1800" dirty="0">
-                <a:solidFill>
-                  <a:srgbClr val="333333"/>
-                </a:solidFill>
-              </a:rPr>
-              <a:t> sebagai langkah </a:t>
-            </a:r>
-            <a:pPr indent="0" marL="0">
-              <a:buNone/>
-            </a:pPr>
-            <a:r>
-              <a:rPr lang="en-US" sz="1800" b="1" dirty="0">
-                <a:solidFill>
-                  <a:srgbClr val="333333"/>
-                </a:solidFill>
-              </a:rPr>
-              <a:t>evakuasi otomatis</a:t>
-            </a:r>
-            <a:pPr indent="0" marL="0">
-              <a:buNone/>
-            </a:pPr>
-            <a:r>
-              <a:rPr lang="en-US" sz="1800" dirty="0">
-                <a:solidFill>
-                  <a:srgbClr val="333333"/>
-                </a:solidFill>
-              </a:rPr>
-              <a:t> (Shock-Absorber).</a:t>
-            </a:r>
-            <a:endParaRPr lang="en-US" sz="1800" dirty="0"/>
-          </a:p>
-          <a:p>
-            <a:pPr indent="0" marL="0">
-              <a:buNone/>
-            </a:pPr>
-            <a:r>
-              <a:rPr lang="en-US" sz="1800" dirty="0">
-                <a:solidFill>
-                  <a:srgbClr val="333333"/>
-                </a:solidFill>
-              </a:rPr>
-              <a:t>   4. Hal ini yang membuat performa Risk-GS (Grid Search) sangat </a:t>
-            </a:r>
-            <a:pPr indent="0" marL="0">
-              <a:buNone/>
-            </a:pPr>
-            <a:r>
-              <a:rPr lang="en-US" sz="1800" b="1" dirty="0">
-                <a:solidFill>
-                  <a:srgbClr val="333333"/>
-                </a:solidFill>
-              </a:rPr>
-              <a:t>tangguh</a:t>
-            </a:r>
-            <a:pPr indent="0" marL="0">
-              <a:buNone/>
-            </a:pPr>
-            <a:r>
-              <a:rPr lang="en-US" sz="1800" dirty="0">
-                <a:solidFill>
-                  <a:srgbClr val="333333"/>
-                </a:solidFill>
-              </a:rPr>
-              <a:t> dari serangan Crypto Winter, suatu kapabilitas pertahanan yang tidak dipahami oleh model ortodoks murni Markowitz.</a:t>
+              <a:t> sebagai evakuasi risiko.</a:t>
             </a:r>
             <a:endParaRPr lang="en-US" sz="1800" dirty="0"/>
           </a:p>
@@ -20838,7 +21028,7 @@
                   <a:srgbClr val="003366"/>
                 </a:solidFill>
               </a:rPr>
-              <a:t>Lampiran: Bukti Empiris Non-Stationarity Pasar</a:t>
+              <a:t>Lampiran: Mengapa Menyertakan Tether (USDT)? (2/2)</a:t>
             </a:r>
             <a:endParaRPr lang="en-US" sz="2600" dirty="0"/>
           </a:p>
@@ -20869,23 +21059,78 @@
               <a:buNone/>
             </a:pPr>
             <a:r>
+              <a:rPr lang="en-US" sz="1800" dirty="0">
+                <a:solidFill>
+                  <a:srgbClr val="333333"/>
+                </a:solidFill>
+              </a:rPr>
+              <a:t>3. Algoritma jaringan </a:t>
+            </a:r>
+            <a:pPr indent="0" marL="0">
+              <a:buNone/>
+            </a:pPr>
+            <a:r>
               <a:rPr lang="en-US" sz="1800" b="1" dirty="0">
                 <a:solidFill>
-                  <a:srgbClr val="C0392B"/>
-                </a:solidFill>
-              </a:rPr>
-              <a:t>Masalah: </a:t>
-            </a:r>
-            <a:pPr indent="0" marL="0">
-              <a:buNone/>
-            </a:pPr>
-            <a:r>
-              <a:rPr lang="en-US" sz="1800" i="1" dirty="0">
-                <a:solidFill>
-                  <a:srgbClr val="333333"/>
-                </a:solidFill>
-              </a:rPr>
-              <a:t>Kenapa harus menggunakan model Adaptif (Dynamic Gamma)?</a:t>
+                  <a:srgbClr val="333333"/>
+                </a:solidFill>
+              </a:rPr>
+              <a:t>Network Markowitz GS (Grid Search)</a:t>
+            </a:r>
+            <a:pPr indent="0" marL="0">
+              <a:buNone/>
+            </a:pPr>
+            <a:r>
+              <a:rPr lang="en-US" sz="1800" dirty="0">
+                <a:solidFill>
+                  <a:srgbClr val="333333"/>
+                </a:solidFill>
+              </a:rPr>
+              <a:t> dilatih secara matematis; jika mendeteksi korelasi ancaman kolaps merambat ke semua altcoin, ia akan melempar alokasi modalnya menuju node </a:t>
+            </a:r>
+            <a:pPr indent="0" marL="0">
+              <a:buNone/>
+            </a:pPr>
+            <a:r>
+              <a:rPr lang="en-US" sz="1800" b="1" dirty="0">
+                <a:solidFill>
+                  <a:srgbClr val="333333"/>
+                </a:solidFill>
+              </a:rPr>
+              <a:t>USDT (Tether)</a:t>
+            </a:r>
+            <a:pPr indent="0" marL="0">
+              <a:buNone/>
+            </a:pPr>
+            <a:r>
+              <a:rPr lang="en-US" sz="1800" dirty="0">
+                <a:solidFill>
+                  <a:srgbClr val="333333"/>
+                </a:solidFill>
+              </a:rPr>
+              <a:t> sebagai langkah </a:t>
+            </a:r>
+            <a:pPr indent="0" marL="0">
+              <a:buNone/>
+            </a:pPr>
+            <a:r>
+              <a:rPr lang="en-US" sz="1800" b="1" dirty="0">
+                <a:solidFill>
+                  <a:srgbClr val="333333"/>
+                </a:solidFill>
+              </a:rPr>
+              <a:t>evakuasi otomatis</a:t>
+            </a:r>
+            <a:pPr indent="0" marL="0">
+              <a:buNone/>
+            </a:pPr>
+            <a:r>
+              <a:rPr lang="en-US" sz="1800" dirty="0">
+                <a:solidFill>
+                  <a:srgbClr val="333333"/>
+                </a:solidFill>
+              </a:rPr>
+              <a:t> (Shock-Absorber).</a:t>
             </a:r>
             <a:endParaRPr lang="en-US" sz="1800" dirty="0"/>
           </a:p>
@@ -20894,19 +21139,26 @@
               <a:buNone/>
             </a:pPr>
             <a:r>
+              <a:rPr lang="en-US" sz="1800" dirty="0">
+                <a:solidFill>
+                  <a:srgbClr val="333333"/>
+                </a:solidFill>
+              </a:rPr>
+              <a:t>   4. Hal ini yang membuat performa Risk-GS (Grid Search) sangat </a:t>
+            </a:r>
+            <a:pPr indent="0" marL="0">
+              <a:buNone/>
+            </a:pPr>
+            <a:r>
               <a:rPr lang="en-US" sz="1800" b="1" dirty="0">
                 <a:solidFill>
-                  <a:srgbClr val="27AE60"/>
-                </a:solidFill>
-              </a:rPr>
-              <a:t>Bukti dari Grid Search:</a:t>
-            </a:r>
-            <a:endParaRPr lang="en-US" sz="1800" dirty="0"/>
-          </a:p>
-          <a:p>
-            <a:pPr marL="342900" indent="-342900">
-              <a:buSzPct val="100000"/>
-              <a:buChar char="•"/>
+                  <a:srgbClr val="333333"/>
+                </a:solidFill>
+              </a:rPr>
+              <a:t>tangguh</a:t>
+            </a:r>
+            <a:pPr indent="0" marL="0">
+              <a:buNone/>
             </a:pPr>
             <a:r>
               <a:rPr lang="en-US" sz="1800" dirty="0">
@@ -20914,103 +21166,7 @@
                   <a:srgbClr val="333333"/>
                 </a:solidFill>
               </a:rPr>
-              <a:t>Data menunjukkan nilai Gamma (γ) optimal </a:t>
-            </a:r>
-            <a:pPr indent="0" marL="0">
-              <a:buNone/>
-            </a:pPr>
-            <a:r>
-              <a:rPr lang="en-US" sz="1800" b="1" dirty="0">
-                <a:solidFill>
-                  <a:srgbClr val="333333"/>
-                </a:solidFill>
-              </a:rPr>
-              <a:t>terus bergeser</a:t>
-            </a:r>
-            <a:pPr indent="0" marL="0">
-              <a:buNone/>
-            </a:pPr>
-            <a:r>
-              <a:rPr lang="en-US" sz="1800" dirty="0">
-                <a:solidFill>
-                  <a:srgbClr val="333333"/>
-                </a:solidFill>
-              </a:rPr>
-              <a:t> setiap periode rebalancing.</a:t>
-            </a:r>
-            <a:endParaRPr lang="en-US" sz="1800" dirty="0"/>
-          </a:p>
-          <a:p>
-            <a:pPr marL="342900" indent="-342900">
-              <a:buSzPct val="100000"/>
-              <a:buChar char="•"/>
-            </a:pPr>
-            <a:r>
-              <a:rPr lang="en-US" sz="1800" dirty="0">
-                <a:solidFill>
-                  <a:srgbClr val="333333"/>
-                </a:solidFill>
-              </a:rPr>
-              <a:t>Penggunaan γ statis tidak cukup untuk menangkap perubahan </a:t>
-            </a:r>
-            <a:pPr indent="0" marL="0">
-              <a:buNone/>
-            </a:pPr>
-            <a:r>
-              <a:rPr lang="en-US" sz="1800" b="1" dirty="0">
-                <a:solidFill>
-                  <a:srgbClr val="333333"/>
-                </a:solidFill>
-              </a:rPr>
-              <a:t>struktur korelasi</a:t>
-            </a:r>
-            <a:pPr indent="0" marL="0">
-              <a:buNone/>
-            </a:pPr>
-            <a:r>
-              <a:rPr lang="en-US" sz="1800" dirty="0">
-                <a:solidFill>
-                  <a:srgbClr val="333333"/>
-                </a:solidFill>
-              </a:rPr>
-              <a:t> yang sangat cepat di pasar kripto.</a:t>
-            </a:r>
-            <a:endParaRPr lang="en-US" sz="1800" dirty="0"/>
-          </a:p>
-          <a:p>
-            <a:pPr marL="342900" indent="-342900">
-              <a:buSzPct val="100000"/>
-              <a:buChar char="•"/>
-            </a:pPr>
-            <a:r>
-              <a:rPr lang="en-US" sz="1800" dirty="0">
-                <a:solidFill>
-                  <a:srgbClr val="333333"/>
-                </a:solidFill>
-              </a:rPr>
-              <a:t>Ini membenarkan bahwa pasar kripto membutuhkan </a:t>
-            </a:r>
-            <a:pPr indent="0" marL="0">
-              <a:buNone/>
-            </a:pPr>
-            <a:r>
-              <a:rPr lang="en-US" sz="1800" b="1" dirty="0">
-                <a:solidFill>
-                  <a:srgbClr val="333333"/>
-                </a:solidFill>
-              </a:rPr>
-              <a:t>kalibrasi otomatis</a:t>
-            </a:r>
-            <a:pPr indent="0" marL="0">
-              <a:buNone/>
-            </a:pPr>
-            <a:r>
-              <a:rPr lang="en-US" sz="1800" dirty="0">
-                <a:solidFill>
-                  <a:srgbClr val="333333"/>
-                </a:solidFill>
-              </a:rPr>
-              <a:t> secara temporal.</a:t>
+              <a:t> dari serangan Crypto Winter, suatu kapabilitas pertahanan yang tidak dipahami oleh model ortodoks murni Markowitz.</a:t>
             </a:r>
             <a:endParaRPr lang="en-US" sz="1800" dirty="0"/>
           </a:p>
@@ -21072,6 +21228,284 @@
 <file path=ppt/slides/slide53.xml><?xml version="1.0" encoding="utf-8"?>
 <p:sld xmlns:a="http://schemas.openxmlformats.org/drawingml/2006/main" xmlns:r="http://schemas.openxmlformats.org/officeDocument/2006/relationships" xmlns:p="http://schemas.openxmlformats.org/presentationml/2006/main">
   <p:cSld name="Slide 53">
+    <p:spTree>
+      <p:nvGrpSpPr>
+        <p:cNvPr id="1" name=""/>
+        <p:cNvGrpSpPr/>
+        <p:nvPr/>
+      </p:nvGrpSpPr>
+      <p:grpSpPr>
+        <a:xfrm>
+          <a:off x="0" y="0"/>
+          <a:ext cx="0" cy="0"/>
+          <a:chOff x="0" y="0"/>
+          <a:chExt cx="0" cy="0"/>
+        </a:xfrm>
+      </p:grpSpPr>
+      <p:sp>
+        <p:nvSpPr>
+          <p:cNvPr id="2" name="Text 0"/>
+          <p:cNvSpPr/>
+          <p:nvPr/>
+        </p:nvSpPr>
+        <p:spPr>
+          <a:xfrm>
+            <a:off x="457200" y="457200"/>
+            <a:ext cx="8229600" cy="0"/>
+          </a:xfrm>
+          <a:prstGeom prst="rect">
+            <a:avLst/>
+          </a:prstGeom>
+          <a:noFill/>
+          <a:ln/>
+        </p:spPr>
+        <p:txBody>
+          <a:bodyPr wrap="square" rtlCol="0" anchor="ctr"/>
+          <a:lstStyle/>
+          <a:p>
+            <a:pPr indent="0" marL="0">
+              <a:buNone/>
+            </a:pPr>
+            <a:r>
+              <a:rPr lang="en-US" sz="2600" b="1" dirty="0">
+                <a:solidFill>
+                  <a:srgbClr val="003366"/>
+                </a:solidFill>
+              </a:rPr>
+              <a:t>Lampiran: Bukti Empiris Non-Stationarity Pasar</a:t>
+            </a:r>
+            <a:endParaRPr lang="en-US" sz="2600" dirty="0"/>
+          </a:p>
+        </p:txBody>
+      </p:sp>
+      <p:sp>
+        <p:nvSpPr>
+          <p:cNvPr id="3" name="Text 1"/>
+          <p:cNvSpPr/>
+          <p:nvPr/>
+        </p:nvSpPr>
+        <p:spPr>
+          <a:xfrm>
+            <a:off x="457200" y="1005840"/>
+            <a:ext cx="8229600" cy="5029200"/>
+          </a:xfrm>
+          <a:prstGeom prst="rect">
+            <a:avLst/>
+          </a:prstGeom>
+          <a:noFill/>
+          <a:ln/>
+        </p:spPr>
+        <p:txBody>
+          <a:bodyPr wrap="square" rtlCol="0" anchor="t"/>
+          <a:lstStyle/>
+          <a:p>
+            <a:pPr indent="0" marL="0">
+              <a:buNone/>
+            </a:pPr>
+            <a:r>
+              <a:rPr lang="en-US" sz="1800" b="1" dirty="0">
+                <a:solidFill>
+                  <a:srgbClr val="C0392B"/>
+                </a:solidFill>
+              </a:rPr>
+              <a:t>Masalah: </a:t>
+            </a:r>
+            <a:pPr indent="0" marL="0">
+              <a:buNone/>
+            </a:pPr>
+            <a:r>
+              <a:rPr lang="en-US" sz="1800" i="1" dirty="0">
+                <a:solidFill>
+                  <a:srgbClr val="333333"/>
+                </a:solidFill>
+              </a:rPr>
+              <a:t>Kenapa harus menggunakan model Adaptif (Dynamic Gamma)?</a:t>
+            </a:r>
+            <a:endParaRPr lang="en-US" sz="1800" dirty="0"/>
+          </a:p>
+          <a:p>
+            <a:pPr indent="0" marL="0">
+              <a:buNone/>
+            </a:pPr>
+            <a:r>
+              <a:rPr lang="en-US" sz="1800" b="1" dirty="0">
+                <a:solidFill>
+                  <a:srgbClr val="27AE60"/>
+                </a:solidFill>
+              </a:rPr>
+              <a:t>Bukti dari Grid Search:</a:t>
+            </a:r>
+            <a:endParaRPr lang="en-US" sz="1800" dirty="0"/>
+          </a:p>
+          <a:p>
+            <a:pPr marL="342900" indent="-342900">
+              <a:buSzPct val="100000"/>
+              <a:buChar char="•"/>
+            </a:pPr>
+            <a:r>
+              <a:rPr lang="en-US" sz="1800" dirty="0">
+                <a:solidFill>
+                  <a:srgbClr val="333333"/>
+                </a:solidFill>
+              </a:rPr>
+              <a:t>Data menunjukkan nilai Gamma (γ) optimal </a:t>
+            </a:r>
+            <a:pPr indent="0" marL="0">
+              <a:buNone/>
+            </a:pPr>
+            <a:r>
+              <a:rPr lang="en-US" sz="1800" b="1" dirty="0">
+                <a:solidFill>
+                  <a:srgbClr val="333333"/>
+                </a:solidFill>
+              </a:rPr>
+              <a:t>terus bergeser</a:t>
+            </a:r>
+            <a:pPr indent="0" marL="0">
+              <a:buNone/>
+            </a:pPr>
+            <a:r>
+              <a:rPr lang="en-US" sz="1800" dirty="0">
+                <a:solidFill>
+                  <a:srgbClr val="333333"/>
+                </a:solidFill>
+              </a:rPr>
+              <a:t> setiap periode rebalancing.</a:t>
+            </a:r>
+            <a:endParaRPr lang="en-US" sz="1800" dirty="0"/>
+          </a:p>
+          <a:p>
+            <a:pPr marL="342900" indent="-342900">
+              <a:buSzPct val="100000"/>
+              <a:buChar char="•"/>
+            </a:pPr>
+            <a:r>
+              <a:rPr lang="en-US" sz="1800" dirty="0">
+                <a:solidFill>
+                  <a:srgbClr val="333333"/>
+                </a:solidFill>
+              </a:rPr>
+              <a:t>Penggunaan γ statis tidak cukup untuk menangkap perubahan </a:t>
+            </a:r>
+            <a:pPr indent="0" marL="0">
+              <a:buNone/>
+            </a:pPr>
+            <a:r>
+              <a:rPr lang="en-US" sz="1800" b="1" dirty="0">
+                <a:solidFill>
+                  <a:srgbClr val="333333"/>
+                </a:solidFill>
+              </a:rPr>
+              <a:t>struktur korelasi</a:t>
+            </a:r>
+            <a:pPr indent="0" marL="0">
+              <a:buNone/>
+            </a:pPr>
+            <a:r>
+              <a:rPr lang="en-US" sz="1800" dirty="0">
+                <a:solidFill>
+                  <a:srgbClr val="333333"/>
+                </a:solidFill>
+              </a:rPr>
+              <a:t> yang sangat cepat di pasar kripto.</a:t>
+            </a:r>
+            <a:endParaRPr lang="en-US" sz="1800" dirty="0"/>
+          </a:p>
+          <a:p>
+            <a:pPr marL="342900" indent="-342900">
+              <a:buSzPct val="100000"/>
+              <a:buChar char="•"/>
+            </a:pPr>
+            <a:r>
+              <a:rPr lang="en-US" sz="1800" dirty="0">
+                <a:solidFill>
+                  <a:srgbClr val="333333"/>
+                </a:solidFill>
+              </a:rPr>
+              <a:t>Ini membenarkan bahwa pasar kripto membutuhkan </a:t>
+            </a:r>
+            <a:pPr indent="0" marL="0">
+              <a:buNone/>
+            </a:pPr>
+            <a:r>
+              <a:rPr lang="en-US" sz="1800" b="1" dirty="0">
+                <a:solidFill>
+                  <a:srgbClr val="333333"/>
+                </a:solidFill>
+              </a:rPr>
+              <a:t>kalibrasi otomatis</a:t>
+            </a:r>
+            <a:pPr indent="0" marL="0">
+              <a:buNone/>
+            </a:pPr>
+            <a:r>
+              <a:rPr lang="en-US" sz="1800" dirty="0">
+                <a:solidFill>
+                  <a:srgbClr val="333333"/>
+                </a:solidFill>
+              </a:rPr>
+              <a:t> secara temporal.</a:t>
+            </a:r>
+            <a:endParaRPr lang="en-US" sz="1800" dirty="0"/>
+          </a:p>
+        </p:txBody>
+      </p:sp>
+      <p:sp>
+        <p:nvSpPr>
+          <p:cNvPr id="4" name="Text 2">
+            <a:hlinkClick r:id="rId1" tooltip="" action="ppaction://hlinksldjump"/>
+          </p:cNvPr>
+          <p:cNvSpPr/>
+          <p:nvPr/>
+        </p:nvSpPr>
+        <p:spPr>
+          <a:xfrm>
+            <a:off x="7772400" y="4846320"/>
+            <a:ext cx="1097280" cy="0"/>
+          </a:xfrm>
+          <a:prstGeom prst="rect">
+            <a:avLst/>
+          </a:prstGeom>
+          <a:noFill/>
+          <a:ln/>
+        </p:spPr>
+        <p:txBody>
+          <a:bodyPr wrap="square" rtlCol="0" anchor="ctr"/>
+          <a:lstStyle/>
+          <a:p>
+            <a:pPr algn="r" indent="0" marL="0">
+              <a:buNone/>
+            </a:pPr>
+            <a:r>
+              <a:rPr lang="en-US" sz="1000" u="sng" dirty="0">
+                <a:solidFill>
+                  <a:srgbClr val="0563C1"/>
+                </a:solidFill>
+                <a:hlinkClick r:id="rId1" action="ppaction://hlinksldjump" tooltip="">
+                  <a:extLst>
+                    <a:ext uri="{A12FA001-AC4F-418D-AE19-62706E023703}">
+                      <ahyp:hlinkClr xmlns:ahyp="http://schemas.microsoft.com/office/drawing/2018/hyperlinkcolor" val="tx"/>
+                    </a:ext>
+                  </a:extLst>
+                </a:hlinkClick>
+              </a:rPr>
+              <a:t>🏠 Daftar Isi</a:t>
+            </a:r>
+            <a:endParaRPr lang="en-US" sz="1000" dirty="0"/>
+          </a:p>
+        </p:txBody>
+      </p:sp>
+    </p:spTree>
+  </p:cSld>
+  <p:clrMapOvr>
+    <a:masterClrMapping/>
+  </p:clrMapOvr>
+</p:sld>
+</file>
+
+<file path=ppt/slides/slide54.xml><?xml version="1.0" encoding="utf-8"?>
+<p:sld xmlns:a="http://schemas.openxmlformats.org/drawingml/2006/main" xmlns:r="http://schemas.openxmlformats.org/officeDocument/2006/relationships" xmlns:p="http://schemas.openxmlformats.org/presentationml/2006/main">
+  <p:cSld name="Slide 54">
     <p:spTree>
       <p:nvGrpSpPr>
         <p:cNvPr id="1" name=""/>

</xml_diff>

<commit_message>
remove closing section from Table of Contents
</commit_message>
<xml_diff>
--- a/Presentasi_Proposal_Update.pptx
+++ b/Presentasi_Proposal_Update.pptx
@@ -9508,52 +9508,6 @@
             <a:pPr indent="0" marL="0">
               <a:buNone/>
             </a:pPr>
-            <a:endParaRPr lang="en-US" sz="1800" dirty="0"/>
-          </a:p>
-          <a:p>
-            <a:pPr indent="0" marL="0">
-              <a:buNone/>
-            </a:pPr>
-            <a:r>
-              <a:rPr lang="en-US" sz="1800" b="1" dirty="0">
-                <a:solidFill>
-                  <a:srgbClr val="003366"/>
-                </a:solidFill>
-              </a:rPr>
-              <a:t>V. PENUTUP</a:t>
-            </a:r>
-            <a:endParaRPr lang="en-US" sz="1800" dirty="0"/>
-          </a:p>
-          <a:p>
-            <a:pPr indent="0" marL="0">
-              <a:buNone/>
-            </a:pPr>
-            <a:r>
-              <a:rPr lang="en-US" sz="1800" dirty="0">
-                <a:solidFill>
-                  <a:srgbClr val="333333"/>
-                </a:solidFill>
-              </a:rPr>
-              <a:t>   • </a:t>
-            </a:r>
-            <a:pPr indent="0" marL="0">
-              <a:buNone/>
-            </a:pPr>
-            <a:r>
-              <a:rPr lang="en-US" sz="1600" u="sng" dirty="0">
-                <a:solidFill>
-                  <a:srgbClr val="333333"/>
-                </a:solidFill>
-                <a:hlinkClick r:id="rId19" action="ppaction://hlinksldjump" tooltip="">
-                  <a:extLst>
-                    <a:ext uri="{A12FA001-AC4F-418D-AE19-62706E023703}">
-                      <ahyp:hlinkClr xmlns:ahyp="http://schemas.microsoft.com/office/drawing/2018/hyperlinkcolor" val="tx"/>
-                    </a:ext>
-                  </a:extLst>
-                </a:hlinkClick>
-              </a:rPr>
-              <a:t>Sesi Tanya Jawab (Q&amp;A)</a:t>
-            </a:r>
             <a:endParaRPr lang="en-US" sz="1800" dirty="0"/>
           </a:p>
         </p:txBody>

</xml_diff>

<commit_message>
update performance metrics slide with detailed academic descriptions
</commit_message>
<xml_diff>
--- a/Presentasi_Proposal_Update.pptx
+++ b/Presentasi_Proposal_Update.pptx
@@ -7386,150 +7386,112 @@
               <a:buNone/>
             </a:pPr>
             <a:r>
-              <a:rPr lang="en-US" sz="1800" b="1" dirty="0">
+              <a:rPr lang="en-US" sz="1700" b="1" dirty="0">
+                <a:solidFill>
+                  <a:srgbClr val="003366"/>
+                </a:solidFill>
+              </a:rPr>
+              <a:t>1. Cumulative Profits &amp; Losses (P&amp;L):</a:t>
+            </a:r>
+            <a:endParaRPr lang="en-US" sz="1700" dirty="0"/>
+          </a:p>
+          <a:p>
+            <a:pPr indent="0" marL="0">
+              <a:buNone/>
+            </a:pPr>
+            <a:r>
+              <a:rPr lang="en-US" sz="1700" dirty="0">
+                <a:solidFill>
+                  <a:srgbClr val="333333"/>
+                </a:solidFill>
+              </a:rPr>
+              <a:t>   Mengukur total keuntungan/kerugian akumulatif. Digunakan untuk membandingkan pertumbuhan modal strategi vs benchmark CRIX.</a:t>
+            </a:r>
+            <a:endParaRPr lang="en-US" sz="1700" dirty="0"/>
+          </a:p>
+          <a:p>
+            <a:pPr indent="0" marL="0">
+              <a:buNone/>
+            </a:pPr>
+            <a:r>
+              <a:rPr lang="en-US" sz="1700" b="1" dirty="0">
+                <a:solidFill>
+                  <a:srgbClr val="C0392B"/>
+                </a:solidFill>
+              </a:rPr>
+              <a:t>2. Value at Risk (VaR):</a:t>
+            </a:r>
+            <a:endParaRPr lang="en-US" sz="1700" dirty="0"/>
+          </a:p>
+          <a:p>
+            <a:pPr indent="0" marL="0">
+              <a:buNone/>
+            </a:pPr>
+            <a:r>
+              <a:rPr lang="en-US" sz="1700" dirty="0">
+                <a:solidFill>
+                  <a:srgbClr val="333333"/>
+                </a:solidFill>
+              </a:rPr>
+              <a:t>   Potensi kerugian maksimal (batas bawah) pada tingkat kepercayaan 95%. Membuktikan resiliensi model saat kondisi pasar crash.</a:t>
+            </a:r>
+            <a:endParaRPr lang="en-US" sz="1700" dirty="0"/>
+          </a:p>
+          <a:p>
+            <a:pPr indent="0" marL="0">
+              <a:buNone/>
+            </a:pPr>
+            <a:r>
+              <a:rPr lang="en-US" sz="1700" b="1" dirty="0">
                 <a:solidFill>
                   <a:srgbClr val="27AE60"/>
                 </a:solidFill>
               </a:rPr>
-              <a:t>1. Sharpe Ratio:</a:t>
-            </a:r>
-            <a:endParaRPr lang="en-US" sz="1800" dirty="0"/>
-          </a:p>
-          <a:p>
-            <a:pPr indent="0" marL="0">
-              <a:buNone/>
-            </a:pPr>
-            <a:r>
-              <a:rPr lang="en-US" sz="1800" dirty="0">
-                <a:solidFill>
-                  <a:srgbClr val="333333"/>
-                </a:solidFill>
-              </a:rPr>
-              <a:t>   Imbal hasil per unit risiko. Semakin besar menunjukkan kualitas </a:t>
-            </a:r>
-            <a:pPr indent="0" marL="0">
-              <a:buNone/>
-            </a:pPr>
-            <a:r>
-              <a:rPr lang="en-US" sz="1800" b="1" dirty="0">
-                <a:solidFill>
-                  <a:srgbClr val="333333"/>
-                </a:solidFill>
-              </a:rPr>
-              <a:t>efisiensi portofolio</a:t>
-            </a:r>
-            <a:pPr indent="0" marL="0">
-              <a:buNone/>
-            </a:pPr>
-            <a:r>
-              <a:rPr lang="en-US" sz="1800" dirty="0">
-                <a:solidFill>
-                  <a:srgbClr val="333333"/>
-                </a:solidFill>
-              </a:rPr>
-              <a:t>.</a:t>
-            </a:r>
-            <a:endParaRPr lang="en-US" sz="1800" dirty="0"/>
-          </a:p>
-          <a:p>
-            <a:pPr indent="0" marL="0">
-              <a:buNone/>
-            </a:pPr>
-            <a:r>
-              <a:rPr lang="en-US" sz="1800" b="1" dirty="0">
-                <a:solidFill>
-                  <a:srgbClr val="C0392B"/>
-                </a:solidFill>
-              </a:rPr>
-              <a:t>2. Value at Risk (VaR):</a:t>
-            </a:r>
-            <a:endParaRPr lang="en-US" sz="1800" dirty="0"/>
-          </a:p>
-          <a:p>
-            <a:pPr indent="0" marL="0">
-              <a:buNone/>
-            </a:pPr>
-            <a:r>
-              <a:rPr lang="en-US" sz="1800" dirty="0">
-                <a:solidFill>
-                  <a:srgbClr val="333333"/>
-                </a:solidFill>
-              </a:rPr>
-              <a:t>   Batas </a:t>
-            </a:r>
-            <a:pPr indent="0" marL="0">
-              <a:buNone/>
-            </a:pPr>
-            <a:r>
-              <a:rPr lang="en-US" sz="1800" b="1" dirty="0">
-                <a:solidFill>
-                  <a:srgbClr val="333333"/>
-                </a:solidFill>
-              </a:rPr>
-              <a:t>kerugian maksimal</a:t>
-            </a:r>
-            <a:pPr indent="0" marL="0">
-              <a:buNone/>
-            </a:pPr>
-            <a:r>
-              <a:rPr lang="en-US" sz="1800" dirty="0">
-                <a:solidFill>
-                  <a:srgbClr val="333333"/>
-                </a:solidFill>
-              </a:rPr>
-              <a:t> kondiri crash. Semakin kecil tandanya perisai sukses.</a:t>
-            </a:r>
-            <a:endParaRPr lang="en-US" sz="1800" dirty="0"/>
-          </a:p>
-          <a:p>
-            <a:pPr indent="0" marL="0">
-              <a:buNone/>
-            </a:pPr>
-            <a:r>
-              <a:rPr lang="en-US" sz="1800" b="1" dirty="0">
+              <a:t>3. Sharpe Ratio (SR):</a:t>
+            </a:r>
+            <a:endParaRPr lang="en-US" sz="1700" dirty="0"/>
+          </a:p>
+          <a:p>
+            <a:pPr indent="0" marL="0">
+              <a:buNone/>
+            </a:pPr>
+            <a:r>
+              <a:rPr lang="en-US" sz="1700" dirty="0">
+                <a:solidFill>
+                  <a:srgbClr val="333333"/>
+                </a:solidFill>
+              </a:rPr>
+              <a:t>   Imbal hasil per unit risiko (volatilitas). Semakin tinggi, semakin baik kualitas efisiensi portofolio dalam menghasilkan profit.</a:t>
+            </a:r>
+            <a:endParaRPr lang="en-US" sz="1700" dirty="0"/>
+          </a:p>
+          <a:p>
+            <a:pPr indent="0" marL="0">
+              <a:buNone/>
+            </a:pPr>
+            <a:r>
+              <a:rPr lang="en-US" sz="1700" b="1" dirty="0">
                 <a:solidFill>
                   <a:srgbClr val="8E44AD"/>
                 </a:solidFill>
               </a:rPr>
-              <a:t>3. Rachev Ratio:</a:t>
-            </a:r>
-            <a:endParaRPr lang="en-US" sz="1800" dirty="0"/>
-          </a:p>
-          <a:p>
-            <a:pPr indent="0" marL="0">
-              <a:buNone/>
-            </a:pPr>
-            <a:r>
-              <a:rPr lang="en-US" sz="1800" dirty="0">
-                <a:solidFill>
-                  <a:srgbClr val="333333"/>
-                </a:solidFill>
-              </a:rPr>
-              <a:t>   Membandingkan potensi 'Profit Ekstrem' vs </a:t>
-            </a:r>
-            <a:pPr indent="0" marL="0">
-              <a:buNone/>
-            </a:pPr>
-            <a:r>
-              <a:rPr lang="en-US" sz="1800" b="1" dirty="0">
-                <a:solidFill>
-                  <a:srgbClr val="333333"/>
-                </a:solidFill>
-              </a:rPr>
-              <a:t>Ancaman Loss</a:t>
-            </a:r>
-            <a:pPr indent="0" marL="0">
-              <a:buNone/>
-            </a:pPr>
-            <a:r>
-              <a:rPr lang="en-US" sz="1800" dirty="0">
-                <a:solidFill>
-                  <a:srgbClr val="333333"/>
-                </a:solidFill>
-              </a:rPr>
-              <a:t>. Menilai asimetri ekor.</a:t>
-            </a:r>
-            <a:endParaRPr lang="en-US" sz="1800" dirty="0"/>
+              <a:t>4. Rachev Ratio (RR):</a:t>
+            </a:r>
+            <a:endParaRPr lang="en-US" sz="1700" dirty="0"/>
+          </a:p>
+          <a:p>
+            <a:pPr indent="0" marL="0">
+              <a:buNone/>
+            </a:pPr>
+            <a:r>
+              <a:rPr lang="en-US" sz="1700" dirty="0">
+                <a:solidFill>
+                  <a:srgbClr val="333333"/>
+                </a:solidFill>
+              </a:rPr>
+              <a:t>   Rasio potensi keuntungan ekstrem vs kerugian ekstrem. Sangat krusial karena data kripto memiliki 'Fat Tails' (distribusi tidak normal).</a:t>
+            </a:r>
+            <a:endParaRPr lang="en-US" sz="1700" dirty="0"/>
           </a:p>
         </p:txBody>
       </p:sp>

</xml_diff>

<commit_message>
feat: add Sharpe Ratio simulation slide and update TOC
</commit_message>
<xml_diff>
--- a/Presentasi_Proposal_Update.pptx
+++ b/Presentasi_Proposal_Update.pptx
@@ -60,9 +60,10 @@
     <p:sldId id="308" r:id="rId54"/>
     <p:sldId id="309" r:id="rId55"/>
     <p:sldId id="310" r:id="rId56"/>
+    <p:sldId id="311" r:id="rId57"/>
   </p:sldIdLst>
   <p:notesMasterIdLst>
-    <p:notesMasterId r:id="rId57"/>
+    <p:notesMasterId r:id="rId58"/>
   </p:notesMasterIdLst>
   <p:sldSz cx="9144000" cy="5143500"/>
   <p:notesSz cx="5143500" cy="9144000"/>
@@ -4980,6 +4981,94 @@
             <a:fld id="{F7021451-1387-4CA6-816F-3879F97B5CBC}" type="slidenum">
               <a:rPr lang="en-US"/>
               <a:t>55</a:t>
+            </a:fld>
+            <a:endParaRPr lang="en-US"/>
+          </a:p>
+        </p:txBody>
+      </p:sp>
+    </p:spTree>
+    <p:extLst>
+      <p:ext uri="{BB962C8B-B14F-4D97-AF65-F5344CB8AC3E}">
+        <p14:creationId xmlns:p14="http://schemas.microsoft.com/office/powerpoint/2010/main" val="1024086991"/>
+      </p:ext>
+    </p:extLst>
+  </p:cSld>
+  <p:clrMapOvr>
+    <a:masterClrMapping/>
+  </p:clrMapOvr>
+</p:notes>
+</file>
+
+<file path=ppt/notesSlides/notesSlide56.xml><?xml version="1.0" encoding="utf-8"?>
+<p:notes xmlns:a="http://schemas.openxmlformats.org/drawingml/2006/main" xmlns:r="http://schemas.openxmlformats.org/officeDocument/2006/relationships" xmlns:p="http://schemas.openxmlformats.org/presentationml/2006/main">
+  <p:cSld>
+    <p:spTree>
+      <p:nvGrpSpPr>
+        <p:cNvPr id="1" name=""/>
+        <p:cNvGrpSpPr/>
+        <p:nvPr/>
+      </p:nvGrpSpPr>
+      <p:grpSpPr>
+        <a:xfrm>
+          <a:off x="0" y="0"/>
+          <a:ext cx="0" cy="0"/>
+          <a:chOff x="0" y="0"/>
+          <a:chExt cx="0" cy="0"/>
+        </a:xfrm>
+      </p:grpSpPr>
+      <p:sp>
+        <p:nvSpPr>
+          <p:cNvPr id="2" name="Slide Image Placeholder 1"/>
+          <p:cNvSpPr>
+            <a:spLocks noGrp="1" noRot="1" noChangeAspect="1"/>
+          </p:cNvSpPr>
+          <p:nvPr>
+            <p:ph type="sldImg"/>
+          </p:nvPr>
+        </p:nvSpPr>
+        <p:spPr/>
+      </p:sp>
+      <p:sp>
+        <p:nvSpPr>
+          <p:cNvPr id="3" name="Notes Placeholder 2"/>
+          <p:cNvSpPr>
+            <a:spLocks noGrp="1"/>
+          </p:cNvSpPr>
+          <p:nvPr>
+            <p:ph type="body" idx="1"/>
+          </p:nvPr>
+        </p:nvSpPr>
+        <p:spPr/>
+        <p:txBody>
+          <a:bodyPr/>
+          <a:lstStyle/>
+          <a:p>
+            <a:r>
+              <a:rPr lang="en-US" dirty="0"/>
+              <a:t/>
+            </a:r>
+            <a:endParaRPr lang="en-US" dirty="0"/>
+          </a:p>
+        </p:txBody>
+      </p:sp>
+      <p:sp>
+        <p:nvSpPr>
+          <p:cNvPr id="4" name="Slide Number Placeholder 3"/>
+          <p:cNvSpPr>
+            <a:spLocks noGrp="1"/>
+          </p:cNvSpPr>
+          <p:nvPr>
+            <p:ph type="sldNum" sz="quarter" idx="10"/>
+          </p:nvPr>
+        </p:nvSpPr>
+        <p:spPr/>
+        <p:txBody>
+          <a:bodyPr/>
+          <a:lstStyle/>
+          <a:p>
+            <a:fld id="{F7021451-1387-4CA6-816F-3879F97B5CBC}" type="slidenum">
+              <a:rPr lang="en-US"/>
+              <a:t>56</a:t>
             </a:fld>
             <a:endParaRPr lang="en-US"/>
           </a:p>
@@ -9738,7 +9827,7 @@
                   </a:extLst>
                 </a:hlinkClick>
               </a:rPr>
-              <a:t>Random Matrix Theory (RMT)</a:t>
+              <a:t>Simulasi Sharpe Ratio</a:t>
             </a:r>
             <a:pPr indent="0" marL="0">
               <a:buNone/>
@@ -9773,7 +9862,7 @@
                   </a:extLst>
                 </a:hlinkClick>
               </a:rPr>
-              <a:t>Minimum Spanning Tree (MST)</a:t>
+              <a:t>Random Matrix Theory (RMT)</a:t>
             </a:r>
             <a:pPr indent="0" marL="0">
               <a:buNone/>
@@ -9808,7 +9897,7 @@
                   </a:extLst>
                 </a:hlinkClick>
               </a:rPr>
-              <a:t>Penalty &amp; Centrality Logic</a:t>
+              <a:t>Minimum Spanning Tree (MST)</a:t>
             </a:r>
             <a:pPr indent="0" marL="0">
               <a:buNone/>
@@ -9843,7 +9932,7 @@
                   </a:extLst>
                 </a:hlinkClick>
               </a:rPr>
-              <a:t>Simulasi 60/40 Weight Shift</a:t>
+              <a:t>Penalty &amp; Centrality Logic</a:t>
             </a:r>
             <a:pPr indent="0" marL="0">
               <a:buNone/>
@@ -9878,6 +9967,41 @@
                   </a:extLst>
                 </a:hlinkClick>
               </a:rPr>
+              <a:t>Simulasi 60/40 Weight Shift</a:t>
+            </a:r>
+            <a:pPr indent="0" marL="0">
+              <a:buNone/>
+            </a:pPr>
+            <a:endParaRPr lang="en-US" sz="1800" dirty="0"/>
+          </a:p>
+          <a:p>
+            <a:pPr indent="0" marL="0">
+              <a:buNone/>
+            </a:pPr>
+            <a:r>
+              <a:rPr lang="en-US" sz="1800" dirty="0">
+                <a:solidFill>
+                  <a:srgbClr val="333333"/>
+                </a:solidFill>
+              </a:rPr>
+              <a:t>   • </a:t>
+            </a:r>
+            <a:pPr indent="0" marL="0">
+              <a:buNone/>
+            </a:pPr>
+            <a:r>
+              <a:rPr lang="en-US" sz="1600" u="sng" dirty="0">
+                <a:solidFill>
+                  <a:srgbClr val="333333"/>
+                </a:solidFill>
+                <a:hlinkClick r:id="rId19" action="ppaction://hlinksldjump" tooltip="">
+                  <a:extLst>
+                    <a:ext uri="{A12FA001-AC4F-418D-AE19-62706E023703}">
+                      <ahyp:hlinkClr xmlns:ahyp="http://schemas.microsoft.com/office/drawing/2018/hyperlinkcolor" val="tx"/>
+                    </a:ext>
+                  </a:extLst>
+                </a:hlinkClick>
+              </a:rPr>
               <a:t>Simulasi Grid Search</a:t>
             </a:r>
             <a:pPr indent="0" marL="0">
@@ -9905,7 +10029,7 @@
                 <a:solidFill>
                   <a:srgbClr val="333333"/>
                 </a:solidFill>
-                <a:hlinkClick r:id="rId19" action="ppaction://hlinksldjump" tooltip="">
+                <a:hlinkClick r:id="rId20" action="ppaction://hlinksldjump" tooltip="">
                   <a:extLst>
                     <a:ext uri="{A12FA001-AC4F-418D-AE19-62706E023703}">
                       <ahyp:hlinkClr xmlns:ahyp="http://schemas.microsoft.com/office/drawing/2018/hyperlinkcolor" val="tx"/>
@@ -22076,6 +22200,344 @@
 <file path=ppt/slides/slide55.xml><?xml version="1.0" encoding="utf-8"?>
 <p:sld xmlns:a="http://schemas.openxmlformats.org/drawingml/2006/main" xmlns:r="http://schemas.openxmlformats.org/officeDocument/2006/relationships" xmlns:p="http://schemas.openxmlformats.org/presentationml/2006/main">
   <p:cSld name="Slide 55">
+    <p:spTree>
+      <p:nvGrpSpPr>
+        <p:cNvPr id="1" name=""/>
+        <p:cNvGrpSpPr/>
+        <p:nvPr/>
+      </p:nvGrpSpPr>
+      <p:grpSpPr>
+        <a:xfrm>
+          <a:off x="0" y="0"/>
+          <a:ext cx="0" cy="0"/>
+          <a:chOff x="0" y="0"/>
+          <a:chExt cx="0" cy="0"/>
+        </a:xfrm>
+      </p:grpSpPr>
+      <p:sp>
+        <p:nvSpPr>
+          <p:cNvPr id="2" name="Text 0"/>
+          <p:cNvSpPr/>
+          <p:nvPr/>
+        </p:nvSpPr>
+        <p:spPr>
+          <a:xfrm>
+            <a:off x="457200" y="457200"/>
+            <a:ext cx="8229600" cy="0"/>
+          </a:xfrm>
+          <a:prstGeom prst="rect">
+            <a:avLst/>
+          </a:prstGeom>
+          <a:noFill/>
+          <a:ln/>
+        </p:spPr>
+        <p:txBody>
+          <a:bodyPr wrap="square" rtlCol="0" anchor="ctr"/>
+          <a:lstStyle/>
+          <a:p>
+            <a:pPr indent="0" marL="0">
+              <a:buNone/>
+            </a:pPr>
+            <a:r>
+              <a:rPr lang="en-US" sz="2400" b="1" dirty="0">
+                <a:solidFill>
+                  <a:srgbClr val="003366"/>
+                </a:solidFill>
+              </a:rPr>
+              <a:t>Lampiran: Simulasi Kalkulasi Sharpe Ratio</a:t>
+            </a:r>
+            <a:endParaRPr lang="en-US" sz="2400" dirty="0"/>
+          </a:p>
+        </p:txBody>
+      </p:sp>
+      <p:sp>
+        <p:nvSpPr>
+          <p:cNvPr id="3" name="Text 1"/>
+          <p:cNvSpPr/>
+          <p:nvPr/>
+        </p:nvSpPr>
+        <p:spPr>
+          <a:xfrm>
+            <a:off x="457200" y="1005840"/>
+            <a:ext cx="8229600" cy="5029200"/>
+          </a:xfrm>
+          <a:prstGeom prst="rect">
+            <a:avLst/>
+          </a:prstGeom>
+          <a:noFill/>
+          <a:ln/>
+        </p:spPr>
+        <p:txBody>
+          <a:bodyPr wrap="square" rtlCol="0" anchor="t"/>
+          <a:lstStyle/>
+          <a:p>
+            <a:pPr indent="0" marL="0">
+              <a:buNone/>
+            </a:pPr>
+            <a:r>
+              <a:rPr lang="en-US" sz="1600" b="1" dirty="0">
+                <a:solidFill>
+                  <a:srgbClr val="333333"/>
+                </a:solidFill>
+              </a:rPr>
+              <a:t>Bagaimana mengukur kualitas imbal hasil per unit risiko?</a:t>
+            </a:r>
+            <a:endParaRPr lang="en-US" sz="1600" dirty="0"/>
+          </a:p>
+          <a:p>
+            <a:pPr indent="0" marL="0">
+              <a:buNone/>
+            </a:pPr>
+            <a:r>
+              <a:rPr lang="en-US" sz="1600" b="1" dirty="0">
+                <a:solidFill>
+                  <a:srgbClr val="003366"/>
+                </a:solidFill>
+              </a:rPr>
+              <a:t>1. Konsep Dasar:</a:t>
+            </a:r>
+            <a:endParaRPr lang="en-US" sz="1600" dirty="0"/>
+          </a:p>
+          <a:p>
+            <a:pPr indent="0" marL="0">
+              <a:buNone/>
+            </a:pPr>
+            <a:r>
+              <a:rPr lang="en-US" sz="1600" dirty="0">
+                <a:solidFill>
+                  <a:srgbClr val="333333"/>
+                </a:solidFill>
+              </a:rPr>
+              <a:t>   Sharpe Ratio mengukur kelebihan imbal hasil (Excess Return) dibandingkan aset aman (Risk-Free) per satu satuan risiko (Volatilitas).</a:t>
+            </a:r>
+            <a:endParaRPr lang="en-US" sz="1600" dirty="0"/>
+          </a:p>
+          <a:p>
+            <a:pPr indent="0" marL="0">
+              <a:buNone/>
+            </a:pPr>
+            <a:r>
+              <a:rPr lang="en-US" sz="1600" b="1" dirty="0">
+                <a:solidFill>
+                  <a:srgbClr val="003366"/>
+                </a:solidFill>
+              </a:rPr>
+              <a:t>2. Rumus Sederhana:</a:t>
+            </a:r>
+            <a:endParaRPr lang="en-US" sz="1600" dirty="0"/>
+          </a:p>
+          <a:p>
+            <a:pPr indent="0" marL="0">
+              <a:buNone/>
+            </a:pPr>
+            <a:r>
+              <a:rPr lang="en-US" sz="1600" b="1" dirty="0">
+                <a:solidFill>
+                  <a:srgbClr val="C0392B"/>
+                </a:solidFill>
+                <a:latin typeface="Courier New" pitchFamily="34" charset="0"/>
+                <a:ea typeface="Courier New" pitchFamily="34" charset="-122"/>
+                <a:cs typeface="Courier New" pitchFamily="34" charset="-120"/>
+              </a:rPr>
+              <a:t>   SR = (Return Portofolio - Risk-Free Rate) / Standar Deviasi</a:t>
+            </a:r>
+            <a:endParaRPr lang="en-US" sz="1600" dirty="0"/>
+          </a:p>
+          <a:p>
+            <a:pPr indent="0" marL="0">
+              <a:buNone/>
+            </a:pPr>
+            <a:r>
+              <a:rPr lang="en-US" sz="1600" b="1" dirty="0">
+                <a:solidFill>
+                  <a:srgbClr val="003366"/>
+                </a:solidFill>
+              </a:rPr>
+              <a:t>3. Simulasi Angka (Dummy):</a:t>
+            </a:r>
+            <a:endParaRPr lang="en-US" sz="1600" dirty="0"/>
+          </a:p>
+          <a:p>
+            <a:pPr indent="0" marL="0">
+              <a:buNone/>
+            </a:pPr>
+            <a:r>
+              <a:rPr lang="en-US" sz="1600" dirty="0">
+                <a:solidFill>
+                  <a:srgbClr val="333333"/>
+                </a:solidFill>
+              </a:rPr>
+              <a:t>   • Return Portofolio (Rp): 15% (0.15)</a:t>
+            </a:r>
+            <a:endParaRPr lang="en-US" sz="1600" dirty="0"/>
+          </a:p>
+          <a:p>
+            <a:pPr indent="0" marL="0">
+              <a:buNone/>
+            </a:pPr>
+            <a:r>
+              <a:rPr lang="en-US" sz="1600" i="1" dirty="0">
+                <a:solidFill>
+                  <a:srgbClr val="333333"/>
+                </a:solidFill>
+              </a:rPr>
+              <a:t>   • Suku Bunga Bebas Risiko (Rf): 2% (0.02) </a:t>
+            </a:r>
+            <a:pPr indent="0" marL="0">
+              <a:buNone/>
+            </a:pPr>
+            <a:r>
+              <a:rPr lang="en-US" sz="1200" dirty="0">
+                <a:solidFill>
+                  <a:srgbClr val="333333"/>
+                </a:solidFill>
+              </a:rPr>
+              <a:t> (Basis: USDT Lending Rate)</a:t>
+            </a:r>
+            <a:endParaRPr lang="en-US" sz="1600" dirty="0"/>
+          </a:p>
+          <a:p>
+            <a:pPr indent="0" marL="0">
+              <a:buNone/>
+            </a:pPr>
+            <a:r>
+              <a:rPr lang="en-US" sz="1600" dirty="0">
+                <a:solidFill>
+                  <a:srgbClr val="333333"/>
+                </a:solidFill>
+              </a:rPr>
+              <a:t>   • Volatilitas Portofolio (σ): 10% (0.10)</a:t>
+            </a:r>
+            <a:endParaRPr lang="en-US" sz="1600" dirty="0"/>
+          </a:p>
+          <a:p>
+            <a:pPr indent="0" marL="0">
+              <a:buNone/>
+            </a:pPr>
+            <a:r>
+              <a:rPr lang="en-US" sz="1600" b="1" dirty="0">
+                <a:solidFill>
+                  <a:srgbClr val="003366"/>
+                </a:solidFill>
+              </a:rPr>
+              <a:t>4. Kalkulasi:</a:t>
+            </a:r>
+            <a:endParaRPr lang="en-US" sz="1600" dirty="0"/>
+          </a:p>
+          <a:p>
+            <a:pPr indent="0" marL="0">
+              <a:buNone/>
+            </a:pPr>
+            <a:r>
+              <a:rPr lang="en-US" sz="1600" dirty="0">
+                <a:solidFill>
+                  <a:srgbClr val="333333"/>
+                </a:solidFill>
+                <a:latin typeface="Courier New" pitchFamily="34" charset="0"/>
+                <a:ea typeface="Courier New" pitchFamily="34" charset="-122"/>
+                <a:cs typeface="Courier New" pitchFamily="34" charset="-120"/>
+              </a:rPr>
+              <a:t>   SR = (0.15 - 0.02) / 0.10 = 0.13 / 0.10 = </a:t>
+            </a:r>
+            <a:pPr indent="0" marL="0">
+              <a:buNone/>
+            </a:pPr>
+            <a:r>
+              <a:rPr lang="en-US" sz="1600" b="1" dirty="0">
+                <a:solidFill>
+                  <a:srgbClr val="27AE60"/>
+                </a:solidFill>
+                <a:latin typeface="Courier New" pitchFamily="34" charset="0"/>
+                <a:ea typeface="Courier New" pitchFamily="34" charset="-122"/>
+                <a:cs typeface="Courier New" pitchFamily="34" charset="-120"/>
+              </a:rPr>
+              <a:t>1.30</a:t>
+            </a:r>
+            <a:pPr indent="0" marL="0">
+              <a:buNone/>
+            </a:pPr>
+            <a:r>
+              <a:rPr lang="en-US" sz="1600" b="1" dirty="0">
+                <a:solidFill>
+                  <a:srgbClr val="8E44AD"/>
+                </a:solidFill>
+              </a:rPr>
+              <a:t>Interpretasi:</a:t>
+            </a:r>
+            <a:endParaRPr lang="en-US" sz="1600" dirty="0"/>
+          </a:p>
+          <a:p>
+            <a:pPr indent="0" marL="0">
+              <a:buNone/>
+            </a:pPr>
+            <a:r>
+              <a:rPr lang="en-US" sz="1600" i="1" dirty="0">
+                <a:solidFill>
+                  <a:srgbClr val="333333"/>
+                </a:solidFill>
+              </a:rPr>
+              <a:t>Nilai 1.30 berarti untuk setiap 1% risiko yang diambil, portofolio memberikan imbal hasil tambahan sebesar 1.30%. Semakin tinggi nilai SR, semakin efisien portofolio tersebut.</a:t>
+            </a:r>
+            <a:endParaRPr lang="en-US" sz="1600" dirty="0"/>
+          </a:p>
+        </p:txBody>
+      </p:sp>
+      <p:sp>
+        <p:nvSpPr>
+          <p:cNvPr id="4" name="Text 2">
+            <a:hlinkClick r:id="rId1" tooltip="" action="ppaction://hlinksldjump"/>
+          </p:cNvPr>
+          <p:cNvSpPr/>
+          <p:nvPr/>
+        </p:nvSpPr>
+        <p:spPr>
+          <a:xfrm>
+            <a:off x="7772400" y="4846320"/>
+            <a:ext cx="1097280" cy="0"/>
+          </a:xfrm>
+          <a:prstGeom prst="rect">
+            <a:avLst/>
+          </a:prstGeom>
+          <a:noFill/>
+          <a:ln/>
+        </p:spPr>
+        <p:txBody>
+          <a:bodyPr wrap="square" rtlCol="0" anchor="ctr"/>
+          <a:lstStyle/>
+          <a:p>
+            <a:pPr algn="r" indent="0" marL="0">
+              <a:buNone/>
+            </a:pPr>
+            <a:r>
+              <a:rPr lang="en-US" sz="1000" u="sng" dirty="0">
+                <a:solidFill>
+                  <a:srgbClr val="0563C1"/>
+                </a:solidFill>
+                <a:hlinkClick r:id="rId1" action="ppaction://hlinksldjump" tooltip="">
+                  <a:extLst>
+                    <a:ext uri="{A12FA001-AC4F-418D-AE19-62706E023703}">
+                      <ahyp:hlinkClr xmlns:ahyp="http://schemas.microsoft.com/office/drawing/2018/hyperlinkcolor" val="tx"/>
+                    </a:ext>
+                  </a:extLst>
+                </a:hlinkClick>
+              </a:rPr>
+              <a:t>🏠 Daftar Isi</a:t>
+            </a:r>
+            <a:endParaRPr lang="en-US" sz="1000" dirty="0"/>
+          </a:p>
+        </p:txBody>
+      </p:sp>
+    </p:spTree>
+  </p:cSld>
+  <p:clrMapOvr>
+    <a:masterClrMapping/>
+  </p:clrMapOvr>
+</p:sld>
+</file>
+
+<file path=ppt/slides/slide56.xml><?xml version="1.0" encoding="utf-8"?>
+<p:sld xmlns:a="http://schemas.openxmlformats.org/drawingml/2006/main" xmlns:r="http://schemas.openxmlformats.org/officeDocument/2006/relationships" xmlns:p="http://schemas.openxmlformats.org/presentationml/2006/main">
+  <p:cSld name="Slide 56">
     <p:spTree>
       <p:nvGrpSpPr>
         <p:cNvPr id="1" name=""/>

</xml_diff>

<commit_message>
feat: add VaR simulation slide and update TOC 2
</commit_message>
<xml_diff>
--- a/Presentasi_Proposal_Update.pptx
+++ b/Presentasi_Proposal_Update.pptx
@@ -62,9 +62,10 @@
     <p:sldId id="310" r:id="rId56"/>
     <p:sldId id="311" r:id="rId57"/>
     <p:sldId id="312" r:id="rId58"/>
+    <p:sldId id="313" r:id="rId59"/>
   </p:sldIdLst>
   <p:notesMasterIdLst>
-    <p:notesMasterId r:id="rId59"/>
+    <p:notesMasterId r:id="rId60"/>
   </p:notesMasterIdLst>
   <p:sldSz cx="9144000" cy="5143500"/>
   <p:notesSz cx="5143500" cy="9144000"/>
@@ -5158,6 +5159,94 @@
             <a:fld id="{F7021451-1387-4CA6-816F-3879F97B5CBC}" type="slidenum">
               <a:rPr lang="en-US"/>
               <a:t>57</a:t>
+            </a:fld>
+            <a:endParaRPr lang="en-US"/>
+          </a:p>
+        </p:txBody>
+      </p:sp>
+    </p:spTree>
+    <p:extLst>
+      <p:ext uri="{BB962C8B-B14F-4D97-AF65-F5344CB8AC3E}">
+        <p14:creationId xmlns:p14="http://schemas.microsoft.com/office/powerpoint/2010/main" val="1024086991"/>
+      </p:ext>
+    </p:extLst>
+  </p:cSld>
+  <p:clrMapOvr>
+    <a:masterClrMapping/>
+  </p:clrMapOvr>
+</p:notes>
+</file>
+
+<file path=ppt/notesSlides/notesSlide58.xml><?xml version="1.0" encoding="utf-8"?>
+<p:notes xmlns:a="http://schemas.openxmlformats.org/drawingml/2006/main" xmlns:r="http://schemas.openxmlformats.org/officeDocument/2006/relationships" xmlns:p="http://schemas.openxmlformats.org/presentationml/2006/main">
+  <p:cSld>
+    <p:spTree>
+      <p:nvGrpSpPr>
+        <p:cNvPr id="1" name=""/>
+        <p:cNvGrpSpPr/>
+        <p:nvPr/>
+      </p:nvGrpSpPr>
+      <p:grpSpPr>
+        <a:xfrm>
+          <a:off x="0" y="0"/>
+          <a:ext cx="0" cy="0"/>
+          <a:chOff x="0" y="0"/>
+          <a:chExt cx="0" cy="0"/>
+        </a:xfrm>
+      </p:grpSpPr>
+      <p:sp>
+        <p:nvSpPr>
+          <p:cNvPr id="2" name="Slide Image Placeholder 1"/>
+          <p:cNvSpPr>
+            <a:spLocks noGrp="1" noRot="1" noChangeAspect="1"/>
+          </p:cNvSpPr>
+          <p:nvPr>
+            <p:ph type="sldImg"/>
+          </p:nvPr>
+        </p:nvSpPr>
+        <p:spPr/>
+      </p:sp>
+      <p:sp>
+        <p:nvSpPr>
+          <p:cNvPr id="3" name="Notes Placeholder 2"/>
+          <p:cNvSpPr>
+            <a:spLocks noGrp="1"/>
+          </p:cNvSpPr>
+          <p:nvPr>
+            <p:ph type="body" idx="1"/>
+          </p:nvPr>
+        </p:nvSpPr>
+        <p:spPr/>
+        <p:txBody>
+          <a:bodyPr/>
+          <a:lstStyle/>
+          <a:p>
+            <a:r>
+              <a:rPr lang="en-US" dirty="0"/>
+              <a:t/>
+            </a:r>
+            <a:endParaRPr lang="en-US" dirty="0"/>
+          </a:p>
+        </p:txBody>
+      </p:sp>
+      <p:sp>
+        <p:nvSpPr>
+          <p:cNvPr id="4" name="Slide Number Placeholder 3"/>
+          <p:cNvSpPr>
+            <a:spLocks noGrp="1"/>
+          </p:cNvSpPr>
+          <p:nvPr>
+            <p:ph type="sldNum" sz="quarter" idx="10"/>
+          </p:nvPr>
+        </p:nvSpPr>
+        <p:spPr/>
+        <p:txBody>
+          <a:bodyPr/>
+          <a:lstStyle/>
+          <a:p>
+            <a:fld id="{F7021451-1387-4CA6-816F-3879F97B5CBC}" type="slidenum">
+              <a:rPr lang="en-US"/>
+              <a:t>58</a:t>
             </a:fld>
             <a:endParaRPr lang="en-US"/>
           </a:p>
@@ -13072,7 +13161,7 @@
                   </a:extLst>
                 </a:hlinkClick>
               </a:rPr>
-              <a:t>Simulasi Sharpe Ratio</a:t>
+              <a:t>Simulasi Value at Risk (VaR)</a:t>
             </a:r>
             <a:pPr indent="0" marL="0">
               <a:buNone/>
@@ -13101,7 +13190,7 @@
                   </a:extLst>
                 </a:hlinkClick>
               </a:rPr>
-              <a:t>Random Matrix Theory (RMT)</a:t>
+              <a:t>Simulasi Sharpe Ratio</a:t>
             </a:r>
             <a:pPr indent="0" marL="0">
               <a:buNone/>
@@ -13130,7 +13219,7 @@
                   </a:extLst>
                 </a:hlinkClick>
               </a:rPr>
-              <a:t>Minimum Spanning Tree (MST)</a:t>
+              <a:t>Random Matrix Theory (RMT)</a:t>
             </a:r>
             <a:pPr indent="0" marL="0">
               <a:buNone/>
@@ -13159,7 +13248,7 @@
                   </a:extLst>
                 </a:hlinkClick>
               </a:rPr>
-              <a:t>Penalty &amp; Centrality Logic</a:t>
+              <a:t>Minimum Spanning Tree (MST)</a:t>
             </a:r>
             <a:pPr indent="0" marL="0">
               <a:buNone/>
@@ -13188,7 +13277,7 @@
                   </a:extLst>
                 </a:hlinkClick>
               </a:rPr>
-              <a:t>Simulasi 60/40 Weight Shift</a:t>
+              <a:t>Penalty &amp; Centrality Logic</a:t>
             </a:r>
             <a:pPr indent="0" marL="0">
               <a:buNone/>
@@ -13217,7 +13306,7 @@
                   </a:extLst>
                 </a:hlinkClick>
               </a:rPr>
-              <a:t>Simulasi Grid Search</a:t>
+              <a:t>Simulasi 60/40 Weight Shift</a:t>
             </a:r>
             <a:pPr indent="0" marL="0">
               <a:buNone/>
@@ -13246,6 +13335,35 @@
                   </a:extLst>
                 </a:hlinkClick>
               </a:rPr>
+              <a:t>Simulasi Grid Search</a:t>
+            </a:r>
+            <a:pPr indent="0" marL="0">
+              <a:buNone/>
+            </a:pPr>
+            <a:r>
+              <a:rPr lang="en-US" sz="1600" dirty="0">
+                <a:solidFill>
+                  <a:srgbClr val="333333"/>
+                </a:solidFill>
+              </a:rPr>
+              <a:t>   • </a:t>
+            </a:r>
+            <a:pPr indent="0" marL="0">
+              <a:buNone/>
+            </a:pPr>
+            <a:r>
+              <a:rPr lang="en-US" sz="1600" u="sng" dirty="0">
+                <a:solidFill>
+                  <a:srgbClr val="333333"/>
+                </a:solidFill>
+                <a:hlinkClick r:id="rId13" action="ppaction://hlinksldjump" tooltip="">
+                  <a:extLst>
+                    <a:ext uri="{A12FA001-AC4F-418D-AE19-62706E023703}">
+                      <ahyp:hlinkClr xmlns:ahyp="http://schemas.microsoft.com/office/drawing/2018/hyperlinkcolor" val="tx"/>
+                    </a:ext>
+                  </a:extLst>
+                </a:hlinkClick>
+              </a:rPr>
               <a:t>Justifikasi Rolling Window</a:t>
             </a:r>
             <a:endParaRPr lang="en-US" sz="1600" dirty="0"/>
@@ -13255,7 +13373,7 @@
       <p:sp>
         <p:nvSpPr>
           <p:cNvPr id="4" name="Text 2">
-            <a:hlinkClick r:id="rId13" tooltip="" action="ppaction://hlinksldjump"/>
+            <a:hlinkClick r:id="rId14" tooltip="" action="ppaction://hlinksldjump"/>
           </p:cNvPr>
           <p:cNvSpPr/>
           <p:nvPr/>
@@ -13283,7 +13401,7 @@
                 <a:solidFill>
                   <a:srgbClr val="7F8C8D"/>
                 </a:solidFill>
-                <a:hlinkClick r:id="rId13" action="ppaction://hlinksldjump" tooltip="">
+                <a:hlinkClick r:id="rId14" action="ppaction://hlinksldjump" tooltip="">
                   <a:extLst>
                     <a:ext uri="{A12FA001-AC4F-418D-AE19-62706E023703}">
                       <ahyp:hlinkClr xmlns:ahyp="http://schemas.microsoft.com/office/drawing/2018/hyperlinkcolor" val="tx"/>
@@ -22400,7 +22518,7 @@
                   <a:srgbClr val="003366"/>
                 </a:solidFill>
               </a:rPr>
-              <a:t>Lampiran: Simulasi Kalkulasi Sharpe Ratio</a:t>
+              <a:t>Lampiran: Simulasi Kalkulasi Value at Risk (VaR)</a:t>
             </a:r>
             <a:endParaRPr lang="en-US" sz="2400" dirty="0"/>
           </a:p>
@@ -22436,7 +22554,7 @@
                   <a:srgbClr val="333333"/>
                 </a:solidFill>
               </a:rPr>
-              <a:t>Bagaimana mengukur kualitas imbal hasil per unit risiko?</a:t>
+              <a:t>Berapa potensi kerugian maksimal dalam kondisi pasar normal?</a:t>
             </a:r>
             <a:endParaRPr lang="en-US" sz="1600" dirty="0"/>
           </a:p>
@@ -22464,7 +22582,7 @@
                   <a:srgbClr val="333333"/>
                 </a:solidFill>
               </a:rPr>
-              <a:t>   Sharpe Ratio mengukur kelebihan imbal hasil (Excess Return) dibandingkan aset aman (Risk-Free) per satu satuan risiko (Volatilitas).</a:t>
+              <a:t>   Value at Risk (VaR) mengukur ambang batas kerugian maksimal pada tingkat kepercayaan tertentu (Confidence Level 95%) dalam periode harian.</a:t>
             </a:r>
             <a:endParaRPr lang="en-US" sz="1600" dirty="0"/>
           </a:p>
@@ -22478,7 +22596,7 @@
                   <a:srgbClr val="003366"/>
                 </a:solidFill>
               </a:rPr>
-              <a:t>2. Rumus Sederhana:</a:t>
+              <a:t>2. Metode Simulasi Historis (Paling Sederhana):</a:t>
             </a:r>
             <a:endParaRPr lang="en-US" sz="1600" dirty="0"/>
           </a:p>
@@ -22487,15 +22605,65 @@
               <a:buNone/>
             </a:pPr>
             <a:r>
+              <a:rPr lang="en-US" sz="1600" dirty="0">
+                <a:solidFill>
+                  <a:srgbClr val="333333"/>
+                </a:solidFill>
+              </a:rPr>
+              <a:t>   Mengurutkan 100 hari return dari terburuk ke terbaik, lalu mengambil nilai persentil ke-5.</a:t>
+            </a:r>
+            <a:endParaRPr lang="en-US" sz="1600" dirty="0"/>
+          </a:p>
+          <a:p>
+            <a:pPr indent="0" marL="0">
+              <a:buNone/>
+            </a:pPr>
+            <a:r>
               <a:rPr lang="en-US" sz="1600" b="1" dirty="0">
                 <a:solidFill>
+                  <a:srgbClr val="003366"/>
+                </a:solidFill>
+              </a:rPr>
+              <a:t>3. Simulasi Angka (Modal: Rp 10.000.000):</a:t>
+            </a:r>
+            <a:endParaRPr lang="en-US" sz="1600" dirty="0"/>
+          </a:p>
+          <a:p>
+            <a:pPr indent="0" marL="0">
+              <a:buNone/>
+            </a:pPr>
+            <a:r>
+              <a:rPr lang="en-US" sz="1600" dirty="0">
+                <a:solidFill>
+                  <a:srgbClr val="333333"/>
+                </a:solidFill>
+              </a:rPr>
+              <a:t>   • Return terburuk urutan ke-5 (P5): -8% (-0.08)</a:t>
+            </a:r>
+            <a:endParaRPr lang="en-US" sz="1600" dirty="0"/>
+          </a:p>
+          <a:p>
+            <a:pPr indent="0" marL="0">
+              <a:buNone/>
+            </a:pPr>
+            <a:r>
+              <a:rPr lang="en-US" sz="1600" dirty="0">
+                <a:solidFill>
+                  <a:srgbClr val="333333"/>
+                </a:solidFill>
+              </a:rPr>
+              <a:t>   • Perhitungan VaR (95%): Rp 10.000.000 × 0.08 = </a:t>
+            </a:r>
+            <a:pPr indent="0" marL="0">
+              <a:buNone/>
+            </a:pPr>
+            <a:r>
+              <a:rPr lang="en-US" sz="1600" b="1" dirty="0">
+                <a:solidFill>
                   <a:srgbClr val="C0392B"/>
                 </a:solidFill>
-                <a:latin typeface="Courier New" pitchFamily="34" charset="0"/>
-                <a:ea typeface="Courier New" pitchFamily="34" charset="-122"/>
-                <a:cs typeface="Courier New" pitchFamily="34" charset="-120"/>
-              </a:rPr>
-              <a:t>   SR = (Return Portofolio - Risk-Free Rate) / Standar Deviasi</a:t>
+              </a:rPr>
+              <a:t>Rp 800.000</a:t>
             </a:r>
             <a:endParaRPr lang="en-US" sz="1600" dirty="0"/>
           </a:p>
@@ -22506,10 +22674,10 @@
             <a:r>
               <a:rPr lang="en-US" sz="1600" b="1" dirty="0">
                 <a:solidFill>
-                  <a:srgbClr val="003366"/>
-                </a:solidFill>
-              </a:rPr>
-              <a:t>3. Simulasi Angka (Dummy):</a:t>
+                  <a:srgbClr val="8E44AD"/>
+                </a:solidFill>
+              </a:rPr>
+              <a:t>4. Interpretasi Hasil:</a:t>
             </a:r>
             <a:endParaRPr lang="en-US" sz="1600" dirty="0"/>
           </a:p>
@@ -22518,121 +22686,12 @@
               <a:buNone/>
             </a:pPr>
             <a:r>
-              <a:rPr lang="en-US" sz="1600" dirty="0">
-                <a:solidFill>
-                  <a:srgbClr val="333333"/>
-                </a:solidFill>
-              </a:rPr>
-              <a:t>   • Return Portofolio (Rp): 15% (0.15)</a:t>
-            </a:r>
-            <a:endParaRPr lang="en-US" sz="1600" dirty="0"/>
-          </a:p>
-          <a:p>
-            <a:pPr indent="0" marL="0">
-              <a:buNone/>
-            </a:pPr>
-            <a:r>
               <a:rPr lang="en-US" sz="1600" i="1" dirty="0">
                 <a:solidFill>
                   <a:srgbClr val="333333"/>
                 </a:solidFill>
               </a:rPr>
-              <a:t>   • Suku Bunga Bebas Risiko (Rf): 2% (0.02) </a:t>
-            </a:r>
-            <a:pPr indent="0" marL="0">
-              <a:buNone/>
-            </a:pPr>
-            <a:r>
-              <a:rPr lang="en-US" sz="1200" dirty="0">
-                <a:solidFill>
-                  <a:srgbClr val="333333"/>
-                </a:solidFill>
-              </a:rPr>
-              <a:t> (Basis: USDT Lending Rate)</a:t>
-            </a:r>
-            <a:endParaRPr lang="en-US" sz="1600" dirty="0"/>
-          </a:p>
-          <a:p>
-            <a:pPr indent="0" marL="0">
-              <a:buNone/>
-            </a:pPr>
-            <a:r>
-              <a:rPr lang="en-US" sz="1600" dirty="0">
-                <a:solidFill>
-                  <a:srgbClr val="333333"/>
-                </a:solidFill>
-              </a:rPr>
-              <a:t>   • Volatilitas Portofolio (σ): 10% (0.10)</a:t>
-            </a:r>
-            <a:endParaRPr lang="en-US" sz="1600" dirty="0"/>
-          </a:p>
-          <a:p>
-            <a:pPr indent="0" marL="0">
-              <a:buNone/>
-            </a:pPr>
-            <a:r>
-              <a:rPr lang="en-US" sz="1600" b="1" dirty="0">
-                <a:solidFill>
-                  <a:srgbClr val="003366"/>
-                </a:solidFill>
-              </a:rPr>
-              <a:t>4. Kalkulasi:</a:t>
-            </a:r>
-            <a:endParaRPr lang="en-US" sz="1600" dirty="0"/>
-          </a:p>
-          <a:p>
-            <a:pPr indent="0" marL="0">
-              <a:buNone/>
-            </a:pPr>
-            <a:r>
-              <a:rPr lang="en-US" sz="1600" dirty="0">
-                <a:solidFill>
-                  <a:srgbClr val="333333"/>
-                </a:solidFill>
-                <a:latin typeface="Courier New" pitchFamily="34" charset="0"/>
-                <a:ea typeface="Courier New" pitchFamily="34" charset="-122"/>
-                <a:cs typeface="Courier New" pitchFamily="34" charset="-120"/>
-              </a:rPr>
-              <a:t>   SR = (0.15 - 0.02) / 0.10 = 0.13 / 0.10 = </a:t>
-            </a:r>
-            <a:pPr indent="0" marL="0">
-              <a:buNone/>
-            </a:pPr>
-            <a:r>
-              <a:rPr lang="en-US" sz="1600" b="1" dirty="0">
-                <a:solidFill>
-                  <a:srgbClr val="27AE60"/>
-                </a:solidFill>
-                <a:latin typeface="Courier New" pitchFamily="34" charset="0"/>
-                <a:ea typeface="Courier New" pitchFamily="34" charset="-122"/>
-                <a:cs typeface="Courier New" pitchFamily="34" charset="-120"/>
-              </a:rPr>
-              <a:t>1.30</a:t>
-            </a:r>
-            <a:pPr indent="0" marL="0">
-              <a:buNone/>
-            </a:pPr>
-            <a:r>
-              <a:rPr lang="en-US" sz="1600" b="1" dirty="0">
-                <a:solidFill>
-                  <a:srgbClr val="8E44AD"/>
-                </a:solidFill>
-              </a:rPr>
-              <a:t>Interpretasi:</a:t>
-            </a:r>
-            <a:endParaRPr lang="en-US" sz="1600" dirty="0"/>
-          </a:p>
-          <a:p>
-            <a:pPr indent="0" marL="0">
-              <a:buNone/>
-            </a:pPr>
-            <a:r>
-              <a:rPr lang="en-US" sz="1600" i="1" dirty="0">
-                <a:solidFill>
-                  <a:srgbClr val="333333"/>
-                </a:solidFill>
-              </a:rPr>
-              <a:t>Nilai 1.30 berarti untuk setiap 1% risiko yang diambil, portofolio memberikan imbal hasil tambahan sebesar 1.30%. Semakin tinggi nilai SR, semakin efisien portofolio tersebut.</a:t>
+              <a:t>Kita yakin 95% bahwa kerugian harian tidak akan melebihi Rp 800.000. Namun, ada 5% risiko (ekstrem) di masa depan di mana kerugian bisa lebih besar dari angka tersebut.</a:t>
             </a:r>
             <a:endParaRPr lang="en-US" sz="1600" dirty="0"/>
           </a:p>
@@ -22694,6 +22753,344 @@
 <file path=ppt/slides/slide57.xml><?xml version="1.0" encoding="utf-8"?>
 <p:sld xmlns:a="http://schemas.openxmlformats.org/drawingml/2006/main" xmlns:r="http://schemas.openxmlformats.org/officeDocument/2006/relationships" xmlns:p="http://schemas.openxmlformats.org/presentationml/2006/main">
   <p:cSld name="Slide 57">
+    <p:spTree>
+      <p:nvGrpSpPr>
+        <p:cNvPr id="1" name=""/>
+        <p:cNvGrpSpPr/>
+        <p:nvPr/>
+      </p:nvGrpSpPr>
+      <p:grpSpPr>
+        <a:xfrm>
+          <a:off x="0" y="0"/>
+          <a:ext cx="0" cy="0"/>
+          <a:chOff x="0" y="0"/>
+          <a:chExt cx="0" cy="0"/>
+        </a:xfrm>
+      </p:grpSpPr>
+      <p:sp>
+        <p:nvSpPr>
+          <p:cNvPr id="2" name="Text 0"/>
+          <p:cNvSpPr/>
+          <p:nvPr/>
+        </p:nvSpPr>
+        <p:spPr>
+          <a:xfrm>
+            <a:off x="457200" y="457200"/>
+            <a:ext cx="8229600" cy="0"/>
+          </a:xfrm>
+          <a:prstGeom prst="rect">
+            <a:avLst/>
+          </a:prstGeom>
+          <a:noFill/>
+          <a:ln/>
+        </p:spPr>
+        <p:txBody>
+          <a:bodyPr wrap="square" rtlCol="0" anchor="ctr"/>
+          <a:lstStyle/>
+          <a:p>
+            <a:pPr indent="0" marL="0">
+              <a:buNone/>
+            </a:pPr>
+            <a:r>
+              <a:rPr lang="en-US" sz="2400" b="1" dirty="0">
+                <a:solidFill>
+                  <a:srgbClr val="003366"/>
+                </a:solidFill>
+              </a:rPr>
+              <a:t>Lampiran: Simulasi Kalkulasi Sharpe Ratio</a:t>
+            </a:r>
+            <a:endParaRPr lang="en-US" sz="2400" dirty="0"/>
+          </a:p>
+        </p:txBody>
+      </p:sp>
+      <p:sp>
+        <p:nvSpPr>
+          <p:cNvPr id="3" name="Text 1"/>
+          <p:cNvSpPr/>
+          <p:nvPr/>
+        </p:nvSpPr>
+        <p:spPr>
+          <a:xfrm>
+            <a:off x="457200" y="1005840"/>
+            <a:ext cx="8229600" cy="5029200"/>
+          </a:xfrm>
+          <a:prstGeom prst="rect">
+            <a:avLst/>
+          </a:prstGeom>
+          <a:noFill/>
+          <a:ln/>
+        </p:spPr>
+        <p:txBody>
+          <a:bodyPr wrap="square" rtlCol="0" anchor="t"/>
+          <a:lstStyle/>
+          <a:p>
+            <a:pPr indent="0" marL="0">
+              <a:buNone/>
+            </a:pPr>
+            <a:r>
+              <a:rPr lang="en-US" sz="1600" b="1" dirty="0">
+                <a:solidFill>
+                  <a:srgbClr val="333333"/>
+                </a:solidFill>
+              </a:rPr>
+              <a:t>Bagaimana mengukur kualitas imbal hasil per unit risiko?</a:t>
+            </a:r>
+            <a:endParaRPr lang="en-US" sz="1600" dirty="0"/>
+          </a:p>
+          <a:p>
+            <a:pPr indent="0" marL="0">
+              <a:buNone/>
+            </a:pPr>
+            <a:r>
+              <a:rPr lang="en-US" sz="1600" b="1" dirty="0">
+                <a:solidFill>
+                  <a:srgbClr val="003366"/>
+                </a:solidFill>
+              </a:rPr>
+              <a:t>1. Konsep Dasar:</a:t>
+            </a:r>
+            <a:endParaRPr lang="en-US" sz="1600" dirty="0"/>
+          </a:p>
+          <a:p>
+            <a:pPr indent="0" marL="0">
+              <a:buNone/>
+            </a:pPr>
+            <a:r>
+              <a:rPr lang="en-US" sz="1600" dirty="0">
+                <a:solidFill>
+                  <a:srgbClr val="333333"/>
+                </a:solidFill>
+              </a:rPr>
+              <a:t>   Sharpe Ratio mengukur kelebihan imbal hasil (Excess Return) dibandingkan aset aman (Risk-Free) per satu satuan risiko (Volatilitas).</a:t>
+            </a:r>
+            <a:endParaRPr lang="en-US" sz="1600" dirty="0"/>
+          </a:p>
+          <a:p>
+            <a:pPr indent="0" marL="0">
+              <a:buNone/>
+            </a:pPr>
+            <a:r>
+              <a:rPr lang="en-US" sz="1600" b="1" dirty="0">
+                <a:solidFill>
+                  <a:srgbClr val="003366"/>
+                </a:solidFill>
+              </a:rPr>
+              <a:t>2. Rumus Sederhana:</a:t>
+            </a:r>
+            <a:endParaRPr lang="en-US" sz="1600" dirty="0"/>
+          </a:p>
+          <a:p>
+            <a:pPr indent="0" marL="0">
+              <a:buNone/>
+            </a:pPr>
+            <a:r>
+              <a:rPr lang="en-US" sz="1600" b="1" dirty="0">
+                <a:solidFill>
+                  <a:srgbClr val="C0392B"/>
+                </a:solidFill>
+                <a:latin typeface="Courier New" pitchFamily="34" charset="0"/>
+                <a:ea typeface="Courier New" pitchFamily="34" charset="-122"/>
+                <a:cs typeface="Courier New" pitchFamily="34" charset="-120"/>
+              </a:rPr>
+              <a:t>   SR = (Return Portofolio - Risk-Free Rate) / Standar Deviasi</a:t>
+            </a:r>
+            <a:endParaRPr lang="en-US" sz="1600" dirty="0"/>
+          </a:p>
+          <a:p>
+            <a:pPr indent="0" marL="0">
+              <a:buNone/>
+            </a:pPr>
+            <a:r>
+              <a:rPr lang="en-US" sz="1600" b="1" dirty="0">
+                <a:solidFill>
+                  <a:srgbClr val="003366"/>
+                </a:solidFill>
+              </a:rPr>
+              <a:t>3. Simulasi Angka (Dummy):</a:t>
+            </a:r>
+            <a:endParaRPr lang="en-US" sz="1600" dirty="0"/>
+          </a:p>
+          <a:p>
+            <a:pPr indent="0" marL="0">
+              <a:buNone/>
+            </a:pPr>
+            <a:r>
+              <a:rPr lang="en-US" sz="1600" dirty="0">
+                <a:solidFill>
+                  <a:srgbClr val="333333"/>
+                </a:solidFill>
+              </a:rPr>
+              <a:t>   • Return Portofolio (Rp): 15% (0.15)</a:t>
+            </a:r>
+            <a:endParaRPr lang="en-US" sz="1600" dirty="0"/>
+          </a:p>
+          <a:p>
+            <a:pPr indent="0" marL="0">
+              <a:buNone/>
+            </a:pPr>
+            <a:r>
+              <a:rPr lang="en-US" sz="1600" i="1" dirty="0">
+                <a:solidFill>
+                  <a:srgbClr val="333333"/>
+                </a:solidFill>
+              </a:rPr>
+              <a:t>   • Suku Bunga Bebas Risiko (Rf): 2% (0.02) </a:t>
+            </a:r>
+            <a:pPr indent="0" marL="0">
+              <a:buNone/>
+            </a:pPr>
+            <a:r>
+              <a:rPr lang="en-US" sz="1200" dirty="0">
+                <a:solidFill>
+                  <a:srgbClr val="333333"/>
+                </a:solidFill>
+              </a:rPr>
+              <a:t> (Basis: USDT Lending Rate)</a:t>
+            </a:r>
+            <a:endParaRPr lang="en-US" sz="1600" dirty="0"/>
+          </a:p>
+          <a:p>
+            <a:pPr indent="0" marL="0">
+              <a:buNone/>
+            </a:pPr>
+            <a:r>
+              <a:rPr lang="en-US" sz="1600" dirty="0">
+                <a:solidFill>
+                  <a:srgbClr val="333333"/>
+                </a:solidFill>
+              </a:rPr>
+              <a:t>   • Volatilitas Portofolio (σ): 10% (0.10)</a:t>
+            </a:r>
+            <a:endParaRPr lang="en-US" sz="1600" dirty="0"/>
+          </a:p>
+          <a:p>
+            <a:pPr indent="0" marL="0">
+              <a:buNone/>
+            </a:pPr>
+            <a:r>
+              <a:rPr lang="en-US" sz="1600" b="1" dirty="0">
+                <a:solidFill>
+                  <a:srgbClr val="003366"/>
+                </a:solidFill>
+              </a:rPr>
+              <a:t>4. Kalkulasi:</a:t>
+            </a:r>
+            <a:endParaRPr lang="en-US" sz="1600" dirty="0"/>
+          </a:p>
+          <a:p>
+            <a:pPr indent="0" marL="0">
+              <a:buNone/>
+            </a:pPr>
+            <a:r>
+              <a:rPr lang="en-US" sz="1600" dirty="0">
+                <a:solidFill>
+                  <a:srgbClr val="333333"/>
+                </a:solidFill>
+                <a:latin typeface="Courier New" pitchFamily="34" charset="0"/>
+                <a:ea typeface="Courier New" pitchFamily="34" charset="-122"/>
+                <a:cs typeface="Courier New" pitchFamily="34" charset="-120"/>
+              </a:rPr>
+              <a:t>   SR = (0.15 - 0.02) / 0.10 = 0.13 / 0.10 = </a:t>
+            </a:r>
+            <a:pPr indent="0" marL="0">
+              <a:buNone/>
+            </a:pPr>
+            <a:r>
+              <a:rPr lang="en-US" sz="1600" b="1" dirty="0">
+                <a:solidFill>
+                  <a:srgbClr val="27AE60"/>
+                </a:solidFill>
+                <a:latin typeface="Courier New" pitchFamily="34" charset="0"/>
+                <a:ea typeface="Courier New" pitchFamily="34" charset="-122"/>
+                <a:cs typeface="Courier New" pitchFamily="34" charset="-120"/>
+              </a:rPr>
+              <a:t>1.30</a:t>
+            </a:r>
+            <a:pPr indent="0" marL="0">
+              <a:buNone/>
+            </a:pPr>
+            <a:r>
+              <a:rPr lang="en-US" sz="1600" b="1" dirty="0">
+                <a:solidFill>
+                  <a:srgbClr val="8E44AD"/>
+                </a:solidFill>
+              </a:rPr>
+              <a:t>Interpretasi:</a:t>
+            </a:r>
+            <a:endParaRPr lang="en-US" sz="1600" dirty="0"/>
+          </a:p>
+          <a:p>
+            <a:pPr indent="0" marL="0">
+              <a:buNone/>
+            </a:pPr>
+            <a:r>
+              <a:rPr lang="en-US" sz="1600" i="1" dirty="0">
+                <a:solidFill>
+                  <a:srgbClr val="333333"/>
+                </a:solidFill>
+              </a:rPr>
+              <a:t>Nilai 1.30 berarti untuk setiap 1% risiko yang diambil, portofolio memberikan imbal hasil tambahan sebesar 1.30%. Semakin tinggi nilai SR, semakin efisien portofolio tersebut.</a:t>
+            </a:r>
+            <a:endParaRPr lang="en-US" sz="1600" dirty="0"/>
+          </a:p>
+        </p:txBody>
+      </p:sp>
+      <p:sp>
+        <p:nvSpPr>
+          <p:cNvPr id="4" name="Text 2">
+            <a:hlinkClick r:id="rId1" tooltip="" action="ppaction://hlinksldjump"/>
+          </p:cNvPr>
+          <p:cNvSpPr/>
+          <p:nvPr/>
+        </p:nvSpPr>
+        <p:spPr>
+          <a:xfrm>
+            <a:off x="7772400" y="4846320"/>
+            <a:ext cx="1097280" cy="0"/>
+          </a:xfrm>
+          <a:prstGeom prst="rect">
+            <a:avLst/>
+          </a:prstGeom>
+          <a:noFill/>
+          <a:ln/>
+        </p:spPr>
+        <p:txBody>
+          <a:bodyPr wrap="square" rtlCol="0" anchor="ctr"/>
+          <a:lstStyle/>
+          <a:p>
+            <a:pPr algn="r" indent="0" marL="0">
+              <a:buNone/>
+            </a:pPr>
+            <a:r>
+              <a:rPr lang="en-US" sz="1000" u="sng" dirty="0">
+                <a:solidFill>
+                  <a:srgbClr val="0563C1"/>
+                </a:solidFill>
+                <a:hlinkClick r:id="rId1" action="ppaction://hlinksldjump" tooltip="">
+                  <a:extLst>
+                    <a:ext uri="{A12FA001-AC4F-418D-AE19-62706E023703}">
+                      <ahyp:hlinkClr xmlns:ahyp="http://schemas.microsoft.com/office/drawing/2018/hyperlinkcolor" val="tx"/>
+                    </a:ext>
+                  </a:extLst>
+                </a:hlinkClick>
+              </a:rPr>
+              <a:t>🏠 Daftar Isi</a:t>
+            </a:r>
+            <a:endParaRPr lang="en-US" sz="1000" dirty="0"/>
+          </a:p>
+        </p:txBody>
+      </p:sp>
+    </p:spTree>
+  </p:cSld>
+  <p:clrMapOvr>
+    <a:masterClrMapping/>
+  </p:clrMapOvr>
+</p:sld>
+</file>
+
+<file path=ppt/slides/slide58.xml><?xml version="1.0" encoding="utf-8"?>
+<p:sld xmlns:a="http://schemas.openxmlformats.org/drawingml/2006/main" xmlns:r="http://schemas.openxmlformats.org/officeDocument/2006/relationships" xmlns:p="http://schemas.openxmlformats.org/presentationml/2006/main">
+  <p:cSld name="Slide 58">
     <p:spTree>
       <p:nvGrpSpPr>
         <p:cNvPr id="1" name=""/>

</xml_diff>

<commit_message>
feat: add Rachev Ratio simulation slide and update TOC 2
</commit_message>
<xml_diff>
--- a/Presentasi_Proposal_Update.pptx
+++ b/Presentasi_Proposal_Update.pptx
@@ -63,9 +63,10 @@
     <p:sldId id="311" r:id="rId57"/>
     <p:sldId id="312" r:id="rId58"/>
     <p:sldId id="313" r:id="rId59"/>
+    <p:sldId id="314" r:id="rId60"/>
   </p:sldIdLst>
   <p:notesMasterIdLst>
-    <p:notesMasterId r:id="rId60"/>
+    <p:notesMasterId r:id="rId61"/>
   </p:notesMasterIdLst>
   <p:sldSz cx="9144000" cy="5143500"/>
   <p:notesSz cx="5143500" cy="9144000"/>
@@ -5247,6 +5248,94 @@
             <a:fld id="{F7021451-1387-4CA6-816F-3879F97B5CBC}" type="slidenum">
               <a:rPr lang="en-US"/>
               <a:t>58</a:t>
+            </a:fld>
+            <a:endParaRPr lang="en-US"/>
+          </a:p>
+        </p:txBody>
+      </p:sp>
+    </p:spTree>
+    <p:extLst>
+      <p:ext uri="{BB962C8B-B14F-4D97-AF65-F5344CB8AC3E}">
+        <p14:creationId xmlns:p14="http://schemas.microsoft.com/office/powerpoint/2010/main" val="1024086991"/>
+      </p:ext>
+    </p:extLst>
+  </p:cSld>
+  <p:clrMapOvr>
+    <a:masterClrMapping/>
+  </p:clrMapOvr>
+</p:notes>
+</file>
+
+<file path=ppt/notesSlides/notesSlide59.xml><?xml version="1.0" encoding="utf-8"?>
+<p:notes xmlns:a="http://schemas.openxmlformats.org/drawingml/2006/main" xmlns:r="http://schemas.openxmlformats.org/officeDocument/2006/relationships" xmlns:p="http://schemas.openxmlformats.org/presentationml/2006/main">
+  <p:cSld>
+    <p:spTree>
+      <p:nvGrpSpPr>
+        <p:cNvPr id="1" name=""/>
+        <p:cNvGrpSpPr/>
+        <p:nvPr/>
+      </p:nvGrpSpPr>
+      <p:grpSpPr>
+        <a:xfrm>
+          <a:off x="0" y="0"/>
+          <a:ext cx="0" cy="0"/>
+          <a:chOff x="0" y="0"/>
+          <a:chExt cx="0" cy="0"/>
+        </a:xfrm>
+      </p:grpSpPr>
+      <p:sp>
+        <p:nvSpPr>
+          <p:cNvPr id="2" name="Slide Image Placeholder 1"/>
+          <p:cNvSpPr>
+            <a:spLocks noGrp="1" noRot="1" noChangeAspect="1"/>
+          </p:cNvSpPr>
+          <p:nvPr>
+            <p:ph type="sldImg"/>
+          </p:nvPr>
+        </p:nvSpPr>
+        <p:spPr/>
+      </p:sp>
+      <p:sp>
+        <p:nvSpPr>
+          <p:cNvPr id="3" name="Notes Placeholder 2"/>
+          <p:cNvSpPr>
+            <a:spLocks noGrp="1"/>
+          </p:cNvSpPr>
+          <p:nvPr>
+            <p:ph type="body" idx="1"/>
+          </p:nvPr>
+        </p:nvSpPr>
+        <p:spPr/>
+        <p:txBody>
+          <a:bodyPr/>
+          <a:lstStyle/>
+          <a:p>
+            <a:r>
+              <a:rPr lang="en-US" dirty="0"/>
+              <a:t/>
+            </a:r>
+            <a:endParaRPr lang="en-US" dirty="0"/>
+          </a:p>
+        </p:txBody>
+      </p:sp>
+      <p:sp>
+        <p:nvSpPr>
+          <p:cNvPr id="4" name="Slide Number Placeholder 3"/>
+          <p:cNvSpPr>
+            <a:spLocks noGrp="1"/>
+          </p:cNvSpPr>
+          <p:nvPr>
+            <p:ph type="sldNum" sz="quarter" idx="10"/>
+          </p:nvPr>
+        </p:nvSpPr>
+        <p:spPr/>
+        <p:txBody>
+          <a:bodyPr/>
+          <a:lstStyle/>
+          <a:p>
+            <a:fld id="{F7021451-1387-4CA6-816F-3879F97B5CBC}" type="slidenum">
+              <a:rPr lang="en-US"/>
+              <a:t>59</a:t>
             </a:fld>
             <a:endParaRPr lang="en-US"/>
           </a:p>
@@ -13219,7 +13308,7 @@
                   </a:extLst>
                 </a:hlinkClick>
               </a:rPr>
-              <a:t>Random Matrix Theory (RMT)</a:t>
+              <a:t>Simulasi Rachev Ratio</a:t>
             </a:r>
             <a:pPr indent="0" marL="0">
               <a:buNone/>
@@ -13248,7 +13337,7 @@
                   </a:extLst>
                 </a:hlinkClick>
               </a:rPr>
-              <a:t>Minimum Spanning Tree (MST)</a:t>
+              <a:t>Random Matrix Theory (RMT)</a:t>
             </a:r>
             <a:pPr indent="0" marL="0">
               <a:buNone/>
@@ -13277,7 +13366,7 @@
                   </a:extLst>
                 </a:hlinkClick>
               </a:rPr>
-              <a:t>Penalty &amp; Centrality Logic</a:t>
+              <a:t>Minimum Spanning Tree (MST)</a:t>
             </a:r>
             <a:pPr indent="0" marL="0">
               <a:buNone/>
@@ -13306,7 +13395,7 @@
                   </a:extLst>
                 </a:hlinkClick>
               </a:rPr>
-              <a:t>Simulasi 60/40 Weight Shift</a:t>
+              <a:t>Penalty &amp; Centrality Logic</a:t>
             </a:r>
             <a:pPr indent="0" marL="0">
               <a:buNone/>
@@ -13335,7 +13424,7 @@
                   </a:extLst>
                 </a:hlinkClick>
               </a:rPr>
-              <a:t>Simulasi Grid Search</a:t>
+              <a:t>Simulasi 60/40 Weight Shift</a:t>
             </a:r>
             <a:pPr indent="0" marL="0">
               <a:buNone/>
@@ -13364,6 +13453,35 @@
                   </a:extLst>
                 </a:hlinkClick>
               </a:rPr>
+              <a:t>Simulasi Grid Search</a:t>
+            </a:r>
+            <a:pPr indent="0" marL="0">
+              <a:buNone/>
+            </a:pPr>
+            <a:r>
+              <a:rPr lang="en-US" sz="1600" dirty="0">
+                <a:solidFill>
+                  <a:srgbClr val="333333"/>
+                </a:solidFill>
+              </a:rPr>
+              <a:t>   • </a:t>
+            </a:r>
+            <a:pPr indent="0" marL="0">
+              <a:buNone/>
+            </a:pPr>
+            <a:r>
+              <a:rPr lang="en-US" sz="1600" u="sng" dirty="0">
+                <a:solidFill>
+                  <a:srgbClr val="333333"/>
+                </a:solidFill>
+                <a:hlinkClick r:id="rId14" action="ppaction://hlinksldjump" tooltip="">
+                  <a:extLst>
+                    <a:ext uri="{A12FA001-AC4F-418D-AE19-62706E023703}">
+                      <ahyp:hlinkClr xmlns:ahyp="http://schemas.microsoft.com/office/drawing/2018/hyperlinkcolor" val="tx"/>
+                    </a:ext>
+                  </a:extLst>
+                </a:hlinkClick>
+              </a:rPr>
               <a:t>Justifikasi Rolling Window</a:t>
             </a:r>
             <a:endParaRPr lang="en-US" sz="1600" dirty="0"/>
@@ -13373,7 +13491,7 @@
       <p:sp>
         <p:nvSpPr>
           <p:cNvPr id="4" name="Text 2">
-            <a:hlinkClick r:id="rId14" tooltip="" action="ppaction://hlinksldjump"/>
+            <a:hlinkClick r:id="rId15" tooltip="" action="ppaction://hlinksldjump"/>
           </p:cNvPr>
           <p:cNvSpPr/>
           <p:nvPr/>
@@ -13401,7 +13519,7 @@
                 <a:solidFill>
                   <a:srgbClr val="7F8C8D"/>
                 </a:solidFill>
-                <a:hlinkClick r:id="rId14" action="ppaction://hlinksldjump" tooltip="">
+                <a:hlinkClick r:id="rId15" action="ppaction://hlinksldjump" tooltip="">
                   <a:extLst>
                     <a:ext uri="{A12FA001-AC4F-418D-AE19-62706E023703}">
                       <ahyp:hlinkClr xmlns:ahyp="http://schemas.microsoft.com/office/drawing/2018/hyperlinkcolor" val="tx"/>
@@ -23091,6 +23209,319 @@
 <file path=ppt/slides/slide58.xml><?xml version="1.0" encoding="utf-8"?>
 <p:sld xmlns:a="http://schemas.openxmlformats.org/drawingml/2006/main" xmlns:r="http://schemas.openxmlformats.org/officeDocument/2006/relationships" xmlns:p="http://schemas.openxmlformats.org/presentationml/2006/main">
   <p:cSld name="Slide 58">
+    <p:spTree>
+      <p:nvGrpSpPr>
+        <p:cNvPr id="1" name=""/>
+        <p:cNvGrpSpPr/>
+        <p:nvPr/>
+      </p:nvGrpSpPr>
+      <p:grpSpPr>
+        <a:xfrm>
+          <a:off x="0" y="0"/>
+          <a:ext cx="0" cy="0"/>
+          <a:chOff x="0" y="0"/>
+          <a:chExt cx="0" cy="0"/>
+        </a:xfrm>
+      </p:grpSpPr>
+      <p:sp>
+        <p:nvSpPr>
+          <p:cNvPr id="2" name="Text 0"/>
+          <p:cNvSpPr/>
+          <p:nvPr/>
+        </p:nvSpPr>
+        <p:spPr>
+          <a:xfrm>
+            <a:off x="457200" y="457200"/>
+            <a:ext cx="8229600" cy="0"/>
+          </a:xfrm>
+          <a:prstGeom prst="rect">
+            <a:avLst/>
+          </a:prstGeom>
+          <a:noFill/>
+          <a:ln/>
+        </p:spPr>
+        <p:txBody>
+          <a:bodyPr wrap="square" rtlCol="0" anchor="ctr"/>
+          <a:lstStyle/>
+          <a:p>
+            <a:pPr indent="0" marL="0">
+              <a:buNone/>
+            </a:pPr>
+            <a:r>
+              <a:rPr lang="en-US" sz="2400" b="1" dirty="0">
+                <a:solidFill>
+                  <a:srgbClr val="003366"/>
+                </a:solidFill>
+              </a:rPr>
+              <a:t>Lampiran: Simulasi Kalkulasi Rachev Ratio</a:t>
+            </a:r>
+            <a:endParaRPr lang="en-US" sz="2400" dirty="0"/>
+          </a:p>
+        </p:txBody>
+      </p:sp>
+      <p:sp>
+        <p:nvSpPr>
+          <p:cNvPr id="3" name="Text 1"/>
+          <p:cNvSpPr/>
+          <p:nvPr/>
+        </p:nvSpPr>
+        <p:spPr>
+          <a:xfrm>
+            <a:off x="457200" y="1005840"/>
+            <a:ext cx="8229600" cy="5029200"/>
+          </a:xfrm>
+          <a:prstGeom prst="rect">
+            <a:avLst/>
+          </a:prstGeom>
+          <a:noFill/>
+          <a:ln/>
+        </p:spPr>
+        <p:txBody>
+          <a:bodyPr wrap="square" rtlCol="0" anchor="t"/>
+          <a:lstStyle/>
+          <a:p>
+            <a:pPr indent="0" marL="0">
+              <a:buNone/>
+            </a:pPr>
+            <a:r>
+              <a:rPr lang="en-US" sz="1600" b="1" dirty="0">
+                <a:solidFill>
+                  <a:srgbClr val="333333"/>
+                </a:solidFill>
+              </a:rPr>
+              <a:t>Bagaimana mengukur rasio 'hadiah ekstrem' vs 'risiko ekstrem'?</a:t>
+            </a:r>
+            <a:endParaRPr lang="en-US" sz="1600" dirty="0"/>
+          </a:p>
+          <a:p>
+            <a:pPr indent="0" marL="0">
+              <a:buNone/>
+            </a:pPr>
+            <a:r>
+              <a:rPr lang="en-US" sz="1600" b="1" dirty="0">
+                <a:solidFill>
+                  <a:srgbClr val="003366"/>
+                </a:solidFill>
+              </a:rPr>
+              <a:t>1. Konsep Dasar:</a:t>
+            </a:r>
+            <a:endParaRPr lang="en-US" sz="1600" dirty="0"/>
+          </a:p>
+          <a:p>
+            <a:pPr indent="0" marL="0">
+              <a:buNone/>
+            </a:pPr>
+            <a:r>
+              <a:rPr lang="en-US" sz="1600" dirty="0">
+                <a:solidFill>
+                  <a:srgbClr val="333333"/>
+                </a:solidFill>
+              </a:rPr>
+              <a:t>   Rachev Ratio mengukur keunggulan potensi keuntungan di ekor kanan (Right Tail) dibandingkan potensi kerugian di ekor kiri (Left Tail). Sangat relevan untuk aset kripto yang tidak berdistribusi normal.</a:t>
+            </a:r>
+            <a:endParaRPr lang="en-US" sz="1600" dirty="0"/>
+          </a:p>
+          <a:p>
+            <a:pPr indent="0" marL="0">
+              <a:buNone/>
+            </a:pPr>
+            <a:r>
+              <a:rPr lang="en-US" sz="1600" b="1" dirty="0">
+                <a:solidFill>
+                  <a:srgbClr val="003366"/>
+                </a:solidFill>
+              </a:rPr>
+              <a:t>2. Rumus Sederhana:</a:t>
+            </a:r>
+            <a:endParaRPr lang="en-US" sz="1600" dirty="0"/>
+          </a:p>
+          <a:p>
+            <a:pPr indent="0" marL="0">
+              <a:buNone/>
+            </a:pPr>
+            <a:r>
+              <a:rPr lang="en-US" sz="1600" b="1" dirty="0">
+                <a:solidFill>
+                  <a:srgbClr val="C0392B"/>
+                </a:solidFill>
+                <a:latin typeface="Courier New" pitchFamily="34" charset="0"/>
+                <a:ea typeface="Courier New" pitchFamily="34" charset="-122"/>
+                <a:cs typeface="Courier New" pitchFamily="34" charset="-120"/>
+              </a:rPr>
+              <a:t>   RR = Avg. Profit (Top 5%) / Avg. Loss (Bottom 5%)</a:t>
+            </a:r>
+            <a:endParaRPr lang="en-US" sz="1600" dirty="0"/>
+          </a:p>
+          <a:p>
+            <a:pPr indent="0" marL="0">
+              <a:buNone/>
+            </a:pPr>
+            <a:r>
+              <a:rPr lang="en-US" sz="1600" b="1" dirty="0">
+                <a:solidFill>
+                  <a:srgbClr val="003366"/>
+                </a:solidFill>
+              </a:rPr>
+              <a:t>3. Simulasi Angka (Dummy):</a:t>
+            </a:r>
+            <a:endParaRPr lang="en-US" sz="1600" dirty="0"/>
+          </a:p>
+          <a:p>
+            <a:pPr indent="0" marL="0">
+              <a:buNone/>
+            </a:pPr>
+            <a:r>
+              <a:rPr lang="en-US" sz="1600" dirty="0">
+                <a:solidFill>
+                  <a:srgbClr val="333333"/>
+                </a:solidFill>
+              </a:rPr>
+              <a:t>   • Rata-rata Profit di Skenario Terbaik (Best 5%): +12%</a:t>
+            </a:r>
+            <a:endParaRPr lang="en-US" sz="1600" dirty="0"/>
+          </a:p>
+          <a:p>
+            <a:pPr indent="0" marL="0">
+              <a:buNone/>
+            </a:pPr>
+            <a:r>
+              <a:rPr lang="en-US" sz="1600" dirty="0">
+                <a:solidFill>
+                  <a:srgbClr val="333333"/>
+                </a:solidFill>
+              </a:rPr>
+              <a:t>   • Rata-rata Loss di Skenario Terburuk (Worst 5%): -8%</a:t>
+            </a:r>
+            <a:endParaRPr lang="en-US" sz="1600" dirty="0"/>
+          </a:p>
+          <a:p>
+            <a:pPr indent="0" marL="0">
+              <a:buNone/>
+            </a:pPr>
+            <a:r>
+              <a:rPr lang="en-US" sz="1600" b="1" dirty="0">
+                <a:solidFill>
+                  <a:srgbClr val="003366"/>
+                </a:solidFill>
+              </a:rPr>
+              <a:t>4. Kalkulasi:</a:t>
+            </a:r>
+            <a:endParaRPr lang="en-US" sz="1600" dirty="0"/>
+          </a:p>
+          <a:p>
+            <a:pPr indent="0" marL="0">
+              <a:buNone/>
+            </a:pPr>
+            <a:r>
+              <a:rPr lang="en-US" sz="1600" dirty="0">
+                <a:solidFill>
+                  <a:srgbClr val="333333"/>
+                </a:solidFill>
+                <a:latin typeface="Courier New" pitchFamily="34" charset="0"/>
+                <a:ea typeface="Courier New" pitchFamily="34" charset="-122"/>
+                <a:cs typeface="Courier New" pitchFamily="34" charset="-120"/>
+              </a:rPr>
+              <a:t>   RR = 12% / 8% = </a:t>
+            </a:r>
+            <a:pPr indent="0" marL="0">
+              <a:buNone/>
+            </a:pPr>
+            <a:r>
+              <a:rPr lang="en-US" sz="1600" b="1" dirty="0">
+                <a:solidFill>
+                  <a:srgbClr val="27AE60"/>
+                </a:solidFill>
+                <a:latin typeface="Courier New" pitchFamily="34" charset="0"/>
+                <a:ea typeface="Courier New" pitchFamily="34" charset="-122"/>
+                <a:cs typeface="Courier New" pitchFamily="34" charset="-120"/>
+              </a:rPr>
+              <a:t>1.50</a:t>
+            </a:r>
+            <a:pPr indent="0" marL="0">
+              <a:buNone/>
+            </a:pPr>
+            <a:r>
+              <a:rPr lang="en-US" sz="1600" b="1" dirty="0">
+                <a:solidFill>
+                  <a:srgbClr val="8E44AD"/>
+                </a:solidFill>
+              </a:rPr>
+              <a:t>Interpretasi:</a:t>
+            </a:r>
+            <a:endParaRPr lang="en-US" sz="1600" dirty="0"/>
+          </a:p>
+          <a:p>
+            <a:pPr indent="0" marL="0">
+              <a:buNone/>
+            </a:pPr>
+            <a:r>
+              <a:rPr lang="en-US" sz="1600" i="1" dirty="0">
+                <a:solidFill>
+                  <a:srgbClr val="333333"/>
+                </a:solidFill>
+              </a:rPr>
+              <a:t>Nilai 1.50 berarti potensi imbal hasil ekstrem 1.5x lebih besar daripada risiko kerugian ekstrem. Angka &gt; 1 menunjukkan portofolio memiliki resiliensi tinggi terhadap 'Black Swan events'.</a:t>
+            </a:r>
+            <a:endParaRPr lang="en-US" sz="1600" dirty="0"/>
+          </a:p>
+        </p:txBody>
+      </p:sp>
+      <p:sp>
+        <p:nvSpPr>
+          <p:cNvPr id="4" name="Text 2">
+            <a:hlinkClick r:id="rId1" tooltip="" action="ppaction://hlinksldjump"/>
+          </p:cNvPr>
+          <p:cNvSpPr/>
+          <p:nvPr/>
+        </p:nvSpPr>
+        <p:spPr>
+          <a:xfrm>
+            <a:off x="7772400" y="4846320"/>
+            <a:ext cx="1097280" cy="0"/>
+          </a:xfrm>
+          <a:prstGeom prst="rect">
+            <a:avLst/>
+          </a:prstGeom>
+          <a:noFill/>
+          <a:ln/>
+        </p:spPr>
+        <p:txBody>
+          <a:bodyPr wrap="square" rtlCol="0" anchor="ctr"/>
+          <a:lstStyle/>
+          <a:p>
+            <a:pPr algn="r" indent="0" marL="0">
+              <a:buNone/>
+            </a:pPr>
+            <a:r>
+              <a:rPr lang="en-US" sz="1000" u="sng" dirty="0">
+                <a:solidFill>
+                  <a:srgbClr val="0563C1"/>
+                </a:solidFill>
+                <a:hlinkClick r:id="rId1" action="ppaction://hlinksldjump" tooltip="">
+                  <a:extLst>
+                    <a:ext uri="{A12FA001-AC4F-418D-AE19-62706E023703}">
+                      <ahyp:hlinkClr xmlns:ahyp="http://schemas.microsoft.com/office/drawing/2018/hyperlinkcolor" val="tx"/>
+                    </a:ext>
+                  </a:extLst>
+                </a:hlinkClick>
+              </a:rPr>
+              <a:t>🏠 Daftar Isi</a:t>
+            </a:r>
+            <a:endParaRPr lang="en-US" sz="1000" dirty="0"/>
+          </a:p>
+        </p:txBody>
+      </p:sp>
+    </p:spTree>
+  </p:cSld>
+  <p:clrMapOvr>
+    <a:masterClrMapping/>
+  </p:clrMapOvr>
+</p:sld>
+</file>
+
+<file path=ppt/slides/slide59.xml><?xml version="1.0" encoding="utf-8"?>
+<p:sld xmlns:a="http://schemas.openxmlformats.org/drawingml/2006/main" xmlns:r="http://schemas.openxmlformats.org/officeDocument/2006/relationships" xmlns:p="http://schemas.openxmlformats.org/presentationml/2006/main">
+  <p:cSld name="Slide 59">
     <p:spTree>
       <p:nvGrpSpPr>
         <p:cNvPr id="1" name=""/>

</xml_diff>

<commit_message>
feat: update Rachev Ratio simulation with bear market scenario
</commit_message>
<xml_diff>
--- a/Presentasi_Proposal_Update.pptx
+++ b/Presentasi_Proposal_Update.pptx
@@ -23286,10 +23286,10 @@
             <a:r>
               <a:rPr lang="en-US" sz="1600" b="1" dirty="0">
                 <a:solidFill>
-                  <a:srgbClr val="333333"/>
-                </a:solidFill>
-              </a:rPr>
-              <a:t>Bagaimana mengukur rasio 'hadiah ekstrem' vs 'risiko ekstrem'?</a:t>
+                  <a:srgbClr val="003366"/>
+                </a:solidFill>
+              </a:rPr>
+              <a:t>1. Konsep Dasar:</a:t>
             </a:r>
             <a:endParaRPr lang="en-US" sz="1600" dirty="0"/>
           </a:p>
@@ -23298,12 +23298,26 @@
               <a:buNone/>
             </a:pPr>
             <a:r>
+              <a:rPr lang="en-US" sz="1600" dirty="0">
+                <a:solidFill>
+                  <a:srgbClr val="333333"/>
+                </a:solidFill>
+              </a:rPr>
+              <a:t>   Rachev Ratio mengukur rasio potensi 'hadiah ekstrem' (Top 5% average) terhadap 'risiko ekstrem' (Bottom 5% average loss).</a:t>
+            </a:r>
+            <a:endParaRPr lang="en-US" sz="1600" dirty="0"/>
+          </a:p>
+          <a:p>
+            <a:pPr indent="0" marL="0">
+              <a:buNone/>
+            </a:pPr>
+            <a:r>
               <a:rPr lang="en-US" sz="1600" b="1" dirty="0">
                 <a:solidFill>
-                  <a:srgbClr val="003366"/>
-                </a:solidFill>
-              </a:rPr>
-              <a:t>1. Konsep Dasar:</a:t>
+                  <a:srgbClr val="27AE60"/>
+                </a:solidFill>
+              </a:rPr>
+              <a:t>2. Skenario A: Normal/Bullish (Menguntungkan):</a:t>
             </a:r>
             <a:endParaRPr lang="en-US" sz="1600" dirty="0"/>
           </a:p>
@@ -23317,7 +23331,7 @@
                   <a:srgbClr val="333333"/>
                 </a:solidFill>
               </a:rPr>
-              <a:t>   Rachev Ratio mengukur keunggulan potensi keuntungan di ekor kanan (Right Tail) dibandingkan potensi kerugian di ekor kiri (Left Tail). Sangat relevan untuk aset kripto yang tidak berdistribusi normal.</a:t>
+              <a:t>   • Avg. Profit (Top 5%): +12% | Avg. Loss (Bottom 5%): -8%</a:t>
             </a:r>
             <a:endParaRPr lang="en-US" sz="1600" dirty="0"/>
           </a:p>
@@ -23326,12 +23340,23 @@
               <a:buNone/>
             </a:pPr>
             <a:r>
+              <a:rPr lang="en-US" sz="1600" dirty="0">
+                <a:solidFill>
+                  <a:srgbClr val="333333"/>
+                </a:solidFill>
+              </a:rPr>
+              <a:t>   • Kalkulasi: 12% / 8% = </a:t>
+            </a:r>
+            <a:pPr indent="0" marL="0">
+              <a:buNone/>
+            </a:pPr>
+            <a:r>
               <a:rPr lang="en-US" sz="1600" b="1" dirty="0">
                 <a:solidFill>
-                  <a:srgbClr val="003366"/>
-                </a:solidFill>
-              </a:rPr>
-              <a:t>2. Rumus Sederhana:</a:t>
+                  <a:srgbClr val="27AE60"/>
+                </a:solidFill>
+              </a:rPr>
+              <a:t>1.50</a:t>
             </a:r>
             <a:endParaRPr lang="en-US" sz="1600" dirty="0"/>
           </a:p>
@@ -23344,11 +23369,8 @@
                 <a:solidFill>
                   <a:srgbClr val="C0392B"/>
                 </a:solidFill>
-                <a:latin typeface="Courier New" pitchFamily="34" charset="0"/>
-                <a:ea typeface="Courier New" pitchFamily="34" charset="-122"/>
-                <a:cs typeface="Courier New" pitchFamily="34" charset="-120"/>
-              </a:rPr>
-              <a:t>   RR = Avg. Profit (Top 5%) / Avg. Loss (Bottom 5%)</a:t>
+              </a:rPr>
+              <a:t>3. Skenario B: Extreme Bear Market (Keduanya Rugi):</a:t>
             </a:r>
             <a:endParaRPr lang="en-US" sz="1600" dirty="0"/>
           </a:p>
@@ -23357,12 +23379,59 @@
               <a:buNone/>
             </a:pPr>
             <a:r>
+              <a:rPr lang="en-US" sz="1200" i="1" dirty="0">
+                <a:solidFill>
+                  <a:srgbClr val="333333"/>
+                </a:solidFill>
+              </a:rPr>
+              <a:t>   • Jika kondisi pasar hancur total, bahkan return terbaik pun bisa negatif.</a:t>
+            </a:r>
+            <a:endParaRPr lang="en-US" sz="1600" dirty="0"/>
+          </a:p>
+          <a:p>
+            <a:pPr indent="0" marL="0">
+              <a:buNone/>
+            </a:pPr>
+            <a:r>
+              <a:rPr lang="en-US" sz="1600" dirty="0">
+                <a:solidFill>
+                  <a:srgbClr val="333333"/>
+                </a:solidFill>
+              </a:rPr>
+              <a:t>   • Avg. Return (Top 5%): </a:t>
+            </a:r>
+            <a:pPr indent="0" marL="0">
+              <a:buNone/>
+            </a:pPr>
+            <a:r>
               <a:rPr lang="en-US" sz="1600" b="1" dirty="0">
                 <a:solidFill>
-                  <a:srgbClr val="003366"/>
-                </a:solidFill>
-              </a:rPr>
-              <a:t>3. Simulasi Angka (Dummy):</a:t>
+                  <a:srgbClr val="333333"/>
+                </a:solidFill>
+              </a:rPr>
+              <a:t>-2% (Rugi)</a:t>
+            </a:r>
+            <a:pPr indent="0" marL="0">
+              <a:buNone/>
+            </a:pPr>
+            <a:r>
+              <a:rPr lang="en-US" sz="1600" dirty="0">
+                <a:solidFill>
+                  <a:srgbClr val="333333"/>
+                </a:solidFill>
+              </a:rPr>
+              <a:t> | Avg. Loss (Bottom 5%): </a:t>
+            </a:r>
+            <a:pPr indent="0" marL="0">
+              <a:buNone/>
+            </a:pPr>
+            <a:r>
+              <a:rPr lang="en-US" sz="1600" b="1" dirty="0">
+                <a:solidFill>
+                  <a:srgbClr val="333333"/>
+                </a:solidFill>
+              </a:rPr>
+              <a:t>-12% (Rugi)</a:t>
             </a:r>
             <a:endParaRPr lang="en-US" sz="1600" dirty="0"/>
           </a:p>
@@ -23376,7 +23445,18 @@
                   <a:srgbClr val="333333"/>
                 </a:solidFill>
               </a:rPr>
-              <a:t>   • Rata-rata Profit di Skenario Terbaik (Best 5%): +12%</a:t>
+              <a:t>   • Kalkulasi: -2% / 12% = </a:t>
+            </a:r>
+            <a:pPr indent="0" marL="0">
+              <a:buNone/>
+            </a:pPr>
+            <a:r>
+              <a:rPr lang="en-US" sz="1600" b="1" dirty="0">
+                <a:solidFill>
+                  <a:srgbClr val="C0392B"/>
+                </a:solidFill>
+              </a:rPr>
+              <a:t>-0.16</a:t>
             </a:r>
             <a:endParaRPr lang="en-US" sz="1600" dirty="0"/>
           </a:p>
@@ -23385,12 +23465,12 @@
               <a:buNone/>
             </a:pPr>
             <a:r>
-              <a:rPr lang="en-US" sz="1600" dirty="0">
-                <a:solidFill>
-                  <a:srgbClr val="333333"/>
-                </a:solidFill>
-              </a:rPr>
-              <a:t>   • Rata-rata Loss di Skenario Terburuk (Worst 5%): -8%</a:t>
+              <a:rPr lang="en-US" sz="1600" b="1" dirty="0">
+                <a:solidFill>
+                  <a:srgbClr val="8E44AD"/>
+                </a:solidFill>
+              </a:rPr>
+              <a:t>Interpretasi:</a:t>
             </a:r>
             <a:endParaRPr lang="en-US" sz="1600" dirty="0"/>
           </a:p>
@@ -23399,68 +23479,12 @@
               <a:buNone/>
             </a:pPr>
             <a:r>
-              <a:rPr lang="en-US" sz="1600" b="1" dirty="0">
-                <a:solidFill>
-                  <a:srgbClr val="003366"/>
-                </a:solidFill>
-              </a:rPr>
-              <a:t>4. Kalkulasi:</a:t>
-            </a:r>
-            <a:endParaRPr lang="en-US" sz="1600" dirty="0"/>
-          </a:p>
-          <a:p>
-            <a:pPr indent="0" marL="0">
-              <a:buNone/>
-            </a:pPr>
-            <a:r>
-              <a:rPr lang="en-US" sz="1600" dirty="0">
-                <a:solidFill>
-                  <a:srgbClr val="333333"/>
-                </a:solidFill>
-                <a:latin typeface="Courier New" pitchFamily="34" charset="0"/>
-                <a:ea typeface="Courier New" pitchFamily="34" charset="-122"/>
-                <a:cs typeface="Courier New" pitchFamily="34" charset="-120"/>
-              </a:rPr>
-              <a:t>   RR = 12% / 8% = </a:t>
-            </a:r>
-            <a:pPr indent="0" marL="0">
-              <a:buNone/>
-            </a:pPr>
-            <a:r>
-              <a:rPr lang="en-US" sz="1600" b="1" dirty="0">
-                <a:solidFill>
-                  <a:srgbClr val="27AE60"/>
-                </a:solidFill>
-                <a:latin typeface="Courier New" pitchFamily="34" charset="0"/>
-                <a:ea typeface="Courier New" pitchFamily="34" charset="-122"/>
-                <a:cs typeface="Courier New" pitchFamily="34" charset="-120"/>
-              </a:rPr>
-              <a:t>1.50</a:t>
-            </a:r>
-            <a:pPr indent="0" marL="0">
-              <a:buNone/>
-            </a:pPr>
-            <a:r>
-              <a:rPr lang="en-US" sz="1600" b="1" dirty="0">
-                <a:solidFill>
-                  <a:srgbClr val="8E44AD"/>
-                </a:solidFill>
-              </a:rPr>
-              <a:t>Interpretasi:</a:t>
-            </a:r>
-            <a:endParaRPr lang="en-US" sz="1600" dirty="0"/>
-          </a:p>
-          <a:p>
-            <a:pPr indent="0" marL="0">
-              <a:buNone/>
-            </a:pPr>
-            <a:r>
               <a:rPr lang="en-US" sz="1600" i="1" dirty="0">
                 <a:solidFill>
                   <a:srgbClr val="333333"/>
                 </a:solidFill>
               </a:rPr>
-              <a:t>Nilai 1.50 berarti potensi imbal hasil ekstrem 1.5x lebih besar daripada risiko kerugian ekstrem. Angka &gt; 1 menunjukkan portofolio memiliki resiliensi tinggi terhadap 'Black Swan events'.</a:t>
+              <a:t>Nilai negatif (Skenario B) menunjukkan strategi gagal total memberikan profit. Sebaliknya, nilai &gt; 1 (Skenario A) menunjukkan portofolio memiliki potensi pemulihan yang jauh lebih besar daripada risiko kejatuhannya.</a:t>
             </a:r>
             <a:endParaRPr lang="en-US" sz="1600" dirty="0"/>
           </a:p>

</xml_diff>

<commit_message>
feat: propose Bayesian Optimization in NW Adaptive slide
</commit_message>
<xml_diff>
--- a/Presentasi_Proposal_Update.pptx
+++ b/Presentasi_Proposal_Update.pptx
@@ -7964,7 +7964,7 @@
                   <a:srgbClr val="003366"/>
                 </a:solidFill>
               </a:rPr>
-              <a:t>Mekanisme Optimasi Dinamis:</a:t>
+              <a:t>Optimasi Bayesian Simultan:</a:t>
             </a:r>
             <a:endParaRPr lang="en-US" sz="2000" dirty="0"/>
           </a:p>
@@ -7978,7 +7978,7 @@
                   <a:srgbClr val="333333"/>
                 </a:solidFill>
               </a:rPr>
-              <a:t>❑ Rolling Window: 30, 60, 90, 120 hari.</a:t>
+              <a:t>❑ Tuning cerdas pasangan (W, γ) secara bersamaan (bukan brute-force).</a:t>
             </a:r>
             <a:endParaRPr lang="en-US" sz="2000" dirty="0"/>
           </a:p>
@@ -7992,7 +7992,7 @@
                   <a:srgbClr val="333333"/>
                 </a:solidFill>
               </a:rPr>
-              <a:t>❑ Rebalancing: Setiap 7 hari.</a:t>
+              <a:t>❑ Parameter 1: Window (W) [20 - 120 hari].</a:t>
             </a:r>
             <a:endParaRPr lang="en-US" sz="2000" dirty="0"/>
           </a:p>
@@ -8006,7 +8006,7 @@
                   <a:srgbClr val="333333"/>
                 </a:solidFill>
               </a:rPr>
-              <a:t>❑ Transaction Cost: 0.1% (10 basis points).</a:t>
+              <a:t>❑ Parameter 2: Gamma (γ) [0.0 - 2.0].</a:t>
             </a:r>
             <a:endParaRPr lang="en-US" sz="2000" dirty="0"/>
           </a:p>
@@ -8015,12 +8015,12 @@
               <a:buNone/>
             </a:pPr>
             <a:r>
-              <a:rPr lang="en-US" sz="2000" dirty="0">
-                <a:solidFill>
-                  <a:srgbClr val="333333"/>
-                </a:solidFill>
-              </a:rPr>
-              <a:t>❑ Grid Search γ: Rentang [0.0 - 2.0].</a:t>
+              <a:rPr lang="en-US" sz="1800" dirty="0">
+                <a:solidFill>
+                  <a:srgbClr val="333333"/>
+                </a:solidFill>
+              </a:rPr>
+              <a:t>❑ Jauh lebih cepat &amp; efisien dibanding Grid Search tradisional.</a:t>
             </a:r>
             <a:endParaRPr lang="en-US" sz="2000" dirty="0"/>
           </a:p>
@@ -8056,7 +8056,7 @@
                   <a:srgbClr val="003366"/>
                 </a:solidFill>
               </a:rPr>
-              <a:t>Split Validasi Internal (80/20):</a:t>
+              <a:t>Efisiensi &amp; Interaksi Parameter:</a:t>
             </a:r>
             <a:endParaRPr lang="en-US" sz="2000" dirty="0"/>
           </a:p>
@@ -8070,7 +8070,7 @@
                   <a:srgbClr val="333333"/>
                 </a:solidFill>
               </a:rPr>
-              <a:t>❑ Training: Estimasi bobot gamma.</a:t>
+              <a:t>❑ Akurasi: Menemukan 'sweet spot' hubungan antara panjang window vs tingkat penalti.</a:t>
             </a:r>
             <a:endParaRPr lang="en-US" sz="2000" dirty="0"/>
           </a:p>
@@ -8084,7 +8084,7 @@
                   <a:srgbClr val="333333"/>
                 </a:solidFill>
               </a:rPr>
-              <a:t>❑ Validation: Seleksi performa optimal.</a:t>
+              <a:t>❑ Fleksibilitas: Menangani data campuran (Integer Window &amp; Float Gamma).</a:t>
             </a:r>
             <a:endParaRPr lang="en-US" sz="2000" dirty="0"/>
           </a:p>
@@ -8098,7 +8098,7 @@
                   <a:srgbClr val="333333"/>
                 </a:solidFill>
               </a:rPr>
-              <a:t>❑ Fallback: Menggunakan strategi EW (Equally Weighted).</a:t>
+              <a:t>❑ Kecepatan: Menghemat waktu komputasi hingga &gt;70%.</a:t>
             </a:r>
             <a:endParaRPr lang="en-US" sz="2000" dirty="0"/>
           </a:p>
@@ -8109,10 +8109,10 @@
             <a:r>
               <a:rPr lang="en-US" sz="2000" dirty="0">
                 <a:solidFill>
-                  <a:srgbClr val="333333"/>
-                </a:solidFill>
-              </a:rPr>
-              <a:t>❑ Tujuan: Adaptasi rezim pasar.</a:t>
+                  <a:srgbClr val="E67E22"/>
+                </a:solidFill>
+              </a:rPr>
+              <a:t>❑ Tujuan: Adaptasi presisi terhadap rezim pasar kripto yang volatil.</a:t>
             </a:r>
             <a:endParaRPr lang="en-US" sz="2000" dirty="0"/>
           </a:p>

</xml_diff>

<commit_message>
feat: updated TOC 1 and generated new PPT
</commit_message>
<xml_diff>
--- a/Presentasi_Proposal_Update.pptx
+++ b/Presentasi_Proposal_Update.pptx
@@ -9720,20 +9720,6 @@
               <a:buNone/>
             </a:pPr>
             <a:r>
-              <a:rPr lang="en-US" sz="1800" b="1" dirty="0">
-                <a:solidFill>
-                  <a:srgbClr val="003366"/>
-                </a:solidFill>
-              </a:rPr>
-              <a:t>II. STRATEGI PORTOFOLIO</a:t>
-            </a:r>
-            <a:endParaRPr lang="en-US" sz="1800" dirty="0"/>
-          </a:p>
-          <a:p>
-            <a:pPr indent="0" marL="0">
-              <a:buNone/>
-            </a:pPr>
-            <a:r>
               <a:rPr lang="en-US" sz="1800" dirty="0">
                 <a:solidFill>
                   <a:srgbClr val="333333"/>
@@ -9757,7 +9743,7 @@
                   </a:extLst>
                 </a:hlinkClick>
               </a:rPr>
-              <a:t>Equally Weighted (EW)</a:t>
+              <a:t>Penelitian Terdahulu</a:t>
             </a:r>
             <a:pPr indent="0" marL="0">
               <a:buNone/>
@@ -9792,7 +9778,7 @@
                   </a:extLst>
                 </a:hlinkClick>
               </a:rPr>
-              <a:t>Classical Markowitz (CM)</a:t>
+              <a:t>Kerangka Pemikiran</a:t>
             </a:r>
             <a:pPr indent="0" marL="0">
               <a:buNone/>
@@ -9827,6 +9813,125 @@
                   </a:extLst>
                 </a:hlinkClick>
               </a:rPr>
+              <a:t>Dataset Penelitian</a:t>
+            </a:r>
+            <a:pPr indent="0" marL="0">
+              <a:buNone/>
+            </a:pPr>
+            <a:endParaRPr lang="en-US" sz="1800" dirty="0"/>
+          </a:p>
+          <a:p>
+            <a:pPr indent="0" marL="0">
+              <a:buNone/>
+            </a:pPr>
+            <a:r>
+              <a:rPr lang="en-US" sz="1800" b="1" dirty="0">
+                <a:solidFill>
+                  <a:srgbClr val="003366"/>
+                </a:solidFill>
+              </a:rPr>
+              <a:t>II. STRATEGI PORTOFOLIO</a:t>
+            </a:r>
+            <a:endParaRPr lang="en-US" sz="1800" dirty="0"/>
+          </a:p>
+          <a:p>
+            <a:pPr indent="0" marL="0">
+              <a:buNone/>
+            </a:pPr>
+            <a:r>
+              <a:rPr lang="en-US" sz="1800" dirty="0">
+                <a:solidFill>
+                  <a:srgbClr val="333333"/>
+                </a:solidFill>
+              </a:rPr>
+              <a:t>   • </a:t>
+            </a:r>
+            <a:pPr indent="0" marL="0">
+              <a:buNone/>
+            </a:pPr>
+            <a:r>
+              <a:rPr lang="en-US" sz="1600" u="sng" dirty="0">
+                <a:solidFill>
+                  <a:srgbClr val="333333"/>
+                </a:solidFill>
+                <a:hlinkClick r:id="rId7" action="ppaction://hlinksldjump" tooltip="">
+                  <a:extLst>
+                    <a:ext uri="{A12FA001-AC4F-418D-AE19-62706E023703}">
+                      <ahyp:hlinkClr xmlns:ahyp="http://schemas.microsoft.com/office/drawing/2018/hyperlinkcolor" val="tx"/>
+                    </a:ext>
+                  </a:extLst>
+                </a:hlinkClick>
+              </a:rPr>
+              <a:t>Equally Weighted (EW)</a:t>
+            </a:r>
+            <a:pPr indent="0" marL="0">
+              <a:buNone/>
+            </a:pPr>
+            <a:endParaRPr lang="en-US" sz="1800" dirty="0"/>
+          </a:p>
+          <a:p>
+            <a:pPr indent="0" marL="0">
+              <a:buNone/>
+            </a:pPr>
+            <a:r>
+              <a:rPr lang="en-US" sz="1800" dirty="0">
+                <a:solidFill>
+                  <a:srgbClr val="333333"/>
+                </a:solidFill>
+              </a:rPr>
+              <a:t>   • </a:t>
+            </a:r>
+            <a:pPr indent="0" marL="0">
+              <a:buNone/>
+            </a:pPr>
+            <a:r>
+              <a:rPr lang="en-US" sz="1600" u="sng" dirty="0">
+                <a:solidFill>
+                  <a:srgbClr val="333333"/>
+                </a:solidFill>
+                <a:hlinkClick r:id="rId8" action="ppaction://hlinksldjump" tooltip="">
+                  <a:extLst>
+                    <a:ext uri="{A12FA001-AC4F-418D-AE19-62706E023703}">
+                      <ahyp:hlinkClr xmlns:ahyp="http://schemas.microsoft.com/office/drawing/2018/hyperlinkcolor" val="tx"/>
+                    </a:ext>
+                  </a:extLst>
+                </a:hlinkClick>
+              </a:rPr>
+              <a:t>Classical Markowitz (CM)</a:t>
+            </a:r>
+            <a:pPr indent="0" marL="0">
+              <a:buNone/>
+            </a:pPr>
+            <a:endParaRPr lang="en-US" sz="1800" dirty="0"/>
+          </a:p>
+          <a:p>
+            <a:pPr indent="0" marL="0">
+              <a:buNone/>
+            </a:pPr>
+            <a:r>
+              <a:rPr lang="en-US" sz="1800" dirty="0">
+                <a:solidFill>
+                  <a:srgbClr val="333333"/>
+                </a:solidFill>
+              </a:rPr>
+              <a:t>   • </a:t>
+            </a:r>
+            <a:pPr indent="0" marL="0">
+              <a:buNone/>
+            </a:pPr>
+            <a:r>
+              <a:rPr lang="en-US" sz="1600" u="sng" dirty="0">
+                <a:solidFill>
+                  <a:srgbClr val="333333"/>
+                </a:solidFill>
+                <a:hlinkClick r:id="rId9" action="ppaction://hlinksldjump" tooltip="">
+                  <a:extLst>
+                    <a:ext uri="{A12FA001-AC4F-418D-AE19-62706E023703}">
+                      <ahyp:hlinkClr xmlns:ahyp="http://schemas.microsoft.com/office/drawing/2018/hyperlinkcolor" val="tx"/>
+                    </a:ext>
+                  </a:extLst>
+                </a:hlinkClick>
+              </a:rPr>
               <a:t>Graphical Lasso (GM)</a:t>
             </a:r>
             <a:pPr indent="0" marL="0">
@@ -9854,7 +9959,7 @@
                 <a:solidFill>
                   <a:srgbClr val="333333"/>
                 </a:solidFill>
-                <a:hlinkClick r:id="rId7" action="ppaction://hlinksldjump" tooltip="">
+                <a:hlinkClick r:id="rId10" action="ppaction://hlinksldjump" tooltip="">
                   <a:extLst>
                     <a:ext uri="{A12FA001-AC4F-418D-AE19-62706E023703}">
                       <ahyp:hlinkClr xmlns:ahyp="http://schemas.microsoft.com/office/drawing/2018/hyperlinkcolor" val="tx"/>
@@ -9922,7 +10027,7 @@
                 <a:solidFill>
                   <a:srgbClr val="333333"/>
                 </a:solidFill>
-                <a:hlinkClick r:id="rId8" action="ppaction://hlinksldjump" tooltip="">
+                <a:hlinkClick r:id="rId11" action="ppaction://hlinksldjump" tooltip="">
                   <a:extLst>
                     <a:ext uri="{A12FA001-AC4F-418D-AE19-62706E023703}">
                       <ahyp:hlinkClr xmlns:ahyp="http://schemas.microsoft.com/office/drawing/2018/hyperlinkcolor" val="tx"/>
@@ -9971,7 +10076,7 @@
                 <a:solidFill>
                   <a:srgbClr val="D35400"/>
                 </a:solidFill>
-                <a:hlinkClick r:id="rId9" action="ppaction://hlinksldjump" tooltip="">
+                <a:hlinkClick r:id="rId12" action="ppaction://hlinksldjump" tooltip="">
                   <a:extLst>
                     <a:ext uri="{A12FA001-AC4F-418D-AE19-62706E023703}">
                       <ahyp:hlinkClr xmlns:ahyp="http://schemas.microsoft.com/office/drawing/2018/hyperlinkcolor" val="tx"/>

</xml_diff>

<commit_message>
feat: add dataset period and observation details to Slide 9
</commit_message>
<xml_diff>
--- a/Presentasi_Proposal_Update.pptx
+++ b/Presentasi_Proposal_Update.pptx
@@ -27138,7 +27138,76 @@
       </p:graphicFrame>
       <p:sp>
         <p:nvSpPr>
-          <p:cNvPr id="4" name="Text 1">
+          <p:cNvPr id="4" name="Text 1"/>
+          <p:cNvSpPr/>
+          <p:nvPr/>
+        </p:nvSpPr>
+        <p:spPr>
+          <a:xfrm>
+            <a:off x="457200" y="4663440"/>
+            <a:ext cx="7315200" cy="0"/>
+          </a:xfrm>
+          <a:prstGeom prst="rect">
+            <a:avLst/>
+          </a:prstGeom>
+          <a:noFill/>
+          <a:ln/>
+        </p:spPr>
+        <p:txBody>
+          <a:bodyPr wrap="square" rtlCol="0" anchor="ctr"/>
+          <a:lstStyle/>
+          <a:p>
+            <a:pPr indent="0" marL="0">
+              <a:buNone/>
+            </a:pPr>
+            <a:r>
+              <a:rPr lang="en-US" sz="1300" b="1" dirty="0">
+                <a:solidFill>
+                  <a:srgbClr val="003366"/>
+                </a:solidFill>
+              </a:rPr>
+              <a:t>Periode: </a:t>
+            </a:r>
+            <a:pPr indent="0" marL="0">
+              <a:buNone/>
+            </a:pPr>
+            <a:r>
+              <a:rPr lang="en-US" sz="1300" dirty="0">
+                <a:solidFill>
+                  <a:srgbClr val="333333"/>
+                </a:solidFill>
+              </a:rPr>
+              <a:t>14 Sept 2017 - 17 Okt 2019 </a:t>
+            </a:r>
+            <a:pPr indent="0" marL="0">
+              <a:buNone/>
+            </a:pPr>
+            <a:r>
+              <a:rPr lang="en-US" sz="1300" b="1" dirty="0">
+                <a:solidFill>
+                  <a:srgbClr val="003366"/>
+                </a:solidFill>
+              </a:rPr>
+              <a:t>| Total: </a:t>
+            </a:r>
+            <a:pPr indent="0" marL="0">
+              <a:buNone/>
+            </a:pPr>
+            <a:r>
+              <a:rPr lang="en-US" sz="1300" dirty="0">
+                <a:solidFill>
+                  <a:srgbClr val="333333"/>
+                </a:solidFill>
+              </a:rPr>
+              <a:t>764 observasi harian</a:t>
+            </a:r>
+            <a:endParaRPr lang="en-US" sz="1300" dirty="0"/>
+          </a:p>
+        </p:txBody>
+      </p:sp>
+      <p:sp>
+        <p:nvSpPr>
+          <p:cNvPr id="5" name="Text 2">
             <a:hlinkClick r:id="rId1" tooltip="" action="ppaction://hlinksldjump"/>
           </p:cNvPr>
           <p:cNvSpPr/>

</xml_diff>

<commit_message>
fix: adjust layout on dataset slide to avoid overlapping
</commit_message>
<xml_diff>
--- a/Presentasi_Proposal_Update.pptx
+++ b/Presentasi_Proposal_Update.pptx
@@ -25175,7 +25175,7 @@
           </p:nvPr>
         </p:nvGraphicFramePr>
         <p:xfrm>
-          <a:off x="457200" y="1005840"/>
+          <a:off x="457200" y="822960"/>
           <a:ext cx="8229600" cy="914400"/>
         </p:xfrm>
         <a:graphic>
@@ -25197,14 +25197,14 @@
                         <a:buNone/>
                       </a:pPr>
                       <a:r>
-                        <a:rPr lang="en-US" sz="1600" b="1" dirty="0">
+                        <a:rPr lang="en-US" sz="1400" b="1" dirty="0">
                           <a:solidFill>
                             <a:srgbClr val="FFFFFF"/>
                           </a:solidFill>
                         </a:rPr>
                         <a:t>Ticker</a:t>
                       </a:r>
-                      <a:endParaRPr lang="en-US" sz="1600" dirty="0"/>
+                      <a:endParaRPr lang="en-US" sz="1400" dirty="0"/>
                     </a:p>
                   </a:txBody>
                   <a:tcPr marL="91440" marR="91440" marT="45720" marB="45720">
@@ -25258,14 +25258,14 @@
                         <a:buNone/>
                       </a:pPr>
                       <a:r>
-                        <a:rPr lang="en-US" sz="1600" b="1" dirty="0">
+                        <a:rPr lang="en-US" sz="1400" b="1" dirty="0">
                           <a:solidFill>
                             <a:srgbClr val="FFFFFF"/>
                           </a:solidFill>
                         </a:rPr>
                         <a:t>Nama Aset</a:t>
                       </a:r>
-                      <a:endParaRPr lang="en-US" sz="1600" dirty="0"/>
+                      <a:endParaRPr lang="en-US" sz="1400" dirty="0"/>
                     </a:p>
                   </a:txBody>
                   <a:tcPr marL="91440" marR="91440" marT="45720" marB="45720">
@@ -25319,14 +25319,14 @@
                         <a:buNone/>
                       </a:pPr>
                       <a:r>
-                        <a:rPr lang="en-US" sz="1600" b="1" dirty="0">
+                        <a:rPr lang="en-US" sz="1400" b="1" dirty="0">
                           <a:solidFill>
                             <a:srgbClr val="FFFFFF"/>
                           </a:solidFill>
                         </a:rPr>
                         <a:t>Kategori / Use Case</a:t>
                       </a:r>
-                      <a:endParaRPr lang="en-US" sz="1600" dirty="0"/>
+                      <a:endParaRPr lang="en-US" sz="1400" dirty="0"/>
                     </a:p>
                   </a:txBody>
                   <a:tcPr marL="91440" marR="91440" marT="45720" marB="45720">
@@ -25382,14 +25382,14 @@
                         <a:buNone/>
                       </a:pPr>
                       <a:r>
-                        <a:rPr lang="en-US" sz="1600" dirty="0">
+                        <a:rPr lang="en-US" sz="1400" dirty="0">
                           <a:solidFill>
                             <a:srgbClr val="333333"/>
                           </a:solidFill>
                         </a:rPr>
                         <a:t>BTC</a:t>
                       </a:r>
-                      <a:endParaRPr lang="en-US" sz="1600" dirty="0"/>
+                      <a:endParaRPr lang="en-US" sz="1400" dirty="0"/>
                     </a:p>
                   </a:txBody>
                   <a:tcPr marL="91440" marR="91440" marT="45720" marB="45720">
@@ -25440,14 +25440,14 @@
                         <a:buNone/>
                       </a:pPr>
                       <a:r>
-                        <a:rPr lang="en-US" sz="1600" dirty="0">
+                        <a:rPr lang="en-US" sz="1400" dirty="0">
                           <a:solidFill>
                             <a:srgbClr val="333333"/>
                           </a:solidFill>
                         </a:rPr>
                         <a:t>Bitcoin</a:t>
                       </a:r>
-                      <a:endParaRPr lang="en-US" sz="1600" dirty="0"/>
+                      <a:endParaRPr lang="en-US" sz="1400" dirty="0"/>
                     </a:p>
                   </a:txBody>
                   <a:tcPr marL="91440" marR="91440" marT="45720" marB="45720">
@@ -25498,14 +25498,14 @@
                         <a:buNone/>
                       </a:pPr>
                       <a:r>
-                        <a:rPr lang="en-US" sz="1600" dirty="0">
+                        <a:rPr lang="en-US" sz="1400" dirty="0">
                           <a:solidFill>
                             <a:srgbClr val="333333"/>
                           </a:solidFill>
                         </a:rPr>
                         <a:t>Layer 1 / Store of Value</a:t>
                       </a:r>
-                      <a:endParaRPr lang="en-US" sz="1600" dirty="0"/>
+                      <a:endParaRPr lang="en-US" sz="1400" dirty="0"/>
                     </a:p>
                   </a:txBody>
                   <a:tcPr marL="91440" marR="91440" marT="45720" marB="45720">
@@ -25558,14 +25558,14 @@
                         <a:buNone/>
                       </a:pPr>
                       <a:r>
-                        <a:rPr lang="en-US" sz="1600" dirty="0">
+                        <a:rPr lang="en-US" sz="1400" dirty="0">
                           <a:solidFill>
                             <a:srgbClr val="333333"/>
                           </a:solidFill>
                         </a:rPr>
                         <a:t>ETH</a:t>
                       </a:r>
-                      <a:endParaRPr lang="en-US" sz="1600" dirty="0"/>
+                      <a:endParaRPr lang="en-US" sz="1400" dirty="0"/>
                     </a:p>
                   </a:txBody>
                   <a:tcPr marL="91440" marR="91440" marT="45720" marB="45720">
@@ -25616,14 +25616,14 @@
                         <a:buNone/>
                       </a:pPr>
                       <a:r>
-                        <a:rPr lang="en-US" sz="1600" dirty="0">
+                        <a:rPr lang="en-US" sz="1400" dirty="0">
                           <a:solidFill>
                             <a:srgbClr val="333333"/>
                           </a:solidFill>
                         </a:rPr>
                         <a:t>Ethereum</a:t>
                       </a:r>
-                      <a:endParaRPr lang="en-US" sz="1600" dirty="0"/>
+                      <a:endParaRPr lang="en-US" sz="1400" dirty="0"/>
                     </a:p>
                   </a:txBody>
                   <a:tcPr marL="91440" marR="91440" marT="45720" marB="45720">
@@ -25674,14 +25674,14 @@
                         <a:buNone/>
                       </a:pPr>
                       <a:r>
-                        <a:rPr lang="en-US" sz="1600" dirty="0">
+                        <a:rPr lang="en-US" sz="1400" dirty="0">
                           <a:solidFill>
                             <a:srgbClr val="333333"/>
                           </a:solidFill>
                         </a:rPr>
                         <a:t>Layer 1 / Smart Contract</a:t>
                       </a:r>
-                      <a:endParaRPr lang="en-US" sz="1600" dirty="0"/>
+                      <a:endParaRPr lang="en-US" sz="1400" dirty="0"/>
                     </a:p>
                   </a:txBody>
                   <a:tcPr marL="91440" marR="91440" marT="45720" marB="45720">
@@ -25734,14 +25734,14 @@
                         <a:buNone/>
                       </a:pPr>
                       <a:r>
-                        <a:rPr lang="en-US" sz="1600" dirty="0">
+                        <a:rPr lang="en-US" sz="1400" dirty="0">
                           <a:solidFill>
                             <a:srgbClr val="333333"/>
                           </a:solidFill>
                         </a:rPr>
                         <a:t>XRP</a:t>
                       </a:r>
-                      <a:endParaRPr lang="en-US" sz="1600" dirty="0"/>
+                      <a:endParaRPr lang="en-US" sz="1400" dirty="0"/>
                     </a:p>
                   </a:txBody>
                   <a:tcPr marL="91440" marR="91440" marT="45720" marB="45720">
@@ -25792,14 +25792,14 @@
                         <a:buNone/>
                       </a:pPr>
                       <a:r>
-                        <a:rPr lang="en-US" sz="1600" dirty="0">
+                        <a:rPr lang="en-US" sz="1400" dirty="0">
                           <a:solidFill>
                             <a:srgbClr val="333333"/>
                           </a:solidFill>
                         </a:rPr>
                         <a:t>Ripple</a:t>
                       </a:r>
-                      <a:endParaRPr lang="en-US" sz="1600" dirty="0"/>
+                      <a:endParaRPr lang="en-US" sz="1400" dirty="0"/>
                     </a:p>
                   </a:txBody>
                   <a:tcPr marL="91440" marR="91440" marT="45720" marB="45720">
@@ -25850,14 +25850,14 @@
                         <a:buNone/>
                       </a:pPr>
                       <a:r>
-                        <a:rPr lang="en-US" sz="1600" dirty="0">
+                        <a:rPr lang="en-US" sz="1400" dirty="0">
                           <a:solidFill>
                             <a:srgbClr val="333333"/>
                           </a:solidFill>
                         </a:rPr>
                         <a:t>Payment / Bridge Currency</a:t>
                       </a:r>
-                      <a:endParaRPr lang="en-US" sz="1600" dirty="0"/>
+                      <a:endParaRPr lang="en-US" sz="1400" dirty="0"/>
                     </a:p>
                   </a:txBody>
                   <a:tcPr marL="91440" marR="91440" marT="45720" marB="45720">
@@ -25910,14 +25910,14 @@
                         <a:buNone/>
                       </a:pPr>
                       <a:r>
-                        <a:rPr lang="en-US" sz="1600" dirty="0">
+                        <a:rPr lang="en-US" sz="1400" dirty="0">
                           <a:solidFill>
                             <a:srgbClr val="333333"/>
                           </a:solidFill>
                         </a:rPr>
                         <a:t>USDT</a:t>
                       </a:r>
-                      <a:endParaRPr lang="en-US" sz="1600" dirty="0"/>
+                      <a:endParaRPr lang="en-US" sz="1400" dirty="0"/>
                     </a:p>
                   </a:txBody>
                   <a:tcPr marL="91440" marR="91440" marT="45720" marB="45720">
@@ -25968,14 +25968,14 @@
                         <a:buNone/>
                       </a:pPr>
                       <a:r>
-                        <a:rPr lang="en-US" sz="1600" dirty="0">
+                        <a:rPr lang="en-US" sz="1400" dirty="0">
                           <a:solidFill>
                             <a:srgbClr val="333333"/>
                           </a:solidFill>
                         </a:rPr>
                         <a:t>Tether</a:t>
                       </a:r>
-                      <a:endParaRPr lang="en-US" sz="1600" dirty="0"/>
+                      <a:endParaRPr lang="en-US" sz="1400" dirty="0"/>
                     </a:p>
                   </a:txBody>
                   <a:tcPr marL="91440" marR="91440" marT="45720" marB="45720">
@@ -26026,14 +26026,14 @@
                         <a:buNone/>
                       </a:pPr>
                       <a:r>
-                        <a:rPr lang="en-US" sz="1600" dirty="0">
+                        <a:rPr lang="en-US" sz="1400" dirty="0">
                           <a:solidFill>
                             <a:srgbClr val="333333"/>
                           </a:solidFill>
                         </a:rPr>
                         <a:t>Stablecoin / USD Pegged</a:t>
                       </a:r>
-                      <a:endParaRPr lang="en-US" sz="1600" dirty="0"/>
+                      <a:endParaRPr lang="en-US" sz="1400" dirty="0"/>
                     </a:p>
                   </a:txBody>
                   <a:tcPr marL="91440" marR="91440" marT="45720" marB="45720">
@@ -26086,14 +26086,14 @@
                         <a:buNone/>
                       </a:pPr>
                       <a:r>
-                        <a:rPr lang="en-US" sz="1600" dirty="0">
+                        <a:rPr lang="en-US" sz="1400" dirty="0">
                           <a:solidFill>
                             <a:srgbClr val="333333"/>
                           </a:solidFill>
                         </a:rPr>
                         <a:t>BCH</a:t>
                       </a:r>
-                      <a:endParaRPr lang="en-US" sz="1600" dirty="0"/>
+                      <a:endParaRPr lang="en-US" sz="1400" dirty="0"/>
                     </a:p>
                   </a:txBody>
                   <a:tcPr marL="91440" marR="91440" marT="45720" marB="45720">
@@ -26144,14 +26144,14 @@
                         <a:buNone/>
                       </a:pPr>
                       <a:r>
-                        <a:rPr lang="en-US" sz="1600" dirty="0">
+                        <a:rPr lang="en-US" sz="1400" dirty="0">
                           <a:solidFill>
                             <a:srgbClr val="333333"/>
                           </a:solidFill>
                         </a:rPr>
                         <a:t>Bitcoin Cash</a:t>
                       </a:r>
-                      <a:endParaRPr lang="en-US" sz="1600" dirty="0"/>
+                      <a:endParaRPr lang="en-US" sz="1400" dirty="0"/>
                     </a:p>
                   </a:txBody>
                   <a:tcPr marL="91440" marR="91440" marT="45720" marB="45720">
@@ -26202,14 +26202,14 @@
                         <a:buNone/>
                       </a:pPr>
                       <a:r>
-                        <a:rPr lang="en-US" sz="1600" dirty="0">
+                        <a:rPr lang="en-US" sz="1400" dirty="0">
                           <a:solidFill>
                             <a:srgbClr val="333333"/>
                           </a:solidFill>
                         </a:rPr>
                         <a:t>Payment / Peer-to-Peer Cash</a:t>
                       </a:r>
-                      <a:endParaRPr lang="en-US" sz="1600" dirty="0"/>
+                      <a:endParaRPr lang="en-US" sz="1400" dirty="0"/>
                     </a:p>
                   </a:txBody>
                   <a:tcPr marL="91440" marR="91440" marT="45720" marB="45720">
@@ -26262,14 +26262,14 @@
                         <a:buNone/>
                       </a:pPr>
                       <a:r>
-                        <a:rPr lang="en-US" sz="1600" dirty="0">
+                        <a:rPr lang="en-US" sz="1400" dirty="0">
                           <a:solidFill>
                             <a:srgbClr val="333333"/>
                           </a:solidFill>
                         </a:rPr>
                         <a:t>LTC</a:t>
                       </a:r>
-                      <a:endParaRPr lang="en-US" sz="1600" dirty="0"/>
+                      <a:endParaRPr lang="en-US" sz="1400" dirty="0"/>
                     </a:p>
                   </a:txBody>
                   <a:tcPr marL="91440" marR="91440" marT="45720" marB="45720">
@@ -26320,14 +26320,14 @@
                         <a:buNone/>
                       </a:pPr>
                       <a:r>
-                        <a:rPr lang="en-US" sz="1600" dirty="0">
+                        <a:rPr lang="en-US" sz="1400" dirty="0">
                           <a:solidFill>
                             <a:srgbClr val="333333"/>
                           </a:solidFill>
                         </a:rPr>
                         <a:t>Litecoin</a:t>
                       </a:r>
-                      <a:endParaRPr lang="en-US" sz="1600" dirty="0"/>
+                      <a:endParaRPr lang="en-US" sz="1400" dirty="0"/>
                     </a:p>
                   </a:txBody>
                   <a:tcPr marL="91440" marR="91440" marT="45720" marB="45720">
@@ -26378,14 +26378,14 @@
                         <a:buNone/>
                       </a:pPr>
                       <a:r>
-                        <a:rPr lang="en-US" sz="1600" dirty="0">
+                        <a:rPr lang="en-US" sz="1400" dirty="0">
                           <a:solidFill>
                             <a:srgbClr val="333333"/>
                           </a:solidFill>
                         </a:rPr>
                         <a:t>Payment / Digital Silver</a:t>
                       </a:r>
-                      <a:endParaRPr lang="en-US" sz="1600" dirty="0"/>
+                      <a:endParaRPr lang="en-US" sz="1400" dirty="0"/>
                     </a:p>
                   </a:txBody>
                   <a:tcPr marL="91440" marR="91440" marT="45720" marB="45720">
@@ -26438,14 +26438,14 @@
                         <a:buNone/>
                       </a:pPr>
                       <a:r>
-                        <a:rPr lang="en-US" sz="1600" dirty="0">
+                        <a:rPr lang="en-US" sz="1400" dirty="0">
                           <a:solidFill>
                             <a:srgbClr val="333333"/>
                           </a:solidFill>
                         </a:rPr>
                         <a:t>BNB</a:t>
                       </a:r>
-                      <a:endParaRPr lang="en-US" sz="1600" dirty="0"/>
+                      <a:endParaRPr lang="en-US" sz="1400" dirty="0"/>
                     </a:p>
                   </a:txBody>
                   <a:tcPr marL="91440" marR="91440" marT="45720" marB="45720">
@@ -26496,14 +26496,14 @@
                         <a:buNone/>
                       </a:pPr>
                       <a:r>
-                        <a:rPr lang="en-US" sz="1600" dirty="0">
+                        <a:rPr lang="en-US" sz="1400" dirty="0">
                           <a:solidFill>
                             <a:srgbClr val="333333"/>
                           </a:solidFill>
                         </a:rPr>
                         <a:t>Binance Coin</a:t>
                       </a:r>
-                      <a:endParaRPr lang="en-US" sz="1600" dirty="0"/>
+                      <a:endParaRPr lang="en-US" sz="1400" dirty="0"/>
                     </a:p>
                   </a:txBody>
                   <a:tcPr marL="91440" marR="91440" marT="45720" marB="45720">
@@ -26554,14 +26554,14 @@
                         <a:buNone/>
                       </a:pPr>
                       <a:r>
-                        <a:rPr lang="en-US" sz="1600" dirty="0">
+                        <a:rPr lang="en-US" sz="1400" dirty="0">
                           <a:solidFill>
                             <a:srgbClr val="333333"/>
                           </a:solidFill>
                         </a:rPr>
                         <a:t>Layer 1 / Exchange Token</a:t>
                       </a:r>
-                      <a:endParaRPr lang="en-US" sz="1600" dirty="0"/>
+                      <a:endParaRPr lang="en-US" sz="1400" dirty="0"/>
                     </a:p>
                   </a:txBody>
                   <a:tcPr marL="91440" marR="91440" marT="45720" marB="45720">
@@ -26614,14 +26614,14 @@
                         <a:buNone/>
                       </a:pPr>
                       <a:r>
-                        <a:rPr lang="en-US" sz="1600" dirty="0">
+                        <a:rPr lang="en-US" sz="1400" dirty="0">
                           <a:solidFill>
                             <a:srgbClr val="333333"/>
                           </a:solidFill>
                         </a:rPr>
                         <a:t>EOS</a:t>
                       </a:r>
-                      <a:endParaRPr lang="en-US" sz="1600" dirty="0"/>
+                      <a:endParaRPr lang="en-US" sz="1400" dirty="0"/>
                     </a:p>
                   </a:txBody>
                   <a:tcPr marL="91440" marR="91440" marT="45720" marB="45720">
@@ -26672,14 +26672,14 @@
                         <a:buNone/>
                       </a:pPr>
                       <a:r>
-                        <a:rPr lang="en-US" sz="1600" dirty="0">
+                        <a:rPr lang="en-US" sz="1400" dirty="0">
                           <a:solidFill>
                             <a:srgbClr val="333333"/>
                           </a:solidFill>
                         </a:rPr>
                         <a:t>EOS</a:t>
                       </a:r>
-                      <a:endParaRPr lang="en-US" sz="1600" dirty="0"/>
+                      <a:endParaRPr lang="en-US" sz="1400" dirty="0"/>
                     </a:p>
                   </a:txBody>
                   <a:tcPr marL="91440" marR="91440" marT="45720" marB="45720">
@@ -26730,14 +26730,14 @@
                         <a:buNone/>
                       </a:pPr>
                       <a:r>
-                        <a:rPr lang="en-US" sz="1600" dirty="0">
+                        <a:rPr lang="en-US" sz="1400" dirty="0">
                           <a:solidFill>
                             <a:srgbClr val="333333"/>
                           </a:solidFill>
                         </a:rPr>
                         <a:t>Layer 1 / Smart Contract</a:t>
                       </a:r>
-                      <a:endParaRPr lang="en-US" sz="1600" dirty="0"/>
+                      <a:endParaRPr lang="en-US" sz="1400" dirty="0"/>
                     </a:p>
                   </a:txBody>
                   <a:tcPr marL="91440" marR="91440" marT="45720" marB="45720">
@@ -26790,14 +26790,14 @@
                         <a:buNone/>
                       </a:pPr>
                       <a:r>
-                        <a:rPr lang="en-US" sz="1600" dirty="0">
+                        <a:rPr lang="en-US" sz="1400" dirty="0">
                           <a:solidFill>
                             <a:srgbClr val="333333"/>
                           </a:solidFill>
                         </a:rPr>
                         <a:t>XLM</a:t>
                       </a:r>
-                      <a:endParaRPr lang="en-US" sz="1600" dirty="0"/>
+                      <a:endParaRPr lang="en-US" sz="1400" dirty="0"/>
                     </a:p>
                   </a:txBody>
                   <a:tcPr marL="91440" marR="91440" marT="45720" marB="45720">
@@ -26848,14 +26848,14 @@
                         <a:buNone/>
                       </a:pPr>
                       <a:r>
-                        <a:rPr lang="en-US" sz="1600" dirty="0">
+                        <a:rPr lang="en-US" sz="1400" dirty="0">
                           <a:solidFill>
                             <a:srgbClr val="333333"/>
                           </a:solidFill>
                         </a:rPr>
                         <a:t>Stellar</a:t>
                       </a:r>
-                      <a:endParaRPr lang="en-US" sz="1600" dirty="0"/>
+                      <a:endParaRPr lang="en-US" sz="1400" dirty="0"/>
                     </a:p>
                   </a:txBody>
                   <a:tcPr marL="91440" marR="91440" marT="45720" marB="45720">
@@ -26906,14 +26906,14 @@
                         <a:buNone/>
                       </a:pPr>
                       <a:r>
-                        <a:rPr lang="en-US" sz="1600" dirty="0">
+                        <a:rPr lang="en-US" sz="1400" dirty="0">
                           <a:solidFill>
                             <a:srgbClr val="333333"/>
                           </a:solidFill>
                         </a:rPr>
                         <a:t>Payment / Bridge Currency</a:t>
                       </a:r>
-                      <a:endParaRPr lang="en-US" sz="1600" dirty="0"/>
+                      <a:endParaRPr lang="en-US" sz="1400" dirty="0"/>
                     </a:p>
                   </a:txBody>
                   <a:tcPr marL="91440" marR="91440" marT="45720" marB="45720">
@@ -26966,14 +26966,14 @@
                         <a:buNone/>
                       </a:pPr>
                       <a:r>
-                        <a:rPr lang="en-US" sz="1600" dirty="0">
+                        <a:rPr lang="en-US" sz="1400" dirty="0">
                           <a:solidFill>
                             <a:srgbClr val="333333"/>
                           </a:solidFill>
                         </a:rPr>
                         <a:t>TRX</a:t>
                       </a:r>
-                      <a:endParaRPr lang="en-US" sz="1600" dirty="0"/>
+                      <a:endParaRPr lang="en-US" sz="1400" dirty="0"/>
                     </a:p>
                   </a:txBody>
                   <a:tcPr marL="91440" marR="91440" marT="45720" marB="45720">
@@ -27024,14 +27024,14 @@
                         <a:buNone/>
                       </a:pPr>
                       <a:r>
-                        <a:rPr lang="en-US" sz="1600" dirty="0">
+                        <a:rPr lang="en-US" sz="1400" dirty="0">
                           <a:solidFill>
                             <a:srgbClr val="333333"/>
                           </a:solidFill>
                         </a:rPr>
                         <a:t>Tron</a:t>
                       </a:r>
-                      <a:endParaRPr lang="en-US" sz="1600" dirty="0"/>
+                      <a:endParaRPr lang="en-US" sz="1400" dirty="0"/>
                     </a:p>
                   </a:txBody>
                   <a:tcPr marL="91440" marR="91440" marT="45720" marB="45720">
@@ -27082,14 +27082,14 @@
                         <a:buNone/>
                       </a:pPr>
                       <a:r>
-                        <a:rPr lang="en-US" sz="1600" dirty="0">
+                        <a:rPr lang="en-US" sz="1400" dirty="0">
                           <a:solidFill>
                             <a:srgbClr val="333333"/>
                           </a:solidFill>
                         </a:rPr>
                         <a:t>Layer 1 / Smart Contract</a:t>
                       </a:r>
-                      <a:endParaRPr lang="en-US" sz="1600" dirty="0"/>
+                      <a:endParaRPr lang="en-US" sz="1400" dirty="0"/>
                     </a:p>
                   </a:txBody>
                   <a:tcPr marL="91440" marR="91440" marT="45720" marB="45720">
@@ -27161,18 +27161,18 @@
               <a:buNone/>
             </a:pPr>
             <a:r>
-              <a:rPr lang="en-US" sz="1300" b="1" dirty="0">
+              <a:rPr lang="en-US" sz="1200" b="1" dirty="0">
                 <a:solidFill>
                   <a:srgbClr val="003366"/>
                 </a:solidFill>
               </a:rPr>
-              <a:t>Periode: </a:t>
-            </a:r>
-            <a:pPr indent="0" marL="0">
-              <a:buNone/>
-            </a:pPr>
-            <a:r>
-              <a:rPr lang="en-US" sz="1300" dirty="0">
+              <a:t>Statistik Dataset: </a:t>
+            </a:r>
+            <a:pPr indent="0" marL="0">
+              <a:buNone/>
+            </a:pPr>
+            <a:r>
+              <a:rPr lang="en-US" sz="1200" dirty="0">
                 <a:solidFill>
                   <a:srgbClr val="333333"/>
                 </a:solidFill>
@@ -27183,7 +27183,7 @@
               <a:buNone/>
             </a:pPr>
             <a:r>
-              <a:rPr lang="en-US" sz="1300" b="1" dirty="0">
+              <a:rPr lang="en-US" sz="1200" b="1" dirty="0">
                 <a:solidFill>
                   <a:srgbClr val="003366"/>
                 </a:solidFill>
@@ -27194,14 +27194,14 @@
               <a:buNone/>
             </a:pPr>
             <a:r>
-              <a:rPr lang="en-US" sz="1300" dirty="0">
+              <a:rPr lang="en-US" sz="1200" dirty="0">
                 <a:solidFill>
                   <a:srgbClr val="333333"/>
                 </a:solidFill>
               </a:rPr>
               <a:t>764 observasi harian</a:t>
             </a:r>
-            <a:endParaRPr lang="en-US" sz="1300" dirty="0"/>
+            <a:endParaRPr lang="en-US" sz="1200" dirty="0"/>
           </a:p>
         </p:txBody>
       </p:sp>

</xml_diff>

<commit_message>
feat: add NW Statis to TOC 1 and generate new PPT
</commit_message>
<xml_diff>
--- a/Presentasi_Proposal_Update.pptx
+++ b/Presentasi_Proposal_Update.pptx
@@ -9967,6 +9967,41 @@
                   </a:extLst>
                 </a:hlinkClick>
               </a:rPr>
+              <a:t>Network Markowitz (Statis)</a:t>
+            </a:r>
+            <a:pPr indent="0" marL="0">
+              <a:buNone/>
+            </a:pPr>
+            <a:endParaRPr lang="en-US" sz="1800" dirty="0"/>
+          </a:p>
+          <a:p>
+            <a:pPr indent="0" marL="0">
+              <a:buNone/>
+            </a:pPr>
+            <a:r>
+              <a:rPr lang="en-US" sz="1800" dirty="0">
+                <a:solidFill>
+                  <a:srgbClr val="333333"/>
+                </a:solidFill>
+              </a:rPr>
+              <a:t>   • </a:t>
+            </a:r>
+            <a:pPr indent="0" marL="0">
+              <a:buNone/>
+            </a:pPr>
+            <a:r>
+              <a:rPr lang="en-US" sz="1600" u="sng" dirty="0">
+                <a:solidFill>
+                  <a:srgbClr val="333333"/>
+                </a:solidFill>
+                <a:hlinkClick r:id="rId11" action="ppaction://hlinksldjump" tooltip="">
+                  <a:extLst>
+                    <a:ext uri="{A12FA001-AC4F-418D-AE19-62706E023703}">
+                      <ahyp:hlinkClr xmlns:ahyp="http://schemas.microsoft.com/office/drawing/2018/hyperlinkcolor" val="tx"/>
+                    </a:ext>
+                  </a:extLst>
+                </a:hlinkClick>
+              </a:rPr>
               <a:t>Network Markowitz (Adaptif)</a:t>
             </a:r>
             <a:endParaRPr lang="en-US" sz="1800" dirty="0"/>
@@ -10027,7 +10062,7 @@
                 <a:solidFill>
                   <a:srgbClr val="333333"/>
                 </a:solidFill>
-                <a:hlinkClick r:id="rId11" action="ppaction://hlinksldjump" tooltip="">
+                <a:hlinkClick r:id="rId12" action="ppaction://hlinksldjump" tooltip="">
                   <a:extLst>
                     <a:ext uri="{A12FA001-AC4F-418D-AE19-62706E023703}">
                       <ahyp:hlinkClr xmlns:ahyp="http://schemas.microsoft.com/office/drawing/2018/hyperlinkcolor" val="tx"/>
@@ -10076,7 +10111,7 @@
                 <a:solidFill>
                   <a:srgbClr val="D35400"/>
                 </a:solidFill>
-                <a:hlinkClick r:id="rId12" action="ppaction://hlinksldjump" tooltip="">
+                <a:hlinkClick r:id="rId13" action="ppaction://hlinksldjump" tooltip="">
                   <a:extLst>
                     <a:ext uri="{A12FA001-AC4F-418D-AE19-62706E023703}">
                       <ahyp:hlinkClr xmlns:ahyp="http://schemas.microsoft.com/office/drawing/2018/hyperlinkcolor" val="tx"/>

</xml_diff>

<commit_message>
feat: add End (Thank You) slide to TOC
</commit_message>
<xml_diff>
--- a/Presentasi_Proposal_Update.pptx
+++ b/Presentasi_Proposal_Update.pptx
@@ -10213,6 +10213,41 @@
                 </a:hlinkClick>
               </a:rPr>
               <a:t>LAMPIRAN TEKNIS (APPENDIX)</a:t>
+            </a:r>
+            <a:pPr indent="0" marL="0">
+              <a:buNone/>
+            </a:pPr>
+            <a:endParaRPr lang="en-US" sz="1800" dirty="0"/>
+          </a:p>
+          <a:p>
+            <a:pPr indent="0" marL="0">
+              <a:buNone/>
+            </a:pPr>
+            <a:r>
+              <a:rPr lang="en-US" sz="1800" dirty="0">
+                <a:solidFill>
+                  <a:srgbClr val="333333"/>
+                </a:solidFill>
+              </a:rPr>
+              <a:t>   ➤ </a:t>
+            </a:r>
+            <a:pPr indent="0" marL="0">
+              <a:buNone/>
+            </a:pPr>
+            <a:r>
+              <a:rPr lang="en-US" sz="1600" b="1" u="sng" dirty="0">
+                <a:solidFill>
+                  <a:srgbClr val="003366"/>
+                </a:solidFill>
+                <a:hlinkClick r:id="rId15" action="ppaction://hlinksldjump" tooltip="">
+                  <a:extLst>
+                    <a:ext uri="{A12FA001-AC4F-418D-AE19-62706E023703}">
+                      <ahyp:hlinkClr xmlns:ahyp="http://schemas.microsoft.com/office/drawing/2018/hyperlinkcolor" val="tx"/>
+                    </a:ext>
+                  </a:extLst>
+                </a:hlinkClick>
+              </a:rPr>
+              <a:t>END (TERIMA KASIH)</a:t>
             </a:r>
             <a:endParaRPr lang="en-US" sz="1800" dirty="0"/>
           </a:p>

</xml_diff>

<commit_message>
fix: calibrate TOC slide indices based on actual slide sequence
</commit_message>
<xml_diff>
--- a/Presentasi_Proposal_Update.pptx
+++ b/Presentasi_Proposal_Update.pptx
@@ -13565,7 +13565,7 @@
                   </a:extLst>
                 </a:hlinkClick>
               </a:rPr>
-              <a:t>Simulasi Cumulative P&amp;L</a:t>
+              <a:t>Random Matrix Theory (RMT)</a:t>
             </a:r>
             <a:pPr indent="0" marL="0">
               <a:buNone/>
@@ -13594,7 +13594,7 @@
                   </a:extLst>
                 </a:hlinkClick>
               </a:rPr>
-              <a:t>Random Matrix Theory (RMT)</a:t>
+              <a:t>Minimum Spanning Tree (MST)</a:t>
             </a:r>
             <a:pPr indent="0" marL="0">
               <a:buNone/>
@@ -13623,7 +13623,7 @@
                   </a:extLst>
                 </a:hlinkClick>
               </a:rPr>
-              <a:t>Minimum Spanning Tree (MST)</a:t>
+              <a:t>Penalty &amp; Centrality Logic</a:t>
             </a:r>
             <a:pPr indent="0" marL="0">
               <a:buNone/>
@@ -13652,7 +13652,7 @@
                   </a:extLst>
                 </a:hlinkClick>
               </a:rPr>
-              <a:t>Penalty &amp; Centrality Logic</a:t>
+              <a:t>Justifikasi Parameter Gamma</a:t>
             </a:r>
             <a:pPr indent="0" marL="0">
               <a:buNone/>
@@ -13681,7 +13681,7 @@
                   </a:extLst>
                 </a:hlinkClick>
               </a:rPr>
-              <a:t>Justifikasi Parameter Gamma</a:t>
+              <a:t>Simulasi 60/40 Weight Shift</a:t>
             </a:r>
             <a:pPr indent="0" marL="0">
               <a:buNone/>
@@ -13710,7 +13710,7 @@
                   </a:extLst>
                 </a:hlinkClick>
               </a:rPr>
-              <a:t>Simulasi 60/40 Weight Shift</a:t>
+              <a:t>Simulasi 2-Stage Grid Search</a:t>
             </a:r>
             <a:pPr indent="0" marL="0">
               <a:buNone/>
@@ -13739,7 +13739,7 @@
                   </a:extLst>
                 </a:hlinkClick>
               </a:rPr>
-              <a:t>Simulasi 2-Stage Grid Search</a:t>
+              <a:t>Justifikasi Rolling Window</a:t>
             </a:r>
             <a:pPr indent="0" marL="0">
               <a:buNone/>
@@ -13768,7 +13768,7 @@
                   </a:extLst>
                 </a:hlinkClick>
               </a:rPr>
-              <a:t>Justifikasi Rolling Window</a:t>
+              <a:t>Simulasi Cumulative P&amp;L</a:t>
             </a:r>
             <a:pPr indent="0" marL="0">
               <a:buNone/>
@@ -13797,7 +13797,7 @@
                   </a:extLst>
                 </a:hlinkClick>
               </a:rPr>
-              <a:t>Simulasi Cumulative P&amp;L</a:t>
+              <a:t>Simulasi Value at Risk (VaR)</a:t>
             </a:r>
             <a:pPr indent="0" marL="0">
               <a:buNone/>
@@ -13826,7 +13826,7 @@
                   </a:extLst>
                 </a:hlinkClick>
               </a:rPr>
-              <a:t>Simulasi Value at Risk (VaR)</a:t>
+              <a:t>Simulasi Sharpe Ratio</a:t>
             </a:r>
             <a:pPr indent="0" marL="0">
               <a:buNone/>
@@ -13855,35 +13855,6 @@
                   </a:extLst>
                 </a:hlinkClick>
               </a:rPr>
-              <a:t>Simulasi Sharpe Ratio</a:t>
-            </a:r>
-            <a:pPr indent="0" marL="0">
-              <a:buNone/>
-            </a:pPr>
-            <a:r>
-              <a:rPr lang="en-US" sz="1600" dirty="0">
-                <a:solidFill>
-                  <a:srgbClr val="333333"/>
-                </a:solidFill>
-              </a:rPr>
-              <a:t>   • </a:t>
-            </a:r>
-            <a:pPr indent="0" marL="0">
-              <a:buNone/>
-            </a:pPr>
-            <a:r>
-              <a:rPr lang="en-US" sz="1600" u="sng" dirty="0">
-                <a:solidFill>
-                  <a:srgbClr val="333333"/>
-                </a:solidFill>
-                <a:hlinkClick r:id="rId16" action="ppaction://hlinksldjump" tooltip="">
-                  <a:extLst>
-                    <a:ext uri="{A12FA001-AC4F-418D-AE19-62706E023703}">
-                      <ahyp:hlinkClr xmlns:ahyp="http://schemas.microsoft.com/office/drawing/2018/hyperlinkcolor" val="tx"/>
-                    </a:ext>
-                  </a:extLst>
-                </a:hlinkClick>
-              </a:rPr>
               <a:t>Simulasi Rachev Ratio</a:t>
             </a:r>
             <a:endParaRPr lang="en-US" sz="1600" dirty="0"/>
@@ -13893,7 +13864,7 @@
       <p:sp>
         <p:nvSpPr>
           <p:cNvPr id="4" name="Text 2">
-            <a:hlinkClick r:id="rId17" tooltip="" action="ppaction://hlinksldjump"/>
+            <a:hlinkClick r:id="rId16" tooltip="" action="ppaction://hlinksldjump"/>
           </p:cNvPr>
           <p:cNvSpPr/>
           <p:nvPr/>
@@ -13921,7 +13892,7 @@
                 <a:solidFill>
                   <a:srgbClr val="7F8C8D"/>
                 </a:solidFill>
-                <a:hlinkClick r:id="rId17" action="ppaction://hlinksldjump" tooltip="">
+                <a:hlinkClick r:id="rId16" action="ppaction://hlinksldjump" tooltip="">
                   <a:extLst>
                     <a:ext uri="{A12FA001-AC4F-418D-AE19-62706E023703}">
                       <ahyp:hlinkClr xmlns:ahyp="http://schemas.microsoft.com/office/drawing/2018/hyperlinkcolor" val="tx"/>

</xml_diff>

<commit_message>
feat: add detailed 2-stage grid search explanation slide
</commit_message>
<xml_diff>
--- a/Presentasi_Proposal_Update.pptx
+++ b/Presentasi_Proposal_Update.pptx
@@ -20623,7 +20623,7 @@
                   <a:srgbClr val="003366"/>
                 </a:solidFill>
               </a:rPr>
-              <a:t>Lampiran: Contoh Sederhana Rolling Window Grid Search</a:t>
+              <a:t>Lampiran: Mekanisme 2-Stage Grid Search (Coarse-to-Fine)</a:t>
             </a:r>
             <a:endParaRPr lang="en-US" sz="2400" dirty="0"/>
           </a:p>
@@ -20659,7 +20659,7 @@
                   <a:srgbClr val="333333"/>
                 </a:solidFill>
               </a:rPr>
-              <a:t>Tujuan: Memilih 'Hukuman' (Gamma) terbaik secara otomatis untuk kondisi pasar saat ini.</a:t>
+              <a:t>Tujuan: Menemukan kombinasi (Window, γ) paling presisi dengan efisiensi tinggi.</a:t>
             </a:r>
             <a:endParaRPr lang="en-US" sz="1600" dirty="0"/>
           </a:p>
@@ -20673,7 +20673,7 @@
                   <a:srgbClr val="003366"/>
                 </a:solidFill>
               </a:rPr>
-              <a:t>1. Siapkan Kandidat (The Grid):</a:t>
+              <a:t>1. Stage 1: Coarse Search (Pemindaian Makro)</a:t>
             </a:r>
             <a:endParaRPr lang="en-US" sz="1600" dirty="0"/>
           </a:p>
@@ -20687,7 +20687,7 @@
                   <a:srgbClr val="333333"/>
                 </a:solidFill>
               </a:rPr>
-              <a:t>   Komputer mencoba 3 nilai: γ=0.0 (Tanpa Penalti), γ=0.5 (Sedang), γ=1.0 (Keras).</a:t>
+              <a:t>   ❑ Mencari kandidat di seluruh ruang parameter dengan langkah (step) lebar.</a:t>
             </a:r>
             <a:endParaRPr lang="en-US" sz="1600" dirty="0"/>
           </a:p>
@@ -20696,12 +20696,40 @@
               <a:buNone/>
             </a:pPr>
             <a:r>
+              <a:rPr lang="en-US" sz="1600" dirty="0">
+                <a:solidFill>
+                  <a:srgbClr val="333333"/>
+                </a:solidFill>
+              </a:rPr>
+              <a:t>   ❑ Contoh: Window dipantau setiap kelipatan 5 hari, dan Gamma setiap 0.2 unit.</a:t>
+            </a:r>
+            <a:endParaRPr lang="en-US" sz="1600" dirty="0"/>
+          </a:p>
+          <a:p>
+            <a:pPr indent="0" marL="0">
+              <a:buNone/>
+            </a:pPr>
+            <a:r>
+              <a:rPr lang="en-US" sz="1600" dirty="0">
+                <a:solidFill>
+                  <a:srgbClr val="333333"/>
+                </a:solidFill>
+              </a:rPr>
+              <a:t>   ❑ Output: Menentukan 'zona potensial' terbaik secara cepat.</a:t>
+            </a:r>
+            <a:endParaRPr lang="en-US" sz="1600" dirty="0"/>
+          </a:p>
+          <a:p>
+            <a:pPr indent="0" marL="0">
+              <a:buNone/>
+            </a:pPr>
+            <a:r>
               <a:rPr lang="en-US" sz="1600" b="1" dirty="0">
                 <a:solidFill>
                   <a:srgbClr val="003366"/>
                 </a:solidFill>
               </a:rPr>
-              <a:t>2. Simulasi Masa Lalu (Lookback Window):</a:t>
+              <a:t>2. Stage 2: Fine Search (Zoom-in Mikro)</a:t>
             </a:r>
             <a:endParaRPr lang="en-US" sz="1600" dirty="0"/>
           </a:p>
@@ -20715,7 +20743,7 @@
                   <a:srgbClr val="333333"/>
                 </a:solidFill>
               </a:rPr>
-              <a:t>   Maju ke belakang 30 hari, lalu hitung performa jika kita memakai nilai tersebut:</a:t>
+              <a:t>   ❑ Melakukan pencarian mendalam hanya di sekitar koordinat terbaik Stage 1.</a:t>
             </a:r>
             <a:endParaRPr lang="en-US" sz="1600" dirty="0"/>
           </a:p>
@@ -20729,7 +20757,7 @@
                   <a:srgbClr val="333333"/>
                 </a:solidFill>
               </a:rPr>
-              <a:t>   • Jika pakai γ=0.0 → Sharpe Ratio: 0.85</a:t>
+              <a:t>   ❑ Contoh: Jika koordinat terbaik Stage 1 adalah (W:40, γ:0.6), Stage 2 mencari di rentang presisi (W: 36-44) dan (γ: 0.55-0.65).</a:t>
             </a:r>
             <a:endParaRPr lang="en-US" sz="1600" dirty="0"/>
           </a:p>
@@ -20738,12 +20766,26 @@
               <a:buNone/>
             </a:pPr>
             <a:r>
+              <a:rPr lang="en-US" sz="1600" dirty="0">
+                <a:solidFill>
+                  <a:srgbClr val="333333"/>
+                </a:solidFill>
+              </a:rPr>
+              <a:t>   ❑ Output: Mendapatkan titik absolut paling optimal.</a:t>
+            </a:r>
+            <a:endParaRPr lang="en-US" sz="1600" dirty="0"/>
+          </a:p>
+          <a:p>
+            <a:pPr indent="0" marL="0">
+              <a:buNone/>
+            </a:pPr>
+            <a:r>
               <a:rPr lang="en-US" sz="1600" b="1" dirty="0">
                 <a:solidFill>
-                  <a:srgbClr val="27AE60"/>
-                </a:solidFill>
-              </a:rPr>
-              <a:t>   • Jika pakai γ=0.5 → Sharpe Ratio: 1.10 (TERBAIK)</a:t>
+                  <a:srgbClr val="8E44AD"/>
+                </a:solidFill>
+              </a:rPr>
+              <a:t>Keunggulan Eksperimen:</a:t>
             </a:r>
             <a:endParaRPr lang="en-US" sz="1600" dirty="0"/>
           </a:p>
@@ -20757,7 +20799,7 @@
                   <a:srgbClr val="333333"/>
                 </a:solidFill>
               </a:rPr>
-              <a:t>   • Jika pakai γ=1.0 → Sharpe Ratio: 0.95</a:t>
+              <a:t>✔ Akurasi: Jauh lebih detail dibanding grid search tunggal konvensional.</a:t>
             </a:r>
             <a:endParaRPr lang="en-US" sz="1600" dirty="0"/>
           </a:p>
@@ -20766,12 +20808,12 @@
               <a:buNone/>
             </a:pPr>
             <a:r>
-              <a:rPr lang="en-US" sz="1600" b="1" dirty="0">
-                <a:solidFill>
-                  <a:srgbClr val="003366"/>
-                </a:solidFill>
-              </a:rPr>
-              <a:t>3. Penentuan Pemenang (The Best Gamma):</a:t>
+              <a:rPr lang="en-US" sz="1600" dirty="0">
+                <a:solidFill>
+                  <a:srgbClr val="333333"/>
+                </a:solidFill>
+              </a:rPr>
+              <a:t>✔ Efisiensi: Mengurangi total percobaan komputasi hingga &gt;60% dibanding brute-force.</a:t>
             </a:r>
             <a:endParaRPr lang="en-US" sz="1600" dirty="0"/>
           </a:p>
@@ -20780,68 +20822,12 @@
               <a:buNone/>
             </a:pPr>
             <a:r>
-              <a:rPr lang="en-US" sz="1600" dirty="0">
-                <a:solidFill>
-                  <a:srgbClr val="333333"/>
-                </a:solidFill>
-              </a:rPr>
-              <a:t>   Karena γ=0.5 menghasilkan efisiensi terbaik di 30 hari terakhir, ia terpilih sebagai pemenang.</a:t>
-            </a:r>
-            <a:endParaRPr lang="en-US" sz="1600" dirty="0"/>
-          </a:p>
-          <a:p>
-            <a:pPr indent="0" marL="0">
-              <a:buNone/>
-            </a:pPr>
-            <a:r>
-              <a:rPr lang="en-US" sz="1600" b="1" dirty="0">
-                <a:solidFill>
-                  <a:srgbClr val="003366"/>
-                </a:solidFill>
-              </a:rPr>
-              <a:t>4. Penerapan (Actual Trade):</a:t>
-            </a:r>
-            <a:endParaRPr lang="en-US" sz="1600" dirty="0"/>
-          </a:p>
-          <a:p>
-            <a:pPr indent="0" marL="0">
-              <a:buNone/>
-            </a:pPr>
-            <a:r>
-              <a:rPr lang="en-US" sz="1600" dirty="0">
-                <a:solidFill>
-                  <a:srgbClr val="333333"/>
-                </a:solidFill>
-              </a:rPr>
-              <a:t>   Gunakan γ=0.5 untuk menghitung bobot portofolio asli di minggu depan.</a:t>
-            </a:r>
-            <a:endParaRPr lang="en-US" sz="1600" dirty="0"/>
-          </a:p>
-          <a:p>
-            <a:pPr indent="0" marL="0">
-              <a:buNone/>
-            </a:pPr>
-            <a:r>
-              <a:rPr lang="en-US" sz="1600" b="1" dirty="0">
-                <a:solidFill>
-                  <a:srgbClr val="8E44AD"/>
-                </a:solidFill>
-              </a:rPr>
-              <a:t>Kesimpulan Adaptif:</a:t>
-            </a:r>
-            <a:endParaRPr lang="en-US" sz="1600" dirty="0"/>
-          </a:p>
-          <a:p>
-            <a:pPr indent="0" marL="0">
-              <a:buNone/>
-            </a:pPr>
-            <a:r>
               <a:rPr lang="en-US" sz="1600" i="1" dirty="0">
                 <a:solidFill>
                   <a:srgbClr val="333333"/>
                 </a:solidFill>
               </a:rPr>
-              <a:t>Minggu depan, proses ini diulang kembali. Jika pasar berubah kacau, mungkin γ=1.0 yang akan menang. Inilah cara model menyesuaikan diri tanpa campur tangan manusia.</a:t>
+              <a:t>✔ Multi-Target: Parameter disesuaikan spesifik untuk target VAR, Sharpe, atau Rachev.</a:t>
             </a:r>
             <a:endParaRPr lang="en-US" sz="1600" dirty="0"/>
           </a:p>

</xml_diff>

<commit_message>
feat: add direct hyperlinks from metric overview to appendix simulations
</commit_message>
<xml_diff>
--- a/Presentasi_Proposal_Update.pptx
+++ b/Presentasi_Proposal_Update.pptx
@@ -8365,10 +8365,17 @@
               <a:buNone/>
             </a:pPr>
             <a:r>
-              <a:rPr lang="en-US" sz="1700" b="1" dirty="0">
+              <a:rPr lang="en-US" sz="1700" b="1" u="sng" dirty="0">
                 <a:solidFill>
                   <a:srgbClr val="003366"/>
                 </a:solidFill>
+                <a:hlinkClick r:id="rId1" action="ppaction://hlinksldjump" tooltip="">
+                  <a:extLst>
+                    <a:ext uri="{A12FA001-AC4F-418D-AE19-62706E023703}">
+                      <ahyp:hlinkClr xmlns:ahyp="http://schemas.microsoft.com/office/drawing/2018/hyperlinkcolor" val="tx"/>
+                    </a:ext>
+                  </a:extLst>
+                </a:hlinkClick>
               </a:rPr>
               <a:t>1. Cumulative Profits &amp; Losses (P&amp;L):</a:t>
             </a:r>
@@ -8393,10 +8400,17 @@
               <a:buNone/>
             </a:pPr>
             <a:r>
-              <a:rPr lang="en-US" sz="1700" b="1" dirty="0">
+              <a:rPr lang="en-US" sz="1700" b="1" u="sng" dirty="0">
                 <a:solidFill>
                   <a:srgbClr val="C0392B"/>
                 </a:solidFill>
+                <a:hlinkClick r:id="rId2" action="ppaction://hlinksldjump" tooltip="">
+                  <a:extLst>
+                    <a:ext uri="{A12FA001-AC4F-418D-AE19-62706E023703}">
+                      <ahyp:hlinkClr xmlns:ahyp="http://schemas.microsoft.com/office/drawing/2018/hyperlinkcolor" val="tx"/>
+                    </a:ext>
+                  </a:extLst>
+                </a:hlinkClick>
               </a:rPr>
               <a:t>2. Value at Risk (VaR 95%):</a:t>
             </a:r>
@@ -8421,10 +8435,17 @@
               <a:buNone/>
             </a:pPr>
             <a:r>
-              <a:rPr lang="en-US" sz="1700" b="1" dirty="0">
+              <a:rPr lang="en-US" sz="1700" b="1" u="sng" dirty="0">
                 <a:solidFill>
                   <a:srgbClr val="27AE60"/>
                 </a:solidFill>
+                <a:hlinkClick r:id="rId3" action="ppaction://hlinksldjump" tooltip="">
+                  <a:extLst>
+                    <a:ext uri="{A12FA001-AC4F-418D-AE19-62706E023703}">
+                      <ahyp:hlinkClr xmlns:ahyp="http://schemas.microsoft.com/office/drawing/2018/hyperlinkcolor" val="tx"/>
+                    </a:ext>
+                  </a:extLst>
+                </a:hlinkClick>
               </a:rPr>
               <a:t>3. Sharpe Ratio (SR):</a:t>
             </a:r>
@@ -8449,10 +8470,17 @@
               <a:buNone/>
             </a:pPr>
             <a:r>
-              <a:rPr lang="en-US" sz="1700" b="1" dirty="0">
+              <a:rPr lang="en-US" sz="1700" b="1" u="sng" dirty="0">
                 <a:solidFill>
                   <a:srgbClr val="8E44AD"/>
                 </a:solidFill>
+                <a:hlinkClick r:id="rId4" action="ppaction://hlinksldjump" tooltip="">
+                  <a:extLst>
+                    <a:ext uri="{A12FA001-AC4F-418D-AE19-62706E023703}">
+                      <ahyp:hlinkClr xmlns:ahyp="http://schemas.microsoft.com/office/drawing/2018/hyperlinkcolor" val="tx"/>
+                    </a:ext>
+                  </a:extLst>
+                </a:hlinkClick>
               </a:rPr>
               <a:t>4. Rachev Ratio (RR):</a:t>
             </a:r>
@@ -8505,7 +8533,7 @@
       <p:sp>
         <p:nvSpPr>
           <p:cNvPr id="4" name="Text 2">
-            <a:hlinkClick r:id="rId1" tooltip="" action="ppaction://hlinksldjump"/>
+            <a:hlinkClick r:id="rId5" tooltip="" action="ppaction://hlinksldjump"/>
           </p:cNvPr>
           <p:cNvSpPr/>
           <p:nvPr/>
@@ -8533,7 +8561,7 @@
                 <a:solidFill>
                   <a:srgbClr val="0563C1"/>
                 </a:solidFill>
-                <a:hlinkClick r:id="rId1" action="ppaction://hlinksldjump" tooltip="">
+                <a:hlinkClick r:id="rId5" action="ppaction://hlinksldjump" tooltip="">
                   <a:extLst>
                     <a:ext uri="{A12FA001-AC4F-418D-AE19-62706E023703}">
                       <ahyp:hlinkClr xmlns:ahyp="http://schemas.microsoft.com/office/drawing/2018/hyperlinkcolor" val="tx"/>

</xml_diff>

<commit_message>
style: reformat Appendix TOC into two vertical columns
</commit_message>
<xml_diff>
--- a/Presentasi_Proposal_Update.pptx
+++ b/Presentasi_Proposal_Update.pptx
@@ -13424,7 +13424,7 @@
         <p:spPr>
           <a:xfrm>
             <a:off x="457200" y="1005840"/>
-            <a:ext cx="8229600" cy="4572000"/>
+            <a:ext cx="4114800" cy="4572000"/>
           </a:xfrm>
           <a:prstGeom prst="rect">
             <a:avLst/>
@@ -13445,7 +13445,7 @@
                   <a:srgbClr val="003366"/>
                 </a:solidFill>
               </a:rPr>
-              <a:t>IV. LAMPIRAN TEKNIS (APPENDIX)</a:t>
+              <a:t>IV. LAMPIRAN (BAGIAN 1)</a:t>
             </a:r>
             <a:endParaRPr lang="en-US" sz="1600" dirty="0"/>
           </a:p>
@@ -13479,6 +13479,9 @@
               </a:rPr>
               <a:t>Simulasi Strategi EW</a:t>
             </a:r>
+            <a:endParaRPr lang="en-US" sz="1600" dirty="0"/>
+          </a:p>
+          <a:p>
             <a:pPr indent="0" marL="0">
               <a:buNone/>
             </a:pPr>
@@ -13508,6 +13511,9 @@
               </a:rPr>
               <a:t>Simulasi Strategi CM</a:t>
             </a:r>
+            <a:endParaRPr lang="en-US" sz="1600" dirty="0"/>
+          </a:p>
+          <a:p>
             <a:pPr indent="0" marL="0">
               <a:buNone/>
             </a:pPr>
@@ -13537,6 +13543,9 @@
               </a:rPr>
               <a:t>Simulasi Strategi GLasso</a:t>
             </a:r>
+            <a:endParaRPr lang="en-US" sz="1600" dirty="0"/>
+          </a:p>
+          <a:p>
             <a:pPr indent="0" marL="0">
               <a:buNone/>
             </a:pPr>
@@ -13566,6 +13575,9 @@
               </a:rPr>
               <a:t>Simulasi Strategi NW</a:t>
             </a:r>
+            <a:endParaRPr lang="en-US" sz="1600" dirty="0"/>
+          </a:p>
+          <a:p>
             <a:pPr indent="0" marL="0">
               <a:buNone/>
             </a:pPr>
@@ -13595,6 +13607,9 @@
               </a:rPr>
               <a:t>Random Matrix Theory (RMT)</a:t>
             </a:r>
+            <a:endParaRPr lang="en-US" sz="1600" dirty="0"/>
+          </a:p>
+          <a:p>
             <a:pPr indent="0" marL="0">
               <a:buNone/>
             </a:pPr>
@@ -13624,6 +13639,9 @@
               </a:rPr>
               <a:t>Minimum Spanning Tree (MST)</a:t>
             </a:r>
+            <a:endParaRPr lang="en-US" sz="1600" dirty="0"/>
+          </a:p>
+          <a:p>
             <a:pPr indent="0" marL="0">
               <a:buNone/>
             </a:pPr>
@@ -13653,6 +13671,9 @@
               </a:rPr>
               <a:t>Penalty &amp; Centrality Logic</a:t>
             </a:r>
+            <a:endParaRPr lang="en-US" sz="1600" dirty="0"/>
+          </a:p>
+          <a:p>
             <a:pPr indent="0" marL="0">
               <a:buNone/>
             </a:pPr>
@@ -13682,6 +13703,45 @@
               </a:rPr>
               <a:t>Justifikasi Parameter Gamma</a:t>
             </a:r>
+            <a:endParaRPr lang="en-US" sz="1600" dirty="0"/>
+          </a:p>
+        </p:txBody>
+      </p:sp>
+      <p:sp>
+        <p:nvSpPr>
+          <p:cNvPr id="4" name="Text 2"/>
+          <p:cNvSpPr/>
+          <p:nvPr/>
+        </p:nvSpPr>
+        <p:spPr>
+          <a:xfrm>
+            <a:off x="4754880" y="1005840"/>
+            <a:ext cx="4114800" cy="4572000"/>
+          </a:xfrm>
+          <a:prstGeom prst="rect">
+            <a:avLst/>
+          </a:prstGeom>
+          <a:noFill/>
+          <a:ln/>
+        </p:spPr>
+        <p:txBody>
+          <a:bodyPr wrap="square" rtlCol="0" anchor="t"/>
+          <a:lstStyle/>
+          <a:p>
+            <a:pPr indent="0" marL="0">
+              <a:buNone/>
+            </a:pPr>
+            <a:r>
+              <a:rPr lang="en-US" sz="1600" b="1" dirty="0">
+                <a:solidFill>
+                  <a:srgbClr val="003366"/>
+                </a:solidFill>
+              </a:rPr>
+              <a:t>IV. LAMPIRAN (BAGIAN 2)</a:t>
+            </a:r>
+            <a:endParaRPr lang="en-US" sz="1600" dirty="0"/>
+          </a:p>
+          <a:p>
             <a:pPr indent="0" marL="0">
               <a:buNone/>
             </a:pPr>
@@ -13711,6 +13771,9 @@
               </a:rPr>
               <a:t>Simulasi 60/40 Weight Shift</a:t>
             </a:r>
+            <a:endParaRPr lang="en-US" sz="1600" dirty="0"/>
+          </a:p>
+          <a:p>
             <a:pPr indent="0" marL="0">
               <a:buNone/>
             </a:pPr>
@@ -13740,6 +13803,9 @@
               </a:rPr>
               <a:t>Simulasi 2-Stage Grid Search</a:t>
             </a:r>
+            <a:endParaRPr lang="en-US" sz="1600" dirty="0"/>
+          </a:p>
+          <a:p>
             <a:pPr indent="0" marL="0">
               <a:buNone/>
             </a:pPr>
@@ -13769,6 +13835,9 @@
               </a:rPr>
               <a:t>Justifikasi Rolling Window</a:t>
             </a:r>
+            <a:endParaRPr lang="en-US" sz="1600" dirty="0"/>
+          </a:p>
+          <a:p>
             <a:pPr indent="0" marL="0">
               <a:buNone/>
             </a:pPr>
@@ -13798,6 +13867,9 @@
               </a:rPr>
               <a:t>Simulasi Cumulative P&amp;L</a:t>
             </a:r>
+            <a:endParaRPr lang="en-US" sz="1600" dirty="0"/>
+          </a:p>
+          <a:p>
             <a:pPr indent="0" marL="0">
               <a:buNone/>
             </a:pPr>
@@ -13827,6 +13899,9 @@
               </a:rPr>
               <a:t>Simulasi Value at Risk (VaR)</a:t>
             </a:r>
+            <a:endParaRPr lang="en-US" sz="1600" dirty="0"/>
+          </a:p>
+          <a:p>
             <a:pPr indent="0" marL="0">
               <a:buNone/>
             </a:pPr>
@@ -13856,6 +13931,9 @@
               </a:rPr>
               <a:t>Simulasi Sharpe Ratio</a:t>
             </a:r>
+            <a:endParaRPr lang="en-US" sz="1600" dirty="0"/>
+          </a:p>
+          <a:p>
             <a:pPr indent="0" marL="0">
               <a:buNone/>
             </a:pPr>
@@ -13891,7 +13969,7 @@
       </p:sp>
       <p:sp>
         <p:nvSpPr>
-          <p:cNvPr id="4" name="Text 2">
+          <p:cNvPr id="5" name="Text 3">
             <a:hlinkClick r:id="rId16" tooltip="" action="ppaction://hlinksldjump"/>
           </p:cNvPr>
           <p:cNvSpPr/>

</xml_diff>

<commit_message>
feat: add global Appendix (TOC 2) link to all slides
</commit_message>
<xml_diff>
--- a/Presentasi_Proposal_Update.pptx
+++ b/Presentasi_Proposal_Update.pptx
@@ -6685,6 +6685,51 @@
         </p:nvSpPr>
         <p:spPr>
           <a:xfrm>
+            <a:off x="6675120" y="4846320"/>
+            <a:ext cx="1097280" cy="0"/>
+          </a:xfrm>
+          <a:prstGeom prst="rect">
+            <a:avLst/>
+          </a:prstGeom>
+          <a:noFill/>
+          <a:ln/>
+        </p:spPr>
+        <p:txBody>
+          <a:bodyPr wrap="square" rtlCol="0" anchor="ctr"/>
+          <a:lstStyle/>
+          <a:p>
+            <a:pPr algn="r" indent="0" marL="0">
+              <a:buNone/>
+            </a:pPr>
+            <a:r>
+              <a:rPr lang="en-US" sz="1000" u="sng" dirty="0">
+                <a:solidFill>
+                  <a:srgbClr val="0563C1"/>
+                </a:solidFill>
+                <a:hlinkClick r:id="rId6" action="ppaction://hlinksldjump" tooltip="">
+                  <a:extLst>
+                    <a:ext uri="{A12FA001-AC4F-418D-AE19-62706E023703}">
+                      <ahyp:hlinkClr xmlns:ahyp="http://schemas.microsoft.com/office/drawing/2018/hyperlinkcolor" val="tx"/>
+                    </a:ext>
+                  </a:extLst>
+                </a:hlinkClick>
+              </a:rPr>
+              <a:t>📂 Lampiran</a:t>
+            </a:r>
+            <a:endParaRPr lang="en-US" sz="1000" dirty="0"/>
+          </a:p>
+        </p:txBody>
+      </p:sp>
+      <p:sp>
+        <p:nvSpPr>
+          <p:cNvPr id="5" name="Text 3">
+            <a:hlinkClick r:id="rId7" tooltip="" action="ppaction://hlinksldjump"/>
+          </p:cNvPr>
+          <p:cNvSpPr/>
+          <p:nvPr/>
+        </p:nvSpPr>
+        <p:spPr>
+          <a:xfrm>
             <a:off x="7772400" y="4846320"/>
             <a:ext cx="1097280" cy="0"/>
           </a:xfrm>
@@ -6706,7 +6751,7 @@
                 <a:solidFill>
                   <a:srgbClr val="0563C1"/>
                 </a:solidFill>
-                <a:hlinkClick r:id="rId6" action="ppaction://hlinksldjump" tooltip="">
+                <a:hlinkClick r:id="rId7" action="ppaction://hlinksldjump" tooltip="">
                   <a:extLst>
                     <a:ext uri="{A12FA001-AC4F-418D-AE19-62706E023703}">
                       <ahyp:hlinkClr xmlns:ahyp="http://schemas.microsoft.com/office/drawing/2018/hyperlinkcolor" val="tx"/>
@@ -7001,6 +7046,51 @@
         </p:nvSpPr>
         <p:spPr>
           <a:xfrm>
+            <a:off x="6675120" y="4846320"/>
+            <a:ext cx="1097280" cy="0"/>
+          </a:xfrm>
+          <a:prstGeom prst="rect">
+            <a:avLst/>
+          </a:prstGeom>
+          <a:noFill/>
+          <a:ln/>
+        </p:spPr>
+        <p:txBody>
+          <a:bodyPr wrap="square" rtlCol="0" anchor="ctr"/>
+          <a:lstStyle/>
+          <a:p>
+            <a:pPr algn="r" indent="0" marL="0">
+              <a:buNone/>
+            </a:pPr>
+            <a:r>
+              <a:rPr lang="en-US" sz="1000" u="sng" dirty="0">
+                <a:solidFill>
+                  <a:srgbClr val="0563C1"/>
+                </a:solidFill>
+                <a:hlinkClick r:id="rId2" action="ppaction://hlinksldjump" tooltip="">
+                  <a:extLst>
+                    <a:ext uri="{A12FA001-AC4F-418D-AE19-62706E023703}">
+                      <ahyp:hlinkClr xmlns:ahyp="http://schemas.microsoft.com/office/drawing/2018/hyperlinkcolor" val="tx"/>
+                    </a:ext>
+                  </a:extLst>
+                </a:hlinkClick>
+              </a:rPr>
+              <a:t>📂 Lampiran</a:t>
+            </a:r>
+            <a:endParaRPr lang="en-US" sz="1000" dirty="0"/>
+          </a:p>
+        </p:txBody>
+      </p:sp>
+      <p:sp>
+        <p:nvSpPr>
+          <p:cNvPr id="5" name="Text 3">
+            <a:hlinkClick r:id="rId3" tooltip="" action="ppaction://hlinksldjump"/>
+          </p:cNvPr>
+          <p:cNvSpPr/>
+          <p:nvPr/>
+        </p:nvSpPr>
+        <p:spPr>
+          <a:xfrm>
             <a:off x="7772400" y="4846320"/>
             <a:ext cx="1097280" cy="0"/>
           </a:xfrm>
@@ -7022,7 +7112,7 @@
                 <a:solidFill>
                   <a:srgbClr val="0563C1"/>
                 </a:solidFill>
-                <a:hlinkClick r:id="rId2" action="ppaction://hlinksldjump" tooltip="">
+                <a:hlinkClick r:id="rId3" action="ppaction://hlinksldjump" tooltip="">
                   <a:extLst>
                     <a:ext uri="{A12FA001-AC4F-418D-AE19-62706E023703}">
                       <ahyp:hlinkClr xmlns:ahyp="http://schemas.microsoft.com/office/drawing/2018/hyperlinkcolor" val="tx"/>
@@ -7317,6 +7407,51 @@
         </p:nvSpPr>
         <p:spPr>
           <a:xfrm>
+            <a:off x="6675120" y="4846320"/>
+            <a:ext cx="1097280" cy="0"/>
+          </a:xfrm>
+          <a:prstGeom prst="rect">
+            <a:avLst/>
+          </a:prstGeom>
+          <a:noFill/>
+          <a:ln/>
+        </p:spPr>
+        <p:txBody>
+          <a:bodyPr wrap="square" rtlCol="0" anchor="ctr"/>
+          <a:lstStyle/>
+          <a:p>
+            <a:pPr algn="r" indent="0" marL="0">
+              <a:buNone/>
+            </a:pPr>
+            <a:r>
+              <a:rPr lang="en-US" sz="1000" u="sng" dirty="0">
+                <a:solidFill>
+                  <a:srgbClr val="0563C1"/>
+                </a:solidFill>
+                <a:hlinkClick r:id="rId2" action="ppaction://hlinksldjump" tooltip="">
+                  <a:extLst>
+                    <a:ext uri="{A12FA001-AC4F-418D-AE19-62706E023703}">
+                      <ahyp:hlinkClr xmlns:ahyp="http://schemas.microsoft.com/office/drawing/2018/hyperlinkcolor" val="tx"/>
+                    </a:ext>
+                  </a:extLst>
+                </a:hlinkClick>
+              </a:rPr>
+              <a:t>📂 Lampiran</a:t>
+            </a:r>
+            <a:endParaRPr lang="en-US" sz="1000" dirty="0"/>
+          </a:p>
+        </p:txBody>
+      </p:sp>
+      <p:sp>
+        <p:nvSpPr>
+          <p:cNvPr id="5" name="Text 3">
+            <a:hlinkClick r:id="rId3" tooltip="" action="ppaction://hlinksldjump"/>
+          </p:cNvPr>
+          <p:cNvSpPr/>
+          <p:nvPr/>
+        </p:nvSpPr>
+        <p:spPr>
+          <a:xfrm>
             <a:off x="7772400" y="4846320"/>
             <a:ext cx="1097280" cy="0"/>
           </a:xfrm>
@@ -7338,7 +7473,7 @@
                 <a:solidFill>
                   <a:srgbClr val="0563C1"/>
                 </a:solidFill>
-                <a:hlinkClick r:id="rId2" action="ppaction://hlinksldjump" tooltip="">
+                <a:hlinkClick r:id="rId3" action="ppaction://hlinksldjump" tooltip="">
                   <a:extLst>
                     <a:ext uri="{A12FA001-AC4F-418D-AE19-62706E023703}">
                       <ahyp:hlinkClr xmlns:ahyp="http://schemas.microsoft.com/office/drawing/2018/hyperlinkcolor" val="tx"/>
@@ -7611,6 +7746,51 @@
         </p:nvSpPr>
         <p:spPr>
           <a:xfrm>
+            <a:off x="6675120" y="4846320"/>
+            <a:ext cx="1097280" cy="0"/>
+          </a:xfrm>
+          <a:prstGeom prst="rect">
+            <a:avLst/>
+          </a:prstGeom>
+          <a:noFill/>
+          <a:ln/>
+        </p:spPr>
+        <p:txBody>
+          <a:bodyPr wrap="square" rtlCol="0" anchor="ctr"/>
+          <a:lstStyle/>
+          <a:p>
+            <a:pPr algn="r" indent="0" marL="0">
+              <a:buNone/>
+            </a:pPr>
+            <a:r>
+              <a:rPr lang="en-US" sz="1000" u="sng" dirty="0">
+                <a:solidFill>
+                  <a:srgbClr val="0563C1"/>
+                </a:solidFill>
+                <a:hlinkClick r:id="rId2" action="ppaction://hlinksldjump" tooltip="">
+                  <a:extLst>
+                    <a:ext uri="{A12FA001-AC4F-418D-AE19-62706E023703}">
+                      <ahyp:hlinkClr xmlns:ahyp="http://schemas.microsoft.com/office/drawing/2018/hyperlinkcolor" val="tx"/>
+                    </a:ext>
+                  </a:extLst>
+                </a:hlinkClick>
+              </a:rPr>
+              <a:t>📂 Lampiran</a:t>
+            </a:r>
+            <a:endParaRPr lang="en-US" sz="1000" dirty="0"/>
+          </a:p>
+        </p:txBody>
+      </p:sp>
+      <p:sp>
+        <p:nvSpPr>
+          <p:cNvPr id="5" name="Text 3">
+            <a:hlinkClick r:id="rId3" tooltip="" action="ppaction://hlinksldjump"/>
+          </p:cNvPr>
+          <p:cNvSpPr/>
+          <p:nvPr/>
+        </p:nvSpPr>
+        <p:spPr>
+          <a:xfrm>
             <a:off x="7772400" y="4846320"/>
             <a:ext cx="1097280" cy="0"/>
           </a:xfrm>
@@ -7632,7 +7812,7 @@
                 <a:solidFill>
                   <a:srgbClr val="0563C1"/>
                 </a:solidFill>
-                <a:hlinkClick r:id="rId2" action="ppaction://hlinksldjump" tooltip="">
+                <a:hlinkClick r:id="rId3" action="ppaction://hlinksldjump" tooltip="">
                   <a:extLst>
                     <a:ext uri="{A12FA001-AC4F-418D-AE19-62706E023703}">
                       <ahyp:hlinkClr xmlns:ahyp="http://schemas.microsoft.com/office/drawing/2018/hyperlinkcolor" val="tx"/>
@@ -7927,6 +8107,51 @@
         </p:nvSpPr>
         <p:spPr>
           <a:xfrm>
+            <a:off x="6675120" y="4846320"/>
+            <a:ext cx="1097280" cy="0"/>
+          </a:xfrm>
+          <a:prstGeom prst="rect">
+            <a:avLst/>
+          </a:prstGeom>
+          <a:noFill/>
+          <a:ln/>
+        </p:spPr>
+        <p:txBody>
+          <a:bodyPr wrap="square" rtlCol="0" anchor="ctr"/>
+          <a:lstStyle/>
+          <a:p>
+            <a:pPr algn="r" indent="0" marL="0">
+              <a:buNone/>
+            </a:pPr>
+            <a:r>
+              <a:rPr lang="en-US" sz="1000" u="sng" dirty="0">
+                <a:solidFill>
+                  <a:srgbClr val="0563C1"/>
+                </a:solidFill>
+                <a:hlinkClick r:id="rId2" action="ppaction://hlinksldjump" tooltip="">
+                  <a:extLst>
+                    <a:ext uri="{A12FA001-AC4F-418D-AE19-62706E023703}">
+                      <ahyp:hlinkClr xmlns:ahyp="http://schemas.microsoft.com/office/drawing/2018/hyperlinkcolor" val="tx"/>
+                    </a:ext>
+                  </a:extLst>
+                </a:hlinkClick>
+              </a:rPr>
+              <a:t>📂 Lampiran</a:t>
+            </a:r>
+            <a:endParaRPr lang="en-US" sz="1000" dirty="0"/>
+          </a:p>
+        </p:txBody>
+      </p:sp>
+      <p:sp>
+        <p:nvSpPr>
+          <p:cNvPr id="5" name="Text 3">
+            <a:hlinkClick r:id="rId3" tooltip="" action="ppaction://hlinksldjump"/>
+          </p:cNvPr>
+          <p:cNvSpPr/>
+          <p:nvPr/>
+        </p:nvSpPr>
+        <p:spPr>
+          <a:xfrm>
             <a:off x="7772400" y="4846320"/>
             <a:ext cx="1097280" cy="0"/>
           </a:xfrm>
@@ -7948,7 +8173,7 @@
                 <a:solidFill>
                   <a:srgbClr val="0563C1"/>
                 </a:solidFill>
-                <a:hlinkClick r:id="rId2" action="ppaction://hlinksldjump" tooltip="">
+                <a:hlinkClick r:id="rId3" action="ppaction://hlinksldjump" tooltip="">
                   <a:extLst>
                     <a:ext uri="{A12FA001-AC4F-418D-AE19-62706E023703}">
                       <ahyp:hlinkClr xmlns:ahyp="http://schemas.microsoft.com/office/drawing/2018/hyperlinkcolor" val="tx"/>
@@ -8244,6 +8469,51 @@
         </p:nvSpPr>
         <p:spPr>
           <a:xfrm>
+            <a:off x="6675120" y="4846320"/>
+            <a:ext cx="1097280" cy="0"/>
+          </a:xfrm>
+          <a:prstGeom prst="rect">
+            <a:avLst/>
+          </a:prstGeom>
+          <a:noFill/>
+          <a:ln/>
+        </p:spPr>
+        <p:txBody>
+          <a:bodyPr wrap="square" rtlCol="0" anchor="ctr"/>
+          <a:lstStyle/>
+          <a:p>
+            <a:pPr algn="r" indent="0" marL="0">
+              <a:buNone/>
+            </a:pPr>
+            <a:r>
+              <a:rPr lang="en-US" sz="1000" u="sng" dirty="0">
+                <a:solidFill>
+                  <a:srgbClr val="0563C1"/>
+                </a:solidFill>
+                <a:hlinkClick r:id="rId2" action="ppaction://hlinksldjump" tooltip="">
+                  <a:extLst>
+                    <a:ext uri="{A12FA001-AC4F-418D-AE19-62706E023703}">
+                      <ahyp:hlinkClr xmlns:ahyp="http://schemas.microsoft.com/office/drawing/2018/hyperlinkcolor" val="tx"/>
+                    </a:ext>
+                  </a:extLst>
+                </a:hlinkClick>
+              </a:rPr>
+              <a:t>📂 Lampiran</a:t>
+            </a:r>
+            <a:endParaRPr lang="en-US" sz="1000" dirty="0"/>
+          </a:p>
+        </p:txBody>
+      </p:sp>
+      <p:sp>
+        <p:nvSpPr>
+          <p:cNvPr id="6" name="Text 4">
+            <a:hlinkClick r:id="rId3" tooltip="" action="ppaction://hlinksldjump"/>
+          </p:cNvPr>
+          <p:cNvSpPr/>
+          <p:nvPr/>
+        </p:nvSpPr>
+        <p:spPr>
+          <a:xfrm>
             <a:off x="7772400" y="4846320"/>
             <a:ext cx="1097280" cy="0"/>
           </a:xfrm>
@@ -8265,7 +8535,7 @@
                 <a:solidFill>
                   <a:srgbClr val="0563C1"/>
                 </a:solidFill>
-                <a:hlinkClick r:id="rId2" action="ppaction://hlinksldjump" tooltip="">
+                <a:hlinkClick r:id="rId3" action="ppaction://hlinksldjump" tooltip="">
                   <a:extLst>
                     <a:ext uri="{A12FA001-AC4F-418D-AE19-62706E023703}">
                       <ahyp:hlinkClr xmlns:ahyp="http://schemas.microsoft.com/office/drawing/2018/hyperlinkcolor" val="tx"/>
@@ -8540,6 +8810,51 @@
         </p:nvSpPr>
         <p:spPr>
           <a:xfrm>
+            <a:off x="6675120" y="4846320"/>
+            <a:ext cx="1097280" cy="0"/>
+          </a:xfrm>
+          <a:prstGeom prst="rect">
+            <a:avLst/>
+          </a:prstGeom>
+          <a:noFill/>
+          <a:ln/>
+        </p:spPr>
+        <p:txBody>
+          <a:bodyPr wrap="square" rtlCol="0" anchor="ctr"/>
+          <a:lstStyle/>
+          <a:p>
+            <a:pPr algn="r" indent="0" marL="0">
+              <a:buNone/>
+            </a:pPr>
+            <a:r>
+              <a:rPr lang="en-US" sz="1000" u="sng" dirty="0">
+                <a:solidFill>
+                  <a:srgbClr val="0563C1"/>
+                </a:solidFill>
+                <a:hlinkClick r:id="rId5" action="ppaction://hlinksldjump" tooltip="">
+                  <a:extLst>
+                    <a:ext uri="{A12FA001-AC4F-418D-AE19-62706E023703}">
+                      <ahyp:hlinkClr xmlns:ahyp="http://schemas.microsoft.com/office/drawing/2018/hyperlinkcolor" val="tx"/>
+                    </a:ext>
+                  </a:extLst>
+                </a:hlinkClick>
+              </a:rPr>
+              <a:t>📂 Lampiran</a:t>
+            </a:r>
+            <a:endParaRPr lang="en-US" sz="1000" dirty="0"/>
+          </a:p>
+        </p:txBody>
+      </p:sp>
+      <p:sp>
+        <p:nvSpPr>
+          <p:cNvPr id="5" name="Text 3">
+            <a:hlinkClick r:id="rId6" tooltip="" action="ppaction://hlinksldjump"/>
+          </p:cNvPr>
+          <p:cNvSpPr/>
+          <p:nvPr/>
+        </p:nvSpPr>
+        <p:spPr>
+          <a:xfrm>
             <a:off x="7772400" y="4846320"/>
             <a:ext cx="1097280" cy="0"/>
           </a:xfrm>
@@ -8561,7 +8876,7 @@
                 <a:solidFill>
                   <a:srgbClr val="0563C1"/>
                 </a:solidFill>
-                <a:hlinkClick r:id="rId5" action="ppaction://hlinksldjump" tooltip="">
+                <a:hlinkClick r:id="rId6" action="ppaction://hlinksldjump" tooltip="">
                   <a:extLst>
                     <a:ext uri="{A12FA001-AC4F-418D-AE19-62706E023703}">
                       <ahyp:hlinkClr xmlns:ahyp="http://schemas.microsoft.com/office/drawing/2018/hyperlinkcolor" val="tx"/>
@@ -8813,6 +9128,51 @@
         </p:nvSpPr>
         <p:spPr>
           <a:xfrm>
+            <a:off x="6675120" y="4846320"/>
+            <a:ext cx="1097280" cy="0"/>
+          </a:xfrm>
+          <a:prstGeom prst="rect">
+            <a:avLst/>
+          </a:prstGeom>
+          <a:noFill/>
+          <a:ln/>
+        </p:spPr>
+        <p:txBody>
+          <a:bodyPr wrap="square" rtlCol="0" anchor="ctr"/>
+          <a:lstStyle/>
+          <a:p>
+            <a:pPr algn="r" indent="0" marL="0">
+              <a:buNone/>
+            </a:pPr>
+            <a:r>
+              <a:rPr lang="en-US" sz="1000" u="sng" dirty="0">
+                <a:solidFill>
+                  <a:srgbClr val="0563C1"/>
+                </a:solidFill>
+                <a:hlinkClick r:id="rId1" action="ppaction://hlinksldjump" tooltip="">
+                  <a:extLst>
+                    <a:ext uri="{A12FA001-AC4F-418D-AE19-62706E023703}">
+                      <ahyp:hlinkClr xmlns:ahyp="http://schemas.microsoft.com/office/drawing/2018/hyperlinkcolor" val="tx"/>
+                    </a:ext>
+                  </a:extLst>
+                </a:hlinkClick>
+              </a:rPr>
+              <a:t>📂 Lampiran</a:t>
+            </a:r>
+            <a:endParaRPr lang="en-US" sz="1000" dirty="0"/>
+          </a:p>
+        </p:txBody>
+      </p:sp>
+      <p:sp>
+        <p:nvSpPr>
+          <p:cNvPr id="5" name="Text 3">
+            <a:hlinkClick r:id="rId2" tooltip="" action="ppaction://hlinksldjump"/>
+          </p:cNvPr>
+          <p:cNvSpPr/>
+          <p:nvPr/>
+        </p:nvSpPr>
+        <p:spPr>
+          <a:xfrm>
             <a:off x="7772400" y="4846320"/>
             <a:ext cx="1097280" cy="0"/>
           </a:xfrm>
@@ -8834,7 +9194,7 @@
                 <a:solidFill>
                   <a:srgbClr val="0563C1"/>
                 </a:solidFill>
-                <a:hlinkClick r:id="rId1" action="ppaction://hlinksldjump" tooltip="">
+                <a:hlinkClick r:id="rId2" action="ppaction://hlinksldjump" tooltip="">
                   <a:extLst>
                     <a:ext uri="{A12FA001-AC4F-418D-AE19-62706E023703}">
                       <ahyp:hlinkClr xmlns:ahyp="http://schemas.microsoft.com/office/drawing/2018/hyperlinkcolor" val="tx"/>
@@ -9197,6 +9557,51 @@
         </p:nvSpPr>
         <p:spPr>
           <a:xfrm>
+            <a:off x="6675120" y="4846320"/>
+            <a:ext cx="1097280" cy="0"/>
+          </a:xfrm>
+          <a:prstGeom prst="rect">
+            <a:avLst/>
+          </a:prstGeom>
+          <a:noFill/>
+          <a:ln/>
+        </p:spPr>
+        <p:txBody>
+          <a:bodyPr wrap="square" rtlCol="0" anchor="ctr"/>
+          <a:lstStyle/>
+          <a:p>
+            <a:pPr algn="r" indent="0" marL="0">
+              <a:buNone/>
+            </a:pPr>
+            <a:r>
+              <a:rPr lang="en-US" sz="1000" u="sng" dirty="0">
+                <a:solidFill>
+                  <a:srgbClr val="0563C1"/>
+                </a:solidFill>
+                <a:hlinkClick r:id="rId2" action="ppaction://hlinksldjump" tooltip="">
+                  <a:extLst>
+                    <a:ext uri="{A12FA001-AC4F-418D-AE19-62706E023703}">
+                      <ahyp:hlinkClr xmlns:ahyp="http://schemas.microsoft.com/office/drawing/2018/hyperlinkcolor" val="tx"/>
+                    </a:ext>
+                  </a:extLst>
+                </a:hlinkClick>
+              </a:rPr>
+              <a:t>📂 Lampiran</a:t>
+            </a:r>
+            <a:endParaRPr lang="en-US" sz="1000" dirty="0"/>
+          </a:p>
+        </p:txBody>
+      </p:sp>
+      <p:sp>
+        <p:nvSpPr>
+          <p:cNvPr id="5" name="Text 3">
+            <a:hlinkClick r:id="rId3" tooltip="" action="ppaction://hlinksldjump"/>
+          </p:cNvPr>
+          <p:cNvSpPr/>
+          <p:nvPr/>
+        </p:nvSpPr>
+        <p:spPr>
+          <a:xfrm>
             <a:off x="7772400" y="4846320"/>
             <a:ext cx="1097280" cy="0"/>
           </a:xfrm>
@@ -9218,7 +9623,7 @@
                 <a:solidFill>
                   <a:srgbClr val="0563C1"/>
                 </a:solidFill>
-                <a:hlinkClick r:id="rId2" action="ppaction://hlinksldjump" tooltip="">
+                <a:hlinkClick r:id="rId3" action="ppaction://hlinksldjump" tooltip="">
                   <a:extLst>
                     <a:ext uri="{A12FA001-AC4F-418D-AE19-62706E023703}">
                       <ahyp:hlinkClr xmlns:ahyp="http://schemas.microsoft.com/office/drawing/2018/hyperlinkcolor" val="tx"/>
@@ -9566,6 +9971,51 @@
         </p:nvSpPr>
         <p:spPr>
           <a:xfrm>
+            <a:off x="6675120" y="4846320"/>
+            <a:ext cx="1097280" cy="0"/>
+          </a:xfrm>
+          <a:prstGeom prst="rect">
+            <a:avLst/>
+          </a:prstGeom>
+          <a:noFill/>
+          <a:ln/>
+        </p:spPr>
+        <p:txBody>
+          <a:bodyPr wrap="square" rtlCol="0" anchor="ctr"/>
+          <a:lstStyle/>
+          <a:p>
+            <a:pPr algn="r" indent="0" marL="0">
+              <a:buNone/>
+            </a:pPr>
+            <a:r>
+              <a:rPr lang="en-US" sz="1000" u="sng" dirty="0">
+                <a:solidFill>
+                  <a:srgbClr val="0563C1"/>
+                </a:solidFill>
+                <a:hlinkClick r:id="rId1" action="ppaction://hlinksldjump" tooltip="">
+                  <a:extLst>
+                    <a:ext uri="{A12FA001-AC4F-418D-AE19-62706E023703}">
+                      <ahyp:hlinkClr xmlns:ahyp="http://schemas.microsoft.com/office/drawing/2018/hyperlinkcolor" val="tx"/>
+                    </a:ext>
+                  </a:extLst>
+                </a:hlinkClick>
+              </a:rPr>
+              <a:t>📂 Lampiran</a:t>
+            </a:r>
+            <a:endParaRPr lang="en-US" sz="1000" dirty="0"/>
+          </a:p>
+        </p:txBody>
+      </p:sp>
+      <p:sp>
+        <p:nvSpPr>
+          <p:cNvPr id="5" name="Text 3">
+            <a:hlinkClick r:id="rId2" tooltip="" action="ppaction://hlinksldjump"/>
+          </p:cNvPr>
+          <p:cNvSpPr/>
+          <p:nvPr/>
+        </p:nvSpPr>
+        <p:spPr>
+          <a:xfrm>
             <a:off x="7772400" y="4846320"/>
             <a:ext cx="1097280" cy="0"/>
           </a:xfrm>
@@ -9587,7 +10037,7 @@
                 <a:solidFill>
                   <a:srgbClr val="0563C1"/>
                 </a:solidFill>
-                <a:hlinkClick r:id="rId1" action="ppaction://hlinksldjump" tooltip="">
+                <a:hlinkClick r:id="rId2" action="ppaction://hlinksldjump" tooltip="">
                   <a:extLst>
                     <a:ext uri="{A12FA001-AC4F-418D-AE19-62706E023703}">
                       <ahyp:hlinkClr xmlns:ahyp="http://schemas.microsoft.com/office/drawing/2018/hyperlinkcolor" val="tx"/>
@@ -10578,6 +11028,51 @@
         </p:nvSpPr>
         <p:spPr>
           <a:xfrm>
+            <a:off x="6675120" y="4846320"/>
+            <a:ext cx="1097280" cy="0"/>
+          </a:xfrm>
+          <a:prstGeom prst="rect">
+            <a:avLst/>
+          </a:prstGeom>
+          <a:noFill/>
+          <a:ln/>
+        </p:spPr>
+        <p:txBody>
+          <a:bodyPr wrap="square" rtlCol="0" anchor="ctr"/>
+          <a:lstStyle/>
+          <a:p>
+            <a:pPr algn="r" indent="0" marL="0">
+              <a:buNone/>
+            </a:pPr>
+            <a:r>
+              <a:rPr lang="en-US" sz="1000" u="sng" dirty="0">
+                <a:solidFill>
+                  <a:srgbClr val="0563C1"/>
+                </a:solidFill>
+                <a:hlinkClick r:id="rId1" action="ppaction://hlinksldjump" tooltip="">
+                  <a:extLst>
+                    <a:ext uri="{A12FA001-AC4F-418D-AE19-62706E023703}">
+                      <ahyp:hlinkClr xmlns:ahyp="http://schemas.microsoft.com/office/drawing/2018/hyperlinkcolor" val="tx"/>
+                    </a:ext>
+                  </a:extLst>
+                </a:hlinkClick>
+              </a:rPr>
+              <a:t>📂 Lampiran</a:t>
+            </a:r>
+            <a:endParaRPr lang="en-US" sz="1000" dirty="0"/>
+          </a:p>
+        </p:txBody>
+      </p:sp>
+      <p:sp>
+        <p:nvSpPr>
+          <p:cNvPr id="5" name="Text 3">
+            <a:hlinkClick r:id="rId2" tooltip="" action="ppaction://hlinksldjump"/>
+          </p:cNvPr>
+          <p:cNvSpPr/>
+          <p:nvPr/>
+        </p:nvSpPr>
+        <p:spPr>
+          <a:xfrm>
             <a:off x="7772400" y="4846320"/>
             <a:ext cx="1097280" cy="0"/>
           </a:xfrm>
@@ -10599,7 +11094,7 @@
                 <a:solidFill>
                   <a:srgbClr val="0563C1"/>
                 </a:solidFill>
-                <a:hlinkClick r:id="rId1" action="ppaction://hlinksldjump" tooltip="">
+                <a:hlinkClick r:id="rId2" action="ppaction://hlinksldjump" tooltip="">
                   <a:extLst>
                     <a:ext uri="{A12FA001-AC4F-418D-AE19-62706E023703}">
                       <ahyp:hlinkClr xmlns:ahyp="http://schemas.microsoft.com/office/drawing/2018/hyperlinkcolor" val="tx"/>
@@ -10963,6 +11458,51 @@
         </p:nvSpPr>
         <p:spPr>
           <a:xfrm>
+            <a:off x="6675120" y="4846320"/>
+            <a:ext cx="1097280" cy="0"/>
+          </a:xfrm>
+          <a:prstGeom prst="rect">
+            <a:avLst/>
+          </a:prstGeom>
+          <a:noFill/>
+          <a:ln/>
+        </p:spPr>
+        <p:txBody>
+          <a:bodyPr wrap="square" rtlCol="0" anchor="ctr"/>
+          <a:lstStyle/>
+          <a:p>
+            <a:pPr algn="r" indent="0" marL="0">
+              <a:buNone/>
+            </a:pPr>
+            <a:r>
+              <a:rPr lang="en-US" sz="1000" u="sng" dirty="0">
+                <a:solidFill>
+                  <a:srgbClr val="0563C1"/>
+                </a:solidFill>
+                <a:hlinkClick r:id="rId1" action="ppaction://hlinksldjump" tooltip="">
+                  <a:extLst>
+                    <a:ext uri="{A12FA001-AC4F-418D-AE19-62706E023703}">
+                      <ahyp:hlinkClr xmlns:ahyp="http://schemas.microsoft.com/office/drawing/2018/hyperlinkcolor" val="tx"/>
+                    </a:ext>
+                  </a:extLst>
+                </a:hlinkClick>
+              </a:rPr>
+              <a:t>📂 Lampiran</a:t>
+            </a:r>
+            <a:endParaRPr lang="en-US" sz="1000" dirty="0"/>
+          </a:p>
+        </p:txBody>
+      </p:sp>
+      <p:sp>
+        <p:nvSpPr>
+          <p:cNvPr id="5" name="Text 3">
+            <a:hlinkClick r:id="rId2" tooltip="" action="ppaction://hlinksldjump"/>
+          </p:cNvPr>
+          <p:cNvSpPr/>
+          <p:nvPr/>
+        </p:nvSpPr>
+        <p:spPr>
+          <a:xfrm>
             <a:off x="7772400" y="4846320"/>
             <a:ext cx="1097280" cy="0"/>
           </a:xfrm>
@@ -10984,7 +11524,7 @@
                 <a:solidFill>
                   <a:srgbClr val="0563C1"/>
                 </a:solidFill>
-                <a:hlinkClick r:id="rId1" action="ppaction://hlinksldjump" tooltip="">
+                <a:hlinkClick r:id="rId2" action="ppaction://hlinksldjump" tooltip="">
                   <a:extLst>
                     <a:ext uri="{A12FA001-AC4F-418D-AE19-62706E023703}">
                       <ahyp:hlinkClr xmlns:ahyp="http://schemas.microsoft.com/office/drawing/2018/hyperlinkcolor" val="tx"/>
@@ -11275,6 +11815,51 @@
         </p:nvSpPr>
         <p:spPr>
           <a:xfrm>
+            <a:off x="6675120" y="4846320"/>
+            <a:ext cx="1097280" cy="0"/>
+          </a:xfrm>
+          <a:prstGeom prst="rect">
+            <a:avLst/>
+          </a:prstGeom>
+          <a:noFill/>
+          <a:ln/>
+        </p:spPr>
+        <p:txBody>
+          <a:bodyPr wrap="square" rtlCol="0" anchor="ctr"/>
+          <a:lstStyle/>
+          <a:p>
+            <a:pPr algn="r" indent="0" marL="0">
+              <a:buNone/>
+            </a:pPr>
+            <a:r>
+              <a:rPr lang="en-US" sz="1000" u="sng" dirty="0">
+                <a:solidFill>
+                  <a:srgbClr val="0563C1"/>
+                </a:solidFill>
+                <a:hlinkClick r:id="rId1" action="ppaction://hlinksldjump" tooltip="">
+                  <a:extLst>
+                    <a:ext uri="{A12FA001-AC4F-418D-AE19-62706E023703}">
+                      <ahyp:hlinkClr xmlns:ahyp="http://schemas.microsoft.com/office/drawing/2018/hyperlinkcolor" val="tx"/>
+                    </a:ext>
+                  </a:extLst>
+                </a:hlinkClick>
+              </a:rPr>
+              <a:t>📂 Lampiran</a:t>
+            </a:r>
+            <a:endParaRPr lang="en-US" sz="1000" dirty="0"/>
+          </a:p>
+        </p:txBody>
+      </p:sp>
+      <p:sp>
+        <p:nvSpPr>
+          <p:cNvPr id="5" name="Text 3">
+            <a:hlinkClick r:id="rId2" tooltip="" action="ppaction://hlinksldjump"/>
+          </p:cNvPr>
+          <p:cNvSpPr/>
+          <p:nvPr/>
+        </p:nvSpPr>
+        <p:spPr>
+          <a:xfrm>
             <a:off x="7772400" y="4846320"/>
             <a:ext cx="1097280" cy="0"/>
           </a:xfrm>
@@ -11296,7 +11881,7 @@
                 <a:solidFill>
                   <a:srgbClr val="0563C1"/>
                 </a:solidFill>
-                <a:hlinkClick r:id="rId1" action="ppaction://hlinksldjump" tooltip="">
+                <a:hlinkClick r:id="rId2" action="ppaction://hlinksldjump" tooltip="">
                   <a:extLst>
                     <a:ext uri="{A12FA001-AC4F-418D-AE19-62706E023703}">
                       <ahyp:hlinkClr xmlns:ahyp="http://schemas.microsoft.com/office/drawing/2018/hyperlinkcolor" val="tx"/>
@@ -11579,6 +12164,51 @@
         </p:nvSpPr>
         <p:spPr>
           <a:xfrm>
+            <a:off x="6675120" y="4846320"/>
+            <a:ext cx="1097280" cy="0"/>
+          </a:xfrm>
+          <a:prstGeom prst="rect">
+            <a:avLst/>
+          </a:prstGeom>
+          <a:noFill/>
+          <a:ln/>
+        </p:spPr>
+        <p:txBody>
+          <a:bodyPr wrap="square" rtlCol="0" anchor="ctr"/>
+          <a:lstStyle/>
+          <a:p>
+            <a:pPr algn="r" indent="0" marL="0">
+              <a:buNone/>
+            </a:pPr>
+            <a:r>
+              <a:rPr lang="en-US" sz="1000" u="sng" dirty="0">
+                <a:solidFill>
+                  <a:srgbClr val="0563C1"/>
+                </a:solidFill>
+                <a:hlinkClick r:id="rId1" action="ppaction://hlinksldjump" tooltip="">
+                  <a:extLst>
+                    <a:ext uri="{A12FA001-AC4F-418D-AE19-62706E023703}">
+                      <ahyp:hlinkClr xmlns:ahyp="http://schemas.microsoft.com/office/drawing/2018/hyperlinkcolor" val="tx"/>
+                    </a:ext>
+                  </a:extLst>
+                </a:hlinkClick>
+              </a:rPr>
+              <a:t>📂 Lampiran</a:t>
+            </a:r>
+            <a:endParaRPr lang="en-US" sz="1000" dirty="0"/>
+          </a:p>
+        </p:txBody>
+      </p:sp>
+      <p:sp>
+        <p:nvSpPr>
+          <p:cNvPr id="5" name="Text 3">
+            <a:hlinkClick r:id="rId2" tooltip="" action="ppaction://hlinksldjump"/>
+          </p:cNvPr>
+          <p:cNvSpPr/>
+          <p:nvPr/>
+        </p:nvSpPr>
+        <p:spPr>
+          <a:xfrm>
             <a:off x="7772400" y="4846320"/>
             <a:ext cx="1097280" cy="0"/>
           </a:xfrm>
@@ -11600,7 +12230,7 @@
                 <a:solidFill>
                   <a:srgbClr val="0563C1"/>
                 </a:solidFill>
-                <a:hlinkClick r:id="rId1" action="ppaction://hlinksldjump" tooltip="">
+                <a:hlinkClick r:id="rId2" action="ppaction://hlinksldjump" tooltip="">
                   <a:extLst>
                     <a:ext uri="{A12FA001-AC4F-418D-AE19-62706E023703}">
                       <ahyp:hlinkClr xmlns:ahyp="http://schemas.microsoft.com/office/drawing/2018/hyperlinkcolor" val="tx"/>
@@ -11913,6 +12543,51 @@
         </p:nvSpPr>
         <p:spPr>
           <a:xfrm>
+            <a:off x="6675120" y="4846320"/>
+            <a:ext cx="1097280" cy="0"/>
+          </a:xfrm>
+          <a:prstGeom prst="rect">
+            <a:avLst/>
+          </a:prstGeom>
+          <a:noFill/>
+          <a:ln/>
+        </p:spPr>
+        <p:txBody>
+          <a:bodyPr wrap="square" rtlCol="0" anchor="ctr"/>
+          <a:lstStyle/>
+          <a:p>
+            <a:pPr algn="r" indent="0" marL="0">
+              <a:buNone/>
+            </a:pPr>
+            <a:r>
+              <a:rPr lang="en-US" sz="1000" u="sng" dirty="0">
+                <a:solidFill>
+                  <a:srgbClr val="0563C1"/>
+                </a:solidFill>
+                <a:hlinkClick r:id="rId1" action="ppaction://hlinksldjump" tooltip="">
+                  <a:extLst>
+                    <a:ext uri="{A12FA001-AC4F-418D-AE19-62706E023703}">
+                      <ahyp:hlinkClr xmlns:ahyp="http://schemas.microsoft.com/office/drawing/2018/hyperlinkcolor" val="tx"/>
+                    </a:ext>
+                  </a:extLst>
+                </a:hlinkClick>
+              </a:rPr>
+              <a:t>📂 Lampiran</a:t>
+            </a:r>
+            <a:endParaRPr lang="en-US" sz="1000" dirty="0"/>
+          </a:p>
+        </p:txBody>
+      </p:sp>
+      <p:sp>
+        <p:nvSpPr>
+          <p:cNvPr id="5" name="Text 3">
+            <a:hlinkClick r:id="rId2" tooltip="" action="ppaction://hlinksldjump"/>
+          </p:cNvPr>
+          <p:cNvSpPr/>
+          <p:nvPr/>
+        </p:nvSpPr>
+        <p:spPr>
+          <a:xfrm>
             <a:off x="7772400" y="4846320"/>
             <a:ext cx="1097280" cy="0"/>
           </a:xfrm>
@@ -11934,7 +12609,7 @@
                 <a:solidFill>
                   <a:srgbClr val="0563C1"/>
                 </a:solidFill>
-                <a:hlinkClick r:id="rId1" action="ppaction://hlinksldjump" tooltip="">
+                <a:hlinkClick r:id="rId2" action="ppaction://hlinksldjump" tooltip="">
                   <a:extLst>
                     <a:ext uri="{A12FA001-AC4F-418D-AE19-62706E023703}">
                       <ahyp:hlinkClr xmlns:ahyp="http://schemas.microsoft.com/office/drawing/2018/hyperlinkcolor" val="tx"/>
@@ -12166,6 +12841,51 @@
         </p:nvSpPr>
         <p:spPr>
           <a:xfrm>
+            <a:off x="6675120" y="4846320"/>
+            <a:ext cx="1097280" cy="0"/>
+          </a:xfrm>
+          <a:prstGeom prst="rect">
+            <a:avLst/>
+          </a:prstGeom>
+          <a:noFill/>
+          <a:ln/>
+        </p:spPr>
+        <p:txBody>
+          <a:bodyPr wrap="square" rtlCol="0" anchor="ctr"/>
+          <a:lstStyle/>
+          <a:p>
+            <a:pPr algn="r" indent="0" marL="0">
+              <a:buNone/>
+            </a:pPr>
+            <a:r>
+              <a:rPr lang="en-US" sz="1000" u="sng" dirty="0">
+                <a:solidFill>
+                  <a:srgbClr val="0563C1"/>
+                </a:solidFill>
+                <a:hlinkClick r:id="rId1" action="ppaction://hlinksldjump" tooltip="">
+                  <a:extLst>
+                    <a:ext uri="{A12FA001-AC4F-418D-AE19-62706E023703}">
+                      <ahyp:hlinkClr xmlns:ahyp="http://schemas.microsoft.com/office/drawing/2018/hyperlinkcolor" val="tx"/>
+                    </a:ext>
+                  </a:extLst>
+                </a:hlinkClick>
+              </a:rPr>
+              <a:t>📂 Lampiran</a:t>
+            </a:r>
+            <a:endParaRPr lang="en-US" sz="1000" dirty="0"/>
+          </a:p>
+        </p:txBody>
+      </p:sp>
+      <p:sp>
+        <p:nvSpPr>
+          <p:cNvPr id="5" name="Text 3">
+            <a:hlinkClick r:id="rId2" tooltip="" action="ppaction://hlinksldjump"/>
+          </p:cNvPr>
+          <p:cNvSpPr/>
+          <p:nvPr/>
+        </p:nvSpPr>
+        <p:spPr>
+          <a:xfrm>
             <a:off x="7772400" y="4846320"/>
             <a:ext cx="1097280" cy="0"/>
           </a:xfrm>
@@ -12187,7 +12907,7 @@
                 <a:solidFill>
                   <a:srgbClr val="0563C1"/>
                 </a:solidFill>
-                <a:hlinkClick r:id="rId1" action="ppaction://hlinksldjump" tooltip="">
+                <a:hlinkClick r:id="rId2" action="ppaction://hlinksldjump" tooltip="">
                   <a:extLst>
                     <a:ext uri="{A12FA001-AC4F-418D-AE19-62706E023703}">
                       <ahyp:hlinkClr xmlns:ahyp="http://schemas.microsoft.com/office/drawing/2018/hyperlinkcolor" val="tx"/>
@@ -12433,6 +13153,51 @@
         </p:nvSpPr>
         <p:spPr>
           <a:xfrm>
+            <a:off x="6675120" y="4846320"/>
+            <a:ext cx="1097280" cy="0"/>
+          </a:xfrm>
+          <a:prstGeom prst="rect">
+            <a:avLst/>
+          </a:prstGeom>
+          <a:noFill/>
+          <a:ln/>
+        </p:spPr>
+        <p:txBody>
+          <a:bodyPr wrap="square" rtlCol="0" anchor="ctr"/>
+          <a:lstStyle/>
+          <a:p>
+            <a:pPr algn="r" indent="0" marL="0">
+              <a:buNone/>
+            </a:pPr>
+            <a:r>
+              <a:rPr lang="en-US" sz="1000" u="sng" dirty="0">
+                <a:solidFill>
+                  <a:srgbClr val="0563C1"/>
+                </a:solidFill>
+                <a:hlinkClick r:id="rId1" action="ppaction://hlinksldjump" tooltip="">
+                  <a:extLst>
+                    <a:ext uri="{A12FA001-AC4F-418D-AE19-62706E023703}">
+                      <ahyp:hlinkClr xmlns:ahyp="http://schemas.microsoft.com/office/drawing/2018/hyperlinkcolor" val="tx"/>
+                    </a:ext>
+                  </a:extLst>
+                </a:hlinkClick>
+              </a:rPr>
+              <a:t>📂 Lampiran</a:t>
+            </a:r>
+            <a:endParaRPr lang="en-US" sz="1000" dirty="0"/>
+          </a:p>
+        </p:txBody>
+      </p:sp>
+      <p:sp>
+        <p:nvSpPr>
+          <p:cNvPr id="5" name="Text 3">
+            <a:hlinkClick r:id="rId2" tooltip="" action="ppaction://hlinksldjump"/>
+          </p:cNvPr>
+          <p:cNvSpPr/>
+          <p:nvPr/>
+        </p:nvSpPr>
+        <p:spPr>
+          <a:xfrm>
             <a:off x="7772400" y="4846320"/>
             <a:ext cx="1097280" cy="0"/>
           </a:xfrm>
@@ -12454,7 +13219,7 @@
                 <a:solidFill>
                   <a:srgbClr val="0563C1"/>
                 </a:solidFill>
-                <a:hlinkClick r:id="rId1" action="ppaction://hlinksldjump" tooltip="">
+                <a:hlinkClick r:id="rId2" action="ppaction://hlinksldjump" tooltip="">
                   <a:extLst>
                     <a:ext uri="{A12FA001-AC4F-418D-AE19-62706E023703}">
                       <ahyp:hlinkClr xmlns:ahyp="http://schemas.microsoft.com/office/drawing/2018/hyperlinkcolor" val="tx"/>
@@ -12765,6 +13530,51 @@
         </p:nvSpPr>
         <p:spPr>
           <a:xfrm>
+            <a:off x="6675120" y="4846320"/>
+            <a:ext cx="1097280" cy="0"/>
+          </a:xfrm>
+          <a:prstGeom prst="rect">
+            <a:avLst/>
+          </a:prstGeom>
+          <a:noFill/>
+          <a:ln/>
+        </p:spPr>
+        <p:txBody>
+          <a:bodyPr wrap="square" rtlCol="0" anchor="ctr"/>
+          <a:lstStyle/>
+          <a:p>
+            <a:pPr algn="r" indent="0" marL="0">
+              <a:buNone/>
+            </a:pPr>
+            <a:r>
+              <a:rPr lang="en-US" sz="1000" u="sng" dirty="0">
+                <a:solidFill>
+                  <a:srgbClr val="0563C1"/>
+                </a:solidFill>
+                <a:hlinkClick r:id="rId1" action="ppaction://hlinksldjump" tooltip="">
+                  <a:extLst>
+                    <a:ext uri="{A12FA001-AC4F-418D-AE19-62706E023703}">
+                      <ahyp:hlinkClr xmlns:ahyp="http://schemas.microsoft.com/office/drawing/2018/hyperlinkcolor" val="tx"/>
+                    </a:ext>
+                  </a:extLst>
+                </a:hlinkClick>
+              </a:rPr>
+              <a:t>📂 Lampiran</a:t>
+            </a:r>
+            <a:endParaRPr lang="en-US" sz="1000" dirty="0"/>
+          </a:p>
+        </p:txBody>
+      </p:sp>
+      <p:sp>
+        <p:nvSpPr>
+          <p:cNvPr id="5" name="Text 3">
+            <a:hlinkClick r:id="rId2" tooltip="" action="ppaction://hlinksldjump"/>
+          </p:cNvPr>
+          <p:cNvSpPr/>
+          <p:nvPr/>
+        </p:nvSpPr>
+        <p:spPr>
+          <a:xfrm>
             <a:off x="7772400" y="4846320"/>
             <a:ext cx="1097280" cy="0"/>
           </a:xfrm>
@@ -12786,7 +13596,7 @@
                 <a:solidFill>
                   <a:srgbClr val="0563C1"/>
                 </a:solidFill>
-                <a:hlinkClick r:id="rId1" action="ppaction://hlinksldjump" tooltip="">
+                <a:hlinkClick r:id="rId2" action="ppaction://hlinksldjump" tooltip="">
                   <a:extLst>
                     <a:ext uri="{A12FA001-AC4F-418D-AE19-62706E023703}">
                       <ahyp:hlinkClr xmlns:ahyp="http://schemas.microsoft.com/office/drawing/2018/hyperlinkcolor" val="tx"/>
@@ -13047,6 +13857,51 @@
         </p:nvSpPr>
         <p:spPr>
           <a:xfrm>
+            <a:off x="6675120" y="4846320"/>
+            <a:ext cx="1097280" cy="0"/>
+          </a:xfrm>
+          <a:prstGeom prst="rect">
+            <a:avLst/>
+          </a:prstGeom>
+          <a:noFill/>
+          <a:ln/>
+        </p:spPr>
+        <p:txBody>
+          <a:bodyPr wrap="square" rtlCol="0" anchor="ctr"/>
+          <a:lstStyle/>
+          <a:p>
+            <a:pPr algn="r" indent="0" marL="0">
+              <a:buNone/>
+            </a:pPr>
+            <a:r>
+              <a:rPr lang="en-US" sz="1000" u="sng" dirty="0">
+                <a:solidFill>
+                  <a:srgbClr val="0563C1"/>
+                </a:solidFill>
+                <a:hlinkClick r:id="rId1" action="ppaction://hlinksldjump" tooltip="">
+                  <a:extLst>
+                    <a:ext uri="{A12FA001-AC4F-418D-AE19-62706E023703}">
+                      <ahyp:hlinkClr xmlns:ahyp="http://schemas.microsoft.com/office/drawing/2018/hyperlinkcolor" val="tx"/>
+                    </a:ext>
+                  </a:extLst>
+                </a:hlinkClick>
+              </a:rPr>
+              <a:t>📂 Lampiran</a:t>
+            </a:r>
+            <a:endParaRPr lang="en-US" sz="1000" dirty="0"/>
+          </a:p>
+        </p:txBody>
+      </p:sp>
+      <p:sp>
+        <p:nvSpPr>
+          <p:cNvPr id="5" name="Text 3">
+            <a:hlinkClick r:id="rId2" tooltip="" action="ppaction://hlinksldjump"/>
+          </p:cNvPr>
+          <p:cNvSpPr/>
+          <p:nvPr/>
+        </p:nvSpPr>
+        <p:spPr>
+          <a:xfrm>
             <a:off x="7772400" y="4846320"/>
             <a:ext cx="1097280" cy="0"/>
           </a:xfrm>
@@ -13068,7 +13923,7 @@
                 <a:solidFill>
                   <a:srgbClr val="0563C1"/>
                 </a:solidFill>
-                <a:hlinkClick r:id="rId1" action="ppaction://hlinksldjump" tooltip="">
+                <a:hlinkClick r:id="rId2" action="ppaction://hlinksldjump" tooltip="">
                   <a:extLst>
                     <a:ext uri="{A12FA001-AC4F-418D-AE19-62706E023703}">
                       <ahyp:hlinkClr xmlns:ahyp="http://schemas.microsoft.com/office/drawing/2018/hyperlinkcolor" val="tx"/>
@@ -13319,6 +14174,51 @@
         </p:nvSpPr>
         <p:spPr>
           <a:xfrm>
+            <a:off x="6675120" y="4846320"/>
+            <a:ext cx="1097280" cy="0"/>
+          </a:xfrm>
+          <a:prstGeom prst="rect">
+            <a:avLst/>
+          </a:prstGeom>
+          <a:noFill/>
+          <a:ln/>
+        </p:spPr>
+        <p:txBody>
+          <a:bodyPr wrap="square" rtlCol="0" anchor="ctr"/>
+          <a:lstStyle/>
+          <a:p>
+            <a:pPr algn="r" indent="0" marL="0">
+              <a:buNone/>
+            </a:pPr>
+            <a:r>
+              <a:rPr lang="en-US" sz="1000" u="sng" dirty="0">
+                <a:solidFill>
+                  <a:srgbClr val="0563C1"/>
+                </a:solidFill>
+                <a:hlinkClick r:id="rId1" action="ppaction://hlinksldjump" tooltip="">
+                  <a:extLst>
+                    <a:ext uri="{A12FA001-AC4F-418D-AE19-62706E023703}">
+                      <ahyp:hlinkClr xmlns:ahyp="http://schemas.microsoft.com/office/drawing/2018/hyperlinkcolor" val="tx"/>
+                    </a:ext>
+                  </a:extLst>
+                </a:hlinkClick>
+              </a:rPr>
+              <a:t>📂 Lampiran</a:t>
+            </a:r>
+            <a:endParaRPr lang="en-US" sz="1000" dirty="0"/>
+          </a:p>
+        </p:txBody>
+      </p:sp>
+      <p:sp>
+        <p:nvSpPr>
+          <p:cNvPr id="5" name="Text 3">
+            <a:hlinkClick r:id="rId2" tooltip="" action="ppaction://hlinksldjump"/>
+          </p:cNvPr>
+          <p:cNvSpPr/>
+          <p:nvPr/>
+        </p:nvSpPr>
+        <p:spPr>
+          <a:xfrm>
             <a:off x="7772400" y="4846320"/>
             <a:ext cx="1097280" cy="0"/>
           </a:xfrm>
@@ -13340,7 +14240,7 @@
                 <a:solidFill>
                   <a:srgbClr val="0563C1"/>
                 </a:solidFill>
-                <a:hlinkClick r:id="rId1" action="ppaction://hlinksldjump" tooltip="">
+                <a:hlinkClick r:id="rId2" action="ppaction://hlinksldjump" tooltip="">
                   <a:extLst>
                     <a:ext uri="{A12FA001-AC4F-418D-AE19-62706E023703}">
                       <ahyp:hlinkClr xmlns:ahyp="http://schemas.microsoft.com/office/drawing/2018/hyperlinkcolor" val="tx"/>
@@ -14244,6 +15144,51 @@
         </p:nvSpPr>
         <p:spPr>
           <a:xfrm>
+            <a:off x="6675120" y="4846320"/>
+            <a:ext cx="1097280" cy="0"/>
+          </a:xfrm>
+          <a:prstGeom prst="rect">
+            <a:avLst/>
+          </a:prstGeom>
+          <a:noFill/>
+          <a:ln/>
+        </p:spPr>
+        <p:txBody>
+          <a:bodyPr wrap="square" rtlCol="0" anchor="ctr"/>
+          <a:lstStyle/>
+          <a:p>
+            <a:pPr algn="r" indent="0" marL="0">
+              <a:buNone/>
+            </a:pPr>
+            <a:r>
+              <a:rPr lang="en-US" sz="1000" u="sng" dirty="0">
+                <a:solidFill>
+                  <a:srgbClr val="0563C1"/>
+                </a:solidFill>
+                <a:hlinkClick r:id="rId1" action="ppaction://hlinksldjump" tooltip="">
+                  <a:extLst>
+                    <a:ext uri="{A12FA001-AC4F-418D-AE19-62706E023703}">
+                      <ahyp:hlinkClr xmlns:ahyp="http://schemas.microsoft.com/office/drawing/2018/hyperlinkcolor" val="tx"/>
+                    </a:ext>
+                  </a:extLst>
+                </a:hlinkClick>
+              </a:rPr>
+              <a:t>📂 Lampiran</a:t>
+            </a:r>
+            <a:endParaRPr lang="en-US" sz="1000" dirty="0"/>
+          </a:p>
+        </p:txBody>
+      </p:sp>
+      <p:sp>
+        <p:nvSpPr>
+          <p:cNvPr id="5" name="Text 3">
+            <a:hlinkClick r:id="rId2" tooltip="" action="ppaction://hlinksldjump"/>
+          </p:cNvPr>
+          <p:cNvSpPr/>
+          <p:nvPr/>
+        </p:nvSpPr>
+        <p:spPr>
+          <a:xfrm>
             <a:off x="7772400" y="4846320"/>
             <a:ext cx="1097280" cy="0"/>
           </a:xfrm>
@@ -14265,7 +15210,7 @@
                 <a:solidFill>
                   <a:srgbClr val="0563C1"/>
                 </a:solidFill>
-                <a:hlinkClick r:id="rId1" action="ppaction://hlinksldjump" tooltip="">
+                <a:hlinkClick r:id="rId2" action="ppaction://hlinksldjump" tooltip="">
                   <a:extLst>
                     <a:ext uri="{A12FA001-AC4F-418D-AE19-62706E023703}">
                       <ahyp:hlinkClr xmlns:ahyp="http://schemas.microsoft.com/office/drawing/2018/hyperlinkcolor" val="tx"/>
@@ -14604,6 +15549,51 @@
         </p:nvSpPr>
         <p:spPr>
           <a:xfrm>
+            <a:off x="6675120" y="4846320"/>
+            <a:ext cx="1097280" cy="0"/>
+          </a:xfrm>
+          <a:prstGeom prst="rect">
+            <a:avLst/>
+          </a:prstGeom>
+          <a:noFill/>
+          <a:ln/>
+        </p:spPr>
+        <p:txBody>
+          <a:bodyPr wrap="square" rtlCol="0" anchor="ctr"/>
+          <a:lstStyle/>
+          <a:p>
+            <a:pPr algn="r" indent="0" marL="0">
+              <a:buNone/>
+            </a:pPr>
+            <a:r>
+              <a:rPr lang="en-US" sz="1000" u="sng" dirty="0">
+                <a:solidFill>
+                  <a:srgbClr val="0563C1"/>
+                </a:solidFill>
+                <a:hlinkClick r:id="rId1" action="ppaction://hlinksldjump" tooltip="">
+                  <a:extLst>
+                    <a:ext uri="{A12FA001-AC4F-418D-AE19-62706E023703}">
+                      <ahyp:hlinkClr xmlns:ahyp="http://schemas.microsoft.com/office/drawing/2018/hyperlinkcolor" val="tx"/>
+                    </a:ext>
+                  </a:extLst>
+                </a:hlinkClick>
+              </a:rPr>
+              <a:t>📂 Lampiran</a:t>
+            </a:r>
+            <a:endParaRPr lang="en-US" sz="1000" dirty="0"/>
+          </a:p>
+        </p:txBody>
+      </p:sp>
+      <p:sp>
+        <p:nvSpPr>
+          <p:cNvPr id="5" name="Text 3">
+            <a:hlinkClick r:id="rId2" tooltip="" action="ppaction://hlinksldjump"/>
+          </p:cNvPr>
+          <p:cNvSpPr/>
+          <p:nvPr/>
+        </p:nvSpPr>
+        <p:spPr>
+          <a:xfrm>
             <a:off x="7772400" y="4846320"/>
             <a:ext cx="1097280" cy="0"/>
           </a:xfrm>
@@ -14625,7 +15615,7 @@
                 <a:solidFill>
                   <a:srgbClr val="0563C1"/>
                 </a:solidFill>
-                <a:hlinkClick r:id="rId1" action="ppaction://hlinksldjump" tooltip="">
+                <a:hlinkClick r:id="rId2" action="ppaction://hlinksldjump" tooltip="">
                   <a:extLst>
                     <a:ext uri="{A12FA001-AC4F-418D-AE19-62706E023703}">
                       <ahyp:hlinkClr xmlns:ahyp="http://schemas.microsoft.com/office/drawing/2018/hyperlinkcolor" val="tx"/>
@@ -14944,6 +15934,51 @@
         </p:nvSpPr>
         <p:spPr>
           <a:xfrm>
+            <a:off x="6675120" y="4846320"/>
+            <a:ext cx="1097280" cy="0"/>
+          </a:xfrm>
+          <a:prstGeom prst="rect">
+            <a:avLst/>
+          </a:prstGeom>
+          <a:noFill/>
+          <a:ln/>
+        </p:spPr>
+        <p:txBody>
+          <a:bodyPr wrap="square" rtlCol="0" anchor="ctr"/>
+          <a:lstStyle/>
+          <a:p>
+            <a:pPr algn="r" indent="0" marL="0">
+              <a:buNone/>
+            </a:pPr>
+            <a:r>
+              <a:rPr lang="en-US" sz="1000" u="sng" dirty="0">
+                <a:solidFill>
+                  <a:srgbClr val="0563C1"/>
+                </a:solidFill>
+                <a:hlinkClick r:id="rId1" action="ppaction://hlinksldjump" tooltip="">
+                  <a:extLst>
+                    <a:ext uri="{A12FA001-AC4F-418D-AE19-62706E023703}">
+                      <ahyp:hlinkClr xmlns:ahyp="http://schemas.microsoft.com/office/drawing/2018/hyperlinkcolor" val="tx"/>
+                    </a:ext>
+                  </a:extLst>
+                </a:hlinkClick>
+              </a:rPr>
+              <a:t>📂 Lampiran</a:t>
+            </a:r>
+            <a:endParaRPr lang="en-US" sz="1000" dirty="0"/>
+          </a:p>
+        </p:txBody>
+      </p:sp>
+      <p:sp>
+        <p:nvSpPr>
+          <p:cNvPr id="5" name="Text 3">
+            <a:hlinkClick r:id="rId2" tooltip="" action="ppaction://hlinksldjump"/>
+          </p:cNvPr>
+          <p:cNvSpPr/>
+          <p:nvPr/>
+        </p:nvSpPr>
+        <p:spPr>
+          <a:xfrm>
             <a:off x="7772400" y="4846320"/>
             <a:ext cx="1097280" cy="0"/>
           </a:xfrm>
@@ -14965,7 +16000,7 @@
                 <a:solidFill>
                   <a:srgbClr val="0563C1"/>
                 </a:solidFill>
-                <a:hlinkClick r:id="rId1" action="ppaction://hlinksldjump" tooltip="">
+                <a:hlinkClick r:id="rId2" action="ppaction://hlinksldjump" tooltip="">
                   <a:extLst>
                     <a:ext uri="{A12FA001-AC4F-418D-AE19-62706E023703}">
                       <ahyp:hlinkClr xmlns:ahyp="http://schemas.microsoft.com/office/drawing/2018/hyperlinkcolor" val="tx"/>
@@ -15334,6 +16369,51 @@
         </p:nvSpPr>
         <p:spPr>
           <a:xfrm>
+            <a:off x="6675120" y="4846320"/>
+            <a:ext cx="1097280" cy="0"/>
+          </a:xfrm>
+          <a:prstGeom prst="rect">
+            <a:avLst/>
+          </a:prstGeom>
+          <a:noFill/>
+          <a:ln/>
+        </p:spPr>
+        <p:txBody>
+          <a:bodyPr wrap="square" rtlCol="0" anchor="ctr"/>
+          <a:lstStyle/>
+          <a:p>
+            <a:pPr algn="r" indent="0" marL="0">
+              <a:buNone/>
+            </a:pPr>
+            <a:r>
+              <a:rPr lang="en-US" sz="1000" u="sng" dirty="0">
+                <a:solidFill>
+                  <a:srgbClr val="0563C1"/>
+                </a:solidFill>
+                <a:hlinkClick r:id="rId1" action="ppaction://hlinksldjump" tooltip="">
+                  <a:extLst>
+                    <a:ext uri="{A12FA001-AC4F-418D-AE19-62706E023703}">
+                      <ahyp:hlinkClr xmlns:ahyp="http://schemas.microsoft.com/office/drawing/2018/hyperlinkcolor" val="tx"/>
+                    </a:ext>
+                  </a:extLst>
+                </a:hlinkClick>
+              </a:rPr>
+              <a:t>📂 Lampiran</a:t>
+            </a:r>
+            <a:endParaRPr lang="en-US" sz="1000" dirty="0"/>
+          </a:p>
+        </p:txBody>
+      </p:sp>
+      <p:sp>
+        <p:nvSpPr>
+          <p:cNvPr id="5" name="Text 3">
+            <a:hlinkClick r:id="rId2" tooltip="" action="ppaction://hlinksldjump"/>
+          </p:cNvPr>
+          <p:cNvSpPr/>
+          <p:nvPr/>
+        </p:nvSpPr>
+        <p:spPr>
+          <a:xfrm>
             <a:off x="7772400" y="4846320"/>
             <a:ext cx="1097280" cy="0"/>
           </a:xfrm>
@@ -15355,7 +16435,7 @@
                 <a:solidFill>
                   <a:srgbClr val="0563C1"/>
                 </a:solidFill>
-                <a:hlinkClick r:id="rId1" action="ppaction://hlinksldjump" tooltip="">
+                <a:hlinkClick r:id="rId2" action="ppaction://hlinksldjump" tooltip="">
                   <a:extLst>
                     <a:ext uri="{A12FA001-AC4F-418D-AE19-62706E023703}">
                       <ahyp:hlinkClr xmlns:ahyp="http://schemas.microsoft.com/office/drawing/2018/hyperlinkcolor" val="tx"/>
@@ -15668,6 +16748,51 @@
         </p:nvSpPr>
         <p:spPr>
           <a:xfrm>
+            <a:off x="6675120" y="4846320"/>
+            <a:ext cx="1097280" cy="0"/>
+          </a:xfrm>
+          <a:prstGeom prst="rect">
+            <a:avLst/>
+          </a:prstGeom>
+          <a:noFill/>
+          <a:ln/>
+        </p:spPr>
+        <p:txBody>
+          <a:bodyPr wrap="square" rtlCol="0" anchor="ctr"/>
+          <a:lstStyle/>
+          <a:p>
+            <a:pPr algn="r" indent="0" marL="0">
+              <a:buNone/>
+            </a:pPr>
+            <a:r>
+              <a:rPr lang="en-US" sz="1000" u="sng" dirty="0">
+                <a:solidFill>
+                  <a:srgbClr val="0563C1"/>
+                </a:solidFill>
+                <a:hlinkClick r:id="rId1" action="ppaction://hlinksldjump" tooltip="">
+                  <a:extLst>
+                    <a:ext uri="{A12FA001-AC4F-418D-AE19-62706E023703}">
+                      <ahyp:hlinkClr xmlns:ahyp="http://schemas.microsoft.com/office/drawing/2018/hyperlinkcolor" val="tx"/>
+                    </a:ext>
+                  </a:extLst>
+                </a:hlinkClick>
+              </a:rPr>
+              <a:t>📂 Lampiran</a:t>
+            </a:r>
+            <a:endParaRPr lang="en-US" sz="1000" dirty="0"/>
+          </a:p>
+        </p:txBody>
+      </p:sp>
+      <p:sp>
+        <p:nvSpPr>
+          <p:cNvPr id="5" name="Text 3">
+            <a:hlinkClick r:id="rId2" tooltip="" action="ppaction://hlinksldjump"/>
+          </p:cNvPr>
+          <p:cNvSpPr/>
+          <p:nvPr/>
+        </p:nvSpPr>
+        <p:spPr>
+          <a:xfrm>
             <a:off x="7772400" y="4846320"/>
             <a:ext cx="1097280" cy="0"/>
           </a:xfrm>
@@ -15689,7 +16814,7 @@
                 <a:solidFill>
                   <a:srgbClr val="0563C1"/>
                 </a:solidFill>
-                <a:hlinkClick r:id="rId1" action="ppaction://hlinksldjump" tooltip="">
+                <a:hlinkClick r:id="rId2" action="ppaction://hlinksldjump" tooltip="">
                   <a:extLst>
                     <a:ext uri="{A12FA001-AC4F-418D-AE19-62706E023703}">
                       <ahyp:hlinkClr xmlns:ahyp="http://schemas.microsoft.com/office/drawing/2018/hyperlinkcolor" val="tx"/>
@@ -15952,6 +17077,51 @@
         </p:nvSpPr>
         <p:spPr>
           <a:xfrm>
+            <a:off x="6675120" y="4846320"/>
+            <a:ext cx="1097280" cy="0"/>
+          </a:xfrm>
+          <a:prstGeom prst="rect">
+            <a:avLst/>
+          </a:prstGeom>
+          <a:noFill/>
+          <a:ln/>
+        </p:spPr>
+        <p:txBody>
+          <a:bodyPr wrap="square" rtlCol="0" anchor="ctr"/>
+          <a:lstStyle/>
+          <a:p>
+            <a:pPr algn="r" indent="0" marL="0">
+              <a:buNone/>
+            </a:pPr>
+            <a:r>
+              <a:rPr lang="en-US" sz="1000" u="sng" dirty="0">
+                <a:solidFill>
+                  <a:srgbClr val="0563C1"/>
+                </a:solidFill>
+                <a:hlinkClick r:id="rId1" action="ppaction://hlinksldjump" tooltip="">
+                  <a:extLst>
+                    <a:ext uri="{A12FA001-AC4F-418D-AE19-62706E023703}">
+                      <ahyp:hlinkClr xmlns:ahyp="http://schemas.microsoft.com/office/drawing/2018/hyperlinkcolor" val="tx"/>
+                    </a:ext>
+                  </a:extLst>
+                </a:hlinkClick>
+              </a:rPr>
+              <a:t>📂 Lampiran</a:t>
+            </a:r>
+            <a:endParaRPr lang="en-US" sz="1000" dirty="0"/>
+          </a:p>
+        </p:txBody>
+      </p:sp>
+      <p:sp>
+        <p:nvSpPr>
+          <p:cNvPr id="5" name="Text 3">
+            <a:hlinkClick r:id="rId2" tooltip="" action="ppaction://hlinksldjump"/>
+          </p:cNvPr>
+          <p:cNvSpPr/>
+          <p:nvPr/>
+        </p:nvSpPr>
+        <p:spPr>
+          <a:xfrm>
             <a:off x="7772400" y="4846320"/>
             <a:ext cx="1097280" cy="0"/>
           </a:xfrm>
@@ -15973,7 +17143,7 @@
                 <a:solidFill>
                   <a:srgbClr val="0563C1"/>
                 </a:solidFill>
-                <a:hlinkClick r:id="rId1" action="ppaction://hlinksldjump" tooltip="">
+                <a:hlinkClick r:id="rId2" action="ppaction://hlinksldjump" tooltip="">
                   <a:extLst>
                     <a:ext uri="{A12FA001-AC4F-418D-AE19-62706E023703}">
                       <ahyp:hlinkClr xmlns:ahyp="http://schemas.microsoft.com/office/drawing/2018/hyperlinkcolor" val="tx"/>
@@ -16317,6 +17487,51 @@
         </p:nvSpPr>
         <p:spPr>
           <a:xfrm>
+            <a:off x="6675120" y="4846320"/>
+            <a:ext cx="1097280" cy="0"/>
+          </a:xfrm>
+          <a:prstGeom prst="rect">
+            <a:avLst/>
+          </a:prstGeom>
+          <a:noFill/>
+          <a:ln/>
+        </p:spPr>
+        <p:txBody>
+          <a:bodyPr wrap="square" rtlCol="0" anchor="ctr"/>
+          <a:lstStyle/>
+          <a:p>
+            <a:pPr algn="r" indent="0" marL="0">
+              <a:buNone/>
+            </a:pPr>
+            <a:r>
+              <a:rPr lang="en-US" sz="1000" u="sng" dirty="0">
+                <a:solidFill>
+                  <a:srgbClr val="0563C1"/>
+                </a:solidFill>
+                <a:hlinkClick r:id="rId1" action="ppaction://hlinksldjump" tooltip="">
+                  <a:extLst>
+                    <a:ext uri="{A12FA001-AC4F-418D-AE19-62706E023703}">
+                      <ahyp:hlinkClr xmlns:ahyp="http://schemas.microsoft.com/office/drawing/2018/hyperlinkcolor" val="tx"/>
+                    </a:ext>
+                  </a:extLst>
+                </a:hlinkClick>
+              </a:rPr>
+              <a:t>📂 Lampiran</a:t>
+            </a:r>
+            <a:endParaRPr lang="en-US" sz="1000" dirty="0"/>
+          </a:p>
+        </p:txBody>
+      </p:sp>
+      <p:sp>
+        <p:nvSpPr>
+          <p:cNvPr id="5" name="Text 3">
+            <a:hlinkClick r:id="rId2" tooltip="" action="ppaction://hlinksldjump"/>
+          </p:cNvPr>
+          <p:cNvSpPr/>
+          <p:nvPr/>
+        </p:nvSpPr>
+        <p:spPr>
+          <a:xfrm>
             <a:off x="7772400" y="4846320"/>
             <a:ext cx="1097280" cy="0"/>
           </a:xfrm>
@@ -16338,7 +17553,7 @@
                 <a:solidFill>
                   <a:srgbClr val="0563C1"/>
                 </a:solidFill>
-                <a:hlinkClick r:id="rId1" action="ppaction://hlinksldjump" tooltip="">
+                <a:hlinkClick r:id="rId2" action="ppaction://hlinksldjump" tooltip="">
                   <a:extLst>
                     <a:ext uri="{A12FA001-AC4F-418D-AE19-62706E023703}">
                       <ahyp:hlinkClr xmlns:ahyp="http://schemas.microsoft.com/office/drawing/2018/hyperlinkcolor" val="tx"/>
@@ -16671,6 +17886,51 @@
         </p:nvSpPr>
         <p:spPr>
           <a:xfrm>
+            <a:off x="6675120" y="4846320"/>
+            <a:ext cx="1097280" cy="0"/>
+          </a:xfrm>
+          <a:prstGeom prst="rect">
+            <a:avLst/>
+          </a:prstGeom>
+          <a:noFill/>
+          <a:ln/>
+        </p:spPr>
+        <p:txBody>
+          <a:bodyPr wrap="square" rtlCol="0" anchor="ctr"/>
+          <a:lstStyle/>
+          <a:p>
+            <a:pPr algn="r" indent="0" marL="0">
+              <a:buNone/>
+            </a:pPr>
+            <a:r>
+              <a:rPr lang="en-US" sz="1000" u="sng" dirty="0">
+                <a:solidFill>
+                  <a:srgbClr val="0563C1"/>
+                </a:solidFill>
+                <a:hlinkClick r:id="rId1" action="ppaction://hlinksldjump" tooltip="">
+                  <a:extLst>
+                    <a:ext uri="{A12FA001-AC4F-418D-AE19-62706E023703}">
+                      <ahyp:hlinkClr xmlns:ahyp="http://schemas.microsoft.com/office/drawing/2018/hyperlinkcolor" val="tx"/>
+                    </a:ext>
+                  </a:extLst>
+                </a:hlinkClick>
+              </a:rPr>
+              <a:t>📂 Lampiran</a:t>
+            </a:r>
+            <a:endParaRPr lang="en-US" sz="1000" dirty="0"/>
+          </a:p>
+        </p:txBody>
+      </p:sp>
+      <p:sp>
+        <p:nvSpPr>
+          <p:cNvPr id="5" name="Text 3">
+            <a:hlinkClick r:id="rId2" tooltip="" action="ppaction://hlinksldjump"/>
+          </p:cNvPr>
+          <p:cNvSpPr/>
+          <p:nvPr/>
+        </p:nvSpPr>
+        <p:spPr>
+          <a:xfrm>
             <a:off x="7772400" y="4846320"/>
             <a:ext cx="1097280" cy="0"/>
           </a:xfrm>
@@ -16692,7 +17952,7 @@
                 <a:solidFill>
                   <a:srgbClr val="0563C1"/>
                 </a:solidFill>
-                <a:hlinkClick r:id="rId1" action="ppaction://hlinksldjump" tooltip="">
+                <a:hlinkClick r:id="rId2" action="ppaction://hlinksldjump" tooltip="">
                   <a:extLst>
                     <a:ext uri="{A12FA001-AC4F-418D-AE19-62706E023703}">
                       <ahyp:hlinkClr xmlns:ahyp="http://schemas.microsoft.com/office/drawing/2018/hyperlinkcolor" val="tx"/>
@@ -17077,6 +18337,51 @@
         </p:nvSpPr>
         <p:spPr>
           <a:xfrm>
+            <a:off x="6675120" y="4846320"/>
+            <a:ext cx="1097280" cy="0"/>
+          </a:xfrm>
+          <a:prstGeom prst="rect">
+            <a:avLst/>
+          </a:prstGeom>
+          <a:noFill/>
+          <a:ln/>
+        </p:spPr>
+        <p:txBody>
+          <a:bodyPr wrap="square" rtlCol="0" anchor="ctr"/>
+          <a:lstStyle/>
+          <a:p>
+            <a:pPr algn="r" indent="0" marL="0">
+              <a:buNone/>
+            </a:pPr>
+            <a:r>
+              <a:rPr lang="en-US" sz="1000" u="sng" dirty="0">
+                <a:solidFill>
+                  <a:srgbClr val="0563C1"/>
+                </a:solidFill>
+                <a:hlinkClick r:id="rId1" action="ppaction://hlinksldjump" tooltip="">
+                  <a:extLst>
+                    <a:ext uri="{A12FA001-AC4F-418D-AE19-62706E023703}">
+                      <ahyp:hlinkClr xmlns:ahyp="http://schemas.microsoft.com/office/drawing/2018/hyperlinkcolor" val="tx"/>
+                    </a:ext>
+                  </a:extLst>
+                </a:hlinkClick>
+              </a:rPr>
+              <a:t>📂 Lampiran</a:t>
+            </a:r>
+            <a:endParaRPr lang="en-US" sz="1000" dirty="0"/>
+          </a:p>
+        </p:txBody>
+      </p:sp>
+      <p:sp>
+        <p:nvSpPr>
+          <p:cNvPr id="5" name="Text 3">
+            <a:hlinkClick r:id="rId2" tooltip="" action="ppaction://hlinksldjump"/>
+          </p:cNvPr>
+          <p:cNvSpPr/>
+          <p:nvPr/>
+        </p:nvSpPr>
+        <p:spPr>
+          <a:xfrm>
             <a:off x="7772400" y="4846320"/>
             <a:ext cx="1097280" cy="0"/>
           </a:xfrm>
@@ -17098,7 +18403,7 @@
                 <a:solidFill>
                   <a:srgbClr val="0563C1"/>
                 </a:solidFill>
-                <a:hlinkClick r:id="rId1" action="ppaction://hlinksldjump" tooltip="">
+                <a:hlinkClick r:id="rId2" action="ppaction://hlinksldjump" tooltip="">
                   <a:extLst>
                     <a:ext uri="{A12FA001-AC4F-418D-AE19-62706E023703}">
                       <ahyp:hlinkClr xmlns:ahyp="http://schemas.microsoft.com/office/drawing/2018/hyperlinkcolor" val="tx"/>
@@ -17439,6 +18744,51 @@
         </p:nvSpPr>
         <p:spPr>
           <a:xfrm>
+            <a:off x="6675120" y="4846320"/>
+            <a:ext cx="1097280" cy="0"/>
+          </a:xfrm>
+          <a:prstGeom prst="rect">
+            <a:avLst/>
+          </a:prstGeom>
+          <a:noFill/>
+          <a:ln/>
+        </p:spPr>
+        <p:txBody>
+          <a:bodyPr wrap="square" rtlCol="0" anchor="ctr"/>
+          <a:lstStyle/>
+          <a:p>
+            <a:pPr algn="r" indent="0" marL="0">
+              <a:buNone/>
+            </a:pPr>
+            <a:r>
+              <a:rPr lang="en-US" sz="1000" u="sng" dirty="0">
+                <a:solidFill>
+                  <a:srgbClr val="0563C1"/>
+                </a:solidFill>
+                <a:hlinkClick r:id="rId1" action="ppaction://hlinksldjump" tooltip="">
+                  <a:extLst>
+                    <a:ext uri="{A12FA001-AC4F-418D-AE19-62706E023703}">
+                      <ahyp:hlinkClr xmlns:ahyp="http://schemas.microsoft.com/office/drawing/2018/hyperlinkcolor" val="tx"/>
+                    </a:ext>
+                  </a:extLst>
+                </a:hlinkClick>
+              </a:rPr>
+              <a:t>📂 Lampiran</a:t>
+            </a:r>
+            <a:endParaRPr lang="en-US" sz="1000" dirty="0"/>
+          </a:p>
+        </p:txBody>
+      </p:sp>
+      <p:sp>
+        <p:nvSpPr>
+          <p:cNvPr id="5" name="Text 3">
+            <a:hlinkClick r:id="rId2" tooltip="" action="ppaction://hlinksldjump"/>
+          </p:cNvPr>
+          <p:cNvSpPr/>
+          <p:nvPr/>
+        </p:nvSpPr>
+        <p:spPr>
+          <a:xfrm>
             <a:off x="7772400" y="4846320"/>
             <a:ext cx="1097280" cy="0"/>
           </a:xfrm>
@@ -17460,7 +18810,7 @@
                 <a:solidFill>
                   <a:srgbClr val="0563C1"/>
                 </a:solidFill>
-                <a:hlinkClick r:id="rId1" action="ppaction://hlinksldjump" tooltip="">
+                <a:hlinkClick r:id="rId2" action="ppaction://hlinksldjump" tooltip="">
                   <a:extLst>
                     <a:ext uri="{A12FA001-AC4F-418D-AE19-62706E023703}">
                       <ahyp:hlinkClr xmlns:ahyp="http://schemas.microsoft.com/office/drawing/2018/hyperlinkcolor" val="tx"/>
@@ -17678,6 +19028,51 @@
         </p:nvSpPr>
         <p:spPr>
           <a:xfrm>
+            <a:off x="6675120" y="4846320"/>
+            <a:ext cx="1097280" cy="0"/>
+          </a:xfrm>
+          <a:prstGeom prst="rect">
+            <a:avLst/>
+          </a:prstGeom>
+          <a:noFill/>
+          <a:ln/>
+        </p:spPr>
+        <p:txBody>
+          <a:bodyPr wrap="square" rtlCol="0" anchor="ctr"/>
+          <a:lstStyle/>
+          <a:p>
+            <a:pPr algn="r" indent="0" marL="0">
+              <a:buNone/>
+            </a:pPr>
+            <a:r>
+              <a:rPr lang="en-US" sz="1000" u="sng" dirty="0">
+                <a:solidFill>
+                  <a:srgbClr val="0563C1"/>
+                </a:solidFill>
+                <a:hlinkClick r:id="rId1" action="ppaction://hlinksldjump" tooltip="">
+                  <a:extLst>
+                    <a:ext uri="{A12FA001-AC4F-418D-AE19-62706E023703}">
+                      <ahyp:hlinkClr xmlns:ahyp="http://schemas.microsoft.com/office/drawing/2018/hyperlinkcolor" val="tx"/>
+                    </a:ext>
+                  </a:extLst>
+                </a:hlinkClick>
+              </a:rPr>
+              <a:t>📂 Lampiran</a:t>
+            </a:r>
+            <a:endParaRPr lang="en-US" sz="1000" dirty="0"/>
+          </a:p>
+        </p:txBody>
+      </p:sp>
+      <p:sp>
+        <p:nvSpPr>
+          <p:cNvPr id="5" name="Text 3">
+            <a:hlinkClick r:id="rId2" tooltip="" action="ppaction://hlinksldjump"/>
+          </p:cNvPr>
+          <p:cNvSpPr/>
+          <p:nvPr/>
+        </p:nvSpPr>
+        <p:spPr>
+          <a:xfrm>
             <a:off x="7772400" y="4846320"/>
             <a:ext cx="1097280" cy="0"/>
           </a:xfrm>
@@ -17699,7 +19094,7 @@
                 <a:solidFill>
                   <a:srgbClr val="0563C1"/>
                 </a:solidFill>
-                <a:hlinkClick r:id="rId1" action="ppaction://hlinksldjump" tooltip="">
+                <a:hlinkClick r:id="rId2" action="ppaction://hlinksldjump" tooltip="">
                   <a:extLst>
                     <a:ext uri="{A12FA001-AC4F-418D-AE19-62706E023703}">
                       <ahyp:hlinkClr xmlns:ahyp="http://schemas.microsoft.com/office/drawing/2018/hyperlinkcolor" val="tx"/>
@@ -18090,6 +19485,51 @@
         </p:nvSpPr>
         <p:spPr>
           <a:xfrm>
+            <a:off x="6675120" y="4846320"/>
+            <a:ext cx="1097280" cy="0"/>
+          </a:xfrm>
+          <a:prstGeom prst="rect">
+            <a:avLst/>
+          </a:prstGeom>
+          <a:noFill/>
+          <a:ln/>
+        </p:spPr>
+        <p:txBody>
+          <a:bodyPr wrap="square" rtlCol="0" anchor="ctr"/>
+          <a:lstStyle/>
+          <a:p>
+            <a:pPr algn="r" indent="0" marL="0">
+              <a:buNone/>
+            </a:pPr>
+            <a:r>
+              <a:rPr lang="en-US" sz="1000" u="sng" dirty="0">
+                <a:solidFill>
+                  <a:srgbClr val="0563C1"/>
+                </a:solidFill>
+                <a:hlinkClick r:id="rId1" action="ppaction://hlinksldjump" tooltip="">
+                  <a:extLst>
+                    <a:ext uri="{A12FA001-AC4F-418D-AE19-62706E023703}">
+                      <ahyp:hlinkClr xmlns:ahyp="http://schemas.microsoft.com/office/drawing/2018/hyperlinkcolor" val="tx"/>
+                    </a:ext>
+                  </a:extLst>
+                </a:hlinkClick>
+              </a:rPr>
+              <a:t>📂 Lampiran</a:t>
+            </a:r>
+            <a:endParaRPr lang="en-US" sz="1000" dirty="0"/>
+          </a:p>
+        </p:txBody>
+      </p:sp>
+      <p:sp>
+        <p:nvSpPr>
+          <p:cNvPr id="5" name="Text 3">
+            <a:hlinkClick r:id="rId2" tooltip="" action="ppaction://hlinksldjump"/>
+          </p:cNvPr>
+          <p:cNvSpPr/>
+          <p:nvPr/>
+        </p:nvSpPr>
+        <p:spPr>
+          <a:xfrm>
             <a:off x="7772400" y="4846320"/>
             <a:ext cx="1097280" cy="0"/>
           </a:xfrm>
@@ -18111,7 +19551,7 @@
                 <a:solidFill>
                   <a:srgbClr val="0563C1"/>
                 </a:solidFill>
-                <a:hlinkClick r:id="rId1" action="ppaction://hlinksldjump" tooltip="">
+                <a:hlinkClick r:id="rId2" action="ppaction://hlinksldjump" tooltip="">
                   <a:extLst>
                     <a:ext uri="{A12FA001-AC4F-418D-AE19-62706E023703}">
                       <ahyp:hlinkClr xmlns:ahyp="http://schemas.microsoft.com/office/drawing/2018/hyperlinkcolor" val="tx"/>
@@ -18439,6 +19879,51 @@
         </p:nvSpPr>
         <p:spPr>
           <a:xfrm>
+            <a:off x="6675120" y="4846320"/>
+            <a:ext cx="1097280" cy="0"/>
+          </a:xfrm>
+          <a:prstGeom prst="rect">
+            <a:avLst/>
+          </a:prstGeom>
+          <a:noFill/>
+          <a:ln/>
+        </p:spPr>
+        <p:txBody>
+          <a:bodyPr wrap="square" rtlCol="0" anchor="ctr"/>
+          <a:lstStyle/>
+          <a:p>
+            <a:pPr algn="r" indent="0" marL="0">
+              <a:buNone/>
+            </a:pPr>
+            <a:r>
+              <a:rPr lang="en-US" sz="1000" u="sng" dirty="0">
+                <a:solidFill>
+                  <a:srgbClr val="0563C1"/>
+                </a:solidFill>
+                <a:hlinkClick r:id="rId1" action="ppaction://hlinksldjump" tooltip="">
+                  <a:extLst>
+                    <a:ext uri="{A12FA001-AC4F-418D-AE19-62706E023703}">
+                      <ahyp:hlinkClr xmlns:ahyp="http://schemas.microsoft.com/office/drawing/2018/hyperlinkcolor" val="tx"/>
+                    </a:ext>
+                  </a:extLst>
+                </a:hlinkClick>
+              </a:rPr>
+              <a:t>📂 Lampiran</a:t>
+            </a:r>
+            <a:endParaRPr lang="en-US" sz="1000" dirty="0"/>
+          </a:p>
+        </p:txBody>
+      </p:sp>
+      <p:sp>
+        <p:nvSpPr>
+          <p:cNvPr id="5" name="Text 3">
+            <a:hlinkClick r:id="rId2" tooltip="" action="ppaction://hlinksldjump"/>
+          </p:cNvPr>
+          <p:cNvSpPr/>
+          <p:nvPr/>
+        </p:nvSpPr>
+        <p:spPr>
+          <a:xfrm>
             <a:off x="7772400" y="4846320"/>
             <a:ext cx="1097280" cy="0"/>
           </a:xfrm>
@@ -18460,7 +19945,7 @@
                 <a:solidFill>
                   <a:srgbClr val="0563C1"/>
                 </a:solidFill>
-                <a:hlinkClick r:id="rId1" action="ppaction://hlinksldjump" tooltip="">
+                <a:hlinkClick r:id="rId2" action="ppaction://hlinksldjump" tooltip="">
                   <a:extLst>
                     <a:ext uri="{A12FA001-AC4F-418D-AE19-62706E023703}">
                       <ahyp:hlinkClr xmlns:ahyp="http://schemas.microsoft.com/office/drawing/2018/hyperlinkcolor" val="tx"/>
@@ -18768,6 +20253,51 @@
         </p:nvSpPr>
         <p:spPr>
           <a:xfrm>
+            <a:off x="6675120" y="4846320"/>
+            <a:ext cx="1097280" cy="0"/>
+          </a:xfrm>
+          <a:prstGeom prst="rect">
+            <a:avLst/>
+          </a:prstGeom>
+          <a:noFill/>
+          <a:ln/>
+        </p:spPr>
+        <p:txBody>
+          <a:bodyPr wrap="square" rtlCol="0" anchor="ctr"/>
+          <a:lstStyle/>
+          <a:p>
+            <a:pPr algn="r" indent="0" marL="0">
+              <a:buNone/>
+            </a:pPr>
+            <a:r>
+              <a:rPr lang="en-US" sz="1000" u="sng" dirty="0">
+                <a:solidFill>
+                  <a:srgbClr val="0563C1"/>
+                </a:solidFill>
+                <a:hlinkClick r:id="rId1" action="ppaction://hlinksldjump" tooltip="">
+                  <a:extLst>
+                    <a:ext uri="{A12FA001-AC4F-418D-AE19-62706E023703}">
+                      <ahyp:hlinkClr xmlns:ahyp="http://schemas.microsoft.com/office/drawing/2018/hyperlinkcolor" val="tx"/>
+                    </a:ext>
+                  </a:extLst>
+                </a:hlinkClick>
+              </a:rPr>
+              <a:t>📂 Lampiran</a:t>
+            </a:r>
+            <a:endParaRPr lang="en-US" sz="1000" dirty="0"/>
+          </a:p>
+        </p:txBody>
+      </p:sp>
+      <p:sp>
+        <p:nvSpPr>
+          <p:cNvPr id="5" name="Text 3">
+            <a:hlinkClick r:id="rId2" tooltip="" action="ppaction://hlinksldjump"/>
+          </p:cNvPr>
+          <p:cNvSpPr/>
+          <p:nvPr/>
+        </p:nvSpPr>
+        <p:spPr>
+          <a:xfrm>
             <a:off x="7772400" y="4846320"/>
             <a:ext cx="1097280" cy="0"/>
           </a:xfrm>
@@ -18789,7 +20319,7 @@
                 <a:solidFill>
                   <a:srgbClr val="0563C1"/>
                 </a:solidFill>
-                <a:hlinkClick r:id="rId1" action="ppaction://hlinksldjump" tooltip="">
+                <a:hlinkClick r:id="rId2" action="ppaction://hlinksldjump" tooltip="">
                   <a:extLst>
                     <a:ext uri="{A12FA001-AC4F-418D-AE19-62706E023703}">
                       <ahyp:hlinkClr xmlns:ahyp="http://schemas.microsoft.com/office/drawing/2018/hyperlinkcolor" val="tx"/>
@@ -19096,6 +20626,51 @@
         </p:nvSpPr>
         <p:spPr>
           <a:xfrm>
+            <a:off x="6675120" y="4846320"/>
+            <a:ext cx="1097280" cy="0"/>
+          </a:xfrm>
+          <a:prstGeom prst="rect">
+            <a:avLst/>
+          </a:prstGeom>
+          <a:noFill/>
+          <a:ln/>
+        </p:spPr>
+        <p:txBody>
+          <a:bodyPr wrap="square" rtlCol="0" anchor="ctr"/>
+          <a:lstStyle/>
+          <a:p>
+            <a:pPr algn="r" indent="0" marL="0">
+              <a:buNone/>
+            </a:pPr>
+            <a:r>
+              <a:rPr lang="en-US" sz="1000" u="sng" dirty="0">
+                <a:solidFill>
+                  <a:srgbClr val="0563C1"/>
+                </a:solidFill>
+                <a:hlinkClick r:id="rId1" action="ppaction://hlinksldjump" tooltip="">
+                  <a:extLst>
+                    <a:ext uri="{A12FA001-AC4F-418D-AE19-62706E023703}">
+                      <ahyp:hlinkClr xmlns:ahyp="http://schemas.microsoft.com/office/drawing/2018/hyperlinkcolor" val="tx"/>
+                    </a:ext>
+                  </a:extLst>
+                </a:hlinkClick>
+              </a:rPr>
+              <a:t>📂 Lampiran</a:t>
+            </a:r>
+            <a:endParaRPr lang="en-US" sz="1000" dirty="0"/>
+          </a:p>
+        </p:txBody>
+      </p:sp>
+      <p:sp>
+        <p:nvSpPr>
+          <p:cNvPr id="5" name="Text 3">
+            <a:hlinkClick r:id="rId2" tooltip="" action="ppaction://hlinksldjump"/>
+          </p:cNvPr>
+          <p:cNvSpPr/>
+          <p:nvPr/>
+        </p:nvSpPr>
+        <p:spPr>
+          <a:xfrm>
             <a:off x="7772400" y="4846320"/>
             <a:ext cx="1097280" cy="0"/>
           </a:xfrm>
@@ -19117,7 +20692,7 @@
                 <a:solidFill>
                   <a:srgbClr val="0563C1"/>
                 </a:solidFill>
-                <a:hlinkClick r:id="rId1" action="ppaction://hlinksldjump" tooltip="">
+                <a:hlinkClick r:id="rId2" action="ppaction://hlinksldjump" tooltip="">
                   <a:extLst>
                     <a:ext uri="{A12FA001-AC4F-418D-AE19-62706E023703}">
                       <ahyp:hlinkClr xmlns:ahyp="http://schemas.microsoft.com/office/drawing/2018/hyperlinkcolor" val="tx"/>
@@ -19378,6 +20953,51 @@
         </p:nvSpPr>
         <p:spPr>
           <a:xfrm>
+            <a:off x="6675120" y="4846320"/>
+            <a:ext cx="1097280" cy="0"/>
+          </a:xfrm>
+          <a:prstGeom prst="rect">
+            <a:avLst/>
+          </a:prstGeom>
+          <a:noFill/>
+          <a:ln/>
+        </p:spPr>
+        <p:txBody>
+          <a:bodyPr wrap="square" rtlCol="0" anchor="ctr"/>
+          <a:lstStyle/>
+          <a:p>
+            <a:pPr algn="r" indent="0" marL="0">
+              <a:buNone/>
+            </a:pPr>
+            <a:r>
+              <a:rPr lang="en-US" sz="1000" u="sng" dirty="0">
+                <a:solidFill>
+                  <a:srgbClr val="0563C1"/>
+                </a:solidFill>
+                <a:hlinkClick r:id="rId1" action="ppaction://hlinksldjump" tooltip="">
+                  <a:extLst>
+                    <a:ext uri="{A12FA001-AC4F-418D-AE19-62706E023703}">
+                      <ahyp:hlinkClr xmlns:ahyp="http://schemas.microsoft.com/office/drawing/2018/hyperlinkcolor" val="tx"/>
+                    </a:ext>
+                  </a:extLst>
+                </a:hlinkClick>
+              </a:rPr>
+              <a:t>📂 Lampiran</a:t>
+            </a:r>
+            <a:endParaRPr lang="en-US" sz="1000" dirty="0"/>
+          </a:p>
+        </p:txBody>
+      </p:sp>
+      <p:sp>
+        <p:nvSpPr>
+          <p:cNvPr id="5" name="Text 3">
+            <a:hlinkClick r:id="rId2" tooltip="" action="ppaction://hlinksldjump"/>
+          </p:cNvPr>
+          <p:cNvSpPr/>
+          <p:nvPr/>
+        </p:nvSpPr>
+        <p:spPr>
+          <a:xfrm>
             <a:off x="7772400" y="4846320"/>
             <a:ext cx="1097280" cy="0"/>
           </a:xfrm>
@@ -19399,7 +21019,7 @@
                 <a:solidFill>
                   <a:srgbClr val="0563C1"/>
                 </a:solidFill>
-                <a:hlinkClick r:id="rId1" action="ppaction://hlinksldjump" tooltip="">
+                <a:hlinkClick r:id="rId2" action="ppaction://hlinksldjump" tooltip="">
                   <a:extLst>
                     <a:ext uri="{A12FA001-AC4F-418D-AE19-62706E023703}">
                       <ahyp:hlinkClr xmlns:ahyp="http://schemas.microsoft.com/office/drawing/2018/hyperlinkcolor" val="tx"/>
@@ -19696,6 +21316,51 @@
         </p:nvSpPr>
         <p:spPr>
           <a:xfrm>
+            <a:off x="6675120" y="4846320"/>
+            <a:ext cx="1097280" cy="0"/>
+          </a:xfrm>
+          <a:prstGeom prst="rect">
+            <a:avLst/>
+          </a:prstGeom>
+          <a:noFill/>
+          <a:ln/>
+        </p:spPr>
+        <p:txBody>
+          <a:bodyPr wrap="square" rtlCol="0" anchor="ctr"/>
+          <a:lstStyle/>
+          <a:p>
+            <a:pPr algn="r" indent="0" marL="0">
+              <a:buNone/>
+            </a:pPr>
+            <a:r>
+              <a:rPr lang="en-US" sz="1000" u="sng" dirty="0">
+                <a:solidFill>
+                  <a:srgbClr val="0563C1"/>
+                </a:solidFill>
+                <a:hlinkClick r:id="rId1" action="ppaction://hlinksldjump" tooltip="">
+                  <a:extLst>
+                    <a:ext uri="{A12FA001-AC4F-418D-AE19-62706E023703}">
+                      <ahyp:hlinkClr xmlns:ahyp="http://schemas.microsoft.com/office/drawing/2018/hyperlinkcolor" val="tx"/>
+                    </a:ext>
+                  </a:extLst>
+                </a:hlinkClick>
+              </a:rPr>
+              <a:t>📂 Lampiran</a:t>
+            </a:r>
+            <a:endParaRPr lang="en-US" sz="1000" dirty="0"/>
+          </a:p>
+        </p:txBody>
+      </p:sp>
+      <p:sp>
+        <p:nvSpPr>
+          <p:cNvPr id="5" name="Text 3">
+            <a:hlinkClick r:id="rId2" tooltip="" action="ppaction://hlinksldjump"/>
+          </p:cNvPr>
+          <p:cNvSpPr/>
+          <p:nvPr/>
+        </p:nvSpPr>
+        <p:spPr>
+          <a:xfrm>
             <a:off x="7772400" y="4846320"/>
             <a:ext cx="1097280" cy="0"/>
           </a:xfrm>
@@ -19717,7 +21382,7 @@
                 <a:solidFill>
                   <a:srgbClr val="0563C1"/>
                 </a:solidFill>
-                <a:hlinkClick r:id="rId1" action="ppaction://hlinksldjump" tooltip="">
+                <a:hlinkClick r:id="rId2" action="ppaction://hlinksldjump" tooltip="">
                   <a:extLst>
                     <a:ext uri="{A12FA001-AC4F-418D-AE19-62706E023703}">
                       <ahyp:hlinkClr xmlns:ahyp="http://schemas.microsoft.com/office/drawing/2018/hyperlinkcolor" val="tx"/>
@@ -19950,6 +21615,51 @@
         </p:nvSpPr>
         <p:spPr>
           <a:xfrm>
+            <a:off x="6675120" y="4846320"/>
+            <a:ext cx="1097280" cy="0"/>
+          </a:xfrm>
+          <a:prstGeom prst="rect">
+            <a:avLst/>
+          </a:prstGeom>
+          <a:noFill/>
+          <a:ln/>
+        </p:spPr>
+        <p:txBody>
+          <a:bodyPr wrap="square" rtlCol="0" anchor="ctr"/>
+          <a:lstStyle/>
+          <a:p>
+            <a:pPr algn="r" indent="0" marL="0">
+              <a:buNone/>
+            </a:pPr>
+            <a:r>
+              <a:rPr lang="en-US" sz="1000" u="sng" dirty="0">
+                <a:solidFill>
+                  <a:srgbClr val="0563C1"/>
+                </a:solidFill>
+                <a:hlinkClick r:id="rId1" action="ppaction://hlinksldjump" tooltip="">
+                  <a:extLst>
+                    <a:ext uri="{A12FA001-AC4F-418D-AE19-62706E023703}">
+                      <ahyp:hlinkClr xmlns:ahyp="http://schemas.microsoft.com/office/drawing/2018/hyperlinkcolor" val="tx"/>
+                    </a:ext>
+                  </a:extLst>
+                </a:hlinkClick>
+              </a:rPr>
+              <a:t>📂 Lampiran</a:t>
+            </a:r>
+            <a:endParaRPr lang="en-US" sz="1000" dirty="0"/>
+          </a:p>
+        </p:txBody>
+      </p:sp>
+      <p:sp>
+        <p:nvSpPr>
+          <p:cNvPr id="5" name="Text 3">
+            <a:hlinkClick r:id="rId2" tooltip="" action="ppaction://hlinksldjump"/>
+          </p:cNvPr>
+          <p:cNvSpPr/>
+          <p:nvPr/>
+        </p:nvSpPr>
+        <p:spPr>
+          <a:xfrm>
             <a:off x="7772400" y="4846320"/>
             <a:ext cx="1097280" cy="0"/>
           </a:xfrm>
@@ -19971,7 +21681,7 @@
                 <a:solidFill>
                   <a:srgbClr val="0563C1"/>
                 </a:solidFill>
-                <a:hlinkClick r:id="rId1" action="ppaction://hlinksldjump" tooltip="">
+                <a:hlinkClick r:id="rId2" action="ppaction://hlinksldjump" tooltip="">
                   <a:extLst>
                     <a:ext uri="{A12FA001-AC4F-418D-AE19-62706E023703}">
                       <ahyp:hlinkClr xmlns:ahyp="http://schemas.microsoft.com/office/drawing/2018/hyperlinkcolor" val="tx"/>
@@ -20262,6 +21972,51 @@
         </p:nvSpPr>
         <p:spPr>
           <a:xfrm>
+            <a:off x="6675120" y="4846320"/>
+            <a:ext cx="1097280" cy="0"/>
+          </a:xfrm>
+          <a:prstGeom prst="rect">
+            <a:avLst/>
+          </a:prstGeom>
+          <a:noFill/>
+          <a:ln/>
+        </p:spPr>
+        <p:txBody>
+          <a:bodyPr wrap="square" rtlCol="0" anchor="ctr"/>
+          <a:lstStyle/>
+          <a:p>
+            <a:pPr algn="r" indent="0" marL="0">
+              <a:buNone/>
+            </a:pPr>
+            <a:r>
+              <a:rPr lang="en-US" sz="1000" u="sng" dirty="0">
+                <a:solidFill>
+                  <a:srgbClr val="0563C1"/>
+                </a:solidFill>
+                <a:hlinkClick r:id="rId1" action="ppaction://hlinksldjump" tooltip="">
+                  <a:extLst>
+                    <a:ext uri="{A12FA001-AC4F-418D-AE19-62706E023703}">
+                      <ahyp:hlinkClr xmlns:ahyp="http://schemas.microsoft.com/office/drawing/2018/hyperlinkcolor" val="tx"/>
+                    </a:ext>
+                  </a:extLst>
+                </a:hlinkClick>
+              </a:rPr>
+              <a:t>📂 Lampiran</a:t>
+            </a:r>
+            <a:endParaRPr lang="en-US" sz="1000" dirty="0"/>
+          </a:p>
+        </p:txBody>
+      </p:sp>
+      <p:sp>
+        <p:nvSpPr>
+          <p:cNvPr id="5" name="Text 3">
+            <a:hlinkClick r:id="rId2" tooltip="" action="ppaction://hlinksldjump"/>
+          </p:cNvPr>
+          <p:cNvSpPr/>
+          <p:nvPr/>
+        </p:nvSpPr>
+        <p:spPr>
+          <a:xfrm>
             <a:off x="7772400" y="4846320"/>
             <a:ext cx="1097280" cy="0"/>
           </a:xfrm>
@@ -20283,7 +22038,7 @@
                 <a:solidFill>
                   <a:srgbClr val="0563C1"/>
                 </a:solidFill>
-                <a:hlinkClick r:id="rId1" action="ppaction://hlinksldjump" tooltip="">
+                <a:hlinkClick r:id="rId2" action="ppaction://hlinksldjump" tooltip="">
                   <a:extLst>
                     <a:ext uri="{A12FA001-AC4F-418D-AE19-62706E023703}">
                       <ahyp:hlinkClr xmlns:ahyp="http://schemas.microsoft.com/office/drawing/2018/hyperlinkcolor" val="tx"/>
@@ -20594,7 +22349,7 @@
         </p:nvSpPr>
         <p:spPr>
           <a:xfrm>
-            <a:off x="7772400" y="4846320"/>
+            <a:off x="6675120" y="4846320"/>
             <a:ext cx="1097280" cy="0"/>
           </a:xfrm>
           <a:prstGeom prst="rect">
@@ -20623,7 +22378,7 @@
                   </a:extLst>
                 </a:hlinkClick>
               </a:rPr>
-              <a:t>🏠 Daftar Isi</a:t>
+              <a:t>📂 Lampiran</a:t>
             </a:r>
             <a:endParaRPr lang="en-US" sz="1000" dirty="0"/>
           </a:p>
@@ -20661,6 +22416,96 @@
                   <a:srgbClr val="0563C1"/>
                 </a:solidFill>
                 <a:hlinkClick r:id="rId2" action="ppaction://hlinksldjump" tooltip="">
+                  <a:extLst>
+                    <a:ext uri="{A12FA001-AC4F-418D-AE19-62706E023703}">
+                      <ahyp:hlinkClr xmlns:ahyp="http://schemas.microsoft.com/office/drawing/2018/hyperlinkcolor" val="tx"/>
+                    </a:ext>
+                  </a:extLst>
+                </a:hlinkClick>
+              </a:rPr>
+              <a:t>🏠 Daftar Isi</a:t>
+            </a:r>
+            <a:endParaRPr lang="en-US" sz="1000" dirty="0"/>
+          </a:p>
+        </p:txBody>
+      </p:sp>
+      <p:sp>
+        <p:nvSpPr>
+          <p:cNvPr id="6" name="Text 4">
+            <a:hlinkClick r:id="rId3" tooltip="" action="ppaction://hlinksldjump"/>
+          </p:cNvPr>
+          <p:cNvSpPr/>
+          <p:nvPr/>
+        </p:nvSpPr>
+        <p:spPr>
+          <a:xfrm>
+            <a:off x="6675120" y="4846320"/>
+            <a:ext cx="1097280" cy="0"/>
+          </a:xfrm>
+          <a:prstGeom prst="rect">
+            <a:avLst/>
+          </a:prstGeom>
+          <a:noFill/>
+          <a:ln/>
+        </p:spPr>
+        <p:txBody>
+          <a:bodyPr wrap="square" rtlCol="0" anchor="ctr"/>
+          <a:lstStyle/>
+          <a:p>
+            <a:pPr algn="r" indent="0" marL="0">
+              <a:buNone/>
+            </a:pPr>
+            <a:r>
+              <a:rPr lang="en-US" sz="1000" u="sng" dirty="0">
+                <a:solidFill>
+                  <a:srgbClr val="0563C1"/>
+                </a:solidFill>
+                <a:hlinkClick r:id="rId3" action="ppaction://hlinksldjump" tooltip="">
+                  <a:extLst>
+                    <a:ext uri="{A12FA001-AC4F-418D-AE19-62706E023703}">
+                      <ahyp:hlinkClr xmlns:ahyp="http://schemas.microsoft.com/office/drawing/2018/hyperlinkcolor" val="tx"/>
+                    </a:ext>
+                  </a:extLst>
+                </a:hlinkClick>
+              </a:rPr>
+              <a:t>📂 Lampiran</a:t>
+            </a:r>
+            <a:endParaRPr lang="en-US" sz="1000" dirty="0"/>
+          </a:p>
+        </p:txBody>
+      </p:sp>
+      <p:sp>
+        <p:nvSpPr>
+          <p:cNvPr id="7" name="Text 5">
+            <a:hlinkClick r:id="rId4" tooltip="" action="ppaction://hlinksldjump"/>
+          </p:cNvPr>
+          <p:cNvSpPr/>
+          <p:nvPr/>
+        </p:nvSpPr>
+        <p:spPr>
+          <a:xfrm>
+            <a:off x="7772400" y="4846320"/>
+            <a:ext cx="1097280" cy="0"/>
+          </a:xfrm>
+          <a:prstGeom prst="rect">
+            <a:avLst/>
+          </a:prstGeom>
+          <a:noFill/>
+          <a:ln/>
+        </p:spPr>
+        <p:txBody>
+          <a:bodyPr wrap="square" rtlCol="0" anchor="ctr"/>
+          <a:lstStyle/>
+          <a:p>
+            <a:pPr algn="r" indent="0" marL="0">
+              <a:buNone/>
+            </a:pPr>
+            <a:r>
+              <a:rPr lang="en-US" sz="1000" u="sng" dirty="0">
+                <a:solidFill>
+                  <a:srgbClr val="0563C1"/>
+                </a:solidFill>
+                <a:hlinkClick r:id="rId4" action="ppaction://hlinksldjump" tooltip="">
                   <a:extLst>
                     <a:ext uri="{A12FA001-AC4F-418D-AE19-62706E023703}">
                       <ahyp:hlinkClr xmlns:ahyp="http://schemas.microsoft.com/office/drawing/2018/hyperlinkcolor" val="tx"/>
@@ -20949,6 +22794,51 @@
         </p:nvSpPr>
         <p:spPr>
           <a:xfrm>
+            <a:off x="6675120" y="4846320"/>
+            <a:ext cx="1097280" cy="0"/>
+          </a:xfrm>
+          <a:prstGeom prst="rect">
+            <a:avLst/>
+          </a:prstGeom>
+          <a:noFill/>
+          <a:ln/>
+        </p:spPr>
+        <p:txBody>
+          <a:bodyPr wrap="square" rtlCol="0" anchor="ctr"/>
+          <a:lstStyle/>
+          <a:p>
+            <a:pPr algn="r" indent="0" marL="0">
+              <a:buNone/>
+            </a:pPr>
+            <a:r>
+              <a:rPr lang="en-US" sz="1000" u="sng" dirty="0">
+                <a:solidFill>
+                  <a:srgbClr val="0563C1"/>
+                </a:solidFill>
+                <a:hlinkClick r:id="rId1" action="ppaction://hlinksldjump" tooltip="">
+                  <a:extLst>
+                    <a:ext uri="{A12FA001-AC4F-418D-AE19-62706E023703}">
+                      <ahyp:hlinkClr xmlns:ahyp="http://schemas.microsoft.com/office/drawing/2018/hyperlinkcolor" val="tx"/>
+                    </a:ext>
+                  </a:extLst>
+                </a:hlinkClick>
+              </a:rPr>
+              <a:t>📂 Lampiran</a:t>
+            </a:r>
+            <a:endParaRPr lang="en-US" sz="1000" dirty="0"/>
+          </a:p>
+        </p:txBody>
+      </p:sp>
+      <p:sp>
+        <p:nvSpPr>
+          <p:cNvPr id="5" name="Text 3">
+            <a:hlinkClick r:id="rId2" tooltip="" action="ppaction://hlinksldjump"/>
+          </p:cNvPr>
+          <p:cNvSpPr/>
+          <p:nvPr/>
+        </p:nvSpPr>
+        <p:spPr>
+          <a:xfrm>
             <a:off x="7772400" y="4846320"/>
             <a:ext cx="1097280" cy="0"/>
           </a:xfrm>
@@ -20970,7 +22860,7 @@
                 <a:solidFill>
                   <a:srgbClr val="0563C1"/>
                 </a:solidFill>
-                <a:hlinkClick r:id="rId1" action="ppaction://hlinksldjump" tooltip="">
+                <a:hlinkClick r:id="rId2" action="ppaction://hlinksldjump" tooltip="">
                   <a:extLst>
                     <a:ext uri="{A12FA001-AC4F-418D-AE19-62706E023703}">
                       <ahyp:hlinkClr xmlns:ahyp="http://schemas.microsoft.com/office/drawing/2018/hyperlinkcolor" val="tx"/>
@@ -21345,6 +23235,51 @@
         </p:nvSpPr>
         <p:spPr>
           <a:xfrm>
+            <a:off x="6675120" y="4846320"/>
+            <a:ext cx="1097280" cy="0"/>
+          </a:xfrm>
+          <a:prstGeom prst="rect">
+            <a:avLst/>
+          </a:prstGeom>
+          <a:noFill/>
+          <a:ln/>
+        </p:spPr>
+        <p:txBody>
+          <a:bodyPr wrap="square" rtlCol="0" anchor="ctr"/>
+          <a:lstStyle/>
+          <a:p>
+            <a:pPr algn="r" indent="0" marL="0">
+              <a:buNone/>
+            </a:pPr>
+            <a:r>
+              <a:rPr lang="en-US" sz="1000" u="sng" dirty="0">
+                <a:solidFill>
+                  <a:srgbClr val="0563C1"/>
+                </a:solidFill>
+                <a:hlinkClick r:id="rId2" action="ppaction://hlinksldjump" tooltip="">
+                  <a:extLst>
+                    <a:ext uri="{A12FA001-AC4F-418D-AE19-62706E023703}">
+                      <ahyp:hlinkClr xmlns:ahyp="http://schemas.microsoft.com/office/drawing/2018/hyperlinkcolor" val="tx"/>
+                    </a:ext>
+                  </a:extLst>
+                </a:hlinkClick>
+              </a:rPr>
+              <a:t>📂 Lampiran</a:t>
+            </a:r>
+            <a:endParaRPr lang="en-US" sz="1000" dirty="0"/>
+          </a:p>
+        </p:txBody>
+      </p:sp>
+      <p:sp>
+        <p:nvSpPr>
+          <p:cNvPr id="5" name="Text 3">
+            <a:hlinkClick r:id="rId3" tooltip="" action="ppaction://hlinksldjump"/>
+          </p:cNvPr>
+          <p:cNvSpPr/>
+          <p:nvPr/>
+        </p:nvSpPr>
+        <p:spPr>
+          <a:xfrm>
             <a:off x="7772400" y="4846320"/>
             <a:ext cx="1097280" cy="0"/>
           </a:xfrm>
@@ -21366,7 +23301,7 @@
                 <a:solidFill>
                   <a:srgbClr val="0563C1"/>
                 </a:solidFill>
-                <a:hlinkClick r:id="rId2" action="ppaction://hlinksldjump" tooltip="">
+                <a:hlinkClick r:id="rId3" action="ppaction://hlinksldjump" tooltip="">
                   <a:extLst>
                     <a:ext uri="{A12FA001-AC4F-418D-AE19-62706E023703}">
                       <ahyp:hlinkClr xmlns:ahyp="http://schemas.microsoft.com/office/drawing/2018/hyperlinkcolor" val="tx"/>
@@ -21655,6 +23590,51 @@
         </p:nvSpPr>
         <p:spPr>
           <a:xfrm>
+            <a:off x="6675120" y="4846320"/>
+            <a:ext cx="1097280" cy="0"/>
+          </a:xfrm>
+          <a:prstGeom prst="rect">
+            <a:avLst/>
+          </a:prstGeom>
+          <a:noFill/>
+          <a:ln/>
+        </p:spPr>
+        <p:txBody>
+          <a:bodyPr wrap="square" rtlCol="0" anchor="ctr"/>
+          <a:lstStyle/>
+          <a:p>
+            <a:pPr algn="r" indent="0" marL="0">
+              <a:buNone/>
+            </a:pPr>
+            <a:r>
+              <a:rPr lang="en-US" sz="1000" u="sng" dirty="0">
+                <a:solidFill>
+                  <a:srgbClr val="0563C1"/>
+                </a:solidFill>
+                <a:hlinkClick r:id="rId1" action="ppaction://hlinksldjump" tooltip="">
+                  <a:extLst>
+                    <a:ext uri="{A12FA001-AC4F-418D-AE19-62706E023703}">
+                      <ahyp:hlinkClr xmlns:ahyp="http://schemas.microsoft.com/office/drawing/2018/hyperlinkcolor" val="tx"/>
+                    </a:ext>
+                  </a:extLst>
+                </a:hlinkClick>
+              </a:rPr>
+              <a:t>📂 Lampiran</a:t>
+            </a:r>
+            <a:endParaRPr lang="en-US" sz="1000" dirty="0"/>
+          </a:p>
+        </p:txBody>
+      </p:sp>
+      <p:sp>
+        <p:nvSpPr>
+          <p:cNvPr id="5" name="Text 3">
+            <a:hlinkClick r:id="rId2" tooltip="" action="ppaction://hlinksldjump"/>
+          </p:cNvPr>
+          <p:cNvSpPr/>
+          <p:nvPr/>
+        </p:nvSpPr>
+        <p:spPr>
+          <a:xfrm>
             <a:off x="7772400" y="4846320"/>
             <a:ext cx="1097280" cy="0"/>
           </a:xfrm>
@@ -21676,7 +23656,7 @@
                 <a:solidFill>
                   <a:srgbClr val="0563C1"/>
                 </a:solidFill>
-                <a:hlinkClick r:id="rId1" action="ppaction://hlinksldjump" tooltip="">
+                <a:hlinkClick r:id="rId2" action="ppaction://hlinksldjump" tooltip="">
                   <a:extLst>
                     <a:ext uri="{A12FA001-AC4F-418D-AE19-62706E023703}">
                       <ahyp:hlinkClr xmlns:ahyp="http://schemas.microsoft.com/office/drawing/2018/hyperlinkcolor" val="tx"/>
@@ -21973,6 +23953,51 @@
         </p:nvSpPr>
         <p:spPr>
           <a:xfrm>
+            <a:off x="6675120" y="4846320"/>
+            <a:ext cx="1097280" cy="0"/>
+          </a:xfrm>
+          <a:prstGeom prst="rect">
+            <a:avLst/>
+          </a:prstGeom>
+          <a:noFill/>
+          <a:ln/>
+        </p:spPr>
+        <p:txBody>
+          <a:bodyPr wrap="square" rtlCol="0" anchor="ctr"/>
+          <a:lstStyle/>
+          <a:p>
+            <a:pPr algn="r" indent="0" marL="0">
+              <a:buNone/>
+            </a:pPr>
+            <a:r>
+              <a:rPr lang="en-US" sz="1000" u="sng" dirty="0">
+                <a:solidFill>
+                  <a:srgbClr val="0563C1"/>
+                </a:solidFill>
+                <a:hlinkClick r:id="rId1" action="ppaction://hlinksldjump" tooltip="">
+                  <a:extLst>
+                    <a:ext uri="{A12FA001-AC4F-418D-AE19-62706E023703}">
+                      <ahyp:hlinkClr xmlns:ahyp="http://schemas.microsoft.com/office/drawing/2018/hyperlinkcolor" val="tx"/>
+                    </a:ext>
+                  </a:extLst>
+                </a:hlinkClick>
+              </a:rPr>
+              <a:t>📂 Lampiran</a:t>
+            </a:r>
+            <a:endParaRPr lang="en-US" sz="1000" dirty="0"/>
+          </a:p>
+        </p:txBody>
+      </p:sp>
+      <p:sp>
+        <p:nvSpPr>
+          <p:cNvPr id="5" name="Text 3">
+            <a:hlinkClick r:id="rId2" tooltip="" action="ppaction://hlinksldjump"/>
+          </p:cNvPr>
+          <p:cNvSpPr/>
+          <p:nvPr/>
+        </p:nvSpPr>
+        <p:spPr>
+          <a:xfrm>
             <a:off x="7772400" y="4846320"/>
             <a:ext cx="1097280" cy="0"/>
           </a:xfrm>
@@ -21994,7 +24019,7 @@
                 <a:solidFill>
                   <a:srgbClr val="0563C1"/>
                 </a:solidFill>
-                <a:hlinkClick r:id="rId1" action="ppaction://hlinksldjump" tooltip="">
+                <a:hlinkClick r:id="rId2" action="ppaction://hlinksldjump" tooltip="">
                   <a:extLst>
                     <a:ext uri="{A12FA001-AC4F-418D-AE19-62706E023703}">
                       <ahyp:hlinkClr xmlns:ahyp="http://schemas.microsoft.com/office/drawing/2018/hyperlinkcolor" val="tx"/>
@@ -22284,6 +24309,51 @@
         </p:nvSpPr>
         <p:spPr>
           <a:xfrm>
+            <a:off x="6675120" y="4846320"/>
+            <a:ext cx="1097280" cy="0"/>
+          </a:xfrm>
+          <a:prstGeom prst="rect">
+            <a:avLst/>
+          </a:prstGeom>
+          <a:noFill/>
+          <a:ln/>
+        </p:spPr>
+        <p:txBody>
+          <a:bodyPr wrap="square" rtlCol="0" anchor="ctr"/>
+          <a:lstStyle/>
+          <a:p>
+            <a:pPr algn="r" indent="0" marL="0">
+              <a:buNone/>
+            </a:pPr>
+            <a:r>
+              <a:rPr lang="en-US" sz="1000" u="sng" dirty="0">
+                <a:solidFill>
+                  <a:srgbClr val="0563C1"/>
+                </a:solidFill>
+                <a:hlinkClick r:id="rId1" action="ppaction://hlinksldjump" tooltip="">
+                  <a:extLst>
+                    <a:ext uri="{A12FA001-AC4F-418D-AE19-62706E023703}">
+                      <ahyp:hlinkClr xmlns:ahyp="http://schemas.microsoft.com/office/drawing/2018/hyperlinkcolor" val="tx"/>
+                    </a:ext>
+                  </a:extLst>
+                </a:hlinkClick>
+              </a:rPr>
+              <a:t>📂 Lampiran</a:t>
+            </a:r>
+            <a:endParaRPr lang="en-US" sz="1000" dirty="0"/>
+          </a:p>
+        </p:txBody>
+      </p:sp>
+      <p:sp>
+        <p:nvSpPr>
+          <p:cNvPr id="5" name="Text 3">
+            <a:hlinkClick r:id="rId2" tooltip="" action="ppaction://hlinksldjump"/>
+          </p:cNvPr>
+          <p:cNvSpPr/>
+          <p:nvPr/>
+        </p:nvSpPr>
+        <p:spPr>
+          <a:xfrm>
             <a:off x="7772400" y="4846320"/>
             <a:ext cx="1097280" cy="0"/>
           </a:xfrm>
@@ -22305,7 +24375,7 @@
                 <a:solidFill>
                   <a:srgbClr val="0563C1"/>
                 </a:solidFill>
-                <a:hlinkClick r:id="rId1" action="ppaction://hlinksldjump" tooltip="">
+                <a:hlinkClick r:id="rId2" action="ppaction://hlinksldjump" tooltip="">
                   <a:extLst>
                     <a:ext uri="{A12FA001-AC4F-418D-AE19-62706E023703}">
                       <ahyp:hlinkClr xmlns:ahyp="http://schemas.microsoft.com/office/drawing/2018/hyperlinkcolor" val="tx"/>
@@ -22525,6 +24595,51 @@
         </p:nvSpPr>
         <p:spPr>
           <a:xfrm>
+            <a:off x="6675120" y="4846320"/>
+            <a:ext cx="1097280" cy="0"/>
+          </a:xfrm>
+          <a:prstGeom prst="rect">
+            <a:avLst/>
+          </a:prstGeom>
+          <a:noFill/>
+          <a:ln/>
+        </p:spPr>
+        <p:txBody>
+          <a:bodyPr wrap="square" rtlCol="0" anchor="ctr"/>
+          <a:lstStyle/>
+          <a:p>
+            <a:pPr algn="r" indent="0" marL="0">
+              <a:buNone/>
+            </a:pPr>
+            <a:r>
+              <a:rPr lang="en-US" sz="1000" u="sng" dirty="0">
+                <a:solidFill>
+                  <a:srgbClr val="0563C1"/>
+                </a:solidFill>
+                <a:hlinkClick r:id="rId1" action="ppaction://hlinksldjump" tooltip="">
+                  <a:extLst>
+                    <a:ext uri="{A12FA001-AC4F-418D-AE19-62706E023703}">
+                      <ahyp:hlinkClr xmlns:ahyp="http://schemas.microsoft.com/office/drawing/2018/hyperlinkcolor" val="tx"/>
+                    </a:ext>
+                  </a:extLst>
+                </a:hlinkClick>
+              </a:rPr>
+              <a:t>📂 Lampiran</a:t>
+            </a:r>
+            <a:endParaRPr lang="en-US" sz="1000" dirty="0"/>
+          </a:p>
+        </p:txBody>
+      </p:sp>
+      <p:sp>
+        <p:nvSpPr>
+          <p:cNvPr id="5" name="Text 3">
+            <a:hlinkClick r:id="rId2" tooltip="" action="ppaction://hlinksldjump"/>
+          </p:cNvPr>
+          <p:cNvSpPr/>
+          <p:nvPr/>
+        </p:nvSpPr>
+        <p:spPr>
+          <a:xfrm>
             <a:off x="7772400" y="4846320"/>
             <a:ext cx="1097280" cy="0"/>
           </a:xfrm>
@@ -22546,7 +24661,7 @@
                 <a:solidFill>
                   <a:srgbClr val="0563C1"/>
                 </a:solidFill>
-                <a:hlinkClick r:id="rId1" action="ppaction://hlinksldjump" tooltip="">
+                <a:hlinkClick r:id="rId2" action="ppaction://hlinksldjump" tooltip="">
                   <a:extLst>
                     <a:ext uri="{A12FA001-AC4F-418D-AE19-62706E023703}">
                       <ahyp:hlinkClr xmlns:ahyp="http://schemas.microsoft.com/office/drawing/2018/hyperlinkcolor" val="tx"/>
@@ -22769,6 +24884,51 @@
         </p:nvSpPr>
         <p:spPr>
           <a:xfrm>
+            <a:off x="6675120" y="4846320"/>
+            <a:ext cx="1097280" cy="0"/>
+          </a:xfrm>
+          <a:prstGeom prst="rect">
+            <a:avLst/>
+          </a:prstGeom>
+          <a:noFill/>
+          <a:ln/>
+        </p:spPr>
+        <p:txBody>
+          <a:bodyPr wrap="square" rtlCol="0" anchor="ctr"/>
+          <a:lstStyle/>
+          <a:p>
+            <a:pPr algn="r" indent="0" marL="0">
+              <a:buNone/>
+            </a:pPr>
+            <a:r>
+              <a:rPr lang="en-US" sz="1000" u="sng" dirty="0">
+                <a:solidFill>
+                  <a:srgbClr val="0563C1"/>
+                </a:solidFill>
+                <a:hlinkClick r:id="rId1" action="ppaction://hlinksldjump" tooltip="">
+                  <a:extLst>
+                    <a:ext uri="{A12FA001-AC4F-418D-AE19-62706E023703}">
+                      <ahyp:hlinkClr xmlns:ahyp="http://schemas.microsoft.com/office/drawing/2018/hyperlinkcolor" val="tx"/>
+                    </a:ext>
+                  </a:extLst>
+                </a:hlinkClick>
+              </a:rPr>
+              <a:t>📂 Lampiran</a:t>
+            </a:r>
+            <a:endParaRPr lang="en-US" sz="1000" dirty="0"/>
+          </a:p>
+        </p:txBody>
+      </p:sp>
+      <p:sp>
+        <p:nvSpPr>
+          <p:cNvPr id="5" name="Text 3">
+            <a:hlinkClick r:id="rId2" tooltip="" action="ppaction://hlinksldjump"/>
+          </p:cNvPr>
+          <p:cNvSpPr/>
+          <p:nvPr/>
+        </p:nvSpPr>
+        <p:spPr>
+          <a:xfrm>
             <a:off x="7772400" y="4846320"/>
             <a:ext cx="1097280" cy="0"/>
           </a:xfrm>
@@ -22790,7 +24950,7 @@
                 <a:solidFill>
                   <a:srgbClr val="0563C1"/>
                 </a:solidFill>
-                <a:hlinkClick r:id="rId1" action="ppaction://hlinksldjump" tooltip="">
+                <a:hlinkClick r:id="rId2" action="ppaction://hlinksldjump" tooltip="">
                   <a:extLst>
                     <a:ext uri="{A12FA001-AC4F-418D-AE19-62706E023703}">
                       <ahyp:hlinkClr xmlns:ahyp="http://schemas.microsoft.com/office/drawing/2018/hyperlinkcolor" val="tx"/>
@@ -23047,6 +25207,51 @@
         </p:nvSpPr>
         <p:spPr>
           <a:xfrm>
+            <a:off x="6675120" y="4846320"/>
+            <a:ext cx="1097280" cy="0"/>
+          </a:xfrm>
+          <a:prstGeom prst="rect">
+            <a:avLst/>
+          </a:prstGeom>
+          <a:noFill/>
+          <a:ln/>
+        </p:spPr>
+        <p:txBody>
+          <a:bodyPr wrap="square" rtlCol="0" anchor="ctr"/>
+          <a:lstStyle/>
+          <a:p>
+            <a:pPr algn="r" indent="0" marL="0">
+              <a:buNone/>
+            </a:pPr>
+            <a:r>
+              <a:rPr lang="en-US" sz="1000" u="sng" dirty="0">
+                <a:solidFill>
+                  <a:srgbClr val="0563C1"/>
+                </a:solidFill>
+                <a:hlinkClick r:id="rId1" action="ppaction://hlinksldjump" tooltip="">
+                  <a:extLst>
+                    <a:ext uri="{A12FA001-AC4F-418D-AE19-62706E023703}">
+                      <ahyp:hlinkClr xmlns:ahyp="http://schemas.microsoft.com/office/drawing/2018/hyperlinkcolor" val="tx"/>
+                    </a:ext>
+                  </a:extLst>
+                </a:hlinkClick>
+              </a:rPr>
+              <a:t>📂 Lampiran</a:t>
+            </a:r>
+            <a:endParaRPr lang="en-US" sz="1000" dirty="0"/>
+          </a:p>
+        </p:txBody>
+      </p:sp>
+      <p:sp>
+        <p:nvSpPr>
+          <p:cNvPr id="5" name="Text 3">
+            <a:hlinkClick r:id="rId2" tooltip="" action="ppaction://hlinksldjump"/>
+          </p:cNvPr>
+          <p:cNvSpPr/>
+          <p:nvPr/>
+        </p:nvSpPr>
+        <p:spPr>
+          <a:xfrm>
             <a:off x="7772400" y="4846320"/>
             <a:ext cx="1097280" cy="0"/>
           </a:xfrm>
@@ -23068,7 +25273,7 @@
                 <a:solidFill>
                   <a:srgbClr val="0563C1"/>
                 </a:solidFill>
-                <a:hlinkClick r:id="rId1" action="ppaction://hlinksldjump" tooltip="">
+                <a:hlinkClick r:id="rId2" action="ppaction://hlinksldjump" tooltip="">
                   <a:extLst>
                     <a:ext uri="{A12FA001-AC4F-418D-AE19-62706E023703}">
                       <ahyp:hlinkClr xmlns:ahyp="http://schemas.microsoft.com/office/drawing/2018/hyperlinkcolor" val="tx"/>
@@ -23638,6 +25843,51 @@
         </p:nvSpPr>
         <p:spPr>
           <a:xfrm>
+            <a:off x="6675120" y="4846320"/>
+            <a:ext cx="1097280" cy="0"/>
+          </a:xfrm>
+          <a:prstGeom prst="rect">
+            <a:avLst/>
+          </a:prstGeom>
+          <a:noFill/>
+          <a:ln/>
+        </p:spPr>
+        <p:txBody>
+          <a:bodyPr wrap="square" rtlCol="0" anchor="ctr"/>
+          <a:lstStyle/>
+          <a:p>
+            <a:pPr algn="r" indent="0" marL="0">
+              <a:buNone/>
+            </a:pPr>
+            <a:r>
+              <a:rPr lang="en-US" sz="1000" u="sng" dirty="0">
+                <a:solidFill>
+                  <a:srgbClr val="0563C1"/>
+                </a:solidFill>
+                <a:hlinkClick r:id="rId1" action="ppaction://hlinksldjump" tooltip="">
+                  <a:extLst>
+                    <a:ext uri="{A12FA001-AC4F-418D-AE19-62706E023703}">
+                      <ahyp:hlinkClr xmlns:ahyp="http://schemas.microsoft.com/office/drawing/2018/hyperlinkcolor" val="tx"/>
+                    </a:ext>
+                  </a:extLst>
+                </a:hlinkClick>
+              </a:rPr>
+              <a:t>📂 Lampiran</a:t>
+            </a:r>
+            <a:endParaRPr lang="en-US" sz="1000" dirty="0"/>
+          </a:p>
+        </p:txBody>
+      </p:sp>
+      <p:sp>
+        <p:nvSpPr>
+          <p:cNvPr id="5" name="Text 3">
+            <a:hlinkClick r:id="rId2" tooltip="" action="ppaction://hlinksldjump"/>
+          </p:cNvPr>
+          <p:cNvSpPr/>
+          <p:nvPr/>
+        </p:nvSpPr>
+        <p:spPr>
+          <a:xfrm>
             <a:off x="7772400" y="4846320"/>
             <a:ext cx="1097280" cy="0"/>
           </a:xfrm>
@@ -23659,7 +25909,7 @@
                 <a:solidFill>
                   <a:srgbClr val="0563C1"/>
                 </a:solidFill>
-                <a:hlinkClick r:id="rId1" action="ppaction://hlinksldjump" tooltip="">
+                <a:hlinkClick r:id="rId2" action="ppaction://hlinksldjump" tooltip="">
                   <a:extLst>
                     <a:ext uri="{A12FA001-AC4F-418D-AE19-62706E023703}">
                       <ahyp:hlinkClr xmlns:ahyp="http://schemas.microsoft.com/office/drawing/2018/hyperlinkcolor" val="tx"/>
@@ -23917,6 +26167,51 @@
         </p:nvSpPr>
         <p:spPr>
           <a:xfrm>
+            <a:off x="6675120" y="4846320"/>
+            <a:ext cx="1097280" cy="0"/>
+          </a:xfrm>
+          <a:prstGeom prst="rect">
+            <a:avLst/>
+          </a:prstGeom>
+          <a:noFill/>
+          <a:ln/>
+        </p:spPr>
+        <p:txBody>
+          <a:bodyPr wrap="square" rtlCol="0" anchor="ctr"/>
+          <a:lstStyle/>
+          <a:p>
+            <a:pPr algn="r" indent="0" marL="0">
+              <a:buNone/>
+            </a:pPr>
+            <a:r>
+              <a:rPr lang="en-US" sz="1000" u="sng" dirty="0">
+                <a:solidFill>
+                  <a:srgbClr val="0563C1"/>
+                </a:solidFill>
+                <a:hlinkClick r:id="rId1" action="ppaction://hlinksldjump" tooltip="">
+                  <a:extLst>
+                    <a:ext uri="{A12FA001-AC4F-418D-AE19-62706E023703}">
+                      <ahyp:hlinkClr xmlns:ahyp="http://schemas.microsoft.com/office/drawing/2018/hyperlinkcolor" val="tx"/>
+                    </a:ext>
+                  </a:extLst>
+                </a:hlinkClick>
+              </a:rPr>
+              <a:t>📂 Lampiran</a:t>
+            </a:r>
+            <a:endParaRPr lang="en-US" sz="1000" dirty="0"/>
+          </a:p>
+        </p:txBody>
+      </p:sp>
+      <p:sp>
+        <p:nvSpPr>
+          <p:cNvPr id="5" name="Text 3">
+            <a:hlinkClick r:id="rId2" tooltip="" action="ppaction://hlinksldjump"/>
+          </p:cNvPr>
+          <p:cNvSpPr/>
+          <p:nvPr/>
+        </p:nvSpPr>
+        <p:spPr>
+          <a:xfrm>
             <a:off x="7772400" y="4846320"/>
             <a:ext cx="1097280" cy="0"/>
           </a:xfrm>
@@ -23938,7 +26233,7 @@
                 <a:solidFill>
                   <a:srgbClr val="0563C1"/>
                 </a:solidFill>
-                <a:hlinkClick r:id="rId1" action="ppaction://hlinksldjump" tooltip="">
+                <a:hlinkClick r:id="rId2" action="ppaction://hlinksldjump" tooltip="">
                   <a:extLst>
                     <a:ext uri="{A12FA001-AC4F-418D-AE19-62706E023703}">
                       <ahyp:hlinkClr xmlns:ahyp="http://schemas.microsoft.com/office/drawing/2018/hyperlinkcolor" val="tx"/>
@@ -24255,6 +26550,51 @@
         </p:nvSpPr>
         <p:spPr>
           <a:xfrm>
+            <a:off x="6675120" y="4846320"/>
+            <a:ext cx="1097280" cy="0"/>
+          </a:xfrm>
+          <a:prstGeom prst="rect">
+            <a:avLst/>
+          </a:prstGeom>
+          <a:noFill/>
+          <a:ln/>
+        </p:spPr>
+        <p:txBody>
+          <a:bodyPr wrap="square" rtlCol="0" anchor="ctr"/>
+          <a:lstStyle/>
+          <a:p>
+            <a:pPr algn="r" indent="0" marL="0">
+              <a:buNone/>
+            </a:pPr>
+            <a:r>
+              <a:rPr lang="en-US" sz="1000" u="sng" dirty="0">
+                <a:solidFill>
+                  <a:srgbClr val="0563C1"/>
+                </a:solidFill>
+                <a:hlinkClick r:id="rId1" action="ppaction://hlinksldjump" tooltip="">
+                  <a:extLst>
+                    <a:ext uri="{A12FA001-AC4F-418D-AE19-62706E023703}">
+                      <ahyp:hlinkClr xmlns:ahyp="http://schemas.microsoft.com/office/drawing/2018/hyperlinkcolor" val="tx"/>
+                    </a:ext>
+                  </a:extLst>
+                </a:hlinkClick>
+              </a:rPr>
+              <a:t>📂 Lampiran</a:t>
+            </a:r>
+            <a:endParaRPr lang="en-US" sz="1000" dirty="0"/>
+          </a:p>
+        </p:txBody>
+      </p:sp>
+      <p:sp>
+        <p:nvSpPr>
+          <p:cNvPr id="5" name="Text 3">
+            <a:hlinkClick r:id="rId2" tooltip="" action="ppaction://hlinksldjump"/>
+          </p:cNvPr>
+          <p:cNvSpPr/>
+          <p:nvPr/>
+        </p:nvSpPr>
+        <p:spPr>
+          <a:xfrm>
             <a:off x="7772400" y="4846320"/>
             <a:ext cx="1097280" cy="0"/>
           </a:xfrm>
@@ -24276,7 +26616,7 @@
                 <a:solidFill>
                   <a:srgbClr val="0563C1"/>
                 </a:solidFill>
-                <a:hlinkClick r:id="rId1" action="ppaction://hlinksldjump" tooltip="">
+                <a:hlinkClick r:id="rId2" action="ppaction://hlinksldjump" tooltip="">
                   <a:extLst>
                     <a:ext uri="{A12FA001-AC4F-418D-AE19-62706E023703}">
                       <ahyp:hlinkClr xmlns:ahyp="http://schemas.microsoft.com/office/drawing/2018/hyperlinkcolor" val="tx"/>
@@ -24649,6 +26989,51 @@
         </p:nvSpPr>
         <p:spPr>
           <a:xfrm>
+            <a:off x="6675120" y="4846320"/>
+            <a:ext cx="1097280" cy="0"/>
+          </a:xfrm>
+          <a:prstGeom prst="rect">
+            <a:avLst/>
+          </a:prstGeom>
+          <a:noFill/>
+          <a:ln/>
+        </p:spPr>
+        <p:txBody>
+          <a:bodyPr wrap="square" rtlCol="0" anchor="ctr"/>
+          <a:lstStyle/>
+          <a:p>
+            <a:pPr algn="r" indent="0" marL="0">
+              <a:buNone/>
+            </a:pPr>
+            <a:r>
+              <a:rPr lang="en-US" sz="1000" u="sng" dirty="0">
+                <a:solidFill>
+                  <a:srgbClr val="0563C1"/>
+                </a:solidFill>
+                <a:hlinkClick r:id="rId1" action="ppaction://hlinksldjump" tooltip="">
+                  <a:extLst>
+                    <a:ext uri="{A12FA001-AC4F-418D-AE19-62706E023703}">
+                      <ahyp:hlinkClr xmlns:ahyp="http://schemas.microsoft.com/office/drawing/2018/hyperlinkcolor" val="tx"/>
+                    </a:ext>
+                  </a:extLst>
+                </a:hlinkClick>
+              </a:rPr>
+              <a:t>📂 Lampiran</a:t>
+            </a:r>
+            <a:endParaRPr lang="en-US" sz="1000" dirty="0"/>
+          </a:p>
+        </p:txBody>
+      </p:sp>
+      <p:sp>
+        <p:nvSpPr>
+          <p:cNvPr id="6" name="Text 4">
+            <a:hlinkClick r:id="rId2" tooltip="" action="ppaction://hlinksldjump"/>
+          </p:cNvPr>
+          <p:cNvSpPr/>
+          <p:nvPr/>
+        </p:nvSpPr>
+        <p:spPr>
+          <a:xfrm>
             <a:off x="7772400" y="4846320"/>
             <a:ext cx="1097280" cy="0"/>
           </a:xfrm>
@@ -24670,7 +27055,7 @@
                 <a:solidFill>
                   <a:srgbClr val="0563C1"/>
                 </a:solidFill>
-                <a:hlinkClick r:id="rId1" action="ppaction://hlinksldjump" tooltip="">
+                <a:hlinkClick r:id="rId2" action="ppaction://hlinksldjump" tooltip="">
                   <a:extLst>
                     <a:ext uri="{A12FA001-AC4F-418D-AE19-62706E023703}">
                       <ahyp:hlinkClr xmlns:ahyp="http://schemas.microsoft.com/office/drawing/2018/hyperlinkcolor" val="tx"/>
@@ -24986,6 +27371,51 @@
         </p:nvSpPr>
         <p:spPr>
           <a:xfrm>
+            <a:off x="6675120" y="4846320"/>
+            <a:ext cx="1097280" cy="0"/>
+          </a:xfrm>
+          <a:prstGeom prst="rect">
+            <a:avLst/>
+          </a:prstGeom>
+          <a:noFill/>
+          <a:ln/>
+        </p:spPr>
+        <p:txBody>
+          <a:bodyPr wrap="square" rtlCol="0" anchor="ctr"/>
+          <a:lstStyle/>
+          <a:p>
+            <a:pPr algn="r" indent="0" marL="0">
+              <a:buNone/>
+            </a:pPr>
+            <a:r>
+              <a:rPr lang="en-US" sz="1000" u="sng" dirty="0">
+                <a:solidFill>
+                  <a:srgbClr val="0563C1"/>
+                </a:solidFill>
+                <a:hlinkClick r:id="rId1" action="ppaction://hlinksldjump" tooltip="">
+                  <a:extLst>
+                    <a:ext uri="{A12FA001-AC4F-418D-AE19-62706E023703}">
+                      <ahyp:hlinkClr xmlns:ahyp="http://schemas.microsoft.com/office/drawing/2018/hyperlinkcolor" val="tx"/>
+                    </a:ext>
+                  </a:extLst>
+                </a:hlinkClick>
+              </a:rPr>
+              <a:t>📂 Lampiran</a:t>
+            </a:r>
+            <a:endParaRPr lang="en-US" sz="1000" dirty="0"/>
+          </a:p>
+        </p:txBody>
+      </p:sp>
+      <p:sp>
+        <p:nvSpPr>
+          <p:cNvPr id="5" name="Text 3">
+            <a:hlinkClick r:id="rId2" tooltip="" action="ppaction://hlinksldjump"/>
+          </p:cNvPr>
+          <p:cNvSpPr/>
+          <p:nvPr/>
+        </p:nvSpPr>
+        <p:spPr>
+          <a:xfrm>
             <a:off x="7772400" y="4846320"/>
             <a:ext cx="1097280" cy="0"/>
           </a:xfrm>
@@ -25007,7 +27437,7 @@
                 <a:solidFill>
                   <a:srgbClr val="0563C1"/>
                 </a:solidFill>
-                <a:hlinkClick r:id="rId1" action="ppaction://hlinksldjump" tooltip="">
+                <a:hlinkClick r:id="rId2" action="ppaction://hlinksldjump" tooltip="">
                   <a:extLst>
                     <a:ext uri="{A12FA001-AC4F-418D-AE19-62706E023703}">
                       <ahyp:hlinkClr xmlns:ahyp="http://schemas.microsoft.com/office/drawing/2018/hyperlinkcolor" val="tx"/>
@@ -25092,6 +27522,51 @@
         </p:nvSpPr>
         <p:spPr>
           <a:xfrm>
+            <a:off x="6675120" y="4846320"/>
+            <a:ext cx="1097280" cy="0"/>
+          </a:xfrm>
+          <a:prstGeom prst="rect">
+            <a:avLst/>
+          </a:prstGeom>
+          <a:noFill/>
+          <a:ln/>
+        </p:spPr>
+        <p:txBody>
+          <a:bodyPr wrap="square" rtlCol="0" anchor="ctr"/>
+          <a:lstStyle/>
+          <a:p>
+            <a:pPr algn="r" indent="0" marL="0">
+              <a:buNone/>
+            </a:pPr>
+            <a:r>
+              <a:rPr lang="en-US" sz="1000" u="sng" dirty="0">
+                <a:solidFill>
+                  <a:srgbClr val="0563C1"/>
+                </a:solidFill>
+                <a:hlinkClick r:id="rId1" action="ppaction://hlinksldjump" tooltip="">
+                  <a:extLst>
+                    <a:ext uri="{A12FA001-AC4F-418D-AE19-62706E023703}">
+                      <ahyp:hlinkClr xmlns:ahyp="http://schemas.microsoft.com/office/drawing/2018/hyperlinkcolor" val="tx"/>
+                    </a:ext>
+                  </a:extLst>
+                </a:hlinkClick>
+              </a:rPr>
+              <a:t>📂 Lampiran</a:t>
+            </a:r>
+            <a:endParaRPr lang="en-US" sz="1000" dirty="0"/>
+          </a:p>
+        </p:txBody>
+      </p:sp>
+      <p:sp>
+        <p:nvSpPr>
+          <p:cNvPr id="4" name="Text 2">
+            <a:hlinkClick r:id="rId2" tooltip="" action="ppaction://hlinksldjump"/>
+          </p:cNvPr>
+          <p:cNvSpPr/>
+          <p:nvPr/>
+        </p:nvSpPr>
+        <p:spPr>
+          <a:xfrm>
             <a:off x="7772400" y="4846320"/>
             <a:ext cx="1097280" cy="0"/>
           </a:xfrm>
@@ -25113,7 +27588,7 @@
                 <a:solidFill>
                   <a:srgbClr val="0563C1"/>
                 </a:solidFill>
-                <a:hlinkClick r:id="rId1" action="ppaction://hlinksldjump" tooltip="">
+                <a:hlinkClick r:id="rId2" action="ppaction://hlinksldjump" tooltip="">
                   <a:extLst>
                     <a:ext uri="{A12FA001-AC4F-418D-AE19-62706E023703}">
                       <ahyp:hlinkClr xmlns:ahyp="http://schemas.microsoft.com/office/drawing/2018/hyperlinkcolor" val="tx"/>
@@ -25492,6 +27967,51 @@
         </p:nvSpPr>
         <p:spPr>
           <a:xfrm>
+            <a:off x="6675120" y="4846320"/>
+            <a:ext cx="1097280" cy="0"/>
+          </a:xfrm>
+          <a:prstGeom prst="rect">
+            <a:avLst/>
+          </a:prstGeom>
+          <a:noFill/>
+          <a:ln/>
+        </p:spPr>
+        <p:txBody>
+          <a:bodyPr wrap="square" rtlCol="0" anchor="ctr"/>
+          <a:lstStyle/>
+          <a:p>
+            <a:pPr algn="r" indent="0" marL="0">
+              <a:buNone/>
+            </a:pPr>
+            <a:r>
+              <a:rPr lang="en-US" sz="1000" u="sng" dirty="0">
+                <a:solidFill>
+                  <a:srgbClr val="0563C1"/>
+                </a:solidFill>
+                <a:hlinkClick r:id="rId1" action="ppaction://hlinksldjump" tooltip="">
+                  <a:extLst>
+                    <a:ext uri="{A12FA001-AC4F-418D-AE19-62706E023703}">
+                      <ahyp:hlinkClr xmlns:ahyp="http://schemas.microsoft.com/office/drawing/2018/hyperlinkcolor" val="tx"/>
+                    </a:ext>
+                  </a:extLst>
+                </a:hlinkClick>
+              </a:rPr>
+              <a:t>📂 Lampiran</a:t>
+            </a:r>
+            <a:endParaRPr lang="en-US" sz="1000" dirty="0"/>
+          </a:p>
+        </p:txBody>
+      </p:sp>
+      <p:sp>
+        <p:nvSpPr>
+          <p:cNvPr id="5" name="Text 3">
+            <a:hlinkClick r:id="rId2" tooltip="" action="ppaction://hlinksldjump"/>
+          </p:cNvPr>
+          <p:cNvSpPr/>
+          <p:nvPr/>
+        </p:nvSpPr>
+        <p:spPr>
+          <a:xfrm>
             <a:off x="7772400" y="4846320"/>
             <a:ext cx="1097280" cy="0"/>
           </a:xfrm>
@@ -25513,7 +28033,7 @@
                 <a:solidFill>
                   <a:srgbClr val="0563C1"/>
                 </a:solidFill>
-                <a:hlinkClick r:id="rId1" action="ppaction://hlinksldjump" tooltip="">
+                <a:hlinkClick r:id="rId2" action="ppaction://hlinksldjump" tooltip="">
                   <a:extLst>
                     <a:ext uri="{A12FA001-AC4F-418D-AE19-62706E023703}">
                       <ahyp:hlinkClr xmlns:ahyp="http://schemas.microsoft.com/office/drawing/2018/hyperlinkcolor" val="tx"/>
@@ -25622,6 +28142,51 @@
         </p:nvSpPr>
         <p:spPr>
           <a:xfrm>
+            <a:off x="6675120" y="4846320"/>
+            <a:ext cx="1097280" cy="0"/>
+          </a:xfrm>
+          <a:prstGeom prst="rect">
+            <a:avLst/>
+          </a:prstGeom>
+          <a:noFill/>
+          <a:ln/>
+        </p:spPr>
+        <p:txBody>
+          <a:bodyPr wrap="square" rtlCol="0" anchor="ctr"/>
+          <a:lstStyle/>
+          <a:p>
+            <a:pPr algn="r" indent="0" marL="0">
+              <a:buNone/>
+            </a:pPr>
+            <a:r>
+              <a:rPr lang="en-US" sz="1000" u="sng" dirty="0">
+                <a:solidFill>
+                  <a:srgbClr val="0563C1"/>
+                </a:solidFill>
+                <a:hlinkClick r:id="rId2" action="ppaction://hlinksldjump" tooltip="">
+                  <a:extLst>
+                    <a:ext uri="{A12FA001-AC4F-418D-AE19-62706E023703}">
+                      <ahyp:hlinkClr xmlns:ahyp="http://schemas.microsoft.com/office/drawing/2018/hyperlinkcolor" val="tx"/>
+                    </a:ext>
+                  </a:extLst>
+                </a:hlinkClick>
+              </a:rPr>
+              <a:t>📂 Lampiran</a:t>
+            </a:r>
+            <a:endParaRPr lang="en-US" sz="1000" dirty="0"/>
+          </a:p>
+        </p:txBody>
+      </p:sp>
+      <p:sp>
+        <p:nvSpPr>
+          <p:cNvPr id="5" name="Text 2">
+            <a:hlinkClick r:id="rId3" tooltip="" action="ppaction://hlinksldjump"/>
+          </p:cNvPr>
+          <p:cNvSpPr/>
+          <p:nvPr/>
+        </p:nvSpPr>
+        <p:spPr>
+          <a:xfrm>
             <a:off x="7772400" y="4846320"/>
             <a:ext cx="1097280" cy="0"/>
           </a:xfrm>
@@ -25643,7 +28208,7 @@
                 <a:solidFill>
                   <a:srgbClr val="0563C1"/>
                 </a:solidFill>
-                <a:hlinkClick r:id="rId2" action="ppaction://hlinksldjump" tooltip="">
+                <a:hlinkClick r:id="rId3" action="ppaction://hlinksldjump" tooltip="">
                   <a:extLst>
                     <a:ext uri="{A12FA001-AC4F-418D-AE19-62706E023703}">
                       <ahyp:hlinkClr xmlns:ahyp="http://schemas.microsoft.com/office/drawing/2018/hyperlinkcolor" val="tx"/>
@@ -27773,6 +30338,51 @@
         </p:nvSpPr>
         <p:spPr>
           <a:xfrm>
+            <a:off x="6675120" y="4846320"/>
+            <a:ext cx="1097280" cy="0"/>
+          </a:xfrm>
+          <a:prstGeom prst="rect">
+            <a:avLst/>
+          </a:prstGeom>
+          <a:noFill/>
+          <a:ln/>
+        </p:spPr>
+        <p:txBody>
+          <a:bodyPr wrap="square" rtlCol="0" anchor="ctr"/>
+          <a:lstStyle/>
+          <a:p>
+            <a:pPr algn="r" indent="0" marL="0">
+              <a:buNone/>
+            </a:pPr>
+            <a:r>
+              <a:rPr lang="en-US" sz="1000" u="sng" dirty="0">
+                <a:solidFill>
+                  <a:srgbClr val="0563C1"/>
+                </a:solidFill>
+                <a:hlinkClick r:id="rId1" action="ppaction://hlinksldjump" tooltip="">
+                  <a:extLst>
+                    <a:ext uri="{A12FA001-AC4F-418D-AE19-62706E023703}">
+                      <ahyp:hlinkClr xmlns:ahyp="http://schemas.microsoft.com/office/drawing/2018/hyperlinkcolor" val="tx"/>
+                    </a:ext>
+                  </a:extLst>
+                </a:hlinkClick>
+              </a:rPr>
+              <a:t>📂 Lampiran</a:t>
+            </a:r>
+            <a:endParaRPr lang="en-US" sz="1000" dirty="0"/>
+          </a:p>
+        </p:txBody>
+      </p:sp>
+      <p:sp>
+        <p:nvSpPr>
+          <p:cNvPr id="6" name="Text 3">
+            <a:hlinkClick r:id="rId2" tooltip="" action="ppaction://hlinksldjump"/>
+          </p:cNvPr>
+          <p:cNvSpPr/>
+          <p:nvPr/>
+        </p:nvSpPr>
+        <p:spPr>
+          <a:xfrm>
             <a:off x="7772400" y="4846320"/>
             <a:ext cx="1097280" cy="0"/>
           </a:xfrm>
@@ -27794,7 +30404,7 @@
                 <a:solidFill>
                   <a:srgbClr val="0563C1"/>
                 </a:solidFill>
-                <a:hlinkClick r:id="rId1" action="ppaction://hlinksldjump" tooltip="">
+                <a:hlinkClick r:id="rId2" action="ppaction://hlinksldjump" tooltip="">
                   <a:extLst>
                     <a:ext uri="{A12FA001-AC4F-418D-AE19-62706E023703}">
                       <ahyp:hlinkClr xmlns:ahyp="http://schemas.microsoft.com/office/drawing/2018/hyperlinkcolor" val="tx"/>

</xml_diff>